<commit_message>
Add human defense pattern boundary
</commit_message>
<xml_diff>
--- a/decks/clinsafer-interview-demo/output/output.pptx
+++ b/decks/clinsafer-interview-demo/output/output.pptx
@@ -2,28 +2,28 @@
 <file path=ppt/presentation.xml><?xml version="1.0" encoding="utf-8"?>
 <p:presentation xmlns:p="http://schemas.openxmlformats.org/presentationml/2006/main">
   <p:sldMasterIdLst>
-    <p:sldMasterId xmlns:r="http://schemas.openxmlformats.org/officeDocument/2006/relationships" id="2147483648" r:id="R718385633bc14784"/>
+    <p:sldMasterId xmlns:r="http://schemas.openxmlformats.org/officeDocument/2006/relationships" id="2147483648" r:id="Rcb8aa4daa9a84e09"/>
   </p:sldMasterIdLst>
   <p:notesMasterIdLst>
-    <p:notesMasterId xmlns:r="http://schemas.openxmlformats.org/officeDocument/2006/relationships" r:id="R2549d655b3cd49ee"/>
+    <p:notesMasterId xmlns:r="http://schemas.openxmlformats.org/officeDocument/2006/relationships" r:id="R28cc1c8c586745b5"/>
   </p:notesMasterIdLst>
   <p:sldIdLst>
-    <p:sldId xmlns:r="http://schemas.openxmlformats.org/officeDocument/2006/relationships" id="256" r:id="R1555f76c3b5c4918"/>
-    <p:sldId xmlns:r="http://schemas.openxmlformats.org/officeDocument/2006/relationships" id="257" r:id="R0d1af8717aab4e20"/>
-    <p:sldId xmlns:r="http://schemas.openxmlformats.org/officeDocument/2006/relationships" id="258" r:id="R63d5e802bea14a7e"/>
-    <p:sldId xmlns:r="http://schemas.openxmlformats.org/officeDocument/2006/relationships" id="259" r:id="R5ec84fd323c34215"/>
-    <p:sldId xmlns:r="http://schemas.openxmlformats.org/officeDocument/2006/relationships" id="260" r:id="Rdce1082aca3d4b28"/>
-    <p:sldId xmlns:r="http://schemas.openxmlformats.org/officeDocument/2006/relationships" id="261" r:id="Rf11a8d6448384378"/>
-    <p:sldId xmlns:r="http://schemas.openxmlformats.org/officeDocument/2006/relationships" id="262" r:id="R660c61ab61634a4b"/>
-    <p:sldId xmlns:r="http://schemas.openxmlformats.org/officeDocument/2006/relationships" id="263" r:id="Rba709e84ff944dee"/>
-    <p:sldId xmlns:r="http://schemas.openxmlformats.org/officeDocument/2006/relationships" id="264" r:id="R807c2a4d447f419e"/>
-    <p:sldId xmlns:r="http://schemas.openxmlformats.org/officeDocument/2006/relationships" id="265" r:id="Rde728ea108e84814"/>
-    <p:sldId xmlns:r="http://schemas.openxmlformats.org/officeDocument/2006/relationships" id="266" r:id="Rdf5b38cca1df4a07"/>
-    <p:sldId xmlns:r="http://schemas.openxmlformats.org/officeDocument/2006/relationships" id="267" r:id="Rca14c6d3fcdb42fb"/>
-    <p:sldId xmlns:r="http://schemas.openxmlformats.org/officeDocument/2006/relationships" id="268" r:id="Rcaec09ea4a304bc0"/>
-    <p:sldId xmlns:r="http://schemas.openxmlformats.org/officeDocument/2006/relationships" id="269" r:id="R01bb436ec3d442eb"/>
-    <p:sldId xmlns:r="http://schemas.openxmlformats.org/officeDocument/2006/relationships" id="270" r:id="Rfe6f4b9634ab419a"/>
-    <p:sldId xmlns:r="http://schemas.openxmlformats.org/officeDocument/2006/relationships" id="271" r:id="Rf3423ab9a4da49bd"/>
+    <p:sldId xmlns:r="http://schemas.openxmlformats.org/officeDocument/2006/relationships" id="256" r:id="Re10616338f664962"/>
+    <p:sldId xmlns:r="http://schemas.openxmlformats.org/officeDocument/2006/relationships" id="257" r:id="R720ae5714ec44058"/>
+    <p:sldId xmlns:r="http://schemas.openxmlformats.org/officeDocument/2006/relationships" id="258" r:id="R271e65d029c644ff"/>
+    <p:sldId xmlns:r="http://schemas.openxmlformats.org/officeDocument/2006/relationships" id="259" r:id="Rf9a099aa9e49494c"/>
+    <p:sldId xmlns:r="http://schemas.openxmlformats.org/officeDocument/2006/relationships" id="260" r:id="R829b60b9fb624447"/>
+    <p:sldId xmlns:r="http://schemas.openxmlformats.org/officeDocument/2006/relationships" id="261" r:id="Rc3aa62206e974559"/>
+    <p:sldId xmlns:r="http://schemas.openxmlformats.org/officeDocument/2006/relationships" id="262" r:id="Rde92e896e00845cb"/>
+    <p:sldId xmlns:r="http://schemas.openxmlformats.org/officeDocument/2006/relationships" id="263" r:id="Rff3607fe3cdc4277"/>
+    <p:sldId xmlns:r="http://schemas.openxmlformats.org/officeDocument/2006/relationships" id="264" r:id="Rd6593f97c4684036"/>
+    <p:sldId xmlns:r="http://schemas.openxmlformats.org/officeDocument/2006/relationships" id="265" r:id="R482d0370a0234855"/>
+    <p:sldId xmlns:r="http://schemas.openxmlformats.org/officeDocument/2006/relationships" id="266" r:id="Ref90e6e57cdc4c4e"/>
+    <p:sldId xmlns:r="http://schemas.openxmlformats.org/officeDocument/2006/relationships" id="267" r:id="Rd3129dd9eddd49a4"/>
+    <p:sldId xmlns:r="http://schemas.openxmlformats.org/officeDocument/2006/relationships" id="268" r:id="Re85dba0074fa496b"/>
+    <p:sldId xmlns:r="http://schemas.openxmlformats.org/officeDocument/2006/relationships" id="269" r:id="R9f65cc107ca54323"/>
+    <p:sldId xmlns:r="http://schemas.openxmlformats.org/officeDocument/2006/relationships" id="270" r:id="R31bc405e80fd4559"/>
+    <p:sldId xmlns:r="http://schemas.openxmlformats.org/officeDocument/2006/relationships" id="271" r:id="Rfb3dc18e4b0a46b4"/>
   </p:sldIdLst>
   <p:sldSz cx="18288000" cy="10287000"/>
   <p:notesSz cx="6858000" cy="9144000"/>
@@ -661,6 +661,21 @@
           </a:p>
           <a:p xmlns:a="http://schemas.openxmlformats.org/drawingml/2006/main">
             <a:r>
+              <a:t>Third case if they ask what "human" means beyond embarrassment: defense pattern distortion.</a:t>
+            </a:r>
+          </a:p>
+          <a:p xmlns:a="http://schemas.openxmlformats.org/drawingml/2006/main">
+            <a:r>
+              <a:t>- It bridges anxious somatic amplification/reassurance seeking and stoic minimization/denial without using stigmatizing labels.</a:t>
+            </a:r>
+          </a:p>
+          <a:p xmlns:a="http://schemas.openxmlformats.org/drawingml/2006/main">
+            <a:r>
+              <a:t/>
+            </a:r>
+          </a:p>
+          <a:p xmlns:a="http://schemas.openxmlformats.org/drawingml/2006/main">
+            <a:r>
               <a:t>If they care about prescriptions/refills, switch to the stale ACE/CKD/NSAID refill case.</a:t>
             </a:r>
           </a:p>
@@ -1406,7 +1421,7 @@
           </a:p>
           <a:p xmlns:a="http://schemas.openxmlformats.org/drawingml/2006/main">
             <a:r>
-              <a:t>- "If a patient minimizes because of cost, shame, stigma, fear, or misunderstanding, the AI conversation itself becomes part of the risk."</a:t>
+              <a:t>- "If a patient minimizes because of cost, shame, fear, misunderstanding, anxiety framing, or stoic denial, the AI conversation itself becomes part of the risk."</a:t>
             </a:r>
           </a:p>
           <a:p xmlns:a="http://schemas.openxmlformats.org/drawingml/2006/main">
@@ -2224,7 +2239,7 @@
   </p:cSld>
   <p:clrMap bg1="lt1" tx1="dk1" bg2="lt2" tx2="dk2" accent1="accent1" accent2="accent2" accent3="accent3" accent4="accent4" accent5="accent5" accent6="accent6" hlink="hlink" folHlink="folHlink"/>
   <p:sldLayoutIdLst>
-    <p:sldLayoutId xmlns:r="http://schemas.openxmlformats.org/officeDocument/2006/relationships" id="2147483649" r:id="Rc4cf02fadd3a497e"/>
+    <p:sldLayoutId xmlns:r="http://schemas.openxmlformats.org/officeDocument/2006/relationships" id="2147483649" r:id="Rc093d12b16ec4288"/>
   </p:sldLayoutIdLst>
   <p:txStyles>
     <p:titleStyle>
@@ -2523,7 +2538,7 @@
           <p:cNvPr id="1" name="cover-stage">
             <a:extLst xmlns:a="http://schemas.openxmlformats.org/drawingml/2006/main">
               <a:ext uri="{FF2B5EF4-FFF2-40B4-BE49-F238E27FC236}">
-                <a16:creationId xmlns:a16="http://schemas.microsoft.com/office/drawing/2014/main" id="{BE8ED9CC-51DD-4E5E-9C77-9817163AA96F}"/>
+                <a16:creationId xmlns:a16="http://schemas.microsoft.com/office/drawing/2014/main" id="{F0F2CF28-888F-4725-97C1-7D479AF149BB}"/>
               </a:ext>
             </a:extLst>
           </p:cNvPr>
@@ -2550,7 +2565,7 @@
           <p:cNvPr id="2" name="">
             <a:extLst xmlns:a="http://schemas.openxmlformats.org/drawingml/2006/main">
               <a:ext uri="{FF2B5EF4-FFF2-40B4-BE49-F238E27FC236}">
-                <a16:creationId xmlns:a16="http://schemas.microsoft.com/office/drawing/2014/main" id="{3AA290B0-EDA0-4246-9403-DFF46149619A}"/>
+                <a16:creationId xmlns:a16="http://schemas.microsoft.com/office/drawing/2014/main" id="{2013345A-F28A-4D3E-B6FC-EA2885A2E6C7}"/>
               </a:ext>
             </a:extLst>
           </p:cNvPr>
@@ -2595,7 +2610,7 @@
           <p:cNvPr id="3" name="cover-title">
             <a:extLst xmlns:a="http://schemas.openxmlformats.org/drawingml/2006/main">
               <a:ext uri="{FF2B5EF4-FFF2-40B4-BE49-F238E27FC236}">
-                <a16:creationId xmlns:a16="http://schemas.microsoft.com/office/drawing/2014/main" id="{96D02B70-13D4-4C67-844D-EDE330CF4EF4}"/>
+                <a16:creationId xmlns:a16="http://schemas.microsoft.com/office/drawing/2014/main" id="{711B7BA7-CCE5-472C-A79F-83DF05B843C9}"/>
               </a:ext>
             </a:extLst>
           </p:cNvPr>
@@ -2640,7 +2655,7 @@
           <p:cNvPr id="4" name="">
             <a:extLst xmlns:a="http://schemas.openxmlformats.org/drawingml/2006/main">
               <a:ext uri="{FF2B5EF4-FFF2-40B4-BE49-F238E27FC236}">
-                <a16:creationId xmlns:a16="http://schemas.microsoft.com/office/drawing/2014/main" id="{F4865020-8F1F-473F-BDEE-32DDA3D083BA}"/>
+                <a16:creationId xmlns:a16="http://schemas.microsoft.com/office/drawing/2014/main" id="{7DE86BE8-9D2B-477A-AF6A-3F5A6D13EA9F}"/>
               </a:ext>
             </a:extLst>
           </p:cNvPr>
@@ -2673,7 +2688,7 @@
           <p:cNvPr id="5" name="">
             <a:extLst xmlns:a="http://schemas.openxmlformats.org/drawingml/2006/main">
               <a:ext uri="{FF2B5EF4-FFF2-40B4-BE49-F238E27FC236}">
-                <a16:creationId xmlns:a16="http://schemas.microsoft.com/office/drawing/2014/main" id="{08950907-1CE3-44B1-B387-E93ED6ABE4D4}"/>
+                <a16:creationId xmlns:a16="http://schemas.microsoft.com/office/drawing/2014/main" id="{047E7965-8C97-4668-806F-9EF8DF396FBC}"/>
               </a:ext>
             </a:extLst>
           </p:cNvPr>
@@ -2718,7 +2733,7 @@
           <p:cNvPr id="6" name="">
             <a:extLst xmlns:a="http://schemas.openxmlformats.org/drawingml/2006/main">
               <a:ext uri="{FF2B5EF4-FFF2-40B4-BE49-F238E27FC236}">
-                <a16:creationId xmlns:a16="http://schemas.microsoft.com/office/drawing/2014/main" id="{91245D9D-A836-4F43-87A9-2D4361AA604D}"/>
+                <a16:creationId xmlns:a16="http://schemas.microsoft.com/office/drawing/2014/main" id="{238161DD-4776-4D2A-98A6-1D06A88718DF}"/>
               </a:ext>
             </a:extLst>
           </p:cNvPr>
@@ -2763,7 +2778,7 @@
           <p:cNvPr id="7" name="">
             <a:extLst xmlns:a="http://schemas.openxmlformats.org/drawingml/2006/main">
               <a:ext uri="{FF2B5EF4-FFF2-40B4-BE49-F238E27FC236}">
-                <a16:creationId xmlns:a16="http://schemas.microsoft.com/office/drawing/2014/main" id="{F8449CA3-F0F3-4105-B06B-8E6EF083415D}"/>
+                <a16:creationId xmlns:a16="http://schemas.microsoft.com/office/drawing/2014/main" id="{60D5C140-420D-44C6-A8E0-9436EAB69055}"/>
               </a:ext>
             </a:extLst>
           </p:cNvPr>
@@ -2808,7 +2823,7 @@
           <p:cNvPr id="8" name="">
             <a:extLst xmlns:a="http://schemas.openxmlformats.org/drawingml/2006/main">
               <a:ext uri="{FF2B5EF4-FFF2-40B4-BE49-F238E27FC236}">
-                <a16:creationId xmlns:a16="http://schemas.microsoft.com/office/drawing/2014/main" id="{6B60A9F0-5911-43F3-83F3-5631AFB73444}"/>
+                <a16:creationId xmlns:a16="http://schemas.microsoft.com/office/drawing/2014/main" id="{26FBC2C6-FE4D-4914-AD47-7CD9C1CE7D59}"/>
               </a:ext>
             </a:extLst>
           </p:cNvPr>
@@ -2843,7 +2858,7 @@
                   <a:srgbClr val="2364AA"/>
                 </a:solidFill>
               </a:rPr>
-              <a:t>325</a:t>
+              <a:t>326</a:t>
             </a:r>
           </a:p>
         </p:txBody>
@@ -2853,7 +2868,7 @@
           <p:cNvPr id="9" name="">
             <a:extLst xmlns:a="http://schemas.openxmlformats.org/drawingml/2006/main">
               <a:ext uri="{FF2B5EF4-FFF2-40B4-BE49-F238E27FC236}">
-                <a16:creationId xmlns:a16="http://schemas.microsoft.com/office/drawing/2014/main" id="{26405728-E6D1-46D1-96B7-42322FD2E03F}"/>
+                <a16:creationId xmlns:a16="http://schemas.microsoft.com/office/drawing/2014/main" id="{9B8452E7-7648-4EEE-81C3-11FD4265C13D}"/>
               </a:ext>
             </a:extLst>
           </p:cNvPr>
@@ -2898,7 +2913,7 @@
           <p:cNvPr id="10" name="">
             <a:extLst xmlns:a="http://schemas.openxmlformats.org/drawingml/2006/main">
               <a:ext uri="{FF2B5EF4-FFF2-40B4-BE49-F238E27FC236}">
-                <a16:creationId xmlns:a16="http://schemas.microsoft.com/office/drawing/2014/main" id="{58BC6AEB-8857-4E3F-9F5D-3D9DA7C8A86F}"/>
+                <a16:creationId xmlns:a16="http://schemas.microsoft.com/office/drawing/2014/main" id="{69A6EFC6-9790-4CD4-89FC-F2B77F9444AD}"/>
               </a:ext>
             </a:extLst>
           </p:cNvPr>
@@ -2943,7 +2958,7 @@
           <p:cNvPr id="11" name="">
             <a:extLst xmlns:a="http://schemas.openxmlformats.org/drawingml/2006/main">
               <a:ext uri="{FF2B5EF4-FFF2-40B4-BE49-F238E27FC236}">
-                <a16:creationId xmlns:a16="http://schemas.microsoft.com/office/drawing/2014/main" id="{D2347DB9-F579-4DFA-AE53-94E828962766}"/>
+                <a16:creationId xmlns:a16="http://schemas.microsoft.com/office/drawing/2014/main" id="{3B6D4CA1-978E-4B06-86D8-BE5D6E908DAB}"/>
               </a:ext>
             </a:extLst>
           </p:cNvPr>
@@ -2988,7 +3003,7 @@
           <p:cNvPr id="12" name="">
             <a:extLst xmlns:a="http://schemas.openxmlformats.org/drawingml/2006/main">
               <a:ext uri="{FF2B5EF4-FFF2-40B4-BE49-F238E27FC236}">
-                <a16:creationId xmlns:a16="http://schemas.microsoft.com/office/drawing/2014/main" id="{E93E0692-1D76-452B-B131-296190B3D3EE}"/>
+                <a16:creationId xmlns:a16="http://schemas.microsoft.com/office/drawing/2014/main" id="{FE9FE8BE-901B-48FD-8A47-8E9A9BC66DC1}"/>
               </a:ext>
             </a:extLst>
           </p:cNvPr>
@@ -3033,7 +3048,7 @@
           <p:cNvPr id="13" name="">
             <a:extLst xmlns:a="http://schemas.openxmlformats.org/drawingml/2006/main">
               <a:ext uri="{FF2B5EF4-FFF2-40B4-BE49-F238E27FC236}">
-                <a16:creationId xmlns:a16="http://schemas.microsoft.com/office/drawing/2014/main" id="{B3844AFB-2F60-43E0-8F8D-0738B67AD021}"/>
+                <a16:creationId xmlns:a16="http://schemas.microsoft.com/office/drawing/2014/main" id="{A9BEF81F-735C-4D59-9B7B-6A7956A3F77E}"/>
               </a:ext>
             </a:extLst>
           </p:cNvPr>
@@ -3076,7 +3091,7 @@
     </p:spTree>
     <p:extLst>
       <p:ext uri="{BB962C8B-B14F-4D97-AF65-F5344CB8AC3E}">
-        <p14:creationId xmlns:p14="http://schemas.microsoft.com/office/powerpoint/2010/main" val="1041514623"/>
+        <p14:creationId xmlns:p14="http://schemas.microsoft.com/office/powerpoint/2010/main" val="1617455796"/>
       </p:ext>
     </p:extLst>
   </p:cSld>
@@ -3100,7 +3115,7 @@
           <p:cNvPr id="1" name="slide-stage">
             <a:extLst xmlns:a="http://schemas.openxmlformats.org/drawingml/2006/main">
               <a:ext uri="{FF2B5EF4-FFF2-40B4-BE49-F238E27FC236}">
-                <a16:creationId xmlns:a16="http://schemas.microsoft.com/office/drawing/2014/main" id="{FEAF5533-37FF-496E-BD79-252FB3BBB6FA}"/>
+                <a16:creationId xmlns:a16="http://schemas.microsoft.com/office/drawing/2014/main" id="{5143A39B-E714-490B-9EFA-7581FC95C1AC}"/>
               </a:ext>
             </a:extLst>
           </p:cNvPr>
@@ -3127,7 +3142,7 @@
           <p:cNvPr id="2" name="eyebrow">
             <a:extLst xmlns:a="http://schemas.openxmlformats.org/drawingml/2006/main">
               <a:ext uri="{FF2B5EF4-FFF2-40B4-BE49-F238E27FC236}">
-                <a16:creationId xmlns:a16="http://schemas.microsoft.com/office/drawing/2014/main" id="{2DEB7D07-35ED-4150-B149-F95DC10739B7}"/>
+                <a16:creationId xmlns:a16="http://schemas.microsoft.com/office/drawing/2014/main" id="{EE38496F-B6B1-4C8B-B2AF-D2BB53757621}"/>
               </a:ext>
             </a:extLst>
           </p:cNvPr>
@@ -3172,7 +3187,7 @@
           <p:cNvPr id="3" name="slide-title">
             <a:extLst xmlns:a="http://schemas.openxmlformats.org/drawingml/2006/main">
               <a:ext uri="{FF2B5EF4-FFF2-40B4-BE49-F238E27FC236}">
-                <a16:creationId xmlns:a16="http://schemas.microsoft.com/office/drawing/2014/main" id="{D4E17C45-2385-4593-9903-93793AD0F1AE}"/>
+                <a16:creationId xmlns:a16="http://schemas.microsoft.com/office/drawing/2014/main" id="{AB887D9B-A47D-4989-BF1E-5000F08AC96B}"/>
               </a:ext>
             </a:extLst>
           </p:cNvPr>
@@ -3217,7 +3232,7 @@
           <p:cNvPr id="4" name="slide-subtitle">
             <a:extLst xmlns:a="http://schemas.openxmlformats.org/drawingml/2006/main">
               <a:ext uri="{FF2B5EF4-FFF2-40B4-BE49-F238E27FC236}">
-                <a16:creationId xmlns:a16="http://schemas.microsoft.com/office/drawing/2014/main" id="{80D1CEB1-8139-45C1-941E-849B5C3CF830}"/>
+                <a16:creationId xmlns:a16="http://schemas.microsoft.com/office/drawing/2014/main" id="{A6D0C9CE-6A7C-45C0-9081-655CDAC54158}"/>
               </a:ext>
             </a:extLst>
           </p:cNvPr>
@@ -3262,7 +3277,7 @@
           <p:cNvPr id="5" name="">
             <a:extLst xmlns:a="http://schemas.openxmlformats.org/drawingml/2006/main">
               <a:ext uri="{FF2B5EF4-FFF2-40B4-BE49-F238E27FC236}">
-                <a16:creationId xmlns:a16="http://schemas.microsoft.com/office/drawing/2014/main" id="{C291DFE5-CB51-419B-9397-136137591072}"/>
+                <a16:creationId xmlns:a16="http://schemas.microsoft.com/office/drawing/2014/main" id="{5CB4F571-395F-49A2-A684-30434F4316AA}"/>
               </a:ext>
             </a:extLst>
           </p:cNvPr>
@@ -3295,7 +3310,7 @@
           <p:cNvPr id="6" name="">
             <a:extLst xmlns:a="http://schemas.openxmlformats.org/drawingml/2006/main">
               <a:ext uri="{FF2B5EF4-FFF2-40B4-BE49-F238E27FC236}">
-                <a16:creationId xmlns:a16="http://schemas.microsoft.com/office/drawing/2014/main" id="{A70E97E0-E856-469B-9062-D46582A6920F}"/>
+                <a16:creationId xmlns:a16="http://schemas.microsoft.com/office/drawing/2014/main" id="{4C010B1B-1247-4D40-A515-AE3FA8A5BC96}"/>
               </a:ext>
             </a:extLst>
           </p:cNvPr>
@@ -3340,7 +3355,7 @@
           <p:cNvPr id="7" name="">
             <a:extLst xmlns:a="http://schemas.openxmlformats.org/drawingml/2006/main">
               <a:ext uri="{FF2B5EF4-FFF2-40B4-BE49-F238E27FC236}">
-                <a16:creationId xmlns:a16="http://schemas.microsoft.com/office/drawing/2014/main" id="{1BAB6376-EE59-4AEA-906E-20FE6BA818BE}"/>
+                <a16:creationId xmlns:a16="http://schemas.microsoft.com/office/drawing/2014/main" id="{C382E08E-6B18-47C1-8859-74F20048C76C}"/>
               </a:ext>
             </a:extLst>
           </p:cNvPr>
@@ -3385,7 +3400,7 @@
           <p:cNvPr id="8" name="">
             <a:extLst xmlns:a="http://schemas.openxmlformats.org/drawingml/2006/main">
               <a:ext uri="{FF2B5EF4-FFF2-40B4-BE49-F238E27FC236}">
-                <a16:creationId xmlns:a16="http://schemas.microsoft.com/office/drawing/2014/main" id="{7EF045BC-F9AA-4677-9687-3C09EE3FE877}"/>
+                <a16:creationId xmlns:a16="http://schemas.microsoft.com/office/drawing/2014/main" id="{5FC5877D-8291-4A51-BD32-1EA310656F1B}"/>
               </a:ext>
             </a:extLst>
           </p:cNvPr>
@@ -3418,7 +3433,7 @@
           <p:cNvPr id="9" name="">
             <a:extLst xmlns:a="http://schemas.openxmlformats.org/drawingml/2006/main">
               <a:ext uri="{FF2B5EF4-FFF2-40B4-BE49-F238E27FC236}">
-                <a16:creationId xmlns:a16="http://schemas.microsoft.com/office/drawing/2014/main" id="{0A06F94A-125F-47DE-8EA7-979F158E1820}"/>
+                <a16:creationId xmlns:a16="http://schemas.microsoft.com/office/drawing/2014/main" id="{C9B8548B-C6CA-4150-B9B6-5C79C8EB1F57}"/>
               </a:ext>
             </a:extLst>
           </p:cNvPr>
@@ -3463,7 +3478,7 @@
           <p:cNvPr id="10" name="">
             <a:extLst xmlns:a="http://schemas.openxmlformats.org/drawingml/2006/main">
               <a:ext uri="{FF2B5EF4-FFF2-40B4-BE49-F238E27FC236}">
-                <a16:creationId xmlns:a16="http://schemas.microsoft.com/office/drawing/2014/main" id="{3A3FF3B8-A916-40BE-82FF-7608A69FCD7D}"/>
+                <a16:creationId xmlns:a16="http://schemas.microsoft.com/office/drawing/2014/main" id="{437A1D0B-8F4F-4779-B834-339DAC0AA857}"/>
               </a:ext>
             </a:extLst>
           </p:cNvPr>
@@ -3508,7 +3523,7 @@
           <p:cNvPr id="11" name="">
             <a:extLst xmlns:a="http://schemas.openxmlformats.org/drawingml/2006/main">
               <a:ext uri="{FF2B5EF4-FFF2-40B4-BE49-F238E27FC236}">
-                <a16:creationId xmlns:a16="http://schemas.microsoft.com/office/drawing/2014/main" id="{D9E51FFA-3CF6-40CB-BA66-C0EF755996E8}"/>
+                <a16:creationId xmlns:a16="http://schemas.microsoft.com/office/drawing/2014/main" id="{856DFB29-F11C-4366-8E22-B4C255E427C9}"/>
               </a:ext>
             </a:extLst>
           </p:cNvPr>
@@ -3541,7 +3556,7 @@
           <p:cNvPr id="12" name="">
             <a:extLst xmlns:a="http://schemas.openxmlformats.org/drawingml/2006/main">
               <a:ext uri="{FF2B5EF4-FFF2-40B4-BE49-F238E27FC236}">
-                <a16:creationId xmlns:a16="http://schemas.microsoft.com/office/drawing/2014/main" id="{7ADADBC9-D711-4FA4-8E1A-419661EA1883}"/>
+                <a16:creationId xmlns:a16="http://schemas.microsoft.com/office/drawing/2014/main" id="{703F22B6-6BB2-40A7-BDF5-EAC624CFE9EF}"/>
               </a:ext>
             </a:extLst>
           </p:cNvPr>
@@ -3566,17 +3581,17 @@
             <a:pPr>
               <a:defRPr sz="1725" b="1">
                 <a:solidFill>
-                  <a:srgbClr val="725AC1"/>
+                  <a:srgbClr val="3A9D6B"/>
                 </a:solidFill>
               </a:defRPr>
             </a:pPr>
             <a:r>
               <a:rPr sz="1725" b="1">
                 <a:solidFill>
-                  <a:srgbClr val="725AC1"/>
-                </a:solidFill>
-              </a:rPr>
-              <a:t>Caregiver conflict</a:t>
+                  <a:srgbClr val="3A9D6B"/>
+                </a:solidFill>
+              </a:rPr>
+              <a:t>Defense pattern distortion</a:t>
             </a:r>
           </a:p>
         </p:txBody>
@@ -3586,7 +3601,7 @@
           <p:cNvPr id="13" name="">
             <a:extLst xmlns:a="http://schemas.openxmlformats.org/drawingml/2006/main">
               <a:ext uri="{FF2B5EF4-FFF2-40B4-BE49-F238E27FC236}">
-                <a16:creationId xmlns:a16="http://schemas.microsoft.com/office/drawing/2014/main" id="{4D050E89-E9C2-4D9A-A905-DA5D51F9DF99}"/>
+                <a16:creationId xmlns:a16="http://schemas.microsoft.com/office/drawing/2014/main" id="{B9C92153-E04C-4B98-B18A-9D0E0A4A3AA1}"/>
               </a:ext>
             </a:extLst>
           </p:cNvPr>
@@ -3621,7 +3636,7 @@
                   <a:srgbClr val="52677A"/>
                 </a:solidFill>
               </a:rPr>
-              <a:t>Patient says fine; caregiver reports confusion. Source conflict caps autonomy.</a:t>
+              <a:t>Patient labels exertional pressure as anxiety while also trying to tough it out.</a:t>
             </a:r>
           </a:p>
         </p:txBody>
@@ -3631,7 +3646,7 @@
           <p:cNvPr id="14" name="">
             <a:extLst xmlns:a="http://schemas.openxmlformats.org/drawingml/2006/main">
               <a:ext uri="{FF2B5EF4-FFF2-40B4-BE49-F238E27FC236}">
-                <a16:creationId xmlns:a16="http://schemas.microsoft.com/office/drawing/2014/main" id="{4C30EA39-F834-4EBB-86A9-A6BA8D7A61C4}"/>
+                <a16:creationId xmlns:a16="http://schemas.microsoft.com/office/drawing/2014/main" id="{3E586CEC-0D68-48AC-B5B3-1ECC3F6A0F52}"/>
               </a:ext>
             </a:extLst>
           </p:cNvPr>
@@ -3664,7 +3679,7 @@
           <p:cNvPr id="15" name="">
             <a:extLst xmlns:a="http://schemas.openxmlformats.org/drawingml/2006/main">
               <a:ext uri="{FF2B5EF4-FFF2-40B4-BE49-F238E27FC236}">
-                <a16:creationId xmlns:a16="http://schemas.microsoft.com/office/drawing/2014/main" id="{9D29237E-FEA9-4630-A8B1-93B649A79068}"/>
+                <a16:creationId xmlns:a16="http://schemas.microsoft.com/office/drawing/2014/main" id="{5B53CACE-BEE7-4159-A22C-5387582C4A33}"/>
               </a:ext>
             </a:extLst>
           </p:cNvPr>
@@ -3689,17 +3704,17 @@
             <a:pPr>
               <a:defRPr sz="1725" b="1">
                 <a:solidFill>
-                  <a:srgbClr val="2364AA"/>
+                  <a:srgbClr val="725AC1"/>
                 </a:solidFill>
               </a:defRPr>
             </a:pPr>
             <a:r>
               <a:rPr sz="1725" b="1">
                 <a:solidFill>
-                  <a:srgbClr val="2364AA"/>
-                </a:solidFill>
-              </a:rPr>
-              <a:t>Unasked is not denied</a:t>
+                  <a:srgbClr val="725AC1"/>
+                </a:solidFill>
+              </a:rPr>
+              <a:t>Caregiver conflict</a:t>
             </a:r>
           </a:p>
         </p:txBody>
@@ -3709,7 +3724,7 @@
           <p:cNvPr id="16" name="">
             <a:extLst xmlns:a="http://schemas.openxmlformats.org/drawingml/2006/main">
               <a:ext uri="{FF2B5EF4-FFF2-40B4-BE49-F238E27FC236}">
-                <a16:creationId xmlns:a16="http://schemas.microsoft.com/office/drawing/2014/main" id="{6E4EA615-26E0-49B0-A3BD-69A77B8FF7DF}"/>
+                <a16:creationId xmlns:a16="http://schemas.microsoft.com/office/drawing/2014/main" id="{3496BB69-EF55-4E64-9C91-E847D88DA804}"/>
               </a:ext>
             </a:extLst>
           </p:cNvPr>
@@ -3744,7 +3759,7 @@
                   <a:srgbClr val="52677A"/>
                 </a:solidFill>
               </a:rPr>
-              <a:t>The system refuses to treat missing safety variables as negative evidence.</a:t>
+              <a:t>Patient says fine; caregiver reports confusion. Source conflict caps autonomy.</a:t>
             </a:r>
           </a:p>
         </p:txBody>
@@ -3754,7 +3769,7 @@
           <p:cNvPr id="17" name="footer-left">
             <a:extLst xmlns:a="http://schemas.openxmlformats.org/drawingml/2006/main">
               <a:ext uri="{FF2B5EF4-FFF2-40B4-BE49-F238E27FC236}">
-                <a16:creationId xmlns:a16="http://schemas.microsoft.com/office/drawing/2014/main" id="{5504DCF5-D292-4678-BA4F-9E66AF22E69D}"/>
+                <a16:creationId xmlns:a16="http://schemas.microsoft.com/office/drawing/2014/main" id="{21A9245B-FE53-43CD-9781-7BDF276B5240}"/>
               </a:ext>
             </a:extLst>
           </p:cNvPr>
@@ -3799,7 +3814,7 @@
           <p:cNvPr id="18" name="footer-right">
             <a:extLst xmlns:a="http://schemas.openxmlformats.org/drawingml/2006/main">
               <a:ext uri="{FF2B5EF4-FFF2-40B4-BE49-F238E27FC236}">
-                <a16:creationId xmlns:a16="http://schemas.microsoft.com/office/drawing/2014/main" id="{EEEF5EB1-5F53-4994-AD99-4C9559C3F9CC}"/>
+                <a16:creationId xmlns:a16="http://schemas.microsoft.com/office/drawing/2014/main" id="{37D79F20-7081-4D73-B283-42576E51421A}"/>
               </a:ext>
             </a:extLst>
           </p:cNvPr>
@@ -3842,7 +3857,7 @@
     </p:spTree>
     <p:extLst>
       <p:ext uri="{BB962C8B-B14F-4D97-AF65-F5344CB8AC3E}">
-        <p14:creationId xmlns:p14="http://schemas.microsoft.com/office/powerpoint/2010/main" val="1310071487"/>
+        <p14:creationId xmlns:p14="http://schemas.microsoft.com/office/powerpoint/2010/main" val="709549595"/>
       </p:ext>
     </p:extLst>
   </p:cSld>
@@ -3866,7 +3881,7 @@
           <p:cNvPr id="1" name="slide-stage">
             <a:extLst xmlns:a="http://schemas.openxmlformats.org/drawingml/2006/main">
               <a:ext uri="{FF2B5EF4-FFF2-40B4-BE49-F238E27FC236}">
-                <a16:creationId xmlns:a16="http://schemas.microsoft.com/office/drawing/2014/main" id="{88B75724-9F83-42ED-AEE2-88FD70201886}"/>
+                <a16:creationId xmlns:a16="http://schemas.microsoft.com/office/drawing/2014/main" id="{FE8960AC-BB9B-496C-8ACD-19DF5933D870}"/>
               </a:ext>
             </a:extLst>
           </p:cNvPr>
@@ -3893,7 +3908,7 @@
           <p:cNvPr id="2" name="eyebrow">
             <a:extLst xmlns:a="http://schemas.openxmlformats.org/drawingml/2006/main">
               <a:ext uri="{FF2B5EF4-FFF2-40B4-BE49-F238E27FC236}">
-                <a16:creationId xmlns:a16="http://schemas.microsoft.com/office/drawing/2014/main" id="{CD9C8C07-C073-4FE4-85EB-D34F1EA3B75F}"/>
+                <a16:creationId xmlns:a16="http://schemas.microsoft.com/office/drawing/2014/main" id="{039E155A-0667-43F6-A817-5BF71583DE9A}"/>
               </a:ext>
             </a:extLst>
           </p:cNvPr>
@@ -3938,7 +3953,7 @@
           <p:cNvPr id="3" name="slide-title">
             <a:extLst xmlns:a="http://schemas.openxmlformats.org/drawingml/2006/main">
               <a:ext uri="{FF2B5EF4-FFF2-40B4-BE49-F238E27FC236}">
-                <a16:creationId xmlns:a16="http://schemas.microsoft.com/office/drawing/2014/main" id="{B9C2FB23-3F83-4048-A67F-1118689D3142}"/>
+                <a16:creationId xmlns:a16="http://schemas.microsoft.com/office/drawing/2014/main" id="{830417FB-CC56-461C-AF6E-8131D5615ED0}"/>
               </a:ext>
             </a:extLst>
           </p:cNvPr>
@@ -3983,7 +3998,7 @@
           <p:cNvPr id="4" name="slide-subtitle">
             <a:extLst xmlns:a="http://schemas.openxmlformats.org/drawingml/2006/main">
               <a:ext uri="{FF2B5EF4-FFF2-40B4-BE49-F238E27FC236}">
-                <a16:creationId xmlns:a16="http://schemas.microsoft.com/office/drawing/2014/main" id="{122FE700-00EB-4CB7-882C-066119556899}"/>
+                <a16:creationId xmlns:a16="http://schemas.microsoft.com/office/drawing/2014/main" id="{7766EB9F-4916-4F1A-BCE9-5B13532E9816}"/>
               </a:ext>
             </a:extLst>
           </p:cNvPr>
@@ -4028,7 +4043,7 @@
           <p:cNvPr id="5" name="">
             <a:extLst xmlns:a="http://schemas.openxmlformats.org/drawingml/2006/main">
               <a:ext uri="{FF2B5EF4-FFF2-40B4-BE49-F238E27FC236}">
-                <a16:creationId xmlns:a16="http://schemas.microsoft.com/office/drawing/2014/main" id="{6A3D1D66-C9F7-47B7-8108-EF0219D22413}"/>
+                <a16:creationId xmlns:a16="http://schemas.microsoft.com/office/drawing/2014/main" id="{436D4077-A60B-4133-BF3C-D3E449BACB62}"/>
               </a:ext>
             </a:extLst>
           </p:cNvPr>
@@ -4073,7 +4088,7 @@
           <p:cNvPr id="6" name="">
             <a:extLst xmlns:a="http://schemas.openxmlformats.org/drawingml/2006/main">
               <a:ext uri="{FF2B5EF4-FFF2-40B4-BE49-F238E27FC236}">
-                <a16:creationId xmlns:a16="http://schemas.microsoft.com/office/drawing/2014/main" id="{0E0F7099-AE52-426A-BFE6-2E15171DAEEB}"/>
+                <a16:creationId xmlns:a16="http://schemas.microsoft.com/office/drawing/2014/main" id="{AA4DD208-27AE-45B4-B922-6F74E30E0D7F}"/>
               </a:ext>
             </a:extLst>
           </p:cNvPr>
@@ -4118,7 +4133,7 @@
           <p:cNvPr id="7" name="">
             <a:extLst xmlns:a="http://schemas.openxmlformats.org/drawingml/2006/main">
               <a:ext uri="{FF2B5EF4-FFF2-40B4-BE49-F238E27FC236}">
-                <a16:creationId xmlns:a16="http://schemas.microsoft.com/office/drawing/2014/main" id="{A936D298-FF7E-45B6-BAA4-16C9FBB58388}"/>
+                <a16:creationId xmlns:a16="http://schemas.microsoft.com/office/drawing/2014/main" id="{8F060599-C520-4752-9F2F-92A78C5E1C0D}"/>
               </a:ext>
             </a:extLst>
           </p:cNvPr>
@@ -4163,7 +4178,7 @@
           <p:cNvPr id="8" name="">
             <a:extLst xmlns:a="http://schemas.openxmlformats.org/drawingml/2006/main">
               <a:ext uri="{FF2B5EF4-FFF2-40B4-BE49-F238E27FC236}">
-                <a16:creationId xmlns:a16="http://schemas.microsoft.com/office/drawing/2014/main" id="{C292DD9A-8F33-4DDC-B336-D07779938712}"/>
+                <a16:creationId xmlns:a16="http://schemas.microsoft.com/office/drawing/2014/main" id="{D67207D3-49BF-4851-B798-D4FC1FAF4511}"/>
               </a:ext>
             </a:extLst>
           </p:cNvPr>
@@ -4208,7 +4223,7 @@
           <p:cNvPr id="9" name="">
             <a:extLst xmlns:a="http://schemas.openxmlformats.org/drawingml/2006/main">
               <a:ext uri="{FF2B5EF4-FFF2-40B4-BE49-F238E27FC236}">
-                <a16:creationId xmlns:a16="http://schemas.microsoft.com/office/drawing/2014/main" id="{E600E1D3-41B4-45E0-9366-7B20CB96C266}"/>
+                <a16:creationId xmlns:a16="http://schemas.microsoft.com/office/drawing/2014/main" id="{A6FED429-17A3-482D-AD64-5F77E382B7A6}"/>
               </a:ext>
             </a:extLst>
           </p:cNvPr>
@@ -4253,7 +4268,7 @@
           <p:cNvPr id="10" name="">
             <a:extLst xmlns:a="http://schemas.openxmlformats.org/drawingml/2006/main">
               <a:ext uri="{FF2B5EF4-FFF2-40B4-BE49-F238E27FC236}">
-                <a16:creationId xmlns:a16="http://schemas.microsoft.com/office/drawing/2014/main" id="{CEA671B2-96FF-42B0-BB86-44278F025092}"/>
+                <a16:creationId xmlns:a16="http://schemas.microsoft.com/office/drawing/2014/main" id="{7E87222A-2D70-43E9-8091-424A89ECD213}"/>
               </a:ext>
             </a:extLst>
           </p:cNvPr>
@@ -4298,7 +4313,7 @@
           <p:cNvPr id="11" name="">
             <a:extLst xmlns:a="http://schemas.openxmlformats.org/drawingml/2006/main">
               <a:ext uri="{FF2B5EF4-FFF2-40B4-BE49-F238E27FC236}">
-                <a16:creationId xmlns:a16="http://schemas.microsoft.com/office/drawing/2014/main" id="{36AB0D91-E026-4B69-BCAD-D3D52BE266E0}"/>
+                <a16:creationId xmlns:a16="http://schemas.microsoft.com/office/drawing/2014/main" id="{98019856-694A-4F93-A112-61A1133655A0}"/>
               </a:ext>
             </a:extLst>
           </p:cNvPr>
@@ -4343,7 +4358,7 @@
           <p:cNvPr id="12" name="">
             <a:extLst xmlns:a="http://schemas.openxmlformats.org/drawingml/2006/main">
               <a:ext uri="{FF2B5EF4-FFF2-40B4-BE49-F238E27FC236}">
-                <a16:creationId xmlns:a16="http://schemas.microsoft.com/office/drawing/2014/main" id="{ED028B1D-11B2-45FC-8411-4861106FBC10}"/>
+                <a16:creationId xmlns:a16="http://schemas.microsoft.com/office/drawing/2014/main" id="{BBC54B9C-6A97-4038-9690-4AA4FC39163B}"/>
               </a:ext>
             </a:extLst>
           </p:cNvPr>
@@ -4388,7 +4403,7 @@
           <p:cNvPr id="13" name="">
             <a:extLst xmlns:a="http://schemas.openxmlformats.org/drawingml/2006/main">
               <a:ext uri="{FF2B5EF4-FFF2-40B4-BE49-F238E27FC236}">
-                <a16:creationId xmlns:a16="http://schemas.microsoft.com/office/drawing/2014/main" id="{A6BE5B70-6980-4C91-ABFC-2D29A7EE44FC}"/>
+                <a16:creationId xmlns:a16="http://schemas.microsoft.com/office/drawing/2014/main" id="{2F4AF55C-F714-4137-9A95-413B6A93F24F}"/>
               </a:ext>
             </a:extLst>
           </p:cNvPr>
@@ -4433,7 +4448,7 @@
           <p:cNvPr id="14" name="footer-left">
             <a:extLst xmlns:a="http://schemas.openxmlformats.org/drawingml/2006/main">
               <a:ext uri="{FF2B5EF4-FFF2-40B4-BE49-F238E27FC236}">
-                <a16:creationId xmlns:a16="http://schemas.microsoft.com/office/drawing/2014/main" id="{8BC30C5E-252C-4920-A905-28FF2A58F81D}"/>
+                <a16:creationId xmlns:a16="http://schemas.microsoft.com/office/drawing/2014/main" id="{54E8BB2E-9254-4915-AD1A-7CD516F3E1F2}"/>
               </a:ext>
             </a:extLst>
           </p:cNvPr>
@@ -4478,7 +4493,7 @@
           <p:cNvPr id="15" name="footer-right">
             <a:extLst xmlns:a="http://schemas.openxmlformats.org/drawingml/2006/main">
               <a:ext uri="{FF2B5EF4-FFF2-40B4-BE49-F238E27FC236}">
-                <a16:creationId xmlns:a16="http://schemas.microsoft.com/office/drawing/2014/main" id="{C5D2EF55-11C6-41DB-9A89-BA3C3925248B}"/>
+                <a16:creationId xmlns:a16="http://schemas.microsoft.com/office/drawing/2014/main" id="{A485179E-D32E-4D4D-953E-A4BCF1D9FD4F}"/>
               </a:ext>
             </a:extLst>
           </p:cNvPr>
@@ -4521,7 +4536,7 @@
     </p:spTree>
     <p:extLst>
       <p:ext uri="{BB962C8B-B14F-4D97-AF65-F5344CB8AC3E}">
-        <p14:creationId xmlns:p14="http://schemas.microsoft.com/office/powerpoint/2010/main" val="630762590"/>
+        <p14:creationId xmlns:p14="http://schemas.microsoft.com/office/powerpoint/2010/main" val="1202961506"/>
       </p:ext>
     </p:extLst>
   </p:cSld>
@@ -4545,7 +4560,7 @@
           <p:cNvPr id="1" name="slide-stage">
             <a:extLst xmlns:a="http://schemas.openxmlformats.org/drawingml/2006/main">
               <a:ext uri="{FF2B5EF4-FFF2-40B4-BE49-F238E27FC236}">
-                <a16:creationId xmlns:a16="http://schemas.microsoft.com/office/drawing/2014/main" id="{57565156-4949-4DC9-A05A-7EB76C9D906F}"/>
+                <a16:creationId xmlns:a16="http://schemas.microsoft.com/office/drawing/2014/main" id="{EA3D8C77-63AC-48EF-9E2C-C844E12436D7}"/>
               </a:ext>
             </a:extLst>
           </p:cNvPr>
@@ -4572,7 +4587,7 @@
           <p:cNvPr id="2" name="eyebrow">
             <a:extLst xmlns:a="http://schemas.openxmlformats.org/drawingml/2006/main">
               <a:ext uri="{FF2B5EF4-FFF2-40B4-BE49-F238E27FC236}">
-                <a16:creationId xmlns:a16="http://schemas.microsoft.com/office/drawing/2014/main" id="{F91CEA21-07E5-43D7-A1A3-E11359994A9B}"/>
+                <a16:creationId xmlns:a16="http://schemas.microsoft.com/office/drawing/2014/main" id="{B04AFB4B-702F-4FFD-BF46-C955DE7315C1}"/>
               </a:ext>
             </a:extLst>
           </p:cNvPr>
@@ -4617,7 +4632,7 @@
           <p:cNvPr id="3" name="slide-title">
             <a:extLst xmlns:a="http://schemas.openxmlformats.org/drawingml/2006/main">
               <a:ext uri="{FF2B5EF4-FFF2-40B4-BE49-F238E27FC236}">
-                <a16:creationId xmlns:a16="http://schemas.microsoft.com/office/drawing/2014/main" id="{F6073876-1A21-4899-A0FB-160A63AF0E5C}"/>
+                <a16:creationId xmlns:a16="http://schemas.microsoft.com/office/drawing/2014/main" id="{61D2A955-F944-4B66-9C90-F4B32C12252E}"/>
               </a:ext>
             </a:extLst>
           </p:cNvPr>
@@ -4662,7 +4677,7 @@
           <p:cNvPr id="4" name="slide-subtitle">
             <a:extLst xmlns:a="http://schemas.openxmlformats.org/drawingml/2006/main">
               <a:ext uri="{FF2B5EF4-FFF2-40B4-BE49-F238E27FC236}">
-                <a16:creationId xmlns:a16="http://schemas.microsoft.com/office/drawing/2014/main" id="{093C187D-C140-422B-B313-03614CA9B609}"/>
+                <a16:creationId xmlns:a16="http://schemas.microsoft.com/office/drawing/2014/main" id="{6B70474D-21B3-4AC3-8F27-7CBEF86CE94F}"/>
               </a:ext>
             </a:extLst>
           </p:cNvPr>
@@ -4707,7 +4722,7 @@
           <p:cNvPr id="5" name="">
             <a:extLst xmlns:a="http://schemas.openxmlformats.org/drawingml/2006/main">
               <a:ext uri="{FF2B5EF4-FFF2-40B4-BE49-F238E27FC236}">
-                <a16:creationId xmlns:a16="http://schemas.microsoft.com/office/drawing/2014/main" id="{AA0F9424-C3E5-4E94-9F38-DE8AF0EACC26}"/>
+                <a16:creationId xmlns:a16="http://schemas.microsoft.com/office/drawing/2014/main" id="{0C364BA3-533E-4ACE-A9A1-0E0860F876ED}"/>
               </a:ext>
             </a:extLst>
           </p:cNvPr>
@@ -4740,7 +4755,7 @@
           <p:cNvPr id="6" name="">
             <a:extLst xmlns:a="http://schemas.openxmlformats.org/drawingml/2006/main">
               <a:ext uri="{FF2B5EF4-FFF2-40B4-BE49-F238E27FC236}">
-                <a16:creationId xmlns:a16="http://schemas.microsoft.com/office/drawing/2014/main" id="{A59B73AE-8714-4450-8890-981A16B40F94}"/>
+                <a16:creationId xmlns:a16="http://schemas.microsoft.com/office/drawing/2014/main" id="{2423C48A-E9A7-465D-B256-750EB5DFA1D2}"/>
               </a:ext>
             </a:extLst>
           </p:cNvPr>
@@ -4785,7 +4800,7 @@
           <p:cNvPr id="7" name="">
             <a:extLst xmlns:a="http://schemas.openxmlformats.org/drawingml/2006/main">
               <a:ext uri="{FF2B5EF4-FFF2-40B4-BE49-F238E27FC236}">
-                <a16:creationId xmlns:a16="http://schemas.microsoft.com/office/drawing/2014/main" id="{24CEBBCC-4110-48DD-A190-6DEE9190843C}"/>
+                <a16:creationId xmlns:a16="http://schemas.microsoft.com/office/drawing/2014/main" id="{EC474E07-07E5-4F53-BD61-843F135677C5}"/>
               </a:ext>
             </a:extLst>
           </p:cNvPr>
@@ -4830,7 +4845,7 @@
           <p:cNvPr id="8" name="">
             <a:extLst xmlns:a="http://schemas.openxmlformats.org/drawingml/2006/main">
               <a:ext uri="{FF2B5EF4-FFF2-40B4-BE49-F238E27FC236}">
-                <a16:creationId xmlns:a16="http://schemas.microsoft.com/office/drawing/2014/main" id="{70C8ED2D-7FCE-4C97-B4C9-1244D5EE1EEC}"/>
+                <a16:creationId xmlns:a16="http://schemas.microsoft.com/office/drawing/2014/main" id="{B78ADC3B-35D9-40F5-AEB5-E27E5E43D0A1}"/>
               </a:ext>
             </a:extLst>
           </p:cNvPr>
@@ -4863,7 +4878,7 @@
           <p:cNvPr id="9" name="">
             <a:extLst xmlns:a="http://schemas.openxmlformats.org/drawingml/2006/main">
               <a:ext uri="{FF2B5EF4-FFF2-40B4-BE49-F238E27FC236}">
-                <a16:creationId xmlns:a16="http://schemas.microsoft.com/office/drawing/2014/main" id="{96E2A10F-30BA-49DA-B894-1186D7C7FA0A}"/>
+                <a16:creationId xmlns:a16="http://schemas.microsoft.com/office/drawing/2014/main" id="{39AA781F-D0F4-488A-AC0B-EB7BD5E4360D}"/>
               </a:ext>
             </a:extLst>
           </p:cNvPr>
@@ -4908,7 +4923,7 @@
           <p:cNvPr id="10" name="">
             <a:extLst xmlns:a="http://schemas.openxmlformats.org/drawingml/2006/main">
               <a:ext uri="{FF2B5EF4-FFF2-40B4-BE49-F238E27FC236}">
-                <a16:creationId xmlns:a16="http://schemas.microsoft.com/office/drawing/2014/main" id="{CB60C3DD-472E-4605-BB70-BAD7777C218A}"/>
+                <a16:creationId xmlns:a16="http://schemas.microsoft.com/office/drawing/2014/main" id="{46B677EC-766D-4F68-A146-7535A05F3725}"/>
               </a:ext>
             </a:extLst>
           </p:cNvPr>
@@ -4953,7 +4968,7 @@
           <p:cNvPr id="11" name="">
             <a:extLst xmlns:a="http://schemas.openxmlformats.org/drawingml/2006/main">
               <a:ext uri="{FF2B5EF4-FFF2-40B4-BE49-F238E27FC236}">
-                <a16:creationId xmlns:a16="http://schemas.microsoft.com/office/drawing/2014/main" id="{D29B7F39-AE03-48BF-9A8E-8C83DC28EDBD}"/>
+                <a16:creationId xmlns:a16="http://schemas.microsoft.com/office/drawing/2014/main" id="{3102C581-11CF-4BD6-A21E-2783C90AD1E5}"/>
               </a:ext>
             </a:extLst>
           </p:cNvPr>
@@ -4986,7 +5001,7 @@
           <p:cNvPr id="12" name="">
             <a:extLst xmlns:a="http://schemas.openxmlformats.org/drawingml/2006/main">
               <a:ext uri="{FF2B5EF4-FFF2-40B4-BE49-F238E27FC236}">
-                <a16:creationId xmlns:a16="http://schemas.microsoft.com/office/drawing/2014/main" id="{9C4C9708-554B-4953-8773-CC9ACD5C6B68}"/>
+                <a16:creationId xmlns:a16="http://schemas.microsoft.com/office/drawing/2014/main" id="{20835C03-E903-4FA3-B9ED-48F864CB443F}"/>
               </a:ext>
             </a:extLst>
           </p:cNvPr>
@@ -5031,7 +5046,7 @@
           <p:cNvPr id="13" name="">
             <a:extLst xmlns:a="http://schemas.openxmlformats.org/drawingml/2006/main">
               <a:ext uri="{FF2B5EF4-FFF2-40B4-BE49-F238E27FC236}">
-                <a16:creationId xmlns:a16="http://schemas.microsoft.com/office/drawing/2014/main" id="{03EECBE5-D61E-4476-84C5-E01A29560865}"/>
+                <a16:creationId xmlns:a16="http://schemas.microsoft.com/office/drawing/2014/main" id="{8BC56F93-6490-449D-AF42-74002FD23FDE}"/>
               </a:ext>
             </a:extLst>
           </p:cNvPr>
@@ -5076,7 +5091,7 @@
           <p:cNvPr id="14" name="">
             <a:extLst xmlns:a="http://schemas.openxmlformats.org/drawingml/2006/main">
               <a:ext uri="{FF2B5EF4-FFF2-40B4-BE49-F238E27FC236}">
-                <a16:creationId xmlns:a16="http://schemas.microsoft.com/office/drawing/2014/main" id="{C5FE5E46-1AC4-47B2-AF99-940F475C922B}"/>
+                <a16:creationId xmlns:a16="http://schemas.microsoft.com/office/drawing/2014/main" id="{78A34909-4580-4DEC-A76E-43E1EEFDD75E}"/>
               </a:ext>
             </a:extLst>
           </p:cNvPr>
@@ -5109,7 +5124,7 @@
           <p:cNvPr id="15" name="">
             <a:extLst xmlns:a="http://schemas.openxmlformats.org/drawingml/2006/main">
               <a:ext uri="{FF2B5EF4-FFF2-40B4-BE49-F238E27FC236}">
-                <a16:creationId xmlns:a16="http://schemas.microsoft.com/office/drawing/2014/main" id="{4B60C85A-DFBC-433B-BF79-BAD95150D3AF}"/>
+                <a16:creationId xmlns:a16="http://schemas.microsoft.com/office/drawing/2014/main" id="{45E42E8F-3335-4A9D-ADE7-C6BB2BE471F2}"/>
               </a:ext>
             </a:extLst>
           </p:cNvPr>
@@ -5154,7 +5169,7 @@
           <p:cNvPr id="16" name="">
             <a:extLst xmlns:a="http://schemas.openxmlformats.org/drawingml/2006/main">
               <a:ext uri="{FF2B5EF4-FFF2-40B4-BE49-F238E27FC236}">
-                <a16:creationId xmlns:a16="http://schemas.microsoft.com/office/drawing/2014/main" id="{95545D07-6063-4496-BE01-623C03BD1A27}"/>
+                <a16:creationId xmlns:a16="http://schemas.microsoft.com/office/drawing/2014/main" id="{3F43FF2A-2931-4F91-BAE2-2C82F245F44F}"/>
               </a:ext>
             </a:extLst>
           </p:cNvPr>
@@ -5199,7 +5214,7 @@
           <p:cNvPr id="17" name="">
             <a:extLst xmlns:a="http://schemas.openxmlformats.org/drawingml/2006/main">
               <a:ext uri="{FF2B5EF4-FFF2-40B4-BE49-F238E27FC236}">
-                <a16:creationId xmlns:a16="http://schemas.microsoft.com/office/drawing/2014/main" id="{6FA3A30E-7ACC-4095-95FC-14DE62363731}"/>
+                <a16:creationId xmlns:a16="http://schemas.microsoft.com/office/drawing/2014/main" id="{6F86BD71-4D54-426A-A11A-2B7C2F1C5BFD}"/>
               </a:ext>
             </a:extLst>
           </p:cNvPr>
@@ -5232,7 +5247,7 @@
           <p:cNvPr id="18" name="">
             <a:extLst xmlns:a="http://schemas.openxmlformats.org/drawingml/2006/main">
               <a:ext uri="{FF2B5EF4-FFF2-40B4-BE49-F238E27FC236}">
-                <a16:creationId xmlns:a16="http://schemas.microsoft.com/office/drawing/2014/main" id="{42525949-4CBA-47A2-B13F-83712E5BBD6A}"/>
+                <a16:creationId xmlns:a16="http://schemas.microsoft.com/office/drawing/2014/main" id="{A02BE156-92F6-47E2-A571-108CFF64D169}"/>
               </a:ext>
             </a:extLst>
           </p:cNvPr>
@@ -5277,7 +5292,7 @@
           <p:cNvPr id="19" name="">
             <a:extLst xmlns:a="http://schemas.openxmlformats.org/drawingml/2006/main">
               <a:ext uri="{FF2B5EF4-FFF2-40B4-BE49-F238E27FC236}">
-                <a16:creationId xmlns:a16="http://schemas.microsoft.com/office/drawing/2014/main" id="{F41144AA-C4FA-4FF2-9761-7EF7412C4092}"/>
+                <a16:creationId xmlns:a16="http://schemas.microsoft.com/office/drawing/2014/main" id="{7AC47501-F151-41DC-BDB7-8EAC4919673D}"/>
               </a:ext>
             </a:extLst>
           </p:cNvPr>
@@ -5322,7 +5337,7 @@
           <p:cNvPr id="20" name="">
             <a:extLst xmlns:a="http://schemas.openxmlformats.org/drawingml/2006/main">
               <a:ext uri="{FF2B5EF4-FFF2-40B4-BE49-F238E27FC236}">
-                <a16:creationId xmlns:a16="http://schemas.microsoft.com/office/drawing/2014/main" id="{67B2D47E-F3F8-4490-A40D-653DFD793FD9}"/>
+                <a16:creationId xmlns:a16="http://schemas.microsoft.com/office/drawing/2014/main" id="{2E286EF0-C5C9-4813-A621-F36110E05B16}"/>
               </a:ext>
             </a:extLst>
           </p:cNvPr>
@@ -5355,7 +5370,7 @@
           <p:cNvPr id="21" name="">
             <a:extLst xmlns:a="http://schemas.openxmlformats.org/drawingml/2006/main">
               <a:ext uri="{FF2B5EF4-FFF2-40B4-BE49-F238E27FC236}">
-                <a16:creationId xmlns:a16="http://schemas.microsoft.com/office/drawing/2014/main" id="{2F2C8877-7F3E-4487-ADC1-B16C81F92578}"/>
+                <a16:creationId xmlns:a16="http://schemas.microsoft.com/office/drawing/2014/main" id="{58331C7B-907D-4628-806E-306D1644E17B}"/>
               </a:ext>
             </a:extLst>
           </p:cNvPr>
@@ -5400,7 +5415,7 @@
           <p:cNvPr id="22" name="">
             <a:extLst xmlns:a="http://schemas.openxmlformats.org/drawingml/2006/main">
               <a:ext uri="{FF2B5EF4-FFF2-40B4-BE49-F238E27FC236}">
-                <a16:creationId xmlns:a16="http://schemas.microsoft.com/office/drawing/2014/main" id="{B5ACAC8E-131A-4797-853E-0F761BEDB321}"/>
+                <a16:creationId xmlns:a16="http://schemas.microsoft.com/office/drawing/2014/main" id="{10A13B76-B172-4977-8129-891B4059BDB1}"/>
               </a:ext>
             </a:extLst>
           </p:cNvPr>
@@ -5445,7 +5460,7 @@
           <p:cNvPr id="23" name="footer-left">
             <a:extLst xmlns:a="http://schemas.openxmlformats.org/drawingml/2006/main">
               <a:ext uri="{FF2B5EF4-FFF2-40B4-BE49-F238E27FC236}">
-                <a16:creationId xmlns:a16="http://schemas.microsoft.com/office/drawing/2014/main" id="{95E71A85-B648-4051-B23E-DC596EDE7AAE}"/>
+                <a16:creationId xmlns:a16="http://schemas.microsoft.com/office/drawing/2014/main" id="{9BDDF1E4-0370-4ECB-85F0-9D35CB2691FC}"/>
               </a:ext>
             </a:extLst>
           </p:cNvPr>
@@ -5490,7 +5505,7 @@
           <p:cNvPr id="24" name="footer-right">
             <a:extLst xmlns:a="http://schemas.openxmlformats.org/drawingml/2006/main">
               <a:ext uri="{FF2B5EF4-FFF2-40B4-BE49-F238E27FC236}">
-                <a16:creationId xmlns:a16="http://schemas.microsoft.com/office/drawing/2014/main" id="{CC4DA47B-D118-465A-8F05-29BF3329B263}"/>
+                <a16:creationId xmlns:a16="http://schemas.microsoft.com/office/drawing/2014/main" id="{3881A0B2-00AB-4003-A02C-8CF81A1FCD21}"/>
               </a:ext>
             </a:extLst>
           </p:cNvPr>
@@ -5533,7 +5548,7 @@
     </p:spTree>
     <p:extLst>
       <p:ext uri="{BB962C8B-B14F-4D97-AF65-F5344CB8AC3E}">
-        <p14:creationId xmlns:p14="http://schemas.microsoft.com/office/powerpoint/2010/main" val="67096784"/>
+        <p14:creationId xmlns:p14="http://schemas.microsoft.com/office/powerpoint/2010/main" val="1049155238"/>
       </p:ext>
     </p:extLst>
   </p:cSld>
@@ -5557,7 +5572,7 @@
           <p:cNvPr id="1" name="slide-stage">
             <a:extLst xmlns:a="http://schemas.openxmlformats.org/drawingml/2006/main">
               <a:ext uri="{FF2B5EF4-FFF2-40B4-BE49-F238E27FC236}">
-                <a16:creationId xmlns:a16="http://schemas.microsoft.com/office/drawing/2014/main" id="{2D0F20BA-D6BB-493D-B66D-E09A7496C5FA}"/>
+                <a16:creationId xmlns:a16="http://schemas.microsoft.com/office/drawing/2014/main" id="{F662B98C-07FF-499C-AF5D-E2503FC1F47B}"/>
               </a:ext>
             </a:extLst>
           </p:cNvPr>
@@ -5584,7 +5599,7 @@
           <p:cNvPr id="2" name="eyebrow">
             <a:extLst xmlns:a="http://schemas.openxmlformats.org/drawingml/2006/main">
               <a:ext uri="{FF2B5EF4-FFF2-40B4-BE49-F238E27FC236}">
-                <a16:creationId xmlns:a16="http://schemas.microsoft.com/office/drawing/2014/main" id="{AC2CE2B9-95D9-4474-BEC3-AF54E5FA7630}"/>
+                <a16:creationId xmlns:a16="http://schemas.microsoft.com/office/drawing/2014/main" id="{098DD1A8-7AE9-4FA9-8832-F7C8817F41B7}"/>
               </a:ext>
             </a:extLst>
           </p:cNvPr>
@@ -5629,7 +5644,7 @@
           <p:cNvPr id="3" name="slide-title">
             <a:extLst xmlns:a="http://schemas.openxmlformats.org/drawingml/2006/main">
               <a:ext uri="{FF2B5EF4-FFF2-40B4-BE49-F238E27FC236}">
-                <a16:creationId xmlns:a16="http://schemas.microsoft.com/office/drawing/2014/main" id="{29A87627-A395-46B3-A94E-CD5389D1C0EA}"/>
+                <a16:creationId xmlns:a16="http://schemas.microsoft.com/office/drawing/2014/main" id="{D22EA0D9-D62C-4CAC-9C26-5F4A1C5D90C0}"/>
               </a:ext>
             </a:extLst>
           </p:cNvPr>
@@ -5674,7 +5689,7 @@
           <p:cNvPr id="4" name="slide-subtitle">
             <a:extLst xmlns:a="http://schemas.openxmlformats.org/drawingml/2006/main">
               <a:ext uri="{FF2B5EF4-FFF2-40B4-BE49-F238E27FC236}">
-                <a16:creationId xmlns:a16="http://schemas.microsoft.com/office/drawing/2014/main" id="{4A601D4E-2D58-425E-8FD3-432EC8ACFA26}"/>
+                <a16:creationId xmlns:a16="http://schemas.microsoft.com/office/drawing/2014/main" id="{01CB6F49-3922-4E2E-A70D-C0C9CB166FB6}"/>
               </a:ext>
             </a:extLst>
           </p:cNvPr>
@@ -5719,7 +5734,7 @@
           <p:cNvPr id="5" name="">
             <a:extLst xmlns:a="http://schemas.openxmlformats.org/drawingml/2006/main">
               <a:ext uri="{FF2B5EF4-FFF2-40B4-BE49-F238E27FC236}">
-                <a16:creationId xmlns:a16="http://schemas.microsoft.com/office/drawing/2014/main" id="{7C2AE415-5135-4744-B904-DD4A71333E27}"/>
+                <a16:creationId xmlns:a16="http://schemas.microsoft.com/office/drawing/2014/main" id="{C6875DDF-24C1-4EBD-A910-0603C3AC3E54}"/>
               </a:ext>
             </a:extLst>
           </p:cNvPr>
@@ -5764,7 +5779,7 @@
           <p:cNvPr id="6" name="">
             <a:extLst xmlns:a="http://schemas.openxmlformats.org/drawingml/2006/main">
               <a:ext uri="{FF2B5EF4-FFF2-40B4-BE49-F238E27FC236}">
-                <a16:creationId xmlns:a16="http://schemas.microsoft.com/office/drawing/2014/main" id="{0177DD23-00D8-4EB1-871E-CD75FAF6A603}"/>
+                <a16:creationId xmlns:a16="http://schemas.microsoft.com/office/drawing/2014/main" id="{668904C9-62D2-48C2-B3DF-26509F08C808}"/>
               </a:ext>
             </a:extLst>
           </p:cNvPr>
@@ -5809,7 +5824,7 @@
           <p:cNvPr id="7" name="">
             <a:extLst xmlns:a="http://schemas.openxmlformats.org/drawingml/2006/main">
               <a:ext uri="{FF2B5EF4-FFF2-40B4-BE49-F238E27FC236}">
-                <a16:creationId xmlns:a16="http://schemas.microsoft.com/office/drawing/2014/main" id="{90953D28-B894-4615-82CA-4E9FAE7D3090}"/>
+                <a16:creationId xmlns:a16="http://schemas.microsoft.com/office/drawing/2014/main" id="{F36414DA-1BE6-4445-AA59-421D4863E5BE}"/>
               </a:ext>
             </a:extLst>
           </p:cNvPr>
@@ -5854,7 +5869,7 @@
           <p:cNvPr id="8" name="">
             <a:extLst xmlns:a="http://schemas.openxmlformats.org/drawingml/2006/main">
               <a:ext uri="{FF2B5EF4-FFF2-40B4-BE49-F238E27FC236}">
-                <a16:creationId xmlns:a16="http://schemas.microsoft.com/office/drawing/2014/main" id="{D8492E6C-2B9D-4C3B-9971-34864FE1FE7B}"/>
+                <a16:creationId xmlns:a16="http://schemas.microsoft.com/office/drawing/2014/main" id="{15D23149-E9B9-4011-8C69-2ECF0ED2E89A}"/>
               </a:ext>
             </a:extLst>
           </p:cNvPr>
@@ -5899,7 +5914,7 @@
           <p:cNvPr id="9" name="">
             <a:extLst xmlns:a="http://schemas.openxmlformats.org/drawingml/2006/main">
               <a:ext uri="{FF2B5EF4-FFF2-40B4-BE49-F238E27FC236}">
-                <a16:creationId xmlns:a16="http://schemas.microsoft.com/office/drawing/2014/main" id="{5372AF0A-7202-449E-9791-ECB601407F47}"/>
+                <a16:creationId xmlns:a16="http://schemas.microsoft.com/office/drawing/2014/main" id="{D2D01C1F-951C-4779-8385-2D7AC641C5A1}"/>
               </a:ext>
             </a:extLst>
           </p:cNvPr>
@@ -5944,7 +5959,7 @@
           <p:cNvPr id="10" name="">
             <a:extLst xmlns:a="http://schemas.openxmlformats.org/drawingml/2006/main">
               <a:ext uri="{FF2B5EF4-FFF2-40B4-BE49-F238E27FC236}">
-                <a16:creationId xmlns:a16="http://schemas.microsoft.com/office/drawing/2014/main" id="{43B131CF-F1C9-4EA3-99CB-C640B137D486}"/>
+                <a16:creationId xmlns:a16="http://schemas.microsoft.com/office/drawing/2014/main" id="{E592F12F-BD27-42B2-BE60-60136583707B}"/>
               </a:ext>
             </a:extLst>
           </p:cNvPr>
@@ -5989,7 +6004,7 @@
           <p:cNvPr id="11" name="">
             <a:extLst xmlns:a="http://schemas.openxmlformats.org/drawingml/2006/main">
               <a:ext uri="{FF2B5EF4-FFF2-40B4-BE49-F238E27FC236}">
-                <a16:creationId xmlns:a16="http://schemas.microsoft.com/office/drawing/2014/main" id="{9D58A19B-50CC-4C06-A21C-C79E8FCB195B}"/>
+                <a16:creationId xmlns:a16="http://schemas.microsoft.com/office/drawing/2014/main" id="{9EC55ABF-0827-4DAB-BE4A-168BA63BCC39}"/>
               </a:ext>
             </a:extLst>
           </p:cNvPr>
@@ -6034,7 +6049,7 @@
           <p:cNvPr id="12" name="">
             <a:extLst xmlns:a="http://schemas.openxmlformats.org/drawingml/2006/main">
               <a:ext uri="{FF2B5EF4-FFF2-40B4-BE49-F238E27FC236}">
-                <a16:creationId xmlns:a16="http://schemas.microsoft.com/office/drawing/2014/main" id="{C132990D-4768-4676-A25A-DF021C819B24}"/>
+                <a16:creationId xmlns:a16="http://schemas.microsoft.com/office/drawing/2014/main" id="{5E518626-F152-46C4-B21F-6F7E587DDB0F}"/>
               </a:ext>
             </a:extLst>
           </p:cNvPr>
@@ -6079,7 +6094,7 @@
           <p:cNvPr id="13" name="">
             <a:extLst xmlns:a="http://schemas.openxmlformats.org/drawingml/2006/main">
               <a:ext uri="{FF2B5EF4-FFF2-40B4-BE49-F238E27FC236}">
-                <a16:creationId xmlns:a16="http://schemas.microsoft.com/office/drawing/2014/main" id="{E2725B6A-B5CC-4C4E-95AF-FE03CD0556B7}"/>
+                <a16:creationId xmlns:a16="http://schemas.microsoft.com/office/drawing/2014/main" id="{ADA67071-873E-4E91-90A3-E552DADF9C2D}"/>
               </a:ext>
             </a:extLst>
           </p:cNvPr>
@@ -6124,7 +6139,7 @@
           <p:cNvPr id="14" name="">
             <a:extLst xmlns:a="http://schemas.openxmlformats.org/drawingml/2006/main">
               <a:ext uri="{FF2B5EF4-FFF2-40B4-BE49-F238E27FC236}">
-                <a16:creationId xmlns:a16="http://schemas.microsoft.com/office/drawing/2014/main" id="{106BC629-6E46-49F8-85CE-428CBFD7DA64}"/>
+                <a16:creationId xmlns:a16="http://schemas.microsoft.com/office/drawing/2014/main" id="{06BD8D35-DED2-43D6-B03A-43B4A842DD4D}"/>
               </a:ext>
             </a:extLst>
           </p:cNvPr>
@@ -6169,7 +6184,7 @@
           <p:cNvPr id="15" name="footer-left">
             <a:extLst xmlns:a="http://schemas.openxmlformats.org/drawingml/2006/main">
               <a:ext uri="{FF2B5EF4-FFF2-40B4-BE49-F238E27FC236}">
-                <a16:creationId xmlns:a16="http://schemas.microsoft.com/office/drawing/2014/main" id="{517ACED2-FB15-49D2-9893-210482FEA9A5}"/>
+                <a16:creationId xmlns:a16="http://schemas.microsoft.com/office/drawing/2014/main" id="{BA701B02-EF0D-4923-833A-D90EF20BC058}"/>
               </a:ext>
             </a:extLst>
           </p:cNvPr>
@@ -6214,7 +6229,7 @@
           <p:cNvPr id="16" name="footer-right">
             <a:extLst xmlns:a="http://schemas.openxmlformats.org/drawingml/2006/main">
               <a:ext uri="{FF2B5EF4-FFF2-40B4-BE49-F238E27FC236}">
-                <a16:creationId xmlns:a16="http://schemas.microsoft.com/office/drawing/2014/main" id="{4F564293-41D4-4AE4-8639-E173417B4C95}"/>
+                <a16:creationId xmlns:a16="http://schemas.microsoft.com/office/drawing/2014/main" id="{0EBE7F0B-C41E-4857-8C74-CA2B6C89D831}"/>
               </a:ext>
             </a:extLst>
           </p:cNvPr>
@@ -6257,7 +6272,7 @@
     </p:spTree>
     <p:extLst>
       <p:ext uri="{BB962C8B-B14F-4D97-AF65-F5344CB8AC3E}">
-        <p14:creationId xmlns:p14="http://schemas.microsoft.com/office/powerpoint/2010/main" val="1261582554"/>
+        <p14:creationId xmlns:p14="http://schemas.microsoft.com/office/powerpoint/2010/main" val="1718503997"/>
       </p:ext>
     </p:extLst>
   </p:cSld>
@@ -6281,7 +6296,7 @@
           <p:cNvPr id="1" name="slide-stage">
             <a:extLst xmlns:a="http://schemas.openxmlformats.org/drawingml/2006/main">
               <a:ext uri="{FF2B5EF4-FFF2-40B4-BE49-F238E27FC236}">
-                <a16:creationId xmlns:a16="http://schemas.microsoft.com/office/drawing/2014/main" id="{25C87743-C165-45BC-A6D7-9A6D9DBA9483}"/>
+                <a16:creationId xmlns:a16="http://schemas.microsoft.com/office/drawing/2014/main" id="{4DF3C3F8-DD4E-4683-B56B-8D60D57FAEB0}"/>
               </a:ext>
             </a:extLst>
           </p:cNvPr>
@@ -6308,7 +6323,7 @@
           <p:cNvPr id="2" name="eyebrow">
             <a:extLst xmlns:a="http://schemas.openxmlformats.org/drawingml/2006/main">
               <a:ext uri="{FF2B5EF4-FFF2-40B4-BE49-F238E27FC236}">
-                <a16:creationId xmlns:a16="http://schemas.microsoft.com/office/drawing/2014/main" id="{B8DC1832-4DF2-4E2D-B131-E10DA17AB348}"/>
+                <a16:creationId xmlns:a16="http://schemas.microsoft.com/office/drawing/2014/main" id="{2B022ECF-CBF8-41C3-9A6A-F99A42D15ACA}"/>
               </a:ext>
             </a:extLst>
           </p:cNvPr>
@@ -6353,7 +6368,7 @@
           <p:cNvPr id="3" name="slide-title">
             <a:extLst xmlns:a="http://schemas.openxmlformats.org/drawingml/2006/main">
               <a:ext uri="{FF2B5EF4-FFF2-40B4-BE49-F238E27FC236}">
-                <a16:creationId xmlns:a16="http://schemas.microsoft.com/office/drawing/2014/main" id="{AD60839D-34B9-46B2-984B-0D2A0685A624}"/>
+                <a16:creationId xmlns:a16="http://schemas.microsoft.com/office/drawing/2014/main" id="{29DBBEC3-72A6-4F70-9AFF-C4FE4AC02314}"/>
               </a:ext>
             </a:extLst>
           </p:cNvPr>
@@ -6398,7 +6413,7 @@
           <p:cNvPr id="4" name="slide-subtitle">
             <a:extLst xmlns:a="http://schemas.openxmlformats.org/drawingml/2006/main">
               <a:ext uri="{FF2B5EF4-FFF2-40B4-BE49-F238E27FC236}">
-                <a16:creationId xmlns:a16="http://schemas.microsoft.com/office/drawing/2014/main" id="{62AA0583-C166-4BFB-93DB-6850B375E482}"/>
+                <a16:creationId xmlns:a16="http://schemas.microsoft.com/office/drawing/2014/main" id="{4392D302-0452-4426-8010-A13A1FA4D606}"/>
               </a:ext>
             </a:extLst>
           </p:cNvPr>
@@ -6443,7 +6458,7 @@
           <p:cNvPr id="5" name="">
             <a:extLst xmlns:a="http://schemas.openxmlformats.org/drawingml/2006/main">
               <a:ext uri="{FF2B5EF4-FFF2-40B4-BE49-F238E27FC236}">
-                <a16:creationId xmlns:a16="http://schemas.microsoft.com/office/drawing/2014/main" id="{6AA8635E-55D3-43A4-9269-8168E1840FFF}"/>
+                <a16:creationId xmlns:a16="http://schemas.microsoft.com/office/drawing/2014/main" id="{B06B9E86-E8BE-4336-A3F4-BF07DA9327D0}"/>
               </a:ext>
             </a:extLst>
           </p:cNvPr>
@@ -6488,7 +6503,7 @@
           <p:cNvPr id="6" name="">
             <a:extLst xmlns:a="http://schemas.openxmlformats.org/drawingml/2006/main">
               <a:ext uri="{FF2B5EF4-FFF2-40B4-BE49-F238E27FC236}">
-                <a16:creationId xmlns:a16="http://schemas.microsoft.com/office/drawing/2014/main" id="{C8610E05-3E76-40BD-A5AB-5F254B94A17F}"/>
+                <a16:creationId xmlns:a16="http://schemas.microsoft.com/office/drawing/2014/main" id="{26DBA68B-19A1-4B14-A1B2-E9E23A190C29}"/>
               </a:ext>
             </a:extLst>
           </p:cNvPr>
@@ -6533,7 +6548,7 @@
           <p:cNvPr id="7" name="">
             <a:extLst xmlns:a="http://schemas.openxmlformats.org/drawingml/2006/main">
               <a:ext uri="{FF2B5EF4-FFF2-40B4-BE49-F238E27FC236}">
-                <a16:creationId xmlns:a16="http://schemas.microsoft.com/office/drawing/2014/main" id="{628E06DB-94EB-49C9-84D9-75A24CF292B0}"/>
+                <a16:creationId xmlns:a16="http://schemas.microsoft.com/office/drawing/2014/main" id="{29704E3A-61DC-4E87-9B6C-279394A81FDF}"/>
               </a:ext>
             </a:extLst>
           </p:cNvPr>
@@ -6578,7 +6593,7 @@
           <p:cNvPr id="8" name="">
             <a:extLst xmlns:a="http://schemas.openxmlformats.org/drawingml/2006/main">
               <a:ext uri="{FF2B5EF4-FFF2-40B4-BE49-F238E27FC236}">
-                <a16:creationId xmlns:a16="http://schemas.microsoft.com/office/drawing/2014/main" id="{1F84B8D3-4A0A-4DDD-8E5E-6BE41DA0EE10}"/>
+                <a16:creationId xmlns:a16="http://schemas.microsoft.com/office/drawing/2014/main" id="{C06688CA-3DBE-42A2-9F83-78B932E84141}"/>
               </a:ext>
             </a:extLst>
           </p:cNvPr>
@@ -6623,7 +6638,7 @@
           <p:cNvPr id="9" name="">
             <a:extLst xmlns:a="http://schemas.openxmlformats.org/drawingml/2006/main">
               <a:ext uri="{FF2B5EF4-FFF2-40B4-BE49-F238E27FC236}">
-                <a16:creationId xmlns:a16="http://schemas.microsoft.com/office/drawing/2014/main" id="{54704B36-F63E-43BB-A3D9-CC1BD11F7E03}"/>
+                <a16:creationId xmlns:a16="http://schemas.microsoft.com/office/drawing/2014/main" id="{136C7B3E-4FF8-4CC2-BD48-9ECE43119A80}"/>
               </a:ext>
             </a:extLst>
           </p:cNvPr>
@@ -6668,7 +6683,7 @@
           <p:cNvPr id="10" name="">
             <a:extLst xmlns:a="http://schemas.openxmlformats.org/drawingml/2006/main">
               <a:ext uri="{FF2B5EF4-FFF2-40B4-BE49-F238E27FC236}">
-                <a16:creationId xmlns:a16="http://schemas.microsoft.com/office/drawing/2014/main" id="{A0101B05-798C-4CB5-BD34-A7FBF2DE220F}"/>
+                <a16:creationId xmlns:a16="http://schemas.microsoft.com/office/drawing/2014/main" id="{11AB03F1-FCCF-4CE1-8560-16B6877FE87D}"/>
               </a:ext>
             </a:extLst>
           </p:cNvPr>
@@ -6713,7 +6728,7 @@
           <p:cNvPr id="11" name="">
             <a:extLst xmlns:a="http://schemas.openxmlformats.org/drawingml/2006/main">
               <a:ext uri="{FF2B5EF4-FFF2-40B4-BE49-F238E27FC236}">
-                <a16:creationId xmlns:a16="http://schemas.microsoft.com/office/drawing/2014/main" id="{3C89C16F-D4A3-4D38-A025-46019A2287C7}"/>
+                <a16:creationId xmlns:a16="http://schemas.microsoft.com/office/drawing/2014/main" id="{C5F20469-751B-430E-B20E-02AB179B3FD3}"/>
               </a:ext>
             </a:extLst>
           </p:cNvPr>
@@ -6758,7 +6773,7 @@
           <p:cNvPr id="12" name="">
             <a:extLst xmlns:a="http://schemas.openxmlformats.org/drawingml/2006/main">
               <a:ext uri="{FF2B5EF4-FFF2-40B4-BE49-F238E27FC236}">
-                <a16:creationId xmlns:a16="http://schemas.microsoft.com/office/drawing/2014/main" id="{E3BAF98A-B680-4110-82DA-7838DD7415EE}"/>
+                <a16:creationId xmlns:a16="http://schemas.microsoft.com/office/drawing/2014/main" id="{E29BF6A0-7B13-43D2-8EAD-71FB8AFBE653}"/>
               </a:ext>
             </a:extLst>
           </p:cNvPr>
@@ -6803,7 +6818,7 @@
           <p:cNvPr id="13" name="">
             <a:extLst xmlns:a="http://schemas.openxmlformats.org/drawingml/2006/main">
               <a:ext uri="{FF2B5EF4-FFF2-40B4-BE49-F238E27FC236}">
-                <a16:creationId xmlns:a16="http://schemas.microsoft.com/office/drawing/2014/main" id="{3D2A9F57-67E3-4C4F-954F-C985738512B1}"/>
+                <a16:creationId xmlns:a16="http://schemas.microsoft.com/office/drawing/2014/main" id="{43A12681-BBAA-47D6-98EC-E3935C8BF36C}"/>
               </a:ext>
             </a:extLst>
           </p:cNvPr>
@@ -6848,7 +6863,7 @@
           <p:cNvPr id="14" name="">
             <a:extLst xmlns:a="http://schemas.openxmlformats.org/drawingml/2006/main">
               <a:ext uri="{FF2B5EF4-FFF2-40B4-BE49-F238E27FC236}">
-                <a16:creationId xmlns:a16="http://schemas.microsoft.com/office/drawing/2014/main" id="{32E3794B-03EC-444A-9EEE-C96A93E11753}"/>
+                <a16:creationId xmlns:a16="http://schemas.microsoft.com/office/drawing/2014/main" id="{AE91803C-4695-4146-B215-EB7367797CD9}"/>
               </a:ext>
             </a:extLst>
           </p:cNvPr>
@@ -6893,7 +6908,7 @@
           <p:cNvPr id="15" name="footer-left">
             <a:extLst xmlns:a="http://schemas.openxmlformats.org/drawingml/2006/main">
               <a:ext uri="{FF2B5EF4-FFF2-40B4-BE49-F238E27FC236}">
-                <a16:creationId xmlns:a16="http://schemas.microsoft.com/office/drawing/2014/main" id="{7576760F-585C-455A-9486-936A41B354C6}"/>
+                <a16:creationId xmlns:a16="http://schemas.microsoft.com/office/drawing/2014/main" id="{68843130-0E2C-4043-A574-CD5D828310E5}"/>
               </a:ext>
             </a:extLst>
           </p:cNvPr>
@@ -6938,7 +6953,7 @@
           <p:cNvPr id="16" name="footer-right">
             <a:extLst xmlns:a="http://schemas.openxmlformats.org/drawingml/2006/main">
               <a:ext uri="{FF2B5EF4-FFF2-40B4-BE49-F238E27FC236}">
-                <a16:creationId xmlns:a16="http://schemas.microsoft.com/office/drawing/2014/main" id="{5D07FB92-0A12-4683-8172-304A6283EA9E}"/>
+                <a16:creationId xmlns:a16="http://schemas.microsoft.com/office/drawing/2014/main" id="{B048FBD0-9C75-4BEC-A312-A222B31FB08A}"/>
               </a:ext>
             </a:extLst>
           </p:cNvPr>
@@ -6981,7 +6996,7 @@
     </p:spTree>
     <p:extLst>
       <p:ext uri="{BB962C8B-B14F-4D97-AF65-F5344CB8AC3E}">
-        <p14:creationId xmlns:p14="http://schemas.microsoft.com/office/powerpoint/2010/main" val="1173909529"/>
+        <p14:creationId xmlns:p14="http://schemas.microsoft.com/office/powerpoint/2010/main" val="2116197196"/>
       </p:ext>
     </p:extLst>
   </p:cSld>
@@ -7005,7 +7020,7 @@
           <p:cNvPr id="1" name="slide-stage">
             <a:extLst xmlns:a="http://schemas.openxmlformats.org/drawingml/2006/main">
               <a:ext uri="{FF2B5EF4-FFF2-40B4-BE49-F238E27FC236}">
-                <a16:creationId xmlns:a16="http://schemas.microsoft.com/office/drawing/2014/main" id="{4EEF53AE-5FBF-4D9F-BD33-B5233BAD95AE}"/>
+                <a16:creationId xmlns:a16="http://schemas.microsoft.com/office/drawing/2014/main" id="{4FC2C2C2-5316-431A-BF3C-6B722F1BC158}"/>
               </a:ext>
             </a:extLst>
           </p:cNvPr>
@@ -7032,7 +7047,7 @@
           <p:cNvPr id="2" name="eyebrow">
             <a:extLst xmlns:a="http://schemas.openxmlformats.org/drawingml/2006/main">
               <a:ext uri="{FF2B5EF4-FFF2-40B4-BE49-F238E27FC236}">
-                <a16:creationId xmlns:a16="http://schemas.microsoft.com/office/drawing/2014/main" id="{5952D038-5C27-423D-8D06-29084A1295B5}"/>
+                <a16:creationId xmlns:a16="http://schemas.microsoft.com/office/drawing/2014/main" id="{BD79489A-C554-4AC2-8033-BAD6EAF685A8}"/>
               </a:ext>
             </a:extLst>
           </p:cNvPr>
@@ -7077,7 +7092,7 @@
           <p:cNvPr id="3" name="slide-title">
             <a:extLst xmlns:a="http://schemas.openxmlformats.org/drawingml/2006/main">
               <a:ext uri="{FF2B5EF4-FFF2-40B4-BE49-F238E27FC236}">
-                <a16:creationId xmlns:a16="http://schemas.microsoft.com/office/drawing/2014/main" id="{A3289E25-9B5D-4F37-AA8C-B05EE9D515B5}"/>
+                <a16:creationId xmlns:a16="http://schemas.microsoft.com/office/drawing/2014/main" id="{76E6D0B7-0BF3-4A99-8A42-2A7910549B79}"/>
               </a:ext>
             </a:extLst>
           </p:cNvPr>
@@ -7122,7 +7137,7 @@
           <p:cNvPr id="4" name="slide-subtitle">
             <a:extLst xmlns:a="http://schemas.openxmlformats.org/drawingml/2006/main">
               <a:ext uri="{FF2B5EF4-FFF2-40B4-BE49-F238E27FC236}">
-                <a16:creationId xmlns:a16="http://schemas.microsoft.com/office/drawing/2014/main" id="{9C08446B-4B95-4F56-82DC-38F39A6C07DB}"/>
+                <a16:creationId xmlns:a16="http://schemas.microsoft.com/office/drawing/2014/main" id="{3E7A123E-FE2C-40D7-BCF0-84CDAD1D171C}"/>
               </a:ext>
             </a:extLst>
           </p:cNvPr>
@@ -7167,7 +7182,7 @@
           <p:cNvPr id="5" name="">
             <a:extLst xmlns:a="http://schemas.openxmlformats.org/drawingml/2006/main">
               <a:ext uri="{FF2B5EF4-FFF2-40B4-BE49-F238E27FC236}">
-                <a16:creationId xmlns:a16="http://schemas.microsoft.com/office/drawing/2014/main" id="{0413DEB3-E839-4115-884C-7934CDACF15B}"/>
+                <a16:creationId xmlns:a16="http://schemas.microsoft.com/office/drawing/2014/main" id="{72199349-DA2F-412C-BDA2-05D67437F97F}"/>
               </a:ext>
             </a:extLst>
           </p:cNvPr>
@@ -7200,7 +7215,7 @@
           <p:cNvPr id="6" name="">
             <a:extLst xmlns:a="http://schemas.openxmlformats.org/drawingml/2006/main">
               <a:ext uri="{FF2B5EF4-FFF2-40B4-BE49-F238E27FC236}">
-                <a16:creationId xmlns:a16="http://schemas.microsoft.com/office/drawing/2014/main" id="{18D1A921-554A-47F8-B4A5-4463F44E976F}"/>
+                <a16:creationId xmlns:a16="http://schemas.microsoft.com/office/drawing/2014/main" id="{E56C233E-FC91-4FF4-8993-A3319D9A0300}"/>
               </a:ext>
             </a:extLst>
           </p:cNvPr>
@@ -7245,7 +7260,7 @@
           <p:cNvPr id="7" name="">
             <a:extLst xmlns:a="http://schemas.openxmlformats.org/drawingml/2006/main">
               <a:ext uri="{FF2B5EF4-FFF2-40B4-BE49-F238E27FC236}">
-                <a16:creationId xmlns:a16="http://schemas.microsoft.com/office/drawing/2014/main" id="{1821EB36-193A-4E8A-8A65-8AEC8593D26D}"/>
+                <a16:creationId xmlns:a16="http://schemas.microsoft.com/office/drawing/2014/main" id="{3D56ED7F-AA95-4855-B1C9-4F6447FDEE19}"/>
               </a:ext>
             </a:extLst>
           </p:cNvPr>
@@ -7290,7 +7305,7 @@
           <p:cNvPr id="8" name="">
             <a:extLst xmlns:a="http://schemas.openxmlformats.org/drawingml/2006/main">
               <a:ext uri="{FF2B5EF4-FFF2-40B4-BE49-F238E27FC236}">
-                <a16:creationId xmlns:a16="http://schemas.microsoft.com/office/drawing/2014/main" id="{3081680F-79D6-418F-A9B4-32AF10053A11}"/>
+                <a16:creationId xmlns:a16="http://schemas.microsoft.com/office/drawing/2014/main" id="{689960C7-D5C9-4D9B-A49B-886FB87A1064}"/>
               </a:ext>
             </a:extLst>
           </p:cNvPr>
@@ -7323,7 +7338,7 @@
           <p:cNvPr id="9" name="">
             <a:extLst xmlns:a="http://schemas.openxmlformats.org/drawingml/2006/main">
               <a:ext uri="{FF2B5EF4-FFF2-40B4-BE49-F238E27FC236}">
-                <a16:creationId xmlns:a16="http://schemas.microsoft.com/office/drawing/2014/main" id="{5DAE64F1-9A81-423F-8DE4-3F21AA6459CB}"/>
+                <a16:creationId xmlns:a16="http://schemas.microsoft.com/office/drawing/2014/main" id="{324920AB-F99B-463E-8B6E-49D9037DD5EB}"/>
               </a:ext>
             </a:extLst>
           </p:cNvPr>
@@ -7368,7 +7383,7 @@
           <p:cNvPr id="10" name="">
             <a:extLst xmlns:a="http://schemas.openxmlformats.org/drawingml/2006/main">
               <a:ext uri="{FF2B5EF4-FFF2-40B4-BE49-F238E27FC236}">
-                <a16:creationId xmlns:a16="http://schemas.microsoft.com/office/drawing/2014/main" id="{566D9178-976D-4FC1-89E1-2949CB5B42F7}"/>
+                <a16:creationId xmlns:a16="http://schemas.microsoft.com/office/drawing/2014/main" id="{EE7EC91D-E1F9-4C40-9C15-546D874C4ABF}"/>
               </a:ext>
             </a:extLst>
           </p:cNvPr>
@@ -7413,7 +7428,7 @@
           <p:cNvPr id="11" name="">
             <a:extLst xmlns:a="http://schemas.openxmlformats.org/drawingml/2006/main">
               <a:ext uri="{FF2B5EF4-FFF2-40B4-BE49-F238E27FC236}">
-                <a16:creationId xmlns:a16="http://schemas.microsoft.com/office/drawing/2014/main" id="{221ECF6B-0F60-4C60-895F-5C72DA650862}"/>
+                <a16:creationId xmlns:a16="http://schemas.microsoft.com/office/drawing/2014/main" id="{1C7388F5-7C87-43FA-9AF5-99373C682EA6}"/>
               </a:ext>
             </a:extLst>
           </p:cNvPr>
@@ -7446,7 +7461,7 @@
           <p:cNvPr id="12" name="">
             <a:extLst xmlns:a="http://schemas.openxmlformats.org/drawingml/2006/main">
               <a:ext uri="{FF2B5EF4-FFF2-40B4-BE49-F238E27FC236}">
-                <a16:creationId xmlns:a16="http://schemas.microsoft.com/office/drawing/2014/main" id="{33C7DEDE-7074-43B1-BD93-6C429ACF45CF}"/>
+                <a16:creationId xmlns:a16="http://schemas.microsoft.com/office/drawing/2014/main" id="{4290E7E4-BA61-4942-BD75-AE063E030A93}"/>
               </a:ext>
             </a:extLst>
           </p:cNvPr>
@@ -7491,7 +7506,7 @@
           <p:cNvPr id="13" name="">
             <a:extLst xmlns:a="http://schemas.openxmlformats.org/drawingml/2006/main">
               <a:ext uri="{FF2B5EF4-FFF2-40B4-BE49-F238E27FC236}">
-                <a16:creationId xmlns:a16="http://schemas.microsoft.com/office/drawing/2014/main" id="{953BB1D8-A155-44B7-8090-5F62651AE7E2}"/>
+                <a16:creationId xmlns:a16="http://schemas.microsoft.com/office/drawing/2014/main" id="{18FAB574-3331-4DFD-8255-49DFEE38E202}"/>
               </a:ext>
             </a:extLst>
           </p:cNvPr>
@@ -7536,7 +7551,7 @@
           <p:cNvPr id="14" name="">
             <a:extLst xmlns:a="http://schemas.openxmlformats.org/drawingml/2006/main">
               <a:ext uri="{FF2B5EF4-FFF2-40B4-BE49-F238E27FC236}">
-                <a16:creationId xmlns:a16="http://schemas.microsoft.com/office/drawing/2014/main" id="{C8CEF3F7-22AF-467F-8B42-263626CE68E0}"/>
+                <a16:creationId xmlns:a16="http://schemas.microsoft.com/office/drawing/2014/main" id="{F5A9FA3E-6BB6-49C9-B38E-4EE2E416D8A3}"/>
               </a:ext>
             </a:extLst>
           </p:cNvPr>
@@ -7569,7 +7584,7 @@
           <p:cNvPr id="15" name="">
             <a:extLst xmlns:a="http://schemas.openxmlformats.org/drawingml/2006/main">
               <a:ext uri="{FF2B5EF4-FFF2-40B4-BE49-F238E27FC236}">
-                <a16:creationId xmlns:a16="http://schemas.microsoft.com/office/drawing/2014/main" id="{89A3FFD4-EAC4-4738-B6F2-A8CA8D728C8D}"/>
+                <a16:creationId xmlns:a16="http://schemas.microsoft.com/office/drawing/2014/main" id="{B8421F54-D8CD-4AA7-BE49-677808464377}"/>
               </a:ext>
             </a:extLst>
           </p:cNvPr>
@@ -7614,7 +7629,7 @@
           <p:cNvPr id="16" name="">
             <a:extLst xmlns:a="http://schemas.openxmlformats.org/drawingml/2006/main">
               <a:ext uri="{FF2B5EF4-FFF2-40B4-BE49-F238E27FC236}">
-                <a16:creationId xmlns:a16="http://schemas.microsoft.com/office/drawing/2014/main" id="{03514F1D-07EB-4753-8745-659A6040715A}"/>
+                <a16:creationId xmlns:a16="http://schemas.microsoft.com/office/drawing/2014/main" id="{095ADEA0-E326-437B-86BF-E428EBABF5BB}"/>
               </a:ext>
             </a:extLst>
           </p:cNvPr>
@@ -7659,7 +7674,7 @@
           <p:cNvPr id="17" name="footer-left">
             <a:extLst xmlns:a="http://schemas.openxmlformats.org/drawingml/2006/main">
               <a:ext uri="{FF2B5EF4-FFF2-40B4-BE49-F238E27FC236}">
-                <a16:creationId xmlns:a16="http://schemas.microsoft.com/office/drawing/2014/main" id="{8B9C488D-0E23-43A7-8E46-098CC153C01D}"/>
+                <a16:creationId xmlns:a16="http://schemas.microsoft.com/office/drawing/2014/main" id="{BEA3DF0E-AABC-4506-A076-BFAE5267FB1A}"/>
               </a:ext>
             </a:extLst>
           </p:cNvPr>
@@ -7704,7 +7719,7 @@
           <p:cNvPr id="18" name="footer-right">
             <a:extLst xmlns:a="http://schemas.openxmlformats.org/drawingml/2006/main">
               <a:ext uri="{FF2B5EF4-FFF2-40B4-BE49-F238E27FC236}">
-                <a16:creationId xmlns:a16="http://schemas.microsoft.com/office/drawing/2014/main" id="{6350EFFB-2C5B-4744-9450-E85C694029F0}"/>
+                <a16:creationId xmlns:a16="http://schemas.microsoft.com/office/drawing/2014/main" id="{7AA84CEF-7609-4D72-A411-CEC7BEE752BC}"/>
               </a:ext>
             </a:extLst>
           </p:cNvPr>
@@ -7747,7 +7762,7 @@
     </p:spTree>
     <p:extLst>
       <p:ext uri="{BB962C8B-B14F-4D97-AF65-F5344CB8AC3E}">
-        <p14:creationId xmlns:p14="http://schemas.microsoft.com/office/powerpoint/2010/main" val="1195165587"/>
+        <p14:creationId xmlns:p14="http://schemas.microsoft.com/office/powerpoint/2010/main" val="982166341"/>
       </p:ext>
     </p:extLst>
   </p:cSld>
@@ -7771,7 +7786,7 @@
           <p:cNvPr id="1" name="slide-stage">
             <a:extLst xmlns:a="http://schemas.openxmlformats.org/drawingml/2006/main">
               <a:ext uri="{FF2B5EF4-FFF2-40B4-BE49-F238E27FC236}">
-                <a16:creationId xmlns:a16="http://schemas.microsoft.com/office/drawing/2014/main" id="{C9DB0358-1511-4151-9D85-7509DE770967}"/>
+                <a16:creationId xmlns:a16="http://schemas.microsoft.com/office/drawing/2014/main" id="{3EBE45DA-D6CB-4D1A-8C0E-08D883044A3D}"/>
               </a:ext>
             </a:extLst>
           </p:cNvPr>
@@ -7798,7 +7813,7 @@
           <p:cNvPr id="2" name="eyebrow">
             <a:extLst xmlns:a="http://schemas.openxmlformats.org/drawingml/2006/main">
               <a:ext uri="{FF2B5EF4-FFF2-40B4-BE49-F238E27FC236}">
-                <a16:creationId xmlns:a16="http://schemas.microsoft.com/office/drawing/2014/main" id="{E26EB78B-D1C4-49F6-A9C4-FD380E37F49E}"/>
+                <a16:creationId xmlns:a16="http://schemas.microsoft.com/office/drawing/2014/main" id="{89FF46CB-0D57-4CA9-BFBB-6FAD80CDA3DF}"/>
               </a:ext>
             </a:extLst>
           </p:cNvPr>
@@ -7843,7 +7858,7 @@
           <p:cNvPr id="3" name="slide-title">
             <a:extLst xmlns:a="http://schemas.openxmlformats.org/drawingml/2006/main">
               <a:ext uri="{FF2B5EF4-FFF2-40B4-BE49-F238E27FC236}">
-                <a16:creationId xmlns:a16="http://schemas.microsoft.com/office/drawing/2014/main" id="{28BF1C2E-0B8D-4D16-B015-67CEABB2B430}"/>
+                <a16:creationId xmlns:a16="http://schemas.microsoft.com/office/drawing/2014/main" id="{557AAFFC-F47E-4009-941C-F3FFAE6C32EC}"/>
               </a:ext>
             </a:extLst>
           </p:cNvPr>
@@ -7888,7 +7903,7 @@
           <p:cNvPr id="4" name="slide-subtitle">
             <a:extLst xmlns:a="http://schemas.openxmlformats.org/drawingml/2006/main">
               <a:ext uri="{FF2B5EF4-FFF2-40B4-BE49-F238E27FC236}">
-                <a16:creationId xmlns:a16="http://schemas.microsoft.com/office/drawing/2014/main" id="{C4FCE80B-20F3-4E9F-A134-E5C4E34A1A05}"/>
+                <a16:creationId xmlns:a16="http://schemas.microsoft.com/office/drawing/2014/main" id="{E1CE086F-1B9A-4104-BA13-632F4228BF35}"/>
               </a:ext>
             </a:extLst>
           </p:cNvPr>
@@ -7933,7 +7948,7 @@
           <p:cNvPr id="5" name="">
             <a:extLst xmlns:a="http://schemas.openxmlformats.org/drawingml/2006/main">
               <a:ext uri="{FF2B5EF4-FFF2-40B4-BE49-F238E27FC236}">
-                <a16:creationId xmlns:a16="http://schemas.microsoft.com/office/drawing/2014/main" id="{65275896-46BC-4A91-AD71-A3121584FF16}"/>
+                <a16:creationId xmlns:a16="http://schemas.microsoft.com/office/drawing/2014/main" id="{10A4AFE0-1A5E-4737-87B1-FA997AC056C1}"/>
               </a:ext>
             </a:extLst>
           </p:cNvPr>
@@ -7978,7 +7993,7 @@
           <p:cNvPr id="6" name="">
             <a:extLst xmlns:a="http://schemas.openxmlformats.org/drawingml/2006/main">
               <a:ext uri="{FF2B5EF4-FFF2-40B4-BE49-F238E27FC236}">
-                <a16:creationId xmlns:a16="http://schemas.microsoft.com/office/drawing/2014/main" id="{3A7D2D03-7ACC-4F8A-ACC0-BDC7516745F3}"/>
+                <a16:creationId xmlns:a16="http://schemas.microsoft.com/office/drawing/2014/main" id="{3D5FFFC3-6FFB-40AE-8148-10F72B07947F}"/>
               </a:ext>
             </a:extLst>
           </p:cNvPr>
@@ -8023,7 +8038,7 @@
           <p:cNvPr id="7" name="">
             <a:extLst xmlns:a="http://schemas.openxmlformats.org/drawingml/2006/main">
               <a:ext uri="{FF2B5EF4-FFF2-40B4-BE49-F238E27FC236}">
-                <a16:creationId xmlns:a16="http://schemas.microsoft.com/office/drawing/2014/main" id="{B2206907-BC05-43F3-87F0-9A17C9A85E56}"/>
+                <a16:creationId xmlns:a16="http://schemas.microsoft.com/office/drawing/2014/main" id="{90DEBB5E-960C-4FE4-81B5-5B94EA4F3135}"/>
               </a:ext>
             </a:extLst>
           </p:cNvPr>
@@ -8056,7 +8071,7 @@
           <p:cNvPr id="8" name="">
             <a:extLst xmlns:a="http://schemas.openxmlformats.org/drawingml/2006/main">
               <a:ext uri="{FF2B5EF4-FFF2-40B4-BE49-F238E27FC236}">
-                <a16:creationId xmlns:a16="http://schemas.microsoft.com/office/drawing/2014/main" id="{4E501FBD-8061-46E9-A17A-3E8452EF6550}"/>
+                <a16:creationId xmlns:a16="http://schemas.microsoft.com/office/drawing/2014/main" id="{771D4945-71B6-4C1D-B79A-2132493DFD15}"/>
               </a:ext>
             </a:extLst>
           </p:cNvPr>
@@ -8101,7 +8116,7 @@
           <p:cNvPr id="9" name="">
             <a:extLst xmlns:a="http://schemas.openxmlformats.org/drawingml/2006/main">
               <a:ext uri="{FF2B5EF4-FFF2-40B4-BE49-F238E27FC236}">
-                <a16:creationId xmlns:a16="http://schemas.microsoft.com/office/drawing/2014/main" id="{C921F060-7DFD-44D5-B2E9-30A11C125D1D}"/>
+                <a16:creationId xmlns:a16="http://schemas.microsoft.com/office/drawing/2014/main" id="{4015A38E-4404-4688-874C-1C3CE5D775A9}"/>
               </a:ext>
             </a:extLst>
           </p:cNvPr>
@@ -8146,7 +8161,7 @@
           <p:cNvPr id="10" name="">
             <a:extLst xmlns:a="http://schemas.openxmlformats.org/drawingml/2006/main">
               <a:ext uri="{FF2B5EF4-FFF2-40B4-BE49-F238E27FC236}">
-                <a16:creationId xmlns:a16="http://schemas.microsoft.com/office/drawing/2014/main" id="{E72C53E1-8CB1-4178-A8F1-039C664D65D6}"/>
+                <a16:creationId xmlns:a16="http://schemas.microsoft.com/office/drawing/2014/main" id="{A1FAEAC7-0EA6-4AD7-92D6-A8742F1C49E0}"/>
               </a:ext>
             </a:extLst>
           </p:cNvPr>
@@ -8179,7 +8194,7 @@
           <p:cNvPr id="11" name="">
             <a:extLst xmlns:a="http://schemas.openxmlformats.org/drawingml/2006/main">
               <a:ext uri="{FF2B5EF4-FFF2-40B4-BE49-F238E27FC236}">
-                <a16:creationId xmlns:a16="http://schemas.microsoft.com/office/drawing/2014/main" id="{9ED7CD61-021E-4C9D-BD79-5F45C543BD8F}"/>
+                <a16:creationId xmlns:a16="http://schemas.microsoft.com/office/drawing/2014/main" id="{D5783BE4-17DD-4BF1-BE57-9E3BDA2A2FB9}"/>
               </a:ext>
             </a:extLst>
           </p:cNvPr>
@@ -8224,7 +8239,7 @@
           <p:cNvPr id="12" name="">
             <a:extLst xmlns:a="http://schemas.openxmlformats.org/drawingml/2006/main">
               <a:ext uri="{FF2B5EF4-FFF2-40B4-BE49-F238E27FC236}">
-                <a16:creationId xmlns:a16="http://schemas.microsoft.com/office/drawing/2014/main" id="{F2DD30D0-F157-481A-AEB7-E890FFD09F4C}"/>
+                <a16:creationId xmlns:a16="http://schemas.microsoft.com/office/drawing/2014/main" id="{70183CC6-0855-4D62-BF3A-02A662282335}"/>
               </a:ext>
             </a:extLst>
           </p:cNvPr>
@@ -8269,7 +8284,7 @@
           <p:cNvPr id="13" name="">
             <a:extLst xmlns:a="http://schemas.openxmlformats.org/drawingml/2006/main">
               <a:ext uri="{FF2B5EF4-FFF2-40B4-BE49-F238E27FC236}">
-                <a16:creationId xmlns:a16="http://schemas.microsoft.com/office/drawing/2014/main" id="{2B231D62-04B7-4C0F-BDE5-1EE8368FAB9A}"/>
+                <a16:creationId xmlns:a16="http://schemas.microsoft.com/office/drawing/2014/main" id="{0A0CB241-BA97-4C69-9FD3-3CAD012509F1}"/>
               </a:ext>
             </a:extLst>
           </p:cNvPr>
@@ -8302,7 +8317,7 @@
           <p:cNvPr id="14" name="">
             <a:extLst xmlns:a="http://schemas.openxmlformats.org/drawingml/2006/main">
               <a:ext uri="{FF2B5EF4-FFF2-40B4-BE49-F238E27FC236}">
-                <a16:creationId xmlns:a16="http://schemas.microsoft.com/office/drawing/2014/main" id="{7E8D167F-0A46-46D4-BF83-1C0D6577CAC8}"/>
+                <a16:creationId xmlns:a16="http://schemas.microsoft.com/office/drawing/2014/main" id="{4F76C395-0E16-474D-9061-4F0B994896BB}"/>
               </a:ext>
             </a:extLst>
           </p:cNvPr>
@@ -8347,7 +8362,7 @@
           <p:cNvPr id="15" name="">
             <a:extLst xmlns:a="http://schemas.openxmlformats.org/drawingml/2006/main">
               <a:ext uri="{FF2B5EF4-FFF2-40B4-BE49-F238E27FC236}">
-                <a16:creationId xmlns:a16="http://schemas.microsoft.com/office/drawing/2014/main" id="{3B5CAEF7-34C2-4873-8AA4-2A1C6136B97F}"/>
+                <a16:creationId xmlns:a16="http://schemas.microsoft.com/office/drawing/2014/main" id="{A100A91D-616D-4FD0-A09D-2DD30D83AB7D}"/>
               </a:ext>
             </a:extLst>
           </p:cNvPr>
@@ -8392,7 +8407,7 @@
           <p:cNvPr id="16" name="footer-left">
             <a:extLst xmlns:a="http://schemas.openxmlformats.org/drawingml/2006/main">
               <a:ext uri="{FF2B5EF4-FFF2-40B4-BE49-F238E27FC236}">
-                <a16:creationId xmlns:a16="http://schemas.microsoft.com/office/drawing/2014/main" id="{8A103698-D5ED-45DC-B6D2-560838745091}"/>
+                <a16:creationId xmlns:a16="http://schemas.microsoft.com/office/drawing/2014/main" id="{3BB4E2CE-5EC0-4790-9677-BFEB68DF578C}"/>
               </a:ext>
             </a:extLst>
           </p:cNvPr>
@@ -8437,7 +8452,7 @@
           <p:cNvPr id="17" name="footer-right">
             <a:extLst xmlns:a="http://schemas.openxmlformats.org/drawingml/2006/main">
               <a:ext uri="{FF2B5EF4-FFF2-40B4-BE49-F238E27FC236}">
-                <a16:creationId xmlns:a16="http://schemas.microsoft.com/office/drawing/2014/main" id="{ECA68970-57FA-47C1-A25B-71FF18315FB2}"/>
+                <a16:creationId xmlns:a16="http://schemas.microsoft.com/office/drawing/2014/main" id="{441DFA8B-5087-45AB-9E20-4E9460967052}"/>
               </a:ext>
             </a:extLst>
           </p:cNvPr>
@@ -8480,7 +8495,7 @@
     </p:spTree>
     <p:extLst>
       <p:ext uri="{BB962C8B-B14F-4D97-AF65-F5344CB8AC3E}">
-        <p14:creationId xmlns:p14="http://schemas.microsoft.com/office/powerpoint/2010/main" val="191919685"/>
+        <p14:creationId xmlns:p14="http://schemas.microsoft.com/office/powerpoint/2010/main" val="226307339"/>
       </p:ext>
     </p:extLst>
   </p:cSld>
@@ -8504,7 +8519,7 @@
           <p:cNvPr id="1" name="slide-stage">
             <a:extLst xmlns:a="http://schemas.openxmlformats.org/drawingml/2006/main">
               <a:ext uri="{FF2B5EF4-FFF2-40B4-BE49-F238E27FC236}">
-                <a16:creationId xmlns:a16="http://schemas.microsoft.com/office/drawing/2014/main" id="{F434662F-627C-4CF4-983C-53C9739FAE58}"/>
+                <a16:creationId xmlns:a16="http://schemas.microsoft.com/office/drawing/2014/main" id="{CEFA1BC0-711B-4975-9AA1-6CB0E30033BB}"/>
               </a:ext>
             </a:extLst>
           </p:cNvPr>
@@ -8531,7 +8546,7 @@
           <p:cNvPr id="2" name="eyebrow">
             <a:extLst xmlns:a="http://schemas.openxmlformats.org/drawingml/2006/main">
               <a:ext uri="{FF2B5EF4-FFF2-40B4-BE49-F238E27FC236}">
-                <a16:creationId xmlns:a16="http://schemas.microsoft.com/office/drawing/2014/main" id="{EB35EBD6-D43E-499F-8C98-1F461FD15950}"/>
+                <a16:creationId xmlns:a16="http://schemas.microsoft.com/office/drawing/2014/main" id="{4FC462A6-B86D-48F3-8310-4245C1075014}"/>
               </a:ext>
             </a:extLst>
           </p:cNvPr>
@@ -8576,7 +8591,7 @@
           <p:cNvPr id="3" name="slide-title">
             <a:extLst xmlns:a="http://schemas.openxmlformats.org/drawingml/2006/main">
               <a:ext uri="{FF2B5EF4-FFF2-40B4-BE49-F238E27FC236}">
-                <a16:creationId xmlns:a16="http://schemas.microsoft.com/office/drawing/2014/main" id="{209AA730-F4EE-4D83-83F1-BAE4D47FE8AD}"/>
+                <a16:creationId xmlns:a16="http://schemas.microsoft.com/office/drawing/2014/main" id="{499B637D-9820-4991-B8A9-28E3CD7411D5}"/>
               </a:ext>
             </a:extLst>
           </p:cNvPr>
@@ -8621,7 +8636,7 @@
           <p:cNvPr id="4" name="slide-subtitle">
             <a:extLst xmlns:a="http://schemas.openxmlformats.org/drawingml/2006/main">
               <a:ext uri="{FF2B5EF4-FFF2-40B4-BE49-F238E27FC236}">
-                <a16:creationId xmlns:a16="http://schemas.microsoft.com/office/drawing/2014/main" id="{FA7C7F9F-D2A5-4AFA-9840-BE2A444D76D2}"/>
+                <a16:creationId xmlns:a16="http://schemas.microsoft.com/office/drawing/2014/main" id="{88579BFC-2C04-4CBD-A475-29C77C157E85}"/>
               </a:ext>
             </a:extLst>
           </p:cNvPr>
@@ -8666,7 +8681,7 @@
           <p:cNvPr id="5" name="">
             <a:extLst xmlns:a="http://schemas.openxmlformats.org/drawingml/2006/main">
               <a:ext uri="{FF2B5EF4-FFF2-40B4-BE49-F238E27FC236}">
-                <a16:creationId xmlns:a16="http://schemas.microsoft.com/office/drawing/2014/main" id="{211030D6-51CB-43FA-923A-F1D7CBC955A2}"/>
+                <a16:creationId xmlns:a16="http://schemas.microsoft.com/office/drawing/2014/main" id="{C4E81ED1-F734-4C14-B71C-C6589D9A4243}"/>
               </a:ext>
             </a:extLst>
           </p:cNvPr>
@@ -8711,7 +8726,7 @@
           <p:cNvPr id="6" name="">
             <a:extLst xmlns:a="http://schemas.openxmlformats.org/drawingml/2006/main">
               <a:ext uri="{FF2B5EF4-FFF2-40B4-BE49-F238E27FC236}">
-                <a16:creationId xmlns:a16="http://schemas.microsoft.com/office/drawing/2014/main" id="{C9393C38-779D-47F4-BEBC-7AC109C35579}"/>
+                <a16:creationId xmlns:a16="http://schemas.microsoft.com/office/drawing/2014/main" id="{18C3BCA8-D691-4357-B6C5-C8F5B53700DB}"/>
               </a:ext>
             </a:extLst>
           </p:cNvPr>
@@ -8756,7 +8771,7 @@
           <p:cNvPr id="7" name="">
             <a:extLst xmlns:a="http://schemas.openxmlformats.org/drawingml/2006/main">
               <a:ext uri="{FF2B5EF4-FFF2-40B4-BE49-F238E27FC236}">
-                <a16:creationId xmlns:a16="http://schemas.microsoft.com/office/drawing/2014/main" id="{92E7452B-035B-4B3F-9D9C-D1A9918E9CA8}"/>
+                <a16:creationId xmlns:a16="http://schemas.microsoft.com/office/drawing/2014/main" id="{051DF28F-AD37-4F9B-A89D-01DBDDF82A5A}"/>
               </a:ext>
             </a:extLst>
           </p:cNvPr>
@@ -8801,7 +8816,7 @@
           <p:cNvPr id="8" name="">
             <a:extLst xmlns:a="http://schemas.openxmlformats.org/drawingml/2006/main">
               <a:ext uri="{FF2B5EF4-FFF2-40B4-BE49-F238E27FC236}">
-                <a16:creationId xmlns:a16="http://schemas.microsoft.com/office/drawing/2014/main" id="{19E14B18-F099-4098-8501-3C9F85F1EC79}"/>
+                <a16:creationId xmlns:a16="http://schemas.microsoft.com/office/drawing/2014/main" id="{B8D21EE0-ED80-46DF-8DB4-A5815D00763C}"/>
               </a:ext>
             </a:extLst>
           </p:cNvPr>
@@ -8846,7 +8861,7 @@
           <p:cNvPr id="9" name="">
             <a:extLst xmlns:a="http://schemas.openxmlformats.org/drawingml/2006/main">
               <a:ext uri="{FF2B5EF4-FFF2-40B4-BE49-F238E27FC236}">
-                <a16:creationId xmlns:a16="http://schemas.microsoft.com/office/drawing/2014/main" id="{A7691B65-55E5-4ED0-B713-EB5F691A2067}"/>
+                <a16:creationId xmlns:a16="http://schemas.microsoft.com/office/drawing/2014/main" id="{DCCA8687-B2E3-4306-A686-977B6B909057}"/>
               </a:ext>
             </a:extLst>
           </p:cNvPr>
@@ -8891,7 +8906,7 @@
           <p:cNvPr id="10" name="">
             <a:extLst xmlns:a="http://schemas.openxmlformats.org/drawingml/2006/main">
               <a:ext uri="{FF2B5EF4-FFF2-40B4-BE49-F238E27FC236}">
-                <a16:creationId xmlns:a16="http://schemas.microsoft.com/office/drawing/2014/main" id="{DFE4E594-E786-4DBA-9982-295A29688B15}"/>
+                <a16:creationId xmlns:a16="http://schemas.microsoft.com/office/drawing/2014/main" id="{97FFC6D0-0578-44D5-9230-EB209B732044}"/>
               </a:ext>
             </a:extLst>
           </p:cNvPr>
@@ -8936,7 +8951,7 @@
           <p:cNvPr id="11" name="">
             <a:extLst xmlns:a="http://schemas.openxmlformats.org/drawingml/2006/main">
               <a:ext uri="{FF2B5EF4-FFF2-40B4-BE49-F238E27FC236}">
-                <a16:creationId xmlns:a16="http://schemas.microsoft.com/office/drawing/2014/main" id="{95CF990D-FC95-4012-95C4-7FCEF612E26A}"/>
+                <a16:creationId xmlns:a16="http://schemas.microsoft.com/office/drawing/2014/main" id="{C30D783C-D828-4CEC-B544-8803C2DA32DA}"/>
               </a:ext>
             </a:extLst>
           </p:cNvPr>
@@ -8981,7 +8996,7 @@
           <p:cNvPr id="12" name="">
             <a:extLst xmlns:a="http://schemas.openxmlformats.org/drawingml/2006/main">
               <a:ext uri="{FF2B5EF4-FFF2-40B4-BE49-F238E27FC236}">
-                <a16:creationId xmlns:a16="http://schemas.microsoft.com/office/drawing/2014/main" id="{6CA5A163-297A-4620-B09A-2262A4632115}"/>
+                <a16:creationId xmlns:a16="http://schemas.microsoft.com/office/drawing/2014/main" id="{8C5F5B4A-55B1-4E92-BCE3-834AE2EEAC2C}"/>
               </a:ext>
             </a:extLst>
           </p:cNvPr>
@@ -9026,7 +9041,7 @@
           <p:cNvPr id="13" name="footer-left">
             <a:extLst xmlns:a="http://schemas.openxmlformats.org/drawingml/2006/main">
               <a:ext uri="{FF2B5EF4-FFF2-40B4-BE49-F238E27FC236}">
-                <a16:creationId xmlns:a16="http://schemas.microsoft.com/office/drawing/2014/main" id="{229B54B0-C6CC-4719-B008-AA959A1043DB}"/>
+                <a16:creationId xmlns:a16="http://schemas.microsoft.com/office/drawing/2014/main" id="{B77F142D-9FFB-49F2-BA78-0E9EF4E2577F}"/>
               </a:ext>
             </a:extLst>
           </p:cNvPr>
@@ -9071,7 +9086,7 @@
           <p:cNvPr id="14" name="footer-right">
             <a:extLst xmlns:a="http://schemas.openxmlformats.org/drawingml/2006/main">
               <a:ext uri="{FF2B5EF4-FFF2-40B4-BE49-F238E27FC236}">
-                <a16:creationId xmlns:a16="http://schemas.microsoft.com/office/drawing/2014/main" id="{BF55B262-8048-431A-A464-FFA1BA5CFF6E}"/>
+                <a16:creationId xmlns:a16="http://schemas.microsoft.com/office/drawing/2014/main" id="{934E18D3-1735-4D90-AF96-028C628F9781}"/>
               </a:ext>
             </a:extLst>
           </p:cNvPr>
@@ -9114,7 +9129,7 @@
     </p:spTree>
     <p:extLst>
       <p:ext uri="{BB962C8B-B14F-4D97-AF65-F5344CB8AC3E}">
-        <p14:creationId xmlns:p14="http://schemas.microsoft.com/office/powerpoint/2010/main" val="466041796"/>
+        <p14:creationId xmlns:p14="http://schemas.microsoft.com/office/powerpoint/2010/main" val="1306192934"/>
       </p:ext>
     </p:extLst>
   </p:cSld>
@@ -9138,7 +9153,7 @@
           <p:cNvPr id="1" name="slide-stage">
             <a:extLst xmlns:a="http://schemas.openxmlformats.org/drawingml/2006/main">
               <a:ext uri="{FF2B5EF4-FFF2-40B4-BE49-F238E27FC236}">
-                <a16:creationId xmlns:a16="http://schemas.microsoft.com/office/drawing/2014/main" id="{E8BF1497-A7C4-465A-B828-198F206DD4EA}"/>
+                <a16:creationId xmlns:a16="http://schemas.microsoft.com/office/drawing/2014/main" id="{8FAFBA5B-531C-4115-9055-EC8E76CBE595}"/>
               </a:ext>
             </a:extLst>
           </p:cNvPr>
@@ -9165,7 +9180,7 @@
           <p:cNvPr id="2" name="eyebrow">
             <a:extLst xmlns:a="http://schemas.openxmlformats.org/drawingml/2006/main">
               <a:ext uri="{FF2B5EF4-FFF2-40B4-BE49-F238E27FC236}">
-                <a16:creationId xmlns:a16="http://schemas.microsoft.com/office/drawing/2014/main" id="{41945F5C-AB50-425B-87A9-6243927A68B1}"/>
+                <a16:creationId xmlns:a16="http://schemas.microsoft.com/office/drawing/2014/main" id="{DCC3BD30-6EC8-45AC-BAB1-A61BC117F05C}"/>
               </a:ext>
             </a:extLst>
           </p:cNvPr>
@@ -9210,7 +9225,7 @@
           <p:cNvPr id="3" name="slide-title">
             <a:extLst xmlns:a="http://schemas.openxmlformats.org/drawingml/2006/main">
               <a:ext uri="{FF2B5EF4-FFF2-40B4-BE49-F238E27FC236}">
-                <a16:creationId xmlns:a16="http://schemas.microsoft.com/office/drawing/2014/main" id="{28DA0B63-F214-4CC6-87B0-19974EAAF4CB}"/>
+                <a16:creationId xmlns:a16="http://schemas.microsoft.com/office/drawing/2014/main" id="{B703112F-C798-4C7E-9057-3C5D4BCE3374}"/>
               </a:ext>
             </a:extLst>
           </p:cNvPr>
@@ -9255,7 +9270,7 @@
           <p:cNvPr id="4" name="slide-subtitle">
             <a:extLst xmlns:a="http://schemas.openxmlformats.org/drawingml/2006/main">
               <a:ext uri="{FF2B5EF4-FFF2-40B4-BE49-F238E27FC236}">
-                <a16:creationId xmlns:a16="http://schemas.microsoft.com/office/drawing/2014/main" id="{A1472EF4-57C0-4941-B0FE-0C053581BC9E}"/>
+                <a16:creationId xmlns:a16="http://schemas.microsoft.com/office/drawing/2014/main" id="{E0427942-DFF1-4E69-9CFB-5E043769382A}"/>
               </a:ext>
             </a:extLst>
           </p:cNvPr>
@@ -9300,7 +9315,7 @@
           <p:cNvPr id="5" name="">
             <a:extLst xmlns:a="http://schemas.openxmlformats.org/drawingml/2006/main">
               <a:ext uri="{FF2B5EF4-FFF2-40B4-BE49-F238E27FC236}">
-                <a16:creationId xmlns:a16="http://schemas.microsoft.com/office/drawing/2014/main" id="{FB0F15C7-7D0C-4A79-B5A9-E9076B439F44}"/>
+                <a16:creationId xmlns:a16="http://schemas.microsoft.com/office/drawing/2014/main" id="{08DEE35D-DC0D-4511-BF2A-CE91437F869C}"/>
               </a:ext>
             </a:extLst>
           </p:cNvPr>
@@ -9333,7 +9348,7 @@
           <p:cNvPr id="6" name="">
             <a:extLst xmlns:a="http://schemas.openxmlformats.org/drawingml/2006/main">
               <a:ext uri="{FF2B5EF4-FFF2-40B4-BE49-F238E27FC236}">
-                <a16:creationId xmlns:a16="http://schemas.microsoft.com/office/drawing/2014/main" id="{98B910C4-EF80-472E-A41F-F285AF5E88A6}"/>
+                <a16:creationId xmlns:a16="http://schemas.microsoft.com/office/drawing/2014/main" id="{B5BC514C-0A3E-4A23-886B-EAA047C055B9}"/>
               </a:ext>
             </a:extLst>
           </p:cNvPr>
@@ -9378,7 +9393,7 @@
           <p:cNvPr id="7" name="">
             <a:extLst xmlns:a="http://schemas.openxmlformats.org/drawingml/2006/main">
               <a:ext uri="{FF2B5EF4-FFF2-40B4-BE49-F238E27FC236}">
-                <a16:creationId xmlns:a16="http://schemas.microsoft.com/office/drawing/2014/main" id="{7BCEB89F-8514-42EE-875F-5778F68DA884}"/>
+                <a16:creationId xmlns:a16="http://schemas.microsoft.com/office/drawing/2014/main" id="{889461A1-3D6F-414E-ABFB-AC8ED8AC4497}"/>
               </a:ext>
             </a:extLst>
           </p:cNvPr>
@@ -9423,7 +9438,7 @@
           <p:cNvPr id="8" name="">
             <a:extLst xmlns:a="http://schemas.openxmlformats.org/drawingml/2006/main">
               <a:ext uri="{FF2B5EF4-FFF2-40B4-BE49-F238E27FC236}">
-                <a16:creationId xmlns:a16="http://schemas.microsoft.com/office/drawing/2014/main" id="{85A3D7DE-5F19-4DFE-B4DF-AF20BA99E949}"/>
+                <a16:creationId xmlns:a16="http://schemas.microsoft.com/office/drawing/2014/main" id="{CAD9EF56-F25C-440C-BACC-092F398C4BBF}"/>
               </a:ext>
             </a:extLst>
           </p:cNvPr>
@@ -9456,7 +9471,7 @@
           <p:cNvPr id="9" name="">
             <a:extLst xmlns:a="http://schemas.openxmlformats.org/drawingml/2006/main">
               <a:ext uri="{FF2B5EF4-FFF2-40B4-BE49-F238E27FC236}">
-                <a16:creationId xmlns:a16="http://schemas.microsoft.com/office/drawing/2014/main" id="{5FF95781-16A4-4918-AD6D-3B06CCBE7A8A}"/>
+                <a16:creationId xmlns:a16="http://schemas.microsoft.com/office/drawing/2014/main" id="{87B73CF5-9A06-4DB2-934C-CE5CBB6CE4BA}"/>
               </a:ext>
             </a:extLst>
           </p:cNvPr>
@@ -9501,7 +9516,7 @@
           <p:cNvPr id="10" name="">
             <a:extLst xmlns:a="http://schemas.openxmlformats.org/drawingml/2006/main">
               <a:ext uri="{FF2B5EF4-FFF2-40B4-BE49-F238E27FC236}">
-                <a16:creationId xmlns:a16="http://schemas.microsoft.com/office/drawing/2014/main" id="{D184768E-F8EE-467D-9C39-14ECD8746E53}"/>
+                <a16:creationId xmlns:a16="http://schemas.microsoft.com/office/drawing/2014/main" id="{9C82C652-8C75-42DA-87CD-932DCAB5F9CF}"/>
               </a:ext>
             </a:extLst>
           </p:cNvPr>
@@ -9546,7 +9561,7 @@
           <p:cNvPr id="11" name="">
             <a:extLst xmlns:a="http://schemas.openxmlformats.org/drawingml/2006/main">
               <a:ext uri="{FF2B5EF4-FFF2-40B4-BE49-F238E27FC236}">
-                <a16:creationId xmlns:a16="http://schemas.microsoft.com/office/drawing/2014/main" id="{69A2D85C-E8D0-442B-98BF-4FFC442DBF07}"/>
+                <a16:creationId xmlns:a16="http://schemas.microsoft.com/office/drawing/2014/main" id="{E2AB85E1-5941-4A4F-80D6-8F82258661AA}"/>
               </a:ext>
             </a:extLst>
           </p:cNvPr>
@@ -9579,7 +9594,7 @@
           <p:cNvPr id="12" name="">
             <a:extLst xmlns:a="http://schemas.openxmlformats.org/drawingml/2006/main">
               <a:ext uri="{FF2B5EF4-FFF2-40B4-BE49-F238E27FC236}">
-                <a16:creationId xmlns:a16="http://schemas.microsoft.com/office/drawing/2014/main" id="{9742FF47-06A4-41A2-93E7-1956F688A2AF}"/>
+                <a16:creationId xmlns:a16="http://schemas.microsoft.com/office/drawing/2014/main" id="{0D9A3E59-CAB8-43C5-8BF8-EB902AE86233}"/>
               </a:ext>
             </a:extLst>
           </p:cNvPr>
@@ -9624,7 +9639,7 @@
           <p:cNvPr id="13" name="">
             <a:extLst xmlns:a="http://schemas.openxmlformats.org/drawingml/2006/main">
               <a:ext uri="{FF2B5EF4-FFF2-40B4-BE49-F238E27FC236}">
-                <a16:creationId xmlns:a16="http://schemas.microsoft.com/office/drawing/2014/main" id="{D10CC10A-5EA7-413E-935C-7EEE4E86A4DF}"/>
+                <a16:creationId xmlns:a16="http://schemas.microsoft.com/office/drawing/2014/main" id="{4A353410-A95D-44CB-AC69-6336CBA0C2BE}"/>
               </a:ext>
             </a:extLst>
           </p:cNvPr>
@@ -9669,7 +9684,7 @@
           <p:cNvPr id="14" name="">
             <a:extLst xmlns:a="http://schemas.openxmlformats.org/drawingml/2006/main">
               <a:ext uri="{FF2B5EF4-FFF2-40B4-BE49-F238E27FC236}">
-                <a16:creationId xmlns:a16="http://schemas.microsoft.com/office/drawing/2014/main" id="{74AE5941-7B04-4FA8-B748-4AB815133170}"/>
+                <a16:creationId xmlns:a16="http://schemas.microsoft.com/office/drawing/2014/main" id="{E962A340-0601-45A8-AAA5-E296F9E233C2}"/>
               </a:ext>
             </a:extLst>
           </p:cNvPr>
@@ -9714,7 +9729,7 @@
           <p:cNvPr id="15" name="footer-left">
             <a:extLst xmlns:a="http://schemas.openxmlformats.org/drawingml/2006/main">
               <a:ext uri="{FF2B5EF4-FFF2-40B4-BE49-F238E27FC236}">
-                <a16:creationId xmlns:a16="http://schemas.microsoft.com/office/drawing/2014/main" id="{BA935324-A4E3-4385-9B7B-A33584CF7637}"/>
+                <a16:creationId xmlns:a16="http://schemas.microsoft.com/office/drawing/2014/main" id="{0EE0B692-907D-43D8-8DFA-BF42BBA6A08C}"/>
               </a:ext>
             </a:extLst>
           </p:cNvPr>
@@ -9759,7 +9774,7 @@
           <p:cNvPr id="16" name="footer-right">
             <a:extLst xmlns:a="http://schemas.openxmlformats.org/drawingml/2006/main">
               <a:ext uri="{FF2B5EF4-FFF2-40B4-BE49-F238E27FC236}">
-                <a16:creationId xmlns:a16="http://schemas.microsoft.com/office/drawing/2014/main" id="{F9E20AB2-A4B2-4C06-B39F-F9A3E05DD992}"/>
+                <a16:creationId xmlns:a16="http://schemas.microsoft.com/office/drawing/2014/main" id="{5E66C8E6-539D-4158-9002-8E41F672E536}"/>
               </a:ext>
             </a:extLst>
           </p:cNvPr>
@@ -9802,7 +9817,7 @@
     </p:spTree>
     <p:extLst>
       <p:ext uri="{BB962C8B-B14F-4D97-AF65-F5344CB8AC3E}">
-        <p14:creationId xmlns:p14="http://schemas.microsoft.com/office/powerpoint/2010/main" val="1038216239"/>
+        <p14:creationId xmlns:p14="http://schemas.microsoft.com/office/powerpoint/2010/main" val="32343896"/>
       </p:ext>
     </p:extLst>
   </p:cSld>
@@ -9826,7 +9841,7 @@
           <p:cNvPr id="1" name="slide-stage">
             <a:extLst xmlns:a="http://schemas.openxmlformats.org/drawingml/2006/main">
               <a:ext uri="{FF2B5EF4-FFF2-40B4-BE49-F238E27FC236}">
-                <a16:creationId xmlns:a16="http://schemas.microsoft.com/office/drawing/2014/main" id="{7573BD3B-A360-4DE7-A797-ED0CF5150CD4}"/>
+                <a16:creationId xmlns:a16="http://schemas.microsoft.com/office/drawing/2014/main" id="{2E7897A9-AC62-47FF-8CD9-31B2513155B2}"/>
               </a:ext>
             </a:extLst>
           </p:cNvPr>
@@ -9853,7 +9868,7 @@
           <p:cNvPr id="2" name="eyebrow">
             <a:extLst xmlns:a="http://schemas.openxmlformats.org/drawingml/2006/main">
               <a:ext uri="{FF2B5EF4-FFF2-40B4-BE49-F238E27FC236}">
-                <a16:creationId xmlns:a16="http://schemas.microsoft.com/office/drawing/2014/main" id="{C6F9B3A5-8269-48E1-8EA5-E3CBAF12CF55}"/>
+                <a16:creationId xmlns:a16="http://schemas.microsoft.com/office/drawing/2014/main" id="{B95FB6EC-008E-43B5-9F0B-686538024C8F}"/>
               </a:ext>
             </a:extLst>
           </p:cNvPr>
@@ -9898,7 +9913,7 @@
           <p:cNvPr id="3" name="slide-title">
             <a:extLst xmlns:a="http://schemas.openxmlformats.org/drawingml/2006/main">
               <a:ext uri="{FF2B5EF4-FFF2-40B4-BE49-F238E27FC236}">
-                <a16:creationId xmlns:a16="http://schemas.microsoft.com/office/drawing/2014/main" id="{7831281B-F697-4DEC-B4CE-3A773F40A0A8}"/>
+                <a16:creationId xmlns:a16="http://schemas.microsoft.com/office/drawing/2014/main" id="{CD92A884-1AA2-4508-A7EC-C0A85371A2E1}"/>
               </a:ext>
             </a:extLst>
           </p:cNvPr>
@@ -9943,7 +9958,7 @@
           <p:cNvPr id="4" name="slide-subtitle">
             <a:extLst xmlns:a="http://schemas.openxmlformats.org/drawingml/2006/main">
               <a:ext uri="{FF2B5EF4-FFF2-40B4-BE49-F238E27FC236}">
-                <a16:creationId xmlns:a16="http://schemas.microsoft.com/office/drawing/2014/main" id="{BDF3F8CB-E943-454F-87A6-5CA4D1350532}"/>
+                <a16:creationId xmlns:a16="http://schemas.microsoft.com/office/drawing/2014/main" id="{639C6B31-ED6C-454B-8567-92AE7CF34479}"/>
               </a:ext>
             </a:extLst>
           </p:cNvPr>
@@ -9988,7 +10003,7 @@
           <p:cNvPr id="5" name="">
             <a:extLst xmlns:a="http://schemas.openxmlformats.org/drawingml/2006/main">
               <a:ext uri="{FF2B5EF4-FFF2-40B4-BE49-F238E27FC236}">
-                <a16:creationId xmlns:a16="http://schemas.microsoft.com/office/drawing/2014/main" id="{66ED5979-CAFB-455C-BB58-29595BB3CE99}"/>
+                <a16:creationId xmlns:a16="http://schemas.microsoft.com/office/drawing/2014/main" id="{10345091-09C4-4132-BC88-07AD726916B3}"/>
               </a:ext>
             </a:extLst>
           </p:cNvPr>
@@ -10033,7 +10048,7 @@
           <p:cNvPr id="6" name="">
             <a:extLst xmlns:a="http://schemas.openxmlformats.org/drawingml/2006/main">
               <a:ext uri="{FF2B5EF4-FFF2-40B4-BE49-F238E27FC236}">
-                <a16:creationId xmlns:a16="http://schemas.microsoft.com/office/drawing/2014/main" id="{C6FF24C4-BDE1-472F-87B6-3AC51478350E}"/>
+                <a16:creationId xmlns:a16="http://schemas.microsoft.com/office/drawing/2014/main" id="{B5E5C7A1-8D66-46BB-8A40-FE1E7EC6C00C}"/>
               </a:ext>
             </a:extLst>
           </p:cNvPr>
@@ -10078,7 +10093,7 @@
           <p:cNvPr id="7" name="">
             <a:extLst xmlns:a="http://schemas.openxmlformats.org/drawingml/2006/main">
               <a:ext uri="{FF2B5EF4-FFF2-40B4-BE49-F238E27FC236}">
-                <a16:creationId xmlns:a16="http://schemas.microsoft.com/office/drawing/2014/main" id="{FBB66EFD-C962-481A-BACA-DEBC1D4D5F55}"/>
+                <a16:creationId xmlns:a16="http://schemas.microsoft.com/office/drawing/2014/main" id="{92395582-CB9A-4DAC-8999-C42330F62B3A}"/>
               </a:ext>
             </a:extLst>
           </p:cNvPr>
@@ -10123,7 +10138,7 @@
           <p:cNvPr id="8" name="">
             <a:extLst xmlns:a="http://schemas.openxmlformats.org/drawingml/2006/main">
               <a:ext uri="{FF2B5EF4-FFF2-40B4-BE49-F238E27FC236}">
-                <a16:creationId xmlns:a16="http://schemas.microsoft.com/office/drawing/2014/main" id="{DE32A63D-0B48-4F82-9BE2-8CC287E6E972}"/>
+                <a16:creationId xmlns:a16="http://schemas.microsoft.com/office/drawing/2014/main" id="{AA00C786-39FC-43F2-8667-F5B86230FC4C}"/>
               </a:ext>
             </a:extLst>
           </p:cNvPr>
@@ -10168,7 +10183,7 @@
           <p:cNvPr id="9" name="">
             <a:extLst xmlns:a="http://schemas.openxmlformats.org/drawingml/2006/main">
               <a:ext uri="{FF2B5EF4-FFF2-40B4-BE49-F238E27FC236}">
-                <a16:creationId xmlns:a16="http://schemas.microsoft.com/office/drawing/2014/main" id="{822004AE-F8EB-4A00-8FC2-E640B5427561}"/>
+                <a16:creationId xmlns:a16="http://schemas.microsoft.com/office/drawing/2014/main" id="{802EC856-255A-4E13-8ACE-635E8CC62905}"/>
               </a:ext>
             </a:extLst>
           </p:cNvPr>
@@ -10213,7 +10228,7 @@
           <p:cNvPr id="10" name="">
             <a:extLst xmlns:a="http://schemas.openxmlformats.org/drawingml/2006/main">
               <a:ext uri="{FF2B5EF4-FFF2-40B4-BE49-F238E27FC236}">
-                <a16:creationId xmlns:a16="http://schemas.microsoft.com/office/drawing/2014/main" id="{F64F03E7-F914-48B0-948F-EEF4DF0636AF}"/>
+                <a16:creationId xmlns:a16="http://schemas.microsoft.com/office/drawing/2014/main" id="{05F143A1-5134-4CC2-A03D-6B56FBAECC95}"/>
               </a:ext>
             </a:extLst>
           </p:cNvPr>
@@ -10258,7 +10273,7 @@
           <p:cNvPr id="11" name="">
             <a:extLst xmlns:a="http://schemas.openxmlformats.org/drawingml/2006/main">
               <a:ext uri="{FF2B5EF4-FFF2-40B4-BE49-F238E27FC236}">
-                <a16:creationId xmlns:a16="http://schemas.microsoft.com/office/drawing/2014/main" id="{D0056A20-3DE5-403F-B84E-A00FB6FEB2F2}"/>
+                <a16:creationId xmlns:a16="http://schemas.microsoft.com/office/drawing/2014/main" id="{6CD41CE2-FA6B-4514-A4FE-875DD7779FDF}"/>
               </a:ext>
             </a:extLst>
           </p:cNvPr>
@@ -10303,7 +10318,7 @@
           <p:cNvPr id="12" name="">
             <a:extLst xmlns:a="http://schemas.openxmlformats.org/drawingml/2006/main">
               <a:ext uri="{FF2B5EF4-FFF2-40B4-BE49-F238E27FC236}">
-                <a16:creationId xmlns:a16="http://schemas.microsoft.com/office/drawing/2014/main" id="{2DA5F020-2EB6-4669-834E-D35991D12EF6}"/>
+                <a16:creationId xmlns:a16="http://schemas.microsoft.com/office/drawing/2014/main" id="{7A6D39D0-5A32-4E77-86BB-D425E34B7BD3}"/>
               </a:ext>
             </a:extLst>
           </p:cNvPr>
@@ -10348,7 +10363,7 @@
           <p:cNvPr id="13" name="">
             <a:extLst xmlns:a="http://schemas.openxmlformats.org/drawingml/2006/main">
               <a:ext uri="{FF2B5EF4-FFF2-40B4-BE49-F238E27FC236}">
-                <a16:creationId xmlns:a16="http://schemas.microsoft.com/office/drawing/2014/main" id="{FB6058F9-300E-4789-8D4E-7571E5E3FA97}"/>
+                <a16:creationId xmlns:a16="http://schemas.microsoft.com/office/drawing/2014/main" id="{AF3AB0F6-1D58-4A09-B61B-4E466D88C0C6}"/>
               </a:ext>
             </a:extLst>
           </p:cNvPr>
@@ -10393,7 +10408,7 @@
           <p:cNvPr id="14" name="">
             <a:extLst xmlns:a="http://schemas.openxmlformats.org/drawingml/2006/main">
               <a:ext uri="{FF2B5EF4-FFF2-40B4-BE49-F238E27FC236}">
-                <a16:creationId xmlns:a16="http://schemas.microsoft.com/office/drawing/2014/main" id="{A98A9E16-4D63-4A27-8189-47C6C7DCF78A}"/>
+                <a16:creationId xmlns:a16="http://schemas.microsoft.com/office/drawing/2014/main" id="{7E1875CE-12BC-4E21-8194-2B08A06D5B0F}"/>
               </a:ext>
             </a:extLst>
           </p:cNvPr>
@@ -10438,7 +10453,7 @@
           <p:cNvPr id="15" name="">
             <a:extLst xmlns:a="http://schemas.openxmlformats.org/drawingml/2006/main">
               <a:ext uri="{FF2B5EF4-FFF2-40B4-BE49-F238E27FC236}">
-                <a16:creationId xmlns:a16="http://schemas.microsoft.com/office/drawing/2014/main" id="{A9D7854A-443E-4C7B-8DD3-BD8677974B92}"/>
+                <a16:creationId xmlns:a16="http://schemas.microsoft.com/office/drawing/2014/main" id="{11072B7C-57E8-4AD0-8940-40AD0E0D20CD}"/>
               </a:ext>
             </a:extLst>
           </p:cNvPr>
@@ -10483,7 +10498,7 @@
           <p:cNvPr id="16" name="">
             <a:extLst xmlns:a="http://schemas.openxmlformats.org/drawingml/2006/main">
               <a:ext uri="{FF2B5EF4-FFF2-40B4-BE49-F238E27FC236}">
-                <a16:creationId xmlns:a16="http://schemas.microsoft.com/office/drawing/2014/main" id="{52BECF8D-0E76-4EA3-B694-ACE98F67A332}"/>
+                <a16:creationId xmlns:a16="http://schemas.microsoft.com/office/drawing/2014/main" id="{C0BAEF67-5F89-4B84-BAB6-2EC17333F6E2}"/>
               </a:ext>
             </a:extLst>
           </p:cNvPr>
@@ -10528,7 +10543,7 @@
           <p:cNvPr id="17" name="">
             <a:extLst xmlns:a="http://schemas.openxmlformats.org/drawingml/2006/main">
               <a:ext uri="{FF2B5EF4-FFF2-40B4-BE49-F238E27FC236}">
-                <a16:creationId xmlns:a16="http://schemas.microsoft.com/office/drawing/2014/main" id="{173867BF-7F97-45CA-BAA7-4BB4A370ADD9}"/>
+                <a16:creationId xmlns:a16="http://schemas.microsoft.com/office/drawing/2014/main" id="{E47D7E86-BFC3-4D60-9521-6A36C03F8DDF}"/>
               </a:ext>
             </a:extLst>
           </p:cNvPr>
@@ -10573,7 +10588,7 @@
           <p:cNvPr id="18" name="">
             <a:extLst xmlns:a="http://schemas.openxmlformats.org/drawingml/2006/main">
               <a:ext uri="{FF2B5EF4-FFF2-40B4-BE49-F238E27FC236}">
-                <a16:creationId xmlns:a16="http://schemas.microsoft.com/office/drawing/2014/main" id="{912B2E23-7A57-4DD7-B9F7-1707FC8A2402}"/>
+                <a16:creationId xmlns:a16="http://schemas.microsoft.com/office/drawing/2014/main" id="{72E8945F-1834-4498-897B-E0F116F27B06}"/>
               </a:ext>
             </a:extLst>
           </p:cNvPr>
@@ -10618,7 +10633,7 @@
           <p:cNvPr id="19" name="">
             <a:extLst xmlns:a="http://schemas.openxmlformats.org/drawingml/2006/main">
               <a:ext uri="{FF2B5EF4-FFF2-40B4-BE49-F238E27FC236}">
-                <a16:creationId xmlns:a16="http://schemas.microsoft.com/office/drawing/2014/main" id="{A33BFCB5-A50A-4E72-A362-E0DF9E73D520}"/>
+                <a16:creationId xmlns:a16="http://schemas.microsoft.com/office/drawing/2014/main" id="{59B61E54-F16E-4441-BC7F-753EAB80C43F}"/>
               </a:ext>
             </a:extLst>
           </p:cNvPr>
@@ -10663,7 +10678,7 @@
           <p:cNvPr id="20" name="footer-left">
             <a:extLst xmlns:a="http://schemas.openxmlformats.org/drawingml/2006/main">
               <a:ext uri="{FF2B5EF4-FFF2-40B4-BE49-F238E27FC236}">
-                <a16:creationId xmlns:a16="http://schemas.microsoft.com/office/drawing/2014/main" id="{29502A18-E8E8-4A3B-A0AC-407A06087FDD}"/>
+                <a16:creationId xmlns:a16="http://schemas.microsoft.com/office/drawing/2014/main" id="{3949957A-12DE-43AF-82E3-E34235680042}"/>
               </a:ext>
             </a:extLst>
           </p:cNvPr>
@@ -10708,7 +10723,7 @@
           <p:cNvPr id="21" name="footer-right">
             <a:extLst xmlns:a="http://schemas.openxmlformats.org/drawingml/2006/main">
               <a:ext uri="{FF2B5EF4-FFF2-40B4-BE49-F238E27FC236}">
-                <a16:creationId xmlns:a16="http://schemas.microsoft.com/office/drawing/2014/main" id="{FD65E675-4E9D-4BB8-8EA2-508B3CB1460F}"/>
+                <a16:creationId xmlns:a16="http://schemas.microsoft.com/office/drawing/2014/main" id="{D5D088AF-BD94-43DC-BA4D-BE6D59F3839E}"/>
               </a:ext>
             </a:extLst>
           </p:cNvPr>
@@ -10751,7 +10766,7 @@
     </p:spTree>
     <p:extLst>
       <p:ext uri="{BB962C8B-B14F-4D97-AF65-F5344CB8AC3E}">
-        <p14:creationId xmlns:p14="http://schemas.microsoft.com/office/powerpoint/2010/main" val="1195507650"/>
+        <p14:creationId xmlns:p14="http://schemas.microsoft.com/office/powerpoint/2010/main" val="1363857978"/>
       </p:ext>
     </p:extLst>
   </p:cSld>
@@ -10775,7 +10790,7 @@
           <p:cNvPr id="1" name="slide-stage">
             <a:extLst xmlns:a="http://schemas.openxmlformats.org/drawingml/2006/main">
               <a:ext uri="{FF2B5EF4-FFF2-40B4-BE49-F238E27FC236}">
-                <a16:creationId xmlns:a16="http://schemas.microsoft.com/office/drawing/2014/main" id="{DF8F13C2-2718-42BE-823D-79CCEBBA2A5B}"/>
+                <a16:creationId xmlns:a16="http://schemas.microsoft.com/office/drawing/2014/main" id="{E572865C-1CC4-42DE-905B-BBE3FAD522E0}"/>
               </a:ext>
             </a:extLst>
           </p:cNvPr>
@@ -10802,7 +10817,7 @@
           <p:cNvPr id="2" name="eyebrow">
             <a:extLst xmlns:a="http://schemas.openxmlformats.org/drawingml/2006/main">
               <a:ext uri="{FF2B5EF4-FFF2-40B4-BE49-F238E27FC236}">
-                <a16:creationId xmlns:a16="http://schemas.microsoft.com/office/drawing/2014/main" id="{B347F9B7-A512-4FC6-8D9C-BE246F3C338B}"/>
+                <a16:creationId xmlns:a16="http://schemas.microsoft.com/office/drawing/2014/main" id="{D753E503-0FCC-487F-BF07-FEBB2E2B058E}"/>
               </a:ext>
             </a:extLst>
           </p:cNvPr>
@@ -10847,7 +10862,7 @@
           <p:cNvPr id="3" name="slide-title">
             <a:extLst xmlns:a="http://schemas.openxmlformats.org/drawingml/2006/main">
               <a:ext uri="{FF2B5EF4-FFF2-40B4-BE49-F238E27FC236}">
-                <a16:creationId xmlns:a16="http://schemas.microsoft.com/office/drawing/2014/main" id="{EC2C7470-3FCE-420B-B52C-ADFC21D11A92}"/>
+                <a16:creationId xmlns:a16="http://schemas.microsoft.com/office/drawing/2014/main" id="{3630166E-5B76-4E5B-8A4C-36C36E5F08B2}"/>
               </a:ext>
             </a:extLst>
           </p:cNvPr>
@@ -10892,7 +10907,7 @@
           <p:cNvPr id="4" name="slide-subtitle">
             <a:extLst xmlns:a="http://schemas.openxmlformats.org/drawingml/2006/main">
               <a:ext uri="{FF2B5EF4-FFF2-40B4-BE49-F238E27FC236}">
-                <a16:creationId xmlns:a16="http://schemas.microsoft.com/office/drawing/2014/main" id="{F36BFE50-A440-4A04-86A0-86FDFAE7B65A}"/>
+                <a16:creationId xmlns:a16="http://schemas.microsoft.com/office/drawing/2014/main" id="{136C253F-672A-4F8D-888F-3E01AA9F7B0F}"/>
               </a:ext>
             </a:extLst>
           </p:cNvPr>
@@ -10937,7 +10952,7 @@
           <p:cNvPr id="5" name="">
             <a:extLst xmlns:a="http://schemas.openxmlformats.org/drawingml/2006/main">
               <a:ext uri="{FF2B5EF4-FFF2-40B4-BE49-F238E27FC236}">
-                <a16:creationId xmlns:a16="http://schemas.microsoft.com/office/drawing/2014/main" id="{8F87CC24-4FC1-4428-BFC1-DCD44B265E5D}"/>
+                <a16:creationId xmlns:a16="http://schemas.microsoft.com/office/drawing/2014/main" id="{ADB0FEAF-31AD-4CB5-BABF-9686C46152C8}"/>
               </a:ext>
             </a:extLst>
           </p:cNvPr>
@@ -10970,7 +10985,7 @@
           <p:cNvPr id="6" name="">
             <a:extLst xmlns:a="http://schemas.openxmlformats.org/drawingml/2006/main">
               <a:ext uri="{FF2B5EF4-FFF2-40B4-BE49-F238E27FC236}">
-                <a16:creationId xmlns:a16="http://schemas.microsoft.com/office/drawing/2014/main" id="{5032AC52-653D-48A5-8D39-CB829D02C899}"/>
+                <a16:creationId xmlns:a16="http://schemas.microsoft.com/office/drawing/2014/main" id="{22AE7514-E6B6-4966-AECE-E66067537323}"/>
               </a:ext>
             </a:extLst>
           </p:cNvPr>
@@ -11066,7 +11081,7 @@
           <p:cNvPr id="7" name="">
             <a:extLst xmlns:a="http://schemas.openxmlformats.org/drawingml/2006/main">
               <a:ext uri="{FF2B5EF4-FFF2-40B4-BE49-F238E27FC236}">
-                <a16:creationId xmlns:a16="http://schemas.microsoft.com/office/drawing/2014/main" id="{A73ED765-E54F-4022-8AE0-1A4DCA829668}"/>
+                <a16:creationId xmlns:a16="http://schemas.microsoft.com/office/drawing/2014/main" id="{DABD0CD8-3A98-44ED-A859-C0CAD7176E74}"/>
               </a:ext>
             </a:extLst>
           </p:cNvPr>
@@ -11099,7 +11114,7 @@
           <p:cNvPr id="8" name="">
             <a:extLst xmlns:a="http://schemas.openxmlformats.org/drawingml/2006/main">
               <a:ext uri="{FF2B5EF4-FFF2-40B4-BE49-F238E27FC236}">
-                <a16:creationId xmlns:a16="http://schemas.microsoft.com/office/drawing/2014/main" id="{497A707B-7D04-4F0A-A887-1AE9F8238256}"/>
+                <a16:creationId xmlns:a16="http://schemas.microsoft.com/office/drawing/2014/main" id="{8453F57B-22E0-4700-B5E2-FC4B40E63525}"/>
               </a:ext>
             </a:extLst>
           </p:cNvPr>
@@ -11144,7 +11159,7 @@
           <p:cNvPr id="9" name="">
             <a:extLst xmlns:a="http://schemas.openxmlformats.org/drawingml/2006/main">
               <a:ext uri="{FF2B5EF4-FFF2-40B4-BE49-F238E27FC236}">
-                <a16:creationId xmlns:a16="http://schemas.microsoft.com/office/drawing/2014/main" id="{64BB709F-0AB9-4B7B-9F87-C0BEC05859A0}"/>
+                <a16:creationId xmlns:a16="http://schemas.microsoft.com/office/drawing/2014/main" id="{4901D14C-3E6F-469F-9B04-E9F09ECD6049}"/>
               </a:ext>
             </a:extLst>
           </p:cNvPr>
@@ -11189,7 +11204,7 @@
           <p:cNvPr id="10" name="">
             <a:extLst xmlns:a="http://schemas.openxmlformats.org/drawingml/2006/main">
               <a:ext uri="{FF2B5EF4-FFF2-40B4-BE49-F238E27FC236}">
-                <a16:creationId xmlns:a16="http://schemas.microsoft.com/office/drawing/2014/main" id="{E5329750-CFFC-46A2-92AE-9D6C8FEF7459}"/>
+                <a16:creationId xmlns:a16="http://schemas.microsoft.com/office/drawing/2014/main" id="{8598E49C-8D89-4902-A7BC-27E860C86FAB}"/>
               </a:ext>
             </a:extLst>
           </p:cNvPr>
@@ -11222,7 +11237,7 @@
           <p:cNvPr id="11" name="">
             <a:extLst xmlns:a="http://schemas.openxmlformats.org/drawingml/2006/main">
               <a:ext uri="{FF2B5EF4-FFF2-40B4-BE49-F238E27FC236}">
-                <a16:creationId xmlns:a16="http://schemas.microsoft.com/office/drawing/2014/main" id="{927771B1-6BA9-4B9F-9A7F-899013E9829D}"/>
+                <a16:creationId xmlns:a16="http://schemas.microsoft.com/office/drawing/2014/main" id="{B8340B01-2510-423D-87A9-6C9EEB3888ED}"/>
               </a:ext>
             </a:extLst>
           </p:cNvPr>
@@ -11267,7 +11282,7 @@
           <p:cNvPr id="12" name="">
             <a:extLst xmlns:a="http://schemas.openxmlformats.org/drawingml/2006/main">
               <a:ext uri="{FF2B5EF4-FFF2-40B4-BE49-F238E27FC236}">
-                <a16:creationId xmlns:a16="http://schemas.microsoft.com/office/drawing/2014/main" id="{89F688FD-8E1C-4A69-8CBE-AC2EB18B081C}"/>
+                <a16:creationId xmlns:a16="http://schemas.microsoft.com/office/drawing/2014/main" id="{8DC1EBB3-6796-42FD-B7E7-A184E5351788}"/>
               </a:ext>
             </a:extLst>
           </p:cNvPr>
@@ -11312,7 +11327,7 @@
           <p:cNvPr id="13" name="">
             <a:extLst xmlns:a="http://schemas.openxmlformats.org/drawingml/2006/main">
               <a:ext uri="{FF2B5EF4-FFF2-40B4-BE49-F238E27FC236}">
-                <a16:creationId xmlns:a16="http://schemas.microsoft.com/office/drawing/2014/main" id="{71916F37-1462-411F-8F6E-B41A1ED59E73}"/>
+                <a16:creationId xmlns:a16="http://schemas.microsoft.com/office/drawing/2014/main" id="{328223EF-5CE0-47AA-9991-7031FF7728F7}"/>
               </a:ext>
             </a:extLst>
           </p:cNvPr>
@@ -11345,7 +11360,7 @@
           <p:cNvPr id="14" name="">
             <a:extLst xmlns:a="http://schemas.openxmlformats.org/drawingml/2006/main">
               <a:ext uri="{FF2B5EF4-FFF2-40B4-BE49-F238E27FC236}">
-                <a16:creationId xmlns:a16="http://schemas.microsoft.com/office/drawing/2014/main" id="{62B04433-8A3C-473F-8812-525BA603C082}"/>
+                <a16:creationId xmlns:a16="http://schemas.microsoft.com/office/drawing/2014/main" id="{96FBBE58-2610-4DAF-9EDD-F29851158FC0}"/>
               </a:ext>
             </a:extLst>
           </p:cNvPr>
@@ -11390,7 +11405,7 @@
           <p:cNvPr id="15" name="">
             <a:extLst xmlns:a="http://schemas.openxmlformats.org/drawingml/2006/main">
               <a:ext uri="{FF2B5EF4-FFF2-40B4-BE49-F238E27FC236}">
-                <a16:creationId xmlns:a16="http://schemas.microsoft.com/office/drawing/2014/main" id="{5ADF3BBC-53ED-4040-8A07-399070FC42AB}"/>
+                <a16:creationId xmlns:a16="http://schemas.microsoft.com/office/drawing/2014/main" id="{9A3C2C64-1829-49E8-ADF8-60AB3CBF4D2D}"/>
               </a:ext>
             </a:extLst>
           </p:cNvPr>
@@ -11435,7 +11450,7 @@
           <p:cNvPr id="16" name="footer-left">
             <a:extLst xmlns:a="http://schemas.openxmlformats.org/drawingml/2006/main">
               <a:ext uri="{FF2B5EF4-FFF2-40B4-BE49-F238E27FC236}">
-                <a16:creationId xmlns:a16="http://schemas.microsoft.com/office/drawing/2014/main" id="{33881F66-EBBF-4157-B67A-FB59CAA37240}"/>
+                <a16:creationId xmlns:a16="http://schemas.microsoft.com/office/drawing/2014/main" id="{0BD4DE80-5246-45D2-9F57-7C544E041996}"/>
               </a:ext>
             </a:extLst>
           </p:cNvPr>
@@ -11480,7 +11495,7 @@
           <p:cNvPr id="17" name="footer-right">
             <a:extLst xmlns:a="http://schemas.openxmlformats.org/drawingml/2006/main">
               <a:ext uri="{FF2B5EF4-FFF2-40B4-BE49-F238E27FC236}">
-                <a16:creationId xmlns:a16="http://schemas.microsoft.com/office/drawing/2014/main" id="{6DBA360F-7DC9-495A-9323-AF75807DE5B3}"/>
+                <a16:creationId xmlns:a16="http://schemas.microsoft.com/office/drawing/2014/main" id="{F64D7FEC-4969-4AC8-8B41-4B6D47363678}"/>
               </a:ext>
             </a:extLst>
           </p:cNvPr>
@@ -11523,7 +11538,7 @@
     </p:spTree>
     <p:extLst>
       <p:ext uri="{BB962C8B-B14F-4D97-AF65-F5344CB8AC3E}">
-        <p14:creationId xmlns:p14="http://schemas.microsoft.com/office/powerpoint/2010/main" val="364061661"/>
+        <p14:creationId xmlns:p14="http://schemas.microsoft.com/office/powerpoint/2010/main" val="2075985493"/>
       </p:ext>
     </p:extLst>
   </p:cSld>
@@ -11547,7 +11562,7 @@
           <p:cNvPr id="1" name="slide-stage">
             <a:extLst xmlns:a="http://schemas.openxmlformats.org/drawingml/2006/main">
               <a:ext uri="{FF2B5EF4-FFF2-40B4-BE49-F238E27FC236}">
-                <a16:creationId xmlns:a16="http://schemas.microsoft.com/office/drawing/2014/main" id="{8D4BA182-9143-4BE0-BFD9-A8D62F7DB218}"/>
+                <a16:creationId xmlns:a16="http://schemas.microsoft.com/office/drawing/2014/main" id="{18D8C37B-6260-43E9-A7E3-FAD89528F91E}"/>
               </a:ext>
             </a:extLst>
           </p:cNvPr>
@@ -11574,7 +11589,7 @@
           <p:cNvPr id="2" name="eyebrow">
             <a:extLst xmlns:a="http://schemas.openxmlformats.org/drawingml/2006/main">
               <a:ext uri="{FF2B5EF4-FFF2-40B4-BE49-F238E27FC236}">
-                <a16:creationId xmlns:a16="http://schemas.microsoft.com/office/drawing/2014/main" id="{4DEDF3C8-B63B-46AC-977D-47FE39B87A42}"/>
+                <a16:creationId xmlns:a16="http://schemas.microsoft.com/office/drawing/2014/main" id="{20881C5C-751E-452E-BEEF-ECB04A225B63}"/>
               </a:ext>
             </a:extLst>
           </p:cNvPr>
@@ -11619,7 +11634,7 @@
           <p:cNvPr id="3" name="slide-title">
             <a:extLst xmlns:a="http://schemas.openxmlformats.org/drawingml/2006/main">
               <a:ext uri="{FF2B5EF4-FFF2-40B4-BE49-F238E27FC236}">
-                <a16:creationId xmlns:a16="http://schemas.microsoft.com/office/drawing/2014/main" id="{7D3254C1-FFA2-44C6-B437-DBE1DCC1D96C}"/>
+                <a16:creationId xmlns:a16="http://schemas.microsoft.com/office/drawing/2014/main" id="{9F17968F-D135-4FB4-B7D3-5F0557E0049C}"/>
               </a:ext>
             </a:extLst>
           </p:cNvPr>
@@ -11664,7 +11679,7 @@
           <p:cNvPr id="4" name="slide-subtitle">
             <a:extLst xmlns:a="http://schemas.openxmlformats.org/drawingml/2006/main">
               <a:ext uri="{FF2B5EF4-FFF2-40B4-BE49-F238E27FC236}">
-                <a16:creationId xmlns:a16="http://schemas.microsoft.com/office/drawing/2014/main" id="{9D5801B9-7F3F-4D2D-9969-61317CE7F2C6}"/>
+                <a16:creationId xmlns:a16="http://schemas.microsoft.com/office/drawing/2014/main" id="{A4746815-E8F0-4BC8-9513-84A4CECA0EEA}"/>
               </a:ext>
             </a:extLst>
           </p:cNvPr>
@@ -11709,7 +11724,7 @@
           <p:cNvPr id="5" name="">
             <a:extLst xmlns:a="http://schemas.openxmlformats.org/drawingml/2006/main">
               <a:ext uri="{FF2B5EF4-FFF2-40B4-BE49-F238E27FC236}">
-                <a16:creationId xmlns:a16="http://schemas.microsoft.com/office/drawing/2014/main" id="{37D80BFA-67C8-4D76-83A6-B571F9815E97}"/>
+                <a16:creationId xmlns:a16="http://schemas.microsoft.com/office/drawing/2014/main" id="{4BA0EE8A-F3C6-401E-9AC7-08915F2CE3CA}"/>
               </a:ext>
             </a:extLst>
           </p:cNvPr>
@@ -11742,7 +11757,7 @@
           <p:cNvPr id="6" name="">
             <a:extLst xmlns:a="http://schemas.openxmlformats.org/drawingml/2006/main">
               <a:ext uri="{FF2B5EF4-FFF2-40B4-BE49-F238E27FC236}">
-                <a16:creationId xmlns:a16="http://schemas.microsoft.com/office/drawing/2014/main" id="{40565EA8-3802-4AAA-B21B-FC6DEAB5EA29}"/>
+                <a16:creationId xmlns:a16="http://schemas.microsoft.com/office/drawing/2014/main" id="{8762F1D8-8FD6-44B6-B2C4-D40DD485E1C2}"/>
               </a:ext>
             </a:extLst>
           </p:cNvPr>
@@ -11787,7 +11802,7 @@
           <p:cNvPr id="7" name="">
             <a:extLst xmlns:a="http://schemas.openxmlformats.org/drawingml/2006/main">
               <a:ext uri="{FF2B5EF4-FFF2-40B4-BE49-F238E27FC236}">
-                <a16:creationId xmlns:a16="http://schemas.microsoft.com/office/drawing/2014/main" id="{BF7EF1C2-5B86-4221-827C-A57859BF18E5}"/>
+                <a16:creationId xmlns:a16="http://schemas.microsoft.com/office/drawing/2014/main" id="{B949E5F6-88CF-4757-96D5-672C2006D281}"/>
               </a:ext>
             </a:extLst>
           </p:cNvPr>
@@ -11832,7 +11847,7 @@
           <p:cNvPr id="8" name="">
             <a:extLst xmlns:a="http://schemas.openxmlformats.org/drawingml/2006/main">
               <a:ext uri="{FF2B5EF4-FFF2-40B4-BE49-F238E27FC236}">
-                <a16:creationId xmlns:a16="http://schemas.microsoft.com/office/drawing/2014/main" id="{F0DAD5D6-5B1A-4AB1-AC55-9E1C97BADE57}"/>
+                <a16:creationId xmlns:a16="http://schemas.microsoft.com/office/drawing/2014/main" id="{318B339E-833B-44D3-BBCB-3C3AE50C4E53}"/>
               </a:ext>
             </a:extLst>
           </p:cNvPr>
@@ -11877,7 +11892,7 @@
           <p:cNvPr id="9" name="">
             <a:extLst xmlns:a="http://schemas.openxmlformats.org/drawingml/2006/main">
               <a:ext uri="{FF2B5EF4-FFF2-40B4-BE49-F238E27FC236}">
-                <a16:creationId xmlns:a16="http://schemas.microsoft.com/office/drawing/2014/main" id="{11490AB1-9574-40B1-A7BA-17B727637893}"/>
+                <a16:creationId xmlns:a16="http://schemas.microsoft.com/office/drawing/2014/main" id="{F38ABB6C-7FED-4D1C-A185-A7B3052F52A1}"/>
               </a:ext>
             </a:extLst>
           </p:cNvPr>
@@ -11910,7 +11925,7 @@
           <p:cNvPr id="10" name="">
             <a:extLst xmlns:a="http://schemas.openxmlformats.org/drawingml/2006/main">
               <a:ext uri="{FF2B5EF4-FFF2-40B4-BE49-F238E27FC236}">
-                <a16:creationId xmlns:a16="http://schemas.microsoft.com/office/drawing/2014/main" id="{0578662A-6F64-4B72-8D75-F848D78CA499}"/>
+                <a16:creationId xmlns:a16="http://schemas.microsoft.com/office/drawing/2014/main" id="{48D97689-1822-4415-BFF3-4DD8C8F9ACE6}"/>
               </a:ext>
             </a:extLst>
           </p:cNvPr>
@@ -11955,7 +11970,7 @@
           <p:cNvPr id="11" name="">
             <a:extLst xmlns:a="http://schemas.openxmlformats.org/drawingml/2006/main">
               <a:ext uri="{FF2B5EF4-FFF2-40B4-BE49-F238E27FC236}">
-                <a16:creationId xmlns:a16="http://schemas.microsoft.com/office/drawing/2014/main" id="{F6541B20-D408-4607-8BEA-557A6D59D9BF}"/>
+                <a16:creationId xmlns:a16="http://schemas.microsoft.com/office/drawing/2014/main" id="{659B84B6-CB12-46E0-95FA-660E199A65C9}"/>
               </a:ext>
             </a:extLst>
           </p:cNvPr>
@@ -12000,7 +12015,7 @@
           <p:cNvPr id="12" name="">
             <a:extLst xmlns:a="http://schemas.openxmlformats.org/drawingml/2006/main">
               <a:ext uri="{FF2B5EF4-FFF2-40B4-BE49-F238E27FC236}">
-                <a16:creationId xmlns:a16="http://schemas.microsoft.com/office/drawing/2014/main" id="{3D6C2979-11ED-4A10-95C9-2BF730BA5BB3}"/>
+                <a16:creationId xmlns:a16="http://schemas.microsoft.com/office/drawing/2014/main" id="{F3A01EDE-AB28-436B-A1E8-C0C67E939C96}"/>
               </a:ext>
             </a:extLst>
           </p:cNvPr>
@@ -12045,7 +12060,7 @@
           <p:cNvPr id="13" name="">
             <a:extLst xmlns:a="http://schemas.openxmlformats.org/drawingml/2006/main">
               <a:ext uri="{FF2B5EF4-FFF2-40B4-BE49-F238E27FC236}">
-                <a16:creationId xmlns:a16="http://schemas.microsoft.com/office/drawing/2014/main" id="{6CC0304F-8322-4157-9129-D046186D56AF}"/>
+                <a16:creationId xmlns:a16="http://schemas.microsoft.com/office/drawing/2014/main" id="{B9263704-118B-433C-B920-D8F589BB86D6}"/>
               </a:ext>
             </a:extLst>
           </p:cNvPr>
@@ -12078,7 +12093,7 @@
           <p:cNvPr id="14" name="">
             <a:extLst xmlns:a="http://schemas.openxmlformats.org/drawingml/2006/main">
               <a:ext uri="{FF2B5EF4-FFF2-40B4-BE49-F238E27FC236}">
-                <a16:creationId xmlns:a16="http://schemas.microsoft.com/office/drawing/2014/main" id="{A17B443A-FAD3-4143-947D-9A01B8106DF6}"/>
+                <a16:creationId xmlns:a16="http://schemas.microsoft.com/office/drawing/2014/main" id="{F5AEB343-81FE-4044-BC2B-A7330A16BA03}"/>
               </a:ext>
             </a:extLst>
           </p:cNvPr>
@@ -12123,7 +12138,7 @@
           <p:cNvPr id="15" name="">
             <a:extLst xmlns:a="http://schemas.openxmlformats.org/drawingml/2006/main">
               <a:ext uri="{FF2B5EF4-FFF2-40B4-BE49-F238E27FC236}">
-                <a16:creationId xmlns:a16="http://schemas.microsoft.com/office/drawing/2014/main" id="{E52114C2-449F-4B63-9F0A-31B79A35F544}"/>
+                <a16:creationId xmlns:a16="http://schemas.microsoft.com/office/drawing/2014/main" id="{0EEBDF4C-CD7A-4954-B885-DC5EA1B63AA5}"/>
               </a:ext>
             </a:extLst>
           </p:cNvPr>
@@ -12168,7 +12183,7 @@
           <p:cNvPr id="16" name="">
             <a:extLst xmlns:a="http://schemas.openxmlformats.org/drawingml/2006/main">
               <a:ext uri="{FF2B5EF4-FFF2-40B4-BE49-F238E27FC236}">
-                <a16:creationId xmlns:a16="http://schemas.microsoft.com/office/drawing/2014/main" id="{9B53FFF3-838A-4300-9514-9C81A794B01B}"/>
+                <a16:creationId xmlns:a16="http://schemas.microsoft.com/office/drawing/2014/main" id="{26A42BCE-F266-4A20-A827-A327184220B8}"/>
               </a:ext>
             </a:extLst>
           </p:cNvPr>
@@ -12213,7 +12228,7 @@
           <p:cNvPr id="17" name="">
             <a:extLst xmlns:a="http://schemas.openxmlformats.org/drawingml/2006/main">
               <a:ext uri="{FF2B5EF4-FFF2-40B4-BE49-F238E27FC236}">
-                <a16:creationId xmlns:a16="http://schemas.microsoft.com/office/drawing/2014/main" id="{FF608B45-C94D-4F64-A00F-A5305A343B59}"/>
+                <a16:creationId xmlns:a16="http://schemas.microsoft.com/office/drawing/2014/main" id="{FF00C5E2-2303-4D96-B36E-C9EA0CD9A040}"/>
               </a:ext>
             </a:extLst>
           </p:cNvPr>
@@ -12246,7 +12261,7 @@
           <p:cNvPr id="18" name="">
             <a:extLst xmlns:a="http://schemas.openxmlformats.org/drawingml/2006/main">
               <a:ext uri="{FF2B5EF4-FFF2-40B4-BE49-F238E27FC236}">
-                <a16:creationId xmlns:a16="http://schemas.microsoft.com/office/drawing/2014/main" id="{34AC8F11-0095-4B49-B8F1-52E9BE72BFF5}"/>
+                <a16:creationId xmlns:a16="http://schemas.microsoft.com/office/drawing/2014/main" id="{E3848556-4901-41C1-9C5F-3714BF0DE26B}"/>
               </a:ext>
             </a:extLst>
           </p:cNvPr>
@@ -12291,7 +12306,7 @@
           <p:cNvPr id="19" name="">
             <a:extLst xmlns:a="http://schemas.openxmlformats.org/drawingml/2006/main">
               <a:ext uri="{FF2B5EF4-FFF2-40B4-BE49-F238E27FC236}">
-                <a16:creationId xmlns:a16="http://schemas.microsoft.com/office/drawing/2014/main" id="{41D0DD07-3F1E-4705-8A1F-B361A4F2CD84}"/>
+                <a16:creationId xmlns:a16="http://schemas.microsoft.com/office/drawing/2014/main" id="{B973A446-D952-404C-8E13-AA8DEB8D4A83}"/>
               </a:ext>
             </a:extLst>
           </p:cNvPr>
@@ -12336,7 +12351,7 @@
           <p:cNvPr id="20" name="">
             <a:extLst xmlns:a="http://schemas.openxmlformats.org/drawingml/2006/main">
               <a:ext uri="{FF2B5EF4-FFF2-40B4-BE49-F238E27FC236}">
-                <a16:creationId xmlns:a16="http://schemas.microsoft.com/office/drawing/2014/main" id="{DFC738CD-DDB1-4CF1-B1BC-3EED3BF06648}"/>
+                <a16:creationId xmlns:a16="http://schemas.microsoft.com/office/drawing/2014/main" id="{E14B11EA-D780-4840-8BD3-2051D5C9CFEB}"/>
               </a:ext>
             </a:extLst>
           </p:cNvPr>
@@ -12381,7 +12396,7 @@
           <p:cNvPr id="21" name="">
             <a:extLst xmlns:a="http://schemas.openxmlformats.org/drawingml/2006/main">
               <a:ext uri="{FF2B5EF4-FFF2-40B4-BE49-F238E27FC236}">
-                <a16:creationId xmlns:a16="http://schemas.microsoft.com/office/drawing/2014/main" id="{E4D5E7C9-6634-41E9-AC88-A70522088FFB}"/>
+                <a16:creationId xmlns:a16="http://schemas.microsoft.com/office/drawing/2014/main" id="{3BFE2A40-DD7A-4577-9B4B-BCCE7B36E54E}"/>
               </a:ext>
             </a:extLst>
           </p:cNvPr>
@@ -12414,7 +12429,7 @@
           <p:cNvPr id="22" name="">
             <a:extLst xmlns:a="http://schemas.openxmlformats.org/drawingml/2006/main">
               <a:ext uri="{FF2B5EF4-FFF2-40B4-BE49-F238E27FC236}">
-                <a16:creationId xmlns:a16="http://schemas.microsoft.com/office/drawing/2014/main" id="{3FC9C932-4B5A-43E3-BE7A-9F02F618C22D}"/>
+                <a16:creationId xmlns:a16="http://schemas.microsoft.com/office/drawing/2014/main" id="{EB801961-57B2-4C83-808C-8738E27EE25C}"/>
               </a:ext>
             </a:extLst>
           </p:cNvPr>
@@ -12459,7 +12474,7 @@
           <p:cNvPr id="23" name="">
             <a:extLst xmlns:a="http://schemas.openxmlformats.org/drawingml/2006/main">
               <a:ext uri="{FF2B5EF4-FFF2-40B4-BE49-F238E27FC236}">
-                <a16:creationId xmlns:a16="http://schemas.microsoft.com/office/drawing/2014/main" id="{3263A8C6-2FA6-4A67-B781-F14FDF0E5B5D}"/>
+                <a16:creationId xmlns:a16="http://schemas.microsoft.com/office/drawing/2014/main" id="{586D0BF5-2D2A-4B81-806E-D6B07CEDEB19}"/>
               </a:ext>
             </a:extLst>
           </p:cNvPr>
@@ -12504,7 +12519,7 @@
           <p:cNvPr id="24" name="">
             <a:extLst xmlns:a="http://schemas.openxmlformats.org/drawingml/2006/main">
               <a:ext uri="{FF2B5EF4-FFF2-40B4-BE49-F238E27FC236}">
-                <a16:creationId xmlns:a16="http://schemas.microsoft.com/office/drawing/2014/main" id="{7D4FD59D-112E-407D-B1B0-F32CB38D7123}"/>
+                <a16:creationId xmlns:a16="http://schemas.microsoft.com/office/drawing/2014/main" id="{6E3B3551-B9E6-466B-9A59-00008E5EBBD5}"/>
               </a:ext>
             </a:extLst>
           </p:cNvPr>
@@ -12549,7 +12564,7 @@
           <p:cNvPr id="25" name="">
             <a:extLst xmlns:a="http://schemas.openxmlformats.org/drawingml/2006/main">
               <a:ext uri="{FF2B5EF4-FFF2-40B4-BE49-F238E27FC236}">
-                <a16:creationId xmlns:a16="http://schemas.microsoft.com/office/drawing/2014/main" id="{745FD731-4B9F-480A-A6BE-B60680684D92}"/>
+                <a16:creationId xmlns:a16="http://schemas.microsoft.com/office/drawing/2014/main" id="{33F96073-B7EB-40C6-A918-7CC01D389453}"/>
               </a:ext>
             </a:extLst>
           </p:cNvPr>
@@ -12582,7 +12597,7 @@
           <p:cNvPr id="26" name="">
             <a:extLst xmlns:a="http://schemas.openxmlformats.org/drawingml/2006/main">
               <a:ext uri="{FF2B5EF4-FFF2-40B4-BE49-F238E27FC236}">
-                <a16:creationId xmlns:a16="http://schemas.microsoft.com/office/drawing/2014/main" id="{D5D34B44-D55E-47F3-AD39-84B28110FBAD}"/>
+                <a16:creationId xmlns:a16="http://schemas.microsoft.com/office/drawing/2014/main" id="{557E0E02-825F-4DB7-AD4C-BE5EB6CB2D17}"/>
               </a:ext>
             </a:extLst>
           </p:cNvPr>
@@ -12627,7 +12642,7 @@
           <p:cNvPr id="27" name="">
             <a:extLst xmlns:a="http://schemas.openxmlformats.org/drawingml/2006/main">
               <a:ext uri="{FF2B5EF4-FFF2-40B4-BE49-F238E27FC236}">
-                <a16:creationId xmlns:a16="http://schemas.microsoft.com/office/drawing/2014/main" id="{F351DA43-5975-4006-A065-2E4042AE7997}"/>
+                <a16:creationId xmlns:a16="http://schemas.microsoft.com/office/drawing/2014/main" id="{47C29502-A985-4AD3-A5FF-FFA19FCF236A}"/>
               </a:ext>
             </a:extLst>
           </p:cNvPr>
@@ -12672,7 +12687,7 @@
           <p:cNvPr id="28" name="">
             <a:extLst xmlns:a="http://schemas.openxmlformats.org/drawingml/2006/main">
               <a:ext uri="{FF2B5EF4-FFF2-40B4-BE49-F238E27FC236}">
-                <a16:creationId xmlns:a16="http://schemas.microsoft.com/office/drawing/2014/main" id="{CE54FDBD-D9D0-4F0F-87BA-8B322C43C71C}"/>
+                <a16:creationId xmlns:a16="http://schemas.microsoft.com/office/drawing/2014/main" id="{97F098B0-B51A-4C18-B3D9-DE4B11B428D5}"/>
               </a:ext>
             </a:extLst>
           </p:cNvPr>
@@ -12717,7 +12732,7 @@
           <p:cNvPr id="29" name="footer-left">
             <a:extLst xmlns:a="http://schemas.openxmlformats.org/drawingml/2006/main">
               <a:ext uri="{FF2B5EF4-FFF2-40B4-BE49-F238E27FC236}">
-                <a16:creationId xmlns:a16="http://schemas.microsoft.com/office/drawing/2014/main" id="{F8FA5004-97BA-4FAE-A5E0-B2EEEBB9BB88}"/>
+                <a16:creationId xmlns:a16="http://schemas.microsoft.com/office/drawing/2014/main" id="{EF42E7DB-1DB3-49A0-92B4-4BCC296FAFDC}"/>
               </a:ext>
             </a:extLst>
           </p:cNvPr>
@@ -12762,7 +12777,7 @@
           <p:cNvPr id="30" name="footer-right">
             <a:extLst xmlns:a="http://schemas.openxmlformats.org/drawingml/2006/main">
               <a:ext uri="{FF2B5EF4-FFF2-40B4-BE49-F238E27FC236}">
-                <a16:creationId xmlns:a16="http://schemas.microsoft.com/office/drawing/2014/main" id="{A542A33C-AFD7-419B-A381-F8021C193FC5}"/>
+                <a16:creationId xmlns:a16="http://schemas.microsoft.com/office/drawing/2014/main" id="{6F010858-0B8D-4448-A931-6AE3157C9DD2}"/>
               </a:ext>
             </a:extLst>
           </p:cNvPr>
@@ -12805,7 +12820,7 @@
     </p:spTree>
     <p:extLst>
       <p:ext uri="{BB962C8B-B14F-4D97-AF65-F5344CB8AC3E}">
-        <p14:creationId xmlns:p14="http://schemas.microsoft.com/office/powerpoint/2010/main" val="1666056034"/>
+        <p14:creationId xmlns:p14="http://schemas.microsoft.com/office/powerpoint/2010/main" val="1709959069"/>
       </p:ext>
     </p:extLst>
   </p:cSld>
@@ -12829,7 +12844,7 @@
           <p:cNvPr id="1" name="slide-stage">
             <a:extLst xmlns:a="http://schemas.openxmlformats.org/drawingml/2006/main">
               <a:ext uri="{FF2B5EF4-FFF2-40B4-BE49-F238E27FC236}">
-                <a16:creationId xmlns:a16="http://schemas.microsoft.com/office/drawing/2014/main" id="{F0E3293D-E66A-4838-B155-5C948F35B52E}"/>
+                <a16:creationId xmlns:a16="http://schemas.microsoft.com/office/drawing/2014/main" id="{3A97C73C-2A5E-4DBB-9AE7-2E3497F8A115}"/>
               </a:ext>
             </a:extLst>
           </p:cNvPr>
@@ -12856,7 +12871,7 @@
           <p:cNvPr id="2" name="eyebrow">
             <a:extLst xmlns:a="http://schemas.openxmlformats.org/drawingml/2006/main">
               <a:ext uri="{FF2B5EF4-FFF2-40B4-BE49-F238E27FC236}">
-                <a16:creationId xmlns:a16="http://schemas.microsoft.com/office/drawing/2014/main" id="{B926DB6C-FE13-4E87-BBA3-4137FC2E5041}"/>
+                <a16:creationId xmlns:a16="http://schemas.microsoft.com/office/drawing/2014/main" id="{BF7872AA-5E6C-439D-BD47-22661431AAE9}"/>
               </a:ext>
             </a:extLst>
           </p:cNvPr>
@@ -12901,7 +12916,7 @@
           <p:cNvPr id="3" name="slide-title">
             <a:extLst xmlns:a="http://schemas.openxmlformats.org/drawingml/2006/main">
               <a:ext uri="{FF2B5EF4-FFF2-40B4-BE49-F238E27FC236}">
-                <a16:creationId xmlns:a16="http://schemas.microsoft.com/office/drawing/2014/main" id="{204AB29C-CBF6-4F41-8A27-6F83591F9580}"/>
+                <a16:creationId xmlns:a16="http://schemas.microsoft.com/office/drawing/2014/main" id="{C6A521E4-2AB2-4B21-B6E6-EA7F5576D2B7}"/>
               </a:ext>
             </a:extLst>
           </p:cNvPr>
@@ -12946,7 +12961,7 @@
           <p:cNvPr id="4" name="slide-subtitle">
             <a:extLst xmlns:a="http://schemas.openxmlformats.org/drawingml/2006/main">
               <a:ext uri="{FF2B5EF4-FFF2-40B4-BE49-F238E27FC236}">
-                <a16:creationId xmlns:a16="http://schemas.microsoft.com/office/drawing/2014/main" id="{8361D4AB-7EFD-438F-83D7-5BA492E1BC93}"/>
+                <a16:creationId xmlns:a16="http://schemas.microsoft.com/office/drawing/2014/main" id="{93C78758-B8D6-4C9F-B911-37DEB5D9D54F}"/>
               </a:ext>
             </a:extLst>
           </p:cNvPr>
@@ -12991,7 +13006,7 @@
           <p:cNvPr id="5" name="">
             <a:extLst xmlns:a="http://schemas.openxmlformats.org/drawingml/2006/main">
               <a:ext uri="{FF2B5EF4-FFF2-40B4-BE49-F238E27FC236}">
-                <a16:creationId xmlns:a16="http://schemas.microsoft.com/office/drawing/2014/main" id="{F86221FE-3711-483C-8D3A-19E191A9C549}"/>
+                <a16:creationId xmlns:a16="http://schemas.microsoft.com/office/drawing/2014/main" id="{55C0655F-BBB3-4850-9CC9-D47733885856}"/>
               </a:ext>
             </a:extLst>
           </p:cNvPr>
@@ -13036,7 +13051,7 @@
           <p:cNvPr id="6" name="">
             <a:extLst xmlns:a="http://schemas.openxmlformats.org/drawingml/2006/main">
               <a:ext uri="{FF2B5EF4-FFF2-40B4-BE49-F238E27FC236}">
-                <a16:creationId xmlns:a16="http://schemas.microsoft.com/office/drawing/2014/main" id="{29537FAC-71E7-4719-BAD0-0258BBCDD824}"/>
+                <a16:creationId xmlns:a16="http://schemas.microsoft.com/office/drawing/2014/main" id="{5EE24EC3-5FC3-4E4E-8A33-C79E6E18D367}"/>
               </a:ext>
             </a:extLst>
           </p:cNvPr>
@@ -13071,7 +13086,7 @@
           <p:cNvPr id="7" name="">
             <a:extLst xmlns:a="http://schemas.openxmlformats.org/drawingml/2006/main">
               <a:ext uri="{FF2B5EF4-FFF2-40B4-BE49-F238E27FC236}">
-                <a16:creationId xmlns:a16="http://schemas.microsoft.com/office/drawing/2014/main" id="{41EC9D52-ABBC-46FE-8972-F9D42F471A83}"/>
+                <a16:creationId xmlns:a16="http://schemas.microsoft.com/office/drawing/2014/main" id="{B4645925-1DC7-4010-B3BD-EE6F46ED3FFE}"/>
               </a:ext>
             </a:extLst>
           </p:cNvPr>
@@ -13116,7 +13131,7 @@
           <p:cNvPr id="8" name="">
             <a:extLst xmlns:a="http://schemas.openxmlformats.org/drawingml/2006/main">
               <a:ext uri="{FF2B5EF4-FFF2-40B4-BE49-F238E27FC236}">
-                <a16:creationId xmlns:a16="http://schemas.microsoft.com/office/drawing/2014/main" id="{03A4B678-E573-406C-803C-4E63276E6546}"/>
+                <a16:creationId xmlns:a16="http://schemas.microsoft.com/office/drawing/2014/main" id="{258CA39A-F775-42A7-A896-20C67BDECC09}"/>
               </a:ext>
             </a:extLst>
           </p:cNvPr>
@@ -13161,7 +13176,7 @@
           <p:cNvPr id="9" name="">
             <a:extLst xmlns:a="http://schemas.openxmlformats.org/drawingml/2006/main">
               <a:ext uri="{FF2B5EF4-FFF2-40B4-BE49-F238E27FC236}">
-                <a16:creationId xmlns:a16="http://schemas.microsoft.com/office/drawing/2014/main" id="{B5687E58-F0F2-48A2-B928-0437B5B57C62}"/>
+                <a16:creationId xmlns:a16="http://schemas.microsoft.com/office/drawing/2014/main" id="{03D82BD8-1411-4960-8DA9-36D45351D376}"/>
               </a:ext>
             </a:extLst>
           </p:cNvPr>
@@ -13206,7 +13221,7 @@
           <p:cNvPr id="10" name="">
             <a:extLst xmlns:a="http://schemas.openxmlformats.org/drawingml/2006/main">
               <a:ext uri="{FF2B5EF4-FFF2-40B4-BE49-F238E27FC236}">
-                <a16:creationId xmlns:a16="http://schemas.microsoft.com/office/drawing/2014/main" id="{5A562B59-4588-4544-A5AB-FE5F1A1E85FE}"/>
+                <a16:creationId xmlns:a16="http://schemas.microsoft.com/office/drawing/2014/main" id="{208FF9DC-C512-4281-BB7E-93A5A25688B7}"/>
               </a:ext>
             </a:extLst>
           </p:cNvPr>
@@ -13241,7 +13256,7 @@
           <p:cNvPr id="11" name="">
             <a:extLst xmlns:a="http://schemas.openxmlformats.org/drawingml/2006/main">
               <a:ext uri="{FF2B5EF4-FFF2-40B4-BE49-F238E27FC236}">
-                <a16:creationId xmlns:a16="http://schemas.microsoft.com/office/drawing/2014/main" id="{B875801E-12F0-412D-9624-225198E80E60}"/>
+                <a16:creationId xmlns:a16="http://schemas.microsoft.com/office/drawing/2014/main" id="{5C2146D8-9C5E-41A2-BDD5-1EBC0CD398FE}"/>
               </a:ext>
             </a:extLst>
           </p:cNvPr>
@@ -13286,7 +13301,7 @@
           <p:cNvPr id="12" name="">
             <a:extLst xmlns:a="http://schemas.openxmlformats.org/drawingml/2006/main">
               <a:ext uri="{FF2B5EF4-FFF2-40B4-BE49-F238E27FC236}">
-                <a16:creationId xmlns:a16="http://schemas.microsoft.com/office/drawing/2014/main" id="{95B638A0-D0B3-471A-872A-7BEDF590FFE8}"/>
+                <a16:creationId xmlns:a16="http://schemas.microsoft.com/office/drawing/2014/main" id="{F09F58E8-0DEA-4FA7-A2AE-EEC23D559C23}"/>
               </a:ext>
             </a:extLst>
           </p:cNvPr>
@@ -13331,7 +13346,7 @@
           <p:cNvPr id="13" name="">
             <a:extLst xmlns:a="http://schemas.openxmlformats.org/drawingml/2006/main">
               <a:ext uri="{FF2B5EF4-FFF2-40B4-BE49-F238E27FC236}">
-                <a16:creationId xmlns:a16="http://schemas.microsoft.com/office/drawing/2014/main" id="{792CD39E-C09A-4D19-A986-DF1C4838904C}"/>
+                <a16:creationId xmlns:a16="http://schemas.microsoft.com/office/drawing/2014/main" id="{CB1E1A42-2B22-4243-A327-9BC2B17F43BF}"/>
               </a:ext>
             </a:extLst>
           </p:cNvPr>
@@ -13376,7 +13391,7 @@
           <p:cNvPr id="14" name="">
             <a:extLst xmlns:a="http://schemas.openxmlformats.org/drawingml/2006/main">
               <a:ext uri="{FF2B5EF4-FFF2-40B4-BE49-F238E27FC236}">
-                <a16:creationId xmlns:a16="http://schemas.microsoft.com/office/drawing/2014/main" id="{B85816B3-79AB-4AA0-8552-04B7A03EF0C9}"/>
+                <a16:creationId xmlns:a16="http://schemas.microsoft.com/office/drawing/2014/main" id="{0608B602-A3BB-4324-AEF0-2F52C916EAFA}"/>
               </a:ext>
             </a:extLst>
           </p:cNvPr>
@@ -13411,7 +13426,7 @@
           <p:cNvPr id="15" name="">
             <a:extLst xmlns:a="http://schemas.openxmlformats.org/drawingml/2006/main">
               <a:ext uri="{FF2B5EF4-FFF2-40B4-BE49-F238E27FC236}">
-                <a16:creationId xmlns:a16="http://schemas.microsoft.com/office/drawing/2014/main" id="{0CFA18BA-E7ED-4A35-81B0-7362B259A9D6}"/>
+                <a16:creationId xmlns:a16="http://schemas.microsoft.com/office/drawing/2014/main" id="{DC2E31E8-CF81-4F02-969D-08FFD606B97B}"/>
               </a:ext>
             </a:extLst>
           </p:cNvPr>
@@ -13456,7 +13471,7 @@
           <p:cNvPr id="16" name="">
             <a:extLst xmlns:a="http://schemas.openxmlformats.org/drawingml/2006/main">
               <a:ext uri="{FF2B5EF4-FFF2-40B4-BE49-F238E27FC236}">
-                <a16:creationId xmlns:a16="http://schemas.microsoft.com/office/drawing/2014/main" id="{4A7CF281-640F-45D8-A297-E756FA784E15}"/>
+                <a16:creationId xmlns:a16="http://schemas.microsoft.com/office/drawing/2014/main" id="{09FC762F-42BD-4518-9E44-F214E39BA288}"/>
               </a:ext>
             </a:extLst>
           </p:cNvPr>
@@ -13501,7 +13516,7 @@
           <p:cNvPr id="17" name="">
             <a:extLst xmlns:a="http://schemas.openxmlformats.org/drawingml/2006/main">
               <a:ext uri="{FF2B5EF4-FFF2-40B4-BE49-F238E27FC236}">
-                <a16:creationId xmlns:a16="http://schemas.microsoft.com/office/drawing/2014/main" id="{AD3B66F8-9089-4549-8A71-FEFFB71F513B}"/>
+                <a16:creationId xmlns:a16="http://schemas.microsoft.com/office/drawing/2014/main" id="{08325A62-3326-47F8-8B79-8E9EF1FABB58}"/>
               </a:ext>
             </a:extLst>
           </p:cNvPr>
@@ -13546,7 +13561,7 @@
           <p:cNvPr id="18" name="">
             <a:extLst xmlns:a="http://schemas.openxmlformats.org/drawingml/2006/main">
               <a:ext uri="{FF2B5EF4-FFF2-40B4-BE49-F238E27FC236}">
-                <a16:creationId xmlns:a16="http://schemas.microsoft.com/office/drawing/2014/main" id="{C43CB242-E4D3-4699-B0E5-D7ED00480209}"/>
+                <a16:creationId xmlns:a16="http://schemas.microsoft.com/office/drawing/2014/main" id="{167295AF-E49C-4869-A5B2-7D4DAAC8F112}"/>
               </a:ext>
             </a:extLst>
           </p:cNvPr>
@@ -13581,7 +13596,7 @@
           <p:cNvPr id="19" name="">
             <a:extLst xmlns:a="http://schemas.openxmlformats.org/drawingml/2006/main">
               <a:ext uri="{FF2B5EF4-FFF2-40B4-BE49-F238E27FC236}">
-                <a16:creationId xmlns:a16="http://schemas.microsoft.com/office/drawing/2014/main" id="{7AE9E14F-FED7-417D-8BE7-3F310E180215}"/>
+                <a16:creationId xmlns:a16="http://schemas.microsoft.com/office/drawing/2014/main" id="{55637AB9-6290-4DF9-9608-5A4B7D0D7E0F}"/>
               </a:ext>
             </a:extLst>
           </p:cNvPr>
@@ -13626,7 +13641,7 @@
           <p:cNvPr id="20" name="">
             <a:extLst xmlns:a="http://schemas.openxmlformats.org/drawingml/2006/main">
               <a:ext uri="{FF2B5EF4-FFF2-40B4-BE49-F238E27FC236}">
-                <a16:creationId xmlns:a16="http://schemas.microsoft.com/office/drawing/2014/main" id="{320978D7-30C4-4BF6-A455-1CABF10BDE33}"/>
+                <a16:creationId xmlns:a16="http://schemas.microsoft.com/office/drawing/2014/main" id="{3434EFD6-DDF7-4B6C-A370-6221ECC38791}"/>
               </a:ext>
             </a:extLst>
           </p:cNvPr>
@@ -13671,7 +13686,7 @@
           <p:cNvPr id="21" name="">
             <a:extLst xmlns:a="http://schemas.openxmlformats.org/drawingml/2006/main">
               <a:ext uri="{FF2B5EF4-FFF2-40B4-BE49-F238E27FC236}">
-                <a16:creationId xmlns:a16="http://schemas.microsoft.com/office/drawing/2014/main" id="{2B2E40EB-4D6C-492E-B7A1-F1AAF1747240}"/>
+                <a16:creationId xmlns:a16="http://schemas.microsoft.com/office/drawing/2014/main" id="{44E38062-A2F0-4CDA-9CE6-D6FBA826D19A}"/>
               </a:ext>
             </a:extLst>
           </p:cNvPr>
@@ -13716,7 +13731,7 @@
           <p:cNvPr id="22" name="">
             <a:extLst xmlns:a="http://schemas.openxmlformats.org/drawingml/2006/main">
               <a:ext uri="{FF2B5EF4-FFF2-40B4-BE49-F238E27FC236}">
-                <a16:creationId xmlns:a16="http://schemas.microsoft.com/office/drawing/2014/main" id="{090A9659-3847-4CA8-B9BB-70471E4B54BA}"/>
+                <a16:creationId xmlns:a16="http://schemas.microsoft.com/office/drawing/2014/main" id="{EB35EAD2-2CBF-4EAF-BE8A-24422B51968F}"/>
               </a:ext>
             </a:extLst>
           </p:cNvPr>
@@ -13751,7 +13766,7 @@
           <p:cNvPr id="23" name="">
             <a:extLst xmlns:a="http://schemas.openxmlformats.org/drawingml/2006/main">
               <a:ext uri="{FF2B5EF4-FFF2-40B4-BE49-F238E27FC236}">
-                <a16:creationId xmlns:a16="http://schemas.microsoft.com/office/drawing/2014/main" id="{71C0B3FF-EA82-4066-937F-8CC20068C6FE}"/>
+                <a16:creationId xmlns:a16="http://schemas.microsoft.com/office/drawing/2014/main" id="{16D7CB45-573F-48DF-A5AF-89A2D22F5513}"/>
               </a:ext>
             </a:extLst>
           </p:cNvPr>
@@ -13796,7 +13811,7 @@
           <p:cNvPr id="24" name="">
             <a:extLst xmlns:a="http://schemas.openxmlformats.org/drawingml/2006/main">
               <a:ext uri="{FF2B5EF4-FFF2-40B4-BE49-F238E27FC236}">
-                <a16:creationId xmlns:a16="http://schemas.microsoft.com/office/drawing/2014/main" id="{28ECF55D-FCA6-4F5D-AC34-17CF83AD0B50}"/>
+                <a16:creationId xmlns:a16="http://schemas.microsoft.com/office/drawing/2014/main" id="{16B87813-F6FE-4225-A9CD-F2898248FF06}"/>
               </a:ext>
             </a:extLst>
           </p:cNvPr>
@@ -13841,7 +13856,7 @@
           <p:cNvPr id="25" name="footer-left">
             <a:extLst xmlns:a="http://schemas.openxmlformats.org/drawingml/2006/main">
               <a:ext uri="{FF2B5EF4-FFF2-40B4-BE49-F238E27FC236}">
-                <a16:creationId xmlns:a16="http://schemas.microsoft.com/office/drawing/2014/main" id="{ECAC9FB2-FE37-4615-BD17-AE12D70AEE7A}"/>
+                <a16:creationId xmlns:a16="http://schemas.microsoft.com/office/drawing/2014/main" id="{F6F84BB9-2049-4CA6-AFDB-2328E9C5AB0B}"/>
               </a:ext>
             </a:extLst>
           </p:cNvPr>
@@ -13886,7 +13901,7 @@
           <p:cNvPr id="26" name="footer-right">
             <a:extLst xmlns:a="http://schemas.openxmlformats.org/drawingml/2006/main">
               <a:ext uri="{FF2B5EF4-FFF2-40B4-BE49-F238E27FC236}">
-                <a16:creationId xmlns:a16="http://schemas.microsoft.com/office/drawing/2014/main" id="{A1651C1E-1037-408D-B284-0A0C4ABE0016}"/>
+                <a16:creationId xmlns:a16="http://schemas.microsoft.com/office/drawing/2014/main" id="{DAC44826-AD5C-458D-A496-EAC92A6E1D23}"/>
               </a:ext>
             </a:extLst>
           </p:cNvPr>
@@ -13929,7 +13944,7 @@
     </p:spTree>
     <p:extLst>
       <p:ext uri="{BB962C8B-B14F-4D97-AF65-F5344CB8AC3E}">
-        <p14:creationId xmlns:p14="http://schemas.microsoft.com/office/powerpoint/2010/main" val="96725478"/>
+        <p14:creationId xmlns:p14="http://schemas.microsoft.com/office/powerpoint/2010/main" val="681628013"/>
       </p:ext>
     </p:extLst>
   </p:cSld>
@@ -13953,7 +13968,7 @@
           <p:cNvPr id="1" name="slide-stage">
             <a:extLst xmlns:a="http://schemas.openxmlformats.org/drawingml/2006/main">
               <a:ext uri="{FF2B5EF4-FFF2-40B4-BE49-F238E27FC236}">
-                <a16:creationId xmlns:a16="http://schemas.microsoft.com/office/drawing/2014/main" id="{7DF47A3B-B363-4063-BBFD-9C1055FA3847}"/>
+                <a16:creationId xmlns:a16="http://schemas.microsoft.com/office/drawing/2014/main" id="{5A3DEFAD-0C1F-4591-9951-C326151B85D4}"/>
               </a:ext>
             </a:extLst>
           </p:cNvPr>
@@ -13980,7 +13995,7 @@
           <p:cNvPr id="2" name="eyebrow">
             <a:extLst xmlns:a="http://schemas.openxmlformats.org/drawingml/2006/main">
               <a:ext uri="{FF2B5EF4-FFF2-40B4-BE49-F238E27FC236}">
-                <a16:creationId xmlns:a16="http://schemas.microsoft.com/office/drawing/2014/main" id="{DE30688D-3532-4EA6-A974-C0D9C9D5F122}"/>
+                <a16:creationId xmlns:a16="http://schemas.microsoft.com/office/drawing/2014/main" id="{69C93D37-FD5C-4B11-B4EB-081A440250E8}"/>
               </a:ext>
             </a:extLst>
           </p:cNvPr>
@@ -14025,7 +14040,7 @@
           <p:cNvPr id="3" name="slide-title">
             <a:extLst xmlns:a="http://schemas.openxmlformats.org/drawingml/2006/main">
               <a:ext uri="{FF2B5EF4-FFF2-40B4-BE49-F238E27FC236}">
-                <a16:creationId xmlns:a16="http://schemas.microsoft.com/office/drawing/2014/main" id="{0A1CA92E-0FF3-45DC-875F-C37CE3DA979C}"/>
+                <a16:creationId xmlns:a16="http://schemas.microsoft.com/office/drawing/2014/main" id="{4F29F39E-39B8-4B44-ADD2-AAE0654795C4}"/>
               </a:ext>
             </a:extLst>
           </p:cNvPr>
@@ -14070,7 +14085,7 @@
           <p:cNvPr id="4" name="slide-subtitle">
             <a:extLst xmlns:a="http://schemas.openxmlformats.org/drawingml/2006/main">
               <a:ext uri="{FF2B5EF4-FFF2-40B4-BE49-F238E27FC236}">
-                <a16:creationId xmlns:a16="http://schemas.microsoft.com/office/drawing/2014/main" id="{14C32591-20EB-4CD5-B30A-8A26BA863FD0}"/>
+                <a16:creationId xmlns:a16="http://schemas.microsoft.com/office/drawing/2014/main" id="{233F3427-046B-4D62-A08B-4AA99B59AF6D}"/>
               </a:ext>
             </a:extLst>
           </p:cNvPr>
@@ -14115,7 +14130,7 @@
           <p:cNvPr id="5" name="">
             <a:extLst xmlns:a="http://schemas.openxmlformats.org/drawingml/2006/main">
               <a:ext uri="{FF2B5EF4-FFF2-40B4-BE49-F238E27FC236}">
-                <a16:creationId xmlns:a16="http://schemas.microsoft.com/office/drawing/2014/main" id="{65A57016-7B2D-4C29-9789-3D0AF6C8FEA8}"/>
+                <a16:creationId xmlns:a16="http://schemas.microsoft.com/office/drawing/2014/main" id="{BB09B9F9-C14D-4326-B0E4-362BE40A4E65}"/>
               </a:ext>
             </a:extLst>
           </p:cNvPr>
@@ -14148,7 +14163,7 @@
           <p:cNvPr id="6" name="">
             <a:extLst xmlns:a="http://schemas.openxmlformats.org/drawingml/2006/main">
               <a:ext uri="{FF2B5EF4-FFF2-40B4-BE49-F238E27FC236}">
-                <a16:creationId xmlns:a16="http://schemas.microsoft.com/office/drawing/2014/main" id="{F9E65187-92D9-4176-977C-22AA0E60B911}"/>
+                <a16:creationId xmlns:a16="http://schemas.microsoft.com/office/drawing/2014/main" id="{9944E821-20EE-411E-A7D7-8FC3036CE8DB}"/>
               </a:ext>
             </a:extLst>
           </p:cNvPr>
@@ -14193,7 +14208,7 @@
           <p:cNvPr id="7" name="">
             <a:extLst xmlns:a="http://schemas.openxmlformats.org/drawingml/2006/main">
               <a:ext uri="{FF2B5EF4-FFF2-40B4-BE49-F238E27FC236}">
-                <a16:creationId xmlns:a16="http://schemas.microsoft.com/office/drawing/2014/main" id="{45F03E41-FB61-4A71-BA48-5D2AB8EF8D00}"/>
+                <a16:creationId xmlns:a16="http://schemas.microsoft.com/office/drawing/2014/main" id="{1F4815E9-B313-48A6-A522-9A477BF80267}"/>
               </a:ext>
             </a:extLst>
           </p:cNvPr>
@@ -14238,7 +14253,7 @@
           <p:cNvPr id="8" name="">
             <a:extLst xmlns:a="http://schemas.openxmlformats.org/drawingml/2006/main">
               <a:ext uri="{FF2B5EF4-FFF2-40B4-BE49-F238E27FC236}">
-                <a16:creationId xmlns:a16="http://schemas.microsoft.com/office/drawing/2014/main" id="{B528B6DB-12E5-402A-B76D-5B424010B508}"/>
+                <a16:creationId xmlns:a16="http://schemas.microsoft.com/office/drawing/2014/main" id="{623945C9-82F7-4BE8-96D2-C333A1F4AD0E}"/>
               </a:ext>
             </a:extLst>
           </p:cNvPr>
@@ -14271,7 +14286,7 @@
           <p:cNvPr id="9" name="">
             <a:extLst xmlns:a="http://schemas.openxmlformats.org/drawingml/2006/main">
               <a:ext uri="{FF2B5EF4-FFF2-40B4-BE49-F238E27FC236}">
-                <a16:creationId xmlns:a16="http://schemas.microsoft.com/office/drawing/2014/main" id="{AE4E08B4-E97E-4EB7-A1F6-88A8E5127484}"/>
+                <a16:creationId xmlns:a16="http://schemas.microsoft.com/office/drawing/2014/main" id="{4C150DF1-6FE4-48FE-8675-5919EDBCF40E}"/>
               </a:ext>
             </a:extLst>
           </p:cNvPr>
@@ -14316,7 +14331,7 @@
           <p:cNvPr id="10" name="">
             <a:extLst xmlns:a="http://schemas.openxmlformats.org/drawingml/2006/main">
               <a:ext uri="{FF2B5EF4-FFF2-40B4-BE49-F238E27FC236}">
-                <a16:creationId xmlns:a16="http://schemas.microsoft.com/office/drawing/2014/main" id="{9948499D-E6E5-42B0-8408-2D8126FF1B3A}"/>
+                <a16:creationId xmlns:a16="http://schemas.microsoft.com/office/drawing/2014/main" id="{A3DE4534-B536-4F06-A90D-9D9503CD8ACD}"/>
               </a:ext>
             </a:extLst>
           </p:cNvPr>
@@ -14361,7 +14376,7 @@
           <p:cNvPr id="11" name="">
             <a:extLst xmlns:a="http://schemas.openxmlformats.org/drawingml/2006/main">
               <a:ext uri="{FF2B5EF4-FFF2-40B4-BE49-F238E27FC236}">
-                <a16:creationId xmlns:a16="http://schemas.microsoft.com/office/drawing/2014/main" id="{2C51100D-BC7B-40B2-8EC8-971C940F32C8}"/>
+                <a16:creationId xmlns:a16="http://schemas.microsoft.com/office/drawing/2014/main" id="{90FFE7A4-3AEF-4D41-AF51-95904085FBD1}"/>
               </a:ext>
             </a:extLst>
           </p:cNvPr>
@@ -14394,7 +14409,7 @@
           <p:cNvPr id="12" name="">
             <a:extLst xmlns:a="http://schemas.openxmlformats.org/drawingml/2006/main">
               <a:ext uri="{FF2B5EF4-FFF2-40B4-BE49-F238E27FC236}">
-                <a16:creationId xmlns:a16="http://schemas.microsoft.com/office/drawing/2014/main" id="{69738C8A-CA82-4673-BC91-3C8458D4DC2A}"/>
+                <a16:creationId xmlns:a16="http://schemas.microsoft.com/office/drawing/2014/main" id="{BD2A06AA-1FD5-4052-950E-2E4100B436EE}"/>
               </a:ext>
             </a:extLst>
           </p:cNvPr>
@@ -14439,7 +14454,7 @@
           <p:cNvPr id="13" name="">
             <a:extLst xmlns:a="http://schemas.openxmlformats.org/drawingml/2006/main">
               <a:ext uri="{FF2B5EF4-FFF2-40B4-BE49-F238E27FC236}">
-                <a16:creationId xmlns:a16="http://schemas.microsoft.com/office/drawing/2014/main" id="{140A8107-BE02-4642-B05E-ACDF97F2B15B}"/>
+                <a16:creationId xmlns:a16="http://schemas.microsoft.com/office/drawing/2014/main" id="{A4E9B975-8FB7-4199-9199-733CA3CC16F9}"/>
               </a:ext>
             </a:extLst>
           </p:cNvPr>
@@ -14484,7 +14499,7 @@
           <p:cNvPr id="14" name="">
             <a:extLst xmlns:a="http://schemas.openxmlformats.org/drawingml/2006/main">
               <a:ext uri="{FF2B5EF4-FFF2-40B4-BE49-F238E27FC236}">
-                <a16:creationId xmlns:a16="http://schemas.microsoft.com/office/drawing/2014/main" id="{3E87CADD-7495-4763-ABA3-D7DCDF06D6DB}"/>
+                <a16:creationId xmlns:a16="http://schemas.microsoft.com/office/drawing/2014/main" id="{EEB9EFBE-5365-4E56-B288-A11F8E2E1626}"/>
               </a:ext>
             </a:extLst>
           </p:cNvPr>
@@ -14517,7 +14532,7 @@
           <p:cNvPr id="15" name="">
             <a:extLst xmlns:a="http://schemas.openxmlformats.org/drawingml/2006/main">
               <a:ext uri="{FF2B5EF4-FFF2-40B4-BE49-F238E27FC236}">
-                <a16:creationId xmlns:a16="http://schemas.microsoft.com/office/drawing/2014/main" id="{1DAA8356-C3A7-42B5-A4A8-CEBAB22FBB97}"/>
+                <a16:creationId xmlns:a16="http://schemas.microsoft.com/office/drawing/2014/main" id="{AC0D2222-EBEF-42BE-92E4-3E4FF9E66A49}"/>
               </a:ext>
             </a:extLst>
           </p:cNvPr>
@@ -14562,7 +14577,7 @@
           <p:cNvPr id="16" name="">
             <a:extLst xmlns:a="http://schemas.openxmlformats.org/drawingml/2006/main">
               <a:ext uri="{FF2B5EF4-FFF2-40B4-BE49-F238E27FC236}">
-                <a16:creationId xmlns:a16="http://schemas.microsoft.com/office/drawing/2014/main" id="{890CA924-CDD8-4E0D-BE62-7BAAFB3AB270}"/>
+                <a16:creationId xmlns:a16="http://schemas.microsoft.com/office/drawing/2014/main" id="{8D717607-9744-488E-B6AB-2D3420BB18E2}"/>
               </a:ext>
             </a:extLst>
           </p:cNvPr>
@@ -14607,7 +14622,7 @@
           <p:cNvPr id="17" name="footer-left">
             <a:extLst xmlns:a="http://schemas.openxmlformats.org/drawingml/2006/main">
               <a:ext uri="{FF2B5EF4-FFF2-40B4-BE49-F238E27FC236}">
-                <a16:creationId xmlns:a16="http://schemas.microsoft.com/office/drawing/2014/main" id="{F3FA3324-B209-4EDA-BABF-9DFC1C93DB91}"/>
+                <a16:creationId xmlns:a16="http://schemas.microsoft.com/office/drawing/2014/main" id="{63AC9DB2-DAB3-4B01-8705-94F3CFBD07FB}"/>
               </a:ext>
             </a:extLst>
           </p:cNvPr>
@@ -14652,7 +14667,7 @@
           <p:cNvPr id="18" name="footer-right">
             <a:extLst xmlns:a="http://schemas.openxmlformats.org/drawingml/2006/main">
               <a:ext uri="{FF2B5EF4-FFF2-40B4-BE49-F238E27FC236}">
-                <a16:creationId xmlns:a16="http://schemas.microsoft.com/office/drawing/2014/main" id="{09BCCA06-EAA8-4A05-BD06-1D5BF9917536}"/>
+                <a16:creationId xmlns:a16="http://schemas.microsoft.com/office/drawing/2014/main" id="{91A30CF9-CBF0-47DF-B44A-D908CABAC884}"/>
               </a:ext>
             </a:extLst>
           </p:cNvPr>
@@ -14695,7 +14710,7 @@
     </p:spTree>
     <p:extLst>
       <p:ext uri="{BB962C8B-B14F-4D97-AF65-F5344CB8AC3E}">
-        <p14:creationId xmlns:p14="http://schemas.microsoft.com/office/powerpoint/2010/main" val="1780067352"/>
+        <p14:creationId xmlns:p14="http://schemas.microsoft.com/office/powerpoint/2010/main" val="2065712235"/>
       </p:ext>
     </p:extLst>
   </p:cSld>
@@ -14719,7 +14734,7 @@
           <p:cNvPr id="1" name="slide-stage">
             <a:extLst xmlns:a="http://schemas.openxmlformats.org/drawingml/2006/main">
               <a:ext uri="{FF2B5EF4-FFF2-40B4-BE49-F238E27FC236}">
-                <a16:creationId xmlns:a16="http://schemas.microsoft.com/office/drawing/2014/main" id="{79B96E3B-C96F-4819-BEC5-FC8D81E5910A}"/>
+                <a16:creationId xmlns:a16="http://schemas.microsoft.com/office/drawing/2014/main" id="{06F7253E-FA2C-4E3A-8EE4-E8DEA18CE21D}"/>
               </a:ext>
             </a:extLst>
           </p:cNvPr>
@@ -14746,7 +14761,7 @@
           <p:cNvPr id="2" name="eyebrow">
             <a:extLst xmlns:a="http://schemas.openxmlformats.org/drawingml/2006/main">
               <a:ext uri="{FF2B5EF4-FFF2-40B4-BE49-F238E27FC236}">
-                <a16:creationId xmlns:a16="http://schemas.microsoft.com/office/drawing/2014/main" id="{63BC36D9-D38E-4C31-A6A9-BA1C0A661E37}"/>
+                <a16:creationId xmlns:a16="http://schemas.microsoft.com/office/drawing/2014/main" id="{C951426C-D3FF-4466-AA31-56EDF559950A}"/>
               </a:ext>
             </a:extLst>
           </p:cNvPr>
@@ -14791,7 +14806,7 @@
           <p:cNvPr id="3" name="slide-title">
             <a:extLst xmlns:a="http://schemas.openxmlformats.org/drawingml/2006/main">
               <a:ext uri="{FF2B5EF4-FFF2-40B4-BE49-F238E27FC236}">
-                <a16:creationId xmlns:a16="http://schemas.microsoft.com/office/drawing/2014/main" id="{11C3F9FF-E133-429F-A3A5-855142DF39C0}"/>
+                <a16:creationId xmlns:a16="http://schemas.microsoft.com/office/drawing/2014/main" id="{8572BE5C-8F29-4D21-8F70-E9EDF0E4032E}"/>
               </a:ext>
             </a:extLst>
           </p:cNvPr>
@@ -14836,7 +14851,7 @@
           <p:cNvPr id="4" name="slide-subtitle">
             <a:extLst xmlns:a="http://schemas.openxmlformats.org/drawingml/2006/main">
               <a:ext uri="{FF2B5EF4-FFF2-40B4-BE49-F238E27FC236}">
-                <a16:creationId xmlns:a16="http://schemas.microsoft.com/office/drawing/2014/main" id="{1DD5EB8C-FCAA-4956-86AA-56172EA30980}"/>
+                <a16:creationId xmlns:a16="http://schemas.microsoft.com/office/drawing/2014/main" id="{515F00C5-2267-41F7-8FFF-F41EE2708384}"/>
               </a:ext>
             </a:extLst>
           </p:cNvPr>
@@ -14881,7 +14896,7 @@
           <p:cNvPr id="5" name="">
             <a:extLst xmlns:a="http://schemas.openxmlformats.org/drawingml/2006/main">
               <a:ext uri="{FF2B5EF4-FFF2-40B4-BE49-F238E27FC236}">
-                <a16:creationId xmlns:a16="http://schemas.microsoft.com/office/drawing/2014/main" id="{1C474785-DBD0-4FD9-B7BD-61D95EC0B266}"/>
+                <a16:creationId xmlns:a16="http://schemas.microsoft.com/office/drawing/2014/main" id="{5A9C3B81-D2F2-4A38-AD4D-30F62B6299B6}"/>
               </a:ext>
             </a:extLst>
           </p:cNvPr>
@@ -14926,7 +14941,7 @@
           <p:cNvPr id="6" name="">
             <a:extLst xmlns:a="http://schemas.openxmlformats.org/drawingml/2006/main">
               <a:ext uri="{FF2B5EF4-FFF2-40B4-BE49-F238E27FC236}">
-                <a16:creationId xmlns:a16="http://schemas.microsoft.com/office/drawing/2014/main" id="{2DF732E8-D5BF-4DA0-BD88-A07ED12B023B}"/>
+                <a16:creationId xmlns:a16="http://schemas.microsoft.com/office/drawing/2014/main" id="{FEEA3BA4-38F6-448D-9F5F-78BE1E6A115C}"/>
               </a:ext>
             </a:extLst>
           </p:cNvPr>
@@ -14971,7 +14986,7 @@
           <p:cNvPr id="7" name="">
             <a:extLst xmlns:a="http://schemas.openxmlformats.org/drawingml/2006/main">
               <a:ext uri="{FF2B5EF4-FFF2-40B4-BE49-F238E27FC236}">
-                <a16:creationId xmlns:a16="http://schemas.microsoft.com/office/drawing/2014/main" id="{18B4ADF1-2539-43A2-A2FA-1ED592F9B652}"/>
+                <a16:creationId xmlns:a16="http://schemas.microsoft.com/office/drawing/2014/main" id="{40F9F6F2-2D64-41B8-9B21-AADCA27D642D}"/>
               </a:ext>
             </a:extLst>
           </p:cNvPr>
@@ -15016,7 +15031,7 @@
           <p:cNvPr id="8" name="">
             <a:extLst xmlns:a="http://schemas.openxmlformats.org/drawingml/2006/main">
               <a:ext uri="{FF2B5EF4-FFF2-40B4-BE49-F238E27FC236}">
-                <a16:creationId xmlns:a16="http://schemas.microsoft.com/office/drawing/2014/main" id="{DCC9CE41-5B4A-48A5-AEA0-D17E18C41096}"/>
+                <a16:creationId xmlns:a16="http://schemas.microsoft.com/office/drawing/2014/main" id="{34629908-AC76-4139-B72E-3D6AACB984D8}"/>
               </a:ext>
             </a:extLst>
           </p:cNvPr>
@@ -15061,7 +15076,7 @@
           <p:cNvPr id="9" name="">
             <a:extLst xmlns:a="http://schemas.openxmlformats.org/drawingml/2006/main">
               <a:ext uri="{FF2B5EF4-FFF2-40B4-BE49-F238E27FC236}">
-                <a16:creationId xmlns:a16="http://schemas.microsoft.com/office/drawing/2014/main" id="{23915A63-A1F1-4EBF-B4F6-25BA808E200E}"/>
+                <a16:creationId xmlns:a16="http://schemas.microsoft.com/office/drawing/2014/main" id="{B907B4F5-0202-48A5-AE87-9CF4B1B3F80E}"/>
               </a:ext>
             </a:extLst>
           </p:cNvPr>
@@ -15106,7 +15121,7 @@
           <p:cNvPr id="10" name="">
             <a:extLst xmlns:a="http://schemas.openxmlformats.org/drawingml/2006/main">
               <a:ext uri="{FF2B5EF4-FFF2-40B4-BE49-F238E27FC236}">
-                <a16:creationId xmlns:a16="http://schemas.microsoft.com/office/drawing/2014/main" id="{9F43F6C8-202E-4758-A2C5-8669E8D05D68}"/>
+                <a16:creationId xmlns:a16="http://schemas.microsoft.com/office/drawing/2014/main" id="{45D89FAF-34C8-4E4D-A794-BA069DED9059}"/>
               </a:ext>
             </a:extLst>
           </p:cNvPr>
@@ -15151,7 +15166,7 @@
           <p:cNvPr id="11" name="">
             <a:extLst xmlns:a="http://schemas.openxmlformats.org/drawingml/2006/main">
               <a:ext uri="{FF2B5EF4-FFF2-40B4-BE49-F238E27FC236}">
-                <a16:creationId xmlns:a16="http://schemas.microsoft.com/office/drawing/2014/main" id="{A18F0A74-B861-4DA6-A8A9-42EAB218F424}"/>
+                <a16:creationId xmlns:a16="http://schemas.microsoft.com/office/drawing/2014/main" id="{38AFE96A-7CB4-42C5-A79B-7B759B7A086E}"/>
               </a:ext>
             </a:extLst>
           </p:cNvPr>
@@ -15186,7 +15201,7 @@
           <p:cNvPr id="12" name="">
             <a:extLst xmlns:a="http://schemas.openxmlformats.org/drawingml/2006/main">
               <a:ext uri="{FF2B5EF4-FFF2-40B4-BE49-F238E27FC236}">
-                <a16:creationId xmlns:a16="http://schemas.microsoft.com/office/drawing/2014/main" id="{1417F107-205C-4FE9-BC38-904F60C2CDDE}"/>
+                <a16:creationId xmlns:a16="http://schemas.microsoft.com/office/drawing/2014/main" id="{0857E012-BA1B-4AB8-9557-F186D635CB10}"/>
               </a:ext>
             </a:extLst>
           </p:cNvPr>
@@ -15221,7 +15236,7 @@
                   <a:srgbClr val="08756F"/>
                 </a:solidFill>
               </a:rPr>
-              <a:t>325 tests passed</a:t>
+              <a:t>326 tests passed</a:t>
             </a:r>
           </a:p>
         </p:txBody>
@@ -15231,7 +15246,7 @@
           <p:cNvPr id="13" name="">
             <a:extLst xmlns:a="http://schemas.openxmlformats.org/drawingml/2006/main">
               <a:ext uri="{FF2B5EF4-FFF2-40B4-BE49-F238E27FC236}">
-                <a16:creationId xmlns:a16="http://schemas.microsoft.com/office/drawing/2014/main" id="{840438BA-8A22-4C4F-AB04-7A92844EB398}"/>
+                <a16:creationId xmlns:a16="http://schemas.microsoft.com/office/drawing/2014/main" id="{FB572BE6-09F5-4102-B50A-DCDD2DE108B5}"/>
               </a:ext>
             </a:extLst>
           </p:cNvPr>
@@ -15266,7 +15281,7 @@
           <p:cNvPr id="14" name="">
             <a:extLst xmlns:a="http://schemas.openxmlformats.org/drawingml/2006/main">
               <a:ext uri="{FF2B5EF4-FFF2-40B4-BE49-F238E27FC236}">
-                <a16:creationId xmlns:a16="http://schemas.microsoft.com/office/drawing/2014/main" id="{AF8455A5-C27E-438D-8E4E-CE55C2BC0998}"/>
+                <a16:creationId xmlns:a16="http://schemas.microsoft.com/office/drawing/2014/main" id="{8233B1F2-BE0A-4C38-B138-BE31528CB37C}"/>
               </a:ext>
             </a:extLst>
           </p:cNvPr>
@@ -15311,7 +15326,7 @@
           <p:cNvPr id="15" name="">
             <a:extLst xmlns:a="http://schemas.openxmlformats.org/drawingml/2006/main">
               <a:ext uri="{FF2B5EF4-FFF2-40B4-BE49-F238E27FC236}">
-                <a16:creationId xmlns:a16="http://schemas.microsoft.com/office/drawing/2014/main" id="{E14C0F80-A329-429C-89D6-0BF81FB5481D}"/>
+                <a16:creationId xmlns:a16="http://schemas.microsoft.com/office/drawing/2014/main" id="{BCDF0E7A-56CE-450E-9271-A1DF0D42DC33}"/>
               </a:ext>
             </a:extLst>
           </p:cNvPr>
@@ -15346,7 +15361,7 @@
           <p:cNvPr id="16" name="">
             <a:extLst xmlns:a="http://schemas.openxmlformats.org/drawingml/2006/main">
               <a:ext uri="{FF2B5EF4-FFF2-40B4-BE49-F238E27FC236}">
-                <a16:creationId xmlns:a16="http://schemas.microsoft.com/office/drawing/2014/main" id="{C4B097AA-407F-4931-911F-FA39AFD1A306}"/>
+                <a16:creationId xmlns:a16="http://schemas.microsoft.com/office/drawing/2014/main" id="{08D5510C-BE75-4452-A005-7A43C24936D1}"/>
               </a:ext>
             </a:extLst>
           </p:cNvPr>
@@ -15391,7 +15406,7 @@
           <p:cNvPr id="17" name="footer-left">
             <a:extLst xmlns:a="http://schemas.openxmlformats.org/drawingml/2006/main">
               <a:ext uri="{FF2B5EF4-FFF2-40B4-BE49-F238E27FC236}">
-                <a16:creationId xmlns:a16="http://schemas.microsoft.com/office/drawing/2014/main" id="{0A9DB1F0-A807-462F-8793-EC2200A3A596}"/>
+                <a16:creationId xmlns:a16="http://schemas.microsoft.com/office/drawing/2014/main" id="{CCEAA19F-D09E-4ABF-9575-AAC476965C8D}"/>
               </a:ext>
             </a:extLst>
           </p:cNvPr>
@@ -15436,7 +15451,7 @@
           <p:cNvPr id="18" name="footer-right">
             <a:extLst xmlns:a="http://schemas.openxmlformats.org/drawingml/2006/main">
               <a:ext uri="{FF2B5EF4-FFF2-40B4-BE49-F238E27FC236}">
-                <a16:creationId xmlns:a16="http://schemas.microsoft.com/office/drawing/2014/main" id="{12525C3C-8FE0-4CF5-A1EA-FE5C152C9D68}"/>
+                <a16:creationId xmlns:a16="http://schemas.microsoft.com/office/drawing/2014/main" id="{0D02E303-6AD2-4458-8C8B-605C8DC163B3}"/>
               </a:ext>
             </a:extLst>
           </p:cNvPr>
@@ -15479,7 +15494,7 @@
     </p:spTree>
     <p:extLst>
       <p:ext uri="{BB962C8B-B14F-4D97-AF65-F5344CB8AC3E}">
-        <p14:creationId xmlns:p14="http://schemas.microsoft.com/office/powerpoint/2010/main" val="1142186583"/>
+        <p14:creationId xmlns:p14="http://schemas.microsoft.com/office/powerpoint/2010/main" val="1554597917"/>
       </p:ext>
     </p:extLst>
   </p:cSld>

</xml_diff>

<commit_message>
Add actionable human factors recommendations
</commit_message>
<xml_diff>
--- a/decks/clinsafer-interview-demo/output/output.pptx
+++ b/decks/clinsafer-interview-demo/output/output.pptx
@@ -2,28 +2,28 @@
 <file path=ppt/presentation.xml><?xml version="1.0" encoding="utf-8"?>
 <p:presentation xmlns:p="http://schemas.openxmlformats.org/presentationml/2006/main">
   <p:sldMasterIdLst>
-    <p:sldMasterId xmlns:r="http://schemas.openxmlformats.org/officeDocument/2006/relationships" id="2147483648" r:id="Rcb8aa4daa9a84e09"/>
+    <p:sldMasterId xmlns:r="http://schemas.openxmlformats.org/officeDocument/2006/relationships" id="2147483648" r:id="R4bc0d80cb12f407e"/>
   </p:sldMasterIdLst>
   <p:notesMasterIdLst>
-    <p:notesMasterId xmlns:r="http://schemas.openxmlformats.org/officeDocument/2006/relationships" r:id="R28cc1c8c586745b5"/>
+    <p:notesMasterId xmlns:r="http://schemas.openxmlformats.org/officeDocument/2006/relationships" r:id="Re9fd2d61b1ad4eb5"/>
   </p:notesMasterIdLst>
   <p:sldIdLst>
-    <p:sldId xmlns:r="http://schemas.openxmlformats.org/officeDocument/2006/relationships" id="256" r:id="Re10616338f664962"/>
-    <p:sldId xmlns:r="http://schemas.openxmlformats.org/officeDocument/2006/relationships" id="257" r:id="R720ae5714ec44058"/>
-    <p:sldId xmlns:r="http://schemas.openxmlformats.org/officeDocument/2006/relationships" id="258" r:id="R271e65d029c644ff"/>
-    <p:sldId xmlns:r="http://schemas.openxmlformats.org/officeDocument/2006/relationships" id="259" r:id="Rf9a099aa9e49494c"/>
-    <p:sldId xmlns:r="http://schemas.openxmlformats.org/officeDocument/2006/relationships" id="260" r:id="R829b60b9fb624447"/>
-    <p:sldId xmlns:r="http://schemas.openxmlformats.org/officeDocument/2006/relationships" id="261" r:id="Rc3aa62206e974559"/>
-    <p:sldId xmlns:r="http://schemas.openxmlformats.org/officeDocument/2006/relationships" id="262" r:id="Rde92e896e00845cb"/>
-    <p:sldId xmlns:r="http://schemas.openxmlformats.org/officeDocument/2006/relationships" id="263" r:id="Rff3607fe3cdc4277"/>
-    <p:sldId xmlns:r="http://schemas.openxmlformats.org/officeDocument/2006/relationships" id="264" r:id="Rd6593f97c4684036"/>
-    <p:sldId xmlns:r="http://schemas.openxmlformats.org/officeDocument/2006/relationships" id="265" r:id="R482d0370a0234855"/>
-    <p:sldId xmlns:r="http://schemas.openxmlformats.org/officeDocument/2006/relationships" id="266" r:id="Ref90e6e57cdc4c4e"/>
-    <p:sldId xmlns:r="http://schemas.openxmlformats.org/officeDocument/2006/relationships" id="267" r:id="Rd3129dd9eddd49a4"/>
-    <p:sldId xmlns:r="http://schemas.openxmlformats.org/officeDocument/2006/relationships" id="268" r:id="Re85dba0074fa496b"/>
-    <p:sldId xmlns:r="http://schemas.openxmlformats.org/officeDocument/2006/relationships" id="269" r:id="R9f65cc107ca54323"/>
-    <p:sldId xmlns:r="http://schemas.openxmlformats.org/officeDocument/2006/relationships" id="270" r:id="R31bc405e80fd4559"/>
-    <p:sldId xmlns:r="http://schemas.openxmlformats.org/officeDocument/2006/relationships" id="271" r:id="Rfb3dc18e4b0a46b4"/>
+    <p:sldId xmlns:r="http://schemas.openxmlformats.org/officeDocument/2006/relationships" id="256" r:id="R864d73f3b3b04e81"/>
+    <p:sldId xmlns:r="http://schemas.openxmlformats.org/officeDocument/2006/relationships" id="257" r:id="R5c17f7115e92445a"/>
+    <p:sldId xmlns:r="http://schemas.openxmlformats.org/officeDocument/2006/relationships" id="258" r:id="Rb465c99fb8a64103"/>
+    <p:sldId xmlns:r="http://schemas.openxmlformats.org/officeDocument/2006/relationships" id="259" r:id="R17508ffef5534ece"/>
+    <p:sldId xmlns:r="http://schemas.openxmlformats.org/officeDocument/2006/relationships" id="260" r:id="Rd27adc1ed37c4b0e"/>
+    <p:sldId xmlns:r="http://schemas.openxmlformats.org/officeDocument/2006/relationships" id="261" r:id="Ra357d4c002e242ec"/>
+    <p:sldId xmlns:r="http://schemas.openxmlformats.org/officeDocument/2006/relationships" id="262" r:id="R5aed199cd2d1483c"/>
+    <p:sldId xmlns:r="http://schemas.openxmlformats.org/officeDocument/2006/relationships" id="263" r:id="R7d5b51cfe8c84bae"/>
+    <p:sldId xmlns:r="http://schemas.openxmlformats.org/officeDocument/2006/relationships" id="264" r:id="Rc7c5416cb9db4d3c"/>
+    <p:sldId xmlns:r="http://schemas.openxmlformats.org/officeDocument/2006/relationships" id="265" r:id="Rd65e4e58bac84074"/>
+    <p:sldId xmlns:r="http://schemas.openxmlformats.org/officeDocument/2006/relationships" id="266" r:id="R0c84b703c7d84283"/>
+    <p:sldId xmlns:r="http://schemas.openxmlformats.org/officeDocument/2006/relationships" id="267" r:id="R3288b4c480774dbd"/>
+    <p:sldId xmlns:r="http://schemas.openxmlformats.org/officeDocument/2006/relationships" id="268" r:id="R1343664df8bd4bbb"/>
+    <p:sldId xmlns:r="http://schemas.openxmlformats.org/officeDocument/2006/relationships" id="269" r:id="R6815e50017954395"/>
+    <p:sldId xmlns:r="http://schemas.openxmlformats.org/officeDocument/2006/relationships" id="270" r:id="R3aa043a5716b4416"/>
+    <p:sldId xmlns:r="http://schemas.openxmlformats.org/officeDocument/2006/relationships" id="271" r:id="R06d9d7e45c5541b8"/>
   </p:sldIdLst>
   <p:sldSz cx="18288000" cy="10287000"/>
   <p:notesSz cx="6858000" cy="9144000"/>
@@ -2051,7 +2051,7 @@
           </a:p>
           <a:p xmlns:a="http://schemas.openxmlformats.org/drawingml/2006/main">
             <a:r>
-              <a:t>- "The page distinguishes patient language, clinical handoff, governance actions, and quality metrics."</a:t>
+              <a:t>- "The page distinguishes patient language, human defense patterns, clinical handoff, governance actions, and quality metrics."</a:t>
             </a:r>
           </a:p>
           <a:p xmlns:a="http://schemas.openxmlformats.org/drawingml/2006/main">
@@ -2239,7 +2239,7 @@
   </p:cSld>
   <p:clrMap bg1="lt1" tx1="dk1" bg2="lt2" tx2="dk2" accent1="accent1" accent2="accent2" accent3="accent3" accent4="accent4" accent5="accent5" accent6="accent6" hlink="hlink" folHlink="folHlink"/>
   <p:sldLayoutIdLst>
-    <p:sldLayoutId xmlns:r="http://schemas.openxmlformats.org/officeDocument/2006/relationships" id="2147483649" r:id="Rc093d12b16ec4288"/>
+    <p:sldLayoutId xmlns:r="http://schemas.openxmlformats.org/officeDocument/2006/relationships" id="2147483649" r:id="Rcb0da33817ee41d7"/>
   </p:sldLayoutIdLst>
   <p:txStyles>
     <p:titleStyle>
@@ -2538,7 +2538,7 @@
           <p:cNvPr id="1" name="cover-stage">
             <a:extLst xmlns:a="http://schemas.openxmlformats.org/drawingml/2006/main">
               <a:ext uri="{FF2B5EF4-FFF2-40B4-BE49-F238E27FC236}">
-                <a16:creationId xmlns:a16="http://schemas.microsoft.com/office/drawing/2014/main" id="{F0F2CF28-888F-4725-97C1-7D479AF149BB}"/>
+                <a16:creationId xmlns:a16="http://schemas.microsoft.com/office/drawing/2014/main" id="{14AC8EB7-3850-40E5-B901-E1255E5843E7}"/>
               </a:ext>
             </a:extLst>
           </p:cNvPr>
@@ -2565,7 +2565,7 @@
           <p:cNvPr id="2" name="">
             <a:extLst xmlns:a="http://schemas.openxmlformats.org/drawingml/2006/main">
               <a:ext uri="{FF2B5EF4-FFF2-40B4-BE49-F238E27FC236}">
-                <a16:creationId xmlns:a16="http://schemas.microsoft.com/office/drawing/2014/main" id="{2013345A-F28A-4D3E-B6FC-EA2885A2E6C7}"/>
+                <a16:creationId xmlns:a16="http://schemas.microsoft.com/office/drawing/2014/main" id="{C8DAA26F-56DD-4F64-AC8C-D353C46EB0CF}"/>
               </a:ext>
             </a:extLst>
           </p:cNvPr>
@@ -2610,7 +2610,7 @@
           <p:cNvPr id="3" name="cover-title">
             <a:extLst xmlns:a="http://schemas.openxmlformats.org/drawingml/2006/main">
               <a:ext uri="{FF2B5EF4-FFF2-40B4-BE49-F238E27FC236}">
-                <a16:creationId xmlns:a16="http://schemas.microsoft.com/office/drawing/2014/main" id="{711B7BA7-CCE5-472C-A79F-83DF05B843C9}"/>
+                <a16:creationId xmlns:a16="http://schemas.microsoft.com/office/drawing/2014/main" id="{4F1F026E-968E-49AB-87B7-74348B535EC4}"/>
               </a:ext>
             </a:extLst>
           </p:cNvPr>
@@ -2655,7 +2655,7 @@
           <p:cNvPr id="4" name="">
             <a:extLst xmlns:a="http://schemas.openxmlformats.org/drawingml/2006/main">
               <a:ext uri="{FF2B5EF4-FFF2-40B4-BE49-F238E27FC236}">
-                <a16:creationId xmlns:a16="http://schemas.microsoft.com/office/drawing/2014/main" id="{7DE86BE8-9D2B-477A-AF6A-3F5A6D13EA9F}"/>
+                <a16:creationId xmlns:a16="http://schemas.microsoft.com/office/drawing/2014/main" id="{F270B925-442A-4E7B-858E-AD7D392CF471}"/>
               </a:ext>
             </a:extLst>
           </p:cNvPr>
@@ -2688,7 +2688,7 @@
           <p:cNvPr id="5" name="">
             <a:extLst xmlns:a="http://schemas.openxmlformats.org/drawingml/2006/main">
               <a:ext uri="{FF2B5EF4-FFF2-40B4-BE49-F238E27FC236}">
-                <a16:creationId xmlns:a16="http://schemas.microsoft.com/office/drawing/2014/main" id="{047E7965-8C97-4668-806F-9EF8DF396FBC}"/>
+                <a16:creationId xmlns:a16="http://schemas.microsoft.com/office/drawing/2014/main" id="{93A59118-C184-4212-BBE8-56A9A4D0A4B6}"/>
               </a:ext>
             </a:extLst>
           </p:cNvPr>
@@ -2733,7 +2733,7 @@
           <p:cNvPr id="6" name="">
             <a:extLst xmlns:a="http://schemas.openxmlformats.org/drawingml/2006/main">
               <a:ext uri="{FF2B5EF4-FFF2-40B4-BE49-F238E27FC236}">
-                <a16:creationId xmlns:a16="http://schemas.microsoft.com/office/drawing/2014/main" id="{238161DD-4776-4D2A-98A6-1D06A88718DF}"/>
+                <a16:creationId xmlns:a16="http://schemas.microsoft.com/office/drawing/2014/main" id="{5F5ACF7D-3B76-41A7-8AB3-529A0BFB16BD}"/>
               </a:ext>
             </a:extLst>
           </p:cNvPr>
@@ -2778,7 +2778,7 @@
           <p:cNvPr id="7" name="">
             <a:extLst xmlns:a="http://schemas.openxmlformats.org/drawingml/2006/main">
               <a:ext uri="{FF2B5EF4-FFF2-40B4-BE49-F238E27FC236}">
-                <a16:creationId xmlns:a16="http://schemas.microsoft.com/office/drawing/2014/main" id="{60D5C140-420D-44C6-A8E0-9436EAB69055}"/>
+                <a16:creationId xmlns:a16="http://schemas.microsoft.com/office/drawing/2014/main" id="{104F46C1-4597-41AC-A0B1-50559F4005AA}"/>
               </a:ext>
             </a:extLst>
           </p:cNvPr>
@@ -2823,7 +2823,7 @@
           <p:cNvPr id="8" name="">
             <a:extLst xmlns:a="http://schemas.openxmlformats.org/drawingml/2006/main">
               <a:ext uri="{FF2B5EF4-FFF2-40B4-BE49-F238E27FC236}">
-                <a16:creationId xmlns:a16="http://schemas.microsoft.com/office/drawing/2014/main" id="{26FBC2C6-FE4D-4914-AD47-7CD9C1CE7D59}"/>
+                <a16:creationId xmlns:a16="http://schemas.microsoft.com/office/drawing/2014/main" id="{BB20620B-0527-4EBD-A193-D3A8E6550006}"/>
               </a:ext>
             </a:extLst>
           </p:cNvPr>
@@ -2858,7 +2858,7 @@
                   <a:srgbClr val="2364AA"/>
                 </a:solidFill>
               </a:rPr>
-              <a:t>326</a:t>
+              <a:t>327</a:t>
             </a:r>
           </a:p>
         </p:txBody>
@@ -2868,7 +2868,7 @@
           <p:cNvPr id="9" name="">
             <a:extLst xmlns:a="http://schemas.openxmlformats.org/drawingml/2006/main">
               <a:ext uri="{FF2B5EF4-FFF2-40B4-BE49-F238E27FC236}">
-                <a16:creationId xmlns:a16="http://schemas.microsoft.com/office/drawing/2014/main" id="{9B8452E7-7648-4EEE-81C3-11FD4265C13D}"/>
+                <a16:creationId xmlns:a16="http://schemas.microsoft.com/office/drawing/2014/main" id="{B5A50761-CAEC-4681-8544-245682E5708C}"/>
               </a:ext>
             </a:extLst>
           </p:cNvPr>
@@ -2913,7 +2913,7 @@
           <p:cNvPr id="10" name="">
             <a:extLst xmlns:a="http://schemas.openxmlformats.org/drawingml/2006/main">
               <a:ext uri="{FF2B5EF4-FFF2-40B4-BE49-F238E27FC236}">
-                <a16:creationId xmlns:a16="http://schemas.microsoft.com/office/drawing/2014/main" id="{69A6EFC6-9790-4CD4-89FC-F2B77F9444AD}"/>
+                <a16:creationId xmlns:a16="http://schemas.microsoft.com/office/drawing/2014/main" id="{7924EDD0-C415-4E88-809A-D253EE084315}"/>
               </a:ext>
             </a:extLst>
           </p:cNvPr>
@@ -2958,7 +2958,7 @@
           <p:cNvPr id="11" name="">
             <a:extLst xmlns:a="http://schemas.openxmlformats.org/drawingml/2006/main">
               <a:ext uri="{FF2B5EF4-FFF2-40B4-BE49-F238E27FC236}">
-                <a16:creationId xmlns:a16="http://schemas.microsoft.com/office/drawing/2014/main" id="{3B6D4CA1-978E-4B06-86D8-BE5D6E908DAB}"/>
+                <a16:creationId xmlns:a16="http://schemas.microsoft.com/office/drawing/2014/main" id="{821B9358-96AF-4E96-83A4-8603DE9C6109}"/>
               </a:ext>
             </a:extLst>
           </p:cNvPr>
@@ -3003,7 +3003,7 @@
           <p:cNvPr id="12" name="">
             <a:extLst xmlns:a="http://schemas.openxmlformats.org/drawingml/2006/main">
               <a:ext uri="{FF2B5EF4-FFF2-40B4-BE49-F238E27FC236}">
-                <a16:creationId xmlns:a16="http://schemas.microsoft.com/office/drawing/2014/main" id="{FE9FE8BE-901B-48FD-8A47-8E9A9BC66DC1}"/>
+                <a16:creationId xmlns:a16="http://schemas.microsoft.com/office/drawing/2014/main" id="{EDED6D34-3B96-4F29-85FF-A4E81E8C8F46}"/>
               </a:ext>
             </a:extLst>
           </p:cNvPr>
@@ -3048,7 +3048,7 @@
           <p:cNvPr id="13" name="">
             <a:extLst xmlns:a="http://schemas.openxmlformats.org/drawingml/2006/main">
               <a:ext uri="{FF2B5EF4-FFF2-40B4-BE49-F238E27FC236}">
-                <a16:creationId xmlns:a16="http://schemas.microsoft.com/office/drawing/2014/main" id="{A9BEF81F-735C-4D59-9B7B-6A7956A3F77E}"/>
+                <a16:creationId xmlns:a16="http://schemas.microsoft.com/office/drawing/2014/main" id="{09790BFF-A044-4BB6-80EE-CE3962B915BA}"/>
               </a:ext>
             </a:extLst>
           </p:cNvPr>
@@ -3091,7 +3091,7 @@
     </p:spTree>
     <p:extLst>
       <p:ext uri="{BB962C8B-B14F-4D97-AF65-F5344CB8AC3E}">
-        <p14:creationId xmlns:p14="http://schemas.microsoft.com/office/powerpoint/2010/main" val="1617455796"/>
+        <p14:creationId xmlns:p14="http://schemas.microsoft.com/office/powerpoint/2010/main" val="824533360"/>
       </p:ext>
     </p:extLst>
   </p:cSld>
@@ -3115,7 +3115,7 @@
           <p:cNvPr id="1" name="slide-stage">
             <a:extLst xmlns:a="http://schemas.openxmlformats.org/drawingml/2006/main">
               <a:ext uri="{FF2B5EF4-FFF2-40B4-BE49-F238E27FC236}">
-                <a16:creationId xmlns:a16="http://schemas.microsoft.com/office/drawing/2014/main" id="{5143A39B-E714-490B-9EFA-7581FC95C1AC}"/>
+                <a16:creationId xmlns:a16="http://schemas.microsoft.com/office/drawing/2014/main" id="{EF7899F1-9090-4373-A0DC-3BA43250B373}"/>
               </a:ext>
             </a:extLst>
           </p:cNvPr>
@@ -3142,7 +3142,7 @@
           <p:cNvPr id="2" name="eyebrow">
             <a:extLst xmlns:a="http://schemas.openxmlformats.org/drawingml/2006/main">
               <a:ext uri="{FF2B5EF4-FFF2-40B4-BE49-F238E27FC236}">
-                <a16:creationId xmlns:a16="http://schemas.microsoft.com/office/drawing/2014/main" id="{EE38496F-B6B1-4C8B-B2AF-D2BB53757621}"/>
+                <a16:creationId xmlns:a16="http://schemas.microsoft.com/office/drawing/2014/main" id="{5730A4F5-8A14-402D-B609-A3378C9EF170}"/>
               </a:ext>
             </a:extLst>
           </p:cNvPr>
@@ -3187,7 +3187,7 @@
           <p:cNvPr id="3" name="slide-title">
             <a:extLst xmlns:a="http://schemas.openxmlformats.org/drawingml/2006/main">
               <a:ext uri="{FF2B5EF4-FFF2-40B4-BE49-F238E27FC236}">
-                <a16:creationId xmlns:a16="http://schemas.microsoft.com/office/drawing/2014/main" id="{AB887D9B-A47D-4989-BF1E-5000F08AC96B}"/>
+                <a16:creationId xmlns:a16="http://schemas.microsoft.com/office/drawing/2014/main" id="{5712A5C2-54D8-4B8C-A388-30FCF1BC9AF2}"/>
               </a:ext>
             </a:extLst>
           </p:cNvPr>
@@ -3232,7 +3232,7 @@
           <p:cNvPr id="4" name="slide-subtitle">
             <a:extLst xmlns:a="http://schemas.openxmlformats.org/drawingml/2006/main">
               <a:ext uri="{FF2B5EF4-FFF2-40B4-BE49-F238E27FC236}">
-                <a16:creationId xmlns:a16="http://schemas.microsoft.com/office/drawing/2014/main" id="{A6D0C9CE-6A7C-45C0-9081-655CDAC54158}"/>
+                <a16:creationId xmlns:a16="http://schemas.microsoft.com/office/drawing/2014/main" id="{EAABA4B1-ACE6-4095-B451-A3DDC47D3D6E}"/>
               </a:ext>
             </a:extLst>
           </p:cNvPr>
@@ -3277,7 +3277,7 @@
           <p:cNvPr id="5" name="">
             <a:extLst xmlns:a="http://schemas.openxmlformats.org/drawingml/2006/main">
               <a:ext uri="{FF2B5EF4-FFF2-40B4-BE49-F238E27FC236}">
-                <a16:creationId xmlns:a16="http://schemas.microsoft.com/office/drawing/2014/main" id="{5CB4F571-395F-49A2-A684-30434F4316AA}"/>
+                <a16:creationId xmlns:a16="http://schemas.microsoft.com/office/drawing/2014/main" id="{CFEEA0AF-EE65-49E7-9918-19E87CD4F78D}"/>
               </a:ext>
             </a:extLst>
           </p:cNvPr>
@@ -3310,7 +3310,7 @@
           <p:cNvPr id="6" name="">
             <a:extLst xmlns:a="http://schemas.openxmlformats.org/drawingml/2006/main">
               <a:ext uri="{FF2B5EF4-FFF2-40B4-BE49-F238E27FC236}">
-                <a16:creationId xmlns:a16="http://schemas.microsoft.com/office/drawing/2014/main" id="{4C010B1B-1247-4D40-A515-AE3FA8A5BC96}"/>
+                <a16:creationId xmlns:a16="http://schemas.microsoft.com/office/drawing/2014/main" id="{FC26AE12-285F-489F-8F1A-F8D623727358}"/>
               </a:ext>
             </a:extLst>
           </p:cNvPr>
@@ -3355,7 +3355,7 @@
           <p:cNvPr id="7" name="">
             <a:extLst xmlns:a="http://schemas.openxmlformats.org/drawingml/2006/main">
               <a:ext uri="{FF2B5EF4-FFF2-40B4-BE49-F238E27FC236}">
-                <a16:creationId xmlns:a16="http://schemas.microsoft.com/office/drawing/2014/main" id="{C382E08E-6B18-47C1-8859-74F20048C76C}"/>
+                <a16:creationId xmlns:a16="http://schemas.microsoft.com/office/drawing/2014/main" id="{B7F25132-C49B-4DAF-AC84-2E3376687270}"/>
               </a:ext>
             </a:extLst>
           </p:cNvPr>
@@ -3400,7 +3400,7 @@
           <p:cNvPr id="8" name="">
             <a:extLst xmlns:a="http://schemas.openxmlformats.org/drawingml/2006/main">
               <a:ext uri="{FF2B5EF4-FFF2-40B4-BE49-F238E27FC236}">
-                <a16:creationId xmlns:a16="http://schemas.microsoft.com/office/drawing/2014/main" id="{5FC5877D-8291-4A51-BD32-1EA310656F1B}"/>
+                <a16:creationId xmlns:a16="http://schemas.microsoft.com/office/drawing/2014/main" id="{2F31F6A7-A81B-4F45-9180-55860C44FDE6}"/>
               </a:ext>
             </a:extLst>
           </p:cNvPr>
@@ -3433,7 +3433,7 @@
           <p:cNvPr id="9" name="">
             <a:extLst xmlns:a="http://schemas.openxmlformats.org/drawingml/2006/main">
               <a:ext uri="{FF2B5EF4-FFF2-40B4-BE49-F238E27FC236}">
-                <a16:creationId xmlns:a16="http://schemas.microsoft.com/office/drawing/2014/main" id="{C9B8548B-C6CA-4150-B9B6-5C79C8EB1F57}"/>
+                <a16:creationId xmlns:a16="http://schemas.microsoft.com/office/drawing/2014/main" id="{DBF67F9F-8AB9-455D-8CF1-C11FE0AA25D8}"/>
               </a:ext>
             </a:extLst>
           </p:cNvPr>
@@ -3478,7 +3478,7 @@
           <p:cNvPr id="10" name="">
             <a:extLst xmlns:a="http://schemas.openxmlformats.org/drawingml/2006/main">
               <a:ext uri="{FF2B5EF4-FFF2-40B4-BE49-F238E27FC236}">
-                <a16:creationId xmlns:a16="http://schemas.microsoft.com/office/drawing/2014/main" id="{437A1D0B-8F4F-4779-B834-339DAC0AA857}"/>
+                <a16:creationId xmlns:a16="http://schemas.microsoft.com/office/drawing/2014/main" id="{30C71A61-0F88-4346-A8E1-61A9D51B9DBC}"/>
               </a:ext>
             </a:extLst>
           </p:cNvPr>
@@ -3523,7 +3523,7 @@
           <p:cNvPr id="11" name="">
             <a:extLst xmlns:a="http://schemas.openxmlformats.org/drawingml/2006/main">
               <a:ext uri="{FF2B5EF4-FFF2-40B4-BE49-F238E27FC236}">
-                <a16:creationId xmlns:a16="http://schemas.microsoft.com/office/drawing/2014/main" id="{856DFB29-F11C-4366-8E22-B4C255E427C9}"/>
+                <a16:creationId xmlns:a16="http://schemas.microsoft.com/office/drawing/2014/main" id="{A830778C-0EC7-4339-8C0E-CBEC4165C883}"/>
               </a:ext>
             </a:extLst>
           </p:cNvPr>
@@ -3556,7 +3556,7 @@
           <p:cNvPr id="12" name="">
             <a:extLst xmlns:a="http://schemas.openxmlformats.org/drawingml/2006/main">
               <a:ext uri="{FF2B5EF4-FFF2-40B4-BE49-F238E27FC236}">
-                <a16:creationId xmlns:a16="http://schemas.microsoft.com/office/drawing/2014/main" id="{703F22B6-6BB2-40A7-BDF5-EAC624CFE9EF}"/>
+                <a16:creationId xmlns:a16="http://schemas.microsoft.com/office/drawing/2014/main" id="{675E4827-5BDD-45A2-9402-F061177369D6}"/>
               </a:ext>
             </a:extLst>
           </p:cNvPr>
@@ -3601,7 +3601,7 @@
           <p:cNvPr id="13" name="">
             <a:extLst xmlns:a="http://schemas.openxmlformats.org/drawingml/2006/main">
               <a:ext uri="{FF2B5EF4-FFF2-40B4-BE49-F238E27FC236}">
-                <a16:creationId xmlns:a16="http://schemas.microsoft.com/office/drawing/2014/main" id="{B9C92153-E04C-4B98-B18A-9D0E0A4A3AA1}"/>
+                <a16:creationId xmlns:a16="http://schemas.microsoft.com/office/drawing/2014/main" id="{867D42C6-0267-415C-8B73-75ABEA95F059}"/>
               </a:ext>
             </a:extLst>
           </p:cNvPr>
@@ -3646,7 +3646,7 @@
           <p:cNvPr id="14" name="">
             <a:extLst xmlns:a="http://schemas.openxmlformats.org/drawingml/2006/main">
               <a:ext uri="{FF2B5EF4-FFF2-40B4-BE49-F238E27FC236}">
-                <a16:creationId xmlns:a16="http://schemas.microsoft.com/office/drawing/2014/main" id="{3E586CEC-0D68-48AC-B5B3-1ECC3F6A0F52}"/>
+                <a16:creationId xmlns:a16="http://schemas.microsoft.com/office/drawing/2014/main" id="{638EB992-C641-46FA-833D-922277D8FD41}"/>
               </a:ext>
             </a:extLst>
           </p:cNvPr>
@@ -3679,7 +3679,7 @@
           <p:cNvPr id="15" name="">
             <a:extLst xmlns:a="http://schemas.openxmlformats.org/drawingml/2006/main">
               <a:ext uri="{FF2B5EF4-FFF2-40B4-BE49-F238E27FC236}">
-                <a16:creationId xmlns:a16="http://schemas.microsoft.com/office/drawing/2014/main" id="{5B53CACE-BEE7-4159-A22C-5387582C4A33}"/>
+                <a16:creationId xmlns:a16="http://schemas.microsoft.com/office/drawing/2014/main" id="{0FE9438A-6FD4-418A-9595-B8640EA892BE}"/>
               </a:ext>
             </a:extLst>
           </p:cNvPr>
@@ -3724,7 +3724,7 @@
           <p:cNvPr id="16" name="">
             <a:extLst xmlns:a="http://schemas.openxmlformats.org/drawingml/2006/main">
               <a:ext uri="{FF2B5EF4-FFF2-40B4-BE49-F238E27FC236}">
-                <a16:creationId xmlns:a16="http://schemas.microsoft.com/office/drawing/2014/main" id="{3496BB69-EF55-4E64-9C91-E847D88DA804}"/>
+                <a16:creationId xmlns:a16="http://schemas.microsoft.com/office/drawing/2014/main" id="{F93BDEC3-F964-4BC4-95DC-745E6D2B0E3A}"/>
               </a:ext>
             </a:extLst>
           </p:cNvPr>
@@ -3769,7 +3769,7 @@
           <p:cNvPr id="17" name="footer-left">
             <a:extLst xmlns:a="http://schemas.openxmlformats.org/drawingml/2006/main">
               <a:ext uri="{FF2B5EF4-FFF2-40B4-BE49-F238E27FC236}">
-                <a16:creationId xmlns:a16="http://schemas.microsoft.com/office/drawing/2014/main" id="{21A9245B-FE53-43CD-9781-7BDF276B5240}"/>
+                <a16:creationId xmlns:a16="http://schemas.microsoft.com/office/drawing/2014/main" id="{BD6157EB-575D-4753-B108-B0E269F67A1A}"/>
               </a:ext>
             </a:extLst>
           </p:cNvPr>
@@ -3814,7 +3814,7 @@
           <p:cNvPr id="18" name="footer-right">
             <a:extLst xmlns:a="http://schemas.openxmlformats.org/drawingml/2006/main">
               <a:ext uri="{FF2B5EF4-FFF2-40B4-BE49-F238E27FC236}">
-                <a16:creationId xmlns:a16="http://schemas.microsoft.com/office/drawing/2014/main" id="{37D79F20-7081-4D73-B283-42576E51421A}"/>
+                <a16:creationId xmlns:a16="http://schemas.microsoft.com/office/drawing/2014/main" id="{EAC8606A-CAAD-4ED9-B31E-D00FD2F025A6}"/>
               </a:ext>
             </a:extLst>
           </p:cNvPr>
@@ -3857,7 +3857,7 @@
     </p:spTree>
     <p:extLst>
       <p:ext uri="{BB962C8B-B14F-4D97-AF65-F5344CB8AC3E}">
-        <p14:creationId xmlns:p14="http://schemas.microsoft.com/office/powerpoint/2010/main" val="709549595"/>
+        <p14:creationId xmlns:p14="http://schemas.microsoft.com/office/powerpoint/2010/main" val="1343075394"/>
       </p:ext>
     </p:extLst>
   </p:cSld>
@@ -3881,7 +3881,7 @@
           <p:cNvPr id="1" name="slide-stage">
             <a:extLst xmlns:a="http://schemas.openxmlformats.org/drawingml/2006/main">
               <a:ext uri="{FF2B5EF4-FFF2-40B4-BE49-F238E27FC236}">
-                <a16:creationId xmlns:a16="http://schemas.microsoft.com/office/drawing/2014/main" id="{FE8960AC-BB9B-496C-8ACD-19DF5933D870}"/>
+                <a16:creationId xmlns:a16="http://schemas.microsoft.com/office/drawing/2014/main" id="{951ED921-1849-4B87-A38A-2D500BC42025}"/>
               </a:ext>
             </a:extLst>
           </p:cNvPr>
@@ -3908,7 +3908,7 @@
           <p:cNvPr id="2" name="eyebrow">
             <a:extLst xmlns:a="http://schemas.openxmlformats.org/drawingml/2006/main">
               <a:ext uri="{FF2B5EF4-FFF2-40B4-BE49-F238E27FC236}">
-                <a16:creationId xmlns:a16="http://schemas.microsoft.com/office/drawing/2014/main" id="{039E155A-0667-43F6-A817-5BF71583DE9A}"/>
+                <a16:creationId xmlns:a16="http://schemas.microsoft.com/office/drawing/2014/main" id="{22C239C7-0907-443F-A21D-34F0078B7D5C}"/>
               </a:ext>
             </a:extLst>
           </p:cNvPr>
@@ -3953,7 +3953,7 @@
           <p:cNvPr id="3" name="slide-title">
             <a:extLst xmlns:a="http://schemas.openxmlformats.org/drawingml/2006/main">
               <a:ext uri="{FF2B5EF4-FFF2-40B4-BE49-F238E27FC236}">
-                <a16:creationId xmlns:a16="http://schemas.microsoft.com/office/drawing/2014/main" id="{830417FB-CC56-461C-AF6E-8131D5615ED0}"/>
+                <a16:creationId xmlns:a16="http://schemas.microsoft.com/office/drawing/2014/main" id="{B946F0A3-799E-4EB5-AF4A-E8940FF167AE}"/>
               </a:ext>
             </a:extLst>
           </p:cNvPr>
@@ -3998,7 +3998,7 @@
           <p:cNvPr id="4" name="slide-subtitle">
             <a:extLst xmlns:a="http://schemas.openxmlformats.org/drawingml/2006/main">
               <a:ext uri="{FF2B5EF4-FFF2-40B4-BE49-F238E27FC236}">
-                <a16:creationId xmlns:a16="http://schemas.microsoft.com/office/drawing/2014/main" id="{7766EB9F-4916-4F1A-BCE9-5B13532E9816}"/>
+                <a16:creationId xmlns:a16="http://schemas.microsoft.com/office/drawing/2014/main" id="{5E0132ED-9873-4D3B-8727-3EBCC6D52E10}"/>
               </a:ext>
             </a:extLst>
           </p:cNvPr>
@@ -4043,7 +4043,7 @@
           <p:cNvPr id="5" name="">
             <a:extLst xmlns:a="http://schemas.openxmlformats.org/drawingml/2006/main">
               <a:ext uri="{FF2B5EF4-FFF2-40B4-BE49-F238E27FC236}">
-                <a16:creationId xmlns:a16="http://schemas.microsoft.com/office/drawing/2014/main" id="{436D4077-A60B-4133-BF3C-D3E449BACB62}"/>
+                <a16:creationId xmlns:a16="http://schemas.microsoft.com/office/drawing/2014/main" id="{FB3D69AB-D649-4435-92C5-5D898CBB8BB8}"/>
               </a:ext>
             </a:extLst>
           </p:cNvPr>
@@ -4088,7 +4088,7 @@
           <p:cNvPr id="6" name="">
             <a:extLst xmlns:a="http://schemas.openxmlformats.org/drawingml/2006/main">
               <a:ext uri="{FF2B5EF4-FFF2-40B4-BE49-F238E27FC236}">
-                <a16:creationId xmlns:a16="http://schemas.microsoft.com/office/drawing/2014/main" id="{AA4DD208-27AE-45B4-B922-6F74E30E0D7F}"/>
+                <a16:creationId xmlns:a16="http://schemas.microsoft.com/office/drawing/2014/main" id="{FA75CEBC-27D5-46A0-8464-C7E8C536104B}"/>
               </a:ext>
             </a:extLst>
           </p:cNvPr>
@@ -4133,7 +4133,7 @@
           <p:cNvPr id="7" name="">
             <a:extLst xmlns:a="http://schemas.openxmlformats.org/drawingml/2006/main">
               <a:ext uri="{FF2B5EF4-FFF2-40B4-BE49-F238E27FC236}">
-                <a16:creationId xmlns:a16="http://schemas.microsoft.com/office/drawing/2014/main" id="{8F060599-C520-4752-9F2F-92A78C5E1C0D}"/>
+                <a16:creationId xmlns:a16="http://schemas.microsoft.com/office/drawing/2014/main" id="{0B30071D-8F85-4040-AF87-587CD2F8A052}"/>
               </a:ext>
             </a:extLst>
           </p:cNvPr>
@@ -4178,7 +4178,7 @@
           <p:cNvPr id="8" name="">
             <a:extLst xmlns:a="http://schemas.openxmlformats.org/drawingml/2006/main">
               <a:ext uri="{FF2B5EF4-FFF2-40B4-BE49-F238E27FC236}">
-                <a16:creationId xmlns:a16="http://schemas.microsoft.com/office/drawing/2014/main" id="{D67207D3-49BF-4851-B798-D4FC1FAF4511}"/>
+                <a16:creationId xmlns:a16="http://schemas.microsoft.com/office/drawing/2014/main" id="{ED197D33-DC6C-4B4C-981F-9C3A838AA533}"/>
               </a:ext>
             </a:extLst>
           </p:cNvPr>
@@ -4223,7 +4223,7 @@
           <p:cNvPr id="9" name="">
             <a:extLst xmlns:a="http://schemas.openxmlformats.org/drawingml/2006/main">
               <a:ext uri="{FF2B5EF4-FFF2-40B4-BE49-F238E27FC236}">
-                <a16:creationId xmlns:a16="http://schemas.microsoft.com/office/drawing/2014/main" id="{A6FED429-17A3-482D-AD64-5F77E382B7A6}"/>
+                <a16:creationId xmlns:a16="http://schemas.microsoft.com/office/drawing/2014/main" id="{FBEF847D-DF28-4B8B-AA7E-95C81E7EECF7}"/>
               </a:ext>
             </a:extLst>
           </p:cNvPr>
@@ -4268,7 +4268,7 @@
           <p:cNvPr id="10" name="">
             <a:extLst xmlns:a="http://schemas.openxmlformats.org/drawingml/2006/main">
               <a:ext uri="{FF2B5EF4-FFF2-40B4-BE49-F238E27FC236}">
-                <a16:creationId xmlns:a16="http://schemas.microsoft.com/office/drawing/2014/main" id="{7E87222A-2D70-43E9-8091-424A89ECD213}"/>
+                <a16:creationId xmlns:a16="http://schemas.microsoft.com/office/drawing/2014/main" id="{4464D895-8377-4C04-B65A-CE48910B2B5F}"/>
               </a:ext>
             </a:extLst>
           </p:cNvPr>
@@ -4313,7 +4313,7 @@
           <p:cNvPr id="11" name="">
             <a:extLst xmlns:a="http://schemas.openxmlformats.org/drawingml/2006/main">
               <a:ext uri="{FF2B5EF4-FFF2-40B4-BE49-F238E27FC236}">
-                <a16:creationId xmlns:a16="http://schemas.microsoft.com/office/drawing/2014/main" id="{98019856-694A-4F93-A112-61A1133655A0}"/>
+                <a16:creationId xmlns:a16="http://schemas.microsoft.com/office/drawing/2014/main" id="{3A07C10E-F5AD-4EF5-B148-19D9E3796788}"/>
               </a:ext>
             </a:extLst>
           </p:cNvPr>
@@ -4358,7 +4358,7 @@
           <p:cNvPr id="12" name="">
             <a:extLst xmlns:a="http://schemas.openxmlformats.org/drawingml/2006/main">
               <a:ext uri="{FF2B5EF4-FFF2-40B4-BE49-F238E27FC236}">
-                <a16:creationId xmlns:a16="http://schemas.microsoft.com/office/drawing/2014/main" id="{BBC54B9C-6A97-4038-9690-4AA4FC39163B}"/>
+                <a16:creationId xmlns:a16="http://schemas.microsoft.com/office/drawing/2014/main" id="{36CFC6E9-DCBD-464D-817D-C870449A834F}"/>
               </a:ext>
             </a:extLst>
           </p:cNvPr>
@@ -4403,7 +4403,7 @@
           <p:cNvPr id="13" name="">
             <a:extLst xmlns:a="http://schemas.openxmlformats.org/drawingml/2006/main">
               <a:ext uri="{FF2B5EF4-FFF2-40B4-BE49-F238E27FC236}">
-                <a16:creationId xmlns:a16="http://schemas.microsoft.com/office/drawing/2014/main" id="{2F4AF55C-F714-4137-9A95-413B6A93F24F}"/>
+                <a16:creationId xmlns:a16="http://schemas.microsoft.com/office/drawing/2014/main" id="{AB883A39-61AF-435C-A776-A7709103BD3E}"/>
               </a:ext>
             </a:extLst>
           </p:cNvPr>
@@ -4448,7 +4448,7 @@
           <p:cNvPr id="14" name="footer-left">
             <a:extLst xmlns:a="http://schemas.openxmlformats.org/drawingml/2006/main">
               <a:ext uri="{FF2B5EF4-FFF2-40B4-BE49-F238E27FC236}">
-                <a16:creationId xmlns:a16="http://schemas.microsoft.com/office/drawing/2014/main" id="{54E8BB2E-9254-4915-AD1A-7CD516F3E1F2}"/>
+                <a16:creationId xmlns:a16="http://schemas.microsoft.com/office/drawing/2014/main" id="{5F91FA6A-3021-4946-9A54-B991145383BE}"/>
               </a:ext>
             </a:extLst>
           </p:cNvPr>
@@ -4493,7 +4493,7 @@
           <p:cNvPr id="15" name="footer-right">
             <a:extLst xmlns:a="http://schemas.openxmlformats.org/drawingml/2006/main">
               <a:ext uri="{FF2B5EF4-FFF2-40B4-BE49-F238E27FC236}">
-                <a16:creationId xmlns:a16="http://schemas.microsoft.com/office/drawing/2014/main" id="{A485179E-D32E-4D4D-953E-A4BCF1D9FD4F}"/>
+                <a16:creationId xmlns:a16="http://schemas.microsoft.com/office/drawing/2014/main" id="{2747D4EB-ED86-40E4-81EB-D7948A621372}"/>
               </a:ext>
             </a:extLst>
           </p:cNvPr>
@@ -4536,7 +4536,7 @@
     </p:spTree>
     <p:extLst>
       <p:ext uri="{BB962C8B-B14F-4D97-AF65-F5344CB8AC3E}">
-        <p14:creationId xmlns:p14="http://schemas.microsoft.com/office/powerpoint/2010/main" val="1202961506"/>
+        <p14:creationId xmlns:p14="http://schemas.microsoft.com/office/powerpoint/2010/main" val="112457966"/>
       </p:ext>
     </p:extLst>
   </p:cSld>
@@ -4560,7 +4560,7 @@
           <p:cNvPr id="1" name="slide-stage">
             <a:extLst xmlns:a="http://schemas.openxmlformats.org/drawingml/2006/main">
               <a:ext uri="{FF2B5EF4-FFF2-40B4-BE49-F238E27FC236}">
-                <a16:creationId xmlns:a16="http://schemas.microsoft.com/office/drawing/2014/main" id="{EA3D8C77-63AC-48EF-9E2C-C844E12436D7}"/>
+                <a16:creationId xmlns:a16="http://schemas.microsoft.com/office/drawing/2014/main" id="{0761F2D3-CD15-4484-B850-E09EA59DBC1D}"/>
               </a:ext>
             </a:extLst>
           </p:cNvPr>
@@ -4587,7 +4587,7 @@
           <p:cNvPr id="2" name="eyebrow">
             <a:extLst xmlns:a="http://schemas.openxmlformats.org/drawingml/2006/main">
               <a:ext uri="{FF2B5EF4-FFF2-40B4-BE49-F238E27FC236}">
-                <a16:creationId xmlns:a16="http://schemas.microsoft.com/office/drawing/2014/main" id="{B04AFB4B-702F-4FFD-BF46-C955DE7315C1}"/>
+                <a16:creationId xmlns:a16="http://schemas.microsoft.com/office/drawing/2014/main" id="{2008484E-792B-4229-AD7F-E8AB5A84723F}"/>
               </a:ext>
             </a:extLst>
           </p:cNvPr>
@@ -4632,7 +4632,7 @@
           <p:cNvPr id="3" name="slide-title">
             <a:extLst xmlns:a="http://schemas.openxmlformats.org/drawingml/2006/main">
               <a:ext uri="{FF2B5EF4-FFF2-40B4-BE49-F238E27FC236}">
-                <a16:creationId xmlns:a16="http://schemas.microsoft.com/office/drawing/2014/main" id="{61D2A955-F944-4B66-9C90-F4B32C12252E}"/>
+                <a16:creationId xmlns:a16="http://schemas.microsoft.com/office/drawing/2014/main" id="{BC8029E6-E22C-401F-91D5-318E42572CA8}"/>
               </a:ext>
             </a:extLst>
           </p:cNvPr>
@@ -4677,7 +4677,7 @@
           <p:cNvPr id="4" name="slide-subtitle">
             <a:extLst xmlns:a="http://schemas.openxmlformats.org/drawingml/2006/main">
               <a:ext uri="{FF2B5EF4-FFF2-40B4-BE49-F238E27FC236}">
-                <a16:creationId xmlns:a16="http://schemas.microsoft.com/office/drawing/2014/main" id="{6B70474D-21B3-4AC3-8F27-7CBEF86CE94F}"/>
+                <a16:creationId xmlns:a16="http://schemas.microsoft.com/office/drawing/2014/main" id="{85E57701-3C60-4997-A49E-13B978CDA989}"/>
               </a:ext>
             </a:extLst>
           </p:cNvPr>
@@ -4722,7 +4722,7 @@
           <p:cNvPr id="5" name="">
             <a:extLst xmlns:a="http://schemas.openxmlformats.org/drawingml/2006/main">
               <a:ext uri="{FF2B5EF4-FFF2-40B4-BE49-F238E27FC236}">
-                <a16:creationId xmlns:a16="http://schemas.microsoft.com/office/drawing/2014/main" id="{0C364BA3-533E-4ACE-A9A1-0E0860F876ED}"/>
+                <a16:creationId xmlns:a16="http://schemas.microsoft.com/office/drawing/2014/main" id="{1706C773-E3F6-4EB2-96A1-381CC7251F5D}"/>
               </a:ext>
             </a:extLst>
           </p:cNvPr>
@@ -4755,7 +4755,7 @@
           <p:cNvPr id="6" name="">
             <a:extLst xmlns:a="http://schemas.openxmlformats.org/drawingml/2006/main">
               <a:ext uri="{FF2B5EF4-FFF2-40B4-BE49-F238E27FC236}">
-                <a16:creationId xmlns:a16="http://schemas.microsoft.com/office/drawing/2014/main" id="{2423C48A-E9A7-465D-B256-750EB5DFA1D2}"/>
+                <a16:creationId xmlns:a16="http://schemas.microsoft.com/office/drawing/2014/main" id="{5E9E8370-65D1-4985-A541-279660AEBA63}"/>
               </a:ext>
             </a:extLst>
           </p:cNvPr>
@@ -4800,7 +4800,7 @@
           <p:cNvPr id="7" name="">
             <a:extLst xmlns:a="http://schemas.openxmlformats.org/drawingml/2006/main">
               <a:ext uri="{FF2B5EF4-FFF2-40B4-BE49-F238E27FC236}">
-                <a16:creationId xmlns:a16="http://schemas.microsoft.com/office/drawing/2014/main" id="{EC474E07-07E5-4F53-BD61-843F135677C5}"/>
+                <a16:creationId xmlns:a16="http://schemas.microsoft.com/office/drawing/2014/main" id="{DF723317-A717-4DB0-AAD8-303D95905EDD}"/>
               </a:ext>
             </a:extLst>
           </p:cNvPr>
@@ -4845,7 +4845,7 @@
           <p:cNvPr id="8" name="">
             <a:extLst xmlns:a="http://schemas.openxmlformats.org/drawingml/2006/main">
               <a:ext uri="{FF2B5EF4-FFF2-40B4-BE49-F238E27FC236}">
-                <a16:creationId xmlns:a16="http://schemas.microsoft.com/office/drawing/2014/main" id="{B78ADC3B-35D9-40F5-AEB5-E27E5E43D0A1}"/>
+                <a16:creationId xmlns:a16="http://schemas.microsoft.com/office/drawing/2014/main" id="{01C68BF0-B7A5-410B-94E4-89A8CA853E80}"/>
               </a:ext>
             </a:extLst>
           </p:cNvPr>
@@ -4878,7 +4878,7 @@
           <p:cNvPr id="9" name="">
             <a:extLst xmlns:a="http://schemas.openxmlformats.org/drawingml/2006/main">
               <a:ext uri="{FF2B5EF4-FFF2-40B4-BE49-F238E27FC236}">
-                <a16:creationId xmlns:a16="http://schemas.microsoft.com/office/drawing/2014/main" id="{39AA781F-D0F4-488A-AC0B-EB7BD5E4360D}"/>
+                <a16:creationId xmlns:a16="http://schemas.microsoft.com/office/drawing/2014/main" id="{04B1F48E-1E60-40ED-94A1-EE653FF4F411}"/>
               </a:ext>
             </a:extLst>
           </p:cNvPr>
@@ -4923,7 +4923,7 @@
           <p:cNvPr id="10" name="">
             <a:extLst xmlns:a="http://schemas.openxmlformats.org/drawingml/2006/main">
               <a:ext uri="{FF2B5EF4-FFF2-40B4-BE49-F238E27FC236}">
-                <a16:creationId xmlns:a16="http://schemas.microsoft.com/office/drawing/2014/main" id="{46B677EC-766D-4F68-A146-7535A05F3725}"/>
+                <a16:creationId xmlns:a16="http://schemas.microsoft.com/office/drawing/2014/main" id="{B3897F9A-327A-42CB-809F-AA51D9C9F834}"/>
               </a:ext>
             </a:extLst>
           </p:cNvPr>
@@ -4968,7 +4968,7 @@
           <p:cNvPr id="11" name="">
             <a:extLst xmlns:a="http://schemas.openxmlformats.org/drawingml/2006/main">
               <a:ext uri="{FF2B5EF4-FFF2-40B4-BE49-F238E27FC236}">
-                <a16:creationId xmlns:a16="http://schemas.microsoft.com/office/drawing/2014/main" id="{3102C581-11CF-4BD6-A21E-2783C90AD1E5}"/>
+                <a16:creationId xmlns:a16="http://schemas.microsoft.com/office/drawing/2014/main" id="{4B76D6AE-B4D2-4D83-803C-2D17F38E82B0}"/>
               </a:ext>
             </a:extLst>
           </p:cNvPr>
@@ -5001,7 +5001,7 @@
           <p:cNvPr id="12" name="">
             <a:extLst xmlns:a="http://schemas.openxmlformats.org/drawingml/2006/main">
               <a:ext uri="{FF2B5EF4-FFF2-40B4-BE49-F238E27FC236}">
-                <a16:creationId xmlns:a16="http://schemas.microsoft.com/office/drawing/2014/main" id="{20835C03-E903-4FA3-B9ED-48F864CB443F}"/>
+                <a16:creationId xmlns:a16="http://schemas.microsoft.com/office/drawing/2014/main" id="{8C5C5E69-F911-47C9-8423-DFEB80EFA1C4}"/>
               </a:ext>
             </a:extLst>
           </p:cNvPr>
@@ -5046,7 +5046,7 @@
           <p:cNvPr id="13" name="">
             <a:extLst xmlns:a="http://schemas.openxmlformats.org/drawingml/2006/main">
               <a:ext uri="{FF2B5EF4-FFF2-40B4-BE49-F238E27FC236}">
-                <a16:creationId xmlns:a16="http://schemas.microsoft.com/office/drawing/2014/main" id="{8BC56F93-6490-449D-AF42-74002FD23FDE}"/>
+                <a16:creationId xmlns:a16="http://schemas.microsoft.com/office/drawing/2014/main" id="{E00F4CDF-CCE3-43E2-966F-0C392D442C51}"/>
               </a:ext>
             </a:extLst>
           </p:cNvPr>
@@ -5091,7 +5091,7 @@
           <p:cNvPr id="14" name="">
             <a:extLst xmlns:a="http://schemas.openxmlformats.org/drawingml/2006/main">
               <a:ext uri="{FF2B5EF4-FFF2-40B4-BE49-F238E27FC236}">
-                <a16:creationId xmlns:a16="http://schemas.microsoft.com/office/drawing/2014/main" id="{78A34909-4580-4DEC-A76E-43E1EEFDD75E}"/>
+                <a16:creationId xmlns:a16="http://schemas.microsoft.com/office/drawing/2014/main" id="{AE204F23-2347-4999-88DF-F90393BA23F9}"/>
               </a:ext>
             </a:extLst>
           </p:cNvPr>
@@ -5124,7 +5124,7 @@
           <p:cNvPr id="15" name="">
             <a:extLst xmlns:a="http://schemas.openxmlformats.org/drawingml/2006/main">
               <a:ext uri="{FF2B5EF4-FFF2-40B4-BE49-F238E27FC236}">
-                <a16:creationId xmlns:a16="http://schemas.microsoft.com/office/drawing/2014/main" id="{45E42E8F-3335-4A9D-ADE7-C6BB2BE471F2}"/>
+                <a16:creationId xmlns:a16="http://schemas.microsoft.com/office/drawing/2014/main" id="{A579C634-F967-4635-BA3C-DC33760954F9}"/>
               </a:ext>
             </a:extLst>
           </p:cNvPr>
@@ -5169,7 +5169,7 @@
           <p:cNvPr id="16" name="">
             <a:extLst xmlns:a="http://schemas.openxmlformats.org/drawingml/2006/main">
               <a:ext uri="{FF2B5EF4-FFF2-40B4-BE49-F238E27FC236}">
-                <a16:creationId xmlns:a16="http://schemas.microsoft.com/office/drawing/2014/main" id="{3F43FF2A-2931-4F91-BAE2-2C82F245F44F}"/>
+                <a16:creationId xmlns:a16="http://schemas.microsoft.com/office/drawing/2014/main" id="{2AAEEB3C-117A-4188-A146-19139F6A3665}"/>
               </a:ext>
             </a:extLst>
           </p:cNvPr>
@@ -5214,7 +5214,7 @@
           <p:cNvPr id="17" name="">
             <a:extLst xmlns:a="http://schemas.openxmlformats.org/drawingml/2006/main">
               <a:ext uri="{FF2B5EF4-FFF2-40B4-BE49-F238E27FC236}">
-                <a16:creationId xmlns:a16="http://schemas.microsoft.com/office/drawing/2014/main" id="{6F86BD71-4D54-426A-A11A-2B7C2F1C5BFD}"/>
+                <a16:creationId xmlns:a16="http://schemas.microsoft.com/office/drawing/2014/main" id="{2D755EDB-8F5B-49D4-9ED3-BC8B125EAF07}"/>
               </a:ext>
             </a:extLst>
           </p:cNvPr>
@@ -5247,7 +5247,7 @@
           <p:cNvPr id="18" name="">
             <a:extLst xmlns:a="http://schemas.openxmlformats.org/drawingml/2006/main">
               <a:ext uri="{FF2B5EF4-FFF2-40B4-BE49-F238E27FC236}">
-                <a16:creationId xmlns:a16="http://schemas.microsoft.com/office/drawing/2014/main" id="{A02BE156-92F6-47E2-A571-108CFF64D169}"/>
+                <a16:creationId xmlns:a16="http://schemas.microsoft.com/office/drawing/2014/main" id="{7735ED81-2A7A-4101-8F6A-AA1FB7FD9AC7}"/>
               </a:ext>
             </a:extLst>
           </p:cNvPr>
@@ -5292,7 +5292,7 @@
           <p:cNvPr id="19" name="">
             <a:extLst xmlns:a="http://schemas.openxmlformats.org/drawingml/2006/main">
               <a:ext uri="{FF2B5EF4-FFF2-40B4-BE49-F238E27FC236}">
-                <a16:creationId xmlns:a16="http://schemas.microsoft.com/office/drawing/2014/main" id="{7AC47501-F151-41DC-BDB7-8EAC4919673D}"/>
+                <a16:creationId xmlns:a16="http://schemas.microsoft.com/office/drawing/2014/main" id="{CC15D670-3BAD-47B4-B59B-4AE2EE332190}"/>
               </a:ext>
             </a:extLst>
           </p:cNvPr>
@@ -5337,7 +5337,7 @@
           <p:cNvPr id="20" name="">
             <a:extLst xmlns:a="http://schemas.openxmlformats.org/drawingml/2006/main">
               <a:ext uri="{FF2B5EF4-FFF2-40B4-BE49-F238E27FC236}">
-                <a16:creationId xmlns:a16="http://schemas.microsoft.com/office/drawing/2014/main" id="{2E286EF0-C5C9-4813-A621-F36110E05B16}"/>
+                <a16:creationId xmlns:a16="http://schemas.microsoft.com/office/drawing/2014/main" id="{7CE83A74-5714-41ED-BAB0-7EE2D0ECEE34}"/>
               </a:ext>
             </a:extLst>
           </p:cNvPr>
@@ -5370,7 +5370,7 @@
           <p:cNvPr id="21" name="">
             <a:extLst xmlns:a="http://schemas.openxmlformats.org/drawingml/2006/main">
               <a:ext uri="{FF2B5EF4-FFF2-40B4-BE49-F238E27FC236}">
-                <a16:creationId xmlns:a16="http://schemas.microsoft.com/office/drawing/2014/main" id="{58331C7B-907D-4628-806E-306D1644E17B}"/>
+                <a16:creationId xmlns:a16="http://schemas.microsoft.com/office/drawing/2014/main" id="{6EC8B2DE-CD06-4D04-8C24-8ADC8092816D}"/>
               </a:ext>
             </a:extLst>
           </p:cNvPr>
@@ -5415,7 +5415,7 @@
           <p:cNvPr id="22" name="">
             <a:extLst xmlns:a="http://schemas.openxmlformats.org/drawingml/2006/main">
               <a:ext uri="{FF2B5EF4-FFF2-40B4-BE49-F238E27FC236}">
-                <a16:creationId xmlns:a16="http://schemas.microsoft.com/office/drawing/2014/main" id="{10A13B76-B172-4977-8129-891B4059BDB1}"/>
+                <a16:creationId xmlns:a16="http://schemas.microsoft.com/office/drawing/2014/main" id="{53FF4919-6D22-4864-9D33-FD4F5804FF05}"/>
               </a:ext>
             </a:extLst>
           </p:cNvPr>
@@ -5460,7 +5460,7 @@
           <p:cNvPr id="23" name="footer-left">
             <a:extLst xmlns:a="http://schemas.openxmlformats.org/drawingml/2006/main">
               <a:ext uri="{FF2B5EF4-FFF2-40B4-BE49-F238E27FC236}">
-                <a16:creationId xmlns:a16="http://schemas.microsoft.com/office/drawing/2014/main" id="{9BDDF1E4-0370-4ECB-85F0-9D35CB2691FC}"/>
+                <a16:creationId xmlns:a16="http://schemas.microsoft.com/office/drawing/2014/main" id="{1F5683A2-1DAE-45EE-8C8E-805124060D8C}"/>
               </a:ext>
             </a:extLst>
           </p:cNvPr>
@@ -5505,7 +5505,7 @@
           <p:cNvPr id="24" name="footer-right">
             <a:extLst xmlns:a="http://schemas.openxmlformats.org/drawingml/2006/main">
               <a:ext uri="{FF2B5EF4-FFF2-40B4-BE49-F238E27FC236}">
-                <a16:creationId xmlns:a16="http://schemas.microsoft.com/office/drawing/2014/main" id="{3881A0B2-00AB-4003-A02C-8CF81A1FCD21}"/>
+                <a16:creationId xmlns:a16="http://schemas.microsoft.com/office/drawing/2014/main" id="{39CD4296-6952-4963-B7FC-A5796CE69505}"/>
               </a:ext>
             </a:extLst>
           </p:cNvPr>
@@ -5548,7 +5548,7 @@
     </p:spTree>
     <p:extLst>
       <p:ext uri="{BB962C8B-B14F-4D97-AF65-F5344CB8AC3E}">
-        <p14:creationId xmlns:p14="http://schemas.microsoft.com/office/powerpoint/2010/main" val="1049155238"/>
+        <p14:creationId xmlns:p14="http://schemas.microsoft.com/office/powerpoint/2010/main" val="317259400"/>
       </p:ext>
     </p:extLst>
   </p:cSld>
@@ -5572,7 +5572,7 @@
           <p:cNvPr id="1" name="slide-stage">
             <a:extLst xmlns:a="http://schemas.openxmlformats.org/drawingml/2006/main">
               <a:ext uri="{FF2B5EF4-FFF2-40B4-BE49-F238E27FC236}">
-                <a16:creationId xmlns:a16="http://schemas.microsoft.com/office/drawing/2014/main" id="{F662B98C-07FF-499C-AF5D-E2503FC1F47B}"/>
+                <a16:creationId xmlns:a16="http://schemas.microsoft.com/office/drawing/2014/main" id="{AE9DEACF-CD77-4FFF-ABB1-F1A8E7F4BFE2}"/>
               </a:ext>
             </a:extLst>
           </p:cNvPr>
@@ -5599,7 +5599,7 @@
           <p:cNvPr id="2" name="eyebrow">
             <a:extLst xmlns:a="http://schemas.openxmlformats.org/drawingml/2006/main">
               <a:ext uri="{FF2B5EF4-FFF2-40B4-BE49-F238E27FC236}">
-                <a16:creationId xmlns:a16="http://schemas.microsoft.com/office/drawing/2014/main" id="{098DD1A8-7AE9-4FA9-8832-F7C8817F41B7}"/>
+                <a16:creationId xmlns:a16="http://schemas.microsoft.com/office/drawing/2014/main" id="{70BF2EFD-E38F-41AF-B88C-BFDFD3EDECBE}"/>
               </a:ext>
             </a:extLst>
           </p:cNvPr>
@@ -5644,7 +5644,7 @@
           <p:cNvPr id="3" name="slide-title">
             <a:extLst xmlns:a="http://schemas.openxmlformats.org/drawingml/2006/main">
               <a:ext uri="{FF2B5EF4-FFF2-40B4-BE49-F238E27FC236}">
-                <a16:creationId xmlns:a16="http://schemas.microsoft.com/office/drawing/2014/main" id="{D22EA0D9-D62C-4CAC-9C26-5F4A1C5D90C0}"/>
+                <a16:creationId xmlns:a16="http://schemas.microsoft.com/office/drawing/2014/main" id="{B5A6BD49-0234-44C2-B400-84EABD8900E1}"/>
               </a:ext>
             </a:extLst>
           </p:cNvPr>
@@ -5689,7 +5689,7 @@
           <p:cNvPr id="4" name="slide-subtitle">
             <a:extLst xmlns:a="http://schemas.openxmlformats.org/drawingml/2006/main">
               <a:ext uri="{FF2B5EF4-FFF2-40B4-BE49-F238E27FC236}">
-                <a16:creationId xmlns:a16="http://schemas.microsoft.com/office/drawing/2014/main" id="{01CB6F49-3922-4E2E-A70D-C0C9CB166FB6}"/>
+                <a16:creationId xmlns:a16="http://schemas.microsoft.com/office/drawing/2014/main" id="{D83F226B-3FEA-41FD-8544-896B7CC164A2}"/>
               </a:ext>
             </a:extLst>
           </p:cNvPr>
@@ -5734,7 +5734,7 @@
           <p:cNvPr id="5" name="">
             <a:extLst xmlns:a="http://schemas.openxmlformats.org/drawingml/2006/main">
               <a:ext uri="{FF2B5EF4-FFF2-40B4-BE49-F238E27FC236}">
-                <a16:creationId xmlns:a16="http://schemas.microsoft.com/office/drawing/2014/main" id="{C6875DDF-24C1-4EBD-A910-0603C3AC3E54}"/>
+                <a16:creationId xmlns:a16="http://schemas.microsoft.com/office/drawing/2014/main" id="{FF3E71D4-D9ED-4579-BF56-5F718A9CEB84}"/>
               </a:ext>
             </a:extLst>
           </p:cNvPr>
@@ -5779,7 +5779,7 @@
           <p:cNvPr id="6" name="">
             <a:extLst xmlns:a="http://schemas.openxmlformats.org/drawingml/2006/main">
               <a:ext uri="{FF2B5EF4-FFF2-40B4-BE49-F238E27FC236}">
-                <a16:creationId xmlns:a16="http://schemas.microsoft.com/office/drawing/2014/main" id="{668904C9-62D2-48C2-B3DF-26509F08C808}"/>
+                <a16:creationId xmlns:a16="http://schemas.microsoft.com/office/drawing/2014/main" id="{186A22D9-1416-4E6C-B0A3-26259766D879}"/>
               </a:ext>
             </a:extLst>
           </p:cNvPr>
@@ -5824,7 +5824,7 @@
           <p:cNvPr id="7" name="">
             <a:extLst xmlns:a="http://schemas.openxmlformats.org/drawingml/2006/main">
               <a:ext uri="{FF2B5EF4-FFF2-40B4-BE49-F238E27FC236}">
-                <a16:creationId xmlns:a16="http://schemas.microsoft.com/office/drawing/2014/main" id="{F36414DA-1BE6-4445-AA59-421D4863E5BE}"/>
+                <a16:creationId xmlns:a16="http://schemas.microsoft.com/office/drawing/2014/main" id="{5280C32B-5329-4D64-AD9E-BB62381DAAA3}"/>
               </a:ext>
             </a:extLst>
           </p:cNvPr>
@@ -5869,7 +5869,7 @@
           <p:cNvPr id="8" name="">
             <a:extLst xmlns:a="http://schemas.openxmlformats.org/drawingml/2006/main">
               <a:ext uri="{FF2B5EF4-FFF2-40B4-BE49-F238E27FC236}">
-                <a16:creationId xmlns:a16="http://schemas.microsoft.com/office/drawing/2014/main" id="{15D23149-E9B9-4011-8C69-2ECF0ED2E89A}"/>
+                <a16:creationId xmlns:a16="http://schemas.microsoft.com/office/drawing/2014/main" id="{E0D794AA-4A1F-4260-9B85-1BD0A9CBB146}"/>
               </a:ext>
             </a:extLst>
           </p:cNvPr>
@@ -5914,7 +5914,7 @@
           <p:cNvPr id="9" name="">
             <a:extLst xmlns:a="http://schemas.openxmlformats.org/drawingml/2006/main">
               <a:ext uri="{FF2B5EF4-FFF2-40B4-BE49-F238E27FC236}">
-                <a16:creationId xmlns:a16="http://schemas.microsoft.com/office/drawing/2014/main" id="{D2D01C1F-951C-4779-8385-2D7AC641C5A1}"/>
+                <a16:creationId xmlns:a16="http://schemas.microsoft.com/office/drawing/2014/main" id="{0200324F-0F43-4A73-9BC9-AD2A94ECABAC}"/>
               </a:ext>
             </a:extLst>
           </p:cNvPr>
@@ -5959,7 +5959,7 @@
           <p:cNvPr id="10" name="">
             <a:extLst xmlns:a="http://schemas.openxmlformats.org/drawingml/2006/main">
               <a:ext uri="{FF2B5EF4-FFF2-40B4-BE49-F238E27FC236}">
-                <a16:creationId xmlns:a16="http://schemas.microsoft.com/office/drawing/2014/main" id="{E592F12F-BD27-42B2-BE60-60136583707B}"/>
+                <a16:creationId xmlns:a16="http://schemas.microsoft.com/office/drawing/2014/main" id="{6F7D7F7D-E637-487E-8113-2C6376BDAF27}"/>
               </a:ext>
             </a:extLst>
           </p:cNvPr>
@@ -6004,7 +6004,7 @@
           <p:cNvPr id="11" name="">
             <a:extLst xmlns:a="http://schemas.openxmlformats.org/drawingml/2006/main">
               <a:ext uri="{FF2B5EF4-FFF2-40B4-BE49-F238E27FC236}">
-                <a16:creationId xmlns:a16="http://schemas.microsoft.com/office/drawing/2014/main" id="{9EC55ABF-0827-4DAB-BE4A-168BA63BCC39}"/>
+                <a16:creationId xmlns:a16="http://schemas.microsoft.com/office/drawing/2014/main" id="{92768B00-7FF8-4A1F-A474-0061DEDC3E2E}"/>
               </a:ext>
             </a:extLst>
           </p:cNvPr>
@@ -6049,7 +6049,7 @@
           <p:cNvPr id="12" name="">
             <a:extLst xmlns:a="http://schemas.openxmlformats.org/drawingml/2006/main">
               <a:ext uri="{FF2B5EF4-FFF2-40B4-BE49-F238E27FC236}">
-                <a16:creationId xmlns:a16="http://schemas.microsoft.com/office/drawing/2014/main" id="{5E518626-F152-46C4-B21F-6F7E587DDB0F}"/>
+                <a16:creationId xmlns:a16="http://schemas.microsoft.com/office/drawing/2014/main" id="{E1050992-8AAA-4A97-8BA4-15C20780DCC9}"/>
               </a:ext>
             </a:extLst>
           </p:cNvPr>
@@ -6094,7 +6094,7 @@
           <p:cNvPr id="13" name="">
             <a:extLst xmlns:a="http://schemas.openxmlformats.org/drawingml/2006/main">
               <a:ext uri="{FF2B5EF4-FFF2-40B4-BE49-F238E27FC236}">
-                <a16:creationId xmlns:a16="http://schemas.microsoft.com/office/drawing/2014/main" id="{ADA67071-873E-4E91-90A3-E552DADF9C2D}"/>
+                <a16:creationId xmlns:a16="http://schemas.microsoft.com/office/drawing/2014/main" id="{83C670FF-FC77-48FF-86EE-8D7333E317B5}"/>
               </a:ext>
             </a:extLst>
           </p:cNvPr>
@@ -6139,7 +6139,7 @@
           <p:cNvPr id="14" name="">
             <a:extLst xmlns:a="http://schemas.openxmlformats.org/drawingml/2006/main">
               <a:ext uri="{FF2B5EF4-FFF2-40B4-BE49-F238E27FC236}">
-                <a16:creationId xmlns:a16="http://schemas.microsoft.com/office/drawing/2014/main" id="{06BD8D35-DED2-43D6-B03A-43B4A842DD4D}"/>
+                <a16:creationId xmlns:a16="http://schemas.microsoft.com/office/drawing/2014/main" id="{64473721-6D1A-41D6-8ABE-A52EA498976C}"/>
               </a:ext>
             </a:extLst>
           </p:cNvPr>
@@ -6184,7 +6184,7 @@
           <p:cNvPr id="15" name="footer-left">
             <a:extLst xmlns:a="http://schemas.openxmlformats.org/drawingml/2006/main">
               <a:ext uri="{FF2B5EF4-FFF2-40B4-BE49-F238E27FC236}">
-                <a16:creationId xmlns:a16="http://schemas.microsoft.com/office/drawing/2014/main" id="{BA701B02-EF0D-4923-833A-D90EF20BC058}"/>
+                <a16:creationId xmlns:a16="http://schemas.microsoft.com/office/drawing/2014/main" id="{A4629BC8-534D-417B-98D2-7B1A5E47E9C9}"/>
               </a:ext>
             </a:extLst>
           </p:cNvPr>
@@ -6229,7 +6229,7 @@
           <p:cNvPr id="16" name="footer-right">
             <a:extLst xmlns:a="http://schemas.openxmlformats.org/drawingml/2006/main">
               <a:ext uri="{FF2B5EF4-FFF2-40B4-BE49-F238E27FC236}">
-                <a16:creationId xmlns:a16="http://schemas.microsoft.com/office/drawing/2014/main" id="{0EBE7F0B-C41E-4857-8C74-CA2B6C89D831}"/>
+                <a16:creationId xmlns:a16="http://schemas.microsoft.com/office/drawing/2014/main" id="{C14490F0-47D7-4B89-BD71-854020B34D5D}"/>
               </a:ext>
             </a:extLst>
           </p:cNvPr>
@@ -6272,7 +6272,7 @@
     </p:spTree>
     <p:extLst>
       <p:ext uri="{BB962C8B-B14F-4D97-AF65-F5344CB8AC3E}">
-        <p14:creationId xmlns:p14="http://schemas.microsoft.com/office/powerpoint/2010/main" val="1718503997"/>
+        <p14:creationId xmlns:p14="http://schemas.microsoft.com/office/powerpoint/2010/main" val="174172476"/>
       </p:ext>
     </p:extLst>
   </p:cSld>
@@ -6296,7 +6296,7 @@
           <p:cNvPr id="1" name="slide-stage">
             <a:extLst xmlns:a="http://schemas.openxmlformats.org/drawingml/2006/main">
               <a:ext uri="{FF2B5EF4-FFF2-40B4-BE49-F238E27FC236}">
-                <a16:creationId xmlns:a16="http://schemas.microsoft.com/office/drawing/2014/main" id="{4DF3C3F8-DD4E-4683-B56B-8D60D57FAEB0}"/>
+                <a16:creationId xmlns:a16="http://schemas.microsoft.com/office/drawing/2014/main" id="{A08BC11D-4B66-4127-8975-09D58FEC2242}"/>
               </a:ext>
             </a:extLst>
           </p:cNvPr>
@@ -6323,7 +6323,7 @@
           <p:cNvPr id="2" name="eyebrow">
             <a:extLst xmlns:a="http://schemas.openxmlformats.org/drawingml/2006/main">
               <a:ext uri="{FF2B5EF4-FFF2-40B4-BE49-F238E27FC236}">
-                <a16:creationId xmlns:a16="http://schemas.microsoft.com/office/drawing/2014/main" id="{2B022ECF-CBF8-41C3-9A6A-F99A42D15ACA}"/>
+                <a16:creationId xmlns:a16="http://schemas.microsoft.com/office/drawing/2014/main" id="{A6A4BDB8-8A51-4F44-9071-2A14637156D8}"/>
               </a:ext>
             </a:extLst>
           </p:cNvPr>
@@ -6368,7 +6368,7 @@
           <p:cNvPr id="3" name="slide-title">
             <a:extLst xmlns:a="http://schemas.openxmlformats.org/drawingml/2006/main">
               <a:ext uri="{FF2B5EF4-FFF2-40B4-BE49-F238E27FC236}">
-                <a16:creationId xmlns:a16="http://schemas.microsoft.com/office/drawing/2014/main" id="{29DBBEC3-72A6-4F70-9AFF-C4FE4AC02314}"/>
+                <a16:creationId xmlns:a16="http://schemas.microsoft.com/office/drawing/2014/main" id="{55AA2CEC-40BB-4A1C-AEC1-FC94B093C4C2}"/>
               </a:ext>
             </a:extLst>
           </p:cNvPr>
@@ -6413,7 +6413,7 @@
           <p:cNvPr id="4" name="slide-subtitle">
             <a:extLst xmlns:a="http://schemas.openxmlformats.org/drawingml/2006/main">
               <a:ext uri="{FF2B5EF4-FFF2-40B4-BE49-F238E27FC236}">
-                <a16:creationId xmlns:a16="http://schemas.microsoft.com/office/drawing/2014/main" id="{4392D302-0452-4426-8010-A13A1FA4D606}"/>
+                <a16:creationId xmlns:a16="http://schemas.microsoft.com/office/drawing/2014/main" id="{E9379D81-64A9-40A0-A536-58DC8093DF3B}"/>
               </a:ext>
             </a:extLst>
           </p:cNvPr>
@@ -6458,7 +6458,7 @@
           <p:cNvPr id="5" name="">
             <a:extLst xmlns:a="http://schemas.openxmlformats.org/drawingml/2006/main">
               <a:ext uri="{FF2B5EF4-FFF2-40B4-BE49-F238E27FC236}">
-                <a16:creationId xmlns:a16="http://schemas.microsoft.com/office/drawing/2014/main" id="{B06B9E86-E8BE-4336-A3F4-BF07DA9327D0}"/>
+                <a16:creationId xmlns:a16="http://schemas.microsoft.com/office/drawing/2014/main" id="{DA560C56-2163-4F10-A393-B9185276BF09}"/>
               </a:ext>
             </a:extLst>
           </p:cNvPr>
@@ -6503,7 +6503,7 @@
           <p:cNvPr id="6" name="">
             <a:extLst xmlns:a="http://schemas.openxmlformats.org/drawingml/2006/main">
               <a:ext uri="{FF2B5EF4-FFF2-40B4-BE49-F238E27FC236}">
-                <a16:creationId xmlns:a16="http://schemas.microsoft.com/office/drawing/2014/main" id="{26DBA68B-19A1-4B14-A1B2-E9E23A190C29}"/>
+                <a16:creationId xmlns:a16="http://schemas.microsoft.com/office/drawing/2014/main" id="{CAC11C0B-48E3-40F6-A7EC-7ED486A7D76B}"/>
               </a:ext>
             </a:extLst>
           </p:cNvPr>
@@ -6548,7 +6548,7 @@
           <p:cNvPr id="7" name="">
             <a:extLst xmlns:a="http://schemas.openxmlformats.org/drawingml/2006/main">
               <a:ext uri="{FF2B5EF4-FFF2-40B4-BE49-F238E27FC236}">
-                <a16:creationId xmlns:a16="http://schemas.microsoft.com/office/drawing/2014/main" id="{29704E3A-61DC-4E87-9B6C-279394A81FDF}"/>
+                <a16:creationId xmlns:a16="http://schemas.microsoft.com/office/drawing/2014/main" id="{56DE225F-9D08-409C-91CB-9999537C392F}"/>
               </a:ext>
             </a:extLst>
           </p:cNvPr>
@@ -6593,7 +6593,7 @@
           <p:cNvPr id="8" name="">
             <a:extLst xmlns:a="http://schemas.openxmlformats.org/drawingml/2006/main">
               <a:ext uri="{FF2B5EF4-FFF2-40B4-BE49-F238E27FC236}">
-                <a16:creationId xmlns:a16="http://schemas.microsoft.com/office/drawing/2014/main" id="{C06688CA-3DBE-42A2-9F83-78B932E84141}"/>
+                <a16:creationId xmlns:a16="http://schemas.microsoft.com/office/drawing/2014/main" id="{9A4C461A-4811-44FC-8CE3-DEEFC9C3DF9F}"/>
               </a:ext>
             </a:extLst>
           </p:cNvPr>
@@ -6638,7 +6638,7 @@
           <p:cNvPr id="9" name="">
             <a:extLst xmlns:a="http://schemas.openxmlformats.org/drawingml/2006/main">
               <a:ext uri="{FF2B5EF4-FFF2-40B4-BE49-F238E27FC236}">
-                <a16:creationId xmlns:a16="http://schemas.microsoft.com/office/drawing/2014/main" id="{136C7B3E-4FF8-4CC2-BD48-9ECE43119A80}"/>
+                <a16:creationId xmlns:a16="http://schemas.microsoft.com/office/drawing/2014/main" id="{139802E4-0373-4A55-8F11-904A0616A4B4}"/>
               </a:ext>
             </a:extLst>
           </p:cNvPr>
@@ -6683,7 +6683,7 @@
           <p:cNvPr id="10" name="">
             <a:extLst xmlns:a="http://schemas.openxmlformats.org/drawingml/2006/main">
               <a:ext uri="{FF2B5EF4-FFF2-40B4-BE49-F238E27FC236}">
-                <a16:creationId xmlns:a16="http://schemas.microsoft.com/office/drawing/2014/main" id="{11AB03F1-FCCF-4CE1-8560-16B6877FE87D}"/>
+                <a16:creationId xmlns:a16="http://schemas.microsoft.com/office/drawing/2014/main" id="{CE80D8F4-559A-4439-9EEA-CF7C886C2D86}"/>
               </a:ext>
             </a:extLst>
           </p:cNvPr>
@@ -6728,7 +6728,7 @@
           <p:cNvPr id="11" name="">
             <a:extLst xmlns:a="http://schemas.openxmlformats.org/drawingml/2006/main">
               <a:ext uri="{FF2B5EF4-FFF2-40B4-BE49-F238E27FC236}">
-                <a16:creationId xmlns:a16="http://schemas.microsoft.com/office/drawing/2014/main" id="{C5F20469-751B-430E-B20E-02AB179B3FD3}"/>
+                <a16:creationId xmlns:a16="http://schemas.microsoft.com/office/drawing/2014/main" id="{590AC83C-6352-472A-95DE-313B5E7212CF}"/>
               </a:ext>
             </a:extLst>
           </p:cNvPr>
@@ -6773,7 +6773,7 @@
           <p:cNvPr id="12" name="">
             <a:extLst xmlns:a="http://schemas.openxmlformats.org/drawingml/2006/main">
               <a:ext uri="{FF2B5EF4-FFF2-40B4-BE49-F238E27FC236}">
-                <a16:creationId xmlns:a16="http://schemas.microsoft.com/office/drawing/2014/main" id="{E29BF6A0-7B13-43D2-8EAD-71FB8AFBE653}"/>
+                <a16:creationId xmlns:a16="http://schemas.microsoft.com/office/drawing/2014/main" id="{29700DD6-936A-46F2-A2B5-07035B900B19}"/>
               </a:ext>
             </a:extLst>
           </p:cNvPr>
@@ -6818,7 +6818,7 @@
           <p:cNvPr id="13" name="">
             <a:extLst xmlns:a="http://schemas.openxmlformats.org/drawingml/2006/main">
               <a:ext uri="{FF2B5EF4-FFF2-40B4-BE49-F238E27FC236}">
-                <a16:creationId xmlns:a16="http://schemas.microsoft.com/office/drawing/2014/main" id="{43A12681-BBAA-47D6-98EC-E3935C8BF36C}"/>
+                <a16:creationId xmlns:a16="http://schemas.microsoft.com/office/drawing/2014/main" id="{3B020B4D-271E-4F07-8BF4-DBBEA1938B1C}"/>
               </a:ext>
             </a:extLst>
           </p:cNvPr>
@@ -6863,7 +6863,7 @@
           <p:cNvPr id="14" name="">
             <a:extLst xmlns:a="http://schemas.openxmlformats.org/drawingml/2006/main">
               <a:ext uri="{FF2B5EF4-FFF2-40B4-BE49-F238E27FC236}">
-                <a16:creationId xmlns:a16="http://schemas.microsoft.com/office/drawing/2014/main" id="{AE91803C-4695-4146-B215-EB7367797CD9}"/>
+                <a16:creationId xmlns:a16="http://schemas.microsoft.com/office/drawing/2014/main" id="{EBA89BBA-9D29-492D-9001-CDDD9C975A8C}"/>
               </a:ext>
             </a:extLst>
           </p:cNvPr>
@@ -6908,7 +6908,7 @@
           <p:cNvPr id="15" name="footer-left">
             <a:extLst xmlns:a="http://schemas.openxmlformats.org/drawingml/2006/main">
               <a:ext uri="{FF2B5EF4-FFF2-40B4-BE49-F238E27FC236}">
-                <a16:creationId xmlns:a16="http://schemas.microsoft.com/office/drawing/2014/main" id="{68843130-0E2C-4043-A574-CD5D828310E5}"/>
+                <a16:creationId xmlns:a16="http://schemas.microsoft.com/office/drawing/2014/main" id="{0B659C3B-9056-46B1-A310-7CA0BC0CFE0A}"/>
               </a:ext>
             </a:extLst>
           </p:cNvPr>
@@ -6953,7 +6953,7 @@
           <p:cNvPr id="16" name="footer-right">
             <a:extLst xmlns:a="http://schemas.openxmlformats.org/drawingml/2006/main">
               <a:ext uri="{FF2B5EF4-FFF2-40B4-BE49-F238E27FC236}">
-                <a16:creationId xmlns:a16="http://schemas.microsoft.com/office/drawing/2014/main" id="{B048FBD0-9C75-4BEC-A312-A222B31FB08A}"/>
+                <a16:creationId xmlns:a16="http://schemas.microsoft.com/office/drawing/2014/main" id="{897FBC2E-AE3F-4BDA-B8AB-1D20E60D22B3}"/>
               </a:ext>
             </a:extLst>
           </p:cNvPr>
@@ -6996,7 +6996,7 @@
     </p:spTree>
     <p:extLst>
       <p:ext uri="{BB962C8B-B14F-4D97-AF65-F5344CB8AC3E}">
-        <p14:creationId xmlns:p14="http://schemas.microsoft.com/office/powerpoint/2010/main" val="2116197196"/>
+        <p14:creationId xmlns:p14="http://schemas.microsoft.com/office/powerpoint/2010/main" val="734539366"/>
       </p:ext>
     </p:extLst>
   </p:cSld>
@@ -7020,7 +7020,7 @@
           <p:cNvPr id="1" name="slide-stage">
             <a:extLst xmlns:a="http://schemas.openxmlformats.org/drawingml/2006/main">
               <a:ext uri="{FF2B5EF4-FFF2-40B4-BE49-F238E27FC236}">
-                <a16:creationId xmlns:a16="http://schemas.microsoft.com/office/drawing/2014/main" id="{4FC2C2C2-5316-431A-BF3C-6B722F1BC158}"/>
+                <a16:creationId xmlns:a16="http://schemas.microsoft.com/office/drawing/2014/main" id="{07C4852A-A0AC-4897-929B-AEECC7FB87B7}"/>
               </a:ext>
             </a:extLst>
           </p:cNvPr>
@@ -7047,7 +7047,7 @@
           <p:cNvPr id="2" name="eyebrow">
             <a:extLst xmlns:a="http://schemas.openxmlformats.org/drawingml/2006/main">
               <a:ext uri="{FF2B5EF4-FFF2-40B4-BE49-F238E27FC236}">
-                <a16:creationId xmlns:a16="http://schemas.microsoft.com/office/drawing/2014/main" id="{BD79489A-C554-4AC2-8033-BAD6EAF685A8}"/>
+                <a16:creationId xmlns:a16="http://schemas.microsoft.com/office/drawing/2014/main" id="{71CD0B19-4C44-4D2C-A729-8C1AC39BC174}"/>
               </a:ext>
             </a:extLst>
           </p:cNvPr>
@@ -7092,7 +7092,7 @@
           <p:cNvPr id="3" name="slide-title">
             <a:extLst xmlns:a="http://schemas.openxmlformats.org/drawingml/2006/main">
               <a:ext uri="{FF2B5EF4-FFF2-40B4-BE49-F238E27FC236}">
-                <a16:creationId xmlns:a16="http://schemas.microsoft.com/office/drawing/2014/main" id="{76E6D0B7-0BF3-4A99-8A42-2A7910549B79}"/>
+                <a16:creationId xmlns:a16="http://schemas.microsoft.com/office/drawing/2014/main" id="{6093A1F0-643F-40FC-AFEB-154D82D3532D}"/>
               </a:ext>
             </a:extLst>
           </p:cNvPr>
@@ -7137,7 +7137,7 @@
           <p:cNvPr id="4" name="slide-subtitle">
             <a:extLst xmlns:a="http://schemas.openxmlformats.org/drawingml/2006/main">
               <a:ext uri="{FF2B5EF4-FFF2-40B4-BE49-F238E27FC236}">
-                <a16:creationId xmlns:a16="http://schemas.microsoft.com/office/drawing/2014/main" id="{3E7A123E-FE2C-40D7-BCF0-84CDAD1D171C}"/>
+                <a16:creationId xmlns:a16="http://schemas.microsoft.com/office/drawing/2014/main" id="{F0F2878D-3204-4204-8A2C-91889AD74349}"/>
               </a:ext>
             </a:extLst>
           </p:cNvPr>
@@ -7182,7 +7182,7 @@
           <p:cNvPr id="5" name="">
             <a:extLst xmlns:a="http://schemas.openxmlformats.org/drawingml/2006/main">
               <a:ext uri="{FF2B5EF4-FFF2-40B4-BE49-F238E27FC236}">
-                <a16:creationId xmlns:a16="http://schemas.microsoft.com/office/drawing/2014/main" id="{72199349-DA2F-412C-BDA2-05D67437F97F}"/>
+                <a16:creationId xmlns:a16="http://schemas.microsoft.com/office/drawing/2014/main" id="{3285091C-145A-4D79-BE87-E8DD53325978}"/>
               </a:ext>
             </a:extLst>
           </p:cNvPr>
@@ -7215,7 +7215,7 @@
           <p:cNvPr id="6" name="">
             <a:extLst xmlns:a="http://schemas.openxmlformats.org/drawingml/2006/main">
               <a:ext uri="{FF2B5EF4-FFF2-40B4-BE49-F238E27FC236}">
-                <a16:creationId xmlns:a16="http://schemas.microsoft.com/office/drawing/2014/main" id="{E56C233E-FC91-4FF4-8993-A3319D9A0300}"/>
+                <a16:creationId xmlns:a16="http://schemas.microsoft.com/office/drawing/2014/main" id="{8E0DE10D-C756-4A22-839E-174E057FC695}"/>
               </a:ext>
             </a:extLst>
           </p:cNvPr>
@@ -7260,7 +7260,7 @@
           <p:cNvPr id="7" name="">
             <a:extLst xmlns:a="http://schemas.openxmlformats.org/drawingml/2006/main">
               <a:ext uri="{FF2B5EF4-FFF2-40B4-BE49-F238E27FC236}">
-                <a16:creationId xmlns:a16="http://schemas.microsoft.com/office/drawing/2014/main" id="{3D56ED7F-AA95-4855-B1C9-4F6447FDEE19}"/>
+                <a16:creationId xmlns:a16="http://schemas.microsoft.com/office/drawing/2014/main" id="{7E70DCA9-C6A2-4A7E-B571-49B26115998C}"/>
               </a:ext>
             </a:extLst>
           </p:cNvPr>
@@ -7305,7 +7305,7 @@
           <p:cNvPr id="8" name="">
             <a:extLst xmlns:a="http://schemas.openxmlformats.org/drawingml/2006/main">
               <a:ext uri="{FF2B5EF4-FFF2-40B4-BE49-F238E27FC236}">
-                <a16:creationId xmlns:a16="http://schemas.microsoft.com/office/drawing/2014/main" id="{689960C7-D5C9-4D9B-A49B-886FB87A1064}"/>
+                <a16:creationId xmlns:a16="http://schemas.microsoft.com/office/drawing/2014/main" id="{FECF38EE-6989-49A6-8408-7EE591DF10A1}"/>
               </a:ext>
             </a:extLst>
           </p:cNvPr>
@@ -7338,7 +7338,7 @@
           <p:cNvPr id="9" name="">
             <a:extLst xmlns:a="http://schemas.openxmlformats.org/drawingml/2006/main">
               <a:ext uri="{FF2B5EF4-FFF2-40B4-BE49-F238E27FC236}">
-                <a16:creationId xmlns:a16="http://schemas.microsoft.com/office/drawing/2014/main" id="{324920AB-F99B-463E-8B6E-49D9037DD5EB}"/>
+                <a16:creationId xmlns:a16="http://schemas.microsoft.com/office/drawing/2014/main" id="{798BA254-A3E9-4A73-AA9C-4ECB291E91EA}"/>
               </a:ext>
             </a:extLst>
           </p:cNvPr>
@@ -7383,7 +7383,7 @@
           <p:cNvPr id="10" name="">
             <a:extLst xmlns:a="http://schemas.openxmlformats.org/drawingml/2006/main">
               <a:ext uri="{FF2B5EF4-FFF2-40B4-BE49-F238E27FC236}">
-                <a16:creationId xmlns:a16="http://schemas.microsoft.com/office/drawing/2014/main" id="{EE7EC91D-E1F9-4C40-9C15-546D874C4ABF}"/>
+                <a16:creationId xmlns:a16="http://schemas.microsoft.com/office/drawing/2014/main" id="{AA43279D-A44E-4E73-8DBE-8B60B41A6E14}"/>
               </a:ext>
             </a:extLst>
           </p:cNvPr>
@@ -7428,7 +7428,7 @@
           <p:cNvPr id="11" name="">
             <a:extLst xmlns:a="http://schemas.openxmlformats.org/drawingml/2006/main">
               <a:ext uri="{FF2B5EF4-FFF2-40B4-BE49-F238E27FC236}">
-                <a16:creationId xmlns:a16="http://schemas.microsoft.com/office/drawing/2014/main" id="{1C7388F5-7C87-43FA-9AF5-99373C682EA6}"/>
+                <a16:creationId xmlns:a16="http://schemas.microsoft.com/office/drawing/2014/main" id="{E11603C3-2716-4BB8-89C3-772620A0AA4A}"/>
               </a:ext>
             </a:extLst>
           </p:cNvPr>
@@ -7461,7 +7461,7 @@
           <p:cNvPr id="12" name="">
             <a:extLst xmlns:a="http://schemas.openxmlformats.org/drawingml/2006/main">
               <a:ext uri="{FF2B5EF4-FFF2-40B4-BE49-F238E27FC236}">
-                <a16:creationId xmlns:a16="http://schemas.microsoft.com/office/drawing/2014/main" id="{4290E7E4-BA61-4942-BD75-AE063E030A93}"/>
+                <a16:creationId xmlns:a16="http://schemas.microsoft.com/office/drawing/2014/main" id="{ACB146CA-9CF9-4817-9555-5CAFC2441E3C}"/>
               </a:ext>
             </a:extLst>
           </p:cNvPr>
@@ -7506,7 +7506,7 @@
           <p:cNvPr id="13" name="">
             <a:extLst xmlns:a="http://schemas.openxmlformats.org/drawingml/2006/main">
               <a:ext uri="{FF2B5EF4-FFF2-40B4-BE49-F238E27FC236}">
-                <a16:creationId xmlns:a16="http://schemas.microsoft.com/office/drawing/2014/main" id="{18FAB574-3331-4DFD-8255-49DFEE38E202}"/>
+                <a16:creationId xmlns:a16="http://schemas.microsoft.com/office/drawing/2014/main" id="{8649976C-DA0A-4FF7-AE6B-ED721538B538}"/>
               </a:ext>
             </a:extLst>
           </p:cNvPr>
@@ -7551,7 +7551,7 @@
           <p:cNvPr id="14" name="">
             <a:extLst xmlns:a="http://schemas.openxmlformats.org/drawingml/2006/main">
               <a:ext uri="{FF2B5EF4-FFF2-40B4-BE49-F238E27FC236}">
-                <a16:creationId xmlns:a16="http://schemas.microsoft.com/office/drawing/2014/main" id="{F5A9FA3E-6BB6-49C9-B38E-4EE2E416D8A3}"/>
+                <a16:creationId xmlns:a16="http://schemas.microsoft.com/office/drawing/2014/main" id="{53A5A763-9BEE-477A-A0B1-1FCD40F3F621}"/>
               </a:ext>
             </a:extLst>
           </p:cNvPr>
@@ -7584,7 +7584,7 @@
           <p:cNvPr id="15" name="">
             <a:extLst xmlns:a="http://schemas.openxmlformats.org/drawingml/2006/main">
               <a:ext uri="{FF2B5EF4-FFF2-40B4-BE49-F238E27FC236}">
-                <a16:creationId xmlns:a16="http://schemas.microsoft.com/office/drawing/2014/main" id="{B8421F54-D8CD-4AA7-BE49-677808464377}"/>
+                <a16:creationId xmlns:a16="http://schemas.microsoft.com/office/drawing/2014/main" id="{072E3992-4188-4A18-B993-FF18A5BD7D38}"/>
               </a:ext>
             </a:extLst>
           </p:cNvPr>
@@ -7629,7 +7629,7 @@
           <p:cNvPr id="16" name="">
             <a:extLst xmlns:a="http://schemas.openxmlformats.org/drawingml/2006/main">
               <a:ext uri="{FF2B5EF4-FFF2-40B4-BE49-F238E27FC236}">
-                <a16:creationId xmlns:a16="http://schemas.microsoft.com/office/drawing/2014/main" id="{095ADEA0-E326-437B-86BF-E428EBABF5BB}"/>
+                <a16:creationId xmlns:a16="http://schemas.microsoft.com/office/drawing/2014/main" id="{702E69D4-E1A3-48BB-BAA9-15373ED1D862}"/>
               </a:ext>
             </a:extLst>
           </p:cNvPr>
@@ -7674,7 +7674,7 @@
           <p:cNvPr id="17" name="footer-left">
             <a:extLst xmlns:a="http://schemas.openxmlformats.org/drawingml/2006/main">
               <a:ext uri="{FF2B5EF4-FFF2-40B4-BE49-F238E27FC236}">
-                <a16:creationId xmlns:a16="http://schemas.microsoft.com/office/drawing/2014/main" id="{BEA3DF0E-AABC-4506-A076-BFAE5267FB1A}"/>
+                <a16:creationId xmlns:a16="http://schemas.microsoft.com/office/drawing/2014/main" id="{137471FF-62A9-4577-B9C5-03794B00140A}"/>
               </a:ext>
             </a:extLst>
           </p:cNvPr>
@@ -7719,7 +7719,7 @@
           <p:cNvPr id="18" name="footer-right">
             <a:extLst xmlns:a="http://schemas.openxmlformats.org/drawingml/2006/main">
               <a:ext uri="{FF2B5EF4-FFF2-40B4-BE49-F238E27FC236}">
-                <a16:creationId xmlns:a16="http://schemas.microsoft.com/office/drawing/2014/main" id="{7AA84CEF-7609-4D72-A411-CEC7BEE752BC}"/>
+                <a16:creationId xmlns:a16="http://schemas.microsoft.com/office/drawing/2014/main" id="{908EB5DA-21A8-4C68-99C9-C8767B814D1D}"/>
               </a:ext>
             </a:extLst>
           </p:cNvPr>
@@ -7762,7 +7762,7 @@
     </p:spTree>
     <p:extLst>
       <p:ext uri="{BB962C8B-B14F-4D97-AF65-F5344CB8AC3E}">
-        <p14:creationId xmlns:p14="http://schemas.microsoft.com/office/powerpoint/2010/main" val="982166341"/>
+        <p14:creationId xmlns:p14="http://schemas.microsoft.com/office/powerpoint/2010/main" val="1872815003"/>
       </p:ext>
     </p:extLst>
   </p:cSld>
@@ -7786,7 +7786,7 @@
           <p:cNvPr id="1" name="slide-stage">
             <a:extLst xmlns:a="http://schemas.openxmlformats.org/drawingml/2006/main">
               <a:ext uri="{FF2B5EF4-FFF2-40B4-BE49-F238E27FC236}">
-                <a16:creationId xmlns:a16="http://schemas.microsoft.com/office/drawing/2014/main" id="{3EBE45DA-D6CB-4D1A-8C0E-08D883044A3D}"/>
+                <a16:creationId xmlns:a16="http://schemas.microsoft.com/office/drawing/2014/main" id="{FED48E2A-0548-49D8-AAAB-A788632B68A0}"/>
               </a:ext>
             </a:extLst>
           </p:cNvPr>
@@ -7813,7 +7813,7 @@
           <p:cNvPr id="2" name="eyebrow">
             <a:extLst xmlns:a="http://schemas.openxmlformats.org/drawingml/2006/main">
               <a:ext uri="{FF2B5EF4-FFF2-40B4-BE49-F238E27FC236}">
-                <a16:creationId xmlns:a16="http://schemas.microsoft.com/office/drawing/2014/main" id="{89FF46CB-0D57-4CA9-BFBB-6FAD80CDA3DF}"/>
+                <a16:creationId xmlns:a16="http://schemas.microsoft.com/office/drawing/2014/main" id="{BDD2F755-0379-4C63-B0DE-8838401E183A}"/>
               </a:ext>
             </a:extLst>
           </p:cNvPr>
@@ -7858,7 +7858,7 @@
           <p:cNvPr id="3" name="slide-title">
             <a:extLst xmlns:a="http://schemas.openxmlformats.org/drawingml/2006/main">
               <a:ext uri="{FF2B5EF4-FFF2-40B4-BE49-F238E27FC236}">
-                <a16:creationId xmlns:a16="http://schemas.microsoft.com/office/drawing/2014/main" id="{557AAFFC-F47E-4009-941C-F3FFAE6C32EC}"/>
+                <a16:creationId xmlns:a16="http://schemas.microsoft.com/office/drawing/2014/main" id="{9789D6AF-236F-4D61-995E-FD279B0D6457}"/>
               </a:ext>
             </a:extLst>
           </p:cNvPr>
@@ -7903,7 +7903,7 @@
           <p:cNvPr id="4" name="slide-subtitle">
             <a:extLst xmlns:a="http://schemas.openxmlformats.org/drawingml/2006/main">
               <a:ext uri="{FF2B5EF4-FFF2-40B4-BE49-F238E27FC236}">
-                <a16:creationId xmlns:a16="http://schemas.microsoft.com/office/drawing/2014/main" id="{E1CE086F-1B9A-4104-BA13-632F4228BF35}"/>
+                <a16:creationId xmlns:a16="http://schemas.microsoft.com/office/drawing/2014/main" id="{4612BED5-B807-4ECF-8062-E908F0F92347}"/>
               </a:ext>
             </a:extLst>
           </p:cNvPr>
@@ -7948,7 +7948,7 @@
           <p:cNvPr id="5" name="">
             <a:extLst xmlns:a="http://schemas.openxmlformats.org/drawingml/2006/main">
               <a:ext uri="{FF2B5EF4-FFF2-40B4-BE49-F238E27FC236}">
-                <a16:creationId xmlns:a16="http://schemas.microsoft.com/office/drawing/2014/main" id="{10A4AFE0-1A5E-4737-87B1-FA997AC056C1}"/>
+                <a16:creationId xmlns:a16="http://schemas.microsoft.com/office/drawing/2014/main" id="{327AEF15-693C-430A-BBED-8D12CC29C82F}"/>
               </a:ext>
             </a:extLst>
           </p:cNvPr>
@@ -7993,7 +7993,7 @@
           <p:cNvPr id="6" name="">
             <a:extLst xmlns:a="http://schemas.openxmlformats.org/drawingml/2006/main">
               <a:ext uri="{FF2B5EF4-FFF2-40B4-BE49-F238E27FC236}">
-                <a16:creationId xmlns:a16="http://schemas.microsoft.com/office/drawing/2014/main" id="{3D5FFFC3-6FFB-40AE-8148-10F72B07947F}"/>
+                <a16:creationId xmlns:a16="http://schemas.microsoft.com/office/drawing/2014/main" id="{63F2CC6A-74E1-45F3-8F88-867FF1FF8D83}"/>
               </a:ext>
             </a:extLst>
           </p:cNvPr>
@@ -8038,7 +8038,7 @@
           <p:cNvPr id="7" name="">
             <a:extLst xmlns:a="http://schemas.openxmlformats.org/drawingml/2006/main">
               <a:ext uri="{FF2B5EF4-FFF2-40B4-BE49-F238E27FC236}">
-                <a16:creationId xmlns:a16="http://schemas.microsoft.com/office/drawing/2014/main" id="{90DEBB5E-960C-4FE4-81B5-5B94EA4F3135}"/>
+                <a16:creationId xmlns:a16="http://schemas.microsoft.com/office/drawing/2014/main" id="{F18A0F58-1ED2-4874-AC8A-19CB3D928D20}"/>
               </a:ext>
             </a:extLst>
           </p:cNvPr>
@@ -8071,7 +8071,7 @@
           <p:cNvPr id="8" name="">
             <a:extLst xmlns:a="http://schemas.openxmlformats.org/drawingml/2006/main">
               <a:ext uri="{FF2B5EF4-FFF2-40B4-BE49-F238E27FC236}">
-                <a16:creationId xmlns:a16="http://schemas.microsoft.com/office/drawing/2014/main" id="{771D4945-71B6-4C1D-B79A-2132493DFD15}"/>
+                <a16:creationId xmlns:a16="http://schemas.microsoft.com/office/drawing/2014/main" id="{FB424678-7D9A-484D-B7F6-8E5C33ED5658}"/>
               </a:ext>
             </a:extLst>
           </p:cNvPr>
@@ -8116,7 +8116,7 @@
           <p:cNvPr id="9" name="">
             <a:extLst xmlns:a="http://schemas.openxmlformats.org/drawingml/2006/main">
               <a:ext uri="{FF2B5EF4-FFF2-40B4-BE49-F238E27FC236}">
-                <a16:creationId xmlns:a16="http://schemas.microsoft.com/office/drawing/2014/main" id="{4015A38E-4404-4688-874C-1C3CE5D775A9}"/>
+                <a16:creationId xmlns:a16="http://schemas.microsoft.com/office/drawing/2014/main" id="{D2E5195E-CC08-4983-8AEA-21730B39448D}"/>
               </a:ext>
             </a:extLst>
           </p:cNvPr>
@@ -8161,7 +8161,7 @@
           <p:cNvPr id="10" name="">
             <a:extLst xmlns:a="http://schemas.openxmlformats.org/drawingml/2006/main">
               <a:ext uri="{FF2B5EF4-FFF2-40B4-BE49-F238E27FC236}">
-                <a16:creationId xmlns:a16="http://schemas.microsoft.com/office/drawing/2014/main" id="{A1FAEAC7-0EA6-4AD7-92D6-A8742F1C49E0}"/>
+                <a16:creationId xmlns:a16="http://schemas.microsoft.com/office/drawing/2014/main" id="{56387260-50CF-4171-AB2C-1397B9079D1D}"/>
               </a:ext>
             </a:extLst>
           </p:cNvPr>
@@ -8194,7 +8194,7 @@
           <p:cNvPr id="11" name="">
             <a:extLst xmlns:a="http://schemas.openxmlformats.org/drawingml/2006/main">
               <a:ext uri="{FF2B5EF4-FFF2-40B4-BE49-F238E27FC236}">
-                <a16:creationId xmlns:a16="http://schemas.microsoft.com/office/drawing/2014/main" id="{D5783BE4-17DD-4BF1-BE57-9E3BDA2A2FB9}"/>
+                <a16:creationId xmlns:a16="http://schemas.microsoft.com/office/drawing/2014/main" id="{89275F2B-03FE-47B6-AB2C-1FAF7D3FEF29}"/>
               </a:ext>
             </a:extLst>
           </p:cNvPr>
@@ -8239,7 +8239,7 @@
           <p:cNvPr id="12" name="">
             <a:extLst xmlns:a="http://schemas.openxmlformats.org/drawingml/2006/main">
               <a:ext uri="{FF2B5EF4-FFF2-40B4-BE49-F238E27FC236}">
-                <a16:creationId xmlns:a16="http://schemas.microsoft.com/office/drawing/2014/main" id="{70183CC6-0855-4D62-BF3A-02A662282335}"/>
+                <a16:creationId xmlns:a16="http://schemas.microsoft.com/office/drawing/2014/main" id="{AF339CE0-CE25-4D3D-884D-27D286A8F778}"/>
               </a:ext>
             </a:extLst>
           </p:cNvPr>
@@ -8284,7 +8284,7 @@
           <p:cNvPr id="13" name="">
             <a:extLst xmlns:a="http://schemas.openxmlformats.org/drawingml/2006/main">
               <a:ext uri="{FF2B5EF4-FFF2-40B4-BE49-F238E27FC236}">
-                <a16:creationId xmlns:a16="http://schemas.microsoft.com/office/drawing/2014/main" id="{0A0CB241-BA97-4C69-9FD3-3CAD012509F1}"/>
+                <a16:creationId xmlns:a16="http://schemas.microsoft.com/office/drawing/2014/main" id="{B9782206-396F-435D-8220-8F2AB5C18233}"/>
               </a:ext>
             </a:extLst>
           </p:cNvPr>
@@ -8317,7 +8317,7 @@
           <p:cNvPr id="14" name="">
             <a:extLst xmlns:a="http://schemas.openxmlformats.org/drawingml/2006/main">
               <a:ext uri="{FF2B5EF4-FFF2-40B4-BE49-F238E27FC236}">
-                <a16:creationId xmlns:a16="http://schemas.microsoft.com/office/drawing/2014/main" id="{4F76C395-0E16-474D-9061-4F0B994896BB}"/>
+                <a16:creationId xmlns:a16="http://schemas.microsoft.com/office/drawing/2014/main" id="{79FE4D89-8889-4F97-907A-2B7AF93675D6}"/>
               </a:ext>
             </a:extLst>
           </p:cNvPr>
@@ -8362,7 +8362,7 @@
           <p:cNvPr id="15" name="">
             <a:extLst xmlns:a="http://schemas.openxmlformats.org/drawingml/2006/main">
               <a:ext uri="{FF2B5EF4-FFF2-40B4-BE49-F238E27FC236}">
-                <a16:creationId xmlns:a16="http://schemas.microsoft.com/office/drawing/2014/main" id="{A100A91D-616D-4FD0-A09D-2DD30D83AB7D}"/>
+                <a16:creationId xmlns:a16="http://schemas.microsoft.com/office/drawing/2014/main" id="{663CD118-E011-4081-9D02-8781D91F2CEF}"/>
               </a:ext>
             </a:extLst>
           </p:cNvPr>
@@ -8407,7 +8407,7 @@
           <p:cNvPr id="16" name="footer-left">
             <a:extLst xmlns:a="http://schemas.openxmlformats.org/drawingml/2006/main">
               <a:ext uri="{FF2B5EF4-FFF2-40B4-BE49-F238E27FC236}">
-                <a16:creationId xmlns:a16="http://schemas.microsoft.com/office/drawing/2014/main" id="{3BB4E2CE-5EC0-4790-9677-BFEB68DF578C}"/>
+                <a16:creationId xmlns:a16="http://schemas.microsoft.com/office/drawing/2014/main" id="{91A33223-2F0A-45EB-A917-DF6BCDAF1993}"/>
               </a:ext>
             </a:extLst>
           </p:cNvPr>
@@ -8452,7 +8452,7 @@
           <p:cNvPr id="17" name="footer-right">
             <a:extLst xmlns:a="http://schemas.openxmlformats.org/drawingml/2006/main">
               <a:ext uri="{FF2B5EF4-FFF2-40B4-BE49-F238E27FC236}">
-                <a16:creationId xmlns:a16="http://schemas.microsoft.com/office/drawing/2014/main" id="{441DFA8B-5087-45AB-9E20-4E9460967052}"/>
+                <a16:creationId xmlns:a16="http://schemas.microsoft.com/office/drawing/2014/main" id="{10E4B461-1D68-486F-A9DF-5EE5DDD50F6A}"/>
               </a:ext>
             </a:extLst>
           </p:cNvPr>
@@ -8495,7 +8495,7 @@
     </p:spTree>
     <p:extLst>
       <p:ext uri="{BB962C8B-B14F-4D97-AF65-F5344CB8AC3E}">
-        <p14:creationId xmlns:p14="http://schemas.microsoft.com/office/powerpoint/2010/main" val="226307339"/>
+        <p14:creationId xmlns:p14="http://schemas.microsoft.com/office/powerpoint/2010/main" val="2107410240"/>
       </p:ext>
     </p:extLst>
   </p:cSld>
@@ -8519,7 +8519,7 @@
           <p:cNvPr id="1" name="slide-stage">
             <a:extLst xmlns:a="http://schemas.openxmlformats.org/drawingml/2006/main">
               <a:ext uri="{FF2B5EF4-FFF2-40B4-BE49-F238E27FC236}">
-                <a16:creationId xmlns:a16="http://schemas.microsoft.com/office/drawing/2014/main" id="{CEFA1BC0-711B-4975-9AA1-6CB0E30033BB}"/>
+                <a16:creationId xmlns:a16="http://schemas.microsoft.com/office/drawing/2014/main" id="{B1ECF297-6D87-4ECC-9421-1354EEF7F6B1}"/>
               </a:ext>
             </a:extLst>
           </p:cNvPr>
@@ -8546,7 +8546,7 @@
           <p:cNvPr id="2" name="eyebrow">
             <a:extLst xmlns:a="http://schemas.openxmlformats.org/drawingml/2006/main">
               <a:ext uri="{FF2B5EF4-FFF2-40B4-BE49-F238E27FC236}">
-                <a16:creationId xmlns:a16="http://schemas.microsoft.com/office/drawing/2014/main" id="{4FC462A6-B86D-48F3-8310-4245C1075014}"/>
+                <a16:creationId xmlns:a16="http://schemas.microsoft.com/office/drawing/2014/main" id="{D94D63EB-3B70-47F0-ABF1-BE8F2F5263B2}"/>
               </a:ext>
             </a:extLst>
           </p:cNvPr>
@@ -8591,7 +8591,7 @@
           <p:cNvPr id="3" name="slide-title">
             <a:extLst xmlns:a="http://schemas.openxmlformats.org/drawingml/2006/main">
               <a:ext uri="{FF2B5EF4-FFF2-40B4-BE49-F238E27FC236}">
-                <a16:creationId xmlns:a16="http://schemas.microsoft.com/office/drawing/2014/main" id="{499B637D-9820-4991-B8A9-28E3CD7411D5}"/>
+                <a16:creationId xmlns:a16="http://schemas.microsoft.com/office/drawing/2014/main" id="{F460A3A7-E248-4C8A-9701-00FB9FCAEBA7}"/>
               </a:ext>
             </a:extLst>
           </p:cNvPr>
@@ -8636,7 +8636,7 @@
           <p:cNvPr id="4" name="slide-subtitle">
             <a:extLst xmlns:a="http://schemas.openxmlformats.org/drawingml/2006/main">
               <a:ext uri="{FF2B5EF4-FFF2-40B4-BE49-F238E27FC236}">
-                <a16:creationId xmlns:a16="http://schemas.microsoft.com/office/drawing/2014/main" id="{88579BFC-2C04-4CBD-A475-29C77C157E85}"/>
+                <a16:creationId xmlns:a16="http://schemas.microsoft.com/office/drawing/2014/main" id="{082B431D-CC41-4768-B1F8-CEBA1683D2D4}"/>
               </a:ext>
             </a:extLst>
           </p:cNvPr>
@@ -8681,7 +8681,7 @@
           <p:cNvPr id="5" name="">
             <a:extLst xmlns:a="http://schemas.openxmlformats.org/drawingml/2006/main">
               <a:ext uri="{FF2B5EF4-FFF2-40B4-BE49-F238E27FC236}">
-                <a16:creationId xmlns:a16="http://schemas.microsoft.com/office/drawing/2014/main" id="{C4E81ED1-F734-4C14-B71C-C6589D9A4243}"/>
+                <a16:creationId xmlns:a16="http://schemas.microsoft.com/office/drawing/2014/main" id="{14C03157-B7A6-495C-8A0B-D155EC5E1F40}"/>
               </a:ext>
             </a:extLst>
           </p:cNvPr>
@@ -8726,7 +8726,7 @@
           <p:cNvPr id="6" name="">
             <a:extLst xmlns:a="http://schemas.openxmlformats.org/drawingml/2006/main">
               <a:ext uri="{FF2B5EF4-FFF2-40B4-BE49-F238E27FC236}">
-                <a16:creationId xmlns:a16="http://schemas.microsoft.com/office/drawing/2014/main" id="{18C3BCA8-D691-4357-B6C5-C8F5B53700DB}"/>
+                <a16:creationId xmlns:a16="http://schemas.microsoft.com/office/drawing/2014/main" id="{BBAF1CD9-F08B-408F-BB7C-8F31A85D66FA}"/>
               </a:ext>
             </a:extLst>
           </p:cNvPr>
@@ -8771,7 +8771,7 @@
           <p:cNvPr id="7" name="">
             <a:extLst xmlns:a="http://schemas.openxmlformats.org/drawingml/2006/main">
               <a:ext uri="{FF2B5EF4-FFF2-40B4-BE49-F238E27FC236}">
-                <a16:creationId xmlns:a16="http://schemas.microsoft.com/office/drawing/2014/main" id="{051DF28F-AD37-4F9B-A89D-01DBDDF82A5A}"/>
+                <a16:creationId xmlns:a16="http://schemas.microsoft.com/office/drawing/2014/main" id="{48A57F6A-2E9D-46FE-ADF1-B6B0B7C1240F}"/>
               </a:ext>
             </a:extLst>
           </p:cNvPr>
@@ -8816,7 +8816,7 @@
           <p:cNvPr id="8" name="">
             <a:extLst xmlns:a="http://schemas.openxmlformats.org/drawingml/2006/main">
               <a:ext uri="{FF2B5EF4-FFF2-40B4-BE49-F238E27FC236}">
-                <a16:creationId xmlns:a16="http://schemas.microsoft.com/office/drawing/2014/main" id="{B8D21EE0-ED80-46DF-8DB4-A5815D00763C}"/>
+                <a16:creationId xmlns:a16="http://schemas.microsoft.com/office/drawing/2014/main" id="{E3880754-8F4C-42F1-BC5E-321BDBA17CC1}"/>
               </a:ext>
             </a:extLst>
           </p:cNvPr>
@@ -8861,7 +8861,7 @@
           <p:cNvPr id="9" name="">
             <a:extLst xmlns:a="http://schemas.openxmlformats.org/drawingml/2006/main">
               <a:ext uri="{FF2B5EF4-FFF2-40B4-BE49-F238E27FC236}">
-                <a16:creationId xmlns:a16="http://schemas.microsoft.com/office/drawing/2014/main" id="{DCCA8687-B2E3-4306-A686-977B6B909057}"/>
+                <a16:creationId xmlns:a16="http://schemas.microsoft.com/office/drawing/2014/main" id="{A9D8774C-0AEF-49D3-9A07-09460487AC69}"/>
               </a:ext>
             </a:extLst>
           </p:cNvPr>
@@ -8906,7 +8906,7 @@
           <p:cNvPr id="10" name="">
             <a:extLst xmlns:a="http://schemas.openxmlformats.org/drawingml/2006/main">
               <a:ext uri="{FF2B5EF4-FFF2-40B4-BE49-F238E27FC236}">
-                <a16:creationId xmlns:a16="http://schemas.microsoft.com/office/drawing/2014/main" id="{97FFC6D0-0578-44D5-9230-EB209B732044}"/>
+                <a16:creationId xmlns:a16="http://schemas.microsoft.com/office/drawing/2014/main" id="{C4EE3FB1-63E0-42FC-9EF4-AD3967F62777}"/>
               </a:ext>
             </a:extLst>
           </p:cNvPr>
@@ -8951,7 +8951,7 @@
           <p:cNvPr id="11" name="">
             <a:extLst xmlns:a="http://schemas.openxmlformats.org/drawingml/2006/main">
               <a:ext uri="{FF2B5EF4-FFF2-40B4-BE49-F238E27FC236}">
-                <a16:creationId xmlns:a16="http://schemas.microsoft.com/office/drawing/2014/main" id="{C30D783C-D828-4CEC-B544-8803C2DA32DA}"/>
+                <a16:creationId xmlns:a16="http://schemas.microsoft.com/office/drawing/2014/main" id="{1FBDC2E2-F6A5-4FBC-9BE6-E5C7BB6F1D5F}"/>
               </a:ext>
             </a:extLst>
           </p:cNvPr>
@@ -8996,7 +8996,7 @@
           <p:cNvPr id="12" name="">
             <a:extLst xmlns:a="http://schemas.openxmlformats.org/drawingml/2006/main">
               <a:ext uri="{FF2B5EF4-FFF2-40B4-BE49-F238E27FC236}">
-                <a16:creationId xmlns:a16="http://schemas.microsoft.com/office/drawing/2014/main" id="{8C5F5B4A-55B1-4E92-BCE3-834AE2EEAC2C}"/>
+                <a16:creationId xmlns:a16="http://schemas.microsoft.com/office/drawing/2014/main" id="{B68BC440-CEC5-48F3-83AA-6DBE1BE66447}"/>
               </a:ext>
             </a:extLst>
           </p:cNvPr>
@@ -9041,7 +9041,7 @@
           <p:cNvPr id="13" name="footer-left">
             <a:extLst xmlns:a="http://schemas.openxmlformats.org/drawingml/2006/main">
               <a:ext uri="{FF2B5EF4-FFF2-40B4-BE49-F238E27FC236}">
-                <a16:creationId xmlns:a16="http://schemas.microsoft.com/office/drawing/2014/main" id="{B77F142D-9FFB-49F2-BA78-0E9EF4E2577F}"/>
+                <a16:creationId xmlns:a16="http://schemas.microsoft.com/office/drawing/2014/main" id="{21CABDC2-E87E-4E8D-928E-2F0E6841D46A}"/>
               </a:ext>
             </a:extLst>
           </p:cNvPr>
@@ -9086,7 +9086,7 @@
           <p:cNvPr id="14" name="footer-right">
             <a:extLst xmlns:a="http://schemas.openxmlformats.org/drawingml/2006/main">
               <a:ext uri="{FF2B5EF4-FFF2-40B4-BE49-F238E27FC236}">
-                <a16:creationId xmlns:a16="http://schemas.microsoft.com/office/drawing/2014/main" id="{934E18D3-1735-4D90-AF96-028C628F9781}"/>
+                <a16:creationId xmlns:a16="http://schemas.microsoft.com/office/drawing/2014/main" id="{2A757F42-83B7-4E2F-9E88-607FD7D63A2D}"/>
               </a:ext>
             </a:extLst>
           </p:cNvPr>
@@ -9129,7 +9129,7 @@
     </p:spTree>
     <p:extLst>
       <p:ext uri="{BB962C8B-B14F-4D97-AF65-F5344CB8AC3E}">
-        <p14:creationId xmlns:p14="http://schemas.microsoft.com/office/powerpoint/2010/main" val="1306192934"/>
+        <p14:creationId xmlns:p14="http://schemas.microsoft.com/office/powerpoint/2010/main" val="56830750"/>
       </p:ext>
     </p:extLst>
   </p:cSld>
@@ -9153,7 +9153,7 @@
           <p:cNvPr id="1" name="slide-stage">
             <a:extLst xmlns:a="http://schemas.openxmlformats.org/drawingml/2006/main">
               <a:ext uri="{FF2B5EF4-FFF2-40B4-BE49-F238E27FC236}">
-                <a16:creationId xmlns:a16="http://schemas.microsoft.com/office/drawing/2014/main" id="{8FAFBA5B-531C-4115-9055-EC8E76CBE595}"/>
+                <a16:creationId xmlns:a16="http://schemas.microsoft.com/office/drawing/2014/main" id="{E730BA58-FC39-4E2D-91B8-A47C0CE3F25C}"/>
               </a:ext>
             </a:extLst>
           </p:cNvPr>
@@ -9180,7 +9180,7 @@
           <p:cNvPr id="2" name="eyebrow">
             <a:extLst xmlns:a="http://schemas.openxmlformats.org/drawingml/2006/main">
               <a:ext uri="{FF2B5EF4-FFF2-40B4-BE49-F238E27FC236}">
-                <a16:creationId xmlns:a16="http://schemas.microsoft.com/office/drawing/2014/main" id="{DCC3BD30-6EC8-45AC-BAB1-A61BC117F05C}"/>
+                <a16:creationId xmlns:a16="http://schemas.microsoft.com/office/drawing/2014/main" id="{5F672D72-A4F8-41B5-A297-0077583DF73C}"/>
               </a:ext>
             </a:extLst>
           </p:cNvPr>
@@ -9225,7 +9225,7 @@
           <p:cNvPr id="3" name="slide-title">
             <a:extLst xmlns:a="http://schemas.openxmlformats.org/drawingml/2006/main">
               <a:ext uri="{FF2B5EF4-FFF2-40B4-BE49-F238E27FC236}">
-                <a16:creationId xmlns:a16="http://schemas.microsoft.com/office/drawing/2014/main" id="{B703112F-C798-4C7E-9057-3C5D4BCE3374}"/>
+                <a16:creationId xmlns:a16="http://schemas.microsoft.com/office/drawing/2014/main" id="{252D3F60-77D7-4FE1-8C2C-B9863A6BC354}"/>
               </a:ext>
             </a:extLst>
           </p:cNvPr>
@@ -9270,7 +9270,7 @@
           <p:cNvPr id="4" name="slide-subtitle">
             <a:extLst xmlns:a="http://schemas.openxmlformats.org/drawingml/2006/main">
               <a:ext uri="{FF2B5EF4-FFF2-40B4-BE49-F238E27FC236}">
-                <a16:creationId xmlns:a16="http://schemas.microsoft.com/office/drawing/2014/main" id="{E0427942-DFF1-4E69-9CFB-5E043769382A}"/>
+                <a16:creationId xmlns:a16="http://schemas.microsoft.com/office/drawing/2014/main" id="{37B35CD0-62A5-4767-9BB6-1CEABA9289F5}"/>
               </a:ext>
             </a:extLst>
           </p:cNvPr>
@@ -9315,7 +9315,7 @@
           <p:cNvPr id="5" name="">
             <a:extLst xmlns:a="http://schemas.openxmlformats.org/drawingml/2006/main">
               <a:ext uri="{FF2B5EF4-FFF2-40B4-BE49-F238E27FC236}">
-                <a16:creationId xmlns:a16="http://schemas.microsoft.com/office/drawing/2014/main" id="{08DEE35D-DC0D-4511-BF2A-CE91437F869C}"/>
+                <a16:creationId xmlns:a16="http://schemas.microsoft.com/office/drawing/2014/main" id="{A0004CE4-9A47-49BA-96DA-E9CE0085AC78}"/>
               </a:ext>
             </a:extLst>
           </p:cNvPr>
@@ -9348,7 +9348,7 @@
           <p:cNvPr id="6" name="">
             <a:extLst xmlns:a="http://schemas.openxmlformats.org/drawingml/2006/main">
               <a:ext uri="{FF2B5EF4-FFF2-40B4-BE49-F238E27FC236}">
-                <a16:creationId xmlns:a16="http://schemas.microsoft.com/office/drawing/2014/main" id="{B5BC514C-0A3E-4A23-886B-EAA047C055B9}"/>
+                <a16:creationId xmlns:a16="http://schemas.microsoft.com/office/drawing/2014/main" id="{AFBF6296-2E63-4DAD-BEAA-4F50B87D2AEB}"/>
               </a:ext>
             </a:extLst>
           </p:cNvPr>
@@ -9393,7 +9393,7 @@
           <p:cNvPr id="7" name="">
             <a:extLst xmlns:a="http://schemas.openxmlformats.org/drawingml/2006/main">
               <a:ext uri="{FF2B5EF4-FFF2-40B4-BE49-F238E27FC236}">
-                <a16:creationId xmlns:a16="http://schemas.microsoft.com/office/drawing/2014/main" id="{889461A1-3D6F-414E-ABFB-AC8ED8AC4497}"/>
+                <a16:creationId xmlns:a16="http://schemas.microsoft.com/office/drawing/2014/main" id="{FF5154A4-D549-45D2-BE1F-6BF6CE3F07E6}"/>
               </a:ext>
             </a:extLst>
           </p:cNvPr>
@@ -9438,7 +9438,7 @@
           <p:cNvPr id="8" name="">
             <a:extLst xmlns:a="http://schemas.openxmlformats.org/drawingml/2006/main">
               <a:ext uri="{FF2B5EF4-FFF2-40B4-BE49-F238E27FC236}">
-                <a16:creationId xmlns:a16="http://schemas.microsoft.com/office/drawing/2014/main" id="{CAD9EF56-F25C-440C-BACC-092F398C4BBF}"/>
+                <a16:creationId xmlns:a16="http://schemas.microsoft.com/office/drawing/2014/main" id="{4AD42A2C-24BA-4273-9CD9-0EC65197D17D}"/>
               </a:ext>
             </a:extLst>
           </p:cNvPr>
@@ -9471,7 +9471,7 @@
           <p:cNvPr id="9" name="">
             <a:extLst xmlns:a="http://schemas.openxmlformats.org/drawingml/2006/main">
               <a:ext uri="{FF2B5EF4-FFF2-40B4-BE49-F238E27FC236}">
-                <a16:creationId xmlns:a16="http://schemas.microsoft.com/office/drawing/2014/main" id="{87B73CF5-9A06-4DB2-934C-CE5CBB6CE4BA}"/>
+                <a16:creationId xmlns:a16="http://schemas.microsoft.com/office/drawing/2014/main" id="{A135F835-4173-483A-945D-4CB201DEA029}"/>
               </a:ext>
             </a:extLst>
           </p:cNvPr>
@@ -9516,7 +9516,7 @@
           <p:cNvPr id="10" name="">
             <a:extLst xmlns:a="http://schemas.openxmlformats.org/drawingml/2006/main">
               <a:ext uri="{FF2B5EF4-FFF2-40B4-BE49-F238E27FC236}">
-                <a16:creationId xmlns:a16="http://schemas.microsoft.com/office/drawing/2014/main" id="{9C82C652-8C75-42DA-87CD-932DCAB5F9CF}"/>
+                <a16:creationId xmlns:a16="http://schemas.microsoft.com/office/drawing/2014/main" id="{23110A51-1F3B-49B5-B5E7-48C0CC1E4A85}"/>
               </a:ext>
             </a:extLst>
           </p:cNvPr>
@@ -9561,7 +9561,7 @@
           <p:cNvPr id="11" name="">
             <a:extLst xmlns:a="http://schemas.openxmlformats.org/drawingml/2006/main">
               <a:ext uri="{FF2B5EF4-FFF2-40B4-BE49-F238E27FC236}">
-                <a16:creationId xmlns:a16="http://schemas.microsoft.com/office/drawing/2014/main" id="{E2AB85E1-5941-4A4F-80D6-8F82258661AA}"/>
+                <a16:creationId xmlns:a16="http://schemas.microsoft.com/office/drawing/2014/main" id="{05B2AD97-64AE-4FE0-82E7-D40A7B6E7AA4}"/>
               </a:ext>
             </a:extLst>
           </p:cNvPr>
@@ -9594,7 +9594,7 @@
           <p:cNvPr id="12" name="">
             <a:extLst xmlns:a="http://schemas.openxmlformats.org/drawingml/2006/main">
               <a:ext uri="{FF2B5EF4-FFF2-40B4-BE49-F238E27FC236}">
-                <a16:creationId xmlns:a16="http://schemas.microsoft.com/office/drawing/2014/main" id="{0D9A3E59-CAB8-43C5-8BF8-EB902AE86233}"/>
+                <a16:creationId xmlns:a16="http://schemas.microsoft.com/office/drawing/2014/main" id="{5D0A0C6D-6358-450D-8372-B0498A1E522E}"/>
               </a:ext>
             </a:extLst>
           </p:cNvPr>
@@ -9639,7 +9639,7 @@
           <p:cNvPr id="13" name="">
             <a:extLst xmlns:a="http://schemas.openxmlformats.org/drawingml/2006/main">
               <a:ext uri="{FF2B5EF4-FFF2-40B4-BE49-F238E27FC236}">
-                <a16:creationId xmlns:a16="http://schemas.microsoft.com/office/drawing/2014/main" id="{4A353410-A95D-44CB-AC69-6336CBA0C2BE}"/>
+                <a16:creationId xmlns:a16="http://schemas.microsoft.com/office/drawing/2014/main" id="{423425CB-4B03-4E81-8D3D-C5D9DFB60273}"/>
               </a:ext>
             </a:extLst>
           </p:cNvPr>
@@ -9684,7 +9684,7 @@
           <p:cNvPr id="14" name="">
             <a:extLst xmlns:a="http://schemas.openxmlformats.org/drawingml/2006/main">
               <a:ext uri="{FF2B5EF4-FFF2-40B4-BE49-F238E27FC236}">
-                <a16:creationId xmlns:a16="http://schemas.microsoft.com/office/drawing/2014/main" id="{E962A340-0601-45A8-AAA5-E296F9E233C2}"/>
+                <a16:creationId xmlns:a16="http://schemas.microsoft.com/office/drawing/2014/main" id="{7D62A5A2-447F-43D0-B8A8-88C245CFB155}"/>
               </a:ext>
             </a:extLst>
           </p:cNvPr>
@@ -9729,7 +9729,7 @@
           <p:cNvPr id="15" name="footer-left">
             <a:extLst xmlns:a="http://schemas.openxmlformats.org/drawingml/2006/main">
               <a:ext uri="{FF2B5EF4-FFF2-40B4-BE49-F238E27FC236}">
-                <a16:creationId xmlns:a16="http://schemas.microsoft.com/office/drawing/2014/main" id="{0EE0B692-907D-43D8-8DFA-BF42BBA6A08C}"/>
+                <a16:creationId xmlns:a16="http://schemas.microsoft.com/office/drawing/2014/main" id="{99B95968-DA8F-4546-A69C-0B575D5AD238}"/>
               </a:ext>
             </a:extLst>
           </p:cNvPr>
@@ -9774,7 +9774,7 @@
           <p:cNvPr id="16" name="footer-right">
             <a:extLst xmlns:a="http://schemas.openxmlformats.org/drawingml/2006/main">
               <a:ext uri="{FF2B5EF4-FFF2-40B4-BE49-F238E27FC236}">
-                <a16:creationId xmlns:a16="http://schemas.microsoft.com/office/drawing/2014/main" id="{5E66C8E6-539D-4158-9002-8E41F672E536}"/>
+                <a16:creationId xmlns:a16="http://schemas.microsoft.com/office/drawing/2014/main" id="{8429BEB1-22CC-429B-A6C7-E01413F77386}"/>
               </a:ext>
             </a:extLst>
           </p:cNvPr>
@@ -9817,7 +9817,7 @@
     </p:spTree>
     <p:extLst>
       <p:ext uri="{BB962C8B-B14F-4D97-AF65-F5344CB8AC3E}">
-        <p14:creationId xmlns:p14="http://schemas.microsoft.com/office/powerpoint/2010/main" val="32343896"/>
+        <p14:creationId xmlns:p14="http://schemas.microsoft.com/office/powerpoint/2010/main" val="1076639204"/>
       </p:ext>
     </p:extLst>
   </p:cSld>
@@ -9841,7 +9841,7 @@
           <p:cNvPr id="1" name="slide-stage">
             <a:extLst xmlns:a="http://schemas.openxmlformats.org/drawingml/2006/main">
               <a:ext uri="{FF2B5EF4-FFF2-40B4-BE49-F238E27FC236}">
-                <a16:creationId xmlns:a16="http://schemas.microsoft.com/office/drawing/2014/main" id="{2E7897A9-AC62-47FF-8CD9-31B2513155B2}"/>
+                <a16:creationId xmlns:a16="http://schemas.microsoft.com/office/drawing/2014/main" id="{B06BCDC1-134D-4B46-9C4F-CA25795026FD}"/>
               </a:ext>
             </a:extLst>
           </p:cNvPr>
@@ -9868,7 +9868,7 @@
           <p:cNvPr id="2" name="eyebrow">
             <a:extLst xmlns:a="http://schemas.openxmlformats.org/drawingml/2006/main">
               <a:ext uri="{FF2B5EF4-FFF2-40B4-BE49-F238E27FC236}">
-                <a16:creationId xmlns:a16="http://schemas.microsoft.com/office/drawing/2014/main" id="{B95FB6EC-008E-43B5-9F0B-686538024C8F}"/>
+                <a16:creationId xmlns:a16="http://schemas.microsoft.com/office/drawing/2014/main" id="{B76219E3-47D8-4038-9A56-893A3B31C241}"/>
               </a:ext>
             </a:extLst>
           </p:cNvPr>
@@ -9913,7 +9913,7 @@
           <p:cNvPr id="3" name="slide-title">
             <a:extLst xmlns:a="http://schemas.openxmlformats.org/drawingml/2006/main">
               <a:ext uri="{FF2B5EF4-FFF2-40B4-BE49-F238E27FC236}">
-                <a16:creationId xmlns:a16="http://schemas.microsoft.com/office/drawing/2014/main" id="{CD92A884-1AA2-4508-A7EC-C0A85371A2E1}"/>
+                <a16:creationId xmlns:a16="http://schemas.microsoft.com/office/drawing/2014/main" id="{421D6DD2-597E-476B-9E39-B8590E06D005}"/>
               </a:ext>
             </a:extLst>
           </p:cNvPr>
@@ -9958,7 +9958,7 @@
           <p:cNvPr id="4" name="slide-subtitle">
             <a:extLst xmlns:a="http://schemas.openxmlformats.org/drawingml/2006/main">
               <a:ext uri="{FF2B5EF4-FFF2-40B4-BE49-F238E27FC236}">
-                <a16:creationId xmlns:a16="http://schemas.microsoft.com/office/drawing/2014/main" id="{639C6B31-ED6C-454B-8567-92AE7CF34479}"/>
+                <a16:creationId xmlns:a16="http://schemas.microsoft.com/office/drawing/2014/main" id="{F1934E26-EE9A-46D2-AF11-92EC17CDA5D4}"/>
               </a:ext>
             </a:extLst>
           </p:cNvPr>
@@ -10003,7 +10003,7 @@
           <p:cNvPr id="5" name="">
             <a:extLst xmlns:a="http://schemas.openxmlformats.org/drawingml/2006/main">
               <a:ext uri="{FF2B5EF4-FFF2-40B4-BE49-F238E27FC236}">
-                <a16:creationId xmlns:a16="http://schemas.microsoft.com/office/drawing/2014/main" id="{10345091-09C4-4132-BC88-07AD726916B3}"/>
+                <a16:creationId xmlns:a16="http://schemas.microsoft.com/office/drawing/2014/main" id="{4E27B528-A3CD-4D0A-9316-9600800E65C7}"/>
               </a:ext>
             </a:extLst>
           </p:cNvPr>
@@ -10048,7 +10048,7 @@
           <p:cNvPr id="6" name="">
             <a:extLst xmlns:a="http://schemas.openxmlformats.org/drawingml/2006/main">
               <a:ext uri="{FF2B5EF4-FFF2-40B4-BE49-F238E27FC236}">
-                <a16:creationId xmlns:a16="http://schemas.microsoft.com/office/drawing/2014/main" id="{B5E5C7A1-8D66-46BB-8A40-FE1E7EC6C00C}"/>
+                <a16:creationId xmlns:a16="http://schemas.microsoft.com/office/drawing/2014/main" id="{BF2DC28D-234B-4ED6-907F-AC1951563DB0}"/>
               </a:ext>
             </a:extLst>
           </p:cNvPr>
@@ -10093,7 +10093,7 @@
           <p:cNvPr id="7" name="">
             <a:extLst xmlns:a="http://schemas.openxmlformats.org/drawingml/2006/main">
               <a:ext uri="{FF2B5EF4-FFF2-40B4-BE49-F238E27FC236}">
-                <a16:creationId xmlns:a16="http://schemas.microsoft.com/office/drawing/2014/main" id="{92395582-CB9A-4DAC-8999-C42330F62B3A}"/>
+                <a16:creationId xmlns:a16="http://schemas.microsoft.com/office/drawing/2014/main" id="{FB7C26C9-D355-4113-9769-DA69684F89E8}"/>
               </a:ext>
             </a:extLst>
           </p:cNvPr>
@@ -10138,7 +10138,7 @@
           <p:cNvPr id="8" name="">
             <a:extLst xmlns:a="http://schemas.openxmlformats.org/drawingml/2006/main">
               <a:ext uri="{FF2B5EF4-FFF2-40B4-BE49-F238E27FC236}">
-                <a16:creationId xmlns:a16="http://schemas.microsoft.com/office/drawing/2014/main" id="{AA00C786-39FC-43F2-8667-F5B86230FC4C}"/>
+                <a16:creationId xmlns:a16="http://schemas.microsoft.com/office/drawing/2014/main" id="{70C1F719-7399-43CB-8563-37DAC6547AA5}"/>
               </a:ext>
             </a:extLst>
           </p:cNvPr>
@@ -10183,7 +10183,7 @@
           <p:cNvPr id="9" name="">
             <a:extLst xmlns:a="http://schemas.openxmlformats.org/drawingml/2006/main">
               <a:ext uri="{FF2B5EF4-FFF2-40B4-BE49-F238E27FC236}">
-                <a16:creationId xmlns:a16="http://schemas.microsoft.com/office/drawing/2014/main" id="{802EC856-255A-4E13-8ACE-635E8CC62905}"/>
+                <a16:creationId xmlns:a16="http://schemas.microsoft.com/office/drawing/2014/main" id="{85F069CC-ADF7-4C7D-A3F5-3DEA507E7C5D}"/>
               </a:ext>
             </a:extLst>
           </p:cNvPr>
@@ -10228,7 +10228,7 @@
           <p:cNvPr id="10" name="">
             <a:extLst xmlns:a="http://schemas.openxmlformats.org/drawingml/2006/main">
               <a:ext uri="{FF2B5EF4-FFF2-40B4-BE49-F238E27FC236}">
-                <a16:creationId xmlns:a16="http://schemas.microsoft.com/office/drawing/2014/main" id="{05F143A1-5134-4CC2-A03D-6B56FBAECC95}"/>
+                <a16:creationId xmlns:a16="http://schemas.microsoft.com/office/drawing/2014/main" id="{F1E8665F-07D4-477E-B850-8D1E579150C5}"/>
               </a:ext>
             </a:extLst>
           </p:cNvPr>
@@ -10273,7 +10273,7 @@
           <p:cNvPr id="11" name="">
             <a:extLst xmlns:a="http://schemas.openxmlformats.org/drawingml/2006/main">
               <a:ext uri="{FF2B5EF4-FFF2-40B4-BE49-F238E27FC236}">
-                <a16:creationId xmlns:a16="http://schemas.microsoft.com/office/drawing/2014/main" id="{6CD41CE2-FA6B-4514-A4FE-875DD7779FDF}"/>
+                <a16:creationId xmlns:a16="http://schemas.microsoft.com/office/drawing/2014/main" id="{054BCB71-F404-4061-96FB-AA68948777B2}"/>
               </a:ext>
             </a:extLst>
           </p:cNvPr>
@@ -10318,7 +10318,7 @@
           <p:cNvPr id="12" name="">
             <a:extLst xmlns:a="http://schemas.openxmlformats.org/drawingml/2006/main">
               <a:ext uri="{FF2B5EF4-FFF2-40B4-BE49-F238E27FC236}">
-                <a16:creationId xmlns:a16="http://schemas.microsoft.com/office/drawing/2014/main" id="{7A6D39D0-5A32-4E77-86BB-D425E34B7BD3}"/>
+                <a16:creationId xmlns:a16="http://schemas.microsoft.com/office/drawing/2014/main" id="{77390838-6867-4035-93DE-E560CFD49F28}"/>
               </a:ext>
             </a:extLst>
           </p:cNvPr>
@@ -10363,7 +10363,7 @@
           <p:cNvPr id="13" name="">
             <a:extLst xmlns:a="http://schemas.openxmlformats.org/drawingml/2006/main">
               <a:ext uri="{FF2B5EF4-FFF2-40B4-BE49-F238E27FC236}">
-                <a16:creationId xmlns:a16="http://schemas.microsoft.com/office/drawing/2014/main" id="{AF3AB0F6-1D58-4A09-B61B-4E466D88C0C6}"/>
+                <a16:creationId xmlns:a16="http://schemas.microsoft.com/office/drawing/2014/main" id="{219AA07E-8F0E-47F9-B837-8416FC0E668D}"/>
               </a:ext>
             </a:extLst>
           </p:cNvPr>
@@ -10408,7 +10408,7 @@
           <p:cNvPr id="14" name="">
             <a:extLst xmlns:a="http://schemas.openxmlformats.org/drawingml/2006/main">
               <a:ext uri="{FF2B5EF4-FFF2-40B4-BE49-F238E27FC236}">
-                <a16:creationId xmlns:a16="http://schemas.microsoft.com/office/drawing/2014/main" id="{7E1875CE-12BC-4E21-8194-2B08A06D5B0F}"/>
+                <a16:creationId xmlns:a16="http://schemas.microsoft.com/office/drawing/2014/main" id="{1C9B5491-D534-4C2B-9950-EF16F45CB51A}"/>
               </a:ext>
             </a:extLst>
           </p:cNvPr>
@@ -10453,7 +10453,7 @@
           <p:cNvPr id="15" name="">
             <a:extLst xmlns:a="http://schemas.openxmlformats.org/drawingml/2006/main">
               <a:ext uri="{FF2B5EF4-FFF2-40B4-BE49-F238E27FC236}">
-                <a16:creationId xmlns:a16="http://schemas.microsoft.com/office/drawing/2014/main" id="{11072B7C-57E8-4AD0-8940-40AD0E0D20CD}"/>
+                <a16:creationId xmlns:a16="http://schemas.microsoft.com/office/drawing/2014/main" id="{D013392C-E4D7-47BF-93E2-0F984CE91555}"/>
               </a:ext>
             </a:extLst>
           </p:cNvPr>
@@ -10498,7 +10498,7 @@
           <p:cNvPr id="16" name="">
             <a:extLst xmlns:a="http://schemas.openxmlformats.org/drawingml/2006/main">
               <a:ext uri="{FF2B5EF4-FFF2-40B4-BE49-F238E27FC236}">
-                <a16:creationId xmlns:a16="http://schemas.microsoft.com/office/drawing/2014/main" id="{C0BAEF67-5F89-4B84-BAB6-2EC17333F6E2}"/>
+                <a16:creationId xmlns:a16="http://schemas.microsoft.com/office/drawing/2014/main" id="{ABBCE12D-3A2A-4133-93B0-1E9FD5FA76CA}"/>
               </a:ext>
             </a:extLst>
           </p:cNvPr>
@@ -10543,7 +10543,7 @@
           <p:cNvPr id="17" name="">
             <a:extLst xmlns:a="http://schemas.openxmlformats.org/drawingml/2006/main">
               <a:ext uri="{FF2B5EF4-FFF2-40B4-BE49-F238E27FC236}">
-                <a16:creationId xmlns:a16="http://schemas.microsoft.com/office/drawing/2014/main" id="{E47D7E86-BFC3-4D60-9521-6A36C03F8DDF}"/>
+                <a16:creationId xmlns:a16="http://schemas.microsoft.com/office/drawing/2014/main" id="{E6C5EF2A-D00B-446C-ABE7-E2EE56809B99}"/>
               </a:ext>
             </a:extLst>
           </p:cNvPr>
@@ -10588,7 +10588,7 @@
           <p:cNvPr id="18" name="">
             <a:extLst xmlns:a="http://schemas.openxmlformats.org/drawingml/2006/main">
               <a:ext uri="{FF2B5EF4-FFF2-40B4-BE49-F238E27FC236}">
-                <a16:creationId xmlns:a16="http://schemas.microsoft.com/office/drawing/2014/main" id="{72E8945F-1834-4498-897B-E0F116F27B06}"/>
+                <a16:creationId xmlns:a16="http://schemas.microsoft.com/office/drawing/2014/main" id="{604A9549-89F1-49CF-98DA-02BC70FC0151}"/>
               </a:ext>
             </a:extLst>
           </p:cNvPr>
@@ -10633,7 +10633,7 @@
           <p:cNvPr id="19" name="">
             <a:extLst xmlns:a="http://schemas.openxmlformats.org/drawingml/2006/main">
               <a:ext uri="{FF2B5EF4-FFF2-40B4-BE49-F238E27FC236}">
-                <a16:creationId xmlns:a16="http://schemas.microsoft.com/office/drawing/2014/main" id="{59B61E54-F16E-4441-BC7F-753EAB80C43F}"/>
+                <a16:creationId xmlns:a16="http://schemas.microsoft.com/office/drawing/2014/main" id="{50A9AD49-083A-49EB-A571-EE046E3F47C1}"/>
               </a:ext>
             </a:extLst>
           </p:cNvPr>
@@ -10678,7 +10678,7 @@
           <p:cNvPr id="20" name="footer-left">
             <a:extLst xmlns:a="http://schemas.openxmlformats.org/drawingml/2006/main">
               <a:ext uri="{FF2B5EF4-FFF2-40B4-BE49-F238E27FC236}">
-                <a16:creationId xmlns:a16="http://schemas.microsoft.com/office/drawing/2014/main" id="{3949957A-12DE-43AF-82E3-E34235680042}"/>
+                <a16:creationId xmlns:a16="http://schemas.microsoft.com/office/drawing/2014/main" id="{F4A4DA1A-1196-4334-A1B8-C32DA240AB7F}"/>
               </a:ext>
             </a:extLst>
           </p:cNvPr>
@@ -10723,7 +10723,7 @@
           <p:cNvPr id="21" name="footer-right">
             <a:extLst xmlns:a="http://schemas.openxmlformats.org/drawingml/2006/main">
               <a:ext uri="{FF2B5EF4-FFF2-40B4-BE49-F238E27FC236}">
-                <a16:creationId xmlns:a16="http://schemas.microsoft.com/office/drawing/2014/main" id="{D5D088AF-BD94-43DC-BA4D-BE6D59F3839E}"/>
+                <a16:creationId xmlns:a16="http://schemas.microsoft.com/office/drawing/2014/main" id="{B863413C-6A64-4701-8890-2EC4BAA416D8}"/>
               </a:ext>
             </a:extLst>
           </p:cNvPr>
@@ -10766,7 +10766,7 @@
     </p:spTree>
     <p:extLst>
       <p:ext uri="{BB962C8B-B14F-4D97-AF65-F5344CB8AC3E}">
-        <p14:creationId xmlns:p14="http://schemas.microsoft.com/office/powerpoint/2010/main" val="1363857978"/>
+        <p14:creationId xmlns:p14="http://schemas.microsoft.com/office/powerpoint/2010/main" val="2106740092"/>
       </p:ext>
     </p:extLst>
   </p:cSld>
@@ -10790,7 +10790,7 @@
           <p:cNvPr id="1" name="slide-stage">
             <a:extLst xmlns:a="http://schemas.openxmlformats.org/drawingml/2006/main">
               <a:ext uri="{FF2B5EF4-FFF2-40B4-BE49-F238E27FC236}">
-                <a16:creationId xmlns:a16="http://schemas.microsoft.com/office/drawing/2014/main" id="{E572865C-1CC4-42DE-905B-BBE3FAD522E0}"/>
+                <a16:creationId xmlns:a16="http://schemas.microsoft.com/office/drawing/2014/main" id="{2621E0E8-C3A6-4F53-8C1C-EBEE94E430E0}"/>
               </a:ext>
             </a:extLst>
           </p:cNvPr>
@@ -10817,7 +10817,7 @@
           <p:cNvPr id="2" name="eyebrow">
             <a:extLst xmlns:a="http://schemas.openxmlformats.org/drawingml/2006/main">
               <a:ext uri="{FF2B5EF4-FFF2-40B4-BE49-F238E27FC236}">
-                <a16:creationId xmlns:a16="http://schemas.microsoft.com/office/drawing/2014/main" id="{D753E503-0FCC-487F-BF07-FEBB2E2B058E}"/>
+                <a16:creationId xmlns:a16="http://schemas.microsoft.com/office/drawing/2014/main" id="{9D8D1312-3D37-499D-B7C4-E10CD23BCD8A}"/>
               </a:ext>
             </a:extLst>
           </p:cNvPr>
@@ -10862,7 +10862,7 @@
           <p:cNvPr id="3" name="slide-title">
             <a:extLst xmlns:a="http://schemas.openxmlformats.org/drawingml/2006/main">
               <a:ext uri="{FF2B5EF4-FFF2-40B4-BE49-F238E27FC236}">
-                <a16:creationId xmlns:a16="http://schemas.microsoft.com/office/drawing/2014/main" id="{3630166E-5B76-4E5B-8A4C-36C36E5F08B2}"/>
+                <a16:creationId xmlns:a16="http://schemas.microsoft.com/office/drawing/2014/main" id="{07474294-B5F6-4AC9-85ED-F13555CAE56A}"/>
               </a:ext>
             </a:extLst>
           </p:cNvPr>
@@ -10907,7 +10907,7 @@
           <p:cNvPr id="4" name="slide-subtitle">
             <a:extLst xmlns:a="http://schemas.openxmlformats.org/drawingml/2006/main">
               <a:ext uri="{FF2B5EF4-FFF2-40B4-BE49-F238E27FC236}">
-                <a16:creationId xmlns:a16="http://schemas.microsoft.com/office/drawing/2014/main" id="{136C253F-672A-4F8D-888F-3E01AA9F7B0F}"/>
+                <a16:creationId xmlns:a16="http://schemas.microsoft.com/office/drawing/2014/main" id="{A189E2E3-8C86-4469-B7B9-D74F1A5BEA42}"/>
               </a:ext>
             </a:extLst>
           </p:cNvPr>
@@ -10952,7 +10952,7 @@
           <p:cNvPr id="5" name="">
             <a:extLst xmlns:a="http://schemas.openxmlformats.org/drawingml/2006/main">
               <a:ext uri="{FF2B5EF4-FFF2-40B4-BE49-F238E27FC236}">
-                <a16:creationId xmlns:a16="http://schemas.microsoft.com/office/drawing/2014/main" id="{ADB0FEAF-31AD-4CB5-BABF-9686C46152C8}"/>
+                <a16:creationId xmlns:a16="http://schemas.microsoft.com/office/drawing/2014/main" id="{856D95CF-0AA6-4821-B6F9-4F650ACDBE69}"/>
               </a:ext>
             </a:extLst>
           </p:cNvPr>
@@ -10985,7 +10985,7 @@
           <p:cNvPr id="6" name="">
             <a:extLst xmlns:a="http://schemas.openxmlformats.org/drawingml/2006/main">
               <a:ext uri="{FF2B5EF4-FFF2-40B4-BE49-F238E27FC236}">
-                <a16:creationId xmlns:a16="http://schemas.microsoft.com/office/drawing/2014/main" id="{22AE7514-E6B6-4966-AECE-E66067537323}"/>
+                <a16:creationId xmlns:a16="http://schemas.microsoft.com/office/drawing/2014/main" id="{2B956F84-F7C5-41DC-9917-7A27012C4575}"/>
               </a:ext>
             </a:extLst>
           </p:cNvPr>
@@ -11081,7 +11081,7 @@
           <p:cNvPr id="7" name="">
             <a:extLst xmlns:a="http://schemas.openxmlformats.org/drawingml/2006/main">
               <a:ext uri="{FF2B5EF4-FFF2-40B4-BE49-F238E27FC236}">
-                <a16:creationId xmlns:a16="http://schemas.microsoft.com/office/drawing/2014/main" id="{DABD0CD8-3A98-44ED-A859-C0CAD7176E74}"/>
+                <a16:creationId xmlns:a16="http://schemas.microsoft.com/office/drawing/2014/main" id="{0A7151E7-2489-4556-A16B-CFC054FE789A}"/>
               </a:ext>
             </a:extLst>
           </p:cNvPr>
@@ -11114,7 +11114,7 @@
           <p:cNvPr id="8" name="">
             <a:extLst xmlns:a="http://schemas.openxmlformats.org/drawingml/2006/main">
               <a:ext uri="{FF2B5EF4-FFF2-40B4-BE49-F238E27FC236}">
-                <a16:creationId xmlns:a16="http://schemas.microsoft.com/office/drawing/2014/main" id="{8453F57B-22E0-4700-B5E2-FC4B40E63525}"/>
+                <a16:creationId xmlns:a16="http://schemas.microsoft.com/office/drawing/2014/main" id="{62D62C8C-9845-44B6-8F6E-5215701D18BB}"/>
               </a:ext>
             </a:extLst>
           </p:cNvPr>
@@ -11159,7 +11159,7 @@
           <p:cNvPr id="9" name="">
             <a:extLst xmlns:a="http://schemas.openxmlformats.org/drawingml/2006/main">
               <a:ext uri="{FF2B5EF4-FFF2-40B4-BE49-F238E27FC236}">
-                <a16:creationId xmlns:a16="http://schemas.microsoft.com/office/drawing/2014/main" id="{4901D14C-3E6F-469F-9B04-E9F09ECD6049}"/>
+                <a16:creationId xmlns:a16="http://schemas.microsoft.com/office/drawing/2014/main" id="{10F55C38-228C-44AD-A7D3-8BC4A1C8CA89}"/>
               </a:ext>
             </a:extLst>
           </p:cNvPr>
@@ -11204,7 +11204,7 @@
           <p:cNvPr id="10" name="">
             <a:extLst xmlns:a="http://schemas.openxmlformats.org/drawingml/2006/main">
               <a:ext uri="{FF2B5EF4-FFF2-40B4-BE49-F238E27FC236}">
-                <a16:creationId xmlns:a16="http://schemas.microsoft.com/office/drawing/2014/main" id="{8598E49C-8D89-4902-A7BC-27E860C86FAB}"/>
+                <a16:creationId xmlns:a16="http://schemas.microsoft.com/office/drawing/2014/main" id="{EAEDCE04-CE7C-4209-88A6-D58C694A31CE}"/>
               </a:ext>
             </a:extLst>
           </p:cNvPr>
@@ -11237,7 +11237,7 @@
           <p:cNvPr id="11" name="">
             <a:extLst xmlns:a="http://schemas.openxmlformats.org/drawingml/2006/main">
               <a:ext uri="{FF2B5EF4-FFF2-40B4-BE49-F238E27FC236}">
-                <a16:creationId xmlns:a16="http://schemas.microsoft.com/office/drawing/2014/main" id="{B8340B01-2510-423D-87A9-6C9EEB3888ED}"/>
+                <a16:creationId xmlns:a16="http://schemas.microsoft.com/office/drawing/2014/main" id="{30487071-CD29-406E-98B3-213EC85FBF26}"/>
               </a:ext>
             </a:extLst>
           </p:cNvPr>
@@ -11282,7 +11282,7 @@
           <p:cNvPr id="12" name="">
             <a:extLst xmlns:a="http://schemas.openxmlformats.org/drawingml/2006/main">
               <a:ext uri="{FF2B5EF4-FFF2-40B4-BE49-F238E27FC236}">
-                <a16:creationId xmlns:a16="http://schemas.microsoft.com/office/drawing/2014/main" id="{8DC1EBB3-6796-42FD-B7E7-A184E5351788}"/>
+                <a16:creationId xmlns:a16="http://schemas.microsoft.com/office/drawing/2014/main" id="{B8BF045B-9F2D-46F8-9D47-E6E90D0D8814}"/>
               </a:ext>
             </a:extLst>
           </p:cNvPr>
@@ -11327,7 +11327,7 @@
           <p:cNvPr id="13" name="">
             <a:extLst xmlns:a="http://schemas.openxmlformats.org/drawingml/2006/main">
               <a:ext uri="{FF2B5EF4-FFF2-40B4-BE49-F238E27FC236}">
-                <a16:creationId xmlns:a16="http://schemas.microsoft.com/office/drawing/2014/main" id="{328223EF-5CE0-47AA-9991-7031FF7728F7}"/>
+                <a16:creationId xmlns:a16="http://schemas.microsoft.com/office/drawing/2014/main" id="{C7FD94EF-2621-451D-A4C6-62C5C5CE7B68}"/>
               </a:ext>
             </a:extLst>
           </p:cNvPr>
@@ -11360,7 +11360,7 @@
           <p:cNvPr id="14" name="">
             <a:extLst xmlns:a="http://schemas.openxmlformats.org/drawingml/2006/main">
               <a:ext uri="{FF2B5EF4-FFF2-40B4-BE49-F238E27FC236}">
-                <a16:creationId xmlns:a16="http://schemas.microsoft.com/office/drawing/2014/main" id="{96FBBE58-2610-4DAF-9EDD-F29851158FC0}"/>
+                <a16:creationId xmlns:a16="http://schemas.microsoft.com/office/drawing/2014/main" id="{E54061D1-2F26-4C6B-948D-98A616F74A50}"/>
               </a:ext>
             </a:extLst>
           </p:cNvPr>
@@ -11405,7 +11405,7 @@
           <p:cNvPr id="15" name="">
             <a:extLst xmlns:a="http://schemas.openxmlformats.org/drawingml/2006/main">
               <a:ext uri="{FF2B5EF4-FFF2-40B4-BE49-F238E27FC236}">
-                <a16:creationId xmlns:a16="http://schemas.microsoft.com/office/drawing/2014/main" id="{9A3C2C64-1829-49E8-ADF8-60AB3CBF4D2D}"/>
+                <a16:creationId xmlns:a16="http://schemas.microsoft.com/office/drawing/2014/main" id="{4BF36C02-C195-4140-B38F-E88DCC9C78EC}"/>
               </a:ext>
             </a:extLst>
           </p:cNvPr>
@@ -11450,7 +11450,7 @@
           <p:cNvPr id="16" name="footer-left">
             <a:extLst xmlns:a="http://schemas.openxmlformats.org/drawingml/2006/main">
               <a:ext uri="{FF2B5EF4-FFF2-40B4-BE49-F238E27FC236}">
-                <a16:creationId xmlns:a16="http://schemas.microsoft.com/office/drawing/2014/main" id="{0BD4DE80-5246-45D2-9F57-7C544E041996}"/>
+                <a16:creationId xmlns:a16="http://schemas.microsoft.com/office/drawing/2014/main" id="{8A643003-C601-4E3E-A47E-C1E82F93695C}"/>
               </a:ext>
             </a:extLst>
           </p:cNvPr>
@@ -11495,7 +11495,7 @@
           <p:cNvPr id="17" name="footer-right">
             <a:extLst xmlns:a="http://schemas.openxmlformats.org/drawingml/2006/main">
               <a:ext uri="{FF2B5EF4-FFF2-40B4-BE49-F238E27FC236}">
-                <a16:creationId xmlns:a16="http://schemas.microsoft.com/office/drawing/2014/main" id="{F64D7FEC-4969-4AC8-8B41-4B6D47363678}"/>
+                <a16:creationId xmlns:a16="http://schemas.microsoft.com/office/drawing/2014/main" id="{659D553C-006F-4265-886E-2C74A941E71C}"/>
               </a:ext>
             </a:extLst>
           </p:cNvPr>
@@ -11538,7 +11538,7 @@
     </p:spTree>
     <p:extLst>
       <p:ext uri="{BB962C8B-B14F-4D97-AF65-F5344CB8AC3E}">
-        <p14:creationId xmlns:p14="http://schemas.microsoft.com/office/powerpoint/2010/main" val="2075985493"/>
+        <p14:creationId xmlns:p14="http://schemas.microsoft.com/office/powerpoint/2010/main" val="760499489"/>
       </p:ext>
     </p:extLst>
   </p:cSld>
@@ -11562,7 +11562,7 @@
           <p:cNvPr id="1" name="slide-stage">
             <a:extLst xmlns:a="http://schemas.openxmlformats.org/drawingml/2006/main">
               <a:ext uri="{FF2B5EF4-FFF2-40B4-BE49-F238E27FC236}">
-                <a16:creationId xmlns:a16="http://schemas.microsoft.com/office/drawing/2014/main" id="{18D8C37B-6260-43E9-A7E3-FAD89528F91E}"/>
+                <a16:creationId xmlns:a16="http://schemas.microsoft.com/office/drawing/2014/main" id="{10E65C01-4729-4EF0-9DEA-99492C8B5EA1}"/>
               </a:ext>
             </a:extLst>
           </p:cNvPr>
@@ -11589,7 +11589,7 @@
           <p:cNvPr id="2" name="eyebrow">
             <a:extLst xmlns:a="http://schemas.openxmlformats.org/drawingml/2006/main">
               <a:ext uri="{FF2B5EF4-FFF2-40B4-BE49-F238E27FC236}">
-                <a16:creationId xmlns:a16="http://schemas.microsoft.com/office/drawing/2014/main" id="{20881C5C-751E-452E-BEEF-ECB04A225B63}"/>
+                <a16:creationId xmlns:a16="http://schemas.microsoft.com/office/drawing/2014/main" id="{AAF0D725-393F-4E06-A647-CE9390A0EAAE}"/>
               </a:ext>
             </a:extLst>
           </p:cNvPr>
@@ -11634,7 +11634,7 @@
           <p:cNvPr id="3" name="slide-title">
             <a:extLst xmlns:a="http://schemas.openxmlformats.org/drawingml/2006/main">
               <a:ext uri="{FF2B5EF4-FFF2-40B4-BE49-F238E27FC236}">
-                <a16:creationId xmlns:a16="http://schemas.microsoft.com/office/drawing/2014/main" id="{9F17968F-D135-4FB4-B7D3-5F0557E0049C}"/>
+                <a16:creationId xmlns:a16="http://schemas.microsoft.com/office/drawing/2014/main" id="{68814EB2-AFB2-4A90-9F88-87F77E0E6F0C}"/>
               </a:ext>
             </a:extLst>
           </p:cNvPr>
@@ -11679,7 +11679,7 @@
           <p:cNvPr id="4" name="slide-subtitle">
             <a:extLst xmlns:a="http://schemas.openxmlformats.org/drawingml/2006/main">
               <a:ext uri="{FF2B5EF4-FFF2-40B4-BE49-F238E27FC236}">
-                <a16:creationId xmlns:a16="http://schemas.microsoft.com/office/drawing/2014/main" id="{A4746815-E8F0-4BC8-9513-84A4CECA0EEA}"/>
+                <a16:creationId xmlns:a16="http://schemas.microsoft.com/office/drawing/2014/main" id="{33E2C068-1D74-4C02-9D9C-D9785FFE7A19}"/>
               </a:ext>
             </a:extLst>
           </p:cNvPr>
@@ -11724,7 +11724,7 @@
           <p:cNvPr id="5" name="">
             <a:extLst xmlns:a="http://schemas.openxmlformats.org/drawingml/2006/main">
               <a:ext uri="{FF2B5EF4-FFF2-40B4-BE49-F238E27FC236}">
-                <a16:creationId xmlns:a16="http://schemas.microsoft.com/office/drawing/2014/main" id="{4BA0EE8A-F3C6-401E-9AC7-08915F2CE3CA}"/>
+                <a16:creationId xmlns:a16="http://schemas.microsoft.com/office/drawing/2014/main" id="{E878A71A-656C-479C-88B1-F4050BC4B33C}"/>
               </a:ext>
             </a:extLst>
           </p:cNvPr>
@@ -11757,7 +11757,7 @@
           <p:cNvPr id="6" name="">
             <a:extLst xmlns:a="http://schemas.openxmlformats.org/drawingml/2006/main">
               <a:ext uri="{FF2B5EF4-FFF2-40B4-BE49-F238E27FC236}">
-                <a16:creationId xmlns:a16="http://schemas.microsoft.com/office/drawing/2014/main" id="{8762F1D8-8FD6-44B6-B2C4-D40DD485E1C2}"/>
+                <a16:creationId xmlns:a16="http://schemas.microsoft.com/office/drawing/2014/main" id="{E7B55405-FD63-4C00-AF66-26A746C73531}"/>
               </a:ext>
             </a:extLst>
           </p:cNvPr>
@@ -11802,7 +11802,7 @@
           <p:cNvPr id="7" name="">
             <a:extLst xmlns:a="http://schemas.openxmlformats.org/drawingml/2006/main">
               <a:ext uri="{FF2B5EF4-FFF2-40B4-BE49-F238E27FC236}">
-                <a16:creationId xmlns:a16="http://schemas.microsoft.com/office/drawing/2014/main" id="{B949E5F6-88CF-4757-96D5-672C2006D281}"/>
+                <a16:creationId xmlns:a16="http://schemas.microsoft.com/office/drawing/2014/main" id="{31BC425F-3B56-4A73-AC70-4ED95E2B5B4B}"/>
               </a:ext>
             </a:extLst>
           </p:cNvPr>
@@ -11847,7 +11847,7 @@
           <p:cNvPr id="8" name="">
             <a:extLst xmlns:a="http://schemas.openxmlformats.org/drawingml/2006/main">
               <a:ext uri="{FF2B5EF4-FFF2-40B4-BE49-F238E27FC236}">
-                <a16:creationId xmlns:a16="http://schemas.microsoft.com/office/drawing/2014/main" id="{318B339E-833B-44D3-BBCB-3C3AE50C4E53}"/>
+                <a16:creationId xmlns:a16="http://schemas.microsoft.com/office/drawing/2014/main" id="{D65049A5-F865-4BE9-86FF-F8B1E87AAF00}"/>
               </a:ext>
             </a:extLst>
           </p:cNvPr>
@@ -11892,7 +11892,7 @@
           <p:cNvPr id="9" name="">
             <a:extLst xmlns:a="http://schemas.openxmlformats.org/drawingml/2006/main">
               <a:ext uri="{FF2B5EF4-FFF2-40B4-BE49-F238E27FC236}">
-                <a16:creationId xmlns:a16="http://schemas.microsoft.com/office/drawing/2014/main" id="{F38ABB6C-7FED-4D1C-A185-A7B3052F52A1}"/>
+                <a16:creationId xmlns:a16="http://schemas.microsoft.com/office/drawing/2014/main" id="{30AF9137-D48A-4B4F-85F6-092F64097DFE}"/>
               </a:ext>
             </a:extLst>
           </p:cNvPr>
@@ -11925,7 +11925,7 @@
           <p:cNvPr id="10" name="">
             <a:extLst xmlns:a="http://schemas.openxmlformats.org/drawingml/2006/main">
               <a:ext uri="{FF2B5EF4-FFF2-40B4-BE49-F238E27FC236}">
-                <a16:creationId xmlns:a16="http://schemas.microsoft.com/office/drawing/2014/main" id="{48D97689-1822-4415-BFF3-4DD8C8F9ACE6}"/>
+                <a16:creationId xmlns:a16="http://schemas.microsoft.com/office/drawing/2014/main" id="{49CF533E-C7DF-45C3-B6C9-A1286CDA4F00}"/>
               </a:ext>
             </a:extLst>
           </p:cNvPr>
@@ -11970,7 +11970,7 @@
           <p:cNvPr id="11" name="">
             <a:extLst xmlns:a="http://schemas.openxmlformats.org/drawingml/2006/main">
               <a:ext uri="{FF2B5EF4-FFF2-40B4-BE49-F238E27FC236}">
-                <a16:creationId xmlns:a16="http://schemas.microsoft.com/office/drawing/2014/main" id="{659B84B6-CB12-46E0-95FA-660E199A65C9}"/>
+                <a16:creationId xmlns:a16="http://schemas.microsoft.com/office/drawing/2014/main" id="{49549C7D-2F37-4512-85B2-213905759EB2}"/>
               </a:ext>
             </a:extLst>
           </p:cNvPr>
@@ -12015,7 +12015,7 @@
           <p:cNvPr id="12" name="">
             <a:extLst xmlns:a="http://schemas.openxmlformats.org/drawingml/2006/main">
               <a:ext uri="{FF2B5EF4-FFF2-40B4-BE49-F238E27FC236}">
-                <a16:creationId xmlns:a16="http://schemas.microsoft.com/office/drawing/2014/main" id="{F3A01EDE-AB28-436B-A1E8-C0C67E939C96}"/>
+                <a16:creationId xmlns:a16="http://schemas.microsoft.com/office/drawing/2014/main" id="{325E827D-F34B-49B8-B9B2-C983B834F5F8}"/>
               </a:ext>
             </a:extLst>
           </p:cNvPr>
@@ -12060,7 +12060,7 @@
           <p:cNvPr id="13" name="">
             <a:extLst xmlns:a="http://schemas.openxmlformats.org/drawingml/2006/main">
               <a:ext uri="{FF2B5EF4-FFF2-40B4-BE49-F238E27FC236}">
-                <a16:creationId xmlns:a16="http://schemas.microsoft.com/office/drawing/2014/main" id="{B9263704-118B-433C-B920-D8F589BB86D6}"/>
+                <a16:creationId xmlns:a16="http://schemas.microsoft.com/office/drawing/2014/main" id="{18BFFA6A-501E-440A-9782-0EBB87D6CFB9}"/>
               </a:ext>
             </a:extLst>
           </p:cNvPr>
@@ -12093,7 +12093,7 @@
           <p:cNvPr id="14" name="">
             <a:extLst xmlns:a="http://schemas.openxmlformats.org/drawingml/2006/main">
               <a:ext uri="{FF2B5EF4-FFF2-40B4-BE49-F238E27FC236}">
-                <a16:creationId xmlns:a16="http://schemas.microsoft.com/office/drawing/2014/main" id="{F5AEB343-81FE-4044-BC2B-A7330A16BA03}"/>
+                <a16:creationId xmlns:a16="http://schemas.microsoft.com/office/drawing/2014/main" id="{B1E70075-02D3-4B10-AA3F-71AADA5BD33D}"/>
               </a:ext>
             </a:extLst>
           </p:cNvPr>
@@ -12138,7 +12138,7 @@
           <p:cNvPr id="15" name="">
             <a:extLst xmlns:a="http://schemas.openxmlformats.org/drawingml/2006/main">
               <a:ext uri="{FF2B5EF4-FFF2-40B4-BE49-F238E27FC236}">
-                <a16:creationId xmlns:a16="http://schemas.microsoft.com/office/drawing/2014/main" id="{0EEBDF4C-CD7A-4954-B885-DC5EA1B63AA5}"/>
+                <a16:creationId xmlns:a16="http://schemas.microsoft.com/office/drawing/2014/main" id="{4B7B4ADC-5F56-42E9-B3DD-26E6ED6E6EF5}"/>
               </a:ext>
             </a:extLst>
           </p:cNvPr>
@@ -12183,7 +12183,7 @@
           <p:cNvPr id="16" name="">
             <a:extLst xmlns:a="http://schemas.openxmlformats.org/drawingml/2006/main">
               <a:ext uri="{FF2B5EF4-FFF2-40B4-BE49-F238E27FC236}">
-                <a16:creationId xmlns:a16="http://schemas.microsoft.com/office/drawing/2014/main" id="{26A42BCE-F266-4A20-A827-A327184220B8}"/>
+                <a16:creationId xmlns:a16="http://schemas.microsoft.com/office/drawing/2014/main" id="{3E2F178D-A596-4C21-B369-15F251C0710D}"/>
               </a:ext>
             </a:extLst>
           </p:cNvPr>
@@ -12228,7 +12228,7 @@
           <p:cNvPr id="17" name="">
             <a:extLst xmlns:a="http://schemas.openxmlformats.org/drawingml/2006/main">
               <a:ext uri="{FF2B5EF4-FFF2-40B4-BE49-F238E27FC236}">
-                <a16:creationId xmlns:a16="http://schemas.microsoft.com/office/drawing/2014/main" id="{FF00C5E2-2303-4D96-B36E-C9EA0CD9A040}"/>
+                <a16:creationId xmlns:a16="http://schemas.microsoft.com/office/drawing/2014/main" id="{D5FEF7B5-067C-476D-A23C-19A38AFB1280}"/>
               </a:ext>
             </a:extLst>
           </p:cNvPr>
@@ -12261,7 +12261,7 @@
           <p:cNvPr id="18" name="">
             <a:extLst xmlns:a="http://schemas.openxmlformats.org/drawingml/2006/main">
               <a:ext uri="{FF2B5EF4-FFF2-40B4-BE49-F238E27FC236}">
-                <a16:creationId xmlns:a16="http://schemas.microsoft.com/office/drawing/2014/main" id="{E3848556-4901-41C1-9C5F-3714BF0DE26B}"/>
+                <a16:creationId xmlns:a16="http://schemas.microsoft.com/office/drawing/2014/main" id="{973B7C46-4E21-4679-BABD-FCCE6764FAD2}"/>
               </a:ext>
             </a:extLst>
           </p:cNvPr>
@@ -12306,7 +12306,7 @@
           <p:cNvPr id="19" name="">
             <a:extLst xmlns:a="http://schemas.openxmlformats.org/drawingml/2006/main">
               <a:ext uri="{FF2B5EF4-FFF2-40B4-BE49-F238E27FC236}">
-                <a16:creationId xmlns:a16="http://schemas.microsoft.com/office/drawing/2014/main" id="{B973A446-D952-404C-8E13-AA8DEB8D4A83}"/>
+                <a16:creationId xmlns:a16="http://schemas.microsoft.com/office/drawing/2014/main" id="{DCBB1FDB-4C27-4AEB-B109-811C95569871}"/>
               </a:ext>
             </a:extLst>
           </p:cNvPr>
@@ -12351,7 +12351,7 @@
           <p:cNvPr id="20" name="">
             <a:extLst xmlns:a="http://schemas.openxmlformats.org/drawingml/2006/main">
               <a:ext uri="{FF2B5EF4-FFF2-40B4-BE49-F238E27FC236}">
-                <a16:creationId xmlns:a16="http://schemas.microsoft.com/office/drawing/2014/main" id="{E14B11EA-D780-4840-8BD3-2051D5C9CFEB}"/>
+                <a16:creationId xmlns:a16="http://schemas.microsoft.com/office/drawing/2014/main" id="{E80AD0A0-DDC7-498E-AA09-0AB48C913C44}"/>
               </a:ext>
             </a:extLst>
           </p:cNvPr>
@@ -12396,7 +12396,7 @@
           <p:cNvPr id="21" name="">
             <a:extLst xmlns:a="http://schemas.openxmlformats.org/drawingml/2006/main">
               <a:ext uri="{FF2B5EF4-FFF2-40B4-BE49-F238E27FC236}">
-                <a16:creationId xmlns:a16="http://schemas.microsoft.com/office/drawing/2014/main" id="{3BFE2A40-DD7A-4577-9B4B-BCCE7B36E54E}"/>
+                <a16:creationId xmlns:a16="http://schemas.microsoft.com/office/drawing/2014/main" id="{AE14123D-9A35-4C55-8C6C-8BC74B81033F}"/>
               </a:ext>
             </a:extLst>
           </p:cNvPr>
@@ -12429,7 +12429,7 @@
           <p:cNvPr id="22" name="">
             <a:extLst xmlns:a="http://schemas.openxmlformats.org/drawingml/2006/main">
               <a:ext uri="{FF2B5EF4-FFF2-40B4-BE49-F238E27FC236}">
-                <a16:creationId xmlns:a16="http://schemas.microsoft.com/office/drawing/2014/main" id="{EB801961-57B2-4C83-808C-8738E27EE25C}"/>
+                <a16:creationId xmlns:a16="http://schemas.microsoft.com/office/drawing/2014/main" id="{ED62300C-5BD2-4B08-B2EB-E3D0170C9B54}"/>
               </a:ext>
             </a:extLst>
           </p:cNvPr>
@@ -12474,7 +12474,7 @@
           <p:cNvPr id="23" name="">
             <a:extLst xmlns:a="http://schemas.openxmlformats.org/drawingml/2006/main">
               <a:ext uri="{FF2B5EF4-FFF2-40B4-BE49-F238E27FC236}">
-                <a16:creationId xmlns:a16="http://schemas.microsoft.com/office/drawing/2014/main" id="{586D0BF5-2D2A-4B81-806E-D6B07CEDEB19}"/>
+                <a16:creationId xmlns:a16="http://schemas.microsoft.com/office/drawing/2014/main" id="{6A05A7F1-3708-4F97-8890-35AE5EA1FEA4}"/>
               </a:ext>
             </a:extLst>
           </p:cNvPr>
@@ -12519,7 +12519,7 @@
           <p:cNvPr id="24" name="">
             <a:extLst xmlns:a="http://schemas.openxmlformats.org/drawingml/2006/main">
               <a:ext uri="{FF2B5EF4-FFF2-40B4-BE49-F238E27FC236}">
-                <a16:creationId xmlns:a16="http://schemas.microsoft.com/office/drawing/2014/main" id="{6E3B3551-B9E6-466B-9A59-00008E5EBBD5}"/>
+                <a16:creationId xmlns:a16="http://schemas.microsoft.com/office/drawing/2014/main" id="{2F6F3458-7B4E-43B3-96CD-563C5046CF6B}"/>
               </a:ext>
             </a:extLst>
           </p:cNvPr>
@@ -12564,7 +12564,7 @@
           <p:cNvPr id="25" name="">
             <a:extLst xmlns:a="http://schemas.openxmlformats.org/drawingml/2006/main">
               <a:ext uri="{FF2B5EF4-FFF2-40B4-BE49-F238E27FC236}">
-                <a16:creationId xmlns:a16="http://schemas.microsoft.com/office/drawing/2014/main" id="{33F96073-B7EB-40C6-A918-7CC01D389453}"/>
+                <a16:creationId xmlns:a16="http://schemas.microsoft.com/office/drawing/2014/main" id="{381482D4-B43A-4C08-A15F-CD15E4F273F5}"/>
               </a:ext>
             </a:extLst>
           </p:cNvPr>
@@ -12597,7 +12597,7 @@
           <p:cNvPr id="26" name="">
             <a:extLst xmlns:a="http://schemas.openxmlformats.org/drawingml/2006/main">
               <a:ext uri="{FF2B5EF4-FFF2-40B4-BE49-F238E27FC236}">
-                <a16:creationId xmlns:a16="http://schemas.microsoft.com/office/drawing/2014/main" id="{557E0E02-825F-4DB7-AD4C-BE5EB6CB2D17}"/>
+                <a16:creationId xmlns:a16="http://schemas.microsoft.com/office/drawing/2014/main" id="{93600937-5934-4122-997E-98CCB706C965}"/>
               </a:ext>
             </a:extLst>
           </p:cNvPr>
@@ -12642,7 +12642,7 @@
           <p:cNvPr id="27" name="">
             <a:extLst xmlns:a="http://schemas.openxmlformats.org/drawingml/2006/main">
               <a:ext uri="{FF2B5EF4-FFF2-40B4-BE49-F238E27FC236}">
-                <a16:creationId xmlns:a16="http://schemas.microsoft.com/office/drawing/2014/main" id="{47C29502-A985-4AD3-A5FF-FFA19FCF236A}"/>
+                <a16:creationId xmlns:a16="http://schemas.microsoft.com/office/drawing/2014/main" id="{66C33E90-BB5A-4008-B8A6-17D2D376A043}"/>
               </a:ext>
             </a:extLst>
           </p:cNvPr>
@@ -12687,7 +12687,7 @@
           <p:cNvPr id="28" name="">
             <a:extLst xmlns:a="http://schemas.openxmlformats.org/drawingml/2006/main">
               <a:ext uri="{FF2B5EF4-FFF2-40B4-BE49-F238E27FC236}">
-                <a16:creationId xmlns:a16="http://schemas.microsoft.com/office/drawing/2014/main" id="{97F098B0-B51A-4C18-B3D9-DE4B11B428D5}"/>
+                <a16:creationId xmlns:a16="http://schemas.microsoft.com/office/drawing/2014/main" id="{3BCB35D9-E6FC-4F62-83F3-8A639FF9A311}"/>
               </a:ext>
             </a:extLst>
           </p:cNvPr>
@@ -12732,7 +12732,7 @@
           <p:cNvPr id="29" name="footer-left">
             <a:extLst xmlns:a="http://schemas.openxmlformats.org/drawingml/2006/main">
               <a:ext uri="{FF2B5EF4-FFF2-40B4-BE49-F238E27FC236}">
-                <a16:creationId xmlns:a16="http://schemas.microsoft.com/office/drawing/2014/main" id="{EF42E7DB-1DB3-49A0-92B4-4BCC296FAFDC}"/>
+                <a16:creationId xmlns:a16="http://schemas.microsoft.com/office/drawing/2014/main" id="{131E3BEA-E909-4917-84A8-61DD8189B1EF}"/>
               </a:ext>
             </a:extLst>
           </p:cNvPr>
@@ -12777,7 +12777,7 @@
           <p:cNvPr id="30" name="footer-right">
             <a:extLst xmlns:a="http://schemas.openxmlformats.org/drawingml/2006/main">
               <a:ext uri="{FF2B5EF4-FFF2-40B4-BE49-F238E27FC236}">
-                <a16:creationId xmlns:a16="http://schemas.microsoft.com/office/drawing/2014/main" id="{6F010858-0B8D-4448-A931-6AE3157C9DD2}"/>
+                <a16:creationId xmlns:a16="http://schemas.microsoft.com/office/drawing/2014/main" id="{62DC2385-C01E-4E0F-AD2F-CFD0D2FAD5FD}"/>
               </a:ext>
             </a:extLst>
           </p:cNvPr>
@@ -12820,7 +12820,7 @@
     </p:spTree>
     <p:extLst>
       <p:ext uri="{BB962C8B-B14F-4D97-AF65-F5344CB8AC3E}">
-        <p14:creationId xmlns:p14="http://schemas.microsoft.com/office/powerpoint/2010/main" val="1709959069"/>
+        <p14:creationId xmlns:p14="http://schemas.microsoft.com/office/powerpoint/2010/main" val="958354899"/>
       </p:ext>
     </p:extLst>
   </p:cSld>
@@ -12844,7 +12844,7 @@
           <p:cNvPr id="1" name="slide-stage">
             <a:extLst xmlns:a="http://schemas.openxmlformats.org/drawingml/2006/main">
               <a:ext uri="{FF2B5EF4-FFF2-40B4-BE49-F238E27FC236}">
-                <a16:creationId xmlns:a16="http://schemas.microsoft.com/office/drawing/2014/main" id="{3A97C73C-2A5E-4DBB-9AE7-2E3497F8A115}"/>
+                <a16:creationId xmlns:a16="http://schemas.microsoft.com/office/drawing/2014/main" id="{2CDD7FA8-360F-4FDB-9AB0-0CE680B1FCDB}"/>
               </a:ext>
             </a:extLst>
           </p:cNvPr>
@@ -12871,7 +12871,7 @@
           <p:cNvPr id="2" name="eyebrow">
             <a:extLst xmlns:a="http://schemas.openxmlformats.org/drawingml/2006/main">
               <a:ext uri="{FF2B5EF4-FFF2-40B4-BE49-F238E27FC236}">
-                <a16:creationId xmlns:a16="http://schemas.microsoft.com/office/drawing/2014/main" id="{BF7872AA-5E6C-439D-BD47-22661431AAE9}"/>
+                <a16:creationId xmlns:a16="http://schemas.microsoft.com/office/drawing/2014/main" id="{4EB9B470-A996-4697-A4D0-F58BA2915B82}"/>
               </a:ext>
             </a:extLst>
           </p:cNvPr>
@@ -12916,7 +12916,7 @@
           <p:cNvPr id="3" name="slide-title">
             <a:extLst xmlns:a="http://schemas.openxmlformats.org/drawingml/2006/main">
               <a:ext uri="{FF2B5EF4-FFF2-40B4-BE49-F238E27FC236}">
-                <a16:creationId xmlns:a16="http://schemas.microsoft.com/office/drawing/2014/main" id="{C6A521E4-2AB2-4B21-B6E6-EA7F5576D2B7}"/>
+                <a16:creationId xmlns:a16="http://schemas.microsoft.com/office/drawing/2014/main" id="{F66FEE5A-A410-4473-BE0B-192AF6E5936D}"/>
               </a:ext>
             </a:extLst>
           </p:cNvPr>
@@ -12961,7 +12961,7 @@
           <p:cNvPr id="4" name="slide-subtitle">
             <a:extLst xmlns:a="http://schemas.openxmlformats.org/drawingml/2006/main">
               <a:ext uri="{FF2B5EF4-FFF2-40B4-BE49-F238E27FC236}">
-                <a16:creationId xmlns:a16="http://schemas.microsoft.com/office/drawing/2014/main" id="{93C78758-B8D6-4C9F-B911-37DEB5D9D54F}"/>
+                <a16:creationId xmlns:a16="http://schemas.microsoft.com/office/drawing/2014/main" id="{3A47F8C3-2C68-4402-92E5-A896B3A9197F}"/>
               </a:ext>
             </a:extLst>
           </p:cNvPr>
@@ -13006,7 +13006,7 @@
           <p:cNvPr id="5" name="">
             <a:extLst xmlns:a="http://schemas.openxmlformats.org/drawingml/2006/main">
               <a:ext uri="{FF2B5EF4-FFF2-40B4-BE49-F238E27FC236}">
-                <a16:creationId xmlns:a16="http://schemas.microsoft.com/office/drawing/2014/main" id="{55C0655F-BBB3-4850-9CC9-D47733885856}"/>
+                <a16:creationId xmlns:a16="http://schemas.microsoft.com/office/drawing/2014/main" id="{C3FDD026-EF51-412A-B334-03E7C193A379}"/>
               </a:ext>
             </a:extLst>
           </p:cNvPr>
@@ -13051,7 +13051,7 @@
           <p:cNvPr id="6" name="">
             <a:extLst xmlns:a="http://schemas.openxmlformats.org/drawingml/2006/main">
               <a:ext uri="{FF2B5EF4-FFF2-40B4-BE49-F238E27FC236}">
-                <a16:creationId xmlns:a16="http://schemas.microsoft.com/office/drawing/2014/main" id="{5EE24EC3-5FC3-4E4E-8A33-C79E6E18D367}"/>
+                <a16:creationId xmlns:a16="http://schemas.microsoft.com/office/drawing/2014/main" id="{A58B9FE9-1265-4668-9033-62922A93309A}"/>
               </a:ext>
             </a:extLst>
           </p:cNvPr>
@@ -13086,7 +13086,7 @@
           <p:cNvPr id="7" name="">
             <a:extLst xmlns:a="http://schemas.openxmlformats.org/drawingml/2006/main">
               <a:ext uri="{FF2B5EF4-FFF2-40B4-BE49-F238E27FC236}">
-                <a16:creationId xmlns:a16="http://schemas.microsoft.com/office/drawing/2014/main" id="{B4645925-1DC7-4010-B3BD-EE6F46ED3FFE}"/>
+                <a16:creationId xmlns:a16="http://schemas.microsoft.com/office/drawing/2014/main" id="{95DD21D9-FF15-4D22-AE60-15EF918E3F9A}"/>
               </a:ext>
             </a:extLst>
           </p:cNvPr>
@@ -13131,7 +13131,7 @@
           <p:cNvPr id="8" name="">
             <a:extLst xmlns:a="http://schemas.openxmlformats.org/drawingml/2006/main">
               <a:ext uri="{FF2B5EF4-FFF2-40B4-BE49-F238E27FC236}">
-                <a16:creationId xmlns:a16="http://schemas.microsoft.com/office/drawing/2014/main" id="{258CA39A-F775-42A7-A896-20C67BDECC09}"/>
+                <a16:creationId xmlns:a16="http://schemas.microsoft.com/office/drawing/2014/main" id="{FC209B56-4DC9-4E9C-B00D-EB1457C57E9B}"/>
               </a:ext>
             </a:extLst>
           </p:cNvPr>
@@ -13176,7 +13176,7 @@
           <p:cNvPr id="9" name="">
             <a:extLst xmlns:a="http://schemas.openxmlformats.org/drawingml/2006/main">
               <a:ext uri="{FF2B5EF4-FFF2-40B4-BE49-F238E27FC236}">
-                <a16:creationId xmlns:a16="http://schemas.microsoft.com/office/drawing/2014/main" id="{03D82BD8-1411-4960-8DA9-36D45351D376}"/>
+                <a16:creationId xmlns:a16="http://schemas.microsoft.com/office/drawing/2014/main" id="{05FCE56F-5D2D-4724-86DB-54DF860A01CC}"/>
               </a:ext>
             </a:extLst>
           </p:cNvPr>
@@ -13221,7 +13221,7 @@
           <p:cNvPr id="10" name="">
             <a:extLst xmlns:a="http://schemas.openxmlformats.org/drawingml/2006/main">
               <a:ext uri="{FF2B5EF4-FFF2-40B4-BE49-F238E27FC236}">
-                <a16:creationId xmlns:a16="http://schemas.microsoft.com/office/drawing/2014/main" id="{208FF9DC-C512-4281-BB7E-93A5A25688B7}"/>
+                <a16:creationId xmlns:a16="http://schemas.microsoft.com/office/drawing/2014/main" id="{29B149CA-CC17-4CC1-9AC4-A5B345727866}"/>
               </a:ext>
             </a:extLst>
           </p:cNvPr>
@@ -13256,7 +13256,7 @@
           <p:cNvPr id="11" name="">
             <a:extLst xmlns:a="http://schemas.openxmlformats.org/drawingml/2006/main">
               <a:ext uri="{FF2B5EF4-FFF2-40B4-BE49-F238E27FC236}">
-                <a16:creationId xmlns:a16="http://schemas.microsoft.com/office/drawing/2014/main" id="{5C2146D8-9C5E-41A2-BDD5-1EBC0CD398FE}"/>
+                <a16:creationId xmlns:a16="http://schemas.microsoft.com/office/drawing/2014/main" id="{3BB35756-302B-4B15-9750-098752D13D1E}"/>
               </a:ext>
             </a:extLst>
           </p:cNvPr>
@@ -13301,7 +13301,7 @@
           <p:cNvPr id="12" name="">
             <a:extLst xmlns:a="http://schemas.openxmlformats.org/drawingml/2006/main">
               <a:ext uri="{FF2B5EF4-FFF2-40B4-BE49-F238E27FC236}">
-                <a16:creationId xmlns:a16="http://schemas.microsoft.com/office/drawing/2014/main" id="{F09F58E8-0DEA-4FA7-A2AE-EEC23D559C23}"/>
+                <a16:creationId xmlns:a16="http://schemas.microsoft.com/office/drawing/2014/main" id="{3CA9CED3-61F7-4DC6-B81C-4284B3FC4292}"/>
               </a:ext>
             </a:extLst>
           </p:cNvPr>
@@ -13346,7 +13346,7 @@
           <p:cNvPr id="13" name="">
             <a:extLst xmlns:a="http://schemas.openxmlformats.org/drawingml/2006/main">
               <a:ext uri="{FF2B5EF4-FFF2-40B4-BE49-F238E27FC236}">
-                <a16:creationId xmlns:a16="http://schemas.microsoft.com/office/drawing/2014/main" id="{CB1E1A42-2B22-4243-A327-9BC2B17F43BF}"/>
+                <a16:creationId xmlns:a16="http://schemas.microsoft.com/office/drawing/2014/main" id="{C736A5B6-74B6-48B3-9FFD-45C80183ECE4}"/>
               </a:ext>
             </a:extLst>
           </p:cNvPr>
@@ -13391,7 +13391,7 @@
           <p:cNvPr id="14" name="">
             <a:extLst xmlns:a="http://schemas.openxmlformats.org/drawingml/2006/main">
               <a:ext uri="{FF2B5EF4-FFF2-40B4-BE49-F238E27FC236}">
-                <a16:creationId xmlns:a16="http://schemas.microsoft.com/office/drawing/2014/main" id="{0608B602-A3BB-4324-AEF0-2F52C916EAFA}"/>
+                <a16:creationId xmlns:a16="http://schemas.microsoft.com/office/drawing/2014/main" id="{94392A34-A8AC-4961-8A5F-7A8AE62262A9}"/>
               </a:ext>
             </a:extLst>
           </p:cNvPr>
@@ -13426,7 +13426,7 @@
           <p:cNvPr id="15" name="">
             <a:extLst xmlns:a="http://schemas.openxmlformats.org/drawingml/2006/main">
               <a:ext uri="{FF2B5EF4-FFF2-40B4-BE49-F238E27FC236}">
-                <a16:creationId xmlns:a16="http://schemas.microsoft.com/office/drawing/2014/main" id="{DC2E31E8-CF81-4F02-969D-08FFD606B97B}"/>
+                <a16:creationId xmlns:a16="http://schemas.microsoft.com/office/drawing/2014/main" id="{F94BB3B6-7358-4259-ABE1-69250AD7E0A0}"/>
               </a:ext>
             </a:extLst>
           </p:cNvPr>
@@ -13471,7 +13471,7 @@
           <p:cNvPr id="16" name="">
             <a:extLst xmlns:a="http://schemas.openxmlformats.org/drawingml/2006/main">
               <a:ext uri="{FF2B5EF4-FFF2-40B4-BE49-F238E27FC236}">
-                <a16:creationId xmlns:a16="http://schemas.microsoft.com/office/drawing/2014/main" id="{09FC762F-42BD-4518-9E44-F214E39BA288}"/>
+                <a16:creationId xmlns:a16="http://schemas.microsoft.com/office/drawing/2014/main" id="{38178A79-8A0E-4A92-A1AE-9A7E468206AD}"/>
               </a:ext>
             </a:extLst>
           </p:cNvPr>
@@ -13516,7 +13516,7 @@
           <p:cNvPr id="17" name="">
             <a:extLst xmlns:a="http://schemas.openxmlformats.org/drawingml/2006/main">
               <a:ext uri="{FF2B5EF4-FFF2-40B4-BE49-F238E27FC236}">
-                <a16:creationId xmlns:a16="http://schemas.microsoft.com/office/drawing/2014/main" id="{08325A62-3326-47F8-8B79-8E9EF1FABB58}"/>
+                <a16:creationId xmlns:a16="http://schemas.microsoft.com/office/drawing/2014/main" id="{569BC58E-80B8-4D98-8E2B-0721F76BC9D1}"/>
               </a:ext>
             </a:extLst>
           </p:cNvPr>
@@ -13561,7 +13561,7 @@
           <p:cNvPr id="18" name="">
             <a:extLst xmlns:a="http://schemas.openxmlformats.org/drawingml/2006/main">
               <a:ext uri="{FF2B5EF4-FFF2-40B4-BE49-F238E27FC236}">
-                <a16:creationId xmlns:a16="http://schemas.microsoft.com/office/drawing/2014/main" id="{167295AF-E49C-4869-A5B2-7D4DAAC8F112}"/>
+                <a16:creationId xmlns:a16="http://schemas.microsoft.com/office/drawing/2014/main" id="{91175B3F-8BCC-4F67-B388-45A33FCBDB78}"/>
               </a:ext>
             </a:extLst>
           </p:cNvPr>
@@ -13596,7 +13596,7 @@
           <p:cNvPr id="19" name="">
             <a:extLst xmlns:a="http://schemas.openxmlformats.org/drawingml/2006/main">
               <a:ext uri="{FF2B5EF4-FFF2-40B4-BE49-F238E27FC236}">
-                <a16:creationId xmlns:a16="http://schemas.microsoft.com/office/drawing/2014/main" id="{55637AB9-6290-4DF9-9608-5A4B7D0D7E0F}"/>
+                <a16:creationId xmlns:a16="http://schemas.microsoft.com/office/drawing/2014/main" id="{983CCAA8-0CE5-463F-AE8C-77C7548FCF89}"/>
               </a:ext>
             </a:extLst>
           </p:cNvPr>
@@ -13641,7 +13641,7 @@
           <p:cNvPr id="20" name="">
             <a:extLst xmlns:a="http://schemas.openxmlformats.org/drawingml/2006/main">
               <a:ext uri="{FF2B5EF4-FFF2-40B4-BE49-F238E27FC236}">
-                <a16:creationId xmlns:a16="http://schemas.microsoft.com/office/drawing/2014/main" id="{3434EFD6-DDF7-4B6C-A370-6221ECC38791}"/>
+                <a16:creationId xmlns:a16="http://schemas.microsoft.com/office/drawing/2014/main" id="{E2A760BC-F9A8-426B-9549-6A06B0B049D4}"/>
               </a:ext>
             </a:extLst>
           </p:cNvPr>
@@ -13686,7 +13686,7 @@
           <p:cNvPr id="21" name="">
             <a:extLst xmlns:a="http://schemas.openxmlformats.org/drawingml/2006/main">
               <a:ext uri="{FF2B5EF4-FFF2-40B4-BE49-F238E27FC236}">
-                <a16:creationId xmlns:a16="http://schemas.microsoft.com/office/drawing/2014/main" id="{44E38062-A2F0-4CDA-9CE6-D6FBA826D19A}"/>
+                <a16:creationId xmlns:a16="http://schemas.microsoft.com/office/drawing/2014/main" id="{235FD54C-038E-4613-88C2-201D24E005F0}"/>
               </a:ext>
             </a:extLst>
           </p:cNvPr>
@@ -13731,7 +13731,7 @@
           <p:cNvPr id="22" name="">
             <a:extLst xmlns:a="http://schemas.openxmlformats.org/drawingml/2006/main">
               <a:ext uri="{FF2B5EF4-FFF2-40B4-BE49-F238E27FC236}">
-                <a16:creationId xmlns:a16="http://schemas.microsoft.com/office/drawing/2014/main" id="{EB35EAD2-2CBF-4EAF-BE8A-24422B51968F}"/>
+                <a16:creationId xmlns:a16="http://schemas.microsoft.com/office/drawing/2014/main" id="{049CE8BE-6CB3-490C-9FD1-5D20738B6D9C}"/>
               </a:ext>
             </a:extLst>
           </p:cNvPr>
@@ -13766,7 +13766,7 @@
           <p:cNvPr id="23" name="">
             <a:extLst xmlns:a="http://schemas.openxmlformats.org/drawingml/2006/main">
               <a:ext uri="{FF2B5EF4-FFF2-40B4-BE49-F238E27FC236}">
-                <a16:creationId xmlns:a16="http://schemas.microsoft.com/office/drawing/2014/main" id="{16D7CB45-573F-48DF-A5AF-89A2D22F5513}"/>
+                <a16:creationId xmlns:a16="http://schemas.microsoft.com/office/drawing/2014/main" id="{7B80C1EB-04A6-43EB-9903-2E5F2D986389}"/>
               </a:ext>
             </a:extLst>
           </p:cNvPr>
@@ -13811,7 +13811,7 @@
           <p:cNvPr id="24" name="">
             <a:extLst xmlns:a="http://schemas.openxmlformats.org/drawingml/2006/main">
               <a:ext uri="{FF2B5EF4-FFF2-40B4-BE49-F238E27FC236}">
-                <a16:creationId xmlns:a16="http://schemas.microsoft.com/office/drawing/2014/main" id="{16B87813-F6FE-4225-A9CD-F2898248FF06}"/>
+                <a16:creationId xmlns:a16="http://schemas.microsoft.com/office/drawing/2014/main" id="{675FCCAF-50B7-430D-98B6-E21D87F933B4}"/>
               </a:ext>
             </a:extLst>
           </p:cNvPr>
@@ -13856,7 +13856,7 @@
           <p:cNvPr id="25" name="footer-left">
             <a:extLst xmlns:a="http://schemas.openxmlformats.org/drawingml/2006/main">
               <a:ext uri="{FF2B5EF4-FFF2-40B4-BE49-F238E27FC236}">
-                <a16:creationId xmlns:a16="http://schemas.microsoft.com/office/drawing/2014/main" id="{F6F84BB9-2049-4CA6-AFDB-2328E9C5AB0B}"/>
+                <a16:creationId xmlns:a16="http://schemas.microsoft.com/office/drawing/2014/main" id="{1C278BB4-F8D3-4150-9886-7108685CBC1A}"/>
               </a:ext>
             </a:extLst>
           </p:cNvPr>
@@ -13901,7 +13901,7 @@
           <p:cNvPr id="26" name="footer-right">
             <a:extLst xmlns:a="http://schemas.openxmlformats.org/drawingml/2006/main">
               <a:ext uri="{FF2B5EF4-FFF2-40B4-BE49-F238E27FC236}">
-                <a16:creationId xmlns:a16="http://schemas.microsoft.com/office/drawing/2014/main" id="{DAC44826-AD5C-458D-A496-EAC92A6E1D23}"/>
+                <a16:creationId xmlns:a16="http://schemas.microsoft.com/office/drawing/2014/main" id="{E5027CB2-9F4A-4633-B688-7045BC922AB7}"/>
               </a:ext>
             </a:extLst>
           </p:cNvPr>
@@ -13944,7 +13944,7 @@
     </p:spTree>
     <p:extLst>
       <p:ext uri="{BB962C8B-B14F-4D97-AF65-F5344CB8AC3E}">
-        <p14:creationId xmlns:p14="http://schemas.microsoft.com/office/powerpoint/2010/main" val="681628013"/>
+        <p14:creationId xmlns:p14="http://schemas.microsoft.com/office/powerpoint/2010/main" val="1595865237"/>
       </p:ext>
     </p:extLst>
   </p:cSld>
@@ -13968,7 +13968,7 @@
           <p:cNvPr id="1" name="slide-stage">
             <a:extLst xmlns:a="http://schemas.openxmlformats.org/drawingml/2006/main">
               <a:ext uri="{FF2B5EF4-FFF2-40B4-BE49-F238E27FC236}">
-                <a16:creationId xmlns:a16="http://schemas.microsoft.com/office/drawing/2014/main" id="{5A3DEFAD-0C1F-4591-9951-C326151B85D4}"/>
+                <a16:creationId xmlns:a16="http://schemas.microsoft.com/office/drawing/2014/main" id="{545C30B7-5297-4D99-8FE7-CE2586321832}"/>
               </a:ext>
             </a:extLst>
           </p:cNvPr>
@@ -13995,7 +13995,7 @@
           <p:cNvPr id="2" name="eyebrow">
             <a:extLst xmlns:a="http://schemas.openxmlformats.org/drawingml/2006/main">
               <a:ext uri="{FF2B5EF4-FFF2-40B4-BE49-F238E27FC236}">
-                <a16:creationId xmlns:a16="http://schemas.microsoft.com/office/drawing/2014/main" id="{69C93D37-FD5C-4B11-B4EB-081A440250E8}"/>
+                <a16:creationId xmlns:a16="http://schemas.microsoft.com/office/drawing/2014/main" id="{B4CF184E-8FF0-4929-B4C3-AA3EBF30D994}"/>
               </a:ext>
             </a:extLst>
           </p:cNvPr>
@@ -14040,7 +14040,7 @@
           <p:cNvPr id="3" name="slide-title">
             <a:extLst xmlns:a="http://schemas.openxmlformats.org/drawingml/2006/main">
               <a:ext uri="{FF2B5EF4-FFF2-40B4-BE49-F238E27FC236}">
-                <a16:creationId xmlns:a16="http://schemas.microsoft.com/office/drawing/2014/main" id="{4F29F39E-39B8-4B44-ADD2-AAE0654795C4}"/>
+                <a16:creationId xmlns:a16="http://schemas.microsoft.com/office/drawing/2014/main" id="{30A410B2-F410-43CD-9793-13291A226616}"/>
               </a:ext>
             </a:extLst>
           </p:cNvPr>
@@ -14085,7 +14085,7 @@
           <p:cNvPr id="4" name="slide-subtitle">
             <a:extLst xmlns:a="http://schemas.openxmlformats.org/drawingml/2006/main">
               <a:ext uri="{FF2B5EF4-FFF2-40B4-BE49-F238E27FC236}">
-                <a16:creationId xmlns:a16="http://schemas.microsoft.com/office/drawing/2014/main" id="{233F3427-046B-4D62-A08B-4AA99B59AF6D}"/>
+                <a16:creationId xmlns:a16="http://schemas.microsoft.com/office/drawing/2014/main" id="{D11F2B85-9087-4BF1-ACB9-1282976762A8}"/>
               </a:ext>
             </a:extLst>
           </p:cNvPr>
@@ -14130,7 +14130,7 @@
           <p:cNvPr id="5" name="">
             <a:extLst xmlns:a="http://schemas.openxmlformats.org/drawingml/2006/main">
               <a:ext uri="{FF2B5EF4-FFF2-40B4-BE49-F238E27FC236}">
-                <a16:creationId xmlns:a16="http://schemas.microsoft.com/office/drawing/2014/main" id="{BB09B9F9-C14D-4326-B0E4-362BE40A4E65}"/>
+                <a16:creationId xmlns:a16="http://schemas.microsoft.com/office/drawing/2014/main" id="{A91D3969-99FB-4BD8-8FFF-7BC83A0A97BB}"/>
               </a:ext>
             </a:extLst>
           </p:cNvPr>
@@ -14163,7 +14163,7 @@
           <p:cNvPr id="6" name="">
             <a:extLst xmlns:a="http://schemas.openxmlformats.org/drawingml/2006/main">
               <a:ext uri="{FF2B5EF4-FFF2-40B4-BE49-F238E27FC236}">
-                <a16:creationId xmlns:a16="http://schemas.microsoft.com/office/drawing/2014/main" id="{9944E821-20EE-411E-A7D7-8FC3036CE8DB}"/>
+                <a16:creationId xmlns:a16="http://schemas.microsoft.com/office/drawing/2014/main" id="{60F1E0C6-5B77-4AA3-9F64-60FDD5BDEDFF}"/>
               </a:ext>
             </a:extLst>
           </p:cNvPr>
@@ -14208,7 +14208,7 @@
           <p:cNvPr id="7" name="">
             <a:extLst xmlns:a="http://schemas.openxmlformats.org/drawingml/2006/main">
               <a:ext uri="{FF2B5EF4-FFF2-40B4-BE49-F238E27FC236}">
-                <a16:creationId xmlns:a16="http://schemas.microsoft.com/office/drawing/2014/main" id="{1F4815E9-B313-48A6-A522-9A477BF80267}"/>
+                <a16:creationId xmlns:a16="http://schemas.microsoft.com/office/drawing/2014/main" id="{2046FAA1-81BE-4EE8-AB93-D873FB3E5EBA}"/>
               </a:ext>
             </a:extLst>
           </p:cNvPr>
@@ -14253,7 +14253,7 @@
           <p:cNvPr id="8" name="">
             <a:extLst xmlns:a="http://schemas.openxmlformats.org/drawingml/2006/main">
               <a:ext uri="{FF2B5EF4-FFF2-40B4-BE49-F238E27FC236}">
-                <a16:creationId xmlns:a16="http://schemas.microsoft.com/office/drawing/2014/main" id="{623945C9-82F7-4BE8-96D2-C333A1F4AD0E}"/>
+                <a16:creationId xmlns:a16="http://schemas.microsoft.com/office/drawing/2014/main" id="{DF177FD9-A539-4095-B49A-00E2245A58E9}"/>
               </a:ext>
             </a:extLst>
           </p:cNvPr>
@@ -14286,7 +14286,7 @@
           <p:cNvPr id="9" name="">
             <a:extLst xmlns:a="http://schemas.openxmlformats.org/drawingml/2006/main">
               <a:ext uri="{FF2B5EF4-FFF2-40B4-BE49-F238E27FC236}">
-                <a16:creationId xmlns:a16="http://schemas.microsoft.com/office/drawing/2014/main" id="{4C150DF1-6FE4-48FE-8675-5919EDBCF40E}"/>
+                <a16:creationId xmlns:a16="http://schemas.microsoft.com/office/drawing/2014/main" id="{1D994284-C081-46C0-A782-3DFAD986B57F}"/>
               </a:ext>
             </a:extLst>
           </p:cNvPr>
@@ -14331,7 +14331,7 @@
           <p:cNvPr id="10" name="">
             <a:extLst xmlns:a="http://schemas.openxmlformats.org/drawingml/2006/main">
               <a:ext uri="{FF2B5EF4-FFF2-40B4-BE49-F238E27FC236}">
-                <a16:creationId xmlns:a16="http://schemas.microsoft.com/office/drawing/2014/main" id="{A3DE4534-B536-4F06-A90D-9D9503CD8ACD}"/>
+                <a16:creationId xmlns:a16="http://schemas.microsoft.com/office/drawing/2014/main" id="{6E413642-3DD1-48FF-B906-88D5B7026953}"/>
               </a:ext>
             </a:extLst>
           </p:cNvPr>
@@ -14376,7 +14376,7 @@
           <p:cNvPr id="11" name="">
             <a:extLst xmlns:a="http://schemas.openxmlformats.org/drawingml/2006/main">
               <a:ext uri="{FF2B5EF4-FFF2-40B4-BE49-F238E27FC236}">
-                <a16:creationId xmlns:a16="http://schemas.microsoft.com/office/drawing/2014/main" id="{90FFE7A4-3AEF-4D41-AF51-95904085FBD1}"/>
+                <a16:creationId xmlns:a16="http://schemas.microsoft.com/office/drawing/2014/main" id="{F5C1FC5D-265A-4DE0-B0F4-56D118B2FA1B}"/>
               </a:ext>
             </a:extLst>
           </p:cNvPr>
@@ -14388,7 +14388,7 @@
         <p:spPr>
           <a:xfrm xmlns:a="http://schemas.openxmlformats.org/drawingml/2006/main">
             <a:off x="781050" y="4324350"/>
-            <a:ext cx="8143875" cy="1116330"/>
+            <a:ext cx="8143875" cy="899160"/>
           </a:xfrm>
           <a:prstGeom xmlns:a="http://schemas.openxmlformats.org/drawingml/2006/main" prst="rect">
             <a:avLst/>
@@ -14409,7 +14409,7 @@
           <p:cNvPr id="12" name="">
             <a:extLst xmlns:a="http://schemas.openxmlformats.org/drawingml/2006/main">
               <a:ext uri="{FF2B5EF4-FFF2-40B4-BE49-F238E27FC236}">
-                <a16:creationId xmlns:a16="http://schemas.microsoft.com/office/drawing/2014/main" id="{BD2A06AA-1FD5-4052-950E-2E4100B436EE}"/>
+                <a16:creationId xmlns:a16="http://schemas.microsoft.com/office/drawing/2014/main" id="{05FDA49C-2F0D-4E81-BCF9-BFB9B9FD36DB}"/>
               </a:ext>
             </a:extLst>
           </p:cNvPr>
@@ -14444,7 +14444,7 @@
                   <a:srgbClr val="2364AA"/>
                 </a:solidFill>
               </a:rPr>
-              <a:t>Patient message</a:t>
+              <a:t>Human factors</a:t>
             </a:r>
           </a:p>
         </p:txBody>
@@ -14454,7 +14454,7 @@
           <p:cNvPr id="13" name="">
             <a:extLst xmlns:a="http://schemas.openxmlformats.org/drawingml/2006/main">
               <a:ext uri="{FF2B5EF4-FFF2-40B4-BE49-F238E27FC236}">
-                <a16:creationId xmlns:a16="http://schemas.microsoft.com/office/drawing/2014/main" id="{A4E9B975-8FB7-4199-9199-733CA3CC16F9}"/>
+                <a16:creationId xmlns:a16="http://schemas.microsoft.com/office/drawing/2014/main" id="{17082FE9-500A-4BD0-9BE0-F052188ADD63}"/>
               </a:ext>
             </a:extLst>
           </p:cNvPr>
@@ -14466,7 +14466,7 @@
         <p:spPr>
           <a:xfrm xmlns:a="http://schemas.openxmlformats.org/drawingml/2006/main">
             <a:off x="990600" y="4838700"/>
-            <a:ext cx="7734300" cy="438150"/>
+            <a:ext cx="7734300" cy="228600"/>
           </a:xfrm>
           <a:prstGeom xmlns:a="http://schemas.openxmlformats.org/drawingml/2006/main" prst="rect">
             <a:avLst/>
@@ -14489,7 +14489,7 @@
                   <a:srgbClr val="52677A"/>
                 </a:solidFill>
               </a:rPr>
-              <a:t>Safety language that addresses cost, fear, embarrassment, stigma, work, or delay without downgrading risk.</a:t>
+              <a:t>Defense/disclosure cues become inference limits and next-question strategy, not patient labels.</a:t>
             </a:r>
           </a:p>
         </p:txBody>
@@ -14499,7 +14499,7 @@
           <p:cNvPr id="14" name="">
             <a:extLst xmlns:a="http://schemas.openxmlformats.org/drawingml/2006/main">
               <a:ext uri="{FF2B5EF4-FFF2-40B4-BE49-F238E27FC236}">
-                <a16:creationId xmlns:a16="http://schemas.microsoft.com/office/drawing/2014/main" id="{EEB9EFBE-5365-4E56-B288-A11F8E2E1626}"/>
+                <a16:creationId xmlns:a16="http://schemas.microsoft.com/office/drawing/2014/main" id="{4C0C0463-C5AB-453E-82D1-4FD04497CDD9}"/>
               </a:ext>
             </a:extLst>
           </p:cNvPr>
@@ -14532,7 +14532,7 @@
           <p:cNvPr id="15" name="">
             <a:extLst xmlns:a="http://schemas.openxmlformats.org/drawingml/2006/main">
               <a:ext uri="{FF2B5EF4-FFF2-40B4-BE49-F238E27FC236}">
-                <a16:creationId xmlns:a16="http://schemas.microsoft.com/office/drawing/2014/main" id="{AC0D2222-EBEF-42BE-92E4-3E4FF9E66A49}"/>
+                <a16:creationId xmlns:a16="http://schemas.microsoft.com/office/drawing/2014/main" id="{5AD65D07-5227-4A57-87DC-4C60A7BBD130}"/>
               </a:ext>
             </a:extLst>
           </p:cNvPr>
@@ -14577,7 +14577,7 @@
           <p:cNvPr id="16" name="">
             <a:extLst xmlns:a="http://schemas.openxmlformats.org/drawingml/2006/main">
               <a:ext uri="{FF2B5EF4-FFF2-40B4-BE49-F238E27FC236}">
-                <a16:creationId xmlns:a16="http://schemas.microsoft.com/office/drawing/2014/main" id="{8D717607-9744-488E-B6AB-2D3420BB18E2}"/>
+                <a16:creationId xmlns:a16="http://schemas.microsoft.com/office/drawing/2014/main" id="{D106090C-FD9D-4ACF-BB73-961BFC7DD7C7}"/>
               </a:ext>
             </a:extLst>
           </p:cNvPr>
@@ -14622,18 +14622,18 @@
           <p:cNvPr id="17" name="footer-left">
             <a:extLst xmlns:a="http://schemas.openxmlformats.org/drawingml/2006/main">
               <a:ext uri="{FF2B5EF4-FFF2-40B4-BE49-F238E27FC236}">
-                <a16:creationId xmlns:a16="http://schemas.microsoft.com/office/drawing/2014/main" id="{63AC9DB2-DAB3-4B01-8705-94F3CFBD07FB}"/>
-              </a:ext>
-            </a:extLst>
-          </p:cNvPr>
-          <p:cNvSpPr>
-            <a:spLocks xmlns:a="http://schemas.openxmlformats.org/drawingml/2006/main" noGrp="1"/>
-          </p:cNvSpPr>
-          <p:nvPr/>
-        </p:nvSpPr>
-        <p:spPr>
-          <a:xfrm xmlns:a="http://schemas.openxmlformats.org/drawingml/2006/main">
-            <a:off x="781050" y="5734050"/>
+                <a16:creationId xmlns:a16="http://schemas.microsoft.com/office/drawing/2014/main" id="{FA4C2D9F-333D-4858-938F-8A9C2B3FB0DE}"/>
+              </a:ext>
+            </a:extLst>
+          </p:cNvPr>
+          <p:cNvSpPr>
+            <a:spLocks xmlns:a="http://schemas.openxmlformats.org/drawingml/2006/main" noGrp="1"/>
+          </p:cNvSpPr>
+          <p:nvPr/>
+        </p:nvSpPr>
+        <p:spPr>
+          <a:xfrm xmlns:a="http://schemas.openxmlformats.org/drawingml/2006/main">
+            <a:off x="781050" y="5524500"/>
             <a:ext cx="2133600" cy="304800"/>
           </a:xfrm>
           <a:prstGeom xmlns:a="http://schemas.openxmlformats.org/drawingml/2006/main" prst="rect">
@@ -14667,18 +14667,18 @@
           <p:cNvPr id="18" name="footer-right">
             <a:extLst xmlns:a="http://schemas.openxmlformats.org/drawingml/2006/main">
               <a:ext uri="{FF2B5EF4-FFF2-40B4-BE49-F238E27FC236}">
-                <a16:creationId xmlns:a16="http://schemas.microsoft.com/office/drawing/2014/main" id="{91A30CF9-CBF0-47DF-B44A-D908CABAC884}"/>
-              </a:ext>
-            </a:extLst>
-          </p:cNvPr>
-          <p:cNvSpPr>
-            <a:spLocks xmlns:a="http://schemas.openxmlformats.org/drawingml/2006/main" noGrp="1"/>
-          </p:cNvSpPr>
-          <p:nvPr/>
-        </p:nvSpPr>
-        <p:spPr>
-          <a:xfrm xmlns:a="http://schemas.openxmlformats.org/drawingml/2006/main">
-            <a:off x="15030450" y="5886450"/>
+                <a16:creationId xmlns:a16="http://schemas.microsoft.com/office/drawing/2014/main" id="{ED387E88-3E69-4B72-B149-6E278A354815}"/>
+              </a:ext>
+            </a:extLst>
+          </p:cNvPr>
+          <p:cNvSpPr>
+            <a:spLocks xmlns:a="http://schemas.openxmlformats.org/drawingml/2006/main" noGrp="1"/>
+          </p:cNvSpPr>
+          <p:nvPr/>
+        </p:nvSpPr>
+        <p:spPr>
+          <a:xfrm xmlns:a="http://schemas.openxmlformats.org/drawingml/2006/main">
+            <a:off x="15030450" y="5676900"/>
             <a:ext cx="2476500" cy="152400"/>
           </a:xfrm>
           <a:prstGeom xmlns:a="http://schemas.openxmlformats.org/drawingml/2006/main" prst="rect">
@@ -14710,7 +14710,7 @@
     </p:spTree>
     <p:extLst>
       <p:ext uri="{BB962C8B-B14F-4D97-AF65-F5344CB8AC3E}">
-        <p14:creationId xmlns:p14="http://schemas.microsoft.com/office/powerpoint/2010/main" val="2065712235"/>
+        <p14:creationId xmlns:p14="http://schemas.microsoft.com/office/powerpoint/2010/main" val="1343988331"/>
       </p:ext>
     </p:extLst>
   </p:cSld>
@@ -14734,7 +14734,7 @@
           <p:cNvPr id="1" name="slide-stage">
             <a:extLst xmlns:a="http://schemas.openxmlformats.org/drawingml/2006/main">
               <a:ext uri="{FF2B5EF4-FFF2-40B4-BE49-F238E27FC236}">
-                <a16:creationId xmlns:a16="http://schemas.microsoft.com/office/drawing/2014/main" id="{06F7253E-FA2C-4E3A-8EE4-E8DEA18CE21D}"/>
+                <a16:creationId xmlns:a16="http://schemas.microsoft.com/office/drawing/2014/main" id="{5D6FFE3D-8CC8-4DA9-9ADB-2956ACA23437}"/>
               </a:ext>
             </a:extLst>
           </p:cNvPr>
@@ -14761,7 +14761,7 @@
           <p:cNvPr id="2" name="eyebrow">
             <a:extLst xmlns:a="http://schemas.openxmlformats.org/drawingml/2006/main">
               <a:ext uri="{FF2B5EF4-FFF2-40B4-BE49-F238E27FC236}">
-                <a16:creationId xmlns:a16="http://schemas.microsoft.com/office/drawing/2014/main" id="{C951426C-D3FF-4466-AA31-56EDF559950A}"/>
+                <a16:creationId xmlns:a16="http://schemas.microsoft.com/office/drawing/2014/main" id="{F912F1D7-FBF9-42B0-9C01-7648A29E7395}"/>
               </a:ext>
             </a:extLst>
           </p:cNvPr>
@@ -14806,7 +14806,7 @@
           <p:cNvPr id="3" name="slide-title">
             <a:extLst xmlns:a="http://schemas.openxmlformats.org/drawingml/2006/main">
               <a:ext uri="{FF2B5EF4-FFF2-40B4-BE49-F238E27FC236}">
-                <a16:creationId xmlns:a16="http://schemas.microsoft.com/office/drawing/2014/main" id="{8572BE5C-8F29-4D21-8F70-E9EDF0E4032E}"/>
+                <a16:creationId xmlns:a16="http://schemas.microsoft.com/office/drawing/2014/main" id="{C915F550-0B7E-4417-A7E4-FFDC57B5F858}"/>
               </a:ext>
             </a:extLst>
           </p:cNvPr>
@@ -14851,7 +14851,7 @@
           <p:cNvPr id="4" name="slide-subtitle">
             <a:extLst xmlns:a="http://schemas.openxmlformats.org/drawingml/2006/main">
               <a:ext uri="{FF2B5EF4-FFF2-40B4-BE49-F238E27FC236}">
-                <a16:creationId xmlns:a16="http://schemas.microsoft.com/office/drawing/2014/main" id="{515F00C5-2267-41F7-8FFF-F41EE2708384}"/>
+                <a16:creationId xmlns:a16="http://schemas.microsoft.com/office/drawing/2014/main" id="{866776EF-CA8E-40DF-8F15-89594B3770FE}"/>
               </a:ext>
             </a:extLst>
           </p:cNvPr>
@@ -14896,7 +14896,7 @@
           <p:cNvPr id="5" name="">
             <a:extLst xmlns:a="http://schemas.openxmlformats.org/drawingml/2006/main">
               <a:ext uri="{FF2B5EF4-FFF2-40B4-BE49-F238E27FC236}">
-                <a16:creationId xmlns:a16="http://schemas.microsoft.com/office/drawing/2014/main" id="{5A9C3B81-D2F2-4A38-AD4D-30F62B6299B6}"/>
+                <a16:creationId xmlns:a16="http://schemas.microsoft.com/office/drawing/2014/main" id="{C8AB9CE9-AE29-4ABA-83D5-2BD922DB6C51}"/>
               </a:ext>
             </a:extLst>
           </p:cNvPr>
@@ -14941,7 +14941,7 @@
           <p:cNvPr id="6" name="">
             <a:extLst xmlns:a="http://schemas.openxmlformats.org/drawingml/2006/main">
               <a:ext uri="{FF2B5EF4-FFF2-40B4-BE49-F238E27FC236}">
-                <a16:creationId xmlns:a16="http://schemas.microsoft.com/office/drawing/2014/main" id="{FEEA3BA4-38F6-448D-9F5F-78BE1E6A115C}"/>
+                <a16:creationId xmlns:a16="http://schemas.microsoft.com/office/drawing/2014/main" id="{80AC5225-6CC0-4B54-B659-BCDBEFFA879F}"/>
               </a:ext>
             </a:extLst>
           </p:cNvPr>
@@ -14986,7 +14986,7 @@
           <p:cNvPr id="7" name="">
             <a:extLst xmlns:a="http://schemas.openxmlformats.org/drawingml/2006/main">
               <a:ext uri="{FF2B5EF4-FFF2-40B4-BE49-F238E27FC236}">
-                <a16:creationId xmlns:a16="http://schemas.microsoft.com/office/drawing/2014/main" id="{40F9F6F2-2D64-41B8-9B21-AADCA27D642D}"/>
+                <a16:creationId xmlns:a16="http://schemas.microsoft.com/office/drawing/2014/main" id="{2EB92CD5-ED17-4A84-9972-C18215190C6F}"/>
               </a:ext>
             </a:extLst>
           </p:cNvPr>
@@ -15031,7 +15031,7 @@
           <p:cNvPr id="8" name="">
             <a:extLst xmlns:a="http://schemas.openxmlformats.org/drawingml/2006/main">
               <a:ext uri="{FF2B5EF4-FFF2-40B4-BE49-F238E27FC236}">
-                <a16:creationId xmlns:a16="http://schemas.microsoft.com/office/drawing/2014/main" id="{34629908-AC76-4139-B72E-3D6AACB984D8}"/>
+                <a16:creationId xmlns:a16="http://schemas.microsoft.com/office/drawing/2014/main" id="{B975C7A7-3703-4EE8-A3D1-233A945CCF83}"/>
               </a:ext>
             </a:extLst>
           </p:cNvPr>
@@ -15076,7 +15076,7 @@
           <p:cNvPr id="9" name="">
             <a:extLst xmlns:a="http://schemas.openxmlformats.org/drawingml/2006/main">
               <a:ext uri="{FF2B5EF4-FFF2-40B4-BE49-F238E27FC236}">
-                <a16:creationId xmlns:a16="http://schemas.microsoft.com/office/drawing/2014/main" id="{B907B4F5-0202-48A5-AE87-9CF4B1B3F80E}"/>
+                <a16:creationId xmlns:a16="http://schemas.microsoft.com/office/drawing/2014/main" id="{9B75FC6E-C602-4D87-9ABD-4D47811A2D22}"/>
               </a:ext>
             </a:extLst>
           </p:cNvPr>
@@ -15121,7 +15121,7 @@
           <p:cNvPr id="10" name="">
             <a:extLst xmlns:a="http://schemas.openxmlformats.org/drawingml/2006/main">
               <a:ext uri="{FF2B5EF4-FFF2-40B4-BE49-F238E27FC236}">
-                <a16:creationId xmlns:a16="http://schemas.microsoft.com/office/drawing/2014/main" id="{45D89FAF-34C8-4E4D-A794-BA069DED9059}"/>
+                <a16:creationId xmlns:a16="http://schemas.microsoft.com/office/drawing/2014/main" id="{F9CD6EAA-FEF6-45C4-9A98-D0D61D187307}"/>
               </a:ext>
             </a:extLst>
           </p:cNvPr>
@@ -15166,7 +15166,7 @@
           <p:cNvPr id="11" name="">
             <a:extLst xmlns:a="http://schemas.openxmlformats.org/drawingml/2006/main">
               <a:ext uri="{FF2B5EF4-FFF2-40B4-BE49-F238E27FC236}">
-                <a16:creationId xmlns:a16="http://schemas.microsoft.com/office/drawing/2014/main" id="{38AFE96A-7CB4-42C5-A79B-7B759B7A086E}"/>
+                <a16:creationId xmlns:a16="http://schemas.microsoft.com/office/drawing/2014/main" id="{1E6035CC-CD1A-4B85-835E-17111B99FAAD}"/>
               </a:ext>
             </a:extLst>
           </p:cNvPr>
@@ -15201,7 +15201,7 @@
           <p:cNvPr id="12" name="">
             <a:extLst xmlns:a="http://schemas.openxmlformats.org/drawingml/2006/main">
               <a:ext uri="{FF2B5EF4-FFF2-40B4-BE49-F238E27FC236}">
-                <a16:creationId xmlns:a16="http://schemas.microsoft.com/office/drawing/2014/main" id="{0857E012-BA1B-4AB8-9557-F186D635CB10}"/>
+                <a16:creationId xmlns:a16="http://schemas.microsoft.com/office/drawing/2014/main" id="{99AC4B58-6B82-4B3E-9C73-CE44DED457AE}"/>
               </a:ext>
             </a:extLst>
           </p:cNvPr>
@@ -15236,7 +15236,7 @@
                   <a:srgbClr val="08756F"/>
                 </a:solidFill>
               </a:rPr>
-              <a:t>326 tests passed</a:t>
+              <a:t>327 tests passed</a:t>
             </a:r>
           </a:p>
         </p:txBody>
@@ -15246,7 +15246,7 @@
           <p:cNvPr id="13" name="">
             <a:extLst xmlns:a="http://schemas.openxmlformats.org/drawingml/2006/main">
               <a:ext uri="{FF2B5EF4-FFF2-40B4-BE49-F238E27FC236}">
-                <a16:creationId xmlns:a16="http://schemas.microsoft.com/office/drawing/2014/main" id="{FB572BE6-09F5-4102-B50A-DCDD2DE108B5}"/>
+                <a16:creationId xmlns:a16="http://schemas.microsoft.com/office/drawing/2014/main" id="{680A483E-AA61-4707-BE61-1F12949E57DD}"/>
               </a:ext>
             </a:extLst>
           </p:cNvPr>
@@ -15281,7 +15281,7 @@
           <p:cNvPr id="14" name="">
             <a:extLst xmlns:a="http://schemas.openxmlformats.org/drawingml/2006/main">
               <a:ext uri="{FF2B5EF4-FFF2-40B4-BE49-F238E27FC236}">
-                <a16:creationId xmlns:a16="http://schemas.microsoft.com/office/drawing/2014/main" id="{8233B1F2-BE0A-4C38-B138-BE31528CB37C}"/>
+                <a16:creationId xmlns:a16="http://schemas.microsoft.com/office/drawing/2014/main" id="{EE0D142E-6111-4E40-8504-20252862CC55}"/>
               </a:ext>
             </a:extLst>
           </p:cNvPr>
@@ -15326,7 +15326,7 @@
           <p:cNvPr id="15" name="">
             <a:extLst xmlns:a="http://schemas.openxmlformats.org/drawingml/2006/main">
               <a:ext uri="{FF2B5EF4-FFF2-40B4-BE49-F238E27FC236}">
-                <a16:creationId xmlns:a16="http://schemas.microsoft.com/office/drawing/2014/main" id="{BCDF0E7A-56CE-450E-9271-A1DF0D42DC33}"/>
+                <a16:creationId xmlns:a16="http://schemas.microsoft.com/office/drawing/2014/main" id="{5A55A9F7-1CCB-485A-875B-DE21F6E9899E}"/>
               </a:ext>
             </a:extLst>
           </p:cNvPr>
@@ -15361,7 +15361,7 @@
           <p:cNvPr id="16" name="">
             <a:extLst xmlns:a="http://schemas.openxmlformats.org/drawingml/2006/main">
               <a:ext uri="{FF2B5EF4-FFF2-40B4-BE49-F238E27FC236}">
-                <a16:creationId xmlns:a16="http://schemas.microsoft.com/office/drawing/2014/main" id="{08D5510C-BE75-4452-A005-7A43C24936D1}"/>
+                <a16:creationId xmlns:a16="http://schemas.microsoft.com/office/drawing/2014/main" id="{5B4E29EE-6CBE-4DB8-B7F6-9C0D7D14A44E}"/>
               </a:ext>
             </a:extLst>
           </p:cNvPr>
@@ -15406,7 +15406,7 @@
           <p:cNvPr id="17" name="footer-left">
             <a:extLst xmlns:a="http://schemas.openxmlformats.org/drawingml/2006/main">
               <a:ext uri="{FF2B5EF4-FFF2-40B4-BE49-F238E27FC236}">
-                <a16:creationId xmlns:a16="http://schemas.microsoft.com/office/drawing/2014/main" id="{CCEAA19F-D09E-4ABF-9575-AAC476965C8D}"/>
+                <a16:creationId xmlns:a16="http://schemas.microsoft.com/office/drawing/2014/main" id="{2C728029-14E5-4879-A875-80DF1F88F5B5}"/>
               </a:ext>
             </a:extLst>
           </p:cNvPr>
@@ -15451,7 +15451,7 @@
           <p:cNvPr id="18" name="footer-right">
             <a:extLst xmlns:a="http://schemas.openxmlformats.org/drawingml/2006/main">
               <a:ext uri="{FF2B5EF4-FFF2-40B4-BE49-F238E27FC236}">
-                <a16:creationId xmlns:a16="http://schemas.microsoft.com/office/drawing/2014/main" id="{0D02E303-6AD2-4458-8C8B-605C8DC163B3}"/>
+                <a16:creationId xmlns:a16="http://schemas.microsoft.com/office/drawing/2014/main" id="{656D10E4-48BB-4EFB-87F4-CC40BD4C03B0}"/>
               </a:ext>
             </a:extLst>
           </p:cNvPr>
@@ -15494,7 +15494,7 @@
     </p:spTree>
     <p:extLst>
       <p:ext uri="{BB962C8B-B14F-4D97-AF65-F5344CB8AC3E}">
-        <p14:creationId xmlns:p14="http://schemas.microsoft.com/office/powerpoint/2010/main" val="1554597917"/>
+        <p14:creationId xmlns:p14="http://schemas.microsoft.com/office/powerpoint/2010/main" val="565224541"/>
       </p:ext>
     </p:extLst>
   </p:cSld>

</xml_diff>

<commit_message>
Route added hemoptysis text through safety layers
</commit_message>
<xml_diff>
--- a/decks/clinsafer-interview-demo/output/output.pptx
+++ b/decks/clinsafer-interview-demo/output/output.pptx
@@ -2,28 +2,28 @@
 <file path=ppt/presentation.xml><?xml version="1.0" encoding="utf-8"?>
 <p:presentation xmlns:p="http://schemas.openxmlformats.org/presentationml/2006/main">
   <p:sldMasterIdLst>
-    <p:sldMasterId xmlns:r="http://schemas.openxmlformats.org/officeDocument/2006/relationships" id="2147483648" r:id="R4bc0d80cb12f407e"/>
+    <p:sldMasterId xmlns:r="http://schemas.openxmlformats.org/officeDocument/2006/relationships" id="2147483648" r:id="R67d97d30a3ed4cc0"/>
   </p:sldMasterIdLst>
   <p:notesMasterIdLst>
-    <p:notesMasterId xmlns:r="http://schemas.openxmlformats.org/officeDocument/2006/relationships" r:id="Re9fd2d61b1ad4eb5"/>
+    <p:notesMasterId xmlns:r="http://schemas.openxmlformats.org/officeDocument/2006/relationships" r:id="R35bf4c5ab63644b4"/>
   </p:notesMasterIdLst>
   <p:sldIdLst>
-    <p:sldId xmlns:r="http://schemas.openxmlformats.org/officeDocument/2006/relationships" id="256" r:id="R864d73f3b3b04e81"/>
-    <p:sldId xmlns:r="http://schemas.openxmlformats.org/officeDocument/2006/relationships" id="257" r:id="R5c17f7115e92445a"/>
-    <p:sldId xmlns:r="http://schemas.openxmlformats.org/officeDocument/2006/relationships" id="258" r:id="Rb465c99fb8a64103"/>
-    <p:sldId xmlns:r="http://schemas.openxmlformats.org/officeDocument/2006/relationships" id="259" r:id="R17508ffef5534ece"/>
-    <p:sldId xmlns:r="http://schemas.openxmlformats.org/officeDocument/2006/relationships" id="260" r:id="Rd27adc1ed37c4b0e"/>
-    <p:sldId xmlns:r="http://schemas.openxmlformats.org/officeDocument/2006/relationships" id="261" r:id="Ra357d4c002e242ec"/>
-    <p:sldId xmlns:r="http://schemas.openxmlformats.org/officeDocument/2006/relationships" id="262" r:id="R5aed199cd2d1483c"/>
-    <p:sldId xmlns:r="http://schemas.openxmlformats.org/officeDocument/2006/relationships" id="263" r:id="R7d5b51cfe8c84bae"/>
-    <p:sldId xmlns:r="http://schemas.openxmlformats.org/officeDocument/2006/relationships" id="264" r:id="Rc7c5416cb9db4d3c"/>
-    <p:sldId xmlns:r="http://schemas.openxmlformats.org/officeDocument/2006/relationships" id="265" r:id="Rd65e4e58bac84074"/>
-    <p:sldId xmlns:r="http://schemas.openxmlformats.org/officeDocument/2006/relationships" id="266" r:id="R0c84b703c7d84283"/>
-    <p:sldId xmlns:r="http://schemas.openxmlformats.org/officeDocument/2006/relationships" id="267" r:id="R3288b4c480774dbd"/>
-    <p:sldId xmlns:r="http://schemas.openxmlformats.org/officeDocument/2006/relationships" id="268" r:id="R1343664df8bd4bbb"/>
-    <p:sldId xmlns:r="http://schemas.openxmlformats.org/officeDocument/2006/relationships" id="269" r:id="R6815e50017954395"/>
-    <p:sldId xmlns:r="http://schemas.openxmlformats.org/officeDocument/2006/relationships" id="270" r:id="R3aa043a5716b4416"/>
-    <p:sldId xmlns:r="http://schemas.openxmlformats.org/officeDocument/2006/relationships" id="271" r:id="R06d9d7e45c5541b8"/>
+    <p:sldId xmlns:r="http://schemas.openxmlformats.org/officeDocument/2006/relationships" id="256" r:id="Ref6e4cfb535f457b"/>
+    <p:sldId xmlns:r="http://schemas.openxmlformats.org/officeDocument/2006/relationships" id="257" r:id="R9bf1d3d9e2df4b88"/>
+    <p:sldId xmlns:r="http://schemas.openxmlformats.org/officeDocument/2006/relationships" id="258" r:id="R1adf3b9eaf394239"/>
+    <p:sldId xmlns:r="http://schemas.openxmlformats.org/officeDocument/2006/relationships" id="259" r:id="Re637aa10a197443e"/>
+    <p:sldId xmlns:r="http://schemas.openxmlformats.org/officeDocument/2006/relationships" id="260" r:id="Rd21238320b394c2a"/>
+    <p:sldId xmlns:r="http://schemas.openxmlformats.org/officeDocument/2006/relationships" id="261" r:id="R3bde9a34b2df45ba"/>
+    <p:sldId xmlns:r="http://schemas.openxmlformats.org/officeDocument/2006/relationships" id="262" r:id="R1c01fe9bb5014aa0"/>
+    <p:sldId xmlns:r="http://schemas.openxmlformats.org/officeDocument/2006/relationships" id="263" r:id="R443ae1409e884c34"/>
+    <p:sldId xmlns:r="http://schemas.openxmlformats.org/officeDocument/2006/relationships" id="264" r:id="R245464f5268c423d"/>
+    <p:sldId xmlns:r="http://schemas.openxmlformats.org/officeDocument/2006/relationships" id="265" r:id="Rc952be149b1f4194"/>
+    <p:sldId xmlns:r="http://schemas.openxmlformats.org/officeDocument/2006/relationships" id="266" r:id="R5c2c1b5b95b74dae"/>
+    <p:sldId xmlns:r="http://schemas.openxmlformats.org/officeDocument/2006/relationships" id="267" r:id="R4b6fc09b61f24442"/>
+    <p:sldId xmlns:r="http://schemas.openxmlformats.org/officeDocument/2006/relationships" id="268" r:id="R7741856b3e644461"/>
+    <p:sldId xmlns:r="http://schemas.openxmlformats.org/officeDocument/2006/relationships" id="269" r:id="Rc7347aee88384b06"/>
+    <p:sldId xmlns:r="http://schemas.openxmlformats.org/officeDocument/2006/relationships" id="270" r:id="R322de2fa38cc4dd4"/>
+    <p:sldId xmlns:r="http://schemas.openxmlformats.org/officeDocument/2006/relationships" id="271" r:id="R09df7ac255f745e1"/>
   </p:sldIdLst>
   <p:sldSz cx="18288000" cy="10287000"/>
   <p:notesSz cx="6858000" cy="9144000"/>
@@ -2239,7 +2239,7 @@
   </p:cSld>
   <p:clrMap bg1="lt1" tx1="dk1" bg2="lt2" tx2="dk2" accent1="accent1" accent2="accent2" accent3="accent3" accent4="accent4" accent5="accent5" accent6="accent6" hlink="hlink" folHlink="folHlink"/>
   <p:sldLayoutIdLst>
-    <p:sldLayoutId xmlns:r="http://schemas.openxmlformats.org/officeDocument/2006/relationships" id="2147483649" r:id="Rcb0da33817ee41d7"/>
+    <p:sldLayoutId xmlns:r="http://schemas.openxmlformats.org/officeDocument/2006/relationships" id="2147483649" r:id="Rdc53772473b4413e"/>
   </p:sldLayoutIdLst>
   <p:txStyles>
     <p:titleStyle>
@@ -2538,7 +2538,7 @@
           <p:cNvPr id="1" name="cover-stage">
             <a:extLst xmlns:a="http://schemas.openxmlformats.org/drawingml/2006/main">
               <a:ext uri="{FF2B5EF4-FFF2-40B4-BE49-F238E27FC236}">
-                <a16:creationId xmlns:a16="http://schemas.microsoft.com/office/drawing/2014/main" id="{14AC8EB7-3850-40E5-B901-E1255E5843E7}"/>
+                <a16:creationId xmlns:a16="http://schemas.microsoft.com/office/drawing/2014/main" id="{18D17DD9-65B4-49EF-BDCE-2CEEE7BF1D25}"/>
               </a:ext>
             </a:extLst>
           </p:cNvPr>
@@ -2565,7 +2565,7 @@
           <p:cNvPr id="2" name="">
             <a:extLst xmlns:a="http://schemas.openxmlformats.org/drawingml/2006/main">
               <a:ext uri="{FF2B5EF4-FFF2-40B4-BE49-F238E27FC236}">
-                <a16:creationId xmlns:a16="http://schemas.microsoft.com/office/drawing/2014/main" id="{C8DAA26F-56DD-4F64-AC8C-D353C46EB0CF}"/>
+                <a16:creationId xmlns:a16="http://schemas.microsoft.com/office/drawing/2014/main" id="{DB3B7496-DB5A-4872-882E-C83EF079330E}"/>
               </a:ext>
             </a:extLst>
           </p:cNvPr>
@@ -2610,7 +2610,7 @@
           <p:cNvPr id="3" name="cover-title">
             <a:extLst xmlns:a="http://schemas.openxmlformats.org/drawingml/2006/main">
               <a:ext uri="{FF2B5EF4-FFF2-40B4-BE49-F238E27FC236}">
-                <a16:creationId xmlns:a16="http://schemas.microsoft.com/office/drawing/2014/main" id="{4F1F026E-968E-49AB-87B7-74348B535EC4}"/>
+                <a16:creationId xmlns:a16="http://schemas.microsoft.com/office/drawing/2014/main" id="{D8012761-22CB-41C7-A3FF-68776B8B170B}"/>
               </a:ext>
             </a:extLst>
           </p:cNvPr>
@@ -2655,7 +2655,7 @@
           <p:cNvPr id="4" name="">
             <a:extLst xmlns:a="http://schemas.openxmlformats.org/drawingml/2006/main">
               <a:ext uri="{FF2B5EF4-FFF2-40B4-BE49-F238E27FC236}">
-                <a16:creationId xmlns:a16="http://schemas.microsoft.com/office/drawing/2014/main" id="{F270B925-442A-4E7B-858E-AD7D392CF471}"/>
+                <a16:creationId xmlns:a16="http://schemas.microsoft.com/office/drawing/2014/main" id="{C5094A6C-D45E-4F5B-8347-56201DDF2C1A}"/>
               </a:ext>
             </a:extLst>
           </p:cNvPr>
@@ -2688,7 +2688,7 @@
           <p:cNvPr id="5" name="">
             <a:extLst xmlns:a="http://schemas.openxmlformats.org/drawingml/2006/main">
               <a:ext uri="{FF2B5EF4-FFF2-40B4-BE49-F238E27FC236}">
-                <a16:creationId xmlns:a16="http://schemas.microsoft.com/office/drawing/2014/main" id="{93A59118-C184-4212-BBE8-56A9A4D0A4B6}"/>
+                <a16:creationId xmlns:a16="http://schemas.microsoft.com/office/drawing/2014/main" id="{B5221C7B-91C7-4100-9962-42846DA9B70B}"/>
               </a:ext>
             </a:extLst>
           </p:cNvPr>
@@ -2733,7 +2733,7 @@
           <p:cNvPr id="6" name="">
             <a:extLst xmlns:a="http://schemas.openxmlformats.org/drawingml/2006/main">
               <a:ext uri="{FF2B5EF4-FFF2-40B4-BE49-F238E27FC236}">
-                <a16:creationId xmlns:a16="http://schemas.microsoft.com/office/drawing/2014/main" id="{5F5ACF7D-3B76-41A7-8AB3-529A0BFB16BD}"/>
+                <a16:creationId xmlns:a16="http://schemas.microsoft.com/office/drawing/2014/main" id="{FCB3A506-B797-4E51-83FD-39C5EB4D9D4B}"/>
               </a:ext>
             </a:extLst>
           </p:cNvPr>
@@ -2778,7 +2778,7 @@
           <p:cNvPr id="7" name="">
             <a:extLst xmlns:a="http://schemas.openxmlformats.org/drawingml/2006/main">
               <a:ext uri="{FF2B5EF4-FFF2-40B4-BE49-F238E27FC236}">
-                <a16:creationId xmlns:a16="http://schemas.microsoft.com/office/drawing/2014/main" id="{104F46C1-4597-41AC-A0B1-50559F4005AA}"/>
+                <a16:creationId xmlns:a16="http://schemas.microsoft.com/office/drawing/2014/main" id="{CBA80C5D-EDE0-4256-AC69-45E783115B68}"/>
               </a:ext>
             </a:extLst>
           </p:cNvPr>
@@ -2823,7 +2823,7 @@
           <p:cNvPr id="8" name="">
             <a:extLst xmlns:a="http://schemas.openxmlformats.org/drawingml/2006/main">
               <a:ext uri="{FF2B5EF4-FFF2-40B4-BE49-F238E27FC236}">
-                <a16:creationId xmlns:a16="http://schemas.microsoft.com/office/drawing/2014/main" id="{BB20620B-0527-4EBD-A193-D3A8E6550006}"/>
+                <a16:creationId xmlns:a16="http://schemas.microsoft.com/office/drawing/2014/main" id="{9F64A78B-7401-48D3-AE81-7D6F6AAE18B0}"/>
               </a:ext>
             </a:extLst>
           </p:cNvPr>
@@ -2858,7 +2858,7 @@
                   <a:srgbClr val="2364AA"/>
                 </a:solidFill>
               </a:rPr>
-              <a:t>327</a:t>
+              <a:t>329</a:t>
             </a:r>
           </a:p>
         </p:txBody>
@@ -2868,7 +2868,7 @@
           <p:cNvPr id="9" name="">
             <a:extLst xmlns:a="http://schemas.openxmlformats.org/drawingml/2006/main">
               <a:ext uri="{FF2B5EF4-FFF2-40B4-BE49-F238E27FC236}">
-                <a16:creationId xmlns:a16="http://schemas.microsoft.com/office/drawing/2014/main" id="{B5A50761-CAEC-4681-8544-245682E5708C}"/>
+                <a16:creationId xmlns:a16="http://schemas.microsoft.com/office/drawing/2014/main" id="{FA6911E4-E681-4D61-894A-1DB747954BFF}"/>
               </a:ext>
             </a:extLst>
           </p:cNvPr>
@@ -2913,7 +2913,7 @@
           <p:cNvPr id="10" name="">
             <a:extLst xmlns:a="http://schemas.openxmlformats.org/drawingml/2006/main">
               <a:ext uri="{FF2B5EF4-FFF2-40B4-BE49-F238E27FC236}">
-                <a16:creationId xmlns:a16="http://schemas.microsoft.com/office/drawing/2014/main" id="{7924EDD0-C415-4E88-809A-D253EE084315}"/>
+                <a16:creationId xmlns:a16="http://schemas.microsoft.com/office/drawing/2014/main" id="{7855D874-9AAE-449A-940D-FE974C86BE28}"/>
               </a:ext>
             </a:extLst>
           </p:cNvPr>
@@ -2958,7 +2958,7 @@
           <p:cNvPr id="11" name="">
             <a:extLst xmlns:a="http://schemas.openxmlformats.org/drawingml/2006/main">
               <a:ext uri="{FF2B5EF4-FFF2-40B4-BE49-F238E27FC236}">
-                <a16:creationId xmlns:a16="http://schemas.microsoft.com/office/drawing/2014/main" id="{821B9358-96AF-4E96-83A4-8603DE9C6109}"/>
+                <a16:creationId xmlns:a16="http://schemas.microsoft.com/office/drawing/2014/main" id="{8079E4FF-40F4-4C86-B8BD-4FDD3B9E2C10}"/>
               </a:ext>
             </a:extLst>
           </p:cNvPr>
@@ -3003,7 +3003,7 @@
           <p:cNvPr id="12" name="">
             <a:extLst xmlns:a="http://schemas.openxmlformats.org/drawingml/2006/main">
               <a:ext uri="{FF2B5EF4-FFF2-40B4-BE49-F238E27FC236}">
-                <a16:creationId xmlns:a16="http://schemas.microsoft.com/office/drawing/2014/main" id="{EDED6D34-3B96-4F29-85FF-A4E81E8C8F46}"/>
+                <a16:creationId xmlns:a16="http://schemas.microsoft.com/office/drawing/2014/main" id="{225B6ABB-7CBB-440F-85D1-332187C506F9}"/>
               </a:ext>
             </a:extLst>
           </p:cNvPr>
@@ -3048,7 +3048,7 @@
           <p:cNvPr id="13" name="">
             <a:extLst xmlns:a="http://schemas.openxmlformats.org/drawingml/2006/main">
               <a:ext uri="{FF2B5EF4-FFF2-40B4-BE49-F238E27FC236}">
-                <a16:creationId xmlns:a16="http://schemas.microsoft.com/office/drawing/2014/main" id="{09790BFF-A044-4BB6-80EE-CE3962B915BA}"/>
+                <a16:creationId xmlns:a16="http://schemas.microsoft.com/office/drawing/2014/main" id="{20584FF4-DB68-4555-A064-FD8EBE781600}"/>
               </a:ext>
             </a:extLst>
           </p:cNvPr>
@@ -3091,7 +3091,7 @@
     </p:spTree>
     <p:extLst>
       <p:ext uri="{BB962C8B-B14F-4D97-AF65-F5344CB8AC3E}">
-        <p14:creationId xmlns:p14="http://schemas.microsoft.com/office/powerpoint/2010/main" val="824533360"/>
+        <p14:creationId xmlns:p14="http://schemas.microsoft.com/office/powerpoint/2010/main" val="1763202994"/>
       </p:ext>
     </p:extLst>
   </p:cSld>
@@ -3115,7 +3115,7 @@
           <p:cNvPr id="1" name="slide-stage">
             <a:extLst xmlns:a="http://schemas.openxmlformats.org/drawingml/2006/main">
               <a:ext uri="{FF2B5EF4-FFF2-40B4-BE49-F238E27FC236}">
-                <a16:creationId xmlns:a16="http://schemas.microsoft.com/office/drawing/2014/main" id="{EF7899F1-9090-4373-A0DC-3BA43250B373}"/>
+                <a16:creationId xmlns:a16="http://schemas.microsoft.com/office/drawing/2014/main" id="{8265ED1A-5739-48F3-A31B-3FE2F45559E9}"/>
               </a:ext>
             </a:extLst>
           </p:cNvPr>
@@ -3142,7 +3142,7 @@
           <p:cNvPr id="2" name="eyebrow">
             <a:extLst xmlns:a="http://schemas.openxmlformats.org/drawingml/2006/main">
               <a:ext uri="{FF2B5EF4-FFF2-40B4-BE49-F238E27FC236}">
-                <a16:creationId xmlns:a16="http://schemas.microsoft.com/office/drawing/2014/main" id="{5730A4F5-8A14-402D-B609-A3378C9EF170}"/>
+                <a16:creationId xmlns:a16="http://schemas.microsoft.com/office/drawing/2014/main" id="{BB324C7E-D2DC-4EB8-BA99-8E0423CDED87}"/>
               </a:ext>
             </a:extLst>
           </p:cNvPr>
@@ -3187,7 +3187,7 @@
           <p:cNvPr id="3" name="slide-title">
             <a:extLst xmlns:a="http://schemas.openxmlformats.org/drawingml/2006/main">
               <a:ext uri="{FF2B5EF4-FFF2-40B4-BE49-F238E27FC236}">
-                <a16:creationId xmlns:a16="http://schemas.microsoft.com/office/drawing/2014/main" id="{5712A5C2-54D8-4B8C-A388-30FCF1BC9AF2}"/>
+                <a16:creationId xmlns:a16="http://schemas.microsoft.com/office/drawing/2014/main" id="{847BB3E3-C3E7-4BFA-843C-1B181F48B698}"/>
               </a:ext>
             </a:extLst>
           </p:cNvPr>
@@ -3232,7 +3232,7 @@
           <p:cNvPr id="4" name="slide-subtitle">
             <a:extLst xmlns:a="http://schemas.openxmlformats.org/drawingml/2006/main">
               <a:ext uri="{FF2B5EF4-FFF2-40B4-BE49-F238E27FC236}">
-                <a16:creationId xmlns:a16="http://schemas.microsoft.com/office/drawing/2014/main" id="{EAABA4B1-ACE6-4095-B451-A3DDC47D3D6E}"/>
+                <a16:creationId xmlns:a16="http://schemas.microsoft.com/office/drawing/2014/main" id="{F2A35C3B-9C84-49D4-BA32-D59C8A0C009C}"/>
               </a:ext>
             </a:extLst>
           </p:cNvPr>
@@ -3277,7 +3277,7 @@
           <p:cNvPr id="5" name="">
             <a:extLst xmlns:a="http://schemas.openxmlformats.org/drawingml/2006/main">
               <a:ext uri="{FF2B5EF4-FFF2-40B4-BE49-F238E27FC236}">
-                <a16:creationId xmlns:a16="http://schemas.microsoft.com/office/drawing/2014/main" id="{CFEEA0AF-EE65-49E7-9918-19E87CD4F78D}"/>
+                <a16:creationId xmlns:a16="http://schemas.microsoft.com/office/drawing/2014/main" id="{C79BF53B-11A3-43EA-ABBC-E849B5118B00}"/>
               </a:ext>
             </a:extLst>
           </p:cNvPr>
@@ -3310,7 +3310,7 @@
           <p:cNvPr id="6" name="">
             <a:extLst xmlns:a="http://schemas.openxmlformats.org/drawingml/2006/main">
               <a:ext uri="{FF2B5EF4-FFF2-40B4-BE49-F238E27FC236}">
-                <a16:creationId xmlns:a16="http://schemas.microsoft.com/office/drawing/2014/main" id="{FC26AE12-285F-489F-8F1A-F8D623727358}"/>
+                <a16:creationId xmlns:a16="http://schemas.microsoft.com/office/drawing/2014/main" id="{A6F73936-90AC-4630-93C7-11736AEB1642}"/>
               </a:ext>
             </a:extLst>
           </p:cNvPr>
@@ -3355,7 +3355,7 @@
           <p:cNvPr id="7" name="">
             <a:extLst xmlns:a="http://schemas.openxmlformats.org/drawingml/2006/main">
               <a:ext uri="{FF2B5EF4-FFF2-40B4-BE49-F238E27FC236}">
-                <a16:creationId xmlns:a16="http://schemas.microsoft.com/office/drawing/2014/main" id="{B7F25132-C49B-4DAF-AC84-2E3376687270}"/>
+                <a16:creationId xmlns:a16="http://schemas.microsoft.com/office/drawing/2014/main" id="{F3EFE018-B1E5-4405-85B5-B432CA691C13}"/>
               </a:ext>
             </a:extLst>
           </p:cNvPr>
@@ -3400,7 +3400,7 @@
           <p:cNvPr id="8" name="">
             <a:extLst xmlns:a="http://schemas.openxmlformats.org/drawingml/2006/main">
               <a:ext uri="{FF2B5EF4-FFF2-40B4-BE49-F238E27FC236}">
-                <a16:creationId xmlns:a16="http://schemas.microsoft.com/office/drawing/2014/main" id="{2F31F6A7-A81B-4F45-9180-55860C44FDE6}"/>
+                <a16:creationId xmlns:a16="http://schemas.microsoft.com/office/drawing/2014/main" id="{E55F45A3-7D32-454B-8A92-87039BAE9874}"/>
               </a:ext>
             </a:extLst>
           </p:cNvPr>
@@ -3433,7 +3433,7 @@
           <p:cNvPr id="9" name="">
             <a:extLst xmlns:a="http://schemas.openxmlformats.org/drawingml/2006/main">
               <a:ext uri="{FF2B5EF4-FFF2-40B4-BE49-F238E27FC236}">
-                <a16:creationId xmlns:a16="http://schemas.microsoft.com/office/drawing/2014/main" id="{DBF67F9F-8AB9-455D-8CF1-C11FE0AA25D8}"/>
+                <a16:creationId xmlns:a16="http://schemas.microsoft.com/office/drawing/2014/main" id="{C033F5A2-4658-4F58-86A7-48827D696693}"/>
               </a:ext>
             </a:extLst>
           </p:cNvPr>
@@ -3478,7 +3478,7 @@
           <p:cNvPr id="10" name="">
             <a:extLst xmlns:a="http://schemas.openxmlformats.org/drawingml/2006/main">
               <a:ext uri="{FF2B5EF4-FFF2-40B4-BE49-F238E27FC236}">
-                <a16:creationId xmlns:a16="http://schemas.microsoft.com/office/drawing/2014/main" id="{30C71A61-0F88-4346-A8E1-61A9D51B9DBC}"/>
+                <a16:creationId xmlns:a16="http://schemas.microsoft.com/office/drawing/2014/main" id="{0BE1FBC7-31E5-42CD-BB1C-A4C0EDB263FC}"/>
               </a:ext>
             </a:extLst>
           </p:cNvPr>
@@ -3523,7 +3523,7 @@
           <p:cNvPr id="11" name="">
             <a:extLst xmlns:a="http://schemas.openxmlformats.org/drawingml/2006/main">
               <a:ext uri="{FF2B5EF4-FFF2-40B4-BE49-F238E27FC236}">
-                <a16:creationId xmlns:a16="http://schemas.microsoft.com/office/drawing/2014/main" id="{A830778C-0EC7-4339-8C0E-CBEC4165C883}"/>
+                <a16:creationId xmlns:a16="http://schemas.microsoft.com/office/drawing/2014/main" id="{3DB68248-6C31-4D96-952D-2D87B9E85380}"/>
               </a:ext>
             </a:extLst>
           </p:cNvPr>
@@ -3556,7 +3556,7 @@
           <p:cNvPr id="12" name="">
             <a:extLst xmlns:a="http://schemas.openxmlformats.org/drawingml/2006/main">
               <a:ext uri="{FF2B5EF4-FFF2-40B4-BE49-F238E27FC236}">
-                <a16:creationId xmlns:a16="http://schemas.microsoft.com/office/drawing/2014/main" id="{675E4827-5BDD-45A2-9402-F061177369D6}"/>
+                <a16:creationId xmlns:a16="http://schemas.microsoft.com/office/drawing/2014/main" id="{73773780-2BCA-491F-AEF3-FE01112893B3}"/>
               </a:ext>
             </a:extLst>
           </p:cNvPr>
@@ -3601,7 +3601,7 @@
           <p:cNvPr id="13" name="">
             <a:extLst xmlns:a="http://schemas.openxmlformats.org/drawingml/2006/main">
               <a:ext uri="{FF2B5EF4-FFF2-40B4-BE49-F238E27FC236}">
-                <a16:creationId xmlns:a16="http://schemas.microsoft.com/office/drawing/2014/main" id="{867D42C6-0267-415C-8B73-75ABEA95F059}"/>
+                <a16:creationId xmlns:a16="http://schemas.microsoft.com/office/drawing/2014/main" id="{C330B655-949D-4EE2-A42F-F1FA39C6B7DE}"/>
               </a:ext>
             </a:extLst>
           </p:cNvPr>
@@ -3646,7 +3646,7 @@
           <p:cNvPr id="14" name="">
             <a:extLst xmlns:a="http://schemas.openxmlformats.org/drawingml/2006/main">
               <a:ext uri="{FF2B5EF4-FFF2-40B4-BE49-F238E27FC236}">
-                <a16:creationId xmlns:a16="http://schemas.microsoft.com/office/drawing/2014/main" id="{638EB992-C641-46FA-833D-922277D8FD41}"/>
+                <a16:creationId xmlns:a16="http://schemas.microsoft.com/office/drawing/2014/main" id="{04B0831E-3FF6-4BCD-ABB9-9F2D222CAB21}"/>
               </a:ext>
             </a:extLst>
           </p:cNvPr>
@@ -3679,7 +3679,7 @@
           <p:cNvPr id="15" name="">
             <a:extLst xmlns:a="http://schemas.openxmlformats.org/drawingml/2006/main">
               <a:ext uri="{FF2B5EF4-FFF2-40B4-BE49-F238E27FC236}">
-                <a16:creationId xmlns:a16="http://schemas.microsoft.com/office/drawing/2014/main" id="{0FE9438A-6FD4-418A-9595-B8640EA892BE}"/>
+                <a16:creationId xmlns:a16="http://schemas.microsoft.com/office/drawing/2014/main" id="{46522B3D-3120-415E-9322-CEF89EBB4FC7}"/>
               </a:ext>
             </a:extLst>
           </p:cNvPr>
@@ -3724,7 +3724,7 @@
           <p:cNvPr id="16" name="">
             <a:extLst xmlns:a="http://schemas.openxmlformats.org/drawingml/2006/main">
               <a:ext uri="{FF2B5EF4-FFF2-40B4-BE49-F238E27FC236}">
-                <a16:creationId xmlns:a16="http://schemas.microsoft.com/office/drawing/2014/main" id="{F93BDEC3-F964-4BC4-95DC-745E6D2B0E3A}"/>
+                <a16:creationId xmlns:a16="http://schemas.microsoft.com/office/drawing/2014/main" id="{59021C4E-E8CC-4EE5-9618-94D6B3019380}"/>
               </a:ext>
             </a:extLst>
           </p:cNvPr>
@@ -3769,7 +3769,7 @@
           <p:cNvPr id="17" name="footer-left">
             <a:extLst xmlns:a="http://schemas.openxmlformats.org/drawingml/2006/main">
               <a:ext uri="{FF2B5EF4-FFF2-40B4-BE49-F238E27FC236}">
-                <a16:creationId xmlns:a16="http://schemas.microsoft.com/office/drawing/2014/main" id="{BD6157EB-575D-4753-B108-B0E269F67A1A}"/>
+                <a16:creationId xmlns:a16="http://schemas.microsoft.com/office/drawing/2014/main" id="{81DD4391-9A79-4E9D-8F8F-BE3F0B62A80E}"/>
               </a:ext>
             </a:extLst>
           </p:cNvPr>
@@ -3814,7 +3814,7 @@
           <p:cNvPr id="18" name="footer-right">
             <a:extLst xmlns:a="http://schemas.openxmlformats.org/drawingml/2006/main">
               <a:ext uri="{FF2B5EF4-FFF2-40B4-BE49-F238E27FC236}">
-                <a16:creationId xmlns:a16="http://schemas.microsoft.com/office/drawing/2014/main" id="{EAC8606A-CAAD-4ED9-B31E-D00FD2F025A6}"/>
+                <a16:creationId xmlns:a16="http://schemas.microsoft.com/office/drawing/2014/main" id="{9DEF46EB-1416-4B41-975E-899B108C2442}"/>
               </a:ext>
             </a:extLst>
           </p:cNvPr>
@@ -3857,7 +3857,7 @@
     </p:spTree>
     <p:extLst>
       <p:ext uri="{BB962C8B-B14F-4D97-AF65-F5344CB8AC3E}">
-        <p14:creationId xmlns:p14="http://schemas.microsoft.com/office/powerpoint/2010/main" val="1343075394"/>
+        <p14:creationId xmlns:p14="http://schemas.microsoft.com/office/powerpoint/2010/main" val="2098453200"/>
       </p:ext>
     </p:extLst>
   </p:cSld>
@@ -3881,7 +3881,7 @@
           <p:cNvPr id="1" name="slide-stage">
             <a:extLst xmlns:a="http://schemas.openxmlformats.org/drawingml/2006/main">
               <a:ext uri="{FF2B5EF4-FFF2-40B4-BE49-F238E27FC236}">
-                <a16:creationId xmlns:a16="http://schemas.microsoft.com/office/drawing/2014/main" id="{951ED921-1849-4B87-A38A-2D500BC42025}"/>
+                <a16:creationId xmlns:a16="http://schemas.microsoft.com/office/drawing/2014/main" id="{B5587C85-5327-45F8-8028-0388D27A06C4}"/>
               </a:ext>
             </a:extLst>
           </p:cNvPr>
@@ -3908,7 +3908,7 @@
           <p:cNvPr id="2" name="eyebrow">
             <a:extLst xmlns:a="http://schemas.openxmlformats.org/drawingml/2006/main">
               <a:ext uri="{FF2B5EF4-FFF2-40B4-BE49-F238E27FC236}">
-                <a16:creationId xmlns:a16="http://schemas.microsoft.com/office/drawing/2014/main" id="{22C239C7-0907-443F-A21D-34F0078B7D5C}"/>
+                <a16:creationId xmlns:a16="http://schemas.microsoft.com/office/drawing/2014/main" id="{EB6179FA-E349-46A2-A76D-D43A326BA858}"/>
               </a:ext>
             </a:extLst>
           </p:cNvPr>
@@ -3953,7 +3953,7 @@
           <p:cNvPr id="3" name="slide-title">
             <a:extLst xmlns:a="http://schemas.openxmlformats.org/drawingml/2006/main">
               <a:ext uri="{FF2B5EF4-FFF2-40B4-BE49-F238E27FC236}">
-                <a16:creationId xmlns:a16="http://schemas.microsoft.com/office/drawing/2014/main" id="{B946F0A3-799E-4EB5-AF4A-E8940FF167AE}"/>
+                <a16:creationId xmlns:a16="http://schemas.microsoft.com/office/drawing/2014/main" id="{E9FC668C-885E-4583-A05B-57725380EC30}"/>
               </a:ext>
             </a:extLst>
           </p:cNvPr>
@@ -3998,7 +3998,7 @@
           <p:cNvPr id="4" name="slide-subtitle">
             <a:extLst xmlns:a="http://schemas.openxmlformats.org/drawingml/2006/main">
               <a:ext uri="{FF2B5EF4-FFF2-40B4-BE49-F238E27FC236}">
-                <a16:creationId xmlns:a16="http://schemas.microsoft.com/office/drawing/2014/main" id="{5E0132ED-9873-4D3B-8727-3EBCC6D52E10}"/>
+                <a16:creationId xmlns:a16="http://schemas.microsoft.com/office/drawing/2014/main" id="{0EF26A80-ACBF-4689-96AC-43EB9B77171A}"/>
               </a:ext>
             </a:extLst>
           </p:cNvPr>
@@ -4043,7 +4043,7 @@
           <p:cNvPr id="5" name="">
             <a:extLst xmlns:a="http://schemas.openxmlformats.org/drawingml/2006/main">
               <a:ext uri="{FF2B5EF4-FFF2-40B4-BE49-F238E27FC236}">
-                <a16:creationId xmlns:a16="http://schemas.microsoft.com/office/drawing/2014/main" id="{FB3D69AB-D649-4435-92C5-5D898CBB8BB8}"/>
+                <a16:creationId xmlns:a16="http://schemas.microsoft.com/office/drawing/2014/main" id="{9CFDA9B7-BB7B-4139-A29A-B74DD456856E}"/>
               </a:ext>
             </a:extLst>
           </p:cNvPr>
@@ -4088,7 +4088,7 @@
           <p:cNvPr id="6" name="">
             <a:extLst xmlns:a="http://schemas.openxmlformats.org/drawingml/2006/main">
               <a:ext uri="{FF2B5EF4-FFF2-40B4-BE49-F238E27FC236}">
-                <a16:creationId xmlns:a16="http://schemas.microsoft.com/office/drawing/2014/main" id="{FA75CEBC-27D5-46A0-8464-C7E8C536104B}"/>
+                <a16:creationId xmlns:a16="http://schemas.microsoft.com/office/drawing/2014/main" id="{36D3CF09-35D8-4B1B-BB89-7350BCA11F04}"/>
               </a:ext>
             </a:extLst>
           </p:cNvPr>
@@ -4133,7 +4133,7 @@
           <p:cNvPr id="7" name="">
             <a:extLst xmlns:a="http://schemas.openxmlformats.org/drawingml/2006/main">
               <a:ext uri="{FF2B5EF4-FFF2-40B4-BE49-F238E27FC236}">
-                <a16:creationId xmlns:a16="http://schemas.microsoft.com/office/drawing/2014/main" id="{0B30071D-8F85-4040-AF87-587CD2F8A052}"/>
+                <a16:creationId xmlns:a16="http://schemas.microsoft.com/office/drawing/2014/main" id="{EC310573-D64B-4116-81D4-A3CB714EC3E9}"/>
               </a:ext>
             </a:extLst>
           </p:cNvPr>
@@ -4178,7 +4178,7 @@
           <p:cNvPr id="8" name="">
             <a:extLst xmlns:a="http://schemas.openxmlformats.org/drawingml/2006/main">
               <a:ext uri="{FF2B5EF4-FFF2-40B4-BE49-F238E27FC236}">
-                <a16:creationId xmlns:a16="http://schemas.microsoft.com/office/drawing/2014/main" id="{ED197D33-DC6C-4B4C-981F-9C3A838AA533}"/>
+                <a16:creationId xmlns:a16="http://schemas.microsoft.com/office/drawing/2014/main" id="{A44C7EDD-9821-451D-8A38-AAA6E3A20569}"/>
               </a:ext>
             </a:extLst>
           </p:cNvPr>
@@ -4223,7 +4223,7 @@
           <p:cNvPr id="9" name="">
             <a:extLst xmlns:a="http://schemas.openxmlformats.org/drawingml/2006/main">
               <a:ext uri="{FF2B5EF4-FFF2-40B4-BE49-F238E27FC236}">
-                <a16:creationId xmlns:a16="http://schemas.microsoft.com/office/drawing/2014/main" id="{FBEF847D-DF28-4B8B-AA7E-95C81E7EECF7}"/>
+                <a16:creationId xmlns:a16="http://schemas.microsoft.com/office/drawing/2014/main" id="{8B37F1C1-6AAC-473A-8E44-095F9B8F2236}"/>
               </a:ext>
             </a:extLst>
           </p:cNvPr>
@@ -4268,7 +4268,7 @@
           <p:cNvPr id="10" name="">
             <a:extLst xmlns:a="http://schemas.openxmlformats.org/drawingml/2006/main">
               <a:ext uri="{FF2B5EF4-FFF2-40B4-BE49-F238E27FC236}">
-                <a16:creationId xmlns:a16="http://schemas.microsoft.com/office/drawing/2014/main" id="{4464D895-8377-4C04-B65A-CE48910B2B5F}"/>
+                <a16:creationId xmlns:a16="http://schemas.microsoft.com/office/drawing/2014/main" id="{C460171E-15EE-40A6-B852-7702F689EFED}"/>
               </a:ext>
             </a:extLst>
           </p:cNvPr>
@@ -4313,7 +4313,7 @@
           <p:cNvPr id="11" name="">
             <a:extLst xmlns:a="http://schemas.openxmlformats.org/drawingml/2006/main">
               <a:ext uri="{FF2B5EF4-FFF2-40B4-BE49-F238E27FC236}">
-                <a16:creationId xmlns:a16="http://schemas.microsoft.com/office/drawing/2014/main" id="{3A07C10E-F5AD-4EF5-B148-19D9E3796788}"/>
+                <a16:creationId xmlns:a16="http://schemas.microsoft.com/office/drawing/2014/main" id="{73EF60CF-DB3A-459F-BA03-408AE7A8D6FE}"/>
               </a:ext>
             </a:extLst>
           </p:cNvPr>
@@ -4358,7 +4358,7 @@
           <p:cNvPr id="12" name="">
             <a:extLst xmlns:a="http://schemas.openxmlformats.org/drawingml/2006/main">
               <a:ext uri="{FF2B5EF4-FFF2-40B4-BE49-F238E27FC236}">
-                <a16:creationId xmlns:a16="http://schemas.microsoft.com/office/drawing/2014/main" id="{36CFC6E9-DCBD-464D-817D-C870449A834F}"/>
+                <a16:creationId xmlns:a16="http://schemas.microsoft.com/office/drawing/2014/main" id="{E953D905-44AA-4B60-816B-5C6C72B52BE4}"/>
               </a:ext>
             </a:extLst>
           </p:cNvPr>
@@ -4403,7 +4403,7 @@
           <p:cNvPr id="13" name="">
             <a:extLst xmlns:a="http://schemas.openxmlformats.org/drawingml/2006/main">
               <a:ext uri="{FF2B5EF4-FFF2-40B4-BE49-F238E27FC236}">
-                <a16:creationId xmlns:a16="http://schemas.microsoft.com/office/drawing/2014/main" id="{AB883A39-61AF-435C-A776-A7709103BD3E}"/>
+                <a16:creationId xmlns:a16="http://schemas.microsoft.com/office/drawing/2014/main" id="{2BD9C7C8-0F79-42FB-A1F7-C8A25FD6ADBC}"/>
               </a:ext>
             </a:extLst>
           </p:cNvPr>
@@ -4448,7 +4448,7 @@
           <p:cNvPr id="14" name="footer-left">
             <a:extLst xmlns:a="http://schemas.openxmlformats.org/drawingml/2006/main">
               <a:ext uri="{FF2B5EF4-FFF2-40B4-BE49-F238E27FC236}">
-                <a16:creationId xmlns:a16="http://schemas.microsoft.com/office/drawing/2014/main" id="{5F91FA6A-3021-4946-9A54-B991145383BE}"/>
+                <a16:creationId xmlns:a16="http://schemas.microsoft.com/office/drawing/2014/main" id="{4BC7AF5C-161A-4D7B-8C9D-A45D1B850D6E}"/>
               </a:ext>
             </a:extLst>
           </p:cNvPr>
@@ -4493,7 +4493,7 @@
           <p:cNvPr id="15" name="footer-right">
             <a:extLst xmlns:a="http://schemas.openxmlformats.org/drawingml/2006/main">
               <a:ext uri="{FF2B5EF4-FFF2-40B4-BE49-F238E27FC236}">
-                <a16:creationId xmlns:a16="http://schemas.microsoft.com/office/drawing/2014/main" id="{2747D4EB-ED86-40E4-81EB-D7948A621372}"/>
+                <a16:creationId xmlns:a16="http://schemas.microsoft.com/office/drawing/2014/main" id="{C670BF55-A4AD-482E-9148-8FB730031A7C}"/>
               </a:ext>
             </a:extLst>
           </p:cNvPr>
@@ -4536,7 +4536,7 @@
     </p:spTree>
     <p:extLst>
       <p:ext uri="{BB962C8B-B14F-4D97-AF65-F5344CB8AC3E}">
-        <p14:creationId xmlns:p14="http://schemas.microsoft.com/office/powerpoint/2010/main" val="112457966"/>
+        <p14:creationId xmlns:p14="http://schemas.microsoft.com/office/powerpoint/2010/main" val="803247839"/>
       </p:ext>
     </p:extLst>
   </p:cSld>
@@ -4560,7 +4560,7 @@
           <p:cNvPr id="1" name="slide-stage">
             <a:extLst xmlns:a="http://schemas.openxmlformats.org/drawingml/2006/main">
               <a:ext uri="{FF2B5EF4-FFF2-40B4-BE49-F238E27FC236}">
-                <a16:creationId xmlns:a16="http://schemas.microsoft.com/office/drawing/2014/main" id="{0761F2D3-CD15-4484-B850-E09EA59DBC1D}"/>
+                <a16:creationId xmlns:a16="http://schemas.microsoft.com/office/drawing/2014/main" id="{E8095F91-D6FC-4AB7-AF11-4D1A654429C4}"/>
               </a:ext>
             </a:extLst>
           </p:cNvPr>
@@ -4587,7 +4587,7 @@
           <p:cNvPr id="2" name="eyebrow">
             <a:extLst xmlns:a="http://schemas.openxmlformats.org/drawingml/2006/main">
               <a:ext uri="{FF2B5EF4-FFF2-40B4-BE49-F238E27FC236}">
-                <a16:creationId xmlns:a16="http://schemas.microsoft.com/office/drawing/2014/main" id="{2008484E-792B-4229-AD7F-E8AB5A84723F}"/>
+                <a16:creationId xmlns:a16="http://schemas.microsoft.com/office/drawing/2014/main" id="{64F87241-66B0-4877-81AD-42AE970E9D3F}"/>
               </a:ext>
             </a:extLst>
           </p:cNvPr>
@@ -4632,7 +4632,7 @@
           <p:cNvPr id="3" name="slide-title">
             <a:extLst xmlns:a="http://schemas.openxmlformats.org/drawingml/2006/main">
               <a:ext uri="{FF2B5EF4-FFF2-40B4-BE49-F238E27FC236}">
-                <a16:creationId xmlns:a16="http://schemas.microsoft.com/office/drawing/2014/main" id="{BC8029E6-E22C-401F-91D5-318E42572CA8}"/>
+                <a16:creationId xmlns:a16="http://schemas.microsoft.com/office/drawing/2014/main" id="{44D4873C-5F64-4760-B913-A6A96888F2BB}"/>
               </a:ext>
             </a:extLst>
           </p:cNvPr>
@@ -4677,7 +4677,7 @@
           <p:cNvPr id="4" name="slide-subtitle">
             <a:extLst xmlns:a="http://schemas.openxmlformats.org/drawingml/2006/main">
               <a:ext uri="{FF2B5EF4-FFF2-40B4-BE49-F238E27FC236}">
-                <a16:creationId xmlns:a16="http://schemas.microsoft.com/office/drawing/2014/main" id="{85E57701-3C60-4997-A49E-13B978CDA989}"/>
+                <a16:creationId xmlns:a16="http://schemas.microsoft.com/office/drawing/2014/main" id="{BBE945BB-1C32-409A-92CE-43C4B4FC8A5C}"/>
               </a:ext>
             </a:extLst>
           </p:cNvPr>
@@ -4722,7 +4722,7 @@
           <p:cNvPr id="5" name="">
             <a:extLst xmlns:a="http://schemas.openxmlformats.org/drawingml/2006/main">
               <a:ext uri="{FF2B5EF4-FFF2-40B4-BE49-F238E27FC236}">
-                <a16:creationId xmlns:a16="http://schemas.microsoft.com/office/drawing/2014/main" id="{1706C773-E3F6-4EB2-96A1-381CC7251F5D}"/>
+                <a16:creationId xmlns:a16="http://schemas.microsoft.com/office/drawing/2014/main" id="{BD430789-F993-491C-9D2D-5CE1E52D8A88}"/>
               </a:ext>
             </a:extLst>
           </p:cNvPr>
@@ -4755,7 +4755,7 @@
           <p:cNvPr id="6" name="">
             <a:extLst xmlns:a="http://schemas.openxmlformats.org/drawingml/2006/main">
               <a:ext uri="{FF2B5EF4-FFF2-40B4-BE49-F238E27FC236}">
-                <a16:creationId xmlns:a16="http://schemas.microsoft.com/office/drawing/2014/main" id="{5E9E8370-65D1-4985-A541-279660AEBA63}"/>
+                <a16:creationId xmlns:a16="http://schemas.microsoft.com/office/drawing/2014/main" id="{A611EA51-2802-4275-B367-C1DEFA7BB85F}"/>
               </a:ext>
             </a:extLst>
           </p:cNvPr>
@@ -4800,7 +4800,7 @@
           <p:cNvPr id="7" name="">
             <a:extLst xmlns:a="http://schemas.openxmlformats.org/drawingml/2006/main">
               <a:ext uri="{FF2B5EF4-FFF2-40B4-BE49-F238E27FC236}">
-                <a16:creationId xmlns:a16="http://schemas.microsoft.com/office/drawing/2014/main" id="{DF723317-A717-4DB0-AAD8-303D95905EDD}"/>
+                <a16:creationId xmlns:a16="http://schemas.microsoft.com/office/drawing/2014/main" id="{E0F7DC91-AD45-421E-9EC6-63C3C21114E0}"/>
               </a:ext>
             </a:extLst>
           </p:cNvPr>
@@ -4845,7 +4845,7 @@
           <p:cNvPr id="8" name="">
             <a:extLst xmlns:a="http://schemas.openxmlformats.org/drawingml/2006/main">
               <a:ext uri="{FF2B5EF4-FFF2-40B4-BE49-F238E27FC236}">
-                <a16:creationId xmlns:a16="http://schemas.microsoft.com/office/drawing/2014/main" id="{01C68BF0-B7A5-410B-94E4-89A8CA853E80}"/>
+                <a16:creationId xmlns:a16="http://schemas.microsoft.com/office/drawing/2014/main" id="{072ECFBA-70B2-4959-A8E7-6A79FC8C5E5F}"/>
               </a:ext>
             </a:extLst>
           </p:cNvPr>
@@ -4878,7 +4878,7 @@
           <p:cNvPr id="9" name="">
             <a:extLst xmlns:a="http://schemas.openxmlformats.org/drawingml/2006/main">
               <a:ext uri="{FF2B5EF4-FFF2-40B4-BE49-F238E27FC236}">
-                <a16:creationId xmlns:a16="http://schemas.microsoft.com/office/drawing/2014/main" id="{04B1F48E-1E60-40ED-94A1-EE653FF4F411}"/>
+                <a16:creationId xmlns:a16="http://schemas.microsoft.com/office/drawing/2014/main" id="{333C34B2-046E-4CCE-9B79-0CC6E0509662}"/>
               </a:ext>
             </a:extLst>
           </p:cNvPr>
@@ -4923,7 +4923,7 @@
           <p:cNvPr id="10" name="">
             <a:extLst xmlns:a="http://schemas.openxmlformats.org/drawingml/2006/main">
               <a:ext uri="{FF2B5EF4-FFF2-40B4-BE49-F238E27FC236}">
-                <a16:creationId xmlns:a16="http://schemas.microsoft.com/office/drawing/2014/main" id="{B3897F9A-327A-42CB-809F-AA51D9C9F834}"/>
+                <a16:creationId xmlns:a16="http://schemas.microsoft.com/office/drawing/2014/main" id="{4FF12552-2942-46B5-BBD8-D6D62F25C062}"/>
               </a:ext>
             </a:extLst>
           </p:cNvPr>
@@ -4968,7 +4968,7 @@
           <p:cNvPr id="11" name="">
             <a:extLst xmlns:a="http://schemas.openxmlformats.org/drawingml/2006/main">
               <a:ext uri="{FF2B5EF4-FFF2-40B4-BE49-F238E27FC236}">
-                <a16:creationId xmlns:a16="http://schemas.microsoft.com/office/drawing/2014/main" id="{4B76D6AE-B4D2-4D83-803C-2D17F38E82B0}"/>
+                <a16:creationId xmlns:a16="http://schemas.microsoft.com/office/drawing/2014/main" id="{920773B3-E4F2-462D-ADB5-8FBDDDD9753B}"/>
               </a:ext>
             </a:extLst>
           </p:cNvPr>
@@ -5001,7 +5001,7 @@
           <p:cNvPr id="12" name="">
             <a:extLst xmlns:a="http://schemas.openxmlformats.org/drawingml/2006/main">
               <a:ext uri="{FF2B5EF4-FFF2-40B4-BE49-F238E27FC236}">
-                <a16:creationId xmlns:a16="http://schemas.microsoft.com/office/drawing/2014/main" id="{8C5C5E69-F911-47C9-8423-DFEB80EFA1C4}"/>
+                <a16:creationId xmlns:a16="http://schemas.microsoft.com/office/drawing/2014/main" id="{693E8DA5-EE00-4699-9EDF-E36CD59BC152}"/>
               </a:ext>
             </a:extLst>
           </p:cNvPr>
@@ -5046,7 +5046,7 @@
           <p:cNvPr id="13" name="">
             <a:extLst xmlns:a="http://schemas.openxmlformats.org/drawingml/2006/main">
               <a:ext uri="{FF2B5EF4-FFF2-40B4-BE49-F238E27FC236}">
-                <a16:creationId xmlns:a16="http://schemas.microsoft.com/office/drawing/2014/main" id="{E00F4CDF-CCE3-43E2-966F-0C392D442C51}"/>
+                <a16:creationId xmlns:a16="http://schemas.microsoft.com/office/drawing/2014/main" id="{5C0CFCF0-6618-4259-9E9D-3751A8AB0631}"/>
               </a:ext>
             </a:extLst>
           </p:cNvPr>
@@ -5091,7 +5091,7 @@
           <p:cNvPr id="14" name="">
             <a:extLst xmlns:a="http://schemas.openxmlformats.org/drawingml/2006/main">
               <a:ext uri="{FF2B5EF4-FFF2-40B4-BE49-F238E27FC236}">
-                <a16:creationId xmlns:a16="http://schemas.microsoft.com/office/drawing/2014/main" id="{AE204F23-2347-4999-88DF-F90393BA23F9}"/>
+                <a16:creationId xmlns:a16="http://schemas.microsoft.com/office/drawing/2014/main" id="{119CAC00-0AA4-40D3-B0D2-45ED0579BF98}"/>
               </a:ext>
             </a:extLst>
           </p:cNvPr>
@@ -5124,7 +5124,7 @@
           <p:cNvPr id="15" name="">
             <a:extLst xmlns:a="http://schemas.openxmlformats.org/drawingml/2006/main">
               <a:ext uri="{FF2B5EF4-FFF2-40B4-BE49-F238E27FC236}">
-                <a16:creationId xmlns:a16="http://schemas.microsoft.com/office/drawing/2014/main" id="{A579C634-F967-4635-BA3C-DC33760954F9}"/>
+                <a16:creationId xmlns:a16="http://schemas.microsoft.com/office/drawing/2014/main" id="{58316327-C442-4DF8-BB16-9E1270A209AA}"/>
               </a:ext>
             </a:extLst>
           </p:cNvPr>
@@ -5169,7 +5169,7 @@
           <p:cNvPr id="16" name="">
             <a:extLst xmlns:a="http://schemas.openxmlformats.org/drawingml/2006/main">
               <a:ext uri="{FF2B5EF4-FFF2-40B4-BE49-F238E27FC236}">
-                <a16:creationId xmlns:a16="http://schemas.microsoft.com/office/drawing/2014/main" id="{2AAEEB3C-117A-4188-A146-19139F6A3665}"/>
+                <a16:creationId xmlns:a16="http://schemas.microsoft.com/office/drawing/2014/main" id="{835D2CE4-2156-42BF-ACB1-17261E56E5D2}"/>
               </a:ext>
             </a:extLst>
           </p:cNvPr>
@@ -5214,7 +5214,7 @@
           <p:cNvPr id="17" name="">
             <a:extLst xmlns:a="http://schemas.openxmlformats.org/drawingml/2006/main">
               <a:ext uri="{FF2B5EF4-FFF2-40B4-BE49-F238E27FC236}">
-                <a16:creationId xmlns:a16="http://schemas.microsoft.com/office/drawing/2014/main" id="{2D755EDB-8F5B-49D4-9ED3-BC8B125EAF07}"/>
+                <a16:creationId xmlns:a16="http://schemas.microsoft.com/office/drawing/2014/main" id="{236F2ACE-6A0F-4D2B-AAD8-DCC6BD48C27B}"/>
               </a:ext>
             </a:extLst>
           </p:cNvPr>
@@ -5247,7 +5247,7 @@
           <p:cNvPr id="18" name="">
             <a:extLst xmlns:a="http://schemas.openxmlformats.org/drawingml/2006/main">
               <a:ext uri="{FF2B5EF4-FFF2-40B4-BE49-F238E27FC236}">
-                <a16:creationId xmlns:a16="http://schemas.microsoft.com/office/drawing/2014/main" id="{7735ED81-2A7A-4101-8F6A-AA1FB7FD9AC7}"/>
+                <a16:creationId xmlns:a16="http://schemas.microsoft.com/office/drawing/2014/main" id="{378E4F5C-D274-47A4-8C57-7B48F11DAB9E}"/>
               </a:ext>
             </a:extLst>
           </p:cNvPr>
@@ -5292,7 +5292,7 @@
           <p:cNvPr id="19" name="">
             <a:extLst xmlns:a="http://schemas.openxmlformats.org/drawingml/2006/main">
               <a:ext uri="{FF2B5EF4-FFF2-40B4-BE49-F238E27FC236}">
-                <a16:creationId xmlns:a16="http://schemas.microsoft.com/office/drawing/2014/main" id="{CC15D670-3BAD-47B4-B59B-4AE2EE332190}"/>
+                <a16:creationId xmlns:a16="http://schemas.microsoft.com/office/drawing/2014/main" id="{4A1D5505-11E0-407A-A636-6E20B11E4692}"/>
               </a:ext>
             </a:extLst>
           </p:cNvPr>
@@ -5337,7 +5337,7 @@
           <p:cNvPr id="20" name="">
             <a:extLst xmlns:a="http://schemas.openxmlformats.org/drawingml/2006/main">
               <a:ext uri="{FF2B5EF4-FFF2-40B4-BE49-F238E27FC236}">
-                <a16:creationId xmlns:a16="http://schemas.microsoft.com/office/drawing/2014/main" id="{7CE83A74-5714-41ED-BAB0-7EE2D0ECEE34}"/>
+                <a16:creationId xmlns:a16="http://schemas.microsoft.com/office/drawing/2014/main" id="{BE24B560-EFD6-41DE-8E44-9889B04F848C}"/>
               </a:ext>
             </a:extLst>
           </p:cNvPr>
@@ -5370,7 +5370,7 @@
           <p:cNvPr id="21" name="">
             <a:extLst xmlns:a="http://schemas.openxmlformats.org/drawingml/2006/main">
               <a:ext uri="{FF2B5EF4-FFF2-40B4-BE49-F238E27FC236}">
-                <a16:creationId xmlns:a16="http://schemas.microsoft.com/office/drawing/2014/main" id="{6EC8B2DE-CD06-4D04-8C24-8ADC8092816D}"/>
+                <a16:creationId xmlns:a16="http://schemas.microsoft.com/office/drawing/2014/main" id="{F0DE3744-2FE2-4046-9B74-C811AC3D24C6}"/>
               </a:ext>
             </a:extLst>
           </p:cNvPr>
@@ -5415,7 +5415,7 @@
           <p:cNvPr id="22" name="">
             <a:extLst xmlns:a="http://schemas.openxmlformats.org/drawingml/2006/main">
               <a:ext uri="{FF2B5EF4-FFF2-40B4-BE49-F238E27FC236}">
-                <a16:creationId xmlns:a16="http://schemas.microsoft.com/office/drawing/2014/main" id="{53FF4919-6D22-4864-9D33-FD4F5804FF05}"/>
+                <a16:creationId xmlns:a16="http://schemas.microsoft.com/office/drawing/2014/main" id="{F30F780E-C2B1-4758-8D2E-5873C8EABDE2}"/>
               </a:ext>
             </a:extLst>
           </p:cNvPr>
@@ -5460,7 +5460,7 @@
           <p:cNvPr id="23" name="footer-left">
             <a:extLst xmlns:a="http://schemas.openxmlformats.org/drawingml/2006/main">
               <a:ext uri="{FF2B5EF4-FFF2-40B4-BE49-F238E27FC236}">
-                <a16:creationId xmlns:a16="http://schemas.microsoft.com/office/drawing/2014/main" id="{1F5683A2-1DAE-45EE-8C8E-805124060D8C}"/>
+                <a16:creationId xmlns:a16="http://schemas.microsoft.com/office/drawing/2014/main" id="{096C7EBD-DD8E-461D-AB26-4A446B5D6718}"/>
               </a:ext>
             </a:extLst>
           </p:cNvPr>
@@ -5505,7 +5505,7 @@
           <p:cNvPr id="24" name="footer-right">
             <a:extLst xmlns:a="http://schemas.openxmlformats.org/drawingml/2006/main">
               <a:ext uri="{FF2B5EF4-FFF2-40B4-BE49-F238E27FC236}">
-                <a16:creationId xmlns:a16="http://schemas.microsoft.com/office/drawing/2014/main" id="{39CD4296-6952-4963-B7FC-A5796CE69505}"/>
+                <a16:creationId xmlns:a16="http://schemas.microsoft.com/office/drawing/2014/main" id="{2D348CD3-1BCF-4F2A-BF48-2632F6FDC181}"/>
               </a:ext>
             </a:extLst>
           </p:cNvPr>
@@ -5548,7 +5548,7 @@
     </p:spTree>
     <p:extLst>
       <p:ext uri="{BB962C8B-B14F-4D97-AF65-F5344CB8AC3E}">
-        <p14:creationId xmlns:p14="http://schemas.microsoft.com/office/powerpoint/2010/main" val="317259400"/>
+        <p14:creationId xmlns:p14="http://schemas.microsoft.com/office/powerpoint/2010/main" val="1506372885"/>
       </p:ext>
     </p:extLst>
   </p:cSld>
@@ -5572,7 +5572,7 @@
           <p:cNvPr id="1" name="slide-stage">
             <a:extLst xmlns:a="http://schemas.openxmlformats.org/drawingml/2006/main">
               <a:ext uri="{FF2B5EF4-FFF2-40B4-BE49-F238E27FC236}">
-                <a16:creationId xmlns:a16="http://schemas.microsoft.com/office/drawing/2014/main" id="{AE9DEACF-CD77-4FFF-ABB1-F1A8E7F4BFE2}"/>
+                <a16:creationId xmlns:a16="http://schemas.microsoft.com/office/drawing/2014/main" id="{98AA8AB2-19BB-41C4-A178-445F1B902180}"/>
               </a:ext>
             </a:extLst>
           </p:cNvPr>
@@ -5599,7 +5599,7 @@
           <p:cNvPr id="2" name="eyebrow">
             <a:extLst xmlns:a="http://schemas.openxmlformats.org/drawingml/2006/main">
               <a:ext uri="{FF2B5EF4-FFF2-40B4-BE49-F238E27FC236}">
-                <a16:creationId xmlns:a16="http://schemas.microsoft.com/office/drawing/2014/main" id="{70BF2EFD-E38F-41AF-B88C-BFDFD3EDECBE}"/>
+                <a16:creationId xmlns:a16="http://schemas.microsoft.com/office/drawing/2014/main" id="{32807DD1-E7EF-4E20-AD3F-DD4C94801AE0}"/>
               </a:ext>
             </a:extLst>
           </p:cNvPr>
@@ -5644,7 +5644,7 @@
           <p:cNvPr id="3" name="slide-title">
             <a:extLst xmlns:a="http://schemas.openxmlformats.org/drawingml/2006/main">
               <a:ext uri="{FF2B5EF4-FFF2-40B4-BE49-F238E27FC236}">
-                <a16:creationId xmlns:a16="http://schemas.microsoft.com/office/drawing/2014/main" id="{B5A6BD49-0234-44C2-B400-84EABD8900E1}"/>
+                <a16:creationId xmlns:a16="http://schemas.microsoft.com/office/drawing/2014/main" id="{C297D38D-1B29-4CED-AE3E-3804E1081358}"/>
               </a:ext>
             </a:extLst>
           </p:cNvPr>
@@ -5689,7 +5689,7 @@
           <p:cNvPr id="4" name="slide-subtitle">
             <a:extLst xmlns:a="http://schemas.openxmlformats.org/drawingml/2006/main">
               <a:ext uri="{FF2B5EF4-FFF2-40B4-BE49-F238E27FC236}">
-                <a16:creationId xmlns:a16="http://schemas.microsoft.com/office/drawing/2014/main" id="{D83F226B-3FEA-41FD-8544-896B7CC164A2}"/>
+                <a16:creationId xmlns:a16="http://schemas.microsoft.com/office/drawing/2014/main" id="{C387B00F-C419-4A7C-B496-BE510A7AD98C}"/>
               </a:ext>
             </a:extLst>
           </p:cNvPr>
@@ -5734,7 +5734,7 @@
           <p:cNvPr id="5" name="">
             <a:extLst xmlns:a="http://schemas.openxmlformats.org/drawingml/2006/main">
               <a:ext uri="{FF2B5EF4-FFF2-40B4-BE49-F238E27FC236}">
-                <a16:creationId xmlns:a16="http://schemas.microsoft.com/office/drawing/2014/main" id="{FF3E71D4-D9ED-4579-BF56-5F718A9CEB84}"/>
+                <a16:creationId xmlns:a16="http://schemas.microsoft.com/office/drawing/2014/main" id="{B01A15D2-13FE-450E-B780-C0B29E9DAE83}"/>
               </a:ext>
             </a:extLst>
           </p:cNvPr>
@@ -5779,7 +5779,7 @@
           <p:cNvPr id="6" name="">
             <a:extLst xmlns:a="http://schemas.openxmlformats.org/drawingml/2006/main">
               <a:ext uri="{FF2B5EF4-FFF2-40B4-BE49-F238E27FC236}">
-                <a16:creationId xmlns:a16="http://schemas.microsoft.com/office/drawing/2014/main" id="{186A22D9-1416-4E6C-B0A3-26259766D879}"/>
+                <a16:creationId xmlns:a16="http://schemas.microsoft.com/office/drawing/2014/main" id="{AF8C327B-3379-4BC6-AC68-D431E40FD0C8}"/>
               </a:ext>
             </a:extLst>
           </p:cNvPr>
@@ -5824,7 +5824,7 @@
           <p:cNvPr id="7" name="">
             <a:extLst xmlns:a="http://schemas.openxmlformats.org/drawingml/2006/main">
               <a:ext uri="{FF2B5EF4-FFF2-40B4-BE49-F238E27FC236}">
-                <a16:creationId xmlns:a16="http://schemas.microsoft.com/office/drawing/2014/main" id="{5280C32B-5329-4D64-AD9E-BB62381DAAA3}"/>
+                <a16:creationId xmlns:a16="http://schemas.microsoft.com/office/drawing/2014/main" id="{F4A57EF5-3C13-4E67-B5EB-C9285890ADF3}"/>
               </a:ext>
             </a:extLst>
           </p:cNvPr>
@@ -5869,7 +5869,7 @@
           <p:cNvPr id="8" name="">
             <a:extLst xmlns:a="http://schemas.openxmlformats.org/drawingml/2006/main">
               <a:ext uri="{FF2B5EF4-FFF2-40B4-BE49-F238E27FC236}">
-                <a16:creationId xmlns:a16="http://schemas.microsoft.com/office/drawing/2014/main" id="{E0D794AA-4A1F-4260-9B85-1BD0A9CBB146}"/>
+                <a16:creationId xmlns:a16="http://schemas.microsoft.com/office/drawing/2014/main" id="{8D49AA1F-4422-40C5-A327-061A57B278E9}"/>
               </a:ext>
             </a:extLst>
           </p:cNvPr>
@@ -5914,7 +5914,7 @@
           <p:cNvPr id="9" name="">
             <a:extLst xmlns:a="http://schemas.openxmlformats.org/drawingml/2006/main">
               <a:ext uri="{FF2B5EF4-FFF2-40B4-BE49-F238E27FC236}">
-                <a16:creationId xmlns:a16="http://schemas.microsoft.com/office/drawing/2014/main" id="{0200324F-0F43-4A73-9BC9-AD2A94ECABAC}"/>
+                <a16:creationId xmlns:a16="http://schemas.microsoft.com/office/drawing/2014/main" id="{DB25E478-0AF0-44C1-B6EE-DD97DED2DFAC}"/>
               </a:ext>
             </a:extLst>
           </p:cNvPr>
@@ -5959,7 +5959,7 @@
           <p:cNvPr id="10" name="">
             <a:extLst xmlns:a="http://schemas.openxmlformats.org/drawingml/2006/main">
               <a:ext uri="{FF2B5EF4-FFF2-40B4-BE49-F238E27FC236}">
-                <a16:creationId xmlns:a16="http://schemas.microsoft.com/office/drawing/2014/main" id="{6F7D7F7D-E637-487E-8113-2C6376BDAF27}"/>
+                <a16:creationId xmlns:a16="http://schemas.microsoft.com/office/drawing/2014/main" id="{7BAAA5E2-B3BE-4CCB-B1C5-F6A53750972B}"/>
               </a:ext>
             </a:extLst>
           </p:cNvPr>
@@ -6004,7 +6004,7 @@
           <p:cNvPr id="11" name="">
             <a:extLst xmlns:a="http://schemas.openxmlformats.org/drawingml/2006/main">
               <a:ext uri="{FF2B5EF4-FFF2-40B4-BE49-F238E27FC236}">
-                <a16:creationId xmlns:a16="http://schemas.microsoft.com/office/drawing/2014/main" id="{92768B00-7FF8-4A1F-A474-0061DEDC3E2E}"/>
+                <a16:creationId xmlns:a16="http://schemas.microsoft.com/office/drawing/2014/main" id="{F29F2233-05CE-4F77-AB73-11A7AC4013D1}"/>
               </a:ext>
             </a:extLst>
           </p:cNvPr>
@@ -6049,7 +6049,7 @@
           <p:cNvPr id="12" name="">
             <a:extLst xmlns:a="http://schemas.openxmlformats.org/drawingml/2006/main">
               <a:ext uri="{FF2B5EF4-FFF2-40B4-BE49-F238E27FC236}">
-                <a16:creationId xmlns:a16="http://schemas.microsoft.com/office/drawing/2014/main" id="{E1050992-8AAA-4A97-8BA4-15C20780DCC9}"/>
+                <a16:creationId xmlns:a16="http://schemas.microsoft.com/office/drawing/2014/main" id="{EB48CDE7-07B5-433D-8757-B5519CB57FAE}"/>
               </a:ext>
             </a:extLst>
           </p:cNvPr>
@@ -6094,7 +6094,7 @@
           <p:cNvPr id="13" name="">
             <a:extLst xmlns:a="http://schemas.openxmlformats.org/drawingml/2006/main">
               <a:ext uri="{FF2B5EF4-FFF2-40B4-BE49-F238E27FC236}">
-                <a16:creationId xmlns:a16="http://schemas.microsoft.com/office/drawing/2014/main" id="{83C670FF-FC77-48FF-86EE-8D7333E317B5}"/>
+                <a16:creationId xmlns:a16="http://schemas.microsoft.com/office/drawing/2014/main" id="{A518AEB5-900D-45AD-A4C8-09BDC1C48D67}"/>
               </a:ext>
             </a:extLst>
           </p:cNvPr>
@@ -6139,7 +6139,7 @@
           <p:cNvPr id="14" name="">
             <a:extLst xmlns:a="http://schemas.openxmlformats.org/drawingml/2006/main">
               <a:ext uri="{FF2B5EF4-FFF2-40B4-BE49-F238E27FC236}">
-                <a16:creationId xmlns:a16="http://schemas.microsoft.com/office/drawing/2014/main" id="{64473721-6D1A-41D6-8ABE-A52EA498976C}"/>
+                <a16:creationId xmlns:a16="http://schemas.microsoft.com/office/drawing/2014/main" id="{55BD6B19-FBFF-47C6-8E54-2363350305EF}"/>
               </a:ext>
             </a:extLst>
           </p:cNvPr>
@@ -6184,7 +6184,7 @@
           <p:cNvPr id="15" name="footer-left">
             <a:extLst xmlns:a="http://schemas.openxmlformats.org/drawingml/2006/main">
               <a:ext uri="{FF2B5EF4-FFF2-40B4-BE49-F238E27FC236}">
-                <a16:creationId xmlns:a16="http://schemas.microsoft.com/office/drawing/2014/main" id="{A4629BC8-534D-417B-98D2-7B1A5E47E9C9}"/>
+                <a16:creationId xmlns:a16="http://schemas.microsoft.com/office/drawing/2014/main" id="{E4D64616-A173-4FB7-A4CE-F4A9CEF21C73}"/>
               </a:ext>
             </a:extLst>
           </p:cNvPr>
@@ -6229,7 +6229,7 @@
           <p:cNvPr id="16" name="footer-right">
             <a:extLst xmlns:a="http://schemas.openxmlformats.org/drawingml/2006/main">
               <a:ext uri="{FF2B5EF4-FFF2-40B4-BE49-F238E27FC236}">
-                <a16:creationId xmlns:a16="http://schemas.microsoft.com/office/drawing/2014/main" id="{C14490F0-47D7-4B89-BD71-854020B34D5D}"/>
+                <a16:creationId xmlns:a16="http://schemas.microsoft.com/office/drawing/2014/main" id="{F3B9BFE1-BFA8-4F37-89BC-D612AE529941}"/>
               </a:ext>
             </a:extLst>
           </p:cNvPr>
@@ -6272,7 +6272,7 @@
     </p:spTree>
     <p:extLst>
       <p:ext uri="{BB962C8B-B14F-4D97-AF65-F5344CB8AC3E}">
-        <p14:creationId xmlns:p14="http://schemas.microsoft.com/office/powerpoint/2010/main" val="174172476"/>
+        <p14:creationId xmlns:p14="http://schemas.microsoft.com/office/powerpoint/2010/main" val="1153048164"/>
       </p:ext>
     </p:extLst>
   </p:cSld>
@@ -6296,7 +6296,7 @@
           <p:cNvPr id="1" name="slide-stage">
             <a:extLst xmlns:a="http://schemas.openxmlformats.org/drawingml/2006/main">
               <a:ext uri="{FF2B5EF4-FFF2-40B4-BE49-F238E27FC236}">
-                <a16:creationId xmlns:a16="http://schemas.microsoft.com/office/drawing/2014/main" id="{A08BC11D-4B66-4127-8975-09D58FEC2242}"/>
+                <a16:creationId xmlns:a16="http://schemas.microsoft.com/office/drawing/2014/main" id="{C57F8EAF-4DA2-4266-8D0D-8B42EB67283D}"/>
               </a:ext>
             </a:extLst>
           </p:cNvPr>
@@ -6323,7 +6323,7 @@
           <p:cNvPr id="2" name="eyebrow">
             <a:extLst xmlns:a="http://schemas.openxmlformats.org/drawingml/2006/main">
               <a:ext uri="{FF2B5EF4-FFF2-40B4-BE49-F238E27FC236}">
-                <a16:creationId xmlns:a16="http://schemas.microsoft.com/office/drawing/2014/main" id="{A6A4BDB8-8A51-4F44-9071-2A14637156D8}"/>
+                <a16:creationId xmlns:a16="http://schemas.microsoft.com/office/drawing/2014/main" id="{71EFC40E-DF68-49C6-8165-3D3FE25EF15C}"/>
               </a:ext>
             </a:extLst>
           </p:cNvPr>
@@ -6368,7 +6368,7 @@
           <p:cNvPr id="3" name="slide-title">
             <a:extLst xmlns:a="http://schemas.openxmlformats.org/drawingml/2006/main">
               <a:ext uri="{FF2B5EF4-FFF2-40B4-BE49-F238E27FC236}">
-                <a16:creationId xmlns:a16="http://schemas.microsoft.com/office/drawing/2014/main" id="{55AA2CEC-40BB-4A1C-AEC1-FC94B093C4C2}"/>
+                <a16:creationId xmlns:a16="http://schemas.microsoft.com/office/drawing/2014/main" id="{9DE15466-E0CF-4FD3-BED9-589EA3DE6FCC}"/>
               </a:ext>
             </a:extLst>
           </p:cNvPr>
@@ -6413,7 +6413,7 @@
           <p:cNvPr id="4" name="slide-subtitle">
             <a:extLst xmlns:a="http://schemas.openxmlformats.org/drawingml/2006/main">
               <a:ext uri="{FF2B5EF4-FFF2-40B4-BE49-F238E27FC236}">
-                <a16:creationId xmlns:a16="http://schemas.microsoft.com/office/drawing/2014/main" id="{E9379D81-64A9-40A0-A536-58DC8093DF3B}"/>
+                <a16:creationId xmlns:a16="http://schemas.microsoft.com/office/drawing/2014/main" id="{3464207F-7F6A-42DF-9D1B-B3863CF70B81}"/>
               </a:ext>
             </a:extLst>
           </p:cNvPr>
@@ -6458,7 +6458,7 @@
           <p:cNvPr id="5" name="">
             <a:extLst xmlns:a="http://schemas.openxmlformats.org/drawingml/2006/main">
               <a:ext uri="{FF2B5EF4-FFF2-40B4-BE49-F238E27FC236}">
-                <a16:creationId xmlns:a16="http://schemas.microsoft.com/office/drawing/2014/main" id="{DA560C56-2163-4F10-A393-B9185276BF09}"/>
+                <a16:creationId xmlns:a16="http://schemas.microsoft.com/office/drawing/2014/main" id="{E99FE2B9-9C0B-4312-8AF5-FDFFB8454DD1}"/>
               </a:ext>
             </a:extLst>
           </p:cNvPr>
@@ -6503,7 +6503,7 @@
           <p:cNvPr id="6" name="">
             <a:extLst xmlns:a="http://schemas.openxmlformats.org/drawingml/2006/main">
               <a:ext uri="{FF2B5EF4-FFF2-40B4-BE49-F238E27FC236}">
-                <a16:creationId xmlns:a16="http://schemas.microsoft.com/office/drawing/2014/main" id="{CAC11C0B-48E3-40F6-A7EC-7ED486A7D76B}"/>
+                <a16:creationId xmlns:a16="http://schemas.microsoft.com/office/drawing/2014/main" id="{3BFB049B-49BE-44A6-A21C-D8076A36EEB7}"/>
               </a:ext>
             </a:extLst>
           </p:cNvPr>
@@ -6548,7 +6548,7 @@
           <p:cNvPr id="7" name="">
             <a:extLst xmlns:a="http://schemas.openxmlformats.org/drawingml/2006/main">
               <a:ext uri="{FF2B5EF4-FFF2-40B4-BE49-F238E27FC236}">
-                <a16:creationId xmlns:a16="http://schemas.microsoft.com/office/drawing/2014/main" id="{56DE225F-9D08-409C-91CB-9999537C392F}"/>
+                <a16:creationId xmlns:a16="http://schemas.microsoft.com/office/drawing/2014/main" id="{99018BDD-DCD3-46DC-9F5D-9E7780D8F9E3}"/>
               </a:ext>
             </a:extLst>
           </p:cNvPr>
@@ -6593,7 +6593,7 @@
           <p:cNvPr id="8" name="">
             <a:extLst xmlns:a="http://schemas.openxmlformats.org/drawingml/2006/main">
               <a:ext uri="{FF2B5EF4-FFF2-40B4-BE49-F238E27FC236}">
-                <a16:creationId xmlns:a16="http://schemas.microsoft.com/office/drawing/2014/main" id="{9A4C461A-4811-44FC-8CE3-DEEFC9C3DF9F}"/>
+                <a16:creationId xmlns:a16="http://schemas.microsoft.com/office/drawing/2014/main" id="{3E0D8FDF-EE11-4019-835C-666FD42B24AB}"/>
               </a:ext>
             </a:extLst>
           </p:cNvPr>
@@ -6638,7 +6638,7 @@
           <p:cNvPr id="9" name="">
             <a:extLst xmlns:a="http://schemas.openxmlformats.org/drawingml/2006/main">
               <a:ext uri="{FF2B5EF4-FFF2-40B4-BE49-F238E27FC236}">
-                <a16:creationId xmlns:a16="http://schemas.microsoft.com/office/drawing/2014/main" id="{139802E4-0373-4A55-8F11-904A0616A4B4}"/>
+                <a16:creationId xmlns:a16="http://schemas.microsoft.com/office/drawing/2014/main" id="{E6C4DF87-FC04-44BB-A7F4-FB9B76FD6A11}"/>
               </a:ext>
             </a:extLst>
           </p:cNvPr>
@@ -6683,7 +6683,7 @@
           <p:cNvPr id="10" name="">
             <a:extLst xmlns:a="http://schemas.openxmlformats.org/drawingml/2006/main">
               <a:ext uri="{FF2B5EF4-FFF2-40B4-BE49-F238E27FC236}">
-                <a16:creationId xmlns:a16="http://schemas.microsoft.com/office/drawing/2014/main" id="{CE80D8F4-559A-4439-9EEA-CF7C886C2D86}"/>
+                <a16:creationId xmlns:a16="http://schemas.microsoft.com/office/drawing/2014/main" id="{7BAD381B-9CC7-454C-B5F2-F8FA5160D322}"/>
               </a:ext>
             </a:extLst>
           </p:cNvPr>
@@ -6728,7 +6728,7 @@
           <p:cNvPr id="11" name="">
             <a:extLst xmlns:a="http://schemas.openxmlformats.org/drawingml/2006/main">
               <a:ext uri="{FF2B5EF4-FFF2-40B4-BE49-F238E27FC236}">
-                <a16:creationId xmlns:a16="http://schemas.microsoft.com/office/drawing/2014/main" id="{590AC83C-6352-472A-95DE-313B5E7212CF}"/>
+                <a16:creationId xmlns:a16="http://schemas.microsoft.com/office/drawing/2014/main" id="{F9B67D0A-8E1C-45D1-8983-F3639B0DBEF4}"/>
               </a:ext>
             </a:extLst>
           </p:cNvPr>
@@ -6773,7 +6773,7 @@
           <p:cNvPr id="12" name="">
             <a:extLst xmlns:a="http://schemas.openxmlformats.org/drawingml/2006/main">
               <a:ext uri="{FF2B5EF4-FFF2-40B4-BE49-F238E27FC236}">
-                <a16:creationId xmlns:a16="http://schemas.microsoft.com/office/drawing/2014/main" id="{29700DD6-936A-46F2-A2B5-07035B900B19}"/>
+                <a16:creationId xmlns:a16="http://schemas.microsoft.com/office/drawing/2014/main" id="{E955BD7F-27A0-4B7A-B8DC-653CF6D46A8A}"/>
               </a:ext>
             </a:extLst>
           </p:cNvPr>
@@ -6818,7 +6818,7 @@
           <p:cNvPr id="13" name="">
             <a:extLst xmlns:a="http://schemas.openxmlformats.org/drawingml/2006/main">
               <a:ext uri="{FF2B5EF4-FFF2-40B4-BE49-F238E27FC236}">
-                <a16:creationId xmlns:a16="http://schemas.microsoft.com/office/drawing/2014/main" id="{3B020B4D-271E-4F07-8BF4-DBBEA1938B1C}"/>
+                <a16:creationId xmlns:a16="http://schemas.microsoft.com/office/drawing/2014/main" id="{2824DDBE-EFB8-4DC9-A8FD-B4F4FE98BBA6}"/>
               </a:ext>
             </a:extLst>
           </p:cNvPr>
@@ -6863,7 +6863,7 @@
           <p:cNvPr id="14" name="">
             <a:extLst xmlns:a="http://schemas.openxmlformats.org/drawingml/2006/main">
               <a:ext uri="{FF2B5EF4-FFF2-40B4-BE49-F238E27FC236}">
-                <a16:creationId xmlns:a16="http://schemas.microsoft.com/office/drawing/2014/main" id="{EBA89BBA-9D29-492D-9001-CDDD9C975A8C}"/>
+                <a16:creationId xmlns:a16="http://schemas.microsoft.com/office/drawing/2014/main" id="{9BC35673-2A91-42E4-B77D-DE798E7D28AF}"/>
               </a:ext>
             </a:extLst>
           </p:cNvPr>
@@ -6908,7 +6908,7 @@
           <p:cNvPr id="15" name="footer-left">
             <a:extLst xmlns:a="http://schemas.openxmlformats.org/drawingml/2006/main">
               <a:ext uri="{FF2B5EF4-FFF2-40B4-BE49-F238E27FC236}">
-                <a16:creationId xmlns:a16="http://schemas.microsoft.com/office/drawing/2014/main" id="{0B659C3B-9056-46B1-A310-7CA0BC0CFE0A}"/>
+                <a16:creationId xmlns:a16="http://schemas.microsoft.com/office/drawing/2014/main" id="{B9CC0C1B-7ADA-4E42-8194-6B5AC8548832}"/>
               </a:ext>
             </a:extLst>
           </p:cNvPr>
@@ -6953,7 +6953,7 @@
           <p:cNvPr id="16" name="footer-right">
             <a:extLst xmlns:a="http://schemas.openxmlformats.org/drawingml/2006/main">
               <a:ext uri="{FF2B5EF4-FFF2-40B4-BE49-F238E27FC236}">
-                <a16:creationId xmlns:a16="http://schemas.microsoft.com/office/drawing/2014/main" id="{897FBC2E-AE3F-4BDA-B8AB-1D20E60D22B3}"/>
+                <a16:creationId xmlns:a16="http://schemas.microsoft.com/office/drawing/2014/main" id="{496CB121-DC58-4191-A554-BBCF813C1BC7}"/>
               </a:ext>
             </a:extLst>
           </p:cNvPr>
@@ -6996,7 +6996,7 @@
     </p:spTree>
     <p:extLst>
       <p:ext uri="{BB962C8B-B14F-4D97-AF65-F5344CB8AC3E}">
-        <p14:creationId xmlns:p14="http://schemas.microsoft.com/office/powerpoint/2010/main" val="734539366"/>
+        <p14:creationId xmlns:p14="http://schemas.microsoft.com/office/powerpoint/2010/main" val="214195747"/>
       </p:ext>
     </p:extLst>
   </p:cSld>
@@ -7020,7 +7020,7 @@
           <p:cNvPr id="1" name="slide-stage">
             <a:extLst xmlns:a="http://schemas.openxmlformats.org/drawingml/2006/main">
               <a:ext uri="{FF2B5EF4-FFF2-40B4-BE49-F238E27FC236}">
-                <a16:creationId xmlns:a16="http://schemas.microsoft.com/office/drawing/2014/main" id="{07C4852A-A0AC-4897-929B-AEECC7FB87B7}"/>
+                <a16:creationId xmlns:a16="http://schemas.microsoft.com/office/drawing/2014/main" id="{D3A36964-BA17-4B9B-8A99-B95DA872ED53}"/>
               </a:ext>
             </a:extLst>
           </p:cNvPr>
@@ -7047,7 +7047,7 @@
           <p:cNvPr id="2" name="eyebrow">
             <a:extLst xmlns:a="http://schemas.openxmlformats.org/drawingml/2006/main">
               <a:ext uri="{FF2B5EF4-FFF2-40B4-BE49-F238E27FC236}">
-                <a16:creationId xmlns:a16="http://schemas.microsoft.com/office/drawing/2014/main" id="{71CD0B19-4C44-4D2C-A729-8C1AC39BC174}"/>
+                <a16:creationId xmlns:a16="http://schemas.microsoft.com/office/drawing/2014/main" id="{9A479237-145A-4139-A032-96FA6917AF78}"/>
               </a:ext>
             </a:extLst>
           </p:cNvPr>
@@ -7092,7 +7092,7 @@
           <p:cNvPr id="3" name="slide-title">
             <a:extLst xmlns:a="http://schemas.openxmlformats.org/drawingml/2006/main">
               <a:ext uri="{FF2B5EF4-FFF2-40B4-BE49-F238E27FC236}">
-                <a16:creationId xmlns:a16="http://schemas.microsoft.com/office/drawing/2014/main" id="{6093A1F0-643F-40FC-AFEB-154D82D3532D}"/>
+                <a16:creationId xmlns:a16="http://schemas.microsoft.com/office/drawing/2014/main" id="{A9734C72-CC72-452D-BA87-7AB09EE9BEB7}"/>
               </a:ext>
             </a:extLst>
           </p:cNvPr>
@@ -7137,7 +7137,7 @@
           <p:cNvPr id="4" name="slide-subtitle">
             <a:extLst xmlns:a="http://schemas.openxmlformats.org/drawingml/2006/main">
               <a:ext uri="{FF2B5EF4-FFF2-40B4-BE49-F238E27FC236}">
-                <a16:creationId xmlns:a16="http://schemas.microsoft.com/office/drawing/2014/main" id="{F0F2878D-3204-4204-8A2C-91889AD74349}"/>
+                <a16:creationId xmlns:a16="http://schemas.microsoft.com/office/drawing/2014/main" id="{91C1F130-342B-4A72-BFB2-A0CE41DDF7C7}"/>
               </a:ext>
             </a:extLst>
           </p:cNvPr>
@@ -7182,7 +7182,7 @@
           <p:cNvPr id="5" name="">
             <a:extLst xmlns:a="http://schemas.openxmlformats.org/drawingml/2006/main">
               <a:ext uri="{FF2B5EF4-FFF2-40B4-BE49-F238E27FC236}">
-                <a16:creationId xmlns:a16="http://schemas.microsoft.com/office/drawing/2014/main" id="{3285091C-145A-4D79-BE87-E8DD53325978}"/>
+                <a16:creationId xmlns:a16="http://schemas.microsoft.com/office/drawing/2014/main" id="{232785A1-E073-4B94-AF7D-791143AD25D0}"/>
               </a:ext>
             </a:extLst>
           </p:cNvPr>
@@ -7215,7 +7215,7 @@
           <p:cNvPr id="6" name="">
             <a:extLst xmlns:a="http://schemas.openxmlformats.org/drawingml/2006/main">
               <a:ext uri="{FF2B5EF4-FFF2-40B4-BE49-F238E27FC236}">
-                <a16:creationId xmlns:a16="http://schemas.microsoft.com/office/drawing/2014/main" id="{8E0DE10D-C756-4A22-839E-174E057FC695}"/>
+                <a16:creationId xmlns:a16="http://schemas.microsoft.com/office/drawing/2014/main" id="{DEEFE5BE-5EC6-4E50-BC5D-BB9F93B1E281}"/>
               </a:ext>
             </a:extLst>
           </p:cNvPr>
@@ -7260,7 +7260,7 @@
           <p:cNvPr id="7" name="">
             <a:extLst xmlns:a="http://schemas.openxmlformats.org/drawingml/2006/main">
               <a:ext uri="{FF2B5EF4-FFF2-40B4-BE49-F238E27FC236}">
-                <a16:creationId xmlns:a16="http://schemas.microsoft.com/office/drawing/2014/main" id="{7E70DCA9-C6A2-4A7E-B571-49B26115998C}"/>
+                <a16:creationId xmlns:a16="http://schemas.microsoft.com/office/drawing/2014/main" id="{90A42005-09E2-4960-9044-18EB86587CE8}"/>
               </a:ext>
             </a:extLst>
           </p:cNvPr>
@@ -7305,7 +7305,7 @@
           <p:cNvPr id="8" name="">
             <a:extLst xmlns:a="http://schemas.openxmlformats.org/drawingml/2006/main">
               <a:ext uri="{FF2B5EF4-FFF2-40B4-BE49-F238E27FC236}">
-                <a16:creationId xmlns:a16="http://schemas.microsoft.com/office/drawing/2014/main" id="{FECF38EE-6989-49A6-8408-7EE591DF10A1}"/>
+                <a16:creationId xmlns:a16="http://schemas.microsoft.com/office/drawing/2014/main" id="{F329832F-1736-4A47-AD8C-326DD48DA405}"/>
               </a:ext>
             </a:extLst>
           </p:cNvPr>
@@ -7338,7 +7338,7 @@
           <p:cNvPr id="9" name="">
             <a:extLst xmlns:a="http://schemas.openxmlformats.org/drawingml/2006/main">
               <a:ext uri="{FF2B5EF4-FFF2-40B4-BE49-F238E27FC236}">
-                <a16:creationId xmlns:a16="http://schemas.microsoft.com/office/drawing/2014/main" id="{798BA254-A3E9-4A73-AA9C-4ECB291E91EA}"/>
+                <a16:creationId xmlns:a16="http://schemas.microsoft.com/office/drawing/2014/main" id="{AF858176-B8C3-4B59-A03B-9417768A98F1}"/>
               </a:ext>
             </a:extLst>
           </p:cNvPr>
@@ -7383,7 +7383,7 @@
           <p:cNvPr id="10" name="">
             <a:extLst xmlns:a="http://schemas.openxmlformats.org/drawingml/2006/main">
               <a:ext uri="{FF2B5EF4-FFF2-40B4-BE49-F238E27FC236}">
-                <a16:creationId xmlns:a16="http://schemas.microsoft.com/office/drawing/2014/main" id="{AA43279D-A44E-4E73-8DBE-8B60B41A6E14}"/>
+                <a16:creationId xmlns:a16="http://schemas.microsoft.com/office/drawing/2014/main" id="{78425D6C-44D8-42E7-8957-B32DE3447971}"/>
               </a:ext>
             </a:extLst>
           </p:cNvPr>
@@ -7428,7 +7428,7 @@
           <p:cNvPr id="11" name="">
             <a:extLst xmlns:a="http://schemas.openxmlformats.org/drawingml/2006/main">
               <a:ext uri="{FF2B5EF4-FFF2-40B4-BE49-F238E27FC236}">
-                <a16:creationId xmlns:a16="http://schemas.microsoft.com/office/drawing/2014/main" id="{E11603C3-2716-4BB8-89C3-772620A0AA4A}"/>
+                <a16:creationId xmlns:a16="http://schemas.microsoft.com/office/drawing/2014/main" id="{3B33EF55-F454-4CA2-AE4C-EABEE3001F56}"/>
               </a:ext>
             </a:extLst>
           </p:cNvPr>
@@ -7461,7 +7461,7 @@
           <p:cNvPr id="12" name="">
             <a:extLst xmlns:a="http://schemas.openxmlformats.org/drawingml/2006/main">
               <a:ext uri="{FF2B5EF4-FFF2-40B4-BE49-F238E27FC236}">
-                <a16:creationId xmlns:a16="http://schemas.microsoft.com/office/drawing/2014/main" id="{ACB146CA-9CF9-4817-9555-5CAFC2441E3C}"/>
+                <a16:creationId xmlns:a16="http://schemas.microsoft.com/office/drawing/2014/main" id="{C6682B61-DB3B-4DF8-9DAD-01BCF1C41A93}"/>
               </a:ext>
             </a:extLst>
           </p:cNvPr>
@@ -7506,7 +7506,7 @@
           <p:cNvPr id="13" name="">
             <a:extLst xmlns:a="http://schemas.openxmlformats.org/drawingml/2006/main">
               <a:ext uri="{FF2B5EF4-FFF2-40B4-BE49-F238E27FC236}">
-                <a16:creationId xmlns:a16="http://schemas.microsoft.com/office/drawing/2014/main" id="{8649976C-DA0A-4FF7-AE6B-ED721538B538}"/>
+                <a16:creationId xmlns:a16="http://schemas.microsoft.com/office/drawing/2014/main" id="{CECCC668-F8D9-48B4-9868-166802953844}"/>
               </a:ext>
             </a:extLst>
           </p:cNvPr>
@@ -7551,7 +7551,7 @@
           <p:cNvPr id="14" name="">
             <a:extLst xmlns:a="http://schemas.openxmlformats.org/drawingml/2006/main">
               <a:ext uri="{FF2B5EF4-FFF2-40B4-BE49-F238E27FC236}">
-                <a16:creationId xmlns:a16="http://schemas.microsoft.com/office/drawing/2014/main" id="{53A5A763-9BEE-477A-A0B1-1FCD40F3F621}"/>
+                <a16:creationId xmlns:a16="http://schemas.microsoft.com/office/drawing/2014/main" id="{E65DFA59-9318-45A4-94B9-3586A94D41D4}"/>
               </a:ext>
             </a:extLst>
           </p:cNvPr>
@@ -7584,7 +7584,7 @@
           <p:cNvPr id="15" name="">
             <a:extLst xmlns:a="http://schemas.openxmlformats.org/drawingml/2006/main">
               <a:ext uri="{FF2B5EF4-FFF2-40B4-BE49-F238E27FC236}">
-                <a16:creationId xmlns:a16="http://schemas.microsoft.com/office/drawing/2014/main" id="{072E3992-4188-4A18-B993-FF18A5BD7D38}"/>
+                <a16:creationId xmlns:a16="http://schemas.microsoft.com/office/drawing/2014/main" id="{3F1AD242-FEDC-4114-86C3-FF6B14599A0F}"/>
               </a:ext>
             </a:extLst>
           </p:cNvPr>
@@ -7629,7 +7629,7 @@
           <p:cNvPr id="16" name="">
             <a:extLst xmlns:a="http://schemas.openxmlformats.org/drawingml/2006/main">
               <a:ext uri="{FF2B5EF4-FFF2-40B4-BE49-F238E27FC236}">
-                <a16:creationId xmlns:a16="http://schemas.microsoft.com/office/drawing/2014/main" id="{702E69D4-E1A3-48BB-BAA9-15373ED1D862}"/>
+                <a16:creationId xmlns:a16="http://schemas.microsoft.com/office/drawing/2014/main" id="{4F6FF959-7B3A-411A-872D-CB26B6168444}"/>
               </a:ext>
             </a:extLst>
           </p:cNvPr>
@@ -7674,7 +7674,7 @@
           <p:cNvPr id="17" name="footer-left">
             <a:extLst xmlns:a="http://schemas.openxmlformats.org/drawingml/2006/main">
               <a:ext uri="{FF2B5EF4-FFF2-40B4-BE49-F238E27FC236}">
-                <a16:creationId xmlns:a16="http://schemas.microsoft.com/office/drawing/2014/main" id="{137471FF-62A9-4577-B9C5-03794B00140A}"/>
+                <a16:creationId xmlns:a16="http://schemas.microsoft.com/office/drawing/2014/main" id="{2ABE6EC4-21B8-4F28-8B29-68DCB8859C36}"/>
               </a:ext>
             </a:extLst>
           </p:cNvPr>
@@ -7719,7 +7719,7 @@
           <p:cNvPr id="18" name="footer-right">
             <a:extLst xmlns:a="http://schemas.openxmlformats.org/drawingml/2006/main">
               <a:ext uri="{FF2B5EF4-FFF2-40B4-BE49-F238E27FC236}">
-                <a16:creationId xmlns:a16="http://schemas.microsoft.com/office/drawing/2014/main" id="{908EB5DA-21A8-4C68-99C9-C8767B814D1D}"/>
+                <a16:creationId xmlns:a16="http://schemas.microsoft.com/office/drawing/2014/main" id="{0E26B2A4-7E1D-4D53-89F4-8F0BE9EB994D}"/>
               </a:ext>
             </a:extLst>
           </p:cNvPr>
@@ -7762,7 +7762,7 @@
     </p:spTree>
     <p:extLst>
       <p:ext uri="{BB962C8B-B14F-4D97-AF65-F5344CB8AC3E}">
-        <p14:creationId xmlns:p14="http://schemas.microsoft.com/office/powerpoint/2010/main" val="1872815003"/>
+        <p14:creationId xmlns:p14="http://schemas.microsoft.com/office/powerpoint/2010/main" val="1788062789"/>
       </p:ext>
     </p:extLst>
   </p:cSld>
@@ -7786,7 +7786,7 @@
           <p:cNvPr id="1" name="slide-stage">
             <a:extLst xmlns:a="http://schemas.openxmlformats.org/drawingml/2006/main">
               <a:ext uri="{FF2B5EF4-FFF2-40B4-BE49-F238E27FC236}">
-                <a16:creationId xmlns:a16="http://schemas.microsoft.com/office/drawing/2014/main" id="{FED48E2A-0548-49D8-AAAB-A788632B68A0}"/>
+                <a16:creationId xmlns:a16="http://schemas.microsoft.com/office/drawing/2014/main" id="{ED21964A-DAEE-4CB1-9788-25FE37CC2906}"/>
               </a:ext>
             </a:extLst>
           </p:cNvPr>
@@ -7813,7 +7813,7 @@
           <p:cNvPr id="2" name="eyebrow">
             <a:extLst xmlns:a="http://schemas.openxmlformats.org/drawingml/2006/main">
               <a:ext uri="{FF2B5EF4-FFF2-40B4-BE49-F238E27FC236}">
-                <a16:creationId xmlns:a16="http://schemas.microsoft.com/office/drawing/2014/main" id="{BDD2F755-0379-4C63-B0DE-8838401E183A}"/>
+                <a16:creationId xmlns:a16="http://schemas.microsoft.com/office/drawing/2014/main" id="{FBE89112-E508-4997-9A7D-B9EE4223A97F}"/>
               </a:ext>
             </a:extLst>
           </p:cNvPr>
@@ -7858,7 +7858,7 @@
           <p:cNvPr id="3" name="slide-title">
             <a:extLst xmlns:a="http://schemas.openxmlformats.org/drawingml/2006/main">
               <a:ext uri="{FF2B5EF4-FFF2-40B4-BE49-F238E27FC236}">
-                <a16:creationId xmlns:a16="http://schemas.microsoft.com/office/drawing/2014/main" id="{9789D6AF-236F-4D61-995E-FD279B0D6457}"/>
+                <a16:creationId xmlns:a16="http://schemas.microsoft.com/office/drawing/2014/main" id="{E19E867B-B0A8-4671-8F6A-02B1A85841B8}"/>
               </a:ext>
             </a:extLst>
           </p:cNvPr>
@@ -7903,7 +7903,7 @@
           <p:cNvPr id="4" name="slide-subtitle">
             <a:extLst xmlns:a="http://schemas.openxmlformats.org/drawingml/2006/main">
               <a:ext uri="{FF2B5EF4-FFF2-40B4-BE49-F238E27FC236}">
-                <a16:creationId xmlns:a16="http://schemas.microsoft.com/office/drawing/2014/main" id="{4612BED5-B807-4ECF-8062-E908F0F92347}"/>
+                <a16:creationId xmlns:a16="http://schemas.microsoft.com/office/drawing/2014/main" id="{2E242730-135C-48E1-951D-E1FE5537D9CE}"/>
               </a:ext>
             </a:extLst>
           </p:cNvPr>
@@ -7948,7 +7948,7 @@
           <p:cNvPr id="5" name="">
             <a:extLst xmlns:a="http://schemas.openxmlformats.org/drawingml/2006/main">
               <a:ext uri="{FF2B5EF4-FFF2-40B4-BE49-F238E27FC236}">
-                <a16:creationId xmlns:a16="http://schemas.microsoft.com/office/drawing/2014/main" id="{327AEF15-693C-430A-BBED-8D12CC29C82F}"/>
+                <a16:creationId xmlns:a16="http://schemas.microsoft.com/office/drawing/2014/main" id="{747DA5F9-52BD-480E-A254-E30011EC65B5}"/>
               </a:ext>
             </a:extLst>
           </p:cNvPr>
@@ -7993,7 +7993,7 @@
           <p:cNvPr id="6" name="">
             <a:extLst xmlns:a="http://schemas.openxmlformats.org/drawingml/2006/main">
               <a:ext uri="{FF2B5EF4-FFF2-40B4-BE49-F238E27FC236}">
-                <a16:creationId xmlns:a16="http://schemas.microsoft.com/office/drawing/2014/main" id="{63F2CC6A-74E1-45F3-8F88-867FF1FF8D83}"/>
+                <a16:creationId xmlns:a16="http://schemas.microsoft.com/office/drawing/2014/main" id="{B1AAAC48-4F95-4D5D-A96B-2FCB5EDD39BA}"/>
               </a:ext>
             </a:extLst>
           </p:cNvPr>
@@ -8038,7 +8038,7 @@
           <p:cNvPr id="7" name="">
             <a:extLst xmlns:a="http://schemas.openxmlformats.org/drawingml/2006/main">
               <a:ext uri="{FF2B5EF4-FFF2-40B4-BE49-F238E27FC236}">
-                <a16:creationId xmlns:a16="http://schemas.microsoft.com/office/drawing/2014/main" id="{F18A0F58-1ED2-4874-AC8A-19CB3D928D20}"/>
+                <a16:creationId xmlns:a16="http://schemas.microsoft.com/office/drawing/2014/main" id="{2E3A6934-D75D-4A41-8990-936DC55A35AC}"/>
               </a:ext>
             </a:extLst>
           </p:cNvPr>
@@ -8071,7 +8071,7 @@
           <p:cNvPr id="8" name="">
             <a:extLst xmlns:a="http://schemas.openxmlformats.org/drawingml/2006/main">
               <a:ext uri="{FF2B5EF4-FFF2-40B4-BE49-F238E27FC236}">
-                <a16:creationId xmlns:a16="http://schemas.microsoft.com/office/drawing/2014/main" id="{FB424678-7D9A-484D-B7F6-8E5C33ED5658}"/>
+                <a16:creationId xmlns:a16="http://schemas.microsoft.com/office/drawing/2014/main" id="{AB6C440C-0EA5-4D16-B336-AABCC2B754F7}"/>
               </a:ext>
             </a:extLst>
           </p:cNvPr>
@@ -8116,7 +8116,7 @@
           <p:cNvPr id="9" name="">
             <a:extLst xmlns:a="http://schemas.openxmlformats.org/drawingml/2006/main">
               <a:ext uri="{FF2B5EF4-FFF2-40B4-BE49-F238E27FC236}">
-                <a16:creationId xmlns:a16="http://schemas.microsoft.com/office/drawing/2014/main" id="{D2E5195E-CC08-4983-8AEA-21730B39448D}"/>
+                <a16:creationId xmlns:a16="http://schemas.microsoft.com/office/drawing/2014/main" id="{06E79F71-87E9-438D-97E4-F25EA331AB63}"/>
               </a:ext>
             </a:extLst>
           </p:cNvPr>
@@ -8161,7 +8161,7 @@
           <p:cNvPr id="10" name="">
             <a:extLst xmlns:a="http://schemas.openxmlformats.org/drawingml/2006/main">
               <a:ext uri="{FF2B5EF4-FFF2-40B4-BE49-F238E27FC236}">
-                <a16:creationId xmlns:a16="http://schemas.microsoft.com/office/drawing/2014/main" id="{56387260-50CF-4171-AB2C-1397B9079D1D}"/>
+                <a16:creationId xmlns:a16="http://schemas.microsoft.com/office/drawing/2014/main" id="{D33DEA02-A80A-4FC4-BA99-5275F10FCB64}"/>
               </a:ext>
             </a:extLst>
           </p:cNvPr>
@@ -8194,7 +8194,7 @@
           <p:cNvPr id="11" name="">
             <a:extLst xmlns:a="http://schemas.openxmlformats.org/drawingml/2006/main">
               <a:ext uri="{FF2B5EF4-FFF2-40B4-BE49-F238E27FC236}">
-                <a16:creationId xmlns:a16="http://schemas.microsoft.com/office/drawing/2014/main" id="{89275F2B-03FE-47B6-AB2C-1FAF7D3FEF29}"/>
+                <a16:creationId xmlns:a16="http://schemas.microsoft.com/office/drawing/2014/main" id="{D58A8D69-50F3-4B61-88DC-BEA5AEF8F7BB}"/>
               </a:ext>
             </a:extLst>
           </p:cNvPr>
@@ -8239,7 +8239,7 @@
           <p:cNvPr id="12" name="">
             <a:extLst xmlns:a="http://schemas.openxmlformats.org/drawingml/2006/main">
               <a:ext uri="{FF2B5EF4-FFF2-40B4-BE49-F238E27FC236}">
-                <a16:creationId xmlns:a16="http://schemas.microsoft.com/office/drawing/2014/main" id="{AF339CE0-CE25-4D3D-884D-27D286A8F778}"/>
+                <a16:creationId xmlns:a16="http://schemas.microsoft.com/office/drawing/2014/main" id="{745A114A-7F86-4684-8CBA-F775786E7FE5}"/>
               </a:ext>
             </a:extLst>
           </p:cNvPr>
@@ -8284,7 +8284,7 @@
           <p:cNvPr id="13" name="">
             <a:extLst xmlns:a="http://schemas.openxmlformats.org/drawingml/2006/main">
               <a:ext uri="{FF2B5EF4-FFF2-40B4-BE49-F238E27FC236}">
-                <a16:creationId xmlns:a16="http://schemas.microsoft.com/office/drawing/2014/main" id="{B9782206-396F-435D-8220-8F2AB5C18233}"/>
+                <a16:creationId xmlns:a16="http://schemas.microsoft.com/office/drawing/2014/main" id="{1BA383DF-72B9-46FE-96B4-FD1EBA2F2375}"/>
               </a:ext>
             </a:extLst>
           </p:cNvPr>
@@ -8317,7 +8317,7 @@
           <p:cNvPr id="14" name="">
             <a:extLst xmlns:a="http://schemas.openxmlformats.org/drawingml/2006/main">
               <a:ext uri="{FF2B5EF4-FFF2-40B4-BE49-F238E27FC236}">
-                <a16:creationId xmlns:a16="http://schemas.microsoft.com/office/drawing/2014/main" id="{79FE4D89-8889-4F97-907A-2B7AF93675D6}"/>
+                <a16:creationId xmlns:a16="http://schemas.microsoft.com/office/drawing/2014/main" id="{5AD708AB-1D58-4503-994C-07E747575402}"/>
               </a:ext>
             </a:extLst>
           </p:cNvPr>
@@ -8362,7 +8362,7 @@
           <p:cNvPr id="15" name="">
             <a:extLst xmlns:a="http://schemas.openxmlformats.org/drawingml/2006/main">
               <a:ext uri="{FF2B5EF4-FFF2-40B4-BE49-F238E27FC236}">
-                <a16:creationId xmlns:a16="http://schemas.microsoft.com/office/drawing/2014/main" id="{663CD118-E011-4081-9D02-8781D91F2CEF}"/>
+                <a16:creationId xmlns:a16="http://schemas.microsoft.com/office/drawing/2014/main" id="{3B8623D9-4B36-4399-9E9C-8D7D7AC925D0}"/>
               </a:ext>
             </a:extLst>
           </p:cNvPr>
@@ -8407,7 +8407,7 @@
           <p:cNvPr id="16" name="footer-left">
             <a:extLst xmlns:a="http://schemas.openxmlformats.org/drawingml/2006/main">
               <a:ext uri="{FF2B5EF4-FFF2-40B4-BE49-F238E27FC236}">
-                <a16:creationId xmlns:a16="http://schemas.microsoft.com/office/drawing/2014/main" id="{91A33223-2F0A-45EB-A917-DF6BCDAF1993}"/>
+                <a16:creationId xmlns:a16="http://schemas.microsoft.com/office/drawing/2014/main" id="{16821C1A-ED55-4BF6-AFFC-EFD86321EA9A}"/>
               </a:ext>
             </a:extLst>
           </p:cNvPr>
@@ -8452,7 +8452,7 @@
           <p:cNvPr id="17" name="footer-right">
             <a:extLst xmlns:a="http://schemas.openxmlformats.org/drawingml/2006/main">
               <a:ext uri="{FF2B5EF4-FFF2-40B4-BE49-F238E27FC236}">
-                <a16:creationId xmlns:a16="http://schemas.microsoft.com/office/drawing/2014/main" id="{10E4B461-1D68-486F-A9DF-5EE5DDD50F6A}"/>
+                <a16:creationId xmlns:a16="http://schemas.microsoft.com/office/drawing/2014/main" id="{E8354CCD-43F4-47CD-9192-F5DF84E5678C}"/>
               </a:ext>
             </a:extLst>
           </p:cNvPr>
@@ -8495,7 +8495,7 @@
     </p:spTree>
     <p:extLst>
       <p:ext uri="{BB962C8B-B14F-4D97-AF65-F5344CB8AC3E}">
-        <p14:creationId xmlns:p14="http://schemas.microsoft.com/office/powerpoint/2010/main" val="2107410240"/>
+        <p14:creationId xmlns:p14="http://schemas.microsoft.com/office/powerpoint/2010/main" val="571617672"/>
       </p:ext>
     </p:extLst>
   </p:cSld>
@@ -8519,7 +8519,7 @@
           <p:cNvPr id="1" name="slide-stage">
             <a:extLst xmlns:a="http://schemas.openxmlformats.org/drawingml/2006/main">
               <a:ext uri="{FF2B5EF4-FFF2-40B4-BE49-F238E27FC236}">
-                <a16:creationId xmlns:a16="http://schemas.microsoft.com/office/drawing/2014/main" id="{B1ECF297-6D87-4ECC-9421-1354EEF7F6B1}"/>
+                <a16:creationId xmlns:a16="http://schemas.microsoft.com/office/drawing/2014/main" id="{02D79C33-60E6-42C0-93DC-F79EF3869EC6}"/>
               </a:ext>
             </a:extLst>
           </p:cNvPr>
@@ -8546,7 +8546,7 @@
           <p:cNvPr id="2" name="eyebrow">
             <a:extLst xmlns:a="http://schemas.openxmlformats.org/drawingml/2006/main">
               <a:ext uri="{FF2B5EF4-FFF2-40B4-BE49-F238E27FC236}">
-                <a16:creationId xmlns:a16="http://schemas.microsoft.com/office/drawing/2014/main" id="{D94D63EB-3B70-47F0-ABF1-BE8F2F5263B2}"/>
+                <a16:creationId xmlns:a16="http://schemas.microsoft.com/office/drawing/2014/main" id="{3E359896-1D04-4BBD-8193-98107D443C86}"/>
               </a:ext>
             </a:extLst>
           </p:cNvPr>
@@ -8591,7 +8591,7 @@
           <p:cNvPr id="3" name="slide-title">
             <a:extLst xmlns:a="http://schemas.openxmlformats.org/drawingml/2006/main">
               <a:ext uri="{FF2B5EF4-FFF2-40B4-BE49-F238E27FC236}">
-                <a16:creationId xmlns:a16="http://schemas.microsoft.com/office/drawing/2014/main" id="{F460A3A7-E248-4C8A-9701-00FB9FCAEBA7}"/>
+                <a16:creationId xmlns:a16="http://schemas.microsoft.com/office/drawing/2014/main" id="{A52D3636-60EA-4A26-AEC7-8F9573920E43}"/>
               </a:ext>
             </a:extLst>
           </p:cNvPr>
@@ -8636,7 +8636,7 @@
           <p:cNvPr id="4" name="slide-subtitle">
             <a:extLst xmlns:a="http://schemas.openxmlformats.org/drawingml/2006/main">
               <a:ext uri="{FF2B5EF4-FFF2-40B4-BE49-F238E27FC236}">
-                <a16:creationId xmlns:a16="http://schemas.microsoft.com/office/drawing/2014/main" id="{082B431D-CC41-4768-B1F8-CEBA1683D2D4}"/>
+                <a16:creationId xmlns:a16="http://schemas.microsoft.com/office/drawing/2014/main" id="{2E27E895-8A18-4BD7-B8BE-362046F7F2F2}"/>
               </a:ext>
             </a:extLst>
           </p:cNvPr>
@@ -8681,7 +8681,7 @@
           <p:cNvPr id="5" name="">
             <a:extLst xmlns:a="http://schemas.openxmlformats.org/drawingml/2006/main">
               <a:ext uri="{FF2B5EF4-FFF2-40B4-BE49-F238E27FC236}">
-                <a16:creationId xmlns:a16="http://schemas.microsoft.com/office/drawing/2014/main" id="{14C03157-B7A6-495C-8A0B-D155EC5E1F40}"/>
+                <a16:creationId xmlns:a16="http://schemas.microsoft.com/office/drawing/2014/main" id="{BF4ED067-4DE6-4BEA-A0C9-1209F2AC940A}"/>
               </a:ext>
             </a:extLst>
           </p:cNvPr>
@@ -8726,7 +8726,7 @@
           <p:cNvPr id="6" name="">
             <a:extLst xmlns:a="http://schemas.openxmlformats.org/drawingml/2006/main">
               <a:ext uri="{FF2B5EF4-FFF2-40B4-BE49-F238E27FC236}">
-                <a16:creationId xmlns:a16="http://schemas.microsoft.com/office/drawing/2014/main" id="{BBAF1CD9-F08B-408F-BB7C-8F31A85D66FA}"/>
+                <a16:creationId xmlns:a16="http://schemas.microsoft.com/office/drawing/2014/main" id="{207222C9-CCB1-4854-B1F7-F0583340C3DC}"/>
               </a:ext>
             </a:extLst>
           </p:cNvPr>
@@ -8771,7 +8771,7 @@
           <p:cNvPr id="7" name="">
             <a:extLst xmlns:a="http://schemas.openxmlformats.org/drawingml/2006/main">
               <a:ext uri="{FF2B5EF4-FFF2-40B4-BE49-F238E27FC236}">
-                <a16:creationId xmlns:a16="http://schemas.microsoft.com/office/drawing/2014/main" id="{48A57F6A-2E9D-46FE-ADF1-B6B0B7C1240F}"/>
+                <a16:creationId xmlns:a16="http://schemas.microsoft.com/office/drawing/2014/main" id="{829FDEA0-B59D-4129-B56C-DB15525C598D}"/>
               </a:ext>
             </a:extLst>
           </p:cNvPr>
@@ -8816,7 +8816,7 @@
           <p:cNvPr id="8" name="">
             <a:extLst xmlns:a="http://schemas.openxmlformats.org/drawingml/2006/main">
               <a:ext uri="{FF2B5EF4-FFF2-40B4-BE49-F238E27FC236}">
-                <a16:creationId xmlns:a16="http://schemas.microsoft.com/office/drawing/2014/main" id="{E3880754-8F4C-42F1-BC5E-321BDBA17CC1}"/>
+                <a16:creationId xmlns:a16="http://schemas.microsoft.com/office/drawing/2014/main" id="{3ACED55A-3189-4FA0-A8C9-9B2497500B11}"/>
               </a:ext>
             </a:extLst>
           </p:cNvPr>
@@ -8861,7 +8861,7 @@
           <p:cNvPr id="9" name="">
             <a:extLst xmlns:a="http://schemas.openxmlformats.org/drawingml/2006/main">
               <a:ext uri="{FF2B5EF4-FFF2-40B4-BE49-F238E27FC236}">
-                <a16:creationId xmlns:a16="http://schemas.microsoft.com/office/drawing/2014/main" id="{A9D8774C-0AEF-49D3-9A07-09460487AC69}"/>
+                <a16:creationId xmlns:a16="http://schemas.microsoft.com/office/drawing/2014/main" id="{1D1FCAB7-6C22-40EC-8CCD-1BC21334BE07}"/>
               </a:ext>
             </a:extLst>
           </p:cNvPr>
@@ -8906,7 +8906,7 @@
           <p:cNvPr id="10" name="">
             <a:extLst xmlns:a="http://schemas.openxmlformats.org/drawingml/2006/main">
               <a:ext uri="{FF2B5EF4-FFF2-40B4-BE49-F238E27FC236}">
-                <a16:creationId xmlns:a16="http://schemas.microsoft.com/office/drawing/2014/main" id="{C4EE3FB1-63E0-42FC-9EF4-AD3967F62777}"/>
+                <a16:creationId xmlns:a16="http://schemas.microsoft.com/office/drawing/2014/main" id="{9DF5F706-BAFD-41CE-922F-0E65327F0583}"/>
               </a:ext>
             </a:extLst>
           </p:cNvPr>
@@ -8951,7 +8951,7 @@
           <p:cNvPr id="11" name="">
             <a:extLst xmlns:a="http://schemas.openxmlformats.org/drawingml/2006/main">
               <a:ext uri="{FF2B5EF4-FFF2-40B4-BE49-F238E27FC236}">
-                <a16:creationId xmlns:a16="http://schemas.microsoft.com/office/drawing/2014/main" id="{1FBDC2E2-F6A5-4FBC-9BE6-E5C7BB6F1D5F}"/>
+                <a16:creationId xmlns:a16="http://schemas.microsoft.com/office/drawing/2014/main" id="{D72AFB62-6DBF-448E-88F8-C41EB78FE661}"/>
               </a:ext>
             </a:extLst>
           </p:cNvPr>
@@ -8996,7 +8996,7 @@
           <p:cNvPr id="12" name="">
             <a:extLst xmlns:a="http://schemas.openxmlformats.org/drawingml/2006/main">
               <a:ext uri="{FF2B5EF4-FFF2-40B4-BE49-F238E27FC236}">
-                <a16:creationId xmlns:a16="http://schemas.microsoft.com/office/drawing/2014/main" id="{B68BC440-CEC5-48F3-83AA-6DBE1BE66447}"/>
+                <a16:creationId xmlns:a16="http://schemas.microsoft.com/office/drawing/2014/main" id="{6A8B0232-A472-47B5-9D58-82F73F4E8DAC}"/>
               </a:ext>
             </a:extLst>
           </p:cNvPr>
@@ -9041,7 +9041,7 @@
           <p:cNvPr id="13" name="footer-left">
             <a:extLst xmlns:a="http://schemas.openxmlformats.org/drawingml/2006/main">
               <a:ext uri="{FF2B5EF4-FFF2-40B4-BE49-F238E27FC236}">
-                <a16:creationId xmlns:a16="http://schemas.microsoft.com/office/drawing/2014/main" id="{21CABDC2-E87E-4E8D-928E-2F0E6841D46A}"/>
+                <a16:creationId xmlns:a16="http://schemas.microsoft.com/office/drawing/2014/main" id="{E3F4A5E9-0885-45B6-9A3B-07EACBB6BDCA}"/>
               </a:ext>
             </a:extLst>
           </p:cNvPr>
@@ -9086,7 +9086,7 @@
           <p:cNvPr id="14" name="footer-right">
             <a:extLst xmlns:a="http://schemas.openxmlformats.org/drawingml/2006/main">
               <a:ext uri="{FF2B5EF4-FFF2-40B4-BE49-F238E27FC236}">
-                <a16:creationId xmlns:a16="http://schemas.microsoft.com/office/drawing/2014/main" id="{2A757F42-83B7-4E2F-9E88-607FD7D63A2D}"/>
+                <a16:creationId xmlns:a16="http://schemas.microsoft.com/office/drawing/2014/main" id="{AFCED534-B5EB-4912-90D9-8FECEA4CE469}"/>
               </a:ext>
             </a:extLst>
           </p:cNvPr>
@@ -9129,7 +9129,7 @@
     </p:spTree>
     <p:extLst>
       <p:ext uri="{BB962C8B-B14F-4D97-AF65-F5344CB8AC3E}">
-        <p14:creationId xmlns:p14="http://schemas.microsoft.com/office/powerpoint/2010/main" val="56830750"/>
+        <p14:creationId xmlns:p14="http://schemas.microsoft.com/office/powerpoint/2010/main" val="83194210"/>
       </p:ext>
     </p:extLst>
   </p:cSld>
@@ -9153,7 +9153,7 @@
           <p:cNvPr id="1" name="slide-stage">
             <a:extLst xmlns:a="http://schemas.openxmlformats.org/drawingml/2006/main">
               <a:ext uri="{FF2B5EF4-FFF2-40B4-BE49-F238E27FC236}">
-                <a16:creationId xmlns:a16="http://schemas.microsoft.com/office/drawing/2014/main" id="{E730BA58-FC39-4E2D-91B8-A47C0CE3F25C}"/>
+                <a16:creationId xmlns:a16="http://schemas.microsoft.com/office/drawing/2014/main" id="{9AB5A9AE-E788-429D-ACB4-08485C3FEC37}"/>
               </a:ext>
             </a:extLst>
           </p:cNvPr>
@@ -9180,7 +9180,7 @@
           <p:cNvPr id="2" name="eyebrow">
             <a:extLst xmlns:a="http://schemas.openxmlformats.org/drawingml/2006/main">
               <a:ext uri="{FF2B5EF4-FFF2-40B4-BE49-F238E27FC236}">
-                <a16:creationId xmlns:a16="http://schemas.microsoft.com/office/drawing/2014/main" id="{5F672D72-A4F8-41B5-A297-0077583DF73C}"/>
+                <a16:creationId xmlns:a16="http://schemas.microsoft.com/office/drawing/2014/main" id="{949DDAA9-2D06-48BF-A47D-77CBB9BE65AA}"/>
               </a:ext>
             </a:extLst>
           </p:cNvPr>
@@ -9225,7 +9225,7 @@
           <p:cNvPr id="3" name="slide-title">
             <a:extLst xmlns:a="http://schemas.openxmlformats.org/drawingml/2006/main">
               <a:ext uri="{FF2B5EF4-FFF2-40B4-BE49-F238E27FC236}">
-                <a16:creationId xmlns:a16="http://schemas.microsoft.com/office/drawing/2014/main" id="{252D3F60-77D7-4FE1-8C2C-B9863A6BC354}"/>
+                <a16:creationId xmlns:a16="http://schemas.microsoft.com/office/drawing/2014/main" id="{B7F4B702-E913-44BA-8865-E92CB396F40A}"/>
               </a:ext>
             </a:extLst>
           </p:cNvPr>
@@ -9270,7 +9270,7 @@
           <p:cNvPr id="4" name="slide-subtitle">
             <a:extLst xmlns:a="http://schemas.openxmlformats.org/drawingml/2006/main">
               <a:ext uri="{FF2B5EF4-FFF2-40B4-BE49-F238E27FC236}">
-                <a16:creationId xmlns:a16="http://schemas.microsoft.com/office/drawing/2014/main" id="{37B35CD0-62A5-4767-9BB6-1CEABA9289F5}"/>
+                <a16:creationId xmlns:a16="http://schemas.microsoft.com/office/drawing/2014/main" id="{7E53A4C8-01E7-4432-B15D-5EF870BFA972}"/>
               </a:ext>
             </a:extLst>
           </p:cNvPr>
@@ -9315,7 +9315,7 @@
           <p:cNvPr id="5" name="">
             <a:extLst xmlns:a="http://schemas.openxmlformats.org/drawingml/2006/main">
               <a:ext uri="{FF2B5EF4-FFF2-40B4-BE49-F238E27FC236}">
-                <a16:creationId xmlns:a16="http://schemas.microsoft.com/office/drawing/2014/main" id="{A0004CE4-9A47-49BA-96DA-E9CE0085AC78}"/>
+                <a16:creationId xmlns:a16="http://schemas.microsoft.com/office/drawing/2014/main" id="{B8977CD3-835F-4D29-9044-67D1E39B3C31}"/>
               </a:ext>
             </a:extLst>
           </p:cNvPr>
@@ -9348,7 +9348,7 @@
           <p:cNvPr id="6" name="">
             <a:extLst xmlns:a="http://schemas.openxmlformats.org/drawingml/2006/main">
               <a:ext uri="{FF2B5EF4-FFF2-40B4-BE49-F238E27FC236}">
-                <a16:creationId xmlns:a16="http://schemas.microsoft.com/office/drawing/2014/main" id="{AFBF6296-2E63-4DAD-BEAA-4F50B87D2AEB}"/>
+                <a16:creationId xmlns:a16="http://schemas.microsoft.com/office/drawing/2014/main" id="{591CB5F3-63E6-4813-A6FE-F72C376FD65E}"/>
               </a:ext>
             </a:extLst>
           </p:cNvPr>
@@ -9393,7 +9393,7 @@
           <p:cNvPr id="7" name="">
             <a:extLst xmlns:a="http://schemas.openxmlformats.org/drawingml/2006/main">
               <a:ext uri="{FF2B5EF4-FFF2-40B4-BE49-F238E27FC236}">
-                <a16:creationId xmlns:a16="http://schemas.microsoft.com/office/drawing/2014/main" id="{FF5154A4-D549-45D2-BE1F-6BF6CE3F07E6}"/>
+                <a16:creationId xmlns:a16="http://schemas.microsoft.com/office/drawing/2014/main" id="{80A9E929-058F-4A94-AFBE-55EA4E338DCC}"/>
               </a:ext>
             </a:extLst>
           </p:cNvPr>
@@ -9438,7 +9438,7 @@
           <p:cNvPr id="8" name="">
             <a:extLst xmlns:a="http://schemas.openxmlformats.org/drawingml/2006/main">
               <a:ext uri="{FF2B5EF4-FFF2-40B4-BE49-F238E27FC236}">
-                <a16:creationId xmlns:a16="http://schemas.microsoft.com/office/drawing/2014/main" id="{4AD42A2C-24BA-4273-9CD9-0EC65197D17D}"/>
+                <a16:creationId xmlns:a16="http://schemas.microsoft.com/office/drawing/2014/main" id="{DE843B78-F2BC-4AD6-8A71-C0FAB56E6E98}"/>
               </a:ext>
             </a:extLst>
           </p:cNvPr>
@@ -9471,7 +9471,7 @@
           <p:cNvPr id="9" name="">
             <a:extLst xmlns:a="http://schemas.openxmlformats.org/drawingml/2006/main">
               <a:ext uri="{FF2B5EF4-FFF2-40B4-BE49-F238E27FC236}">
-                <a16:creationId xmlns:a16="http://schemas.microsoft.com/office/drawing/2014/main" id="{A135F835-4173-483A-945D-4CB201DEA029}"/>
+                <a16:creationId xmlns:a16="http://schemas.microsoft.com/office/drawing/2014/main" id="{707630B7-486F-4B92-A7C9-CE48882558EB}"/>
               </a:ext>
             </a:extLst>
           </p:cNvPr>
@@ -9516,7 +9516,7 @@
           <p:cNvPr id="10" name="">
             <a:extLst xmlns:a="http://schemas.openxmlformats.org/drawingml/2006/main">
               <a:ext uri="{FF2B5EF4-FFF2-40B4-BE49-F238E27FC236}">
-                <a16:creationId xmlns:a16="http://schemas.microsoft.com/office/drawing/2014/main" id="{23110A51-1F3B-49B5-B5E7-48C0CC1E4A85}"/>
+                <a16:creationId xmlns:a16="http://schemas.microsoft.com/office/drawing/2014/main" id="{F4553390-5983-4FBC-A305-066E65AC856B}"/>
               </a:ext>
             </a:extLst>
           </p:cNvPr>
@@ -9561,7 +9561,7 @@
           <p:cNvPr id="11" name="">
             <a:extLst xmlns:a="http://schemas.openxmlformats.org/drawingml/2006/main">
               <a:ext uri="{FF2B5EF4-FFF2-40B4-BE49-F238E27FC236}">
-                <a16:creationId xmlns:a16="http://schemas.microsoft.com/office/drawing/2014/main" id="{05B2AD97-64AE-4FE0-82E7-D40A7B6E7AA4}"/>
+                <a16:creationId xmlns:a16="http://schemas.microsoft.com/office/drawing/2014/main" id="{BC38A486-A572-4B88-B303-6166172DA1AC}"/>
               </a:ext>
             </a:extLst>
           </p:cNvPr>
@@ -9594,7 +9594,7 @@
           <p:cNvPr id="12" name="">
             <a:extLst xmlns:a="http://schemas.openxmlformats.org/drawingml/2006/main">
               <a:ext uri="{FF2B5EF4-FFF2-40B4-BE49-F238E27FC236}">
-                <a16:creationId xmlns:a16="http://schemas.microsoft.com/office/drawing/2014/main" id="{5D0A0C6D-6358-450D-8372-B0498A1E522E}"/>
+                <a16:creationId xmlns:a16="http://schemas.microsoft.com/office/drawing/2014/main" id="{2B573524-A6AE-4C0E-88B2-74D78DB40631}"/>
               </a:ext>
             </a:extLst>
           </p:cNvPr>
@@ -9639,7 +9639,7 @@
           <p:cNvPr id="13" name="">
             <a:extLst xmlns:a="http://schemas.openxmlformats.org/drawingml/2006/main">
               <a:ext uri="{FF2B5EF4-FFF2-40B4-BE49-F238E27FC236}">
-                <a16:creationId xmlns:a16="http://schemas.microsoft.com/office/drawing/2014/main" id="{423425CB-4B03-4E81-8D3D-C5D9DFB60273}"/>
+                <a16:creationId xmlns:a16="http://schemas.microsoft.com/office/drawing/2014/main" id="{9219B931-37AB-4A78-B96C-7983B144FE4C}"/>
               </a:ext>
             </a:extLst>
           </p:cNvPr>
@@ -9684,7 +9684,7 @@
           <p:cNvPr id="14" name="">
             <a:extLst xmlns:a="http://schemas.openxmlformats.org/drawingml/2006/main">
               <a:ext uri="{FF2B5EF4-FFF2-40B4-BE49-F238E27FC236}">
-                <a16:creationId xmlns:a16="http://schemas.microsoft.com/office/drawing/2014/main" id="{7D62A5A2-447F-43D0-B8A8-88C245CFB155}"/>
+                <a16:creationId xmlns:a16="http://schemas.microsoft.com/office/drawing/2014/main" id="{12E6689C-54ED-4951-9C52-0A6CB759D8F0}"/>
               </a:ext>
             </a:extLst>
           </p:cNvPr>
@@ -9729,7 +9729,7 @@
           <p:cNvPr id="15" name="footer-left">
             <a:extLst xmlns:a="http://schemas.openxmlformats.org/drawingml/2006/main">
               <a:ext uri="{FF2B5EF4-FFF2-40B4-BE49-F238E27FC236}">
-                <a16:creationId xmlns:a16="http://schemas.microsoft.com/office/drawing/2014/main" id="{99B95968-DA8F-4546-A69C-0B575D5AD238}"/>
+                <a16:creationId xmlns:a16="http://schemas.microsoft.com/office/drawing/2014/main" id="{402BD2E8-560F-48E0-94C1-AACCC1F6A5CA}"/>
               </a:ext>
             </a:extLst>
           </p:cNvPr>
@@ -9774,7 +9774,7 @@
           <p:cNvPr id="16" name="footer-right">
             <a:extLst xmlns:a="http://schemas.openxmlformats.org/drawingml/2006/main">
               <a:ext uri="{FF2B5EF4-FFF2-40B4-BE49-F238E27FC236}">
-                <a16:creationId xmlns:a16="http://schemas.microsoft.com/office/drawing/2014/main" id="{8429BEB1-22CC-429B-A6C7-E01413F77386}"/>
+                <a16:creationId xmlns:a16="http://schemas.microsoft.com/office/drawing/2014/main" id="{55714D32-951B-4C9E-8B28-65C94373C132}"/>
               </a:ext>
             </a:extLst>
           </p:cNvPr>
@@ -9817,7 +9817,7 @@
     </p:spTree>
     <p:extLst>
       <p:ext uri="{BB962C8B-B14F-4D97-AF65-F5344CB8AC3E}">
-        <p14:creationId xmlns:p14="http://schemas.microsoft.com/office/powerpoint/2010/main" val="1076639204"/>
+        <p14:creationId xmlns:p14="http://schemas.microsoft.com/office/powerpoint/2010/main" val="1465159540"/>
       </p:ext>
     </p:extLst>
   </p:cSld>
@@ -9841,7 +9841,7 @@
           <p:cNvPr id="1" name="slide-stage">
             <a:extLst xmlns:a="http://schemas.openxmlformats.org/drawingml/2006/main">
               <a:ext uri="{FF2B5EF4-FFF2-40B4-BE49-F238E27FC236}">
-                <a16:creationId xmlns:a16="http://schemas.microsoft.com/office/drawing/2014/main" id="{B06BCDC1-134D-4B46-9C4F-CA25795026FD}"/>
+                <a16:creationId xmlns:a16="http://schemas.microsoft.com/office/drawing/2014/main" id="{5349F0D0-DD57-4D50-A71A-7D8E4738F0F7}"/>
               </a:ext>
             </a:extLst>
           </p:cNvPr>
@@ -9868,7 +9868,7 @@
           <p:cNvPr id="2" name="eyebrow">
             <a:extLst xmlns:a="http://schemas.openxmlformats.org/drawingml/2006/main">
               <a:ext uri="{FF2B5EF4-FFF2-40B4-BE49-F238E27FC236}">
-                <a16:creationId xmlns:a16="http://schemas.microsoft.com/office/drawing/2014/main" id="{B76219E3-47D8-4038-9A56-893A3B31C241}"/>
+                <a16:creationId xmlns:a16="http://schemas.microsoft.com/office/drawing/2014/main" id="{C16781D3-6A84-4C40-945B-51668A72E580}"/>
               </a:ext>
             </a:extLst>
           </p:cNvPr>
@@ -9913,7 +9913,7 @@
           <p:cNvPr id="3" name="slide-title">
             <a:extLst xmlns:a="http://schemas.openxmlformats.org/drawingml/2006/main">
               <a:ext uri="{FF2B5EF4-FFF2-40B4-BE49-F238E27FC236}">
-                <a16:creationId xmlns:a16="http://schemas.microsoft.com/office/drawing/2014/main" id="{421D6DD2-597E-476B-9E39-B8590E06D005}"/>
+                <a16:creationId xmlns:a16="http://schemas.microsoft.com/office/drawing/2014/main" id="{9A6DA9DC-0ED8-4BB5-A086-FEA8058B0C4E}"/>
               </a:ext>
             </a:extLst>
           </p:cNvPr>
@@ -9958,7 +9958,7 @@
           <p:cNvPr id="4" name="slide-subtitle">
             <a:extLst xmlns:a="http://schemas.openxmlformats.org/drawingml/2006/main">
               <a:ext uri="{FF2B5EF4-FFF2-40B4-BE49-F238E27FC236}">
-                <a16:creationId xmlns:a16="http://schemas.microsoft.com/office/drawing/2014/main" id="{F1934E26-EE9A-46D2-AF11-92EC17CDA5D4}"/>
+                <a16:creationId xmlns:a16="http://schemas.microsoft.com/office/drawing/2014/main" id="{D42D8391-3225-431D-90D0-976D3DAC9E82}"/>
               </a:ext>
             </a:extLst>
           </p:cNvPr>
@@ -10003,7 +10003,7 @@
           <p:cNvPr id="5" name="">
             <a:extLst xmlns:a="http://schemas.openxmlformats.org/drawingml/2006/main">
               <a:ext uri="{FF2B5EF4-FFF2-40B4-BE49-F238E27FC236}">
-                <a16:creationId xmlns:a16="http://schemas.microsoft.com/office/drawing/2014/main" id="{4E27B528-A3CD-4D0A-9316-9600800E65C7}"/>
+                <a16:creationId xmlns:a16="http://schemas.microsoft.com/office/drawing/2014/main" id="{1036B1BD-14CE-4B4E-B4C8-CC4BD8E65E1C}"/>
               </a:ext>
             </a:extLst>
           </p:cNvPr>
@@ -10048,7 +10048,7 @@
           <p:cNvPr id="6" name="">
             <a:extLst xmlns:a="http://schemas.openxmlformats.org/drawingml/2006/main">
               <a:ext uri="{FF2B5EF4-FFF2-40B4-BE49-F238E27FC236}">
-                <a16:creationId xmlns:a16="http://schemas.microsoft.com/office/drawing/2014/main" id="{BF2DC28D-234B-4ED6-907F-AC1951563DB0}"/>
+                <a16:creationId xmlns:a16="http://schemas.microsoft.com/office/drawing/2014/main" id="{067934B6-EA3F-4DE8-AA7E-609849FC2C96}"/>
               </a:ext>
             </a:extLst>
           </p:cNvPr>
@@ -10093,7 +10093,7 @@
           <p:cNvPr id="7" name="">
             <a:extLst xmlns:a="http://schemas.openxmlformats.org/drawingml/2006/main">
               <a:ext uri="{FF2B5EF4-FFF2-40B4-BE49-F238E27FC236}">
-                <a16:creationId xmlns:a16="http://schemas.microsoft.com/office/drawing/2014/main" id="{FB7C26C9-D355-4113-9769-DA69684F89E8}"/>
+                <a16:creationId xmlns:a16="http://schemas.microsoft.com/office/drawing/2014/main" id="{A612DC95-5F79-41A1-B701-5F8808B1B53A}"/>
               </a:ext>
             </a:extLst>
           </p:cNvPr>
@@ -10138,7 +10138,7 @@
           <p:cNvPr id="8" name="">
             <a:extLst xmlns:a="http://schemas.openxmlformats.org/drawingml/2006/main">
               <a:ext uri="{FF2B5EF4-FFF2-40B4-BE49-F238E27FC236}">
-                <a16:creationId xmlns:a16="http://schemas.microsoft.com/office/drawing/2014/main" id="{70C1F719-7399-43CB-8563-37DAC6547AA5}"/>
+                <a16:creationId xmlns:a16="http://schemas.microsoft.com/office/drawing/2014/main" id="{B91A75F7-C0E0-463C-BCF9-9664B025140E}"/>
               </a:ext>
             </a:extLst>
           </p:cNvPr>
@@ -10183,7 +10183,7 @@
           <p:cNvPr id="9" name="">
             <a:extLst xmlns:a="http://schemas.openxmlformats.org/drawingml/2006/main">
               <a:ext uri="{FF2B5EF4-FFF2-40B4-BE49-F238E27FC236}">
-                <a16:creationId xmlns:a16="http://schemas.microsoft.com/office/drawing/2014/main" id="{85F069CC-ADF7-4C7D-A3F5-3DEA507E7C5D}"/>
+                <a16:creationId xmlns:a16="http://schemas.microsoft.com/office/drawing/2014/main" id="{6FD97C8E-A35B-4821-B9D3-6C5B9478E666}"/>
               </a:ext>
             </a:extLst>
           </p:cNvPr>
@@ -10228,7 +10228,7 @@
           <p:cNvPr id="10" name="">
             <a:extLst xmlns:a="http://schemas.openxmlformats.org/drawingml/2006/main">
               <a:ext uri="{FF2B5EF4-FFF2-40B4-BE49-F238E27FC236}">
-                <a16:creationId xmlns:a16="http://schemas.microsoft.com/office/drawing/2014/main" id="{F1E8665F-07D4-477E-B850-8D1E579150C5}"/>
+                <a16:creationId xmlns:a16="http://schemas.microsoft.com/office/drawing/2014/main" id="{29C5333B-6F8F-4C21-99FB-1795A4A3ECF5}"/>
               </a:ext>
             </a:extLst>
           </p:cNvPr>
@@ -10273,7 +10273,7 @@
           <p:cNvPr id="11" name="">
             <a:extLst xmlns:a="http://schemas.openxmlformats.org/drawingml/2006/main">
               <a:ext uri="{FF2B5EF4-FFF2-40B4-BE49-F238E27FC236}">
-                <a16:creationId xmlns:a16="http://schemas.microsoft.com/office/drawing/2014/main" id="{054BCB71-F404-4061-96FB-AA68948777B2}"/>
+                <a16:creationId xmlns:a16="http://schemas.microsoft.com/office/drawing/2014/main" id="{693E6E2C-5171-4411-88CD-235149FD36D8}"/>
               </a:ext>
             </a:extLst>
           </p:cNvPr>
@@ -10318,7 +10318,7 @@
           <p:cNvPr id="12" name="">
             <a:extLst xmlns:a="http://schemas.openxmlformats.org/drawingml/2006/main">
               <a:ext uri="{FF2B5EF4-FFF2-40B4-BE49-F238E27FC236}">
-                <a16:creationId xmlns:a16="http://schemas.microsoft.com/office/drawing/2014/main" id="{77390838-6867-4035-93DE-E560CFD49F28}"/>
+                <a16:creationId xmlns:a16="http://schemas.microsoft.com/office/drawing/2014/main" id="{CA393337-59CE-44B3-89D1-ED13948A6CF1}"/>
               </a:ext>
             </a:extLst>
           </p:cNvPr>
@@ -10363,7 +10363,7 @@
           <p:cNvPr id="13" name="">
             <a:extLst xmlns:a="http://schemas.openxmlformats.org/drawingml/2006/main">
               <a:ext uri="{FF2B5EF4-FFF2-40B4-BE49-F238E27FC236}">
-                <a16:creationId xmlns:a16="http://schemas.microsoft.com/office/drawing/2014/main" id="{219AA07E-8F0E-47F9-B837-8416FC0E668D}"/>
+                <a16:creationId xmlns:a16="http://schemas.microsoft.com/office/drawing/2014/main" id="{C603679C-612E-456A-93BD-FA37E954BEFA}"/>
               </a:ext>
             </a:extLst>
           </p:cNvPr>
@@ -10408,7 +10408,7 @@
           <p:cNvPr id="14" name="">
             <a:extLst xmlns:a="http://schemas.openxmlformats.org/drawingml/2006/main">
               <a:ext uri="{FF2B5EF4-FFF2-40B4-BE49-F238E27FC236}">
-                <a16:creationId xmlns:a16="http://schemas.microsoft.com/office/drawing/2014/main" id="{1C9B5491-D534-4C2B-9950-EF16F45CB51A}"/>
+                <a16:creationId xmlns:a16="http://schemas.microsoft.com/office/drawing/2014/main" id="{81C37F5E-5E7E-4C11-B531-6BCBD1AB66EC}"/>
               </a:ext>
             </a:extLst>
           </p:cNvPr>
@@ -10453,7 +10453,7 @@
           <p:cNvPr id="15" name="">
             <a:extLst xmlns:a="http://schemas.openxmlformats.org/drawingml/2006/main">
               <a:ext uri="{FF2B5EF4-FFF2-40B4-BE49-F238E27FC236}">
-                <a16:creationId xmlns:a16="http://schemas.microsoft.com/office/drawing/2014/main" id="{D013392C-E4D7-47BF-93E2-0F984CE91555}"/>
+                <a16:creationId xmlns:a16="http://schemas.microsoft.com/office/drawing/2014/main" id="{9CBD24DE-6E69-47EA-8398-39D07B76AF29}"/>
               </a:ext>
             </a:extLst>
           </p:cNvPr>
@@ -10498,7 +10498,7 @@
           <p:cNvPr id="16" name="">
             <a:extLst xmlns:a="http://schemas.openxmlformats.org/drawingml/2006/main">
               <a:ext uri="{FF2B5EF4-FFF2-40B4-BE49-F238E27FC236}">
-                <a16:creationId xmlns:a16="http://schemas.microsoft.com/office/drawing/2014/main" id="{ABBCE12D-3A2A-4133-93B0-1E9FD5FA76CA}"/>
+                <a16:creationId xmlns:a16="http://schemas.microsoft.com/office/drawing/2014/main" id="{98F51275-6314-49E1-B04C-4D323A390D84}"/>
               </a:ext>
             </a:extLst>
           </p:cNvPr>
@@ -10543,7 +10543,7 @@
           <p:cNvPr id="17" name="">
             <a:extLst xmlns:a="http://schemas.openxmlformats.org/drawingml/2006/main">
               <a:ext uri="{FF2B5EF4-FFF2-40B4-BE49-F238E27FC236}">
-                <a16:creationId xmlns:a16="http://schemas.microsoft.com/office/drawing/2014/main" id="{E6C5EF2A-D00B-446C-ABE7-E2EE56809B99}"/>
+                <a16:creationId xmlns:a16="http://schemas.microsoft.com/office/drawing/2014/main" id="{54EFD441-A9E5-4B6B-A35A-7172D900600D}"/>
               </a:ext>
             </a:extLst>
           </p:cNvPr>
@@ -10588,7 +10588,7 @@
           <p:cNvPr id="18" name="">
             <a:extLst xmlns:a="http://schemas.openxmlformats.org/drawingml/2006/main">
               <a:ext uri="{FF2B5EF4-FFF2-40B4-BE49-F238E27FC236}">
-                <a16:creationId xmlns:a16="http://schemas.microsoft.com/office/drawing/2014/main" id="{604A9549-89F1-49CF-98DA-02BC70FC0151}"/>
+                <a16:creationId xmlns:a16="http://schemas.microsoft.com/office/drawing/2014/main" id="{B330DF16-EEE0-4CAC-B56C-1030727F059B}"/>
               </a:ext>
             </a:extLst>
           </p:cNvPr>
@@ -10633,7 +10633,7 @@
           <p:cNvPr id="19" name="">
             <a:extLst xmlns:a="http://schemas.openxmlformats.org/drawingml/2006/main">
               <a:ext uri="{FF2B5EF4-FFF2-40B4-BE49-F238E27FC236}">
-                <a16:creationId xmlns:a16="http://schemas.microsoft.com/office/drawing/2014/main" id="{50A9AD49-083A-49EB-A571-EE046E3F47C1}"/>
+                <a16:creationId xmlns:a16="http://schemas.microsoft.com/office/drawing/2014/main" id="{C97BFE32-9EBB-4C8A-80C3-F8861C1E35B5}"/>
               </a:ext>
             </a:extLst>
           </p:cNvPr>
@@ -10678,7 +10678,7 @@
           <p:cNvPr id="20" name="footer-left">
             <a:extLst xmlns:a="http://schemas.openxmlformats.org/drawingml/2006/main">
               <a:ext uri="{FF2B5EF4-FFF2-40B4-BE49-F238E27FC236}">
-                <a16:creationId xmlns:a16="http://schemas.microsoft.com/office/drawing/2014/main" id="{F4A4DA1A-1196-4334-A1B8-C32DA240AB7F}"/>
+                <a16:creationId xmlns:a16="http://schemas.microsoft.com/office/drawing/2014/main" id="{77F5EC0C-7A74-47C8-9424-6F675B2792AB}"/>
               </a:ext>
             </a:extLst>
           </p:cNvPr>
@@ -10723,7 +10723,7 @@
           <p:cNvPr id="21" name="footer-right">
             <a:extLst xmlns:a="http://schemas.openxmlformats.org/drawingml/2006/main">
               <a:ext uri="{FF2B5EF4-FFF2-40B4-BE49-F238E27FC236}">
-                <a16:creationId xmlns:a16="http://schemas.microsoft.com/office/drawing/2014/main" id="{B863413C-6A64-4701-8890-2EC4BAA416D8}"/>
+                <a16:creationId xmlns:a16="http://schemas.microsoft.com/office/drawing/2014/main" id="{BCC17668-854F-4933-98AF-B99BA877BD9A}"/>
               </a:ext>
             </a:extLst>
           </p:cNvPr>
@@ -10766,7 +10766,7 @@
     </p:spTree>
     <p:extLst>
       <p:ext uri="{BB962C8B-B14F-4D97-AF65-F5344CB8AC3E}">
-        <p14:creationId xmlns:p14="http://schemas.microsoft.com/office/powerpoint/2010/main" val="2106740092"/>
+        <p14:creationId xmlns:p14="http://schemas.microsoft.com/office/powerpoint/2010/main" val="1679430510"/>
       </p:ext>
     </p:extLst>
   </p:cSld>
@@ -10790,7 +10790,7 @@
           <p:cNvPr id="1" name="slide-stage">
             <a:extLst xmlns:a="http://schemas.openxmlformats.org/drawingml/2006/main">
               <a:ext uri="{FF2B5EF4-FFF2-40B4-BE49-F238E27FC236}">
-                <a16:creationId xmlns:a16="http://schemas.microsoft.com/office/drawing/2014/main" id="{2621E0E8-C3A6-4F53-8C1C-EBEE94E430E0}"/>
+                <a16:creationId xmlns:a16="http://schemas.microsoft.com/office/drawing/2014/main" id="{3F97D45C-9BED-4ED0-8E28-AF099059EEA8}"/>
               </a:ext>
             </a:extLst>
           </p:cNvPr>
@@ -10817,7 +10817,7 @@
           <p:cNvPr id="2" name="eyebrow">
             <a:extLst xmlns:a="http://schemas.openxmlformats.org/drawingml/2006/main">
               <a:ext uri="{FF2B5EF4-FFF2-40B4-BE49-F238E27FC236}">
-                <a16:creationId xmlns:a16="http://schemas.microsoft.com/office/drawing/2014/main" id="{9D8D1312-3D37-499D-B7C4-E10CD23BCD8A}"/>
+                <a16:creationId xmlns:a16="http://schemas.microsoft.com/office/drawing/2014/main" id="{C124265C-43E5-481F-BC0A-FE323EAE2C34}"/>
               </a:ext>
             </a:extLst>
           </p:cNvPr>
@@ -10862,7 +10862,7 @@
           <p:cNvPr id="3" name="slide-title">
             <a:extLst xmlns:a="http://schemas.openxmlformats.org/drawingml/2006/main">
               <a:ext uri="{FF2B5EF4-FFF2-40B4-BE49-F238E27FC236}">
-                <a16:creationId xmlns:a16="http://schemas.microsoft.com/office/drawing/2014/main" id="{07474294-B5F6-4AC9-85ED-F13555CAE56A}"/>
+                <a16:creationId xmlns:a16="http://schemas.microsoft.com/office/drawing/2014/main" id="{3ADE39F0-5DD4-4509-8A5F-C9CFCC50E387}"/>
               </a:ext>
             </a:extLst>
           </p:cNvPr>
@@ -10907,7 +10907,7 @@
           <p:cNvPr id="4" name="slide-subtitle">
             <a:extLst xmlns:a="http://schemas.openxmlformats.org/drawingml/2006/main">
               <a:ext uri="{FF2B5EF4-FFF2-40B4-BE49-F238E27FC236}">
-                <a16:creationId xmlns:a16="http://schemas.microsoft.com/office/drawing/2014/main" id="{A189E2E3-8C86-4469-B7B9-D74F1A5BEA42}"/>
+                <a16:creationId xmlns:a16="http://schemas.microsoft.com/office/drawing/2014/main" id="{AF634D89-C94D-4658-999B-FB47CC53B115}"/>
               </a:ext>
             </a:extLst>
           </p:cNvPr>
@@ -10952,7 +10952,7 @@
           <p:cNvPr id="5" name="">
             <a:extLst xmlns:a="http://schemas.openxmlformats.org/drawingml/2006/main">
               <a:ext uri="{FF2B5EF4-FFF2-40B4-BE49-F238E27FC236}">
-                <a16:creationId xmlns:a16="http://schemas.microsoft.com/office/drawing/2014/main" id="{856D95CF-0AA6-4821-B6F9-4F650ACDBE69}"/>
+                <a16:creationId xmlns:a16="http://schemas.microsoft.com/office/drawing/2014/main" id="{A113532A-A855-44D1-9009-B2FDE6567D8C}"/>
               </a:ext>
             </a:extLst>
           </p:cNvPr>
@@ -10985,7 +10985,7 @@
           <p:cNvPr id="6" name="">
             <a:extLst xmlns:a="http://schemas.openxmlformats.org/drawingml/2006/main">
               <a:ext uri="{FF2B5EF4-FFF2-40B4-BE49-F238E27FC236}">
-                <a16:creationId xmlns:a16="http://schemas.microsoft.com/office/drawing/2014/main" id="{2B956F84-F7C5-41DC-9917-7A27012C4575}"/>
+                <a16:creationId xmlns:a16="http://schemas.microsoft.com/office/drawing/2014/main" id="{462118A1-4436-431D-91AC-61C37F13BBE8}"/>
               </a:ext>
             </a:extLst>
           </p:cNvPr>
@@ -11081,7 +11081,7 @@
           <p:cNvPr id="7" name="">
             <a:extLst xmlns:a="http://schemas.openxmlformats.org/drawingml/2006/main">
               <a:ext uri="{FF2B5EF4-FFF2-40B4-BE49-F238E27FC236}">
-                <a16:creationId xmlns:a16="http://schemas.microsoft.com/office/drawing/2014/main" id="{0A7151E7-2489-4556-A16B-CFC054FE789A}"/>
+                <a16:creationId xmlns:a16="http://schemas.microsoft.com/office/drawing/2014/main" id="{752D5B38-0EA5-47CC-AEFC-D683150E8AD0}"/>
               </a:ext>
             </a:extLst>
           </p:cNvPr>
@@ -11114,7 +11114,7 @@
           <p:cNvPr id="8" name="">
             <a:extLst xmlns:a="http://schemas.openxmlformats.org/drawingml/2006/main">
               <a:ext uri="{FF2B5EF4-FFF2-40B4-BE49-F238E27FC236}">
-                <a16:creationId xmlns:a16="http://schemas.microsoft.com/office/drawing/2014/main" id="{62D62C8C-9845-44B6-8F6E-5215701D18BB}"/>
+                <a16:creationId xmlns:a16="http://schemas.microsoft.com/office/drawing/2014/main" id="{F2E8788B-7321-40A4-BF81-B31EC88448DD}"/>
               </a:ext>
             </a:extLst>
           </p:cNvPr>
@@ -11159,7 +11159,7 @@
           <p:cNvPr id="9" name="">
             <a:extLst xmlns:a="http://schemas.openxmlformats.org/drawingml/2006/main">
               <a:ext uri="{FF2B5EF4-FFF2-40B4-BE49-F238E27FC236}">
-                <a16:creationId xmlns:a16="http://schemas.microsoft.com/office/drawing/2014/main" id="{10F55C38-228C-44AD-A7D3-8BC4A1C8CA89}"/>
+                <a16:creationId xmlns:a16="http://schemas.microsoft.com/office/drawing/2014/main" id="{A7DA3960-8D9B-4ABC-8A42-2F643E795132}"/>
               </a:ext>
             </a:extLst>
           </p:cNvPr>
@@ -11204,7 +11204,7 @@
           <p:cNvPr id="10" name="">
             <a:extLst xmlns:a="http://schemas.openxmlformats.org/drawingml/2006/main">
               <a:ext uri="{FF2B5EF4-FFF2-40B4-BE49-F238E27FC236}">
-                <a16:creationId xmlns:a16="http://schemas.microsoft.com/office/drawing/2014/main" id="{EAEDCE04-CE7C-4209-88A6-D58C694A31CE}"/>
+                <a16:creationId xmlns:a16="http://schemas.microsoft.com/office/drawing/2014/main" id="{3633D117-A84D-4BFE-9A8C-031F06DA952D}"/>
               </a:ext>
             </a:extLst>
           </p:cNvPr>
@@ -11237,7 +11237,7 @@
           <p:cNvPr id="11" name="">
             <a:extLst xmlns:a="http://schemas.openxmlformats.org/drawingml/2006/main">
               <a:ext uri="{FF2B5EF4-FFF2-40B4-BE49-F238E27FC236}">
-                <a16:creationId xmlns:a16="http://schemas.microsoft.com/office/drawing/2014/main" id="{30487071-CD29-406E-98B3-213EC85FBF26}"/>
+                <a16:creationId xmlns:a16="http://schemas.microsoft.com/office/drawing/2014/main" id="{7D838FF6-EEE7-4BB5-9EE8-D45BCF4A67CD}"/>
               </a:ext>
             </a:extLst>
           </p:cNvPr>
@@ -11282,7 +11282,7 @@
           <p:cNvPr id="12" name="">
             <a:extLst xmlns:a="http://schemas.openxmlformats.org/drawingml/2006/main">
               <a:ext uri="{FF2B5EF4-FFF2-40B4-BE49-F238E27FC236}">
-                <a16:creationId xmlns:a16="http://schemas.microsoft.com/office/drawing/2014/main" id="{B8BF045B-9F2D-46F8-9D47-E6E90D0D8814}"/>
+                <a16:creationId xmlns:a16="http://schemas.microsoft.com/office/drawing/2014/main" id="{D7C65495-7E58-40E0-BCFE-AFF1F300AC58}"/>
               </a:ext>
             </a:extLst>
           </p:cNvPr>
@@ -11327,7 +11327,7 @@
           <p:cNvPr id="13" name="">
             <a:extLst xmlns:a="http://schemas.openxmlformats.org/drawingml/2006/main">
               <a:ext uri="{FF2B5EF4-FFF2-40B4-BE49-F238E27FC236}">
-                <a16:creationId xmlns:a16="http://schemas.microsoft.com/office/drawing/2014/main" id="{C7FD94EF-2621-451D-A4C6-62C5C5CE7B68}"/>
+                <a16:creationId xmlns:a16="http://schemas.microsoft.com/office/drawing/2014/main" id="{99B65775-8F7B-4937-9741-C16D4B13DB44}"/>
               </a:ext>
             </a:extLst>
           </p:cNvPr>
@@ -11360,7 +11360,7 @@
           <p:cNvPr id="14" name="">
             <a:extLst xmlns:a="http://schemas.openxmlformats.org/drawingml/2006/main">
               <a:ext uri="{FF2B5EF4-FFF2-40B4-BE49-F238E27FC236}">
-                <a16:creationId xmlns:a16="http://schemas.microsoft.com/office/drawing/2014/main" id="{E54061D1-2F26-4C6B-948D-98A616F74A50}"/>
+                <a16:creationId xmlns:a16="http://schemas.microsoft.com/office/drawing/2014/main" id="{D5628DB3-D9B4-4643-B95C-D26B1706393E}"/>
               </a:ext>
             </a:extLst>
           </p:cNvPr>
@@ -11405,7 +11405,7 @@
           <p:cNvPr id="15" name="">
             <a:extLst xmlns:a="http://schemas.openxmlformats.org/drawingml/2006/main">
               <a:ext uri="{FF2B5EF4-FFF2-40B4-BE49-F238E27FC236}">
-                <a16:creationId xmlns:a16="http://schemas.microsoft.com/office/drawing/2014/main" id="{4BF36C02-C195-4140-B38F-E88DCC9C78EC}"/>
+                <a16:creationId xmlns:a16="http://schemas.microsoft.com/office/drawing/2014/main" id="{562AB1B9-BD7C-4892-92E4-13B5C5ED4F0D}"/>
               </a:ext>
             </a:extLst>
           </p:cNvPr>
@@ -11450,7 +11450,7 @@
           <p:cNvPr id="16" name="footer-left">
             <a:extLst xmlns:a="http://schemas.openxmlformats.org/drawingml/2006/main">
               <a:ext uri="{FF2B5EF4-FFF2-40B4-BE49-F238E27FC236}">
-                <a16:creationId xmlns:a16="http://schemas.microsoft.com/office/drawing/2014/main" id="{8A643003-C601-4E3E-A47E-C1E82F93695C}"/>
+                <a16:creationId xmlns:a16="http://schemas.microsoft.com/office/drawing/2014/main" id="{EC1D9B27-1769-4BAE-97D6-0F00C1B19978}"/>
               </a:ext>
             </a:extLst>
           </p:cNvPr>
@@ -11495,7 +11495,7 @@
           <p:cNvPr id="17" name="footer-right">
             <a:extLst xmlns:a="http://schemas.openxmlformats.org/drawingml/2006/main">
               <a:ext uri="{FF2B5EF4-FFF2-40B4-BE49-F238E27FC236}">
-                <a16:creationId xmlns:a16="http://schemas.microsoft.com/office/drawing/2014/main" id="{659D553C-006F-4265-886E-2C74A941E71C}"/>
+                <a16:creationId xmlns:a16="http://schemas.microsoft.com/office/drawing/2014/main" id="{2876EA0C-8546-4787-AC8B-4A09F2E1FD31}"/>
               </a:ext>
             </a:extLst>
           </p:cNvPr>
@@ -11538,7 +11538,7 @@
     </p:spTree>
     <p:extLst>
       <p:ext uri="{BB962C8B-B14F-4D97-AF65-F5344CB8AC3E}">
-        <p14:creationId xmlns:p14="http://schemas.microsoft.com/office/powerpoint/2010/main" val="760499489"/>
+        <p14:creationId xmlns:p14="http://schemas.microsoft.com/office/powerpoint/2010/main" val="685077814"/>
       </p:ext>
     </p:extLst>
   </p:cSld>
@@ -11562,7 +11562,7 @@
           <p:cNvPr id="1" name="slide-stage">
             <a:extLst xmlns:a="http://schemas.openxmlformats.org/drawingml/2006/main">
               <a:ext uri="{FF2B5EF4-FFF2-40B4-BE49-F238E27FC236}">
-                <a16:creationId xmlns:a16="http://schemas.microsoft.com/office/drawing/2014/main" id="{10E65C01-4729-4EF0-9DEA-99492C8B5EA1}"/>
+                <a16:creationId xmlns:a16="http://schemas.microsoft.com/office/drawing/2014/main" id="{62C83DAC-CBC0-4AAF-9F4E-829BB2C891FD}"/>
               </a:ext>
             </a:extLst>
           </p:cNvPr>
@@ -11589,7 +11589,7 @@
           <p:cNvPr id="2" name="eyebrow">
             <a:extLst xmlns:a="http://schemas.openxmlformats.org/drawingml/2006/main">
               <a:ext uri="{FF2B5EF4-FFF2-40B4-BE49-F238E27FC236}">
-                <a16:creationId xmlns:a16="http://schemas.microsoft.com/office/drawing/2014/main" id="{AAF0D725-393F-4E06-A647-CE9390A0EAAE}"/>
+                <a16:creationId xmlns:a16="http://schemas.microsoft.com/office/drawing/2014/main" id="{6325C214-2E89-4CD5-A846-EAB6852DFBB1}"/>
               </a:ext>
             </a:extLst>
           </p:cNvPr>
@@ -11634,7 +11634,7 @@
           <p:cNvPr id="3" name="slide-title">
             <a:extLst xmlns:a="http://schemas.openxmlformats.org/drawingml/2006/main">
               <a:ext uri="{FF2B5EF4-FFF2-40B4-BE49-F238E27FC236}">
-                <a16:creationId xmlns:a16="http://schemas.microsoft.com/office/drawing/2014/main" id="{68814EB2-AFB2-4A90-9F88-87F77E0E6F0C}"/>
+                <a16:creationId xmlns:a16="http://schemas.microsoft.com/office/drawing/2014/main" id="{B7798096-0CAB-4AFB-B67C-BEA58EC81688}"/>
               </a:ext>
             </a:extLst>
           </p:cNvPr>
@@ -11679,7 +11679,7 @@
           <p:cNvPr id="4" name="slide-subtitle">
             <a:extLst xmlns:a="http://schemas.openxmlformats.org/drawingml/2006/main">
               <a:ext uri="{FF2B5EF4-FFF2-40B4-BE49-F238E27FC236}">
-                <a16:creationId xmlns:a16="http://schemas.microsoft.com/office/drawing/2014/main" id="{33E2C068-1D74-4C02-9D9C-D9785FFE7A19}"/>
+                <a16:creationId xmlns:a16="http://schemas.microsoft.com/office/drawing/2014/main" id="{AFA19DE7-9FA6-4854-B0D4-D6C3367F3E5C}"/>
               </a:ext>
             </a:extLst>
           </p:cNvPr>
@@ -11724,7 +11724,7 @@
           <p:cNvPr id="5" name="">
             <a:extLst xmlns:a="http://schemas.openxmlformats.org/drawingml/2006/main">
               <a:ext uri="{FF2B5EF4-FFF2-40B4-BE49-F238E27FC236}">
-                <a16:creationId xmlns:a16="http://schemas.microsoft.com/office/drawing/2014/main" id="{E878A71A-656C-479C-88B1-F4050BC4B33C}"/>
+                <a16:creationId xmlns:a16="http://schemas.microsoft.com/office/drawing/2014/main" id="{B64EE1E7-D07E-40AF-9777-573D5423784E}"/>
               </a:ext>
             </a:extLst>
           </p:cNvPr>
@@ -11757,7 +11757,7 @@
           <p:cNvPr id="6" name="">
             <a:extLst xmlns:a="http://schemas.openxmlformats.org/drawingml/2006/main">
               <a:ext uri="{FF2B5EF4-FFF2-40B4-BE49-F238E27FC236}">
-                <a16:creationId xmlns:a16="http://schemas.microsoft.com/office/drawing/2014/main" id="{E7B55405-FD63-4C00-AF66-26A746C73531}"/>
+                <a16:creationId xmlns:a16="http://schemas.microsoft.com/office/drawing/2014/main" id="{14F79C1E-564D-4D2C-AC67-F303D2281727}"/>
               </a:ext>
             </a:extLst>
           </p:cNvPr>
@@ -11802,7 +11802,7 @@
           <p:cNvPr id="7" name="">
             <a:extLst xmlns:a="http://schemas.openxmlformats.org/drawingml/2006/main">
               <a:ext uri="{FF2B5EF4-FFF2-40B4-BE49-F238E27FC236}">
-                <a16:creationId xmlns:a16="http://schemas.microsoft.com/office/drawing/2014/main" id="{31BC425F-3B56-4A73-AC70-4ED95E2B5B4B}"/>
+                <a16:creationId xmlns:a16="http://schemas.microsoft.com/office/drawing/2014/main" id="{D867E6A7-95EA-4C35-BD8A-BA9DBFC807E1}"/>
               </a:ext>
             </a:extLst>
           </p:cNvPr>
@@ -11847,7 +11847,7 @@
           <p:cNvPr id="8" name="">
             <a:extLst xmlns:a="http://schemas.openxmlformats.org/drawingml/2006/main">
               <a:ext uri="{FF2B5EF4-FFF2-40B4-BE49-F238E27FC236}">
-                <a16:creationId xmlns:a16="http://schemas.microsoft.com/office/drawing/2014/main" id="{D65049A5-F865-4BE9-86FF-F8B1E87AAF00}"/>
+                <a16:creationId xmlns:a16="http://schemas.microsoft.com/office/drawing/2014/main" id="{81C83EAA-01BA-4301-90DC-D506D46A400B}"/>
               </a:ext>
             </a:extLst>
           </p:cNvPr>
@@ -11892,7 +11892,7 @@
           <p:cNvPr id="9" name="">
             <a:extLst xmlns:a="http://schemas.openxmlformats.org/drawingml/2006/main">
               <a:ext uri="{FF2B5EF4-FFF2-40B4-BE49-F238E27FC236}">
-                <a16:creationId xmlns:a16="http://schemas.microsoft.com/office/drawing/2014/main" id="{30AF9137-D48A-4B4F-85F6-092F64097DFE}"/>
+                <a16:creationId xmlns:a16="http://schemas.microsoft.com/office/drawing/2014/main" id="{6493DEF3-F842-46BF-957C-F109AFEE5E3F}"/>
               </a:ext>
             </a:extLst>
           </p:cNvPr>
@@ -11925,7 +11925,7 @@
           <p:cNvPr id="10" name="">
             <a:extLst xmlns:a="http://schemas.openxmlformats.org/drawingml/2006/main">
               <a:ext uri="{FF2B5EF4-FFF2-40B4-BE49-F238E27FC236}">
-                <a16:creationId xmlns:a16="http://schemas.microsoft.com/office/drawing/2014/main" id="{49CF533E-C7DF-45C3-B6C9-A1286CDA4F00}"/>
+                <a16:creationId xmlns:a16="http://schemas.microsoft.com/office/drawing/2014/main" id="{04BF9898-D767-4CEC-B883-2C2C58701671}"/>
               </a:ext>
             </a:extLst>
           </p:cNvPr>
@@ -11970,7 +11970,7 @@
           <p:cNvPr id="11" name="">
             <a:extLst xmlns:a="http://schemas.openxmlformats.org/drawingml/2006/main">
               <a:ext uri="{FF2B5EF4-FFF2-40B4-BE49-F238E27FC236}">
-                <a16:creationId xmlns:a16="http://schemas.microsoft.com/office/drawing/2014/main" id="{49549C7D-2F37-4512-85B2-213905759EB2}"/>
+                <a16:creationId xmlns:a16="http://schemas.microsoft.com/office/drawing/2014/main" id="{9A1FC7C0-5DD7-43C6-8E84-58D7B8D54821}"/>
               </a:ext>
             </a:extLst>
           </p:cNvPr>
@@ -12015,7 +12015,7 @@
           <p:cNvPr id="12" name="">
             <a:extLst xmlns:a="http://schemas.openxmlformats.org/drawingml/2006/main">
               <a:ext uri="{FF2B5EF4-FFF2-40B4-BE49-F238E27FC236}">
-                <a16:creationId xmlns:a16="http://schemas.microsoft.com/office/drawing/2014/main" id="{325E827D-F34B-49B8-B9B2-C983B834F5F8}"/>
+                <a16:creationId xmlns:a16="http://schemas.microsoft.com/office/drawing/2014/main" id="{AED4210A-B8BC-495F-AFE0-A0AB40DA3647}"/>
               </a:ext>
             </a:extLst>
           </p:cNvPr>
@@ -12060,7 +12060,7 @@
           <p:cNvPr id="13" name="">
             <a:extLst xmlns:a="http://schemas.openxmlformats.org/drawingml/2006/main">
               <a:ext uri="{FF2B5EF4-FFF2-40B4-BE49-F238E27FC236}">
-                <a16:creationId xmlns:a16="http://schemas.microsoft.com/office/drawing/2014/main" id="{18BFFA6A-501E-440A-9782-0EBB87D6CFB9}"/>
+                <a16:creationId xmlns:a16="http://schemas.microsoft.com/office/drawing/2014/main" id="{2FAD4DD1-2EDE-4319-A686-6983C3E994D2}"/>
               </a:ext>
             </a:extLst>
           </p:cNvPr>
@@ -12093,7 +12093,7 @@
           <p:cNvPr id="14" name="">
             <a:extLst xmlns:a="http://schemas.openxmlformats.org/drawingml/2006/main">
               <a:ext uri="{FF2B5EF4-FFF2-40B4-BE49-F238E27FC236}">
-                <a16:creationId xmlns:a16="http://schemas.microsoft.com/office/drawing/2014/main" id="{B1E70075-02D3-4B10-AA3F-71AADA5BD33D}"/>
+                <a16:creationId xmlns:a16="http://schemas.microsoft.com/office/drawing/2014/main" id="{C0974677-E3AB-4B74-80F6-A61317CC0851}"/>
               </a:ext>
             </a:extLst>
           </p:cNvPr>
@@ -12138,7 +12138,7 @@
           <p:cNvPr id="15" name="">
             <a:extLst xmlns:a="http://schemas.openxmlformats.org/drawingml/2006/main">
               <a:ext uri="{FF2B5EF4-FFF2-40B4-BE49-F238E27FC236}">
-                <a16:creationId xmlns:a16="http://schemas.microsoft.com/office/drawing/2014/main" id="{4B7B4ADC-5F56-42E9-B3DD-26E6ED6E6EF5}"/>
+                <a16:creationId xmlns:a16="http://schemas.microsoft.com/office/drawing/2014/main" id="{B2E4DB5F-58C2-4B9F-9B41-778F810F5BAE}"/>
               </a:ext>
             </a:extLst>
           </p:cNvPr>
@@ -12183,7 +12183,7 @@
           <p:cNvPr id="16" name="">
             <a:extLst xmlns:a="http://schemas.openxmlformats.org/drawingml/2006/main">
               <a:ext uri="{FF2B5EF4-FFF2-40B4-BE49-F238E27FC236}">
-                <a16:creationId xmlns:a16="http://schemas.microsoft.com/office/drawing/2014/main" id="{3E2F178D-A596-4C21-B369-15F251C0710D}"/>
+                <a16:creationId xmlns:a16="http://schemas.microsoft.com/office/drawing/2014/main" id="{B49A7263-2F89-469C-9E28-A2E108F0E380}"/>
               </a:ext>
             </a:extLst>
           </p:cNvPr>
@@ -12228,7 +12228,7 @@
           <p:cNvPr id="17" name="">
             <a:extLst xmlns:a="http://schemas.openxmlformats.org/drawingml/2006/main">
               <a:ext uri="{FF2B5EF4-FFF2-40B4-BE49-F238E27FC236}">
-                <a16:creationId xmlns:a16="http://schemas.microsoft.com/office/drawing/2014/main" id="{D5FEF7B5-067C-476D-A23C-19A38AFB1280}"/>
+                <a16:creationId xmlns:a16="http://schemas.microsoft.com/office/drawing/2014/main" id="{A729D4F4-B479-44AC-9856-04CBA2301A87}"/>
               </a:ext>
             </a:extLst>
           </p:cNvPr>
@@ -12261,7 +12261,7 @@
           <p:cNvPr id="18" name="">
             <a:extLst xmlns:a="http://schemas.openxmlformats.org/drawingml/2006/main">
               <a:ext uri="{FF2B5EF4-FFF2-40B4-BE49-F238E27FC236}">
-                <a16:creationId xmlns:a16="http://schemas.microsoft.com/office/drawing/2014/main" id="{973B7C46-4E21-4679-BABD-FCCE6764FAD2}"/>
+                <a16:creationId xmlns:a16="http://schemas.microsoft.com/office/drawing/2014/main" id="{8D8E0A44-B899-40F2-B0F9-F62E079CA595}"/>
               </a:ext>
             </a:extLst>
           </p:cNvPr>
@@ -12306,7 +12306,7 @@
           <p:cNvPr id="19" name="">
             <a:extLst xmlns:a="http://schemas.openxmlformats.org/drawingml/2006/main">
               <a:ext uri="{FF2B5EF4-FFF2-40B4-BE49-F238E27FC236}">
-                <a16:creationId xmlns:a16="http://schemas.microsoft.com/office/drawing/2014/main" id="{DCBB1FDB-4C27-4AEB-B109-811C95569871}"/>
+                <a16:creationId xmlns:a16="http://schemas.microsoft.com/office/drawing/2014/main" id="{484D3CF8-503C-4E86-A092-4E125CE32E98}"/>
               </a:ext>
             </a:extLst>
           </p:cNvPr>
@@ -12351,7 +12351,7 @@
           <p:cNvPr id="20" name="">
             <a:extLst xmlns:a="http://schemas.openxmlformats.org/drawingml/2006/main">
               <a:ext uri="{FF2B5EF4-FFF2-40B4-BE49-F238E27FC236}">
-                <a16:creationId xmlns:a16="http://schemas.microsoft.com/office/drawing/2014/main" id="{E80AD0A0-DDC7-498E-AA09-0AB48C913C44}"/>
+                <a16:creationId xmlns:a16="http://schemas.microsoft.com/office/drawing/2014/main" id="{B041F9EF-B65C-4D91-9070-65A56C625DF5}"/>
               </a:ext>
             </a:extLst>
           </p:cNvPr>
@@ -12396,7 +12396,7 @@
           <p:cNvPr id="21" name="">
             <a:extLst xmlns:a="http://schemas.openxmlformats.org/drawingml/2006/main">
               <a:ext uri="{FF2B5EF4-FFF2-40B4-BE49-F238E27FC236}">
-                <a16:creationId xmlns:a16="http://schemas.microsoft.com/office/drawing/2014/main" id="{AE14123D-9A35-4C55-8C6C-8BC74B81033F}"/>
+                <a16:creationId xmlns:a16="http://schemas.microsoft.com/office/drawing/2014/main" id="{C0F5D2FB-47FE-42AB-9112-5BA81A3B0B3E}"/>
               </a:ext>
             </a:extLst>
           </p:cNvPr>
@@ -12429,7 +12429,7 @@
           <p:cNvPr id="22" name="">
             <a:extLst xmlns:a="http://schemas.openxmlformats.org/drawingml/2006/main">
               <a:ext uri="{FF2B5EF4-FFF2-40B4-BE49-F238E27FC236}">
-                <a16:creationId xmlns:a16="http://schemas.microsoft.com/office/drawing/2014/main" id="{ED62300C-5BD2-4B08-B2EB-E3D0170C9B54}"/>
+                <a16:creationId xmlns:a16="http://schemas.microsoft.com/office/drawing/2014/main" id="{D4A07100-5A8B-4DE4-B9E2-CC0B18C6F0BD}"/>
               </a:ext>
             </a:extLst>
           </p:cNvPr>
@@ -12474,7 +12474,7 @@
           <p:cNvPr id="23" name="">
             <a:extLst xmlns:a="http://schemas.openxmlformats.org/drawingml/2006/main">
               <a:ext uri="{FF2B5EF4-FFF2-40B4-BE49-F238E27FC236}">
-                <a16:creationId xmlns:a16="http://schemas.microsoft.com/office/drawing/2014/main" id="{6A05A7F1-3708-4F97-8890-35AE5EA1FEA4}"/>
+                <a16:creationId xmlns:a16="http://schemas.microsoft.com/office/drawing/2014/main" id="{C3DE5FC1-7970-491C-95FF-0BBD9F8CC21A}"/>
               </a:ext>
             </a:extLst>
           </p:cNvPr>
@@ -12519,7 +12519,7 @@
           <p:cNvPr id="24" name="">
             <a:extLst xmlns:a="http://schemas.openxmlformats.org/drawingml/2006/main">
               <a:ext uri="{FF2B5EF4-FFF2-40B4-BE49-F238E27FC236}">
-                <a16:creationId xmlns:a16="http://schemas.microsoft.com/office/drawing/2014/main" id="{2F6F3458-7B4E-43B3-96CD-563C5046CF6B}"/>
+                <a16:creationId xmlns:a16="http://schemas.microsoft.com/office/drawing/2014/main" id="{A7B62D4C-C97F-4C2F-B508-11D3354009BB}"/>
               </a:ext>
             </a:extLst>
           </p:cNvPr>
@@ -12564,7 +12564,7 @@
           <p:cNvPr id="25" name="">
             <a:extLst xmlns:a="http://schemas.openxmlformats.org/drawingml/2006/main">
               <a:ext uri="{FF2B5EF4-FFF2-40B4-BE49-F238E27FC236}">
-                <a16:creationId xmlns:a16="http://schemas.microsoft.com/office/drawing/2014/main" id="{381482D4-B43A-4C08-A15F-CD15E4F273F5}"/>
+                <a16:creationId xmlns:a16="http://schemas.microsoft.com/office/drawing/2014/main" id="{3EDF5E02-7DC1-4BAD-B087-B6A1FB98500E}"/>
               </a:ext>
             </a:extLst>
           </p:cNvPr>
@@ -12597,7 +12597,7 @@
           <p:cNvPr id="26" name="">
             <a:extLst xmlns:a="http://schemas.openxmlformats.org/drawingml/2006/main">
               <a:ext uri="{FF2B5EF4-FFF2-40B4-BE49-F238E27FC236}">
-                <a16:creationId xmlns:a16="http://schemas.microsoft.com/office/drawing/2014/main" id="{93600937-5934-4122-997E-98CCB706C965}"/>
+                <a16:creationId xmlns:a16="http://schemas.microsoft.com/office/drawing/2014/main" id="{DC157E57-50BE-4D67-835D-508A8495F047}"/>
               </a:ext>
             </a:extLst>
           </p:cNvPr>
@@ -12642,7 +12642,7 @@
           <p:cNvPr id="27" name="">
             <a:extLst xmlns:a="http://schemas.openxmlformats.org/drawingml/2006/main">
               <a:ext uri="{FF2B5EF4-FFF2-40B4-BE49-F238E27FC236}">
-                <a16:creationId xmlns:a16="http://schemas.microsoft.com/office/drawing/2014/main" id="{66C33E90-BB5A-4008-B8A6-17D2D376A043}"/>
+                <a16:creationId xmlns:a16="http://schemas.microsoft.com/office/drawing/2014/main" id="{41D7E964-C07C-4636-B332-5A9366798837}"/>
               </a:ext>
             </a:extLst>
           </p:cNvPr>
@@ -12687,7 +12687,7 @@
           <p:cNvPr id="28" name="">
             <a:extLst xmlns:a="http://schemas.openxmlformats.org/drawingml/2006/main">
               <a:ext uri="{FF2B5EF4-FFF2-40B4-BE49-F238E27FC236}">
-                <a16:creationId xmlns:a16="http://schemas.microsoft.com/office/drawing/2014/main" id="{3BCB35D9-E6FC-4F62-83F3-8A639FF9A311}"/>
+                <a16:creationId xmlns:a16="http://schemas.microsoft.com/office/drawing/2014/main" id="{A5F65C70-A222-4535-84DC-D0701C78A27E}"/>
               </a:ext>
             </a:extLst>
           </p:cNvPr>
@@ -12732,7 +12732,7 @@
           <p:cNvPr id="29" name="footer-left">
             <a:extLst xmlns:a="http://schemas.openxmlformats.org/drawingml/2006/main">
               <a:ext uri="{FF2B5EF4-FFF2-40B4-BE49-F238E27FC236}">
-                <a16:creationId xmlns:a16="http://schemas.microsoft.com/office/drawing/2014/main" id="{131E3BEA-E909-4917-84A8-61DD8189B1EF}"/>
+                <a16:creationId xmlns:a16="http://schemas.microsoft.com/office/drawing/2014/main" id="{24889C5E-6324-46BE-BBF4-E11A180D84C8}"/>
               </a:ext>
             </a:extLst>
           </p:cNvPr>
@@ -12777,7 +12777,7 @@
           <p:cNvPr id="30" name="footer-right">
             <a:extLst xmlns:a="http://schemas.openxmlformats.org/drawingml/2006/main">
               <a:ext uri="{FF2B5EF4-FFF2-40B4-BE49-F238E27FC236}">
-                <a16:creationId xmlns:a16="http://schemas.microsoft.com/office/drawing/2014/main" id="{62DC2385-C01E-4E0F-AD2F-CFD0D2FAD5FD}"/>
+                <a16:creationId xmlns:a16="http://schemas.microsoft.com/office/drawing/2014/main" id="{4DC04AFF-C58D-4E4D-AF50-85A943A1E4FE}"/>
               </a:ext>
             </a:extLst>
           </p:cNvPr>
@@ -12820,7 +12820,7 @@
     </p:spTree>
     <p:extLst>
       <p:ext uri="{BB962C8B-B14F-4D97-AF65-F5344CB8AC3E}">
-        <p14:creationId xmlns:p14="http://schemas.microsoft.com/office/powerpoint/2010/main" val="958354899"/>
+        <p14:creationId xmlns:p14="http://schemas.microsoft.com/office/powerpoint/2010/main" val="684283847"/>
       </p:ext>
     </p:extLst>
   </p:cSld>
@@ -12844,7 +12844,7 @@
           <p:cNvPr id="1" name="slide-stage">
             <a:extLst xmlns:a="http://schemas.openxmlformats.org/drawingml/2006/main">
               <a:ext uri="{FF2B5EF4-FFF2-40B4-BE49-F238E27FC236}">
-                <a16:creationId xmlns:a16="http://schemas.microsoft.com/office/drawing/2014/main" id="{2CDD7FA8-360F-4FDB-9AB0-0CE680B1FCDB}"/>
+                <a16:creationId xmlns:a16="http://schemas.microsoft.com/office/drawing/2014/main" id="{42957934-71CC-40A8-BB28-6B88AD5EDED6}"/>
               </a:ext>
             </a:extLst>
           </p:cNvPr>
@@ -12871,7 +12871,7 @@
           <p:cNvPr id="2" name="eyebrow">
             <a:extLst xmlns:a="http://schemas.openxmlformats.org/drawingml/2006/main">
               <a:ext uri="{FF2B5EF4-FFF2-40B4-BE49-F238E27FC236}">
-                <a16:creationId xmlns:a16="http://schemas.microsoft.com/office/drawing/2014/main" id="{4EB9B470-A996-4697-A4D0-F58BA2915B82}"/>
+                <a16:creationId xmlns:a16="http://schemas.microsoft.com/office/drawing/2014/main" id="{2A7CCA93-FB46-4799-87A9-19F36AF830F8}"/>
               </a:ext>
             </a:extLst>
           </p:cNvPr>
@@ -12916,7 +12916,7 @@
           <p:cNvPr id="3" name="slide-title">
             <a:extLst xmlns:a="http://schemas.openxmlformats.org/drawingml/2006/main">
               <a:ext uri="{FF2B5EF4-FFF2-40B4-BE49-F238E27FC236}">
-                <a16:creationId xmlns:a16="http://schemas.microsoft.com/office/drawing/2014/main" id="{F66FEE5A-A410-4473-BE0B-192AF6E5936D}"/>
+                <a16:creationId xmlns:a16="http://schemas.microsoft.com/office/drawing/2014/main" id="{5087343D-D321-403F-9EC2-0DF7DD31FBA6}"/>
               </a:ext>
             </a:extLst>
           </p:cNvPr>
@@ -12961,7 +12961,7 @@
           <p:cNvPr id="4" name="slide-subtitle">
             <a:extLst xmlns:a="http://schemas.openxmlformats.org/drawingml/2006/main">
               <a:ext uri="{FF2B5EF4-FFF2-40B4-BE49-F238E27FC236}">
-                <a16:creationId xmlns:a16="http://schemas.microsoft.com/office/drawing/2014/main" id="{3A47F8C3-2C68-4402-92E5-A896B3A9197F}"/>
+                <a16:creationId xmlns:a16="http://schemas.microsoft.com/office/drawing/2014/main" id="{42156CDC-BBB4-416B-AC45-46357F4C1CC9}"/>
               </a:ext>
             </a:extLst>
           </p:cNvPr>
@@ -13006,7 +13006,7 @@
           <p:cNvPr id="5" name="">
             <a:extLst xmlns:a="http://schemas.openxmlformats.org/drawingml/2006/main">
               <a:ext uri="{FF2B5EF4-FFF2-40B4-BE49-F238E27FC236}">
-                <a16:creationId xmlns:a16="http://schemas.microsoft.com/office/drawing/2014/main" id="{C3FDD026-EF51-412A-B334-03E7C193A379}"/>
+                <a16:creationId xmlns:a16="http://schemas.microsoft.com/office/drawing/2014/main" id="{C7C8D27A-7099-4E34-95C0-0E716E7DC96B}"/>
               </a:ext>
             </a:extLst>
           </p:cNvPr>
@@ -13051,7 +13051,7 @@
           <p:cNvPr id="6" name="">
             <a:extLst xmlns:a="http://schemas.openxmlformats.org/drawingml/2006/main">
               <a:ext uri="{FF2B5EF4-FFF2-40B4-BE49-F238E27FC236}">
-                <a16:creationId xmlns:a16="http://schemas.microsoft.com/office/drawing/2014/main" id="{A58B9FE9-1265-4668-9033-62922A93309A}"/>
+                <a16:creationId xmlns:a16="http://schemas.microsoft.com/office/drawing/2014/main" id="{B09291A3-8A33-4C43-8BA7-F5707C5C1F16}"/>
               </a:ext>
             </a:extLst>
           </p:cNvPr>
@@ -13086,7 +13086,7 @@
           <p:cNvPr id="7" name="">
             <a:extLst xmlns:a="http://schemas.openxmlformats.org/drawingml/2006/main">
               <a:ext uri="{FF2B5EF4-FFF2-40B4-BE49-F238E27FC236}">
-                <a16:creationId xmlns:a16="http://schemas.microsoft.com/office/drawing/2014/main" id="{95DD21D9-FF15-4D22-AE60-15EF918E3F9A}"/>
+                <a16:creationId xmlns:a16="http://schemas.microsoft.com/office/drawing/2014/main" id="{8974674C-B8BC-46D0-AD15-F7CF229EF1AC}"/>
               </a:ext>
             </a:extLst>
           </p:cNvPr>
@@ -13131,7 +13131,7 @@
           <p:cNvPr id="8" name="">
             <a:extLst xmlns:a="http://schemas.openxmlformats.org/drawingml/2006/main">
               <a:ext uri="{FF2B5EF4-FFF2-40B4-BE49-F238E27FC236}">
-                <a16:creationId xmlns:a16="http://schemas.microsoft.com/office/drawing/2014/main" id="{FC209B56-4DC9-4E9C-B00D-EB1457C57E9B}"/>
+                <a16:creationId xmlns:a16="http://schemas.microsoft.com/office/drawing/2014/main" id="{2DF18FBB-BFB3-4144-A5EB-3F7C67D0C883}"/>
               </a:ext>
             </a:extLst>
           </p:cNvPr>
@@ -13176,7 +13176,7 @@
           <p:cNvPr id="9" name="">
             <a:extLst xmlns:a="http://schemas.openxmlformats.org/drawingml/2006/main">
               <a:ext uri="{FF2B5EF4-FFF2-40B4-BE49-F238E27FC236}">
-                <a16:creationId xmlns:a16="http://schemas.microsoft.com/office/drawing/2014/main" id="{05FCE56F-5D2D-4724-86DB-54DF860A01CC}"/>
+                <a16:creationId xmlns:a16="http://schemas.microsoft.com/office/drawing/2014/main" id="{5A03A583-A00A-4359-B8EF-62A87B6D1FCF}"/>
               </a:ext>
             </a:extLst>
           </p:cNvPr>
@@ -13221,7 +13221,7 @@
           <p:cNvPr id="10" name="">
             <a:extLst xmlns:a="http://schemas.openxmlformats.org/drawingml/2006/main">
               <a:ext uri="{FF2B5EF4-FFF2-40B4-BE49-F238E27FC236}">
-                <a16:creationId xmlns:a16="http://schemas.microsoft.com/office/drawing/2014/main" id="{29B149CA-CC17-4CC1-9AC4-A5B345727866}"/>
+                <a16:creationId xmlns:a16="http://schemas.microsoft.com/office/drawing/2014/main" id="{BFED12C1-A95A-4FEA-9D65-7BFF3FA53200}"/>
               </a:ext>
             </a:extLst>
           </p:cNvPr>
@@ -13256,7 +13256,7 @@
           <p:cNvPr id="11" name="">
             <a:extLst xmlns:a="http://schemas.openxmlformats.org/drawingml/2006/main">
               <a:ext uri="{FF2B5EF4-FFF2-40B4-BE49-F238E27FC236}">
-                <a16:creationId xmlns:a16="http://schemas.microsoft.com/office/drawing/2014/main" id="{3BB35756-302B-4B15-9750-098752D13D1E}"/>
+                <a16:creationId xmlns:a16="http://schemas.microsoft.com/office/drawing/2014/main" id="{3D1C9C8F-2B42-4D7B-A534-095100E7CCC2}"/>
               </a:ext>
             </a:extLst>
           </p:cNvPr>
@@ -13301,7 +13301,7 @@
           <p:cNvPr id="12" name="">
             <a:extLst xmlns:a="http://schemas.openxmlformats.org/drawingml/2006/main">
               <a:ext uri="{FF2B5EF4-FFF2-40B4-BE49-F238E27FC236}">
-                <a16:creationId xmlns:a16="http://schemas.microsoft.com/office/drawing/2014/main" id="{3CA9CED3-61F7-4DC6-B81C-4284B3FC4292}"/>
+                <a16:creationId xmlns:a16="http://schemas.microsoft.com/office/drawing/2014/main" id="{27E410D2-5AB5-4FE6-AD84-D7126473A02B}"/>
               </a:ext>
             </a:extLst>
           </p:cNvPr>
@@ -13346,7 +13346,7 @@
           <p:cNvPr id="13" name="">
             <a:extLst xmlns:a="http://schemas.openxmlformats.org/drawingml/2006/main">
               <a:ext uri="{FF2B5EF4-FFF2-40B4-BE49-F238E27FC236}">
-                <a16:creationId xmlns:a16="http://schemas.microsoft.com/office/drawing/2014/main" id="{C736A5B6-74B6-48B3-9FFD-45C80183ECE4}"/>
+                <a16:creationId xmlns:a16="http://schemas.microsoft.com/office/drawing/2014/main" id="{A1258F47-6A74-4274-811C-027004D3F1D0}"/>
               </a:ext>
             </a:extLst>
           </p:cNvPr>
@@ -13391,7 +13391,7 @@
           <p:cNvPr id="14" name="">
             <a:extLst xmlns:a="http://schemas.openxmlformats.org/drawingml/2006/main">
               <a:ext uri="{FF2B5EF4-FFF2-40B4-BE49-F238E27FC236}">
-                <a16:creationId xmlns:a16="http://schemas.microsoft.com/office/drawing/2014/main" id="{94392A34-A8AC-4961-8A5F-7A8AE62262A9}"/>
+                <a16:creationId xmlns:a16="http://schemas.microsoft.com/office/drawing/2014/main" id="{A0053EB0-06FB-4B8B-B061-7956598073FA}"/>
               </a:ext>
             </a:extLst>
           </p:cNvPr>
@@ -13426,7 +13426,7 @@
           <p:cNvPr id="15" name="">
             <a:extLst xmlns:a="http://schemas.openxmlformats.org/drawingml/2006/main">
               <a:ext uri="{FF2B5EF4-FFF2-40B4-BE49-F238E27FC236}">
-                <a16:creationId xmlns:a16="http://schemas.microsoft.com/office/drawing/2014/main" id="{F94BB3B6-7358-4259-ABE1-69250AD7E0A0}"/>
+                <a16:creationId xmlns:a16="http://schemas.microsoft.com/office/drawing/2014/main" id="{A11907C3-9439-4089-8C1B-485206BB9D0C}"/>
               </a:ext>
             </a:extLst>
           </p:cNvPr>
@@ -13471,7 +13471,7 @@
           <p:cNvPr id="16" name="">
             <a:extLst xmlns:a="http://schemas.openxmlformats.org/drawingml/2006/main">
               <a:ext uri="{FF2B5EF4-FFF2-40B4-BE49-F238E27FC236}">
-                <a16:creationId xmlns:a16="http://schemas.microsoft.com/office/drawing/2014/main" id="{38178A79-8A0E-4A92-A1AE-9A7E468206AD}"/>
+                <a16:creationId xmlns:a16="http://schemas.microsoft.com/office/drawing/2014/main" id="{9F1B45B3-D981-4957-BB78-6D9F94DA232E}"/>
               </a:ext>
             </a:extLst>
           </p:cNvPr>
@@ -13516,7 +13516,7 @@
           <p:cNvPr id="17" name="">
             <a:extLst xmlns:a="http://schemas.openxmlformats.org/drawingml/2006/main">
               <a:ext uri="{FF2B5EF4-FFF2-40B4-BE49-F238E27FC236}">
-                <a16:creationId xmlns:a16="http://schemas.microsoft.com/office/drawing/2014/main" id="{569BC58E-80B8-4D98-8E2B-0721F76BC9D1}"/>
+                <a16:creationId xmlns:a16="http://schemas.microsoft.com/office/drawing/2014/main" id="{FDC49311-5118-4304-B67B-B922408DD2AD}"/>
               </a:ext>
             </a:extLst>
           </p:cNvPr>
@@ -13561,7 +13561,7 @@
           <p:cNvPr id="18" name="">
             <a:extLst xmlns:a="http://schemas.openxmlformats.org/drawingml/2006/main">
               <a:ext uri="{FF2B5EF4-FFF2-40B4-BE49-F238E27FC236}">
-                <a16:creationId xmlns:a16="http://schemas.microsoft.com/office/drawing/2014/main" id="{91175B3F-8BCC-4F67-B388-45A33FCBDB78}"/>
+                <a16:creationId xmlns:a16="http://schemas.microsoft.com/office/drawing/2014/main" id="{169E7EC1-D4F8-4D1B-B6F8-CFD8DC775C71}"/>
               </a:ext>
             </a:extLst>
           </p:cNvPr>
@@ -13596,7 +13596,7 @@
           <p:cNvPr id="19" name="">
             <a:extLst xmlns:a="http://schemas.openxmlformats.org/drawingml/2006/main">
               <a:ext uri="{FF2B5EF4-FFF2-40B4-BE49-F238E27FC236}">
-                <a16:creationId xmlns:a16="http://schemas.microsoft.com/office/drawing/2014/main" id="{983CCAA8-0CE5-463F-AE8C-77C7548FCF89}"/>
+                <a16:creationId xmlns:a16="http://schemas.microsoft.com/office/drawing/2014/main" id="{608508C3-1E32-4224-8199-B1A4E99D5D89}"/>
               </a:ext>
             </a:extLst>
           </p:cNvPr>
@@ -13641,7 +13641,7 @@
           <p:cNvPr id="20" name="">
             <a:extLst xmlns:a="http://schemas.openxmlformats.org/drawingml/2006/main">
               <a:ext uri="{FF2B5EF4-FFF2-40B4-BE49-F238E27FC236}">
-                <a16:creationId xmlns:a16="http://schemas.microsoft.com/office/drawing/2014/main" id="{E2A760BC-F9A8-426B-9549-6A06B0B049D4}"/>
+                <a16:creationId xmlns:a16="http://schemas.microsoft.com/office/drawing/2014/main" id="{9FAAF468-881D-475A-B399-DB247AA9EDAC}"/>
               </a:ext>
             </a:extLst>
           </p:cNvPr>
@@ -13686,7 +13686,7 @@
           <p:cNvPr id="21" name="">
             <a:extLst xmlns:a="http://schemas.openxmlformats.org/drawingml/2006/main">
               <a:ext uri="{FF2B5EF4-FFF2-40B4-BE49-F238E27FC236}">
-                <a16:creationId xmlns:a16="http://schemas.microsoft.com/office/drawing/2014/main" id="{235FD54C-038E-4613-88C2-201D24E005F0}"/>
+                <a16:creationId xmlns:a16="http://schemas.microsoft.com/office/drawing/2014/main" id="{52292AC9-FE12-4DAF-96D1-6E653A592F5C}"/>
               </a:ext>
             </a:extLst>
           </p:cNvPr>
@@ -13731,7 +13731,7 @@
           <p:cNvPr id="22" name="">
             <a:extLst xmlns:a="http://schemas.openxmlformats.org/drawingml/2006/main">
               <a:ext uri="{FF2B5EF4-FFF2-40B4-BE49-F238E27FC236}">
-                <a16:creationId xmlns:a16="http://schemas.microsoft.com/office/drawing/2014/main" id="{049CE8BE-6CB3-490C-9FD1-5D20738B6D9C}"/>
+                <a16:creationId xmlns:a16="http://schemas.microsoft.com/office/drawing/2014/main" id="{1BDB8CB4-6FA6-4AD9-B161-7B9627C5B197}"/>
               </a:ext>
             </a:extLst>
           </p:cNvPr>
@@ -13766,7 +13766,7 @@
           <p:cNvPr id="23" name="">
             <a:extLst xmlns:a="http://schemas.openxmlformats.org/drawingml/2006/main">
               <a:ext uri="{FF2B5EF4-FFF2-40B4-BE49-F238E27FC236}">
-                <a16:creationId xmlns:a16="http://schemas.microsoft.com/office/drawing/2014/main" id="{7B80C1EB-04A6-43EB-9903-2E5F2D986389}"/>
+                <a16:creationId xmlns:a16="http://schemas.microsoft.com/office/drawing/2014/main" id="{7500FCD9-8353-402F-82A3-C7C8D389EB06}"/>
               </a:ext>
             </a:extLst>
           </p:cNvPr>
@@ -13811,7 +13811,7 @@
           <p:cNvPr id="24" name="">
             <a:extLst xmlns:a="http://schemas.openxmlformats.org/drawingml/2006/main">
               <a:ext uri="{FF2B5EF4-FFF2-40B4-BE49-F238E27FC236}">
-                <a16:creationId xmlns:a16="http://schemas.microsoft.com/office/drawing/2014/main" id="{675FCCAF-50B7-430D-98B6-E21D87F933B4}"/>
+                <a16:creationId xmlns:a16="http://schemas.microsoft.com/office/drawing/2014/main" id="{0C34539A-7B7B-4BEE-BED8-2079821922B2}"/>
               </a:ext>
             </a:extLst>
           </p:cNvPr>
@@ -13856,7 +13856,7 @@
           <p:cNvPr id="25" name="footer-left">
             <a:extLst xmlns:a="http://schemas.openxmlformats.org/drawingml/2006/main">
               <a:ext uri="{FF2B5EF4-FFF2-40B4-BE49-F238E27FC236}">
-                <a16:creationId xmlns:a16="http://schemas.microsoft.com/office/drawing/2014/main" id="{1C278BB4-F8D3-4150-9886-7108685CBC1A}"/>
+                <a16:creationId xmlns:a16="http://schemas.microsoft.com/office/drawing/2014/main" id="{4C398A88-584E-4EA0-92A3-C9775D817A5C}"/>
               </a:ext>
             </a:extLst>
           </p:cNvPr>
@@ -13901,7 +13901,7 @@
           <p:cNvPr id="26" name="footer-right">
             <a:extLst xmlns:a="http://schemas.openxmlformats.org/drawingml/2006/main">
               <a:ext uri="{FF2B5EF4-FFF2-40B4-BE49-F238E27FC236}">
-                <a16:creationId xmlns:a16="http://schemas.microsoft.com/office/drawing/2014/main" id="{E5027CB2-9F4A-4633-B688-7045BC922AB7}"/>
+                <a16:creationId xmlns:a16="http://schemas.microsoft.com/office/drawing/2014/main" id="{A8981731-F2F1-44EB-B79B-90B4DC8E967F}"/>
               </a:ext>
             </a:extLst>
           </p:cNvPr>
@@ -13944,7 +13944,7 @@
     </p:spTree>
     <p:extLst>
       <p:ext uri="{BB962C8B-B14F-4D97-AF65-F5344CB8AC3E}">
-        <p14:creationId xmlns:p14="http://schemas.microsoft.com/office/powerpoint/2010/main" val="1595865237"/>
+        <p14:creationId xmlns:p14="http://schemas.microsoft.com/office/powerpoint/2010/main" val="1432048041"/>
       </p:ext>
     </p:extLst>
   </p:cSld>
@@ -13968,7 +13968,7 @@
           <p:cNvPr id="1" name="slide-stage">
             <a:extLst xmlns:a="http://schemas.openxmlformats.org/drawingml/2006/main">
               <a:ext uri="{FF2B5EF4-FFF2-40B4-BE49-F238E27FC236}">
-                <a16:creationId xmlns:a16="http://schemas.microsoft.com/office/drawing/2014/main" id="{545C30B7-5297-4D99-8FE7-CE2586321832}"/>
+                <a16:creationId xmlns:a16="http://schemas.microsoft.com/office/drawing/2014/main" id="{FEEF9632-99FC-4608-AA8F-301603EE7E19}"/>
               </a:ext>
             </a:extLst>
           </p:cNvPr>
@@ -13995,7 +13995,7 @@
           <p:cNvPr id="2" name="eyebrow">
             <a:extLst xmlns:a="http://schemas.openxmlformats.org/drawingml/2006/main">
               <a:ext uri="{FF2B5EF4-FFF2-40B4-BE49-F238E27FC236}">
-                <a16:creationId xmlns:a16="http://schemas.microsoft.com/office/drawing/2014/main" id="{B4CF184E-8FF0-4929-B4C3-AA3EBF30D994}"/>
+                <a16:creationId xmlns:a16="http://schemas.microsoft.com/office/drawing/2014/main" id="{7C5E69A0-F918-4347-9AD7-608AB97A674C}"/>
               </a:ext>
             </a:extLst>
           </p:cNvPr>
@@ -14040,7 +14040,7 @@
           <p:cNvPr id="3" name="slide-title">
             <a:extLst xmlns:a="http://schemas.openxmlformats.org/drawingml/2006/main">
               <a:ext uri="{FF2B5EF4-FFF2-40B4-BE49-F238E27FC236}">
-                <a16:creationId xmlns:a16="http://schemas.microsoft.com/office/drawing/2014/main" id="{30A410B2-F410-43CD-9793-13291A226616}"/>
+                <a16:creationId xmlns:a16="http://schemas.microsoft.com/office/drawing/2014/main" id="{4A062FAF-FC98-4A5A-9275-F4995115AEC3}"/>
               </a:ext>
             </a:extLst>
           </p:cNvPr>
@@ -14085,7 +14085,7 @@
           <p:cNvPr id="4" name="slide-subtitle">
             <a:extLst xmlns:a="http://schemas.openxmlformats.org/drawingml/2006/main">
               <a:ext uri="{FF2B5EF4-FFF2-40B4-BE49-F238E27FC236}">
-                <a16:creationId xmlns:a16="http://schemas.microsoft.com/office/drawing/2014/main" id="{D11F2B85-9087-4BF1-ACB9-1282976762A8}"/>
+                <a16:creationId xmlns:a16="http://schemas.microsoft.com/office/drawing/2014/main" id="{A648F949-D4E2-46C1-811E-25C35B07CB3A}"/>
               </a:ext>
             </a:extLst>
           </p:cNvPr>
@@ -14130,7 +14130,7 @@
           <p:cNvPr id="5" name="">
             <a:extLst xmlns:a="http://schemas.openxmlformats.org/drawingml/2006/main">
               <a:ext uri="{FF2B5EF4-FFF2-40B4-BE49-F238E27FC236}">
-                <a16:creationId xmlns:a16="http://schemas.microsoft.com/office/drawing/2014/main" id="{A91D3969-99FB-4BD8-8FFF-7BC83A0A97BB}"/>
+                <a16:creationId xmlns:a16="http://schemas.microsoft.com/office/drawing/2014/main" id="{32508BC5-798B-4361-8343-A2505A255023}"/>
               </a:ext>
             </a:extLst>
           </p:cNvPr>
@@ -14163,7 +14163,7 @@
           <p:cNvPr id="6" name="">
             <a:extLst xmlns:a="http://schemas.openxmlformats.org/drawingml/2006/main">
               <a:ext uri="{FF2B5EF4-FFF2-40B4-BE49-F238E27FC236}">
-                <a16:creationId xmlns:a16="http://schemas.microsoft.com/office/drawing/2014/main" id="{60F1E0C6-5B77-4AA3-9F64-60FDD5BDEDFF}"/>
+                <a16:creationId xmlns:a16="http://schemas.microsoft.com/office/drawing/2014/main" id="{291D4CFE-78BC-41DF-B28B-6A720A601552}"/>
               </a:ext>
             </a:extLst>
           </p:cNvPr>
@@ -14208,7 +14208,7 @@
           <p:cNvPr id="7" name="">
             <a:extLst xmlns:a="http://schemas.openxmlformats.org/drawingml/2006/main">
               <a:ext uri="{FF2B5EF4-FFF2-40B4-BE49-F238E27FC236}">
-                <a16:creationId xmlns:a16="http://schemas.microsoft.com/office/drawing/2014/main" id="{2046FAA1-81BE-4EE8-AB93-D873FB3E5EBA}"/>
+                <a16:creationId xmlns:a16="http://schemas.microsoft.com/office/drawing/2014/main" id="{E94A8E33-D1EB-495E-9337-DC38680031AD}"/>
               </a:ext>
             </a:extLst>
           </p:cNvPr>
@@ -14253,7 +14253,7 @@
           <p:cNvPr id="8" name="">
             <a:extLst xmlns:a="http://schemas.openxmlformats.org/drawingml/2006/main">
               <a:ext uri="{FF2B5EF4-FFF2-40B4-BE49-F238E27FC236}">
-                <a16:creationId xmlns:a16="http://schemas.microsoft.com/office/drawing/2014/main" id="{DF177FD9-A539-4095-B49A-00E2245A58E9}"/>
+                <a16:creationId xmlns:a16="http://schemas.microsoft.com/office/drawing/2014/main" id="{ACB59632-B3AD-4C8A-A0AA-DD97367E162C}"/>
               </a:ext>
             </a:extLst>
           </p:cNvPr>
@@ -14286,7 +14286,7 @@
           <p:cNvPr id="9" name="">
             <a:extLst xmlns:a="http://schemas.openxmlformats.org/drawingml/2006/main">
               <a:ext uri="{FF2B5EF4-FFF2-40B4-BE49-F238E27FC236}">
-                <a16:creationId xmlns:a16="http://schemas.microsoft.com/office/drawing/2014/main" id="{1D994284-C081-46C0-A782-3DFAD986B57F}"/>
+                <a16:creationId xmlns:a16="http://schemas.microsoft.com/office/drawing/2014/main" id="{1D78E814-CC1E-4AD5-B29C-DD6922D79AE3}"/>
               </a:ext>
             </a:extLst>
           </p:cNvPr>
@@ -14331,7 +14331,7 @@
           <p:cNvPr id="10" name="">
             <a:extLst xmlns:a="http://schemas.openxmlformats.org/drawingml/2006/main">
               <a:ext uri="{FF2B5EF4-FFF2-40B4-BE49-F238E27FC236}">
-                <a16:creationId xmlns:a16="http://schemas.microsoft.com/office/drawing/2014/main" id="{6E413642-3DD1-48FF-B906-88D5B7026953}"/>
+                <a16:creationId xmlns:a16="http://schemas.microsoft.com/office/drawing/2014/main" id="{04D7483E-480F-4C20-B222-4C9CAFA9640D}"/>
               </a:ext>
             </a:extLst>
           </p:cNvPr>
@@ -14376,7 +14376,7 @@
           <p:cNvPr id="11" name="">
             <a:extLst xmlns:a="http://schemas.openxmlformats.org/drawingml/2006/main">
               <a:ext uri="{FF2B5EF4-FFF2-40B4-BE49-F238E27FC236}">
-                <a16:creationId xmlns:a16="http://schemas.microsoft.com/office/drawing/2014/main" id="{F5C1FC5D-265A-4DE0-B0F4-56D118B2FA1B}"/>
+                <a16:creationId xmlns:a16="http://schemas.microsoft.com/office/drawing/2014/main" id="{91B845EF-1E83-43D1-A5B3-7A499165EE6D}"/>
               </a:ext>
             </a:extLst>
           </p:cNvPr>
@@ -14409,7 +14409,7 @@
           <p:cNvPr id="12" name="">
             <a:extLst xmlns:a="http://schemas.openxmlformats.org/drawingml/2006/main">
               <a:ext uri="{FF2B5EF4-FFF2-40B4-BE49-F238E27FC236}">
-                <a16:creationId xmlns:a16="http://schemas.microsoft.com/office/drawing/2014/main" id="{05FDA49C-2F0D-4E81-BCF9-BFB9B9FD36DB}"/>
+                <a16:creationId xmlns:a16="http://schemas.microsoft.com/office/drawing/2014/main" id="{1D21E08B-19AF-494A-B708-9FBAC93F3156}"/>
               </a:ext>
             </a:extLst>
           </p:cNvPr>
@@ -14454,7 +14454,7 @@
           <p:cNvPr id="13" name="">
             <a:extLst xmlns:a="http://schemas.openxmlformats.org/drawingml/2006/main">
               <a:ext uri="{FF2B5EF4-FFF2-40B4-BE49-F238E27FC236}">
-                <a16:creationId xmlns:a16="http://schemas.microsoft.com/office/drawing/2014/main" id="{17082FE9-500A-4BD0-9BE0-F052188ADD63}"/>
+                <a16:creationId xmlns:a16="http://schemas.microsoft.com/office/drawing/2014/main" id="{6D944758-8C6C-4C0E-87A3-4BB3B797C3F9}"/>
               </a:ext>
             </a:extLst>
           </p:cNvPr>
@@ -14499,7 +14499,7 @@
           <p:cNvPr id="14" name="">
             <a:extLst xmlns:a="http://schemas.openxmlformats.org/drawingml/2006/main">
               <a:ext uri="{FF2B5EF4-FFF2-40B4-BE49-F238E27FC236}">
-                <a16:creationId xmlns:a16="http://schemas.microsoft.com/office/drawing/2014/main" id="{4C0C0463-C5AB-453E-82D1-4FD04497CDD9}"/>
+                <a16:creationId xmlns:a16="http://schemas.microsoft.com/office/drawing/2014/main" id="{99706958-E18F-4935-BF98-2DD670546139}"/>
               </a:ext>
             </a:extLst>
           </p:cNvPr>
@@ -14532,7 +14532,7 @@
           <p:cNvPr id="15" name="">
             <a:extLst xmlns:a="http://schemas.openxmlformats.org/drawingml/2006/main">
               <a:ext uri="{FF2B5EF4-FFF2-40B4-BE49-F238E27FC236}">
-                <a16:creationId xmlns:a16="http://schemas.microsoft.com/office/drawing/2014/main" id="{5AD65D07-5227-4A57-87DC-4C60A7BBD130}"/>
+                <a16:creationId xmlns:a16="http://schemas.microsoft.com/office/drawing/2014/main" id="{F2EE26A7-E1F0-4097-8E0B-30E897912892}"/>
               </a:ext>
             </a:extLst>
           </p:cNvPr>
@@ -14577,7 +14577,7 @@
           <p:cNvPr id="16" name="">
             <a:extLst xmlns:a="http://schemas.openxmlformats.org/drawingml/2006/main">
               <a:ext uri="{FF2B5EF4-FFF2-40B4-BE49-F238E27FC236}">
-                <a16:creationId xmlns:a16="http://schemas.microsoft.com/office/drawing/2014/main" id="{D106090C-FD9D-4ACF-BB73-961BFC7DD7C7}"/>
+                <a16:creationId xmlns:a16="http://schemas.microsoft.com/office/drawing/2014/main" id="{3B4A5795-1116-4D5F-B046-E838E208BD1E}"/>
               </a:ext>
             </a:extLst>
           </p:cNvPr>
@@ -14622,7 +14622,7 @@
           <p:cNvPr id="17" name="footer-left">
             <a:extLst xmlns:a="http://schemas.openxmlformats.org/drawingml/2006/main">
               <a:ext uri="{FF2B5EF4-FFF2-40B4-BE49-F238E27FC236}">
-                <a16:creationId xmlns:a16="http://schemas.microsoft.com/office/drawing/2014/main" id="{FA4C2D9F-333D-4858-938F-8A9C2B3FB0DE}"/>
+                <a16:creationId xmlns:a16="http://schemas.microsoft.com/office/drawing/2014/main" id="{996F7236-89E6-430C-B2D6-53423E314982}"/>
               </a:ext>
             </a:extLst>
           </p:cNvPr>
@@ -14667,7 +14667,7 @@
           <p:cNvPr id="18" name="footer-right">
             <a:extLst xmlns:a="http://schemas.openxmlformats.org/drawingml/2006/main">
               <a:ext uri="{FF2B5EF4-FFF2-40B4-BE49-F238E27FC236}">
-                <a16:creationId xmlns:a16="http://schemas.microsoft.com/office/drawing/2014/main" id="{ED387E88-3E69-4B72-B149-6E278A354815}"/>
+                <a16:creationId xmlns:a16="http://schemas.microsoft.com/office/drawing/2014/main" id="{896CBBAE-C5B0-4A66-B213-F10D54838BA0}"/>
               </a:ext>
             </a:extLst>
           </p:cNvPr>
@@ -14710,7 +14710,7 @@
     </p:spTree>
     <p:extLst>
       <p:ext uri="{BB962C8B-B14F-4D97-AF65-F5344CB8AC3E}">
-        <p14:creationId xmlns:p14="http://schemas.microsoft.com/office/powerpoint/2010/main" val="1343988331"/>
+        <p14:creationId xmlns:p14="http://schemas.microsoft.com/office/powerpoint/2010/main" val="930167189"/>
       </p:ext>
     </p:extLst>
   </p:cSld>
@@ -14734,7 +14734,7 @@
           <p:cNvPr id="1" name="slide-stage">
             <a:extLst xmlns:a="http://schemas.openxmlformats.org/drawingml/2006/main">
               <a:ext uri="{FF2B5EF4-FFF2-40B4-BE49-F238E27FC236}">
-                <a16:creationId xmlns:a16="http://schemas.microsoft.com/office/drawing/2014/main" id="{5D6FFE3D-8CC8-4DA9-9ADB-2956ACA23437}"/>
+                <a16:creationId xmlns:a16="http://schemas.microsoft.com/office/drawing/2014/main" id="{AB26B5DD-4366-49D9-97DC-E82A2912D0D0}"/>
               </a:ext>
             </a:extLst>
           </p:cNvPr>
@@ -14761,7 +14761,7 @@
           <p:cNvPr id="2" name="eyebrow">
             <a:extLst xmlns:a="http://schemas.openxmlformats.org/drawingml/2006/main">
               <a:ext uri="{FF2B5EF4-FFF2-40B4-BE49-F238E27FC236}">
-                <a16:creationId xmlns:a16="http://schemas.microsoft.com/office/drawing/2014/main" id="{F912F1D7-FBF9-42B0-9C01-7648A29E7395}"/>
+                <a16:creationId xmlns:a16="http://schemas.microsoft.com/office/drawing/2014/main" id="{88D12A8D-64F9-496C-8530-C90A1493D4FA}"/>
               </a:ext>
             </a:extLst>
           </p:cNvPr>
@@ -14806,7 +14806,7 @@
           <p:cNvPr id="3" name="slide-title">
             <a:extLst xmlns:a="http://schemas.openxmlformats.org/drawingml/2006/main">
               <a:ext uri="{FF2B5EF4-FFF2-40B4-BE49-F238E27FC236}">
-                <a16:creationId xmlns:a16="http://schemas.microsoft.com/office/drawing/2014/main" id="{C915F550-0B7E-4417-A7E4-FFDC57B5F858}"/>
+                <a16:creationId xmlns:a16="http://schemas.microsoft.com/office/drawing/2014/main" id="{F34DEDF7-E925-4210-A156-98226AB97AD8}"/>
               </a:ext>
             </a:extLst>
           </p:cNvPr>
@@ -14851,7 +14851,7 @@
           <p:cNvPr id="4" name="slide-subtitle">
             <a:extLst xmlns:a="http://schemas.openxmlformats.org/drawingml/2006/main">
               <a:ext uri="{FF2B5EF4-FFF2-40B4-BE49-F238E27FC236}">
-                <a16:creationId xmlns:a16="http://schemas.microsoft.com/office/drawing/2014/main" id="{866776EF-CA8E-40DF-8F15-89594B3770FE}"/>
+                <a16:creationId xmlns:a16="http://schemas.microsoft.com/office/drawing/2014/main" id="{4921C511-D4B9-4CDA-9B6E-3195F0B46944}"/>
               </a:ext>
             </a:extLst>
           </p:cNvPr>
@@ -14896,7 +14896,7 @@
           <p:cNvPr id="5" name="">
             <a:extLst xmlns:a="http://schemas.openxmlformats.org/drawingml/2006/main">
               <a:ext uri="{FF2B5EF4-FFF2-40B4-BE49-F238E27FC236}">
-                <a16:creationId xmlns:a16="http://schemas.microsoft.com/office/drawing/2014/main" id="{C8AB9CE9-AE29-4ABA-83D5-2BD922DB6C51}"/>
+                <a16:creationId xmlns:a16="http://schemas.microsoft.com/office/drawing/2014/main" id="{2963B7DF-6FF7-46E5-B176-204030120FAA}"/>
               </a:ext>
             </a:extLst>
           </p:cNvPr>
@@ -14941,7 +14941,7 @@
           <p:cNvPr id="6" name="">
             <a:extLst xmlns:a="http://schemas.openxmlformats.org/drawingml/2006/main">
               <a:ext uri="{FF2B5EF4-FFF2-40B4-BE49-F238E27FC236}">
-                <a16:creationId xmlns:a16="http://schemas.microsoft.com/office/drawing/2014/main" id="{80AC5225-6CC0-4B54-B659-BCDBEFFA879F}"/>
+                <a16:creationId xmlns:a16="http://schemas.microsoft.com/office/drawing/2014/main" id="{EC4B77FB-4835-47C5-A2AC-157B49490486}"/>
               </a:ext>
             </a:extLst>
           </p:cNvPr>
@@ -14986,7 +14986,7 @@
           <p:cNvPr id="7" name="">
             <a:extLst xmlns:a="http://schemas.openxmlformats.org/drawingml/2006/main">
               <a:ext uri="{FF2B5EF4-FFF2-40B4-BE49-F238E27FC236}">
-                <a16:creationId xmlns:a16="http://schemas.microsoft.com/office/drawing/2014/main" id="{2EB92CD5-ED17-4A84-9972-C18215190C6F}"/>
+                <a16:creationId xmlns:a16="http://schemas.microsoft.com/office/drawing/2014/main" id="{2573F034-3789-4DE6-A255-DEA617F0333E}"/>
               </a:ext>
             </a:extLst>
           </p:cNvPr>
@@ -15031,7 +15031,7 @@
           <p:cNvPr id="8" name="">
             <a:extLst xmlns:a="http://schemas.openxmlformats.org/drawingml/2006/main">
               <a:ext uri="{FF2B5EF4-FFF2-40B4-BE49-F238E27FC236}">
-                <a16:creationId xmlns:a16="http://schemas.microsoft.com/office/drawing/2014/main" id="{B975C7A7-3703-4EE8-A3D1-233A945CCF83}"/>
+                <a16:creationId xmlns:a16="http://schemas.microsoft.com/office/drawing/2014/main" id="{A079A3E4-78F4-4B1A-95BB-F77E2EA8D5A5}"/>
               </a:ext>
             </a:extLst>
           </p:cNvPr>
@@ -15076,7 +15076,7 @@
           <p:cNvPr id="9" name="">
             <a:extLst xmlns:a="http://schemas.openxmlformats.org/drawingml/2006/main">
               <a:ext uri="{FF2B5EF4-FFF2-40B4-BE49-F238E27FC236}">
-                <a16:creationId xmlns:a16="http://schemas.microsoft.com/office/drawing/2014/main" id="{9B75FC6E-C602-4D87-9ABD-4D47811A2D22}"/>
+                <a16:creationId xmlns:a16="http://schemas.microsoft.com/office/drawing/2014/main" id="{C4D0F2B7-A886-4990-AC55-D6D26610096D}"/>
               </a:ext>
             </a:extLst>
           </p:cNvPr>
@@ -15121,7 +15121,7 @@
           <p:cNvPr id="10" name="">
             <a:extLst xmlns:a="http://schemas.openxmlformats.org/drawingml/2006/main">
               <a:ext uri="{FF2B5EF4-FFF2-40B4-BE49-F238E27FC236}">
-                <a16:creationId xmlns:a16="http://schemas.microsoft.com/office/drawing/2014/main" id="{F9CD6EAA-FEF6-45C4-9A98-D0D61D187307}"/>
+                <a16:creationId xmlns:a16="http://schemas.microsoft.com/office/drawing/2014/main" id="{6FF988AF-35F2-426B-A120-20691235EAA9}"/>
               </a:ext>
             </a:extLst>
           </p:cNvPr>
@@ -15166,7 +15166,7 @@
           <p:cNvPr id="11" name="">
             <a:extLst xmlns:a="http://schemas.openxmlformats.org/drawingml/2006/main">
               <a:ext uri="{FF2B5EF4-FFF2-40B4-BE49-F238E27FC236}">
-                <a16:creationId xmlns:a16="http://schemas.microsoft.com/office/drawing/2014/main" id="{1E6035CC-CD1A-4B85-835E-17111B99FAAD}"/>
+                <a16:creationId xmlns:a16="http://schemas.microsoft.com/office/drawing/2014/main" id="{2BEEB487-23E0-4E7B-AEF9-A561095B71D3}"/>
               </a:ext>
             </a:extLst>
           </p:cNvPr>
@@ -15201,7 +15201,7 @@
           <p:cNvPr id="12" name="">
             <a:extLst xmlns:a="http://schemas.openxmlformats.org/drawingml/2006/main">
               <a:ext uri="{FF2B5EF4-FFF2-40B4-BE49-F238E27FC236}">
-                <a16:creationId xmlns:a16="http://schemas.microsoft.com/office/drawing/2014/main" id="{99AC4B58-6B82-4B3E-9C73-CE44DED457AE}"/>
+                <a16:creationId xmlns:a16="http://schemas.microsoft.com/office/drawing/2014/main" id="{DDBB4879-2BA0-4BDC-A202-E2A9FD54669F}"/>
               </a:ext>
             </a:extLst>
           </p:cNvPr>
@@ -15236,7 +15236,7 @@
                   <a:srgbClr val="08756F"/>
                 </a:solidFill>
               </a:rPr>
-              <a:t>327 tests passed</a:t>
+              <a:t>329 tests passed</a:t>
             </a:r>
           </a:p>
         </p:txBody>
@@ -15246,7 +15246,7 @@
           <p:cNvPr id="13" name="">
             <a:extLst xmlns:a="http://schemas.openxmlformats.org/drawingml/2006/main">
               <a:ext uri="{FF2B5EF4-FFF2-40B4-BE49-F238E27FC236}">
-                <a16:creationId xmlns:a16="http://schemas.microsoft.com/office/drawing/2014/main" id="{680A483E-AA61-4707-BE61-1F12949E57DD}"/>
+                <a16:creationId xmlns:a16="http://schemas.microsoft.com/office/drawing/2014/main" id="{4469B3C6-4E86-40FD-A59B-D91E22A2BA1D}"/>
               </a:ext>
             </a:extLst>
           </p:cNvPr>
@@ -15281,7 +15281,7 @@
           <p:cNvPr id="14" name="">
             <a:extLst xmlns:a="http://schemas.openxmlformats.org/drawingml/2006/main">
               <a:ext uri="{FF2B5EF4-FFF2-40B4-BE49-F238E27FC236}">
-                <a16:creationId xmlns:a16="http://schemas.microsoft.com/office/drawing/2014/main" id="{EE0D142E-6111-4E40-8504-20252862CC55}"/>
+                <a16:creationId xmlns:a16="http://schemas.microsoft.com/office/drawing/2014/main" id="{D537DCE2-3C2A-4279-AF63-7EC9734801B2}"/>
               </a:ext>
             </a:extLst>
           </p:cNvPr>
@@ -15326,7 +15326,7 @@
           <p:cNvPr id="15" name="">
             <a:extLst xmlns:a="http://schemas.openxmlformats.org/drawingml/2006/main">
               <a:ext uri="{FF2B5EF4-FFF2-40B4-BE49-F238E27FC236}">
-                <a16:creationId xmlns:a16="http://schemas.microsoft.com/office/drawing/2014/main" id="{5A55A9F7-1CCB-485A-875B-DE21F6E9899E}"/>
+                <a16:creationId xmlns:a16="http://schemas.microsoft.com/office/drawing/2014/main" id="{C229A0F6-54D7-437E-8671-1890C12E3B1F}"/>
               </a:ext>
             </a:extLst>
           </p:cNvPr>
@@ -15361,7 +15361,7 @@
           <p:cNvPr id="16" name="">
             <a:extLst xmlns:a="http://schemas.openxmlformats.org/drawingml/2006/main">
               <a:ext uri="{FF2B5EF4-FFF2-40B4-BE49-F238E27FC236}">
-                <a16:creationId xmlns:a16="http://schemas.microsoft.com/office/drawing/2014/main" id="{5B4E29EE-6CBE-4DB8-B7F6-9C0D7D14A44E}"/>
+                <a16:creationId xmlns:a16="http://schemas.microsoft.com/office/drawing/2014/main" id="{54300004-E988-49DB-9835-F662F097CE03}"/>
               </a:ext>
             </a:extLst>
           </p:cNvPr>
@@ -15406,7 +15406,7 @@
           <p:cNvPr id="17" name="footer-left">
             <a:extLst xmlns:a="http://schemas.openxmlformats.org/drawingml/2006/main">
               <a:ext uri="{FF2B5EF4-FFF2-40B4-BE49-F238E27FC236}">
-                <a16:creationId xmlns:a16="http://schemas.microsoft.com/office/drawing/2014/main" id="{2C728029-14E5-4879-A875-80DF1F88F5B5}"/>
+                <a16:creationId xmlns:a16="http://schemas.microsoft.com/office/drawing/2014/main" id="{FC20BF4D-6C6C-4F8D-B14C-CBFBB5E38B7D}"/>
               </a:ext>
             </a:extLst>
           </p:cNvPr>
@@ -15451,7 +15451,7 @@
           <p:cNvPr id="18" name="footer-right">
             <a:extLst xmlns:a="http://schemas.openxmlformats.org/drawingml/2006/main">
               <a:ext uri="{FF2B5EF4-FFF2-40B4-BE49-F238E27FC236}">
-                <a16:creationId xmlns:a16="http://schemas.microsoft.com/office/drawing/2014/main" id="{656D10E4-48BB-4EFB-87F4-CC40BD4C03B0}"/>
+                <a16:creationId xmlns:a16="http://schemas.microsoft.com/office/drawing/2014/main" id="{03D49773-DD03-4E91-87DF-6EE280F12C08}"/>
               </a:ext>
             </a:extLst>
           </p:cNvPr>
@@ -15494,7 +15494,7 @@
     </p:spTree>
     <p:extLst>
       <p:ext uri="{BB962C8B-B14F-4D97-AF65-F5344CB8AC3E}">
-        <p14:creationId xmlns:p14="http://schemas.microsoft.com/office/powerpoint/2010/main" val="565224541"/>
+        <p14:creationId xmlns:p14="http://schemas.microsoft.com/office/powerpoint/2010/main" val="585180545"/>
       </p:ext>
     </p:extLst>
   </p:cSld>

</xml_diff>

<commit_message>
Add transcript-first encounter workflow
</commit_message>
<xml_diff>
--- a/decks/clinsafer-interview-demo/output/output.pptx
+++ b/decks/clinsafer-interview-demo/output/output.pptx
@@ -2,28 +2,28 @@
 <file path=ppt/presentation.xml><?xml version="1.0" encoding="utf-8"?>
 <p:presentation xmlns:p="http://schemas.openxmlformats.org/presentationml/2006/main">
   <p:sldMasterIdLst>
-    <p:sldMasterId xmlns:r="http://schemas.openxmlformats.org/officeDocument/2006/relationships" id="2147483648" r:id="R67d97d30a3ed4cc0"/>
+    <p:sldMasterId xmlns:r="http://schemas.openxmlformats.org/officeDocument/2006/relationships" id="2147483648" r:id="R6c5d7a63f0194495"/>
   </p:sldMasterIdLst>
   <p:notesMasterIdLst>
-    <p:notesMasterId xmlns:r="http://schemas.openxmlformats.org/officeDocument/2006/relationships" r:id="R35bf4c5ab63644b4"/>
+    <p:notesMasterId xmlns:r="http://schemas.openxmlformats.org/officeDocument/2006/relationships" r:id="R1dfbd57421e7402d"/>
   </p:notesMasterIdLst>
   <p:sldIdLst>
-    <p:sldId xmlns:r="http://schemas.openxmlformats.org/officeDocument/2006/relationships" id="256" r:id="Ref6e4cfb535f457b"/>
-    <p:sldId xmlns:r="http://schemas.openxmlformats.org/officeDocument/2006/relationships" id="257" r:id="R9bf1d3d9e2df4b88"/>
-    <p:sldId xmlns:r="http://schemas.openxmlformats.org/officeDocument/2006/relationships" id="258" r:id="R1adf3b9eaf394239"/>
-    <p:sldId xmlns:r="http://schemas.openxmlformats.org/officeDocument/2006/relationships" id="259" r:id="Re637aa10a197443e"/>
-    <p:sldId xmlns:r="http://schemas.openxmlformats.org/officeDocument/2006/relationships" id="260" r:id="Rd21238320b394c2a"/>
-    <p:sldId xmlns:r="http://schemas.openxmlformats.org/officeDocument/2006/relationships" id="261" r:id="R3bde9a34b2df45ba"/>
-    <p:sldId xmlns:r="http://schemas.openxmlformats.org/officeDocument/2006/relationships" id="262" r:id="R1c01fe9bb5014aa0"/>
-    <p:sldId xmlns:r="http://schemas.openxmlformats.org/officeDocument/2006/relationships" id="263" r:id="R443ae1409e884c34"/>
-    <p:sldId xmlns:r="http://schemas.openxmlformats.org/officeDocument/2006/relationships" id="264" r:id="R245464f5268c423d"/>
-    <p:sldId xmlns:r="http://schemas.openxmlformats.org/officeDocument/2006/relationships" id="265" r:id="Rc952be149b1f4194"/>
-    <p:sldId xmlns:r="http://schemas.openxmlformats.org/officeDocument/2006/relationships" id="266" r:id="R5c2c1b5b95b74dae"/>
-    <p:sldId xmlns:r="http://schemas.openxmlformats.org/officeDocument/2006/relationships" id="267" r:id="R4b6fc09b61f24442"/>
-    <p:sldId xmlns:r="http://schemas.openxmlformats.org/officeDocument/2006/relationships" id="268" r:id="R7741856b3e644461"/>
-    <p:sldId xmlns:r="http://schemas.openxmlformats.org/officeDocument/2006/relationships" id="269" r:id="Rc7347aee88384b06"/>
-    <p:sldId xmlns:r="http://schemas.openxmlformats.org/officeDocument/2006/relationships" id="270" r:id="R322de2fa38cc4dd4"/>
-    <p:sldId xmlns:r="http://schemas.openxmlformats.org/officeDocument/2006/relationships" id="271" r:id="R09df7ac255f745e1"/>
+    <p:sldId xmlns:r="http://schemas.openxmlformats.org/officeDocument/2006/relationships" id="256" r:id="R1733d9cd8d854999"/>
+    <p:sldId xmlns:r="http://schemas.openxmlformats.org/officeDocument/2006/relationships" id="257" r:id="Rac6bd8add575434b"/>
+    <p:sldId xmlns:r="http://schemas.openxmlformats.org/officeDocument/2006/relationships" id="258" r:id="Rd1f3892d53504831"/>
+    <p:sldId xmlns:r="http://schemas.openxmlformats.org/officeDocument/2006/relationships" id="259" r:id="Rdab1e7b064994a02"/>
+    <p:sldId xmlns:r="http://schemas.openxmlformats.org/officeDocument/2006/relationships" id="260" r:id="Ra3082c7710c04aec"/>
+    <p:sldId xmlns:r="http://schemas.openxmlformats.org/officeDocument/2006/relationships" id="261" r:id="Rff5c1f8753784cea"/>
+    <p:sldId xmlns:r="http://schemas.openxmlformats.org/officeDocument/2006/relationships" id="262" r:id="Rf5effb1151b84f54"/>
+    <p:sldId xmlns:r="http://schemas.openxmlformats.org/officeDocument/2006/relationships" id="263" r:id="R200bad3f6b224fa0"/>
+    <p:sldId xmlns:r="http://schemas.openxmlformats.org/officeDocument/2006/relationships" id="264" r:id="R2b97b1df3de14bd4"/>
+    <p:sldId xmlns:r="http://schemas.openxmlformats.org/officeDocument/2006/relationships" id="265" r:id="R0a41a3ab02914235"/>
+    <p:sldId xmlns:r="http://schemas.openxmlformats.org/officeDocument/2006/relationships" id="266" r:id="Rd083746f98ec4d9b"/>
+    <p:sldId xmlns:r="http://schemas.openxmlformats.org/officeDocument/2006/relationships" id="267" r:id="Rca81ae1802484434"/>
+    <p:sldId xmlns:r="http://schemas.openxmlformats.org/officeDocument/2006/relationships" id="268" r:id="R1be49dae42144c87"/>
+    <p:sldId xmlns:r="http://schemas.openxmlformats.org/officeDocument/2006/relationships" id="269" r:id="Rbddb5fd6b7bf4f61"/>
+    <p:sldId xmlns:r="http://schemas.openxmlformats.org/officeDocument/2006/relationships" id="270" r:id="R60963dd063f94aca"/>
+    <p:sldId xmlns:r="http://schemas.openxmlformats.org/officeDocument/2006/relationships" id="271" r:id="R49b4742d42284d67"/>
   </p:sldIdLst>
   <p:sldSz cx="18288000" cy="10287000"/>
   <p:notesSz cx="6858000" cy="9144000"/>
@@ -2239,7 +2239,7 @@
   </p:cSld>
   <p:clrMap bg1="lt1" tx1="dk1" bg2="lt2" tx2="dk2" accent1="accent1" accent2="accent2" accent3="accent3" accent4="accent4" accent5="accent5" accent6="accent6" hlink="hlink" folHlink="folHlink"/>
   <p:sldLayoutIdLst>
-    <p:sldLayoutId xmlns:r="http://schemas.openxmlformats.org/officeDocument/2006/relationships" id="2147483649" r:id="Rdc53772473b4413e"/>
+    <p:sldLayoutId xmlns:r="http://schemas.openxmlformats.org/officeDocument/2006/relationships" id="2147483649" r:id="R5463909fe89343ae"/>
   </p:sldLayoutIdLst>
   <p:txStyles>
     <p:titleStyle>
@@ -2538,7 +2538,7 @@
           <p:cNvPr id="1" name="cover-stage">
             <a:extLst xmlns:a="http://schemas.openxmlformats.org/drawingml/2006/main">
               <a:ext uri="{FF2B5EF4-FFF2-40B4-BE49-F238E27FC236}">
-                <a16:creationId xmlns:a16="http://schemas.microsoft.com/office/drawing/2014/main" id="{18D17DD9-65B4-49EF-BDCE-2CEEE7BF1D25}"/>
+                <a16:creationId xmlns:a16="http://schemas.microsoft.com/office/drawing/2014/main" id="{FFA05298-8857-4B02-9DE4-74E80624AD7B}"/>
               </a:ext>
             </a:extLst>
           </p:cNvPr>
@@ -2565,7 +2565,7 @@
           <p:cNvPr id="2" name="">
             <a:extLst xmlns:a="http://schemas.openxmlformats.org/drawingml/2006/main">
               <a:ext uri="{FF2B5EF4-FFF2-40B4-BE49-F238E27FC236}">
-                <a16:creationId xmlns:a16="http://schemas.microsoft.com/office/drawing/2014/main" id="{DB3B7496-DB5A-4872-882E-C83EF079330E}"/>
+                <a16:creationId xmlns:a16="http://schemas.microsoft.com/office/drawing/2014/main" id="{C64D3FDF-6626-4970-9C13-ACA86FBC5DFB}"/>
               </a:ext>
             </a:extLst>
           </p:cNvPr>
@@ -2610,7 +2610,7 @@
           <p:cNvPr id="3" name="cover-title">
             <a:extLst xmlns:a="http://schemas.openxmlformats.org/drawingml/2006/main">
               <a:ext uri="{FF2B5EF4-FFF2-40B4-BE49-F238E27FC236}">
-                <a16:creationId xmlns:a16="http://schemas.microsoft.com/office/drawing/2014/main" id="{D8012761-22CB-41C7-A3FF-68776B8B170B}"/>
+                <a16:creationId xmlns:a16="http://schemas.microsoft.com/office/drawing/2014/main" id="{4A339B06-E96A-4439-93F6-9EFCFF8A2F84}"/>
               </a:ext>
             </a:extLst>
           </p:cNvPr>
@@ -2655,7 +2655,7 @@
           <p:cNvPr id="4" name="">
             <a:extLst xmlns:a="http://schemas.openxmlformats.org/drawingml/2006/main">
               <a:ext uri="{FF2B5EF4-FFF2-40B4-BE49-F238E27FC236}">
-                <a16:creationId xmlns:a16="http://schemas.microsoft.com/office/drawing/2014/main" id="{C5094A6C-D45E-4F5B-8347-56201DDF2C1A}"/>
+                <a16:creationId xmlns:a16="http://schemas.microsoft.com/office/drawing/2014/main" id="{D8B78E09-4FD9-436A-9D8C-DDFC28A1BFC2}"/>
               </a:ext>
             </a:extLst>
           </p:cNvPr>
@@ -2688,7 +2688,7 @@
           <p:cNvPr id="5" name="">
             <a:extLst xmlns:a="http://schemas.openxmlformats.org/drawingml/2006/main">
               <a:ext uri="{FF2B5EF4-FFF2-40B4-BE49-F238E27FC236}">
-                <a16:creationId xmlns:a16="http://schemas.microsoft.com/office/drawing/2014/main" id="{B5221C7B-91C7-4100-9962-42846DA9B70B}"/>
+                <a16:creationId xmlns:a16="http://schemas.microsoft.com/office/drawing/2014/main" id="{CB28D5C8-02B0-4215-8D00-327113D62561}"/>
               </a:ext>
             </a:extLst>
           </p:cNvPr>
@@ -2733,7 +2733,7 @@
           <p:cNvPr id="6" name="">
             <a:extLst xmlns:a="http://schemas.openxmlformats.org/drawingml/2006/main">
               <a:ext uri="{FF2B5EF4-FFF2-40B4-BE49-F238E27FC236}">
-                <a16:creationId xmlns:a16="http://schemas.microsoft.com/office/drawing/2014/main" id="{FCB3A506-B797-4E51-83FD-39C5EB4D9D4B}"/>
+                <a16:creationId xmlns:a16="http://schemas.microsoft.com/office/drawing/2014/main" id="{F4AF0E68-626D-4C2A-968B-4FC7C0D2E68B}"/>
               </a:ext>
             </a:extLst>
           </p:cNvPr>
@@ -2778,7 +2778,7 @@
           <p:cNvPr id="7" name="">
             <a:extLst xmlns:a="http://schemas.openxmlformats.org/drawingml/2006/main">
               <a:ext uri="{FF2B5EF4-FFF2-40B4-BE49-F238E27FC236}">
-                <a16:creationId xmlns:a16="http://schemas.microsoft.com/office/drawing/2014/main" id="{CBA80C5D-EDE0-4256-AC69-45E783115B68}"/>
+                <a16:creationId xmlns:a16="http://schemas.microsoft.com/office/drawing/2014/main" id="{1D068FEE-1CFF-4FBC-96B1-96D07DEE8953}"/>
               </a:ext>
             </a:extLst>
           </p:cNvPr>
@@ -2823,7 +2823,7 @@
           <p:cNvPr id="8" name="">
             <a:extLst xmlns:a="http://schemas.openxmlformats.org/drawingml/2006/main">
               <a:ext uri="{FF2B5EF4-FFF2-40B4-BE49-F238E27FC236}">
-                <a16:creationId xmlns:a16="http://schemas.microsoft.com/office/drawing/2014/main" id="{9F64A78B-7401-48D3-AE81-7D6F6AAE18B0}"/>
+                <a16:creationId xmlns:a16="http://schemas.microsoft.com/office/drawing/2014/main" id="{B519A6A1-04B8-4B35-BE3C-CAA05F3D48D1}"/>
               </a:ext>
             </a:extLst>
           </p:cNvPr>
@@ -2858,7 +2858,7 @@
                   <a:srgbClr val="2364AA"/>
                 </a:solidFill>
               </a:rPr>
-              <a:t>329</a:t>
+              <a:t>330</a:t>
             </a:r>
           </a:p>
         </p:txBody>
@@ -2868,7 +2868,7 @@
           <p:cNvPr id="9" name="">
             <a:extLst xmlns:a="http://schemas.openxmlformats.org/drawingml/2006/main">
               <a:ext uri="{FF2B5EF4-FFF2-40B4-BE49-F238E27FC236}">
-                <a16:creationId xmlns:a16="http://schemas.microsoft.com/office/drawing/2014/main" id="{FA6911E4-E681-4D61-894A-1DB747954BFF}"/>
+                <a16:creationId xmlns:a16="http://schemas.microsoft.com/office/drawing/2014/main" id="{CAEC219B-A4AA-406C-8310-D38054293AE1}"/>
               </a:ext>
             </a:extLst>
           </p:cNvPr>
@@ -2913,7 +2913,7 @@
           <p:cNvPr id="10" name="">
             <a:extLst xmlns:a="http://schemas.openxmlformats.org/drawingml/2006/main">
               <a:ext uri="{FF2B5EF4-FFF2-40B4-BE49-F238E27FC236}">
-                <a16:creationId xmlns:a16="http://schemas.microsoft.com/office/drawing/2014/main" id="{7855D874-9AAE-449A-940D-FE974C86BE28}"/>
+                <a16:creationId xmlns:a16="http://schemas.microsoft.com/office/drawing/2014/main" id="{6B3C6AF1-662C-4610-961A-BF473BAECD85}"/>
               </a:ext>
             </a:extLst>
           </p:cNvPr>
@@ -2958,7 +2958,7 @@
           <p:cNvPr id="11" name="">
             <a:extLst xmlns:a="http://schemas.openxmlformats.org/drawingml/2006/main">
               <a:ext uri="{FF2B5EF4-FFF2-40B4-BE49-F238E27FC236}">
-                <a16:creationId xmlns:a16="http://schemas.microsoft.com/office/drawing/2014/main" id="{8079E4FF-40F4-4C86-B8BD-4FDD3B9E2C10}"/>
+                <a16:creationId xmlns:a16="http://schemas.microsoft.com/office/drawing/2014/main" id="{70D7A5C3-ACC3-4511-B1FC-5569DCBC4154}"/>
               </a:ext>
             </a:extLst>
           </p:cNvPr>
@@ -3003,7 +3003,7 @@
           <p:cNvPr id="12" name="">
             <a:extLst xmlns:a="http://schemas.openxmlformats.org/drawingml/2006/main">
               <a:ext uri="{FF2B5EF4-FFF2-40B4-BE49-F238E27FC236}">
-                <a16:creationId xmlns:a16="http://schemas.microsoft.com/office/drawing/2014/main" id="{225B6ABB-7CBB-440F-85D1-332187C506F9}"/>
+                <a16:creationId xmlns:a16="http://schemas.microsoft.com/office/drawing/2014/main" id="{C510121B-138A-4ADB-B2A3-30E04A6654B3}"/>
               </a:ext>
             </a:extLst>
           </p:cNvPr>
@@ -3048,7 +3048,7 @@
           <p:cNvPr id="13" name="">
             <a:extLst xmlns:a="http://schemas.openxmlformats.org/drawingml/2006/main">
               <a:ext uri="{FF2B5EF4-FFF2-40B4-BE49-F238E27FC236}">
-                <a16:creationId xmlns:a16="http://schemas.microsoft.com/office/drawing/2014/main" id="{20584FF4-DB68-4555-A064-FD8EBE781600}"/>
+                <a16:creationId xmlns:a16="http://schemas.microsoft.com/office/drawing/2014/main" id="{750CFE86-055F-4DFF-811C-74545DC5A4D7}"/>
               </a:ext>
             </a:extLst>
           </p:cNvPr>
@@ -3091,7 +3091,7 @@
     </p:spTree>
     <p:extLst>
       <p:ext uri="{BB962C8B-B14F-4D97-AF65-F5344CB8AC3E}">
-        <p14:creationId xmlns:p14="http://schemas.microsoft.com/office/powerpoint/2010/main" val="1763202994"/>
+        <p14:creationId xmlns:p14="http://schemas.microsoft.com/office/powerpoint/2010/main" val="181196493"/>
       </p:ext>
     </p:extLst>
   </p:cSld>
@@ -3115,7 +3115,7 @@
           <p:cNvPr id="1" name="slide-stage">
             <a:extLst xmlns:a="http://schemas.openxmlformats.org/drawingml/2006/main">
               <a:ext uri="{FF2B5EF4-FFF2-40B4-BE49-F238E27FC236}">
-                <a16:creationId xmlns:a16="http://schemas.microsoft.com/office/drawing/2014/main" id="{8265ED1A-5739-48F3-A31B-3FE2F45559E9}"/>
+                <a16:creationId xmlns:a16="http://schemas.microsoft.com/office/drawing/2014/main" id="{5BF617C2-592E-4973-B99F-2245602CDCAE}"/>
               </a:ext>
             </a:extLst>
           </p:cNvPr>
@@ -3142,7 +3142,7 @@
           <p:cNvPr id="2" name="eyebrow">
             <a:extLst xmlns:a="http://schemas.openxmlformats.org/drawingml/2006/main">
               <a:ext uri="{FF2B5EF4-FFF2-40B4-BE49-F238E27FC236}">
-                <a16:creationId xmlns:a16="http://schemas.microsoft.com/office/drawing/2014/main" id="{BB324C7E-D2DC-4EB8-BA99-8E0423CDED87}"/>
+                <a16:creationId xmlns:a16="http://schemas.microsoft.com/office/drawing/2014/main" id="{F7EA5E6D-498D-4ED6-8D85-5AA41EC22924}"/>
               </a:ext>
             </a:extLst>
           </p:cNvPr>
@@ -3187,7 +3187,7 @@
           <p:cNvPr id="3" name="slide-title">
             <a:extLst xmlns:a="http://schemas.openxmlformats.org/drawingml/2006/main">
               <a:ext uri="{FF2B5EF4-FFF2-40B4-BE49-F238E27FC236}">
-                <a16:creationId xmlns:a16="http://schemas.microsoft.com/office/drawing/2014/main" id="{847BB3E3-C3E7-4BFA-843C-1B181F48B698}"/>
+                <a16:creationId xmlns:a16="http://schemas.microsoft.com/office/drawing/2014/main" id="{9B2C65E0-79E0-4CC3-BEBF-17264E7DB407}"/>
               </a:ext>
             </a:extLst>
           </p:cNvPr>
@@ -3232,7 +3232,7 @@
           <p:cNvPr id="4" name="slide-subtitle">
             <a:extLst xmlns:a="http://schemas.openxmlformats.org/drawingml/2006/main">
               <a:ext uri="{FF2B5EF4-FFF2-40B4-BE49-F238E27FC236}">
-                <a16:creationId xmlns:a16="http://schemas.microsoft.com/office/drawing/2014/main" id="{F2A35C3B-9C84-49D4-BA32-D59C8A0C009C}"/>
+                <a16:creationId xmlns:a16="http://schemas.microsoft.com/office/drawing/2014/main" id="{E0368150-7DB4-495A-A6D6-C41EBAAE23A1}"/>
               </a:ext>
             </a:extLst>
           </p:cNvPr>
@@ -3277,7 +3277,7 @@
           <p:cNvPr id="5" name="">
             <a:extLst xmlns:a="http://schemas.openxmlformats.org/drawingml/2006/main">
               <a:ext uri="{FF2B5EF4-FFF2-40B4-BE49-F238E27FC236}">
-                <a16:creationId xmlns:a16="http://schemas.microsoft.com/office/drawing/2014/main" id="{C79BF53B-11A3-43EA-ABBC-E849B5118B00}"/>
+                <a16:creationId xmlns:a16="http://schemas.microsoft.com/office/drawing/2014/main" id="{95326204-7A7A-4FBD-9144-6E8E07A9A9F5}"/>
               </a:ext>
             </a:extLst>
           </p:cNvPr>
@@ -3310,7 +3310,7 @@
           <p:cNvPr id="6" name="">
             <a:extLst xmlns:a="http://schemas.openxmlformats.org/drawingml/2006/main">
               <a:ext uri="{FF2B5EF4-FFF2-40B4-BE49-F238E27FC236}">
-                <a16:creationId xmlns:a16="http://schemas.microsoft.com/office/drawing/2014/main" id="{A6F73936-90AC-4630-93C7-11736AEB1642}"/>
+                <a16:creationId xmlns:a16="http://schemas.microsoft.com/office/drawing/2014/main" id="{382CC5B1-2F07-49DE-8CB8-8AEE4BE83BDF}"/>
               </a:ext>
             </a:extLst>
           </p:cNvPr>
@@ -3355,7 +3355,7 @@
           <p:cNvPr id="7" name="">
             <a:extLst xmlns:a="http://schemas.openxmlformats.org/drawingml/2006/main">
               <a:ext uri="{FF2B5EF4-FFF2-40B4-BE49-F238E27FC236}">
-                <a16:creationId xmlns:a16="http://schemas.microsoft.com/office/drawing/2014/main" id="{F3EFE018-B1E5-4405-85B5-B432CA691C13}"/>
+                <a16:creationId xmlns:a16="http://schemas.microsoft.com/office/drawing/2014/main" id="{3B7663DA-990C-4E8B-9D1C-DA09B77E7CFD}"/>
               </a:ext>
             </a:extLst>
           </p:cNvPr>
@@ -3400,7 +3400,7 @@
           <p:cNvPr id="8" name="">
             <a:extLst xmlns:a="http://schemas.openxmlformats.org/drawingml/2006/main">
               <a:ext uri="{FF2B5EF4-FFF2-40B4-BE49-F238E27FC236}">
-                <a16:creationId xmlns:a16="http://schemas.microsoft.com/office/drawing/2014/main" id="{E55F45A3-7D32-454B-8A92-87039BAE9874}"/>
+                <a16:creationId xmlns:a16="http://schemas.microsoft.com/office/drawing/2014/main" id="{E381CF70-3046-4925-9571-92ECE57C132F}"/>
               </a:ext>
             </a:extLst>
           </p:cNvPr>
@@ -3433,7 +3433,7 @@
           <p:cNvPr id="9" name="">
             <a:extLst xmlns:a="http://schemas.openxmlformats.org/drawingml/2006/main">
               <a:ext uri="{FF2B5EF4-FFF2-40B4-BE49-F238E27FC236}">
-                <a16:creationId xmlns:a16="http://schemas.microsoft.com/office/drawing/2014/main" id="{C033F5A2-4658-4F58-86A7-48827D696693}"/>
+                <a16:creationId xmlns:a16="http://schemas.microsoft.com/office/drawing/2014/main" id="{708A25C5-67F6-4F55-A908-5217EA020BA0}"/>
               </a:ext>
             </a:extLst>
           </p:cNvPr>
@@ -3478,7 +3478,7 @@
           <p:cNvPr id="10" name="">
             <a:extLst xmlns:a="http://schemas.openxmlformats.org/drawingml/2006/main">
               <a:ext uri="{FF2B5EF4-FFF2-40B4-BE49-F238E27FC236}">
-                <a16:creationId xmlns:a16="http://schemas.microsoft.com/office/drawing/2014/main" id="{0BE1FBC7-31E5-42CD-BB1C-A4C0EDB263FC}"/>
+                <a16:creationId xmlns:a16="http://schemas.microsoft.com/office/drawing/2014/main" id="{532B8B29-6FA8-452F-8D70-CF30B85DE2B3}"/>
               </a:ext>
             </a:extLst>
           </p:cNvPr>
@@ -3523,7 +3523,7 @@
           <p:cNvPr id="11" name="">
             <a:extLst xmlns:a="http://schemas.openxmlformats.org/drawingml/2006/main">
               <a:ext uri="{FF2B5EF4-FFF2-40B4-BE49-F238E27FC236}">
-                <a16:creationId xmlns:a16="http://schemas.microsoft.com/office/drawing/2014/main" id="{3DB68248-6C31-4D96-952D-2D87B9E85380}"/>
+                <a16:creationId xmlns:a16="http://schemas.microsoft.com/office/drawing/2014/main" id="{37F1B1A3-CBDC-4298-83CA-0BA6210E3973}"/>
               </a:ext>
             </a:extLst>
           </p:cNvPr>
@@ -3556,7 +3556,7 @@
           <p:cNvPr id="12" name="">
             <a:extLst xmlns:a="http://schemas.openxmlformats.org/drawingml/2006/main">
               <a:ext uri="{FF2B5EF4-FFF2-40B4-BE49-F238E27FC236}">
-                <a16:creationId xmlns:a16="http://schemas.microsoft.com/office/drawing/2014/main" id="{73773780-2BCA-491F-AEF3-FE01112893B3}"/>
+                <a16:creationId xmlns:a16="http://schemas.microsoft.com/office/drawing/2014/main" id="{38A8A460-6F26-4403-9015-372676488D11}"/>
               </a:ext>
             </a:extLst>
           </p:cNvPr>
@@ -3601,7 +3601,7 @@
           <p:cNvPr id="13" name="">
             <a:extLst xmlns:a="http://schemas.openxmlformats.org/drawingml/2006/main">
               <a:ext uri="{FF2B5EF4-FFF2-40B4-BE49-F238E27FC236}">
-                <a16:creationId xmlns:a16="http://schemas.microsoft.com/office/drawing/2014/main" id="{C330B655-949D-4EE2-A42F-F1FA39C6B7DE}"/>
+                <a16:creationId xmlns:a16="http://schemas.microsoft.com/office/drawing/2014/main" id="{E2D84990-A23D-4F7A-ACBA-372D040D593F}"/>
               </a:ext>
             </a:extLst>
           </p:cNvPr>
@@ -3646,7 +3646,7 @@
           <p:cNvPr id="14" name="">
             <a:extLst xmlns:a="http://schemas.openxmlformats.org/drawingml/2006/main">
               <a:ext uri="{FF2B5EF4-FFF2-40B4-BE49-F238E27FC236}">
-                <a16:creationId xmlns:a16="http://schemas.microsoft.com/office/drawing/2014/main" id="{04B0831E-3FF6-4BCD-ABB9-9F2D222CAB21}"/>
+                <a16:creationId xmlns:a16="http://schemas.microsoft.com/office/drawing/2014/main" id="{712BC088-D3AC-4BD2-A2DA-BF3EDB20E88B}"/>
               </a:ext>
             </a:extLst>
           </p:cNvPr>
@@ -3679,7 +3679,7 @@
           <p:cNvPr id="15" name="">
             <a:extLst xmlns:a="http://schemas.openxmlformats.org/drawingml/2006/main">
               <a:ext uri="{FF2B5EF4-FFF2-40B4-BE49-F238E27FC236}">
-                <a16:creationId xmlns:a16="http://schemas.microsoft.com/office/drawing/2014/main" id="{46522B3D-3120-415E-9322-CEF89EBB4FC7}"/>
+                <a16:creationId xmlns:a16="http://schemas.microsoft.com/office/drawing/2014/main" id="{A085BAB8-85BE-487D-84A0-D36431D3C5AE}"/>
               </a:ext>
             </a:extLst>
           </p:cNvPr>
@@ -3724,7 +3724,7 @@
           <p:cNvPr id="16" name="">
             <a:extLst xmlns:a="http://schemas.openxmlformats.org/drawingml/2006/main">
               <a:ext uri="{FF2B5EF4-FFF2-40B4-BE49-F238E27FC236}">
-                <a16:creationId xmlns:a16="http://schemas.microsoft.com/office/drawing/2014/main" id="{59021C4E-E8CC-4EE5-9618-94D6B3019380}"/>
+                <a16:creationId xmlns:a16="http://schemas.microsoft.com/office/drawing/2014/main" id="{E528894D-0C4B-4C1E-B683-3B27F81E57D5}"/>
               </a:ext>
             </a:extLst>
           </p:cNvPr>
@@ -3769,7 +3769,7 @@
           <p:cNvPr id="17" name="footer-left">
             <a:extLst xmlns:a="http://schemas.openxmlformats.org/drawingml/2006/main">
               <a:ext uri="{FF2B5EF4-FFF2-40B4-BE49-F238E27FC236}">
-                <a16:creationId xmlns:a16="http://schemas.microsoft.com/office/drawing/2014/main" id="{81DD4391-9A79-4E9D-8F8F-BE3F0B62A80E}"/>
+                <a16:creationId xmlns:a16="http://schemas.microsoft.com/office/drawing/2014/main" id="{4D43DF96-0A72-4952-871D-FADD1D1DAC30}"/>
               </a:ext>
             </a:extLst>
           </p:cNvPr>
@@ -3814,7 +3814,7 @@
           <p:cNvPr id="18" name="footer-right">
             <a:extLst xmlns:a="http://schemas.openxmlformats.org/drawingml/2006/main">
               <a:ext uri="{FF2B5EF4-FFF2-40B4-BE49-F238E27FC236}">
-                <a16:creationId xmlns:a16="http://schemas.microsoft.com/office/drawing/2014/main" id="{9DEF46EB-1416-4B41-975E-899B108C2442}"/>
+                <a16:creationId xmlns:a16="http://schemas.microsoft.com/office/drawing/2014/main" id="{ABC838C5-D628-4E5E-990F-56C3D44A3976}"/>
               </a:ext>
             </a:extLst>
           </p:cNvPr>
@@ -3857,7 +3857,7 @@
     </p:spTree>
     <p:extLst>
       <p:ext uri="{BB962C8B-B14F-4D97-AF65-F5344CB8AC3E}">
-        <p14:creationId xmlns:p14="http://schemas.microsoft.com/office/powerpoint/2010/main" val="2098453200"/>
+        <p14:creationId xmlns:p14="http://schemas.microsoft.com/office/powerpoint/2010/main" val="1276092727"/>
       </p:ext>
     </p:extLst>
   </p:cSld>
@@ -3881,7 +3881,7 @@
           <p:cNvPr id="1" name="slide-stage">
             <a:extLst xmlns:a="http://schemas.openxmlformats.org/drawingml/2006/main">
               <a:ext uri="{FF2B5EF4-FFF2-40B4-BE49-F238E27FC236}">
-                <a16:creationId xmlns:a16="http://schemas.microsoft.com/office/drawing/2014/main" id="{B5587C85-5327-45F8-8028-0388D27A06C4}"/>
+                <a16:creationId xmlns:a16="http://schemas.microsoft.com/office/drawing/2014/main" id="{F81E9A10-3D35-4DB1-9441-6D3D49CB989E}"/>
               </a:ext>
             </a:extLst>
           </p:cNvPr>
@@ -3908,7 +3908,7 @@
           <p:cNvPr id="2" name="eyebrow">
             <a:extLst xmlns:a="http://schemas.openxmlformats.org/drawingml/2006/main">
               <a:ext uri="{FF2B5EF4-FFF2-40B4-BE49-F238E27FC236}">
-                <a16:creationId xmlns:a16="http://schemas.microsoft.com/office/drawing/2014/main" id="{EB6179FA-E349-46A2-A76D-D43A326BA858}"/>
+                <a16:creationId xmlns:a16="http://schemas.microsoft.com/office/drawing/2014/main" id="{ACFD4BF7-119E-46D6-85C8-E186B269EF52}"/>
               </a:ext>
             </a:extLst>
           </p:cNvPr>
@@ -3953,7 +3953,7 @@
           <p:cNvPr id="3" name="slide-title">
             <a:extLst xmlns:a="http://schemas.openxmlformats.org/drawingml/2006/main">
               <a:ext uri="{FF2B5EF4-FFF2-40B4-BE49-F238E27FC236}">
-                <a16:creationId xmlns:a16="http://schemas.microsoft.com/office/drawing/2014/main" id="{E9FC668C-885E-4583-A05B-57725380EC30}"/>
+                <a16:creationId xmlns:a16="http://schemas.microsoft.com/office/drawing/2014/main" id="{C9EBC452-BA2A-4021-BC2F-367A2AF2CE9A}"/>
               </a:ext>
             </a:extLst>
           </p:cNvPr>
@@ -3998,7 +3998,7 @@
           <p:cNvPr id="4" name="slide-subtitle">
             <a:extLst xmlns:a="http://schemas.openxmlformats.org/drawingml/2006/main">
               <a:ext uri="{FF2B5EF4-FFF2-40B4-BE49-F238E27FC236}">
-                <a16:creationId xmlns:a16="http://schemas.microsoft.com/office/drawing/2014/main" id="{0EF26A80-ACBF-4689-96AC-43EB9B77171A}"/>
+                <a16:creationId xmlns:a16="http://schemas.microsoft.com/office/drawing/2014/main" id="{28CDD761-9435-47CB-96E4-CD04929D8D8B}"/>
               </a:ext>
             </a:extLst>
           </p:cNvPr>
@@ -4043,7 +4043,7 @@
           <p:cNvPr id="5" name="">
             <a:extLst xmlns:a="http://schemas.openxmlformats.org/drawingml/2006/main">
               <a:ext uri="{FF2B5EF4-FFF2-40B4-BE49-F238E27FC236}">
-                <a16:creationId xmlns:a16="http://schemas.microsoft.com/office/drawing/2014/main" id="{9CFDA9B7-BB7B-4139-A29A-B74DD456856E}"/>
+                <a16:creationId xmlns:a16="http://schemas.microsoft.com/office/drawing/2014/main" id="{5C1F5DFF-D69D-450F-B634-C77B3165E3EB}"/>
               </a:ext>
             </a:extLst>
           </p:cNvPr>
@@ -4088,7 +4088,7 @@
           <p:cNvPr id="6" name="">
             <a:extLst xmlns:a="http://schemas.openxmlformats.org/drawingml/2006/main">
               <a:ext uri="{FF2B5EF4-FFF2-40B4-BE49-F238E27FC236}">
-                <a16:creationId xmlns:a16="http://schemas.microsoft.com/office/drawing/2014/main" id="{36D3CF09-35D8-4B1B-BB89-7350BCA11F04}"/>
+                <a16:creationId xmlns:a16="http://schemas.microsoft.com/office/drawing/2014/main" id="{FD326B83-D5BB-4D5C-A5EB-FB86067A4AA7}"/>
               </a:ext>
             </a:extLst>
           </p:cNvPr>
@@ -4133,7 +4133,7 @@
           <p:cNvPr id="7" name="">
             <a:extLst xmlns:a="http://schemas.openxmlformats.org/drawingml/2006/main">
               <a:ext uri="{FF2B5EF4-FFF2-40B4-BE49-F238E27FC236}">
-                <a16:creationId xmlns:a16="http://schemas.microsoft.com/office/drawing/2014/main" id="{EC310573-D64B-4116-81D4-A3CB714EC3E9}"/>
+                <a16:creationId xmlns:a16="http://schemas.microsoft.com/office/drawing/2014/main" id="{4DA5C2D2-BCC0-4946-8CF8-A319CFC3C557}"/>
               </a:ext>
             </a:extLst>
           </p:cNvPr>
@@ -4178,7 +4178,7 @@
           <p:cNvPr id="8" name="">
             <a:extLst xmlns:a="http://schemas.openxmlformats.org/drawingml/2006/main">
               <a:ext uri="{FF2B5EF4-FFF2-40B4-BE49-F238E27FC236}">
-                <a16:creationId xmlns:a16="http://schemas.microsoft.com/office/drawing/2014/main" id="{A44C7EDD-9821-451D-8A38-AAA6E3A20569}"/>
+                <a16:creationId xmlns:a16="http://schemas.microsoft.com/office/drawing/2014/main" id="{6EE4D62D-9A13-47F6-99F0-A64AA5511EE2}"/>
               </a:ext>
             </a:extLst>
           </p:cNvPr>
@@ -4223,7 +4223,7 @@
           <p:cNvPr id="9" name="">
             <a:extLst xmlns:a="http://schemas.openxmlformats.org/drawingml/2006/main">
               <a:ext uri="{FF2B5EF4-FFF2-40B4-BE49-F238E27FC236}">
-                <a16:creationId xmlns:a16="http://schemas.microsoft.com/office/drawing/2014/main" id="{8B37F1C1-6AAC-473A-8E44-095F9B8F2236}"/>
+                <a16:creationId xmlns:a16="http://schemas.microsoft.com/office/drawing/2014/main" id="{E92DF640-0559-4835-B855-C847C6B36774}"/>
               </a:ext>
             </a:extLst>
           </p:cNvPr>
@@ -4268,7 +4268,7 @@
           <p:cNvPr id="10" name="">
             <a:extLst xmlns:a="http://schemas.openxmlformats.org/drawingml/2006/main">
               <a:ext uri="{FF2B5EF4-FFF2-40B4-BE49-F238E27FC236}">
-                <a16:creationId xmlns:a16="http://schemas.microsoft.com/office/drawing/2014/main" id="{C460171E-15EE-40A6-B852-7702F689EFED}"/>
+                <a16:creationId xmlns:a16="http://schemas.microsoft.com/office/drawing/2014/main" id="{028A9CCB-2DE5-4C67-B256-BBDA31329A52}"/>
               </a:ext>
             </a:extLst>
           </p:cNvPr>
@@ -4313,7 +4313,7 @@
           <p:cNvPr id="11" name="">
             <a:extLst xmlns:a="http://schemas.openxmlformats.org/drawingml/2006/main">
               <a:ext uri="{FF2B5EF4-FFF2-40B4-BE49-F238E27FC236}">
-                <a16:creationId xmlns:a16="http://schemas.microsoft.com/office/drawing/2014/main" id="{73EF60CF-DB3A-459F-BA03-408AE7A8D6FE}"/>
+                <a16:creationId xmlns:a16="http://schemas.microsoft.com/office/drawing/2014/main" id="{BD81438E-E29E-4FA5-AB0B-AFA5653B8ED4}"/>
               </a:ext>
             </a:extLst>
           </p:cNvPr>
@@ -4358,7 +4358,7 @@
           <p:cNvPr id="12" name="">
             <a:extLst xmlns:a="http://schemas.openxmlformats.org/drawingml/2006/main">
               <a:ext uri="{FF2B5EF4-FFF2-40B4-BE49-F238E27FC236}">
-                <a16:creationId xmlns:a16="http://schemas.microsoft.com/office/drawing/2014/main" id="{E953D905-44AA-4B60-816B-5C6C72B52BE4}"/>
+                <a16:creationId xmlns:a16="http://schemas.microsoft.com/office/drawing/2014/main" id="{6AD3B44C-9932-4843-B14F-7B1067A81B3B}"/>
               </a:ext>
             </a:extLst>
           </p:cNvPr>
@@ -4403,7 +4403,7 @@
           <p:cNvPr id="13" name="">
             <a:extLst xmlns:a="http://schemas.openxmlformats.org/drawingml/2006/main">
               <a:ext uri="{FF2B5EF4-FFF2-40B4-BE49-F238E27FC236}">
-                <a16:creationId xmlns:a16="http://schemas.microsoft.com/office/drawing/2014/main" id="{2BD9C7C8-0F79-42FB-A1F7-C8A25FD6ADBC}"/>
+                <a16:creationId xmlns:a16="http://schemas.microsoft.com/office/drawing/2014/main" id="{2C020465-2F33-4A26-BCAF-02285B9796E3}"/>
               </a:ext>
             </a:extLst>
           </p:cNvPr>
@@ -4448,7 +4448,7 @@
           <p:cNvPr id="14" name="footer-left">
             <a:extLst xmlns:a="http://schemas.openxmlformats.org/drawingml/2006/main">
               <a:ext uri="{FF2B5EF4-FFF2-40B4-BE49-F238E27FC236}">
-                <a16:creationId xmlns:a16="http://schemas.microsoft.com/office/drawing/2014/main" id="{4BC7AF5C-161A-4D7B-8C9D-A45D1B850D6E}"/>
+                <a16:creationId xmlns:a16="http://schemas.microsoft.com/office/drawing/2014/main" id="{4B729B2A-DD22-4C3F-AA5A-640C5F436B72}"/>
               </a:ext>
             </a:extLst>
           </p:cNvPr>
@@ -4493,7 +4493,7 @@
           <p:cNvPr id="15" name="footer-right">
             <a:extLst xmlns:a="http://schemas.openxmlformats.org/drawingml/2006/main">
               <a:ext uri="{FF2B5EF4-FFF2-40B4-BE49-F238E27FC236}">
-                <a16:creationId xmlns:a16="http://schemas.microsoft.com/office/drawing/2014/main" id="{C670BF55-A4AD-482E-9148-8FB730031A7C}"/>
+                <a16:creationId xmlns:a16="http://schemas.microsoft.com/office/drawing/2014/main" id="{4BBB2BBC-E7FA-40CC-BE14-5E355A94B70D}"/>
               </a:ext>
             </a:extLst>
           </p:cNvPr>
@@ -4536,7 +4536,7 @@
     </p:spTree>
     <p:extLst>
       <p:ext uri="{BB962C8B-B14F-4D97-AF65-F5344CB8AC3E}">
-        <p14:creationId xmlns:p14="http://schemas.microsoft.com/office/powerpoint/2010/main" val="803247839"/>
+        <p14:creationId xmlns:p14="http://schemas.microsoft.com/office/powerpoint/2010/main" val="543642799"/>
       </p:ext>
     </p:extLst>
   </p:cSld>
@@ -4560,7 +4560,7 @@
           <p:cNvPr id="1" name="slide-stage">
             <a:extLst xmlns:a="http://schemas.openxmlformats.org/drawingml/2006/main">
               <a:ext uri="{FF2B5EF4-FFF2-40B4-BE49-F238E27FC236}">
-                <a16:creationId xmlns:a16="http://schemas.microsoft.com/office/drawing/2014/main" id="{E8095F91-D6FC-4AB7-AF11-4D1A654429C4}"/>
+                <a16:creationId xmlns:a16="http://schemas.microsoft.com/office/drawing/2014/main" id="{30039FF8-3B7A-49CA-BC55-774EB4934B3F}"/>
               </a:ext>
             </a:extLst>
           </p:cNvPr>
@@ -4587,7 +4587,7 @@
           <p:cNvPr id="2" name="eyebrow">
             <a:extLst xmlns:a="http://schemas.openxmlformats.org/drawingml/2006/main">
               <a:ext uri="{FF2B5EF4-FFF2-40B4-BE49-F238E27FC236}">
-                <a16:creationId xmlns:a16="http://schemas.microsoft.com/office/drawing/2014/main" id="{64F87241-66B0-4877-81AD-42AE970E9D3F}"/>
+                <a16:creationId xmlns:a16="http://schemas.microsoft.com/office/drawing/2014/main" id="{5AC8DD24-B80E-49A2-A4FF-9006DCCA5E00}"/>
               </a:ext>
             </a:extLst>
           </p:cNvPr>
@@ -4632,7 +4632,7 @@
           <p:cNvPr id="3" name="slide-title">
             <a:extLst xmlns:a="http://schemas.openxmlformats.org/drawingml/2006/main">
               <a:ext uri="{FF2B5EF4-FFF2-40B4-BE49-F238E27FC236}">
-                <a16:creationId xmlns:a16="http://schemas.microsoft.com/office/drawing/2014/main" id="{44D4873C-5F64-4760-B913-A6A96888F2BB}"/>
+                <a16:creationId xmlns:a16="http://schemas.microsoft.com/office/drawing/2014/main" id="{95D0A45E-A260-4C05-ACD4-C2873E33DAB2}"/>
               </a:ext>
             </a:extLst>
           </p:cNvPr>
@@ -4677,7 +4677,7 @@
           <p:cNvPr id="4" name="slide-subtitle">
             <a:extLst xmlns:a="http://schemas.openxmlformats.org/drawingml/2006/main">
               <a:ext uri="{FF2B5EF4-FFF2-40B4-BE49-F238E27FC236}">
-                <a16:creationId xmlns:a16="http://schemas.microsoft.com/office/drawing/2014/main" id="{BBE945BB-1C32-409A-92CE-43C4B4FC8A5C}"/>
+                <a16:creationId xmlns:a16="http://schemas.microsoft.com/office/drawing/2014/main" id="{24432A89-43E3-4420-A931-AA6A387A9304}"/>
               </a:ext>
             </a:extLst>
           </p:cNvPr>
@@ -4722,7 +4722,7 @@
           <p:cNvPr id="5" name="">
             <a:extLst xmlns:a="http://schemas.openxmlformats.org/drawingml/2006/main">
               <a:ext uri="{FF2B5EF4-FFF2-40B4-BE49-F238E27FC236}">
-                <a16:creationId xmlns:a16="http://schemas.microsoft.com/office/drawing/2014/main" id="{BD430789-F993-491C-9D2D-5CE1E52D8A88}"/>
+                <a16:creationId xmlns:a16="http://schemas.microsoft.com/office/drawing/2014/main" id="{0BF438BC-ED1D-403C-88E6-C406E5E7482A}"/>
               </a:ext>
             </a:extLst>
           </p:cNvPr>
@@ -4755,7 +4755,7 @@
           <p:cNvPr id="6" name="">
             <a:extLst xmlns:a="http://schemas.openxmlformats.org/drawingml/2006/main">
               <a:ext uri="{FF2B5EF4-FFF2-40B4-BE49-F238E27FC236}">
-                <a16:creationId xmlns:a16="http://schemas.microsoft.com/office/drawing/2014/main" id="{A611EA51-2802-4275-B367-C1DEFA7BB85F}"/>
+                <a16:creationId xmlns:a16="http://schemas.microsoft.com/office/drawing/2014/main" id="{70C6D479-CE08-487D-BEAF-1CF405299E5F}"/>
               </a:ext>
             </a:extLst>
           </p:cNvPr>
@@ -4800,7 +4800,7 @@
           <p:cNvPr id="7" name="">
             <a:extLst xmlns:a="http://schemas.openxmlformats.org/drawingml/2006/main">
               <a:ext uri="{FF2B5EF4-FFF2-40B4-BE49-F238E27FC236}">
-                <a16:creationId xmlns:a16="http://schemas.microsoft.com/office/drawing/2014/main" id="{E0F7DC91-AD45-421E-9EC6-63C3C21114E0}"/>
+                <a16:creationId xmlns:a16="http://schemas.microsoft.com/office/drawing/2014/main" id="{84C74395-95B2-4A9B-8CF3-6BCF595425BF}"/>
               </a:ext>
             </a:extLst>
           </p:cNvPr>
@@ -4845,7 +4845,7 @@
           <p:cNvPr id="8" name="">
             <a:extLst xmlns:a="http://schemas.openxmlformats.org/drawingml/2006/main">
               <a:ext uri="{FF2B5EF4-FFF2-40B4-BE49-F238E27FC236}">
-                <a16:creationId xmlns:a16="http://schemas.microsoft.com/office/drawing/2014/main" id="{072ECFBA-70B2-4959-A8E7-6A79FC8C5E5F}"/>
+                <a16:creationId xmlns:a16="http://schemas.microsoft.com/office/drawing/2014/main" id="{CC721062-63A1-4B24-8714-C1FC66E95DCC}"/>
               </a:ext>
             </a:extLst>
           </p:cNvPr>
@@ -4878,7 +4878,7 @@
           <p:cNvPr id="9" name="">
             <a:extLst xmlns:a="http://schemas.openxmlformats.org/drawingml/2006/main">
               <a:ext uri="{FF2B5EF4-FFF2-40B4-BE49-F238E27FC236}">
-                <a16:creationId xmlns:a16="http://schemas.microsoft.com/office/drawing/2014/main" id="{333C34B2-046E-4CCE-9B79-0CC6E0509662}"/>
+                <a16:creationId xmlns:a16="http://schemas.microsoft.com/office/drawing/2014/main" id="{B8966E26-134C-40FF-BD23-5F4A68C465D9}"/>
               </a:ext>
             </a:extLst>
           </p:cNvPr>
@@ -4923,7 +4923,7 @@
           <p:cNvPr id="10" name="">
             <a:extLst xmlns:a="http://schemas.openxmlformats.org/drawingml/2006/main">
               <a:ext uri="{FF2B5EF4-FFF2-40B4-BE49-F238E27FC236}">
-                <a16:creationId xmlns:a16="http://schemas.microsoft.com/office/drawing/2014/main" id="{4FF12552-2942-46B5-BBD8-D6D62F25C062}"/>
+                <a16:creationId xmlns:a16="http://schemas.microsoft.com/office/drawing/2014/main" id="{D4EDB9B1-5DFB-4B3E-8E68-E3361346ECAC}"/>
               </a:ext>
             </a:extLst>
           </p:cNvPr>
@@ -4968,7 +4968,7 @@
           <p:cNvPr id="11" name="">
             <a:extLst xmlns:a="http://schemas.openxmlformats.org/drawingml/2006/main">
               <a:ext uri="{FF2B5EF4-FFF2-40B4-BE49-F238E27FC236}">
-                <a16:creationId xmlns:a16="http://schemas.microsoft.com/office/drawing/2014/main" id="{920773B3-E4F2-462D-ADB5-8FBDDDD9753B}"/>
+                <a16:creationId xmlns:a16="http://schemas.microsoft.com/office/drawing/2014/main" id="{82808E54-E180-433F-8CFE-87F09A56277C}"/>
               </a:ext>
             </a:extLst>
           </p:cNvPr>
@@ -5001,7 +5001,7 @@
           <p:cNvPr id="12" name="">
             <a:extLst xmlns:a="http://schemas.openxmlformats.org/drawingml/2006/main">
               <a:ext uri="{FF2B5EF4-FFF2-40B4-BE49-F238E27FC236}">
-                <a16:creationId xmlns:a16="http://schemas.microsoft.com/office/drawing/2014/main" id="{693E8DA5-EE00-4699-9EDF-E36CD59BC152}"/>
+                <a16:creationId xmlns:a16="http://schemas.microsoft.com/office/drawing/2014/main" id="{65FCFFCE-0501-4D49-8C09-65648F8D50DE}"/>
               </a:ext>
             </a:extLst>
           </p:cNvPr>
@@ -5046,7 +5046,7 @@
           <p:cNvPr id="13" name="">
             <a:extLst xmlns:a="http://schemas.openxmlformats.org/drawingml/2006/main">
               <a:ext uri="{FF2B5EF4-FFF2-40B4-BE49-F238E27FC236}">
-                <a16:creationId xmlns:a16="http://schemas.microsoft.com/office/drawing/2014/main" id="{5C0CFCF0-6618-4259-9E9D-3751A8AB0631}"/>
+                <a16:creationId xmlns:a16="http://schemas.microsoft.com/office/drawing/2014/main" id="{3CCC522E-AFAC-4D17-A963-E475A22DD68A}"/>
               </a:ext>
             </a:extLst>
           </p:cNvPr>
@@ -5091,7 +5091,7 @@
           <p:cNvPr id="14" name="">
             <a:extLst xmlns:a="http://schemas.openxmlformats.org/drawingml/2006/main">
               <a:ext uri="{FF2B5EF4-FFF2-40B4-BE49-F238E27FC236}">
-                <a16:creationId xmlns:a16="http://schemas.microsoft.com/office/drawing/2014/main" id="{119CAC00-0AA4-40D3-B0D2-45ED0579BF98}"/>
+                <a16:creationId xmlns:a16="http://schemas.microsoft.com/office/drawing/2014/main" id="{4BD4C8F1-24C2-49F7-AC85-56E3A6097F3C}"/>
               </a:ext>
             </a:extLst>
           </p:cNvPr>
@@ -5124,7 +5124,7 @@
           <p:cNvPr id="15" name="">
             <a:extLst xmlns:a="http://schemas.openxmlformats.org/drawingml/2006/main">
               <a:ext uri="{FF2B5EF4-FFF2-40B4-BE49-F238E27FC236}">
-                <a16:creationId xmlns:a16="http://schemas.microsoft.com/office/drawing/2014/main" id="{58316327-C442-4DF8-BB16-9E1270A209AA}"/>
+                <a16:creationId xmlns:a16="http://schemas.microsoft.com/office/drawing/2014/main" id="{70A3E358-340D-444C-B1A2-0FAFBB3E8599}"/>
               </a:ext>
             </a:extLst>
           </p:cNvPr>
@@ -5169,7 +5169,7 @@
           <p:cNvPr id="16" name="">
             <a:extLst xmlns:a="http://schemas.openxmlformats.org/drawingml/2006/main">
               <a:ext uri="{FF2B5EF4-FFF2-40B4-BE49-F238E27FC236}">
-                <a16:creationId xmlns:a16="http://schemas.microsoft.com/office/drawing/2014/main" id="{835D2CE4-2156-42BF-ACB1-17261E56E5D2}"/>
+                <a16:creationId xmlns:a16="http://schemas.microsoft.com/office/drawing/2014/main" id="{934F1038-E899-414B-B252-581C9D47ACB9}"/>
               </a:ext>
             </a:extLst>
           </p:cNvPr>
@@ -5214,7 +5214,7 @@
           <p:cNvPr id="17" name="">
             <a:extLst xmlns:a="http://schemas.openxmlformats.org/drawingml/2006/main">
               <a:ext uri="{FF2B5EF4-FFF2-40B4-BE49-F238E27FC236}">
-                <a16:creationId xmlns:a16="http://schemas.microsoft.com/office/drawing/2014/main" id="{236F2ACE-6A0F-4D2B-AAD8-DCC6BD48C27B}"/>
+                <a16:creationId xmlns:a16="http://schemas.microsoft.com/office/drawing/2014/main" id="{E9D494C0-20A1-4A82-AA02-70737C5B16C3}"/>
               </a:ext>
             </a:extLst>
           </p:cNvPr>
@@ -5247,7 +5247,7 @@
           <p:cNvPr id="18" name="">
             <a:extLst xmlns:a="http://schemas.openxmlformats.org/drawingml/2006/main">
               <a:ext uri="{FF2B5EF4-FFF2-40B4-BE49-F238E27FC236}">
-                <a16:creationId xmlns:a16="http://schemas.microsoft.com/office/drawing/2014/main" id="{378E4F5C-D274-47A4-8C57-7B48F11DAB9E}"/>
+                <a16:creationId xmlns:a16="http://schemas.microsoft.com/office/drawing/2014/main" id="{F877CFC9-ED4A-4BEA-B3DF-DFA52DE29848}"/>
               </a:ext>
             </a:extLst>
           </p:cNvPr>
@@ -5292,7 +5292,7 @@
           <p:cNvPr id="19" name="">
             <a:extLst xmlns:a="http://schemas.openxmlformats.org/drawingml/2006/main">
               <a:ext uri="{FF2B5EF4-FFF2-40B4-BE49-F238E27FC236}">
-                <a16:creationId xmlns:a16="http://schemas.microsoft.com/office/drawing/2014/main" id="{4A1D5505-11E0-407A-A636-6E20B11E4692}"/>
+                <a16:creationId xmlns:a16="http://schemas.microsoft.com/office/drawing/2014/main" id="{D835C493-7056-4A45-91ED-C0166B02A258}"/>
               </a:ext>
             </a:extLst>
           </p:cNvPr>
@@ -5337,7 +5337,7 @@
           <p:cNvPr id="20" name="">
             <a:extLst xmlns:a="http://schemas.openxmlformats.org/drawingml/2006/main">
               <a:ext uri="{FF2B5EF4-FFF2-40B4-BE49-F238E27FC236}">
-                <a16:creationId xmlns:a16="http://schemas.microsoft.com/office/drawing/2014/main" id="{BE24B560-EFD6-41DE-8E44-9889B04F848C}"/>
+                <a16:creationId xmlns:a16="http://schemas.microsoft.com/office/drawing/2014/main" id="{3708B9E1-6B20-49D5-9A93-73D296F15F98}"/>
               </a:ext>
             </a:extLst>
           </p:cNvPr>
@@ -5370,7 +5370,7 @@
           <p:cNvPr id="21" name="">
             <a:extLst xmlns:a="http://schemas.openxmlformats.org/drawingml/2006/main">
               <a:ext uri="{FF2B5EF4-FFF2-40B4-BE49-F238E27FC236}">
-                <a16:creationId xmlns:a16="http://schemas.microsoft.com/office/drawing/2014/main" id="{F0DE3744-2FE2-4046-9B74-C811AC3D24C6}"/>
+                <a16:creationId xmlns:a16="http://schemas.microsoft.com/office/drawing/2014/main" id="{68FE578D-2C92-4270-A3B6-90980968737B}"/>
               </a:ext>
             </a:extLst>
           </p:cNvPr>
@@ -5415,7 +5415,7 @@
           <p:cNvPr id="22" name="">
             <a:extLst xmlns:a="http://schemas.openxmlformats.org/drawingml/2006/main">
               <a:ext uri="{FF2B5EF4-FFF2-40B4-BE49-F238E27FC236}">
-                <a16:creationId xmlns:a16="http://schemas.microsoft.com/office/drawing/2014/main" id="{F30F780E-C2B1-4758-8D2E-5873C8EABDE2}"/>
+                <a16:creationId xmlns:a16="http://schemas.microsoft.com/office/drawing/2014/main" id="{08CD7959-973B-4D43-B743-B94326B13510}"/>
               </a:ext>
             </a:extLst>
           </p:cNvPr>
@@ -5460,7 +5460,7 @@
           <p:cNvPr id="23" name="footer-left">
             <a:extLst xmlns:a="http://schemas.openxmlformats.org/drawingml/2006/main">
               <a:ext uri="{FF2B5EF4-FFF2-40B4-BE49-F238E27FC236}">
-                <a16:creationId xmlns:a16="http://schemas.microsoft.com/office/drawing/2014/main" id="{096C7EBD-DD8E-461D-AB26-4A446B5D6718}"/>
+                <a16:creationId xmlns:a16="http://schemas.microsoft.com/office/drawing/2014/main" id="{D4E81E91-5AA2-401E-9962-199AD89A439E}"/>
               </a:ext>
             </a:extLst>
           </p:cNvPr>
@@ -5505,7 +5505,7 @@
           <p:cNvPr id="24" name="footer-right">
             <a:extLst xmlns:a="http://schemas.openxmlformats.org/drawingml/2006/main">
               <a:ext uri="{FF2B5EF4-FFF2-40B4-BE49-F238E27FC236}">
-                <a16:creationId xmlns:a16="http://schemas.microsoft.com/office/drawing/2014/main" id="{2D348CD3-1BCF-4F2A-BF48-2632F6FDC181}"/>
+                <a16:creationId xmlns:a16="http://schemas.microsoft.com/office/drawing/2014/main" id="{ABC5E64E-B5B0-4F79-A0CF-B095A9036FB1}"/>
               </a:ext>
             </a:extLst>
           </p:cNvPr>
@@ -5548,7 +5548,7 @@
     </p:spTree>
     <p:extLst>
       <p:ext uri="{BB962C8B-B14F-4D97-AF65-F5344CB8AC3E}">
-        <p14:creationId xmlns:p14="http://schemas.microsoft.com/office/powerpoint/2010/main" val="1506372885"/>
+        <p14:creationId xmlns:p14="http://schemas.microsoft.com/office/powerpoint/2010/main" val="1324060484"/>
       </p:ext>
     </p:extLst>
   </p:cSld>
@@ -5572,7 +5572,7 @@
           <p:cNvPr id="1" name="slide-stage">
             <a:extLst xmlns:a="http://schemas.openxmlformats.org/drawingml/2006/main">
               <a:ext uri="{FF2B5EF4-FFF2-40B4-BE49-F238E27FC236}">
-                <a16:creationId xmlns:a16="http://schemas.microsoft.com/office/drawing/2014/main" id="{98AA8AB2-19BB-41C4-A178-445F1B902180}"/>
+                <a16:creationId xmlns:a16="http://schemas.microsoft.com/office/drawing/2014/main" id="{388A11AF-4FBA-4D29-BE70-2538A2ECD872}"/>
               </a:ext>
             </a:extLst>
           </p:cNvPr>
@@ -5599,7 +5599,7 @@
           <p:cNvPr id="2" name="eyebrow">
             <a:extLst xmlns:a="http://schemas.openxmlformats.org/drawingml/2006/main">
               <a:ext uri="{FF2B5EF4-FFF2-40B4-BE49-F238E27FC236}">
-                <a16:creationId xmlns:a16="http://schemas.microsoft.com/office/drawing/2014/main" id="{32807DD1-E7EF-4E20-AD3F-DD4C94801AE0}"/>
+                <a16:creationId xmlns:a16="http://schemas.microsoft.com/office/drawing/2014/main" id="{B1DC5D6F-16D5-48AB-8229-F86A45AA1F4A}"/>
               </a:ext>
             </a:extLst>
           </p:cNvPr>
@@ -5644,7 +5644,7 @@
           <p:cNvPr id="3" name="slide-title">
             <a:extLst xmlns:a="http://schemas.openxmlformats.org/drawingml/2006/main">
               <a:ext uri="{FF2B5EF4-FFF2-40B4-BE49-F238E27FC236}">
-                <a16:creationId xmlns:a16="http://schemas.microsoft.com/office/drawing/2014/main" id="{C297D38D-1B29-4CED-AE3E-3804E1081358}"/>
+                <a16:creationId xmlns:a16="http://schemas.microsoft.com/office/drawing/2014/main" id="{5292FB50-229E-4762-BBEE-C9DB43E61B93}"/>
               </a:ext>
             </a:extLst>
           </p:cNvPr>
@@ -5689,7 +5689,7 @@
           <p:cNvPr id="4" name="slide-subtitle">
             <a:extLst xmlns:a="http://schemas.openxmlformats.org/drawingml/2006/main">
               <a:ext uri="{FF2B5EF4-FFF2-40B4-BE49-F238E27FC236}">
-                <a16:creationId xmlns:a16="http://schemas.microsoft.com/office/drawing/2014/main" id="{C387B00F-C419-4A7C-B496-BE510A7AD98C}"/>
+                <a16:creationId xmlns:a16="http://schemas.microsoft.com/office/drawing/2014/main" id="{701E9B13-A82E-4F01-8E08-163C9978B329}"/>
               </a:ext>
             </a:extLst>
           </p:cNvPr>
@@ -5734,7 +5734,7 @@
           <p:cNvPr id="5" name="">
             <a:extLst xmlns:a="http://schemas.openxmlformats.org/drawingml/2006/main">
               <a:ext uri="{FF2B5EF4-FFF2-40B4-BE49-F238E27FC236}">
-                <a16:creationId xmlns:a16="http://schemas.microsoft.com/office/drawing/2014/main" id="{B01A15D2-13FE-450E-B780-C0B29E9DAE83}"/>
+                <a16:creationId xmlns:a16="http://schemas.microsoft.com/office/drawing/2014/main" id="{901E7D88-E0DC-483C-930D-EFAA77B8303D}"/>
               </a:ext>
             </a:extLst>
           </p:cNvPr>
@@ -5779,7 +5779,7 @@
           <p:cNvPr id="6" name="">
             <a:extLst xmlns:a="http://schemas.openxmlformats.org/drawingml/2006/main">
               <a:ext uri="{FF2B5EF4-FFF2-40B4-BE49-F238E27FC236}">
-                <a16:creationId xmlns:a16="http://schemas.microsoft.com/office/drawing/2014/main" id="{AF8C327B-3379-4BC6-AC68-D431E40FD0C8}"/>
+                <a16:creationId xmlns:a16="http://schemas.microsoft.com/office/drawing/2014/main" id="{BE51D4EE-5EF3-4609-8B83-3A096E9286D0}"/>
               </a:ext>
             </a:extLst>
           </p:cNvPr>
@@ -5824,7 +5824,7 @@
           <p:cNvPr id="7" name="">
             <a:extLst xmlns:a="http://schemas.openxmlformats.org/drawingml/2006/main">
               <a:ext uri="{FF2B5EF4-FFF2-40B4-BE49-F238E27FC236}">
-                <a16:creationId xmlns:a16="http://schemas.microsoft.com/office/drawing/2014/main" id="{F4A57EF5-3C13-4E67-B5EB-C9285890ADF3}"/>
+                <a16:creationId xmlns:a16="http://schemas.microsoft.com/office/drawing/2014/main" id="{EC64DD34-0F8F-4045-8F1F-81D267850582}"/>
               </a:ext>
             </a:extLst>
           </p:cNvPr>
@@ -5869,7 +5869,7 @@
           <p:cNvPr id="8" name="">
             <a:extLst xmlns:a="http://schemas.openxmlformats.org/drawingml/2006/main">
               <a:ext uri="{FF2B5EF4-FFF2-40B4-BE49-F238E27FC236}">
-                <a16:creationId xmlns:a16="http://schemas.microsoft.com/office/drawing/2014/main" id="{8D49AA1F-4422-40C5-A327-061A57B278E9}"/>
+                <a16:creationId xmlns:a16="http://schemas.microsoft.com/office/drawing/2014/main" id="{DEBD1333-1B4F-4164-B9E5-3D41F7FD37DB}"/>
               </a:ext>
             </a:extLst>
           </p:cNvPr>
@@ -5914,7 +5914,7 @@
           <p:cNvPr id="9" name="">
             <a:extLst xmlns:a="http://schemas.openxmlformats.org/drawingml/2006/main">
               <a:ext uri="{FF2B5EF4-FFF2-40B4-BE49-F238E27FC236}">
-                <a16:creationId xmlns:a16="http://schemas.microsoft.com/office/drawing/2014/main" id="{DB25E478-0AF0-44C1-B6EE-DD97DED2DFAC}"/>
+                <a16:creationId xmlns:a16="http://schemas.microsoft.com/office/drawing/2014/main" id="{DD50C74A-F565-4DA9-9999-4B891CF9F425}"/>
               </a:ext>
             </a:extLst>
           </p:cNvPr>
@@ -5959,7 +5959,7 @@
           <p:cNvPr id="10" name="">
             <a:extLst xmlns:a="http://schemas.openxmlformats.org/drawingml/2006/main">
               <a:ext uri="{FF2B5EF4-FFF2-40B4-BE49-F238E27FC236}">
-                <a16:creationId xmlns:a16="http://schemas.microsoft.com/office/drawing/2014/main" id="{7BAAA5E2-B3BE-4CCB-B1C5-F6A53750972B}"/>
+                <a16:creationId xmlns:a16="http://schemas.microsoft.com/office/drawing/2014/main" id="{343E694A-4EDF-4850-9FAE-658A98648032}"/>
               </a:ext>
             </a:extLst>
           </p:cNvPr>
@@ -6004,7 +6004,7 @@
           <p:cNvPr id="11" name="">
             <a:extLst xmlns:a="http://schemas.openxmlformats.org/drawingml/2006/main">
               <a:ext uri="{FF2B5EF4-FFF2-40B4-BE49-F238E27FC236}">
-                <a16:creationId xmlns:a16="http://schemas.microsoft.com/office/drawing/2014/main" id="{F29F2233-05CE-4F77-AB73-11A7AC4013D1}"/>
+                <a16:creationId xmlns:a16="http://schemas.microsoft.com/office/drawing/2014/main" id="{0C5ED769-1343-4789-9EF4-46FD55750FBA}"/>
               </a:ext>
             </a:extLst>
           </p:cNvPr>
@@ -6049,7 +6049,7 @@
           <p:cNvPr id="12" name="">
             <a:extLst xmlns:a="http://schemas.openxmlformats.org/drawingml/2006/main">
               <a:ext uri="{FF2B5EF4-FFF2-40B4-BE49-F238E27FC236}">
-                <a16:creationId xmlns:a16="http://schemas.microsoft.com/office/drawing/2014/main" id="{EB48CDE7-07B5-433D-8757-B5519CB57FAE}"/>
+                <a16:creationId xmlns:a16="http://schemas.microsoft.com/office/drawing/2014/main" id="{B53767F0-E521-40B8-B77C-78D9267E9069}"/>
               </a:ext>
             </a:extLst>
           </p:cNvPr>
@@ -6094,7 +6094,7 @@
           <p:cNvPr id="13" name="">
             <a:extLst xmlns:a="http://schemas.openxmlformats.org/drawingml/2006/main">
               <a:ext uri="{FF2B5EF4-FFF2-40B4-BE49-F238E27FC236}">
-                <a16:creationId xmlns:a16="http://schemas.microsoft.com/office/drawing/2014/main" id="{A518AEB5-900D-45AD-A4C8-09BDC1C48D67}"/>
+                <a16:creationId xmlns:a16="http://schemas.microsoft.com/office/drawing/2014/main" id="{F56ADC59-09AA-469A-9BDE-B0E2FB6E1EC6}"/>
               </a:ext>
             </a:extLst>
           </p:cNvPr>
@@ -6139,7 +6139,7 @@
           <p:cNvPr id="14" name="">
             <a:extLst xmlns:a="http://schemas.openxmlformats.org/drawingml/2006/main">
               <a:ext uri="{FF2B5EF4-FFF2-40B4-BE49-F238E27FC236}">
-                <a16:creationId xmlns:a16="http://schemas.microsoft.com/office/drawing/2014/main" id="{55BD6B19-FBFF-47C6-8E54-2363350305EF}"/>
+                <a16:creationId xmlns:a16="http://schemas.microsoft.com/office/drawing/2014/main" id="{E4C999D6-BD5D-4E23-93F2-B61647A25315}"/>
               </a:ext>
             </a:extLst>
           </p:cNvPr>
@@ -6184,7 +6184,7 @@
           <p:cNvPr id="15" name="footer-left">
             <a:extLst xmlns:a="http://schemas.openxmlformats.org/drawingml/2006/main">
               <a:ext uri="{FF2B5EF4-FFF2-40B4-BE49-F238E27FC236}">
-                <a16:creationId xmlns:a16="http://schemas.microsoft.com/office/drawing/2014/main" id="{E4D64616-A173-4FB7-A4CE-F4A9CEF21C73}"/>
+                <a16:creationId xmlns:a16="http://schemas.microsoft.com/office/drawing/2014/main" id="{4F2FACE3-0875-4501-A20E-F362B1855199}"/>
               </a:ext>
             </a:extLst>
           </p:cNvPr>
@@ -6229,7 +6229,7 @@
           <p:cNvPr id="16" name="footer-right">
             <a:extLst xmlns:a="http://schemas.openxmlformats.org/drawingml/2006/main">
               <a:ext uri="{FF2B5EF4-FFF2-40B4-BE49-F238E27FC236}">
-                <a16:creationId xmlns:a16="http://schemas.microsoft.com/office/drawing/2014/main" id="{F3B9BFE1-BFA8-4F37-89BC-D612AE529941}"/>
+                <a16:creationId xmlns:a16="http://schemas.microsoft.com/office/drawing/2014/main" id="{3EB73339-75E4-4A3F-B1FB-0CADF1F96D49}"/>
               </a:ext>
             </a:extLst>
           </p:cNvPr>
@@ -6272,7 +6272,7 @@
     </p:spTree>
     <p:extLst>
       <p:ext uri="{BB962C8B-B14F-4D97-AF65-F5344CB8AC3E}">
-        <p14:creationId xmlns:p14="http://schemas.microsoft.com/office/powerpoint/2010/main" val="1153048164"/>
+        <p14:creationId xmlns:p14="http://schemas.microsoft.com/office/powerpoint/2010/main" val="194853322"/>
       </p:ext>
     </p:extLst>
   </p:cSld>
@@ -6296,7 +6296,7 @@
           <p:cNvPr id="1" name="slide-stage">
             <a:extLst xmlns:a="http://schemas.openxmlformats.org/drawingml/2006/main">
               <a:ext uri="{FF2B5EF4-FFF2-40B4-BE49-F238E27FC236}">
-                <a16:creationId xmlns:a16="http://schemas.microsoft.com/office/drawing/2014/main" id="{C57F8EAF-4DA2-4266-8D0D-8B42EB67283D}"/>
+                <a16:creationId xmlns:a16="http://schemas.microsoft.com/office/drawing/2014/main" id="{B1CA6529-2072-42AB-9B36-930D5C0B8121}"/>
               </a:ext>
             </a:extLst>
           </p:cNvPr>
@@ -6323,7 +6323,7 @@
           <p:cNvPr id="2" name="eyebrow">
             <a:extLst xmlns:a="http://schemas.openxmlformats.org/drawingml/2006/main">
               <a:ext uri="{FF2B5EF4-FFF2-40B4-BE49-F238E27FC236}">
-                <a16:creationId xmlns:a16="http://schemas.microsoft.com/office/drawing/2014/main" id="{71EFC40E-DF68-49C6-8165-3D3FE25EF15C}"/>
+                <a16:creationId xmlns:a16="http://schemas.microsoft.com/office/drawing/2014/main" id="{04377308-90FD-48E8-BD24-EA304E8F926D}"/>
               </a:ext>
             </a:extLst>
           </p:cNvPr>
@@ -6368,7 +6368,7 @@
           <p:cNvPr id="3" name="slide-title">
             <a:extLst xmlns:a="http://schemas.openxmlformats.org/drawingml/2006/main">
               <a:ext uri="{FF2B5EF4-FFF2-40B4-BE49-F238E27FC236}">
-                <a16:creationId xmlns:a16="http://schemas.microsoft.com/office/drawing/2014/main" id="{9DE15466-E0CF-4FD3-BED9-589EA3DE6FCC}"/>
+                <a16:creationId xmlns:a16="http://schemas.microsoft.com/office/drawing/2014/main" id="{9D802199-2B14-4FC2-B3BD-F65521969755}"/>
               </a:ext>
             </a:extLst>
           </p:cNvPr>
@@ -6413,7 +6413,7 @@
           <p:cNvPr id="4" name="slide-subtitle">
             <a:extLst xmlns:a="http://schemas.openxmlformats.org/drawingml/2006/main">
               <a:ext uri="{FF2B5EF4-FFF2-40B4-BE49-F238E27FC236}">
-                <a16:creationId xmlns:a16="http://schemas.microsoft.com/office/drawing/2014/main" id="{3464207F-7F6A-42DF-9D1B-B3863CF70B81}"/>
+                <a16:creationId xmlns:a16="http://schemas.microsoft.com/office/drawing/2014/main" id="{A553F659-FA28-4C55-9E01-5AE2B0E40923}"/>
               </a:ext>
             </a:extLst>
           </p:cNvPr>
@@ -6458,7 +6458,7 @@
           <p:cNvPr id="5" name="">
             <a:extLst xmlns:a="http://schemas.openxmlformats.org/drawingml/2006/main">
               <a:ext uri="{FF2B5EF4-FFF2-40B4-BE49-F238E27FC236}">
-                <a16:creationId xmlns:a16="http://schemas.microsoft.com/office/drawing/2014/main" id="{E99FE2B9-9C0B-4312-8AF5-FDFFB8454DD1}"/>
+                <a16:creationId xmlns:a16="http://schemas.microsoft.com/office/drawing/2014/main" id="{09CA7695-5F37-489F-A972-C0889F3734E3}"/>
               </a:ext>
             </a:extLst>
           </p:cNvPr>
@@ -6503,7 +6503,7 @@
           <p:cNvPr id="6" name="">
             <a:extLst xmlns:a="http://schemas.openxmlformats.org/drawingml/2006/main">
               <a:ext uri="{FF2B5EF4-FFF2-40B4-BE49-F238E27FC236}">
-                <a16:creationId xmlns:a16="http://schemas.microsoft.com/office/drawing/2014/main" id="{3BFB049B-49BE-44A6-A21C-D8076A36EEB7}"/>
+                <a16:creationId xmlns:a16="http://schemas.microsoft.com/office/drawing/2014/main" id="{A12D888C-DCF8-4D1E-B336-92A43F551E78}"/>
               </a:ext>
             </a:extLst>
           </p:cNvPr>
@@ -6548,7 +6548,7 @@
           <p:cNvPr id="7" name="">
             <a:extLst xmlns:a="http://schemas.openxmlformats.org/drawingml/2006/main">
               <a:ext uri="{FF2B5EF4-FFF2-40B4-BE49-F238E27FC236}">
-                <a16:creationId xmlns:a16="http://schemas.microsoft.com/office/drawing/2014/main" id="{99018BDD-DCD3-46DC-9F5D-9E7780D8F9E3}"/>
+                <a16:creationId xmlns:a16="http://schemas.microsoft.com/office/drawing/2014/main" id="{219AED1A-B7BC-4AE0-9D4F-D80E273D466C}"/>
               </a:ext>
             </a:extLst>
           </p:cNvPr>
@@ -6593,7 +6593,7 @@
           <p:cNvPr id="8" name="">
             <a:extLst xmlns:a="http://schemas.openxmlformats.org/drawingml/2006/main">
               <a:ext uri="{FF2B5EF4-FFF2-40B4-BE49-F238E27FC236}">
-                <a16:creationId xmlns:a16="http://schemas.microsoft.com/office/drawing/2014/main" id="{3E0D8FDF-EE11-4019-835C-666FD42B24AB}"/>
+                <a16:creationId xmlns:a16="http://schemas.microsoft.com/office/drawing/2014/main" id="{1091E37A-F5E5-42C2-B2C6-C5E5D87706EE}"/>
               </a:ext>
             </a:extLst>
           </p:cNvPr>
@@ -6638,7 +6638,7 @@
           <p:cNvPr id="9" name="">
             <a:extLst xmlns:a="http://schemas.openxmlformats.org/drawingml/2006/main">
               <a:ext uri="{FF2B5EF4-FFF2-40B4-BE49-F238E27FC236}">
-                <a16:creationId xmlns:a16="http://schemas.microsoft.com/office/drawing/2014/main" id="{E6C4DF87-FC04-44BB-A7F4-FB9B76FD6A11}"/>
+                <a16:creationId xmlns:a16="http://schemas.microsoft.com/office/drawing/2014/main" id="{B2DDDF2F-104F-4869-BF66-2B9C6297C8AF}"/>
               </a:ext>
             </a:extLst>
           </p:cNvPr>
@@ -6683,7 +6683,7 @@
           <p:cNvPr id="10" name="">
             <a:extLst xmlns:a="http://schemas.openxmlformats.org/drawingml/2006/main">
               <a:ext uri="{FF2B5EF4-FFF2-40B4-BE49-F238E27FC236}">
-                <a16:creationId xmlns:a16="http://schemas.microsoft.com/office/drawing/2014/main" id="{7BAD381B-9CC7-454C-B5F2-F8FA5160D322}"/>
+                <a16:creationId xmlns:a16="http://schemas.microsoft.com/office/drawing/2014/main" id="{08866ADE-DE2C-47FD-A4A6-9A0571123B30}"/>
               </a:ext>
             </a:extLst>
           </p:cNvPr>
@@ -6728,7 +6728,7 @@
           <p:cNvPr id="11" name="">
             <a:extLst xmlns:a="http://schemas.openxmlformats.org/drawingml/2006/main">
               <a:ext uri="{FF2B5EF4-FFF2-40B4-BE49-F238E27FC236}">
-                <a16:creationId xmlns:a16="http://schemas.microsoft.com/office/drawing/2014/main" id="{F9B67D0A-8E1C-45D1-8983-F3639B0DBEF4}"/>
+                <a16:creationId xmlns:a16="http://schemas.microsoft.com/office/drawing/2014/main" id="{58193A04-3306-4F16-8CB9-74C39BBEFFF0}"/>
               </a:ext>
             </a:extLst>
           </p:cNvPr>
@@ -6773,7 +6773,7 @@
           <p:cNvPr id="12" name="">
             <a:extLst xmlns:a="http://schemas.openxmlformats.org/drawingml/2006/main">
               <a:ext uri="{FF2B5EF4-FFF2-40B4-BE49-F238E27FC236}">
-                <a16:creationId xmlns:a16="http://schemas.microsoft.com/office/drawing/2014/main" id="{E955BD7F-27A0-4B7A-B8DC-653CF6D46A8A}"/>
+                <a16:creationId xmlns:a16="http://schemas.microsoft.com/office/drawing/2014/main" id="{178D30ED-771A-41FA-AE74-2A069625C8DB}"/>
               </a:ext>
             </a:extLst>
           </p:cNvPr>
@@ -6818,7 +6818,7 @@
           <p:cNvPr id="13" name="">
             <a:extLst xmlns:a="http://schemas.openxmlformats.org/drawingml/2006/main">
               <a:ext uri="{FF2B5EF4-FFF2-40B4-BE49-F238E27FC236}">
-                <a16:creationId xmlns:a16="http://schemas.microsoft.com/office/drawing/2014/main" id="{2824DDBE-EFB8-4DC9-A8FD-B4F4FE98BBA6}"/>
+                <a16:creationId xmlns:a16="http://schemas.microsoft.com/office/drawing/2014/main" id="{46EBE61F-44BC-4765-8EEB-996EBC86EE4E}"/>
               </a:ext>
             </a:extLst>
           </p:cNvPr>
@@ -6863,7 +6863,7 @@
           <p:cNvPr id="14" name="">
             <a:extLst xmlns:a="http://schemas.openxmlformats.org/drawingml/2006/main">
               <a:ext uri="{FF2B5EF4-FFF2-40B4-BE49-F238E27FC236}">
-                <a16:creationId xmlns:a16="http://schemas.microsoft.com/office/drawing/2014/main" id="{9BC35673-2A91-42E4-B77D-DE798E7D28AF}"/>
+                <a16:creationId xmlns:a16="http://schemas.microsoft.com/office/drawing/2014/main" id="{17A7595F-8BB7-470F-9AA6-6E69C666EA27}"/>
               </a:ext>
             </a:extLst>
           </p:cNvPr>
@@ -6908,7 +6908,7 @@
           <p:cNvPr id="15" name="footer-left">
             <a:extLst xmlns:a="http://schemas.openxmlformats.org/drawingml/2006/main">
               <a:ext uri="{FF2B5EF4-FFF2-40B4-BE49-F238E27FC236}">
-                <a16:creationId xmlns:a16="http://schemas.microsoft.com/office/drawing/2014/main" id="{B9CC0C1B-7ADA-4E42-8194-6B5AC8548832}"/>
+                <a16:creationId xmlns:a16="http://schemas.microsoft.com/office/drawing/2014/main" id="{284E4415-AF0D-43E3-9C84-2D2642CC9A18}"/>
               </a:ext>
             </a:extLst>
           </p:cNvPr>
@@ -6953,7 +6953,7 @@
           <p:cNvPr id="16" name="footer-right">
             <a:extLst xmlns:a="http://schemas.openxmlformats.org/drawingml/2006/main">
               <a:ext uri="{FF2B5EF4-FFF2-40B4-BE49-F238E27FC236}">
-                <a16:creationId xmlns:a16="http://schemas.microsoft.com/office/drawing/2014/main" id="{496CB121-DC58-4191-A554-BBCF813C1BC7}"/>
+                <a16:creationId xmlns:a16="http://schemas.microsoft.com/office/drawing/2014/main" id="{3C4123BE-CC86-489C-BAEF-3AFB2B70DD7D}"/>
               </a:ext>
             </a:extLst>
           </p:cNvPr>
@@ -6996,7 +6996,7 @@
     </p:spTree>
     <p:extLst>
       <p:ext uri="{BB962C8B-B14F-4D97-AF65-F5344CB8AC3E}">
-        <p14:creationId xmlns:p14="http://schemas.microsoft.com/office/powerpoint/2010/main" val="214195747"/>
+        <p14:creationId xmlns:p14="http://schemas.microsoft.com/office/powerpoint/2010/main" val="1504003896"/>
       </p:ext>
     </p:extLst>
   </p:cSld>
@@ -7020,7 +7020,7 @@
           <p:cNvPr id="1" name="slide-stage">
             <a:extLst xmlns:a="http://schemas.openxmlformats.org/drawingml/2006/main">
               <a:ext uri="{FF2B5EF4-FFF2-40B4-BE49-F238E27FC236}">
-                <a16:creationId xmlns:a16="http://schemas.microsoft.com/office/drawing/2014/main" id="{D3A36964-BA17-4B9B-8A99-B95DA872ED53}"/>
+                <a16:creationId xmlns:a16="http://schemas.microsoft.com/office/drawing/2014/main" id="{78FBE7CF-144D-438E-90AC-43DB122CBFF7}"/>
               </a:ext>
             </a:extLst>
           </p:cNvPr>
@@ -7047,7 +7047,7 @@
           <p:cNvPr id="2" name="eyebrow">
             <a:extLst xmlns:a="http://schemas.openxmlformats.org/drawingml/2006/main">
               <a:ext uri="{FF2B5EF4-FFF2-40B4-BE49-F238E27FC236}">
-                <a16:creationId xmlns:a16="http://schemas.microsoft.com/office/drawing/2014/main" id="{9A479237-145A-4139-A032-96FA6917AF78}"/>
+                <a16:creationId xmlns:a16="http://schemas.microsoft.com/office/drawing/2014/main" id="{AC23FFB6-3662-469B-80DA-842ABD3586D9}"/>
               </a:ext>
             </a:extLst>
           </p:cNvPr>
@@ -7092,7 +7092,7 @@
           <p:cNvPr id="3" name="slide-title">
             <a:extLst xmlns:a="http://schemas.openxmlformats.org/drawingml/2006/main">
               <a:ext uri="{FF2B5EF4-FFF2-40B4-BE49-F238E27FC236}">
-                <a16:creationId xmlns:a16="http://schemas.microsoft.com/office/drawing/2014/main" id="{A9734C72-CC72-452D-BA87-7AB09EE9BEB7}"/>
+                <a16:creationId xmlns:a16="http://schemas.microsoft.com/office/drawing/2014/main" id="{46FABA02-C9D1-46F7-AE08-A7BA9C2193EE}"/>
               </a:ext>
             </a:extLst>
           </p:cNvPr>
@@ -7137,7 +7137,7 @@
           <p:cNvPr id="4" name="slide-subtitle">
             <a:extLst xmlns:a="http://schemas.openxmlformats.org/drawingml/2006/main">
               <a:ext uri="{FF2B5EF4-FFF2-40B4-BE49-F238E27FC236}">
-                <a16:creationId xmlns:a16="http://schemas.microsoft.com/office/drawing/2014/main" id="{91C1F130-342B-4A72-BFB2-A0CE41DDF7C7}"/>
+                <a16:creationId xmlns:a16="http://schemas.microsoft.com/office/drawing/2014/main" id="{1B0294F3-D91C-42FC-BA4E-2B99606A9D49}"/>
               </a:ext>
             </a:extLst>
           </p:cNvPr>
@@ -7182,7 +7182,7 @@
           <p:cNvPr id="5" name="">
             <a:extLst xmlns:a="http://schemas.openxmlformats.org/drawingml/2006/main">
               <a:ext uri="{FF2B5EF4-FFF2-40B4-BE49-F238E27FC236}">
-                <a16:creationId xmlns:a16="http://schemas.microsoft.com/office/drawing/2014/main" id="{232785A1-E073-4B94-AF7D-791143AD25D0}"/>
+                <a16:creationId xmlns:a16="http://schemas.microsoft.com/office/drawing/2014/main" id="{58848915-5038-4AFF-8C2A-7AEDE1D4C148}"/>
               </a:ext>
             </a:extLst>
           </p:cNvPr>
@@ -7215,7 +7215,7 @@
           <p:cNvPr id="6" name="">
             <a:extLst xmlns:a="http://schemas.openxmlformats.org/drawingml/2006/main">
               <a:ext uri="{FF2B5EF4-FFF2-40B4-BE49-F238E27FC236}">
-                <a16:creationId xmlns:a16="http://schemas.microsoft.com/office/drawing/2014/main" id="{DEEFE5BE-5EC6-4E50-BC5D-BB9F93B1E281}"/>
+                <a16:creationId xmlns:a16="http://schemas.microsoft.com/office/drawing/2014/main" id="{355244D4-7E01-42E6-8F39-08AEF8208275}"/>
               </a:ext>
             </a:extLst>
           </p:cNvPr>
@@ -7260,7 +7260,7 @@
           <p:cNvPr id="7" name="">
             <a:extLst xmlns:a="http://schemas.openxmlformats.org/drawingml/2006/main">
               <a:ext uri="{FF2B5EF4-FFF2-40B4-BE49-F238E27FC236}">
-                <a16:creationId xmlns:a16="http://schemas.microsoft.com/office/drawing/2014/main" id="{90A42005-09E2-4960-9044-18EB86587CE8}"/>
+                <a16:creationId xmlns:a16="http://schemas.microsoft.com/office/drawing/2014/main" id="{35A5F741-34EA-4F8F-93DE-7E0501934B7F}"/>
               </a:ext>
             </a:extLst>
           </p:cNvPr>
@@ -7305,7 +7305,7 @@
           <p:cNvPr id="8" name="">
             <a:extLst xmlns:a="http://schemas.openxmlformats.org/drawingml/2006/main">
               <a:ext uri="{FF2B5EF4-FFF2-40B4-BE49-F238E27FC236}">
-                <a16:creationId xmlns:a16="http://schemas.microsoft.com/office/drawing/2014/main" id="{F329832F-1736-4A47-AD8C-326DD48DA405}"/>
+                <a16:creationId xmlns:a16="http://schemas.microsoft.com/office/drawing/2014/main" id="{5B3E8FB9-0CCC-4B30-A0C4-6CAF6B16FDBB}"/>
               </a:ext>
             </a:extLst>
           </p:cNvPr>
@@ -7338,7 +7338,7 @@
           <p:cNvPr id="9" name="">
             <a:extLst xmlns:a="http://schemas.openxmlformats.org/drawingml/2006/main">
               <a:ext uri="{FF2B5EF4-FFF2-40B4-BE49-F238E27FC236}">
-                <a16:creationId xmlns:a16="http://schemas.microsoft.com/office/drawing/2014/main" id="{AF858176-B8C3-4B59-A03B-9417768A98F1}"/>
+                <a16:creationId xmlns:a16="http://schemas.microsoft.com/office/drawing/2014/main" id="{C24949A4-19B3-46DE-BA45-FFDA588711DD}"/>
               </a:ext>
             </a:extLst>
           </p:cNvPr>
@@ -7383,7 +7383,7 @@
           <p:cNvPr id="10" name="">
             <a:extLst xmlns:a="http://schemas.openxmlformats.org/drawingml/2006/main">
               <a:ext uri="{FF2B5EF4-FFF2-40B4-BE49-F238E27FC236}">
-                <a16:creationId xmlns:a16="http://schemas.microsoft.com/office/drawing/2014/main" id="{78425D6C-44D8-42E7-8957-B32DE3447971}"/>
+                <a16:creationId xmlns:a16="http://schemas.microsoft.com/office/drawing/2014/main" id="{4CC5D729-8FE5-4466-977F-AF8683F2635A}"/>
               </a:ext>
             </a:extLst>
           </p:cNvPr>
@@ -7428,7 +7428,7 @@
           <p:cNvPr id="11" name="">
             <a:extLst xmlns:a="http://schemas.openxmlformats.org/drawingml/2006/main">
               <a:ext uri="{FF2B5EF4-FFF2-40B4-BE49-F238E27FC236}">
-                <a16:creationId xmlns:a16="http://schemas.microsoft.com/office/drawing/2014/main" id="{3B33EF55-F454-4CA2-AE4C-EABEE3001F56}"/>
+                <a16:creationId xmlns:a16="http://schemas.microsoft.com/office/drawing/2014/main" id="{AB834136-7AA4-45E0-B0E8-3567D7EC128D}"/>
               </a:ext>
             </a:extLst>
           </p:cNvPr>
@@ -7461,7 +7461,7 @@
           <p:cNvPr id="12" name="">
             <a:extLst xmlns:a="http://schemas.openxmlformats.org/drawingml/2006/main">
               <a:ext uri="{FF2B5EF4-FFF2-40B4-BE49-F238E27FC236}">
-                <a16:creationId xmlns:a16="http://schemas.microsoft.com/office/drawing/2014/main" id="{C6682B61-DB3B-4DF8-9DAD-01BCF1C41A93}"/>
+                <a16:creationId xmlns:a16="http://schemas.microsoft.com/office/drawing/2014/main" id="{83BD82D7-B5EE-4373-9B1D-5730C5CF4BF6}"/>
               </a:ext>
             </a:extLst>
           </p:cNvPr>
@@ -7506,7 +7506,7 @@
           <p:cNvPr id="13" name="">
             <a:extLst xmlns:a="http://schemas.openxmlformats.org/drawingml/2006/main">
               <a:ext uri="{FF2B5EF4-FFF2-40B4-BE49-F238E27FC236}">
-                <a16:creationId xmlns:a16="http://schemas.microsoft.com/office/drawing/2014/main" id="{CECCC668-F8D9-48B4-9868-166802953844}"/>
+                <a16:creationId xmlns:a16="http://schemas.microsoft.com/office/drawing/2014/main" id="{6CEBDCDB-0753-42AF-BF64-498F3BC1CB40}"/>
               </a:ext>
             </a:extLst>
           </p:cNvPr>
@@ -7551,7 +7551,7 @@
           <p:cNvPr id="14" name="">
             <a:extLst xmlns:a="http://schemas.openxmlformats.org/drawingml/2006/main">
               <a:ext uri="{FF2B5EF4-FFF2-40B4-BE49-F238E27FC236}">
-                <a16:creationId xmlns:a16="http://schemas.microsoft.com/office/drawing/2014/main" id="{E65DFA59-9318-45A4-94B9-3586A94D41D4}"/>
+                <a16:creationId xmlns:a16="http://schemas.microsoft.com/office/drawing/2014/main" id="{7B8184D5-5880-4AB4-86D8-70FEC6B87C99}"/>
               </a:ext>
             </a:extLst>
           </p:cNvPr>
@@ -7584,7 +7584,7 @@
           <p:cNvPr id="15" name="">
             <a:extLst xmlns:a="http://schemas.openxmlformats.org/drawingml/2006/main">
               <a:ext uri="{FF2B5EF4-FFF2-40B4-BE49-F238E27FC236}">
-                <a16:creationId xmlns:a16="http://schemas.microsoft.com/office/drawing/2014/main" id="{3F1AD242-FEDC-4114-86C3-FF6B14599A0F}"/>
+                <a16:creationId xmlns:a16="http://schemas.microsoft.com/office/drawing/2014/main" id="{C8B1B527-31C5-4F90-BEFC-0F06664B277E}"/>
               </a:ext>
             </a:extLst>
           </p:cNvPr>
@@ -7629,7 +7629,7 @@
           <p:cNvPr id="16" name="">
             <a:extLst xmlns:a="http://schemas.openxmlformats.org/drawingml/2006/main">
               <a:ext uri="{FF2B5EF4-FFF2-40B4-BE49-F238E27FC236}">
-                <a16:creationId xmlns:a16="http://schemas.microsoft.com/office/drawing/2014/main" id="{4F6FF959-7B3A-411A-872D-CB26B6168444}"/>
+                <a16:creationId xmlns:a16="http://schemas.microsoft.com/office/drawing/2014/main" id="{05CB6AF5-6337-4E8B-AB91-9CB0FFEAD9B1}"/>
               </a:ext>
             </a:extLst>
           </p:cNvPr>
@@ -7674,7 +7674,7 @@
           <p:cNvPr id="17" name="footer-left">
             <a:extLst xmlns:a="http://schemas.openxmlformats.org/drawingml/2006/main">
               <a:ext uri="{FF2B5EF4-FFF2-40B4-BE49-F238E27FC236}">
-                <a16:creationId xmlns:a16="http://schemas.microsoft.com/office/drawing/2014/main" id="{2ABE6EC4-21B8-4F28-8B29-68DCB8859C36}"/>
+                <a16:creationId xmlns:a16="http://schemas.microsoft.com/office/drawing/2014/main" id="{2B715287-C38A-4564-AF89-ADE0B019B7DD}"/>
               </a:ext>
             </a:extLst>
           </p:cNvPr>
@@ -7719,7 +7719,7 @@
           <p:cNvPr id="18" name="footer-right">
             <a:extLst xmlns:a="http://schemas.openxmlformats.org/drawingml/2006/main">
               <a:ext uri="{FF2B5EF4-FFF2-40B4-BE49-F238E27FC236}">
-                <a16:creationId xmlns:a16="http://schemas.microsoft.com/office/drawing/2014/main" id="{0E26B2A4-7E1D-4D53-89F4-8F0BE9EB994D}"/>
+                <a16:creationId xmlns:a16="http://schemas.microsoft.com/office/drawing/2014/main" id="{1922C7D2-E0B3-40B1-BC03-8CA6F312DD1E}"/>
               </a:ext>
             </a:extLst>
           </p:cNvPr>
@@ -7762,7 +7762,7 @@
     </p:spTree>
     <p:extLst>
       <p:ext uri="{BB962C8B-B14F-4D97-AF65-F5344CB8AC3E}">
-        <p14:creationId xmlns:p14="http://schemas.microsoft.com/office/powerpoint/2010/main" val="1788062789"/>
+        <p14:creationId xmlns:p14="http://schemas.microsoft.com/office/powerpoint/2010/main" val="1466779401"/>
       </p:ext>
     </p:extLst>
   </p:cSld>
@@ -7786,7 +7786,7 @@
           <p:cNvPr id="1" name="slide-stage">
             <a:extLst xmlns:a="http://schemas.openxmlformats.org/drawingml/2006/main">
               <a:ext uri="{FF2B5EF4-FFF2-40B4-BE49-F238E27FC236}">
-                <a16:creationId xmlns:a16="http://schemas.microsoft.com/office/drawing/2014/main" id="{ED21964A-DAEE-4CB1-9788-25FE37CC2906}"/>
+                <a16:creationId xmlns:a16="http://schemas.microsoft.com/office/drawing/2014/main" id="{17C97D96-0950-40B7-9AD5-D3BDC2155186}"/>
               </a:ext>
             </a:extLst>
           </p:cNvPr>
@@ -7813,7 +7813,7 @@
           <p:cNvPr id="2" name="eyebrow">
             <a:extLst xmlns:a="http://schemas.openxmlformats.org/drawingml/2006/main">
               <a:ext uri="{FF2B5EF4-FFF2-40B4-BE49-F238E27FC236}">
-                <a16:creationId xmlns:a16="http://schemas.microsoft.com/office/drawing/2014/main" id="{FBE89112-E508-4997-9A7D-B9EE4223A97F}"/>
+                <a16:creationId xmlns:a16="http://schemas.microsoft.com/office/drawing/2014/main" id="{2F8467A5-0ED7-4E37-B637-A006386502E5}"/>
               </a:ext>
             </a:extLst>
           </p:cNvPr>
@@ -7858,7 +7858,7 @@
           <p:cNvPr id="3" name="slide-title">
             <a:extLst xmlns:a="http://schemas.openxmlformats.org/drawingml/2006/main">
               <a:ext uri="{FF2B5EF4-FFF2-40B4-BE49-F238E27FC236}">
-                <a16:creationId xmlns:a16="http://schemas.microsoft.com/office/drawing/2014/main" id="{E19E867B-B0A8-4671-8F6A-02B1A85841B8}"/>
+                <a16:creationId xmlns:a16="http://schemas.microsoft.com/office/drawing/2014/main" id="{5843E03C-6B2A-44DE-99E4-40FD1C0FBEA3}"/>
               </a:ext>
             </a:extLst>
           </p:cNvPr>
@@ -7903,7 +7903,7 @@
           <p:cNvPr id="4" name="slide-subtitle">
             <a:extLst xmlns:a="http://schemas.openxmlformats.org/drawingml/2006/main">
               <a:ext uri="{FF2B5EF4-FFF2-40B4-BE49-F238E27FC236}">
-                <a16:creationId xmlns:a16="http://schemas.microsoft.com/office/drawing/2014/main" id="{2E242730-135C-48E1-951D-E1FE5537D9CE}"/>
+                <a16:creationId xmlns:a16="http://schemas.microsoft.com/office/drawing/2014/main" id="{E14CC5B3-1750-4D0E-96FA-5898698B2392}"/>
               </a:ext>
             </a:extLst>
           </p:cNvPr>
@@ -7948,7 +7948,7 @@
           <p:cNvPr id="5" name="">
             <a:extLst xmlns:a="http://schemas.openxmlformats.org/drawingml/2006/main">
               <a:ext uri="{FF2B5EF4-FFF2-40B4-BE49-F238E27FC236}">
-                <a16:creationId xmlns:a16="http://schemas.microsoft.com/office/drawing/2014/main" id="{747DA5F9-52BD-480E-A254-E30011EC65B5}"/>
+                <a16:creationId xmlns:a16="http://schemas.microsoft.com/office/drawing/2014/main" id="{37680CDB-DC6E-413E-99B1-49B8E77D51D4}"/>
               </a:ext>
             </a:extLst>
           </p:cNvPr>
@@ -7993,7 +7993,7 @@
           <p:cNvPr id="6" name="">
             <a:extLst xmlns:a="http://schemas.openxmlformats.org/drawingml/2006/main">
               <a:ext uri="{FF2B5EF4-FFF2-40B4-BE49-F238E27FC236}">
-                <a16:creationId xmlns:a16="http://schemas.microsoft.com/office/drawing/2014/main" id="{B1AAAC48-4F95-4D5D-A96B-2FCB5EDD39BA}"/>
+                <a16:creationId xmlns:a16="http://schemas.microsoft.com/office/drawing/2014/main" id="{0B171333-4B2C-4763-B07C-DA7B61BB9737}"/>
               </a:ext>
             </a:extLst>
           </p:cNvPr>
@@ -8038,7 +8038,7 @@
           <p:cNvPr id="7" name="">
             <a:extLst xmlns:a="http://schemas.openxmlformats.org/drawingml/2006/main">
               <a:ext uri="{FF2B5EF4-FFF2-40B4-BE49-F238E27FC236}">
-                <a16:creationId xmlns:a16="http://schemas.microsoft.com/office/drawing/2014/main" id="{2E3A6934-D75D-4A41-8990-936DC55A35AC}"/>
+                <a16:creationId xmlns:a16="http://schemas.microsoft.com/office/drawing/2014/main" id="{A55A225B-2D40-4C2B-A127-94EE7AA18A19}"/>
               </a:ext>
             </a:extLst>
           </p:cNvPr>
@@ -8071,7 +8071,7 @@
           <p:cNvPr id="8" name="">
             <a:extLst xmlns:a="http://schemas.openxmlformats.org/drawingml/2006/main">
               <a:ext uri="{FF2B5EF4-FFF2-40B4-BE49-F238E27FC236}">
-                <a16:creationId xmlns:a16="http://schemas.microsoft.com/office/drawing/2014/main" id="{AB6C440C-0EA5-4D16-B336-AABCC2B754F7}"/>
+                <a16:creationId xmlns:a16="http://schemas.microsoft.com/office/drawing/2014/main" id="{21619DE8-E603-4D6D-9E03-637B286BBCC9}"/>
               </a:ext>
             </a:extLst>
           </p:cNvPr>
@@ -8116,7 +8116,7 @@
           <p:cNvPr id="9" name="">
             <a:extLst xmlns:a="http://schemas.openxmlformats.org/drawingml/2006/main">
               <a:ext uri="{FF2B5EF4-FFF2-40B4-BE49-F238E27FC236}">
-                <a16:creationId xmlns:a16="http://schemas.microsoft.com/office/drawing/2014/main" id="{06E79F71-87E9-438D-97E4-F25EA331AB63}"/>
+                <a16:creationId xmlns:a16="http://schemas.microsoft.com/office/drawing/2014/main" id="{7063B47C-00F2-4824-B99F-6B8EEE94E02D}"/>
               </a:ext>
             </a:extLst>
           </p:cNvPr>
@@ -8161,7 +8161,7 @@
           <p:cNvPr id="10" name="">
             <a:extLst xmlns:a="http://schemas.openxmlformats.org/drawingml/2006/main">
               <a:ext uri="{FF2B5EF4-FFF2-40B4-BE49-F238E27FC236}">
-                <a16:creationId xmlns:a16="http://schemas.microsoft.com/office/drawing/2014/main" id="{D33DEA02-A80A-4FC4-BA99-5275F10FCB64}"/>
+                <a16:creationId xmlns:a16="http://schemas.microsoft.com/office/drawing/2014/main" id="{5DA03796-22D5-42CD-BDAF-E24D8F94419B}"/>
               </a:ext>
             </a:extLst>
           </p:cNvPr>
@@ -8194,7 +8194,7 @@
           <p:cNvPr id="11" name="">
             <a:extLst xmlns:a="http://schemas.openxmlformats.org/drawingml/2006/main">
               <a:ext uri="{FF2B5EF4-FFF2-40B4-BE49-F238E27FC236}">
-                <a16:creationId xmlns:a16="http://schemas.microsoft.com/office/drawing/2014/main" id="{D58A8D69-50F3-4B61-88DC-BEA5AEF8F7BB}"/>
+                <a16:creationId xmlns:a16="http://schemas.microsoft.com/office/drawing/2014/main" id="{7553F657-43BB-4376-8DAF-03C0399EE474}"/>
               </a:ext>
             </a:extLst>
           </p:cNvPr>
@@ -8239,7 +8239,7 @@
           <p:cNvPr id="12" name="">
             <a:extLst xmlns:a="http://schemas.openxmlformats.org/drawingml/2006/main">
               <a:ext uri="{FF2B5EF4-FFF2-40B4-BE49-F238E27FC236}">
-                <a16:creationId xmlns:a16="http://schemas.microsoft.com/office/drawing/2014/main" id="{745A114A-7F86-4684-8CBA-F775786E7FE5}"/>
+                <a16:creationId xmlns:a16="http://schemas.microsoft.com/office/drawing/2014/main" id="{97210712-5CEB-407E-BFF2-A3E87D68045B}"/>
               </a:ext>
             </a:extLst>
           </p:cNvPr>
@@ -8284,7 +8284,7 @@
           <p:cNvPr id="13" name="">
             <a:extLst xmlns:a="http://schemas.openxmlformats.org/drawingml/2006/main">
               <a:ext uri="{FF2B5EF4-FFF2-40B4-BE49-F238E27FC236}">
-                <a16:creationId xmlns:a16="http://schemas.microsoft.com/office/drawing/2014/main" id="{1BA383DF-72B9-46FE-96B4-FD1EBA2F2375}"/>
+                <a16:creationId xmlns:a16="http://schemas.microsoft.com/office/drawing/2014/main" id="{566B6D24-3799-4CD4-B6E2-C202D5E130D7}"/>
               </a:ext>
             </a:extLst>
           </p:cNvPr>
@@ -8317,7 +8317,7 @@
           <p:cNvPr id="14" name="">
             <a:extLst xmlns:a="http://schemas.openxmlformats.org/drawingml/2006/main">
               <a:ext uri="{FF2B5EF4-FFF2-40B4-BE49-F238E27FC236}">
-                <a16:creationId xmlns:a16="http://schemas.microsoft.com/office/drawing/2014/main" id="{5AD708AB-1D58-4503-994C-07E747575402}"/>
+                <a16:creationId xmlns:a16="http://schemas.microsoft.com/office/drawing/2014/main" id="{18315B27-BBCB-49B3-9E85-30290F46DD93}"/>
               </a:ext>
             </a:extLst>
           </p:cNvPr>
@@ -8362,7 +8362,7 @@
           <p:cNvPr id="15" name="">
             <a:extLst xmlns:a="http://schemas.openxmlformats.org/drawingml/2006/main">
               <a:ext uri="{FF2B5EF4-FFF2-40B4-BE49-F238E27FC236}">
-                <a16:creationId xmlns:a16="http://schemas.microsoft.com/office/drawing/2014/main" id="{3B8623D9-4B36-4399-9E9C-8D7D7AC925D0}"/>
+                <a16:creationId xmlns:a16="http://schemas.microsoft.com/office/drawing/2014/main" id="{E59D4E65-AC57-4AB4-AF61-AA63EADC5073}"/>
               </a:ext>
             </a:extLst>
           </p:cNvPr>
@@ -8407,7 +8407,7 @@
           <p:cNvPr id="16" name="footer-left">
             <a:extLst xmlns:a="http://schemas.openxmlformats.org/drawingml/2006/main">
               <a:ext uri="{FF2B5EF4-FFF2-40B4-BE49-F238E27FC236}">
-                <a16:creationId xmlns:a16="http://schemas.microsoft.com/office/drawing/2014/main" id="{16821C1A-ED55-4BF6-AFFC-EFD86321EA9A}"/>
+                <a16:creationId xmlns:a16="http://schemas.microsoft.com/office/drawing/2014/main" id="{D6D56CB5-EBA6-445E-92B5-A095BD3B46F2}"/>
               </a:ext>
             </a:extLst>
           </p:cNvPr>
@@ -8452,7 +8452,7 @@
           <p:cNvPr id="17" name="footer-right">
             <a:extLst xmlns:a="http://schemas.openxmlformats.org/drawingml/2006/main">
               <a:ext uri="{FF2B5EF4-FFF2-40B4-BE49-F238E27FC236}">
-                <a16:creationId xmlns:a16="http://schemas.microsoft.com/office/drawing/2014/main" id="{E8354CCD-43F4-47CD-9192-F5DF84E5678C}"/>
+                <a16:creationId xmlns:a16="http://schemas.microsoft.com/office/drawing/2014/main" id="{FD6A1172-4E7F-4415-98D9-A96544E5F961}"/>
               </a:ext>
             </a:extLst>
           </p:cNvPr>
@@ -8495,7 +8495,7 @@
     </p:spTree>
     <p:extLst>
       <p:ext uri="{BB962C8B-B14F-4D97-AF65-F5344CB8AC3E}">
-        <p14:creationId xmlns:p14="http://schemas.microsoft.com/office/powerpoint/2010/main" val="571617672"/>
+        <p14:creationId xmlns:p14="http://schemas.microsoft.com/office/powerpoint/2010/main" val="1123800418"/>
       </p:ext>
     </p:extLst>
   </p:cSld>
@@ -8519,7 +8519,7 @@
           <p:cNvPr id="1" name="slide-stage">
             <a:extLst xmlns:a="http://schemas.openxmlformats.org/drawingml/2006/main">
               <a:ext uri="{FF2B5EF4-FFF2-40B4-BE49-F238E27FC236}">
-                <a16:creationId xmlns:a16="http://schemas.microsoft.com/office/drawing/2014/main" id="{02D79C33-60E6-42C0-93DC-F79EF3869EC6}"/>
+                <a16:creationId xmlns:a16="http://schemas.microsoft.com/office/drawing/2014/main" id="{29896C42-185A-4AC8-AC02-62116B53F270}"/>
               </a:ext>
             </a:extLst>
           </p:cNvPr>
@@ -8546,7 +8546,7 @@
           <p:cNvPr id="2" name="eyebrow">
             <a:extLst xmlns:a="http://schemas.openxmlformats.org/drawingml/2006/main">
               <a:ext uri="{FF2B5EF4-FFF2-40B4-BE49-F238E27FC236}">
-                <a16:creationId xmlns:a16="http://schemas.microsoft.com/office/drawing/2014/main" id="{3E359896-1D04-4BBD-8193-98107D443C86}"/>
+                <a16:creationId xmlns:a16="http://schemas.microsoft.com/office/drawing/2014/main" id="{4224ABAD-59E7-40C9-83F9-17BEDF4C7D90}"/>
               </a:ext>
             </a:extLst>
           </p:cNvPr>
@@ -8591,7 +8591,7 @@
           <p:cNvPr id="3" name="slide-title">
             <a:extLst xmlns:a="http://schemas.openxmlformats.org/drawingml/2006/main">
               <a:ext uri="{FF2B5EF4-FFF2-40B4-BE49-F238E27FC236}">
-                <a16:creationId xmlns:a16="http://schemas.microsoft.com/office/drawing/2014/main" id="{A52D3636-60EA-4A26-AEC7-8F9573920E43}"/>
+                <a16:creationId xmlns:a16="http://schemas.microsoft.com/office/drawing/2014/main" id="{2FDE2CFF-3066-474B-9AB9-30AF59702E0C}"/>
               </a:ext>
             </a:extLst>
           </p:cNvPr>
@@ -8636,7 +8636,7 @@
           <p:cNvPr id="4" name="slide-subtitle">
             <a:extLst xmlns:a="http://schemas.openxmlformats.org/drawingml/2006/main">
               <a:ext uri="{FF2B5EF4-FFF2-40B4-BE49-F238E27FC236}">
-                <a16:creationId xmlns:a16="http://schemas.microsoft.com/office/drawing/2014/main" id="{2E27E895-8A18-4BD7-B8BE-362046F7F2F2}"/>
+                <a16:creationId xmlns:a16="http://schemas.microsoft.com/office/drawing/2014/main" id="{956E82A8-F709-4299-A80D-DA07577AAC6E}"/>
               </a:ext>
             </a:extLst>
           </p:cNvPr>
@@ -8681,7 +8681,7 @@
           <p:cNvPr id="5" name="">
             <a:extLst xmlns:a="http://schemas.openxmlformats.org/drawingml/2006/main">
               <a:ext uri="{FF2B5EF4-FFF2-40B4-BE49-F238E27FC236}">
-                <a16:creationId xmlns:a16="http://schemas.microsoft.com/office/drawing/2014/main" id="{BF4ED067-4DE6-4BEA-A0C9-1209F2AC940A}"/>
+                <a16:creationId xmlns:a16="http://schemas.microsoft.com/office/drawing/2014/main" id="{A35CD549-E718-43AB-963B-71593DEF9476}"/>
               </a:ext>
             </a:extLst>
           </p:cNvPr>
@@ -8726,7 +8726,7 @@
           <p:cNvPr id="6" name="">
             <a:extLst xmlns:a="http://schemas.openxmlformats.org/drawingml/2006/main">
               <a:ext uri="{FF2B5EF4-FFF2-40B4-BE49-F238E27FC236}">
-                <a16:creationId xmlns:a16="http://schemas.microsoft.com/office/drawing/2014/main" id="{207222C9-CCB1-4854-B1F7-F0583340C3DC}"/>
+                <a16:creationId xmlns:a16="http://schemas.microsoft.com/office/drawing/2014/main" id="{1657CEF8-43A9-484F-A95D-02A158B7DB09}"/>
               </a:ext>
             </a:extLst>
           </p:cNvPr>
@@ -8771,7 +8771,7 @@
           <p:cNvPr id="7" name="">
             <a:extLst xmlns:a="http://schemas.openxmlformats.org/drawingml/2006/main">
               <a:ext uri="{FF2B5EF4-FFF2-40B4-BE49-F238E27FC236}">
-                <a16:creationId xmlns:a16="http://schemas.microsoft.com/office/drawing/2014/main" id="{829FDEA0-B59D-4129-B56C-DB15525C598D}"/>
+                <a16:creationId xmlns:a16="http://schemas.microsoft.com/office/drawing/2014/main" id="{608335D2-0D7E-4D2C-8568-858E7AE240EC}"/>
               </a:ext>
             </a:extLst>
           </p:cNvPr>
@@ -8816,7 +8816,7 @@
           <p:cNvPr id="8" name="">
             <a:extLst xmlns:a="http://schemas.openxmlformats.org/drawingml/2006/main">
               <a:ext uri="{FF2B5EF4-FFF2-40B4-BE49-F238E27FC236}">
-                <a16:creationId xmlns:a16="http://schemas.microsoft.com/office/drawing/2014/main" id="{3ACED55A-3189-4FA0-A8C9-9B2497500B11}"/>
+                <a16:creationId xmlns:a16="http://schemas.microsoft.com/office/drawing/2014/main" id="{370B5704-8BA4-4BB2-89BE-9DE0FF4BC353}"/>
               </a:ext>
             </a:extLst>
           </p:cNvPr>
@@ -8861,7 +8861,7 @@
           <p:cNvPr id="9" name="">
             <a:extLst xmlns:a="http://schemas.openxmlformats.org/drawingml/2006/main">
               <a:ext uri="{FF2B5EF4-FFF2-40B4-BE49-F238E27FC236}">
-                <a16:creationId xmlns:a16="http://schemas.microsoft.com/office/drawing/2014/main" id="{1D1FCAB7-6C22-40EC-8CCD-1BC21334BE07}"/>
+                <a16:creationId xmlns:a16="http://schemas.microsoft.com/office/drawing/2014/main" id="{BFAF74BC-6866-416B-8BA2-D2CE21E6A05F}"/>
               </a:ext>
             </a:extLst>
           </p:cNvPr>
@@ -8906,7 +8906,7 @@
           <p:cNvPr id="10" name="">
             <a:extLst xmlns:a="http://schemas.openxmlformats.org/drawingml/2006/main">
               <a:ext uri="{FF2B5EF4-FFF2-40B4-BE49-F238E27FC236}">
-                <a16:creationId xmlns:a16="http://schemas.microsoft.com/office/drawing/2014/main" id="{9DF5F706-BAFD-41CE-922F-0E65327F0583}"/>
+                <a16:creationId xmlns:a16="http://schemas.microsoft.com/office/drawing/2014/main" id="{D32A122A-7002-4A85-9BA1-972CF552EA65}"/>
               </a:ext>
             </a:extLst>
           </p:cNvPr>
@@ -8951,7 +8951,7 @@
           <p:cNvPr id="11" name="">
             <a:extLst xmlns:a="http://schemas.openxmlformats.org/drawingml/2006/main">
               <a:ext uri="{FF2B5EF4-FFF2-40B4-BE49-F238E27FC236}">
-                <a16:creationId xmlns:a16="http://schemas.microsoft.com/office/drawing/2014/main" id="{D72AFB62-6DBF-448E-88F8-C41EB78FE661}"/>
+                <a16:creationId xmlns:a16="http://schemas.microsoft.com/office/drawing/2014/main" id="{5A403386-D03C-4C59-BD33-6CBB28A6E579}"/>
               </a:ext>
             </a:extLst>
           </p:cNvPr>
@@ -8996,7 +8996,7 @@
           <p:cNvPr id="12" name="">
             <a:extLst xmlns:a="http://schemas.openxmlformats.org/drawingml/2006/main">
               <a:ext uri="{FF2B5EF4-FFF2-40B4-BE49-F238E27FC236}">
-                <a16:creationId xmlns:a16="http://schemas.microsoft.com/office/drawing/2014/main" id="{6A8B0232-A472-47B5-9D58-82F73F4E8DAC}"/>
+                <a16:creationId xmlns:a16="http://schemas.microsoft.com/office/drawing/2014/main" id="{C147EE26-E72B-4622-956A-344FBA2DE99C}"/>
               </a:ext>
             </a:extLst>
           </p:cNvPr>
@@ -9041,7 +9041,7 @@
           <p:cNvPr id="13" name="footer-left">
             <a:extLst xmlns:a="http://schemas.openxmlformats.org/drawingml/2006/main">
               <a:ext uri="{FF2B5EF4-FFF2-40B4-BE49-F238E27FC236}">
-                <a16:creationId xmlns:a16="http://schemas.microsoft.com/office/drawing/2014/main" id="{E3F4A5E9-0885-45B6-9A3B-07EACBB6BDCA}"/>
+                <a16:creationId xmlns:a16="http://schemas.microsoft.com/office/drawing/2014/main" id="{A413C38F-29B7-4A26-8F01-4CB32D095415}"/>
               </a:ext>
             </a:extLst>
           </p:cNvPr>
@@ -9086,7 +9086,7 @@
           <p:cNvPr id="14" name="footer-right">
             <a:extLst xmlns:a="http://schemas.openxmlformats.org/drawingml/2006/main">
               <a:ext uri="{FF2B5EF4-FFF2-40B4-BE49-F238E27FC236}">
-                <a16:creationId xmlns:a16="http://schemas.microsoft.com/office/drawing/2014/main" id="{AFCED534-B5EB-4912-90D9-8FECEA4CE469}"/>
+                <a16:creationId xmlns:a16="http://schemas.microsoft.com/office/drawing/2014/main" id="{A8BD07B1-1DF5-4DEE-BC5B-D62A321C8CFA}"/>
               </a:ext>
             </a:extLst>
           </p:cNvPr>
@@ -9129,7 +9129,7 @@
     </p:spTree>
     <p:extLst>
       <p:ext uri="{BB962C8B-B14F-4D97-AF65-F5344CB8AC3E}">
-        <p14:creationId xmlns:p14="http://schemas.microsoft.com/office/powerpoint/2010/main" val="83194210"/>
+        <p14:creationId xmlns:p14="http://schemas.microsoft.com/office/powerpoint/2010/main" val="472024529"/>
       </p:ext>
     </p:extLst>
   </p:cSld>
@@ -9153,7 +9153,7 @@
           <p:cNvPr id="1" name="slide-stage">
             <a:extLst xmlns:a="http://schemas.openxmlformats.org/drawingml/2006/main">
               <a:ext uri="{FF2B5EF4-FFF2-40B4-BE49-F238E27FC236}">
-                <a16:creationId xmlns:a16="http://schemas.microsoft.com/office/drawing/2014/main" id="{9AB5A9AE-E788-429D-ACB4-08485C3FEC37}"/>
+                <a16:creationId xmlns:a16="http://schemas.microsoft.com/office/drawing/2014/main" id="{75B94760-0F4D-4CA3-9529-9728836F1852}"/>
               </a:ext>
             </a:extLst>
           </p:cNvPr>
@@ -9180,7 +9180,7 @@
           <p:cNvPr id="2" name="eyebrow">
             <a:extLst xmlns:a="http://schemas.openxmlformats.org/drawingml/2006/main">
               <a:ext uri="{FF2B5EF4-FFF2-40B4-BE49-F238E27FC236}">
-                <a16:creationId xmlns:a16="http://schemas.microsoft.com/office/drawing/2014/main" id="{949DDAA9-2D06-48BF-A47D-77CBB9BE65AA}"/>
+                <a16:creationId xmlns:a16="http://schemas.microsoft.com/office/drawing/2014/main" id="{579146AA-54DD-4589-8A59-8ED24FC2CB39}"/>
               </a:ext>
             </a:extLst>
           </p:cNvPr>
@@ -9225,7 +9225,7 @@
           <p:cNvPr id="3" name="slide-title">
             <a:extLst xmlns:a="http://schemas.openxmlformats.org/drawingml/2006/main">
               <a:ext uri="{FF2B5EF4-FFF2-40B4-BE49-F238E27FC236}">
-                <a16:creationId xmlns:a16="http://schemas.microsoft.com/office/drawing/2014/main" id="{B7F4B702-E913-44BA-8865-E92CB396F40A}"/>
+                <a16:creationId xmlns:a16="http://schemas.microsoft.com/office/drawing/2014/main" id="{595FB698-DE5D-450D-B471-AFBC49878D92}"/>
               </a:ext>
             </a:extLst>
           </p:cNvPr>
@@ -9270,7 +9270,7 @@
           <p:cNvPr id="4" name="slide-subtitle">
             <a:extLst xmlns:a="http://schemas.openxmlformats.org/drawingml/2006/main">
               <a:ext uri="{FF2B5EF4-FFF2-40B4-BE49-F238E27FC236}">
-                <a16:creationId xmlns:a16="http://schemas.microsoft.com/office/drawing/2014/main" id="{7E53A4C8-01E7-4432-B15D-5EF870BFA972}"/>
+                <a16:creationId xmlns:a16="http://schemas.microsoft.com/office/drawing/2014/main" id="{A0BB9702-ADE3-4BC1-ADD4-7516D3DD625B}"/>
               </a:ext>
             </a:extLst>
           </p:cNvPr>
@@ -9315,7 +9315,7 @@
           <p:cNvPr id="5" name="">
             <a:extLst xmlns:a="http://schemas.openxmlformats.org/drawingml/2006/main">
               <a:ext uri="{FF2B5EF4-FFF2-40B4-BE49-F238E27FC236}">
-                <a16:creationId xmlns:a16="http://schemas.microsoft.com/office/drawing/2014/main" id="{B8977CD3-835F-4D29-9044-67D1E39B3C31}"/>
+                <a16:creationId xmlns:a16="http://schemas.microsoft.com/office/drawing/2014/main" id="{575A4143-1911-4CC7-9966-049DB70025FB}"/>
               </a:ext>
             </a:extLst>
           </p:cNvPr>
@@ -9348,7 +9348,7 @@
           <p:cNvPr id="6" name="">
             <a:extLst xmlns:a="http://schemas.openxmlformats.org/drawingml/2006/main">
               <a:ext uri="{FF2B5EF4-FFF2-40B4-BE49-F238E27FC236}">
-                <a16:creationId xmlns:a16="http://schemas.microsoft.com/office/drawing/2014/main" id="{591CB5F3-63E6-4813-A6FE-F72C376FD65E}"/>
+                <a16:creationId xmlns:a16="http://schemas.microsoft.com/office/drawing/2014/main" id="{CD76DA4C-E28B-40CA-8A3B-2A8FAD1B5A42}"/>
               </a:ext>
             </a:extLst>
           </p:cNvPr>
@@ -9393,7 +9393,7 @@
           <p:cNvPr id="7" name="">
             <a:extLst xmlns:a="http://schemas.openxmlformats.org/drawingml/2006/main">
               <a:ext uri="{FF2B5EF4-FFF2-40B4-BE49-F238E27FC236}">
-                <a16:creationId xmlns:a16="http://schemas.microsoft.com/office/drawing/2014/main" id="{80A9E929-058F-4A94-AFBE-55EA4E338DCC}"/>
+                <a16:creationId xmlns:a16="http://schemas.microsoft.com/office/drawing/2014/main" id="{30D02445-ED51-4CE2-A390-55E32E14CE7F}"/>
               </a:ext>
             </a:extLst>
           </p:cNvPr>
@@ -9438,7 +9438,7 @@
           <p:cNvPr id="8" name="">
             <a:extLst xmlns:a="http://schemas.openxmlformats.org/drawingml/2006/main">
               <a:ext uri="{FF2B5EF4-FFF2-40B4-BE49-F238E27FC236}">
-                <a16:creationId xmlns:a16="http://schemas.microsoft.com/office/drawing/2014/main" id="{DE843B78-F2BC-4AD6-8A71-C0FAB56E6E98}"/>
+                <a16:creationId xmlns:a16="http://schemas.microsoft.com/office/drawing/2014/main" id="{9270AAA3-E94D-453A-90A1-C16A537E9473}"/>
               </a:ext>
             </a:extLst>
           </p:cNvPr>
@@ -9471,7 +9471,7 @@
           <p:cNvPr id="9" name="">
             <a:extLst xmlns:a="http://schemas.openxmlformats.org/drawingml/2006/main">
               <a:ext uri="{FF2B5EF4-FFF2-40B4-BE49-F238E27FC236}">
-                <a16:creationId xmlns:a16="http://schemas.microsoft.com/office/drawing/2014/main" id="{707630B7-486F-4B92-A7C9-CE48882558EB}"/>
+                <a16:creationId xmlns:a16="http://schemas.microsoft.com/office/drawing/2014/main" id="{6CEEC6AC-A4FF-47BF-B9B8-F34C8D3ED078}"/>
               </a:ext>
             </a:extLst>
           </p:cNvPr>
@@ -9516,7 +9516,7 @@
           <p:cNvPr id="10" name="">
             <a:extLst xmlns:a="http://schemas.openxmlformats.org/drawingml/2006/main">
               <a:ext uri="{FF2B5EF4-FFF2-40B4-BE49-F238E27FC236}">
-                <a16:creationId xmlns:a16="http://schemas.microsoft.com/office/drawing/2014/main" id="{F4553390-5983-4FBC-A305-066E65AC856B}"/>
+                <a16:creationId xmlns:a16="http://schemas.microsoft.com/office/drawing/2014/main" id="{4EF43BF5-92DE-42D8-A1ED-3750720848DF}"/>
               </a:ext>
             </a:extLst>
           </p:cNvPr>
@@ -9561,7 +9561,7 @@
           <p:cNvPr id="11" name="">
             <a:extLst xmlns:a="http://schemas.openxmlformats.org/drawingml/2006/main">
               <a:ext uri="{FF2B5EF4-FFF2-40B4-BE49-F238E27FC236}">
-                <a16:creationId xmlns:a16="http://schemas.microsoft.com/office/drawing/2014/main" id="{BC38A486-A572-4B88-B303-6166172DA1AC}"/>
+                <a16:creationId xmlns:a16="http://schemas.microsoft.com/office/drawing/2014/main" id="{A4D52B09-4538-4458-96F4-58FF26E6A713}"/>
               </a:ext>
             </a:extLst>
           </p:cNvPr>
@@ -9594,7 +9594,7 @@
           <p:cNvPr id="12" name="">
             <a:extLst xmlns:a="http://schemas.openxmlformats.org/drawingml/2006/main">
               <a:ext uri="{FF2B5EF4-FFF2-40B4-BE49-F238E27FC236}">
-                <a16:creationId xmlns:a16="http://schemas.microsoft.com/office/drawing/2014/main" id="{2B573524-A6AE-4C0E-88B2-74D78DB40631}"/>
+                <a16:creationId xmlns:a16="http://schemas.microsoft.com/office/drawing/2014/main" id="{41E31344-0915-428F-B9FC-B61DBD213502}"/>
               </a:ext>
             </a:extLst>
           </p:cNvPr>
@@ -9639,7 +9639,7 @@
           <p:cNvPr id="13" name="">
             <a:extLst xmlns:a="http://schemas.openxmlformats.org/drawingml/2006/main">
               <a:ext uri="{FF2B5EF4-FFF2-40B4-BE49-F238E27FC236}">
-                <a16:creationId xmlns:a16="http://schemas.microsoft.com/office/drawing/2014/main" id="{9219B931-37AB-4A78-B96C-7983B144FE4C}"/>
+                <a16:creationId xmlns:a16="http://schemas.microsoft.com/office/drawing/2014/main" id="{C22BB0EC-EBB1-4FF0-85C3-2DFB72B8F59F}"/>
               </a:ext>
             </a:extLst>
           </p:cNvPr>
@@ -9684,7 +9684,7 @@
           <p:cNvPr id="14" name="">
             <a:extLst xmlns:a="http://schemas.openxmlformats.org/drawingml/2006/main">
               <a:ext uri="{FF2B5EF4-FFF2-40B4-BE49-F238E27FC236}">
-                <a16:creationId xmlns:a16="http://schemas.microsoft.com/office/drawing/2014/main" id="{12E6689C-54ED-4951-9C52-0A6CB759D8F0}"/>
+                <a16:creationId xmlns:a16="http://schemas.microsoft.com/office/drawing/2014/main" id="{FCE8F2F1-0BF3-4F1C-9A6B-CBCD10C75220}"/>
               </a:ext>
             </a:extLst>
           </p:cNvPr>
@@ -9729,7 +9729,7 @@
           <p:cNvPr id="15" name="footer-left">
             <a:extLst xmlns:a="http://schemas.openxmlformats.org/drawingml/2006/main">
               <a:ext uri="{FF2B5EF4-FFF2-40B4-BE49-F238E27FC236}">
-                <a16:creationId xmlns:a16="http://schemas.microsoft.com/office/drawing/2014/main" id="{402BD2E8-560F-48E0-94C1-AACCC1F6A5CA}"/>
+                <a16:creationId xmlns:a16="http://schemas.microsoft.com/office/drawing/2014/main" id="{1D4C4678-80D2-407B-954B-F71676FE7BF5}"/>
               </a:ext>
             </a:extLst>
           </p:cNvPr>
@@ -9774,7 +9774,7 @@
           <p:cNvPr id="16" name="footer-right">
             <a:extLst xmlns:a="http://schemas.openxmlformats.org/drawingml/2006/main">
               <a:ext uri="{FF2B5EF4-FFF2-40B4-BE49-F238E27FC236}">
-                <a16:creationId xmlns:a16="http://schemas.microsoft.com/office/drawing/2014/main" id="{55714D32-951B-4C9E-8B28-65C94373C132}"/>
+                <a16:creationId xmlns:a16="http://schemas.microsoft.com/office/drawing/2014/main" id="{FFA09D75-1115-479F-BDD0-3576216E067C}"/>
               </a:ext>
             </a:extLst>
           </p:cNvPr>
@@ -9817,7 +9817,7 @@
     </p:spTree>
     <p:extLst>
       <p:ext uri="{BB962C8B-B14F-4D97-AF65-F5344CB8AC3E}">
-        <p14:creationId xmlns:p14="http://schemas.microsoft.com/office/powerpoint/2010/main" val="1465159540"/>
+        <p14:creationId xmlns:p14="http://schemas.microsoft.com/office/powerpoint/2010/main" val="1406701449"/>
       </p:ext>
     </p:extLst>
   </p:cSld>
@@ -9841,7 +9841,7 @@
           <p:cNvPr id="1" name="slide-stage">
             <a:extLst xmlns:a="http://schemas.openxmlformats.org/drawingml/2006/main">
               <a:ext uri="{FF2B5EF4-FFF2-40B4-BE49-F238E27FC236}">
-                <a16:creationId xmlns:a16="http://schemas.microsoft.com/office/drawing/2014/main" id="{5349F0D0-DD57-4D50-A71A-7D8E4738F0F7}"/>
+                <a16:creationId xmlns:a16="http://schemas.microsoft.com/office/drawing/2014/main" id="{B6DD3E5F-C5E3-42DC-8DAC-73D6BFB2F29B}"/>
               </a:ext>
             </a:extLst>
           </p:cNvPr>
@@ -9868,7 +9868,7 @@
           <p:cNvPr id="2" name="eyebrow">
             <a:extLst xmlns:a="http://schemas.openxmlformats.org/drawingml/2006/main">
               <a:ext uri="{FF2B5EF4-FFF2-40B4-BE49-F238E27FC236}">
-                <a16:creationId xmlns:a16="http://schemas.microsoft.com/office/drawing/2014/main" id="{C16781D3-6A84-4C40-945B-51668A72E580}"/>
+                <a16:creationId xmlns:a16="http://schemas.microsoft.com/office/drawing/2014/main" id="{B7E1081D-55DC-4031-A412-E4A9F1C6ADA0}"/>
               </a:ext>
             </a:extLst>
           </p:cNvPr>
@@ -9913,7 +9913,7 @@
           <p:cNvPr id="3" name="slide-title">
             <a:extLst xmlns:a="http://schemas.openxmlformats.org/drawingml/2006/main">
               <a:ext uri="{FF2B5EF4-FFF2-40B4-BE49-F238E27FC236}">
-                <a16:creationId xmlns:a16="http://schemas.microsoft.com/office/drawing/2014/main" id="{9A6DA9DC-0ED8-4BB5-A086-FEA8058B0C4E}"/>
+                <a16:creationId xmlns:a16="http://schemas.microsoft.com/office/drawing/2014/main" id="{CFC062B6-ED42-4ADD-8270-14B17E17CD49}"/>
               </a:ext>
             </a:extLst>
           </p:cNvPr>
@@ -9958,7 +9958,7 @@
           <p:cNvPr id="4" name="slide-subtitle">
             <a:extLst xmlns:a="http://schemas.openxmlformats.org/drawingml/2006/main">
               <a:ext uri="{FF2B5EF4-FFF2-40B4-BE49-F238E27FC236}">
-                <a16:creationId xmlns:a16="http://schemas.microsoft.com/office/drawing/2014/main" id="{D42D8391-3225-431D-90D0-976D3DAC9E82}"/>
+                <a16:creationId xmlns:a16="http://schemas.microsoft.com/office/drawing/2014/main" id="{AF1CF44C-2312-4EFD-9DE7-E1DF60FBA434}"/>
               </a:ext>
             </a:extLst>
           </p:cNvPr>
@@ -10003,7 +10003,7 @@
           <p:cNvPr id="5" name="">
             <a:extLst xmlns:a="http://schemas.openxmlformats.org/drawingml/2006/main">
               <a:ext uri="{FF2B5EF4-FFF2-40B4-BE49-F238E27FC236}">
-                <a16:creationId xmlns:a16="http://schemas.microsoft.com/office/drawing/2014/main" id="{1036B1BD-14CE-4B4E-B4C8-CC4BD8E65E1C}"/>
+                <a16:creationId xmlns:a16="http://schemas.microsoft.com/office/drawing/2014/main" id="{8EA7B540-EBF8-41D6-AA53-39D4A823CE84}"/>
               </a:ext>
             </a:extLst>
           </p:cNvPr>
@@ -10048,7 +10048,7 @@
           <p:cNvPr id="6" name="">
             <a:extLst xmlns:a="http://schemas.openxmlformats.org/drawingml/2006/main">
               <a:ext uri="{FF2B5EF4-FFF2-40B4-BE49-F238E27FC236}">
-                <a16:creationId xmlns:a16="http://schemas.microsoft.com/office/drawing/2014/main" id="{067934B6-EA3F-4DE8-AA7E-609849FC2C96}"/>
+                <a16:creationId xmlns:a16="http://schemas.microsoft.com/office/drawing/2014/main" id="{DE0107AC-71D5-492A-9ADC-8D39DEB267D6}"/>
               </a:ext>
             </a:extLst>
           </p:cNvPr>
@@ -10093,7 +10093,7 @@
           <p:cNvPr id="7" name="">
             <a:extLst xmlns:a="http://schemas.openxmlformats.org/drawingml/2006/main">
               <a:ext uri="{FF2B5EF4-FFF2-40B4-BE49-F238E27FC236}">
-                <a16:creationId xmlns:a16="http://schemas.microsoft.com/office/drawing/2014/main" id="{A612DC95-5F79-41A1-B701-5F8808B1B53A}"/>
+                <a16:creationId xmlns:a16="http://schemas.microsoft.com/office/drawing/2014/main" id="{8782B6ED-FFDF-4D91-B54B-0CB47335CD64}"/>
               </a:ext>
             </a:extLst>
           </p:cNvPr>
@@ -10138,7 +10138,7 @@
           <p:cNvPr id="8" name="">
             <a:extLst xmlns:a="http://schemas.openxmlformats.org/drawingml/2006/main">
               <a:ext uri="{FF2B5EF4-FFF2-40B4-BE49-F238E27FC236}">
-                <a16:creationId xmlns:a16="http://schemas.microsoft.com/office/drawing/2014/main" id="{B91A75F7-C0E0-463C-BCF9-9664B025140E}"/>
+                <a16:creationId xmlns:a16="http://schemas.microsoft.com/office/drawing/2014/main" id="{05C404FC-6850-4411-947B-BCFD9EDFC01A}"/>
               </a:ext>
             </a:extLst>
           </p:cNvPr>
@@ -10183,7 +10183,7 @@
           <p:cNvPr id="9" name="">
             <a:extLst xmlns:a="http://schemas.openxmlformats.org/drawingml/2006/main">
               <a:ext uri="{FF2B5EF4-FFF2-40B4-BE49-F238E27FC236}">
-                <a16:creationId xmlns:a16="http://schemas.microsoft.com/office/drawing/2014/main" id="{6FD97C8E-A35B-4821-B9D3-6C5B9478E666}"/>
+                <a16:creationId xmlns:a16="http://schemas.microsoft.com/office/drawing/2014/main" id="{FA43A1AE-C357-43EE-B648-5FF4EE53EA64}"/>
               </a:ext>
             </a:extLst>
           </p:cNvPr>
@@ -10228,7 +10228,7 @@
           <p:cNvPr id="10" name="">
             <a:extLst xmlns:a="http://schemas.openxmlformats.org/drawingml/2006/main">
               <a:ext uri="{FF2B5EF4-FFF2-40B4-BE49-F238E27FC236}">
-                <a16:creationId xmlns:a16="http://schemas.microsoft.com/office/drawing/2014/main" id="{29C5333B-6F8F-4C21-99FB-1795A4A3ECF5}"/>
+                <a16:creationId xmlns:a16="http://schemas.microsoft.com/office/drawing/2014/main" id="{82A6DB58-90BA-4CAB-897B-700063FFF0F4}"/>
               </a:ext>
             </a:extLst>
           </p:cNvPr>
@@ -10273,7 +10273,7 @@
           <p:cNvPr id="11" name="">
             <a:extLst xmlns:a="http://schemas.openxmlformats.org/drawingml/2006/main">
               <a:ext uri="{FF2B5EF4-FFF2-40B4-BE49-F238E27FC236}">
-                <a16:creationId xmlns:a16="http://schemas.microsoft.com/office/drawing/2014/main" id="{693E6E2C-5171-4411-88CD-235149FD36D8}"/>
+                <a16:creationId xmlns:a16="http://schemas.microsoft.com/office/drawing/2014/main" id="{11F6BDB6-EED2-4127-8DDF-0DCD8E123085}"/>
               </a:ext>
             </a:extLst>
           </p:cNvPr>
@@ -10318,7 +10318,7 @@
           <p:cNvPr id="12" name="">
             <a:extLst xmlns:a="http://schemas.openxmlformats.org/drawingml/2006/main">
               <a:ext uri="{FF2B5EF4-FFF2-40B4-BE49-F238E27FC236}">
-                <a16:creationId xmlns:a16="http://schemas.microsoft.com/office/drawing/2014/main" id="{CA393337-59CE-44B3-89D1-ED13948A6CF1}"/>
+                <a16:creationId xmlns:a16="http://schemas.microsoft.com/office/drawing/2014/main" id="{50605773-109A-438B-81E2-F0F8A859BCB3}"/>
               </a:ext>
             </a:extLst>
           </p:cNvPr>
@@ -10363,7 +10363,7 @@
           <p:cNvPr id="13" name="">
             <a:extLst xmlns:a="http://schemas.openxmlformats.org/drawingml/2006/main">
               <a:ext uri="{FF2B5EF4-FFF2-40B4-BE49-F238E27FC236}">
-                <a16:creationId xmlns:a16="http://schemas.microsoft.com/office/drawing/2014/main" id="{C603679C-612E-456A-93BD-FA37E954BEFA}"/>
+                <a16:creationId xmlns:a16="http://schemas.microsoft.com/office/drawing/2014/main" id="{C8B50F6E-8E55-4BFE-927C-ED070BD09B4B}"/>
               </a:ext>
             </a:extLst>
           </p:cNvPr>
@@ -10408,7 +10408,7 @@
           <p:cNvPr id="14" name="">
             <a:extLst xmlns:a="http://schemas.openxmlformats.org/drawingml/2006/main">
               <a:ext uri="{FF2B5EF4-FFF2-40B4-BE49-F238E27FC236}">
-                <a16:creationId xmlns:a16="http://schemas.microsoft.com/office/drawing/2014/main" id="{81C37F5E-5E7E-4C11-B531-6BCBD1AB66EC}"/>
+                <a16:creationId xmlns:a16="http://schemas.microsoft.com/office/drawing/2014/main" id="{E1998EC3-9C59-4A90-82F8-61AADE88190A}"/>
               </a:ext>
             </a:extLst>
           </p:cNvPr>
@@ -10453,7 +10453,7 @@
           <p:cNvPr id="15" name="">
             <a:extLst xmlns:a="http://schemas.openxmlformats.org/drawingml/2006/main">
               <a:ext uri="{FF2B5EF4-FFF2-40B4-BE49-F238E27FC236}">
-                <a16:creationId xmlns:a16="http://schemas.microsoft.com/office/drawing/2014/main" id="{9CBD24DE-6E69-47EA-8398-39D07B76AF29}"/>
+                <a16:creationId xmlns:a16="http://schemas.microsoft.com/office/drawing/2014/main" id="{B14A07A3-BF1E-4C9B-AF46-34A49DAD6CAC}"/>
               </a:ext>
             </a:extLst>
           </p:cNvPr>
@@ -10498,7 +10498,7 @@
           <p:cNvPr id="16" name="">
             <a:extLst xmlns:a="http://schemas.openxmlformats.org/drawingml/2006/main">
               <a:ext uri="{FF2B5EF4-FFF2-40B4-BE49-F238E27FC236}">
-                <a16:creationId xmlns:a16="http://schemas.microsoft.com/office/drawing/2014/main" id="{98F51275-6314-49E1-B04C-4D323A390D84}"/>
+                <a16:creationId xmlns:a16="http://schemas.microsoft.com/office/drawing/2014/main" id="{CE2A2BBA-923F-4937-9C80-5D83CBF95BA9}"/>
               </a:ext>
             </a:extLst>
           </p:cNvPr>
@@ -10543,7 +10543,7 @@
           <p:cNvPr id="17" name="">
             <a:extLst xmlns:a="http://schemas.openxmlformats.org/drawingml/2006/main">
               <a:ext uri="{FF2B5EF4-FFF2-40B4-BE49-F238E27FC236}">
-                <a16:creationId xmlns:a16="http://schemas.microsoft.com/office/drawing/2014/main" id="{54EFD441-A9E5-4B6B-A35A-7172D900600D}"/>
+                <a16:creationId xmlns:a16="http://schemas.microsoft.com/office/drawing/2014/main" id="{C270211E-24DB-4C67-BD4C-A291E61F9CF3}"/>
               </a:ext>
             </a:extLst>
           </p:cNvPr>
@@ -10588,7 +10588,7 @@
           <p:cNvPr id="18" name="">
             <a:extLst xmlns:a="http://schemas.openxmlformats.org/drawingml/2006/main">
               <a:ext uri="{FF2B5EF4-FFF2-40B4-BE49-F238E27FC236}">
-                <a16:creationId xmlns:a16="http://schemas.microsoft.com/office/drawing/2014/main" id="{B330DF16-EEE0-4CAC-B56C-1030727F059B}"/>
+                <a16:creationId xmlns:a16="http://schemas.microsoft.com/office/drawing/2014/main" id="{A8FD643D-3FC6-429B-BA25-7297A1A2F578}"/>
               </a:ext>
             </a:extLst>
           </p:cNvPr>
@@ -10633,7 +10633,7 @@
           <p:cNvPr id="19" name="">
             <a:extLst xmlns:a="http://schemas.openxmlformats.org/drawingml/2006/main">
               <a:ext uri="{FF2B5EF4-FFF2-40B4-BE49-F238E27FC236}">
-                <a16:creationId xmlns:a16="http://schemas.microsoft.com/office/drawing/2014/main" id="{C97BFE32-9EBB-4C8A-80C3-F8861C1E35B5}"/>
+                <a16:creationId xmlns:a16="http://schemas.microsoft.com/office/drawing/2014/main" id="{D275F921-A134-4F8C-B317-71BFA8D34B46}"/>
               </a:ext>
             </a:extLst>
           </p:cNvPr>
@@ -10678,7 +10678,7 @@
           <p:cNvPr id="20" name="footer-left">
             <a:extLst xmlns:a="http://schemas.openxmlformats.org/drawingml/2006/main">
               <a:ext uri="{FF2B5EF4-FFF2-40B4-BE49-F238E27FC236}">
-                <a16:creationId xmlns:a16="http://schemas.microsoft.com/office/drawing/2014/main" id="{77F5EC0C-7A74-47C8-9424-6F675B2792AB}"/>
+                <a16:creationId xmlns:a16="http://schemas.microsoft.com/office/drawing/2014/main" id="{EB28AD91-76CE-4980-9F1A-7CEDF2A5016C}"/>
               </a:ext>
             </a:extLst>
           </p:cNvPr>
@@ -10723,7 +10723,7 @@
           <p:cNvPr id="21" name="footer-right">
             <a:extLst xmlns:a="http://schemas.openxmlformats.org/drawingml/2006/main">
               <a:ext uri="{FF2B5EF4-FFF2-40B4-BE49-F238E27FC236}">
-                <a16:creationId xmlns:a16="http://schemas.microsoft.com/office/drawing/2014/main" id="{BCC17668-854F-4933-98AF-B99BA877BD9A}"/>
+                <a16:creationId xmlns:a16="http://schemas.microsoft.com/office/drawing/2014/main" id="{1D7219F5-6BAF-4542-A096-9A97EED21549}"/>
               </a:ext>
             </a:extLst>
           </p:cNvPr>
@@ -10766,7 +10766,7 @@
     </p:spTree>
     <p:extLst>
       <p:ext uri="{BB962C8B-B14F-4D97-AF65-F5344CB8AC3E}">
-        <p14:creationId xmlns:p14="http://schemas.microsoft.com/office/powerpoint/2010/main" val="1679430510"/>
+        <p14:creationId xmlns:p14="http://schemas.microsoft.com/office/powerpoint/2010/main" val="878588150"/>
       </p:ext>
     </p:extLst>
   </p:cSld>
@@ -10790,7 +10790,7 @@
           <p:cNvPr id="1" name="slide-stage">
             <a:extLst xmlns:a="http://schemas.openxmlformats.org/drawingml/2006/main">
               <a:ext uri="{FF2B5EF4-FFF2-40B4-BE49-F238E27FC236}">
-                <a16:creationId xmlns:a16="http://schemas.microsoft.com/office/drawing/2014/main" id="{3F97D45C-9BED-4ED0-8E28-AF099059EEA8}"/>
+                <a16:creationId xmlns:a16="http://schemas.microsoft.com/office/drawing/2014/main" id="{B8F37E99-B9DE-47D5-BB26-8E8CFD3F1479}"/>
               </a:ext>
             </a:extLst>
           </p:cNvPr>
@@ -10817,7 +10817,7 @@
           <p:cNvPr id="2" name="eyebrow">
             <a:extLst xmlns:a="http://schemas.openxmlformats.org/drawingml/2006/main">
               <a:ext uri="{FF2B5EF4-FFF2-40B4-BE49-F238E27FC236}">
-                <a16:creationId xmlns:a16="http://schemas.microsoft.com/office/drawing/2014/main" id="{C124265C-43E5-481F-BC0A-FE323EAE2C34}"/>
+                <a16:creationId xmlns:a16="http://schemas.microsoft.com/office/drawing/2014/main" id="{B69C0CAB-6541-48DB-8757-0D3564F0B59F}"/>
               </a:ext>
             </a:extLst>
           </p:cNvPr>
@@ -10862,7 +10862,7 @@
           <p:cNvPr id="3" name="slide-title">
             <a:extLst xmlns:a="http://schemas.openxmlformats.org/drawingml/2006/main">
               <a:ext uri="{FF2B5EF4-FFF2-40B4-BE49-F238E27FC236}">
-                <a16:creationId xmlns:a16="http://schemas.microsoft.com/office/drawing/2014/main" id="{3ADE39F0-5DD4-4509-8A5F-C9CFCC50E387}"/>
+                <a16:creationId xmlns:a16="http://schemas.microsoft.com/office/drawing/2014/main" id="{D3B3CAB6-2337-4D8F-9E42-51D6FE6A082F}"/>
               </a:ext>
             </a:extLst>
           </p:cNvPr>
@@ -10907,7 +10907,7 @@
           <p:cNvPr id="4" name="slide-subtitle">
             <a:extLst xmlns:a="http://schemas.openxmlformats.org/drawingml/2006/main">
               <a:ext uri="{FF2B5EF4-FFF2-40B4-BE49-F238E27FC236}">
-                <a16:creationId xmlns:a16="http://schemas.microsoft.com/office/drawing/2014/main" id="{AF634D89-C94D-4658-999B-FB47CC53B115}"/>
+                <a16:creationId xmlns:a16="http://schemas.microsoft.com/office/drawing/2014/main" id="{0B6E51F6-3904-4888-96A1-57837C4C6FD3}"/>
               </a:ext>
             </a:extLst>
           </p:cNvPr>
@@ -10952,7 +10952,7 @@
           <p:cNvPr id="5" name="">
             <a:extLst xmlns:a="http://schemas.openxmlformats.org/drawingml/2006/main">
               <a:ext uri="{FF2B5EF4-FFF2-40B4-BE49-F238E27FC236}">
-                <a16:creationId xmlns:a16="http://schemas.microsoft.com/office/drawing/2014/main" id="{A113532A-A855-44D1-9009-B2FDE6567D8C}"/>
+                <a16:creationId xmlns:a16="http://schemas.microsoft.com/office/drawing/2014/main" id="{6412D5F5-E79D-4802-83AA-9940C435A122}"/>
               </a:ext>
             </a:extLst>
           </p:cNvPr>
@@ -10985,7 +10985,7 @@
           <p:cNvPr id="6" name="">
             <a:extLst xmlns:a="http://schemas.openxmlformats.org/drawingml/2006/main">
               <a:ext uri="{FF2B5EF4-FFF2-40B4-BE49-F238E27FC236}">
-                <a16:creationId xmlns:a16="http://schemas.microsoft.com/office/drawing/2014/main" id="{462118A1-4436-431D-91AC-61C37F13BBE8}"/>
+                <a16:creationId xmlns:a16="http://schemas.microsoft.com/office/drawing/2014/main" id="{AE7BFAC4-74D3-47FD-8D52-6D47E56FE4D8}"/>
               </a:ext>
             </a:extLst>
           </p:cNvPr>
@@ -11081,7 +11081,7 @@
           <p:cNvPr id="7" name="">
             <a:extLst xmlns:a="http://schemas.openxmlformats.org/drawingml/2006/main">
               <a:ext uri="{FF2B5EF4-FFF2-40B4-BE49-F238E27FC236}">
-                <a16:creationId xmlns:a16="http://schemas.microsoft.com/office/drawing/2014/main" id="{752D5B38-0EA5-47CC-AEFC-D683150E8AD0}"/>
+                <a16:creationId xmlns:a16="http://schemas.microsoft.com/office/drawing/2014/main" id="{EFA9D121-B5EC-4295-88E5-165419B63984}"/>
               </a:ext>
             </a:extLst>
           </p:cNvPr>
@@ -11114,7 +11114,7 @@
           <p:cNvPr id="8" name="">
             <a:extLst xmlns:a="http://schemas.openxmlformats.org/drawingml/2006/main">
               <a:ext uri="{FF2B5EF4-FFF2-40B4-BE49-F238E27FC236}">
-                <a16:creationId xmlns:a16="http://schemas.microsoft.com/office/drawing/2014/main" id="{F2E8788B-7321-40A4-BF81-B31EC88448DD}"/>
+                <a16:creationId xmlns:a16="http://schemas.microsoft.com/office/drawing/2014/main" id="{69640B4C-4ACB-4146-AA48-FD67F49694F8}"/>
               </a:ext>
             </a:extLst>
           </p:cNvPr>
@@ -11159,7 +11159,7 @@
           <p:cNvPr id="9" name="">
             <a:extLst xmlns:a="http://schemas.openxmlformats.org/drawingml/2006/main">
               <a:ext uri="{FF2B5EF4-FFF2-40B4-BE49-F238E27FC236}">
-                <a16:creationId xmlns:a16="http://schemas.microsoft.com/office/drawing/2014/main" id="{A7DA3960-8D9B-4ABC-8A42-2F643E795132}"/>
+                <a16:creationId xmlns:a16="http://schemas.microsoft.com/office/drawing/2014/main" id="{9DD358BC-36FC-4E30-AB59-6D8D11E9A18F}"/>
               </a:ext>
             </a:extLst>
           </p:cNvPr>
@@ -11204,7 +11204,7 @@
           <p:cNvPr id="10" name="">
             <a:extLst xmlns:a="http://schemas.openxmlformats.org/drawingml/2006/main">
               <a:ext uri="{FF2B5EF4-FFF2-40B4-BE49-F238E27FC236}">
-                <a16:creationId xmlns:a16="http://schemas.microsoft.com/office/drawing/2014/main" id="{3633D117-A84D-4BFE-9A8C-031F06DA952D}"/>
+                <a16:creationId xmlns:a16="http://schemas.microsoft.com/office/drawing/2014/main" id="{8FB521A0-560B-4D7D-BDCC-CF255DC07AD5}"/>
               </a:ext>
             </a:extLst>
           </p:cNvPr>
@@ -11237,7 +11237,7 @@
           <p:cNvPr id="11" name="">
             <a:extLst xmlns:a="http://schemas.openxmlformats.org/drawingml/2006/main">
               <a:ext uri="{FF2B5EF4-FFF2-40B4-BE49-F238E27FC236}">
-                <a16:creationId xmlns:a16="http://schemas.microsoft.com/office/drawing/2014/main" id="{7D838FF6-EEE7-4BB5-9EE8-D45BCF4A67CD}"/>
+                <a16:creationId xmlns:a16="http://schemas.microsoft.com/office/drawing/2014/main" id="{4ABD0AD5-3EF5-4EA8-AF85-DF2383489973}"/>
               </a:ext>
             </a:extLst>
           </p:cNvPr>
@@ -11282,7 +11282,7 @@
           <p:cNvPr id="12" name="">
             <a:extLst xmlns:a="http://schemas.openxmlformats.org/drawingml/2006/main">
               <a:ext uri="{FF2B5EF4-FFF2-40B4-BE49-F238E27FC236}">
-                <a16:creationId xmlns:a16="http://schemas.microsoft.com/office/drawing/2014/main" id="{D7C65495-7E58-40E0-BCFE-AFF1F300AC58}"/>
+                <a16:creationId xmlns:a16="http://schemas.microsoft.com/office/drawing/2014/main" id="{A9D99290-4888-4E7C-9593-7EDD25A1FB50}"/>
               </a:ext>
             </a:extLst>
           </p:cNvPr>
@@ -11327,7 +11327,7 @@
           <p:cNvPr id="13" name="">
             <a:extLst xmlns:a="http://schemas.openxmlformats.org/drawingml/2006/main">
               <a:ext uri="{FF2B5EF4-FFF2-40B4-BE49-F238E27FC236}">
-                <a16:creationId xmlns:a16="http://schemas.microsoft.com/office/drawing/2014/main" id="{99B65775-8F7B-4937-9741-C16D4B13DB44}"/>
+                <a16:creationId xmlns:a16="http://schemas.microsoft.com/office/drawing/2014/main" id="{7C9668CF-6B03-486B-AC4C-8C44509E4E2D}"/>
               </a:ext>
             </a:extLst>
           </p:cNvPr>
@@ -11360,7 +11360,7 @@
           <p:cNvPr id="14" name="">
             <a:extLst xmlns:a="http://schemas.openxmlformats.org/drawingml/2006/main">
               <a:ext uri="{FF2B5EF4-FFF2-40B4-BE49-F238E27FC236}">
-                <a16:creationId xmlns:a16="http://schemas.microsoft.com/office/drawing/2014/main" id="{D5628DB3-D9B4-4643-B95C-D26B1706393E}"/>
+                <a16:creationId xmlns:a16="http://schemas.microsoft.com/office/drawing/2014/main" id="{1232B0B3-51C5-4211-9450-6ABFC2D2A750}"/>
               </a:ext>
             </a:extLst>
           </p:cNvPr>
@@ -11405,7 +11405,7 @@
           <p:cNvPr id="15" name="">
             <a:extLst xmlns:a="http://schemas.openxmlformats.org/drawingml/2006/main">
               <a:ext uri="{FF2B5EF4-FFF2-40B4-BE49-F238E27FC236}">
-                <a16:creationId xmlns:a16="http://schemas.microsoft.com/office/drawing/2014/main" id="{562AB1B9-BD7C-4892-92E4-13B5C5ED4F0D}"/>
+                <a16:creationId xmlns:a16="http://schemas.microsoft.com/office/drawing/2014/main" id="{552EB6A2-DB57-43EE-B66D-88BE663DAEBA}"/>
               </a:ext>
             </a:extLst>
           </p:cNvPr>
@@ -11450,7 +11450,7 @@
           <p:cNvPr id="16" name="footer-left">
             <a:extLst xmlns:a="http://schemas.openxmlformats.org/drawingml/2006/main">
               <a:ext uri="{FF2B5EF4-FFF2-40B4-BE49-F238E27FC236}">
-                <a16:creationId xmlns:a16="http://schemas.microsoft.com/office/drawing/2014/main" id="{EC1D9B27-1769-4BAE-97D6-0F00C1B19978}"/>
+                <a16:creationId xmlns:a16="http://schemas.microsoft.com/office/drawing/2014/main" id="{D1FE85D5-00D1-44DB-A408-19058DBF8DB2}"/>
               </a:ext>
             </a:extLst>
           </p:cNvPr>
@@ -11495,7 +11495,7 @@
           <p:cNvPr id="17" name="footer-right">
             <a:extLst xmlns:a="http://schemas.openxmlformats.org/drawingml/2006/main">
               <a:ext uri="{FF2B5EF4-FFF2-40B4-BE49-F238E27FC236}">
-                <a16:creationId xmlns:a16="http://schemas.microsoft.com/office/drawing/2014/main" id="{2876EA0C-8546-4787-AC8B-4A09F2E1FD31}"/>
+                <a16:creationId xmlns:a16="http://schemas.microsoft.com/office/drawing/2014/main" id="{31CED28E-FD55-4A4B-B375-A9731D3F7EBF}"/>
               </a:ext>
             </a:extLst>
           </p:cNvPr>
@@ -11538,7 +11538,7 @@
     </p:spTree>
     <p:extLst>
       <p:ext uri="{BB962C8B-B14F-4D97-AF65-F5344CB8AC3E}">
-        <p14:creationId xmlns:p14="http://schemas.microsoft.com/office/powerpoint/2010/main" val="685077814"/>
+        <p14:creationId xmlns:p14="http://schemas.microsoft.com/office/powerpoint/2010/main" val="239398099"/>
       </p:ext>
     </p:extLst>
   </p:cSld>
@@ -11562,7 +11562,7 @@
           <p:cNvPr id="1" name="slide-stage">
             <a:extLst xmlns:a="http://schemas.openxmlformats.org/drawingml/2006/main">
               <a:ext uri="{FF2B5EF4-FFF2-40B4-BE49-F238E27FC236}">
-                <a16:creationId xmlns:a16="http://schemas.microsoft.com/office/drawing/2014/main" id="{62C83DAC-CBC0-4AAF-9F4E-829BB2C891FD}"/>
+                <a16:creationId xmlns:a16="http://schemas.microsoft.com/office/drawing/2014/main" id="{E9FD7830-B85A-482B-867D-3AC039B14DF1}"/>
               </a:ext>
             </a:extLst>
           </p:cNvPr>
@@ -11589,7 +11589,7 @@
           <p:cNvPr id="2" name="eyebrow">
             <a:extLst xmlns:a="http://schemas.openxmlformats.org/drawingml/2006/main">
               <a:ext uri="{FF2B5EF4-FFF2-40B4-BE49-F238E27FC236}">
-                <a16:creationId xmlns:a16="http://schemas.microsoft.com/office/drawing/2014/main" id="{6325C214-2E89-4CD5-A846-EAB6852DFBB1}"/>
+                <a16:creationId xmlns:a16="http://schemas.microsoft.com/office/drawing/2014/main" id="{2857D30F-4C28-459C-BBD1-36407F335CA6}"/>
               </a:ext>
             </a:extLst>
           </p:cNvPr>
@@ -11634,7 +11634,7 @@
           <p:cNvPr id="3" name="slide-title">
             <a:extLst xmlns:a="http://schemas.openxmlformats.org/drawingml/2006/main">
               <a:ext uri="{FF2B5EF4-FFF2-40B4-BE49-F238E27FC236}">
-                <a16:creationId xmlns:a16="http://schemas.microsoft.com/office/drawing/2014/main" id="{B7798096-0CAB-4AFB-B67C-BEA58EC81688}"/>
+                <a16:creationId xmlns:a16="http://schemas.microsoft.com/office/drawing/2014/main" id="{7F0B30D2-40AB-420F-9AC5-EEF5DD428BE6}"/>
               </a:ext>
             </a:extLst>
           </p:cNvPr>
@@ -11679,7 +11679,7 @@
           <p:cNvPr id="4" name="slide-subtitle">
             <a:extLst xmlns:a="http://schemas.openxmlformats.org/drawingml/2006/main">
               <a:ext uri="{FF2B5EF4-FFF2-40B4-BE49-F238E27FC236}">
-                <a16:creationId xmlns:a16="http://schemas.microsoft.com/office/drawing/2014/main" id="{AFA19DE7-9FA6-4854-B0D4-D6C3367F3E5C}"/>
+                <a16:creationId xmlns:a16="http://schemas.microsoft.com/office/drawing/2014/main" id="{90A26F46-00CB-470F-A762-7129DB1950B6}"/>
               </a:ext>
             </a:extLst>
           </p:cNvPr>
@@ -11724,7 +11724,7 @@
           <p:cNvPr id="5" name="">
             <a:extLst xmlns:a="http://schemas.openxmlformats.org/drawingml/2006/main">
               <a:ext uri="{FF2B5EF4-FFF2-40B4-BE49-F238E27FC236}">
-                <a16:creationId xmlns:a16="http://schemas.microsoft.com/office/drawing/2014/main" id="{B64EE1E7-D07E-40AF-9777-573D5423784E}"/>
+                <a16:creationId xmlns:a16="http://schemas.microsoft.com/office/drawing/2014/main" id="{3BC2792F-DCC3-4A91-988D-B1113F1AC4A6}"/>
               </a:ext>
             </a:extLst>
           </p:cNvPr>
@@ -11757,7 +11757,7 @@
           <p:cNvPr id="6" name="">
             <a:extLst xmlns:a="http://schemas.openxmlformats.org/drawingml/2006/main">
               <a:ext uri="{FF2B5EF4-FFF2-40B4-BE49-F238E27FC236}">
-                <a16:creationId xmlns:a16="http://schemas.microsoft.com/office/drawing/2014/main" id="{14F79C1E-564D-4D2C-AC67-F303D2281727}"/>
+                <a16:creationId xmlns:a16="http://schemas.microsoft.com/office/drawing/2014/main" id="{A406AA54-9BBF-4B21-A709-076941293033}"/>
               </a:ext>
             </a:extLst>
           </p:cNvPr>
@@ -11802,7 +11802,7 @@
           <p:cNvPr id="7" name="">
             <a:extLst xmlns:a="http://schemas.openxmlformats.org/drawingml/2006/main">
               <a:ext uri="{FF2B5EF4-FFF2-40B4-BE49-F238E27FC236}">
-                <a16:creationId xmlns:a16="http://schemas.microsoft.com/office/drawing/2014/main" id="{D867E6A7-95EA-4C35-BD8A-BA9DBFC807E1}"/>
+                <a16:creationId xmlns:a16="http://schemas.microsoft.com/office/drawing/2014/main" id="{50009957-24E5-4D07-853E-3F75E036CCA8}"/>
               </a:ext>
             </a:extLst>
           </p:cNvPr>
@@ -11847,7 +11847,7 @@
           <p:cNvPr id="8" name="">
             <a:extLst xmlns:a="http://schemas.openxmlformats.org/drawingml/2006/main">
               <a:ext uri="{FF2B5EF4-FFF2-40B4-BE49-F238E27FC236}">
-                <a16:creationId xmlns:a16="http://schemas.microsoft.com/office/drawing/2014/main" id="{81C83EAA-01BA-4301-90DC-D506D46A400B}"/>
+                <a16:creationId xmlns:a16="http://schemas.microsoft.com/office/drawing/2014/main" id="{3738D10A-C902-4E27-894F-F378BF373C3C}"/>
               </a:ext>
             </a:extLst>
           </p:cNvPr>
@@ -11892,7 +11892,7 @@
           <p:cNvPr id="9" name="">
             <a:extLst xmlns:a="http://schemas.openxmlformats.org/drawingml/2006/main">
               <a:ext uri="{FF2B5EF4-FFF2-40B4-BE49-F238E27FC236}">
-                <a16:creationId xmlns:a16="http://schemas.microsoft.com/office/drawing/2014/main" id="{6493DEF3-F842-46BF-957C-F109AFEE5E3F}"/>
+                <a16:creationId xmlns:a16="http://schemas.microsoft.com/office/drawing/2014/main" id="{9D3A40BF-627B-4BCB-8F2A-FA11D9A79D9D}"/>
               </a:ext>
             </a:extLst>
           </p:cNvPr>
@@ -11925,7 +11925,7 @@
           <p:cNvPr id="10" name="">
             <a:extLst xmlns:a="http://schemas.openxmlformats.org/drawingml/2006/main">
               <a:ext uri="{FF2B5EF4-FFF2-40B4-BE49-F238E27FC236}">
-                <a16:creationId xmlns:a16="http://schemas.microsoft.com/office/drawing/2014/main" id="{04BF9898-D767-4CEC-B883-2C2C58701671}"/>
+                <a16:creationId xmlns:a16="http://schemas.microsoft.com/office/drawing/2014/main" id="{AFBBF7F7-FBEB-49FD-8B5E-9C2EF83581B6}"/>
               </a:ext>
             </a:extLst>
           </p:cNvPr>
@@ -11970,7 +11970,7 @@
           <p:cNvPr id="11" name="">
             <a:extLst xmlns:a="http://schemas.openxmlformats.org/drawingml/2006/main">
               <a:ext uri="{FF2B5EF4-FFF2-40B4-BE49-F238E27FC236}">
-                <a16:creationId xmlns:a16="http://schemas.microsoft.com/office/drawing/2014/main" id="{9A1FC7C0-5DD7-43C6-8E84-58D7B8D54821}"/>
+                <a16:creationId xmlns:a16="http://schemas.microsoft.com/office/drawing/2014/main" id="{6C045FAF-05B2-4054-A936-8BA41405B48F}"/>
               </a:ext>
             </a:extLst>
           </p:cNvPr>
@@ -12015,7 +12015,7 @@
           <p:cNvPr id="12" name="">
             <a:extLst xmlns:a="http://schemas.openxmlformats.org/drawingml/2006/main">
               <a:ext uri="{FF2B5EF4-FFF2-40B4-BE49-F238E27FC236}">
-                <a16:creationId xmlns:a16="http://schemas.microsoft.com/office/drawing/2014/main" id="{AED4210A-B8BC-495F-AFE0-A0AB40DA3647}"/>
+                <a16:creationId xmlns:a16="http://schemas.microsoft.com/office/drawing/2014/main" id="{8AF12DEC-2CBE-449F-90B7-F8E6DC5A0B8F}"/>
               </a:ext>
             </a:extLst>
           </p:cNvPr>
@@ -12060,7 +12060,7 @@
           <p:cNvPr id="13" name="">
             <a:extLst xmlns:a="http://schemas.openxmlformats.org/drawingml/2006/main">
               <a:ext uri="{FF2B5EF4-FFF2-40B4-BE49-F238E27FC236}">
-                <a16:creationId xmlns:a16="http://schemas.microsoft.com/office/drawing/2014/main" id="{2FAD4DD1-2EDE-4319-A686-6983C3E994D2}"/>
+                <a16:creationId xmlns:a16="http://schemas.microsoft.com/office/drawing/2014/main" id="{61F5ACDB-1A20-4C27-BCC9-45DE1C3290CA}"/>
               </a:ext>
             </a:extLst>
           </p:cNvPr>
@@ -12093,7 +12093,7 @@
           <p:cNvPr id="14" name="">
             <a:extLst xmlns:a="http://schemas.openxmlformats.org/drawingml/2006/main">
               <a:ext uri="{FF2B5EF4-FFF2-40B4-BE49-F238E27FC236}">
-                <a16:creationId xmlns:a16="http://schemas.microsoft.com/office/drawing/2014/main" id="{C0974677-E3AB-4B74-80F6-A61317CC0851}"/>
+                <a16:creationId xmlns:a16="http://schemas.microsoft.com/office/drawing/2014/main" id="{0F233F5A-DD11-4B6F-B21A-B10D78584C9B}"/>
               </a:ext>
             </a:extLst>
           </p:cNvPr>
@@ -12138,7 +12138,7 @@
           <p:cNvPr id="15" name="">
             <a:extLst xmlns:a="http://schemas.openxmlformats.org/drawingml/2006/main">
               <a:ext uri="{FF2B5EF4-FFF2-40B4-BE49-F238E27FC236}">
-                <a16:creationId xmlns:a16="http://schemas.microsoft.com/office/drawing/2014/main" id="{B2E4DB5F-58C2-4B9F-9B41-778F810F5BAE}"/>
+                <a16:creationId xmlns:a16="http://schemas.microsoft.com/office/drawing/2014/main" id="{C1D77157-8DAD-4375-AC9F-5977B0D43E4A}"/>
               </a:ext>
             </a:extLst>
           </p:cNvPr>
@@ -12183,7 +12183,7 @@
           <p:cNvPr id="16" name="">
             <a:extLst xmlns:a="http://schemas.openxmlformats.org/drawingml/2006/main">
               <a:ext uri="{FF2B5EF4-FFF2-40B4-BE49-F238E27FC236}">
-                <a16:creationId xmlns:a16="http://schemas.microsoft.com/office/drawing/2014/main" id="{B49A7263-2F89-469C-9E28-A2E108F0E380}"/>
+                <a16:creationId xmlns:a16="http://schemas.microsoft.com/office/drawing/2014/main" id="{D12BFC0B-2206-4EDA-B616-BA92FF3F00E0}"/>
               </a:ext>
             </a:extLst>
           </p:cNvPr>
@@ -12228,7 +12228,7 @@
           <p:cNvPr id="17" name="">
             <a:extLst xmlns:a="http://schemas.openxmlformats.org/drawingml/2006/main">
               <a:ext uri="{FF2B5EF4-FFF2-40B4-BE49-F238E27FC236}">
-                <a16:creationId xmlns:a16="http://schemas.microsoft.com/office/drawing/2014/main" id="{A729D4F4-B479-44AC-9856-04CBA2301A87}"/>
+                <a16:creationId xmlns:a16="http://schemas.microsoft.com/office/drawing/2014/main" id="{923133A6-CE6A-4C06-AB33-FE6A9C09569E}"/>
               </a:ext>
             </a:extLst>
           </p:cNvPr>
@@ -12261,7 +12261,7 @@
           <p:cNvPr id="18" name="">
             <a:extLst xmlns:a="http://schemas.openxmlformats.org/drawingml/2006/main">
               <a:ext uri="{FF2B5EF4-FFF2-40B4-BE49-F238E27FC236}">
-                <a16:creationId xmlns:a16="http://schemas.microsoft.com/office/drawing/2014/main" id="{8D8E0A44-B899-40F2-B0F9-F62E079CA595}"/>
+                <a16:creationId xmlns:a16="http://schemas.microsoft.com/office/drawing/2014/main" id="{D03EE359-24BA-47C7-8E63-E4A764007DA7}"/>
               </a:ext>
             </a:extLst>
           </p:cNvPr>
@@ -12306,7 +12306,7 @@
           <p:cNvPr id="19" name="">
             <a:extLst xmlns:a="http://schemas.openxmlformats.org/drawingml/2006/main">
               <a:ext uri="{FF2B5EF4-FFF2-40B4-BE49-F238E27FC236}">
-                <a16:creationId xmlns:a16="http://schemas.microsoft.com/office/drawing/2014/main" id="{484D3CF8-503C-4E86-A092-4E125CE32E98}"/>
+                <a16:creationId xmlns:a16="http://schemas.microsoft.com/office/drawing/2014/main" id="{D98EF12A-5CC5-4BE5-98D2-D16B407C5420}"/>
               </a:ext>
             </a:extLst>
           </p:cNvPr>
@@ -12351,7 +12351,7 @@
           <p:cNvPr id="20" name="">
             <a:extLst xmlns:a="http://schemas.openxmlformats.org/drawingml/2006/main">
               <a:ext uri="{FF2B5EF4-FFF2-40B4-BE49-F238E27FC236}">
-                <a16:creationId xmlns:a16="http://schemas.microsoft.com/office/drawing/2014/main" id="{B041F9EF-B65C-4D91-9070-65A56C625DF5}"/>
+                <a16:creationId xmlns:a16="http://schemas.microsoft.com/office/drawing/2014/main" id="{88C1E3B0-4F91-4639-81A2-1B97F2C4B9B5}"/>
               </a:ext>
             </a:extLst>
           </p:cNvPr>
@@ -12396,7 +12396,7 @@
           <p:cNvPr id="21" name="">
             <a:extLst xmlns:a="http://schemas.openxmlformats.org/drawingml/2006/main">
               <a:ext uri="{FF2B5EF4-FFF2-40B4-BE49-F238E27FC236}">
-                <a16:creationId xmlns:a16="http://schemas.microsoft.com/office/drawing/2014/main" id="{C0F5D2FB-47FE-42AB-9112-5BA81A3B0B3E}"/>
+                <a16:creationId xmlns:a16="http://schemas.microsoft.com/office/drawing/2014/main" id="{22AB288A-AB5A-4CED-A18E-EDCBF0AA4DEF}"/>
               </a:ext>
             </a:extLst>
           </p:cNvPr>
@@ -12429,7 +12429,7 @@
           <p:cNvPr id="22" name="">
             <a:extLst xmlns:a="http://schemas.openxmlformats.org/drawingml/2006/main">
               <a:ext uri="{FF2B5EF4-FFF2-40B4-BE49-F238E27FC236}">
-                <a16:creationId xmlns:a16="http://schemas.microsoft.com/office/drawing/2014/main" id="{D4A07100-5A8B-4DE4-B9E2-CC0B18C6F0BD}"/>
+                <a16:creationId xmlns:a16="http://schemas.microsoft.com/office/drawing/2014/main" id="{D226F154-8115-43FA-BBEC-EB291F4ADE28}"/>
               </a:ext>
             </a:extLst>
           </p:cNvPr>
@@ -12474,7 +12474,7 @@
           <p:cNvPr id="23" name="">
             <a:extLst xmlns:a="http://schemas.openxmlformats.org/drawingml/2006/main">
               <a:ext uri="{FF2B5EF4-FFF2-40B4-BE49-F238E27FC236}">
-                <a16:creationId xmlns:a16="http://schemas.microsoft.com/office/drawing/2014/main" id="{C3DE5FC1-7970-491C-95FF-0BBD9F8CC21A}"/>
+                <a16:creationId xmlns:a16="http://schemas.microsoft.com/office/drawing/2014/main" id="{D1808808-BAC4-42B3-B574-4ECF640EAC51}"/>
               </a:ext>
             </a:extLst>
           </p:cNvPr>
@@ -12519,7 +12519,7 @@
           <p:cNvPr id="24" name="">
             <a:extLst xmlns:a="http://schemas.openxmlformats.org/drawingml/2006/main">
               <a:ext uri="{FF2B5EF4-FFF2-40B4-BE49-F238E27FC236}">
-                <a16:creationId xmlns:a16="http://schemas.microsoft.com/office/drawing/2014/main" id="{A7B62D4C-C97F-4C2F-B508-11D3354009BB}"/>
+                <a16:creationId xmlns:a16="http://schemas.microsoft.com/office/drawing/2014/main" id="{E339C72B-3639-4054-B2BF-D9A5DC8E3B33}"/>
               </a:ext>
             </a:extLst>
           </p:cNvPr>
@@ -12564,7 +12564,7 @@
           <p:cNvPr id="25" name="">
             <a:extLst xmlns:a="http://schemas.openxmlformats.org/drawingml/2006/main">
               <a:ext uri="{FF2B5EF4-FFF2-40B4-BE49-F238E27FC236}">
-                <a16:creationId xmlns:a16="http://schemas.microsoft.com/office/drawing/2014/main" id="{3EDF5E02-7DC1-4BAD-B087-B6A1FB98500E}"/>
+                <a16:creationId xmlns:a16="http://schemas.microsoft.com/office/drawing/2014/main" id="{6959102E-1CD6-47FB-BC69-E32BA59D84A6}"/>
               </a:ext>
             </a:extLst>
           </p:cNvPr>
@@ -12597,7 +12597,7 @@
           <p:cNvPr id="26" name="">
             <a:extLst xmlns:a="http://schemas.openxmlformats.org/drawingml/2006/main">
               <a:ext uri="{FF2B5EF4-FFF2-40B4-BE49-F238E27FC236}">
-                <a16:creationId xmlns:a16="http://schemas.microsoft.com/office/drawing/2014/main" id="{DC157E57-50BE-4D67-835D-508A8495F047}"/>
+                <a16:creationId xmlns:a16="http://schemas.microsoft.com/office/drawing/2014/main" id="{4009EAC0-C933-45F7-9E5D-A8EB3A765B4F}"/>
               </a:ext>
             </a:extLst>
           </p:cNvPr>
@@ -12642,7 +12642,7 @@
           <p:cNvPr id="27" name="">
             <a:extLst xmlns:a="http://schemas.openxmlformats.org/drawingml/2006/main">
               <a:ext uri="{FF2B5EF4-FFF2-40B4-BE49-F238E27FC236}">
-                <a16:creationId xmlns:a16="http://schemas.microsoft.com/office/drawing/2014/main" id="{41D7E964-C07C-4636-B332-5A9366798837}"/>
+                <a16:creationId xmlns:a16="http://schemas.microsoft.com/office/drawing/2014/main" id="{F791949E-89FE-4926-9076-9BD8C34B0BEA}"/>
               </a:ext>
             </a:extLst>
           </p:cNvPr>
@@ -12687,7 +12687,7 @@
           <p:cNvPr id="28" name="">
             <a:extLst xmlns:a="http://schemas.openxmlformats.org/drawingml/2006/main">
               <a:ext uri="{FF2B5EF4-FFF2-40B4-BE49-F238E27FC236}">
-                <a16:creationId xmlns:a16="http://schemas.microsoft.com/office/drawing/2014/main" id="{A5F65C70-A222-4535-84DC-D0701C78A27E}"/>
+                <a16:creationId xmlns:a16="http://schemas.microsoft.com/office/drawing/2014/main" id="{3EC16F64-960E-49AC-A352-524902CAF4B6}"/>
               </a:ext>
             </a:extLst>
           </p:cNvPr>
@@ -12732,7 +12732,7 @@
           <p:cNvPr id="29" name="footer-left">
             <a:extLst xmlns:a="http://schemas.openxmlformats.org/drawingml/2006/main">
               <a:ext uri="{FF2B5EF4-FFF2-40B4-BE49-F238E27FC236}">
-                <a16:creationId xmlns:a16="http://schemas.microsoft.com/office/drawing/2014/main" id="{24889C5E-6324-46BE-BBF4-E11A180D84C8}"/>
+                <a16:creationId xmlns:a16="http://schemas.microsoft.com/office/drawing/2014/main" id="{20E769F9-5FAA-40D4-942F-3E85FA315B86}"/>
               </a:ext>
             </a:extLst>
           </p:cNvPr>
@@ -12777,7 +12777,7 @@
           <p:cNvPr id="30" name="footer-right">
             <a:extLst xmlns:a="http://schemas.openxmlformats.org/drawingml/2006/main">
               <a:ext uri="{FF2B5EF4-FFF2-40B4-BE49-F238E27FC236}">
-                <a16:creationId xmlns:a16="http://schemas.microsoft.com/office/drawing/2014/main" id="{4DC04AFF-C58D-4E4D-AF50-85A943A1E4FE}"/>
+                <a16:creationId xmlns:a16="http://schemas.microsoft.com/office/drawing/2014/main" id="{8DD2CCE1-A7D4-4C4A-835D-7B3EF9B34F13}"/>
               </a:ext>
             </a:extLst>
           </p:cNvPr>
@@ -12820,7 +12820,7 @@
     </p:spTree>
     <p:extLst>
       <p:ext uri="{BB962C8B-B14F-4D97-AF65-F5344CB8AC3E}">
-        <p14:creationId xmlns:p14="http://schemas.microsoft.com/office/powerpoint/2010/main" val="684283847"/>
+        <p14:creationId xmlns:p14="http://schemas.microsoft.com/office/powerpoint/2010/main" val="916441880"/>
       </p:ext>
     </p:extLst>
   </p:cSld>
@@ -12844,7 +12844,7 @@
           <p:cNvPr id="1" name="slide-stage">
             <a:extLst xmlns:a="http://schemas.openxmlformats.org/drawingml/2006/main">
               <a:ext uri="{FF2B5EF4-FFF2-40B4-BE49-F238E27FC236}">
-                <a16:creationId xmlns:a16="http://schemas.microsoft.com/office/drawing/2014/main" id="{42957934-71CC-40A8-BB28-6B88AD5EDED6}"/>
+                <a16:creationId xmlns:a16="http://schemas.microsoft.com/office/drawing/2014/main" id="{92B3FEB4-4778-4859-B297-830B04278C56}"/>
               </a:ext>
             </a:extLst>
           </p:cNvPr>
@@ -12871,7 +12871,7 @@
           <p:cNvPr id="2" name="eyebrow">
             <a:extLst xmlns:a="http://schemas.openxmlformats.org/drawingml/2006/main">
               <a:ext uri="{FF2B5EF4-FFF2-40B4-BE49-F238E27FC236}">
-                <a16:creationId xmlns:a16="http://schemas.microsoft.com/office/drawing/2014/main" id="{2A7CCA93-FB46-4799-87A9-19F36AF830F8}"/>
+                <a16:creationId xmlns:a16="http://schemas.microsoft.com/office/drawing/2014/main" id="{5B8449B9-9E71-4BF7-A20A-4CB511029C58}"/>
               </a:ext>
             </a:extLst>
           </p:cNvPr>
@@ -12916,7 +12916,7 @@
           <p:cNvPr id="3" name="slide-title">
             <a:extLst xmlns:a="http://schemas.openxmlformats.org/drawingml/2006/main">
               <a:ext uri="{FF2B5EF4-FFF2-40B4-BE49-F238E27FC236}">
-                <a16:creationId xmlns:a16="http://schemas.microsoft.com/office/drawing/2014/main" id="{5087343D-D321-403F-9EC2-0DF7DD31FBA6}"/>
+                <a16:creationId xmlns:a16="http://schemas.microsoft.com/office/drawing/2014/main" id="{E4FBA149-E53E-4397-8716-BEE87453C3C8}"/>
               </a:ext>
             </a:extLst>
           </p:cNvPr>
@@ -12961,7 +12961,7 @@
           <p:cNvPr id="4" name="slide-subtitle">
             <a:extLst xmlns:a="http://schemas.openxmlformats.org/drawingml/2006/main">
               <a:ext uri="{FF2B5EF4-FFF2-40B4-BE49-F238E27FC236}">
-                <a16:creationId xmlns:a16="http://schemas.microsoft.com/office/drawing/2014/main" id="{42156CDC-BBB4-416B-AC45-46357F4C1CC9}"/>
+                <a16:creationId xmlns:a16="http://schemas.microsoft.com/office/drawing/2014/main" id="{FEE3E7C2-AC69-4C47-A43D-188D3B5BCF3E}"/>
               </a:ext>
             </a:extLst>
           </p:cNvPr>
@@ -13006,7 +13006,7 @@
           <p:cNvPr id="5" name="">
             <a:extLst xmlns:a="http://schemas.openxmlformats.org/drawingml/2006/main">
               <a:ext uri="{FF2B5EF4-FFF2-40B4-BE49-F238E27FC236}">
-                <a16:creationId xmlns:a16="http://schemas.microsoft.com/office/drawing/2014/main" id="{C7C8D27A-7099-4E34-95C0-0E716E7DC96B}"/>
+                <a16:creationId xmlns:a16="http://schemas.microsoft.com/office/drawing/2014/main" id="{312655F3-970D-4709-AE24-666C0D3FD0A7}"/>
               </a:ext>
             </a:extLst>
           </p:cNvPr>
@@ -13051,7 +13051,7 @@
           <p:cNvPr id="6" name="">
             <a:extLst xmlns:a="http://schemas.openxmlformats.org/drawingml/2006/main">
               <a:ext uri="{FF2B5EF4-FFF2-40B4-BE49-F238E27FC236}">
-                <a16:creationId xmlns:a16="http://schemas.microsoft.com/office/drawing/2014/main" id="{B09291A3-8A33-4C43-8BA7-F5707C5C1F16}"/>
+                <a16:creationId xmlns:a16="http://schemas.microsoft.com/office/drawing/2014/main" id="{A842855C-30DD-4E94-870A-DAD763332CAE}"/>
               </a:ext>
             </a:extLst>
           </p:cNvPr>
@@ -13086,7 +13086,7 @@
           <p:cNvPr id="7" name="">
             <a:extLst xmlns:a="http://schemas.openxmlformats.org/drawingml/2006/main">
               <a:ext uri="{FF2B5EF4-FFF2-40B4-BE49-F238E27FC236}">
-                <a16:creationId xmlns:a16="http://schemas.microsoft.com/office/drawing/2014/main" id="{8974674C-B8BC-46D0-AD15-F7CF229EF1AC}"/>
+                <a16:creationId xmlns:a16="http://schemas.microsoft.com/office/drawing/2014/main" id="{2C6CF8DF-4B44-4C42-86C4-148C6D46FF4E}"/>
               </a:ext>
             </a:extLst>
           </p:cNvPr>
@@ -13131,7 +13131,7 @@
           <p:cNvPr id="8" name="">
             <a:extLst xmlns:a="http://schemas.openxmlformats.org/drawingml/2006/main">
               <a:ext uri="{FF2B5EF4-FFF2-40B4-BE49-F238E27FC236}">
-                <a16:creationId xmlns:a16="http://schemas.microsoft.com/office/drawing/2014/main" id="{2DF18FBB-BFB3-4144-A5EB-3F7C67D0C883}"/>
+                <a16:creationId xmlns:a16="http://schemas.microsoft.com/office/drawing/2014/main" id="{FD036E5B-A3FF-4AAB-9F7F-213F5A0857A9}"/>
               </a:ext>
             </a:extLst>
           </p:cNvPr>
@@ -13176,7 +13176,7 @@
           <p:cNvPr id="9" name="">
             <a:extLst xmlns:a="http://schemas.openxmlformats.org/drawingml/2006/main">
               <a:ext uri="{FF2B5EF4-FFF2-40B4-BE49-F238E27FC236}">
-                <a16:creationId xmlns:a16="http://schemas.microsoft.com/office/drawing/2014/main" id="{5A03A583-A00A-4359-B8EF-62A87B6D1FCF}"/>
+                <a16:creationId xmlns:a16="http://schemas.microsoft.com/office/drawing/2014/main" id="{5006A86A-2DBF-46C6-A93C-7BB46D196AD9}"/>
               </a:ext>
             </a:extLst>
           </p:cNvPr>
@@ -13221,7 +13221,7 @@
           <p:cNvPr id="10" name="">
             <a:extLst xmlns:a="http://schemas.openxmlformats.org/drawingml/2006/main">
               <a:ext uri="{FF2B5EF4-FFF2-40B4-BE49-F238E27FC236}">
-                <a16:creationId xmlns:a16="http://schemas.microsoft.com/office/drawing/2014/main" id="{BFED12C1-A95A-4FEA-9D65-7BFF3FA53200}"/>
+                <a16:creationId xmlns:a16="http://schemas.microsoft.com/office/drawing/2014/main" id="{E7A082FB-78A1-4E08-BAFE-8AA31246D4FF}"/>
               </a:ext>
             </a:extLst>
           </p:cNvPr>
@@ -13256,7 +13256,7 @@
           <p:cNvPr id="11" name="">
             <a:extLst xmlns:a="http://schemas.openxmlformats.org/drawingml/2006/main">
               <a:ext uri="{FF2B5EF4-FFF2-40B4-BE49-F238E27FC236}">
-                <a16:creationId xmlns:a16="http://schemas.microsoft.com/office/drawing/2014/main" id="{3D1C9C8F-2B42-4D7B-A534-095100E7CCC2}"/>
+                <a16:creationId xmlns:a16="http://schemas.microsoft.com/office/drawing/2014/main" id="{22BB6ADB-0173-43C5-8DF4-0F2FE9039716}"/>
               </a:ext>
             </a:extLst>
           </p:cNvPr>
@@ -13301,7 +13301,7 @@
           <p:cNvPr id="12" name="">
             <a:extLst xmlns:a="http://schemas.openxmlformats.org/drawingml/2006/main">
               <a:ext uri="{FF2B5EF4-FFF2-40B4-BE49-F238E27FC236}">
-                <a16:creationId xmlns:a16="http://schemas.microsoft.com/office/drawing/2014/main" id="{27E410D2-5AB5-4FE6-AD84-D7126473A02B}"/>
+                <a16:creationId xmlns:a16="http://schemas.microsoft.com/office/drawing/2014/main" id="{6679C48B-9873-4242-89CF-8BCF564043CC}"/>
               </a:ext>
             </a:extLst>
           </p:cNvPr>
@@ -13346,7 +13346,7 @@
           <p:cNvPr id="13" name="">
             <a:extLst xmlns:a="http://schemas.openxmlformats.org/drawingml/2006/main">
               <a:ext uri="{FF2B5EF4-FFF2-40B4-BE49-F238E27FC236}">
-                <a16:creationId xmlns:a16="http://schemas.microsoft.com/office/drawing/2014/main" id="{A1258F47-6A74-4274-811C-027004D3F1D0}"/>
+                <a16:creationId xmlns:a16="http://schemas.microsoft.com/office/drawing/2014/main" id="{86B841C1-43AF-4D5B-A3F7-9A0A71474B82}"/>
               </a:ext>
             </a:extLst>
           </p:cNvPr>
@@ -13391,7 +13391,7 @@
           <p:cNvPr id="14" name="">
             <a:extLst xmlns:a="http://schemas.openxmlformats.org/drawingml/2006/main">
               <a:ext uri="{FF2B5EF4-FFF2-40B4-BE49-F238E27FC236}">
-                <a16:creationId xmlns:a16="http://schemas.microsoft.com/office/drawing/2014/main" id="{A0053EB0-06FB-4B8B-B061-7956598073FA}"/>
+                <a16:creationId xmlns:a16="http://schemas.microsoft.com/office/drawing/2014/main" id="{96AFC1C1-8D72-4327-9522-5389D0B0C61C}"/>
               </a:ext>
             </a:extLst>
           </p:cNvPr>
@@ -13426,7 +13426,7 @@
           <p:cNvPr id="15" name="">
             <a:extLst xmlns:a="http://schemas.openxmlformats.org/drawingml/2006/main">
               <a:ext uri="{FF2B5EF4-FFF2-40B4-BE49-F238E27FC236}">
-                <a16:creationId xmlns:a16="http://schemas.microsoft.com/office/drawing/2014/main" id="{A11907C3-9439-4089-8C1B-485206BB9D0C}"/>
+                <a16:creationId xmlns:a16="http://schemas.microsoft.com/office/drawing/2014/main" id="{9CC0BFDB-AD9B-4712-B0FB-B16C761B67E9}"/>
               </a:ext>
             </a:extLst>
           </p:cNvPr>
@@ -13471,7 +13471,7 @@
           <p:cNvPr id="16" name="">
             <a:extLst xmlns:a="http://schemas.openxmlformats.org/drawingml/2006/main">
               <a:ext uri="{FF2B5EF4-FFF2-40B4-BE49-F238E27FC236}">
-                <a16:creationId xmlns:a16="http://schemas.microsoft.com/office/drawing/2014/main" id="{9F1B45B3-D981-4957-BB78-6D9F94DA232E}"/>
+                <a16:creationId xmlns:a16="http://schemas.microsoft.com/office/drawing/2014/main" id="{8781AE89-92D6-4E02-9A78-E06C7555BE74}"/>
               </a:ext>
             </a:extLst>
           </p:cNvPr>
@@ -13516,7 +13516,7 @@
           <p:cNvPr id="17" name="">
             <a:extLst xmlns:a="http://schemas.openxmlformats.org/drawingml/2006/main">
               <a:ext uri="{FF2B5EF4-FFF2-40B4-BE49-F238E27FC236}">
-                <a16:creationId xmlns:a16="http://schemas.microsoft.com/office/drawing/2014/main" id="{FDC49311-5118-4304-B67B-B922408DD2AD}"/>
+                <a16:creationId xmlns:a16="http://schemas.microsoft.com/office/drawing/2014/main" id="{90BF2C87-2EAB-41F9-BED9-DD800F1BE22B}"/>
               </a:ext>
             </a:extLst>
           </p:cNvPr>
@@ -13561,7 +13561,7 @@
           <p:cNvPr id="18" name="">
             <a:extLst xmlns:a="http://schemas.openxmlformats.org/drawingml/2006/main">
               <a:ext uri="{FF2B5EF4-FFF2-40B4-BE49-F238E27FC236}">
-                <a16:creationId xmlns:a16="http://schemas.microsoft.com/office/drawing/2014/main" id="{169E7EC1-D4F8-4D1B-B6F8-CFD8DC775C71}"/>
+                <a16:creationId xmlns:a16="http://schemas.microsoft.com/office/drawing/2014/main" id="{0B119829-0FCE-4BBC-A53D-A8BA48543D03}"/>
               </a:ext>
             </a:extLst>
           </p:cNvPr>
@@ -13596,7 +13596,7 @@
           <p:cNvPr id="19" name="">
             <a:extLst xmlns:a="http://schemas.openxmlformats.org/drawingml/2006/main">
               <a:ext uri="{FF2B5EF4-FFF2-40B4-BE49-F238E27FC236}">
-                <a16:creationId xmlns:a16="http://schemas.microsoft.com/office/drawing/2014/main" id="{608508C3-1E32-4224-8199-B1A4E99D5D89}"/>
+                <a16:creationId xmlns:a16="http://schemas.microsoft.com/office/drawing/2014/main" id="{8D61F764-8498-4D84-A10F-E532BC2D4FA1}"/>
               </a:ext>
             </a:extLst>
           </p:cNvPr>
@@ -13641,7 +13641,7 @@
           <p:cNvPr id="20" name="">
             <a:extLst xmlns:a="http://schemas.openxmlformats.org/drawingml/2006/main">
               <a:ext uri="{FF2B5EF4-FFF2-40B4-BE49-F238E27FC236}">
-                <a16:creationId xmlns:a16="http://schemas.microsoft.com/office/drawing/2014/main" id="{9FAAF468-881D-475A-B399-DB247AA9EDAC}"/>
+                <a16:creationId xmlns:a16="http://schemas.microsoft.com/office/drawing/2014/main" id="{5763B257-208C-4747-9817-CA48672F2999}"/>
               </a:ext>
             </a:extLst>
           </p:cNvPr>
@@ -13686,7 +13686,7 @@
           <p:cNvPr id="21" name="">
             <a:extLst xmlns:a="http://schemas.openxmlformats.org/drawingml/2006/main">
               <a:ext uri="{FF2B5EF4-FFF2-40B4-BE49-F238E27FC236}">
-                <a16:creationId xmlns:a16="http://schemas.microsoft.com/office/drawing/2014/main" id="{52292AC9-FE12-4DAF-96D1-6E653A592F5C}"/>
+                <a16:creationId xmlns:a16="http://schemas.microsoft.com/office/drawing/2014/main" id="{D1E228C0-DDDC-4E9E-BD8B-171FA0E35854}"/>
               </a:ext>
             </a:extLst>
           </p:cNvPr>
@@ -13731,7 +13731,7 @@
           <p:cNvPr id="22" name="">
             <a:extLst xmlns:a="http://schemas.openxmlformats.org/drawingml/2006/main">
               <a:ext uri="{FF2B5EF4-FFF2-40B4-BE49-F238E27FC236}">
-                <a16:creationId xmlns:a16="http://schemas.microsoft.com/office/drawing/2014/main" id="{1BDB8CB4-6FA6-4AD9-B161-7B9627C5B197}"/>
+                <a16:creationId xmlns:a16="http://schemas.microsoft.com/office/drawing/2014/main" id="{2D6B09FD-49E0-4315-93D6-D13C6D0E66FE}"/>
               </a:ext>
             </a:extLst>
           </p:cNvPr>
@@ -13766,7 +13766,7 @@
           <p:cNvPr id="23" name="">
             <a:extLst xmlns:a="http://schemas.openxmlformats.org/drawingml/2006/main">
               <a:ext uri="{FF2B5EF4-FFF2-40B4-BE49-F238E27FC236}">
-                <a16:creationId xmlns:a16="http://schemas.microsoft.com/office/drawing/2014/main" id="{7500FCD9-8353-402F-82A3-C7C8D389EB06}"/>
+                <a16:creationId xmlns:a16="http://schemas.microsoft.com/office/drawing/2014/main" id="{7CF3F805-9F6B-4BBB-91A4-999FE32C5C34}"/>
               </a:ext>
             </a:extLst>
           </p:cNvPr>
@@ -13811,7 +13811,7 @@
           <p:cNvPr id="24" name="">
             <a:extLst xmlns:a="http://schemas.openxmlformats.org/drawingml/2006/main">
               <a:ext uri="{FF2B5EF4-FFF2-40B4-BE49-F238E27FC236}">
-                <a16:creationId xmlns:a16="http://schemas.microsoft.com/office/drawing/2014/main" id="{0C34539A-7B7B-4BEE-BED8-2079821922B2}"/>
+                <a16:creationId xmlns:a16="http://schemas.microsoft.com/office/drawing/2014/main" id="{BB26CF55-411C-404F-BDFD-F2CA19FA1286}"/>
               </a:ext>
             </a:extLst>
           </p:cNvPr>
@@ -13856,7 +13856,7 @@
           <p:cNvPr id="25" name="footer-left">
             <a:extLst xmlns:a="http://schemas.openxmlformats.org/drawingml/2006/main">
               <a:ext uri="{FF2B5EF4-FFF2-40B4-BE49-F238E27FC236}">
-                <a16:creationId xmlns:a16="http://schemas.microsoft.com/office/drawing/2014/main" id="{4C398A88-584E-4EA0-92A3-C9775D817A5C}"/>
+                <a16:creationId xmlns:a16="http://schemas.microsoft.com/office/drawing/2014/main" id="{D76025CE-823F-411B-A2D7-19F73362011B}"/>
               </a:ext>
             </a:extLst>
           </p:cNvPr>
@@ -13901,7 +13901,7 @@
           <p:cNvPr id="26" name="footer-right">
             <a:extLst xmlns:a="http://schemas.openxmlformats.org/drawingml/2006/main">
               <a:ext uri="{FF2B5EF4-FFF2-40B4-BE49-F238E27FC236}">
-                <a16:creationId xmlns:a16="http://schemas.microsoft.com/office/drawing/2014/main" id="{A8981731-F2F1-44EB-B79B-90B4DC8E967F}"/>
+                <a16:creationId xmlns:a16="http://schemas.microsoft.com/office/drawing/2014/main" id="{9F263B34-C4CF-4ABC-8D9B-C0D77F781289}"/>
               </a:ext>
             </a:extLst>
           </p:cNvPr>
@@ -13944,7 +13944,7 @@
     </p:spTree>
     <p:extLst>
       <p:ext uri="{BB962C8B-B14F-4D97-AF65-F5344CB8AC3E}">
-        <p14:creationId xmlns:p14="http://schemas.microsoft.com/office/powerpoint/2010/main" val="1432048041"/>
+        <p14:creationId xmlns:p14="http://schemas.microsoft.com/office/powerpoint/2010/main" val="594305591"/>
       </p:ext>
     </p:extLst>
   </p:cSld>
@@ -13968,7 +13968,7 @@
           <p:cNvPr id="1" name="slide-stage">
             <a:extLst xmlns:a="http://schemas.openxmlformats.org/drawingml/2006/main">
               <a:ext uri="{FF2B5EF4-FFF2-40B4-BE49-F238E27FC236}">
-                <a16:creationId xmlns:a16="http://schemas.microsoft.com/office/drawing/2014/main" id="{FEEF9632-99FC-4608-AA8F-301603EE7E19}"/>
+                <a16:creationId xmlns:a16="http://schemas.microsoft.com/office/drawing/2014/main" id="{C9DB7840-E7F3-4851-ABDE-F885E0B80ED9}"/>
               </a:ext>
             </a:extLst>
           </p:cNvPr>
@@ -13995,7 +13995,7 @@
           <p:cNvPr id="2" name="eyebrow">
             <a:extLst xmlns:a="http://schemas.openxmlformats.org/drawingml/2006/main">
               <a:ext uri="{FF2B5EF4-FFF2-40B4-BE49-F238E27FC236}">
-                <a16:creationId xmlns:a16="http://schemas.microsoft.com/office/drawing/2014/main" id="{7C5E69A0-F918-4347-9AD7-608AB97A674C}"/>
+                <a16:creationId xmlns:a16="http://schemas.microsoft.com/office/drawing/2014/main" id="{B0C2497B-2E16-4709-8B03-393A15D859BC}"/>
               </a:ext>
             </a:extLst>
           </p:cNvPr>
@@ -14040,7 +14040,7 @@
           <p:cNvPr id="3" name="slide-title">
             <a:extLst xmlns:a="http://schemas.openxmlformats.org/drawingml/2006/main">
               <a:ext uri="{FF2B5EF4-FFF2-40B4-BE49-F238E27FC236}">
-                <a16:creationId xmlns:a16="http://schemas.microsoft.com/office/drawing/2014/main" id="{4A062FAF-FC98-4A5A-9275-F4995115AEC3}"/>
+                <a16:creationId xmlns:a16="http://schemas.microsoft.com/office/drawing/2014/main" id="{3DE4BCAD-9094-4480-9211-08CE3AB335DF}"/>
               </a:ext>
             </a:extLst>
           </p:cNvPr>
@@ -14085,7 +14085,7 @@
           <p:cNvPr id="4" name="slide-subtitle">
             <a:extLst xmlns:a="http://schemas.openxmlformats.org/drawingml/2006/main">
               <a:ext uri="{FF2B5EF4-FFF2-40B4-BE49-F238E27FC236}">
-                <a16:creationId xmlns:a16="http://schemas.microsoft.com/office/drawing/2014/main" id="{A648F949-D4E2-46C1-811E-25C35B07CB3A}"/>
+                <a16:creationId xmlns:a16="http://schemas.microsoft.com/office/drawing/2014/main" id="{0B351630-E8E6-4A39-882F-A1D7423D8F6C}"/>
               </a:ext>
             </a:extLst>
           </p:cNvPr>
@@ -14130,7 +14130,7 @@
           <p:cNvPr id="5" name="">
             <a:extLst xmlns:a="http://schemas.openxmlformats.org/drawingml/2006/main">
               <a:ext uri="{FF2B5EF4-FFF2-40B4-BE49-F238E27FC236}">
-                <a16:creationId xmlns:a16="http://schemas.microsoft.com/office/drawing/2014/main" id="{32508BC5-798B-4361-8343-A2505A255023}"/>
+                <a16:creationId xmlns:a16="http://schemas.microsoft.com/office/drawing/2014/main" id="{6DA760E6-FE52-4343-9F70-FAB5D22966E8}"/>
               </a:ext>
             </a:extLst>
           </p:cNvPr>
@@ -14163,7 +14163,7 @@
           <p:cNvPr id="6" name="">
             <a:extLst xmlns:a="http://schemas.openxmlformats.org/drawingml/2006/main">
               <a:ext uri="{FF2B5EF4-FFF2-40B4-BE49-F238E27FC236}">
-                <a16:creationId xmlns:a16="http://schemas.microsoft.com/office/drawing/2014/main" id="{291D4CFE-78BC-41DF-B28B-6A720A601552}"/>
+                <a16:creationId xmlns:a16="http://schemas.microsoft.com/office/drawing/2014/main" id="{25663392-9E71-49E0-9AB7-92BD89B467A8}"/>
               </a:ext>
             </a:extLst>
           </p:cNvPr>
@@ -14208,7 +14208,7 @@
           <p:cNvPr id="7" name="">
             <a:extLst xmlns:a="http://schemas.openxmlformats.org/drawingml/2006/main">
               <a:ext uri="{FF2B5EF4-FFF2-40B4-BE49-F238E27FC236}">
-                <a16:creationId xmlns:a16="http://schemas.microsoft.com/office/drawing/2014/main" id="{E94A8E33-D1EB-495E-9337-DC38680031AD}"/>
+                <a16:creationId xmlns:a16="http://schemas.microsoft.com/office/drawing/2014/main" id="{FAA55A78-A15B-414E-9A72-A3D46A006545}"/>
               </a:ext>
             </a:extLst>
           </p:cNvPr>
@@ -14253,7 +14253,7 @@
           <p:cNvPr id="8" name="">
             <a:extLst xmlns:a="http://schemas.openxmlformats.org/drawingml/2006/main">
               <a:ext uri="{FF2B5EF4-FFF2-40B4-BE49-F238E27FC236}">
-                <a16:creationId xmlns:a16="http://schemas.microsoft.com/office/drawing/2014/main" id="{ACB59632-B3AD-4C8A-A0AA-DD97367E162C}"/>
+                <a16:creationId xmlns:a16="http://schemas.microsoft.com/office/drawing/2014/main" id="{1BF45004-B908-461B-AB4A-2BF9E997B214}"/>
               </a:ext>
             </a:extLst>
           </p:cNvPr>
@@ -14286,7 +14286,7 @@
           <p:cNvPr id="9" name="">
             <a:extLst xmlns:a="http://schemas.openxmlformats.org/drawingml/2006/main">
               <a:ext uri="{FF2B5EF4-FFF2-40B4-BE49-F238E27FC236}">
-                <a16:creationId xmlns:a16="http://schemas.microsoft.com/office/drawing/2014/main" id="{1D78E814-CC1E-4AD5-B29C-DD6922D79AE3}"/>
+                <a16:creationId xmlns:a16="http://schemas.microsoft.com/office/drawing/2014/main" id="{4B8232E8-E35D-49CE-A2A0-ACC46FF9DDE5}"/>
               </a:ext>
             </a:extLst>
           </p:cNvPr>
@@ -14331,7 +14331,7 @@
           <p:cNvPr id="10" name="">
             <a:extLst xmlns:a="http://schemas.openxmlformats.org/drawingml/2006/main">
               <a:ext uri="{FF2B5EF4-FFF2-40B4-BE49-F238E27FC236}">
-                <a16:creationId xmlns:a16="http://schemas.microsoft.com/office/drawing/2014/main" id="{04D7483E-480F-4C20-B222-4C9CAFA9640D}"/>
+                <a16:creationId xmlns:a16="http://schemas.microsoft.com/office/drawing/2014/main" id="{9D0F5123-AE2D-4C25-B5E9-00C96D6DA1AB}"/>
               </a:ext>
             </a:extLst>
           </p:cNvPr>
@@ -14376,7 +14376,7 @@
           <p:cNvPr id="11" name="">
             <a:extLst xmlns:a="http://schemas.openxmlformats.org/drawingml/2006/main">
               <a:ext uri="{FF2B5EF4-FFF2-40B4-BE49-F238E27FC236}">
-                <a16:creationId xmlns:a16="http://schemas.microsoft.com/office/drawing/2014/main" id="{91B845EF-1E83-43D1-A5B3-7A499165EE6D}"/>
+                <a16:creationId xmlns:a16="http://schemas.microsoft.com/office/drawing/2014/main" id="{5E78F8A9-078D-40B4-8D65-BD8A17E83C16}"/>
               </a:ext>
             </a:extLst>
           </p:cNvPr>
@@ -14409,7 +14409,7 @@
           <p:cNvPr id="12" name="">
             <a:extLst xmlns:a="http://schemas.openxmlformats.org/drawingml/2006/main">
               <a:ext uri="{FF2B5EF4-FFF2-40B4-BE49-F238E27FC236}">
-                <a16:creationId xmlns:a16="http://schemas.microsoft.com/office/drawing/2014/main" id="{1D21E08B-19AF-494A-B708-9FBAC93F3156}"/>
+                <a16:creationId xmlns:a16="http://schemas.microsoft.com/office/drawing/2014/main" id="{884899CD-8824-48B2-867B-4153508EF9EE}"/>
               </a:ext>
             </a:extLst>
           </p:cNvPr>
@@ -14454,7 +14454,7 @@
           <p:cNvPr id="13" name="">
             <a:extLst xmlns:a="http://schemas.openxmlformats.org/drawingml/2006/main">
               <a:ext uri="{FF2B5EF4-FFF2-40B4-BE49-F238E27FC236}">
-                <a16:creationId xmlns:a16="http://schemas.microsoft.com/office/drawing/2014/main" id="{6D944758-8C6C-4C0E-87A3-4BB3B797C3F9}"/>
+                <a16:creationId xmlns:a16="http://schemas.microsoft.com/office/drawing/2014/main" id="{54FF87CD-142B-4827-A96C-2553CFAA41FF}"/>
               </a:ext>
             </a:extLst>
           </p:cNvPr>
@@ -14499,7 +14499,7 @@
           <p:cNvPr id="14" name="">
             <a:extLst xmlns:a="http://schemas.openxmlformats.org/drawingml/2006/main">
               <a:ext uri="{FF2B5EF4-FFF2-40B4-BE49-F238E27FC236}">
-                <a16:creationId xmlns:a16="http://schemas.microsoft.com/office/drawing/2014/main" id="{99706958-E18F-4935-BF98-2DD670546139}"/>
+                <a16:creationId xmlns:a16="http://schemas.microsoft.com/office/drawing/2014/main" id="{397127EA-C08A-47BE-BD43-2A2FB1270F1B}"/>
               </a:ext>
             </a:extLst>
           </p:cNvPr>
@@ -14532,7 +14532,7 @@
           <p:cNvPr id="15" name="">
             <a:extLst xmlns:a="http://schemas.openxmlformats.org/drawingml/2006/main">
               <a:ext uri="{FF2B5EF4-FFF2-40B4-BE49-F238E27FC236}">
-                <a16:creationId xmlns:a16="http://schemas.microsoft.com/office/drawing/2014/main" id="{F2EE26A7-E1F0-4097-8E0B-30E897912892}"/>
+                <a16:creationId xmlns:a16="http://schemas.microsoft.com/office/drawing/2014/main" id="{520DA27F-8467-44EF-8067-3FB52FA68C14}"/>
               </a:ext>
             </a:extLst>
           </p:cNvPr>
@@ -14577,7 +14577,7 @@
           <p:cNvPr id="16" name="">
             <a:extLst xmlns:a="http://schemas.openxmlformats.org/drawingml/2006/main">
               <a:ext uri="{FF2B5EF4-FFF2-40B4-BE49-F238E27FC236}">
-                <a16:creationId xmlns:a16="http://schemas.microsoft.com/office/drawing/2014/main" id="{3B4A5795-1116-4D5F-B046-E838E208BD1E}"/>
+                <a16:creationId xmlns:a16="http://schemas.microsoft.com/office/drawing/2014/main" id="{C8C5A873-1454-4D9D-8041-B0F59B941853}"/>
               </a:ext>
             </a:extLst>
           </p:cNvPr>
@@ -14622,7 +14622,7 @@
           <p:cNvPr id="17" name="footer-left">
             <a:extLst xmlns:a="http://schemas.openxmlformats.org/drawingml/2006/main">
               <a:ext uri="{FF2B5EF4-FFF2-40B4-BE49-F238E27FC236}">
-                <a16:creationId xmlns:a16="http://schemas.microsoft.com/office/drawing/2014/main" id="{996F7236-89E6-430C-B2D6-53423E314982}"/>
+                <a16:creationId xmlns:a16="http://schemas.microsoft.com/office/drawing/2014/main" id="{CB11AE16-0A67-456E-963F-BB848DECBA9A}"/>
               </a:ext>
             </a:extLst>
           </p:cNvPr>
@@ -14667,7 +14667,7 @@
           <p:cNvPr id="18" name="footer-right">
             <a:extLst xmlns:a="http://schemas.openxmlformats.org/drawingml/2006/main">
               <a:ext uri="{FF2B5EF4-FFF2-40B4-BE49-F238E27FC236}">
-                <a16:creationId xmlns:a16="http://schemas.microsoft.com/office/drawing/2014/main" id="{896CBBAE-C5B0-4A66-B213-F10D54838BA0}"/>
+                <a16:creationId xmlns:a16="http://schemas.microsoft.com/office/drawing/2014/main" id="{65AEAE08-D30D-4BB3-AC4D-E4EFEFE8E104}"/>
               </a:ext>
             </a:extLst>
           </p:cNvPr>
@@ -14710,7 +14710,7 @@
     </p:spTree>
     <p:extLst>
       <p:ext uri="{BB962C8B-B14F-4D97-AF65-F5344CB8AC3E}">
-        <p14:creationId xmlns:p14="http://schemas.microsoft.com/office/powerpoint/2010/main" val="930167189"/>
+        <p14:creationId xmlns:p14="http://schemas.microsoft.com/office/powerpoint/2010/main" val="1670310892"/>
       </p:ext>
     </p:extLst>
   </p:cSld>
@@ -14734,7 +14734,7 @@
           <p:cNvPr id="1" name="slide-stage">
             <a:extLst xmlns:a="http://schemas.openxmlformats.org/drawingml/2006/main">
               <a:ext uri="{FF2B5EF4-FFF2-40B4-BE49-F238E27FC236}">
-                <a16:creationId xmlns:a16="http://schemas.microsoft.com/office/drawing/2014/main" id="{AB26B5DD-4366-49D9-97DC-E82A2912D0D0}"/>
+                <a16:creationId xmlns:a16="http://schemas.microsoft.com/office/drawing/2014/main" id="{9C4018C4-0B3C-42F1-B744-AC655B88C9C9}"/>
               </a:ext>
             </a:extLst>
           </p:cNvPr>
@@ -14761,7 +14761,7 @@
           <p:cNvPr id="2" name="eyebrow">
             <a:extLst xmlns:a="http://schemas.openxmlformats.org/drawingml/2006/main">
               <a:ext uri="{FF2B5EF4-FFF2-40B4-BE49-F238E27FC236}">
-                <a16:creationId xmlns:a16="http://schemas.microsoft.com/office/drawing/2014/main" id="{88D12A8D-64F9-496C-8530-C90A1493D4FA}"/>
+                <a16:creationId xmlns:a16="http://schemas.microsoft.com/office/drawing/2014/main" id="{FD48E631-58AD-46E2-BFF5-450527C59DB0}"/>
               </a:ext>
             </a:extLst>
           </p:cNvPr>
@@ -14806,7 +14806,7 @@
           <p:cNvPr id="3" name="slide-title">
             <a:extLst xmlns:a="http://schemas.openxmlformats.org/drawingml/2006/main">
               <a:ext uri="{FF2B5EF4-FFF2-40B4-BE49-F238E27FC236}">
-                <a16:creationId xmlns:a16="http://schemas.microsoft.com/office/drawing/2014/main" id="{F34DEDF7-E925-4210-A156-98226AB97AD8}"/>
+                <a16:creationId xmlns:a16="http://schemas.microsoft.com/office/drawing/2014/main" id="{56194603-C43F-40AC-ADCC-FE900D9B679F}"/>
               </a:ext>
             </a:extLst>
           </p:cNvPr>
@@ -14851,7 +14851,7 @@
           <p:cNvPr id="4" name="slide-subtitle">
             <a:extLst xmlns:a="http://schemas.openxmlformats.org/drawingml/2006/main">
               <a:ext uri="{FF2B5EF4-FFF2-40B4-BE49-F238E27FC236}">
-                <a16:creationId xmlns:a16="http://schemas.microsoft.com/office/drawing/2014/main" id="{4921C511-D4B9-4CDA-9B6E-3195F0B46944}"/>
+                <a16:creationId xmlns:a16="http://schemas.microsoft.com/office/drawing/2014/main" id="{6377ECB4-6C5F-4487-BDF2-905A8F33A960}"/>
               </a:ext>
             </a:extLst>
           </p:cNvPr>
@@ -14896,7 +14896,7 @@
           <p:cNvPr id="5" name="">
             <a:extLst xmlns:a="http://schemas.openxmlformats.org/drawingml/2006/main">
               <a:ext uri="{FF2B5EF4-FFF2-40B4-BE49-F238E27FC236}">
-                <a16:creationId xmlns:a16="http://schemas.microsoft.com/office/drawing/2014/main" id="{2963B7DF-6FF7-46E5-B176-204030120FAA}"/>
+                <a16:creationId xmlns:a16="http://schemas.microsoft.com/office/drawing/2014/main" id="{94655EEE-CF42-4C32-A2EC-502F19762F46}"/>
               </a:ext>
             </a:extLst>
           </p:cNvPr>
@@ -14941,7 +14941,7 @@
           <p:cNvPr id="6" name="">
             <a:extLst xmlns:a="http://schemas.openxmlformats.org/drawingml/2006/main">
               <a:ext uri="{FF2B5EF4-FFF2-40B4-BE49-F238E27FC236}">
-                <a16:creationId xmlns:a16="http://schemas.microsoft.com/office/drawing/2014/main" id="{EC4B77FB-4835-47C5-A2AC-157B49490486}"/>
+                <a16:creationId xmlns:a16="http://schemas.microsoft.com/office/drawing/2014/main" id="{39A7D61B-E49A-4339-91C7-651ABE26D953}"/>
               </a:ext>
             </a:extLst>
           </p:cNvPr>
@@ -14986,7 +14986,7 @@
           <p:cNvPr id="7" name="">
             <a:extLst xmlns:a="http://schemas.openxmlformats.org/drawingml/2006/main">
               <a:ext uri="{FF2B5EF4-FFF2-40B4-BE49-F238E27FC236}">
-                <a16:creationId xmlns:a16="http://schemas.microsoft.com/office/drawing/2014/main" id="{2573F034-3789-4DE6-A255-DEA617F0333E}"/>
+                <a16:creationId xmlns:a16="http://schemas.microsoft.com/office/drawing/2014/main" id="{28BBA2A4-DFF5-40ED-BE4D-9BBCB1D90E29}"/>
               </a:ext>
             </a:extLst>
           </p:cNvPr>
@@ -15031,7 +15031,7 @@
           <p:cNvPr id="8" name="">
             <a:extLst xmlns:a="http://schemas.openxmlformats.org/drawingml/2006/main">
               <a:ext uri="{FF2B5EF4-FFF2-40B4-BE49-F238E27FC236}">
-                <a16:creationId xmlns:a16="http://schemas.microsoft.com/office/drawing/2014/main" id="{A079A3E4-78F4-4B1A-95BB-F77E2EA8D5A5}"/>
+                <a16:creationId xmlns:a16="http://schemas.microsoft.com/office/drawing/2014/main" id="{B5B6A4D1-4A6F-4CF5-A904-846B9B786302}"/>
               </a:ext>
             </a:extLst>
           </p:cNvPr>
@@ -15076,7 +15076,7 @@
           <p:cNvPr id="9" name="">
             <a:extLst xmlns:a="http://schemas.openxmlformats.org/drawingml/2006/main">
               <a:ext uri="{FF2B5EF4-FFF2-40B4-BE49-F238E27FC236}">
-                <a16:creationId xmlns:a16="http://schemas.microsoft.com/office/drawing/2014/main" id="{C4D0F2B7-A886-4990-AC55-D6D26610096D}"/>
+                <a16:creationId xmlns:a16="http://schemas.microsoft.com/office/drawing/2014/main" id="{26CB5549-6992-466F-8D02-C1535E004CE6}"/>
               </a:ext>
             </a:extLst>
           </p:cNvPr>
@@ -15121,7 +15121,7 @@
           <p:cNvPr id="10" name="">
             <a:extLst xmlns:a="http://schemas.openxmlformats.org/drawingml/2006/main">
               <a:ext uri="{FF2B5EF4-FFF2-40B4-BE49-F238E27FC236}">
-                <a16:creationId xmlns:a16="http://schemas.microsoft.com/office/drawing/2014/main" id="{6FF988AF-35F2-426B-A120-20691235EAA9}"/>
+                <a16:creationId xmlns:a16="http://schemas.microsoft.com/office/drawing/2014/main" id="{3C7FB149-09D7-445C-A57B-F9DCF227B937}"/>
               </a:ext>
             </a:extLst>
           </p:cNvPr>
@@ -15166,7 +15166,7 @@
           <p:cNvPr id="11" name="">
             <a:extLst xmlns:a="http://schemas.openxmlformats.org/drawingml/2006/main">
               <a:ext uri="{FF2B5EF4-FFF2-40B4-BE49-F238E27FC236}">
-                <a16:creationId xmlns:a16="http://schemas.microsoft.com/office/drawing/2014/main" id="{2BEEB487-23E0-4E7B-AEF9-A561095B71D3}"/>
+                <a16:creationId xmlns:a16="http://schemas.microsoft.com/office/drawing/2014/main" id="{8EC68C01-85BD-4A78-9A80-8A7FECFD9A72}"/>
               </a:ext>
             </a:extLst>
           </p:cNvPr>
@@ -15201,7 +15201,7 @@
           <p:cNvPr id="12" name="">
             <a:extLst xmlns:a="http://schemas.openxmlformats.org/drawingml/2006/main">
               <a:ext uri="{FF2B5EF4-FFF2-40B4-BE49-F238E27FC236}">
-                <a16:creationId xmlns:a16="http://schemas.microsoft.com/office/drawing/2014/main" id="{DDBB4879-2BA0-4BDC-A202-E2A9FD54669F}"/>
+                <a16:creationId xmlns:a16="http://schemas.microsoft.com/office/drawing/2014/main" id="{282AD749-2193-44AB-9DF1-F7F69EE4D90D}"/>
               </a:ext>
             </a:extLst>
           </p:cNvPr>
@@ -15236,7 +15236,7 @@
                   <a:srgbClr val="08756F"/>
                 </a:solidFill>
               </a:rPr>
-              <a:t>329 tests passed</a:t>
+              <a:t>330 tests passed</a:t>
             </a:r>
           </a:p>
         </p:txBody>
@@ -15246,7 +15246,7 @@
           <p:cNvPr id="13" name="">
             <a:extLst xmlns:a="http://schemas.openxmlformats.org/drawingml/2006/main">
               <a:ext uri="{FF2B5EF4-FFF2-40B4-BE49-F238E27FC236}">
-                <a16:creationId xmlns:a16="http://schemas.microsoft.com/office/drawing/2014/main" id="{4469B3C6-4E86-40FD-A59B-D91E22A2BA1D}"/>
+                <a16:creationId xmlns:a16="http://schemas.microsoft.com/office/drawing/2014/main" id="{F5D93687-B917-4688-90B5-B0F37D1434FF}"/>
               </a:ext>
             </a:extLst>
           </p:cNvPr>
@@ -15281,7 +15281,7 @@
           <p:cNvPr id="14" name="">
             <a:extLst xmlns:a="http://schemas.openxmlformats.org/drawingml/2006/main">
               <a:ext uri="{FF2B5EF4-FFF2-40B4-BE49-F238E27FC236}">
-                <a16:creationId xmlns:a16="http://schemas.microsoft.com/office/drawing/2014/main" id="{D537DCE2-3C2A-4279-AF63-7EC9734801B2}"/>
+                <a16:creationId xmlns:a16="http://schemas.microsoft.com/office/drawing/2014/main" id="{A9A55F02-AEF6-4DFE-AEE7-75CDFE3DDE70}"/>
               </a:ext>
             </a:extLst>
           </p:cNvPr>
@@ -15326,7 +15326,7 @@
           <p:cNvPr id="15" name="">
             <a:extLst xmlns:a="http://schemas.openxmlformats.org/drawingml/2006/main">
               <a:ext uri="{FF2B5EF4-FFF2-40B4-BE49-F238E27FC236}">
-                <a16:creationId xmlns:a16="http://schemas.microsoft.com/office/drawing/2014/main" id="{C229A0F6-54D7-437E-8671-1890C12E3B1F}"/>
+                <a16:creationId xmlns:a16="http://schemas.microsoft.com/office/drawing/2014/main" id="{23FADA23-58D3-452F-A0C8-2D67D1684E99}"/>
               </a:ext>
             </a:extLst>
           </p:cNvPr>
@@ -15361,7 +15361,7 @@
           <p:cNvPr id="16" name="">
             <a:extLst xmlns:a="http://schemas.openxmlformats.org/drawingml/2006/main">
               <a:ext uri="{FF2B5EF4-FFF2-40B4-BE49-F238E27FC236}">
-                <a16:creationId xmlns:a16="http://schemas.microsoft.com/office/drawing/2014/main" id="{54300004-E988-49DB-9835-F662F097CE03}"/>
+                <a16:creationId xmlns:a16="http://schemas.microsoft.com/office/drawing/2014/main" id="{916EF8AF-F7D5-4A60-AE6F-817AFF9BEFA5}"/>
               </a:ext>
             </a:extLst>
           </p:cNvPr>
@@ -15406,7 +15406,7 @@
           <p:cNvPr id="17" name="footer-left">
             <a:extLst xmlns:a="http://schemas.openxmlformats.org/drawingml/2006/main">
               <a:ext uri="{FF2B5EF4-FFF2-40B4-BE49-F238E27FC236}">
-                <a16:creationId xmlns:a16="http://schemas.microsoft.com/office/drawing/2014/main" id="{FC20BF4D-6C6C-4F8D-B14C-CBFBB5E38B7D}"/>
+                <a16:creationId xmlns:a16="http://schemas.microsoft.com/office/drawing/2014/main" id="{9760B938-E88F-4905-87D4-AA5556CB7A0A}"/>
               </a:ext>
             </a:extLst>
           </p:cNvPr>
@@ -15451,7 +15451,7 @@
           <p:cNvPr id="18" name="footer-right">
             <a:extLst xmlns:a="http://schemas.openxmlformats.org/drawingml/2006/main">
               <a:ext uri="{FF2B5EF4-FFF2-40B4-BE49-F238E27FC236}">
-                <a16:creationId xmlns:a16="http://schemas.microsoft.com/office/drawing/2014/main" id="{03D49773-DD03-4E91-87DF-6EE280F12C08}"/>
+                <a16:creationId xmlns:a16="http://schemas.microsoft.com/office/drawing/2014/main" id="{1E2A67BE-A5CD-4817-9318-34BFACB55139}"/>
               </a:ext>
             </a:extLst>
           </p:cNvPr>
@@ -15494,7 +15494,7 @@
     </p:spTree>
     <p:extLst>
       <p:ext uri="{BB962C8B-B14F-4D97-AF65-F5344CB8AC3E}">
-        <p14:creationId xmlns:p14="http://schemas.microsoft.com/office/powerpoint/2010/main" val="585180545"/>
+        <p14:creationId xmlns:p14="http://schemas.microsoft.com/office/powerpoint/2010/main" val="880011752"/>
       </p:ext>
     </p:extLst>
   </p:cSld>

</xml_diff>

<commit_message>
Make transcript intake the primary workflow
</commit_message>
<xml_diff>
--- a/decks/clinsafer-interview-demo/output/output.pptx
+++ b/decks/clinsafer-interview-demo/output/output.pptx
@@ -2,28 +2,28 @@
 <file path=ppt/presentation.xml><?xml version="1.0" encoding="utf-8"?>
 <p:presentation xmlns:p="http://schemas.openxmlformats.org/presentationml/2006/main">
   <p:sldMasterIdLst>
-    <p:sldMasterId xmlns:r="http://schemas.openxmlformats.org/officeDocument/2006/relationships" id="2147483648" r:id="R6c5d7a63f0194495"/>
+    <p:sldMasterId xmlns:r="http://schemas.openxmlformats.org/officeDocument/2006/relationships" id="2147483648" r:id="R71306ee5153842a5"/>
   </p:sldMasterIdLst>
   <p:notesMasterIdLst>
-    <p:notesMasterId xmlns:r="http://schemas.openxmlformats.org/officeDocument/2006/relationships" r:id="R1dfbd57421e7402d"/>
+    <p:notesMasterId xmlns:r="http://schemas.openxmlformats.org/officeDocument/2006/relationships" r:id="Rb4215a4d4120423d"/>
   </p:notesMasterIdLst>
   <p:sldIdLst>
-    <p:sldId xmlns:r="http://schemas.openxmlformats.org/officeDocument/2006/relationships" id="256" r:id="R1733d9cd8d854999"/>
-    <p:sldId xmlns:r="http://schemas.openxmlformats.org/officeDocument/2006/relationships" id="257" r:id="Rac6bd8add575434b"/>
-    <p:sldId xmlns:r="http://schemas.openxmlformats.org/officeDocument/2006/relationships" id="258" r:id="Rd1f3892d53504831"/>
-    <p:sldId xmlns:r="http://schemas.openxmlformats.org/officeDocument/2006/relationships" id="259" r:id="Rdab1e7b064994a02"/>
-    <p:sldId xmlns:r="http://schemas.openxmlformats.org/officeDocument/2006/relationships" id="260" r:id="Ra3082c7710c04aec"/>
-    <p:sldId xmlns:r="http://schemas.openxmlformats.org/officeDocument/2006/relationships" id="261" r:id="Rff5c1f8753784cea"/>
-    <p:sldId xmlns:r="http://schemas.openxmlformats.org/officeDocument/2006/relationships" id="262" r:id="Rf5effb1151b84f54"/>
-    <p:sldId xmlns:r="http://schemas.openxmlformats.org/officeDocument/2006/relationships" id="263" r:id="R200bad3f6b224fa0"/>
-    <p:sldId xmlns:r="http://schemas.openxmlformats.org/officeDocument/2006/relationships" id="264" r:id="R2b97b1df3de14bd4"/>
-    <p:sldId xmlns:r="http://schemas.openxmlformats.org/officeDocument/2006/relationships" id="265" r:id="R0a41a3ab02914235"/>
-    <p:sldId xmlns:r="http://schemas.openxmlformats.org/officeDocument/2006/relationships" id="266" r:id="Rd083746f98ec4d9b"/>
-    <p:sldId xmlns:r="http://schemas.openxmlformats.org/officeDocument/2006/relationships" id="267" r:id="Rca81ae1802484434"/>
-    <p:sldId xmlns:r="http://schemas.openxmlformats.org/officeDocument/2006/relationships" id="268" r:id="R1be49dae42144c87"/>
-    <p:sldId xmlns:r="http://schemas.openxmlformats.org/officeDocument/2006/relationships" id="269" r:id="Rbddb5fd6b7bf4f61"/>
-    <p:sldId xmlns:r="http://schemas.openxmlformats.org/officeDocument/2006/relationships" id="270" r:id="R60963dd063f94aca"/>
-    <p:sldId xmlns:r="http://schemas.openxmlformats.org/officeDocument/2006/relationships" id="271" r:id="R49b4742d42284d67"/>
+    <p:sldId xmlns:r="http://schemas.openxmlformats.org/officeDocument/2006/relationships" id="256" r:id="Re07794cec6f249d4"/>
+    <p:sldId xmlns:r="http://schemas.openxmlformats.org/officeDocument/2006/relationships" id="257" r:id="R652f8e453e5144a0"/>
+    <p:sldId xmlns:r="http://schemas.openxmlformats.org/officeDocument/2006/relationships" id="258" r:id="Rd9e31df618db4849"/>
+    <p:sldId xmlns:r="http://schemas.openxmlformats.org/officeDocument/2006/relationships" id="259" r:id="R8e5859fc0f3f4422"/>
+    <p:sldId xmlns:r="http://schemas.openxmlformats.org/officeDocument/2006/relationships" id="260" r:id="R19b5b9aaaac24bcf"/>
+    <p:sldId xmlns:r="http://schemas.openxmlformats.org/officeDocument/2006/relationships" id="261" r:id="R20ecb1d858e5490c"/>
+    <p:sldId xmlns:r="http://schemas.openxmlformats.org/officeDocument/2006/relationships" id="262" r:id="R939acde7ddf845ae"/>
+    <p:sldId xmlns:r="http://schemas.openxmlformats.org/officeDocument/2006/relationships" id="263" r:id="R1a65f8ef9fbd4b8f"/>
+    <p:sldId xmlns:r="http://schemas.openxmlformats.org/officeDocument/2006/relationships" id="264" r:id="R8a6237acc2c04b16"/>
+    <p:sldId xmlns:r="http://schemas.openxmlformats.org/officeDocument/2006/relationships" id="265" r:id="Rcbc61d3ff1784330"/>
+    <p:sldId xmlns:r="http://schemas.openxmlformats.org/officeDocument/2006/relationships" id="266" r:id="Rc3eb430a02864404"/>
+    <p:sldId xmlns:r="http://schemas.openxmlformats.org/officeDocument/2006/relationships" id="267" r:id="R8f2a168c594e4893"/>
+    <p:sldId xmlns:r="http://schemas.openxmlformats.org/officeDocument/2006/relationships" id="268" r:id="Rceb856d306db460c"/>
+    <p:sldId xmlns:r="http://schemas.openxmlformats.org/officeDocument/2006/relationships" id="269" r:id="Rb0f4c95d173648f5"/>
+    <p:sldId xmlns:r="http://schemas.openxmlformats.org/officeDocument/2006/relationships" id="270" r:id="R81dce22f1bd04dae"/>
+    <p:sldId xmlns:r="http://schemas.openxmlformats.org/officeDocument/2006/relationships" id="271" r:id="Rfeb41aa398504f33"/>
   </p:sldIdLst>
   <p:sldSz cx="18288000" cy="10287000"/>
   <p:notesSz cx="6858000" cy="9144000"/>
@@ -2239,7 +2239,7 @@
   </p:cSld>
   <p:clrMap bg1="lt1" tx1="dk1" bg2="lt2" tx2="dk2" accent1="accent1" accent2="accent2" accent3="accent3" accent4="accent4" accent5="accent5" accent6="accent6" hlink="hlink" folHlink="folHlink"/>
   <p:sldLayoutIdLst>
-    <p:sldLayoutId xmlns:r="http://schemas.openxmlformats.org/officeDocument/2006/relationships" id="2147483649" r:id="R5463909fe89343ae"/>
+    <p:sldLayoutId xmlns:r="http://schemas.openxmlformats.org/officeDocument/2006/relationships" id="2147483649" r:id="R6c99f4999d5b499b"/>
   </p:sldLayoutIdLst>
   <p:txStyles>
     <p:titleStyle>
@@ -2538,7 +2538,7 @@
           <p:cNvPr id="1" name="cover-stage">
             <a:extLst xmlns:a="http://schemas.openxmlformats.org/drawingml/2006/main">
               <a:ext uri="{FF2B5EF4-FFF2-40B4-BE49-F238E27FC236}">
-                <a16:creationId xmlns:a16="http://schemas.microsoft.com/office/drawing/2014/main" id="{FFA05298-8857-4B02-9DE4-74E80624AD7B}"/>
+                <a16:creationId xmlns:a16="http://schemas.microsoft.com/office/drawing/2014/main" id="{A30237BF-AA81-43A4-93AD-4B655DB76830}"/>
               </a:ext>
             </a:extLst>
           </p:cNvPr>
@@ -2565,7 +2565,7 @@
           <p:cNvPr id="2" name="">
             <a:extLst xmlns:a="http://schemas.openxmlformats.org/drawingml/2006/main">
               <a:ext uri="{FF2B5EF4-FFF2-40B4-BE49-F238E27FC236}">
-                <a16:creationId xmlns:a16="http://schemas.microsoft.com/office/drawing/2014/main" id="{C64D3FDF-6626-4970-9C13-ACA86FBC5DFB}"/>
+                <a16:creationId xmlns:a16="http://schemas.microsoft.com/office/drawing/2014/main" id="{794FE17F-79D7-47DA-8570-907EE3C17FD4}"/>
               </a:ext>
             </a:extLst>
           </p:cNvPr>
@@ -2610,7 +2610,7 @@
           <p:cNvPr id="3" name="cover-title">
             <a:extLst xmlns:a="http://schemas.openxmlformats.org/drawingml/2006/main">
               <a:ext uri="{FF2B5EF4-FFF2-40B4-BE49-F238E27FC236}">
-                <a16:creationId xmlns:a16="http://schemas.microsoft.com/office/drawing/2014/main" id="{4A339B06-E96A-4439-93F6-9EFCFF8A2F84}"/>
+                <a16:creationId xmlns:a16="http://schemas.microsoft.com/office/drawing/2014/main" id="{2BC88DD1-FD26-4553-A9B3-B1E30C46AE28}"/>
               </a:ext>
             </a:extLst>
           </p:cNvPr>
@@ -2655,7 +2655,7 @@
           <p:cNvPr id="4" name="">
             <a:extLst xmlns:a="http://schemas.openxmlformats.org/drawingml/2006/main">
               <a:ext uri="{FF2B5EF4-FFF2-40B4-BE49-F238E27FC236}">
-                <a16:creationId xmlns:a16="http://schemas.microsoft.com/office/drawing/2014/main" id="{D8B78E09-4FD9-436A-9D8C-DDFC28A1BFC2}"/>
+                <a16:creationId xmlns:a16="http://schemas.microsoft.com/office/drawing/2014/main" id="{ED9DB5E8-48E6-4D2E-8485-8A0702CD4E08}"/>
               </a:ext>
             </a:extLst>
           </p:cNvPr>
@@ -2688,7 +2688,7 @@
           <p:cNvPr id="5" name="">
             <a:extLst xmlns:a="http://schemas.openxmlformats.org/drawingml/2006/main">
               <a:ext uri="{FF2B5EF4-FFF2-40B4-BE49-F238E27FC236}">
-                <a16:creationId xmlns:a16="http://schemas.microsoft.com/office/drawing/2014/main" id="{CB28D5C8-02B0-4215-8D00-327113D62561}"/>
+                <a16:creationId xmlns:a16="http://schemas.microsoft.com/office/drawing/2014/main" id="{F954A73E-6DE4-4EE3-BF69-5CD81490921D}"/>
               </a:ext>
             </a:extLst>
           </p:cNvPr>
@@ -2733,7 +2733,7 @@
           <p:cNvPr id="6" name="">
             <a:extLst xmlns:a="http://schemas.openxmlformats.org/drawingml/2006/main">
               <a:ext uri="{FF2B5EF4-FFF2-40B4-BE49-F238E27FC236}">
-                <a16:creationId xmlns:a16="http://schemas.microsoft.com/office/drawing/2014/main" id="{F4AF0E68-626D-4C2A-968B-4FC7C0D2E68B}"/>
+                <a16:creationId xmlns:a16="http://schemas.microsoft.com/office/drawing/2014/main" id="{C3F609F7-E29B-4C9E-8E40-26D636B9EAB0}"/>
               </a:ext>
             </a:extLst>
           </p:cNvPr>
@@ -2778,7 +2778,7 @@
           <p:cNvPr id="7" name="">
             <a:extLst xmlns:a="http://schemas.openxmlformats.org/drawingml/2006/main">
               <a:ext uri="{FF2B5EF4-FFF2-40B4-BE49-F238E27FC236}">
-                <a16:creationId xmlns:a16="http://schemas.microsoft.com/office/drawing/2014/main" id="{1D068FEE-1CFF-4FBC-96B1-96D07DEE8953}"/>
+                <a16:creationId xmlns:a16="http://schemas.microsoft.com/office/drawing/2014/main" id="{3A3AD807-F3E9-4548-BE05-3855C39B64A3}"/>
               </a:ext>
             </a:extLst>
           </p:cNvPr>
@@ -2823,7 +2823,7 @@
           <p:cNvPr id="8" name="">
             <a:extLst xmlns:a="http://schemas.openxmlformats.org/drawingml/2006/main">
               <a:ext uri="{FF2B5EF4-FFF2-40B4-BE49-F238E27FC236}">
-                <a16:creationId xmlns:a16="http://schemas.microsoft.com/office/drawing/2014/main" id="{B519A6A1-04B8-4B35-BE3C-CAA05F3D48D1}"/>
+                <a16:creationId xmlns:a16="http://schemas.microsoft.com/office/drawing/2014/main" id="{6ED3A03B-DE16-4EB3-9F1E-E6700E5272AA}"/>
               </a:ext>
             </a:extLst>
           </p:cNvPr>
@@ -2858,7 +2858,7 @@
                   <a:srgbClr val="2364AA"/>
                 </a:solidFill>
               </a:rPr>
-              <a:t>330</a:t>
+              <a:t>332</a:t>
             </a:r>
           </a:p>
         </p:txBody>
@@ -2868,7 +2868,7 @@
           <p:cNvPr id="9" name="">
             <a:extLst xmlns:a="http://schemas.openxmlformats.org/drawingml/2006/main">
               <a:ext uri="{FF2B5EF4-FFF2-40B4-BE49-F238E27FC236}">
-                <a16:creationId xmlns:a16="http://schemas.microsoft.com/office/drawing/2014/main" id="{CAEC219B-A4AA-406C-8310-D38054293AE1}"/>
+                <a16:creationId xmlns:a16="http://schemas.microsoft.com/office/drawing/2014/main" id="{2720000E-E197-495C-B555-8DDBE2046725}"/>
               </a:ext>
             </a:extLst>
           </p:cNvPr>
@@ -2913,7 +2913,7 @@
           <p:cNvPr id="10" name="">
             <a:extLst xmlns:a="http://schemas.openxmlformats.org/drawingml/2006/main">
               <a:ext uri="{FF2B5EF4-FFF2-40B4-BE49-F238E27FC236}">
-                <a16:creationId xmlns:a16="http://schemas.microsoft.com/office/drawing/2014/main" id="{6B3C6AF1-662C-4610-961A-BF473BAECD85}"/>
+                <a16:creationId xmlns:a16="http://schemas.microsoft.com/office/drawing/2014/main" id="{DC22CE68-215A-4F5E-8EEE-5A2435D7FDA4}"/>
               </a:ext>
             </a:extLst>
           </p:cNvPr>
@@ -2958,7 +2958,7 @@
           <p:cNvPr id="11" name="">
             <a:extLst xmlns:a="http://schemas.openxmlformats.org/drawingml/2006/main">
               <a:ext uri="{FF2B5EF4-FFF2-40B4-BE49-F238E27FC236}">
-                <a16:creationId xmlns:a16="http://schemas.microsoft.com/office/drawing/2014/main" id="{70D7A5C3-ACC3-4511-B1FC-5569DCBC4154}"/>
+                <a16:creationId xmlns:a16="http://schemas.microsoft.com/office/drawing/2014/main" id="{CBC00487-5A27-4176-8E5B-82CD18C78C9F}"/>
               </a:ext>
             </a:extLst>
           </p:cNvPr>
@@ -3003,7 +3003,7 @@
           <p:cNvPr id="12" name="">
             <a:extLst xmlns:a="http://schemas.openxmlformats.org/drawingml/2006/main">
               <a:ext uri="{FF2B5EF4-FFF2-40B4-BE49-F238E27FC236}">
-                <a16:creationId xmlns:a16="http://schemas.microsoft.com/office/drawing/2014/main" id="{C510121B-138A-4ADB-B2A3-30E04A6654B3}"/>
+                <a16:creationId xmlns:a16="http://schemas.microsoft.com/office/drawing/2014/main" id="{16D8C782-481F-4425-8ED1-A22019BEAD33}"/>
               </a:ext>
             </a:extLst>
           </p:cNvPr>
@@ -3048,7 +3048,7 @@
           <p:cNvPr id="13" name="">
             <a:extLst xmlns:a="http://schemas.openxmlformats.org/drawingml/2006/main">
               <a:ext uri="{FF2B5EF4-FFF2-40B4-BE49-F238E27FC236}">
-                <a16:creationId xmlns:a16="http://schemas.microsoft.com/office/drawing/2014/main" id="{750CFE86-055F-4DFF-811C-74545DC5A4D7}"/>
+                <a16:creationId xmlns:a16="http://schemas.microsoft.com/office/drawing/2014/main" id="{5CDAA691-16A6-4E31-9E0E-0104CEC39A39}"/>
               </a:ext>
             </a:extLst>
           </p:cNvPr>
@@ -3091,7 +3091,7 @@
     </p:spTree>
     <p:extLst>
       <p:ext uri="{BB962C8B-B14F-4D97-AF65-F5344CB8AC3E}">
-        <p14:creationId xmlns:p14="http://schemas.microsoft.com/office/powerpoint/2010/main" val="181196493"/>
+        <p14:creationId xmlns:p14="http://schemas.microsoft.com/office/powerpoint/2010/main" val="1528411685"/>
       </p:ext>
     </p:extLst>
   </p:cSld>
@@ -3115,7 +3115,7 @@
           <p:cNvPr id="1" name="slide-stage">
             <a:extLst xmlns:a="http://schemas.openxmlformats.org/drawingml/2006/main">
               <a:ext uri="{FF2B5EF4-FFF2-40B4-BE49-F238E27FC236}">
-                <a16:creationId xmlns:a16="http://schemas.microsoft.com/office/drawing/2014/main" id="{5BF617C2-592E-4973-B99F-2245602CDCAE}"/>
+                <a16:creationId xmlns:a16="http://schemas.microsoft.com/office/drawing/2014/main" id="{07C2EF1E-8854-46BE-832C-80AA273CB80C}"/>
               </a:ext>
             </a:extLst>
           </p:cNvPr>
@@ -3142,7 +3142,7 @@
           <p:cNvPr id="2" name="eyebrow">
             <a:extLst xmlns:a="http://schemas.openxmlformats.org/drawingml/2006/main">
               <a:ext uri="{FF2B5EF4-FFF2-40B4-BE49-F238E27FC236}">
-                <a16:creationId xmlns:a16="http://schemas.microsoft.com/office/drawing/2014/main" id="{F7EA5E6D-498D-4ED6-8D85-5AA41EC22924}"/>
+                <a16:creationId xmlns:a16="http://schemas.microsoft.com/office/drawing/2014/main" id="{268844C8-A6E1-4824-B84B-B2E7C989DDE0}"/>
               </a:ext>
             </a:extLst>
           </p:cNvPr>
@@ -3187,7 +3187,7 @@
           <p:cNvPr id="3" name="slide-title">
             <a:extLst xmlns:a="http://schemas.openxmlformats.org/drawingml/2006/main">
               <a:ext uri="{FF2B5EF4-FFF2-40B4-BE49-F238E27FC236}">
-                <a16:creationId xmlns:a16="http://schemas.microsoft.com/office/drawing/2014/main" id="{9B2C65E0-79E0-4CC3-BEBF-17264E7DB407}"/>
+                <a16:creationId xmlns:a16="http://schemas.microsoft.com/office/drawing/2014/main" id="{CCEA3CFF-D264-4E56-A9A5-80EA2569FC9F}"/>
               </a:ext>
             </a:extLst>
           </p:cNvPr>
@@ -3232,7 +3232,7 @@
           <p:cNvPr id="4" name="slide-subtitle">
             <a:extLst xmlns:a="http://schemas.openxmlformats.org/drawingml/2006/main">
               <a:ext uri="{FF2B5EF4-FFF2-40B4-BE49-F238E27FC236}">
-                <a16:creationId xmlns:a16="http://schemas.microsoft.com/office/drawing/2014/main" id="{E0368150-7DB4-495A-A6D6-C41EBAAE23A1}"/>
+                <a16:creationId xmlns:a16="http://schemas.microsoft.com/office/drawing/2014/main" id="{B46C774F-3192-4150-999A-6B9D4B8BF708}"/>
               </a:ext>
             </a:extLst>
           </p:cNvPr>
@@ -3277,7 +3277,7 @@
           <p:cNvPr id="5" name="">
             <a:extLst xmlns:a="http://schemas.openxmlformats.org/drawingml/2006/main">
               <a:ext uri="{FF2B5EF4-FFF2-40B4-BE49-F238E27FC236}">
-                <a16:creationId xmlns:a16="http://schemas.microsoft.com/office/drawing/2014/main" id="{95326204-7A7A-4FBD-9144-6E8E07A9A9F5}"/>
+                <a16:creationId xmlns:a16="http://schemas.microsoft.com/office/drawing/2014/main" id="{1680B99B-9190-4A7D-922F-5D2472FE6FA8}"/>
               </a:ext>
             </a:extLst>
           </p:cNvPr>
@@ -3310,7 +3310,7 @@
           <p:cNvPr id="6" name="">
             <a:extLst xmlns:a="http://schemas.openxmlformats.org/drawingml/2006/main">
               <a:ext uri="{FF2B5EF4-FFF2-40B4-BE49-F238E27FC236}">
-                <a16:creationId xmlns:a16="http://schemas.microsoft.com/office/drawing/2014/main" id="{382CC5B1-2F07-49DE-8CB8-8AEE4BE83BDF}"/>
+                <a16:creationId xmlns:a16="http://schemas.microsoft.com/office/drawing/2014/main" id="{1E10D435-EDDB-4906-BA3B-C95F88886E21}"/>
               </a:ext>
             </a:extLst>
           </p:cNvPr>
@@ -3355,7 +3355,7 @@
           <p:cNvPr id="7" name="">
             <a:extLst xmlns:a="http://schemas.openxmlformats.org/drawingml/2006/main">
               <a:ext uri="{FF2B5EF4-FFF2-40B4-BE49-F238E27FC236}">
-                <a16:creationId xmlns:a16="http://schemas.microsoft.com/office/drawing/2014/main" id="{3B7663DA-990C-4E8B-9D1C-DA09B77E7CFD}"/>
+                <a16:creationId xmlns:a16="http://schemas.microsoft.com/office/drawing/2014/main" id="{58B85365-F3B0-4779-A8E7-70475E0450A9}"/>
               </a:ext>
             </a:extLst>
           </p:cNvPr>
@@ -3400,7 +3400,7 @@
           <p:cNvPr id="8" name="">
             <a:extLst xmlns:a="http://schemas.openxmlformats.org/drawingml/2006/main">
               <a:ext uri="{FF2B5EF4-FFF2-40B4-BE49-F238E27FC236}">
-                <a16:creationId xmlns:a16="http://schemas.microsoft.com/office/drawing/2014/main" id="{E381CF70-3046-4925-9571-92ECE57C132F}"/>
+                <a16:creationId xmlns:a16="http://schemas.microsoft.com/office/drawing/2014/main" id="{5B12F127-82C0-4092-ADAA-C17EAFCA4116}"/>
               </a:ext>
             </a:extLst>
           </p:cNvPr>
@@ -3433,7 +3433,7 @@
           <p:cNvPr id="9" name="">
             <a:extLst xmlns:a="http://schemas.openxmlformats.org/drawingml/2006/main">
               <a:ext uri="{FF2B5EF4-FFF2-40B4-BE49-F238E27FC236}">
-                <a16:creationId xmlns:a16="http://schemas.microsoft.com/office/drawing/2014/main" id="{708A25C5-67F6-4F55-A908-5217EA020BA0}"/>
+                <a16:creationId xmlns:a16="http://schemas.microsoft.com/office/drawing/2014/main" id="{98B058F2-0765-4E73-B285-9D5130AF384C}"/>
               </a:ext>
             </a:extLst>
           </p:cNvPr>
@@ -3478,7 +3478,7 @@
           <p:cNvPr id="10" name="">
             <a:extLst xmlns:a="http://schemas.openxmlformats.org/drawingml/2006/main">
               <a:ext uri="{FF2B5EF4-FFF2-40B4-BE49-F238E27FC236}">
-                <a16:creationId xmlns:a16="http://schemas.microsoft.com/office/drawing/2014/main" id="{532B8B29-6FA8-452F-8D70-CF30B85DE2B3}"/>
+                <a16:creationId xmlns:a16="http://schemas.microsoft.com/office/drawing/2014/main" id="{38468482-AAA1-4DE3-9680-2E45ACB6E4FB}"/>
               </a:ext>
             </a:extLst>
           </p:cNvPr>
@@ -3523,7 +3523,7 @@
           <p:cNvPr id="11" name="">
             <a:extLst xmlns:a="http://schemas.openxmlformats.org/drawingml/2006/main">
               <a:ext uri="{FF2B5EF4-FFF2-40B4-BE49-F238E27FC236}">
-                <a16:creationId xmlns:a16="http://schemas.microsoft.com/office/drawing/2014/main" id="{37F1B1A3-CBDC-4298-83CA-0BA6210E3973}"/>
+                <a16:creationId xmlns:a16="http://schemas.microsoft.com/office/drawing/2014/main" id="{50A298A4-97F1-4985-AA69-91531785FE86}"/>
               </a:ext>
             </a:extLst>
           </p:cNvPr>
@@ -3556,7 +3556,7 @@
           <p:cNvPr id="12" name="">
             <a:extLst xmlns:a="http://schemas.openxmlformats.org/drawingml/2006/main">
               <a:ext uri="{FF2B5EF4-FFF2-40B4-BE49-F238E27FC236}">
-                <a16:creationId xmlns:a16="http://schemas.microsoft.com/office/drawing/2014/main" id="{38A8A460-6F26-4403-9015-372676488D11}"/>
+                <a16:creationId xmlns:a16="http://schemas.microsoft.com/office/drawing/2014/main" id="{9687C60E-1EDC-4868-A5CB-BFE13D427CF9}"/>
               </a:ext>
             </a:extLst>
           </p:cNvPr>
@@ -3601,7 +3601,7 @@
           <p:cNvPr id="13" name="">
             <a:extLst xmlns:a="http://schemas.openxmlformats.org/drawingml/2006/main">
               <a:ext uri="{FF2B5EF4-FFF2-40B4-BE49-F238E27FC236}">
-                <a16:creationId xmlns:a16="http://schemas.microsoft.com/office/drawing/2014/main" id="{E2D84990-A23D-4F7A-ACBA-372D040D593F}"/>
+                <a16:creationId xmlns:a16="http://schemas.microsoft.com/office/drawing/2014/main" id="{DBA96D4E-617F-46DC-8016-93AC29D04D8F}"/>
               </a:ext>
             </a:extLst>
           </p:cNvPr>
@@ -3646,7 +3646,7 @@
           <p:cNvPr id="14" name="">
             <a:extLst xmlns:a="http://schemas.openxmlformats.org/drawingml/2006/main">
               <a:ext uri="{FF2B5EF4-FFF2-40B4-BE49-F238E27FC236}">
-                <a16:creationId xmlns:a16="http://schemas.microsoft.com/office/drawing/2014/main" id="{712BC088-D3AC-4BD2-A2DA-BF3EDB20E88B}"/>
+                <a16:creationId xmlns:a16="http://schemas.microsoft.com/office/drawing/2014/main" id="{7AAA4311-8895-47A1-8F64-C4CA30F7CBB4}"/>
               </a:ext>
             </a:extLst>
           </p:cNvPr>
@@ -3679,7 +3679,7 @@
           <p:cNvPr id="15" name="">
             <a:extLst xmlns:a="http://schemas.openxmlformats.org/drawingml/2006/main">
               <a:ext uri="{FF2B5EF4-FFF2-40B4-BE49-F238E27FC236}">
-                <a16:creationId xmlns:a16="http://schemas.microsoft.com/office/drawing/2014/main" id="{A085BAB8-85BE-487D-84A0-D36431D3C5AE}"/>
+                <a16:creationId xmlns:a16="http://schemas.microsoft.com/office/drawing/2014/main" id="{95BA2FA1-FAEE-4579-9546-9A46917C72A4}"/>
               </a:ext>
             </a:extLst>
           </p:cNvPr>
@@ -3724,7 +3724,7 @@
           <p:cNvPr id="16" name="">
             <a:extLst xmlns:a="http://schemas.openxmlformats.org/drawingml/2006/main">
               <a:ext uri="{FF2B5EF4-FFF2-40B4-BE49-F238E27FC236}">
-                <a16:creationId xmlns:a16="http://schemas.microsoft.com/office/drawing/2014/main" id="{E528894D-0C4B-4C1E-B683-3B27F81E57D5}"/>
+                <a16:creationId xmlns:a16="http://schemas.microsoft.com/office/drawing/2014/main" id="{41B1A8BF-12D0-45DD-8468-816CA82BE72E}"/>
               </a:ext>
             </a:extLst>
           </p:cNvPr>
@@ -3769,7 +3769,7 @@
           <p:cNvPr id="17" name="footer-left">
             <a:extLst xmlns:a="http://schemas.openxmlformats.org/drawingml/2006/main">
               <a:ext uri="{FF2B5EF4-FFF2-40B4-BE49-F238E27FC236}">
-                <a16:creationId xmlns:a16="http://schemas.microsoft.com/office/drawing/2014/main" id="{4D43DF96-0A72-4952-871D-FADD1D1DAC30}"/>
+                <a16:creationId xmlns:a16="http://schemas.microsoft.com/office/drawing/2014/main" id="{3B16AD98-A686-4DCC-B3F7-7D5BE4ACED55}"/>
               </a:ext>
             </a:extLst>
           </p:cNvPr>
@@ -3814,7 +3814,7 @@
           <p:cNvPr id="18" name="footer-right">
             <a:extLst xmlns:a="http://schemas.openxmlformats.org/drawingml/2006/main">
               <a:ext uri="{FF2B5EF4-FFF2-40B4-BE49-F238E27FC236}">
-                <a16:creationId xmlns:a16="http://schemas.microsoft.com/office/drawing/2014/main" id="{ABC838C5-D628-4E5E-990F-56C3D44A3976}"/>
+                <a16:creationId xmlns:a16="http://schemas.microsoft.com/office/drawing/2014/main" id="{F8FE28E3-8054-4979-9837-768613FA802B}"/>
               </a:ext>
             </a:extLst>
           </p:cNvPr>
@@ -3857,7 +3857,7 @@
     </p:spTree>
     <p:extLst>
       <p:ext uri="{BB962C8B-B14F-4D97-AF65-F5344CB8AC3E}">
-        <p14:creationId xmlns:p14="http://schemas.microsoft.com/office/powerpoint/2010/main" val="1276092727"/>
+        <p14:creationId xmlns:p14="http://schemas.microsoft.com/office/powerpoint/2010/main" val="944318917"/>
       </p:ext>
     </p:extLst>
   </p:cSld>
@@ -3881,7 +3881,7 @@
           <p:cNvPr id="1" name="slide-stage">
             <a:extLst xmlns:a="http://schemas.openxmlformats.org/drawingml/2006/main">
               <a:ext uri="{FF2B5EF4-FFF2-40B4-BE49-F238E27FC236}">
-                <a16:creationId xmlns:a16="http://schemas.microsoft.com/office/drawing/2014/main" id="{F81E9A10-3D35-4DB1-9441-6D3D49CB989E}"/>
+                <a16:creationId xmlns:a16="http://schemas.microsoft.com/office/drawing/2014/main" id="{8B903E5F-41BD-4265-91D6-870AEFC9663D}"/>
               </a:ext>
             </a:extLst>
           </p:cNvPr>
@@ -3908,7 +3908,7 @@
           <p:cNvPr id="2" name="eyebrow">
             <a:extLst xmlns:a="http://schemas.openxmlformats.org/drawingml/2006/main">
               <a:ext uri="{FF2B5EF4-FFF2-40B4-BE49-F238E27FC236}">
-                <a16:creationId xmlns:a16="http://schemas.microsoft.com/office/drawing/2014/main" id="{ACFD4BF7-119E-46D6-85C8-E186B269EF52}"/>
+                <a16:creationId xmlns:a16="http://schemas.microsoft.com/office/drawing/2014/main" id="{514207E0-25A3-4417-90DE-94DF0A943BE5}"/>
               </a:ext>
             </a:extLst>
           </p:cNvPr>
@@ -3953,7 +3953,7 @@
           <p:cNvPr id="3" name="slide-title">
             <a:extLst xmlns:a="http://schemas.openxmlformats.org/drawingml/2006/main">
               <a:ext uri="{FF2B5EF4-FFF2-40B4-BE49-F238E27FC236}">
-                <a16:creationId xmlns:a16="http://schemas.microsoft.com/office/drawing/2014/main" id="{C9EBC452-BA2A-4021-BC2F-367A2AF2CE9A}"/>
+                <a16:creationId xmlns:a16="http://schemas.microsoft.com/office/drawing/2014/main" id="{673030C9-1BFA-420A-985A-8B1F7AFB1060}"/>
               </a:ext>
             </a:extLst>
           </p:cNvPr>
@@ -3998,7 +3998,7 @@
           <p:cNvPr id="4" name="slide-subtitle">
             <a:extLst xmlns:a="http://schemas.openxmlformats.org/drawingml/2006/main">
               <a:ext uri="{FF2B5EF4-FFF2-40B4-BE49-F238E27FC236}">
-                <a16:creationId xmlns:a16="http://schemas.microsoft.com/office/drawing/2014/main" id="{28CDD761-9435-47CB-96E4-CD04929D8D8B}"/>
+                <a16:creationId xmlns:a16="http://schemas.microsoft.com/office/drawing/2014/main" id="{65C21849-25EA-4871-95B5-D18FFA38C434}"/>
               </a:ext>
             </a:extLst>
           </p:cNvPr>
@@ -4043,7 +4043,7 @@
           <p:cNvPr id="5" name="">
             <a:extLst xmlns:a="http://schemas.openxmlformats.org/drawingml/2006/main">
               <a:ext uri="{FF2B5EF4-FFF2-40B4-BE49-F238E27FC236}">
-                <a16:creationId xmlns:a16="http://schemas.microsoft.com/office/drawing/2014/main" id="{5C1F5DFF-D69D-450F-B634-C77B3165E3EB}"/>
+                <a16:creationId xmlns:a16="http://schemas.microsoft.com/office/drawing/2014/main" id="{6FB78A44-EC15-470C-B8A3-3C18CD1B123E}"/>
               </a:ext>
             </a:extLst>
           </p:cNvPr>
@@ -4088,7 +4088,7 @@
           <p:cNvPr id="6" name="">
             <a:extLst xmlns:a="http://schemas.openxmlformats.org/drawingml/2006/main">
               <a:ext uri="{FF2B5EF4-FFF2-40B4-BE49-F238E27FC236}">
-                <a16:creationId xmlns:a16="http://schemas.microsoft.com/office/drawing/2014/main" id="{FD326B83-D5BB-4D5C-A5EB-FB86067A4AA7}"/>
+                <a16:creationId xmlns:a16="http://schemas.microsoft.com/office/drawing/2014/main" id="{2AFCEF1F-1006-491F-89FD-1EA091BDBAF2}"/>
               </a:ext>
             </a:extLst>
           </p:cNvPr>
@@ -4133,7 +4133,7 @@
           <p:cNvPr id="7" name="">
             <a:extLst xmlns:a="http://schemas.openxmlformats.org/drawingml/2006/main">
               <a:ext uri="{FF2B5EF4-FFF2-40B4-BE49-F238E27FC236}">
-                <a16:creationId xmlns:a16="http://schemas.microsoft.com/office/drawing/2014/main" id="{4DA5C2D2-BCC0-4946-8CF8-A319CFC3C557}"/>
+                <a16:creationId xmlns:a16="http://schemas.microsoft.com/office/drawing/2014/main" id="{CEF0E492-42AF-4082-966F-0788D5DF5783}"/>
               </a:ext>
             </a:extLst>
           </p:cNvPr>
@@ -4178,7 +4178,7 @@
           <p:cNvPr id="8" name="">
             <a:extLst xmlns:a="http://schemas.openxmlformats.org/drawingml/2006/main">
               <a:ext uri="{FF2B5EF4-FFF2-40B4-BE49-F238E27FC236}">
-                <a16:creationId xmlns:a16="http://schemas.microsoft.com/office/drawing/2014/main" id="{6EE4D62D-9A13-47F6-99F0-A64AA5511EE2}"/>
+                <a16:creationId xmlns:a16="http://schemas.microsoft.com/office/drawing/2014/main" id="{A0199D2F-3319-4670-AD49-15F60CB2AB82}"/>
               </a:ext>
             </a:extLst>
           </p:cNvPr>
@@ -4223,7 +4223,7 @@
           <p:cNvPr id="9" name="">
             <a:extLst xmlns:a="http://schemas.openxmlformats.org/drawingml/2006/main">
               <a:ext uri="{FF2B5EF4-FFF2-40B4-BE49-F238E27FC236}">
-                <a16:creationId xmlns:a16="http://schemas.microsoft.com/office/drawing/2014/main" id="{E92DF640-0559-4835-B855-C847C6B36774}"/>
+                <a16:creationId xmlns:a16="http://schemas.microsoft.com/office/drawing/2014/main" id="{E77F9F2D-2CF8-41D2-881C-BF272AF14F5D}"/>
               </a:ext>
             </a:extLst>
           </p:cNvPr>
@@ -4268,7 +4268,7 @@
           <p:cNvPr id="10" name="">
             <a:extLst xmlns:a="http://schemas.openxmlformats.org/drawingml/2006/main">
               <a:ext uri="{FF2B5EF4-FFF2-40B4-BE49-F238E27FC236}">
-                <a16:creationId xmlns:a16="http://schemas.microsoft.com/office/drawing/2014/main" id="{028A9CCB-2DE5-4C67-B256-BBDA31329A52}"/>
+                <a16:creationId xmlns:a16="http://schemas.microsoft.com/office/drawing/2014/main" id="{691C4CAF-BCF4-43BB-8538-AD0F20D05874}"/>
               </a:ext>
             </a:extLst>
           </p:cNvPr>
@@ -4313,7 +4313,7 @@
           <p:cNvPr id="11" name="">
             <a:extLst xmlns:a="http://schemas.openxmlformats.org/drawingml/2006/main">
               <a:ext uri="{FF2B5EF4-FFF2-40B4-BE49-F238E27FC236}">
-                <a16:creationId xmlns:a16="http://schemas.microsoft.com/office/drawing/2014/main" id="{BD81438E-E29E-4FA5-AB0B-AFA5653B8ED4}"/>
+                <a16:creationId xmlns:a16="http://schemas.microsoft.com/office/drawing/2014/main" id="{36C8FEFE-FC6A-45DE-AD3D-C539314AF534}"/>
               </a:ext>
             </a:extLst>
           </p:cNvPr>
@@ -4358,7 +4358,7 @@
           <p:cNvPr id="12" name="">
             <a:extLst xmlns:a="http://schemas.openxmlformats.org/drawingml/2006/main">
               <a:ext uri="{FF2B5EF4-FFF2-40B4-BE49-F238E27FC236}">
-                <a16:creationId xmlns:a16="http://schemas.microsoft.com/office/drawing/2014/main" id="{6AD3B44C-9932-4843-B14F-7B1067A81B3B}"/>
+                <a16:creationId xmlns:a16="http://schemas.microsoft.com/office/drawing/2014/main" id="{5D658494-F8BE-4A3D-A567-19D341E5B4DC}"/>
               </a:ext>
             </a:extLst>
           </p:cNvPr>
@@ -4403,7 +4403,7 @@
           <p:cNvPr id="13" name="">
             <a:extLst xmlns:a="http://schemas.openxmlformats.org/drawingml/2006/main">
               <a:ext uri="{FF2B5EF4-FFF2-40B4-BE49-F238E27FC236}">
-                <a16:creationId xmlns:a16="http://schemas.microsoft.com/office/drawing/2014/main" id="{2C020465-2F33-4A26-BCAF-02285B9796E3}"/>
+                <a16:creationId xmlns:a16="http://schemas.microsoft.com/office/drawing/2014/main" id="{EB57CEA1-8618-4802-8044-3E2EE5C94A13}"/>
               </a:ext>
             </a:extLst>
           </p:cNvPr>
@@ -4448,7 +4448,7 @@
           <p:cNvPr id="14" name="footer-left">
             <a:extLst xmlns:a="http://schemas.openxmlformats.org/drawingml/2006/main">
               <a:ext uri="{FF2B5EF4-FFF2-40B4-BE49-F238E27FC236}">
-                <a16:creationId xmlns:a16="http://schemas.microsoft.com/office/drawing/2014/main" id="{4B729B2A-DD22-4C3F-AA5A-640C5F436B72}"/>
+                <a16:creationId xmlns:a16="http://schemas.microsoft.com/office/drawing/2014/main" id="{A4936FDF-9059-455F-A687-4601D5678AAA}"/>
               </a:ext>
             </a:extLst>
           </p:cNvPr>
@@ -4493,7 +4493,7 @@
           <p:cNvPr id="15" name="footer-right">
             <a:extLst xmlns:a="http://schemas.openxmlformats.org/drawingml/2006/main">
               <a:ext uri="{FF2B5EF4-FFF2-40B4-BE49-F238E27FC236}">
-                <a16:creationId xmlns:a16="http://schemas.microsoft.com/office/drawing/2014/main" id="{4BBB2BBC-E7FA-40CC-BE14-5E355A94B70D}"/>
+                <a16:creationId xmlns:a16="http://schemas.microsoft.com/office/drawing/2014/main" id="{CFBE17FE-DC38-4BE2-AA7C-B73355D34D55}"/>
               </a:ext>
             </a:extLst>
           </p:cNvPr>
@@ -4536,7 +4536,7 @@
     </p:spTree>
     <p:extLst>
       <p:ext uri="{BB962C8B-B14F-4D97-AF65-F5344CB8AC3E}">
-        <p14:creationId xmlns:p14="http://schemas.microsoft.com/office/powerpoint/2010/main" val="543642799"/>
+        <p14:creationId xmlns:p14="http://schemas.microsoft.com/office/powerpoint/2010/main" val="280772076"/>
       </p:ext>
     </p:extLst>
   </p:cSld>
@@ -4560,7 +4560,7 @@
           <p:cNvPr id="1" name="slide-stage">
             <a:extLst xmlns:a="http://schemas.openxmlformats.org/drawingml/2006/main">
               <a:ext uri="{FF2B5EF4-FFF2-40B4-BE49-F238E27FC236}">
-                <a16:creationId xmlns:a16="http://schemas.microsoft.com/office/drawing/2014/main" id="{30039FF8-3B7A-49CA-BC55-774EB4934B3F}"/>
+                <a16:creationId xmlns:a16="http://schemas.microsoft.com/office/drawing/2014/main" id="{888CF8A1-3576-414E-B2E9-B7E052493377}"/>
               </a:ext>
             </a:extLst>
           </p:cNvPr>
@@ -4587,7 +4587,7 @@
           <p:cNvPr id="2" name="eyebrow">
             <a:extLst xmlns:a="http://schemas.openxmlformats.org/drawingml/2006/main">
               <a:ext uri="{FF2B5EF4-FFF2-40B4-BE49-F238E27FC236}">
-                <a16:creationId xmlns:a16="http://schemas.microsoft.com/office/drawing/2014/main" id="{5AC8DD24-B80E-49A2-A4FF-9006DCCA5E00}"/>
+                <a16:creationId xmlns:a16="http://schemas.microsoft.com/office/drawing/2014/main" id="{ACA87A8E-2C6B-401F-89F9-1151344EFF8F}"/>
               </a:ext>
             </a:extLst>
           </p:cNvPr>
@@ -4632,7 +4632,7 @@
           <p:cNvPr id="3" name="slide-title">
             <a:extLst xmlns:a="http://schemas.openxmlformats.org/drawingml/2006/main">
               <a:ext uri="{FF2B5EF4-FFF2-40B4-BE49-F238E27FC236}">
-                <a16:creationId xmlns:a16="http://schemas.microsoft.com/office/drawing/2014/main" id="{95D0A45E-A260-4C05-ACD4-C2873E33DAB2}"/>
+                <a16:creationId xmlns:a16="http://schemas.microsoft.com/office/drawing/2014/main" id="{1C6AA8DB-D29F-4336-8CDC-59E9FD868A1E}"/>
               </a:ext>
             </a:extLst>
           </p:cNvPr>
@@ -4677,7 +4677,7 @@
           <p:cNvPr id="4" name="slide-subtitle">
             <a:extLst xmlns:a="http://schemas.openxmlformats.org/drawingml/2006/main">
               <a:ext uri="{FF2B5EF4-FFF2-40B4-BE49-F238E27FC236}">
-                <a16:creationId xmlns:a16="http://schemas.microsoft.com/office/drawing/2014/main" id="{24432A89-43E3-4420-A931-AA6A387A9304}"/>
+                <a16:creationId xmlns:a16="http://schemas.microsoft.com/office/drawing/2014/main" id="{AF455C71-40F4-4A82-AF9F-CF54C146E27F}"/>
               </a:ext>
             </a:extLst>
           </p:cNvPr>
@@ -4722,7 +4722,7 @@
           <p:cNvPr id="5" name="">
             <a:extLst xmlns:a="http://schemas.openxmlformats.org/drawingml/2006/main">
               <a:ext uri="{FF2B5EF4-FFF2-40B4-BE49-F238E27FC236}">
-                <a16:creationId xmlns:a16="http://schemas.microsoft.com/office/drawing/2014/main" id="{0BF438BC-ED1D-403C-88E6-C406E5E7482A}"/>
+                <a16:creationId xmlns:a16="http://schemas.microsoft.com/office/drawing/2014/main" id="{1F5FE08F-402C-4A49-A7D2-456F401070E2}"/>
               </a:ext>
             </a:extLst>
           </p:cNvPr>
@@ -4755,7 +4755,7 @@
           <p:cNvPr id="6" name="">
             <a:extLst xmlns:a="http://schemas.openxmlformats.org/drawingml/2006/main">
               <a:ext uri="{FF2B5EF4-FFF2-40B4-BE49-F238E27FC236}">
-                <a16:creationId xmlns:a16="http://schemas.microsoft.com/office/drawing/2014/main" id="{70C6D479-CE08-487D-BEAF-1CF405299E5F}"/>
+                <a16:creationId xmlns:a16="http://schemas.microsoft.com/office/drawing/2014/main" id="{E8DDBA7C-EF87-4D90-B1C6-2D69BC03CFFA}"/>
               </a:ext>
             </a:extLst>
           </p:cNvPr>
@@ -4800,7 +4800,7 @@
           <p:cNvPr id="7" name="">
             <a:extLst xmlns:a="http://schemas.openxmlformats.org/drawingml/2006/main">
               <a:ext uri="{FF2B5EF4-FFF2-40B4-BE49-F238E27FC236}">
-                <a16:creationId xmlns:a16="http://schemas.microsoft.com/office/drawing/2014/main" id="{84C74395-95B2-4A9B-8CF3-6BCF595425BF}"/>
+                <a16:creationId xmlns:a16="http://schemas.microsoft.com/office/drawing/2014/main" id="{0198DC04-8FEC-4D17-A9BD-E195B866A3CD}"/>
               </a:ext>
             </a:extLst>
           </p:cNvPr>
@@ -4845,7 +4845,7 @@
           <p:cNvPr id="8" name="">
             <a:extLst xmlns:a="http://schemas.openxmlformats.org/drawingml/2006/main">
               <a:ext uri="{FF2B5EF4-FFF2-40B4-BE49-F238E27FC236}">
-                <a16:creationId xmlns:a16="http://schemas.microsoft.com/office/drawing/2014/main" id="{CC721062-63A1-4B24-8714-C1FC66E95DCC}"/>
+                <a16:creationId xmlns:a16="http://schemas.microsoft.com/office/drawing/2014/main" id="{100D2EEF-706D-4E9E-8A28-54E2F11F7C0E}"/>
               </a:ext>
             </a:extLst>
           </p:cNvPr>
@@ -4878,7 +4878,7 @@
           <p:cNvPr id="9" name="">
             <a:extLst xmlns:a="http://schemas.openxmlformats.org/drawingml/2006/main">
               <a:ext uri="{FF2B5EF4-FFF2-40B4-BE49-F238E27FC236}">
-                <a16:creationId xmlns:a16="http://schemas.microsoft.com/office/drawing/2014/main" id="{B8966E26-134C-40FF-BD23-5F4A68C465D9}"/>
+                <a16:creationId xmlns:a16="http://schemas.microsoft.com/office/drawing/2014/main" id="{601412C7-7579-4647-BC18-08548BCD22B4}"/>
               </a:ext>
             </a:extLst>
           </p:cNvPr>
@@ -4923,7 +4923,7 @@
           <p:cNvPr id="10" name="">
             <a:extLst xmlns:a="http://schemas.openxmlformats.org/drawingml/2006/main">
               <a:ext uri="{FF2B5EF4-FFF2-40B4-BE49-F238E27FC236}">
-                <a16:creationId xmlns:a16="http://schemas.microsoft.com/office/drawing/2014/main" id="{D4EDB9B1-5DFB-4B3E-8E68-E3361346ECAC}"/>
+                <a16:creationId xmlns:a16="http://schemas.microsoft.com/office/drawing/2014/main" id="{287EC1AB-9E32-4964-B916-D175E3A756BA}"/>
               </a:ext>
             </a:extLst>
           </p:cNvPr>
@@ -4968,7 +4968,7 @@
           <p:cNvPr id="11" name="">
             <a:extLst xmlns:a="http://schemas.openxmlformats.org/drawingml/2006/main">
               <a:ext uri="{FF2B5EF4-FFF2-40B4-BE49-F238E27FC236}">
-                <a16:creationId xmlns:a16="http://schemas.microsoft.com/office/drawing/2014/main" id="{82808E54-E180-433F-8CFE-87F09A56277C}"/>
+                <a16:creationId xmlns:a16="http://schemas.microsoft.com/office/drawing/2014/main" id="{2BD22580-794E-4CF0-A945-DA608547B719}"/>
               </a:ext>
             </a:extLst>
           </p:cNvPr>
@@ -5001,7 +5001,7 @@
           <p:cNvPr id="12" name="">
             <a:extLst xmlns:a="http://schemas.openxmlformats.org/drawingml/2006/main">
               <a:ext uri="{FF2B5EF4-FFF2-40B4-BE49-F238E27FC236}">
-                <a16:creationId xmlns:a16="http://schemas.microsoft.com/office/drawing/2014/main" id="{65FCFFCE-0501-4D49-8C09-65648F8D50DE}"/>
+                <a16:creationId xmlns:a16="http://schemas.microsoft.com/office/drawing/2014/main" id="{AF443FB9-1C3D-480B-9A06-E6BAF8AD8F06}"/>
               </a:ext>
             </a:extLst>
           </p:cNvPr>
@@ -5046,7 +5046,7 @@
           <p:cNvPr id="13" name="">
             <a:extLst xmlns:a="http://schemas.openxmlformats.org/drawingml/2006/main">
               <a:ext uri="{FF2B5EF4-FFF2-40B4-BE49-F238E27FC236}">
-                <a16:creationId xmlns:a16="http://schemas.microsoft.com/office/drawing/2014/main" id="{3CCC522E-AFAC-4D17-A963-E475A22DD68A}"/>
+                <a16:creationId xmlns:a16="http://schemas.microsoft.com/office/drawing/2014/main" id="{6EDB2DBF-BD81-4F98-8A99-2998785770E4}"/>
               </a:ext>
             </a:extLst>
           </p:cNvPr>
@@ -5091,7 +5091,7 @@
           <p:cNvPr id="14" name="">
             <a:extLst xmlns:a="http://schemas.openxmlformats.org/drawingml/2006/main">
               <a:ext uri="{FF2B5EF4-FFF2-40B4-BE49-F238E27FC236}">
-                <a16:creationId xmlns:a16="http://schemas.microsoft.com/office/drawing/2014/main" id="{4BD4C8F1-24C2-49F7-AC85-56E3A6097F3C}"/>
+                <a16:creationId xmlns:a16="http://schemas.microsoft.com/office/drawing/2014/main" id="{3EFBA3F9-79CB-417A-AE9A-7BED22328F46}"/>
               </a:ext>
             </a:extLst>
           </p:cNvPr>
@@ -5124,7 +5124,7 @@
           <p:cNvPr id="15" name="">
             <a:extLst xmlns:a="http://schemas.openxmlformats.org/drawingml/2006/main">
               <a:ext uri="{FF2B5EF4-FFF2-40B4-BE49-F238E27FC236}">
-                <a16:creationId xmlns:a16="http://schemas.microsoft.com/office/drawing/2014/main" id="{70A3E358-340D-444C-B1A2-0FAFBB3E8599}"/>
+                <a16:creationId xmlns:a16="http://schemas.microsoft.com/office/drawing/2014/main" id="{6FDD896B-9F7C-4010-A3FF-160757EA5879}"/>
               </a:ext>
             </a:extLst>
           </p:cNvPr>
@@ -5169,7 +5169,7 @@
           <p:cNvPr id="16" name="">
             <a:extLst xmlns:a="http://schemas.openxmlformats.org/drawingml/2006/main">
               <a:ext uri="{FF2B5EF4-FFF2-40B4-BE49-F238E27FC236}">
-                <a16:creationId xmlns:a16="http://schemas.microsoft.com/office/drawing/2014/main" id="{934F1038-E899-414B-B252-581C9D47ACB9}"/>
+                <a16:creationId xmlns:a16="http://schemas.microsoft.com/office/drawing/2014/main" id="{1132B273-C1A8-43ED-87C8-93D97B25B335}"/>
               </a:ext>
             </a:extLst>
           </p:cNvPr>
@@ -5214,7 +5214,7 @@
           <p:cNvPr id="17" name="">
             <a:extLst xmlns:a="http://schemas.openxmlformats.org/drawingml/2006/main">
               <a:ext uri="{FF2B5EF4-FFF2-40B4-BE49-F238E27FC236}">
-                <a16:creationId xmlns:a16="http://schemas.microsoft.com/office/drawing/2014/main" id="{E9D494C0-20A1-4A82-AA02-70737C5B16C3}"/>
+                <a16:creationId xmlns:a16="http://schemas.microsoft.com/office/drawing/2014/main" id="{2868B56A-4E17-4301-97FD-3B23A086EC8A}"/>
               </a:ext>
             </a:extLst>
           </p:cNvPr>
@@ -5247,7 +5247,7 @@
           <p:cNvPr id="18" name="">
             <a:extLst xmlns:a="http://schemas.openxmlformats.org/drawingml/2006/main">
               <a:ext uri="{FF2B5EF4-FFF2-40B4-BE49-F238E27FC236}">
-                <a16:creationId xmlns:a16="http://schemas.microsoft.com/office/drawing/2014/main" id="{F877CFC9-ED4A-4BEA-B3DF-DFA52DE29848}"/>
+                <a16:creationId xmlns:a16="http://schemas.microsoft.com/office/drawing/2014/main" id="{0EAFF826-0A0B-4B49-B9F7-742368A2E28B}"/>
               </a:ext>
             </a:extLst>
           </p:cNvPr>
@@ -5292,7 +5292,7 @@
           <p:cNvPr id="19" name="">
             <a:extLst xmlns:a="http://schemas.openxmlformats.org/drawingml/2006/main">
               <a:ext uri="{FF2B5EF4-FFF2-40B4-BE49-F238E27FC236}">
-                <a16:creationId xmlns:a16="http://schemas.microsoft.com/office/drawing/2014/main" id="{D835C493-7056-4A45-91ED-C0166B02A258}"/>
+                <a16:creationId xmlns:a16="http://schemas.microsoft.com/office/drawing/2014/main" id="{36AF0D1A-1DBC-4523-B54E-41EE96D81F38}"/>
               </a:ext>
             </a:extLst>
           </p:cNvPr>
@@ -5337,7 +5337,7 @@
           <p:cNvPr id="20" name="">
             <a:extLst xmlns:a="http://schemas.openxmlformats.org/drawingml/2006/main">
               <a:ext uri="{FF2B5EF4-FFF2-40B4-BE49-F238E27FC236}">
-                <a16:creationId xmlns:a16="http://schemas.microsoft.com/office/drawing/2014/main" id="{3708B9E1-6B20-49D5-9A93-73D296F15F98}"/>
+                <a16:creationId xmlns:a16="http://schemas.microsoft.com/office/drawing/2014/main" id="{25686D14-B8BB-41E6-8F03-0C442E77544C}"/>
               </a:ext>
             </a:extLst>
           </p:cNvPr>
@@ -5370,7 +5370,7 @@
           <p:cNvPr id="21" name="">
             <a:extLst xmlns:a="http://schemas.openxmlformats.org/drawingml/2006/main">
               <a:ext uri="{FF2B5EF4-FFF2-40B4-BE49-F238E27FC236}">
-                <a16:creationId xmlns:a16="http://schemas.microsoft.com/office/drawing/2014/main" id="{68FE578D-2C92-4270-A3B6-90980968737B}"/>
+                <a16:creationId xmlns:a16="http://schemas.microsoft.com/office/drawing/2014/main" id="{18DD584F-C51E-4D7A-951E-06FEB944EEA7}"/>
               </a:ext>
             </a:extLst>
           </p:cNvPr>
@@ -5415,7 +5415,7 @@
           <p:cNvPr id="22" name="">
             <a:extLst xmlns:a="http://schemas.openxmlformats.org/drawingml/2006/main">
               <a:ext uri="{FF2B5EF4-FFF2-40B4-BE49-F238E27FC236}">
-                <a16:creationId xmlns:a16="http://schemas.microsoft.com/office/drawing/2014/main" id="{08CD7959-973B-4D43-B743-B94326B13510}"/>
+                <a16:creationId xmlns:a16="http://schemas.microsoft.com/office/drawing/2014/main" id="{E942282F-CF85-455E-88D3-8EA965C58C7C}"/>
               </a:ext>
             </a:extLst>
           </p:cNvPr>
@@ -5460,7 +5460,7 @@
           <p:cNvPr id="23" name="footer-left">
             <a:extLst xmlns:a="http://schemas.openxmlformats.org/drawingml/2006/main">
               <a:ext uri="{FF2B5EF4-FFF2-40B4-BE49-F238E27FC236}">
-                <a16:creationId xmlns:a16="http://schemas.microsoft.com/office/drawing/2014/main" id="{D4E81E91-5AA2-401E-9962-199AD89A439E}"/>
+                <a16:creationId xmlns:a16="http://schemas.microsoft.com/office/drawing/2014/main" id="{99055695-C80B-41C3-B9F5-29133F0A9F29}"/>
               </a:ext>
             </a:extLst>
           </p:cNvPr>
@@ -5505,7 +5505,7 @@
           <p:cNvPr id="24" name="footer-right">
             <a:extLst xmlns:a="http://schemas.openxmlformats.org/drawingml/2006/main">
               <a:ext uri="{FF2B5EF4-FFF2-40B4-BE49-F238E27FC236}">
-                <a16:creationId xmlns:a16="http://schemas.microsoft.com/office/drawing/2014/main" id="{ABC5E64E-B5B0-4F79-A0CF-B095A9036FB1}"/>
+                <a16:creationId xmlns:a16="http://schemas.microsoft.com/office/drawing/2014/main" id="{0AE8E1CF-CD0F-4FD7-9E5A-26FDE8AD43DF}"/>
               </a:ext>
             </a:extLst>
           </p:cNvPr>
@@ -5548,7 +5548,7 @@
     </p:spTree>
     <p:extLst>
       <p:ext uri="{BB962C8B-B14F-4D97-AF65-F5344CB8AC3E}">
-        <p14:creationId xmlns:p14="http://schemas.microsoft.com/office/powerpoint/2010/main" val="1324060484"/>
+        <p14:creationId xmlns:p14="http://schemas.microsoft.com/office/powerpoint/2010/main" val="1247643844"/>
       </p:ext>
     </p:extLst>
   </p:cSld>
@@ -5572,7 +5572,7 @@
           <p:cNvPr id="1" name="slide-stage">
             <a:extLst xmlns:a="http://schemas.openxmlformats.org/drawingml/2006/main">
               <a:ext uri="{FF2B5EF4-FFF2-40B4-BE49-F238E27FC236}">
-                <a16:creationId xmlns:a16="http://schemas.microsoft.com/office/drawing/2014/main" id="{388A11AF-4FBA-4D29-BE70-2538A2ECD872}"/>
+                <a16:creationId xmlns:a16="http://schemas.microsoft.com/office/drawing/2014/main" id="{9EEAF2EC-652E-44A6-949D-E41558012BA9}"/>
               </a:ext>
             </a:extLst>
           </p:cNvPr>
@@ -5599,7 +5599,7 @@
           <p:cNvPr id="2" name="eyebrow">
             <a:extLst xmlns:a="http://schemas.openxmlformats.org/drawingml/2006/main">
               <a:ext uri="{FF2B5EF4-FFF2-40B4-BE49-F238E27FC236}">
-                <a16:creationId xmlns:a16="http://schemas.microsoft.com/office/drawing/2014/main" id="{B1DC5D6F-16D5-48AB-8229-F86A45AA1F4A}"/>
+                <a16:creationId xmlns:a16="http://schemas.microsoft.com/office/drawing/2014/main" id="{32866784-AB1F-4FCE-B120-F95E2D6D00B6}"/>
               </a:ext>
             </a:extLst>
           </p:cNvPr>
@@ -5644,7 +5644,7 @@
           <p:cNvPr id="3" name="slide-title">
             <a:extLst xmlns:a="http://schemas.openxmlformats.org/drawingml/2006/main">
               <a:ext uri="{FF2B5EF4-FFF2-40B4-BE49-F238E27FC236}">
-                <a16:creationId xmlns:a16="http://schemas.microsoft.com/office/drawing/2014/main" id="{5292FB50-229E-4762-BBEE-C9DB43E61B93}"/>
+                <a16:creationId xmlns:a16="http://schemas.microsoft.com/office/drawing/2014/main" id="{585EE8E8-DEF2-4328-BF9A-D291F2B5B397}"/>
               </a:ext>
             </a:extLst>
           </p:cNvPr>
@@ -5689,7 +5689,7 @@
           <p:cNvPr id="4" name="slide-subtitle">
             <a:extLst xmlns:a="http://schemas.openxmlformats.org/drawingml/2006/main">
               <a:ext uri="{FF2B5EF4-FFF2-40B4-BE49-F238E27FC236}">
-                <a16:creationId xmlns:a16="http://schemas.microsoft.com/office/drawing/2014/main" id="{701E9B13-A82E-4F01-8E08-163C9978B329}"/>
+                <a16:creationId xmlns:a16="http://schemas.microsoft.com/office/drawing/2014/main" id="{193366EF-FE3A-46DA-93F4-9266C731552D}"/>
               </a:ext>
             </a:extLst>
           </p:cNvPr>
@@ -5734,7 +5734,7 @@
           <p:cNvPr id="5" name="">
             <a:extLst xmlns:a="http://schemas.openxmlformats.org/drawingml/2006/main">
               <a:ext uri="{FF2B5EF4-FFF2-40B4-BE49-F238E27FC236}">
-                <a16:creationId xmlns:a16="http://schemas.microsoft.com/office/drawing/2014/main" id="{901E7D88-E0DC-483C-930D-EFAA77B8303D}"/>
+                <a16:creationId xmlns:a16="http://schemas.microsoft.com/office/drawing/2014/main" id="{C9FE3003-AA52-42A3-8349-7CFA9B397136}"/>
               </a:ext>
             </a:extLst>
           </p:cNvPr>
@@ -5779,7 +5779,7 @@
           <p:cNvPr id="6" name="">
             <a:extLst xmlns:a="http://schemas.openxmlformats.org/drawingml/2006/main">
               <a:ext uri="{FF2B5EF4-FFF2-40B4-BE49-F238E27FC236}">
-                <a16:creationId xmlns:a16="http://schemas.microsoft.com/office/drawing/2014/main" id="{BE51D4EE-5EF3-4609-8B83-3A096E9286D0}"/>
+                <a16:creationId xmlns:a16="http://schemas.microsoft.com/office/drawing/2014/main" id="{B1CC16D6-BCC4-407B-B10D-B7E6406BE29B}"/>
               </a:ext>
             </a:extLst>
           </p:cNvPr>
@@ -5824,7 +5824,7 @@
           <p:cNvPr id="7" name="">
             <a:extLst xmlns:a="http://schemas.openxmlformats.org/drawingml/2006/main">
               <a:ext uri="{FF2B5EF4-FFF2-40B4-BE49-F238E27FC236}">
-                <a16:creationId xmlns:a16="http://schemas.microsoft.com/office/drawing/2014/main" id="{EC64DD34-0F8F-4045-8F1F-81D267850582}"/>
+                <a16:creationId xmlns:a16="http://schemas.microsoft.com/office/drawing/2014/main" id="{455D0F89-8DA8-415B-B33F-E8DD06455E38}"/>
               </a:ext>
             </a:extLst>
           </p:cNvPr>
@@ -5869,7 +5869,7 @@
           <p:cNvPr id="8" name="">
             <a:extLst xmlns:a="http://schemas.openxmlformats.org/drawingml/2006/main">
               <a:ext uri="{FF2B5EF4-FFF2-40B4-BE49-F238E27FC236}">
-                <a16:creationId xmlns:a16="http://schemas.microsoft.com/office/drawing/2014/main" id="{DEBD1333-1B4F-4164-B9E5-3D41F7FD37DB}"/>
+                <a16:creationId xmlns:a16="http://schemas.microsoft.com/office/drawing/2014/main" id="{93A60DA8-CC17-445F-9058-46A9CC73C6A9}"/>
               </a:ext>
             </a:extLst>
           </p:cNvPr>
@@ -5914,7 +5914,7 @@
           <p:cNvPr id="9" name="">
             <a:extLst xmlns:a="http://schemas.openxmlformats.org/drawingml/2006/main">
               <a:ext uri="{FF2B5EF4-FFF2-40B4-BE49-F238E27FC236}">
-                <a16:creationId xmlns:a16="http://schemas.microsoft.com/office/drawing/2014/main" id="{DD50C74A-F565-4DA9-9999-4B891CF9F425}"/>
+                <a16:creationId xmlns:a16="http://schemas.microsoft.com/office/drawing/2014/main" id="{209CD026-804A-4B06-94DF-DD26738D46F8}"/>
               </a:ext>
             </a:extLst>
           </p:cNvPr>
@@ -5959,7 +5959,7 @@
           <p:cNvPr id="10" name="">
             <a:extLst xmlns:a="http://schemas.openxmlformats.org/drawingml/2006/main">
               <a:ext uri="{FF2B5EF4-FFF2-40B4-BE49-F238E27FC236}">
-                <a16:creationId xmlns:a16="http://schemas.microsoft.com/office/drawing/2014/main" id="{343E694A-4EDF-4850-9FAE-658A98648032}"/>
+                <a16:creationId xmlns:a16="http://schemas.microsoft.com/office/drawing/2014/main" id="{79E7E4BE-CD80-4759-BCA2-593CD09863AB}"/>
               </a:ext>
             </a:extLst>
           </p:cNvPr>
@@ -6004,7 +6004,7 @@
           <p:cNvPr id="11" name="">
             <a:extLst xmlns:a="http://schemas.openxmlformats.org/drawingml/2006/main">
               <a:ext uri="{FF2B5EF4-FFF2-40B4-BE49-F238E27FC236}">
-                <a16:creationId xmlns:a16="http://schemas.microsoft.com/office/drawing/2014/main" id="{0C5ED769-1343-4789-9EF4-46FD55750FBA}"/>
+                <a16:creationId xmlns:a16="http://schemas.microsoft.com/office/drawing/2014/main" id="{B9F6C136-91D6-410B-ACD7-AA7DF7DE1DDA}"/>
               </a:ext>
             </a:extLst>
           </p:cNvPr>
@@ -6049,7 +6049,7 @@
           <p:cNvPr id="12" name="">
             <a:extLst xmlns:a="http://schemas.openxmlformats.org/drawingml/2006/main">
               <a:ext uri="{FF2B5EF4-FFF2-40B4-BE49-F238E27FC236}">
-                <a16:creationId xmlns:a16="http://schemas.microsoft.com/office/drawing/2014/main" id="{B53767F0-E521-40B8-B77C-78D9267E9069}"/>
+                <a16:creationId xmlns:a16="http://schemas.microsoft.com/office/drawing/2014/main" id="{C2452DAA-2842-4995-AA4A-A7AAF35C94A6}"/>
               </a:ext>
             </a:extLst>
           </p:cNvPr>
@@ -6094,7 +6094,7 @@
           <p:cNvPr id="13" name="">
             <a:extLst xmlns:a="http://schemas.openxmlformats.org/drawingml/2006/main">
               <a:ext uri="{FF2B5EF4-FFF2-40B4-BE49-F238E27FC236}">
-                <a16:creationId xmlns:a16="http://schemas.microsoft.com/office/drawing/2014/main" id="{F56ADC59-09AA-469A-9BDE-B0E2FB6E1EC6}"/>
+                <a16:creationId xmlns:a16="http://schemas.microsoft.com/office/drawing/2014/main" id="{52B8782A-9C43-4252-9AC6-7E4A65248D89}"/>
               </a:ext>
             </a:extLst>
           </p:cNvPr>
@@ -6139,7 +6139,7 @@
           <p:cNvPr id="14" name="">
             <a:extLst xmlns:a="http://schemas.openxmlformats.org/drawingml/2006/main">
               <a:ext uri="{FF2B5EF4-FFF2-40B4-BE49-F238E27FC236}">
-                <a16:creationId xmlns:a16="http://schemas.microsoft.com/office/drawing/2014/main" id="{E4C999D6-BD5D-4E23-93F2-B61647A25315}"/>
+                <a16:creationId xmlns:a16="http://schemas.microsoft.com/office/drawing/2014/main" id="{A3A393A3-D8C4-4268-B47C-297161AA1620}"/>
               </a:ext>
             </a:extLst>
           </p:cNvPr>
@@ -6184,7 +6184,7 @@
           <p:cNvPr id="15" name="footer-left">
             <a:extLst xmlns:a="http://schemas.openxmlformats.org/drawingml/2006/main">
               <a:ext uri="{FF2B5EF4-FFF2-40B4-BE49-F238E27FC236}">
-                <a16:creationId xmlns:a16="http://schemas.microsoft.com/office/drawing/2014/main" id="{4F2FACE3-0875-4501-A20E-F362B1855199}"/>
+                <a16:creationId xmlns:a16="http://schemas.microsoft.com/office/drawing/2014/main" id="{9582808C-3EB1-45AB-8E82-B5D95AC7B00A}"/>
               </a:ext>
             </a:extLst>
           </p:cNvPr>
@@ -6229,7 +6229,7 @@
           <p:cNvPr id="16" name="footer-right">
             <a:extLst xmlns:a="http://schemas.openxmlformats.org/drawingml/2006/main">
               <a:ext uri="{FF2B5EF4-FFF2-40B4-BE49-F238E27FC236}">
-                <a16:creationId xmlns:a16="http://schemas.microsoft.com/office/drawing/2014/main" id="{3EB73339-75E4-4A3F-B1FB-0CADF1F96D49}"/>
+                <a16:creationId xmlns:a16="http://schemas.microsoft.com/office/drawing/2014/main" id="{A57C7F6D-E9DD-4913-9428-AE48CC45BC09}"/>
               </a:ext>
             </a:extLst>
           </p:cNvPr>
@@ -6272,7 +6272,7 @@
     </p:spTree>
     <p:extLst>
       <p:ext uri="{BB962C8B-B14F-4D97-AF65-F5344CB8AC3E}">
-        <p14:creationId xmlns:p14="http://schemas.microsoft.com/office/powerpoint/2010/main" val="194853322"/>
+        <p14:creationId xmlns:p14="http://schemas.microsoft.com/office/powerpoint/2010/main" val="663607802"/>
       </p:ext>
     </p:extLst>
   </p:cSld>
@@ -6296,7 +6296,7 @@
           <p:cNvPr id="1" name="slide-stage">
             <a:extLst xmlns:a="http://schemas.openxmlformats.org/drawingml/2006/main">
               <a:ext uri="{FF2B5EF4-FFF2-40B4-BE49-F238E27FC236}">
-                <a16:creationId xmlns:a16="http://schemas.microsoft.com/office/drawing/2014/main" id="{B1CA6529-2072-42AB-9B36-930D5C0B8121}"/>
+                <a16:creationId xmlns:a16="http://schemas.microsoft.com/office/drawing/2014/main" id="{73DDF3F7-E61A-44BE-8797-73EA54CC3840}"/>
               </a:ext>
             </a:extLst>
           </p:cNvPr>
@@ -6323,7 +6323,7 @@
           <p:cNvPr id="2" name="eyebrow">
             <a:extLst xmlns:a="http://schemas.openxmlformats.org/drawingml/2006/main">
               <a:ext uri="{FF2B5EF4-FFF2-40B4-BE49-F238E27FC236}">
-                <a16:creationId xmlns:a16="http://schemas.microsoft.com/office/drawing/2014/main" id="{04377308-90FD-48E8-BD24-EA304E8F926D}"/>
+                <a16:creationId xmlns:a16="http://schemas.microsoft.com/office/drawing/2014/main" id="{A2B8FC83-2CFF-407A-8AFD-2D06D8CAC2B9}"/>
               </a:ext>
             </a:extLst>
           </p:cNvPr>
@@ -6368,7 +6368,7 @@
           <p:cNvPr id="3" name="slide-title">
             <a:extLst xmlns:a="http://schemas.openxmlformats.org/drawingml/2006/main">
               <a:ext uri="{FF2B5EF4-FFF2-40B4-BE49-F238E27FC236}">
-                <a16:creationId xmlns:a16="http://schemas.microsoft.com/office/drawing/2014/main" id="{9D802199-2B14-4FC2-B3BD-F65521969755}"/>
+                <a16:creationId xmlns:a16="http://schemas.microsoft.com/office/drawing/2014/main" id="{BEA4662D-0867-4D1A-A0FE-905C2DF55CE4}"/>
               </a:ext>
             </a:extLst>
           </p:cNvPr>
@@ -6413,7 +6413,7 @@
           <p:cNvPr id="4" name="slide-subtitle">
             <a:extLst xmlns:a="http://schemas.openxmlformats.org/drawingml/2006/main">
               <a:ext uri="{FF2B5EF4-FFF2-40B4-BE49-F238E27FC236}">
-                <a16:creationId xmlns:a16="http://schemas.microsoft.com/office/drawing/2014/main" id="{A553F659-FA28-4C55-9E01-5AE2B0E40923}"/>
+                <a16:creationId xmlns:a16="http://schemas.microsoft.com/office/drawing/2014/main" id="{649788AB-5DA7-4456-A20B-AC8394A50826}"/>
               </a:ext>
             </a:extLst>
           </p:cNvPr>
@@ -6458,7 +6458,7 @@
           <p:cNvPr id="5" name="">
             <a:extLst xmlns:a="http://schemas.openxmlformats.org/drawingml/2006/main">
               <a:ext uri="{FF2B5EF4-FFF2-40B4-BE49-F238E27FC236}">
-                <a16:creationId xmlns:a16="http://schemas.microsoft.com/office/drawing/2014/main" id="{09CA7695-5F37-489F-A972-C0889F3734E3}"/>
+                <a16:creationId xmlns:a16="http://schemas.microsoft.com/office/drawing/2014/main" id="{1D656FA9-5003-430E-BC80-F2FFBB2F9B8E}"/>
               </a:ext>
             </a:extLst>
           </p:cNvPr>
@@ -6503,7 +6503,7 @@
           <p:cNvPr id="6" name="">
             <a:extLst xmlns:a="http://schemas.openxmlformats.org/drawingml/2006/main">
               <a:ext uri="{FF2B5EF4-FFF2-40B4-BE49-F238E27FC236}">
-                <a16:creationId xmlns:a16="http://schemas.microsoft.com/office/drawing/2014/main" id="{A12D888C-DCF8-4D1E-B336-92A43F551E78}"/>
+                <a16:creationId xmlns:a16="http://schemas.microsoft.com/office/drawing/2014/main" id="{4FB9404B-006B-46EB-8FD0-02ABC5C3E6FF}"/>
               </a:ext>
             </a:extLst>
           </p:cNvPr>
@@ -6548,7 +6548,7 @@
           <p:cNvPr id="7" name="">
             <a:extLst xmlns:a="http://schemas.openxmlformats.org/drawingml/2006/main">
               <a:ext uri="{FF2B5EF4-FFF2-40B4-BE49-F238E27FC236}">
-                <a16:creationId xmlns:a16="http://schemas.microsoft.com/office/drawing/2014/main" id="{219AED1A-B7BC-4AE0-9D4F-D80E273D466C}"/>
+                <a16:creationId xmlns:a16="http://schemas.microsoft.com/office/drawing/2014/main" id="{3AA35931-8E74-46BA-AB76-B18C41FE9293}"/>
               </a:ext>
             </a:extLst>
           </p:cNvPr>
@@ -6593,7 +6593,7 @@
           <p:cNvPr id="8" name="">
             <a:extLst xmlns:a="http://schemas.openxmlformats.org/drawingml/2006/main">
               <a:ext uri="{FF2B5EF4-FFF2-40B4-BE49-F238E27FC236}">
-                <a16:creationId xmlns:a16="http://schemas.microsoft.com/office/drawing/2014/main" id="{1091E37A-F5E5-42C2-B2C6-C5E5D87706EE}"/>
+                <a16:creationId xmlns:a16="http://schemas.microsoft.com/office/drawing/2014/main" id="{6D973EC2-CABB-4AFE-A939-6740DCE72907}"/>
               </a:ext>
             </a:extLst>
           </p:cNvPr>
@@ -6638,7 +6638,7 @@
           <p:cNvPr id="9" name="">
             <a:extLst xmlns:a="http://schemas.openxmlformats.org/drawingml/2006/main">
               <a:ext uri="{FF2B5EF4-FFF2-40B4-BE49-F238E27FC236}">
-                <a16:creationId xmlns:a16="http://schemas.microsoft.com/office/drawing/2014/main" id="{B2DDDF2F-104F-4869-BF66-2B9C6297C8AF}"/>
+                <a16:creationId xmlns:a16="http://schemas.microsoft.com/office/drawing/2014/main" id="{14311911-C60A-4BA1-AC24-ED1A96BD081D}"/>
               </a:ext>
             </a:extLst>
           </p:cNvPr>
@@ -6683,7 +6683,7 @@
           <p:cNvPr id="10" name="">
             <a:extLst xmlns:a="http://schemas.openxmlformats.org/drawingml/2006/main">
               <a:ext uri="{FF2B5EF4-FFF2-40B4-BE49-F238E27FC236}">
-                <a16:creationId xmlns:a16="http://schemas.microsoft.com/office/drawing/2014/main" id="{08866ADE-DE2C-47FD-A4A6-9A0571123B30}"/>
+                <a16:creationId xmlns:a16="http://schemas.microsoft.com/office/drawing/2014/main" id="{7A8ACA64-4C30-41F8-9460-F3A0FF518496}"/>
               </a:ext>
             </a:extLst>
           </p:cNvPr>
@@ -6728,7 +6728,7 @@
           <p:cNvPr id="11" name="">
             <a:extLst xmlns:a="http://schemas.openxmlformats.org/drawingml/2006/main">
               <a:ext uri="{FF2B5EF4-FFF2-40B4-BE49-F238E27FC236}">
-                <a16:creationId xmlns:a16="http://schemas.microsoft.com/office/drawing/2014/main" id="{58193A04-3306-4F16-8CB9-74C39BBEFFF0}"/>
+                <a16:creationId xmlns:a16="http://schemas.microsoft.com/office/drawing/2014/main" id="{AA6E27A5-5E54-4427-8A89-361BDA81844A}"/>
               </a:ext>
             </a:extLst>
           </p:cNvPr>
@@ -6773,7 +6773,7 @@
           <p:cNvPr id="12" name="">
             <a:extLst xmlns:a="http://schemas.openxmlformats.org/drawingml/2006/main">
               <a:ext uri="{FF2B5EF4-FFF2-40B4-BE49-F238E27FC236}">
-                <a16:creationId xmlns:a16="http://schemas.microsoft.com/office/drawing/2014/main" id="{178D30ED-771A-41FA-AE74-2A069625C8DB}"/>
+                <a16:creationId xmlns:a16="http://schemas.microsoft.com/office/drawing/2014/main" id="{AD300A34-8747-4EE0-A006-7BA321B49848}"/>
               </a:ext>
             </a:extLst>
           </p:cNvPr>
@@ -6818,7 +6818,7 @@
           <p:cNvPr id="13" name="">
             <a:extLst xmlns:a="http://schemas.openxmlformats.org/drawingml/2006/main">
               <a:ext uri="{FF2B5EF4-FFF2-40B4-BE49-F238E27FC236}">
-                <a16:creationId xmlns:a16="http://schemas.microsoft.com/office/drawing/2014/main" id="{46EBE61F-44BC-4765-8EEB-996EBC86EE4E}"/>
+                <a16:creationId xmlns:a16="http://schemas.microsoft.com/office/drawing/2014/main" id="{2634FABB-EFC6-4965-BE73-5226775A1205}"/>
               </a:ext>
             </a:extLst>
           </p:cNvPr>
@@ -6863,7 +6863,7 @@
           <p:cNvPr id="14" name="">
             <a:extLst xmlns:a="http://schemas.openxmlformats.org/drawingml/2006/main">
               <a:ext uri="{FF2B5EF4-FFF2-40B4-BE49-F238E27FC236}">
-                <a16:creationId xmlns:a16="http://schemas.microsoft.com/office/drawing/2014/main" id="{17A7595F-8BB7-470F-9AA6-6E69C666EA27}"/>
+                <a16:creationId xmlns:a16="http://schemas.microsoft.com/office/drawing/2014/main" id="{C2FB2D7A-85E3-4DEE-9F98-CAEBDFC130AA}"/>
               </a:ext>
             </a:extLst>
           </p:cNvPr>
@@ -6908,7 +6908,7 @@
           <p:cNvPr id="15" name="footer-left">
             <a:extLst xmlns:a="http://schemas.openxmlformats.org/drawingml/2006/main">
               <a:ext uri="{FF2B5EF4-FFF2-40B4-BE49-F238E27FC236}">
-                <a16:creationId xmlns:a16="http://schemas.microsoft.com/office/drawing/2014/main" id="{284E4415-AF0D-43E3-9C84-2D2642CC9A18}"/>
+                <a16:creationId xmlns:a16="http://schemas.microsoft.com/office/drawing/2014/main" id="{8C3E0B03-B00E-408A-8E40-6B3F4973B350}"/>
               </a:ext>
             </a:extLst>
           </p:cNvPr>
@@ -6953,7 +6953,7 @@
           <p:cNvPr id="16" name="footer-right">
             <a:extLst xmlns:a="http://schemas.openxmlformats.org/drawingml/2006/main">
               <a:ext uri="{FF2B5EF4-FFF2-40B4-BE49-F238E27FC236}">
-                <a16:creationId xmlns:a16="http://schemas.microsoft.com/office/drawing/2014/main" id="{3C4123BE-CC86-489C-BAEF-3AFB2B70DD7D}"/>
+                <a16:creationId xmlns:a16="http://schemas.microsoft.com/office/drawing/2014/main" id="{3F6157AE-0C4B-4835-A967-8AF8C22B21BA}"/>
               </a:ext>
             </a:extLst>
           </p:cNvPr>
@@ -6996,7 +6996,7 @@
     </p:spTree>
     <p:extLst>
       <p:ext uri="{BB962C8B-B14F-4D97-AF65-F5344CB8AC3E}">
-        <p14:creationId xmlns:p14="http://schemas.microsoft.com/office/powerpoint/2010/main" val="1504003896"/>
+        <p14:creationId xmlns:p14="http://schemas.microsoft.com/office/powerpoint/2010/main" val="1201971796"/>
       </p:ext>
     </p:extLst>
   </p:cSld>
@@ -7020,7 +7020,7 @@
           <p:cNvPr id="1" name="slide-stage">
             <a:extLst xmlns:a="http://schemas.openxmlformats.org/drawingml/2006/main">
               <a:ext uri="{FF2B5EF4-FFF2-40B4-BE49-F238E27FC236}">
-                <a16:creationId xmlns:a16="http://schemas.microsoft.com/office/drawing/2014/main" id="{78FBE7CF-144D-438E-90AC-43DB122CBFF7}"/>
+                <a16:creationId xmlns:a16="http://schemas.microsoft.com/office/drawing/2014/main" id="{40A4A56C-5C57-487C-BF5E-6D34A9314C07}"/>
               </a:ext>
             </a:extLst>
           </p:cNvPr>
@@ -7047,7 +7047,7 @@
           <p:cNvPr id="2" name="eyebrow">
             <a:extLst xmlns:a="http://schemas.openxmlformats.org/drawingml/2006/main">
               <a:ext uri="{FF2B5EF4-FFF2-40B4-BE49-F238E27FC236}">
-                <a16:creationId xmlns:a16="http://schemas.microsoft.com/office/drawing/2014/main" id="{AC23FFB6-3662-469B-80DA-842ABD3586D9}"/>
+                <a16:creationId xmlns:a16="http://schemas.microsoft.com/office/drawing/2014/main" id="{B698276E-CB4E-4755-9CE3-89E7D0AD604E}"/>
               </a:ext>
             </a:extLst>
           </p:cNvPr>
@@ -7092,7 +7092,7 @@
           <p:cNvPr id="3" name="slide-title">
             <a:extLst xmlns:a="http://schemas.openxmlformats.org/drawingml/2006/main">
               <a:ext uri="{FF2B5EF4-FFF2-40B4-BE49-F238E27FC236}">
-                <a16:creationId xmlns:a16="http://schemas.microsoft.com/office/drawing/2014/main" id="{46FABA02-C9D1-46F7-AE08-A7BA9C2193EE}"/>
+                <a16:creationId xmlns:a16="http://schemas.microsoft.com/office/drawing/2014/main" id="{C50B0DCF-43FB-4FE7-91D8-9668BA2B25BA}"/>
               </a:ext>
             </a:extLst>
           </p:cNvPr>
@@ -7137,7 +7137,7 @@
           <p:cNvPr id="4" name="slide-subtitle">
             <a:extLst xmlns:a="http://schemas.openxmlformats.org/drawingml/2006/main">
               <a:ext uri="{FF2B5EF4-FFF2-40B4-BE49-F238E27FC236}">
-                <a16:creationId xmlns:a16="http://schemas.microsoft.com/office/drawing/2014/main" id="{1B0294F3-D91C-42FC-BA4E-2B99606A9D49}"/>
+                <a16:creationId xmlns:a16="http://schemas.microsoft.com/office/drawing/2014/main" id="{EE3B5186-7D45-444B-BE3F-6C7703A8C1B0}"/>
               </a:ext>
             </a:extLst>
           </p:cNvPr>
@@ -7182,7 +7182,7 @@
           <p:cNvPr id="5" name="">
             <a:extLst xmlns:a="http://schemas.openxmlformats.org/drawingml/2006/main">
               <a:ext uri="{FF2B5EF4-FFF2-40B4-BE49-F238E27FC236}">
-                <a16:creationId xmlns:a16="http://schemas.microsoft.com/office/drawing/2014/main" id="{58848915-5038-4AFF-8C2A-7AEDE1D4C148}"/>
+                <a16:creationId xmlns:a16="http://schemas.microsoft.com/office/drawing/2014/main" id="{106C3D3D-E966-4E49-9B19-957685A6FF39}"/>
               </a:ext>
             </a:extLst>
           </p:cNvPr>
@@ -7215,7 +7215,7 @@
           <p:cNvPr id="6" name="">
             <a:extLst xmlns:a="http://schemas.openxmlformats.org/drawingml/2006/main">
               <a:ext uri="{FF2B5EF4-FFF2-40B4-BE49-F238E27FC236}">
-                <a16:creationId xmlns:a16="http://schemas.microsoft.com/office/drawing/2014/main" id="{355244D4-7E01-42E6-8F39-08AEF8208275}"/>
+                <a16:creationId xmlns:a16="http://schemas.microsoft.com/office/drawing/2014/main" id="{7242EBF4-E831-40A5-9422-4C44E39205B3}"/>
               </a:ext>
             </a:extLst>
           </p:cNvPr>
@@ -7260,7 +7260,7 @@
           <p:cNvPr id="7" name="">
             <a:extLst xmlns:a="http://schemas.openxmlformats.org/drawingml/2006/main">
               <a:ext uri="{FF2B5EF4-FFF2-40B4-BE49-F238E27FC236}">
-                <a16:creationId xmlns:a16="http://schemas.microsoft.com/office/drawing/2014/main" id="{35A5F741-34EA-4F8F-93DE-7E0501934B7F}"/>
+                <a16:creationId xmlns:a16="http://schemas.microsoft.com/office/drawing/2014/main" id="{FEC75AB8-019B-43A6-9109-DA0A3A5FFC20}"/>
               </a:ext>
             </a:extLst>
           </p:cNvPr>
@@ -7305,7 +7305,7 @@
           <p:cNvPr id="8" name="">
             <a:extLst xmlns:a="http://schemas.openxmlformats.org/drawingml/2006/main">
               <a:ext uri="{FF2B5EF4-FFF2-40B4-BE49-F238E27FC236}">
-                <a16:creationId xmlns:a16="http://schemas.microsoft.com/office/drawing/2014/main" id="{5B3E8FB9-0CCC-4B30-A0C4-6CAF6B16FDBB}"/>
+                <a16:creationId xmlns:a16="http://schemas.microsoft.com/office/drawing/2014/main" id="{A385879C-71C1-45F9-B623-26C82EFC02A9}"/>
               </a:ext>
             </a:extLst>
           </p:cNvPr>
@@ -7338,7 +7338,7 @@
           <p:cNvPr id="9" name="">
             <a:extLst xmlns:a="http://schemas.openxmlformats.org/drawingml/2006/main">
               <a:ext uri="{FF2B5EF4-FFF2-40B4-BE49-F238E27FC236}">
-                <a16:creationId xmlns:a16="http://schemas.microsoft.com/office/drawing/2014/main" id="{C24949A4-19B3-46DE-BA45-FFDA588711DD}"/>
+                <a16:creationId xmlns:a16="http://schemas.microsoft.com/office/drawing/2014/main" id="{4DD3515F-B39A-4A9A-A5F6-2546F2009C5D}"/>
               </a:ext>
             </a:extLst>
           </p:cNvPr>
@@ -7383,7 +7383,7 @@
           <p:cNvPr id="10" name="">
             <a:extLst xmlns:a="http://schemas.openxmlformats.org/drawingml/2006/main">
               <a:ext uri="{FF2B5EF4-FFF2-40B4-BE49-F238E27FC236}">
-                <a16:creationId xmlns:a16="http://schemas.microsoft.com/office/drawing/2014/main" id="{4CC5D729-8FE5-4466-977F-AF8683F2635A}"/>
+                <a16:creationId xmlns:a16="http://schemas.microsoft.com/office/drawing/2014/main" id="{00080E1F-4B3B-46FB-B8C1-88CE8631DBA9}"/>
               </a:ext>
             </a:extLst>
           </p:cNvPr>
@@ -7428,7 +7428,7 @@
           <p:cNvPr id="11" name="">
             <a:extLst xmlns:a="http://schemas.openxmlformats.org/drawingml/2006/main">
               <a:ext uri="{FF2B5EF4-FFF2-40B4-BE49-F238E27FC236}">
-                <a16:creationId xmlns:a16="http://schemas.microsoft.com/office/drawing/2014/main" id="{AB834136-7AA4-45E0-B0E8-3567D7EC128D}"/>
+                <a16:creationId xmlns:a16="http://schemas.microsoft.com/office/drawing/2014/main" id="{AD448C2A-2E8C-451E-B02A-043FFF71B1CE}"/>
               </a:ext>
             </a:extLst>
           </p:cNvPr>
@@ -7461,7 +7461,7 @@
           <p:cNvPr id="12" name="">
             <a:extLst xmlns:a="http://schemas.openxmlformats.org/drawingml/2006/main">
               <a:ext uri="{FF2B5EF4-FFF2-40B4-BE49-F238E27FC236}">
-                <a16:creationId xmlns:a16="http://schemas.microsoft.com/office/drawing/2014/main" id="{83BD82D7-B5EE-4373-9B1D-5730C5CF4BF6}"/>
+                <a16:creationId xmlns:a16="http://schemas.microsoft.com/office/drawing/2014/main" id="{80BB4B57-6B10-4B24-9E7A-1B5DDC784966}"/>
               </a:ext>
             </a:extLst>
           </p:cNvPr>
@@ -7506,7 +7506,7 @@
           <p:cNvPr id="13" name="">
             <a:extLst xmlns:a="http://schemas.openxmlformats.org/drawingml/2006/main">
               <a:ext uri="{FF2B5EF4-FFF2-40B4-BE49-F238E27FC236}">
-                <a16:creationId xmlns:a16="http://schemas.microsoft.com/office/drawing/2014/main" id="{6CEBDCDB-0753-42AF-BF64-498F3BC1CB40}"/>
+                <a16:creationId xmlns:a16="http://schemas.microsoft.com/office/drawing/2014/main" id="{F1F211DC-FCE0-4F88-A552-B86A9036D8F3}"/>
               </a:ext>
             </a:extLst>
           </p:cNvPr>
@@ -7551,7 +7551,7 @@
           <p:cNvPr id="14" name="">
             <a:extLst xmlns:a="http://schemas.openxmlformats.org/drawingml/2006/main">
               <a:ext uri="{FF2B5EF4-FFF2-40B4-BE49-F238E27FC236}">
-                <a16:creationId xmlns:a16="http://schemas.microsoft.com/office/drawing/2014/main" id="{7B8184D5-5880-4AB4-86D8-70FEC6B87C99}"/>
+                <a16:creationId xmlns:a16="http://schemas.microsoft.com/office/drawing/2014/main" id="{D26C85CA-6B01-4800-999B-0542CEA36064}"/>
               </a:ext>
             </a:extLst>
           </p:cNvPr>
@@ -7584,7 +7584,7 @@
           <p:cNvPr id="15" name="">
             <a:extLst xmlns:a="http://schemas.openxmlformats.org/drawingml/2006/main">
               <a:ext uri="{FF2B5EF4-FFF2-40B4-BE49-F238E27FC236}">
-                <a16:creationId xmlns:a16="http://schemas.microsoft.com/office/drawing/2014/main" id="{C8B1B527-31C5-4F90-BEFC-0F06664B277E}"/>
+                <a16:creationId xmlns:a16="http://schemas.microsoft.com/office/drawing/2014/main" id="{450ECB65-360B-4565-8B41-F306A4FC4548}"/>
               </a:ext>
             </a:extLst>
           </p:cNvPr>
@@ -7629,7 +7629,7 @@
           <p:cNvPr id="16" name="">
             <a:extLst xmlns:a="http://schemas.openxmlformats.org/drawingml/2006/main">
               <a:ext uri="{FF2B5EF4-FFF2-40B4-BE49-F238E27FC236}">
-                <a16:creationId xmlns:a16="http://schemas.microsoft.com/office/drawing/2014/main" id="{05CB6AF5-6337-4E8B-AB91-9CB0FFEAD9B1}"/>
+                <a16:creationId xmlns:a16="http://schemas.microsoft.com/office/drawing/2014/main" id="{7B8F963C-6EAB-406F-ADF1-4BBD52115E15}"/>
               </a:ext>
             </a:extLst>
           </p:cNvPr>
@@ -7674,7 +7674,7 @@
           <p:cNvPr id="17" name="footer-left">
             <a:extLst xmlns:a="http://schemas.openxmlformats.org/drawingml/2006/main">
               <a:ext uri="{FF2B5EF4-FFF2-40B4-BE49-F238E27FC236}">
-                <a16:creationId xmlns:a16="http://schemas.microsoft.com/office/drawing/2014/main" id="{2B715287-C38A-4564-AF89-ADE0B019B7DD}"/>
+                <a16:creationId xmlns:a16="http://schemas.microsoft.com/office/drawing/2014/main" id="{36ADF64D-0342-469B-9C46-EA4272499C59}"/>
               </a:ext>
             </a:extLst>
           </p:cNvPr>
@@ -7719,7 +7719,7 @@
           <p:cNvPr id="18" name="footer-right">
             <a:extLst xmlns:a="http://schemas.openxmlformats.org/drawingml/2006/main">
               <a:ext uri="{FF2B5EF4-FFF2-40B4-BE49-F238E27FC236}">
-                <a16:creationId xmlns:a16="http://schemas.microsoft.com/office/drawing/2014/main" id="{1922C7D2-E0B3-40B1-BC03-8CA6F312DD1E}"/>
+                <a16:creationId xmlns:a16="http://schemas.microsoft.com/office/drawing/2014/main" id="{4CA777F6-6724-4D0A-862D-A125540951C6}"/>
               </a:ext>
             </a:extLst>
           </p:cNvPr>
@@ -7762,7 +7762,7 @@
     </p:spTree>
     <p:extLst>
       <p:ext uri="{BB962C8B-B14F-4D97-AF65-F5344CB8AC3E}">
-        <p14:creationId xmlns:p14="http://schemas.microsoft.com/office/powerpoint/2010/main" val="1466779401"/>
+        <p14:creationId xmlns:p14="http://schemas.microsoft.com/office/powerpoint/2010/main" val="1654452484"/>
       </p:ext>
     </p:extLst>
   </p:cSld>
@@ -7786,7 +7786,7 @@
           <p:cNvPr id="1" name="slide-stage">
             <a:extLst xmlns:a="http://schemas.openxmlformats.org/drawingml/2006/main">
               <a:ext uri="{FF2B5EF4-FFF2-40B4-BE49-F238E27FC236}">
-                <a16:creationId xmlns:a16="http://schemas.microsoft.com/office/drawing/2014/main" id="{17C97D96-0950-40B7-9AD5-D3BDC2155186}"/>
+                <a16:creationId xmlns:a16="http://schemas.microsoft.com/office/drawing/2014/main" id="{E1C1EC10-00EF-4B5D-91E0-9999D56B6AA2}"/>
               </a:ext>
             </a:extLst>
           </p:cNvPr>
@@ -7813,7 +7813,7 @@
           <p:cNvPr id="2" name="eyebrow">
             <a:extLst xmlns:a="http://schemas.openxmlformats.org/drawingml/2006/main">
               <a:ext uri="{FF2B5EF4-FFF2-40B4-BE49-F238E27FC236}">
-                <a16:creationId xmlns:a16="http://schemas.microsoft.com/office/drawing/2014/main" id="{2F8467A5-0ED7-4E37-B637-A006386502E5}"/>
+                <a16:creationId xmlns:a16="http://schemas.microsoft.com/office/drawing/2014/main" id="{62E6B594-B3CA-4B25-AB46-3D827EE29A0C}"/>
               </a:ext>
             </a:extLst>
           </p:cNvPr>
@@ -7858,7 +7858,7 @@
           <p:cNvPr id="3" name="slide-title">
             <a:extLst xmlns:a="http://schemas.openxmlformats.org/drawingml/2006/main">
               <a:ext uri="{FF2B5EF4-FFF2-40B4-BE49-F238E27FC236}">
-                <a16:creationId xmlns:a16="http://schemas.microsoft.com/office/drawing/2014/main" id="{5843E03C-6B2A-44DE-99E4-40FD1C0FBEA3}"/>
+                <a16:creationId xmlns:a16="http://schemas.microsoft.com/office/drawing/2014/main" id="{FA35C7DC-AA8B-432B-89EC-251B6BA1E976}"/>
               </a:ext>
             </a:extLst>
           </p:cNvPr>
@@ -7903,7 +7903,7 @@
           <p:cNvPr id="4" name="slide-subtitle">
             <a:extLst xmlns:a="http://schemas.openxmlformats.org/drawingml/2006/main">
               <a:ext uri="{FF2B5EF4-FFF2-40B4-BE49-F238E27FC236}">
-                <a16:creationId xmlns:a16="http://schemas.microsoft.com/office/drawing/2014/main" id="{E14CC5B3-1750-4D0E-96FA-5898698B2392}"/>
+                <a16:creationId xmlns:a16="http://schemas.microsoft.com/office/drawing/2014/main" id="{266157DF-8900-42D1-9AED-862069F6A311}"/>
               </a:ext>
             </a:extLst>
           </p:cNvPr>
@@ -7948,7 +7948,7 @@
           <p:cNvPr id="5" name="">
             <a:extLst xmlns:a="http://schemas.openxmlformats.org/drawingml/2006/main">
               <a:ext uri="{FF2B5EF4-FFF2-40B4-BE49-F238E27FC236}">
-                <a16:creationId xmlns:a16="http://schemas.microsoft.com/office/drawing/2014/main" id="{37680CDB-DC6E-413E-99B1-49B8E77D51D4}"/>
+                <a16:creationId xmlns:a16="http://schemas.microsoft.com/office/drawing/2014/main" id="{D1282453-0CA1-4952-93D8-C04C336C6A90}"/>
               </a:ext>
             </a:extLst>
           </p:cNvPr>
@@ -7993,7 +7993,7 @@
           <p:cNvPr id="6" name="">
             <a:extLst xmlns:a="http://schemas.openxmlformats.org/drawingml/2006/main">
               <a:ext uri="{FF2B5EF4-FFF2-40B4-BE49-F238E27FC236}">
-                <a16:creationId xmlns:a16="http://schemas.microsoft.com/office/drawing/2014/main" id="{0B171333-4B2C-4763-B07C-DA7B61BB9737}"/>
+                <a16:creationId xmlns:a16="http://schemas.microsoft.com/office/drawing/2014/main" id="{F6BDAF6A-9954-40B8-9440-6E5B7EDA0319}"/>
               </a:ext>
             </a:extLst>
           </p:cNvPr>
@@ -8038,7 +8038,7 @@
           <p:cNvPr id="7" name="">
             <a:extLst xmlns:a="http://schemas.openxmlformats.org/drawingml/2006/main">
               <a:ext uri="{FF2B5EF4-FFF2-40B4-BE49-F238E27FC236}">
-                <a16:creationId xmlns:a16="http://schemas.microsoft.com/office/drawing/2014/main" id="{A55A225B-2D40-4C2B-A127-94EE7AA18A19}"/>
+                <a16:creationId xmlns:a16="http://schemas.microsoft.com/office/drawing/2014/main" id="{928B6428-DC11-434A-ACF8-48BA920B7F10}"/>
               </a:ext>
             </a:extLst>
           </p:cNvPr>
@@ -8071,7 +8071,7 @@
           <p:cNvPr id="8" name="">
             <a:extLst xmlns:a="http://schemas.openxmlformats.org/drawingml/2006/main">
               <a:ext uri="{FF2B5EF4-FFF2-40B4-BE49-F238E27FC236}">
-                <a16:creationId xmlns:a16="http://schemas.microsoft.com/office/drawing/2014/main" id="{21619DE8-E603-4D6D-9E03-637B286BBCC9}"/>
+                <a16:creationId xmlns:a16="http://schemas.microsoft.com/office/drawing/2014/main" id="{0D473EAE-50B4-4F18-A6CC-CA1E80406C79}"/>
               </a:ext>
             </a:extLst>
           </p:cNvPr>
@@ -8116,7 +8116,7 @@
           <p:cNvPr id="9" name="">
             <a:extLst xmlns:a="http://schemas.openxmlformats.org/drawingml/2006/main">
               <a:ext uri="{FF2B5EF4-FFF2-40B4-BE49-F238E27FC236}">
-                <a16:creationId xmlns:a16="http://schemas.microsoft.com/office/drawing/2014/main" id="{7063B47C-00F2-4824-B99F-6B8EEE94E02D}"/>
+                <a16:creationId xmlns:a16="http://schemas.microsoft.com/office/drawing/2014/main" id="{AB0A300E-E736-4502-84B9-B06D808BF282}"/>
               </a:ext>
             </a:extLst>
           </p:cNvPr>
@@ -8161,7 +8161,7 @@
           <p:cNvPr id="10" name="">
             <a:extLst xmlns:a="http://schemas.openxmlformats.org/drawingml/2006/main">
               <a:ext uri="{FF2B5EF4-FFF2-40B4-BE49-F238E27FC236}">
-                <a16:creationId xmlns:a16="http://schemas.microsoft.com/office/drawing/2014/main" id="{5DA03796-22D5-42CD-BDAF-E24D8F94419B}"/>
+                <a16:creationId xmlns:a16="http://schemas.microsoft.com/office/drawing/2014/main" id="{83340EE0-AD5E-4DC8-8E93-51B6F3755057}"/>
               </a:ext>
             </a:extLst>
           </p:cNvPr>
@@ -8194,7 +8194,7 @@
           <p:cNvPr id="11" name="">
             <a:extLst xmlns:a="http://schemas.openxmlformats.org/drawingml/2006/main">
               <a:ext uri="{FF2B5EF4-FFF2-40B4-BE49-F238E27FC236}">
-                <a16:creationId xmlns:a16="http://schemas.microsoft.com/office/drawing/2014/main" id="{7553F657-43BB-4376-8DAF-03C0399EE474}"/>
+                <a16:creationId xmlns:a16="http://schemas.microsoft.com/office/drawing/2014/main" id="{2BD7152A-3C4A-4D77-AECA-E0D8B63AFD3B}"/>
               </a:ext>
             </a:extLst>
           </p:cNvPr>
@@ -8239,7 +8239,7 @@
           <p:cNvPr id="12" name="">
             <a:extLst xmlns:a="http://schemas.openxmlformats.org/drawingml/2006/main">
               <a:ext uri="{FF2B5EF4-FFF2-40B4-BE49-F238E27FC236}">
-                <a16:creationId xmlns:a16="http://schemas.microsoft.com/office/drawing/2014/main" id="{97210712-5CEB-407E-BFF2-A3E87D68045B}"/>
+                <a16:creationId xmlns:a16="http://schemas.microsoft.com/office/drawing/2014/main" id="{6100D2E9-1AB4-4612-8AA3-6E6957BA14B1}"/>
               </a:ext>
             </a:extLst>
           </p:cNvPr>
@@ -8284,7 +8284,7 @@
           <p:cNvPr id="13" name="">
             <a:extLst xmlns:a="http://schemas.openxmlformats.org/drawingml/2006/main">
               <a:ext uri="{FF2B5EF4-FFF2-40B4-BE49-F238E27FC236}">
-                <a16:creationId xmlns:a16="http://schemas.microsoft.com/office/drawing/2014/main" id="{566B6D24-3799-4CD4-B6E2-C202D5E130D7}"/>
+                <a16:creationId xmlns:a16="http://schemas.microsoft.com/office/drawing/2014/main" id="{515A2EC7-8136-4D54-8316-D23B68F2F855}"/>
               </a:ext>
             </a:extLst>
           </p:cNvPr>
@@ -8317,7 +8317,7 @@
           <p:cNvPr id="14" name="">
             <a:extLst xmlns:a="http://schemas.openxmlformats.org/drawingml/2006/main">
               <a:ext uri="{FF2B5EF4-FFF2-40B4-BE49-F238E27FC236}">
-                <a16:creationId xmlns:a16="http://schemas.microsoft.com/office/drawing/2014/main" id="{18315B27-BBCB-49B3-9E85-30290F46DD93}"/>
+                <a16:creationId xmlns:a16="http://schemas.microsoft.com/office/drawing/2014/main" id="{00EC85F9-D1EF-4526-BC30-14949AA8DE01}"/>
               </a:ext>
             </a:extLst>
           </p:cNvPr>
@@ -8362,7 +8362,7 @@
           <p:cNvPr id="15" name="">
             <a:extLst xmlns:a="http://schemas.openxmlformats.org/drawingml/2006/main">
               <a:ext uri="{FF2B5EF4-FFF2-40B4-BE49-F238E27FC236}">
-                <a16:creationId xmlns:a16="http://schemas.microsoft.com/office/drawing/2014/main" id="{E59D4E65-AC57-4AB4-AF61-AA63EADC5073}"/>
+                <a16:creationId xmlns:a16="http://schemas.microsoft.com/office/drawing/2014/main" id="{BD02A505-2515-42D8-947C-6AF76D1E56B5}"/>
               </a:ext>
             </a:extLst>
           </p:cNvPr>
@@ -8407,7 +8407,7 @@
           <p:cNvPr id="16" name="footer-left">
             <a:extLst xmlns:a="http://schemas.openxmlformats.org/drawingml/2006/main">
               <a:ext uri="{FF2B5EF4-FFF2-40B4-BE49-F238E27FC236}">
-                <a16:creationId xmlns:a16="http://schemas.microsoft.com/office/drawing/2014/main" id="{D6D56CB5-EBA6-445E-92B5-A095BD3B46F2}"/>
+                <a16:creationId xmlns:a16="http://schemas.microsoft.com/office/drawing/2014/main" id="{41751508-CD2E-4556-A20D-83C520B0C748}"/>
               </a:ext>
             </a:extLst>
           </p:cNvPr>
@@ -8452,7 +8452,7 @@
           <p:cNvPr id="17" name="footer-right">
             <a:extLst xmlns:a="http://schemas.openxmlformats.org/drawingml/2006/main">
               <a:ext uri="{FF2B5EF4-FFF2-40B4-BE49-F238E27FC236}">
-                <a16:creationId xmlns:a16="http://schemas.microsoft.com/office/drawing/2014/main" id="{FD6A1172-4E7F-4415-98D9-A96544E5F961}"/>
+                <a16:creationId xmlns:a16="http://schemas.microsoft.com/office/drawing/2014/main" id="{CC2CB7DC-3F6C-401B-8963-E161B08F94F3}"/>
               </a:ext>
             </a:extLst>
           </p:cNvPr>
@@ -8495,7 +8495,7 @@
     </p:spTree>
     <p:extLst>
       <p:ext uri="{BB962C8B-B14F-4D97-AF65-F5344CB8AC3E}">
-        <p14:creationId xmlns:p14="http://schemas.microsoft.com/office/powerpoint/2010/main" val="1123800418"/>
+        <p14:creationId xmlns:p14="http://schemas.microsoft.com/office/powerpoint/2010/main" val="1874771671"/>
       </p:ext>
     </p:extLst>
   </p:cSld>
@@ -8519,7 +8519,7 @@
           <p:cNvPr id="1" name="slide-stage">
             <a:extLst xmlns:a="http://schemas.openxmlformats.org/drawingml/2006/main">
               <a:ext uri="{FF2B5EF4-FFF2-40B4-BE49-F238E27FC236}">
-                <a16:creationId xmlns:a16="http://schemas.microsoft.com/office/drawing/2014/main" id="{29896C42-185A-4AC8-AC02-62116B53F270}"/>
+                <a16:creationId xmlns:a16="http://schemas.microsoft.com/office/drawing/2014/main" id="{45E43D22-E9AC-4DA6-8108-F751EC82F722}"/>
               </a:ext>
             </a:extLst>
           </p:cNvPr>
@@ -8546,7 +8546,7 @@
           <p:cNvPr id="2" name="eyebrow">
             <a:extLst xmlns:a="http://schemas.openxmlformats.org/drawingml/2006/main">
               <a:ext uri="{FF2B5EF4-FFF2-40B4-BE49-F238E27FC236}">
-                <a16:creationId xmlns:a16="http://schemas.microsoft.com/office/drawing/2014/main" id="{4224ABAD-59E7-40C9-83F9-17BEDF4C7D90}"/>
+                <a16:creationId xmlns:a16="http://schemas.microsoft.com/office/drawing/2014/main" id="{BC09050C-BD16-4D1F-A463-8CF5F74E2881}"/>
               </a:ext>
             </a:extLst>
           </p:cNvPr>
@@ -8591,7 +8591,7 @@
           <p:cNvPr id="3" name="slide-title">
             <a:extLst xmlns:a="http://schemas.openxmlformats.org/drawingml/2006/main">
               <a:ext uri="{FF2B5EF4-FFF2-40B4-BE49-F238E27FC236}">
-                <a16:creationId xmlns:a16="http://schemas.microsoft.com/office/drawing/2014/main" id="{2FDE2CFF-3066-474B-9AB9-30AF59702E0C}"/>
+                <a16:creationId xmlns:a16="http://schemas.microsoft.com/office/drawing/2014/main" id="{C62E7169-EA75-41C2-A415-9FCF76FD82FF}"/>
               </a:ext>
             </a:extLst>
           </p:cNvPr>
@@ -8636,7 +8636,7 @@
           <p:cNvPr id="4" name="slide-subtitle">
             <a:extLst xmlns:a="http://schemas.openxmlformats.org/drawingml/2006/main">
               <a:ext uri="{FF2B5EF4-FFF2-40B4-BE49-F238E27FC236}">
-                <a16:creationId xmlns:a16="http://schemas.microsoft.com/office/drawing/2014/main" id="{956E82A8-F709-4299-A80D-DA07577AAC6E}"/>
+                <a16:creationId xmlns:a16="http://schemas.microsoft.com/office/drawing/2014/main" id="{921A7AA6-E943-46AF-83B2-089E41116E6E}"/>
               </a:ext>
             </a:extLst>
           </p:cNvPr>
@@ -8681,7 +8681,7 @@
           <p:cNvPr id="5" name="">
             <a:extLst xmlns:a="http://schemas.openxmlformats.org/drawingml/2006/main">
               <a:ext uri="{FF2B5EF4-FFF2-40B4-BE49-F238E27FC236}">
-                <a16:creationId xmlns:a16="http://schemas.microsoft.com/office/drawing/2014/main" id="{A35CD549-E718-43AB-963B-71593DEF9476}"/>
+                <a16:creationId xmlns:a16="http://schemas.microsoft.com/office/drawing/2014/main" id="{60067D71-4D84-46B3-AF81-0407561035CF}"/>
               </a:ext>
             </a:extLst>
           </p:cNvPr>
@@ -8726,7 +8726,7 @@
           <p:cNvPr id="6" name="">
             <a:extLst xmlns:a="http://schemas.openxmlformats.org/drawingml/2006/main">
               <a:ext uri="{FF2B5EF4-FFF2-40B4-BE49-F238E27FC236}">
-                <a16:creationId xmlns:a16="http://schemas.microsoft.com/office/drawing/2014/main" id="{1657CEF8-43A9-484F-A95D-02A158B7DB09}"/>
+                <a16:creationId xmlns:a16="http://schemas.microsoft.com/office/drawing/2014/main" id="{C695EAD9-9581-4A2C-B43A-40F32EDD324B}"/>
               </a:ext>
             </a:extLst>
           </p:cNvPr>
@@ -8771,7 +8771,7 @@
           <p:cNvPr id="7" name="">
             <a:extLst xmlns:a="http://schemas.openxmlformats.org/drawingml/2006/main">
               <a:ext uri="{FF2B5EF4-FFF2-40B4-BE49-F238E27FC236}">
-                <a16:creationId xmlns:a16="http://schemas.microsoft.com/office/drawing/2014/main" id="{608335D2-0D7E-4D2C-8568-858E7AE240EC}"/>
+                <a16:creationId xmlns:a16="http://schemas.microsoft.com/office/drawing/2014/main" id="{2F1A162B-1E31-4676-AE78-94E1F0C5FD6E}"/>
               </a:ext>
             </a:extLst>
           </p:cNvPr>
@@ -8816,7 +8816,7 @@
           <p:cNvPr id="8" name="">
             <a:extLst xmlns:a="http://schemas.openxmlformats.org/drawingml/2006/main">
               <a:ext uri="{FF2B5EF4-FFF2-40B4-BE49-F238E27FC236}">
-                <a16:creationId xmlns:a16="http://schemas.microsoft.com/office/drawing/2014/main" id="{370B5704-8BA4-4BB2-89BE-9DE0FF4BC353}"/>
+                <a16:creationId xmlns:a16="http://schemas.microsoft.com/office/drawing/2014/main" id="{8B917CAB-1E5C-486D-BFCB-85F5B53E44AA}"/>
               </a:ext>
             </a:extLst>
           </p:cNvPr>
@@ -8861,7 +8861,7 @@
           <p:cNvPr id="9" name="">
             <a:extLst xmlns:a="http://schemas.openxmlformats.org/drawingml/2006/main">
               <a:ext uri="{FF2B5EF4-FFF2-40B4-BE49-F238E27FC236}">
-                <a16:creationId xmlns:a16="http://schemas.microsoft.com/office/drawing/2014/main" id="{BFAF74BC-6866-416B-8BA2-D2CE21E6A05F}"/>
+                <a16:creationId xmlns:a16="http://schemas.microsoft.com/office/drawing/2014/main" id="{56E41F46-22E5-435A-8CF9-E6C163B3C70E}"/>
               </a:ext>
             </a:extLst>
           </p:cNvPr>
@@ -8906,7 +8906,7 @@
           <p:cNvPr id="10" name="">
             <a:extLst xmlns:a="http://schemas.openxmlformats.org/drawingml/2006/main">
               <a:ext uri="{FF2B5EF4-FFF2-40B4-BE49-F238E27FC236}">
-                <a16:creationId xmlns:a16="http://schemas.microsoft.com/office/drawing/2014/main" id="{D32A122A-7002-4A85-9BA1-972CF552EA65}"/>
+                <a16:creationId xmlns:a16="http://schemas.microsoft.com/office/drawing/2014/main" id="{0C4FA8FF-88D1-4D23-B17A-38189115D2F8}"/>
               </a:ext>
             </a:extLst>
           </p:cNvPr>
@@ -8951,7 +8951,7 @@
           <p:cNvPr id="11" name="">
             <a:extLst xmlns:a="http://schemas.openxmlformats.org/drawingml/2006/main">
               <a:ext uri="{FF2B5EF4-FFF2-40B4-BE49-F238E27FC236}">
-                <a16:creationId xmlns:a16="http://schemas.microsoft.com/office/drawing/2014/main" id="{5A403386-D03C-4C59-BD33-6CBB28A6E579}"/>
+                <a16:creationId xmlns:a16="http://schemas.microsoft.com/office/drawing/2014/main" id="{51AE1E4A-DF8A-4129-A037-C48433C73ABD}"/>
               </a:ext>
             </a:extLst>
           </p:cNvPr>
@@ -8996,7 +8996,7 @@
           <p:cNvPr id="12" name="">
             <a:extLst xmlns:a="http://schemas.openxmlformats.org/drawingml/2006/main">
               <a:ext uri="{FF2B5EF4-FFF2-40B4-BE49-F238E27FC236}">
-                <a16:creationId xmlns:a16="http://schemas.microsoft.com/office/drawing/2014/main" id="{C147EE26-E72B-4622-956A-344FBA2DE99C}"/>
+                <a16:creationId xmlns:a16="http://schemas.microsoft.com/office/drawing/2014/main" id="{EF83ADDA-090F-4252-9A7B-875D0FFE65F5}"/>
               </a:ext>
             </a:extLst>
           </p:cNvPr>
@@ -9041,7 +9041,7 @@
           <p:cNvPr id="13" name="footer-left">
             <a:extLst xmlns:a="http://schemas.openxmlformats.org/drawingml/2006/main">
               <a:ext uri="{FF2B5EF4-FFF2-40B4-BE49-F238E27FC236}">
-                <a16:creationId xmlns:a16="http://schemas.microsoft.com/office/drawing/2014/main" id="{A413C38F-29B7-4A26-8F01-4CB32D095415}"/>
+                <a16:creationId xmlns:a16="http://schemas.microsoft.com/office/drawing/2014/main" id="{A7934F5F-2A81-4E55-82C2-3B5818FF9FB8}"/>
               </a:ext>
             </a:extLst>
           </p:cNvPr>
@@ -9086,7 +9086,7 @@
           <p:cNvPr id="14" name="footer-right">
             <a:extLst xmlns:a="http://schemas.openxmlformats.org/drawingml/2006/main">
               <a:ext uri="{FF2B5EF4-FFF2-40B4-BE49-F238E27FC236}">
-                <a16:creationId xmlns:a16="http://schemas.microsoft.com/office/drawing/2014/main" id="{A8BD07B1-1DF5-4DEE-BC5B-D62A321C8CFA}"/>
+                <a16:creationId xmlns:a16="http://schemas.microsoft.com/office/drawing/2014/main" id="{6067FE77-570D-44A6-82CE-441438FE3CD0}"/>
               </a:ext>
             </a:extLst>
           </p:cNvPr>
@@ -9129,7 +9129,7 @@
     </p:spTree>
     <p:extLst>
       <p:ext uri="{BB962C8B-B14F-4D97-AF65-F5344CB8AC3E}">
-        <p14:creationId xmlns:p14="http://schemas.microsoft.com/office/powerpoint/2010/main" val="472024529"/>
+        <p14:creationId xmlns:p14="http://schemas.microsoft.com/office/powerpoint/2010/main" val="91597172"/>
       </p:ext>
     </p:extLst>
   </p:cSld>
@@ -9153,7 +9153,7 @@
           <p:cNvPr id="1" name="slide-stage">
             <a:extLst xmlns:a="http://schemas.openxmlformats.org/drawingml/2006/main">
               <a:ext uri="{FF2B5EF4-FFF2-40B4-BE49-F238E27FC236}">
-                <a16:creationId xmlns:a16="http://schemas.microsoft.com/office/drawing/2014/main" id="{75B94760-0F4D-4CA3-9529-9728836F1852}"/>
+                <a16:creationId xmlns:a16="http://schemas.microsoft.com/office/drawing/2014/main" id="{EA1E9340-BF78-4876-87DB-AAEF97855F16}"/>
               </a:ext>
             </a:extLst>
           </p:cNvPr>
@@ -9180,7 +9180,7 @@
           <p:cNvPr id="2" name="eyebrow">
             <a:extLst xmlns:a="http://schemas.openxmlformats.org/drawingml/2006/main">
               <a:ext uri="{FF2B5EF4-FFF2-40B4-BE49-F238E27FC236}">
-                <a16:creationId xmlns:a16="http://schemas.microsoft.com/office/drawing/2014/main" id="{579146AA-54DD-4589-8A59-8ED24FC2CB39}"/>
+                <a16:creationId xmlns:a16="http://schemas.microsoft.com/office/drawing/2014/main" id="{DC3FAECD-202A-46A8-B126-ABF49FEC6E93}"/>
               </a:ext>
             </a:extLst>
           </p:cNvPr>
@@ -9225,7 +9225,7 @@
           <p:cNvPr id="3" name="slide-title">
             <a:extLst xmlns:a="http://schemas.openxmlformats.org/drawingml/2006/main">
               <a:ext uri="{FF2B5EF4-FFF2-40B4-BE49-F238E27FC236}">
-                <a16:creationId xmlns:a16="http://schemas.microsoft.com/office/drawing/2014/main" id="{595FB698-DE5D-450D-B471-AFBC49878D92}"/>
+                <a16:creationId xmlns:a16="http://schemas.microsoft.com/office/drawing/2014/main" id="{349D3150-1D0D-4951-9066-4F24E3F95945}"/>
               </a:ext>
             </a:extLst>
           </p:cNvPr>
@@ -9270,7 +9270,7 @@
           <p:cNvPr id="4" name="slide-subtitle">
             <a:extLst xmlns:a="http://schemas.openxmlformats.org/drawingml/2006/main">
               <a:ext uri="{FF2B5EF4-FFF2-40B4-BE49-F238E27FC236}">
-                <a16:creationId xmlns:a16="http://schemas.microsoft.com/office/drawing/2014/main" id="{A0BB9702-ADE3-4BC1-ADD4-7516D3DD625B}"/>
+                <a16:creationId xmlns:a16="http://schemas.microsoft.com/office/drawing/2014/main" id="{1841E23C-85F5-497D-9B4D-A28245F2184D}"/>
               </a:ext>
             </a:extLst>
           </p:cNvPr>
@@ -9315,7 +9315,7 @@
           <p:cNvPr id="5" name="">
             <a:extLst xmlns:a="http://schemas.openxmlformats.org/drawingml/2006/main">
               <a:ext uri="{FF2B5EF4-FFF2-40B4-BE49-F238E27FC236}">
-                <a16:creationId xmlns:a16="http://schemas.microsoft.com/office/drawing/2014/main" id="{575A4143-1911-4CC7-9966-049DB70025FB}"/>
+                <a16:creationId xmlns:a16="http://schemas.microsoft.com/office/drawing/2014/main" id="{30228937-7B46-47EC-B6FB-2DCCE06F9DD7}"/>
               </a:ext>
             </a:extLst>
           </p:cNvPr>
@@ -9348,7 +9348,7 @@
           <p:cNvPr id="6" name="">
             <a:extLst xmlns:a="http://schemas.openxmlformats.org/drawingml/2006/main">
               <a:ext uri="{FF2B5EF4-FFF2-40B4-BE49-F238E27FC236}">
-                <a16:creationId xmlns:a16="http://schemas.microsoft.com/office/drawing/2014/main" id="{CD76DA4C-E28B-40CA-8A3B-2A8FAD1B5A42}"/>
+                <a16:creationId xmlns:a16="http://schemas.microsoft.com/office/drawing/2014/main" id="{04279883-368B-491A-AD21-08B1F83DF521}"/>
               </a:ext>
             </a:extLst>
           </p:cNvPr>
@@ -9393,7 +9393,7 @@
           <p:cNvPr id="7" name="">
             <a:extLst xmlns:a="http://schemas.openxmlformats.org/drawingml/2006/main">
               <a:ext uri="{FF2B5EF4-FFF2-40B4-BE49-F238E27FC236}">
-                <a16:creationId xmlns:a16="http://schemas.microsoft.com/office/drawing/2014/main" id="{30D02445-ED51-4CE2-A390-55E32E14CE7F}"/>
+                <a16:creationId xmlns:a16="http://schemas.microsoft.com/office/drawing/2014/main" id="{D36CA32A-2420-45B0-A51C-6A412211463D}"/>
               </a:ext>
             </a:extLst>
           </p:cNvPr>
@@ -9438,7 +9438,7 @@
           <p:cNvPr id="8" name="">
             <a:extLst xmlns:a="http://schemas.openxmlformats.org/drawingml/2006/main">
               <a:ext uri="{FF2B5EF4-FFF2-40B4-BE49-F238E27FC236}">
-                <a16:creationId xmlns:a16="http://schemas.microsoft.com/office/drawing/2014/main" id="{9270AAA3-E94D-453A-90A1-C16A537E9473}"/>
+                <a16:creationId xmlns:a16="http://schemas.microsoft.com/office/drawing/2014/main" id="{C205E78A-2DDC-478C-B1D0-AAF2338AA7C8}"/>
               </a:ext>
             </a:extLst>
           </p:cNvPr>
@@ -9471,7 +9471,7 @@
           <p:cNvPr id="9" name="">
             <a:extLst xmlns:a="http://schemas.openxmlformats.org/drawingml/2006/main">
               <a:ext uri="{FF2B5EF4-FFF2-40B4-BE49-F238E27FC236}">
-                <a16:creationId xmlns:a16="http://schemas.microsoft.com/office/drawing/2014/main" id="{6CEEC6AC-A4FF-47BF-B9B8-F34C8D3ED078}"/>
+                <a16:creationId xmlns:a16="http://schemas.microsoft.com/office/drawing/2014/main" id="{EFA4DFE2-DA05-4F3A-8965-B97036A94410}"/>
               </a:ext>
             </a:extLst>
           </p:cNvPr>
@@ -9516,7 +9516,7 @@
           <p:cNvPr id="10" name="">
             <a:extLst xmlns:a="http://schemas.openxmlformats.org/drawingml/2006/main">
               <a:ext uri="{FF2B5EF4-FFF2-40B4-BE49-F238E27FC236}">
-                <a16:creationId xmlns:a16="http://schemas.microsoft.com/office/drawing/2014/main" id="{4EF43BF5-92DE-42D8-A1ED-3750720848DF}"/>
+                <a16:creationId xmlns:a16="http://schemas.microsoft.com/office/drawing/2014/main" id="{CD11FDF8-920F-4B4D-888C-3264580BB325}"/>
               </a:ext>
             </a:extLst>
           </p:cNvPr>
@@ -9561,7 +9561,7 @@
           <p:cNvPr id="11" name="">
             <a:extLst xmlns:a="http://schemas.openxmlformats.org/drawingml/2006/main">
               <a:ext uri="{FF2B5EF4-FFF2-40B4-BE49-F238E27FC236}">
-                <a16:creationId xmlns:a16="http://schemas.microsoft.com/office/drawing/2014/main" id="{A4D52B09-4538-4458-96F4-58FF26E6A713}"/>
+                <a16:creationId xmlns:a16="http://schemas.microsoft.com/office/drawing/2014/main" id="{773D74DA-ACCE-467A-984B-C4EFBFD9B904}"/>
               </a:ext>
             </a:extLst>
           </p:cNvPr>
@@ -9594,7 +9594,7 @@
           <p:cNvPr id="12" name="">
             <a:extLst xmlns:a="http://schemas.openxmlformats.org/drawingml/2006/main">
               <a:ext uri="{FF2B5EF4-FFF2-40B4-BE49-F238E27FC236}">
-                <a16:creationId xmlns:a16="http://schemas.microsoft.com/office/drawing/2014/main" id="{41E31344-0915-428F-B9FC-B61DBD213502}"/>
+                <a16:creationId xmlns:a16="http://schemas.microsoft.com/office/drawing/2014/main" id="{30EB1F3C-FE41-4DEC-97D4-D693ABE4FA85}"/>
               </a:ext>
             </a:extLst>
           </p:cNvPr>
@@ -9639,7 +9639,7 @@
           <p:cNvPr id="13" name="">
             <a:extLst xmlns:a="http://schemas.openxmlformats.org/drawingml/2006/main">
               <a:ext uri="{FF2B5EF4-FFF2-40B4-BE49-F238E27FC236}">
-                <a16:creationId xmlns:a16="http://schemas.microsoft.com/office/drawing/2014/main" id="{C22BB0EC-EBB1-4FF0-85C3-2DFB72B8F59F}"/>
+                <a16:creationId xmlns:a16="http://schemas.microsoft.com/office/drawing/2014/main" id="{16707567-5D78-418E-B806-390343BEA0AF}"/>
               </a:ext>
             </a:extLst>
           </p:cNvPr>
@@ -9684,7 +9684,7 @@
           <p:cNvPr id="14" name="">
             <a:extLst xmlns:a="http://schemas.openxmlformats.org/drawingml/2006/main">
               <a:ext uri="{FF2B5EF4-FFF2-40B4-BE49-F238E27FC236}">
-                <a16:creationId xmlns:a16="http://schemas.microsoft.com/office/drawing/2014/main" id="{FCE8F2F1-0BF3-4F1C-9A6B-CBCD10C75220}"/>
+                <a16:creationId xmlns:a16="http://schemas.microsoft.com/office/drawing/2014/main" id="{7E6C3D59-3DA6-456E-8BC9-271D87AF9BB9}"/>
               </a:ext>
             </a:extLst>
           </p:cNvPr>
@@ -9729,7 +9729,7 @@
           <p:cNvPr id="15" name="footer-left">
             <a:extLst xmlns:a="http://schemas.openxmlformats.org/drawingml/2006/main">
               <a:ext uri="{FF2B5EF4-FFF2-40B4-BE49-F238E27FC236}">
-                <a16:creationId xmlns:a16="http://schemas.microsoft.com/office/drawing/2014/main" id="{1D4C4678-80D2-407B-954B-F71676FE7BF5}"/>
+                <a16:creationId xmlns:a16="http://schemas.microsoft.com/office/drawing/2014/main" id="{17A90459-E347-40E3-8366-DF0FA2EFFB2A}"/>
               </a:ext>
             </a:extLst>
           </p:cNvPr>
@@ -9774,7 +9774,7 @@
           <p:cNvPr id="16" name="footer-right">
             <a:extLst xmlns:a="http://schemas.openxmlformats.org/drawingml/2006/main">
               <a:ext uri="{FF2B5EF4-FFF2-40B4-BE49-F238E27FC236}">
-                <a16:creationId xmlns:a16="http://schemas.microsoft.com/office/drawing/2014/main" id="{FFA09D75-1115-479F-BDD0-3576216E067C}"/>
+                <a16:creationId xmlns:a16="http://schemas.microsoft.com/office/drawing/2014/main" id="{F0C63A69-0138-4243-AD12-297ED2738C8E}"/>
               </a:ext>
             </a:extLst>
           </p:cNvPr>
@@ -9817,7 +9817,7 @@
     </p:spTree>
     <p:extLst>
       <p:ext uri="{BB962C8B-B14F-4D97-AF65-F5344CB8AC3E}">
-        <p14:creationId xmlns:p14="http://schemas.microsoft.com/office/powerpoint/2010/main" val="1406701449"/>
+        <p14:creationId xmlns:p14="http://schemas.microsoft.com/office/powerpoint/2010/main" val="963148749"/>
       </p:ext>
     </p:extLst>
   </p:cSld>
@@ -9841,7 +9841,7 @@
           <p:cNvPr id="1" name="slide-stage">
             <a:extLst xmlns:a="http://schemas.openxmlformats.org/drawingml/2006/main">
               <a:ext uri="{FF2B5EF4-FFF2-40B4-BE49-F238E27FC236}">
-                <a16:creationId xmlns:a16="http://schemas.microsoft.com/office/drawing/2014/main" id="{B6DD3E5F-C5E3-42DC-8DAC-73D6BFB2F29B}"/>
+                <a16:creationId xmlns:a16="http://schemas.microsoft.com/office/drawing/2014/main" id="{2BBF1982-6326-4368-8765-42321CF26115}"/>
               </a:ext>
             </a:extLst>
           </p:cNvPr>
@@ -9868,7 +9868,7 @@
           <p:cNvPr id="2" name="eyebrow">
             <a:extLst xmlns:a="http://schemas.openxmlformats.org/drawingml/2006/main">
               <a:ext uri="{FF2B5EF4-FFF2-40B4-BE49-F238E27FC236}">
-                <a16:creationId xmlns:a16="http://schemas.microsoft.com/office/drawing/2014/main" id="{B7E1081D-55DC-4031-A412-E4A9F1C6ADA0}"/>
+                <a16:creationId xmlns:a16="http://schemas.microsoft.com/office/drawing/2014/main" id="{4710FA7E-139A-41ED-9E48-568FF366FE2E}"/>
               </a:ext>
             </a:extLst>
           </p:cNvPr>
@@ -9913,7 +9913,7 @@
           <p:cNvPr id="3" name="slide-title">
             <a:extLst xmlns:a="http://schemas.openxmlformats.org/drawingml/2006/main">
               <a:ext uri="{FF2B5EF4-FFF2-40B4-BE49-F238E27FC236}">
-                <a16:creationId xmlns:a16="http://schemas.microsoft.com/office/drawing/2014/main" id="{CFC062B6-ED42-4ADD-8270-14B17E17CD49}"/>
+                <a16:creationId xmlns:a16="http://schemas.microsoft.com/office/drawing/2014/main" id="{714E55BB-22E1-45A8-B260-4FBB7322D46D}"/>
               </a:ext>
             </a:extLst>
           </p:cNvPr>
@@ -9958,7 +9958,7 @@
           <p:cNvPr id="4" name="slide-subtitle">
             <a:extLst xmlns:a="http://schemas.openxmlformats.org/drawingml/2006/main">
               <a:ext uri="{FF2B5EF4-FFF2-40B4-BE49-F238E27FC236}">
-                <a16:creationId xmlns:a16="http://schemas.microsoft.com/office/drawing/2014/main" id="{AF1CF44C-2312-4EFD-9DE7-E1DF60FBA434}"/>
+                <a16:creationId xmlns:a16="http://schemas.microsoft.com/office/drawing/2014/main" id="{4AD40384-64F1-4252-BE04-33C1FB649542}"/>
               </a:ext>
             </a:extLst>
           </p:cNvPr>
@@ -10003,7 +10003,7 @@
           <p:cNvPr id="5" name="">
             <a:extLst xmlns:a="http://schemas.openxmlformats.org/drawingml/2006/main">
               <a:ext uri="{FF2B5EF4-FFF2-40B4-BE49-F238E27FC236}">
-                <a16:creationId xmlns:a16="http://schemas.microsoft.com/office/drawing/2014/main" id="{8EA7B540-EBF8-41D6-AA53-39D4A823CE84}"/>
+                <a16:creationId xmlns:a16="http://schemas.microsoft.com/office/drawing/2014/main" id="{14E16C36-AAB1-4F2B-AD1F-331D018B8158}"/>
               </a:ext>
             </a:extLst>
           </p:cNvPr>
@@ -10048,7 +10048,7 @@
           <p:cNvPr id="6" name="">
             <a:extLst xmlns:a="http://schemas.openxmlformats.org/drawingml/2006/main">
               <a:ext uri="{FF2B5EF4-FFF2-40B4-BE49-F238E27FC236}">
-                <a16:creationId xmlns:a16="http://schemas.microsoft.com/office/drawing/2014/main" id="{DE0107AC-71D5-492A-9ADC-8D39DEB267D6}"/>
+                <a16:creationId xmlns:a16="http://schemas.microsoft.com/office/drawing/2014/main" id="{0498F2F2-3D82-4760-855E-6D7757A162F8}"/>
               </a:ext>
             </a:extLst>
           </p:cNvPr>
@@ -10093,7 +10093,7 @@
           <p:cNvPr id="7" name="">
             <a:extLst xmlns:a="http://schemas.openxmlformats.org/drawingml/2006/main">
               <a:ext uri="{FF2B5EF4-FFF2-40B4-BE49-F238E27FC236}">
-                <a16:creationId xmlns:a16="http://schemas.microsoft.com/office/drawing/2014/main" id="{8782B6ED-FFDF-4D91-B54B-0CB47335CD64}"/>
+                <a16:creationId xmlns:a16="http://schemas.microsoft.com/office/drawing/2014/main" id="{48ACA7BE-E156-4FFF-B972-38386F69A4C6}"/>
               </a:ext>
             </a:extLst>
           </p:cNvPr>
@@ -10138,7 +10138,7 @@
           <p:cNvPr id="8" name="">
             <a:extLst xmlns:a="http://schemas.openxmlformats.org/drawingml/2006/main">
               <a:ext uri="{FF2B5EF4-FFF2-40B4-BE49-F238E27FC236}">
-                <a16:creationId xmlns:a16="http://schemas.microsoft.com/office/drawing/2014/main" id="{05C404FC-6850-4411-947B-BCFD9EDFC01A}"/>
+                <a16:creationId xmlns:a16="http://schemas.microsoft.com/office/drawing/2014/main" id="{1B4D0FA3-5E91-4307-ADF6-5BC038C7B25D}"/>
               </a:ext>
             </a:extLst>
           </p:cNvPr>
@@ -10183,7 +10183,7 @@
           <p:cNvPr id="9" name="">
             <a:extLst xmlns:a="http://schemas.openxmlformats.org/drawingml/2006/main">
               <a:ext uri="{FF2B5EF4-FFF2-40B4-BE49-F238E27FC236}">
-                <a16:creationId xmlns:a16="http://schemas.microsoft.com/office/drawing/2014/main" id="{FA43A1AE-C357-43EE-B648-5FF4EE53EA64}"/>
+                <a16:creationId xmlns:a16="http://schemas.microsoft.com/office/drawing/2014/main" id="{C75C6F1C-BC10-4570-A554-55CE73A7FF58}"/>
               </a:ext>
             </a:extLst>
           </p:cNvPr>
@@ -10228,7 +10228,7 @@
           <p:cNvPr id="10" name="">
             <a:extLst xmlns:a="http://schemas.openxmlformats.org/drawingml/2006/main">
               <a:ext uri="{FF2B5EF4-FFF2-40B4-BE49-F238E27FC236}">
-                <a16:creationId xmlns:a16="http://schemas.microsoft.com/office/drawing/2014/main" id="{82A6DB58-90BA-4CAB-897B-700063FFF0F4}"/>
+                <a16:creationId xmlns:a16="http://schemas.microsoft.com/office/drawing/2014/main" id="{BBAEBEAF-2F28-4FDD-8761-20D5E509E911}"/>
               </a:ext>
             </a:extLst>
           </p:cNvPr>
@@ -10273,7 +10273,7 @@
           <p:cNvPr id="11" name="">
             <a:extLst xmlns:a="http://schemas.openxmlformats.org/drawingml/2006/main">
               <a:ext uri="{FF2B5EF4-FFF2-40B4-BE49-F238E27FC236}">
-                <a16:creationId xmlns:a16="http://schemas.microsoft.com/office/drawing/2014/main" id="{11F6BDB6-EED2-4127-8DDF-0DCD8E123085}"/>
+                <a16:creationId xmlns:a16="http://schemas.microsoft.com/office/drawing/2014/main" id="{3C5D9B43-A912-4144-AC1A-522054813DE3}"/>
               </a:ext>
             </a:extLst>
           </p:cNvPr>
@@ -10318,7 +10318,7 @@
           <p:cNvPr id="12" name="">
             <a:extLst xmlns:a="http://schemas.openxmlformats.org/drawingml/2006/main">
               <a:ext uri="{FF2B5EF4-FFF2-40B4-BE49-F238E27FC236}">
-                <a16:creationId xmlns:a16="http://schemas.microsoft.com/office/drawing/2014/main" id="{50605773-109A-438B-81E2-F0F8A859BCB3}"/>
+                <a16:creationId xmlns:a16="http://schemas.microsoft.com/office/drawing/2014/main" id="{9EDE9848-89B8-4693-B685-69D2C5FB412B}"/>
               </a:ext>
             </a:extLst>
           </p:cNvPr>
@@ -10363,7 +10363,7 @@
           <p:cNvPr id="13" name="">
             <a:extLst xmlns:a="http://schemas.openxmlformats.org/drawingml/2006/main">
               <a:ext uri="{FF2B5EF4-FFF2-40B4-BE49-F238E27FC236}">
-                <a16:creationId xmlns:a16="http://schemas.microsoft.com/office/drawing/2014/main" id="{C8B50F6E-8E55-4BFE-927C-ED070BD09B4B}"/>
+                <a16:creationId xmlns:a16="http://schemas.microsoft.com/office/drawing/2014/main" id="{2FFB39FF-656B-4272-8ADD-EDFCF72A21BF}"/>
               </a:ext>
             </a:extLst>
           </p:cNvPr>
@@ -10408,7 +10408,7 @@
           <p:cNvPr id="14" name="">
             <a:extLst xmlns:a="http://schemas.openxmlformats.org/drawingml/2006/main">
               <a:ext uri="{FF2B5EF4-FFF2-40B4-BE49-F238E27FC236}">
-                <a16:creationId xmlns:a16="http://schemas.microsoft.com/office/drawing/2014/main" id="{E1998EC3-9C59-4A90-82F8-61AADE88190A}"/>
+                <a16:creationId xmlns:a16="http://schemas.microsoft.com/office/drawing/2014/main" id="{8C3ADEB7-D43D-4512-B1FD-25A5CBF4EE77}"/>
               </a:ext>
             </a:extLst>
           </p:cNvPr>
@@ -10453,7 +10453,7 @@
           <p:cNvPr id="15" name="">
             <a:extLst xmlns:a="http://schemas.openxmlformats.org/drawingml/2006/main">
               <a:ext uri="{FF2B5EF4-FFF2-40B4-BE49-F238E27FC236}">
-                <a16:creationId xmlns:a16="http://schemas.microsoft.com/office/drawing/2014/main" id="{B14A07A3-BF1E-4C9B-AF46-34A49DAD6CAC}"/>
+                <a16:creationId xmlns:a16="http://schemas.microsoft.com/office/drawing/2014/main" id="{841BC9F0-A0AE-4382-B0F8-605DE562F7D1}"/>
               </a:ext>
             </a:extLst>
           </p:cNvPr>
@@ -10498,7 +10498,7 @@
           <p:cNvPr id="16" name="">
             <a:extLst xmlns:a="http://schemas.openxmlformats.org/drawingml/2006/main">
               <a:ext uri="{FF2B5EF4-FFF2-40B4-BE49-F238E27FC236}">
-                <a16:creationId xmlns:a16="http://schemas.microsoft.com/office/drawing/2014/main" id="{CE2A2BBA-923F-4937-9C80-5D83CBF95BA9}"/>
+                <a16:creationId xmlns:a16="http://schemas.microsoft.com/office/drawing/2014/main" id="{1405EDA3-DA42-4BFB-AB8D-4A3292756F62}"/>
               </a:ext>
             </a:extLst>
           </p:cNvPr>
@@ -10543,7 +10543,7 @@
           <p:cNvPr id="17" name="">
             <a:extLst xmlns:a="http://schemas.openxmlformats.org/drawingml/2006/main">
               <a:ext uri="{FF2B5EF4-FFF2-40B4-BE49-F238E27FC236}">
-                <a16:creationId xmlns:a16="http://schemas.microsoft.com/office/drawing/2014/main" id="{C270211E-24DB-4C67-BD4C-A291E61F9CF3}"/>
+                <a16:creationId xmlns:a16="http://schemas.microsoft.com/office/drawing/2014/main" id="{842F9E0E-264C-4750-95E7-86447C9480EF}"/>
               </a:ext>
             </a:extLst>
           </p:cNvPr>
@@ -10588,7 +10588,7 @@
           <p:cNvPr id="18" name="">
             <a:extLst xmlns:a="http://schemas.openxmlformats.org/drawingml/2006/main">
               <a:ext uri="{FF2B5EF4-FFF2-40B4-BE49-F238E27FC236}">
-                <a16:creationId xmlns:a16="http://schemas.microsoft.com/office/drawing/2014/main" id="{A8FD643D-3FC6-429B-BA25-7297A1A2F578}"/>
+                <a16:creationId xmlns:a16="http://schemas.microsoft.com/office/drawing/2014/main" id="{438A5357-049A-4C65-AC28-375F09D66899}"/>
               </a:ext>
             </a:extLst>
           </p:cNvPr>
@@ -10633,7 +10633,7 @@
           <p:cNvPr id="19" name="">
             <a:extLst xmlns:a="http://schemas.openxmlformats.org/drawingml/2006/main">
               <a:ext uri="{FF2B5EF4-FFF2-40B4-BE49-F238E27FC236}">
-                <a16:creationId xmlns:a16="http://schemas.microsoft.com/office/drawing/2014/main" id="{D275F921-A134-4F8C-B317-71BFA8D34B46}"/>
+                <a16:creationId xmlns:a16="http://schemas.microsoft.com/office/drawing/2014/main" id="{FAD1397F-2D8E-4AA3-9569-D8C65B5E962A}"/>
               </a:ext>
             </a:extLst>
           </p:cNvPr>
@@ -10678,7 +10678,7 @@
           <p:cNvPr id="20" name="footer-left">
             <a:extLst xmlns:a="http://schemas.openxmlformats.org/drawingml/2006/main">
               <a:ext uri="{FF2B5EF4-FFF2-40B4-BE49-F238E27FC236}">
-                <a16:creationId xmlns:a16="http://schemas.microsoft.com/office/drawing/2014/main" id="{EB28AD91-76CE-4980-9F1A-7CEDF2A5016C}"/>
+                <a16:creationId xmlns:a16="http://schemas.microsoft.com/office/drawing/2014/main" id="{D2065C97-EA77-4C46-9C4C-67F3B74C5641}"/>
               </a:ext>
             </a:extLst>
           </p:cNvPr>
@@ -10723,7 +10723,7 @@
           <p:cNvPr id="21" name="footer-right">
             <a:extLst xmlns:a="http://schemas.openxmlformats.org/drawingml/2006/main">
               <a:ext uri="{FF2B5EF4-FFF2-40B4-BE49-F238E27FC236}">
-                <a16:creationId xmlns:a16="http://schemas.microsoft.com/office/drawing/2014/main" id="{1D7219F5-6BAF-4542-A096-9A97EED21549}"/>
+                <a16:creationId xmlns:a16="http://schemas.microsoft.com/office/drawing/2014/main" id="{15AC7ECB-F004-4727-8C76-90A4C9F9AD6E}"/>
               </a:ext>
             </a:extLst>
           </p:cNvPr>
@@ -10766,7 +10766,7 @@
     </p:spTree>
     <p:extLst>
       <p:ext uri="{BB962C8B-B14F-4D97-AF65-F5344CB8AC3E}">
-        <p14:creationId xmlns:p14="http://schemas.microsoft.com/office/powerpoint/2010/main" val="878588150"/>
+        <p14:creationId xmlns:p14="http://schemas.microsoft.com/office/powerpoint/2010/main" val="1691585456"/>
       </p:ext>
     </p:extLst>
   </p:cSld>
@@ -10790,7 +10790,7 @@
           <p:cNvPr id="1" name="slide-stage">
             <a:extLst xmlns:a="http://schemas.openxmlformats.org/drawingml/2006/main">
               <a:ext uri="{FF2B5EF4-FFF2-40B4-BE49-F238E27FC236}">
-                <a16:creationId xmlns:a16="http://schemas.microsoft.com/office/drawing/2014/main" id="{B8F37E99-B9DE-47D5-BB26-8E8CFD3F1479}"/>
+                <a16:creationId xmlns:a16="http://schemas.microsoft.com/office/drawing/2014/main" id="{2E959592-C9EB-4169-96F6-816B3B9F1C14}"/>
               </a:ext>
             </a:extLst>
           </p:cNvPr>
@@ -10817,7 +10817,7 @@
           <p:cNvPr id="2" name="eyebrow">
             <a:extLst xmlns:a="http://schemas.openxmlformats.org/drawingml/2006/main">
               <a:ext uri="{FF2B5EF4-FFF2-40B4-BE49-F238E27FC236}">
-                <a16:creationId xmlns:a16="http://schemas.microsoft.com/office/drawing/2014/main" id="{B69C0CAB-6541-48DB-8757-0D3564F0B59F}"/>
+                <a16:creationId xmlns:a16="http://schemas.microsoft.com/office/drawing/2014/main" id="{00CA6ED4-FB84-41DD-99C6-6FE4024F88B4}"/>
               </a:ext>
             </a:extLst>
           </p:cNvPr>
@@ -10862,7 +10862,7 @@
           <p:cNvPr id="3" name="slide-title">
             <a:extLst xmlns:a="http://schemas.openxmlformats.org/drawingml/2006/main">
               <a:ext uri="{FF2B5EF4-FFF2-40B4-BE49-F238E27FC236}">
-                <a16:creationId xmlns:a16="http://schemas.microsoft.com/office/drawing/2014/main" id="{D3B3CAB6-2337-4D8F-9E42-51D6FE6A082F}"/>
+                <a16:creationId xmlns:a16="http://schemas.microsoft.com/office/drawing/2014/main" id="{9F291B9C-E4E7-4DC2-9CC9-79AD82AAF6C1}"/>
               </a:ext>
             </a:extLst>
           </p:cNvPr>
@@ -10907,7 +10907,7 @@
           <p:cNvPr id="4" name="slide-subtitle">
             <a:extLst xmlns:a="http://schemas.openxmlformats.org/drawingml/2006/main">
               <a:ext uri="{FF2B5EF4-FFF2-40B4-BE49-F238E27FC236}">
-                <a16:creationId xmlns:a16="http://schemas.microsoft.com/office/drawing/2014/main" id="{0B6E51F6-3904-4888-96A1-57837C4C6FD3}"/>
+                <a16:creationId xmlns:a16="http://schemas.microsoft.com/office/drawing/2014/main" id="{8A66DC5B-9099-4FBD-92AD-09BC472ACE51}"/>
               </a:ext>
             </a:extLst>
           </p:cNvPr>
@@ -10952,7 +10952,7 @@
           <p:cNvPr id="5" name="">
             <a:extLst xmlns:a="http://schemas.openxmlformats.org/drawingml/2006/main">
               <a:ext uri="{FF2B5EF4-FFF2-40B4-BE49-F238E27FC236}">
-                <a16:creationId xmlns:a16="http://schemas.microsoft.com/office/drawing/2014/main" id="{6412D5F5-E79D-4802-83AA-9940C435A122}"/>
+                <a16:creationId xmlns:a16="http://schemas.microsoft.com/office/drawing/2014/main" id="{90950519-AFB2-4F0F-95ED-D65AD5D8BC64}"/>
               </a:ext>
             </a:extLst>
           </p:cNvPr>
@@ -10985,7 +10985,7 @@
           <p:cNvPr id="6" name="">
             <a:extLst xmlns:a="http://schemas.openxmlformats.org/drawingml/2006/main">
               <a:ext uri="{FF2B5EF4-FFF2-40B4-BE49-F238E27FC236}">
-                <a16:creationId xmlns:a16="http://schemas.microsoft.com/office/drawing/2014/main" id="{AE7BFAC4-74D3-47FD-8D52-6D47E56FE4D8}"/>
+                <a16:creationId xmlns:a16="http://schemas.microsoft.com/office/drawing/2014/main" id="{166E732A-7711-4106-B931-0AA4D0CA707E}"/>
               </a:ext>
             </a:extLst>
           </p:cNvPr>
@@ -11081,7 +11081,7 @@
           <p:cNvPr id="7" name="">
             <a:extLst xmlns:a="http://schemas.openxmlformats.org/drawingml/2006/main">
               <a:ext uri="{FF2B5EF4-FFF2-40B4-BE49-F238E27FC236}">
-                <a16:creationId xmlns:a16="http://schemas.microsoft.com/office/drawing/2014/main" id="{EFA9D121-B5EC-4295-88E5-165419B63984}"/>
+                <a16:creationId xmlns:a16="http://schemas.microsoft.com/office/drawing/2014/main" id="{93FD27F0-581A-4ED1-80E3-3BF2475C8D41}"/>
               </a:ext>
             </a:extLst>
           </p:cNvPr>
@@ -11114,7 +11114,7 @@
           <p:cNvPr id="8" name="">
             <a:extLst xmlns:a="http://schemas.openxmlformats.org/drawingml/2006/main">
               <a:ext uri="{FF2B5EF4-FFF2-40B4-BE49-F238E27FC236}">
-                <a16:creationId xmlns:a16="http://schemas.microsoft.com/office/drawing/2014/main" id="{69640B4C-4ACB-4146-AA48-FD67F49694F8}"/>
+                <a16:creationId xmlns:a16="http://schemas.microsoft.com/office/drawing/2014/main" id="{8D6A2504-A494-4ED3-95D2-1436D624CBE9}"/>
               </a:ext>
             </a:extLst>
           </p:cNvPr>
@@ -11159,7 +11159,7 @@
           <p:cNvPr id="9" name="">
             <a:extLst xmlns:a="http://schemas.openxmlformats.org/drawingml/2006/main">
               <a:ext uri="{FF2B5EF4-FFF2-40B4-BE49-F238E27FC236}">
-                <a16:creationId xmlns:a16="http://schemas.microsoft.com/office/drawing/2014/main" id="{9DD358BC-36FC-4E30-AB59-6D8D11E9A18F}"/>
+                <a16:creationId xmlns:a16="http://schemas.microsoft.com/office/drawing/2014/main" id="{C82B8413-D43A-497C-97C4-1DFBF7C9473F}"/>
               </a:ext>
             </a:extLst>
           </p:cNvPr>
@@ -11204,7 +11204,7 @@
           <p:cNvPr id="10" name="">
             <a:extLst xmlns:a="http://schemas.openxmlformats.org/drawingml/2006/main">
               <a:ext uri="{FF2B5EF4-FFF2-40B4-BE49-F238E27FC236}">
-                <a16:creationId xmlns:a16="http://schemas.microsoft.com/office/drawing/2014/main" id="{8FB521A0-560B-4D7D-BDCC-CF255DC07AD5}"/>
+                <a16:creationId xmlns:a16="http://schemas.microsoft.com/office/drawing/2014/main" id="{170CD3C3-DE7E-4070-904E-ECCB209BD28C}"/>
               </a:ext>
             </a:extLst>
           </p:cNvPr>
@@ -11237,7 +11237,7 @@
           <p:cNvPr id="11" name="">
             <a:extLst xmlns:a="http://schemas.openxmlformats.org/drawingml/2006/main">
               <a:ext uri="{FF2B5EF4-FFF2-40B4-BE49-F238E27FC236}">
-                <a16:creationId xmlns:a16="http://schemas.microsoft.com/office/drawing/2014/main" id="{4ABD0AD5-3EF5-4EA8-AF85-DF2383489973}"/>
+                <a16:creationId xmlns:a16="http://schemas.microsoft.com/office/drawing/2014/main" id="{41C5A44B-7CA8-4C38-9FE7-BDBC4CE19B6B}"/>
               </a:ext>
             </a:extLst>
           </p:cNvPr>
@@ -11282,7 +11282,7 @@
           <p:cNvPr id="12" name="">
             <a:extLst xmlns:a="http://schemas.openxmlformats.org/drawingml/2006/main">
               <a:ext uri="{FF2B5EF4-FFF2-40B4-BE49-F238E27FC236}">
-                <a16:creationId xmlns:a16="http://schemas.microsoft.com/office/drawing/2014/main" id="{A9D99290-4888-4E7C-9593-7EDD25A1FB50}"/>
+                <a16:creationId xmlns:a16="http://schemas.microsoft.com/office/drawing/2014/main" id="{EC3AAFEE-CE7A-4EED-B181-F1FC4972C504}"/>
               </a:ext>
             </a:extLst>
           </p:cNvPr>
@@ -11327,7 +11327,7 @@
           <p:cNvPr id="13" name="">
             <a:extLst xmlns:a="http://schemas.openxmlformats.org/drawingml/2006/main">
               <a:ext uri="{FF2B5EF4-FFF2-40B4-BE49-F238E27FC236}">
-                <a16:creationId xmlns:a16="http://schemas.microsoft.com/office/drawing/2014/main" id="{7C9668CF-6B03-486B-AC4C-8C44509E4E2D}"/>
+                <a16:creationId xmlns:a16="http://schemas.microsoft.com/office/drawing/2014/main" id="{4B914B70-5ECC-4700-AC2C-AB77A41B66E6}"/>
               </a:ext>
             </a:extLst>
           </p:cNvPr>
@@ -11360,7 +11360,7 @@
           <p:cNvPr id="14" name="">
             <a:extLst xmlns:a="http://schemas.openxmlformats.org/drawingml/2006/main">
               <a:ext uri="{FF2B5EF4-FFF2-40B4-BE49-F238E27FC236}">
-                <a16:creationId xmlns:a16="http://schemas.microsoft.com/office/drawing/2014/main" id="{1232B0B3-51C5-4211-9450-6ABFC2D2A750}"/>
+                <a16:creationId xmlns:a16="http://schemas.microsoft.com/office/drawing/2014/main" id="{77149241-BAC5-43B3-B9C7-987FD39171B0}"/>
               </a:ext>
             </a:extLst>
           </p:cNvPr>
@@ -11405,7 +11405,7 @@
           <p:cNvPr id="15" name="">
             <a:extLst xmlns:a="http://schemas.openxmlformats.org/drawingml/2006/main">
               <a:ext uri="{FF2B5EF4-FFF2-40B4-BE49-F238E27FC236}">
-                <a16:creationId xmlns:a16="http://schemas.microsoft.com/office/drawing/2014/main" id="{552EB6A2-DB57-43EE-B66D-88BE663DAEBA}"/>
+                <a16:creationId xmlns:a16="http://schemas.microsoft.com/office/drawing/2014/main" id="{DAAB19F5-2FA1-4A0C-9D3B-777864CC87DA}"/>
               </a:ext>
             </a:extLst>
           </p:cNvPr>
@@ -11450,7 +11450,7 @@
           <p:cNvPr id="16" name="footer-left">
             <a:extLst xmlns:a="http://schemas.openxmlformats.org/drawingml/2006/main">
               <a:ext uri="{FF2B5EF4-FFF2-40B4-BE49-F238E27FC236}">
-                <a16:creationId xmlns:a16="http://schemas.microsoft.com/office/drawing/2014/main" id="{D1FE85D5-00D1-44DB-A408-19058DBF8DB2}"/>
+                <a16:creationId xmlns:a16="http://schemas.microsoft.com/office/drawing/2014/main" id="{9D137FBF-D488-4B06-A56F-38ED9B4CA028}"/>
               </a:ext>
             </a:extLst>
           </p:cNvPr>
@@ -11495,7 +11495,7 @@
           <p:cNvPr id="17" name="footer-right">
             <a:extLst xmlns:a="http://schemas.openxmlformats.org/drawingml/2006/main">
               <a:ext uri="{FF2B5EF4-FFF2-40B4-BE49-F238E27FC236}">
-                <a16:creationId xmlns:a16="http://schemas.microsoft.com/office/drawing/2014/main" id="{31CED28E-FD55-4A4B-B375-A9731D3F7EBF}"/>
+                <a16:creationId xmlns:a16="http://schemas.microsoft.com/office/drawing/2014/main" id="{91FDD594-6B2F-4C17-B088-0B0A20A067EC}"/>
               </a:ext>
             </a:extLst>
           </p:cNvPr>
@@ -11538,7 +11538,7 @@
     </p:spTree>
     <p:extLst>
       <p:ext uri="{BB962C8B-B14F-4D97-AF65-F5344CB8AC3E}">
-        <p14:creationId xmlns:p14="http://schemas.microsoft.com/office/powerpoint/2010/main" val="239398099"/>
+        <p14:creationId xmlns:p14="http://schemas.microsoft.com/office/powerpoint/2010/main" val="42339774"/>
       </p:ext>
     </p:extLst>
   </p:cSld>
@@ -11562,7 +11562,7 @@
           <p:cNvPr id="1" name="slide-stage">
             <a:extLst xmlns:a="http://schemas.openxmlformats.org/drawingml/2006/main">
               <a:ext uri="{FF2B5EF4-FFF2-40B4-BE49-F238E27FC236}">
-                <a16:creationId xmlns:a16="http://schemas.microsoft.com/office/drawing/2014/main" id="{E9FD7830-B85A-482B-867D-3AC039B14DF1}"/>
+                <a16:creationId xmlns:a16="http://schemas.microsoft.com/office/drawing/2014/main" id="{E1E1B7C6-10F1-42EB-B1D4-47B0681BEA39}"/>
               </a:ext>
             </a:extLst>
           </p:cNvPr>
@@ -11589,7 +11589,7 @@
           <p:cNvPr id="2" name="eyebrow">
             <a:extLst xmlns:a="http://schemas.openxmlformats.org/drawingml/2006/main">
               <a:ext uri="{FF2B5EF4-FFF2-40B4-BE49-F238E27FC236}">
-                <a16:creationId xmlns:a16="http://schemas.microsoft.com/office/drawing/2014/main" id="{2857D30F-4C28-459C-BBD1-36407F335CA6}"/>
+                <a16:creationId xmlns:a16="http://schemas.microsoft.com/office/drawing/2014/main" id="{9CE1AAF5-6994-45B7-AAF7-FE46BA1B93E9}"/>
               </a:ext>
             </a:extLst>
           </p:cNvPr>
@@ -11634,7 +11634,7 @@
           <p:cNvPr id="3" name="slide-title">
             <a:extLst xmlns:a="http://schemas.openxmlformats.org/drawingml/2006/main">
               <a:ext uri="{FF2B5EF4-FFF2-40B4-BE49-F238E27FC236}">
-                <a16:creationId xmlns:a16="http://schemas.microsoft.com/office/drawing/2014/main" id="{7F0B30D2-40AB-420F-9AC5-EEF5DD428BE6}"/>
+                <a16:creationId xmlns:a16="http://schemas.microsoft.com/office/drawing/2014/main" id="{9FDA45FD-327D-4C32-B432-F0127B89C635}"/>
               </a:ext>
             </a:extLst>
           </p:cNvPr>
@@ -11679,7 +11679,7 @@
           <p:cNvPr id="4" name="slide-subtitle">
             <a:extLst xmlns:a="http://schemas.openxmlformats.org/drawingml/2006/main">
               <a:ext uri="{FF2B5EF4-FFF2-40B4-BE49-F238E27FC236}">
-                <a16:creationId xmlns:a16="http://schemas.microsoft.com/office/drawing/2014/main" id="{90A26F46-00CB-470F-A762-7129DB1950B6}"/>
+                <a16:creationId xmlns:a16="http://schemas.microsoft.com/office/drawing/2014/main" id="{3C71344E-C84F-4EA0-B8D9-EFCE8A831809}"/>
               </a:ext>
             </a:extLst>
           </p:cNvPr>
@@ -11724,7 +11724,7 @@
           <p:cNvPr id="5" name="">
             <a:extLst xmlns:a="http://schemas.openxmlformats.org/drawingml/2006/main">
               <a:ext uri="{FF2B5EF4-FFF2-40B4-BE49-F238E27FC236}">
-                <a16:creationId xmlns:a16="http://schemas.microsoft.com/office/drawing/2014/main" id="{3BC2792F-DCC3-4A91-988D-B1113F1AC4A6}"/>
+                <a16:creationId xmlns:a16="http://schemas.microsoft.com/office/drawing/2014/main" id="{CFDEE6D4-913A-4C28-9F8B-C27DAB9FC265}"/>
               </a:ext>
             </a:extLst>
           </p:cNvPr>
@@ -11757,7 +11757,7 @@
           <p:cNvPr id="6" name="">
             <a:extLst xmlns:a="http://schemas.openxmlformats.org/drawingml/2006/main">
               <a:ext uri="{FF2B5EF4-FFF2-40B4-BE49-F238E27FC236}">
-                <a16:creationId xmlns:a16="http://schemas.microsoft.com/office/drawing/2014/main" id="{A406AA54-9BBF-4B21-A709-076941293033}"/>
+                <a16:creationId xmlns:a16="http://schemas.microsoft.com/office/drawing/2014/main" id="{A514F556-0AB7-4F99-A233-A0E2641D204A}"/>
               </a:ext>
             </a:extLst>
           </p:cNvPr>
@@ -11802,7 +11802,7 @@
           <p:cNvPr id="7" name="">
             <a:extLst xmlns:a="http://schemas.openxmlformats.org/drawingml/2006/main">
               <a:ext uri="{FF2B5EF4-FFF2-40B4-BE49-F238E27FC236}">
-                <a16:creationId xmlns:a16="http://schemas.microsoft.com/office/drawing/2014/main" id="{50009957-24E5-4D07-853E-3F75E036CCA8}"/>
+                <a16:creationId xmlns:a16="http://schemas.microsoft.com/office/drawing/2014/main" id="{F933B383-5945-4BFB-9AC2-1B04CE5FA8E3}"/>
               </a:ext>
             </a:extLst>
           </p:cNvPr>
@@ -11847,7 +11847,7 @@
           <p:cNvPr id="8" name="">
             <a:extLst xmlns:a="http://schemas.openxmlformats.org/drawingml/2006/main">
               <a:ext uri="{FF2B5EF4-FFF2-40B4-BE49-F238E27FC236}">
-                <a16:creationId xmlns:a16="http://schemas.microsoft.com/office/drawing/2014/main" id="{3738D10A-C902-4E27-894F-F378BF373C3C}"/>
+                <a16:creationId xmlns:a16="http://schemas.microsoft.com/office/drawing/2014/main" id="{D9B8480B-7367-4033-903D-2B129C14A9A4}"/>
               </a:ext>
             </a:extLst>
           </p:cNvPr>
@@ -11892,7 +11892,7 @@
           <p:cNvPr id="9" name="">
             <a:extLst xmlns:a="http://schemas.openxmlformats.org/drawingml/2006/main">
               <a:ext uri="{FF2B5EF4-FFF2-40B4-BE49-F238E27FC236}">
-                <a16:creationId xmlns:a16="http://schemas.microsoft.com/office/drawing/2014/main" id="{9D3A40BF-627B-4BCB-8F2A-FA11D9A79D9D}"/>
+                <a16:creationId xmlns:a16="http://schemas.microsoft.com/office/drawing/2014/main" id="{D54B5F17-13C9-4153-9485-0EEE8C34ABF1}"/>
               </a:ext>
             </a:extLst>
           </p:cNvPr>
@@ -11925,7 +11925,7 @@
           <p:cNvPr id="10" name="">
             <a:extLst xmlns:a="http://schemas.openxmlformats.org/drawingml/2006/main">
               <a:ext uri="{FF2B5EF4-FFF2-40B4-BE49-F238E27FC236}">
-                <a16:creationId xmlns:a16="http://schemas.microsoft.com/office/drawing/2014/main" id="{AFBBF7F7-FBEB-49FD-8B5E-9C2EF83581B6}"/>
+                <a16:creationId xmlns:a16="http://schemas.microsoft.com/office/drawing/2014/main" id="{2C33603E-EB38-407F-B47D-8D21E8CCC7ED}"/>
               </a:ext>
             </a:extLst>
           </p:cNvPr>
@@ -11970,7 +11970,7 @@
           <p:cNvPr id="11" name="">
             <a:extLst xmlns:a="http://schemas.openxmlformats.org/drawingml/2006/main">
               <a:ext uri="{FF2B5EF4-FFF2-40B4-BE49-F238E27FC236}">
-                <a16:creationId xmlns:a16="http://schemas.microsoft.com/office/drawing/2014/main" id="{6C045FAF-05B2-4054-A936-8BA41405B48F}"/>
+                <a16:creationId xmlns:a16="http://schemas.microsoft.com/office/drawing/2014/main" id="{14105E9D-0945-4C68-B66D-A5606CB58640}"/>
               </a:ext>
             </a:extLst>
           </p:cNvPr>
@@ -12015,7 +12015,7 @@
           <p:cNvPr id="12" name="">
             <a:extLst xmlns:a="http://schemas.openxmlformats.org/drawingml/2006/main">
               <a:ext uri="{FF2B5EF4-FFF2-40B4-BE49-F238E27FC236}">
-                <a16:creationId xmlns:a16="http://schemas.microsoft.com/office/drawing/2014/main" id="{8AF12DEC-2CBE-449F-90B7-F8E6DC5A0B8F}"/>
+                <a16:creationId xmlns:a16="http://schemas.microsoft.com/office/drawing/2014/main" id="{15DD2A27-EABF-4D39-A400-128E67A1FCFE}"/>
               </a:ext>
             </a:extLst>
           </p:cNvPr>
@@ -12060,7 +12060,7 @@
           <p:cNvPr id="13" name="">
             <a:extLst xmlns:a="http://schemas.openxmlformats.org/drawingml/2006/main">
               <a:ext uri="{FF2B5EF4-FFF2-40B4-BE49-F238E27FC236}">
-                <a16:creationId xmlns:a16="http://schemas.microsoft.com/office/drawing/2014/main" id="{61F5ACDB-1A20-4C27-BCC9-45DE1C3290CA}"/>
+                <a16:creationId xmlns:a16="http://schemas.microsoft.com/office/drawing/2014/main" id="{F59D5BD5-8FEA-41BC-B147-DE0C2EBBCB5D}"/>
               </a:ext>
             </a:extLst>
           </p:cNvPr>
@@ -12093,7 +12093,7 @@
           <p:cNvPr id="14" name="">
             <a:extLst xmlns:a="http://schemas.openxmlformats.org/drawingml/2006/main">
               <a:ext uri="{FF2B5EF4-FFF2-40B4-BE49-F238E27FC236}">
-                <a16:creationId xmlns:a16="http://schemas.microsoft.com/office/drawing/2014/main" id="{0F233F5A-DD11-4B6F-B21A-B10D78584C9B}"/>
+                <a16:creationId xmlns:a16="http://schemas.microsoft.com/office/drawing/2014/main" id="{60629A3E-A6BB-4BC8-8575-D98CC5415D9D}"/>
               </a:ext>
             </a:extLst>
           </p:cNvPr>
@@ -12138,7 +12138,7 @@
           <p:cNvPr id="15" name="">
             <a:extLst xmlns:a="http://schemas.openxmlformats.org/drawingml/2006/main">
               <a:ext uri="{FF2B5EF4-FFF2-40B4-BE49-F238E27FC236}">
-                <a16:creationId xmlns:a16="http://schemas.microsoft.com/office/drawing/2014/main" id="{C1D77157-8DAD-4375-AC9F-5977B0D43E4A}"/>
+                <a16:creationId xmlns:a16="http://schemas.microsoft.com/office/drawing/2014/main" id="{85A89CB0-A778-421A-92C5-090C0B05143A}"/>
               </a:ext>
             </a:extLst>
           </p:cNvPr>
@@ -12183,7 +12183,7 @@
           <p:cNvPr id="16" name="">
             <a:extLst xmlns:a="http://schemas.openxmlformats.org/drawingml/2006/main">
               <a:ext uri="{FF2B5EF4-FFF2-40B4-BE49-F238E27FC236}">
-                <a16:creationId xmlns:a16="http://schemas.microsoft.com/office/drawing/2014/main" id="{D12BFC0B-2206-4EDA-B616-BA92FF3F00E0}"/>
+                <a16:creationId xmlns:a16="http://schemas.microsoft.com/office/drawing/2014/main" id="{582178C8-7031-474A-9CBF-002D1C31359D}"/>
               </a:ext>
             </a:extLst>
           </p:cNvPr>
@@ -12228,7 +12228,7 @@
           <p:cNvPr id="17" name="">
             <a:extLst xmlns:a="http://schemas.openxmlformats.org/drawingml/2006/main">
               <a:ext uri="{FF2B5EF4-FFF2-40B4-BE49-F238E27FC236}">
-                <a16:creationId xmlns:a16="http://schemas.microsoft.com/office/drawing/2014/main" id="{923133A6-CE6A-4C06-AB33-FE6A9C09569E}"/>
+                <a16:creationId xmlns:a16="http://schemas.microsoft.com/office/drawing/2014/main" id="{C543C694-F642-4990-9B41-D48A122583C4}"/>
               </a:ext>
             </a:extLst>
           </p:cNvPr>
@@ -12261,7 +12261,7 @@
           <p:cNvPr id="18" name="">
             <a:extLst xmlns:a="http://schemas.openxmlformats.org/drawingml/2006/main">
               <a:ext uri="{FF2B5EF4-FFF2-40B4-BE49-F238E27FC236}">
-                <a16:creationId xmlns:a16="http://schemas.microsoft.com/office/drawing/2014/main" id="{D03EE359-24BA-47C7-8E63-E4A764007DA7}"/>
+                <a16:creationId xmlns:a16="http://schemas.microsoft.com/office/drawing/2014/main" id="{490F08C1-7059-4FB9-BA15-EBE7EE8C425D}"/>
               </a:ext>
             </a:extLst>
           </p:cNvPr>
@@ -12306,7 +12306,7 @@
           <p:cNvPr id="19" name="">
             <a:extLst xmlns:a="http://schemas.openxmlformats.org/drawingml/2006/main">
               <a:ext uri="{FF2B5EF4-FFF2-40B4-BE49-F238E27FC236}">
-                <a16:creationId xmlns:a16="http://schemas.microsoft.com/office/drawing/2014/main" id="{D98EF12A-5CC5-4BE5-98D2-D16B407C5420}"/>
+                <a16:creationId xmlns:a16="http://schemas.microsoft.com/office/drawing/2014/main" id="{56CD7B0D-B446-4AB3-9178-F623344B8437}"/>
               </a:ext>
             </a:extLst>
           </p:cNvPr>
@@ -12351,7 +12351,7 @@
           <p:cNvPr id="20" name="">
             <a:extLst xmlns:a="http://schemas.openxmlformats.org/drawingml/2006/main">
               <a:ext uri="{FF2B5EF4-FFF2-40B4-BE49-F238E27FC236}">
-                <a16:creationId xmlns:a16="http://schemas.microsoft.com/office/drawing/2014/main" id="{88C1E3B0-4F91-4639-81A2-1B97F2C4B9B5}"/>
+                <a16:creationId xmlns:a16="http://schemas.microsoft.com/office/drawing/2014/main" id="{D69879A1-1D3C-4D71-832A-D210D8218C3C}"/>
               </a:ext>
             </a:extLst>
           </p:cNvPr>
@@ -12396,7 +12396,7 @@
           <p:cNvPr id="21" name="">
             <a:extLst xmlns:a="http://schemas.openxmlformats.org/drawingml/2006/main">
               <a:ext uri="{FF2B5EF4-FFF2-40B4-BE49-F238E27FC236}">
-                <a16:creationId xmlns:a16="http://schemas.microsoft.com/office/drawing/2014/main" id="{22AB288A-AB5A-4CED-A18E-EDCBF0AA4DEF}"/>
+                <a16:creationId xmlns:a16="http://schemas.microsoft.com/office/drawing/2014/main" id="{3E9B2A92-65FD-41AE-99C7-34E6F54BADD5}"/>
               </a:ext>
             </a:extLst>
           </p:cNvPr>
@@ -12429,7 +12429,7 @@
           <p:cNvPr id="22" name="">
             <a:extLst xmlns:a="http://schemas.openxmlformats.org/drawingml/2006/main">
               <a:ext uri="{FF2B5EF4-FFF2-40B4-BE49-F238E27FC236}">
-                <a16:creationId xmlns:a16="http://schemas.microsoft.com/office/drawing/2014/main" id="{D226F154-8115-43FA-BBEC-EB291F4ADE28}"/>
+                <a16:creationId xmlns:a16="http://schemas.microsoft.com/office/drawing/2014/main" id="{20174DBA-A235-4CE7-B9C8-19BC20714704}"/>
               </a:ext>
             </a:extLst>
           </p:cNvPr>
@@ -12474,7 +12474,7 @@
           <p:cNvPr id="23" name="">
             <a:extLst xmlns:a="http://schemas.openxmlformats.org/drawingml/2006/main">
               <a:ext uri="{FF2B5EF4-FFF2-40B4-BE49-F238E27FC236}">
-                <a16:creationId xmlns:a16="http://schemas.microsoft.com/office/drawing/2014/main" id="{D1808808-BAC4-42B3-B574-4ECF640EAC51}"/>
+                <a16:creationId xmlns:a16="http://schemas.microsoft.com/office/drawing/2014/main" id="{CED10972-1B46-44DF-96AF-A82B96CD4219}"/>
               </a:ext>
             </a:extLst>
           </p:cNvPr>
@@ -12519,7 +12519,7 @@
           <p:cNvPr id="24" name="">
             <a:extLst xmlns:a="http://schemas.openxmlformats.org/drawingml/2006/main">
               <a:ext uri="{FF2B5EF4-FFF2-40B4-BE49-F238E27FC236}">
-                <a16:creationId xmlns:a16="http://schemas.microsoft.com/office/drawing/2014/main" id="{E339C72B-3639-4054-B2BF-D9A5DC8E3B33}"/>
+                <a16:creationId xmlns:a16="http://schemas.microsoft.com/office/drawing/2014/main" id="{13E79894-24E2-462C-9BB7-9F51E35C868F}"/>
               </a:ext>
             </a:extLst>
           </p:cNvPr>
@@ -12564,7 +12564,7 @@
           <p:cNvPr id="25" name="">
             <a:extLst xmlns:a="http://schemas.openxmlformats.org/drawingml/2006/main">
               <a:ext uri="{FF2B5EF4-FFF2-40B4-BE49-F238E27FC236}">
-                <a16:creationId xmlns:a16="http://schemas.microsoft.com/office/drawing/2014/main" id="{6959102E-1CD6-47FB-BC69-E32BA59D84A6}"/>
+                <a16:creationId xmlns:a16="http://schemas.microsoft.com/office/drawing/2014/main" id="{CBD17157-3F5C-4014-AC56-892391118FE9}"/>
               </a:ext>
             </a:extLst>
           </p:cNvPr>
@@ -12597,7 +12597,7 @@
           <p:cNvPr id="26" name="">
             <a:extLst xmlns:a="http://schemas.openxmlformats.org/drawingml/2006/main">
               <a:ext uri="{FF2B5EF4-FFF2-40B4-BE49-F238E27FC236}">
-                <a16:creationId xmlns:a16="http://schemas.microsoft.com/office/drawing/2014/main" id="{4009EAC0-C933-45F7-9E5D-A8EB3A765B4F}"/>
+                <a16:creationId xmlns:a16="http://schemas.microsoft.com/office/drawing/2014/main" id="{BA49017F-E072-43F3-9F7D-52A0B094B6C7}"/>
               </a:ext>
             </a:extLst>
           </p:cNvPr>
@@ -12642,7 +12642,7 @@
           <p:cNvPr id="27" name="">
             <a:extLst xmlns:a="http://schemas.openxmlformats.org/drawingml/2006/main">
               <a:ext uri="{FF2B5EF4-FFF2-40B4-BE49-F238E27FC236}">
-                <a16:creationId xmlns:a16="http://schemas.microsoft.com/office/drawing/2014/main" id="{F791949E-89FE-4926-9076-9BD8C34B0BEA}"/>
+                <a16:creationId xmlns:a16="http://schemas.microsoft.com/office/drawing/2014/main" id="{EEB7682F-AD6F-4BFB-AE42-3631D80E1F03}"/>
               </a:ext>
             </a:extLst>
           </p:cNvPr>
@@ -12687,7 +12687,7 @@
           <p:cNvPr id="28" name="">
             <a:extLst xmlns:a="http://schemas.openxmlformats.org/drawingml/2006/main">
               <a:ext uri="{FF2B5EF4-FFF2-40B4-BE49-F238E27FC236}">
-                <a16:creationId xmlns:a16="http://schemas.microsoft.com/office/drawing/2014/main" id="{3EC16F64-960E-49AC-A352-524902CAF4B6}"/>
+                <a16:creationId xmlns:a16="http://schemas.microsoft.com/office/drawing/2014/main" id="{CDC22E72-42C4-4926-9514-A6690A7E61DE}"/>
               </a:ext>
             </a:extLst>
           </p:cNvPr>
@@ -12732,7 +12732,7 @@
           <p:cNvPr id="29" name="footer-left">
             <a:extLst xmlns:a="http://schemas.openxmlformats.org/drawingml/2006/main">
               <a:ext uri="{FF2B5EF4-FFF2-40B4-BE49-F238E27FC236}">
-                <a16:creationId xmlns:a16="http://schemas.microsoft.com/office/drawing/2014/main" id="{20E769F9-5FAA-40D4-942F-3E85FA315B86}"/>
+                <a16:creationId xmlns:a16="http://schemas.microsoft.com/office/drawing/2014/main" id="{F366A05E-00C1-46D5-8F40-68C00503CB5B}"/>
               </a:ext>
             </a:extLst>
           </p:cNvPr>
@@ -12777,7 +12777,7 @@
           <p:cNvPr id="30" name="footer-right">
             <a:extLst xmlns:a="http://schemas.openxmlformats.org/drawingml/2006/main">
               <a:ext uri="{FF2B5EF4-FFF2-40B4-BE49-F238E27FC236}">
-                <a16:creationId xmlns:a16="http://schemas.microsoft.com/office/drawing/2014/main" id="{8DD2CCE1-A7D4-4C4A-835D-7B3EF9B34F13}"/>
+                <a16:creationId xmlns:a16="http://schemas.microsoft.com/office/drawing/2014/main" id="{673E1E2E-9BE7-4324-AA35-1B52406AA488}"/>
               </a:ext>
             </a:extLst>
           </p:cNvPr>
@@ -12820,7 +12820,7 @@
     </p:spTree>
     <p:extLst>
       <p:ext uri="{BB962C8B-B14F-4D97-AF65-F5344CB8AC3E}">
-        <p14:creationId xmlns:p14="http://schemas.microsoft.com/office/powerpoint/2010/main" val="916441880"/>
+        <p14:creationId xmlns:p14="http://schemas.microsoft.com/office/powerpoint/2010/main" val="460392954"/>
       </p:ext>
     </p:extLst>
   </p:cSld>
@@ -12844,7 +12844,7 @@
           <p:cNvPr id="1" name="slide-stage">
             <a:extLst xmlns:a="http://schemas.openxmlformats.org/drawingml/2006/main">
               <a:ext uri="{FF2B5EF4-FFF2-40B4-BE49-F238E27FC236}">
-                <a16:creationId xmlns:a16="http://schemas.microsoft.com/office/drawing/2014/main" id="{92B3FEB4-4778-4859-B297-830B04278C56}"/>
+                <a16:creationId xmlns:a16="http://schemas.microsoft.com/office/drawing/2014/main" id="{66F3D3AF-4017-4224-896D-20672B788494}"/>
               </a:ext>
             </a:extLst>
           </p:cNvPr>
@@ -12871,7 +12871,7 @@
           <p:cNvPr id="2" name="eyebrow">
             <a:extLst xmlns:a="http://schemas.openxmlformats.org/drawingml/2006/main">
               <a:ext uri="{FF2B5EF4-FFF2-40B4-BE49-F238E27FC236}">
-                <a16:creationId xmlns:a16="http://schemas.microsoft.com/office/drawing/2014/main" id="{5B8449B9-9E71-4BF7-A20A-4CB511029C58}"/>
+                <a16:creationId xmlns:a16="http://schemas.microsoft.com/office/drawing/2014/main" id="{337A634C-60E3-4B35-887A-E1F1E4432931}"/>
               </a:ext>
             </a:extLst>
           </p:cNvPr>
@@ -12916,7 +12916,7 @@
           <p:cNvPr id="3" name="slide-title">
             <a:extLst xmlns:a="http://schemas.openxmlformats.org/drawingml/2006/main">
               <a:ext uri="{FF2B5EF4-FFF2-40B4-BE49-F238E27FC236}">
-                <a16:creationId xmlns:a16="http://schemas.microsoft.com/office/drawing/2014/main" id="{E4FBA149-E53E-4397-8716-BEE87453C3C8}"/>
+                <a16:creationId xmlns:a16="http://schemas.microsoft.com/office/drawing/2014/main" id="{0DCC568D-357C-42CF-9EA6-B526E4426312}"/>
               </a:ext>
             </a:extLst>
           </p:cNvPr>
@@ -12961,7 +12961,7 @@
           <p:cNvPr id="4" name="slide-subtitle">
             <a:extLst xmlns:a="http://schemas.openxmlformats.org/drawingml/2006/main">
               <a:ext uri="{FF2B5EF4-FFF2-40B4-BE49-F238E27FC236}">
-                <a16:creationId xmlns:a16="http://schemas.microsoft.com/office/drawing/2014/main" id="{FEE3E7C2-AC69-4C47-A43D-188D3B5BCF3E}"/>
+                <a16:creationId xmlns:a16="http://schemas.microsoft.com/office/drawing/2014/main" id="{E0D20908-38A0-4C22-8A61-9905DE36B042}"/>
               </a:ext>
             </a:extLst>
           </p:cNvPr>
@@ -13006,7 +13006,7 @@
           <p:cNvPr id="5" name="">
             <a:extLst xmlns:a="http://schemas.openxmlformats.org/drawingml/2006/main">
               <a:ext uri="{FF2B5EF4-FFF2-40B4-BE49-F238E27FC236}">
-                <a16:creationId xmlns:a16="http://schemas.microsoft.com/office/drawing/2014/main" id="{312655F3-970D-4709-AE24-666C0D3FD0A7}"/>
+                <a16:creationId xmlns:a16="http://schemas.microsoft.com/office/drawing/2014/main" id="{C7A4A19F-77EC-40AF-B6A3-688C703AE01D}"/>
               </a:ext>
             </a:extLst>
           </p:cNvPr>
@@ -13051,7 +13051,7 @@
           <p:cNvPr id="6" name="">
             <a:extLst xmlns:a="http://schemas.openxmlformats.org/drawingml/2006/main">
               <a:ext uri="{FF2B5EF4-FFF2-40B4-BE49-F238E27FC236}">
-                <a16:creationId xmlns:a16="http://schemas.microsoft.com/office/drawing/2014/main" id="{A842855C-30DD-4E94-870A-DAD763332CAE}"/>
+                <a16:creationId xmlns:a16="http://schemas.microsoft.com/office/drawing/2014/main" id="{D911F026-BA0A-4F7B-8292-5FC8917D66A1}"/>
               </a:ext>
             </a:extLst>
           </p:cNvPr>
@@ -13086,7 +13086,7 @@
           <p:cNvPr id="7" name="">
             <a:extLst xmlns:a="http://schemas.openxmlformats.org/drawingml/2006/main">
               <a:ext uri="{FF2B5EF4-FFF2-40B4-BE49-F238E27FC236}">
-                <a16:creationId xmlns:a16="http://schemas.microsoft.com/office/drawing/2014/main" id="{2C6CF8DF-4B44-4C42-86C4-148C6D46FF4E}"/>
+                <a16:creationId xmlns:a16="http://schemas.microsoft.com/office/drawing/2014/main" id="{5233D477-5B25-4F5E-BA0E-3B5582856857}"/>
               </a:ext>
             </a:extLst>
           </p:cNvPr>
@@ -13131,7 +13131,7 @@
           <p:cNvPr id="8" name="">
             <a:extLst xmlns:a="http://schemas.openxmlformats.org/drawingml/2006/main">
               <a:ext uri="{FF2B5EF4-FFF2-40B4-BE49-F238E27FC236}">
-                <a16:creationId xmlns:a16="http://schemas.microsoft.com/office/drawing/2014/main" id="{FD036E5B-A3FF-4AAB-9F7F-213F5A0857A9}"/>
+                <a16:creationId xmlns:a16="http://schemas.microsoft.com/office/drawing/2014/main" id="{9BB3818A-A0B8-472C-8946-731784DBE2E6}"/>
               </a:ext>
             </a:extLst>
           </p:cNvPr>
@@ -13176,7 +13176,7 @@
           <p:cNvPr id="9" name="">
             <a:extLst xmlns:a="http://schemas.openxmlformats.org/drawingml/2006/main">
               <a:ext uri="{FF2B5EF4-FFF2-40B4-BE49-F238E27FC236}">
-                <a16:creationId xmlns:a16="http://schemas.microsoft.com/office/drawing/2014/main" id="{5006A86A-2DBF-46C6-A93C-7BB46D196AD9}"/>
+                <a16:creationId xmlns:a16="http://schemas.microsoft.com/office/drawing/2014/main" id="{ACF15D20-0E84-45B2-A51C-30E209442032}"/>
               </a:ext>
             </a:extLst>
           </p:cNvPr>
@@ -13221,7 +13221,7 @@
           <p:cNvPr id="10" name="">
             <a:extLst xmlns:a="http://schemas.openxmlformats.org/drawingml/2006/main">
               <a:ext uri="{FF2B5EF4-FFF2-40B4-BE49-F238E27FC236}">
-                <a16:creationId xmlns:a16="http://schemas.microsoft.com/office/drawing/2014/main" id="{E7A082FB-78A1-4E08-BAFE-8AA31246D4FF}"/>
+                <a16:creationId xmlns:a16="http://schemas.microsoft.com/office/drawing/2014/main" id="{FD29E174-E21D-4977-AFA5-9324C58C9B97}"/>
               </a:ext>
             </a:extLst>
           </p:cNvPr>
@@ -13256,7 +13256,7 @@
           <p:cNvPr id="11" name="">
             <a:extLst xmlns:a="http://schemas.openxmlformats.org/drawingml/2006/main">
               <a:ext uri="{FF2B5EF4-FFF2-40B4-BE49-F238E27FC236}">
-                <a16:creationId xmlns:a16="http://schemas.microsoft.com/office/drawing/2014/main" id="{22BB6ADB-0173-43C5-8DF4-0F2FE9039716}"/>
+                <a16:creationId xmlns:a16="http://schemas.microsoft.com/office/drawing/2014/main" id="{36E216A5-A953-489E-BC69-80BDFFA558AD}"/>
               </a:ext>
             </a:extLst>
           </p:cNvPr>
@@ -13301,7 +13301,7 @@
           <p:cNvPr id="12" name="">
             <a:extLst xmlns:a="http://schemas.openxmlformats.org/drawingml/2006/main">
               <a:ext uri="{FF2B5EF4-FFF2-40B4-BE49-F238E27FC236}">
-                <a16:creationId xmlns:a16="http://schemas.microsoft.com/office/drawing/2014/main" id="{6679C48B-9873-4242-89CF-8BCF564043CC}"/>
+                <a16:creationId xmlns:a16="http://schemas.microsoft.com/office/drawing/2014/main" id="{125035BB-C0A4-49D4-B905-20C8F1622202}"/>
               </a:ext>
             </a:extLst>
           </p:cNvPr>
@@ -13346,7 +13346,7 @@
           <p:cNvPr id="13" name="">
             <a:extLst xmlns:a="http://schemas.openxmlformats.org/drawingml/2006/main">
               <a:ext uri="{FF2B5EF4-FFF2-40B4-BE49-F238E27FC236}">
-                <a16:creationId xmlns:a16="http://schemas.microsoft.com/office/drawing/2014/main" id="{86B841C1-43AF-4D5B-A3F7-9A0A71474B82}"/>
+                <a16:creationId xmlns:a16="http://schemas.microsoft.com/office/drawing/2014/main" id="{B4A0BEA4-8464-48C8-BC95-802E57CA0DA2}"/>
               </a:ext>
             </a:extLst>
           </p:cNvPr>
@@ -13391,7 +13391,7 @@
           <p:cNvPr id="14" name="">
             <a:extLst xmlns:a="http://schemas.openxmlformats.org/drawingml/2006/main">
               <a:ext uri="{FF2B5EF4-FFF2-40B4-BE49-F238E27FC236}">
-                <a16:creationId xmlns:a16="http://schemas.microsoft.com/office/drawing/2014/main" id="{96AFC1C1-8D72-4327-9522-5389D0B0C61C}"/>
+                <a16:creationId xmlns:a16="http://schemas.microsoft.com/office/drawing/2014/main" id="{1469443D-DDAC-418D-A66B-85357EAA2CAB}"/>
               </a:ext>
             </a:extLst>
           </p:cNvPr>
@@ -13426,7 +13426,7 @@
           <p:cNvPr id="15" name="">
             <a:extLst xmlns:a="http://schemas.openxmlformats.org/drawingml/2006/main">
               <a:ext uri="{FF2B5EF4-FFF2-40B4-BE49-F238E27FC236}">
-                <a16:creationId xmlns:a16="http://schemas.microsoft.com/office/drawing/2014/main" id="{9CC0BFDB-AD9B-4712-B0FB-B16C761B67E9}"/>
+                <a16:creationId xmlns:a16="http://schemas.microsoft.com/office/drawing/2014/main" id="{934CE117-0079-483A-9B39-F6650F3BCFF5}"/>
               </a:ext>
             </a:extLst>
           </p:cNvPr>
@@ -13471,7 +13471,7 @@
           <p:cNvPr id="16" name="">
             <a:extLst xmlns:a="http://schemas.openxmlformats.org/drawingml/2006/main">
               <a:ext uri="{FF2B5EF4-FFF2-40B4-BE49-F238E27FC236}">
-                <a16:creationId xmlns:a16="http://schemas.microsoft.com/office/drawing/2014/main" id="{8781AE89-92D6-4E02-9A78-E06C7555BE74}"/>
+                <a16:creationId xmlns:a16="http://schemas.microsoft.com/office/drawing/2014/main" id="{7227B23A-0318-4740-8029-DFD7CBFF9CB4}"/>
               </a:ext>
             </a:extLst>
           </p:cNvPr>
@@ -13516,7 +13516,7 @@
           <p:cNvPr id="17" name="">
             <a:extLst xmlns:a="http://schemas.openxmlformats.org/drawingml/2006/main">
               <a:ext uri="{FF2B5EF4-FFF2-40B4-BE49-F238E27FC236}">
-                <a16:creationId xmlns:a16="http://schemas.microsoft.com/office/drawing/2014/main" id="{90BF2C87-2EAB-41F9-BED9-DD800F1BE22B}"/>
+                <a16:creationId xmlns:a16="http://schemas.microsoft.com/office/drawing/2014/main" id="{47B0B97E-F9D8-47C4-85EC-C49C6925C0CB}"/>
               </a:ext>
             </a:extLst>
           </p:cNvPr>
@@ -13561,7 +13561,7 @@
           <p:cNvPr id="18" name="">
             <a:extLst xmlns:a="http://schemas.openxmlformats.org/drawingml/2006/main">
               <a:ext uri="{FF2B5EF4-FFF2-40B4-BE49-F238E27FC236}">
-                <a16:creationId xmlns:a16="http://schemas.microsoft.com/office/drawing/2014/main" id="{0B119829-0FCE-4BBC-A53D-A8BA48543D03}"/>
+                <a16:creationId xmlns:a16="http://schemas.microsoft.com/office/drawing/2014/main" id="{C46A31B1-734F-4C50-A8F2-638BBDEBD3C0}"/>
               </a:ext>
             </a:extLst>
           </p:cNvPr>
@@ -13596,7 +13596,7 @@
           <p:cNvPr id="19" name="">
             <a:extLst xmlns:a="http://schemas.openxmlformats.org/drawingml/2006/main">
               <a:ext uri="{FF2B5EF4-FFF2-40B4-BE49-F238E27FC236}">
-                <a16:creationId xmlns:a16="http://schemas.microsoft.com/office/drawing/2014/main" id="{8D61F764-8498-4D84-A10F-E532BC2D4FA1}"/>
+                <a16:creationId xmlns:a16="http://schemas.microsoft.com/office/drawing/2014/main" id="{97CC97B8-4D98-4D65-ACDB-F3FF81F785ED}"/>
               </a:ext>
             </a:extLst>
           </p:cNvPr>
@@ -13641,7 +13641,7 @@
           <p:cNvPr id="20" name="">
             <a:extLst xmlns:a="http://schemas.openxmlformats.org/drawingml/2006/main">
               <a:ext uri="{FF2B5EF4-FFF2-40B4-BE49-F238E27FC236}">
-                <a16:creationId xmlns:a16="http://schemas.microsoft.com/office/drawing/2014/main" id="{5763B257-208C-4747-9817-CA48672F2999}"/>
+                <a16:creationId xmlns:a16="http://schemas.microsoft.com/office/drawing/2014/main" id="{B768446C-7945-4BBD-B546-C5F3851B2222}"/>
               </a:ext>
             </a:extLst>
           </p:cNvPr>
@@ -13686,7 +13686,7 @@
           <p:cNvPr id="21" name="">
             <a:extLst xmlns:a="http://schemas.openxmlformats.org/drawingml/2006/main">
               <a:ext uri="{FF2B5EF4-FFF2-40B4-BE49-F238E27FC236}">
-                <a16:creationId xmlns:a16="http://schemas.microsoft.com/office/drawing/2014/main" id="{D1E228C0-DDDC-4E9E-BD8B-171FA0E35854}"/>
+                <a16:creationId xmlns:a16="http://schemas.microsoft.com/office/drawing/2014/main" id="{BE0D05EB-3F44-4B05-8528-FFB49F5AE3BE}"/>
               </a:ext>
             </a:extLst>
           </p:cNvPr>
@@ -13731,7 +13731,7 @@
           <p:cNvPr id="22" name="">
             <a:extLst xmlns:a="http://schemas.openxmlformats.org/drawingml/2006/main">
               <a:ext uri="{FF2B5EF4-FFF2-40B4-BE49-F238E27FC236}">
-                <a16:creationId xmlns:a16="http://schemas.microsoft.com/office/drawing/2014/main" id="{2D6B09FD-49E0-4315-93D6-D13C6D0E66FE}"/>
+                <a16:creationId xmlns:a16="http://schemas.microsoft.com/office/drawing/2014/main" id="{339EDF7E-8BEE-4F3A-A60F-B4BF9FDB6640}"/>
               </a:ext>
             </a:extLst>
           </p:cNvPr>
@@ -13766,7 +13766,7 @@
           <p:cNvPr id="23" name="">
             <a:extLst xmlns:a="http://schemas.openxmlformats.org/drawingml/2006/main">
               <a:ext uri="{FF2B5EF4-FFF2-40B4-BE49-F238E27FC236}">
-                <a16:creationId xmlns:a16="http://schemas.microsoft.com/office/drawing/2014/main" id="{7CF3F805-9F6B-4BBB-91A4-999FE32C5C34}"/>
+                <a16:creationId xmlns:a16="http://schemas.microsoft.com/office/drawing/2014/main" id="{02BCBE71-1658-463B-843A-00F236603A4F}"/>
               </a:ext>
             </a:extLst>
           </p:cNvPr>
@@ -13811,7 +13811,7 @@
           <p:cNvPr id="24" name="">
             <a:extLst xmlns:a="http://schemas.openxmlformats.org/drawingml/2006/main">
               <a:ext uri="{FF2B5EF4-FFF2-40B4-BE49-F238E27FC236}">
-                <a16:creationId xmlns:a16="http://schemas.microsoft.com/office/drawing/2014/main" id="{BB26CF55-411C-404F-BDFD-F2CA19FA1286}"/>
+                <a16:creationId xmlns:a16="http://schemas.microsoft.com/office/drawing/2014/main" id="{FCC8995F-A49C-417C-BE27-3ABC3D05C899}"/>
               </a:ext>
             </a:extLst>
           </p:cNvPr>
@@ -13856,7 +13856,7 @@
           <p:cNvPr id="25" name="footer-left">
             <a:extLst xmlns:a="http://schemas.openxmlformats.org/drawingml/2006/main">
               <a:ext uri="{FF2B5EF4-FFF2-40B4-BE49-F238E27FC236}">
-                <a16:creationId xmlns:a16="http://schemas.microsoft.com/office/drawing/2014/main" id="{D76025CE-823F-411B-A2D7-19F73362011B}"/>
+                <a16:creationId xmlns:a16="http://schemas.microsoft.com/office/drawing/2014/main" id="{5C60D63A-A66F-456B-B6A3-E3ECF595498C}"/>
               </a:ext>
             </a:extLst>
           </p:cNvPr>
@@ -13901,7 +13901,7 @@
           <p:cNvPr id="26" name="footer-right">
             <a:extLst xmlns:a="http://schemas.openxmlformats.org/drawingml/2006/main">
               <a:ext uri="{FF2B5EF4-FFF2-40B4-BE49-F238E27FC236}">
-                <a16:creationId xmlns:a16="http://schemas.microsoft.com/office/drawing/2014/main" id="{9F263B34-C4CF-4ABC-8D9B-C0D77F781289}"/>
+                <a16:creationId xmlns:a16="http://schemas.microsoft.com/office/drawing/2014/main" id="{FB76E3B1-3E10-41D2-9F7E-3713F0E9B79E}"/>
               </a:ext>
             </a:extLst>
           </p:cNvPr>
@@ -13944,7 +13944,7 @@
     </p:spTree>
     <p:extLst>
       <p:ext uri="{BB962C8B-B14F-4D97-AF65-F5344CB8AC3E}">
-        <p14:creationId xmlns:p14="http://schemas.microsoft.com/office/powerpoint/2010/main" val="594305591"/>
+        <p14:creationId xmlns:p14="http://schemas.microsoft.com/office/powerpoint/2010/main" val="449734662"/>
       </p:ext>
     </p:extLst>
   </p:cSld>
@@ -13968,7 +13968,7 @@
           <p:cNvPr id="1" name="slide-stage">
             <a:extLst xmlns:a="http://schemas.openxmlformats.org/drawingml/2006/main">
               <a:ext uri="{FF2B5EF4-FFF2-40B4-BE49-F238E27FC236}">
-                <a16:creationId xmlns:a16="http://schemas.microsoft.com/office/drawing/2014/main" id="{C9DB7840-E7F3-4851-ABDE-F885E0B80ED9}"/>
+                <a16:creationId xmlns:a16="http://schemas.microsoft.com/office/drawing/2014/main" id="{8E70A715-BB81-41AA-BB0F-8E1E6FE2544E}"/>
               </a:ext>
             </a:extLst>
           </p:cNvPr>
@@ -13995,7 +13995,7 @@
           <p:cNvPr id="2" name="eyebrow">
             <a:extLst xmlns:a="http://schemas.openxmlformats.org/drawingml/2006/main">
               <a:ext uri="{FF2B5EF4-FFF2-40B4-BE49-F238E27FC236}">
-                <a16:creationId xmlns:a16="http://schemas.microsoft.com/office/drawing/2014/main" id="{B0C2497B-2E16-4709-8B03-393A15D859BC}"/>
+                <a16:creationId xmlns:a16="http://schemas.microsoft.com/office/drawing/2014/main" id="{5D400C23-B048-45DC-AFCD-FEA99AA7DA4D}"/>
               </a:ext>
             </a:extLst>
           </p:cNvPr>
@@ -14040,7 +14040,7 @@
           <p:cNvPr id="3" name="slide-title">
             <a:extLst xmlns:a="http://schemas.openxmlformats.org/drawingml/2006/main">
               <a:ext uri="{FF2B5EF4-FFF2-40B4-BE49-F238E27FC236}">
-                <a16:creationId xmlns:a16="http://schemas.microsoft.com/office/drawing/2014/main" id="{3DE4BCAD-9094-4480-9211-08CE3AB335DF}"/>
+                <a16:creationId xmlns:a16="http://schemas.microsoft.com/office/drawing/2014/main" id="{BE07D584-9252-432E-B457-8DF35807AC0F}"/>
               </a:ext>
             </a:extLst>
           </p:cNvPr>
@@ -14085,7 +14085,7 @@
           <p:cNvPr id="4" name="slide-subtitle">
             <a:extLst xmlns:a="http://schemas.openxmlformats.org/drawingml/2006/main">
               <a:ext uri="{FF2B5EF4-FFF2-40B4-BE49-F238E27FC236}">
-                <a16:creationId xmlns:a16="http://schemas.microsoft.com/office/drawing/2014/main" id="{0B351630-E8E6-4A39-882F-A1D7423D8F6C}"/>
+                <a16:creationId xmlns:a16="http://schemas.microsoft.com/office/drawing/2014/main" id="{821AEAA8-B428-4EE6-90AC-76515894DAAD}"/>
               </a:ext>
             </a:extLst>
           </p:cNvPr>
@@ -14130,7 +14130,7 @@
           <p:cNvPr id="5" name="">
             <a:extLst xmlns:a="http://schemas.openxmlformats.org/drawingml/2006/main">
               <a:ext uri="{FF2B5EF4-FFF2-40B4-BE49-F238E27FC236}">
-                <a16:creationId xmlns:a16="http://schemas.microsoft.com/office/drawing/2014/main" id="{6DA760E6-FE52-4343-9F70-FAB5D22966E8}"/>
+                <a16:creationId xmlns:a16="http://schemas.microsoft.com/office/drawing/2014/main" id="{E4E66F25-DA57-44A4-9892-DD8C7B2BBD57}"/>
               </a:ext>
             </a:extLst>
           </p:cNvPr>
@@ -14163,7 +14163,7 @@
           <p:cNvPr id="6" name="">
             <a:extLst xmlns:a="http://schemas.openxmlformats.org/drawingml/2006/main">
               <a:ext uri="{FF2B5EF4-FFF2-40B4-BE49-F238E27FC236}">
-                <a16:creationId xmlns:a16="http://schemas.microsoft.com/office/drawing/2014/main" id="{25663392-9E71-49E0-9AB7-92BD89B467A8}"/>
+                <a16:creationId xmlns:a16="http://schemas.microsoft.com/office/drawing/2014/main" id="{0F3EF78D-7308-4307-ABB3-123D3E3BC4E3}"/>
               </a:ext>
             </a:extLst>
           </p:cNvPr>
@@ -14208,7 +14208,7 @@
           <p:cNvPr id="7" name="">
             <a:extLst xmlns:a="http://schemas.openxmlformats.org/drawingml/2006/main">
               <a:ext uri="{FF2B5EF4-FFF2-40B4-BE49-F238E27FC236}">
-                <a16:creationId xmlns:a16="http://schemas.microsoft.com/office/drawing/2014/main" id="{FAA55A78-A15B-414E-9A72-A3D46A006545}"/>
+                <a16:creationId xmlns:a16="http://schemas.microsoft.com/office/drawing/2014/main" id="{4E9725AF-966B-4835-A3CD-92EE3D18101A}"/>
               </a:ext>
             </a:extLst>
           </p:cNvPr>
@@ -14253,7 +14253,7 @@
           <p:cNvPr id="8" name="">
             <a:extLst xmlns:a="http://schemas.openxmlformats.org/drawingml/2006/main">
               <a:ext uri="{FF2B5EF4-FFF2-40B4-BE49-F238E27FC236}">
-                <a16:creationId xmlns:a16="http://schemas.microsoft.com/office/drawing/2014/main" id="{1BF45004-B908-461B-AB4A-2BF9E997B214}"/>
+                <a16:creationId xmlns:a16="http://schemas.microsoft.com/office/drawing/2014/main" id="{192273B9-5800-49FF-BBC3-92FA9CF6391C}"/>
               </a:ext>
             </a:extLst>
           </p:cNvPr>
@@ -14286,7 +14286,7 @@
           <p:cNvPr id="9" name="">
             <a:extLst xmlns:a="http://schemas.openxmlformats.org/drawingml/2006/main">
               <a:ext uri="{FF2B5EF4-FFF2-40B4-BE49-F238E27FC236}">
-                <a16:creationId xmlns:a16="http://schemas.microsoft.com/office/drawing/2014/main" id="{4B8232E8-E35D-49CE-A2A0-ACC46FF9DDE5}"/>
+                <a16:creationId xmlns:a16="http://schemas.microsoft.com/office/drawing/2014/main" id="{8D47BF81-BD88-4A75-BA0D-7B33300665B5}"/>
               </a:ext>
             </a:extLst>
           </p:cNvPr>
@@ -14331,7 +14331,7 @@
           <p:cNvPr id="10" name="">
             <a:extLst xmlns:a="http://schemas.openxmlformats.org/drawingml/2006/main">
               <a:ext uri="{FF2B5EF4-FFF2-40B4-BE49-F238E27FC236}">
-                <a16:creationId xmlns:a16="http://schemas.microsoft.com/office/drawing/2014/main" id="{9D0F5123-AE2D-4C25-B5E9-00C96D6DA1AB}"/>
+                <a16:creationId xmlns:a16="http://schemas.microsoft.com/office/drawing/2014/main" id="{967B4C41-E1DE-4D6B-9D13-D59951526ABE}"/>
               </a:ext>
             </a:extLst>
           </p:cNvPr>
@@ -14376,7 +14376,7 @@
           <p:cNvPr id="11" name="">
             <a:extLst xmlns:a="http://schemas.openxmlformats.org/drawingml/2006/main">
               <a:ext uri="{FF2B5EF4-FFF2-40B4-BE49-F238E27FC236}">
-                <a16:creationId xmlns:a16="http://schemas.microsoft.com/office/drawing/2014/main" id="{5E78F8A9-078D-40B4-8D65-BD8A17E83C16}"/>
+                <a16:creationId xmlns:a16="http://schemas.microsoft.com/office/drawing/2014/main" id="{C67A59C7-0AE9-4848-98F7-2C48273909CA}"/>
               </a:ext>
             </a:extLst>
           </p:cNvPr>
@@ -14409,7 +14409,7 @@
           <p:cNvPr id="12" name="">
             <a:extLst xmlns:a="http://schemas.openxmlformats.org/drawingml/2006/main">
               <a:ext uri="{FF2B5EF4-FFF2-40B4-BE49-F238E27FC236}">
-                <a16:creationId xmlns:a16="http://schemas.microsoft.com/office/drawing/2014/main" id="{884899CD-8824-48B2-867B-4153508EF9EE}"/>
+                <a16:creationId xmlns:a16="http://schemas.microsoft.com/office/drawing/2014/main" id="{756FA7F1-A697-4E7E-9AB7-BB9F2ECA6552}"/>
               </a:ext>
             </a:extLst>
           </p:cNvPr>
@@ -14454,7 +14454,7 @@
           <p:cNvPr id="13" name="">
             <a:extLst xmlns:a="http://schemas.openxmlformats.org/drawingml/2006/main">
               <a:ext uri="{FF2B5EF4-FFF2-40B4-BE49-F238E27FC236}">
-                <a16:creationId xmlns:a16="http://schemas.microsoft.com/office/drawing/2014/main" id="{54FF87CD-142B-4827-A96C-2553CFAA41FF}"/>
+                <a16:creationId xmlns:a16="http://schemas.microsoft.com/office/drawing/2014/main" id="{B9138D6F-EA05-4C98-A51E-5F7563C31DE4}"/>
               </a:ext>
             </a:extLst>
           </p:cNvPr>
@@ -14499,7 +14499,7 @@
           <p:cNvPr id="14" name="">
             <a:extLst xmlns:a="http://schemas.openxmlformats.org/drawingml/2006/main">
               <a:ext uri="{FF2B5EF4-FFF2-40B4-BE49-F238E27FC236}">
-                <a16:creationId xmlns:a16="http://schemas.microsoft.com/office/drawing/2014/main" id="{397127EA-C08A-47BE-BD43-2A2FB1270F1B}"/>
+                <a16:creationId xmlns:a16="http://schemas.microsoft.com/office/drawing/2014/main" id="{6ACD8EC6-7AAB-4128-98AA-155771A878B0}"/>
               </a:ext>
             </a:extLst>
           </p:cNvPr>
@@ -14532,7 +14532,7 @@
           <p:cNvPr id="15" name="">
             <a:extLst xmlns:a="http://schemas.openxmlformats.org/drawingml/2006/main">
               <a:ext uri="{FF2B5EF4-FFF2-40B4-BE49-F238E27FC236}">
-                <a16:creationId xmlns:a16="http://schemas.microsoft.com/office/drawing/2014/main" id="{520DA27F-8467-44EF-8067-3FB52FA68C14}"/>
+                <a16:creationId xmlns:a16="http://schemas.microsoft.com/office/drawing/2014/main" id="{6064C6F8-A2E8-4673-A9FE-B316DFA47D7C}"/>
               </a:ext>
             </a:extLst>
           </p:cNvPr>
@@ -14577,7 +14577,7 @@
           <p:cNvPr id="16" name="">
             <a:extLst xmlns:a="http://schemas.openxmlformats.org/drawingml/2006/main">
               <a:ext uri="{FF2B5EF4-FFF2-40B4-BE49-F238E27FC236}">
-                <a16:creationId xmlns:a16="http://schemas.microsoft.com/office/drawing/2014/main" id="{C8C5A873-1454-4D9D-8041-B0F59B941853}"/>
+                <a16:creationId xmlns:a16="http://schemas.microsoft.com/office/drawing/2014/main" id="{15FBAAF9-AB23-4BA7-AFC9-4F863DCE5B19}"/>
               </a:ext>
             </a:extLst>
           </p:cNvPr>
@@ -14622,7 +14622,7 @@
           <p:cNvPr id="17" name="footer-left">
             <a:extLst xmlns:a="http://schemas.openxmlformats.org/drawingml/2006/main">
               <a:ext uri="{FF2B5EF4-FFF2-40B4-BE49-F238E27FC236}">
-                <a16:creationId xmlns:a16="http://schemas.microsoft.com/office/drawing/2014/main" id="{CB11AE16-0A67-456E-963F-BB848DECBA9A}"/>
+                <a16:creationId xmlns:a16="http://schemas.microsoft.com/office/drawing/2014/main" id="{2B821AC5-79CE-4924-A339-585D2FC56030}"/>
               </a:ext>
             </a:extLst>
           </p:cNvPr>
@@ -14667,7 +14667,7 @@
           <p:cNvPr id="18" name="footer-right">
             <a:extLst xmlns:a="http://schemas.openxmlformats.org/drawingml/2006/main">
               <a:ext uri="{FF2B5EF4-FFF2-40B4-BE49-F238E27FC236}">
-                <a16:creationId xmlns:a16="http://schemas.microsoft.com/office/drawing/2014/main" id="{65AEAE08-D30D-4BB3-AC4D-E4EFEFE8E104}"/>
+                <a16:creationId xmlns:a16="http://schemas.microsoft.com/office/drawing/2014/main" id="{528678F5-745B-4AF7-8DAE-6D48C5BBA13D}"/>
               </a:ext>
             </a:extLst>
           </p:cNvPr>
@@ -14710,7 +14710,7 @@
     </p:spTree>
     <p:extLst>
       <p:ext uri="{BB962C8B-B14F-4D97-AF65-F5344CB8AC3E}">
-        <p14:creationId xmlns:p14="http://schemas.microsoft.com/office/powerpoint/2010/main" val="1670310892"/>
+        <p14:creationId xmlns:p14="http://schemas.microsoft.com/office/powerpoint/2010/main" val="70564107"/>
       </p:ext>
     </p:extLst>
   </p:cSld>
@@ -14734,7 +14734,7 @@
           <p:cNvPr id="1" name="slide-stage">
             <a:extLst xmlns:a="http://schemas.openxmlformats.org/drawingml/2006/main">
               <a:ext uri="{FF2B5EF4-FFF2-40B4-BE49-F238E27FC236}">
-                <a16:creationId xmlns:a16="http://schemas.microsoft.com/office/drawing/2014/main" id="{9C4018C4-0B3C-42F1-B744-AC655B88C9C9}"/>
+                <a16:creationId xmlns:a16="http://schemas.microsoft.com/office/drawing/2014/main" id="{C15F07C4-2D71-4A0A-9099-5987097DC34E}"/>
               </a:ext>
             </a:extLst>
           </p:cNvPr>
@@ -14761,7 +14761,7 @@
           <p:cNvPr id="2" name="eyebrow">
             <a:extLst xmlns:a="http://schemas.openxmlformats.org/drawingml/2006/main">
               <a:ext uri="{FF2B5EF4-FFF2-40B4-BE49-F238E27FC236}">
-                <a16:creationId xmlns:a16="http://schemas.microsoft.com/office/drawing/2014/main" id="{FD48E631-58AD-46E2-BFF5-450527C59DB0}"/>
+                <a16:creationId xmlns:a16="http://schemas.microsoft.com/office/drawing/2014/main" id="{3E175620-5B43-4A39-8939-132D86100DC3}"/>
               </a:ext>
             </a:extLst>
           </p:cNvPr>
@@ -14806,7 +14806,7 @@
           <p:cNvPr id="3" name="slide-title">
             <a:extLst xmlns:a="http://schemas.openxmlformats.org/drawingml/2006/main">
               <a:ext uri="{FF2B5EF4-FFF2-40B4-BE49-F238E27FC236}">
-                <a16:creationId xmlns:a16="http://schemas.microsoft.com/office/drawing/2014/main" id="{56194603-C43F-40AC-ADCC-FE900D9B679F}"/>
+                <a16:creationId xmlns:a16="http://schemas.microsoft.com/office/drawing/2014/main" id="{8A26EFFE-4278-4999-A2B7-60941A711CE3}"/>
               </a:ext>
             </a:extLst>
           </p:cNvPr>
@@ -14851,7 +14851,7 @@
           <p:cNvPr id="4" name="slide-subtitle">
             <a:extLst xmlns:a="http://schemas.openxmlformats.org/drawingml/2006/main">
               <a:ext uri="{FF2B5EF4-FFF2-40B4-BE49-F238E27FC236}">
-                <a16:creationId xmlns:a16="http://schemas.microsoft.com/office/drawing/2014/main" id="{6377ECB4-6C5F-4487-BDF2-905A8F33A960}"/>
+                <a16:creationId xmlns:a16="http://schemas.microsoft.com/office/drawing/2014/main" id="{2AFC0D92-43DC-41A5-8F8B-F5ACE49F05A1}"/>
               </a:ext>
             </a:extLst>
           </p:cNvPr>
@@ -14896,7 +14896,7 @@
           <p:cNvPr id="5" name="">
             <a:extLst xmlns:a="http://schemas.openxmlformats.org/drawingml/2006/main">
               <a:ext uri="{FF2B5EF4-FFF2-40B4-BE49-F238E27FC236}">
-                <a16:creationId xmlns:a16="http://schemas.microsoft.com/office/drawing/2014/main" id="{94655EEE-CF42-4C32-A2EC-502F19762F46}"/>
+                <a16:creationId xmlns:a16="http://schemas.microsoft.com/office/drawing/2014/main" id="{B408C89E-2F26-4FA0-884B-46034C9291BE}"/>
               </a:ext>
             </a:extLst>
           </p:cNvPr>
@@ -14941,7 +14941,7 @@
           <p:cNvPr id="6" name="">
             <a:extLst xmlns:a="http://schemas.openxmlformats.org/drawingml/2006/main">
               <a:ext uri="{FF2B5EF4-FFF2-40B4-BE49-F238E27FC236}">
-                <a16:creationId xmlns:a16="http://schemas.microsoft.com/office/drawing/2014/main" id="{39A7D61B-E49A-4339-91C7-651ABE26D953}"/>
+                <a16:creationId xmlns:a16="http://schemas.microsoft.com/office/drawing/2014/main" id="{6108FB01-D831-437B-AA3B-82D0AA860104}"/>
               </a:ext>
             </a:extLst>
           </p:cNvPr>
@@ -14986,7 +14986,7 @@
           <p:cNvPr id="7" name="">
             <a:extLst xmlns:a="http://schemas.openxmlformats.org/drawingml/2006/main">
               <a:ext uri="{FF2B5EF4-FFF2-40B4-BE49-F238E27FC236}">
-                <a16:creationId xmlns:a16="http://schemas.microsoft.com/office/drawing/2014/main" id="{28BBA2A4-DFF5-40ED-BE4D-9BBCB1D90E29}"/>
+                <a16:creationId xmlns:a16="http://schemas.microsoft.com/office/drawing/2014/main" id="{CB13C3D3-E3A0-4E23-A141-ED9B2BE8FCBB}"/>
               </a:ext>
             </a:extLst>
           </p:cNvPr>
@@ -15031,7 +15031,7 @@
           <p:cNvPr id="8" name="">
             <a:extLst xmlns:a="http://schemas.openxmlformats.org/drawingml/2006/main">
               <a:ext uri="{FF2B5EF4-FFF2-40B4-BE49-F238E27FC236}">
-                <a16:creationId xmlns:a16="http://schemas.microsoft.com/office/drawing/2014/main" id="{B5B6A4D1-4A6F-4CF5-A904-846B9B786302}"/>
+                <a16:creationId xmlns:a16="http://schemas.microsoft.com/office/drawing/2014/main" id="{D55386BA-545E-4EEE-B3C8-3E657668C7A3}"/>
               </a:ext>
             </a:extLst>
           </p:cNvPr>
@@ -15076,7 +15076,7 @@
           <p:cNvPr id="9" name="">
             <a:extLst xmlns:a="http://schemas.openxmlformats.org/drawingml/2006/main">
               <a:ext uri="{FF2B5EF4-FFF2-40B4-BE49-F238E27FC236}">
-                <a16:creationId xmlns:a16="http://schemas.microsoft.com/office/drawing/2014/main" id="{26CB5549-6992-466F-8D02-C1535E004CE6}"/>
+                <a16:creationId xmlns:a16="http://schemas.microsoft.com/office/drawing/2014/main" id="{6861E548-B893-49F0-BECF-A3C0D9030B31}"/>
               </a:ext>
             </a:extLst>
           </p:cNvPr>
@@ -15121,7 +15121,7 @@
           <p:cNvPr id="10" name="">
             <a:extLst xmlns:a="http://schemas.openxmlformats.org/drawingml/2006/main">
               <a:ext uri="{FF2B5EF4-FFF2-40B4-BE49-F238E27FC236}">
-                <a16:creationId xmlns:a16="http://schemas.microsoft.com/office/drawing/2014/main" id="{3C7FB149-09D7-445C-A57B-F9DCF227B937}"/>
+                <a16:creationId xmlns:a16="http://schemas.microsoft.com/office/drawing/2014/main" id="{070D2A01-4E45-449B-B8F4-2D1EB1D3851E}"/>
               </a:ext>
             </a:extLst>
           </p:cNvPr>
@@ -15166,7 +15166,7 @@
           <p:cNvPr id="11" name="">
             <a:extLst xmlns:a="http://schemas.openxmlformats.org/drawingml/2006/main">
               <a:ext uri="{FF2B5EF4-FFF2-40B4-BE49-F238E27FC236}">
-                <a16:creationId xmlns:a16="http://schemas.microsoft.com/office/drawing/2014/main" id="{8EC68C01-85BD-4A78-9A80-8A7FECFD9A72}"/>
+                <a16:creationId xmlns:a16="http://schemas.microsoft.com/office/drawing/2014/main" id="{DF073EA6-7E34-4A0E-BAEE-D754E1F3B147}"/>
               </a:ext>
             </a:extLst>
           </p:cNvPr>
@@ -15201,7 +15201,7 @@
           <p:cNvPr id="12" name="">
             <a:extLst xmlns:a="http://schemas.openxmlformats.org/drawingml/2006/main">
               <a:ext uri="{FF2B5EF4-FFF2-40B4-BE49-F238E27FC236}">
-                <a16:creationId xmlns:a16="http://schemas.microsoft.com/office/drawing/2014/main" id="{282AD749-2193-44AB-9DF1-F7F69EE4D90D}"/>
+                <a16:creationId xmlns:a16="http://schemas.microsoft.com/office/drawing/2014/main" id="{8FD7564D-DF1D-430A-BCF9-9F5B330C4196}"/>
               </a:ext>
             </a:extLst>
           </p:cNvPr>
@@ -15236,7 +15236,7 @@
                   <a:srgbClr val="08756F"/>
                 </a:solidFill>
               </a:rPr>
-              <a:t>330 tests passed</a:t>
+              <a:t>332 tests passed</a:t>
             </a:r>
           </a:p>
         </p:txBody>
@@ -15246,7 +15246,7 @@
           <p:cNvPr id="13" name="">
             <a:extLst xmlns:a="http://schemas.openxmlformats.org/drawingml/2006/main">
               <a:ext uri="{FF2B5EF4-FFF2-40B4-BE49-F238E27FC236}">
-                <a16:creationId xmlns:a16="http://schemas.microsoft.com/office/drawing/2014/main" id="{F5D93687-B917-4688-90B5-B0F37D1434FF}"/>
+                <a16:creationId xmlns:a16="http://schemas.microsoft.com/office/drawing/2014/main" id="{E80AE697-A026-4435-86EF-CEAFF51892DE}"/>
               </a:ext>
             </a:extLst>
           </p:cNvPr>
@@ -15281,7 +15281,7 @@
           <p:cNvPr id="14" name="">
             <a:extLst xmlns:a="http://schemas.openxmlformats.org/drawingml/2006/main">
               <a:ext uri="{FF2B5EF4-FFF2-40B4-BE49-F238E27FC236}">
-                <a16:creationId xmlns:a16="http://schemas.microsoft.com/office/drawing/2014/main" id="{A9A55F02-AEF6-4DFE-AEE7-75CDFE3DDE70}"/>
+                <a16:creationId xmlns:a16="http://schemas.microsoft.com/office/drawing/2014/main" id="{0358B8A6-F2CD-4238-82AB-B1AE1BD75768}"/>
               </a:ext>
             </a:extLst>
           </p:cNvPr>
@@ -15326,7 +15326,7 @@
           <p:cNvPr id="15" name="">
             <a:extLst xmlns:a="http://schemas.openxmlformats.org/drawingml/2006/main">
               <a:ext uri="{FF2B5EF4-FFF2-40B4-BE49-F238E27FC236}">
-                <a16:creationId xmlns:a16="http://schemas.microsoft.com/office/drawing/2014/main" id="{23FADA23-58D3-452F-A0C8-2D67D1684E99}"/>
+                <a16:creationId xmlns:a16="http://schemas.microsoft.com/office/drawing/2014/main" id="{4971C1D0-3AD4-443F-B9F4-3B4122D5C26B}"/>
               </a:ext>
             </a:extLst>
           </p:cNvPr>
@@ -15361,7 +15361,7 @@
           <p:cNvPr id="16" name="">
             <a:extLst xmlns:a="http://schemas.openxmlformats.org/drawingml/2006/main">
               <a:ext uri="{FF2B5EF4-FFF2-40B4-BE49-F238E27FC236}">
-                <a16:creationId xmlns:a16="http://schemas.microsoft.com/office/drawing/2014/main" id="{916EF8AF-F7D5-4A60-AE6F-817AFF9BEFA5}"/>
+                <a16:creationId xmlns:a16="http://schemas.microsoft.com/office/drawing/2014/main" id="{CFFAC275-7761-412C-A5B4-2F3A6F9350B1}"/>
               </a:ext>
             </a:extLst>
           </p:cNvPr>
@@ -15406,7 +15406,7 @@
           <p:cNvPr id="17" name="footer-left">
             <a:extLst xmlns:a="http://schemas.openxmlformats.org/drawingml/2006/main">
               <a:ext uri="{FF2B5EF4-FFF2-40B4-BE49-F238E27FC236}">
-                <a16:creationId xmlns:a16="http://schemas.microsoft.com/office/drawing/2014/main" id="{9760B938-E88F-4905-87D4-AA5556CB7A0A}"/>
+                <a16:creationId xmlns:a16="http://schemas.microsoft.com/office/drawing/2014/main" id="{C81A74EB-190E-4B32-8821-35D0F1785494}"/>
               </a:ext>
             </a:extLst>
           </p:cNvPr>
@@ -15451,7 +15451,7 @@
           <p:cNvPr id="18" name="footer-right">
             <a:extLst xmlns:a="http://schemas.openxmlformats.org/drawingml/2006/main">
               <a:ext uri="{FF2B5EF4-FFF2-40B4-BE49-F238E27FC236}">
-                <a16:creationId xmlns:a16="http://schemas.microsoft.com/office/drawing/2014/main" id="{1E2A67BE-A5CD-4817-9318-34BFACB55139}"/>
+                <a16:creationId xmlns:a16="http://schemas.microsoft.com/office/drawing/2014/main" id="{779B47CC-D49C-4C8E-8B59-F0AA474C6B94}"/>
               </a:ext>
             </a:extLst>
           </p:cNvPr>
@@ -15494,7 +15494,7 @@
     </p:spTree>
     <p:extLst>
       <p:ext uri="{BB962C8B-B14F-4D97-AF65-F5344CB8AC3E}">
-        <p14:creationId xmlns:p14="http://schemas.microsoft.com/office/powerpoint/2010/main" val="880011752"/>
+        <p14:creationId xmlns:p14="http://schemas.microsoft.com/office/powerpoint/2010/main" val="1589603711"/>
       </p:ext>
     </p:extLst>
   </p:cSld>

</xml_diff>

<commit_message>
Reclassify manual red flags by domain
</commit_message>
<xml_diff>
--- a/decks/clinsafer-interview-demo/output/output.pptx
+++ b/decks/clinsafer-interview-demo/output/output.pptx
@@ -2,28 +2,28 @@
 <file path=ppt/presentation.xml><?xml version="1.0" encoding="utf-8"?>
 <p:presentation xmlns:p="http://schemas.openxmlformats.org/presentationml/2006/main">
   <p:sldMasterIdLst>
-    <p:sldMasterId xmlns:r="http://schemas.openxmlformats.org/officeDocument/2006/relationships" id="2147483648" r:id="R71306ee5153842a5"/>
+    <p:sldMasterId xmlns:r="http://schemas.openxmlformats.org/officeDocument/2006/relationships" id="2147483648" r:id="R3596b55194524504"/>
   </p:sldMasterIdLst>
   <p:notesMasterIdLst>
-    <p:notesMasterId xmlns:r="http://schemas.openxmlformats.org/officeDocument/2006/relationships" r:id="Rb4215a4d4120423d"/>
+    <p:notesMasterId xmlns:r="http://schemas.openxmlformats.org/officeDocument/2006/relationships" r:id="R932d9ce007984ae7"/>
   </p:notesMasterIdLst>
   <p:sldIdLst>
-    <p:sldId xmlns:r="http://schemas.openxmlformats.org/officeDocument/2006/relationships" id="256" r:id="Re07794cec6f249d4"/>
-    <p:sldId xmlns:r="http://schemas.openxmlformats.org/officeDocument/2006/relationships" id="257" r:id="R652f8e453e5144a0"/>
-    <p:sldId xmlns:r="http://schemas.openxmlformats.org/officeDocument/2006/relationships" id="258" r:id="Rd9e31df618db4849"/>
-    <p:sldId xmlns:r="http://schemas.openxmlformats.org/officeDocument/2006/relationships" id="259" r:id="R8e5859fc0f3f4422"/>
-    <p:sldId xmlns:r="http://schemas.openxmlformats.org/officeDocument/2006/relationships" id="260" r:id="R19b5b9aaaac24bcf"/>
-    <p:sldId xmlns:r="http://schemas.openxmlformats.org/officeDocument/2006/relationships" id="261" r:id="R20ecb1d858e5490c"/>
-    <p:sldId xmlns:r="http://schemas.openxmlformats.org/officeDocument/2006/relationships" id="262" r:id="R939acde7ddf845ae"/>
-    <p:sldId xmlns:r="http://schemas.openxmlformats.org/officeDocument/2006/relationships" id="263" r:id="R1a65f8ef9fbd4b8f"/>
-    <p:sldId xmlns:r="http://schemas.openxmlformats.org/officeDocument/2006/relationships" id="264" r:id="R8a6237acc2c04b16"/>
-    <p:sldId xmlns:r="http://schemas.openxmlformats.org/officeDocument/2006/relationships" id="265" r:id="Rcbc61d3ff1784330"/>
-    <p:sldId xmlns:r="http://schemas.openxmlformats.org/officeDocument/2006/relationships" id="266" r:id="Rc3eb430a02864404"/>
-    <p:sldId xmlns:r="http://schemas.openxmlformats.org/officeDocument/2006/relationships" id="267" r:id="R8f2a168c594e4893"/>
-    <p:sldId xmlns:r="http://schemas.openxmlformats.org/officeDocument/2006/relationships" id="268" r:id="Rceb856d306db460c"/>
-    <p:sldId xmlns:r="http://schemas.openxmlformats.org/officeDocument/2006/relationships" id="269" r:id="Rb0f4c95d173648f5"/>
-    <p:sldId xmlns:r="http://schemas.openxmlformats.org/officeDocument/2006/relationships" id="270" r:id="R81dce22f1bd04dae"/>
-    <p:sldId xmlns:r="http://schemas.openxmlformats.org/officeDocument/2006/relationships" id="271" r:id="Rfeb41aa398504f33"/>
+    <p:sldId xmlns:r="http://schemas.openxmlformats.org/officeDocument/2006/relationships" id="256" r:id="R5e26830b296a42ed"/>
+    <p:sldId xmlns:r="http://schemas.openxmlformats.org/officeDocument/2006/relationships" id="257" r:id="R00c7b79bc3474066"/>
+    <p:sldId xmlns:r="http://schemas.openxmlformats.org/officeDocument/2006/relationships" id="258" r:id="Rcbc8e64d0c6b4dd7"/>
+    <p:sldId xmlns:r="http://schemas.openxmlformats.org/officeDocument/2006/relationships" id="259" r:id="Rc07c1aef5ca34c6b"/>
+    <p:sldId xmlns:r="http://schemas.openxmlformats.org/officeDocument/2006/relationships" id="260" r:id="Ra2603d15721348ae"/>
+    <p:sldId xmlns:r="http://schemas.openxmlformats.org/officeDocument/2006/relationships" id="261" r:id="Rcd130ecd5f34446d"/>
+    <p:sldId xmlns:r="http://schemas.openxmlformats.org/officeDocument/2006/relationships" id="262" r:id="R8eda9ab6ebff4b11"/>
+    <p:sldId xmlns:r="http://schemas.openxmlformats.org/officeDocument/2006/relationships" id="263" r:id="Re7c72a99ea844982"/>
+    <p:sldId xmlns:r="http://schemas.openxmlformats.org/officeDocument/2006/relationships" id="264" r:id="Rc600ea8b1be94305"/>
+    <p:sldId xmlns:r="http://schemas.openxmlformats.org/officeDocument/2006/relationships" id="265" r:id="R0ca0e816877c4c57"/>
+    <p:sldId xmlns:r="http://schemas.openxmlformats.org/officeDocument/2006/relationships" id="266" r:id="R68b9949b64834606"/>
+    <p:sldId xmlns:r="http://schemas.openxmlformats.org/officeDocument/2006/relationships" id="267" r:id="R34f9abaf12a0417c"/>
+    <p:sldId xmlns:r="http://schemas.openxmlformats.org/officeDocument/2006/relationships" id="268" r:id="R8afab2cf80e945cc"/>
+    <p:sldId xmlns:r="http://schemas.openxmlformats.org/officeDocument/2006/relationships" id="269" r:id="R7b8a9f83d6564b34"/>
+    <p:sldId xmlns:r="http://schemas.openxmlformats.org/officeDocument/2006/relationships" id="270" r:id="R6aac4e82d89b4d60"/>
+    <p:sldId xmlns:r="http://schemas.openxmlformats.org/officeDocument/2006/relationships" id="271" r:id="Rba960ab6c48b4abe"/>
   </p:sldIdLst>
   <p:sldSz cx="18288000" cy="10287000"/>
   <p:notesSz cx="6858000" cy="9144000"/>
@@ -2239,7 +2239,7 @@
   </p:cSld>
   <p:clrMap bg1="lt1" tx1="dk1" bg2="lt2" tx2="dk2" accent1="accent1" accent2="accent2" accent3="accent3" accent4="accent4" accent5="accent5" accent6="accent6" hlink="hlink" folHlink="folHlink"/>
   <p:sldLayoutIdLst>
-    <p:sldLayoutId xmlns:r="http://schemas.openxmlformats.org/officeDocument/2006/relationships" id="2147483649" r:id="R6c99f4999d5b499b"/>
+    <p:sldLayoutId xmlns:r="http://schemas.openxmlformats.org/officeDocument/2006/relationships" id="2147483649" r:id="R97e33901144e4fb6"/>
   </p:sldLayoutIdLst>
   <p:txStyles>
     <p:titleStyle>
@@ -2538,7 +2538,7 @@
           <p:cNvPr id="1" name="cover-stage">
             <a:extLst xmlns:a="http://schemas.openxmlformats.org/drawingml/2006/main">
               <a:ext uri="{FF2B5EF4-FFF2-40B4-BE49-F238E27FC236}">
-                <a16:creationId xmlns:a16="http://schemas.microsoft.com/office/drawing/2014/main" id="{A30237BF-AA81-43A4-93AD-4B655DB76830}"/>
+                <a16:creationId xmlns:a16="http://schemas.microsoft.com/office/drawing/2014/main" id="{E0B75FC5-CC15-456C-BF34-72EF08A59F0E}"/>
               </a:ext>
             </a:extLst>
           </p:cNvPr>
@@ -2565,7 +2565,7 @@
           <p:cNvPr id="2" name="">
             <a:extLst xmlns:a="http://schemas.openxmlformats.org/drawingml/2006/main">
               <a:ext uri="{FF2B5EF4-FFF2-40B4-BE49-F238E27FC236}">
-                <a16:creationId xmlns:a16="http://schemas.microsoft.com/office/drawing/2014/main" id="{794FE17F-79D7-47DA-8570-907EE3C17FD4}"/>
+                <a16:creationId xmlns:a16="http://schemas.microsoft.com/office/drawing/2014/main" id="{6B3743CA-367A-430B-92E4-124F4127B217}"/>
               </a:ext>
             </a:extLst>
           </p:cNvPr>
@@ -2610,7 +2610,7 @@
           <p:cNvPr id="3" name="cover-title">
             <a:extLst xmlns:a="http://schemas.openxmlformats.org/drawingml/2006/main">
               <a:ext uri="{FF2B5EF4-FFF2-40B4-BE49-F238E27FC236}">
-                <a16:creationId xmlns:a16="http://schemas.microsoft.com/office/drawing/2014/main" id="{2BC88DD1-FD26-4553-A9B3-B1E30C46AE28}"/>
+                <a16:creationId xmlns:a16="http://schemas.microsoft.com/office/drawing/2014/main" id="{FDE25A23-4767-4C03-A4FF-0C1F67C66498}"/>
               </a:ext>
             </a:extLst>
           </p:cNvPr>
@@ -2655,7 +2655,7 @@
           <p:cNvPr id="4" name="">
             <a:extLst xmlns:a="http://schemas.openxmlformats.org/drawingml/2006/main">
               <a:ext uri="{FF2B5EF4-FFF2-40B4-BE49-F238E27FC236}">
-                <a16:creationId xmlns:a16="http://schemas.microsoft.com/office/drawing/2014/main" id="{ED9DB5E8-48E6-4D2E-8485-8A0702CD4E08}"/>
+                <a16:creationId xmlns:a16="http://schemas.microsoft.com/office/drawing/2014/main" id="{EF6972ED-DF84-4EFB-A071-588C7A300775}"/>
               </a:ext>
             </a:extLst>
           </p:cNvPr>
@@ -2688,7 +2688,7 @@
           <p:cNvPr id="5" name="">
             <a:extLst xmlns:a="http://schemas.openxmlformats.org/drawingml/2006/main">
               <a:ext uri="{FF2B5EF4-FFF2-40B4-BE49-F238E27FC236}">
-                <a16:creationId xmlns:a16="http://schemas.microsoft.com/office/drawing/2014/main" id="{F954A73E-6DE4-4EE3-BF69-5CD81490921D}"/>
+                <a16:creationId xmlns:a16="http://schemas.microsoft.com/office/drawing/2014/main" id="{9D69351C-FC7F-42AE-9584-3EF7DCBC5BF6}"/>
               </a:ext>
             </a:extLst>
           </p:cNvPr>
@@ -2733,7 +2733,7 @@
           <p:cNvPr id="6" name="">
             <a:extLst xmlns:a="http://schemas.openxmlformats.org/drawingml/2006/main">
               <a:ext uri="{FF2B5EF4-FFF2-40B4-BE49-F238E27FC236}">
-                <a16:creationId xmlns:a16="http://schemas.microsoft.com/office/drawing/2014/main" id="{C3F609F7-E29B-4C9E-8E40-26D636B9EAB0}"/>
+                <a16:creationId xmlns:a16="http://schemas.microsoft.com/office/drawing/2014/main" id="{D4CDD545-5ADA-439A-8938-7F865BA95BF1}"/>
               </a:ext>
             </a:extLst>
           </p:cNvPr>
@@ -2778,7 +2778,7 @@
           <p:cNvPr id="7" name="">
             <a:extLst xmlns:a="http://schemas.openxmlformats.org/drawingml/2006/main">
               <a:ext uri="{FF2B5EF4-FFF2-40B4-BE49-F238E27FC236}">
-                <a16:creationId xmlns:a16="http://schemas.microsoft.com/office/drawing/2014/main" id="{3A3AD807-F3E9-4548-BE05-3855C39B64A3}"/>
+                <a16:creationId xmlns:a16="http://schemas.microsoft.com/office/drawing/2014/main" id="{99E0891C-23EE-4250-A170-3AB7EA4B6C63}"/>
               </a:ext>
             </a:extLst>
           </p:cNvPr>
@@ -2823,7 +2823,7 @@
           <p:cNvPr id="8" name="">
             <a:extLst xmlns:a="http://schemas.openxmlformats.org/drawingml/2006/main">
               <a:ext uri="{FF2B5EF4-FFF2-40B4-BE49-F238E27FC236}">
-                <a16:creationId xmlns:a16="http://schemas.microsoft.com/office/drawing/2014/main" id="{6ED3A03B-DE16-4EB3-9F1E-E6700E5272AA}"/>
+                <a16:creationId xmlns:a16="http://schemas.microsoft.com/office/drawing/2014/main" id="{536765F9-D198-498F-96F3-05B7DC50CF4A}"/>
               </a:ext>
             </a:extLst>
           </p:cNvPr>
@@ -2858,7 +2858,7 @@
                   <a:srgbClr val="2364AA"/>
                 </a:solidFill>
               </a:rPr>
-              <a:t>332</a:t>
+              <a:t>333</a:t>
             </a:r>
           </a:p>
         </p:txBody>
@@ -2868,7 +2868,7 @@
           <p:cNvPr id="9" name="">
             <a:extLst xmlns:a="http://schemas.openxmlformats.org/drawingml/2006/main">
               <a:ext uri="{FF2B5EF4-FFF2-40B4-BE49-F238E27FC236}">
-                <a16:creationId xmlns:a16="http://schemas.microsoft.com/office/drawing/2014/main" id="{2720000E-E197-495C-B555-8DDBE2046725}"/>
+                <a16:creationId xmlns:a16="http://schemas.microsoft.com/office/drawing/2014/main" id="{637EC364-F780-4C86-A0D3-650A209B3BE4}"/>
               </a:ext>
             </a:extLst>
           </p:cNvPr>
@@ -2913,7 +2913,7 @@
           <p:cNvPr id="10" name="">
             <a:extLst xmlns:a="http://schemas.openxmlformats.org/drawingml/2006/main">
               <a:ext uri="{FF2B5EF4-FFF2-40B4-BE49-F238E27FC236}">
-                <a16:creationId xmlns:a16="http://schemas.microsoft.com/office/drawing/2014/main" id="{DC22CE68-215A-4F5E-8EEE-5A2435D7FDA4}"/>
+                <a16:creationId xmlns:a16="http://schemas.microsoft.com/office/drawing/2014/main" id="{E4D6AF85-3539-43B6-9873-02AB8DF29675}"/>
               </a:ext>
             </a:extLst>
           </p:cNvPr>
@@ -2958,7 +2958,7 @@
           <p:cNvPr id="11" name="">
             <a:extLst xmlns:a="http://schemas.openxmlformats.org/drawingml/2006/main">
               <a:ext uri="{FF2B5EF4-FFF2-40B4-BE49-F238E27FC236}">
-                <a16:creationId xmlns:a16="http://schemas.microsoft.com/office/drawing/2014/main" id="{CBC00487-5A27-4176-8E5B-82CD18C78C9F}"/>
+                <a16:creationId xmlns:a16="http://schemas.microsoft.com/office/drawing/2014/main" id="{95D3EF25-16B2-4B64-AD73-FC372D68412C}"/>
               </a:ext>
             </a:extLst>
           </p:cNvPr>
@@ -3003,7 +3003,7 @@
           <p:cNvPr id="12" name="">
             <a:extLst xmlns:a="http://schemas.openxmlformats.org/drawingml/2006/main">
               <a:ext uri="{FF2B5EF4-FFF2-40B4-BE49-F238E27FC236}">
-                <a16:creationId xmlns:a16="http://schemas.microsoft.com/office/drawing/2014/main" id="{16D8C782-481F-4425-8ED1-A22019BEAD33}"/>
+                <a16:creationId xmlns:a16="http://schemas.microsoft.com/office/drawing/2014/main" id="{077C0798-E106-4D08-9CC8-37B7CDD1B138}"/>
               </a:ext>
             </a:extLst>
           </p:cNvPr>
@@ -3048,7 +3048,7 @@
           <p:cNvPr id="13" name="">
             <a:extLst xmlns:a="http://schemas.openxmlformats.org/drawingml/2006/main">
               <a:ext uri="{FF2B5EF4-FFF2-40B4-BE49-F238E27FC236}">
-                <a16:creationId xmlns:a16="http://schemas.microsoft.com/office/drawing/2014/main" id="{5CDAA691-16A6-4E31-9E0E-0104CEC39A39}"/>
+                <a16:creationId xmlns:a16="http://schemas.microsoft.com/office/drawing/2014/main" id="{0B0DE66E-DD0B-41B7-9A2A-8728059D286B}"/>
               </a:ext>
             </a:extLst>
           </p:cNvPr>
@@ -3091,7 +3091,7 @@
     </p:spTree>
     <p:extLst>
       <p:ext uri="{BB962C8B-B14F-4D97-AF65-F5344CB8AC3E}">
-        <p14:creationId xmlns:p14="http://schemas.microsoft.com/office/powerpoint/2010/main" val="1528411685"/>
+        <p14:creationId xmlns:p14="http://schemas.microsoft.com/office/powerpoint/2010/main" val="1335793174"/>
       </p:ext>
     </p:extLst>
   </p:cSld>
@@ -3115,7 +3115,7 @@
           <p:cNvPr id="1" name="slide-stage">
             <a:extLst xmlns:a="http://schemas.openxmlformats.org/drawingml/2006/main">
               <a:ext uri="{FF2B5EF4-FFF2-40B4-BE49-F238E27FC236}">
-                <a16:creationId xmlns:a16="http://schemas.microsoft.com/office/drawing/2014/main" id="{07C2EF1E-8854-46BE-832C-80AA273CB80C}"/>
+                <a16:creationId xmlns:a16="http://schemas.microsoft.com/office/drawing/2014/main" id="{6F8B6743-6027-4CDB-B622-2BEE18562E6D}"/>
               </a:ext>
             </a:extLst>
           </p:cNvPr>
@@ -3142,7 +3142,7 @@
           <p:cNvPr id="2" name="eyebrow">
             <a:extLst xmlns:a="http://schemas.openxmlformats.org/drawingml/2006/main">
               <a:ext uri="{FF2B5EF4-FFF2-40B4-BE49-F238E27FC236}">
-                <a16:creationId xmlns:a16="http://schemas.microsoft.com/office/drawing/2014/main" id="{268844C8-A6E1-4824-B84B-B2E7C989DDE0}"/>
+                <a16:creationId xmlns:a16="http://schemas.microsoft.com/office/drawing/2014/main" id="{52242FCD-C51A-475F-A78F-E1313F0B41DB}"/>
               </a:ext>
             </a:extLst>
           </p:cNvPr>
@@ -3187,7 +3187,7 @@
           <p:cNvPr id="3" name="slide-title">
             <a:extLst xmlns:a="http://schemas.openxmlformats.org/drawingml/2006/main">
               <a:ext uri="{FF2B5EF4-FFF2-40B4-BE49-F238E27FC236}">
-                <a16:creationId xmlns:a16="http://schemas.microsoft.com/office/drawing/2014/main" id="{CCEA3CFF-D264-4E56-A9A5-80EA2569FC9F}"/>
+                <a16:creationId xmlns:a16="http://schemas.microsoft.com/office/drawing/2014/main" id="{60D96225-49F9-4965-8F99-8280143F56A0}"/>
               </a:ext>
             </a:extLst>
           </p:cNvPr>
@@ -3232,7 +3232,7 @@
           <p:cNvPr id="4" name="slide-subtitle">
             <a:extLst xmlns:a="http://schemas.openxmlformats.org/drawingml/2006/main">
               <a:ext uri="{FF2B5EF4-FFF2-40B4-BE49-F238E27FC236}">
-                <a16:creationId xmlns:a16="http://schemas.microsoft.com/office/drawing/2014/main" id="{B46C774F-3192-4150-999A-6B9D4B8BF708}"/>
+                <a16:creationId xmlns:a16="http://schemas.microsoft.com/office/drawing/2014/main" id="{63CAB99A-490C-4508-8541-3A15385DC69F}"/>
               </a:ext>
             </a:extLst>
           </p:cNvPr>
@@ -3277,7 +3277,7 @@
           <p:cNvPr id="5" name="">
             <a:extLst xmlns:a="http://schemas.openxmlformats.org/drawingml/2006/main">
               <a:ext uri="{FF2B5EF4-FFF2-40B4-BE49-F238E27FC236}">
-                <a16:creationId xmlns:a16="http://schemas.microsoft.com/office/drawing/2014/main" id="{1680B99B-9190-4A7D-922F-5D2472FE6FA8}"/>
+                <a16:creationId xmlns:a16="http://schemas.microsoft.com/office/drawing/2014/main" id="{66B4CEBD-8727-4CFC-978D-3444031042DA}"/>
               </a:ext>
             </a:extLst>
           </p:cNvPr>
@@ -3310,7 +3310,7 @@
           <p:cNvPr id="6" name="">
             <a:extLst xmlns:a="http://schemas.openxmlformats.org/drawingml/2006/main">
               <a:ext uri="{FF2B5EF4-FFF2-40B4-BE49-F238E27FC236}">
-                <a16:creationId xmlns:a16="http://schemas.microsoft.com/office/drawing/2014/main" id="{1E10D435-EDDB-4906-BA3B-C95F88886E21}"/>
+                <a16:creationId xmlns:a16="http://schemas.microsoft.com/office/drawing/2014/main" id="{67D5A012-49F4-4E2B-A138-8592AE4BC446}"/>
               </a:ext>
             </a:extLst>
           </p:cNvPr>
@@ -3355,7 +3355,7 @@
           <p:cNvPr id="7" name="">
             <a:extLst xmlns:a="http://schemas.openxmlformats.org/drawingml/2006/main">
               <a:ext uri="{FF2B5EF4-FFF2-40B4-BE49-F238E27FC236}">
-                <a16:creationId xmlns:a16="http://schemas.microsoft.com/office/drawing/2014/main" id="{58B85365-F3B0-4779-A8E7-70475E0450A9}"/>
+                <a16:creationId xmlns:a16="http://schemas.microsoft.com/office/drawing/2014/main" id="{029A6125-2002-4336-8CF5-A46F73B48C80}"/>
               </a:ext>
             </a:extLst>
           </p:cNvPr>
@@ -3400,7 +3400,7 @@
           <p:cNvPr id="8" name="">
             <a:extLst xmlns:a="http://schemas.openxmlformats.org/drawingml/2006/main">
               <a:ext uri="{FF2B5EF4-FFF2-40B4-BE49-F238E27FC236}">
-                <a16:creationId xmlns:a16="http://schemas.microsoft.com/office/drawing/2014/main" id="{5B12F127-82C0-4092-ADAA-C17EAFCA4116}"/>
+                <a16:creationId xmlns:a16="http://schemas.microsoft.com/office/drawing/2014/main" id="{D16A96A0-3D3B-418F-819D-D208CBA5626E}"/>
               </a:ext>
             </a:extLst>
           </p:cNvPr>
@@ -3433,7 +3433,7 @@
           <p:cNvPr id="9" name="">
             <a:extLst xmlns:a="http://schemas.openxmlformats.org/drawingml/2006/main">
               <a:ext uri="{FF2B5EF4-FFF2-40B4-BE49-F238E27FC236}">
-                <a16:creationId xmlns:a16="http://schemas.microsoft.com/office/drawing/2014/main" id="{98B058F2-0765-4E73-B285-9D5130AF384C}"/>
+                <a16:creationId xmlns:a16="http://schemas.microsoft.com/office/drawing/2014/main" id="{57E5303F-AB9B-4122-B73B-E2224AF2D924}"/>
               </a:ext>
             </a:extLst>
           </p:cNvPr>
@@ -3478,7 +3478,7 @@
           <p:cNvPr id="10" name="">
             <a:extLst xmlns:a="http://schemas.openxmlformats.org/drawingml/2006/main">
               <a:ext uri="{FF2B5EF4-FFF2-40B4-BE49-F238E27FC236}">
-                <a16:creationId xmlns:a16="http://schemas.microsoft.com/office/drawing/2014/main" id="{38468482-AAA1-4DE3-9680-2E45ACB6E4FB}"/>
+                <a16:creationId xmlns:a16="http://schemas.microsoft.com/office/drawing/2014/main" id="{8D38BF67-C4F8-4DEC-A7F7-54C4CE5A3CA0}"/>
               </a:ext>
             </a:extLst>
           </p:cNvPr>
@@ -3523,7 +3523,7 @@
           <p:cNvPr id="11" name="">
             <a:extLst xmlns:a="http://schemas.openxmlformats.org/drawingml/2006/main">
               <a:ext uri="{FF2B5EF4-FFF2-40B4-BE49-F238E27FC236}">
-                <a16:creationId xmlns:a16="http://schemas.microsoft.com/office/drawing/2014/main" id="{50A298A4-97F1-4985-AA69-91531785FE86}"/>
+                <a16:creationId xmlns:a16="http://schemas.microsoft.com/office/drawing/2014/main" id="{6844DEA2-6375-4EE9-A9C9-1411FE10B0F5}"/>
               </a:ext>
             </a:extLst>
           </p:cNvPr>
@@ -3556,7 +3556,7 @@
           <p:cNvPr id="12" name="">
             <a:extLst xmlns:a="http://schemas.openxmlformats.org/drawingml/2006/main">
               <a:ext uri="{FF2B5EF4-FFF2-40B4-BE49-F238E27FC236}">
-                <a16:creationId xmlns:a16="http://schemas.microsoft.com/office/drawing/2014/main" id="{9687C60E-1EDC-4868-A5CB-BFE13D427CF9}"/>
+                <a16:creationId xmlns:a16="http://schemas.microsoft.com/office/drawing/2014/main" id="{1923EC69-7E03-44E2-9C52-2DFC2229DCED}"/>
               </a:ext>
             </a:extLst>
           </p:cNvPr>
@@ -3601,7 +3601,7 @@
           <p:cNvPr id="13" name="">
             <a:extLst xmlns:a="http://schemas.openxmlformats.org/drawingml/2006/main">
               <a:ext uri="{FF2B5EF4-FFF2-40B4-BE49-F238E27FC236}">
-                <a16:creationId xmlns:a16="http://schemas.microsoft.com/office/drawing/2014/main" id="{DBA96D4E-617F-46DC-8016-93AC29D04D8F}"/>
+                <a16:creationId xmlns:a16="http://schemas.microsoft.com/office/drawing/2014/main" id="{8CF6AF0E-A32F-454C-A265-FE483BF13886}"/>
               </a:ext>
             </a:extLst>
           </p:cNvPr>
@@ -3646,7 +3646,7 @@
           <p:cNvPr id="14" name="">
             <a:extLst xmlns:a="http://schemas.openxmlformats.org/drawingml/2006/main">
               <a:ext uri="{FF2B5EF4-FFF2-40B4-BE49-F238E27FC236}">
-                <a16:creationId xmlns:a16="http://schemas.microsoft.com/office/drawing/2014/main" id="{7AAA4311-8895-47A1-8F64-C4CA30F7CBB4}"/>
+                <a16:creationId xmlns:a16="http://schemas.microsoft.com/office/drawing/2014/main" id="{51A4E5A0-7CFF-411D-8E04-B9B08D1274C0}"/>
               </a:ext>
             </a:extLst>
           </p:cNvPr>
@@ -3679,7 +3679,7 @@
           <p:cNvPr id="15" name="">
             <a:extLst xmlns:a="http://schemas.openxmlformats.org/drawingml/2006/main">
               <a:ext uri="{FF2B5EF4-FFF2-40B4-BE49-F238E27FC236}">
-                <a16:creationId xmlns:a16="http://schemas.microsoft.com/office/drawing/2014/main" id="{95BA2FA1-FAEE-4579-9546-9A46917C72A4}"/>
+                <a16:creationId xmlns:a16="http://schemas.microsoft.com/office/drawing/2014/main" id="{2E00F15A-4FCF-4958-8090-D49ED1CE7E4F}"/>
               </a:ext>
             </a:extLst>
           </p:cNvPr>
@@ -3724,7 +3724,7 @@
           <p:cNvPr id="16" name="">
             <a:extLst xmlns:a="http://schemas.openxmlformats.org/drawingml/2006/main">
               <a:ext uri="{FF2B5EF4-FFF2-40B4-BE49-F238E27FC236}">
-                <a16:creationId xmlns:a16="http://schemas.microsoft.com/office/drawing/2014/main" id="{41B1A8BF-12D0-45DD-8468-816CA82BE72E}"/>
+                <a16:creationId xmlns:a16="http://schemas.microsoft.com/office/drawing/2014/main" id="{FB691DD7-89D9-4077-B287-D7596AFC99E7}"/>
               </a:ext>
             </a:extLst>
           </p:cNvPr>
@@ -3769,7 +3769,7 @@
           <p:cNvPr id="17" name="footer-left">
             <a:extLst xmlns:a="http://schemas.openxmlformats.org/drawingml/2006/main">
               <a:ext uri="{FF2B5EF4-FFF2-40B4-BE49-F238E27FC236}">
-                <a16:creationId xmlns:a16="http://schemas.microsoft.com/office/drawing/2014/main" id="{3B16AD98-A686-4DCC-B3F7-7D5BE4ACED55}"/>
+                <a16:creationId xmlns:a16="http://schemas.microsoft.com/office/drawing/2014/main" id="{EE63098D-894C-4BD0-8958-A87DE440F637}"/>
               </a:ext>
             </a:extLst>
           </p:cNvPr>
@@ -3814,7 +3814,7 @@
           <p:cNvPr id="18" name="footer-right">
             <a:extLst xmlns:a="http://schemas.openxmlformats.org/drawingml/2006/main">
               <a:ext uri="{FF2B5EF4-FFF2-40B4-BE49-F238E27FC236}">
-                <a16:creationId xmlns:a16="http://schemas.microsoft.com/office/drawing/2014/main" id="{F8FE28E3-8054-4979-9837-768613FA802B}"/>
+                <a16:creationId xmlns:a16="http://schemas.microsoft.com/office/drawing/2014/main" id="{5DD74546-E530-435C-B94C-FC2A8EB8CE30}"/>
               </a:ext>
             </a:extLst>
           </p:cNvPr>
@@ -3857,7 +3857,7 @@
     </p:spTree>
     <p:extLst>
       <p:ext uri="{BB962C8B-B14F-4D97-AF65-F5344CB8AC3E}">
-        <p14:creationId xmlns:p14="http://schemas.microsoft.com/office/powerpoint/2010/main" val="944318917"/>
+        <p14:creationId xmlns:p14="http://schemas.microsoft.com/office/powerpoint/2010/main" val="1920393124"/>
       </p:ext>
     </p:extLst>
   </p:cSld>
@@ -3881,7 +3881,7 @@
           <p:cNvPr id="1" name="slide-stage">
             <a:extLst xmlns:a="http://schemas.openxmlformats.org/drawingml/2006/main">
               <a:ext uri="{FF2B5EF4-FFF2-40B4-BE49-F238E27FC236}">
-                <a16:creationId xmlns:a16="http://schemas.microsoft.com/office/drawing/2014/main" id="{8B903E5F-41BD-4265-91D6-870AEFC9663D}"/>
+                <a16:creationId xmlns:a16="http://schemas.microsoft.com/office/drawing/2014/main" id="{267A9AF9-6159-47EF-83F4-FF8FAAFB1ECE}"/>
               </a:ext>
             </a:extLst>
           </p:cNvPr>
@@ -3908,7 +3908,7 @@
           <p:cNvPr id="2" name="eyebrow">
             <a:extLst xmlns:a="http://schemas.openxmlformats.org/drawingml/2006/main">
               <a:ext uri="{FF2B5EF4-FFF2-40B4-BE49-F238E27FC236}">
-                <a16:creationId xmlns:a16="http://schemas.microsoft.com/office/drawing/2014/main" id="{514207E0-25A3-4417-90DE-94DF0A943BE5}"/>
+                <a16:creationId xmlns:a16="http://schemas.microsoft.com/office/drawing/2014/main" id="{C0C16961-FAAE-46BB-AFFC-9AC4A0747681}"/>
               </a:ext>
             </a:extLst>
           </p:cNvPr>
@@ -3953,7 +3953,7 @@
           <p:cNvPr id="3" name="slide-title">
             <a:extLst xmlns:a="http://schemas.openxmlformats.org/drawingml/2006/main">
               <a:ext uri="{FF2B5EF4-FFF2-40B4-BE49-F238E27FC236}">
-                <a16:creationId xmlns:a16="http://schemas.microsoft.com/office/drawing/2014/main" id="{673030C9-1BFA-420A-985A-8B1F7AFB1060}"/>
+                <a16:creationId xmlns:a16="http://schemas.microsoft.com/office/drawing/2014/main" id="{E7458030-933D-403D-8FFC-772F0B66CCE7}"/>
               </a:ext>
             </a:extLst>
           </p:cNvPr>
@@ -3998,7 +3998,7 @@
           <p:cNvPr id="4" name="slide-subtitle">
             <a:extLst xmlns:a="http://schemas.openxmlformats.org/drawingml/2006/main">
               <a:ext uri="{FF2B5EF4-FFF2-40B4-BE49-F238E27FC236}">
-                <a16:creationId xmlns:a16="http://schemas.microsoft.com/office/drawing/2014/main" id="{65C21849-25EA-4871-95B5-D18FFA38C434}"/>
+                <a16:creationId xmlns:a16="http://schemas.microsoft.com/office/drawing/2014/main" id="{87CCF845-EE72-4A4C-86B0-6A43A732FCA9}"/>
               </a:ext>
             </a:extLst>
           </p:cNvPr>
@@ -4043,7 +4043,7 @@
           <p:cNvPr id="5" name="">
             <a:extLst xmlns:a="http://schemas.openxmlformats.org/drawingml/2006/main">
               <a:ext uri="{FF2B5EF4-FFF2-40B4-BE49-F238E27FC236}">
-                <a16:creationId xmlns:a16="http://schemas.microsoft.com/office/drawing/2014/main" id="{6FB78A44-EC15-470C-B8A3-3C18CD1B123E}"/>
+                <a16:creationId xmlns:a16="http://schemas.microsoft.com/office/drawing/2014/main" id="{04D8E547-0A25-4354-84B2-782E7DA37E99}"/>
               </a:ext>
             </a:extLst>
           </p:cNvPr>
@@ -4088,7 +4088,7 @@
           <p:cNvPr id="6" name="">
             <a:extLst xmlns:a="http://schemas.openxmlformats.org/drawingml/2006/main">
               <a:ext uri="{FF2B5EF4-FFF2-40B4-BE49-F238E27FC236}">
-                <a16:creationId xmlns:a16="http://schemas.microsoft.com/office/drawing/2014/main" id="{2AFCEF1F-1006-491F-89FD-1EA091BDBAF2}"/>
+                <a16:creationId xmlns:a16="http://schemas.microsoft.com/office/drawing/2014/main" id="{19258CBD-540C-4E86-AF62-23D5D459C549}"/>
               </a:ext>
             </a:extLst>
           </p:cNvPr>
@@ -4133,7 +4133,7 @@
           <p:cNvPr id="7" name="">
             <a:extLst xmlns:a="http://schemas.openxmlformats.org/drawingml/2006/main">
               <a:ext uri="{FF2B5EF4-FFF2-40B4-BE49-F238E27FC236}">
-                <a16:creationId xmlns:a16="http://schemas.microsoft.com/office/drawing/2014/main" id="{CEF0E492-42AF-4082-966F-0788D5DF5783}"/>
+                <a16:creationId xmlns:a16="http://schemas.microsoft.com/office/drawing/2014/main" id="{EFDA87D4-2B3C-475C-B6D6-FA7F4269A6E8}"/>
               </a:ext>
             </a:extLst>
           </p:cNvPr>
@@ -4178,7 +4178,7 @@
           <p:cNvPr id="8" name="">
             <a:extLst xmlns:a="http://schemas.openxmlformats.org/drawingml/2006/main">
               <a:ext uri="{FF2B5EF4-FFF2-40B4-BE49-F238E27FC236}">
-                <a16:creationId xmlns:a16="http://schemas.microsoft.com/office/drawing/2014/main" id="{A0199D2F-3319-4670-AD49-15F60CB2AB82}"/>
+                <a16:creationId xmlns:a16="http://schemas.microsoft.com/office/drawing/2014/main" id="{7086AFE7-DA0A-48A7-ACA9-A95F0F926299}"/>
               </a:ext>
             </a:extLst>
           </p:cNvPr>
@@ -4223,7 +4223,7 @@
           <p:cNvPr id="9" name="">
             <a:extLst xmlns:a="http://schemas.openxmlformats.org/drawingml/2006/main">
               <a:ext uri="{FF2B5EF4-FFF2-40B4-BE49-F238E27FC236}">
-                <a16:creationId xmlns:a16="http://schemas.microsoft.com/office/drawing/2014/main" id="{E77F9F2D-2CF8-41D2-881C-BF272AF14F5D}"/>
+                <a16:creationId xmlns:a16="http://schemas.microsoft.com/office/drawing/2014/main" id="{44B31B6F-776F-405C-AB57-66CDE9859FF6}"/>
               </a:ext>
             </a:extLst>
           </p:cNvPr>
@@ -4268,7 +4268,7 @@
           <p:cNvPr id="10" name="">
             <a:extLst xmlns:a="http://schemas.openxmlformats.org/drawingml/2006/main">
               <a:ext uri="{FF2B5EF4-FFF2-40B4-BE49-F238E27FC236}">
-                <a16:creationId xmlns:a16="http://schemas.microsoft.com/office/drawing/2014/main" id="{691C4CAF-BCF4-43BB-8538-AD0F20D05874}"/>
+                <a16:creationId xmlns:a16="http://schemas.microsoft.com/office/drawing/2014/main" id="{D8E0691E-582D-4EF6-BA77-C11EF3523342}"/>
               </a:ext>
             </a:extLst>
           </p:cNvPr>
@@ -4313,7 +4313,7 @@
           <p:cNvPr id="11" name="">
             <a:extLst xmlns:a="http://schemas.openxmlformats.org/drawingml/2006/main">
               <a:ext uri="{FF2B5EF4-FFF2-40B4-BE49-F238E27FC236}">
-                <a16:creationId xmlns:a16="http://schemas.microsoft.com/office/drawing/2014/main" id="{36C8FEFE-FC6A-45DE-AD3D-C539314AF534}"/>
+                <a16:creationId xmlns:a16="http://schemas.microsoft.com/office/drawing/2014/main" id="{579F6DBD-2445-43EF-B102-99184BC1997F}"/>
               </a:ext>
             </a:extLst>
           </p:cNvPr>
@@ -4358,7 +4358,7 @@
           <p:cNvPr id="12" name="">
             <a:extLst xmlns:a="http://schemas.openxmlformats.org/drawingml/2006/main">
               <a:ext uri="{FF2B5EF4-FFF2-40B4-BE49-F238E27FC236}">
-                <a16:creationId xmlns:a16="http://schemas.microsoft.com/office/drawing/2014/main" id="{5D658494-F8BE-4A3D-A567-19D341E5B4DC}"/>
+                <a16:creationId xmlns:a16="http://schemas.microsoft.com/office/drawing/2014/main" id="{448F3E38-EB48-4971-824B-3BF1386A5A2A}"/>
               </a:ext>
             </a:extLst>
           </p:cNvPr>
@@ -4403,7 +4403,7 @@
           <p:cNvPr id="13" name="">
             <a:extLst xmlns:a="http://schemas.openxmlformats.org/drawingml/2006/main">
               <a:ext uri="{FF2B5EF4-FFF2-40B4-BE49-F238E27FC236}">
-                <a16:creationId xmlns:a16="http://schemas.microsoft.com/office/drawing/2014/main" id="{EB57CEA1-8618-4802-8044-3E2EE5C94A13}"/>
+                <a16:creationId xmlns:a16="http://schemas.microsoft.com/office/drawing/2014/main" id="{9DE1E2DA-D663-412E-B4FF-EB9CFA51DD0D}"/>
               </a:ext>
             </a:extLst>
           </p:cNvPr>
@@ -4448,7 +4448,7 @@
           <p:cNvPr id="14" name="footer-left">
             <a:extLst xmlns:a="http://schemas.openxmlformats.org/drawingml/2006/main">
               <a:ext uri="{FF2B5EF4-FFF2-40B4-BE49-F238E27FC236}">
-                <a16:creationId xmlns:a16="http://schemas.microsoft.com/office/drawing/2014/main" id="{A4936FDF-9059-455F-A687-4601D5678AAA}"/>
+                <a16:creationId xmlns:a16="http://schemas.microsoft.com/office/drawing/2014/main" id="{F28149B7-8145-4143-A452-D72E15E86F28}"/>
               </a:ext>
             </a:extLst>
           </p:cNvPr>
@@ -4493,7 +4493,7 @@
           <p:cNvPr id="15" name="footer-right">
             <a:extLst xmlns:a="http://schemas.openxmlformats.org/drawingml/2006/main">
               <a:ext uri="{FF2B5EF4-FFF2-40B4-BE49-F238E27FC236}">
-                <a16:creationId xmlns:a16="http://schemas.microsoft.com/office/drawing/2014/main" id="{CFBE17FE-DC38-4BE2-AA7C-B73355D34D55}"/>
+                <a16:creationId xmlns:a16="http://schemas.microsoft.com/office/drawing/2014/main" id="{1295F417-A91B-4238-9050-E733F3CA427A}"/>
               </a:ext>
             </a:extLst>
           </p:cNvPr>
@@ -4536,7 +4536,7 @@
     </p:spTree>
     <p:extLst>
       <p:ext uri="{BB962C8B-B14F-4D97-AF65-F5344CB8AC3E}">
-        <p14:creationId xmlns:p14="http://schemas.microsoft.com/office/powerpoint/2010/main" val="280772076"/>
+        <p14:creationId xmlns:p14="http://schemas.microsoft.com/office/powerpoint/2010/main" val="1496486049"/>
       </p:ext>
     </p:extLst>
   </p:cSld>
@@ -4560,7 +4560,7 @@
           <p:cNvPr id="1" name="slide-stage">
             <a:extLst xmlns:a="http://schemas.openxmlformats.org/drawingml/2006/main">
               <a:ext uri="{FF2B5EF4-FFF2-40B4-BE49-F238E27FC236}">
-                <a16:creationId xmlns:a16="http://schemas.microsoft.com/office/drawing/2014/main" id="{888CF8A1-3576-414E-B2E9-B7E052493377}"/>
+                <a16:creationId xmlns:a16="http://schemas.microsoft.com/office/drawing/2014/main" id="{678B48CB-A6C3-47F4-A191-2F6389B72A09}"/>
               </a:ext>
             </a:extLst>
           </p:cNvPr>
@@ -4587,7 +4587,7 @@
           <p:cNvPr id="2" name="eyebrow">
             <a:extLst xmlns:a="http://schemas.openxmlformats.org/drawingml/2006/main">
               <a:ext uri="{FF2B5EF4-FFF2-40B4-BE49-F238E27FC236}">
-                <a16:creationId xmlns:a16="http://schemas.microsoft.com/office/drawing/2014/main" id="{ACA87A8E-2C6B-401F-89F9-1151344EFF8F}"/>
+                <a16:creationId xmlns:a16="http://schemas.microsoft.com/office/drawing/2014/main" id="{679DE1AD-939D-44DD-BDE2-F3EAC9761B63}"/>
               </a:ext>
             </a:extLst>
           </p:cNvPr>
@@ -4632,7 +4632,7 @@
           <p:cNvPr id="3" name="slide-title">
             <a:extLst xmlns:a="http://schemas.openxmlformats.org/drawingml/2006/main">
               <a:ext uri="{FF2B5EF4-FFF2-40B4-BE49-F238E27FC236}">
-                <a16:creationId xmlns:a16="http://schemas.microsoft.com/office/drawing/2014/main" id="{1C6AA8DB-D29F-4336-8CDC-59E9FD868A1E}"/>
+                <a16:creationId xmlns:a16="http://schemas.microsoft.com/office/drawing/2014/main" id="{61B85F24-0361-4739-B4AF-CE886E5664BE}"/>
               </a:ext>
             </a:extLst>
           </p:cNvPr>
@@ -4677,7 +4677,7 @@
           <p:cNvPr id="4" name="slide-subtitle">
             <a:extLst xmlns:a="http://schemas.openxmlformats.org/drawingml/2006/main">
               <a:ext uri="{FF2B5EF4-FFF2-40B4-BE49-F238E27FC236}">
-                <a16:creationId xmlns:a16="http://schemas.microsoft.com/office/drawing/2014/main" id="{AF455C71-40F4-4A82-AF9F-CF54C146E27F}"/>
+                <a16:creationId xmlns:a16="http://schemas.microsoft.com/office/drawing/2014/main" id="{87B40A5D-F25A-421B-9542-F2B91B4FB595}"/>
               </a:ext>
             </a:extLst>
           </p:cNvPr>
@@ -4722,7 +4722,7 @@
           <p:cNvPr id="5" name="">
             <a:extLst xmlns:a="http://schemas.openxmlformats.org/drawingml/2006/main">
               <a:ext uri="{FF2B5EF4-FFF2-40B4-BE49-F238E27FC236}">
-                <a16:creationId xmlns:a16="http://schemas.microsoft.com/office/drawing/2014/main" id="{1F5FE08F-402C-4A49-A7D2-456F401070E2}"/>
+                <a16:creationId xmlns:a16="http://schemas.microsoft.com/office/drawing/2014/main" id="{8133D80A-40D2-4DAE-8269-81499DC72296}"/>
               </a:ext>
             </a:extLst>
           </p:cNvPr>
@@ -4755,7 +4755,7 @@
           <p:cNvPr id="6" name="">
             <a:extLst xmlns:a="http://schemas.openxmlformats.org/drawingml/2006/main">
               <a:ext uri="{FF2B5EF4-FFF2-40B4-BE49-F238E27FC236}">
-                <a16:creationId xmlns:a16="http://schemas.microsoft.com/office/drawing/2014/main" id="{E8DDBA7C-EF87-4D90-B1C6-2D69BC03CFFA}"/>
+                <a16:creationId xmlns:a16="http://schemas.microsoft.com/office/drawing/2014/main" id="{888B7FF9-B73D-42B7-81B5-62508D4FF512}"/>
               </a:ext>
             </a:extLst>
           </p:cNvPr>
@@ -4800,7 +4800,7 @@
           <p:cNvPr id="7" name="">
             <a:extLst xmlns:a="http://schemas.openxmlformats.org/drawingml/2006/main">
               <a:ext uri="{FF2B5EF4-FFF2-40B4-BE49-F238E27FC236}">
-                <a16:creationId xmlns:a16="http://schemas.microsoft.com/office/drawing/2014/main" id="{0198DC04-8FEC-4D17-A9BD-E195B866A3CD}"/>
+                <a16:creationId xmlns:a16="http://schemas.microsoft.com/office/drawing/2014/main" id="{8B526378-DE60-45A8-88A8-B6C88DE0EFA5}"/>
               </a:ext>
             </a:extLst>
           </p:cNvPr>
@@ -4845,7 +4845,7 @@
           <p:cNvPr id="8" name="">
             <a:extLst xmlns:a="http://schemas.openxmlformats.org/drawingml/2006/main">
               <a:ext uri="{FF2B5EF4-FFF2-40B4-BE49-F238E27FC236}">
-                <a16:creationId xmlns:a16="http://schemas.microsoft.com/office/drawing/2014/main" id="{100D2EEF-706D-4E9E-8A28-54E2F11F7C0E}"/>
+                <a16:creationId xmlns:a16="http://schemas.microsoft.com/office/drawing/2014/main" id="{2C873D23-4848-4EB6-BA97-F8EF51B1ACCF}"/>
               </a:ext>
             </a:extLst>
           </p:cNvPr>
@@ -4878,7 +4878,7 @@
           <p:cNvPr id="9" name="">
             <a:extLst xmlns:a="http://schemas.openxmlformats.org/drawingml/2006/main">
               <a:ext uri="{FF2B5EF4-FFF2-40B4-BE49-F238E27FC236}">
-                <a16:creationId xmlns:a16="http://schemas.microsoft.com/office/drawing/2014/main" id="{601412C7-7579-4647-BC18-08548BCD22B4}"/>
+                <a16:creationId xmlns:a16="http://schemas.microsoft.com/office/drawing/2014/main" id="{E302AE54-FB01-4E62-BDFA-CC513B9DB462}"/>
               </a:ext>
             </a:extLst>
           </p:cNvPr>
@@ -4923,7 +4923,7 @@
           <p:cNvPr id="10" name="">
             <a:extLst xmlns:a="http://schemas.openxmlformats.org/drawingml/2006/main">
               <a:ext uri="{FF2B5EF4-FFF2-40B4-BE49-F238E27FC236}">
-                <a16:creationId xmlns:a16="http://schemas.microsoft.com/office/drawing/2014/main" id="{287EC1AB-9E32-4964-B916-D175E3A756BA}"/>
+                <a16:creationId xmlns:a16="http://schemas.microsoft.com/office/drawing/2014/main" id="{A3C23404-5366-40BC-BA61-3F6689D35F2C}"/>
               </a:ext>
             </a:extLst>
           </p:cNvPr>
@@ -4968,7 +4968,7 @@
           <p:cNvPr id="11" name="">
             <a:extLst xmlns:a="http://schemas.openxmlformats.org/drawingml/2006/main">
               <a:ext uri="{FF2B5EF4-FFF2-40B4-BE49-F238E27FC236}">
-                <a16:creationId xmlns:a16="http://schemas.microsoft.com/office/drawing/2014/main" id="{2BD22580-794E-4CF0-A945-DA608547B719}"/>
+                <a16:creationId xmlns:a16="http://schemas.microsoft.com/office/drawing/2014/main" id="{1D006D34-A145-4247-8960-AE566C2F4115}"/>
               </a:ext>
             </a:extLst>
           </p:cNvPr>
@@ -5001,7 +5001,7 @@
           <p:cNvPr id="12" name="">
             <a:extLst xmlns:a="http://schemas.openxmlformats.org/drawingml/2006/main">
               <a:ext uri="{FF2B5EF4-FFF2-40B4-BE49-F238E27FC236}">
-                <a16:creationId xmlns:a16="http://schemas.microsoft.com/office/drawing/2014/main" id="{AF443FB9-1C3D-480B-9A06-E6BAF8AD8F06}"/>
+                <a16:creationId xmlns:a16="http://schemas.microsoft.com/office/drawing/2014/main" id="{F5D595E7-D075-4A13-A465-5A1ED8E3481E}"/>
               </a:ext>
             </a:extLst>
           </p:cNvPr>
@@ -5046,7 +5046,7 @@
           <p:cNvPr id="13" name="">
             <a:extLst xmlns:a="http://schemas.openxmlformats.org/drawingml/2006/main">
               <a:ext uri="{FF2B5EF4-FFF2-40B4-BE49-F238E27FC236}">
-                <a16:creationId xmlns:a16="http://schemas.microsoft.com/office/drawing/2014/main" id="{6EDB2DBF-BD81-4F98-8A99-2998785770E4}"/>
+                <a16:creationId xmlns:a16="http://schemas.microsoft.com/office/drawing/2014/main" id="{D084A9A7-89ED-492A-93E3-976F91B6B864}"/>
               </a:ext>
             </a:extLst>
           </p:cNvPr>
@@ -5091,7 +5091,7 @@
           <p:cNvPr id="14" name="">
             <a:extLst xmlns:a="http://schemas.openxmlformats.org/drawingml/2006/main">
               <a:ext uri="{FF2B5EF4-FFF2-40B4-BE49-F238E27FC236}">
-                <a16:creationId xmlns:a16="http://schemas.microsoft.com/office/drawing/2014/main" id="{3EFBA3F9-79CB-417A-AE9A-7BED22328F46}"/>
+                <a16:creationId xmlns:a16="http://schemas.microsoft.com/office/drawing/2014/main" id="{D45F157B-DB56-4102-A322-72AE44CEFF7A}"/>
               </a:ext>
             </a:extLst>
           </p:cNvPr>
@@ -5124,7 +5124,7 @@
           <p:cNvPr id="15" name="">
             <a:extLst xmlns:a="http://schemas.openxmlformats.org/drawingml/2006/main">
               <a:ext uri="{FF2B5EF4-FFF2-40B4-BE49-F238E27FC236}">
-                <a16:creationId xmlns:a16="http://schemas.microsoft.com/office/drawing/2014/main" id="{6FDD896B-9F7C-4010-A3FF-160757EA5879}"/>
+                <a16:creationId xmlns:a16="http://schemas.microsoft.com/office/drawing/2014/main" id="{D3264823-D71C-4942-8027-CDBD8A1DEA11}"/>
               </a:ext>
             </a:extLst>
           </p:cNvPr>
@@ -5169,7 +5169,7 @@
           <p:cNvPr id="16" name="">
             <a:extLst xmlns:a="http://schemas.openxmlformats.org/drawingml/2006/main">
               <a:ext uri="{FF2B5EF4-FFF2-40B4-BE49-F238E27FC236}">
-                <a16:creationId xmlns:a16="http://schemas.microsoft.com/office/drawing/2014/main" id="{1132B273-C1A8-43ED-87C8-93D97B25B335}"/>
+                <a16:creationId xmlns:a16="http://schemas.microsoft.com/office/drawing/2014/main" id="{1D4A549E-D095-4272-909E-0BEFF70721B8}"/>
               </a:ext>
             </a:extLst>
           </p:cNvPr>
@@ -5214,7 +5214,7 @@
           <p:cNvPr id="17" name="">
             <a:extLst xmlns:a="http://schemas.openxmlformats.org/drawingml/2006/main">
               <a:ext uri="{FF2B5EF4-FFF2-40B4-BE49-F238E27FC236}">
-                <a16:creationId xmlns:a16="http://schemas.microsoft.com/office/drawing/2014/main" id="{2868B56A-4E17-4301-97FD-3B23A086EC8A}"/>
+                <a16:creationId xmlns:a16="http://schemas.microsoft.com/office/drawing/2014/main" id="{E3012D4E-E37E-4319-B098-4DDB2AA52D73}"/>
               </a:ext>
             </a:extLst>
           </p:cNvPr>
@@ -5247,7 +5247,7 @@
           <p:cNvPr id="18" name="">
             <a:extLst xmlns:a="http://schemas.openxmlformats.org/drawingml/2006/main">
               <a:ext uri="{FF2B5EF4-FFF2-40B4-BE49-F238E27FC236}">
-                <a16:creationId xmlns:a16="http://schemas.microsoft.com/office/drawing/2014/main" id="{0EAFF826-0A0B-4B49-B9F7-742368A2E28B}"/>
+                <a16:creationId xmlns:a16="http://schemas.microsoft.com/office/drawing/2014/main" id="{E93055EF-479D-4CFE-B76B-F9C6BF64F9ED}"/>
               </a:ext>
             </a:extLst>
           </p:cNvPr>
@@ -5292,7 +5292,7 @@
           <p:cNvPr id="19" name="">
             <a:extLst xmlns:a="http://schemas.openxmlformats.org/drawingml/2006/main">
               <a:ext uri="{FF2B5EF4-FFF2-40B4-BE49-F238E27FC236}">
-                <a16:creationId xmlns:a16="http://schemas.microsoft.com/office/drawing/2014/main" id="{36AF0D1A-1DBC-4523-B54E-41EE96D81F38}"/>
+                <a16:creationId xmlns:a16="http://schemas.microsoft.com/office/drawing/2014/main" id="{D9ACCFA2-0B59-4080-B8DB-2518764049B0}"/>
               </a:ext>
             </a:extLst>
           </p:cNvPr>
@@ -5337,7 +5337,7 @@
           <p:cNvPr id="20" name="">
             <a:extLst xmlns:a="http://schemas.openxmlformats.org/drawingml/2006/main">
               <a:ext uri="{FF2B5EF4-FFF2-40B4-BE49-F238E27FC236}">
-                <a16:creationId xmlns:a16="http://schemas.microsoft.com/office/drawing/2014/main" id="{25686D14-B8BB-41E6-8F03-0C442E77544C}"/>
+                <a16:creationId xmlns:a16="http://schemas.microsoft.com/office/drawing/2014/main" id="{708A1FF8-464B-4880-AF1A-79C6A59F951C}"/>
               </a:ext>
             </a:extLst>
           </p:cNvPr>
@@ -5370,7 +5370,7 @@
           <p:cNvPr id="21" name="">
             <a:extLst xmlns:a="http://schemas.openxmlformats.org/drawingml/2006/main">
               <a:ext uri="{FF2B5EF4-FFF2-40B4-BE49-F238E27FC236}">
-                <a16:creationId xmlns:a16="http://schemas.microsoft.com/office/drawing/2014/main" id="{18DD584F-C51E-4D7A-951E-06FEB944EEA7}"/>
+                <a16:creationId xmlns:a16="http://schemas.microsoft.com/office/drawing/2014/main" id="{BC3127D7-FE62-4360-AACB-75BD017C832B}"/>
               </a:ext>
             </a:extLst>
           </p:cNvPr>
@@ -5415,7 +5415,7 @@
           <p:cNvPr id="22" name="">
             <a:extLst xmlns:a="http://schemas.openxmlformats.org/drawingml/2006/main">
               <a:ext uri="{FF2B5EF4-FFF2-40B4-BE49-F238E27FC236}">
-                <a16:creationId xmlns:a16="http://schemas.microsoft.com/office/drawing/2014/main" id="{E942282F-CF85-455E-88D3-8EA965C58C7C}"/>
+                <a16:creationId xmlns:a16="http://schemas.microsoft.com/office/drawing/2014/main" id="{7DDDC478-E25D-4B4F-97F7-ED8084917C2A}"/>
               </a:ext>
             </a:extLst>
           </p:cNvPr>
@@ -5460,7 +5460,7 @@
           <p:cNvPr id="23" name="footer-left">
             <a:extLst xmlns:a="http://schemas.openxmlformats.org/drawingml/2006/main">
               <a:ext uri="{FF2B5EF4-FFF2-40B4-BE49-F238E27FC236}">
-                <a16:creationId xmlns:a16="http://schemas.microsoft.com/office/drawing/2014/main" id="{99055695-C80B-41C3-B9F5-29133F0A9F29}"/>
+                <a16:creationId xmlns:a16="http://schemas.microsoft.com/office/drawing/2014/main" id="{DE34F14E-4049-4FF4-B977-143BDA340685}"/>
               </a:ext>
             </a:extLst>
           </p:cNvPr>
@@ -5505,7 +5505,7 @@
           <p:cNvPr id="24" name="footer-right">
             <a:extLst xmlns:a="http://schemas.openxmlformats.org/drawingml/2006/main">
               <a:ext uri="{FF2B5EF4-FFF2-40B4-BE49-F238E27FC236}">
-                <a16:creationId xmlns:a16="http://schemas.microsoft.com/office/drawing/2014/main" id="{0AE8E1CF-CD0F-4FD7-9E5A-26FDE8AD43DF}"/>
+                <a16:creationId xmlns:a16="http://schemas.microsoft.com/office/drawing/2014/main" id="{743AB6EB-E8B3-4819-9273-8E4D9B084BE6}"/>
               </a:ext>
             </a:extLst>
           </p:cNvPr>
@@ -5548,7 +5548,7 @@
     </p:spTree>
     <p:extLst>
       <p:ext uri="{BB962C8B-B14F-4D97-AF65-F5344CB8AC3E}">
-        <p14:creationId xmlns:p14="http://schemas.microsoft.com/office/powerpoint/2010/main" val="1247643844"/>
+        <p14:creationId xmlns:p14="http://schemas.microsoft.com/office/powerpoint/2010/main" val="1761691523"/>
       </p:ext>
     </p:extLst>
   </p:cSld>
@@ -5572,7 +5572,7 @@
           <p:cNvPr id="1" name="slide-stage">
             <a:extLst xmlns:a="http://schemas.openxmlformats.org/drawingml/2006/main">
               <a:ext uri="{FF2B5EF4-FFF2-40B4-BE49-F238E27FC236}">
-                <a16:creationId xmlns:a16="http://schemas.microsoft.com/office/drawing/2014/main" id="{9EEAF2EC-652E-44A6-949D-E41558012BA9}"/>
+                <a16:creationId xmlns:a16="http://schemas.microsoft.com/office/drawing/2014/main" id="{9187CCE6-7CAC-4A34-9CF2-CAF3ABB44FEE}"/>
               </a:ext>
             </a:extLst>
           </p:cNvPr>
@@ -5599,7 +5599,7 @@
           <p:cNvPr id="2" name="eyebrow">
             <a:extLst xmlns:a="http://schemas.openxmlformats.org/drawingml/2006/main">
               <a:ext uri="{FF2B5EF4-FFF2-40B4-BE49-F238E27FC236}">
-                <a16:creationId xmlns:a16="http://schemas.microsoft.com/office/drawing/2014/main" id="{32866784-AB1F-4FCE-B120-F95E2D6D00B6}"/>
+                <a16:creationId xmlns:a16="http://schemas.microsoft.com/office/drawing/2014/main" id="{30F77B53-3E47-4E8A-B82E-A4C6DB7E127A}"/>
               </a:ext>
             </a:extLst>
           </p:cNvPr>
@@ -5644,7 +5644,7 @@
           <p:cNvPr id="3" name="slide-title">
             <a:extLst xmlns:a="http://schemas.openxmlformats.org/drawingml/2006/main">
               <a:ext uri="{FF2B5EF4-FFF2-40B4-BE49-F238E27FC236}">
-                <a16:creationId xmlns:a16="http://schemas.microsoft.com/office/drawing/2014/main" id="{585EE8E8-DEF2-4328-BF9A-D291F2B5B397}"/>
+                <a16:creationId xmlns:a16="http://schemas.microsoft.com/office/drawing/2014/main" id="{444E50EA-6526-4704-8745-C892006B2CD7}"/>
               </a:ext>
             </a:extLst>
           </p:cNvPr>
@@ -5689,7 +5689,7 @@
           <p:cNvPr id="4" name="slide-subtitle">
             <a:extLst xmlns:a="http://schemas.openxmlformats.org/drawingml/2006/main">
               <a:ext uri="{FF2B5EF4-FFF2-40B4-BE49-F238E27FC236}">
-                <a16:creationId xmlns:a16="http://schemas.microsoft.com/office/drawing/2014/main" id="{193366EF-FE3A-46DA-93F4-9266C731552D}"/>
+                <a16:creationId xmlns:a16="http://schemas.microsoft.com/office/drawing/2014/main" id="{2BD7C25C-77BD-43AC-8669-E52447A11F3D}"/>
               </a:ext>
             </a:extLst>
           </p:cNvPr>
@@ -5734,7 +5734,7 @@
           <p:cNvPr id="5" name="">
             <a:extLst xmlns:a="http://schemas.openxmlformats.org/drawingml/2006/main">
               <a:ext uri="{FF2B5EF4-FFF2-40B4-BE49-F238E27FC236}">
-                <a16:creationId xmlns:a16="http://schemas.microsoft.com/office/drawing/2014/main" id="{C9FE3003-AA52-42A3-8349-7CFA9B397136}"/>
+                <a16:creationId xmlns:a16="http://schemas.microsoft.com/office/drawing/2014/main" id="{8DB9E721-6A85-4713-B818-9BEE083133CB}"/>
               </a:ext>
             </a:extLst>
           </p:cNvPr>
@@ -5779,7 +5779,7 @@
           <p:cNvPr id="6" name="">
             <a:extLst xmlns:a="http://schemas.openxmlformats.org/drawingml/2006/main">
               <a:ext uri="{FF2B5EF4-FFF2-40B4-BE49-F238E27FC236}">
-                <a16:creationId xmlns:a16="http://schemas.microsoft.com/office/drawing/2014/main" id="{B1CC16D6-BCC4-407B-B10D-B7E6406BE29B}"/>
+                <a16:creationId xmlns:a16="http://schemas.microsoft.com/office/drawing/2014/main" id="{56757F39-A23C-4FDE-9476-B29990CD6C33}"/>
               </a:ext>
             </a:extLst>
           </p:cNvPr>
@@ -5824,7 +5824,7 @@
           <p:cNvPr id="7" name="">
             <a:extLst xmlns:a="http://schemas.openxmlformats.org/drawingml/2006/main">
               <a:ext uri="{FF2B5EF4-FFF2-40B4-BE49-F238E27FC236}">
-                <a16:creationId xmlns:a16="http://schemas.microsoft.com/office/drawing/2014/main" id="{455D0F89-8DA8-415B-B33F-E8DD06455E38}"/>
+                <a16:creationId xmlns:a16="http://schemas.microsoft.com/office/drawing/2014/main" id="{D3B98B7A-D886-412D-B065-0F5E9E8D7063}"/>
               </a:ext>
             </a:extLst>
           </p:cNvPr>
@@ -5869,7 +5869,7 @@
           <p:cNvPr id="8" name="">
             <a:extLst xmlns:a="http://schemas.openxmlformats.org/drawingml/2006/main">
               <a:ext uri="{FF2B5EF4-FFF2-40B4-BE49-F238E27FC236}">
-                <a16:creationId xmlns:a16="http://schemas.microsoft.com/office/drawing/2014/main" id="{93A60DA8-CC17-445F-9058-46A9CC73C6A9}"/>
+                <a16:creationId xmlns:a16="http://schemas.microsoft.com/office/drawing/2014/main" id="{E0B9072E-64E4-4C87-A34E-54E4FD8FB528}"/>
               </a:ext>
             </a:extLst>
           </p:cNvPr>
@@ -5914,7 +5914,7 @@
           <p:cNvPr id="9" name="">
             <a:extLst xmlns:a="http://schemas.openxmlformats.org/drawingml/2006/main">
               <a:ext uri="{FF2B5EF4-FFF2-40B4-BE49-F238E27FC236}">
-                <a16:creationId xmlns:a16="http://schemas.microsoft.com/office/drawing/2014/main" id="{209CD026-804A-4B06-94DF-DD26738D46F8}"/>
+                <a16:creationId xmlns:a16="http://schemas.microsoft.com/office/drawing/2014/main" id="{C638F9DE-51EA-48FE-A6D9-89E4E40EC3F3}"/>
               </a:ext>
             </a:extLst>
           </p:cNvPr>
@@ -5959,7 +5959,7 @@
           <p:cNvPr id="10" name="">
             <a:extLst xmlns:a="http://schemas.openxmlformats.org/drawingml/2006/main">
               <a:ext uri="{FF2B5EF4-FFF2-40B4-BE49-F238E27FC236}">
-                <a16:creationId xmlns:a16="http://schemas.microsoft.com/office/drawing/2014/main" id="{79E7E4BE-CD80-4759-BCA2-593CD09863AB}"/>
+                <a16:creationId xmlns:a16="http://schemas.microsoft.com/office/drawing/2014/main" id="{C2CE20B9-363A-4E3D-B184-4F5B64CD389F}"/>
               </a:ext>
             </a:extLst>
           </p:cNvPr>
@@ -6004,7 +6004,7 @@
           <p:cNvPr id="11" name="">
             <a:extLst xmlns:a="http://schemas.openxmlformats.org/drawingml/2006/main">
               <a:ext uri="{FF2B5EF4-FFF2-40B4-BE49-F238E27FC236}">
-                <a16:creationId xmlns:a16="http://schemas.microsoft.com/office/drawing/2014/main" id="{B9F6C136-91D6-410B-ACD7-AA7DF7DE1DDA}"/>
+                <a16:creationId xmlns:a16="http://schemas.microsoft.com/office/drawing/2014/main" id="{FC02184B-8CF3-4766-8232-21A60EAEFB52}"/>
               </a:ext>
             </a:extLst>
           </p:cNvPr>
@@ -6049,7 +6049,7 @@
           <p:cNvPr id="12" name="">
             <a:extLst xmlns:a="http://schemas.openxmlformats.org/drawingml/2006/main">
               <a:ext uri="{FF2B5EF4-FFF2-40B4-BE49-F238E27FC236}">
-                <a16:creationId xmlns:a16="http://schemas.microsoft.com/office/drawing/2014/main" id="{C2452DAA-2842-4995-AA4A-A7AAF35C94A6}"/>
+                <a16:creationId xmlns:a16="http://schemas.microsoft.com/office/drawing/2014/main" id="{D8EC2434-FCD0-4D8F-8460-2320BB53C664}"/>
               </a:ext>
             </a:extLst>
           </p:cNvPr>
@@ -6094,7 +6094,7 @@
           <p:cNvPr id="13" name="">
             <a:extLst xmlns:a="http://schemas.openxmlformats.org/drawingml/2006/main">
               <a:ext uri="{FF2B5EF4-FFF2-40B4-BE49-F238E27FC236}">
-                <a16:creationId xmlns:a16="http://schemas.microsoft.com/office/drawing/2014/main" id="{52B8782A-9C43-4252-9AC6-7E4A65248D89}"/>
+                <a16:creationId xmlns:a16="http://schemas.microsoft.com/office/drawing/2014/main" id="{829D999C-71A6-4DAC-B50B-707C2E1D2CEE}"/>
               </a:ext>
             </a:extLst>
           </p:cNvPr>
@@ -6139,7 +6139,7 @@
           <p:cNvPr id="14" name="">
             <a:extLst xmlns:a="http://schemas.openxmlformats.org/drawingml/2006/main">
               <a:ext uri="{FF2B5EF4-FFF2-40B4-BE49-F238E27FC236}">
-                <a16:creationId xmlns:a16="http://schemas.microsoft.com/office/drawing/2014/main" id="{A3A393A3-D8C4-4268-B47C-297161AA1620}"/>
+                <a16:creationId xmlns:a16="http://schemas.microsoft.com/office/drawing/2014/main" id="{ADF0ACD1-93BC-4B3E-ABDE-7EB3AEC9EC28}"/>
               </a:ext>
             </a:extLst>
           </p:cNvPr>
@@ -6184,7 +6184,7 @@
           <p:cNvPr id="15" name="footer-left">
             <a:extLst xmlns:a="http://schemas.openxmlformats.org/drawingml/2006/main">
               <a:ext uri="{FF2B5EF4-FFF2-40B4-BE49-F238E27FC236}">
-                <a16:creationId xmlns:a16="http://schemas.microsoft.com/office/drawing/2014/main" id="{9582808C-3EB1-45AB-8E82-B5D95AC7B00A}"/>
+                <a16:creationId xmlns:a16="http://schemas.microsoft.com/office/drawing/2014/main" id="{18496EAD-735A-42C8-B506-57A6A2F8D164}"/>
               </a:ext>
             </a:extLst>
           </p:cNvPr>
@@ -6229,7 +6229,7 @@
           <p:cNvPr id="16" name="footer-right">
             <a:extLst xmlns:a="http://schemas.openxmlformats.org/drawingml/2006/main">
               <a:ext uri="{FF2B5EF4-FFF2-40B4-BE49-F238E27FC236}">
-                <a16:creationId xmlns:a16="http://schemas.microsoft.com/office/drawing/2014/main" id="{A57C7F6D-E9DD-4913-9428-AE48CC45BC09}"/>
+                <a16:creationId xmlns:a16="http://schemas.microsoft.com/office/drawing/2014/main" id="{1C3C372E-1144-4FDD-B332-D2B8AF5609B7}"/>
               </a:ext>
             </a:extLst>
           </p:cNvPr>
@@ -6272,7 +6272,7 @@
     </p:spTree>
     <p:extLst>
       <p:ext uri="{BB962C8B-B14F-4D97-AF65-F5344CB8AC3E}">
-        <p14:creationId xmlns:p14="http://schemas.microsoft.com/office/powerpoint/2010/main" val="663607802"/>
+        <p14:creationId xmlns:p14="http://schemas.microsoft.com/office/powerpoint/2010/main" val="1381433028"/>
       </p:ext>
     </p:extLst>
   </p:cSld>
@@ -6296,7 +6296,7 @@
           <p:cNvPr id="1" name="slide-stage">
             <a:extLst xmlns:a="http://schemas.openxmlformats.org/drawingml/2006/main">
               <a:ext uri="{FF2B5EF4-FFF2-40B4-BE49-F238E27FC236}">
-                <a16:creationId xmlns:a16="http://schemas.microsoft.com/office/drawing/2014/main" id="{73DDF3F7-E61A-44BE-8797-73EA54CC3840}"/>
+                <a16:creationId xmlns:a16="http://schemas.microsoft.com/office/drawing/2014/main" id="{B402896F-6EF1-4541-B85B-ACC1788DFCC2}"/>
               </a:ext>
             </a:extLst>
           </p:cNvPr>
@@ -6323,7 +6323,7 @@
           <p:cNvPr id="2" name="eyebrow">
             <a:extLst xmlns:a="http://schemas.openxmlformats.org/drawingml/2006/main">
               <a:ext uri="{FF2B5EF4-FFF2-40B4-BE49-F238E27FC236}">
-                <a16:creationId xmlns:a16="http://schemas.microsoft.com/office/drawing/2014/main" id="{A2B8FC83-2CFF-407A-8AFD-2D06D8CAC2B9}"/>
+                <a16:creationId xmlns:a16="http://schemas.microsoft.com/office/drawing/2014/main" id="{A9FA68EA-F2DE-4392-B5A8-CED41DDA6961}"/>
               </a:ext>
             </a:extLst>
           </p:cNvPr>
@@ -6368,7 +6368,7 @@
           <p:cNvPr id="3" name="slide-title">
             <a:extLst xmlns:a="http://schemas.openxmlformats.org/drawingml/2006/main">
               <a:ext uri="{FF2B5EF4-FFF2-40B4-BE49-F238E27FC236}">
-                <a16:creationId xmlns:a16="http://schemas.microsoft.com/office/drawing/2014/main" id="{BEA4662D-0867-4D1A-A0FE-905C2DF55CE4}"/>
+                <a16:creationId xmlns:a16="http://schemas.microsoft.com/office/drawing/2014/main" id="{7F16C891-CCA9-4D94-9117-D547FABC035A}"/>
               </a:ext>
             </a:extLst>
           </p:cNvPr>
@@ -6413,7 +6413,7 @@
           <p:cNvPr id="4" name="slide-subtitle">
             <a:extLst xmlns:a="http://schemas.openxmlformats.org/drawingml/2006/main">
               <a:ext uri="{FF2B5EF4-FFF2-40B4-BE49-F238E27FC236}">
-                <a16:creationId xmlns:a16="http://schemas.microsoft.com/office/drawing/2014/main" id="{649788AB-5DA7-4456-A20B-AC8394A50826}"/>
+                <a16:creationId xmlns:a16="http://schemas.microsoft.com/office/drawing/2014/main" id="{A47C26EF-F2A8-46F6-9E9D-69D93BDBEC0B}"/>
               </a:ext>
             </a:extLst>
           </p:cNvPr>
@@ -6458,7 +6458,7 @@
           <p:cNvPr id="5" name="">
             <a:extLst xmlns:a="http://schemas.openxmlformats.org/drawingml/2006/main">
               <a:ext uri="{FF2B5EF4-FFF2-40B4-BE49-F238E27FC236}">
-                <a16:creationId xmlns:a16="http://schemas.microsoft.com/office/drawing/2014/main" id="{1D656FA9-5003-430E-BC80-F2FFBB2F9B8E}"/>
+                <a16:creationId xmlns:a16="http://schemas.microsoft.com/office/drawing/2014/main" id="{B40A948A-884F-406F-8B7D-08BDC1464A4E}"/>
               </a:ext>
             </a:extLst>
           </p:cNvPr>
@@ -6503,7 +6503,7 @@
           <p:cNvPr id="6" name="">
             <a:extLst xmlns:a="http://schemas.openxmlformats.org/drawingml/2006/main">
               <a:ext uri="{FF2B5EF4-FFF2-40B4-BE49-F238E27FC236}">
-                <a16:creationId xmlns:a16="http://schemas.microsoft.com/office/drawing/2014/main" id="{4FB9404B-006B-46EB-8FD0-02ABC5C3E6FF}"/>
+                <a16:creationId xmlns:a16="http://schemas.microsoft.com/office/drawing/2014/main" id="{7D5064B3-2E73-4573-8C07-80338E28BE77}"/>
               </a:ext>
             </a:extLst>
           </p:cNvPr>
@@ -6548,7 +6548,7 @@
           <p:cNvPr id="7" name="">
             <a:extLst xmlns:a="http://schemas.openxmlformats.org/drawingml/2006/main">
               <a:ext uri="{FF2B5EF4-FFF2-40B4-BE49-F238E27FC236}">
-                <a16:creationId xmlns:a16="http://schemas.microsoft.com/office/drawing/2014/main" id="{3AA35931-8E74-46BA-AB76-B18C41FE9293}"/>
+                <a16:creationId xmlns:a16="http://schemas.microsoft.com/office/drawing/2014/main" id="{468DAEA8-2BDB-4DE6-A720-7014C2F79B89}"/>
               </a:ext>
             </a:extLst>
           </p:cNvPr>
@@ -6593,7 +6593,7 @@
           <p:cNvPr id="8" name="">
             <a:extLst xmlns:a="http://schemas.openxmlformats.org/drawingml/2006/main">
               <a:ext uri="{FF2B5EF4-FFF2-40B4-BE49-F238E27FC236}">
-                <a16:creationId xmlns:a16="http://schemas.microsoft.com/office/drawing/2014/main" id="{6D973EC2-CABB-4AFE-A939-6740DCE72907}"/>
+                <a16:creationId xmlns:a16="http://schemas.microsoft.com/office/drawing/2014/main" id="{024E01B6-0608-4701-A90B-640CCC3FC01E}"/>
               </a:ext>
             </a:extLst>
           </p:cNvPr>
@@ -6638,7 +6638,7 @@
           <p:cNvPr id="9" name="">
             <a:extLst xmlns:a="http://schemas.openxmlformats.org/drawingml/2006/main">
               <a:ext uri="{FF2B5EF4-FFF2-40B4-BE49-F238E27FC236}">
-                <a16:creationId xmlns:a16="http://schemas.microsoft.com/office/drawing/2014/main" id="{14311911-C60A-4BA1-AC24-ED1A96BD081D}"/>
+                <a16:creationId xmlns:a16="http://schemas.microsoft.com/office/drawing/2014/main" id="{0314BD16-880C-4F7A-92F1-D44319C77C93}"/>
               </a:ext>
             </a:extLst>
           </p:cNvPr>
@@ -6683,7 +6683,7 @@
           <p:cNvPr id="10" name="">
             <a:extLst xmlns:a="http://schemas.openxmlformats.org/drawingml/2006/main">
               <a:ext uri="{FF2B5EF4-FFF2-40B4-BE49-F238E27FC236}">
-                <a16:creationId xmlns:a16="http://schemas.microsoft.com/office/drawing/2014/main" id="{7A8ACA64-4C30-41F8-9460-F3A0FF518496}"/>
+                <a16:creationId xmlns:a16="http://schemas.microsoft.com/office/drawing/2014/main" id="{99F36015-824B-4408-B0BC-457C82AA5727}"/>
               </a:ext>
             </a:extLst>
           </p:cNvPr>
@@ -6728,7 +6728,7 @@
           <p:cNvPr id="11" name="">
             <a:extLst xmlns:a="http://schemas.openxmlformats.org/drawingml/2006/main">
               <a:ext uri="{FF2B5EF4-FFF2-40B4-BE49-F238E27FC236}">
-                <a16:creationId xmlns:a16="http://schemas.microsoft.com/office/drawing/2014/main" id="{AA6E27A5-5E54-4427-8A89-361BDA81844A}"/>
+                <a16:creationId xmlns:a16="http://schemas.microsoft.com/office/drawing/2014/main" id="{2ECBFABF-5BDD-458B-8150-898090D2D297}"/>
               </a:ext>
             </a:extLst>
           </p:cNvPr>
@@ -6773,7 +6773,7 @@
           <p:cNvPr id="12" name="">
             <a:extLst xmlns:a="http://schemas.openxmlformats.org/drawingml/2006/main">
               <a:ext uri="{FF2B5EF4-FFF2-40B4-BE49-F238E27FC236}">
-                <a16:creationId xmlns:a16="http://schemas.microsoft.com/office/drawing/2014/main" id="{AD300A34-8747-4EE0-A006-7BA321B49848}"/>
+                <a16:creationId xmlns:a16="http://schemas.microsoft.com/office/drawing/2014/main" id="{52500DFE-B595-4E40-BCAC-5C26FF4C9BBC}"/>
               </a:ext>
             </a:extLst>
           </p:cNvPr>
@@ -6818,7 +6818,7 @@
           <p:cNvPr id="13" name="">
             <a:extLst xmlns:a="http://schemas.openxmlformats.org/drawingml/2006/main">
               <a:ext uri="{FF2B5EF4-FFF2-40B4-BE49-F238E27FC236}">
-                <a16:creationId xmlns:a16="http://schemas.microsoft.com/office/drawing/2014/main" id="{2634FABB-EFC6-4965-BE73-5226775A1205}"/>
+                <a16:creationId xmlns:a16="http://schemas.microsoft.com/office/drawing/2014/main" id="{977FC2C2-2495-4C83-8B77-CBF76390FEEF}"/>
               </a:ext>
             </a:extLst>
           </p:cNvPr>
@@ -6863,7 +6863,7 @@
           <p:cNvPr id="14" name="">
             <a:extLst xmlns:a="http://schemas.openxmlformats.org/drawingml/2006/main">
               <a:ext uri="{FF2B5EF4-FFF2-40B4-BE49-F238E27FC236}">
-                <a16:creationId xmlns:a16="http://schemas.microsoft.com/office/drawing/2014/main" id="{C2FB2D7A-85E3-4DEE-9F98-CAEBDFC130AA}"/>
+                <a16:creationId xmlns:a16="http://schemas.microsoft.com/office/drawing/2014/main" id="{F72B6827-32CD-4241-8A28-F237693D1E2D}"/>
               </a:ext>
             </a:extLst>
           </p:cNvPr>
@@ -6908,7 +6908,7 @@
           <p:cNvPr id="15" name="footer-left">
             <a:extLst xmlns:a="http://schemas.openxmlformats.org/drawingml/2006/main">
               <a:ext uri="{FF2B5EF4-FFF2-40B4-BE49-F238E27FC236}">
-                <a16:creationId xmlns:a16="http://schemas.microsoft.com/office/drawing/2014/main" id="{8C3E0B03-B00E-408A-8E40-6B3F4973B350}"/>
+                <a16:creationId xmlns:a16="http://schemas.microsoft.com/office/drawing/2014/main" id="{43814ED2-3FA5-4C8A-A794-D5FBB66FFE0B}"/>
               </a:ext>
             </a:extLst>
           </p:cNvPr>
@@ -6953,7 +6953,7 @@
           <p:cNvPr id="16" name="footer-right">
             <a:extLst xmlns:a="http://schemas.openxmlformats.org/drawingml/2006/main">
               <a:ext uri="{FF2B5EF4-FFF2-40B4-BE49-F238E27FC236}">
-                <a16:creationId xmlns:a16="http://schemas.microsoft.com/office/drawing/2014/main" id="{3F6157AE-0C4B-4835-A967-8AF8C22B21BA}"/>
+                <a16:creationId xmlns:a16="http://schemas.microsoft.com/office/drawing/2014/main" id="{07F039FA-994F-4CCF-8480-99F7FB05CBF8}"/>
               </a:ext>
             </a:extLst>
           </p:cNvPr>
@@ -6996,7 +6996,7 @@
     </p:spTree>
     <p:extLst>
       <p:ext uri="{BB962C8B-B14F-4D97-AF65-F5344CB8AC3E}">
-        <p14:creationId xmlns:p14="http://schemas.microsoft.com/office/powerpoint/2010/main" val="1201971796"/>
+        <p14:creationId xmlns:p14="http://schemas.microsoft.com/office/powerpoint/2010/main" val="594364464"/>
       </p:ext>
     </p:extLst>
   </p:cSld>
@@ -7020,7 +7020,7 @@
           <p:cNvPr id="1" name="slide-stage">
             <a:extLst xmlns:a="http://schemas.openxmlformats.org/drawingml/2006/main">
               <a:ext uri="{FF2B5EF4-FFF2-40B4-BE49-F238E27FC236}">
-                <a16:creationId xmlns:a16="http://schemas.microsoft.com/office/drawing/2014/main" id="{40A4A56C-5C57-487C-BF5E-6D34A9314C07}"/>
+                <a16:creationId xmlns:a16="http://schemas.microsoft.com/office/drawing/2014/main" id="{F38B3170-1105-4B08-B9B3-A3F4D738A908}"/>
               </a:ext>
             </a:extLst>
           </p:cNvPr>
@@ -7047,7 +7047,7 @@
           <p:cNvPr id="2" name="eyebrow">
             <a:extLst xmlns:a="http://schemas.openxmlformats.org/drawingml/2006/main">
               <a:ext uri="{FF2B5EF4-FFF2-40B4-BE49-F238E27FC236}">
-                <a16:creationId xmlns:a16="http://schemas.microsoft.com/office/drawing/2014/main" id="{B698276E-CB4E-4755-9CE3-89E7D0AD604E}"/>
+                <a16:creationId xmlns:a16="http://schemas.microsoft.com/office/drawing/2014/main" id="{DC89BE01-4293-44E7-9DD2-1F70482A3799}"/>
               </a:ext>
             </a:extLst>
           </p:cNvPr>
@@ -7092,7 +7092,7 @@
           <p:cNvPr id="3" name="slide-title">
             <a:extLst xmlns:a="http://schemas.openxmlformats.org/drawingml/2006/main">
               <a:ext uri="{FF2B5EF4-FFF2-40B4-BE49-F238E27FC236}">
-                <a16:creationId xmlns:a16="http://schemas.microsoft.com/office/drawing/2014/main" id="{C50B0DCF-43FB-4FE7-91D8-9668BA2B25BA}"/>
+                <a16:creationId xmlns:a16="http://schemas.microsoft.com/office/drawing/2014/main" id="{09D1E222-2F2C-46C5-8F45-701C0DFA655F}"/>
               </a:ext>
             </a:extLst>
           </p:cNvPr>
@@ -7137,7 +7137,7 @@
           <p:cNvPr id="4" name="slide-subtitle">
             <a:extLst xmlns:a="http://schemas.openxmlformats.org/drawingml/2006/main">
               <a:ext uri="{FF2B5EF4-FFF2-40B4-BE49-F238E27FC236}">
-                <a16:creationId xmlns:a16="http://schemas.microsoft.com/office/drawing/2014/main" id="{EE3B5186-7D45-444B-BE3F-6C7703A8C1B0}"/>
+                <a16:creationId xmlns:a16="http://schemas.microsoft.com/office/drawing/2014/main" id="{1AD04CBA-64B3-4E8D-9C6B-F4017F328789}"/>
               </a:ext>
             </a:extLst>
           </p:cNvPr>
@@ -7182,7 +7182,7 @@
           <p:cNvPr id="5" name="">
             <a:extLst xmlns:a="http://schemas.openxmlformats.org/drawingml/2006/main">
               <a:ext uri="{FF2B5EF4-FFF2-40B4-BE49-F238E27FC236}">
-                <a16:creationId xmlns:a16="http://schemas.microsoft.com/office/drawing/2014/main" id="{106C3D3D-E966-4E49-9B19-957685A6FF39}"/>
+                <a16:creationId xmlns:a16="http://schemas.microsoft.com/office/drawing/2014/main" id="{3DD216D8-6967-4AF1-AC82-B67E0DDA3B5E}"/>
               </a:ext>
             </a:extLst>
           </p:cNvPr>
@@ -7215,7 +7215,7 @@
           <p:cNvPr id="6" name="">
             <a:extLst xmlns:a="http://schemas.openxmlformats.org/drawingml/2006/main">
               <a:ext uri="{FF2B5EF4-FFF2-40B4-BE49-F238E27FC236}">
-                <a16:creationId xmlns:a16="http://schemas.microsoft.com/office/drawing/2014/main" id="{7242EBF4-E831-40A5-9422-4C44E39205B3}"/>
+                <a16:creationId xmlns:a16="http://schemas.microsoft.com/office/drawing/2014/main" id="{1F2FAB1D-294E-42A2-BCDC-BEA30EBBB883}"/>
               </a:ext>
             </a:extLst>
           </p:cNvPr>
@@ -7260,7 +7260,7 @@
           <p:cNvPr id="7" name="">
             <a:extLst xmlns:a="http://schemas.openxmlformats.org/drawingml/2006/main">
               <a:ext uri="{FF2B5EF4-FFF2-40B4-BE49-F238E27FC236}">
-                <a16:creationId xmlns:a16="http://schemas.microsoft.com/office/drawing/2014/main" id="{FEC75AB8-019B-43A6-9109-DA0A3A5FFC20}"/>
+                <a16:creationId xmlns:a16="http://schemas.microsoft.com/office/drawing/2014/main" id="{951B3B70-770E-48D7-8101-EFFBE605828E}"/>
               </a:ext>
             </a:extLst>
           </p:cNvPr>
@@ -7305,7 +7305,7 @@
           <p:cNvPr id="8" name="">
             <a:extLst xmlns:a="http://schemas.openxmlformats.org/drawingml/2006/main">
               <a:ext uri="{FF2B5EF4-FFF2-40B4-BE49-F238E27FC236}">
-                <a16:creationId xmlns:a16="http://schemas.microsoft.com/office/drawing/2014/main" id="{A385879C-71C1-45F9-B623-26C82EFC02A9}"/>
+                <a16:creationId xmlns:a16="http://schemas.microsoft.com/office/drawing/2014/main" id="{3045F300-3703-44AE-AE62-9EA052ACE6B9}"/>
               </a:ext>
             </a:extLst>
           </p:cNvPr>
@@ -7338,7 +7338,7 @@
           <p:cNvPr id="9" name="">
             <a:extLst xmlns:a="http://schemas.openxmlformats.org/drawingml/2006/main">
               <a:ext uri="{FF2B5EF4-FFF2-40B4-BE49-F238E27FC236}">
-                <a16:creationId xmlns:a16="http://schemas.microsoft.com/office/drawing/2014/main" id="{4DD3515F-B39A-4A9A-A5F6-2546F2009C5D}"/>
+                <a16:creationId xmlns:a16="http://schemas.microsoft.com/office/drawing/2014/main" id="{8D525213-FD34-4684-8265-AE758FE21B35}"/>
               </a:ext>
             </a:extLst>
           </p:cNvPr>
@@ -7383,7 +7383,7 @@
           <p:cNvPr id="10" name="">
             <a:extLst xmlns:a="http://schemas.openxmlformats.org/drawingml/2006/main">
               <a:ext uri="{FF2B5EF4-FFF2-40B4-BE49-F238E27FC236}">
-                <a16:creationId xmlns:a16="http://schemas.microsoft.com/office/drawing/2014/main" id="{00080E1F-4B3B-46FB-B8C1-88CE8631DBA9}"/>
+                <a16:creationId xmlns:a16="http://schemas.microsoft.com/office/drawing/2014/main" id="{D29CB37F-5788-4A44-8BC5-EDF8B35D3DCF}"/>
               </a:ext>
             </a:extLst>
           </p:cNvPr>
@@ -7428,7 +7428,7 @@
           <p:cNvPr id="11" name="">
             <a:extLst xmlns:a="http://schemas.openxmlformats.org/drawingml/2006/main">
               <a:ext uri="{FF2B5EF4-FFF2-40B4-BE49-F238E27FC236}">
-                <a16:creationId xmlns:a16="http://schemas.microsoft.com/office/drawing/2014/main" id="{AD448C2A-2E8C-451E-B02A-043FFF71B1CE}"/>
+                <a16:creationId xmlns:a16="http://schemas.microsoft.com/office/drawing/2014/main" id="{18DFF567-B21C-4955-BC61-262F4E23BEC0}"/>
               </a:ext>
             </a:extLst>
           </p:cNvPr>
@@ -7461,7 +7461,7 @@
           <p:cNvPr id="12" name="">
             <a:extLst xmlns:a="http://schemas.openxmlformats.org/drawingml/2006/main">
               <a:ext uri="{FF2B5EF4-FFF2-40B4-BE49-F238E27FC236}">
-                <a16:creationId xmlns:a16="http://schemas.microsoft.com/office/drawing/2014/main" id="{80BB4B57-6B10-4B24-9E7A-1B5DDC784966}"/>
+                <a16:creationId xmlns:a16="http://schemas.microsoft.com/office/drawing/2014/main" id="{95A6BFDC-19E0-4AE7-9F0D-52571DC83C35}"/>
               </a:ext>
             </a:extLst>
           </p:cNvPr>
@@ -7506,7 +7506,7 @@
           <p:cNvPr id="13" name="">
             <a:extLst xmlns:a="http://schemas.openxmlformats.org/drawingml/2006/main">
               <a:ext uri="{FF2B5EF4-FFF2-40B4-BE49-F238E27FC236}">
-                <a16:creationId xmlns:a16="http://schemas.microsoft.com/office/drawing/2014/main" id="{F1F211DC-FCE0-4F88-A552-B86A9036D8F3}"/>
+                <a16:creationId xmlns:a16="http://schemas.microsoft.com/office/drawing/2014/main" id="{D29AC59E-A73D-463D-A63E-4683826C3DD3}"/>
               </a:ext>
             </a:extLst>
           </p:cNvPr>
@@ -7551,7 +7551,7 @@
           <p:cNvPr id="14" name="">
             <a:extLst xmlns:a="http://schemas.openxmlformats.org/drawingml/2006/main">
               <a:ext uri="{FF2B5EF4-FFF2-40B4-BE49-F238E27FC236}">
-                <a16:creationId xmlns:a16="http://schemas.microsoft.com/office/drawing/2014/main" id="{D26C85CA-6B01-4800-999B-0542CEA36064}"/>
+                <a16:creationId xmlns:a16="http://schemas.microsoft.com/office/drawing/2014/main" id="{76EF1C76-8D6F-49D5-B09F-57B98158D5A8}"/>
               </a:ext>
             </a:extLst>
           </p:cNvPr>
@@ -7584,7 +7584,7 @@
           <p:cNvPr id="15" name="">
             <a:extLst xmlns:a="http://schemas.openxmlformats.org/drawingml/2006/main">
               <a:ext uri="{FF2B5EF4-FFF2-40B4-BE49-F238E27FC236}">
-                <a16:creationId xmlns:a16="http://schemas.microsoft.com/office/drawing/2014/main" id="{450ECB65-360B-4565-8B41-F306A4FC4548}"/>
+                <a16:creationId xmlns:a16="http://schemas.microsoft.com/office/drawing/2014/main" id="{95D39D7D-A9C8-42B2-B84B-D7D4DF36A9E4}"/>
               </a:ext>
             </a:extLst>
           </p:cNvPr>
@@ -7629,7 +7629,7 @@
           <p:cNvPr id="16" name="">
             <a:extLst xmlns:a="http://schemas.openxmlformats.org/drawingml/2006/main">
               <a:ext uri="{FF2B5EF4-FFF2-40B4-BE49-F238E27FC236}">
-                <a16:creationId xmlns:a16="http://schemas.microsoft.com/office/drawing/2014/main" id="{7B8F963C-6EAB-406F-ADF1-4BBD52115E15}"/>
+                <a16:creationId xmlns:a16="http://schemas.microsoft.com/office/drawing/2014/main" id="{14B4F60D-B832-4731-9EDE-B9BDD6966FFE}"/>
               </a:ext>
             </a:extLst>
           </p:cNvPr>
@@ -7674,7 +7674,7 @@
           <p:cNvPr id="17" name="footer-left">
             <a:extLst xmlns:a="http://schemas.openxmlformats.org/drawingml/2006/main">
               <a:ext uri="{FF2B5EF4-FFF2-40B4-BE49-F238E27FC236}">
-                <a16:creationId xmlns:a16="http://schemas.microsoft.com/office/drawing/2014/main" id="{36ADF64D-0342-469B-9C46-EA4272499C59}"/>
+                <a16:creationId xmlns:a16="http://schemas.microsoft.com/office/drawing/2014/main" id="{D9B4443F-1C67-498F-8F7C-64468E427F62}"/>
               </a:ext>
             </a:extLst>
           </p:cNvPr>
@@ -7719,7 +7719,7 @@
           <p:cNvPr id="18" name="footer-right">
             <a:extLst xmlns:a="http://schemas.openxmlformats.org/drawingml/2006/main">
               <a:ext uri="{FF2B5EF4-FFF2-40B4-BE49-F238E27FC236}">
-                <a16:creationId xmlns:a16="http://schemas.microsoft.com/office/drawing/2014/main" id="{4CA777F6-6724-4D0A-862D-A125540951C6}"/>
+                <a16:creationId xmlns:a16="http://schemas.microsoft.com/office/drawing/2014/main" id="{A4D0E34C-B841-41CD-8B36-9A2A01E9997B}"/>
               </a:ext>
             </a:extLst>
           </p:cNvPr>
@@ -7762,7 +7762,7 @@
     </p:spTree>
     <p:extLst>
       <p:ext uri="{BB962C8B-B14F-4D97-AF65-F5344CB8AC3E}">
-        <p14:creationId xmlns:p14="http://schemas.microsoft.com/office/powerpoint/2010/main" val="1654452484"/>
+        <p14:creationId xmlns:p14="http://schemas.microsoft.com/office/powerpoint/2010/main" val="1640546849"/>
       </p:ext>
     </p:extLst>
   </p:cSld>
@@ -7786,7 +7786,7 @@
           <p:cNvPr id="1" name="slide-stage">
             <a:extLst xmlns:a="http://schemas.openxmlformats.org/drawingml/2006/main">
               <a:ext uri="{FF2B5EF4-FFF2-40B4-BE49-F238E27FC236}">
-                <a16:creationId xmlns:a16="http://schemas.microsoft.com/office/drawing/2014/main" id="{E1C1EC10-00EF-4B5D-91E0-9999D56B6AA2}"/>
+                <a16:creationId xmlns:a16="http://schemas.microsoft.com/office/drawing/2014/main" id="{570B25E0-9776-43E2-A67B-F5023826EE43}"/>
               </a:ext>
             </a:extLst>
           </p:cNvPr>
@@ -7813,7 +7813,7 @@
           <p:cNvPr id="2" name="eyebrow">
             <a:extLst xmlns:a="http://schemas.openxmlformats.org/drawingml/2006/main">
               <a:ext uri="{FF2B5EF4-FFF2-40B4-BE49-F238E27FC236}">
-                <a16:creationId xmlns:a16="http://schemas.microsoft.com/office/drawing/2014/main" id="{62E6B594-B3CA-4B25-AB46-3D827EE29A0C}"/>
+                <a16:creationId xmlns:a16="http://schemas.microsoft.com/office/drawing/2014/main" id="{9582FED7-B486-4FEA-9489-84C525071A97}"/>
               </a:ext>
             </a:extLst>
           </p:cNvPr>
@@ -7858,7 +7858,7 @@
           <p:cNvPr id="3" name="slide-title">
             <a:extLst xmlns:a="http://schemas.openxmlformats.org/drawingml/2006/main">
               <a:ext uri="{FF2B5EF4-FFF2-40B4-BE49-F238E27FC236}">
-                <a16:creationId xmlns:a16="http://schemas.microsoft.com/office/drawing/2014/main" id="{FA35C7DC-AA8B-432B-89EC-251B6BA1E976}"/>
+                <a16:creationId xmlns:a16="http://schemas.microsoft.com/office/drawing/2014/main" id="{D3664EC5-457F-4E69-8566-20BE17F32402}"/>
               </a:ext>
             </a:extLst>
           </p:cNvPr>
@@ -7903,7 +7903,7 @@
           <p:cNvPr id="4" name="slide-subtitle">
             <a:extLst xmlns:a="http://schemas.openxmlformats.org/drawingml/2006/main">
               <a:ext uri="{FF2B5EF4-FFF2-40B4-BE49-F238E27FC236}">
-                <a16:creationId xmlns:a16="http://schemas.microsoft.com/office/drawing/2014/main" id="{266157DF-8900-42D1-9AED-862069F6A311}"/>
+                <a16:creationId xmlns:a16="http://schemas.microsoft.com/office/drawing/2014/main" id="{91FFCA1D-3CB9-4784-B487-D940D40831CF}"/>
               </a:ext>
             </a:extLst>
           </p:cNvPr>
@@ -7948,7 +7948,7 @@
           <p:cNvPr id="5" name="">
             <a:extLst xmlns:a="http://schemas.openxmlformats.org/drawingml/2006/main">
               <a:ext uri="{FF2B5EF4-FFF2-40B4-BE49-F238E27FC236}">
-                <a16:creationId xmlns:a16="http://schemas.microsoft.com/office/drawing/2014/main" id="{D1282453-0CA1-4952-93D8-C04C336C6A90}"/>
+                <a16:creationId xmlns:a16="http://schemas.microsoft.com/office/drawing/2014/main" id="{198F388B-3DC2-4ED2-8AD3-4856553DE659}"/>
               </a:ext>
             </a:extLst>
           </p:cNvPr>
@@ -7993,7 +7993,7 @@
           <p:cNvPr id="6" name="">
             <a:extLst xmlns:a="http://schemas.openxmlformats.org/drawingml/2006/main">
               <a:ext uri="{FF2B5EF4-FFF2-40B4-BE49-F238E27FC236}">
-                <a16:creationId xmlns:a16="http://schemas.microsoft.com/office/drawing/2014/main" id="{F6BDAF6A-9954-40B8-9440-6E5B7EDA0319}"/>
+                <a16:creationId xmlns:a16="http://schemas.microsoft.com/office/drawing/2014/main" id="{FB23E619-B842-4F41-9C1C-9433E4FB6ACF}"/>
               </a:ext>
             </a:extLst>
           </p:cNvPr>
@@ -8038,7 +8038,7 @@
           <p:cNvPr id="7" name="">
             <a:extLst xmlns:a="http://schemas.openxmlformats.org/drawingml/2006/main">
               <a:ext uri="{FF2B5EF4-FFF2-40B4-BE49-F238E27FC236}">
-                <a16:creationId xmlns:a16="http://schemas.microsoft.com/office/drawing/2014/main" id="{928B6428-DC11-434A-ACF8-48BA920B7F10}"/>
+                <a16:creationId xmlns:a16="http://schemas.microsoft.com/office/drawing/2014/main" id="{6BA949E0-E5A6-4D51-AF3A-EF64FBEAE2A2}"/>
               </a:ext>
             </a:extLst>
           </p:cNvPr>
@@ -8071,7 +8071,7 @@
           <p:cNvPr id="8" name="">
             <a:extLst xmlns:a="http://schemas.openxmlformats.org/drawingml/2006/main">
               <a:ext uri="{FF2B5EF4-FFF2-40B4-BE49-F238E27FC236}">
-                <a16:creationId xmlns:a16="http://schemas.microsoft.com/office/drawing/2014/main" id="{0D473EAE-50B4-4F18-A6CC-CA1E80406C79}"/>
+                <a16:creationId xmlns:a16="http://schemas.microsoft.com/office/drawing/2014/main" id="{17484AFC-9B6A-4849-8C7B-E7F3B2FD9513}"/>
               </a:ext>
             </a:extLst>
           </p:cNvPr>
@@ -8116,7 +8116,7 @@
           <p:cNvPr id="9" name="">
             <a:extLst xmlns:a="http://schemas.openxmlformats.org/drawingml/2006/main">
               <a:ext uri="{FF2B5EF4-FFF2-40B4-BE49-F238E27FC236}">
-                <a16:creationId xmlns:a16="http://schemas.microsoft.com/office/drawing/2014/main" id="{AB0A300E-E736-4502-84B9-B06D808BF282}"/>
+                <a16:creationId xmlns:a16="http://schemas.microsoft.com/office/drawing/2014/main" id="{A800D2D8-1A60-4896-858E-79D695C2BEEA}"/>
               </a:ext>
             </a:extLst>
           </p:cNvPr>
@@ -8161,7 +8161,7 @@
           <p:cNvPr id="10" name="">
             <a:extLst xmlns:a="http://schemas.openxmlformats.org/drawingml/2006/main">
               <a:ext uri="{FF2B5EF4-FFF2-40B4-BE49-F238E27FC236}">
-                <a16:creationId xmlns:a16="http://schemas.microsoft.com/office/drawing/2014/main" id="{83340EE0-AD5E-4DC8-8E93-51B6F3755057}"/>
+                <a16:creationId xmlns:a16="http://schemas.microsoft.com/office/drawing/2014/main" id="{47802322-AFD2-47C7-AC78-AAD1323720EE}"/>
               </a:ext>
             </a:extLst>
           </p:cNvPr>
@@ -8194,7 +8194,7 @@
           <p:cNvPr id="11" name="">
             <a:extLst xmlns:a="http://schemas.openxmlformats.org/drawingml/2006/main">
               <a:ext uri="{FF2B5EF4-FFF2-40B4-BE49-F238E27FC236}">
-                <a16:creationId xmlns:a16="http://schemas.microsoft.com/office/drawing/2014/main" id="{2BD7152A-3C4A-4D77-AECA-E0D8B63AFD3B}"/>
+                <a16:creationId xmlns:a16="http://schemas.microsoft.com/office/drawing/2014/main" id="{5AFCBACA-C114-4379-B806-9A614681C500}"/>
               </a:ext>
             </a:extLst>
           </p:cNvPr>
@@ -8239,7 +8239,7 @@
           <p:cNvPr id="12" name="">
             <a:extLst xmlns:a="http://schemas.openxmlformats.org/drawingml/2006/main">
               <a:ext uri="{FF2B5EF4-FFF2-40B4-BE49-F238E27FC236}">
-                <a16:creationId xmlns:a16="http://schemas.microsoft.com/office/drawing/2014/main" id="{6100D2E9-1AB4-4612-8AA3-6E6957BA14B1}"/>
+                <a16:creationId xmlns:a16="http://schemas.microsoft.com/office/drawing/2014/main" id="{2F29C9B6-E8F6-40E0-9A61-ED10CA24FFE8}"/>
               </a:ext>
             </a:extLst>
           </p:cNvPr>
@@ -8284,7 +8284,7 @@
           <p:cNvPr id="13" name="">
             <a:extLst xmlns:a="http://schemas.openxmlformats.org/drawingml/2006/main">
               <a:ext uri="{FF2B5EF4-FFF2-40B4-BE49-F238E27FC236}">
-                <a16:creationId xmlns:a16="http://schemas.microsoft.com/office/drawing/2014/main" id="{515A2EC7-8136-4D54-8316-D23B68F2F855}"/>
+                <a16:creationId xmlns:a16="http://schemas.microsoft.com/office/drawing/2014/main" id="{D4290171-9672-46C6-9691-A00FED764E73}"/>
               </a:ext>
             </a:extLst>
           </p:cNvPr>
@@ -8317,7 +8317,7 @@
           <p:cNvPr id="14" name="">
             <a:extLst xmlns:a="http://schemas.openxmlformats.org/drawingml/2006/main">
               <a:ext uri="{FF2B5EF4-FFF2-40B4-BE49-F238E27FC236}">
-                <a16:creationId xmlns:a16="http://schemas.microsoft.com/office/drawing/2014/main" id="{00EC85F9-D1EF-4526-BC30-14949AA8DE01}"/>
+                <a16:creationId xmlns:a16="http://schemas.microsoft.com/office/drawing/2014/main" id="{49289234-25FD-4574-A5CB-14F4B7B5B615}"/>
               </a:ext>
             </a:extLst>
           </p:cNvPr>
@@ -8362,7 +8362,7 @@
           <p:cNvPr id="15" name="">
             <a:extLst xmlns:a="http://schemas.openxmlformats.org/drawingml/2006/main">
               <a:ext uri="{FF2B5EF4-FFF2-40B4-BE49-F238E27FC236}">
-                <a16:creationId xmlns:a16="http://schemas.microsoft.com/office/drawing/2014/main" id="{BD02A505-2515-42D8-947C-6AF76D1E56B5}"/>
+                <a16:creationId xmlns:a16="http://schemas.microsoft.com/office/drawing/2014/main" id="{ACDE023E-0C16-42AA-8C90-94DA8A727EB6}"/>
               </a:ext>
             </a:extLst>
           </p:cNvPr>
@@ -8407,7 +8407,7 @@
           <p:cNvPr id="16" name="footer-left">
             <a:extLst xmlns:a="http://schemas.openxmlformats.org/drawingml/2006/main">
               <a:ext uri="{FF2B5EF4-FFF2-40B4-BE49-F238E27FC236}">
-                <a16:creationId xmlns:a16="http://schemas.microsoft.com/office/drawing/2014/main" id="{41751508-CD2E-4556-A20D-83C520B0C748}"/>
+                <a16:creationId xmlns:a16="http://schemas.microsoft.com/office/drawing/2014/main" id="{8FAAED7B-8167-423C-9D31-54C17008ABEB}"/>
               </a:ext>
             </a:extLst>
           </p:cNvPr>
@@ -8452,7 +8452,7 @@
           <p:cNvPr id="17" name="footer-right">
             <a:extLst xmlns:a="http://schemas.openxmlformats.org/drawingml/2006/main">
               <a:ext uri="{FF2B5EF4-FFF2-40B4-BE49-F238E27FC236}">
-                <a16:creationId xmlns:a16="http://schemas.microsoft.com/office/drawing/2014/main" id="{CC2CB7DC-3F6C-401B-8963-E161B08F94F3}"/>
+                <a16:creationId xmlns:a16="http://schemas.microsoft.com/office/drawing/2014/main" id="{864B39F9-D9B5-4D2A-B589-110619C5F04A}"/>
               </a:ext>
             </a:extLst>
           </p:cNvPr>
@@ -8495,7 +8495,7 @@
     </p:spTree>
     <p:extLst>
       <p:ext uri="{BB962C8B-B14F-4D97-AF65-F5344CB8AC3E}">
-        <p14:creationId xmlns:p14="http://schemas.microsoft.com/office/powerpoint/2010/main" val="1874771671"/>
+        <p14:creationId xmlns:p14="http://schemas.microsoft.com/office/powerpoint/2010/main" val="883098571"/>
       </p:ext>
     </p:extLst>
   </p:cSld>
@@ -8519,7 +8519,7 @@
           <p:cNvPr id="1" name="slide-stage">
             <a:extLst xmlns:a="http://schemas.openxmlformats.org/drawingml/2006/main">
               <a:ext uri="{FF2B5EF4-FFF2-40B4-BE49-F238E27FC236}">
-                <a16:creationId xmlns:a16="http://schemas.microsoft.com/office/drawing/2014/main" id="{45E43D22-E9AC-4DA6-8108-F751EC82F722}"/>
+                <a16:creationId xmlns:a16="http://schemas.microsoft.com/office/drawing/2014/main" id="{36439962-F143-407C-857F-5A483D03EF4F}"/>
               </a:ext>
             </a:extLst>
           </p:cNvPr>
@@ -8546,7 +8546,7 @@
           <p:cNvPr id="2" name="eyebrow">
             <a:extLst xmlns:a="http://schemas.openxmlformats.org/drawingml/2006/main">
               <a:ext uri="{FF2B5EF4-FFF2-40B4-BE49-F238E27FC236}">
-                <a16:creationId xmlns:a16="http://schemas.microsoft.com/office/drawing/2014/main" id="{BC09050C-BD16-4D1F-A463-8CF5F74E2881}"/>
+                <a16:creationId xmlns:a16="http://schemas.microsoft.com/office/drawing/2014/main" id="{64A09503-0B29-4793-BC6D-945B1C98609C}"/>
               </a:ext>
             </a:extLst>
           </p:cNvPr>
@@ -8591,7 +8591,7 @@
           <p:cNvPr id="3" name="slide-title">
             <a:extLst xmlns:a="http://schemas.openxmlformats.org/drawingml/2006/main">
               <a:ext uri="{FF2B5EF4-FFF2-40B4-BE49-F238E27FC236}">
-                <a16:creationId xmlns:a16="http://schemas.microsoft.com/office/drawing/2014/main" id="{C62E7169-EA75-41C2-A415-9FCF76FD82FF}"/>
+                <a16:creationId xmlns:a16="http://schemas.microsoft.com/office/drawing/2014/main" id="{1C724486-6D17-4BDA-BD28-193A293DE74C}"/>
               </a:ext>
             </a:extLst>
           </p:cNvPr>
@@ -8636,7 +8636,7 @@
           <p:cNvPr id="4" name="slide-subtitle">
             <a:extLst xmlns:a="http://schemas.openxmlformats.org/drawingml/2006/main">
               <a:ext uri="{FF2B5EF4-FFF2-40B4-BE49-F238E27FC236}">
-                <a16:creationId xmlns:a16="http://schemas.microsoft.com/office/drawing/2014/main" id="{921A7AA6-E943-46AF-83B2-089E41116E6E}"/>
+                <a16:creationId xmlns:a16="http://schemas.microsoft.com/office/drawing/2014/main" id="{370636EB-B438-4124-BE71-3C8F3057FB01}"/>
               </a:ext>
             </a:extLst>
           </p:cNvPr>
@@ -8681,7 +8681,7 @@
           <p:cNvPr id="5" name="">
             <a:extLst xmlns:a="http://schemas.openxmlformats.org/drawingml/2006/main">
               <a:ext uri="{FF2B5EF4-FFF2-40B4-BE49-F238E27FC236}">
-                <a16:creationId xmlns:a16="http://schemas.microsoft.com/office/drawing/2014/main" id="{60067D71-4D84-46B3-AF81-0407561035CF}"/>
+                <a16:creationId xmlns:a16="http://schemas.microsoft.com/office/drawing/2014/main" id="{7B620AF1-FB3D-4856-9595-1A33AB4B365F}"/>
               </a:ext>
             </a:extLst>
           </p:cNvPr>
@@ -8726,7 +8726,7 @@
           <p:cNvPr id="6" name="">
             <a:extLst xmlns:a="http://schemas.openxmlformats.org/drawingml/2006/main">
               <a:ext uri="{FF2B5EF4-FFF2-40B4-BE49-F238E27FC236}">
-                <a16:creationId xmlns:a16="http://schemas.microsoft.com/office/drawing/2014/main" id="{C695EAD9-9581-4A2C-B43A-40F32EDD324B}"/>
+                <a16:creationId xmlns:a16="http://schemas.microsoft.com/office/drawing/2014/main" id="{4C4EEBD8-8E3B-47F4-B083-5D8A127EE270}"/>
               </a:ext>
             </a:extLst>
           </p:cNvPr>
@@ -8771,7 +8771,7 @@
           <p:cNvPr id="7" name="">
             <a:extLst xmlns:a="http://schemas.openxmlformats.org/drawingml/2006/main">
               <a:ext uri="{FF2B5EF4-FFF2-40B4-BE49-F238E27FC236}">
-                <a16:creationId xmlns:a16="http://schemas.microsoft.com/office/drawing/2014/main" id="{2F1A162B-1E31-4676-AE78-94E1F0C5FD6E}"/>
+                <a16:creationId xmlns:a16="http://schemas.microsoft.com/office/drawing/2014/main" id="{6DA3C35B-437A-4198-8073-FE678DE1A93B}"/>
               </a:ext>
             </a:extLst>
           </p:cNvPr>
@@ -8816,7 +8816,7 @@
           <p:cNvPr id="8" name="">
             <a:extLst xmlns:a="http://schemas.openxmlformats.org/drawingml/2006/main">
               <a:ext uri="{FF2B5EF4-FFF2-40B4-BE49-F238E27FC236}">
-                <a16:creationId xmlns:a16="http://schemas.microsoft.com/office/drawing/2014/main" id="{8B917CAB-1E5C-486D-BFCB-85F5B53E44AA}"/>
+                <a16:creationId xmlns:a16="http://schemas.microsoft.com/office/drawing/2014/main" id="{79D07155-0B08-4D2B-846F-7D19FD47F90C}"/>
               </a:ext>
             </a:extLst>
           </p:cNvPr>
@@ -8861,7 +8861,7 @@
           <p:cNvPr id="9" name="">
             <a:extLst xmlns:a="http://schemas.openxmlformats.org/drawingml/2006/main">
               <a:ext uri="{FF2B5EF4-FFF2-40B4-BE49-F238E27FC236}">
-                <a16:creationId xmlns:a16="http://schemas.microsoft.com/office/drawing/2014/main" id="{56E41F46-22E5-435A-8CF9-E6C163B3C70E}"/>
+                <a16:creationId xmlns:a16="http://schemas.microsoft.com/office/drawing/2014/main" id="{A73D2F1D-DAEF-4FE5-AA5A-3E129F273D89}"/>
               </a:ext>
             </a:extLst>
           </p:cNvPr>
@@ -8906,7 +8906,7 @@
           <p:cNvPr id="10" name="">
             <a:extLst xmlns:a="http://schemas.openxmlformats.org/drawingml/2006/main">
               <a:ext uri="{FF2B5EF4-FFF2-40B4-BE49-F238E27FC236}">
-                <a16:creationId xmlns:a16="http://schemas.microsoft.com/office/drawing/2014/main" id="{0C4FA8FF-88D1-4D23-B17A-38189115D2F8}"/>
+                <a16:creationId xmlns:a16="http://schemas.microsoft.com/office/drawing/2014/main" id="{32C378C3-3619-40B8-B547-ED0BFF0873DB}"/>
               </a:ext>
             </a:extLst>
           </p:cNvPr>
@@ -8951,7 +8951,7 @@
           <p:cNvPr id="11" name="">
             <a:extLst xmlns:a="http://schemas.openxmlformats.org/drawingml/2006/main">
               <a:ext uri="{FF2B5EF4-FFF2-40B4-BE49-F238E27FC236}">
-                <a16:creationId xmlns:a16="http://schemas.microsoft.com/office/drawing/2014/main" id="{51AE1E4A-DF8A-4129-A037-C48433C73ABD}"/>
+                <a16:creationId xmlns:a16="http://schemas.microsoft.com/office/drawing/2014/main" id="{3CF453B0-442F-41F5-BEC1-3EEB5B09791A}"/>
               </a:ext>
             </a:extLst>
           </p:cNvPr>
@@ -8996,7 +8996,7 @@
           <p:cNvPr id="12" name="">
             <a:extLst xmlns:a="http://schemas.openxmlformats.org/drawingml/2006/main">
               <a:ext uri="{FF2B5EF4-FFF2-40B4-BE49-F238E27FC236}">
-                <a16:creationId xmlns:a16="http://schemas.microsoft.com/office/drawing/2014/main" id="{EF83ADDA-090F-4252-9A7B-875D0FFE65F5}"/>
+                <a16:creationId xmlns:a16="http://schemas.microsoft.com/office/drawing/2014/main" id="{C63CE070-E907-428E-B01B-89C913597728}"/>
               </a:ext>
             </a:extLst>
           </p:cNvPr>
@@ -9041,7 +9041,7 @@
           <p:cNvPr id="13" name="footer-left">
             <a:extLst xmlns:a="http://schemas.openxmlformats.org/drawingml/2006/main">
               <a:ext uri="{FF2B5EF4-FFF2-40B4-BE49-F238E27FC236}">
-                <a16:creationId xmlns:a16="http://schemas.microsoft.com/office/drawing/2014/main" id="{A7934F5F-2A81-4E55-82C2-3B5818FF9FB8}"/>
+                <a16:creationId xmlns:a16="http://schemas.microsoft.com/office/drawing/2014/main" id="{CF33C4AC-5B8F-468A-B73D-B77279A3D32F}"/>
               </a:ext>
             </a:extLst>
           </p:cNvPr>
@@ -9086,7 +9086,7 @@
           <p:cNvPr id="14" name="footer-right">
             <a:extLst xmlns:a="http://schemas.openxmlformats.org/drawingml/2006/main">
               <a:ext uri="{FF2B5EF4-FFF2-40B4-BE49-F238E27FC236}">
-                <a16:creationId xmlns:a16="http://schemas.microsoft.com/office/drawing/2014/main" id="{6067FE77-570D-44A6-82CE-441438FE3CD0}"/>
+                <a16:creationId xmlns:a16="http://schemas.microsoft.com/office/drawing/2014/main" id="{4F6FEE95-BF0C-42FE-8CE3-4CE2952790F2}"/>
               </a:ext>
             </a:extLst>
           </p:cNvPr>
@@ -9129,7 +9129,7 @@
     </p:spTree>
     <p:extLst>
       <p:ext uri="{BB962C8B-B14F-4D97-AF65-F5344CB8AC3E}">
-        <p14:creationId xmlns:p14="http://schemas.microsoft.com/office/powerpoint/2010/main" val="91597172"/>
+        <p14:creationId xmlns:p14="http://schemas.microsoft.com/office/powerpoint/2010/main" val="1854277021"/>
       </p:ext>
     </p:extLst>
   </p:cSld>
@@ -9153,7 +9153,7 @@
           <p:cNvPr id="1" name="slide-stage">
             <a:extLst xmlns:a="http://schemas.openxmlformats.org/drawingml/2006/main">
               <a:ext uri="{FF2B5EF4-FFF2-40B4-BE49-F238E27FC236}">
-                <a16:creationId xmlns:a16="http://schemas.microsoft.com/office/drawing/2014/main" id="{EA1E9340-BF78-4876-87DB-AAEF97855F16}"/>
+                <a16:creationId xmlns:a16="http://schemas.microsoft.com/office/drawing/2014/main" id="{3091B0F4-CAAC-4514-9415-84A54B9EA065}"/>
               </a:ext>
             </a:extLst>
           </p:cNvPr>
@@ -9180,7 +9180,7 @@
           <p:cNvPr id="2" name="eyebrow">
             <a:extLst xmlns:a="http://schemas.openxmlformats.org/drawingml/2006/main">
               <a:ext uri="{FF2B5EF4-FFF2-40B4-BE49-F238E27FC236}">
-                <a16:creationId xmlns:a16="http://schemas.microsoft.com/office/drawing/2014/main" id="{DC3FAECD-202A-46A8-B126-ABF49FEC6E93}"/>
+                <a16:creationId xmlns:a16="http://schemas.microsoft.com/office/drawing/2014/main" id="{EEECC71A-C072-4EE3-B3D5-BDDF2AD5EE1C}"/>
               </a:ext>
             </a:extLst>
           </p:cNvPr>
@@ -9225,7 +9225,7 @@
           <p:cNvPr id="3" name="slide-title">
             <a:extLst xmlns:a="http://schemas.openxmlformats.org/drawingml/2006/main">
               <a:ext uri="{FF2B5EF4-FFF2-40B4-BE49-F238E27FC236}">
-                <a16:creationId xmlns:a16="http://schemas.microsoft.com/office/drawing/2014/main" id="{349D3150-1D0D-4951-9066-4F24E3F95945}"/>
+                <a16:creationId xmlns:a16="http://schemas.microsoft.com/office/drawing/2014/main" id="{FD4581BA-B684-4A9F-86E2-C7B633572AAD}"/>
               </a:ext>
             </a:extLst>
           </p:cNvPr>
@@ -9270,7 +9270,7 @@
           <p:cNvPr id="4" name="slide-subtitle">
             <a:extLst xmlns:a="http://schemas.openxmlformats.org/drawingml/2006/main">
               <a:ext uri="{FF2B5EF4-FFF2-40B4-BE49-F238E27FC236}">
-                <a16:creationId xmlns:a16="http://schemas.microsoft.com/office/drawing/2014/main" id="{1841E23C-85F5-497D-9B4D-A28245F2184D}"/>
+                <a16:creationId xmlns:a16="http://schemas.microsoft.com/office/drawing/2014/main" id="{5DB5BFAA-CD3F-4E6E-993F-80D42EED172D}"/>
               </a:ext>
             </a:extLst>
           </p:cNvPr>
@@ -9315,7 +9315,7 @@
           <p:cNvPr id="5" name="">
             <a:extLst xmlns:a="http://schemas.openxmlformats.org/drawingml/2006/main">
               <a:ext uri="{FF2B5EF4-FFF2-40B4-BE49-F238E27FC236}">
-                <a16:creationId xmlns:a16="http://schemas.microsoft.com/office/drawing/2014/main" id="{30228937-7B46-47EC-B6FB-2DCCE06F9DD7}"/>
+                <a16:creationId xmlns:a16="http://schemas.microsoft.com/office/drawing/2014/main" id="{ACF2AE4D-81AF-4D59-B31C-D9A50352146A}"/>
               </a:ext>
             </a:extLst>
           </p:cNvPr>
@@ -9348,7 +9348,7 @@
           <p:cNvPr id="6" name="">
             <a:extLst xmlns:a="http://schemas.openxmlformats.org/drawingml/2006/main">
               <a:ext uri="{FF2B5EF4-FFF2-40B4-BE49-F238E27FC236}">
-                <a16:creationId xmlns:a16="http://schemas.microsoft.com/office/drawing/2014/main" id="{04279883-368B-491A-AD21-08B1F83DF521}"/>
+                <a16:creationId xmlns:a16="http://schemas.microsoft.com/office/drawing/2014/main" id="{D3943FE9-5A0E-4409-9DB1-6C09F5B22338}"/>
               </a:ext>
             </a:extLst>
           </p:cNvPr>
@@ -9393,7 +9393,7 @@
           <p:cNvPr id="7" name="">
             <a:extLst xmlns:a="http://schemas.openxmlformats.org/drawingml/2006/main">
               <a:ext uri="{FF2B5EF4-FFF2-40B4-BE49-F238E27FC236}">
-                <a16:creationId xmlns:a16="http://schemas.microsoft.com/office/drawing/2014/main" id="{D36CA32A-2420-45B0-A51C-6A412211463D}"/>
+                <a16:creationId xmlns:a16="http://schemas.microsoft.com/office/drawing/2014/main" id="{F23BBC74-1552-47FB-B692-7056CEEF2638}"/>
               </a:ext>
             </a:extLst>
           </p:cNvPr>
@@ -9438,7 +9438,7 @@
           <p:cNvPr id="8" name="">
             <a:extLst xmlns:a="http://schemas.openxmlformats.org/drawingml/2006/main">
               <a:ext uri="{FF2B5EF4-FFF2-40B4-BE49-F238E27FC236}">
-                <a16:creationId xmlns:a16="http://schemas.microsoft.com/office/drawing/2014/main" id="{C205E78A-2DDC-478C-B1D0-AAF2338AA7C8}"/>
+                <a16:creationId xmlns:a16="http://schemas.microsoft.com/office/drawing/2014/main" id="{50DCE530-5F09-4038-843D-9B7814CD9696}"/>
               </a:ext>
             </a:extLst>
           </p:cNvPr>
@@ -9471,7 +9471,7 @@
           <p:cNvPr id="9" name="">
             <a:extLst xmlns:a="http://schemas.openxmlformats.org/drawingml/2006/main">
               <a:ext uri="{FF2B5EF4-FFF2-40B4-BE49-F238E27FC236}">
-                <a16:creationId xmlns:a16="http://schemas.microsoft.com/office/drawing/2014/main" id="{EFA4DFE2-DA05-4F3A-8965-B97036A94410}"/>
+                <a16:creationId xmlns:a16="http://schemas.microsoft.com/office/drawing/2014/main" id="{E24063BA-9990-40D2-94AF-402CA828E615}"/>
               </a:ext>
             </a:extLst>
           </p:cNvPr>
@@ -9516,7 +9516,7 @@
           <p:cNvPr id="10" name="">
             <a:extLst xmlns:a="http://schemas.openxmlformats.org/drawingml/2006/main">
               <a:ext uri="{FF2B5EF4-FFF2-40B4-BE49-F238E27FC236}">
-                <a16:creationId xmlns:a16="http://schemas.microsoft.com/office/drawing/2014/main" id="{CD11FDF8-920F-4B4D-888C-3264580BB325}"/>
+                <a16:creationId xmlns:a16="http://schemas.microsoft.com/office/drawing/2014/main" id="{570FCE29-1245-400D-B63E-45B7330C6257}"/>
               </a:ext>
             </a:extLst>
           </p:cNvPr>
@@ -9561,7 +9561,7 @@
           <p:cNvPr id="11" name="">
             <a:extLst xmlns:a="http://schemas.openxmlformats.org/drawingml/2006/main">
               <a:ext uri="{FF2B5EF4-FFF2-40B4-BE49-F238E27FC236}">
-                <a16:creationId xmlns:a16="http://schemas.microsoft.com/office/drawing/2014/main" id="{773D74DA-ACCE-467A-984B-C4EFBFD9B904}"/>
+                <a16:creationId xmlns:a16="http://schemas.microsoft.com/office/drawing/2014/main" id="{1A9FC3B7-CD42-4117-B5B7-055078E67820}"/>
               </a:ext>
             </a:extLst>
           </p:cNvPr>
@@ -9594,7 +9594,7 @@
           <p:cNvPr id="12" name="">
             <a:extLst xmlns:a="http://schemas.openxmlformats.org/drawingml/2006/main">
               <a:ext uri="{FF2B5EF4-FFF2-40B4-BE49-F238E27FC236}">
-                <a16:creationId xmlns:a16="http://schemas.microsoft.com/office/drawing/2014/main" id="{30EB1F3C-FE41-4DEC-97D4-D693ABE4FA85}"/>
+                <a16:creationId xmlns:a16="http://schemas.microsoft.com/office/drawing/2014/main" id="{2DAB80DD-19AD-4FF9-9782-E1A5CD9D5357}"/>
               </a:ext>
             </a:extLst>
           </p:cNvPr>
@@ -9639,7 +9639,7 @@
           <p:cNvPr id="13" name="">
             <a:extLst xmlns:a="http://schemas.openxmlformats.org/drawingml/2006/main">
               <a:ext uri="{FF2B5EF4-FFF2-40B4-BE49-F238E27FC236}">
-                <a16:creationId xmlns:a16="http://schemas.microsoft.com/office/drawing/2014/main" id="{16707567-5D78-418E-B806-390343BEA0AF}"/>
+                <a16:creationId xmlns:a16="http://schemas.microsoft.com/office/drawing/2014/main" id="{5735E3E3-0862-4030-A4FF-6AA674847D45}"/>
               </a:ext>
             </a:extLst>
           </p:cNvPr>
@@ -9684,7 +9684,7 @@
           <p:cNvPr id="14" name="">
             <a:extLst xmlns:a="http://schemas.openxmlformats.org/drawingml/2006/main">
               <a:ext uri="{FF2B5EF4-FFF2-40B4-BE49-F238E27FC236}">
-                <a16:creationId xmlns:a16="http://schemas.microsoft.com/office/drawing/2014/main" id="{7E6C3D59-3DA6-456E-8BC9-271D87AF9BB9}"/>
+                <a16:creationId xmlns:a16="http://schemas.microsoft.com/office/drawing/2014/main" id="{DF9AE6CD-A9BB-433F-A150-A6792B595205}"/>
               </a:ext>
             </a:extLst>
           </p:cNvPr>
@@ -9729,7 +9729,7 @@
           <p:cNvPr id="15" name="footer-left">
             <a:extLst xmlns:a="http://schemas.openxmlformats.org/drawingml/2006/main">
               <a:ext uri="{FF2B5EF4-FFF2-40B4-BE49-F238E27FC236}">
-                <a16:creationId xmlns:a16="http://schemas.microsoft.com/office/drawing/2014/main" id="{17A90459-E347-40E3-8366-DF0FA2EFFB2A}"/>
+                <a16:creationId xmlns:a16="http://schemas.microsoft.com/office/drawing/2014/main" id="{A4167BAE-0BD2-473F-AD3A-8B14E2665335}"/>
               </a:ext>
             </a:extLst>
           </p:cNvPr>
@@ -9774,7 +9774,7 @@
           <p:cNvPr id="16" name="footer-right">
             <a:extLst xmlns:a="http://schemas.openxmlformats.org/drawingml/2006/main">
               <a:ext uri="{FF2B5EF4-FFF2-40B4-BE49-F238E27FC236}">
-                <a16:creationId xmlns:a16="http://schemas.microsoft.com/office/drawing/2014/main" id="{F0C63A69-0138-4243-AD12-297ED2738C8E}"/>
+                <a16:creationId xmlns:a16="http://schemas.microsoft.com/office/drawing/2014/main" id="{2245CB06-1161-4D76-9954-C24281E05E42}"/>
               </a:ext>
             </a:extLst>
           </p:cNvPr>
@@ -9817,7 +9817,7 @@
     </p:spTree>
     <p:extLst>
       <p:ext uri="{BB962C8B-B14F-4D97-AF65-F5344CB8AC3E}">
-        <p14:creationId xmlns:p14="http://schemas.microsoft.com/office/powerpoint/2010/main" val="963148749"/>
+        <p14:creationId xmlns:p14="http://schemas.microsoft.com/office/powerpoint/2010/main" val="1182598606"/>
       </p:ext>
     </p:extLst>
   </p:cSld>
@@ -9841,7 +9841,7 @@
           <p:cNvPr id="1" name="slide-stage">
             <a:extLst xmlns:a="http://schemas.openxmlformats.org/drawingml/2006/main">
               <a:ext uri="{FF2B5EF4-FFF2-40B4-BE49-F238E27FC236}">
-                <a16:creationId xmlns:a16="http://schemas.microsoft.com/office/drawing/2014/main" id="{2BBF1982-6326-4368-8765-42321CF26115}"/>
+                <a16:creationId xmlns:a16="http://schemas.microsoft.com/office/drawing/2014/main" id="{0286B3FE-DEB3-4390-AC86-43FFD81EBF23}"/>
               </a:ext>
             </a:extLst>
           </p:cNvPr>
@@ -9868,7 +9868,7 @@
           <p:cNvPr id="2" name="eyebrow">
             <a:extLst xmlns:a="http://schemas.openxmlformats.org/drawingml/2006/main">
               <a:ext uri="{FF2B5EF4-FFF2-40B4-BE49-F238E27FC236}">
-                <a16:creationId xmlns:a16="http://schemas.microsoft.com/office/drawing/2014/main" id="{4710FA7E-139A-41ED-9E48-568FF366FE2E}"/>
+                <a16:creationId xmlns:a16="http://schemas.microsoft.com/office/drawing/2014/main" id="{2818AAA5-8954-4F24-AC46-BD97B9670279}"/>
               </a:ext>
             </a:extLst>
           </p:cNvPr>
@@ -9913,7 +9913,7 @@
           <p:cNvPr id="3" name="slide-title">
             <a:extLst xmlns:a="http://schemas.openxmlformats.org/drawingml/2006/main">
               <a:ext uri="{FF2B5EF4-FFF2-40B4-BE49-F238E27FC236}">
-                <a16:creationId xmlns:a16="http://schemas.microsoft.com/office/drawing/2014/main" id="{714E55BB-22E1-45A8-B260-4FBB7322D46D}"/>
+                <a16:creationId xmlns:a16="http://schemas.microsoft.com/office/drawing/2014/main" id="{89C0115C-CA57-4A41-8A45-AF6CDEC72625}"/>
               </a:ext>
             </a:extLst>
           </p:cNvPr>
@@ -9958,7 +9958,7 @@
           <p:cNvPr id="4" name="slide-subtitle">
             <a:extLst xmlns:a="http://schemas.openxmlformats.org/drawingml/2006/main">
               <a:ext uri="{FF2B5EF4-FFF2-40B4-BE49-F238E27FC236}">
-                <a16:creationId xmlns:a16="http://schemas.microsoft.com/office/drawing/2014/main" id="{4AD40384-64F1-4252-BE04-33C1FB649542}"/>
+                <a16:creationId xmlns:a16="http://schemas.microsoft.com/office/drawing/2014/main" id="{4D27B987-F126-4479-981A-A12655844AAE}"/>
               </a:ext>
             </a:extLst>
           </p:cNvPr>
@@ -10003,7 +10003,7 @@
           <p:cNvPr id="5" name="">
             <a:extLst xmlns:a="http://schemas.openxmlformats.org/drawingml/2006/main">
               <a:ext uri="{FF2B5EF4-FFF2-40B4-BE49-F238E27FC236}">
-                <a16:creationId xmlns:a16="http://schemas.microsoft.com/office/drawing/2014/main" id="{14E16C36-AAB1-4F2B-AD1F-331D018B8158}"/>
+                <a16:creationId xmlns:a16="http://schemas.microsoft.com/office/drawing/2014/main" id="{2D7AC227-CACD-43DC-969D-286147D3C560}"/>
               </a:ext>
             </a:extLst>
           </p:cNvPr>
@@ -10048,7 +10048,7 @@
           <p:cNvPr id="6" name="">
             <a:extLst xmlns:a="http://schemas.openxmlformats.org/drawingml/2006/main">
               <a:ext uri="{FF2B5EF4-FFF2-40B4-BE49-F238E27FC236}">
-                <a16:creationId xmlns:a16="http://schemas.microsoft.com/office/drawing/2014/main" id="{0498F2F2-3D82-4760-855E-6D7757A162F8}"/>
+                <a16:creationId xmlns:a16="http://schemas.microsoft.com/office/drawing/2014/main" id="{198FBEEA-C2E0-4C09-B82C-0E2DAEA09241}"/>
               </a:ext>
             </a:extLst>
           </p:cNvPr>
@@ -10093,7 +10093,7 @@
           <p:cNvPr id="7" name="">
             <a:extLst xmlns:a="http://schemas.openxmlformats.org/drawingml/2006/main">
               <a:ext uri="{FF2B5EF4-FFF2-40B4-BE49-F238E27FC236}">
-                <a16:creationId xmlns:a16="http://schemas.microsoft.com/office/drawing/2014/main" id="{48ACA7BE-E156-4FFF-B972-38386F69A4C6}"/>
+                <a16:creationId xmlns:a16="http://schemas.microsoft.com/office/drawing/2014/main" id="{C1DC53AA-86D8-4D9B-86AD-A83CE3D131D2}"/>
               </a:ext>
             </a:extLst>
           </p:cNvPr>
@@ -10138,7 +10138,7 @@
           <p:cNvPr id="8" name="">
             <a:extLst xmlns:a="http://schemas.openxmlformats.org/drawingml/2006/main">
               <a:ext uri="{FF2B5EF4-FFF2-40B4-BE49-F238E27FC236}">
-                <a16:creationId xmlns:a16="http://schemas.microsoft.com/office/drawing/2014/main" id="{1B4D0FA3-5E91-4307-ADF6-5BC038C7B25D}"/>
+                <a16:creationId xmlns:a16="http://schemas.microsoft.com/office/drawing/2014/main" id="{C79777D9-40A1-4989-93D3-F139315BA262}"/>
               </a:ext>
             </a:extLst>
           </p:cNvPr>
@@ -10183,7 +10183,7 @@
           <p:cNvPr id="9" name="">
             <a:extLst xmlns:a="http://schemas.openxmlformats.org/drawingml/2006/main">
               <a:ext uri="{FF2B5EF4-FFF2-40B4-BE49-F238E27FC236}">
-                <a16:creationId xmlns:a16="http://schemas.microsoft.com/office/drawing/2014/main" id="{C75C6F1C-BC10-4570-A554-55CE73A7FF58}"/>
+                <a16:creationId xmlns:a16="http://schemas.microsoft.com/office/drawing/2014/main" id="{20802CBE-01D3-4017-BFBA-72617D6614D6}"/>
               </a:ext>
             </a:extLst>
           </p:cNvPr>
@@ -10228,7 +10228,7 @@
           <p:cNvPr id="10" name="">
             <a:extLst xmlns:a="http://schemas.openxmlformats.org/drawingml/2006/main">
               <a:ext uri="{FF2B5EF4-FFF2-40B4-BE49-F238E27FC236}">
-                <a16:creationId xmlns:a16="http://schemas.microsoft.com/office/drawing/2014/main" id="{BBAEBEAF-2F28-4FDD-8761-20D5E509E911}"/>
+                <a16:creationId xmlns:a16="http://schemas.microsoft.com/office/drawing/2014/main" id="{4DA90E3E-3BC2-4279-8B13-BD9FC9C497A8}"/>
               </a:ext>
             </a:extLst>
           </p:cNvPr>
@@ -10273,7 +10273,7 @@
           <p:cNvPr id="11" name="">
             <a:extLst xmlns:a="http://schemas.openxmlformats.org/drawingml/2006/main">
               <a:ext uri="{FF2B5EF4-FFF2-40B4-BE49-F238E27FC236}">
-                <a16:creationId xmlns:a16="http://schemas.microsoft.com/office/drawing/2014/main" id="{3C5D9B43-A912-4144-AC1A-522054813DE3}"/>
+                <a16:creationId xmlns:a16="http://schemas.microsoft.com/office/drawing/2014/main" id="{0194CBBF-4D5F-49D0-A0B3-A0F67B33EDB1}"/>
               </a:ext>
             </a:extLst>
           </p:cNvPr>
@@ -10318,7 +10318,7 @@
           <p:cNvPr id="12" name="">
             <a:extLst xmlns:a="http://schemas.openxmlformats.org/drawingml/2006/main">
               <a:ext uri="{FF2B5EF4-FFF2-40B4-BE49-F238E27FC236}">
-                <a16:creationId xmlns:a16="http://schemas.microsoft.com/office/drawing/2014/main" id="{9EDE9848-89B8-4693-B685-69D2C5FB412B}"/>
+                <a16:creationId xmlns:a16="http://schemas.microsoft.com/office/drawing/2014/main" id="{B275C517-3E5D-4C6B-8A63-674A883952C9}"/>
               </a:ext>
             </a:extLst>
           </p:cNvPr>
@@ -10363,7 +10363,7 @@
           <p:cNvPr id="13" name="">
             <a:extLst xmlns:a="http://schemas.openxmlformats.org/drawingml/2006/main">
               <a:ext uri="{FF2B5EF4-FFF2-40B4-BE49-F238E27FC236}">
-                <a16:creationId xmlns:a16="http://schemas.microsoft.com/office/drawing/2014/main" id="{2FFB39FF-656B-4272-8ADD-EDFCF72A21BF}"/>
+                <a16:creationId xmlns:a16="http://schemas.microsoft.com/office/drawing/2014/main" id="{3B3E69B5-2494-455E-97C1-C19FA6F1747B}"/>
               </a:ext>
             </a:extLst>
           </p:cNvPr>
@@ -10408,7 +10408,7 @@
           <p:cNvPr id="14" name="">
             <a:extLst xmlns:a="http://schemas.openxmlformats.org/drawingml/2006/main">
               <a:ext uri="{FF2B5EF4-FFF2-40B4-BE49-F238E27FC236}">
-                <a16:creationId xmlns:a16="http://schemas.microsoft.com/office/drawing/2014/main" id="{8C3ADEB7-D43D-4512-B1FD-25A5CBF4EE77}"/>
+                <a16:creationId xmlns:a16="http://schemas.microsoft.com/office/drawing/2014/main" id="{AA6CD404-50D6-4678-A775-2D20C3B1EC36}"/>
               </a:ext>
             </a:extLst>
           </p:cNvPr>
@@ -10453,7 +10453,7 @@
           <p:cNvPr id="15" name="">
             <a:extLst xmlns:a="http://schemas.openxmlformats.org/drawingml/2006/main">
               <a:ext uri="{FF2B5EF4-FFF2-40B4-BE49-F238E27FC236}">
-                <a16:creationId xmlns:a16="http://schemas.microsoft.com/office/drawing/2014/main" id="{841BC9F0-A0AE-4382-B0F8-605DE562F7D1}"/>
+                <a16:creationId xmlns:a16="http://schemas.microsoft.com/office/drawing/2014/main" id="{37424A3F-332C-40CB-9F9A-CEC860D2490E}"/>
               </a:ext>
             </a:extLst>
           </p:cNvPr>
@@ -10498,7 +10498,7 @@
           <p:cNvPr id="16" name="">
             <a:extLst xmlns:a="http://schemas.openxmlformats.org/drawingml/2006/main">
               <a:ext uri="{FF2B5EF4-FFF2-40B4-BE49-F238E27FC236}">
-                <a16:creationId xmlns:a16="http://schemas.microsoft.com/office/drawing/2014/main" id="{1405EDA3-DA42-4BFB-AB8D-4A3292756F62}"/>
+                <a16:creationId xmlns:a16="http://schemas.microsoft.com/office/drawing/2014/main" id="{E050976E-C4AD-47B5-BFCA-D1A02E321B3B}"/>
               </a:ext>
             </a:extLst>
           </p:cNvPr>
@@ -10543,7 +10543,7 @@
           <p:cNvPr id="17" name="">
             <a:extLst xmlns:a="http://schemas.openxmlformats.org/drawingml/2006/main">
               <a:ext uri="{FF2B5EF4-FFF2-40B4-BE49-F238E27FC236}">
-                <a16:creationId xmlns:a16="http://schemas.microsoft.com/office/drawing/2014/main" id="{842F9E0E-264C-4750-95E7-86447C9480EF}"/>
+                <a16:creationId xmlns:a16="http://schemas.microsoft.com/office/drawing/2014/main" id="{8AECFFC0-9A4A-4BFA-B295-DF9DDC19375C}"/>
               </a:ext>
             </a:extLst>
           </p:cNvPr>
@@ -10588,7 +10588,7 @@
           <p:cNvPr id="18" name="">
             <a:extLst xmlns:a="http://schemas.openxmlformats.org/drawingml/2006/main">
               <a:ext uri="{FF2B5EF4-FFF2-40B4-BE49-F238E27FC236}">
-                <a16:creationId xmlns:a16="http://schemas.microsoft.com/office/drawing/2014/main" id="{438A5357-049A-4C65-AC28-375F09D66899}"/>
+                <a16:creationId xmlns:a16="http://schemas.microsoft.com/office/drawing/2014/main" id="{8889D807-4FA0-41D8-AF3D-E58DAA51410F}"/>
               </a:ext>
             </a:extLst>
           </p:cNvPr>
@@ -10633,7 +10633,7 @@
           <p:cNvPr id="19" name="">
             <a:extLst xmlns:a="http://schemas.openxmlformats.org/drawingml/2006/main">
               <a:ext uri="{FF2B5EF4-FFF2-40B4-BE49-F238E27FC236}">
-                <a16:creationId xmlns:a16="http://schemas.microsoft.com/office/drawing/2014/main" id="{FAD1397F-2D8E-4AA3-9569-D8C65B5E962A}"/>
+                <a16:creationId xmlns:a16="http://schemas.microsoft.com/office/drawing/2014/main" id="{4670DA8C-DBAA-4F04-96CB-1F5013339816}"/>
               </a:ext>
             </a:extLst>
           </p:cNvPr>
@@ -10678,7 +10678,7 @@
           <p:cNvPr id="20" name="footer-left">
             <a:extLst xmlns:a="http://schemas.openxmlformats.org/drawingml/2006/main">
               <a:ext uri="{FF2B5EF4-FFF2-40B4-BE49-F238E27FC236}">
-                <a16:creationId xmlns:a16="http://schemas.microsoft.com/office/drawing/2014/main" id="{D2065C97-EA77-4C46-9C4C-67F3B74C5641}"/>
+                <a16:creationId xmlns:a16="http://schemas.microsoft.com/office/drawing/2014/main" id="{FB91F304-1C9B-4E0C-BA90-8094C35A649B}"/>
               </a:ext>
             </a:extLst>
           </p:cNvPr>
@@ -10723,7 +10723,7 @@
           <p:cNvPr id="21" name="footer-right">
             <a:extLst xmlns:a="http://schemas.openxmlformats.org/drawingml/2006/main">
               <a:ext uri="{FF2B5EF4-FFF2-40B4-BE49-F238E27FC236}">
-                <a16:creationId xmlns:a16="http://schemas.microsoft.com/office/drawing/2014/main" id="{15AC7ECB-F004-4727-8C76-90A4C9F9AD6E}"/>
+                <a16:creationId xmlns:a16="http://schemas.microsoft.com/office/drawing/2014/main" id="{DAA97FB9-6B9E-4FB3-BDA7-671F9137E57A}"/>
               </a:ext>
             </a:extLst>
           </p:cNvPr>
@@ -10766,7 +10766,7 @@
     </p:spTree>
     <p:extLst>
       <p:ext uri="{BB962C8B-B14F-4D97-AF65-F5344CB8AC3E}">
-        <p14:creationId xmlns:p14="http://schemas.microsoft.com/office/powerpoint/2010/main" val="1691585456"/>
+        <p14:creationId xmlns:p14="http://schemas.microsoft.com/office/powerpoint/2010/main" val="1650655636"/>
       </p:ext>
     </p:extLst>
   </p:cSld>
@@ -10790,7 +10790,7 @@
           <p:cNvPr id="1" name="slide-stage">
             <a:extLst xmlns:a="http://schemas.openxmlformats.org/drawingml/2006/main">
               <a:ext uri="{FF2B5EF4-FFF2-40B4-BE49-F238E27FC236}">
-                <a16:creationId xmlns:a16="http://schemas.microsoft.com/office/drawing/2014/main" id="{2E959592-C9EB-4169-96F6-816B3B9F1C14}"/>
+                <a16:creationId xmlns:a16="http://schemas.microsoft.com/office/drawing/2014/main" id="{8B762F74-2918-4F95-83C1-6CF97BD559E6}"/>
               </a:ext>
             </a:extLst>
           </p:cNvPr>
@@ -10817,7 +10817,7 @@
           <p:cNvPr id="2" name="eyebrow">
             <a:extLst xmlns:a="http://schemas.openxmlformats.org/drawingml/2006/main">
               <a:ext uri="{FF2B5EF4-FFF2-40B4-BE49-F238E27FC236}">
-                <a16:creationId xmlns:a16="http://schemas.microsoft.com/office/drawing/2014/main" id="{00CA6ED4-FB84-41DD-99C6-6FE4024F88B4}"/>
+                <a16:creationId xmlns:a16="http://schemas.microsoft.com/office/drawing/2014/main" id="{FCD05252-0491-4A40-975E-2C01B83BEFE4}"/>
               </a:ext>
             </a:extLst>
           </p:cNvPr>
@@ -10862,7 +10862,7 @@
           <p:cNvPr id="3" name="slide-title">
             <a:extLst xmlns:a="http://schemas.openxmlformats.org/drawingml/2006/main">
               <a:ext uri="{FF2B5EF4-FFF2-40B4-BE49-F238E27FC236}">
-                <a16:creationId xmlns:a16="http://schemas.microsoft.com/office/drawing/2014/main" id="{9F291B9C-E4E7-4DC2-9CC9-79AD82AAF6C1}"/>
+                <a16:creationId xmlns:a16="http://schemas.microsoft.com/office/drawing/2014/main" id="{8D3A3F47-DD8E-4403-8699-BC0AA7D44695}"/>
               </a:ext>
             </a:extLst>
           </p:cNvPr>
@@ -10907,7 +10907,7 @@
           <p:cNvPr id="4" name="slide-subtitle">
             <a:extLst xmlns:a="http://schemas.openxmlformats.org/drawingml/2006/main">
               <a:ext uri="{FF2B5EF4-FFF2-40B4-BE49-F238E27FC236}">
-                <a16:creationId xmlns:a16="http://schemas.microsoft.com/office/drawing/2014/main" id="{8A66DC5B-9099-4FBD-92AD-09BC472ACE51}"/>
+                <a16:creationId xmlns:a16="http://schemas.microsoft.com/office/drawing/2014/main" id="{28A07075-D7B3-464D-831C-44150A1B3139}"/>
               </a:ext>
             </a:extLst>
           </p:cNvPr>
@@ -10952,7 +10952,7 @@
           <p:cNvPr id="5" name="">
             <a:extLst xmlns:a="http://schemas.openxmlformats.org/drawingml/2006/main">
               <a:ext uri="{FF2B5EF4-FFF2-40B4-BE49-F238E27FC236}">
-                <a16:creationId xmlns:a16="http://schemas.microsoft.com/office/drawing/2014/main" id="{90950519-AFB2-4F0F-95ED-D65AD5D8BC64}"/>
+                <a16:creationId xmlns:a16="http://schemas.microsoft.com/office/drawing/2014/main" id="{281EC4F7-5BE3-42EF-9866-C3485A15B39F}"/>
               </a:ext>
             </a:extLst>
           </p:cNvPr>
@@ -10985,7 +10985,7 @@
           <p:cNvPr id="6" name="">
             <a:extLst xmlns:a="http://schemas.openxmlformats.org/drawingml/2006/main">
               <a:ext uri="{FF2B5EF4-FFF2-40B4-BE49-F238E27FC236}">
-                <a16:creationId xmlns:a16="http://schemas.microsoft.com/office/drawing/2014/main" id="{166E732A-7711-4106-B931-0AA4D0CA707E}"/>
+                <a16:creationId xmlns:a16="http://schemas.microsoft.com/office/drawing/2014/main" id="{39F5A4B3-EE4A-4322-AA01-FE4DAD3C255F}"/>
               </a:ext>
             </a:extLst>
           </p:cNvPr>
@@ -11081,7 +11081,7 @@
           <p:cNvPr id="7" name="">
             <a:extLst xmlns:a="http://schemas.openxmlformats.org/drawingml/2006/main">
               <a:ext uri="{FF2B5EF4-FFF2-40B4-BE49-F238E27FC236}">
-                <a16:creationId xmlns:a16="http://schemas.microsoft.com/office/drawing/2014/main" id="{93FD27F0-581A-4ED1-80E3-3BF2475C8D41}"/>
+                <a16:creationId xmlns:a16="http://schemas.microsoft.com/office/drawing/2014/main" id="{A6DF28A5-41E8-4BA5-ADAF-228BFC89F4A1}"/>
               </a:ext>
             </a:extLst>
           </p:cNvPr>
@@ -11114,7 +11114,7 @@
           <p:cNvPr id="8" name="">
             <a:extLst xmlns:a="http://schemas.openxmlformats.org/drawingml/2006/main">
               <a:ext uri="{FF2B5EF4-FFF2-40B4-BE49-F238E27FC236}">
-                <a16:creationId xmlns:a16="http://schemas.microsoft.com/office/drawing/2014/main" id="{8D6A2504-A494-4ED3-95D2-1436D624CBE9}"/>
+                <a16:creationId xmlns:a16="http://schemas.microsoft.com/office/drawing/2014/main" id="{41B04FF1-1374-4B43-94F7-B05A5A00550F}"/>
               </a:ext>
             </a:extLst>
           </p:cNvPr>
@@ -11159,7 +11159,7 @@
           <p:cNvPr id="9" name="">
             <a:extLst xmlns:a="http://schemas.openxmlformats.org/drawingml/2006/main">
               <a:ext uri="{FF2B5EF4-FFF2-40B4-BE49-F238E27FC236}">
-                <a16:creationId xmlns:a16="http://schemas.microsoft.com/office/drawing/2014/main" id="{C82B8413-D43A-497C-97C4-1DFBF7C9473F}"/>
+                <a16:creationId xmlns:a16="http://schemas.microsoft.com/office/drawing/2014/main" id="{87C678FD-5B9C-41CA-BD02-7843D5F72447}"/>
               </a:ext>
             </a:extLst>
           </p:cNvPr>
@@ -11204,7 +11204,7 @@
           <p:cNvPr id="10" name="">
             <a:extLst xmlns:a="http://schemas.openxmlformats.org/drawingml/2006/main">
               <a:ext uri="{FF2B5EF4-FFF2-40B4-BE49-F238E27FC236}">
-                <a16:creationId xmlns:a16="http://schemas.microsoft.com/office/drawing/2014/main" id="{170CD3C3-DE7E-4070-904E-ECCB209BD28C}"/>
+                <a16:creationId xmlns:a16="http://schemas.microsoft.com/office/drawing/2014/main" id="{1D80795B-4CF7-4B64-BCB6-AE1080100C37}"/>
               </a:ext>
             </a:extLst>
           </p:cNvPr>
@@ -11237,7 +11237,7 @@
           <p:cNvPr id="11" name="">
             <a:extLst xmlns:a="http://schemas.openxmlformats.org/drawingml/2006/main">
               <a:ext uri="{FF2B5EF4-FFF2-40B4-BE49-F238E27FC236}">
-                <a16:creationId xmlns:a16="http://schemas.microsoft.com/office/drawing/2014/main" id="{41C5A44B-7CA8-4C38-9FE7-BDBC4CE19B6B}"/>
+                <a16:creationId xmlns:a16="http://schemas.microsoft.com/office/drawing/2014/main" id="{2C3076B2-D667-49E6-BD64-0B727AC6E042}"/>
               </a:ext>
             </a:extLst>
           </p:cNvPr>
@@ -11282,7 +11282,7 @@
           <p:cNvPr id="12" name="">
             <a:extLst xmlns:a="http://schemas.openxmlformats.org/drawingml/2006/main">
               <a:ext uri="{FF2B5EF4-FFF2-40B4-BE49-F238E27FC236}">
-                <a16:creationId xmlns:a16="http://schemas.microsoft.com/office/drawing/2014/main" id="{EC3AAFEE-CE7A-4EED-B181-F1FC4972C504}"/>
+                <a16:creationId xmlns:a16="http://schemas.microsoft.com/office/drawing/2014/main" id="{9744E718-24F0-4F8C-A535-51B6B664B447}"/>
               </a:ext>
             </a:extLst>
           </p:cNvPr>
@@ -11327,7 +11327,7 @@
           <p:cNvPr id="13" name="">
             <a:extLst xmlns:a="http://schemas.openxmlformats.org/drawingml/2006/main">
               <a:ext uri="{FF2B5EF4-FFF2-40B4-BE49-F238E27FC236}">
-                <a16:creationId xmlns:a16="http://schemas.microsoft.com/office/drawing/2014/main" id="{4B914B70-5ECC-4700-AC2C-AB77A41B66E6}"/>
+                <a16:creationId xmlns:a16="http://schemas.microsoft.com/office/drawing/2014/main" id="{4084B033-3BDA-4080-919F-2E38B648152B}"/>
               </a:ext>
             </a:extLst>
           </p:cNvPr>
@@ -11360,7 +11360,7 @@
           <p:cNvPr id="14" name="">
             <a:extLst xmlns:a="http://schemas.openxmlformats.org/drawingml/2006/main">
               <a:ext uri="{FF2B5EF4-FFF2-40B4-BE49-F238E27FC236}">
-                <a16:creationId xmlns:a16="http://schemas.microsoft.com/office/drawing/2014/main" id="{77149241-BAC5-43B3-B9C7-987FD39171B0}"/>
+                <a16:creationId xmlns:a16="http://schemas.microsoft.com/office/drawing/2014/main" id="{87F3EC05-8B14-4078-86FE-C19F2FAA632D}"/>
               </a:ext>
             </a:extLst>
           </p:cNvPr>
@@ -11405,7 +11405,7 @@
           <p:cNvPr id="15" name="">
             <a:extLst xmlns:a="http://schemas.openxmlformats.org/drawingml/2006/main">
               <a:ext uri="{FF2B5EF4-FFF2-40B4-BE49-F238E27FC236}">
-                <a16:creationId xmlns:a16="http://schemas.microsoft.com/office/drawing/2014/main" id="{DAAB19F5-2FA1-4A0C-9D3B-777864CC87DA}"/>
+                <a16:creationId xmlns:a16="http://schemas.microsoft.com/office/drawing/2014/main" id="{202D79D8-63BE-4D7E-A634-127ACEA122D8}"/>
               </a:ext>
             </a:extLst>
           </p:cNvPr>
@@ -11450,7 +11450,7 @@
           <p:cNvPr id="16" name="footer-left">
             <a:extLst xmlns:a="http://schemas.openxmlformats.org/drawingml/2006/main">
               <a:ext uri="{FF2B5EF4-FFF2-40B4-BE49-F238E27FC236}">
-                <a16:creationId xmlns:a16="http://schemas.microsoft.com/office/drawing/2014/main" id="{9D137FBF-D488-4B06-A56F-38ED9B4CA028}"/>
+                <a16:creationId xmlns:a16="http://schemas.microsoft.com/office/drawing/2014/main" id="{083215C4-C34C-48D6-8F67-F5F62268F9D0}"/>
               </a:ext>
             </a:extLst>
           </p:cNvPr>
@@ -11495,7 +11495,7 @@
           <p:cNvPr id="17" name="footer-right">
             <a:extLst xmlns:a="http://schemas.openxmlformats.org/drawingml/2006/main">
               <a:ext uri="{FF2B5EF4-FFF2-40B4-BE49-F238E27FC236}">
-                <a16:creationId xmlns:a16="http://schemas.microsoft.com/office/drawing/2014/main" id="{91FDD594-6B2F-4C17-B088-0B0A20A067EC}"/>
+                <a16:creationId xmlns:a16="http://schemas.microsoft.com/office/drawing/2014/main" id="{F7DEE0F9-105A-44EB-AADC-8526BC133A36}"/>
               </a:ext>
             </a:extLst>
           </p:cNvPr>
@@ -11538,7 +11538,7 @@
     </p:spTree>
     <p:extLst>
       <p:ext uri="{BB962C8B-B14F-4D97-AF65-F5344CB8AC3E}">
-        <p14:creationId xmlns:p14="http://schemas.microsoft.com/office/powerpoint/2010/main" val="42339774"/>
+        <p14:creationId xmlns:p14="http://schemas.microsoft.com/office/powerpoint/2010/main" val="715765277"/>
       </p:ext>
     </p:extLst>
   </p:cSld>
@@ -11562,7 +11562,7 @@
           <p:cNvPr id="1" name="slide-stage">
             <a:extLst xmlns:a="http://schemas.openxmlformats.org/drawingml/2006/main">
               <a:ext uri="{FF2B5EF4-FFF2-40B4-BE49-F238E27FC236}">
-                <a16:creationId xmlns:a16="http://schemas.microsoft.com/office/drawing/2014/main" id="{E1E1B7C6-10F1-42EB-B1D4-47B0681BEA39}"/>
+                <a16:creationId xmlns:a16="http://schemas.microsoft.com/office/drawing/2014/main" id="{F106C5A2-65BA-4B02-BBD7-52558CDC83AC}"/>
               </a:ext>
             </a:extLst>
           </p:cNvPr>
@@ -11589,7 +11589,7 @@
           <p:cNvPr id="2" name="eyebrow">
             <a:extLst xmlns:a="http://schemas.openxmlformats.org/drawingml/2006/main">
               <a:ext uri="{FF2B5EF4-FFF2-40B4-BE49-F238E27FC236}">
-                <a16:creationId xmlns:a16="http://schemas.microsoft.com/office/drawing/2014/main" id="{9CE1AAF5-6994-45B7-AAF7-FE46BA1B93E9}"/>
+                <a16:creationId xmlns:a16="http://schemas.microsoft.com/office/drawing/2014/main" id="{ED81A0C5-2C26-4170-904E-30FF61D90B76}"/>
               </a:ext>
             </a:extLst>
           </p:cNvPr>
@@ -11634,7 +11634,7 @@
           <p:cNvPr id="3" name="slide-title">
             <a:extLst xmlns:a="http://schemas.openxmlformats.org/drawingml/2006/main">
               <a:ext uri="{FF2B5EF4-FFF2-40B4-BE49-F238E27FC236}">
-                <a16:creationId xmlns:a16="http://schemas.microsoft.com/office/drawing/2014/main" id="{9FDA45FD-327D-4C32-B432-F0127B89C635}"/>
+                <a16:creationId xmlns:a16="http://schemas.microsoft.com/office/drawing/2014/main" id="{66CEEE43-3B47-44B1-AF4E-B22CAEE06A5A}"/>
               </a:ext>
             </a:extLst>
           </p:cNvPr>
@@ -11679,7 +11679,7 @@
           <p:cNvPr id="4" name="slide-subtitle">
             <a:extLst xmlns:a="http://schemas.openxmlformats.org/drawingml/2006/main">
               <a:ext uri="{FF2B5EF4-FFF2-40B4-BE49-F238E27FC236}">
-                <a16:creationId xmlns:a16="http://schemas.microsoft.com/office/drawing/2014/main" id="{3C71344E-C84F-4EA0-B8D9-EFCE8A831809}"/>
+                <a16:creationId xmlns:a16="http://schemas.microsoft.com/office/drawing/2014/main" id="{DA57D0CE-CEC3-4C3C-A970-D266C96208F0}"/>
               </a:ext>
             </a:extLst>
           </p:cNvPr>
@@ -11724,7 +11724,7 @@
           <p:cNvPr id="5" name="">
             <a:extLst xmlns:a="http://schemas.openxmlformats.org/drawingml/2006/main">
               <a:ext uri="{FF2B5EF4-FFF2-40B4-BE49-F238E27FC236}">
-                <a16:creationId xmlns:a16="http://schemas.microsoft.com/office/drawing/2014/main" id="{CFDEE6D4-913A-4C28-9F8B-C27DAB9FC265}"/>
+                <a16:creationId xmlns:a16="http://schemas.microsoft.com/office/drawing/2014/main" id="{702517CE-97B4-4D85-8866-EB2B52941E6E}"/>
               </a:ext>
             </a:extLst>
           </p:cNvPr>
@@ -11757,7 +11757,7 @@
           <p:cNvPr id="6" name="">
             <a:extLst xmlns:a="http://schemas.openxmlformats.org/drawingml/2006/main">
               <a:ext uri="{FF2B5EF4-FFF2-40B4-BE49-F238E27FC236}">
-                <a16:creationId xmlns:a16="http://schemas.microsoft.com/office/drawing/2014/main" id="{A514F556-0AB7-4F99-A233-A0E2641D204A}"/>
+                <a16:creationId xmlns:a16="http://schemas.microsoft.com/office/drawing/2014/main" id="{A558CDE6-6E21-419C-8EB1-784B2BD2ABD7}"/>
               </a:ext>
             </a:extLst>
           </p:cNvPr>
@@ -11802,7 +11802,7 @@
           <p:cNvPr id="7" name="">
             <a:extLst xmlns:a="http://schemas.openxmlformats.org/drawingml/2006/main">
               <a:ext uri="{FF2B5EF4-FFF2-40B4-BE49-F238E27FC236}">
-                <a16:creationId xmlns:a16="http://schemas.microsoft.com/office/drawing/2014/main" id="{F933B383-5945-4BFB-9AC2-1B04CE5FA8E3}"/>
+                <a16:creationId xmlns:a16="http://schemas.microsoft.com/office/drawing/2014/main" id="{1B940AA6-B0A9-4BE0-B779-9BAE983E5890}"/>
               </a:ext>
             </a:extLst>
           </p:cNvPr>
@@ -11847,7 +11847,7 @@
           <p:cNvPr id="8" name="">
             <a:extLst xmlns:a="http://schemas.openxmlformats.org/drawingml/2006/main">
               <a:ext uri="{FF2B5EF4-FFF2-40B4-BE49-F238E27FC236}">
-                <a16:creationId xmlns:a16="http://schemas.microsoft.com/office/drawing/2014/main" id="{D9B8480B-7367-4033-903D-2B129C14A9A4}"/>
+                <a16:creationId xmlns:a16="http://schemas.microsoft.com/office/drawing/2014/main" id="{403B32F5-6354-4174-9A29-1EE8AF0C6F91}"/>
               </a:ext>
             </a:extLst>
           </p:cNvPr>
@@ -11892,7 +11892,7 @@
           <p:cNvPr id="9" name="">
             <a:extLst xmlns:a="http://schemas.openxmlformats.org/drawingml/2006/main">
               <a:ext uri="{FF2B5EF4-FFF2-40B4-BE49-F238E27FC236}">
-                <a16:creationId xmlns:a16="http://schemas.microsoft.com/office/drawing/2014/main" id="{D54B5F17-13C9-4153-9485-0EEE8C34ABF1}"/>
+                <a16:creationId xmlns:a16="http://schemas.microsoft.com/office/drawing/2014/main" id="{064A02CD-B14E-4BA8-9AB1-A6C326D10D48}"/>
               </a:ext>
             </a:extLst>
           </p:cNvPr>
@@ -11925,7 +11925,7 @@
           <p:cNvPr id="10" name="">
             <a:extLst xmlns:a="http://schemas.openxmlformats.org/drawingml/2006/main">
               <a:ext uri="{FF2B5EF4-FFF2-40B4-BE49-F238E27FC236}">
-                <a16:creationId xmlns:a16="http://schemas.microsoft.com/office/drawing/2014/main" id="{2C33603E-EB38-407F-B47D-8D21E8CCC7ED}"/>
+                <a16:creationId xmlns:a16="http://schemas.microsoft.com/office/drawing/2014/main" id="{16783F4B-2F25-4607-9D23-3F544F8FB14D}"/>
               </a:ext>
             </a:extLst>
           </p:cNvPr>
@@ -11970,7 +11970,7 @@
           <p:cNvPr id="11" name="">
             <a:extLst xmlns:a="http://schemas.openxmlformats.org/drawingml/2006/main">
               <a:ext uri="{FF2B5EF4-FFF2-40B4-BE49-F238E27FC236}">
-                <a16:creationId xmlns:a16="http://schemas.microsoft.com/office/drawing/2014/main" id="{14105E9D-0945-4C68-B66D-A5606CB58640}"/>
+                <a16:creationId xmlns:a16="http://schemas.microsoft.com/office/drawing/2014/main" id="{5308CCB0-EA0A-48D9-A012-CA32D01286C8}"/>
               </a:ext>
             </a:extLst>
           </p:cNvPr>
@@ -12015,7 +12015,7 @@
           <p:cNvPr id="12" name="">
             <a:extLst xmlns:a="http://schemas.openxmlformats.org/drawingml/2006/main">
               <a:ext uri="{FF2B5EF4-FFF2-40B4-BE49-F238E27FC236}">
-                <a16:creationId xmlns:a16="http://schemas.microsoft.com/office/drawing/2014/main" id="{15DD2A27-EABF-4D39-A400-128E67A1FCFE}"/>
+                <a16:creationId xmlns:a16="http://schemas.microsoft.com/office/drawing/2014/main" id="{A77659BE-1F64-4C71-9B12-506F9343AC0A}"/>
               </a:ext>
             </a:extLst>
           </p:cNvPr>
@@ -12060,7 +12060,7 @@
           <p:cNvPr id="13" name="">
             <a:extLst xmlns:a="http://schemas.openxmlformats.org/drawingml/2006/main">
               <a:ext uri="{FF2B5EF4-FFF2-40B4-BE49-F238E27FC236}">
-                <a16:creationId xmlns:a16="http://schemas.microsoft.com/office/drawing/2014/main" id="{F59D5BD5-8FEA-41BC-B147-DE0C2EBBCB5D}"/>
+                <a16:creationId xmlns:a16="http://schemas.microsoft.com/office/drawing/2014/main" id="{BDF8F5EC-AA9E-438B-B5AF-BA92CA5A756A}"/>
               </a:ext>
             </a:extLst>
           </p:cNvPr>
@@ -12093,7 +12093,7 @@
           <p:cNvPr id="14" name="">
             <a:extLst xmlns:a="http://schemas.openxmlformats.org/drawingml/2006/main">
               <a:ext uri="{FF2B5EF4-FFF2-40B4-BE49-F238E27FC236}">
-                <a16:creationId xmlns:a16="http://schemas.microsoft.com/office/drawing/2014/main" id="{60629A3E-A6BB-4BC8-8575-D98CC5415D9D}"/>
+                <a16:creationId xmlns:a16="http://schemas.microsoft.com/office/drawing/2014/main" id="{8934D15B-5600-41AB-A928-521385E45FC7}"/>
               </a:ext>
             </a:extLst>
           </p:cNvPr>
@@ -12138,7 +12138,7 @@
           <p:cNvPr id="15" name="">
             <a:extLst xmlns:a="http://schemas.openxmlformats.org/drawingml/2006/main">
               <a:ext uri="{FF2B5EF4-FFF2-40B4-BE49-F238E27FC236}">
-                <a16:creationId xmlns:a16="http://schemas.microsoft.com/office/drawing/2014/main" id="{85A89CB0-A778-421A-92C5-090C0B05143A}"/>
+                <a16:creationId xmlns:a16="http://schemas.microsoft.com/office/drawing/2014/main" id="{4234885C-E5CB-45CB-92DE-C50B58F2392A}"/>
               </a:ext>
             </a:extLst>
           </p:cNvPr>
@@ -12183,7 +12183,7 @@
           <p:cNvPr id="16" name="">
             <a:extLst xmlns:a="http://schemas.openxmlformats.org/drawingml/2006/main">
               <a:ext uri="{FF2B5EF4-FFF2-40B4-BE49-F238E27FC236}">
-                <a16:creationId xmlns:a16="http://schemas.microsoft.com/office/drawing/2014/main" id="{582178C8-7031-474A-9CBF-002D1C31359D}"/>
+                <a16:creationId xmlns:a16="http://schemas.microsoft.com/office/drawing/2014/main" id="{95C0AD0E-F04A-4D74-90AF-E44BC3338961}"/>
               </a:ext>
             </a:extLst>
           </p:cNvPr>
@@ -12228,7 +12228,7 @@
           <p:cNvPr id="17" name="">
             <a:extLst xmlns:a="http://schemas.openxmlformats.org/drawingml/2006/main">
               <a:ext uri="{FF2B5EF4-FFF2-40B4-BE49-F238E27FC236}">
-                <a16:creationId xmlns:a16="http://schemas.microsoft.com/office/drawing/2014/main" id="{C543C694-F642-4990-9B41-D48A122583C4}"/>
+                <a16:creationId xmlns:a16="http://schemas.microsoft.com/office/drawing/2014/main" id="{DC3628D6-78BE-4F87-B44E-20612B3DDF2B}"/>
               </a:ext>
             </a:extLst>
           </p:cNvPr>
@@ -12261,7 +12261,7 @@
           <p:cNvPr id="18" name="">
             <a:extLst xmlns:a="http://schemas.openxmlformats.org/drawingml/2006/main">
               <a:ext uri="{FF2B5EF4-FFF2-40B4-BE49-F238E27FC236}">
-                <a16:creationId xmlns:a16="http://schemas.microsoft.com/office/drawing/2014/main" id="{490F08C1-7059-4FB9-BA15-EBE7EE8C425D}"/>
+                <a16:creationId xmlns:a16="http://schemas.microsoft.com/office/drawing/2014/main" id="{F9B01E5D-642E-456A-A805-CF7C77B9994A}"/>
               </a:ext>
             </a:extLst>
           </p:cNvPr>
@@ -12306,7 +12306,7 @@
           <p:cNvPr id="19" name="">
             <a:extLst xmlns:a="http://schemas.openxmlformats.org/drawingml/2006/main">
               <a:ext uri="{FF2B5EF4-FFF2-40B4-BE49-F238E27FC236}">
-                <a16:creationId xmlns:a16="http://schemas.microsoft.com/office/drawing/2014/main" id="{56CD7B0D-B446-4AB3-9178-F623344B8437}"/>
+                <a16:creationId xmlns:a16="http://schemas.microsoft.com/office/drawing/2014/main" id="{DB57DC81-66E4-45E5-BB27-B703D8FBFBFA}"/>
               </a:ext>
             </a:extLst>
           </p:cNvPr>
@@ -12351,7 +12351,7 @@
           <p:cNvPr id="20" name="">
             <a:extLst xmlns:a="http://schemas.openxmlformats.org/drawingml/2006/main">
               <a:ext uri="{FF2B5EF4-FFF2-40B4-BE49-F238E27FC236}">
-                <a16:creationId xmlns:a16="http://schemas.microsoft.com/office/drawing/2014/main" id="{D69879A1-1D3C-4D71-832A-D210D8218C3C}"/>
+                <a16:creationId xmlns:a16="http://schemas.microsoft.com/office/drawing/2014/main" id="{4D9EF77C-7C7E-4A5A-B3E9-5190DD340A5A}"/>
               </a:ext>
             </a:extLst>
           </p:cNvPr>
@@ -12396,7 +12396,7 @@
           <p:cNvPr id="21" name="">
             <a:extLst xmlns:a="http://schemas.openxmlformats.org/drawingml/2006/main">
               <a:ext uri="{FF2B5EF4-FFF2-40B4-BE49-F238E27FC236}">
-                <a16:creationId xmlns:a16="http://schemas.microsoft.com/office/drawing/2014/main" id="{3E9B2A92-65FD-41AE-99C7-34E6F54BADD5}"/>
+                <a16:creationId xmlns:a16="http://schemas.microsoft.com/office/drawing/2014/main" id="{0547C900-0E24-4A93-97E3-2D99C4C6F3D9}"/>
               </a:ext>
             </a:extLst>
           </p:cNvPr>
@@ -12429,7 +12429,7 @@
           <p:cNvPr id="22" name="">
             <a:extLst xmlns:a="http://schemas.openxmlformats.org/drawingml/2006/main">
               <a:ext uri="{FF2B5EF4-FFF2-40B4-BE49-F238E27FC236}">
-                <a16:creationId xmlns:a16="http://schemas.microsoft.com/office/drawing/2014/main" id="{20174DBA-A235-4CE7-B9C8-19BC20714704}"/>
+                <a16:creationId xmlns:a16="http://schemas.microsoft.com/office/drawing/2014/main" id="{349B7A55-ADDE-42E7-9583-328C0D403C78}"/>
               </a:ext>
             </a:extLst>
           </p:cNvPr>
@@ -12474,7 +12474,7 @@
           <p:cNvPr id="23" name="">
             <a:extLst xmlns:a="http://schemas.openxmlformats.org/drawingml/2006/main">
               <a:ext uri="{FF2B5EF4-FFF2-40B4-BE49-F238E27FC236}">
-                <a16:creationId xmlns:a16="http://schemas.microsoft.com/office/drawing/2014/main" id="{CED10972-1B46-44DF-96AF-A82B96CD4219}"/>
+                <a16:creationId xmlns:a16="http://schemas.microsoft.com/office/drawing/2014/main" id="{6D6D3690-CDA0-4639-A285-101CFCC46220}"/>
               </a:ext>
             </a:extLst>
           </p:cNvPr>
@@ -12519,7 +12519,7 @@
           <p:cNvPr id="24" name="">
             <a:extLst xmlns:a="http://schemas.openxmlformats.org/drawingml/2006/main">
               <a:ext uri="{FF2B5EF4-FFF2-40B4-BE49-F238E27FC236}">
-                <a16:creationId xmlns:a16="http://schemas.microsoft.com/office/drawing/2014/main" id="{13E79894-24E2-462C-9BB7-9F51E35C868F}"/>
+                <a16:creationId xmlns:a16="http://schemas.microsoft.com/office/drawing/2014/main" id="{C4A7A322-58D4-4E09-A3FA-2F7047D280FE}"/>
               </a:ext>
             </a:extLst>
           </p:cNvPr>
@@ -12564,7 +12564,7 @@
           <p:cNvPr id="25" name="">
             <a:extLst xmlns:a="http://schemas.openxmlformats.org/drawingml/2006/main">
               <a:ext uri="{FF2B5EF4-FFF2-40B4-BE49-F238E27FC236}">
-                <a16:creationId xmlns:a16="http://schemas.microsoft.com/office/drawing/2014/main" id="{CBD17157-3F5C-4014-AC56-892391118FE9}"/>
+                <a16:creationId xmlns:a16="http://schemas.microsoft.com/office/drawing/2014/main" id="{7900E0F3-7D52-4528-A99B-FC2C6DC965B5}"/>
               </a:ext>
             </a:extLst>
           </p:cNvPr>
@@ -12597,7 +12597,7 @@
           <p:cNvPr id="26" name="">
             <a:extLst xmlns:a="http://schemas.openxmlformats.org/drawingml/2006/main">
               <a:ext uri="{FF2B5EF4-FFF2-40B4-BE49-F238E27FC236}">
-                <a16:creationId xmlns:a16="http://schemas.microsoft.com/office/drawing/2014/main" id="{BA49017F-E072-43F3-9F7D-52A0B094B6C7}"/>
+                <a16:creationId xmlns:a16="http://schemas.microsoft.com/office/drawing/2014/main" id="{34FF8F1A-8F7A-44B9-BDBC-CEE6D4041FFF}"/>
               </a:ext>
             </a:extLst>
           </p:cNvPr>
@@ -12642,7 +12642,7 @@
           <p:cNvPr id="27" name="">
             <a:extLst xmlns:a="http://schemas.openxmlformats.org/drawingml/2006/main">
               <a:ext uri="{FF2B5EF4-FFF2-40B4-BE49-F238E27FC236}">
-                <a16:creationId xmlns:a16="http://schemas.microsoft.com/office/drawing/2014/main" id="{EEB7682F-AD6F-4BFB-AE42-3631D80E1F03}"/>
+                <a16:creationId xmlns:a16="http://schemas.microsoft.com/office/drawing/2014/main" id="{CA1FE7F0-28D4-4F76-8DF7-46CABA0EADFD}"/>
               </a:ext>
             </a:extLst>
           </p:cNvPr>
@@ -12687,7 +12687,7 @@
           <p:cNvPr id="28" name="">
             <a:extLst xmlns:a="http://schemas.openxmlformats.org/drawingml/2006/main">
               <a:ext uri="{FF2B5EF4-FFF2-40B4-BE49-F238E27FC236}">
-                <a16:creationId xmlns:a16="http://schemas.microsoft.com/office/drawing/2014/main" id="{CDC22E72-42C4-4926-9514-A6690A7E61DE}"/>
+                <a16:creationId xmlns:a16="http://schemas.microsoft.com/office/drawing/2014/main" id="{18D93C5D-78A8-4CC9-B1E3-64B28DEEDC87}"/>
               </a:ext>
             </a:extLst>
           </p:cNvPr>
@@ -12732,7 +12732,7 @@
           <p:cNvPr id="29" name="footer-left">
             <a:extLst xmlns:a="http://schemas.openxmlformats.org/drawingml/2006/main">
               <a:ext uri="{FF2B5EF4-FFF2-40B4-BE49-F238E27FC236}">
-                <a16:creationId xmlns:a16="http://schemas.microsoft.com/office/drawing/2014/main" id="{F366A05E-00C1-46D5-8F40-68C00503CB5B}"/>
+                <a16:creationId xmlns:a16="http://schemas.microsoft.com/office/drawing/2014/main" id="{F1DC0F73-67F2-4C72-AA5F-3718E2A2F674}"/>
               </a:ext>
             </a:extLst>
           </p:cNvPr>
@@ -12777,7 +12777,7 @@
           <p:cNvPr id="30" name="footer-right">
             <a:extLst xmlns:a="http://schemas.openxmlformats.org/drawingml/2006/main">
               <a:ext uri="{FF2B5EF4-FFF2-40B4-BE49-F238E27FC236}">
-                <a16:creationId xmlns:a16="http://schemas.microsoft.com/office/drawing/2014/main" id="{673E1E2E-9BE7-4324-AA35-1B52406AA488}"/>
+                <a16:creationId xmlns:a16="http://schemas.microsoft.com/office/drawing/2014/main" id="{0B5800A3-25DF-45A2-8E7E-A3B5EED111C2}"/>
               </a:ext>
             </a:extLst>
           </p:cNvPr>
@@ -12820,7 +12820,7 @@
     </p:spTree>
     <p:extLst>
       <p:ext uri="{BB962C8B-B14F-4D97-AF65-F5344CB8AC3E}">
-        <p14:creationId xmlns:p14="http://schemas.microsoft.com/office/powerpoint/2010/main" val="460392954"/>
+        <p14:creationId xmlns:p14="http://schemas.microsoft.com/office/powerpoint/2010/main" val="1361070387"/>
       </p:ext>
     </p:extLst>
   </p:cSld>
@@ -12844,7 +12844,7 @@
           <p:cNvPr id="1" name="slide-stage">
             <a:extLst xmlns:a="http://schemas.openxmlformats.org/drawingml/2006/main">
               <a:ext uri="{FF2B5EF4-FFF2-40B4-BE49-F238E27FC236}">
-                <a16:creationId xmlns:a16="http://schemas.microsoft.com/office/drawing/2014/main" id="{66F3D3AF-4017-4224-896D-20672B788494}"/>
+                <a16:creationId xmlns:a16="http://schemas.microsoft.com/office/drawing/2014/main" id="{121D6E2C-186F-42A7-808A-051EEA83C44C}"/>
               </a:ext>
             </a:extLst>
           </p:cNvPr>
@@ -12871,7 +12871,7 @@
           <p:cNvPr id="2" name="eyebrow">
             <a:extLst xmlns:a="http://schemas.openxmlformats.org/drawingml/2006/main">
               <a:ext uri="{FF2B5EF4-FFF2-40B4-BE49-F238E27FC236}">
-                <a16:creationId xmlns:a16="http://schemas.microsoft.com/office/drawing/2014/main" id="{337A634C-60E3-4B35-887A-E1F1E4432931}"/>
+                <a16:creationId xmlns:a16="http://schemas.microsoft.com/office/drawing/2014/main" id="{38D11AE0-37DF-401E-888B-C37931B8C92A}"/>
               </a:ext>
             </a:extLst>
           </p:cNvPr>
@@ -12916,7 +12916,7 @@
           <p:cNvPr id="3" name="slide-title">
             <a:extLst xmlns:a="http://schemas.openxmlformats.org/drawingml/2006/main">
               <a:ext uri="{FF2B5EF4-FFF2-40B4-BE49-F238E27FC236}">
-                <a16:creationId xmlns:a16="http://schemas.microsoft.com/office/drawing/2014/main" id="{0DCC568D-357C-42CF-9EA6-B526E4426312}"/>
+                <a16:creationId xmlns:a16="http://schemas.microsoft.com/office/drawing/2014/main" id="{9419A003-7F9C-4D94-B136-B9E35D418E3C}"/>
               </a:ext>
             </a:extLst>
           </p:cNvPr>
@@ -12961,7 +12961,7 @@
           <p:cNvPr id="4" name="slide-subtitle">
             <a:extLst xmlns:a="http://schemas.openxmlformats.org/drawingml/2006/main">
               <a:ext uri="{FF2B5EF4-FFF2-40B4-BE49-F238E27FC236}">
-                <a16:creationId xmlns:a16="http://schemas.microsoft.com/office/drawing/2014/main" id="{E0D20908-38A0-4C22-8A61-9905DE36B042}"/>
+                <a16:creationId xmlns:a16="http://schemas.microsoft.com/office/drawing/2014/main" id="{C4FA3A7F-AC51-4AB7-AB8A-184C98B6FC63}"/>
               </a:ext>
             </a:extLst>
           </p:cNvPr>
@@ -13006,7 +13006,7 @@
           <p:cNvPr id="5" name="">
             <a:extLst xmlns:a="http://schemas.openxmlformats.org/drawingml/2006/main">
               <a:ext uri="{FF2B5EF4-FFF2-40B4-BE49-F238E27FC236}">
-                <a16:creationId xmlns:a16="http://schemas.microsoft.com/office/drawing/2014/main" id="{C7A4A19F-77EC-40AF-B6A3-688C703AE01D}"/>
+                <a16:creationId xmlns:a16="http://schemas.microsoft.com/office/drawing/2014/main" id="{65C570E7-F2E6-4A03-BC2F-9616ED98ECCB}"/>
               </a:ext>
             </a:extLst>
           </p:cNvPr>
@@ -13051,7 +13051,7 @@
           <p:cNvPr id="6" name="">
             <a:extLst xmlns:a="http://schemas.openxmlformats.org/drawingml/2006/main">
               <a:ext uri="{FF2B5EF4-FFF2-40B4-BE49-F238E27FC236}">
-                <a16:creationId xmlns:a16="http://schemas.microsoft.com/office/drawing/2014/main" id="{D911F026-BA0A-4F7B-8292-5FC8917D66A1}"/>
+                <a16:creationId xmlns:a16="http://schemas.microsoft.com/office/drawing/2014/main" id="{299D6410-02DE-4A3D-AC66-8758B6F9DEBE}"/>
               </a:ext>
             </a:extLst>
           </p:cNvPr>
@@ -13086,7 +13086,7 @@
           <p:cNvPr id="7" name="">
             <a:extLst xmlns:a="http://schemas.openxmlformats.org/drawingml/2006/main">
               <a:ext uri="{FF2B5EF4-FFF2-40B4-BE49-F238E27FC236}">
-                <a16:creationId xmlns:a16="http://schemas.microsoft.com/office/drawing/2014/main" id="{5233D477-5B25-4F5E-BA0E-3B5582856857}"/>
+                <a16:creationId xmlns:a16="http://schemas.microsoft.com/office/drawing/2014/main" id="{A34C177B-5998-4A4E-B2F1-5B296BE592E9}"/>
               </a:ext>
             </a:extLst>
           </p:cNvPr>
@@ -13131,7 +13131,7 @@
           <p:cNvPr id="8" name="">
             <a:extLst xmlns:a="http://schemas.openxmlformats.org/drawingml/2006/main">
               <a:ext uri="{FF2B5EF4-FFF2-40B4-BE49-F238E27FC236}">
-                <a16:creationId xmlns:a16="http://schemas.microsoft.com/office/drawing/2014/main" id="{9BB3818A-A0B8-472C-8946-731784DBE2E6}"/>
+                <a16:creationId xmlns:a16="http://schemas.microsoft.com/office/drawing/2014/main" id="{A0A54BB2-C421-481C-B122-43B42558CD88}"/>
               </a:ext>
             </a:extLst>
           </p:cNvPr>
@@ -13176,7 +13176,7 @@
           <p:cNvPr id="9" name="">
             <a:extLst xmlns:a="http://schemas.openxmlformats.org/drawingml/2006/main">
               <a:ext uri="{FF2B5EF4-FFF2-40B4-BE49-F238E27FC236}">
-                <a16:creationId xmlns:a16="http://schemas.microsoft.com/office/drawing/2014/main" id="{ACF15D20-0E84-45B2-A51C-30E209442032}"/>
+                <a16:creationId xmlns:a16="http://schemas.microsoft.com/office/drawing/2014/main" id="{E42264E5-8E39-484F-B555-1235FFD7094C}"/>
               </a:ext>
             </a:extLst>
           </p:cNvPr>
@@ -13221,7 +13221,7 @@
           <p:cNvPr id="10" name="">
             <a:extLst xmlns:a="http://schemas.openxmlformats.org/drawingml/2006/main">
               <a:ext uri="{FF2B5EF4-FFF2-40B4-BE49-F238E27FC236}">
-                <a16:creationId xmlns:a16="http://schemas.microsoft.com/office/drawing/2014/main" id="{FD29E174-E21D-4977-AFA5-9324C58C9B97}"/>
+                <a16:creationId xmlns:a16="http://schemas.microsoft.com/office/drawing/2014/main" id="{9A6A4875-4176-45AD-8CDE-20C1B0C36089}"/>
               </a:ext>
             </a:extLst>
           </p:cNvPr>
@@ -13256,7 +13256,7 @@
           <p:cNvPr id="11" name="">
             <a:extLst xmlns:a="http://schemas.openxmlformats.org/drawingml/2006/main">
               <a:ext uri="{FF2B5EF4-FFF2-40B4-BE49-F238E27FC236}">
-                <a16:creationId xmlns:a16="http://schemas.microsoft.com/office/drawing/2014/main" id="{36E216A5-A953-489E-BC69-80BDFFA558AD}"/>
+                <a16:creationId xmlns:a16="http://schemas.microsoft.com/office/drawing/2014/main" id="{A0F5ACA1-7476-4A2E-B643-091995660AF1}"/>
               </a:ext>
             </a:extLst>
           </p:cNvPr>
@@ -13301,7 +13301,7 @@
           <p:cNvPr id="12" name="">
             <a:extLst xmlns:a="http://schemas.openxmlformats.org/drawingml/2006/main">
               <a:ext uri="{FF2B5EF4-FFF2-40B4-BE49-F238E27FC236}">
-                <a16:creationId xmlns:a16="http://schemas.microsoft.com/office/drawing/2014/main" id="{125035BB-C0A4-49D4-B905-20C8F1622202}"/>
+                <a16:creationId xmlns:a16="http://schemas.microsoft.com/office/drawing/2014/main" id="{C2B7F0DB-06E4-48DE-AAF1-4266783B068A}"/>
               </a:ext>
             </a:extLst>
           </p:cNvPr>
@@ -13346,7 +13346,7 @@
           <p:cNvPr id="13" name="">
             <a:extLst xmlns:a="http://schemas.openxmlformats.org/drawingml/2006/main">
               <a:ext uri="{FF2B5EF4-FFF2-40B4-BE49-F238E27FC236}">
-                <a16:creationId xmlns:a16="http://schemas.microsoft.com/office/drawing/2014/main" id="{B4A0BEA4-8464-48C8-BC95-802E57CA0DA2}"/>
+                <a16:creationId xmlns:a16="http://schemas.microsoft.com/office/drawing/2014/main" id="{6A22717C-39A7-415D-A276-F773BD4E6F68}"/>
               </a:ext>
             </a:extLst>
           </p:cNvPr>
@@ -13391,7 +13391,7 @@
           <p:cNvPr id="14" name="">
             <a:extLst xmlns:a="http://schemas.openxmlformats.org/drawingml/2006/main">
               <a:ext uri="{FF2B5EF4-FFF2-40B4-BE49-F238E27FC236}">
-                <a16:creationId xmlns:a16="http://schemas.microsoft.com/office/drawing/2014/main" id="{1469443D-DDAC-418D-A66B-85357EAA2CAB}"/>
+                <a16:creationId xmlns:a16="http://schemas.microsoft.com/office/drawing/2014/main" id="{01C39FA4-28F1-4F9B-9BAC-DCA62933E279}"/>
               </a:ext>
             </a:extLst>
           </p:cNvPr>
@@ -13426,7 +13426,7 @@
           <p:cNvPr id="15" name="">
             <a:extLst xmlns:a="http://schemas.openxmlformats.org/drawingml/2006/main">
               <a:ext uri="{FF2B5EF4-FFF2-40B4-BE49-F238E27FC236}">
-                <a16:creationId xmlns:a16="http://schemas.microsoft.com/office/drawing/2014/main" id="{934CE117-0079-483A-9B39-F6650F3BCFF5}"/>
+                <a16:creationId xmlns:a16="http://schemas.microsoft.com/office/drawing/2014/main" id="{1D0DC7AA-53FC-488A-BAF0-C52D5FC5770A}"/>
               </a:ext>
             </a:extLst>
           </p:cNvPr>
@@ -13471,7 +13471,7 @@
           <p:cNvPr id="16" name="">
             <a:extLst xmlns:a="http://schemas.openxmlformats.org/drawingml/2006/main">
               <a:ext uri="{FF2B5EF4-FFF2-40B4-BE49-F238E27FC236}">
-                <a16:creationId xmlns:a16="http://schemas.microsoft.com/office/drawing/2014/main" id="{7227B23A-0318-4740-8029-DFD7CBFF9CB4}"/>
+                <a16:creationId xmlns:a16="http://schemas.microsoft.com/office/drawing/2014/main" id="{BB00F1E7-BEB0-436E-8A4C-01089FC48B1D}"/>
               </a:ext>
             </a:extLst>
           </p:cNvPr>
@@ -13516,7 +13516,7 @@
           <p:cNvPr id="17" name="">
             <a:extLst xmlns:a="http://schemas.openxmlformats.org/drawingml/2006/main">
               <a:ext uri="{FF2B5EF4-FFF2-40B4-BE49-F238E27FC236}">
-                <a16:creationId xmlns:a16="http://schemas.microsoft.com/office/drawing/2014/main" id="{47B0B97E-F9D8-47C4-85EC-C49C6925C0CB}"/>
+                <a16:creationId xmlns:a16="http://schemas.microsoft.com/office/drawing/2014/main" id="{2139EA21-7DBC-48F1-8F81-6CA000A82105}"/>
               </a:ext>
             </a:extLst>
           </p:cNvPr>
@@ -13561,7 +13561,7 @@
           <p:cNvPr id="18" name="">
             <a:extLst xmlns:a="http://schemas.openxmlformats.org/drawingml/2006/main">
               <a:ext uri="{FF2B5EF4-FFF2-40B4-BE49-F238E27FC236}">
-                <a16:creationId xmlns:a16="http://schemas.microsoft.com/office/drawing/2014/main" id="{C46A31B1-734F-4C50-A8F2-638BBDEBD3C0}"/>
+                <a16:creationId xmlns:a16="http://schemas.microsoft.com/office/drawing/2014/main" id="{FF86FC2C-87C9-4C1C-ADBD-2B57D6B92479}"/>
               </a:ext>
             </a:extLst>
           </p:cNvPr>
@@ -13596,7 +13596,7 @@
           <p:cNvPr id="19" name="">
             <a:extLst xmlns:a="http://schemas.openxmlformats.org/drawingml/2006/main">
               <a:ext uri="{FF2B5EF4-FFF2-40B4-BE49-F238E27FC236}">
-                <a16:creationId xmlns:a16="http://schemas.microsoft.com/office/drawing/2014/main" id="{97CC97B8-4D98-4D65-ACDB-F3FF81F785ED}"/>
+                <a16:creationId xmlns:a16="http://schemas.microsoft.com/office/drawing/2014/main" id="{3C522F25-78C2-45D4-A150-B2AA2322033F}"/>
               </a:ext>
             </a:extLst>
           </p:cNvPr>
@@ -13641,7 +13641,7 @@
           <p:cNvPr id="20" name="">
             <a:extLst xmlns:a="http://schemas.openxmlformats.org/drawingml/2006/main">
               <a:ext uri="{FF2B5EF4-FFF2-40B4-BE49-F238E27FC236}">
-                <a16:creationId xmlns:a16="http://schemas.microsoft.com/office/drawing/2014/main" id="{B768446C-7945-4BBD-B546-C5F3851B2222}"/>
+                <a16:creationId xmlns:a16="http://schemas.microsoft.com/office/drawing/2014/main" id="{BA513F26-CAC7-4B46-9DB0-C1000AF4AC48}"/>
               </a:ext>
             </a:extLst>
           </p:cNvPr>
@@ -13686,7 +13686,7 @@
           <p:cNvPr id="21" name="">
             <a:extLst xmlns:a="http://schemas.openxmlformats.org/drawingml/2006/main">
               <a:ext uri="{FF2B5EF4-FFF2-40B4-BE49-F238E27FC236}">
-                <a16:creationId xmlns:a16="http://schemas.microsoft.com/office/drawing/2014/main" id="{BE0D05EB-3F44-4B05-8528-FFB49F5AE3BE}"/>
+                <a16:creationId xmlns:a16="http://schemas.microsoft.com/office/drawing/2014/main" id="{5CD44723-BC40-4CEE-993D-FAF9CC4EA138}"/>
               </a:ext>
             </a:extLst>
           </p:cNvPr>
@@ -13731,7 +13731,7 @@
           <p:cNvPr id="22" name="">
             <a:extLst xmlns:a="http://schemas.openxmlformats.org/drawingml/2006/main">
               <a:ext uri="{FF2B5EF4-FFF2-40B4-BE49-F238E27FC236}">
-                <a16:creationId xmlns:a16="http://schemas.microsoft.com/office/drawing/2014/main" id="{339EDF7E-8BEE-4F3A-A60F-B4BF9FDB6640}"/>
+                <a16:creationId xmlns:a16="http://schemas.microsoft.com/office/drawing/2014/main" id="{AE7425BB-DF40-4188-9D20-79D5BF2F09FB}"/>
               </a:ext>
             </a:extLst>
           </p:cNvPr>
@@ -13766,7 +13766,7 @@
           <p:cNvPr id="23" name="">
             <a:extLst xmlns:a="http://schemas.openxmlformats.org/drawingml/2006/main">
               <a:ext uri="{FF2B5EF4-FFF2-40B4-BE49-F238E27FC236}">
-                <a16:creationId xmlns:a16="http://schemas.microsoft.com/office/drawing/2014/main" id="{02BCBE71-1658-463B-843A-00F236603A4F}"/>
+                <a16:creationId xmlns:a16="http://schemas.microsoft.com/office/drawing/2014/main" id="{4783A19C-023F-4497-B026-2C09755CD5B3}"/>
               </a:ext>
             </a:extLst>
           </p:cNvPr>
@@ -13811,7 +13811,7 @@
           <p:cNvPr id="24" name="">
             <a:extLst xmlns:a="http://schemas.openxmlformats.org/drawingml/2006/main">
               <a:ext uri="{FF2B5EF4-FFF2-40B4-BE49-F238E27FC236}">
-                <a16:creationId xmlns:a16="http://schemas.microsoft.com/office/drawing/2014/main" id="{FCC8995F-A49C-417C-BE27-3ABC3D05C899}"/>
+                <a16:creationId xmlns:a16="http://schemas.microsoft.com/office/drawing/2014/main" id="{95018670-BFFD-44C9-B87C-03B8373E3077}"/>
               </a:ext>
             </a:extLst>
           </p:cNvPr>
@@ -13856,7 +13856,7 @@
           <p:cNvPr id="25" name="footer-left">
             <a:extLst xmlns:a="http://schemas.openxmlformats.org/drawingml/2006/main">
               <a:ext uri="{FF2B5EF4-FFF2-40B4-BE49-F238E27FC236}">
-                <a16:creationId xmlns:a16="http://schemas.microsoft.com/office/drawing/2014/main" id="{5C60D63A-A66F-456B-B6A3-E3ECF595498C}"/>
+                <a16:creationId xmlns:a16="http://schemas.microsoft.com/office/drawing/2014/main" id="{36B1D4E8-7B35-4779-B859-367B6A931D22}"/>
               </a:ext>
             </a:extLst>
           </p:cNvPr>
@@ -13901,7 +13901,7 @@
           <p:cNvPr id="26" name="footer-right">
             <a:extLst xmlns:a="http://schemas.openxmlformats.org/drawingml/2006/main">
               <a:ext uri="{FF2B5EF4-FFF2-40B4-BE49-F238E27FC236}">
-                <a16:creationId xmlns:a16="http://schemas.microsoft.com/office/drawing/2014/main" id="{FB76E3B1-3E10-41D2-9F7E-3713F0E9B79E}"/>
+                <a16:creationId xmlns:a16="http://schemas.microsoft.com/office/drawing/2014/main" id="{E4CBB8B6-7757-47F9-BD40-969CE99C0C6E}"/>
               </a:ext>
             </a:extLst>
           </p:cNvPr>
@@ -13944,7 +13944,7 @@
     </p:spTree>
     <p:extLst>
       <p:ext uri="{BB962C8B-B14F-4D97-AF65-F5344CB8AC3E}">
-        <p14:creationId xmlns:p14="http://schemas.microsoft.com/office/powerpoint/2010/main" val="449734662"/>
+        <p14:creationId xmlns:p14="http://schemas.microsoft.com/office/powerpoint/2010/main" val="393817817"/>
       </p:ext>
     </p:extLst>
   </p:cSld>
@@ -13968,7 +13968,7 @@
           <p:cNvPr id="1" name="slide-stage">
             <a:extLst xmlns:a="http://schemas.openxmlformats.org/drawingml/2006/main">
               <a:ext uri="{FF2B5EF4-FFF2-40B4-BE49-F238E27FC236}">
-                <a16:creationId xmlns:a16="http://schemas.microsoft.com/office/drawing/2014/main" id="{8E70A715-BB81-41AA-BB0F-8E1E6FE2544E}"/>
+                <a16:creationId xmlns:a16="http://schemas.microsoft.com/office/drawing/2014/main" id="{11E784D9-C903-4C39-BFEB-AB15FCFA6FD0}"/>
               </a:ext>
             </a:extLst>
           </p:cNvPr>
@@ -13995,7 +13995,7 @@
           <p:cNvPr id="2" name="eyebrow">
             <a:extLst xmlns:a="http://schemas.openxmlformats.org/drawingml/2006/main">
               <a:ext uri="{FF2B5EF4-FFF2-40B4-BE49-F238E27FC236}">
-                <a16:creationId xmlns:a16="http://schemas.microsoft.com/office/drawing/2014/main" id="{5D400C23-B048-45DC-AFCD-FEA99AA7DA4D}"/>
+                <a16:creationId xmlns:a16="http://schemas.microsoft.com/office/drawing/2014/main" id="{761AFC41-D739-4E76-8A76-4F4A310E07BD}"/>
               </a:ext>
             </a:extLst>
           </p:cNvPr>
@@ -14040,7 +14040,7 @@
           <p:cNvPr id="3" name="slide-title">
             <a:extLst xmlns:a="http://schemas.openxmlformats.org/drawingml/2006/main">
               <a:ext uri="{FF2B5EF4-FFF2-40B4-BE49-F238E27FC236}">
-                <a16:creationId xmlns:a16="http://schemas.microsoft.com/office/drawing/2014/main" id="{BE07D584-9252-432E-B457-8DF35807AC0F}"/>
+                <a16:creationId xmlns:a16="http://schemas.microsoft.com/office/drawing/2014/main" id="{EC4AFC63-1DF9-4D6B-9703-B9224F0BC756}"/>
               </a:ext>
             </a:extLst>
           </p:cNvPr>
@@ -14085,7 +14085,7 @@
           <p:cNvPr id="4" name="slide-subtitle">
             <a:extLst xmlns:a="http://schemas.openxmlformats.org/drawingml/2006/main">
               <a:ext uri="{FF2B5EF4-FFF2-40B4-BE49-F238E27FC236}">
-                <a16:creationId xmlns:a16="http://schemas.microsoft.com/office/drawing/2014/main" id="{821AEAA8-B428-4EE6-90AC-76515894DAAD}"/>
+                <a16:creationId xmlns:a16="http://schemas.microsoft.com/office/drawing/2014/main" id="{51112165-97D1-4C26-8AEC-C42604CE683D}"/>
               </a:ext>
             </a:extLst>
           </p:cNvPr>
@@ -14130,7 +14130,7 @@
           <p:cNvPr id="5" name="">
             <a:extLst xmlns:a="http://schemas.openxmlformats.org/drawingml/2006/main">
               <a:ext uri="{FF2B5EF4-FFF2-40B4-BE49-F238E27FC236}">
-                <a16:creationId xmlns:a16="http://schemas.microsoft.com/office/drawing/2014/main" id="{E4E66F25-DA57-44A4-9892-DD8C7B2BBD57}"/>
+                <a16:creationId xmlns:a16="http://schemas.microsoft.com/office/drawing/2014/main" id="{C34397B3-AA02-4B15-B125-718F06A10D83}"/>
               </a:ext>
             </a:extLst>
           </p:cNvPr>
@@ -14163,7 +14163,7 @@
           <p:cNvPr id="6" name="">
             <a:extLst xmlns:a="http://schemas.openxmlformats.org/drawingml/2006/main">
               <a:ext uri="{FF2B5EF4-FFF2-40B4-BE49-F238E27FC236}">
-                <a16:creationId xmlns:a16="http://schemas.microsoft.com/office/drawing/2014/main" id="{0F3EF78D-7308-4307-ABB3-123D3E3BC4E3}"/>
+                <a16:creationId xmlns:a16="http://schemas.microsoft.com/office/drawing/2014/main" id="{00993B8D-566B-40FC-832E-3B8184C468FB}"/>
               </a:ext>
             </a:extLst>
           </p:cNvPr>
@@ -14208,7 +14208,7 @@
           <p:cNvPr id="7" name="">
             <a:extLst xmlns:a="http://schemas.openxmlformats.org/drawingml/2006/main">
               <a:ext uri="{FF2B5EF4-FFF2-40B4-BE49-F238E27FC236}">
-                <a16:creationId xmlns:a16="http://schemas.microsoft.com/office/drawing/2014/main" id="{4E9725AF-966B-4835-A3CD-92EE3D18101A}"/>
+                <a16:creationId xmlns:a16="http://schemas.microsoft.com/office/drawing/2014/main" id="{AC4C5D0A-965E-4AEA-948D-9DCA4990812A}"/>
               </a:ext>
             </a:extLst>
           </p:cNvPr>
@@ -14253,7 +14253,7 @@
           <p:cNvPr id="8" name="">
             <a:extLst xmlns:a="http://schemas.openxmlformats.org/drawingml/2006/main">
               <a:ext uri="{FF2B5EF4-FFF2-40B4-BE49-F238E27FC236}">
-                <a16:creationId xmlns:a16="http://schemas.microsoft.com/office/drawing/2014/main" id="{192273B9-5800-49FF-BBC3-92FA9CF6391C}"/>
+                <a16:creationId xmlns:a16="http://schemas.microsoft.com/office/drawing/2014/main" id="{04B08A04-C2AE-4222-BE8C-6E9D3BBD3EC4}"/>
               </a:ext>
             </a:extLst>
           </p:cNvPr>
@@ -14286,7 +14286,7 @@
           <p:cNvPr id="9" name="">
             <a:extLst xmlns:a="http://schemas.openxmlformats.org/drawingml/2006/main">
               <a:ext uri="{FF2B5EF4-FFF2-40B4-BE49-F238E27FC236}">
-                <a16:creationId xmlns:a16="http://schemas.microsoft.com/office/drawing/2014/main" id="{8D47BF81-BD88-4A75-BA0D-7B33300665B5}"/>
+                <a16:creationId xmlns:a16="http://schemas.microsoft.com/office/drawing/2014/main" id="{D4E3ABDF-FAFB-4F72-B9F8-E9A1F1DA39FA}"/>
               </a:ext>
             </a:extLst>
           </p:cNvPr>
@@ -14331,7 +14331,7 @@
           <p:cNvPr id="10" name="">
             <a:extLst xmlns:a="http://schemas.openxmlformats.org/drawingml/2006/main">
               <a:ext uri="{FF2B5EF4-FFF2-40B4-BE49-F238E27FC236}">
-                <a16:creationId xmlns:a16="http://schemas.microsoft.com/office/drawing/2014/main" id="{967B4C41-E1DE-4D6B-9D13-D59951526ABE}"/>
+                <a16:creationId xmlns:a16="http://schemas.microsoft.com/office/drawing/2014/main" id="{6459A15B-6100-4627-9300-5790E800C077}"/>
               </a:ext>
             </a:extLst>
           </p:cNvPr>
@@ -14376,7 +14376,7 @@
           <p:cNvPr id="11" name="">
             <a:extLst xmlns:a="http://schemas.openxmlformats.org/drawingml/2006/main">
               <a:ext uri="{FF2B5EF4-FFF2-40B4-BE49-F238E27FC236}">
-                <a16:creationId xmlns:a16="http://schemas.microsoft.com/office/drawing/2014/main" id="{C67A59C7-0AE9-4848-98F7-2C48273909CA}"/>
+                <a16:creationId xmlns:a16="http://schemas.microsoft.com/office/drawing/2014/main" id="{A6BAC9A2-AD21-421E-B87E-F0BF905E3B70}"/>
               </a:ext>
             </a:extLst>
           </p:cNvPr>
@@ -14409,7 +14409,7 @@
           <p:cNvPr id="12" name="">
             <a:extLst xmlns:a="http://schemas.openxmlformats.org/drawingml/2006/main">
               <a:ext uri="{FF2B5EF4-FFF2-40B4-BE49-F238E27FC236}">
-                <a16:creationId xmlns:a16="http://schemas.microsoft.com/office/drawing/2014/main" id="{756FA7F1-A697-4E7E-9AB7-BB9F2ECA6552}"/>
+                <a16:creationId xmlns:a16="http://schemas.microsoft.com/office/drawing/2014/main" id="{7038FD3F-64DA-461D-973C-BF3B64F2A33B}"/>
               </a:ext>
             </a:extLst>
           </p:cNvPr>
@@ -14454,7 +14454,7 @@
           <p:cNvPr id="13" name="">
             <a:extLst xmlns:a="http://schemas.openxmlformats.org/drawingml/2006/main">
               <a:ext uri="{FF2B5EF4-FFF2-40B4-BE49-F238E27FC236}">
-                <a16:creationId xmlns:a16="http://schemas.microsoft.com/office/drawing/2014/main" id="{B9138D6F-EA05-4C98-A51E-5F7563C31DE4}"/>
+                <a16:creationId xmlns:a16="http://schemas.microsoft.com/office/drawing/2014/main" id="{334979CB-9AF0-4932-AC00-EF3A5A747F14}"/>
               </a:ext>
             </a:extLst>
           </p:cNvPr>
@@ -14499,7 +14499,7 @@
           <p:cNvPr id="14" name="">
             <a:extLst xmlns:a="http://schemas.openxmlformats.org/drawingml/2006/main">
               <a:ext uri="{FF2B5EF4-FFF2-40B4-BE49-F238E27FC236}">
-                <a16:creationId xmlns:a16="http://schemas.microsoft.com/office/drawing/2014/main" id="{6ACD8EC6-7AAB-4128-98AA-155771A878B0}"/>
+                <a16:creationId xmlns:a16="http://schemas.microsoft.com/office/drawing/2014/main" id="{63B13E70-F4F3-4954-A2BE-EE6D8AF1392A}"/>
               </a:ext>
             </a:extLst>
           </p:cNvPr>
@@ -14532,7 +14532,7 @@
           <p:cNvPr id="15" name="">
             <a:extLst xmlns:a="http://schemas.openxmlformats.org/drawingml/2006/main">
               <a:ext uri="{FF2B5EF4-FFF2-40B4-BE49-F238E27FC236}">
-                <a16:creationId xmlns:a16="http://schemas.microsoft.com/office/drawing/2014/main" id="{6064C6F8-A2E8-4673-A9FE-B316DFA47D7C}"/>
+                <a16:creationId xmlns:a16="http://schemas.microsoft.com/office/drawing/2014/main" id="{DDAED00E-B4E4-458C-8E47-3F2E892DFEA7}"/>
               </a:ext>
             </a:extLst>
           </p:cNvPr>
@@ -14577,7 +14577,7 @@
           <p:cNvPr id="16" name="">
             <a:extLst xmlns:a="http://schemas.openxmlformats.org/drawingml/2006/main">
               <a:ext uri="{FF2B5EF4-FFF2-40B4-BE49-F238E27FC236}">
-                <a16:creationId xmlns:a16="http://schemas.microsoft.com/office/drawing/2014/main" id="{15FBAAF9-AB23-4BA7-AFC9-4F863DCE5B19}"/>
+                <a16:creationId xmlns:a16="http://schemas.microsoft.com/office/drawing/2014/main" id="{6752C6CB-B90B-4D07-8327-BB025A87664C}"/>
               </a:ext>
             </a:extLst>
           </p:cNvPr>
@@ -14622,7 +14622,7 @@
           <p:cNvPr id="17" name="footer-left">
             <a:extLst xmlns:a="http://schemas.openxmlformats.org/drawingml/2006/main">
               <a:ext uri="{FF2B5EF4-FFF2-40B4-BE49-F238E27FC236}">
-                <a16:creationId xmlns:a16="http://schemas.microsoft.com/office/drawing/2014/main" id="{2B821AC5-79CE-4924-A339-585D2FC56030}"/>
+                <a16:creationId xmlns:a16="http://schemas.microsoft.com/office/drawing/2014/main" id="{3C9819A6-96AB-4EF7-8E23-475F83FE954A}"/>
               </a:ext>
             </a:extLst>
           </p:cNvPr>
@@ -14667,7 +14667,7 @@
           <p:cNvPr id="18" name="footer-right">
             <a:extLst xmlns:a="http://schemas.openxmlformats.org/drawingml/2006/main">
               <a:ext uri="{FF2B5EF4-FFF2-40B4-BE49-F238E27FC236}">
-                <a16:creationId xmlns:a16="http://schemas.microsoft.com/office/drawing/2014/main" id="{528678F5-745B-4AF7-8DAE-6D48C5BBA13D}"/>
+                <a16:creationId xmlns:a16="http://schemas.microsoft.com/office/drawing/2014/main" id="{D5DDE8EA-D25E-4735-80BB-E8D2D738BB45}"/>
               </a:ext>
             </a:extLst>
           </p:cNvPr>
@@ -14710,7 +14710,7 @@
     </p:spTree>
     <p:extLst>
       <p:ext uri="{BB962C8B-B14F-4D97-AF65-F5344CB8AC3E}">
-        <p14:creationId xmlns:p14="http://schemas.microsoft.com/office/powerpoint/2010/main" val="70564107"/>
+        <p14:creationId xmlns:p14="http://schemas.microsoft.com/office/powerpoint/2010/main" val="1520830265"/>
       </p:ext>
     </p:extLst>
   </p:cSld>
@@ -14734,7 +14734,7 @@
           <p:cNvPr id="1" name="slide-stage">
             <a:extLst xmlns:a="http://schemas.openxmlformats.org/drawingml/2006/main">
               <a:ext uri="{FF2B5EF4-FFF2-40B4-BE49-F238E27FC236}">
-                <a16:creationId xmlns:a16="http://schemas.microsoft.com/office/drawing/2014/main" id="{C15F07C4-2D71-4A0A-9099-5987097DC34E}"/>
+                <a16:creationId xmlns:a16="http://schemas.microsoft.com/office/drawing/2014/main" id="{61D71293-E08B-486A-9DFE-2D9FC96251FA}"/>
               </a:ext>
             </a:extLst>
           </p:cNvPr>
@@ -14761,7 +14761,7 @@
           <p:cNvPr id="2" name="eyebrow">
             <a:extLst xmlns:a="http://schemas.openxmlformats.org/drawingml/2006/main">
               <a:ext uri="{FF2B5EF4-FFF2-40B4-BE49-F238E27FC236}">
-                <a16:creationId xmlns:a16="http://schemas.microsoft.com/office/drawing/2014/main" id="{3E175620-5B43-4A39-8939-132D86100DC3}"/>
+                <a16:creationId xmlns:a16="http://schemas.microsoft.com/office/drawing/2014/main" id="{6DF1B0C7-BB4B-45E7-ABA3-3B9A4128A9B0}"/>
               </a:ext>
             </a:extLst>
           </p:cNvPr>
@@ -14806,7 +14806,7 @@
           <p:cNvPr id="3" name="slide-title">
             <a:extLst xmlns:a="http://schemas.openxmlformats.org/drawingml/2006/main">
               <a:ext uri="{FF2B5EF4-FFF2-40B4-BE49-F238E27FC236}">
-                <a16:creationId xmlns:a16="http://schemas.microsoft.com/office/drawing/2014/main" id="{8A26EFFE-4278-4999-A2B7-60941A711CE3}"/>
+                <a16:creationId xmlns:a16="http://schemas.microsoft.com/office/drawing/2014/main" id="{7356C249-C67A-4940-ACBB-EF1D4A82DCAC}"/>
               </a:ext>
             </a:extLst>
           </p:cNvPr>
@@ -14851,7 +14851,7 @@
           <p:cNvPr id="4" name="slide-subtitle">
             <a:extLst xmlns:a="http://schemas.openxmlformats.org/drawingml/2006/main">
               <a:ext uri="{FF2B5EF4-FFF2-40B4-BE49-F238E27FC236}">
-                <a16:creationId xmlns:a16="http://schemas.microsoft.com/office/drawing/2014/main" id="{2AFC0D92-43DC-41A5-8F8B-F5ACE49F05A1}"/>
+                <a16:creationId xmlns:a16="http://schemas.microsoft.com/office/drawing/2014/main" id="{2D72A8A1-92A6-4BDC-8E9B-4C50EA887747}"/>
               </a:ext>
             </a:extLst>
           </p:cNvPr>
@@ -14896,7 +14896,7 @@
           <p:cNvPr id="5" name="">
             <a:extLst xmlns:a="http://schemas.openxmlformats.org/drawingml/2006/main">
               <a:ext uri="{FF2B5EF4-FFF2-40B4-BE49-F238E27FC236}">
-                <a16:creationId xmlns:a16="http://schemas.microsoft.com/office/drawing/2014/main" id="{B408C89E-2F26-4FA0-884B-46034C9291BE}"/>
+                <a16:creationId xmlns:a16="http://schemas.microsoft.com/office/drawing/2014/main" id="{5017CED2-38FA-4593-8953-F9EF153025A5}"/>
               </a:ext>
             </a:extLst>
           </p:cNvPr>
@@ -14941,7 +14941,7 @@
           <p:cNvPr id="6" name="">
             <a:extLst xmlns:a="http://schemas.openxmlformats.org/drawingml/2006/main">
               <a:ext uri="{FF2B5EF4-FFF2-40B4-BE49-F238E27FC236}">
-                <a16:creationId xmlns:a16="http://schemas.microsoft.com/office/drawing/2014/main" id="{6108FB01-D831-437B-AA3B-82D0AA860104}"/>
+                <a16:creationId xmlns:a16="http://schemas.microsoft.com/office/drawing/2014/main" id="{702BBC8E-3B9A-46D6-80FB-551AA36EA9D0}"/>
               </a:ext>
             </a:extLst>
           </p:cNvPr>
@@ -14986,7 +14986,7 @@
           <p:cNvPr id="7" name="">
             <a:extLst xmlns:a="http://schemas.openxmlformats.org/drawingml/2006/main">
               <a:ext uri="{FF2B5EF4-FFF2-40B4-BE49-F238E27FC236}">
-                <a16:creationId xmlns:a16="http://schemas.microsoft.com/office/drawing/2014/main" id="{CB13C3D3-E3A0-4E23-A141-ED9B2BE8FCBB}"/>
+                <a16:creationId xmlns:a16="http://schemas.microsoft.com/office/drawing/2014/main" id="{2909ADD9-9EC6-41FA-8F9D-800F7B259494}"/>
               </a:ext>
             </a:extLst>
           </p:cNvPr>
@@ -15031,7 +15031,7 @@
           <p:cNvPr id="8" name="">
             <a:extLst xmlns:a="http://schemas.openxmlformats.org/drawingml/2006/main">
               <a:ext uri="{FF2B5EF4-FFF2-40B4-BE49-F238E27FC236}">
-                <a16:creationId xmlns:a16="http://schemas.microsoft.com/office/drawing/2014/main" id="{D55386BA-545E-4EEE-B3C8-3E657668C7A3}"/>
+                <a16:creationId xmlns:a16="http://schemas.microsoft.com/office/drawing/2014/main" id="{84CDA97C-9A33-48B4-A778-46DB28BC4818}"/>
               </a:ext>
             </a:extLst>
           </p:cNvPr>
@@ -15076,7 +15076,7 @@
           <p:cNvPr id="9" name="">
             <a:extLst xmlns:a="http://schemas.openxmlformats.org/drawingml/2006/main">
               <a:ext uri="{FF2B5EF4-FFF2-40B4-BE49-F238E27FC236}">
-                <a16:creationId xmlns:a16="http://schemas.microsoft.com/office/drawing/2014/main" id="{6861E548-B893-49F0-BECF-A3C0D9030B31}"/>
+                <a16:creationId xmlns:a16="http://schemas.microsoft.com/office/drawing/2014/main" id="{1D0C2C6D-88DE-487A-922B-5DE0D7BC0CA2}"/>
               </a:ext>
             </a:extLst>
           </p:cNvPr>
@@ -15121,7 +15121,7 @@
           <p:cNvPr id="10" name="">
             <a:extLst xmlns:a="http://schemas.openxmlformats.org/drawingml/2006/main">
               <a:ext uri="{FF2B5EF4-FFF2-40B4-BE49-F238E27FC236}">
-                <a16:creationId xmlns:a16="http://schemas.microsoft.com/office/drawing/2014/main" id="{070D2A01-4E45-449B-B8F4-2D1EB1D3851E}"/>
+                <a16:creationId xmlns:a16="http://schemas.microsoft.com/office/drawing/2014/main" id="{7ED61776-4ECB-4D0F-AEB2-43CAF55B1084}"/>
               </a:ext>
             </a:extLst>
           </p:cNvPr>
@@ -15166,7 +15166,7 @@
           <p:cNvPr id="11" name="">
             <a:extLst xmlns:a="http://schemas.openxmlformats.org/drawingml/2006/main">
               <a:ext uri="{FF2B5EF4-FFF2-40B4-BE49-F238E27FC236}">
-                <a16:creationId xmlns:a16="http://schemas.microsoft.com/office/drawing/2014/main" id="{DF073EA6-7E34-4A0E-BAEE-D754E1F3B147}"/>
+                <a16:creationId xmlns:a16="http://schemas.microsoft.com/office/drawing/2014/main" id="{2D5B9B03-9CDC-4DCD-A2AA-F413AD7F5437}"/>
               </a:ext>
             </a:extLst>
           </p:cNvPr>
@@ -15201,7 +15201,7 @@
           <p:cNvPr id="12" name="">
             <a:extLst xmlns:a="http://schemas.openxmlformats.org/drawingml/2006/main">
               <a:ext uri="{FF2B5EF4-FFF2-40B4-BE49-F238E27FC236}">
-                <a16:creationId xmlns:a16="http://schemas.microsoft.com/office/drawing/2014/main" id="{8FD7564D-DF1D-430A-BCF9-9F5B330C4196}"/>
+                <a16:creationId xmlns:a16="http://schemas.microsoft.com/office/drawing/2014/main" id="{B4D2AD11-6BCA-46B2-9E36-1586A4AC9732}"/>
               </a:ext>
             </a:extLst>
           </p:cNvPr>
@@ -15236,7 +15236,7 @@
                   <a:srgbClr val="08756F"/>
                 </a:solidFill>
               </a:rPr>
-              <a:t>332 tests passed</a:t>
+              <a:t>333 tests passed</a:t>
             </a:r>
           </a:p>
         </p:txBody>
@@ -15246,7 +15246,7 @@
           <p:cNvPr id="13" name="">
             <a:extLst xmlns:a="http://schemas.openxmlformats.org/drawingml/2006/main">
               <a:ext uri="{FF2B5EF4-FFF2-40B4-BE49-F238E27FC236}">
-                <a16:creationId xmlns:a16="http://schemas.microsoft.com/office/drawing/2014/main" id="{E80AE697-A026-4435-86EF-CEAFF51892DE}"/>
+                <a16:creationId xmlns:a16="http://schemas.microsoft.com/office/drawing/2014/main" id="{5B9AD954-4BC6-4900-B330-151A5841021B}"/>
               </a:ext>
             </a:extLst>
           </p:cNvPr>
@@ -15281,7 +15281,7 @@
           <p:cNvPr id="14" name="">
             <a:extLst xmlns:a="http://schemas.openxmlformats.org/drawingml/2006/main">
               <a:ext uri="{FF2B5EF4-FFF2-40B4-BE49-F238E27FC236}">
-                <a16:creationId xmlns:a16="http://schemas.microsoft.com/office/drawing/2014/main" id="{0358B8A6-F2CD-4238-82AB-B1AE1BD75768}"/>
+                <a16:creationId xmlns:a16="http://schemas.microsoft.com/office/drawing/2014/main" id="{4C394A76-A492-43F7-BB02-53B3B4820AE3}"/>
               </a:ext>
             </a:extLst>
           </p:cNvPr>
@@ -15326,7 +15326,7 @@
           <p:cNvPr id="15" name="">
             <a:extLst xmlns:a="http://schemas.openxmlformats.org/drawingml/2006/main">
               <a:ext uri="{FF2B5EF4-FFF2-40B4-BE49-F238E27FC236}">
-                <a16:creationId xmlns:a16="http://schemas.microsoft.com/office/drawing/2014/main" id="{4971C1D0-3AD4-443F-B9F4-3B4122D5C26B}"/>
+                <a16:creationId xmlns:a16="http://schemas.microsoft.com/office/drawing/2014/main" id="{98E4FD3D-85C2-4071-8272-F83077E0CAB7}"/>
               </a:ext>
             </a:extLst>
           </p:cNvPr>
@@ -15361,7 +15361,7 @@
           <p:cNvPr id="16" name="">
             <a:extLst xmlns:a="http://schemas.openxmlformats.org/drawingml/2006/main">
               <a:ext uri="{FF2B5EF4-FFF2-40B4-BE49-F238E27FC236}">
-                <a16:creationId xmlns:a16="http://schemas.microsoft.com/office/drawing/2014/main" id="{CFFAC275-7761-412C-A5B4-2F3A6F9350B1}"/>
+                <a16:creationId xmlns:a16="http://schemas.microsoft.com/office/drawing/2014/main" id="{5C36FE37-66E8-4CFF-B23A-20DD8F8B28F2}"/>
               </a:ext>
             </a:extLst>
           </p:cNvPr>
@@ -15406,7 +15406,7 @@
           <p:cNvPr id="17" name="footer-left">
             <a:extLst xmlns:a="http://schemas.openxmlformats.org/drawingml/2006/main">
               <a:ext uri="{FF2B5EF4-FFF2-40B4-BE49-F238E27FC236}">
-                <a16:creationId xmlns:a16="http://schemas.microsoft.com/office/drawing/2014/main" id="{C81A74EB-190E-4B32-8821-35D0F1785494}"/>
+                <a16:creationId xmlns:a16="http://schemas.microsoft.com/office/drawing/2014/main" id="{56DA161A-B179-4E65-8940-B9A223F0E159}"/>
               </a:ext>
             </a:extLst>
           </p:cNvPr>
@@ -15451,7 +15451,7 @@
           <p:cNvPr id="18" name="footer-right">
             <a:extLst xmlns:a="http://schemas.openxmlformats.org/drawingml/2006/main">
               <a:ext uri="{FF2B5EF4-FFF2-40B4-BE49-F238E27FC236}">
-                <a16:creationId xmlns:a16="http://schemas.microsoft.com/office/drawing/2014/main" id="{779B47CC-D49C-4C8E-8B59-F0AA474C6B94}"/>
+                <a16:creationId xmlns:a16="http://schemas.microsoft.com/office/drawing/2014/main" id="{4B9EA37B-5E76-41CA-B0E5-B12E1CDD21BC}"/>
               </a:ext>
             </a:extLst>
           </p:cNvPr>
@@ -15494,7 +15494,7 @@
     </p:spTree>
     <p:extLst>
       <p:ext uri="{BB962C8B-B14F-4D97-AF65-F5344CB8AC3E}">
-        <p14:creationId xmlns:p14="http://schemas.microsoft.com/office/powerpoint/2010/main" val="1589603711"/>
+        <p14:creationId xmlns:p14="http://schemas.microsoft.com/office/powerpoint/2010/main" val="2052081262"/>
       </p:ext>
     </p:extLst>
   </p:cSld>

</xml_diff>

<commit_message>
Add input coverage audit
</commit_message>
<xml_diff>
--- a/decks/clinsafer-interview-demo/output/output.pptx
+++ b/decks/clinsafer-interview-demo/output/output.pptx
@@ -2,28 +2,28 @@
 <file path=ppt/presentation.xml><?xml version="1.0" encoding="utf-8"?>
 <p:presentation xmlns:p="http://schemas.openxmlformats.org/presentationml/2006/main">
   <p:sldMasterIdLst>
-    <p:sldMasterId xmlns:r="http://schemas.openxmlformats.org/officeDocument/2006/relationships" id="2147483648" r:id="R3596b55194524504"/>
+    <p:sldMasterId xmlns:r="http://schemas.openxmlformats.org/officeDocument/2006/relationships" id="2147483648" r:id="R30792f44d48e4db5"/>
   </p:sldMasterIdLst>
   <p:notesMasterIdLst>
-    <p:notesMasterId xmlns:r="http://schemas.openxmlformats.org/officeDocument/2006/relationships" r:id="R932d9ce007984ae7"/>
+    <p:notesMasterId xmlns:r="http://schemas.openxmlformats.org/officeDocument/2006/relationships" r:id="R2acac280b647457f"/>
   </p:notesMasterIdLst>
   <p:sldIdLst>
-    <p:sldId xmlns:r="http://schemas.openxmlformats.org/officeDocument/2006/relationships" id="256" r:id="R5e26830b296a42ed"/>
-    <p:sldId xmlns:r="http://schemas.openxmlformats.org/officeDocument/2006/relationships" id="257" r:id="R00c7b79bc3474066"/>
-    <p:sldId xmlns:r="http://schemas.openxmlformats.org/officeDocument/2006/relationships" id="258" r:id="Rcbc8e64d0c6b4dd7"/>
-    <p:sldId xmlns:r="http://schemas.openxmlformats.org/officeDocument/2006/relationships" id="259" r:id="Rc07c1aef5ca34c6b"/>
-    <p:sldId xmlns:r="http://schemas.openxmlformats.org/officeDocument/2006/relationships" id="260" r:id="Ra2603d15721348ae"/>
-    <p:sldId xmlns:r="http://schemas.openxmlformats.org/officeDocument/2006/relationships" id="261" r:id="Rcd130ecd5f34446d"/>
-    <p:sldId xmlns:r="http://schemas.openxmlformats.org/officeDocument/2006/relationships" id="262" r:id="R8eda9ab6ebff4b11"/>
-    <p:sldId xmlns:r="http://schemas.openxmlformats.org/officeDocument/2006/relationships" id="263" r:id="Re7c72a99ea844982"/>
-    <p:sldId xmlns:r="http://schemas.openxmlformats.org/officeDocument/2006/relationships" id="264" r:id="Rc600ea8b1be94305"/>
-    <p:sldId xmlns:r="http://schemas.openxmlformats.org/officeDocument/2006/relationships" id="265" r:id="R0ca0e816877c4c57"/>
-    <p:sldId xmlns:r="http://schemas.openxmlformats.org/officeDocument/2006/relationships" id="266" r:id="R68b9949b64834606"/>
-    <p:sldId xmlns:r="http://schemas.openxmlformats.org/officeDocument/2006/relationships" id="267" r:id="R34f9abaf12a0417c"/>
-    <p:sldId xmlns:r="http://schemas.openxmlformats.org/officeDocument/2006/relationships" id="268" r:id="R8afab2cf80e945cc"/>
-    <p:sldId xmlns:r="http://schemas.openxmlformats.org/officeDocument/2006/relationships" id="269" r:id="R7b8a9f83d6564b34"/>
-    <p:sldId xmlns:r="http://schemas.openxmlformats.org/officeDocument/2006/relationships" id="270" r:id="R6aac4e82d89b4d60"/>
-    <p:sldId xmlns:r="http://schemas.openxmlformats.org/officeDocument/2006/relationships" id="271" r:id="Rba960ab6c48b4abe"/>
+    <p:sldId xmlns:r="http://schemas.openxmlformats.org/officeDocument/2006/relationships" id="256" r:id="R8d6b89053b524b6b"/>
+    <p:sldId xmlns:r="http://schemas.openxmlformats.org/officeDocument/2006/relationships" id="257" r:id="R1b7a1fbdf9a24d67"/>
+    <p:sldId xmlns:r="http://schemas.openxmlformats.org/officeDocument/2006/relationships" id="258" r:id="Rc8310eb544264791"/>
+    <p:sldId xmlns:r="http://schemas.openxmlformats.org/officeDocument/2006/relationships" id="259" r:id="R15089ea6497f43f4"/>
+    <p:sldId xmlns:r="http://schemas.openxmlformats.org/officeDocument/2006/relationships" id="260" r:id="R9be3fa7f55ef44b2"/>
+    <p:sldId xmlns:r="http://schemas.openxmlformats.org/officeDocument/2006/relationships" id="261" r:id="R698c26104fad4f85"/>
+    <p:sldId xmlns:r="http://schemas.openxmlformats.org/officeDocument/2006/relationships" id="262" r:id="Rda2c3b63f61b430e"/>
+    <p:sldId xmlns:r="http://schemas.openxmlformats.org/officeDocument/2006/relationships" id="263" r:id="R7eb85b06fc6d4fbe"/>
+    <p:sldId xmlns:r="http://schemas.openxmlformats.org/officeDocument/2006/relationships" id="264" r:id="R20008c99ea384e07"/>
+    <p:sldId xmlns:r="http://schemas.openxmlformats.org/officeDocument/2006/relationships" id="265" r:id="R750ba3b28b5048e8"/>
+    <p:sldId xmlns:r="http://schemas.openxmlformats.org/officeDocument/2006/relationships" id="266" r:id="R68c5038c80234835"/>
+    <p:sldId xmlns:r="http://schemas.openxmlformats.org/officeDocument/2006/relationships" id="267" r:id="R76ddb4f8e0a0418d"/>
+    <p:sldId xmlns:r="http://schemas.openxmlformats.org/officeDocument/2006/relationships" id="268" r:id="R42584fab7a87419e"/>
+    <p:sldId xmlns:r="http://schemas.openxmlformats.org/officeDocument/2006/relationships" id="269" r:id="R7fd2ff7e30854f2f"/>
+    <p:sldId xmlns:r="http://schemas.openxmlformats.org/officeDocument/2006/relationships" id="270" r:id="R7a0bcd8db9c44c41"/>
+    <p:sldId xmlns:r="http://schemas.openxmlformats.org/officeDocument/2006/relationships" id="271" r:id="Rcdeab7797518410d"/>
   </p:sldIdLst>
   <p:sldSz cx="18288000" cy="10287000"/>
   <p:notesSz cx="6858000" cy="9144000"/>
@@ -1641,7 +1641,7 @@
           </a:p>
           <a:p xmlns:a="http://schemas.openxmlformats.org/drawingml/2006/main">
             <a:r>
-              <a:t>If he asks for a real encounter: paste it. The app now parses Q/A and speaker-labeled transcripts, leaves turns editable, and infers concepts if blank.</a:t>
+              <a:t>If he asks for a real encounter: paste it. The app now parses Q/A and speaker-labeled transcripts, leaves turns editable, infers concepts if blank, and shows an Input Coverage Audit proving each line was used, mapped, routed, or held for review.</a:t>
             </a:r>
           </a:p>
         </p:txBody>
@@ -1737,6 +1737,11 @@
           <a:p xmlns:a="http://schemas.openxmlformats.org/drawingml/2006/main">
             <a:r>
               <a:t>- "Concepts can be blank. The engine infers the likely slot from the question and answer."</a:t>
+            </a:r>
+          </a:p>
+          <a:p xmlns:a="http://schemas.openxmlformats.org/drawingml/2006/main">
+            <a:r>
+              <a:t>- "The Input Coverage Audit is the proof that no line quietly disappears."</a:t>
             </a:r>
           </a:p>
           <a:p xmlns:a="http://schemas.openxmlformats.org/drawingml/2006/main">
@@ -2239,7 +2244,7 @@
   </p:cSld>
   <p:clrMap bg1="lt1" tx1="dk1" bg2="lt2" tx2="dk2" accent1="accent1" accent2="accent2" accent3="accent3" accent4="accent4" accent5="accent5" accent6="accent6" hlink="hlink" folHlink="folHlink"/>
   <p:sldLayoutIdLst>
-    <p:sldLayoutId xmlns:r="http://schemas.openxmlformats.org/officeDocument/2006/relationships" id="2147483649" r:id="R97e33901144e4fb6"/>
+    <p:sldLayoutId xmlns:r="http://schemas.openxmlformats.org/officeDocument/2006/relationships" id="2147483649" r:id="R95a354ce51a34c0c"/>
   </p:sldLayoutIdLst>
   <p:txStyles>
     <p:titleStyle>
@@ -2538,7 +2543,7 @@
           <p:cNvPr id="1" name="cover-stage">
             <a:extLst xmlns:a="http://schemas.openxmlformats.org/drawingml/2006/main">
               <a:ext uri="{FF2B5EF4-FFF2-40B4-BE49-F238E27FC236}">
-                <a16:creationId xmlns:a16="http://schemas.microsoft.com/office/drawing/2014/main" id="{E0B75FC5-CC15-456C-BF34-72EF08A59F0E}"/>
+                <a16:creationId xmlns:a16="http://schemas.microsoft.com/office/drawing/2014/main" id="{69920191-57C6-483B-81F9-765006933AFE}"/>
               </a:ext>
             </a:extLst>
           </p:cNvPr>
@@ -2565,7 +2570,7 @@
           <p:cNvPr id="2" name="">
             <a:extLst xmlns:a="http://schemas.openxmlformats.org/drawingml/2006/main">
               <a:ext uri="{FF2B5EF4-FFF2-40B4-BE49-F238E27FC236}">
-                <a16:creationId xmlns:a16="http://schemas.microsoft.com/office/drawing/2014/main" id="{6B3743CA-367A-430B-92E4-124F4127B217}"/>
+                <a16:creationId xmlns:a16="http://schemas.microsoft.com/office/drawing/2014/main" id="{775968C1-CC9C-4A49-A4DC-60AEA4A80580}"/>
               </a:ext>
             </a:extLst>
           </p:cNvPr>
@@ -2610,7 +2615,7 @@
           <p:cNvPr id="3" name="cover-title">
             <a:extLst xmlns:a="http://schemas.openxmlformats.org/drawingml/2006/main">
               <a:ext uri="{FF2B5EF4-FFF2-40B4-BE49-F238E27FC236}">
-                <a16:creationId xmlns:a16="http://schemas.microsoft.com/office/drawing/2014/main" id="{FDE25A23-4767-4C03-A4FF-0C1F67C66498}"/>
+                <a16:creationId xmlns:a16="http://schemas.microsoft.com/office/drawing/2014/main" id="{F24EB365-E349-454A-AF10-AD48E3477DB1}"/>
               </a:ext>
             </a:extLst>
           </p:cNvPr>
@@ -2655,7 +2660,7 @@
           <p:cNvPr id="4" name="">
             <a:extLst xmlns:a="http://schemas.openxmlformats.org/drawingml/2006/main">
               <a:ext uri="{FF2B5EF4-FFF2-40B4-BE49-F238E27FC236}">
-                <a16:creationId xmlns:a16="http://schemas.microsoft.com/office/drawing/2014/main" id="{EF6972ED-DF84-4EFB-A071-588C7A300775}"/>
+                <a16:creationId xmlns:a16="http://schemas.microsoft.com/office/drawing/2014/main" id="{387D1816-B25F-4578-8DEB-842A2E4114B3}"/>
               </a:ext>
             </a:extLst>
           </p:cNvPr>
@@ -2688,7 +2693,7 @@
           <p:cNvPr id="5" name="">
             <a:extLst xmlns:a="http://schemas.openxmlformats.org/drawingml/2006/main">
               <a:ext uri="{FF2B5EF4-FFF2-40B4-BE49-F238E27FC236}">
-                <a16:creationId xmlns:a16="http://schemas.microsoft.com/office/drawing/2014/main" id="{9D69351C-FC7F-42AE-9584-3EF7DCBC5BF6}"/>
+                <a16:creationId xmlns:a16="http://schemas.microsoft.com/office/drawing/2014/main" id="{531A7206-43AB-4825-82FE-D29C21E782D0}"/>
               </a:ext>
             </a:extLst>
           </p:cNvPr>
@@ -2733,7 +2738,7 @@
           <p:cNvPr id="6" name="">
             <a:extLst xmlns:a="http://schemas.openxmlformats.org/drawingml/2006/main">
               <a:ext uri="{FF2B5EF4-FFF2-40B4-BE49-F238E27FC236}">
-                <a16:creationId xmlns:a16="http://schemas.microsoft.com/office/drawing/2014/main" id="{D4CDD545-5ADA-439A-8938-7F865BA95BF1}"/>
+                <a16:creationId xmlns:a16="http://schemas.microsoft.com/office/drawing/2014/main" id="{7FB233A1-FAE4-4939-BA7C-3320EA8C522A}"/>
               </a:ext>
             </a:extLst>
           </p:cNvPr>
@@ -2778,7 +2783,7 @@
           <p:cNvPr id="7" name="">
             <a:extLst xmlns:a="http://schemas.openxmlformats.org/drawingml/2006/main">
               <a:ext uri="{FF2B5EF4-FFF2-40B4-BE49-F238E27FC236}">
-                <a16:creationId xmlns:a16="http://schemas.microsoft.com/office/drawing/2014/main" id="{99E0891C-23EE-4250-A170-3AB7EA4B6C63}"/>
+                <a16:creationId xmlns:a16="http://schemas.microsoft.com/office/drawing/2014/main" id="{7C6E3DA8-FA06-46BF-92AD-B50D18803DAD}"/>
               </a:ext>
             </a:extLst>
           </p:cNvPr>
@@ -2823,7 +2828,7 @@
           <p:cNvPr id="8" name="">
             <a:extLst xmlns:a="http://schemas.openxmlformats.org/drawingml/2006/main">
               <a:ext uri="{FF2B5EF4-FFF2-40B4-BE49-F238E27FC236}">
-                <a16:creationId xmlns:a16="http://schemas.microsoft.com/office/drawing/2014/main" id="{536765F9-D198-498F-96F3-05B7DC50CF4A}"/>
+                <a16:creationId xmlns:a16="http://schemas.microsoft.com/office/drawing/2014/main" id="{93BB0B3F-1522-4C5A-9415-70910C9F87A3}"/>
               </a:ext>
             </a:extLst>
           </p:cNvPr>
@@ -2868,7 +2873,7 @@
           <p:cNvPr id="9" name="">
             <a:extLst xmlns:a="http://schemas.openxmlformats.org/drawingml/2006/main">
               <a:ext uri="{FF2B5EF4-FFF2-40B4-BE49-F238E27FC236}">
-                <a16:creationId xmlns:a16="http://schemas.microsoft.com/office/drawing/2014/main" id="{637EC364-F780-4C86-A0D3-650A209B3BE4}"/>
+                <a16:creationId xmlns:a16="http://schemas.microsoft.com/office/drawing/2014/main" id="{599DB5F4-81DB-4C0A-B200-AD5DE1C100D6}"/>
               </a:ext>
             </a:extLst>
           </p:cNvPr>
@@ -2913,7 +2918,7 @@
           <p:cNvPr id="10" name="">
             <a:extLst xmlns:a="http://schemas.openxmlformats.org/drawingml/2006/main">
               <a:ext uri="{FF2B5EF4-FFF2-40B4-BE49-F238E27FC236}">
-                <a16:creationId xmlns:a16="http://schemas.microsoft.com/office/drawing/2014/main" id="{E4D6AF85-3539-43B6-9873-02AB8DF29675}"/>
+                <a16:creationId xmlns:a16="http://schemas.microsoft.com/office/drawing/2014/main" id="{FA4A771B-7F4E-414E-9985-7BA1940C219E}"/>
               </a:ext>
             </a:extLst>
           </p:cNvPr>
@@ -2958,7 +2963,7 @@
           <p:cNvPr id="11" name="">
             <a:extLst xmlns:a="http://schemas.openxmlformats.org/drawingml/2006/main">
               <a:ext uri="{FF2B5EF4-FFF2-40B4-BE49-F238E27FC236}">
-                <a16:creationId xmlns:a16="http://schemas.microsoft.com/office/drawing/2014/main" id="{95D3EF25-16B2-4B64-AD73-FC372D68412C}"/>
+                <a16:creationId xmlns:a16="http://schemas.microsoft.com/office/drawing/2014/main" id="{0253A04D-7A18-4E57-872F-51358165C05E}"/>
               </a:ext>
             </a:extLst>
           </p:cNvPr>
@@ -3003,7 +3008,7 @@
           <p:cNvPr id="12" name="">
             <a:extLst xmlns:a="http://schemas.openxmlformats.org/drawingml/2006/main">
               <a:ext uri="{FF2B5EF4-FFF2-40B4-BE49-F238E27FC236}">
-                <a16:creationId xmlns:a16="http://schemas.microsoft.com/office/drawing/2014/main" id="{077C0798-E106-4D08-9CC8-37B7CDD1B138}"/>
+                <a16:creationId xmlns:a16="http://schemas.microsoft.com/office/drawing/2014/main" id="{DDEF8CB1-97B0-4245-982A-5B2A2F7772BE}"/>
               </a:ext>
             </a:extLst>
           </p:cNvPr>
@@ -3048,7 +3053,7 @@
           <p:cNvPr id="13" name="">
             <a:extLst xmlns:a="http://schemas.openxmlformats.org/drawingml/2006/main">
               <a:ext uri="{FF2B5EF4-FFF2-40B4-BE49-F238E27FC236}">
-                <a16:creationId xmlns:a16="http://schemas.microsoft.com/office/drawing/2014/main" id="{0B0DE66E-DD0B-41B7-9A2A-8728059D286B}"/>
+                <a16:creationId xmlns:a16="http://schemas.microsoft.com/office/drawing/2014/main" id="{FA34772C-6F0A-4849-AC7B-513A02815FA9}"/>
               </a:ext>
             </a:extLst>
           </p:cNvPr>
@@ -3091,7 +3096,7 @@
     </p:spTree>
     <p:extLst>
       <p:ext uri="{BB962C8B-B14F-4D97-AF65-F5344CB8AC3E}">
-        <p14:creationId xmlns:p14="http://schemas.microsoft.com/office/powerpoint/2010/main" val="1335793174"/>
+        <p14:creationId xmlns:p14="http://schemas.microsoft.com/office/powerpoint/2010/main" val="1506221159"/>
       </p:ext>
     </p:extLst>
   </p:cSld>
@@ -3115,7 +3120,7 @@
           <p:cNvPr id="1" name="slide-stage">
             <a:extLst xmlns:a="http://schemas.openxmlformats.org/drawingml/2006/main">
               <a:ext uri="{FF2B5EF4-FFF2-40B4-BE49-F238E27FC236}">
-                <a16:creationId xmlns:a16="http://schemas.microsoft.com/office/drawing/2014/main" id="{6F8B6743-6027-4CDB-B622-2BEE18562E6D}"/>
+                <a16:creationId xmlns:a16="http://schemas.microsoft.com/office/drawing/2014/main" id="{CA491AEE-FAF8-4B4F-AE3A-8D5D43959AA8}"/>
               </a:ext>
             </a:extLst>
           </p:cNvPr>
@@ -3142,7 +3147,7 @@
           <p:cNvPr id="2" name="eyebrow">
             <a:extLst xmlns:a="http://schemas.openxmlformats.org/drawingml/2006/main">
               <a:ext uri="{FF2B5EF4-FFF2-40B4-BE49-F238E27FC236}">
-                <a16:creationId xmlns:a16="http://schemas.microsoft.com/office/drawing/2014/main" id="{52242FCD-C51A-475F-A78F-E1313F0B41DB}"/>
+                <a16:creationId xmlns:a16="http://schemas.microsoft.com/office/drawing/2014/main" id="{214E4D96-BF80-49B3-8827-8E2ADC821F77}"/>
               </a:ext>
             </a:extLst>
           </p:cNvPr>
@@ -3187,7 +3192,7 @@
           <p:cNvPr id="3" name="slide-title">
             <a:extLst xmlns:a="http://schemas.openxmlformats.org/drawingml/2006/main">
               <a:ext uri="{FF2B5EF4-FFF2-40B4-BE49-F238E27FC236}">
-                <a16:creationId xmlns:a16="http://schemas.microsoft.com/office/drawing/2014/main" id="{60D96225-49F9-4965-8F99-8280143F56A0}"/>
+                <a16:creationId xmlns:a16="http://schemas.microsoft.com/office/drawing/2014/main" id="{1EA78086-BF9C-4A98-ACCE-69430053893B}"/>
               </a:ext>
             </a:extLst>
           </p:cNvPr>
@@ -3232,7 +3237,7 @@
           <p:cNvPr id="4" name="slide-subtitle">
             <a:extLst xmlns:a="http://schemas.openxmlformats.org/drawingml/2006/main">
               <a:ext uri="{FF2B5EF4-FFF2-40B4-BE49-F238E27FC236}">
-                <a16:creationId xmlns:a16="http://schemas.microsoft.com/office/drawing/2014/main" id="{63CAB99A-490C-4508-8541-3A15385DC69F}"/>
+                <a16:creationId xmlns:a16="http://schemas.microsoft.com/office/drawing/2014/main" id="{7D3A76F6-4C2E-4522-BB54-9C2F1DECF267}"/>
               </a:ext>
             </a:extLst>
           </p:cNvPr>
@@ -3277,7 +3282,7 @@
           <p:cNvPr id="5" name="">
             <a:extLst xmlns:a="http://schemas.openxmlformats.org/drawingml/2006/main">
               <a:ext uri="{FF2B5EF4-FFF2-40B4-BE49-F238E27FC236}">
-                <a16:creationId xmlns:a16="http://schemas.microsoft.com/office/drawing/2014/main" id="{66B4CEBD-8727-4CFC-978D-3444031042DA}"/>
+                <a16:creationId xmlns:a16="http://schemas.microsoft.com/office/drawing/2014/main" id="{00306729-0CF9-4270-A73E-38201F702C9B}"/>
               </a:ext>
             </a:extLst>
           </p:cNvPr>
@@ -3310,7 +3315,7 @@
           <p:cNvPr id="6" name="">
             <a:extLst xmlns:a="http://schemas.openxmlformats.org/drawingml/2006/main">
               <a:ext uri="{FF2B5EF4-FFF2-40B4-BE49-F238E27FC236}">
-                <a16:creationId xmlns:a16="http://schemas.microsoft.com/office/drawing/2014/main" id="{67D5A012-49F4-4E2B-A138-8592AE4BC446}"/>
+                <a16:creationId xmlns:a16="http://schemas.microsoft.com/office/drawing/2014/main" id="{2A58567C-1B73-4782-A8AC-739AFB3FC888}"/>
               </a:ext>
             </a:extLst>
           </p:cNvPr>
@@ -3355,7 +3360,7 @@
           <p:cNvPr id="7" name="">
             <a:extLst xmlns:a="http://schemas.openxmlformats.org/drawingml/2006/main">
               <a:ext uri="{FF2B5EF4-FFF2-40B4-BE49-F238E27FC236}">
-                <a16:creationId xmlns:a16="http://schemas.microsoft.com/office/drawing/2014/main" id="{029A6125-2002-4336-8CF5-A46F73B48C80}"/>
+                <a16:creationId xmlns:a16="http://schemas.microsoft.com/office/drawing/2014/main" id="{DC980D26-902F-4604-9D3A-B9763B882588}"/>
               </a:ext>
             </a:extLst>
           </p:cNvPr>
@@ -3400,7 +3405,7 @@
           <p:cNvPr id="8" name="">
             <a:extLst xmlns:a="http://schemas.openxmlformats.org/drawingml/2006/main">
               <a:ext uri="{FF2B5EF4-FFF2-40B4-BE49-F238E27FC236}">
-                <a16:creationId xmlns:a16="http://schemas.microsoft.com/office/drawing/2014/main" id="{D16A96A0-3D3B-418F-819D-D208CBA5626E}"/>
+                <a16:creationId xmlns:a16="http://schemas.microsoft.com/office/drawing/2014/main" id="{DC1EDBF7-457E-4FDC-8915-1AB4DD882C59}"/>
               </a:ext>
             </a:extLst>
           </p:cNvPr>
@@ -3433,7 +3438,7 @@
           <p:cNvPr id="9" name="">
             <a:extLst xmlns:a="http://schemas.openxmlformats.org/drawingml/2006/main">
               <a:ext uri="{FF2B5EF4-FFF2-40B4-BE49-F238E27FC236}">
-                <a16:creationId xmlns:a16="http://schemas.microsoft.com/office/drawing/2014/main" id="{57E5303F-AB9B-4122-B73B-E2224AF2D924}"/>
+                <a16:creationId xmlns:a16="http://schemas.microsoft.com/office/drawing/2014/main" id="{920826C9-A59B-40A1-9880-3FA83B5FE724}"/>
               </a:ext>
             </a:extLst>
           </p:cNvPr>
@@ -3478,7 +3483,7 @@
           <p:cNvPr id="10" name="">
             <a:extLst xmlns:a="http://schemas.openxmlformats.org/drawingml/2006/main">
               <a:ext uri="{FF2B5EF4-FFF2-40B4-BE49-F238E27FC236}">
-                <a16:creationId xmlns:a16="http://schemas.microsoft.com/office/drawing/2014/main" id="{8D38BF67-C4F8-4DEC-A7F7-54C4CE5A3CA0}"/>
+                <a16:creationId xmlns:a16="http://schemas.microsoft.com/office/drawing/2014/main" id="{2E76C1AC-0AAF-442F-96E0-CC76DC6A528D}"/>
               </a:ext>
             </a:extLst>
           </p:cNvPr>
@@ -3523,7 +3528,7 @@
           <p:cNvPr id="11" name="">
             <a:extLst xmlns:a="http://schemas.openxmlformats.org/drawingml/2006/main">
               <a:ext uri="{FF2B5EF4-FFF2-40B4-BE49-F238E27FC236}">
-                <a16:creationId xmlns:a16="http://schemas.microsoft.com/office/drawing/2014/main" id="{6844DEA2-6375-4EE9-A9C9-1411FE10B0F5}"/>
+                <a16:creationId xmlns:a16="http://schemas.microsoft.com/office/drawing/2014/main" id="{9AB65E73-5E76-4255-8CEA-C07BC089FB3E}"/>
               </a:ext>
             </a:extLst>
           </p:cNvPr>
@@ -3556,7 +3561,7 @@
           <p:cNvPr id="12" name="">
             <a:extLst xmlns:a="http://schemas.openxmlformats.org/drawingml/2006/main">
               <a:ext uri="{FF2B5EF4-FFF2-40B4-BE49-F238E27FC236}">
-                <a16:creationId xmlns:a16="http://schemas.microsoft.com/office/drawing/2014/main" id="{1923EC69-7E03-44E2-9C52-2DFC2229DCED}"/>
+                <a16:creationId xmlns:a16="http://schemas.microsoft.com/office/drawing/2014/main" id="{D994C54D-0E5A-4172-A9B1-5AC8590EDE9D}"/>
               </a:ext>
             </a:extLst>
           </p:cNvPr>
@@ -3601,7 +3606,7 @@
           <p:cNvPr id="13" name="">
             <a:extLst xmlns:a="http://schemas.openxmlformats.org/drawingml/2006/main">
               <a:ext uri="{FF2B5EF4-FFF2-40B4-BE49-F238E27FC236}">
-                <a16:creationId xmlns:a16="http://schemas.microsoft.com/office/drawing/2014/main" id="{8CF6AF0E-A32F-454C-A265-FE483BF13886}"/>
+                <a16:creationId xmlns:a16="http://schemas.microsoft.com/office/drawing/2014/main" id="{DEA4F4AD-EB10-4D54-A9E4-854A59ED3EB9}"/>
               </a:ext>
             </a:extLst>
           </p:cNvPr>
@@ -3646,7 +3651,7 @@
           <p:cNvPr id="14" name="">
             <a:extLst xmlns:a="http://schemas.openxmlformats.org/drawingml/2006/main">
               <a:ext uri="{FF2B5EF4-FFF2-40B4-BE49-F238E27FC236}">
-                <a16:creationId xmlns:a16="http://schemas.microsoft.com/office/drawing/2014/main" id="{51A4E5A0-7CFF-411D-8E04-B9B08D1274C0}"/>
+                <a16:creationId xmlns:a16="http://schemas.microsoft.com/office/drawing/2014/main" id="{F6A2F9E2-37E2-4EBE-A2A9-F0908783B0A7}"/>
               </a:ext>
             </a:extLst>
           </p:cNvPr>
@@ -3679,7 +3684,7 @@
           <p:cNvPr id="15" name="">
             <a:extLst xmlns:a="http://schemas.openxmlformats.org/drawingml/2006/main">
               <a:ext uri="{FF2B5EF4-FFF2-40B4-BE49-F238E27FC236}">
-                <a16:creationId xmlns:a16="http://schemas.microsoft.com/office/drawing/2014/main" id="{2E00F15A-4FCF-4958-8090-D49ED1CE7E4F}"/>
+                <a16:creationId xmlns:a16="http://schemas.microsoft.com/office/drawing/2014/main" id="{775EC693-74F2-4101-813E-F80C7A5C6D94}"/>
               </a:ext>
             </a:extLst>
           </p:cNvPr>
@@ -3724,7 +3729,7 @@
           <p:cNvPr id="16" name="">
             <a:extLst xmlns:a="http://schemas.openxmlformats.org/drawingml/2006/main">
               <a:ext uri="{FF2B5EF4-FFF2-40B4-BE49-F238E27FC236}">
-                <a16:creationId xmlns:a16="http://schemas.microsoft.com/office/drawing/2014/main" id="{FB691DD7-89D9-4077-B287-D7596AFC99E7}"/>
+                <a16:creationId xmlns:a16="http://schemas.microsoft.com/office/drawing/2014/main" id="{94521468-056A-4939-B55A-21556A65CE2F}"/>
               </a:ext>
             </a:extLst>
           </p:cNvPr>
@@ -3769,7 +3774,7 @@
           <p:cNvPr id="17" name="footer-left">
             <a:extLst xmlns:a="http://schemas.openxmlformats.org/drawingml/2006/main">
               <a:ext uri="{FF2B5EF4-FFF2-40B4-BE49-F238E27FC236}">
-                <a16:creationId xmlns:a16="http://schemas.microsoft.com/office/drawing/2014/main" id="{EE63098D-894C-4BD0-8958-A87DE440F637}"/>
+                <a16:creationId xmlns:a16="http://schemas.microsoft.com/office/drawing/2014/main" id="{12D213D5-B46F-4913-83B3-660CB5529658}"/>
               </a:ext>
             </a:extLst>
           </p:cNvPr>
@@ -3814,7 +3819,7 @@
           <p:cNvPr id="18" name="footer-right">
             <a:extLst xmlns:a="http://schemas.openxmlformats.org/drawingml/2006/main">
               <a:ext uri="{FF2B5EF4-FFF2-40B4-BE49-F238E27FC236}">
-                <a16:creationId xmlns:a16="http://schemas.microsoft.com/office/drawing/2014/main" id="{5DD74546-E530-435C-B94C-FC2A8EB8CE30}"/>
+                <a16:creationId xmlns:a16="http://schemas.microsoft.com/office/drawing/2014/main" id="{FF764E00-5DC6-4EF7-9F4A-9CF4611C89F4}"/>
               </a:ext>
             </a:extLst>
           </p:cNvPr>
@@ -3857,7 +3862,7 @@
     </p:spTree>
     <p:extLst>
       <p:ext uri="{BB962C8B-B14F-4D97-AF65-F5344CB8AC3E}">
-        <p14:creationId xmlns:p14="http://schemas.microsoft.com/office/powerpoint/2010/main" val="1920393124"/>
+        <p14:creationId xmlns:p14="http://schemas.microsoft.com/office/powerpoint/2010/main" val="2117495206"/>
       </p:ext>
     </p:extLst>
   </p:cSld>
@@ -3881,7 +3886,7 @@
           <p:cNvPr id="1" name="slide-stage">
             <a:extLst xmlns:a="http://schemas.openxmlformats.org/drawingml/2006/main">
               <a:ext uri="{FF2B5EF4-FFF2-40B4-BE49-F238E27FC236}">
-                <a16:creationId xmlns:a16="http://schemas.microsoft.com/office/drawing/2014/main" id="{267A9AF9-6159-47EF-83F4-FF8FAAFB1ECE}"/>
+                <a16:creationId xmlns:a16="http://schemas.microsoft.com/office/drawing/2014/main" id="{74855B4D-FADF-46CE-A8B4-46ADA59DB159}"/>
               </a:ext>
             </a:extLst>
           </p:cNvPr>
@@ -3908,7 +3913,7 @@
           <p:cNvPr id="2" name="eyebrow">
             <a:extLst xmlns:a="http://schemas.openxmlformats.org/drawingml/2006/main">
               <a:ext uri="{FF2B5EF4-FFF2-40B4-BE49-F238E27FC236}">
-                <a16:creationId xmlns:a16="http://schemas.microsoft.com/office/drawing/2014/main" id="{C0C16961-FAAE-46BB-AFFC-9AC4A0747681}"/>
+                <a16:creationId xmlns:a16="http://schemas.microsoft.com/office/drawing/2014/main" id="{540D820B-D987-4010-924C-55C8A617E7B9}"/>
               </a:ext>
             </a:extLst>
           </p:cNvPr>
@@ -3953,7 +3958,7 @@
           <p:cNvPr id="3" name="slide-title">
             <a:extLst xmlns:a="http://schemas.openxmlformats.org/drawingml/2006/main">
               <a:ext uri="{FF2B5EF4-FFF2-40B4-BE49-F238E27FC236}">
-                <a16:creationId xmlns:a16="http://schemas.microsoft.com/office/drawing/2014/main" id="{E7458030-933D-403D-8FFC-772F0B66CCE7}"/>
+                <a16:creationId xmlns:a16="http://schemas.microsoft.com/office/drawing/2014/main" id="{0DBC6420-B397-4903-84D2-2EB7354EF9AE}"/>
               </a:ext>
             </a:extLst>
           </p:cNvPr>
@@ -3998,7 +4003,7 @@
           <p:cNvPr id="4" name="slide-subtitle">
             <a:extLst xmlns:a="http://schemas.openxmlformats.org/drawingml/2006/main">
               <a:ext uri="{FF2B5EF4-FFF2-40B4-BE49-F238E27FC236}">
-                <a16:creationId xmlns:a16="http://schemas.microsoft.com/office/drawing/2014/main" id="{87CCF845-EE72-4A4C-86B0-6A43A732FCA9}"/>
+                <a16:creationId xmlns:a16="http://schemas.microsoft.com/office/drawing/2014/main" id="{10D0BBC1-1398-4CDA-8CFC-8AD04FE5EE61}"/>
               </a:ext>
             </a:extLst>
           </p:cNvPr>
@@ -4043,7 +4048,7 @@
           <p:cNvPr id="5" name="">
             <a:extLst xmlns:a="http://schemas.openxmlformats.org/drawingml/2006/main">
               <a:ext uri="{FF2B5EF4-FFF2-40B4-BE49-F238E27FC236}">
-                <a16:creationId xmlns:a16="http://schemas.microsoft.com/office/drawing/2014/main" id="{04D8E547-0A25-4354-84B2-782E7DA37E99}"/>
+                <a16:creationId xmlns:a16="http://schemas.microsoft.com/office/drawing/2014/main" id="{9B941CEE-0256-485E-BFCE-08165137E5D5}"/>
               </a:ext>
             </a:extLst>
           </p:cNvPr>
@@ -4088,7 +4093,7 @@
           <p:cNvPr id="6" name="">
             <a:extLst xmlns:a="http://schemas.openxmlformats.org/drawingml/2006/main">
               <a:ext uri="{FF2B5EF4-FFF2-40B4-BE49-F238E27FC236}">
-                <a16:creationId xmlns:a16="http://schemas.microsoft.com/office/drawing/2014/main" id="{19258CBD-540C-4E86-AF62-23D5D459C549}"/>
+                <a16:creationId xmlns:a16="http://schemas.microsoft.com/office/drawing/2014/main" id="{79842BAC-C64A-4D6A-91F0-9CBCEFC1656F}"/>
               </a:ext>
             </a:extLst>
           </p:cNvPr>
@@ -4133,7 +4138,7 @@
           <p:cNvPr id="7" name="">
             <a:extLst xmlns:a="http://schemas.openxmlformats.org/drawingml/2006/main">
               <a:ext uri="{FF2B5EF4-FFF2-40B4-BE49-F238E27FC236}">
-                <a16:creationId xmlns:a16="http://schemas.microsoft.com/office/drawing/2014/main" id="{EFDA87D4-2B3C-475C-B6D6-FA7F4269A6E8}"/>
+                <a16:creationId xmlns:a16="http://schemas.microsoft.com/office/drawing/2014/main" id="{F040C33B-0035-40EA-9491-84DE702D3DBE}"/>
               </a:ext>
             </a:extLst>
           </p:cNvPr>
@@ -4178,7 +4183,7 @@
           <p:cNvPr id="8" name="">
             <a:extLst xmlns:a="http://schemas.openxmlformats.org/drawingml/2006/main">
               <a:ext uri="{FF2B5EF4-FFF2-40B4-BE49-F238E27FC236}">
-                <a16:creationId xmlns:a16="http://schemas.microsoft.com/office/drawing/2014/main" id="{7086AFE7-DA0A-48A7-ACA9-A95F0F926299}"/>
+                <a16:creationId xmlns:a16="http://schemas.microsoft.com/office/drawing/2014/main" id="{471D2FDA-F8B5-4031-9E39-6DB50495BB72}"/>
               </a:ext>
             </a:extLst>
           </p:cNvPr>
@@ -4223,7 +4228,7 @@
           <p:cNvPr id="9" name="">
             <a:extLst xmlns:a="http://schemas.openxmlformats.org/drawingml/2006/main">
               <a:ext uri="{FF2B5EF4-FFF2-40B4-BE49-F238E27FC236}">
-                <a16:creationId xmlns:a16="http://schemas.microsoft.com/office/drawing/2014/main" id="{44B31B6F-776F-405C-AB57-66CDE9859FF6}"/>
+                <a16:creationId xmlns:a16="http://schemas.microsoft.com/office/drawing/2014/main" id="{36E158C2-1F0E-4A0E-94DC-50671A37BF02}"/>
               </a:ext>
             </a:extLst>
           </p:cNvPr>
@@ -4268,7 +4273,7 @@
           <p:cNvPr id="10" name="">
             <a:extLst xmlns:a="http://schemas.openxmlformats.org/drawingml/2006/main">
               <a:ext uri="{FF2B5EF4-FFF2-40B4-BE49-F238E27FC236}">
-                <a16:creationId xmlns:a16="http://schemas.microsoft.com/office/drawing/2014/main" id="{D8E0691E-582D-4EF6-BA77-C11EF3523342}"/>
+                <a16:creationId xmlns:a16="http://schemas.microsoft.com/office/drawing/2014/main" id="{66347E7B-316F-467A-AFE4-2AA732124BB6}"/>
               </a:ext>
             </a:extLst>
           </p:cNvPr>
@@ -4313,7 +4318,7 @@
           <p:cNvPr id="11" name="">
             <a:extLst xmlns:a="http://schemas.openxmlformats.org/drawingml/2006/main">
               <a:ext uri="{FF2B5EF4-FFF2-40B4-BE49-F238E27FC236}">
-                <a16:creationId xmlns:a16="http://schemas.microsoft.com/office/drawing/2014/main" id="{579F6DBD-2445-43EF-B102-99184BC1997F}"/>
+                <a16:creationId xmlns:a16="http://schemas.microsoft.com/office/drawing/2014/main" id="{1B74754A-D177-48CC-A282-333D4DE1D0CB}"/>
               </a:ext>
             </a:extLst>
           </p:cNvPr>
@@ -4358,7 +4363,7 @@
           <p:cNvPr id="12" name="">
             <a:extLst xmlns:a="http://schemas.openxmlformats.org/drawingml/2006/main">
               <a:ext uri="{FF2B5EF4-FFF2-40B4-BE49-F238E27FC236}">
-                <a16:creationId xmlns:a16="http://schemas.microsoft.com/office/drawing/2014/main" id="{448F3E38-EB48-4971-824B-3BF1386A5A2A}"/>
+                <a16:creationId xmlns:a16="http://schemas.microsoft.com/office/drawing/2014/main" id="{D31A5FFC-585D-452F-B073-80668DC01687}"/>
               </a:ext>
             </a:extLst>
           </p:cNvPr>
@@ -4403,7 +4408,7 @@
           <p:cNvPr id="13" name="">
             <a:extLst xmlns:a="http://schemas.openxmlformats.org/drawingml/2006/main">
               <a:ext uri="{FF2B5EF4-FFF2-40B4-BE49-F238E27FC236}">
-                <a16:creationId xmlns:a16="http://schemas.microsoft.com/office/drawing/2014/main" id="{9DE1E2DA-D663-412E-B4FF-EB9CFA51DD0D}"/>
+                <a16:creationId xmlns:a16="http://schemas.microsoft.com/office/drawing/2014/main" id="{073DB5BD-183D-4423-9658-35E39C305888}"/>
               </a:ext>
             </a:extLst>
           </p:cNvPr>
@@ -4448,7 +4453,7 @@
           <p:cNvPr id="14" name="footer-left">
             <a:extLst xmlns:a="http://schemas.openxmlformats.org/drawingml/2006/main">
               <a:ext uri="{FF2B5EF4-FFF2-40B4-BE49-F238E27FC236}">
-                <a16:creationId xmlns:a16="http://schemas.microsoft.com/office/drawing/2014/main" id="{F28149B7-8145-4143-A452-D72E15E86F28}"/>
+                <a16:creationId xmlns:a16="http://schemas.microsoft.com/office/drawing/2014/main" id="{973F01EF-4858-4D62-8054-AC5A75271384}"/>
               </a:ext>
             </a:extLst>
           </p:cNvPr>
@@ -4493,7 +4498,7 @@
           <p:cNvPr id="15" name="footer-right">
             <a:extLst xmlns:a="http://schemas.openxmlformats.org/drawingml/2006/main">
               <a:ext uri="{FF2B5EF4-FFF2-40B4-BE49-F238E27FC236}">
-                <a16:creationId xmlns:a16="http://schemas.microsoft.com/office/drawing/2014/main" id="{1295F417-A91B-4238-9050-E733F3CA427A}"/>
+                <a16:creationId xmlns:a16="http://schemas.microsoft.com/office/drawing/2014/main" id="{B63236BE-AC05-4CBA-B234-D1DB7EDB1F77}"/>
               </a:ext>
             </a:extLst>
           </p:cNvPr>
@@ -4536,7 +4541,7 @@
     </p:spTree>
     <p:extLst>
       <p:ext uri="{BB962C8B-B14F-4D97-AF65-F5344CB8AC3E}">
-        <p14:creationId xmlns:p14="http://schemas.microsoft.com/office/powerpoint/2010/main" val="1496486049"/>
+        <p14:creationId xmlns:p14="http://schemas.microsoft.com/office/powerpoint/2010/main" val="1039523852"/>
       </p:ext>
     </p:extLst>
   </p:cSld>
@@ -4560,7 +4565,7 @@
           <p:cNvPr id="1" name="slide-stage">
             <a:extLst xmlns:a="http://schemas.openxmlformats.org/drawingml/2006/main">
               <a:ext uri="{FF2B5EF4-FFF2-40B4-BE49-F238E27FC236}">
-                <a16:creationId xmlns:a16="http://schemas.microsoft.com/office/drawing/2014/main" id="{678B48CB-A6C3-47F4-A191-2F6389B72A09}"/>
+                <a16:creationId xmlns:a16="http://schemas.microsoft.com/office/drawing/2014/main" id="{CBFEBDC2-8562-41F5-8B43-D66C9459371D}"/>
               </a:ext>
             </a:extLst>
           </p:cNvPr>
@@ -4587,7 +4592,7 @@
           <p:cNvPr id="2" name="eyebrow">
             <a:extLst xmlns:a="http://schemas.openxmlformats.org/drawingml/2006/main">
               <a:ext uri="{FF2B5EF4-FFF2-40B4-BE49-F238E27FC236}">
-                <a16:creationId xmlns:a16="http://schemas.microsoft.com/office/drawing/2014/main" id="{679DE1AD-939D-44DD-BDE2-F3EAC9761B63}"/>
+                <a16:creationId xmlns:a16="http://schemas.microsoft.com/office/drawing/2014/main" id="{0D065611-7DDF-4365-B60B-D643456C3AC0}"/>
               </a:ext>
             </a:extLst>
           </p:cNvPr>
@@ -4632,7 +4637,7 @@
           <p:cNvPr id="3" name="slide-title">
             <a:extLst xmlns:a="http://schemas.openxmlformats.org/drawingml/2006/main">
               <a:ext uri="{FF2B5EF4-FFF2-40B4-BE49-F238E27FC236}">
-                <a16:creationId xmlns:a16="http://schemas.microsoft.com/office/drawing/2014/main" id="{61B85F24-0361-4739-B4AF-CE886E5664BE}"/>
+                <a16:creationId xmlns:a16="http://schemas.microsoft.com/office/drawing/2014/main" id="{AE03A058-2A2F-43EB-9147-716D4D30EACA}"/>
               </a:ext>
             </a:extLst>
           </p:cNvPr>
@@ -4677,7 +4682,7 @@
           <p:cNvPr id="4" name="slide-subtitle">
             <a:extLst xmlns:a="http://schemas.openxmlformats.org/drawingml/2006/main">
               <a:ext uri="{FF2B5EF4-FFF2-40B4-BE49-F238E27FC236}">
-                <a16:creationId xmlns:a16="http://schemas.microsoft.com/office/drawing/2014/main" id="{87B40A5D-F25A-421B-9542-F2B91B4FB595}"/>
+                <a16:creationId xmlns:a16="http://schemas.microsoft.com/office/drawing/2014/main" id="{8BC7C1C3-062C-4BFA-AE59-DA5EE14BB1EF}"/>
               </a:ext>
             </a:extLst>
           </p:cNvPr>
@@ -4722,7 +4727,7 @@
           <p:cNvPr id="5" name="">
             <a:extLst xmlns:a="http://schemas.openxmlformats.org/drawingml/2006/main">
               <a:ext uri="{FF2B5EF4-FFF2-40B4-BE49-F238E27FC236}">
-                <a16:creationId xmlns:a16="http://schemas.microsoft.com/office/drawing/2014/main" id="{8133D80A-40D2-4DAE-8269-81499DC72296}"/>
+                <a16:creationId xmlns:a16="http://schemas.microsoft.com/office/drawing/2014/main" id="{A6E8D5F4-4163-4D42-878F-EA786B12AD3A}"/>
               </a:ext>
             </a:extLst>
           </p:cNvPr>
@@ -4755,7 +4760,7 @@
           <p:cNvPr id="6" name="">
             <a:extLst xmlns:a="http://schemas.openxmlformats.org/drawingml/2006/main">
               <a:ext uri="{FF2B5EF4-FFF2-40B4-BE49-F238E27FC236}">
-                <a16:creationId xmlns:a16="http://schemas.microsoft.com/office/drawing/2014/main" id="{888B7FF9-B73D-42B7-81B5-62508D4FF512}"/>
+                <a16:creationId xmlns:a16="http://schemas.microsoft.com/office/drawing/2014/main" id="{B84AB730-E3D2-4A8C-A3DE-073210062077}"/>
               </a:ext>
             </a:extLst>
           </p:cNvPr>
@@ -4800,7 +4805,7 @@
           <p:cNvPr id="7" name="">
             <a:extLst xmlns:a="http://schemas.openxmlformats.org/drawingml/2006/main">
               <a:ext uri="{FF2B5EF4-FFF2-40B4-BE49-F238E27FC236}">
-                <a16:creationId xmlns:a16="http://schemas.microsoft.com/office/drawing/2014/main" id="{8B526378-DE60-45A8-88A8-B6C88DE0EFA5}"/>
+                <a16:creationId xmlns:a16="http://schemas.microsoft.com/office/drawing/2014/main" id="{FDA8E92D-D8EB-4408-8C2F-3491CDDAB6FE}"/>
               </a:ext>
             </a:extLst>
           </p:cNvPr>
@@ -4845,7 +4850,7 @@
           <p:cNvPr id="8" name="">
             <a:extLst xmlns:a="http://schemas.openxmlformats.org/drawingml/2006/main">
               <a:ext uri="{FF2B5EF4-FFF2-40B4-BE49-F238E27FC236}">
-                <a16:creationId xmlns:a16="http://schemas.microsoft.com/office/drawing/2014/main" id="{2C873D23-4848-4EB6-BA97-F8EF51B1ACCF}"/>
+                <a16:creationId xmlns:a16="http://schemas.microsoft.com/office/drawing/2014/main" id="{529122B7-D626-459A-AD62-305E8C0DB64E}"/>
               </a:ext>
             </a:extLst>
           </p:cNvPr>
@@ -4878,7 +4883,7 @@
           <p:cNvPr id="9" name="">
             <a:extLst xmlns:a="http://schemas.openxmlformats.org/drawingml/2006/main">
               <a:ext uri="{FF2B5EF4-FFF2-40B4-BE49-F238E27FC236}">
-                <a16:creationId xmlns:a16="http://schemas.microsoft.com/office/drawing/2014/main" id="{E302AE54-FB01-4E62-BDFA-CC513B9DB462}"/>
+                <a16:creationId xmlns:a16="http://schemas.microsoft.com/office/drawing/2014/main" id="{D9723989-C103-4DF8-A08C-34F00DABC40F}"/>
               </a:ext>
             </a:extLst>
           </p:cNvPr>
@@ -4923,7 +4928,7 @@
           <p:cNvPr id="10" name="">
             <a:extLst xmlns:a="http://schemas.openxmlformats.org/drawingml/2006/main">
               <a:ext uri="{FF2B5EF4-FFF2-40B4-BE49-F238E27FC236}">
-                <a16:creationId xmlns:a16="http://schemas.microsoft.com/office/drawing/2014/main" id="{A3C23404-5366-40BC-BA61-3F6689D35F2C}"/>
+                <a16:creationId xmlns:a16="http://schemas.microsoft.com/office/drawing/2014/main" id="{03F5A5F4-F69D-43F4-AB7B-8CE4E724E359}"/>
               </a:ext>
             </a:extLst>
           </p:cNvPr>
@@ -4968,7 +4973,7 @@
           <p:cNvPr id="11" name="">
             <a:extLst xmlns:a="http://schemas.openxmlformats.org/drawingml/2006/main">
               <a:ext uri="{FF2B5EF4-FFF2-40B4-BE49-F238E27FC236}">
-                <a16:creationId xmlns:a16="http://schemas.microsoft.com/office/drawing/2014/main" id="{1D006D34-A145-4247-8960-AE566C2F4115}"/>
+                <a16:creationId xmlns:a16="http://schemas.microsoft.com/office/drawing/2014/main" id="{79673025-25F3-4ACE-A42A-8AF2A99E3F88}"/>
               </a:ext>
             </a:extLst>
           </p:cNvPr>
@@ -5001,7 +5006,7 @@
           <p:cNvPr id="12" name="">
             <a:extLst xmlns:a="http://schemas.openxmlformats.org/drawingml/2006/main">
               <a:ext uri="{FF2B5EF4-FFF2-40B4-BE49-F238E27FC236}">
-                <a16:creationId xmlns:a16="http://schemas.microsoft.com/office/drawing/2014/main" id="{F5D595E7-D075-4A13-A465-5A1ED8E3481E}"/>
+                <a16:creationId xmlns:a16="http://schemas.microsoft.com/office/drawing/2014/main" id="{402EE4B7-9539-4B20-A0D9-D124F16E0997}"/>
               </a:ext>
             </a:extLst>
           </p:cNvPr>
@@ -5046,7 +5051,7 @@
           <p:cNvPr id="13" name="">
             <a:extLst xmlns:a="http://schemas.openxmlformats.org/drawingml/2006/main">
               <a:ext uri="{FF2B5EF4-FFF2-40B4-BE49-F238E27FC236}">
-                <a16:creationId xmlns:a16="http://schemas.microsoft.com/office/drawing/2014/main" id="{D084A9A7-89ED-492A-93E3-976F91B6B864}"/>
+                <a16:creationId xmlns:a16="http://schemas.microsoft.com/office/drawing/2014/main" id="{4EEA7F8F-5E6E-42C4-902D-B7B1FEAE0B7F}"/>
               </a:ext>
             </a:extLst>
           </p:cNvPr>
@@ -5091,7 +5096,7 @@
           <p:cNvPr id="14" name="">
             <a:extLst xmlns:a="http://schemas.openxmlformats.org/drawingml/2006/main">
               <a:ext uri="{FF2B5EF4-FFF2-40B4-BE49-F238E27FC236}">
-                <a16:creationId xmlns:a16="http://schemas.microsoft.com/office/drawing/2014/main" id="{D45F157B-DB56-4102-A322-72AE44CEFF7A}"/>
+                <a16:creationId xmlns:a16="http://schemas.microsoft.com/office/drawing/2014/main" id="{4D81A7B0-87DD-40EA-9CE3-3E82AEE595D1}"/>
               </a:ext>
             </a:extLst>
           </p:cNvPr>
@@ -5124,7 +5129,7 @@
           <p:cNvPr id="15" name="">
             <a:extLst xmlns:a="http://schemas.openxmlformats.org/drawingml/2006/main">
               <a:ext uri="{FF2B5EF4-FFF2-40B4-BE49-F238E27FC236}">
-                <a16:creationId xmlns:a16="http://schemas.microsoft.com/office/drawing/2014/main" id="{D3264823-D71C-4942-8027-CDBD8A1DEA11}"/>
+                <a16:creationId xmlns:a16="http://schemas.microsoft.com/office/drawing/2014/main" id="{C478C517-8484-4910-89C8-F25970F8657A}"/>
               </a:ext>
             </a:extLst>
           </p:cNvPr>
@@ -5169,7 +5174,7 @@
           <p:cNvPr id="16" name="">
             <a:extLst xmlns:a="http://schemas.openxmlformats.org/drawingml/2006/main">
               <a:ext uri="{FF2B5EF4-FFF2-40B4-BE49-F238E27FC236}">
-                <a16:creationId xmlns:a16="http://schemas.microsoft.com/office/drawing/2014/main" id="{1D4A549E-D095-4272-909E-0BEFF70721B8}"/>
+                <a16:creationId xmlns:a16="http://schemas.microsoft.com/office/drawing/2014/main" id="{EF36DCF5-E953-433D-96BF-67B46EEF75AE}"/>
               </a:ext>
             </a:extLst>
           </p:cNvPr>
@@ -5214,7 +5219,7 @@
           <p:cNvPr id="17" name="">
             <a:extLst xmlns:a="http://schemas.openxmlformats.org/drawingml/2006/main">
               <a:ext uri="{FF2B5EF4-FFF2-40B4-BE49-F238E27FC236}">
-                <a16:creationId xmlns:a16="http://schemas.microsoft.com/office/drawing/2014/main" id="{E3012D4E-E37E-4319-B098-4DDB2AA52D73}"/>
+                <a16:creationId xmlns:a16="http://schemas.microsoft.com/office/drawing/2014/main" id="{0258F5AF-402B-406B-8F10-2331A4D9CCD3}"/>
               </a:ext>
             </a:extLst>
           </p:cNvPr>
@@ -5247,7 +5252,7 @@
           <p:cNvPr id="18" name="">
             <a:extLst xmlns:a="http://schemas.openxmlformats.org/drawingml/2006/main">
               <a:ext uri="{FF2B5EF4-FFF2-40B4-BE49-F238E27FC236}">
-                <a16:creationId xmlns:a16="http://schemas.microsoft.com/office/drawing/2014/main" id="{E93055EF-479D-4CFE-B76B-F9C6BF64F9ED}"/>
+                <a16:creationId xmlns:a16="http://schemas.microsoft.com/office/drawing/2014/main" id="{2FC20A8D-E991-463C-8378-153DD43FB053}"/>
               </a:ext>
             </a:extLst>
           </p:cNvPr>
@@ -5292,7 +5297,7 @@
           <p:cNvPr id="19" name="">
             <a:extLst xmlns:a="http://schemas.openxmlformats.org/drawingml/2006/main">
               <a:ext uri="{FF2B5EF4-FFF2-40B4-BE49-F238E27FC236}">
-                <a16:creationId xmlns:a16="http://schemas.microsoft.com/office/drawing/2014/main" id="{D9ACCFA2-0B59-4080-B8DB-2518764049B0}"/>
+                <a16:creationId xmlns:a16="http://schemas.microsoft.com/office/drawing/2014/main" id="{D5A7984F-879E-4A25-BC2F-F122A292F732}"/>
               </a:ext>
             </a:extLst>
           </p:cNvPr>
@@ -5337,7 +5342,7 @@
           <p:cNvPr id="20" name="">
             <a:extLst xmlns:a="http://schemas.openxmlformats.org/drawingml/2006/main">
               <a:ext uri="{FF2B5EF4-FFF2-40B4-BE49-F238E27FC236}">
-                <a16:creationId xmlns:a16="http://schemas.microsoft.com/office/drawing/2014/main" id="{708A1FF8-464B-4880-AF1A-79C6A59F951C}"/>
+                <a16:creationId xmlns:a16="http://schemas.microsoft.com/office/drawing/2014/main" id="{29B7B050-7469-47B2-B09E-81AB3A63B1C4}"/>
               </a:ext>
             </a:extLst>
           </p:cNvPr>
@@ -5370,7 +5375,7 @@
           <p:cNvPr id="21" name="">
             <a:extLst xmlns:a="http://schemas.openxmlformats.org/drawingml/2006/main">
               <a:ext uri="{FF2B5EF4-FFF2-40B4-BE49-F238E27FC236}">
-                <a16:creationId xmlns:a16="http://schemas.microsoft.com/office/drawing/2014/main" id="{BC3127D7-FE62-4360-AACB-75BD017C832B}"/>
+                <a16:creationId xmlns:a16="http://schemas.microsoft.com/office/drawing/2014/main" id="{21CC97A8-8761-470B-A349-6251B6F4C86B}"/>
               </a:ext>
             </a:extLst>
           </p:cNvPr>
@@ -5415,7 +5420,7 @@
           <p:cNvPr id="22" name="">
             <a:extLst xmlns:a="http://schemas.openxmlformats.org/drawingml/2006/main">
               <a:ext uri="{FF2B5EF4-FFF2-40B4-BE49-F238E27FC236}">
-                <a16:creationId xmlns:a16="http://schemas.microsoft.com/office/drawing/2014/main" id="{7DDDC478-E25D-4B4F-97F7-ED8084917C2A}"/>
+                <a16:creationId xmlns:a16="http://schemas.microsoft.com/office/drawing/2014/main" id="{923E9B91-2255-4FFC-B717-7B1DCEECD459}"/>
               </a:ext>
             </a:extLst>
           </p:cNvPr>
@@ -5460,7 +5465,7 @@
           <p:cNvPr id="23" name="footer-left">
             <a:extLst xmlns:a="http://schemas.openxmlformats.org/drawingml/2006/main">
               <a:ext uri="{FF2B5EF4-FFF2-40B4-BE49-F238E27FC236}">
-                <a16:creationId xmlns:a16="http://schemas.microsoft.com/office/drawing/2014/main" id="{DE34F14E-4049-4FF4-B977-143BDA340685}"/>
+                <a16:creationId xmlns:a16="http://schemas.microsoft.com/office/drawing/2014/main" id="{3B1B189D-73DA-4ED9-85D3-6B7F79E122F6}"/>
               </a:ext>
             </a:extLst>
           </p:cNvPr>
@@ -5505,7 +5510,7 @@
           <p:cNvPr id="24" name="footer-right">
             <a:extLst xmlns:a="http://schemas.openxmlformats.org/drawingml/2006/main">
               <a:ext uri="{FF2B5EF4-FFF2-40B4-BE49-F238E27FC236}">
-                <a16:creationId xmlns:a16="http://schemas.microsoft.com/office/drawing/2014/main" id="{743AB6EB-E8B3-4819-9273-8E4D9B084BE6}"/>
+                <a16:creationId xmlns:a16="http://schemas.microsoft.com/office/drawing/2014/main" id="{52EA4619-8AE4-4BF4-89CE-CE688EF98D45}"/>
               </a:ext>
             </a:extLst>
           </p:cNvPr>
@@ -5548,7 +5553,7 @@
     </p:spTree>
     <p:extLst>
       <p:ext uri="{BB962C8B-B14F-4D97-AF65-F5344CB8AC3E}">
-        <p14:creationId xmlns:p14="http://schemas.microsoft.com/office/powerpoint/2010/main" val="1761691523"/>
+        <p14:creationId xmlns:p14="http://schemas.microsoft.com/office/powerpoint/2010/main" val="1742783559"/>
       </p:ext>
     </p:extLst>
   </p:cSld>
@@ -5572,7 +5577,7 @@
           <p:cNvPr id="1" name="slide-stage">
             <a:extLst xmlns:a="http://schemas.openxmlformats.org/drawingml/2006/main">
               <a:ext uri="{FF2B5EF4-FFF2-40B4-BE49-F238E27FC236}">
-                <a16:creationId xmlns:a16="http://schemas.microsoft.com/office/drawing/2014/main" id="{9187CCE6-7CAC-4A34-9CF2-CAF3ABB44FEE}"/>
+                <a16:creationId xmlns:a16="http://schemas.microsoft.com/office/drawing/2014/main" id="{A4BBDEA4-34F6-4D22-8CA5-DA1350E1A9D9}"/>
               </a:ext>
             </a:extLst>
           </p:cNvPr>
@@ -5599,7 +5604,7 @@
           <p:cNvPr id="2" name="eyebrow">
             <a:extLst xmlns:a="http://schemas.openxmlformats.org/drawingml/2006/main">
               <a:ext uri="{FF2B5EF4-FFF2-40B4-BE49-F238E27FC236}">
-                <a16:creationId xmlns:a16="http://schemas.microsoft.com/office/drawing/2014/main" id="{30F77B53-3E47-4E8A-B82E-A4C6DB7E127A}"/>
+                <a16:creationId xmlns:a16="http://schemas.microsoft.com/office/drawing/2014/main" id="{9A9FBAF3-123E-423E-B871-0B93F315C0D3}"/>
               </a:ext>
             </a:extLst>
           </p:cNvPr>
@@ -5644,7 +5649,7 @@
           <p:cNvPr id="3" name="slide-title">
             <a:extLst xmlns:a="http://schemas.openxmlformats.org/drawingml/2006/main">
               <a:ext uri="{FF2B5EF4-FFF2-40B4-BE49-F238E27FC236}">
-                <a16:creationId xmlns:a16="http://schemas.microsoft.com/office/drawing/2014/main" id="{444E50EA-6526-4704-8745-C892006B2CD7}"/>
+                <a16:creationId xmlns:a16="http://schemas.microsoft.com/office/drawing/2014/main" id="{D95F6633-ABCF-4431-B013-C210CE01D226}"/>
               </a:ext>
             </a:extLst>
           </p:cNvPr>
@@ -5689,7 +5694,7 @@
           <p:cNvPr id="4" name="slide-subtitle">
             <a:extLst xmlns:a="http://schemas.openxmlformats.org/drawingml/2006/main">
               <a:ext uri="{FF2B5EF4-FFF2-40B4-BE49-F238E27FC236}">
-                <a16:creationId xmlns:a16="http://schemas.microsoft.com/office/drawing/2014/main" id="{2BD7C25C-77BD-43AC-8669-E52447A11F3D}"/>
+                <a16:creationId xmlns:a16="http://schemas.microsoft.com/office/drawing/2014/main" id="{003701AB-8756-4DA4-B8DE-7B760AA0E66E}"/>
               </a:ext>
             </a:extLst>
           </p:cNvPr>
@@ -5734,7 +5739,7 @@
           <p:cNvPr id="5" name="">
             <a:extLst xmlns:a="http://schemas.openxmlformats.org/drawingml/2006/main">
               <a:ext uri="{FF2B5EF4-FFF2-40B4-BE49-F238E27FC236}">
-                <a16:creationId xmlns:a16="http://schemas.microsoft.com/office/drawing/2014/main" id="{8DB9E721-6A85-4713-B818-9BEE083133CB}"/>
+                <a16:creationId xmlns:a16="http://schemas.microsoft.com/office/drawing/2014/main" id="{D14948A7-9EAA-47DE-A5D3-724148641A79}"/>
               </a:ext>
             </a:extLst>
           </p:cNvPr>
@@ -5779,7 +5784,7 @@
           <p:cNvPr id="6" name="">
             <a:extLst xmlns:a="http://schemas.openxmlformats.org/drawingml/2006/main">
               <a:ext uri="{FF2B5EF4-FFF2-40B4-BE49-F238E27FC236}">
-                <a16:creationId xmlns:a16="http://schemas.microsoft.com/office/drawing/2014/main" id="{56757F39-A23C-4FDE-9476-B29990CD6C33}"/>
+                <a16:creationId xmlns:a16="http://schemas.microsoft.com/office/drawing/2014/main" id="{22BBF7D6-E1CA-4312-87B6-BC48A3C15B8C}"/>
               </a:ext>
             </a:extLst>
           </p:cNvPr>
@@ -5824,7 +5829,7 @@
           <p:cNvPr id="7" name="">
             <a:extLst xmlns:a="http://schemas.openxmlformats.org/drawingml/2006/main">
               <a:ext uri="{FF2B5EF4-FFF2-40B4-BE49-F238E27FC236}">
-                <a16:creationId xmlns:a16="http://schemas.microsoft.com/office/drawing/2014/main" id="{D3B98B7A-D886-412D-B065-0F5E9E8D7063}"/>
+                <a16:creationId xmlns:a16="http://schemas.microsoft.com/office/drawing/2014/main" id="{21ECDEAC-2BA1-4308-9972-86997C20203D}"/>
               </a:ext>
             </a:extLst>
           </p:cNvPr>
@@ -5869,7 +5874,7 @@
           <p:cNvPr id="8" name="">
             <a:extLst xmlns:a="http://schemas.openxmlformats.org/drawingml/2006/main">
               <a:ext uri="{FF2B5EF4-FFF2-40B4-BE49-F238E27FC236}">
-                <a16:creationId xmlns:a16="http://schemas.microsoft.com/office/drawing/2014/main" id="{E0B9072E-64E4-4C87-A34E-54E4FD8FB528}"/>
+                <a16:creationId xmlns:a16="http://schemas.microsoft.com/office/drawing/2014/main" id="{ED94184D-D39D-44E0-9169-392361804A0A}"/>
               </a:ext>
             </a:extLst>
           </p:cNvPr>
@@ -5914,7 +5919,7 @@
           <p:cNvPr id="9" name="">
             <a:extLst xmlns:a="http://schemas.openxmlformats.org/drawingml/2006/main">
               <a:ext uri="{FF2B5EF4-FFF2-40B4-BE49-F238E27FC236}">
-                <a16:creationId xmlns:a16="http://schemas.microsoft.com/office/drawing/2014/main" id="{C638F9DE-51EA-48FE-A6D9-89E4E40EC3F3}"/>
+                <a16:creationId xmlns:a16="http://schemas.microsoft.com/office/drawing/2014/main" id="{A949C375-54CB-43CA-A900-5CB779214F8D}"/>
               </a:ext>
             </a:extLst>
           </p:cNvPr>
@@ -5959,7 +5964,7 @@
           <p:cNvPr id="10" name="">
             <a:extLst xmlns:a="http://schemas.openxmlformats.org/drawingml/2006/main">
               <a:ext uri="{FF2B5EF4-FFF2-40B4-BE49-F238E27FC236}">
-                <a16:creationId xmlns:a16="http://schemas.microsoft.com/office/drawing/2014/main" id="{C2CE20B9-363A-4E3D-B184-4F5B64CD389F}"/>
+                <a16:creationId xmlns:a16="http://schemas.microsoft.com/office/drawing/2014/main" id="{30A6F783-4827-46C3-B1FD-04809A80BBA1}"/>
               </a:ext>
             </a:extLst>
           </p:cNvPr>
@@ -6004,7 +6009,7 @@
           <p:cNvPr id="11" name="">
             <a:extLst xmlns:a="http://schemas.openxmlformats.org/drawingml/2006/main">
               <a:ext uri="{FF2B5EF4-FFF2-40B4-BE49-F238E27FC236}">
-                <a16:creationId xmlns:a16="http://schemas.microsoft.com/office/drawing/2014/main" id="{FC02184B-8CF3-4766-8232-21A60EAEFB52}"/>
+                <a16:creationId xmlns:a16="http://schemas.microsoft.com/office/drawing/2014/main" id="{5CE4AC72-6030-4073-B342-05262C801422}"/>
               </a:ext>
             </a:extLst>
           </p:cNvPr>
@@ -6049,7 +6054,7 @@
           <p:cNvPr id="12" name="">
             <a:extLst xmlns:a="http://schemas.openxmlformats.org/drawingml/2006/main">
               <a:ext uri="{FF2B5EF4-FFF2-40B4-BE49-F238E27FC236}">
-                <a16:creationId xmlns:a16="http://schemas.microsoft.com/office/drawing/2014/main" id="{D8EC2434-FCD0-4D8F-8460-2320BB53C664}"/>
+                <a16:creationId xmlns:a16="http://schemas.microsoft.com/office/drawing/2014/main" id="{6AF86456-75B1-494D-9610-B75CCF5879AC}"/>
               </a:ext>
             </a:extLst>
           </p:cNvPr>
@@ -6094,7 +6099,7 @@
           <p:cNvPr id="13" name="">
             <a:extLst xmlns:a="http://schemas.openxmlformats.org/drawingml/2006/main">
               <a:ext uri="{FF2B5EF4-FFF2-40B4-BE49-F238E27FC236}">
-                <a16:creationId xmlns:a16="http://schemas.microsoft.com/office/drawing/2014/main" id="{829D999C-71A6-4DAC-B50B-707C2E1D2CEE}"/>
+                <a16:creationId xmlns:a16="http://schemas.microsoft.com/office/drawing/2014/main" id="{6EAD38EF-0376-4220-85AB-EDAC102AF2D5}"/>
               </a:ext>
             </a:extLst>
           </p:cNvPr>
@@ -6139,7 +6144,7 @@
           <p:cNvPr id="14" name="">
             <a:extLst xmlns:a="http://schemas.openxmlformats.org/drawingml/2006/main">
               <a:ext uri="{FF2B5EF4-FFF2-40B4-BE49-F238E27FC236}">
-                <a16:creationId xmlns:a16="http://schemas.microsoft.com/office/drawing/2014/main" id="{ADF0ACD1-93BC-4B3E-ABDE-7EB3AEC9EC28}"/>
+                <a16:creationId xmlns:a16="http://schemas.microsoft.com/office/drawing/2014/main" id="{2DDD6C29-E38B-4E2F-A208-BEA151AF9050}"/>
               </a:ext>
             </a:extLst>
           </p:cNvPr>
@@ -6184,7 +6189,7 @@
           <p:cNvPr id="15" name="footer-left">
             <a:extLst xmlns:a="http://schemas.openxmlformats.org/drawingml/2006/main">
               <a:ext uri="{FF2B5EF4-FFF2-40B4-BE49-F238E27FC236}">
-                <a16:creationId xmlns:a16="http://schemas.microsoft.com/office/drawing/2014/main" id="{18496EAD-735A-42C8-B506-57A6A2F8D164}"/>
+                <a16:creationId xmlns:a16="http://schemas.microsoft.com/office/drawing/2014/main" id="{11062FCF-8F1F-4DB2-836C-1FDA622C0E86}"/>
               </a:ext>
             </a:extLst>
           </p:cNvPr>
@@ -6229,7 +6234,7 @@
           <p:cNvPr id="16" name="footer-right">
             <a:extLst xmlns:a="http://schemas.openxmlformats.org/drawingml/2006/main">
               <a:ext uri="{FF2B5EF4-FFF2-40B4-BE49-F238E27FC236}">
-                <a16:creationId xmlns:a16="http://schemas.microsoft.com/office/drawing/2014/main" id="{1C3C372E-1144-4FDD-B332-D2B8AF5609B7}"/>
+                <a16:creationId xmlns:a16="http://schemas.microsoft.com/office/drawing/2014/main" id="{F594C0AC-C493-4332-9627-D5856C837BC7}"/>
               </a:ext>
             </a:extLst>
           </p:cNvPr>
@@ -6272,7 +6277,7 @@
     </p:spTree>
     <p:extLst>
       <p:ext uri="{BB962C8B-B14F-4D97-AF65-F5344CB8AC3E}">
-        <p14:creationId xmlns:p14="http://schemas.microsoft.com/office/powerpoint/2010/main" val="1381433028"/>
+        <p14:creationId xmlns:p14="http://schemas.microsoft.com/office/powerpoint/2010/main" val="990441153"/>
       </p:ext>
     </p:extLst>
   </p:cSld>
@@ -6296,7 +6301,7 @@
           <p:cNvPr id="1" name="slide-stage">
             <a:extLst xmlns:a="http://schemas.openxmlformats.org/drawingml/2006/main">
               <a:ext uri="{FF2B5EF4-FFF2-40B4-BE49-F238E27FC236}">
-                <a16:creationId xmlns:a16="http://schemas.microsoft.com/office/drawing/2014/main" id="{B402896F-6EF1-4541-B85B-ACC1788DFCC2}"/>
+                <a16:creationId xmlns:a16="http://schemas.microsoft.com/office/drawing/2014/main" id="{E2106AFD-8AE2-4F98-A1BD-5BBB0B421B9C}"/>
               </a:ext>
             </a:extLst>
           </p:cNvPr>
@@ -6323,7 +6328,7 @@
           <p:cNvPr id="2" name="eyebrow">
             <a:extLst xmlns:a="http://schemas.openxmlformats.org/drawingml/2006/main">
               <a:ext uri="{FF2B5EF4-FFF2-40B4-BE49-F238E27FC236}">
-                <a16:creationId xmlns:a16="http://schemas.microsoft.com/office/drawing/2014/main" id="{A9FA68EA-F2DE-4392-B5A8-CED41DDA6961}"/>
+                <a16:creationId xmlns:a16="http://schemas.microsoft.com/office/drawing/2014/main" id="{D296706F-1F6D-4DDD-AA3B-3980601E3240}"/>
               </a:ext>
             </a:extLst>
           </p:cNvPr>
@@ -6368,7 +6373,7 @@
           <p:cNvPr id="3" name="slide-title">
             <a:extLst xmlns:a="http://schemas.openxmlformats.org/drawingml/2006/main">
               <a:ext uri="{FF2B5EF4-FFF2-40B4-BE49-F238E27FC236}">
-                <a16:creationId xmlns:a16="http://schemas.microsoft.com/office/drawing/2014/main" id="{7F16C891-CCA9-4D94-9117-D547FABC035A}"/>
+                <a16:creationId xmlns:a16="http://schemas.microsoft.com/office/drawing/2014/main" id="{C00CDEE1-3CB3-4344-A74F-BE97E2D407AD}"/>
               </a:ext>
             </a:extLst>
           </p:cNvPr>
@@ -6413,7 +6418,7 @@
           <p:cNvPr id="4" name="slide-subtitle">
             <a:extLst xmlns:a="http://schemas.openxmlformats.org/drawingml/2006/main">
               <a:ext uri="{FF2B5EF4-FFF2-40B4-BE49-F238E27FC236}">
-                <a16:creationId xmlns:a16="http://schemas.microsoft.com/office/drawing/2014/main" id="{A47C26EF-F2A8-46F6-9E9D-69D93BDBEC0B}"/>
+                <a16:creationId xmlns:a16="http://schemas.microsoft.com/office/drawing/2014/main" id="{9D90B12B-68AB-4290-988D-BE5EE223DC98}"/>
               </a:ext>
             </a:extLst>
           </p:cNvPr>
@@ -6458,7 +6463,7 @@
           <p:cNvPr id="5" name="">
             <a:extLst xmlns:a="http://schemas.openxmlformats.org/drawingml/2006/main">
               <a:ext uri="{FF2B5EF4-FFF2-40B4-BE49-F238E27FC236}">
-                <a16:creationId xmlns:a16="http://schemas.microsoft.com/office/drawing/2014/main" id="{B40A948A-884F-406F-8B7D-08BDC1464A4E}"/>
+                <a16:creationId xmlns:a16="http://schemas.microsoft.com/office/drawing/2014/main" id="{65393DF6-FE08-41F7-AD6C-994CD5AE7659}"/>
               </a:ext>
             </a:extLst>
           </p:cNvPr>
@@ -6503,7 +6508,7 @@
           <p:cNvPr id="6" name="">
             <a:extLst xmlns:a="http://schemas.openxmlformats.org/drawingml/2006/main">
               <a:ext uri="{FF2B5EF4-FFF2-40B4-BE49-F238E27FC236}">
-                <a16:creationId xmlns:a16="http://schemas.microsoft.com/office/drawing/2014/main" id="{7D5064B3-2E73-4573-8C07-80338E28BE77}"/>
+                <a16:creationId xmlns:a16="http://schemas.microsoft.com/office/drawing/2014/main" id="{BCAD8A89-580D-4ED4-9A4E-6591468A7521}"/>
               </a:ext>
             </a:extLst>
           </p:cNvPr>
@@ -6548,7 +6553,7 @@
           <p:cNvPr id="7" name="">
             <a:extLst xmlns:a="http://schemas.openxmlformats.org/drawingml/2006/main">
               <a:ext uri="{FF2B5EF4-FFF2-40B4-BE49-F238E27FC236}">
-                <a16:creationId xmlns:a16="http://schemas.microsoft.com/office/drawing/2014/main" id="{468DAEA8-2BDB-4DE6-A720-7014C2F79B89}"/>
+                <a16:creationId xmlns:a16="http://schemas.microsoft.com/office/drawing/2014/main" id="{B8D35D00-FA77-4D5A-8C17-09E895371952}"/>
               </a:ext>
             </a:extLst>
           </p:cNvPr>
@@ -6593,7 +6598,7 @@
           <p:cNvPr id="8" name="">
             <a:extLst xmlns:a="http://schemas.openxmlformats.org/drawingml/2006/main">
               <a:ext uri="{FF2B5EF4-FFF2-40B4-BE49-F238E27FC236}">
-                <a16:creationId xmlns:a16="http://schemas.microsoft.com/office/drawing/2014/main" id="{024E01B6-0608-4701-A90B-640CCC3FC01E}"/>
+                <a16:creationId xmlns:a16="http://schemas.microsoft.com/office/drawing/2014/main" id="{DAE62760-AC7A-46E8-9867-79E7CF94EC28}"/>
               </a:ext>
             </a:extLst>
           </p:cNvPr>
@@ -6638,7 +6643,7 @@
           <p:cNvPr id="9" name="">
             <a:extLst xmlns:a="http://schemas.openxmlformats.org/drawingml/2006/main">
               <a:ext uri="{FF2B5EF4-FFF2-40B4-BE49-F238E27FC236}">
-                <a16:creationId xmlns:a16="http://schemas.microsoft.com/office/drawing/2014/main" id="{0314BD16-880C-4F7A-92F1-D44319C77C93}"/>
+                <a16:creationId xmlns:a16="http://schemas.microsoft.com/office/drawing/2014/main" id="{B13C97C5-F857-4557-B7C0-945C12FD865B}"/>
               </a:ext>
             </a:extLst>
           </p:cNvPr>
@@ -6683,7 +6688,7 @@
           <p:cNvPr id="10" name="">
             <a:extLst xmlns:a="http://schemas.openxmlformats.org/drawingml/2006/main">
               <a:ext uri="{FF2B5EF4-FFF2-40B4-BE49-F238E27FC236}">
-                <a16:creationId xmlns:a16="http://schemas.microsoft.com/office/drawing/2014/main" id="{99F36015-824B-4408-B0BC-457C82AA5727}"/>
+                <a16:creationId xmlns:a16="http://schemas.microsoft.com/office/drawing/2014/main" id="{139A95CE-B9E6-4E86-A26A-A95A7E197FE9}"/>
               </a:ext>
             </a:extLst>
           </p:cNvPr>
@@ -6728,7 +6733,7 @@
           <p:cNvPr id="11" name="">
             <a:extLst xmlns:a="http://schemas.openxmlformats.org/drawingml/2006/main">
               <a:ext uri="{FF2B5EF4-FFF2-40B4-BE49-F238E27FC236}">
-                <a16:creationId xmlns:a16="http://schemas.microsoft.com/office/drawing/2014/main" id="{2ECBFABF-5BDD-458B-8150-898090D2D297}"/>
+                <a16:creationId xmlns:a16="http://schemas.microsoft.com/office/drawing/2014/main" id="{91C92DF7-2C81-4BEC-8816-466D6A0AAFEE}"/>
               </a:ext>
             </a:extLst>
           </p:cNvPr>
@@ -6773,7 +6778,7 @@
           <p:cNvPr id="12" name="">
             <a:extLst xmlns:a="http://schemas.openxmlformats.org/drawingml/2006/main">
               <a:ext uri="{FF2B5EF4-FFF2-40B4-BE49-F238E27FC236}">
-                <a16:creationId xmlns:a16="http://schemas.microsoft.com/office/drawing/2014/main" id="{52500DFE-B595-4E40-BCAC-5C26FF4C9BBC}"/>
+                <a16:creationId xmlns:a16="http://schemas.microsoft.com/office/drawing/2014/main" id="{599D47D0-F097-4175-8B51-0B8241A49318}"/>
               </a:ext>
             </a:extLst>
           </p:cNvPr>
@@ -6818,7 +6823,7 @@
           <p:cNvPr id="13" name="">
             <a:extLst xmlns:a="http://schemas.openxmlformats.org/drawingml/2006/main">
               <a:ext uri="{FF2B5EF4-FFF2-40B4-BE49-F238E27FC236}">
-                <a16:creationId xmlns:a16="http://schemas.microsoft.com/office/drawing/2014/main" id="{977FC2C2-2495-4C83-8B77-CBF76390FEEF}"/>
+                <a16:creationId xmlns:a16="http://schemas.microsoft.com/office/drawing/2014/main" id="{0E9C1769-95D1-462E-9B99-C34D8CF1F6E1}"/>
               </a:ext>
             </a:extLst>
           </p:cNvPr>
@@ -6863,7 +6868,7 @@
           <p:cNvPr id="14" name="">
             <a:extLst xmlns:a="http://schemas.openxmlformats.org/drawingml/2006/main">
               <a:ext uri="{FF2B5EF4-FFF2-40B4-BE49-F238E27FC236}">
-                <a16:creationId xmlns:a16="http://schemas.microsoft.com/office/drawing/2014/main" id="{F72B6827-32CD-4241-8A28-F237693D1E2D}"/>
+                <a16:creationId xmlns:a16="http://schemas.microsoft.com/office/drawing/2014/main" id="{B4A0597E-F0FA-41DC-9CA4-C41F9C1F270E}"/>
               </a:ext>
             </a:extLst>
           </p:cNvPr>
@@ -6908,7 +6913,7 @@
           <p:cNvPr id="15" name="footer-left">
             <a:extLst xmlns:a="http://schemas.openxmlformats.org/drawingml/2006/main">
               <a:ext uri="{FF2B5EF4-FFF2-40B4-BE49-F238E27FC236}">
-                <a16:creationId xmlns:a16="http://schemas.microsoft.com/office/drawing/2014/main" id="{43814ED2-3FA5-4C8A-A794-D5FBB66FFE0B}"/>
+                <a16:creationId xmlns:a16="http://schemas.microsoft.com/office/drawing/2014/main" id="{7514B731-E1F3-4ED3-A17D-1D8610D88C8C}"/>
               </a:ext>
             </a:extLst>
           </p:cNvPr>
@@ -6953,7 +6958,7 @@
           <p:cNvPr id="16" name="footer-right">
             <a:extLst xmlns:a="http://schemas.openxmlformats.org/drawingml/2006/main">
               <a:ext uri="{FF2B5EF4-FFF2-40B4-BE49-F238E27FC236}">
-                <a16:creationId xmlns:a16="http://schemas.microsoft.com/office/drawing/2014/main" id="{07F039FA-994F-4CCF-8480-99F7FB05CBF8}"/>
+                <a16:creationId xmlns:a16="http://schemas.microsoft.com/office/drawing/2014/main" id="{B0174807-5B10-4BE5-948D-8A8955B136EC}"/>
               </a:ext>
             </a:extLst>
           </p:cNvPr>
@@ -6996,7 +7001,7 @@
     </p:spTree>
     <p:extLst>
       <p:ext uri="{BB962C8B-B14F-4D97-AF65-F5344CB8AC3E}">
-        <p14:creationId xmlns:p14="http://schemas.microsoft.com/office/powerpoint/2010/main" val="594364464"/>
+        <p14:creationId xmlns:p14="http://schemas.microsoft.com/office/powerpoint/2010/main" val="324923039"/>
       </p:ext>
     </p:extLst>
   </p:cSld>
@@ -7020,7 +7025,7 @@
           <p:cNvPr id="1" name="slide-stage">
             <a:extLst xmlns:a="http://schemas.openxmlformats.org/drawingml/2006/main">
               <a:ext uri="{FF2B5EF4-FFF2-40B4-BE49-F238E27FC236}">
-                <a16:creationId xmlns:a16="http://schemas.microsoft.com/office/drawing/2014/main" id="{F38B3170-1105-4B08-B9B3-A3F4D738A908}"/>
+                <a16:creationId xmlns:a16="http://schemas.microsoft.com/office/drawing/2014/main" id="{90859BB7-34D0-455E-84F6-4F196C886D87}"/>
               </a:ext>
             </a:extLst>
           </p:cNvPr>
@@ -7047,7 +7052,7 @@
           <p:cNvPr id="2" name="eyebrow">
             <a:extLst xmlns:a="http://schemas.openxmlformats.org/drawingml/2006/main">
               <a:ext uri="{FF2B5EF4-FFF2-40B4-BE49-F238E27FC236}">
-                <a16:creationId xmlns:a16="http://schemas.microsoft.com/office/drawing/2014/main" id="{DC89BE01-4293-44E7-9DD2-1F70482A3799}"/>
+                <a16:creationId xmlns:a16="http://schemas.microsoft.com/office/drawing/2014/main" id="{BF1E40EA-67E6-44C6-8E85-79767A9C8CD9}"/>
               </a:ext>
             </a:extLst>
           </p:cNvPr>
@@ -7092,7 +7097,7 @@
           <p:cNvPr id="3" name="slide-title">
             <a:extLst xmlns:a="http://schemas.openxmlformats.org/drawingml/2006/main">
               <a:ext uri="{FF2B5EF4-FFF2-40B4-BE49-F238E27FC236}">
-                <a16:creationId xmlns:a16="http://schemas.microsoft.com/office/drawing/2014/main" id="{09D1E222-2F2C-46C5-8F45-701C0DFA655F}"/>
+                <a16:creationId xmlns:a16="http://schemas.microsoft.com/office/drawing/2014/main" id="{3889EB71-9CC0-4783-8B00-CA09CCBBE0BB}"/>
               </a:ext>
             </a:extLst>
           </p:cNvPr>
@@ -7137,7 +7142,7 @@
           <p:cNvPr id="4" name="slide-subtitle">
             <a:extLst xmlns:a="http://schemas.openxmlformats.org/drawingml/2006/main">
               <a:ext uri="{FF2B5EF4-FFF2-40B4-BE49-F238E27FC236}">
-                <a16:creationId xmlns:a16="http://schemas.microsoft.com/office/drawing/2014/main" id="{1AD04CBA-64B3-4E8D-9C6B-F4017F328789}"/>
+                <a16:creationId xmlns:a16="http://schemas.microsoft.com/office/drawing/2014/main" id="{930298A3-288C-4C51-88E0-95FA7E90EF82}"/>
               </a:ext>
             </a:extLst>
           </p:cNvPr>
@@ -7182,7 +7187,7 @@
           <p:cNvPr id="5" name="">
             <a:extLst xmlns:a="http://schemas.openxmlformats.org/drawingml/2006/main">
               <a:ext uri="{FF2B5EF4-FFF2-40B4-BE49-F238E27FC236}">
-                <a16:creationId xmlns:a16="http://schemas.microsoft.com/office/drawing/2014/main" id="{3DD216D8-6967-4AF1-AC82-B67E0DDA3B5E}"/>
+                <a16:creationId xmlns:a16="http://schemas.microsoft.com/office/drawing/2014/main" id="{47FD772B-B2A0-4313-BDC2-EDFAAC41F05D}"/>
               </a:ext>
             </a:extLst>
           </p:cNvPr>
@@ -7215,7 +7220,7 @@
           <p:cNvPr id="6" name="">
             <a:extLst xmlns:a="http://schemas.openxmlformats.org/drawingml/2006/main">
               <a:ext uri="{FF2B5EF4-FFF2-40B4-BE49-F238E27FC236}">
-                <a16:creationId xmlns:a16="http://schemas.microsoft.com/office/drawing/2014/main" id="{1F2FAB1D-294E-42A2-BCDC-BEA30EBBB883}"/>
+                <a16:creationId xmlns:a16="http://schemas.microsoft.com/office/drawing/2014/main" id="{9154218F-A1CE-424D-9FB7-9E6653E725EB}"/>
               </a:ext>
             </a:extLst>
           </p:cNvPr>
@@ -7260,7 +7265,7 @@
           <p:cNvPr id="7" name="">
             <a:extLst xmlns:a="http://schemas.openxmlformats.org/drawingml/2006/main">
               <a:ext uri="{FF2B5EF4-FFF2-40B4-BE49-F238E27FC236}">
-                <a16:creationId xmlns:a16="http://schemas.microsoft.com/office/drawing/2014/main" id="{951B3B70-770E-48D7-8101-EFFBE605828E}"/>
+                <a16:creationId xmlns:a16="http://schemas.microsoft.com/office/drawing/2014/main" id="{B2BE9684-1389-402A-AD22-A9DAF2668740}"/>
               </a:ext>
             </a:extLst>
           </p:cNvPr>
@@ -7305,7 +7310,7 @@
           <p:cNvPr id="8" name="">
             <a:extLst xmlns:a="http://schemas.openxmlformats.org/drawingml/2006/main">
               <a:ext uri="{FF2B5EF4-FFF2-40B4-BE49-F238E27FC236}">
-                <a16:creationId xmlns:a16="http://schemas.microsoft.com/office/drawing/2014/main" id="{3045F300-3703-44AE-AE62-9EA052ACE6B9}"/>
+                <a16:creationId xmlns:a16="http://schemas.microsoft.com/office/drawing/2014/main" id="{AB430208-228D-461C-B136-C843D62434F2}"/>
               </a:ext>
             </a:extLst>
           </p:cNvPr>
@@ -7338,7 +7343,7 @@
           <p:cNvPr id="9" name="">
             <a:extLst xmlns:a="http://schemas.openxmlformats.org/drawingml/2006/main">
               <a:ext uri="{FF2B5EF4-FFF2-40B4-BE49-F238E27FC236}">
-                <a16:creationId xmlns:a16="http://schemas.microsoft.com/office/drawing/2014/main" id="{8D525213-FD34-4684-8265-AE758FE21B35}"/>
+                <a16:creationId xmlns:a16="http://schemas.microsoft.com/office/drawing/2014/main" id="{ADEFA505-BE52-4EFA-AF48-8B173313BE27}"/>
               </a:ext>
             </a:extLst>
           </p:cNvPr>
@@ -7383,7 +7388,7 @@
           <p:cNvPr id="10" name="">
             <a:extLst xmlns:a="http://schemas.openxmlformats.org/drawingml/2006/main">
               <a:ext uri="{FF2B5EF4-FFF2-40B4-BE49-F238E27FC236}">
-                <a16:creationId xmlns:a16="http://schemas.microsoft.com/office/drawing/2014/main" id="{D29CB37F-5788-4A44-8BC5-EDF8B35D3DCF}"/>
+                <a16:creationId xmlns:a16="http://schemas.microsoft.com/office/drawing/2014/main" id="{F289C442-F523-43CB-BD9F-38DD01EA93A8}"/>
               </a:ext>
             </a:extLst>
           </p:cNvPr>
@@ -7428,7 +7433,7 @@
           <p:cNvPr id="11" name="">
             <a:extLst xmlns:a="http://schemas.openxmlformats.org/drawingml/2006/main">
               <a:ext uri="{FF2B5EF4-FFF2-40B4-BE49-F238E27FC236}">
-                <a16:creationId xmlns:a16="http://schemas.microsoft.com/office/drawing/2014/main" id="{18DFF567-B21C-4955-BC61-262F4E23BEC0}"/>
+                <a16:creationId xmlns:a16="http://schemas.microsoft.com/office/drawing/2014/main" id="{7E312A6A-EFA0-4509-957C-E24CFDF9CD2B}"/>
               </a:ext>
             </a:extLst>
           </p:cNvPr>
@@ -7461,7 +7466,7 @@
           <p:cNvPr id="12" name="">
             <a:extLst xmlns:a="http://schemas.openxmlformats.org/drawingml/2006/main">
               <a:ext uri="{FF2B5EF4-FFF2-40B4-BE49-F238E27FC236}">
-                <a16:creationId xmlns:a16="http://schemas.microsoft.com/office/drawing/2014/main" id="{95A6BFDC-19E0-4AE7-9F0D-52571DC83C35}"/>
+                <a16:creationId xmlns:a16="http://schemas.microsoft.com/office/drawing/2014/main" id="{A726CFCC-46B3-4A3A-8455-821617193DAA}"/>
               </a:ext>
             </a:extLst>
           </p:cNvPr>
@@ -7506,7 +7511,7 @@
           <p:cNvPr id="13" name="">
             <a:extLst xmlns:a="http://schemas.openxmlformats.org/drawingml/2006/main">
               <a:ext uri="{FF2B5EF4-FFF2-40B4-BE49-F238E27FC236}">
-                <a16:creationId xmlns:a16="http://schemas.microsoft.com/office/drawing/2014/main" id="{D29AC59E-A73D-463D-A63E-4683826C3DD3}"/>
+                <a16:creationId xmlns:a16="http://schemas.microsoft.com/office/drawing/2014/main" id="{80937880-AB83-48B5-9B42-C04F0581B12D}"/>
               </a:ext>
             </a:extLst>
           </p:cNvPr>
@@ -7551,7 +7556,7 @@
           <p:cNvPr id="14" name="">
             <a:extLst xmlns:a="http://schemas.openxmlformats.org/drawingml/2006/main">
               <a:ext uri="{FF2B5EF4-FFF2-40B4-BE49-F238E27FC236}">
-                <a16:creationId xmlns:a16="http://schemas.microsoft.com/office/drawing/2014/main" id="{76EF1C76-8D6F-49D5-B09F-57B98158D5A8}"/>
+                <a16:creationId xmlns:a16="http://schemas.microsoft.com/office/drawing/2014/main" id="{C94C310D-9CAE-4B8C-A740-1E76F7C68839}"/>
               </a:ext>
             </a:extLst>
           </p:cNvPr>
@@ -7584,7 +7589,7 @@
           <p:cNvPr id="15" name="">
             <a:extLst xmlns:a="http://schemas.openxmlformats.org/drawingml/2006/main">
               <a:ext uri="{FF2B5EF4-FFF2-40B4-BE49-F238E27FC236}">
-                <a16:creationId xmlns:a16="http://schemas.microsoft.com/office/drawing/2014/main" id="{95D39D7D-A9C8-42B2-B84B-D7D4DF36A9E4}"/>
+                <a16:creationId xmlns:a16="http://schemas.microsoft.com/office/drawing/2014/main" id="{F5BC52EF-F9F0-4485-85A8-D0734D1A6847}"/>
               </a:ext>
             </a:extLst>
           </p:cNvPr>
@@ -7629,7 +7634,7 @@
           <p:cNvPr id="16" name="">
             <a:extLst xmlns:a="http://schemas.openxmlformats.org/drawingml/2006/main">
               <a:ext uri="{FF2B5EF4-FFF2-40B4-BE49-F238E27FC236}">
-                <a16:creationId xmlns:a16="http://schemas.microsoft.com/office/drawing/2014/main" id="{14B4F60D-B832-4731-9EDE-B9BDD6966FFE}"/>
+                <a16:creationId xmlns:a16="http://schemas.microsoft.com/office/drawing/2014/main" id="{AD15EB65-B7D3-4023-A583-279AA8AE384C}"/>
               </a:ext>
             </a:extLst>
           </p:cNvPr>
@@ -7674,7 +7679,7 @@
           <p:cNvPr id="17" name="footer-left">
             <a:extLst xmlns:a="http://schemas.openxmlformats.org/drawingml/2006/main">
               <a:ext uri="{FF2B5EF4-FFF2-40B4-BE49-F238E27FC236}">
-                <a16:creationId xmlns:a16="http://schemas.microsoft.com/office/drawing/2014/main" id="{D9B4443F-1C67-498F-8F7C-64468E427F62}"/>
+                <a16:creationId xmlns:a16="http://schemas.microsoft.com/office/drawing/2014/main" id="{8782F3B5-06B0-4029-9CD2-AD495F1A288E}"/>
               </a:ext>
             </a:extLst>
           </p:cNvPr>
@@ -7719,7 +7724,7 @@
           <p:cNvPr id="18" name="footer-right">
             <a:extLst xmlns:a="http://schemas.openxmlformats.org/drawingml/2006/main">
               <a:ext uri="{FF2B5EF4-FFF2-40B4-BE49-F238E27FC236}">
-                <a16:creationId xmlns:a16="http://schemas.microsoft.com/office/drawing/2014/main" id="{A4D0E34C-B841-41CD-8B36-9A2A01E9997B}"/>
+                <a16:creationId xmlns:a16="http://schemas.microsoft.com/office/drawing/2014/main" id="{8D9D826A-E087-46F1-9A14-6AF3FF9332D9}"/>
               </a:ext>
             </a:extLst>
           </p:cNvPr>
@@ -7762,7 +7767,7 @@
     </p:spTree>
     <p:extLst>
       <p:ext uri="{BB962C8B-B14F-4D97-AF65-F5344CB8AC3E}">
-        <p14:creationId xmlns:p14="http://schemas.microsoft.com/office/powerpoint/2010/main" val="1640546849"/>
+        <p14:creationId xmlns:p14="http://schemas.microsoft.com/office/powerpoint/2010/main" val="1689065625"/>
       </p:ext>
     </p:extLst>
   </p:cSld>
@@ -7786,7 +7791,7 @@
           <p:cNvPr id="1" name="slide-stage">
             <a:extLst xmlns:a="http://schemas.openxmlformats.org/drawingml/2006/main">
               <a:ext uri="{FF2B5EF4-FFF2-40B4-BE49-F238E27FC236}">
-                <a16:creationId xmlns:a16="http://schemas.microsoft.com/office/drawing/2014/main" id="{570B25E0-9776-43E2-A67B-F5023826EE43}"/>
+                <a16:creationId xmlns:a16="http://schemas.microsoft.com/office/drawing/2014/main" id="{257787EC-FDAE-4952-B6D5-EEF5F2D129CD}"/>
               </a:ext>
             </a:extLst>
           </p:cNvPr>
@@ -7813,7 +7818,7 @@
           <p:cNvPr id="2" name="eyebrow">
             <a:extLst xmlns:a="http://schemas.openxmlformats.org/drawingml/2006/main">
               <a:ext uri="{FF2B5EF4-FFF2-40B4-BE49-F238E27FC236}">
-                <a16:creationId xmlns:a16="http://schemas.microsoft.com/office/drawing/2014/main" id="{9582FED7-B486-4FEA-9489-84C525071A97}"/>
+                <a16:creationId xmlns:a16="http://schemas.microsoft.com/office/drawing/2014/main" id="{D0122E51-CA54-4A27-8B61-6149DD02C579}"/>
               </a:ext>
             </a:extLst>
           </p:cNvPr>
@@ -7858,7 +7863,7 @@
           <p:cNvPr id="3" name="slide-title">
             <a:extLst xmlns:a="http://schemas.openxmlformats.org/drawingml/2006/main">
               <a:ext uri="{FF2B5EF4-FFF2-40B4-BE49-F238E27FC236}">
-                <a16:creationId xmlns:a16="http://schemas.microsoft.com/office/drawing/2014/main" id="{D3664EC5-457F-4E69-8566-20BE17F32402}"/>
+                <a16:creationId xmlns:a16="http://schemas.microsoft.com/office/drawing/2014/main" id="{F7C16FEE-C834-43E8-95B9-DAB930E30EB6}"/>
               </a:ext>
             </a:extLst>
           </p:cNvPr>
@@ -7903,7 +7908,7 @@
           <p:cNvPr id="4" name="slide-subtitle">
             <a:extLst xmlns:a="http://schemas.openxmlformats.org/drawingml/2006/main">
               <a:ext uri="{FF2B5EF4-FFF2-40B4-BE49-F238E27FC236}">
-                <a16:creationId xmlns:a16="http://schemas.microsoft.com/office/drawing/2014/main" id="{91FFCA1D-3CB9-4784-B487-D940D40831CF}"/>
+                <a16:creationId xmlns:a16="http://schemas.microsoft.com/office/drawing/2014/main" id="{04891C57-7419-4F2B-B41C-32CF910FA5BE}"/>
               </a:ext>
             </a:extLst>
           </p:cNvPr>
@@ -7948,7 +7953,7 @@
           <p:cNvPr id="5" name="">
             <a:extLst xmlns:a="http://schemas.openxmlformats.org/drawingml/2006/main">
               <a:ext uri="{FF2B5EF4-FFF2-40B4-BE49-F238E27FC236}">
-                <a16:creationId xmlns:a16="http://schemas.microsoft.com/office/drawing/2014/main" id="{198F388B-3DC2-4ED2-8AD3-4856553DE659}"/>
+                <a16:creationId xmlns:a16="http://schemas.microsoft.com/office/drawing/2014/main" id="{2FB5E7A6-F971-4CB7-9A6D-58E3E65D53FE}"/>
               </a:ext>
             </a:extLst>
           </p:cNvPr>
@@ -7993,7 +7998,7 @@
           <p:cNvPr id="6" name="">
             <a:extLst xmlns:a="http://schemas.openxmlformats.org/drawingml/2006/main">
               <a:ext uri="{FF2B5EF4-FFF2-40B4-BE49-F238E27FC236}">
-                <a16:creationId xmlns:a16="http://schemas.microsoft.com/office/drawing/2014/main" id="{FB23E619-B842-4F41-9C1C-9433E4FB6ACF}"/>
+                <a16:creationId xmlns:a16="http://schemas.microsoft.com/office/drawing/2014/main" id="{96F728C8-F671-479F-A48E-05ED353C72B6}"/>
               </a:ext>
             </a:extLst>
           </p:cNvPr>
@@ -8038,7 +8043,7 @@
           <p:cNvPr id="7" name="">
             <a:extLst xmlns:a="http://schemas.openxmlformats.org/drawingml/2006/main">
               <a:ext uri="{FF2B5EF4-FFF2-40B4-BE49-F238E27FC236}">
-                <a16:creationId xmlns:a16="http://schemas.microsoft.com/office/drawing/2014/main" id="{6BA949E0-E5A6-4D51-AF3A-EF64FBEAE2A2}"/>
+                <a16:creationId xmlns:a16="http://schemas.microsoft.com/office/drawing/2014/main" id="{18915F43-C905-423C-9B99-2D62286ED13B}"/>
               </a:ext>
             </a:extLst>
           </p:cNvPr>
@@ -8071,7 +8076,7 @@
           <p:cNvPr id="8" name="">
             <a:extLst xmlns:a="http://schemas.openxmlformats.org/drawingml/2006/main">
               <a:ext uri="{FF2B5EF4-FFF2-40B4-BE49-F238E27FC236}">
-                <a16:creationId xmlns:a16="http://schemas.microsoft.com/office/drawing/2014/main" id="{17484AFC-9B6A-4849-8C7B-E7F3B2FD9513}"/>
+                <a16:creationId xmlns:a16="http://schemas.microsoft.com/office/drawing/2014/main" id="{36108535-BF91-4300-9F02-70735A5FC2E2}"/>
               </a:ext>
             </a:extLst>
           </p:cNvPr>
@@ -8116,7 +8121,7 @@
           <p:cNvPr id="9" name="">
             <a:extLst xmlns:a="http://schemas.openxmlformats.org/drawingml/2006/main">
               <a:ext uri="{FF2B5EF4-FFF2-40B4-BE49-F238E27FC236}">
-                <a16:creationId xmlns:a16="http://schemas.microsoft.com/office/drawing/2014/main" id="{A800D2D8-1A60-4896-858E-79D695C2BEEA}"/>
+                <a16:creationId xmlns:a16="http://schemas.microsoft.com/office/drawing/2014/main" id="{58F96ACE-D87B-4813-BCC9-6C543F7CE69E}"/>
               </a:ext>
             </a:extLst>
           </p:cNvPr>
@@ -8161,7 +8166,7 @@
           <p:cNvPr id="10" name="">
             <a:extLst xmlns:a="http://schemas.openxmlformats.org/drawingml/2006/main">
               <a:ext uri="{FF2B5EF4-FFF2-40B4-BE49-F238E27FC236}">
-                <a16:creationId xmlns:a16="http://schemas.microsoft.com/office/drawing/2014/main" id="{47802322-AFD2-47C7-AC78-AAD1323720EE}"/>
+                <a16:creationId xmlns:a16="http://schemas.microsoft.com/office/drawing/2014/main" id="{0B726606-84A1-4905-95AF-BD7B94A878A1}"/>
               </a:ext>
             </a:extLst>
           </p:cNvPr>
@@ -8194,7 +8199,7 @@
           <p:cNvPr id="11" name="">
             <a:extLst xmlns:a="http://schemas.openxmlformats.org/drawingml/2006/main">
               <a:ext uri="{FF2B5EF4-FFF2-40B4-BE49-F238E27FC236}">
-                <a16:creationId xmlns:a16="http://schemas.microsoft.com/office/drawing/2014/main" id="{5AFCBACA-C114-4379-B806-9A614681C500}"/>
+                <a16:creationId xmlns:a16="http://schemas.microsoft.com/office/drawing/2014/main" id="{2732D0BC-0E72-4172-A96E-836750585EB1}"/>
               </a:ext>
             </a:extLst>
           </p:cNvPr>
@@ -8239,7 +8244,7 @@
           <p:cNvPr id="12" name="">
             <a:extLst xmlns:a="http://schemas.openxmlformats.org/drawingml/2006/main">
               <a:ext uri="{FF2B5EF4-FFF2-40B4-BE49-F238E27FC236}">
-                <a16:creationId xmlns:a16="http://schemas.microsoft.com/office/drawing/2014/main" id="{2F29C9B6-E8F6-40E0-9A61-ED10CA24FFE8}"/>
+                <a16:creationId xmlns:a16="http://schemas.microsoft.com/office/drawing/2014/main" id="{1F9C48E8-F274-41C6-986F-B242739B2CE9}"/>
               </a:ext>
             </a:extLst>
           </p:cNvPr>
@@ -8284,7 +8289,7 @@
           <p:cNvPr id="13" name="">
             <a:extLst xmlns:a="http://schemas.openxmlformats.org/drawingml/2006/main">
               <a:ext uri="{FF2B5EF4-FFF2-40B4-BE49-F238E27FC236}">
-                <a16:creationId xmlns:a16="http://schemas.microsoft.com/office/drawing/2014/main" id="{D4290171-9672-46C6-9691-A00FED764E73}"/>
+                <a16:creationId xmlns:a16="http://schemas.microsoft.com/office/drawing/2014/main" id="{A0760BDD-07C5-4ABF-95CB-438B487CF904}"/>
               </a:ext>
             </a:extLst>
           </p:cNvPr>
@@ -8317,7 +8322,7 @@
           <p:cNvPr id="14" name="">
             <a:extLst xmlns:a="http://schemas.openxmlformats.org/drawingml/2006/main">
               <a:ext uri="{FF2B5EF4-FFF2-40B4-BE49-F238E27FC236}">
-                <a16:creationId xmlns:a16="http://schemas.microsoft.com/office/drawing/2014/main" id="{49289234-25FD-4574-A5CB-14F4B7B5B615}"/>
+                <a16:creationId xmlns:a16="http://schemas.microsoft.com/office/drawing/2014/main" id="{5A4D1213-CA61-49F1-A3BF-963D34A04E8C}"/>
               </a:ext>
             </a:extLst>
           </p:cNvPr>
@@ -8362,7 +8367,7 @@
           <p:cNvPr id="15" name="">
             <a:extLst xmlns:a="http://schemas.openxmlformats.org/drawingml/2006/main">
               <a:ext uri="{FF2B5EF4-FFF2-40B4-BE49-F238E27FC236}">
-                <a16:creationId xmlns:a16="http://schemas.microsoft.com/office/drawing/2014/main" id="{ACDE023E-0C16-42AA-8C90-94DA8A727EB6}"/>
+                <a16:creationId xmlns:a16="http://schemas.microsoft.com/office/drawing/2014/main" id="{282859CA-D58C-409E-82ED-FCD5801179CD}"/>
               </a:ext>
             </a:extLst>
           </p:cNvPr>
@@ -8407,7 +8412,7 @@
           <p:cNvPr id="16" name="footer-left">
             <a:extLst xmlns:a="http://schemas.openxmlformats.org/drawingml/2006/main">
               <a:ext uri="{FF2B5EF4-FFF2-40B4-BE49-F238E27FC236}">
-                <a16:creationId xmlns:a16="http://schemas.microsoft.com/office/drawing/2014/main" id="{8FAAED7B-8167-423C-9D31-54C17008ABEB}"/>
+                <a16:creationId xmlns:a16="http://schemas.microsoft.com/office/drawing/2014/main" id="{1904A290-466D-47A9-9511-D1A75E24A19B}"/>
               </a:ext>
             </a:extLst>
           </p:cNvPr>
@@ -8452,7 +8457,7 @@
           <p:cNvPr id="17" name="footer-right">
             <a:extLst xmlns:a="http://schemas.openxmlformats.org/drawingml/2006/main">
               <a:ext uri="{FF2B5EF4-FFF2-40B4-BE49-F238E27FC236}">
-                <a16:creationId xmlns:a16="http://schemas.microsoft.com/office/drawing/2014/main" id="{864B39F9-D9B5-4D2A-B589-110619C5F04A}"/>
+                <a16:creationId xmlns:a16="http://schemas.microsoft.com/office/drawing/2014/main" id="{D4582870-1D6D-4333-92B7-0506E5ACFF40}"/>
               </a:ext>
             </a:extLst>
           </p:cNvPr>
@@ -8495,7 +8500,7 @@
     </p:spTree>
     <p:extLst>
       <p:ext uri="{BB962C8B-B14F-4D97-AF65-F5344CB8AC3E}">
-        <p14:creationId xmlns:p14="http://schemas.microsoft.com/office/powerpoint/2010/main" val="883098571"/>
+        <p14:creationId xmlns:p14="http://schemas.microsoft.com/office/powerpoint/2010/main" val="898037544"/>
       </p:ext>
     </p:extLst>
   </p:cSld>
@@ -8519,7 +8524,7 @@
           <p:cNvPr id="1" name="slide-stage">
             <a:extLst xmlns:a="http://schemas.openxmlformats.org/drawingml/2006/main">
               <a:ext uri="{FF2B5EF4-FFF2-40B4-BE49-F238E27FC236}">
-                <a16:creationId xmlns:a16="http://schemas.microsoft.com/office/drawing/2014/main" id="{36439962-F143-407C-857F-5A483D03EF4F}"/>
+                <a16:creationId xmlns:a16="http://schemas.microsoft.com/office/drawing/2014/main" id="{67CE4638-CF72-454B-807E-8F1ACF0DFAC2}"/>
               </a:ext>
             </a:extLst>
           </p:cNvPr>
@@ -8546,7 +8551,7 @@
           <p:cNvPr id="2" name="eyebrow">
             <a:extLst xmlns:a="http://schemas.openxmlformats.org/drawingml/2006/main">
               <a:ext uri="{FF2B5EF4-FFF2-40B4-BE49-F238E27FC236}">
-                <a16:creationId xmlns:a16="http://schemas.microsoft.com/office/drawing/2014/main" id="{64A09503-0B29-4793-BC6D-945B1C98609C}"/>
+                <a16:creationId xmlns:a16="http://schemas.microsoft.com/office/drawing/2014/main" id="{C76ED70F-CAC0-414A-A2C8-D51F6AE39528}"/>
               </a:ext>
             </a:extLst>
           </p:cNvPr>
@@ -8591,7 +8596,7 @@
           <p:cNvPr id="3" name="slide-title">
             <a:extLst xmlns:a="http://schemas.openxmlformats.org/drawingml/2006/main">
               <a:ext uri="{FF2B5EF4-FFF2-40B4-BE49-F238E27FC236}">
-                <a16:creationId xmlns:a16="http://schemas.microsoft.com/office/drawing/2014/main" id="{1C724486-6D17-4BDA-BD28-193A293DE74C}"/>
+                <a16:creationId xmlns:a16="http://schemas.microsoft.com/office/drawing/2014/main" id="{7464B4CE-EBF4-4409-B8F5-BC97629293A8}"/>
               </a:ext>
             </a:extLst>
           </p:cNvPr>
@@ -8636,7 +8641,7 @@
           <p:cNvPr id="4" name="slide-subtitle">
             <a:extLst xmlns:a="http://schemas.openxmlformats.org/drawingml/2006/main">
               <a:ext uri="{FF2B5EF4-FFF2-40B4-BE49-F238E27FC236}">
-                <a16:creationId xmlns:a16="http://schemas.microsoft.com/office/drawing/2014/main" id="{370636EB-B438-4124-BE71-3C8F3057FB01}"/>
+                <a16:creationId xmlns:a16="http://schemas.microsoft.com/office/drawing/2014/main" id="{76F48DC3-6CC8-4B64-AB09-F12DADAFC63A}"/>
               </a:ext>
             </a:extLst>
           </p:cNvPr>
@@ -8681,7 +8686,7 @@
           <p:cNvPr id="5" name="">
             <a:extLst xmlns:a="http://schemas.openxmlformats.org/drawingml/2006/main">
               <a:ext uri="{FF2B5EF4-FFF2-40B4-BE49-F238E27FC236}">
-                <a16:creationId xmlns:a16="http://schemas.microsoft.com/office/drawing/2014/main" id="{7B620AF1-FB3D-4856-9595-1A33AB4B365F}"/>
+                <a16:creationId xmlns:a16="http://schemas.microsoft.com/office/drawing/2014/main" id="{A30204FE-D5D0-45F9-9C3C-FC07A35EE705}"/>
               </a:ext>
             </a:extLst>
           </p:cNvPr>
@@ -8726,7 +8731,7 @@
           <p:cNvPr id="6" name="">
             <a:extLst xmlns:a="http://schemas.openxmlformats.org/drawingml/2006/main">
               <a:ext uri="{FF2B5EF4-FFF2-40B4-BE49-F238E27FC236}">
-                <a16:creationId xmlns:a16="http://schemas.microsoft.com/office/drawing/2014/main" id="{4C4EEBD8-8E3B-47F4-B083-5D8A127EE270}"/>
+                <a16:creationId xmlns:a16="http://schemas.microsoft.com/office/drawing/2014/main" id="{6F2A6B3D-72E7-48F2-958F-49EE13E8B59A}"/>
               </a:ext>
             </a:extLst>
           </p:cNvPr>
@@ -8771,7 +8776,7 @@
           <p:cNvPr id="7" name="">
             <a:extLst xmlns:a="http://schemas.openxmlformats.org/drawingml/2006/main">
               <a:ext uri="{FF2B5EF4-FFF2-40B4-BE49-F238E27FC236}">
-                <a16:creationId xmlns:a16="http://schemas.microsoft.com/office/drawing/2014/main" id="{6DA3C35B-437A-4198-8073-FE678DE1A93B}"/>
+                <a16:creationId xmlns:a16="http://schemas.microsoft.com/office/drawing/2014/main" id="{73C28E2F-F135-41D0-B13F-159D2D4F976C}"/>
               </a:ext>
             </a:extLst>
           </p:cNvPr>
@@ -8816,7 +8821,7 @@
           <p:cNvPr id="8" name="">
             <a:extLst xmlns:a="http://schemas.openxmlformats.org/drawingml/2006/main">
               <a:ext uri="{FF2B5EF4-FFF2-40B4-BE49-F238E27FC236}">
-                <a16:creationId xmlns:a16="http://schemas.microsoft.com/office/drawing/2014/main" id="{79D07155-0B08-4D2B-846F-7D19FD47F90C}"/>
+                <a16:creationId xmlns:a16="http://schemas.microsoft.com/office/drawing/2014/main" id="{BA39A936-E092-4F70-988A-185F723A8543}"/>
               </a:ext>
             </a:extLst>
           </p:cNvPr>
@@ -8861,7 +8866,7 @@
           <p:cNvPr id="9" name="">
             <a:extLst xmlns:a="http://schemas.openxmlformats.org/drawingml/2006/main">
               <a:ext uri="{FF2B5EF4-FFF2-40B4-BE49-F238E27FC236}">
-                <a16:creationId xmlns:a16="http://schemas.microsoft.com/office/drawing/2014/main" id="{A73D2F1D-DAEF-4FE5-AA5A-3E129F273D89}"/>
+                <a16:creationId xmlns:a16="http://schemas.microsoft.com/office/drawing/2014/main" id="{482B532E-3A89-422C-A111-A5A47C56E16E}"/>
               </a:ext>
             </a:extLst>
           </p:cNvPr>
@@ -8906,7 +8911,7 @@
           <p:cNvPr id="10" name="">
             <a:extLst xmlns:a="http://schemas.openxmlformats.org/drawingml/2006/main">
               <a:ext uri="{FF2B5EF4-FFF2-40B4-BE49-F238E27FC236}">
-                <a16:creationId xmlns:a16="http://schemas.microsoft.com/office/drawing/2014/main" id="{32C378C3-3619-40B8-B547-ED0BFF0873DB}"/>
+                <a16:creationId xmlns:a16="http://schemas.microsoft.com/office/drawing/2014/main" id="{93FA8D8D-D721-4FCF-BCC8-84DED0BEEB75}"/>
               </a:ext>
             </a:extLst>
           </p:cNvPr>
@@ -8951,7 +8956,7 @@
           <p:cNvPr id="11" name="">
             <a:extLst xmlns:a="http://schemas.openxmlformats.org/drawingml/2006/main">
               <a:ext uri="{FF2B5EF4-FFF2-40B4-BE49-F238E27FC236}">
-                <a16:creationId xmlns:a16="http://schemas.microsoft.com/office/drawing/2014/main" id="{3CF453B0-442F-41F5-BEC1-3EEB5B09791A}"/>
+                <a16:creationId xmlns:a16="http://schemas.microsoft.com/office/drawing/2014/main" id="{49F53B4E-FE0F-4AA2-8757-C12DB5304B96}"/>
               </a:ext>
             </a:extLst>
           </p:cNvPr>
@@ -8996,7 +9001,7 @@
           <p:cNvPr id="12" name="">
             <a:extLst xmlns:a="http://schemas.openxmlformats.org/drawingml/2006/main">
               <a:ext uri="{FF2B5EF4-FFF2-40B4-BE49-F238E27FC236}">
-                <a16:creationId xmlns:a16="http://schemas.microsoft.com/office/drawing/2014/main" id="{C63CE070-E907-428E-B01B-89C913597728}"/>
+                <a16:creationId xmlns:a16="http://schemas.microsoft.com/office/drawing/2014/main" id="{B641669C-68B7-40D5-B06D-BCC58244685F}"/>
               </a:ext>
             </a:extLst>
           </p:cNvPr>
@@ -9041,7 +9046,7 @@
           <p:cNvPr id="13" name="footer-left">
             <a:extLst xmlns:a="http://schemas.openxmlformats.org/drawingml/2006/main">
               <a:ext uri="{FF2B5EF4-FFF2-40B4-BE49-F238E27FC236}">
-                <a16:creationId xmlns:a16="http://schemas.microsoft.com/office/drawing/2014/main" id="{CF33C4AC-5B8F-468A-B73D-B77279A3D32F}"/>
+                <a16:creationId xmlns:a16="http://schemas.microsoft.com/office/drawing/2014/main" id="{A1B87324-8BF2-4633-876A-73156525254F}"/>
               </a:ext>
             </a:extLst>
           </p:cNvPr>
@@ -9086,7 +9091,7 @@
           <p:cNvPr id="14" name="footer-right">
             <a:extLst xmlns:a="http://schemas.openxmlformats.org/drawingml/2006/main">
               <a:ext uri="{FF2B5EF4-FFF2-40B4-BE49-F238E27FC236}">
-                <a16:creationId xmlns:a16="http://schemas.microsoft.com/office/drawing/2014/main" id="{4F6FEE95-BF0C-42FE-8CE3-4CE2952790F2}"/>
+                <a16:creationId xmlns:a16="http://schemas.microsoft.com/office/drawing/2014/main" id="{49D51C5E-00FA-41FE-94D0-937E970FCFFE}"/>
               </a:ext>
             </a:extLst>
           </p:cNvPr>
@@ -9129,7 +9134,7 @@
     </p:spTree>
     <p:extLst>
       <p:ext uri="{BB962C8B-B14F-4D97-AF65-F5344CB8AC3E}">
-        <p14:creationId xmlns:p14="http://schemas.microsoft.com/office/powerpoint/2010/main" val="1854277021"/>
+        <p14:creationId xmlns:p14="http://schemas.microsoft.com/office/powerpoint/2010/main" val="1621208645"/>
       </p:ext>
     </p:extLst>
   </p:cSld>
@@ -9153,7 +9158,7 @@
           <p:cNvPr id="1" name="slide-stage">
             <a:extLst xmlns:a="http://schemas.openxmlformats.org/drawingml/2006/main">
               <a:ext uri="{FF2B5EF4-FFF2-40B4-BE49-F238E27FC236}">
-                <a16:creationId xmlns:a16="http://schemas.microsoft.com/office/drawing/2014/main" id="{3091B0F4-CAAC-4514-9415-84A54B9EA065}"/>
+                <a16:creationId xmlns:a16="http://schemas.microsoft.com/office/drawing/2014/main" id="{B5F98A42-862C-48BB-8C3C-AAA9C0FEC3D3}"/>
               </a:ext>
             </a:extLst>
           </p:cNvPr>
@@ -9180,7 +9185,7 @@
           <p:cNvPr id="2" name="eyebrow">
             <a:extLst xmlns:a="http://schemas.openxmlformats.org/drawingml/2006/main">
               <a:ext uri="{FF2B5EF4-FFF2-40B4-BE49-F238E27FC236}">
-                <a16:creationId xmlns:a16="http://schemas.microsoft.com/office/drawing/2014/main" id="{EEECC71A-C072-4EE3-B3D5-BDDF2AD5EE1C}"/>
+                <a16:creationId xmlns:a16="http://schemas.microsoft.com/office/drawing/2014/main" id="{F176E832-F02C-4089-B5E8-BC9D9676C8A8}"/>
               </a:ext>
             </a:extLst>
           </p:cNvPr>
@@ -9225,7 +9230,7 @@
           <p:cNvPr id="3" name="slide-title">
             <a:extLst xmlns:a="http://schemas.openxmlformats.org/drawingml/2006/main">
               <a:ext uri="{FF2B5EF4-FFF2-40B4-BE49-F238E27FC236}">
-                <a16:creationId xmlns:a16="http://schemas.microsoft.com/office/drawing/2014/main" id="{FD4581BA-B684-4A9F-86E2-C7B633572AAD}"/>
+                <a16:creationId xmlns:a16="http://schemas.microsoft.com/office/drawing/2014/main" id="{1F484CC0-E4FD-4D4D-BE61-8E577AD7A2A4}"/>
               </a:ext>
             </a:extLst>
           </p:cNvPr>
@@ -9270,7 +9275,7 @@
           <p:cNvPr id="4" name="slide-subtitle">
             <a:extLst xmlns:a="http://schemas.openxmlformats.org/drawingml/2006/main">
               <a:ext uri="{FF2B5EF4-FFF2-40B4-BE49-F238E27FC236}">
-                <a16:creationId xmlns:a16="http://schemas.microsoft.com/office/drawing/2014/main" id="{5DB5BFAA-CD3F-4E6E-993F-80D42EED172D}"/>
+                <a16:creationId xmlns:a16="http://schemas.microsoft.com/office/drawing/2014/main" id="{5E5003A5-DD30-49CA-AE37-E9CDFFC8A3D6}"/>
               </a:ext>
             </a:extLst>
           </p:cNvPr>
@@ -9315,7 +9320,7 @@
           <p:cNvPr id="5" name="">
             <a:extLst xmlns:a="http://schemas.openxmlformats.org/drawingml/2006/main">
               <a:ext uri="{FF2B5EF4-FFF2-40B4-BE49-F238E27FC236}">
-                <a16:creationId xmlns:a16="http://schemas.microsoft.com/office/drawing/2014/main" id="{ACF2AE4D-81AF-4D59-B31C-D9A50352146A}"/>
+                <a16:creationId xmlns:a16="http://schemas.microsoft.com/office/drawing/2014/main" id="{1B6204AC-4442-4304-96DA-DB64D538B551}"/>
               </a:ext>
             </a:extLst>
           </p:cNvPr>
@@ -9348,7 +9353,7 @@
           <p:cNvPr id="6" name="">
             <a:extLst xmlns:a="http://schemas.openxmlformats.org/drawingml/2006/main">
               <a:ext uri="{FF2B5EF4-FFF2-40B4-BE49-F238E27FC236}">
-                <a16:creationId xmlns:a16="http://schemas.microsoft.com/office/drawing/2014/main" id="{D3943FE9-5A0E-4409-9DB1-6C09F5B22338}"/>
+                <a16:creationId xmlns:a16="http://schemas.microsoft.com/office/drawing/2014/main" id="{2EF85E69-7BED-488E-8F15-A67F4FEEADC6}"/>
               </a:ext>
             </a:extLst>
           </p:cNvPr>
@@ -9393,7 +9398,7 @@
           <p:cNvPr id="7" name="">
             <a:extLst xmlns:a="http://schemas.openxmlformats.org/drawingml/2006/main">
               <a:ext uri="{FF2B5EF4-FFF2-40B4-BE49-F238E27FC236}">
-                <a16:creationId xmlns:a16="http://schemas.microsoft.com/office/drawing/2014/main" id="{F23BBC74-1552-47FB-B692-7056CEEF2638}"/>
+                <a16:creationId xmlns:a16="http://schemas.microsoft.com/office/drawing/2014/main" id="{45968DF2-B136-4693-8C07-4DA7B2E43F5F}"/>
               </a:ext>
             </a:extLst>
           </p:cNvPr>
@@ -9438,7 +9443,7 @@
           <p:cNvPr id="8" name="">
             <a:extLst xmlns:a="http://schemas.openxmlformats.org/drawingml/2006/main">
               <a:ext uri="{FF2B5EF4-FFF2-40B4-BE49-F238E27FC236}">
-                <a16:creationId xmlns:a16="http://schemas.microsoft.com/office/drawing/2014/main" id="{50DCE530-5F09-4038-843D-9B7814CD9696}"/>
+                <a16:creationId xmlns:a16="http://schemas.microsoft.com/office/drawing/2014/main" id="{DA19333A-A003-4097-8B15-E47AA77B880B}"/>
               </a:ext>
             </a:extLst>
           </p:cNvPr>
@@ -9471,7 +9476,7 @@
           <p:cNvPr id="9" name="">
             <a:extLst xmlns:a="http://schemas.openxmlformats.org/drawingml/2006/main">
               <a:ext uri="{FF2B5EF4-FFF2-40B4-BE49-F238E27FC236}">
-                <a16:creationId xmlns:a16="http://schemas.microsoft.com/office/drawing/2014/main" id="{E24063BA-9990-40D2-94AF-402CA828E615}"/>
+                <a16:creationId xmlns:a16="http://schemas.microsoft.com/office/drawing/2014/main" id="{E51635F3-29DD-470E-B07F-157DC3E3B619}"/>
               </a:ext>
             </a:extLst>
           </p:cNvPr>
@@ -9516,7 +9521,7 @@
           <p:cNvPr id="10" name="">
             <a:extLst xmlns:a="http://schemas.openxmlformats.org/drawingml/2006/main">
               <a:ext uri="{FF2B5EF4-FFF2-40B4-BE49-F238E27FC236}">
-                <a16:creationId xmlns:a16="http://schemas.microsoft.com/office/drawing/2014/main" id="{570FCE29-1245-400D-B63E-45B7330C6257}"/>
+                <a16:creationId xmlns:a16="http://schemas.microsoft.com/office/drawing/2014/main" id="{C71DD25C-AA4D-4239-8216-53942837658F}"/>
               </a:ext>
             </a:extLst>
           </p:cNvPr>
@@ -9561,7 +9566,7 @@
           <p:cNvPr id="11" name="">
             <a:extLst xmlns:a="http://schemas.openxmlformats.org/drawingml/2006/main">
               <a:ext uri="{FF2B5EF4-FFF2-40B4-BE49-F238E27FC236}">
-                <a16:creationId xmlns:a16="http://schemas.microsoft.com/office/drawing/2014/main" id="{1A9FC3B7-CD42-4117-B5B7-055078E67820}"/>
+                <a16:creationId xmlns:a16="http://schemas.microsoft.com/office/drawing/2014/main" id="{94D55A33-70DE-440F-AB6C-1BDB9C1C6379}"/>
               </a:ext>
             </a:extLst>
           </p:cNvPr>
@@ -9594,7 +9599,7 @@
           <p:cNvPr id="12" name="">
             <a:extLst xmlns:a="http://schemas.openxmlformats.org/drawingml/2006/main">
               <a:ext uri="{FF2B5EF4-FFF2-40B4-BE49-F238E27FC236}">
-                <a16:creationId xmlns:a16="http://schemas.microsoft.com/office/drawing/2014/main" id="{2DAB80DD-19AD-4FF9-9782-E1A5CD9D5357}"/>
+                <a16:creationId xmlns:a16="http://schemas.microsoft.com/office/drawing/2014/main" id="{BB6C93A0-96DC-49AE-86AB-4B4C5F3FADBC}"/>
               </a:ext>
             </a:extLst>
           </p:cNvPr>
@@ -9639,7 +9644,7 @@
           <p:cNvPr id="13" name="">
             <a:extLst xmlns:a="http://schemas.openxmlformats.org/drawingml/2006/main">
               <a:ext uri="{FF2B5EF4-FFF2-40B4-BE49-F238E27FC236}">
-                <a16:creationId xmlns:a16="http://schemas.microsoft.com/office/drawing/2014/main" id="{5735E3E3-0862-4030-A4FF-6AA674847D45}"/>
+                <a16:creationId xmlns:a16="http://schemas.microsoft.com/office/drawing/2014/main" id="{89E69919-3AF9-4FC7-BABF-C9FB4403BEC8}"/>
               </a:ext>
             </a:extLst>
           </p:cNvPr>
@@ -9684,7 +9689,7 @@
           <p:cNvPr id="14" name="">
             <a:extLst xmlns:a="http://schemas.openxmlformats.org/drawingml/2006/main">
               <a:ext uri="{FF2B5EF4-FFF2-40B4-BE49-F238E27FC236}">
-                <a16:creationId xmlns:a16="http://schemas.microsoft.com/office/drawing/2014/main" id="{DF9AE6CD-A9BB-433F-A150-A6792B595205}"/>
+                <a16:creationId xmlns:a16="http://schemas.microsoft.com/office/drawing/2014/main" id="{43A3BDFF-659B-4AC3-9B95-EA649DFB38EF}"/>
               </a:ext>
             </a:extLst>
           </p:cNvPr>
@@ -9729,7 +9734,7 @@
           <p:cNvPr id="15" name="footer-left">
             <a:extLst xmlns:a="http://schemas.openxmlformats.org/drawingml/2006/main">
               <a:ext uri="{FF2B5EF4-FFF2-40B4-BE49-F238E27FC236}">
-                <a16:creationId xmlns:a16="http://schemas.microsoft.com/office/drawing/2014/main" id="{A4167BAE-0BD2-473F-AD3A-8B14E2665335}"/>
+                <a16:creationId xmlns:a16="http://schemas.microsoft.com/office/drawing/2014/main" id="{8755B0F5-EDEB-4281-A8F5-71C73D91606E}"/>
               </a:ext>
             </a:extLst>
           </p:cNvPr>
@@ -9774,7 +9779,7 @@
           <p:cNvPr id="16" name="footer-right">
             <a:extLst xmlns:a="http://schemas.openxmlformats.org/drawingml/2006/main">
               <a:ext uri="{FF2B5EF4-FFF2-40B4-BE49-F238E27FC236}">
-                <a16:creationId xmlns:a16="http://schemas.microsoft.com/office/drawing/2014/main" id="{2245CB06-1161-4D76-9954-C24281E05E42}"/>
+                <a16:creationId xmlns:a16="http://schemas.microsoft.com/office/drawing/2014/main" id="{E00C2DAE-4158-4AC8-A464-BCD5C0DCA5A0}"/>
               </a:ext>
             </a:extLst>
           </p:cNvPr>
@@ -9817,7 +9822,7 @@
     </p:spTree>
     <p:extLst>
       <p:ext uri="{BB962C8B-B14F-4D97-AF65-F5344CB8AC3E}">
-        <p14:creationId xmlns:p14="http://schemas.microsoft.com/office/powerpoint/2010/main" val="1182598606"/>
+        <p14:creationId xmlns:p14="http://schemas.microsoft.com/office/powerpoint/2010/main" val="1452135391"/>
       </p:ext>
     </p:extLst>
   </p:cSld>
@@ -9841,7 +9846,7 @@
           <p:cNvPr id="1" name="slide-stage">
             <a:extLst xmlns:a="http://schemas.openxmlformats.org/drawingml/2006/main">
               <a:ext uri="{FF2B5EF4-FFF2-40B4-BE49-F238E27FC236}">
-                <a16:creationId xmlns:a16="http://schemas.microsoft.com/office/drawing/2014/main" id="{0286B3FE-DEB3-4390-AC86-43FFD81EBF23}"/>
+                <a16:creationId xmlns:a16="http://schemas.microsoft.com/office/drawing/2014/main" id="{ADA7D6BC-C614-4BFB-8992-1FA45A35EA80}"/>
               </a:ext>
             </a:extLst>
           </p:cNvPr>
@@ -9868,7 +9873,7 @@
           <p:cNvPr id="2" name="eyebrow">
             <a:extLst xmlns:a="http://schemas.openxmlformats.org/drawingml/2006/main">
               <a:ext uri="{FF2B5EF4-FFF2-40B4-BE49-F238E27FC236}">
-                <a16:creationId xmlns:a16="http://schemas.microsoft.com/office/drawing/2014/main" id="{2818AAA5-8954-4F24-AC46-BD97B9670279}"/>
+                <a16:creationId xmlns:a16="http://schemas.microsoft.com/office/drawing/2014/main" id="{C766C007-2494-4931-9C2D-FD9D4D479E26}"/>
               </a:ext>
             </a:extLst>
           </p:cNvPr>
@@ -9913,7 +9918,7 @@
           <p:cNvPr id="3" name="slide-title">
             <a:extLst xmlns:a="http://schemas.openxmlformats.org/drawingml/2006/main">
               <a:ext uri="{FF2B5EF4-FFF2-40B4-BE49-F238E27FC236}">
-                <a16:creationId xmlns:a16="http://schemas.microsoft.com/office/drawing/2014/main" id="{89C0115C-CA57-4A41-8A45-AF6CDEC72625}"/>
+                <a16:creationId xmlns:a16="http://schemas.microsoft.com/office/drawing/2014/main" id="{46FD8048-5CBF-440C-B2A9-EB1B940EBAB9}"/>
               </a:ext>
             </a:extLst>
           </p:cNvPr>
@@ -9958,7 +9963,7 @@
           <p:cNvPr id="4" name="slide-subtitle">
             <a:extLst xmlns:a="http://schemas.openxmlformats.org/drawingml/2006/main">
               <a:ext uri="{FF2B5EF4-FFF2-40B4-BE49-F238E27FC236}">
-                <a16:creationId xmlns:a16="http://schemas.microsoft.com/office/drawing/2014/main" id="{4D27B987-F126-4479-981A-A12655844AAE}"/>
+                <a16:creationId xmlns:a16="http://schemas.microsoft.com/office/drawing/2014/main" id="{1276FE7A-FBC0-445C-99D3-3423F0D14634}"/>
               </a:ext>
             </a:extLst>
           </p:cNvPr>
@@ -10003,7 +10008,7 @@
           <p:cNvPr id="5" name="">
             <a:extLst xmlns:a="http://schemas.openxmlformats.org/drawingml/2006/main">
               <a:ext uri="{FF2B5EF4-FFF2-40B4-BE49-F238E27FC236}">
-                <a16:creationId xmlns:a16="http://schemas.microsoft.com/office/drawing/2014/main" id="{2D7AC227-CACD-43DC-969D-286147D3C560}"/>
+                <a16:creationId xmlns:a16="http://schemas.microsoft.com/office/drawing/2014/main" id="{15161624-3A9A-4333-BE2C-34195FB48BF5}"/>
               </a:ext>
             </a:extLst>
           </p:cNvPr>
@@ -10048,7 +10053,7 @@
           <p:cNvPr id="6" name="">
             <a:extLst xmlns:a="http://schemas.openxmlformats.org/drawingml/2006/main">
               <a:ext uri="{FF2B5EF4-FFF2-40B4-BE49-F238E27FC236}">
-                <a16:creationId xmlns:a16="http://schemas.microsoft.com/office/drawing/2014/main" id="{198FBEEA-C2E0-4C09-B82C-0E2DAEA09241}"/>
+                <a16:creationId xmlns:a16="http://schemas.microsoft.com/office/drawing/2014/main" id="{B4D11E3C-D5EE-40DF-A1BF-A12BE0017BE8}"/>
               </a:ext>
             </a:extLst>
           </p:cNvPr>
@@ -10093,7 +10098,7 @@
           <p:cNvPr id="7" name="">
             <a:extLst xmlns:a="http://schemas.openxmlformats.org/drawingml/2006/main">
               <a:ext uri="{FF2B5EF4-FFF2-40B4-BE49-F238E27FC236}">
-                <a16:creationId xmlns:a16="http://schemas.microsoft.com/office/drawing/2014/main" id="{C1DC53AA-86D8-4D9B-86AD-A83CE3D131D2}"/>
+                <a16:creationId xmlns:a16="http://schemas.microsoft.com/office/drawing/2014/main" id="{690E6C21-63BA-4D6D-9A87-9A34BBDFF91E}"/>
               </a:ext>
             </a:extLst>
           </p:cNvPr>
@@ -10138,7 +10143,7 @@
           <p:cNvPr id="8" name="">
             <a:extLst xmlns:a="http://schemas.openxmlformats.org/drawingml/2006/main">
               <a:ext uri="{FF2B5EF4-FFF2-40B4-BE49-F238E27FC236}">
-                <a16:creationId xmlns:a16="http://schemas.microsoft.com/office/drawing/2014/main" id="{C79777D9-40A1-4989-93D3-F139315BA262}"/>
+                <a16:creationId xmlns:a16="http://schemas.microsoft.com/office/drawing/2014/main" id="{3552236D-6EAB-422C-9959-0C48E0E55C82}"/>
               </a:ext>
             </a:extLst>
           </p:cNvPr>
@@ -10183,7 +10188,7 @@
           <p:cNvPr id="9" name="">
             <a:extLst xmlns:a="http://schemas.openxmlformats.org/drawingml/2006/main">
               <a:ext uri="{FF2B5EF4-FFF2-40B4-BE49-F238E27FC236}">
-                <a16:creationId xmlns:a16="http://schemas.microsoft.com/office/drawing/2014/main" id="{20802CBE-01D3-4017-BFBA-72617D6614D6}"/>
+                <a16:creationId xmlns:a16="http://schemas.microsoft.com/office/drawing/2014/main" id="{2C52629B-42BB-4ED5-BDDC-778A948736B7}"/>
               </a:ext>
             </a:extLst>
           </p:cNvPr>
@@ -10228,7 +10233,7 @@
           <p:cNvPr id="10" name="">
             <a:extLst xmlns:a="http://schemas.openxmlformats.org/drawingml/2006/main">
               <a:ext uri="{FF2B5EF4-FFF2-40B4-BE49-F238E27FC236}">
-                <a16:creationId xmlns:a16="http://schemas.microsoft.com/office/drawing/2014/main" id="{4DA90E3E-3BC2-4279-8B13-BD9FC9C497A8}"/>
+                <a16:creationId xmlns:a16="http://schemas.microsoft.com/office/drawing/2014/main" id="{4442824C-3B60-4D81-851F-C5D94345E596}"/>
               </a:ext>
             </a:extLst>
           </p:cNvPr>
@@ -10273,7 +10278,7 @@
           <p:cNvPr id="11" name="">
             <a:extLst xmlns:a="http://schemas.openxmlformats.org/drawingml/2006/main">
               <a:ext uri="{FF2B5EF4-FFF2-40B4-BE49-F238E27FC236}">
-                <a16:creationId xmlns:a16="http://schemas.microsoft.com/office/drawing/2014/main" id="{0194CBBF-4D5F-49D0-A0B3-A0F67B33EDB1}"/>
+                <a16:creationId xmlns:a16="http://schemas.microsoft.com/office/drawing/2014/main" id="{979C30E7-F6A8-44C5-AA78-8D2951972341}"/>
               </a:ext>
             </a:extLst>
           </p:cNvPr>
@@ -10318,7 +10323,7 @@
           <p:cNvPr id="12" name="">
             <a:extLst xmlns:a="http://schemas.openxmlformats.org/drawingml/2006/main">
               <a:ext uri="{FF2B5EF4-FFF2-40B4-BE49-F238E27FC236}">
-                <a16:creationId xmlns:a16="http://schemas.microsoft.com/office/drawing/2014/main" id="{B275C517-3E5D-4C6B-8A63-674A883952C9}"/>
+                <a16:creationId xmlns:a16="http://schemas.microsoft.com/office/drawing/2014/main" id="{A400629A-C7EB-465A-AFA6-EAF4AF4A0100}"/>
               </a:ext>
             </a:extLst>
           </p:cNvPr>
@@ -10363,7 +10368,7 @@
           <p:cNvPr id="13" name="">
             <a:extLst xmlns:a="http://schemas.openxmlformats.org/drawingml/2006/main">
               <a:ext uri="{FF2B5EF4-FFF2-40B4-BE49-F238E27FC236}">
-                <a16:creationId xmlns:a16="http://schemas.microsoft.com/office/drawing/2014/main" id="{3B3E69B5-2494-455E-97C1-C19FA6F1747B}"/>
+                <a16:creationId xmlns:a16="http://schemas.microsoft.com/office/drawing/2014/main" id="{AC2D1D1C-13B5-42DB-BFB9-E25A3799DC8B}"/>
               </a:ext>
             </a:extLst>
           </p:cNvPr>
@@ -10408,7 +10413,7 @@
           <p:cNvPr id="14" name="">
             <a:extLst xmlns:a="http://schemas.openxmlformats.org/drawingml/2006/main">
               <a:ext uri="{FF2B5EF4-FFF2-40B4-BE49-F238E27FC236}">
-                <a16:creationId xmlns:a16="http://schemas.microsoft.com/office/drawing/2014/main" id="{AA6CD404-50D6-4678-A775-2D20C3B1EC36}"/>
+                <a16:creationId xmlns:a16="http://schemas.microsoft.com/office/drawing/2014/main" id="{88B56DED-832D-42A5-B863-ED8F9BC407CD}"/>
               </a:ext>
             </a:extLst>
           </p:cNvPr>
@@ -10453,7 +10458,7 @@
           <p:cNvPr id="15" name="">
             <a:extLst xmlns:a="http://schemas.openxmlformats.org/drawingml/2006/main">
               <a:ext uri="{FF2B5EF4-FFF2-40B4-BE49-F238E27FC236}">
-                <a16:creationId xmlns:a16="http://schemas.microsoft.com/office/drawing/2014/main" id="{37424A3F-332C-40CB-9F9A-CEC860D2490E}"/>
+                <a16:creationId xmlns:a16="http://schemas.microsoft.com/office/drawing/2014/main" id="{3677A383-CE17-471D-882A-84CBD0390772}"/>
               </a:ext>
             </a:extLst>
           </p:cNvPr>
@@ -10498,7 +10503,7 @@
           <p:cNvPr id="16" name="">
             <a:extLst xmlns:a="http://schemas.openxmlformats.org/drawingml/2006/main">
               <a:ext uri="{FF2B5EF4-FFF2-40B4-BE49-F238E27FC236}">
-                <a16:creationId xmlns:a16="http://schemas.microsoft.com/office/drawing/2014/main" id="{E050976E-C4AD-47B5-BFCA-D1A02E321B3B}"/>
+                <a16:creationId xmlns:a16="http://schemas.microsoft.com/office/drawing/2014/main" id="{205C5E58-F329-4678-A255-6D50162D43DF}"/>
               </a:ext>
             </a:extLst>
           </p:cNvPr>
@@ -10543,7 +10548,7 @@
           <p:cNvPr id="17" name="">
             <a:extLst xmlns:a="http://schemas.openxmlformats.org/drawingml/2006/main">
               <a:ext uri="{FF2B5EF4-FFF2-40B4-BE49-F238E27FC236}">
-                <a16:creationId xmlns:a16="http://schemas.microsoft.com/office/drawing/2014/main" id="{8AECFFC0-9A4A-4BFA-B295-DF9DDC19375C}"/>
+                <a16:creationId xmlns:a16="http://schemas.microsoft.com/office/drawing/2014/main" id="{FD0CE395-C2CF-4EFB-8F75-52C0484F0769}"/>
               </a:ext>
             </a:extLst>
           </p:cNvPr>
@@ -10588,7 +10593,7 @@
           <p:cNvPr id="18" name="">
             <a:extLst xmlns:a="http://schemas.openxmlformats.org/drawingml/2006/main">
               <a:ext uri="{FF2B5EF4-FFF2-40B4-BE49-F238E27FC236}">
-                <a16:creationId xmlns:a16="http://schemas.microsoft.com/office/drawing/2014/main" id="{8889D807-4FA0-41D8-AF3D-E58DAA51410F}"/>
+                <a16:creationId xmlns:a16="http://schemas.microsoft.com/office/drawing/2014/main" id="{36CCDC8A-6FCD-4FD9-B842-FA936543A99B}"/>
               </a:ext>
             </a:extLst>
           </p:cNvPr>
@@ -10633,7 +10638,7 @@
           <p:cNvPr id="19" name="">
             <a:extLst xmlns:a="http://schemas.openxmlformats.org/drawingml/2006/main">
               <a:ext uri="{FF2B5EF4-FFF2-40B4-BE49-F238E27FC236}">
-                <a16:creationId xmlns:a16="http://schemas.microsoft.com/office/drawing/2014/main" id="{4670DA8C-DBAA-4F04-96CB-1F5013339816}"/>
+                <a16:creationId xmlns:a16="http://schemas.microsoft.com/office/drawing/2014/main" id="{5DEE0CA4-6D85-45DD-ABAC-7CDD1B1EE8F5}"/>
               </a:ext>
             </a:extLst>
           </p:cNvPr>
@@ -10678,7 +10683,7 @@
           <p:cNvPr id="20" name="footer-left">
             <a:extLst xmlns:a="http://schemas.openxmlformats.org/drawingml/2006/main">
               <a:ext uri="{FF2B5EF4-FFF2-40B4-BE49-F238E27FC236}">
-                <a16:creationId xmlns:a16="http://schemas.microsoft.com/office/drawing/2014/main" id="{FB91F304-1C9B-4E0C-BA90-8094C35A649B}"/>
+                <a16:creationId xmlns:a16="http://schemas.microsoft.com/office/drawing/2014/main" id="{1A68E39D-7761-4E84-ADA3-996DE4B14584}"/>
               </a:ext>
             </a:extLst>
           </p:cNvPr>
@@ -10723,7 +10728,7 @@
           <p:cNvPr id="21" name="footer-right">
             <a:extLst xmlns:a="http://schemas.openxmlformats.org/drawingml/2006/main">
               <a:ext uri="{FF2B5EF4-FFF2-40B4-BE49-F238E27FC236}">
-                <a16:creationId xmlns:a16="http://schemas.microsoft.com/office/drawing/2014/main" id="{DAA97FB9-6B9E-4FB3-BDA7-671F9137E57A}"/>
+                <a16:creationId xmlns:a16="http://schemas.microsoft.com/office/drawing/2014/main" id="{4082BB75-81CE-4392-9337-6899EB652D5A}"/>
               </a:ext>
             </a:extLst>
           </p:cNvPr>
@@ -10766,7 +10771,7 @@
     </p:spTree>
     <p:extLst>
       <p:ext uri="{BB962C8B-B14F-4D97-AF65-F5344CB8AC3E}">
-        <p14:creationId xmlns:p14="http://schemas.microsoft.com/office/powerpoint/2010/main" val="1650655636"/>
+        <p14:creationId xmlns:p14="http://schemas.microsoft.com/office/powerpoint/2010/main" val="1401808842"/>
       </p:ext>
     </p:extLst>
   </p:cSld>
@@ -10790,7 +10795,7 @@
           <p:cNvPr id="1" name="slide-stage">
             <a:extLst xmlns:a="http://schemas.openxmlformats.org/drawingml/2006/main">
               <a:ext uri="{FF2B5EF4-FFF2-40B4-BE49-F238E27FC236}">
-                <a16:creationId xmlns:a16="http://schemas.microsoft.com/office/drawing/2014/main" id="{8B762F74-2918-4F95-83C1-6CF97BD559E6}"/>
+                <a16:creationId xmlns:a16="http://schemas.microsoft.com/office/drawing/2014/main" id="{6D1CB724-FFA1-49EC-A0C1-280C19242C4D}"/>
               </a:ext>
             </a:extLst>
           </p:cNvPr>
@@ -10817,7 +10822,7 @@
           <p:cNvPr id="2" name="eyebrow">
             <a:extLst xmlns:a="http://schemas.openxmlformats.org/drawingml/2006/main">
               <a:ext uri="{FF2B5EF4-FFF2-40B4-BE49-F238E27FC236}">
-                <a16:creationId xmlns:a16="http://schemas.microsoft.com/office/drawing/2014/main" id="{FCD05252-0491-4A40-975E-2C01B83BEFE4}"/>
+                <a16:creationId xmlns:a16="http://schemas.microsoft.com/office/drawing/2014/main" id="{211F6C13-EA1C-4989-AB16-D92B9C329DD0}"/>
               </a:ext>
             </a:extLst>
           </p:cNvPr>
@@ -10862,7 +10867,7 @@
           <p:cNvPr id="3" name="slide-title">
             <a:extLst xmlns:a="http://schemas.openxmlformats.org/drawingml/2006/main">
               <a:ext uri="{FF2B5EF4-FFF2-40B4-BE49-F238E27FC236}">
-                <a16:creationId xmlns:a16="http://schemas.microsoft.com/office/drawing/2014/main" id="{8D3A3F47-DD8E-4403-8699-BC0AA7D44695}"/>
+                <a16:creationId xmlns:a16="http://schemas.microsoft.com/office/drawing/2014/main" id="{940A54D9-A1C8-418F-ABC0-D4D599802585}"/>
               </a:ext>
             </a:extLst>
           </p:cNvPr>
@@ -10907,7 +10912,7 @@
           <p:cNvPr id="4" name="slide-subtitle">
             <a:extLst xmlns:a="http://schemas.openxmlformats.org/drawingml/2006/main">
               <a:ext uri="{FF2B5EF4-FFF2-40B4-BE49-F238E27FC236}">
-                <a16:creationId xmlns:a16="http://schemas.microsoft.com/office/drawing/2014/main" id="{28A07075-D7B3-464D-831C-44150A1B3139}"/>
+                <a16:creationId xmlns:a16="http://schemas.microsoft.com/office/drawing/2014/main" id="{3E2CA2AC-6ACE-435C-AA52-3EE3C4B14682}"/>
               </a:ext>
             </a:extLst>
           </p:cNvPr>
@@ -10952,7 +10957,7 @@
           <p:cNvPr id="5" name="">
             <a:extLst xmlns:a="http://schemas.openxmlformats.org/drawingml/2006/main">
               <a:ext uri="{FF2B5EF4-FFF2-40B4-BE49-F238E27FC236}">
-                <a16:creationId xmlns:a16="http://schemas.microsoft.com/office/drawing/2014/main" id="{281EC4F7-5BE3-42EF-9866-C3485A15B39F}"/>
+                <a16:creationId xmlns:a16="http://schemas.microsoft.com/office/drawing/2014/main" id="{1FD30044-3B73-4AB6-B699-3A328531C5E7}"/>
               </a:ext>
             </a:extLst>
           </p:cNvPr>
@@ -10985,7 +10990,7 @@
           <p:cNvPr id="6" name="">
             <a:extLst xmlns:a="http://schemas.openxmlformats.org/drawingml/2006/main">
               <a:ext uri="{FF2B5EF4-FFF2-40B4-BE49-F238E27FC236}">
-                <a16:creationId xmlns:a16="http://schemas.microsoft.com/office/drawing/2014/main" id="{39F5A4B3-EE4A-4322-AA01-FE4DAD3C255F}"/>
+                <a16:creationId xmlns:a16="http://schemas.microsoft.com/office/drawing/2014/main" id="{80514EE2-7B48-4CBB-B8D8-107DED260029}"/>
               </a:ext>
             </a:extLst>
           </p:cNvPr>
@@ -11081,18 +11086,18 @@
           <p:cNvPr id="7" name="">
             <a:extLst xmlns:a="http://schemas.openxmlformats.org/drawingml/2006/main">
               <a:ext uri="{FF2B5EF4-FFF2-40B4-BE49-F238E27FC236}">
-                <a16:creationId xmlns:a16="http://schemas.microsoft.com/office/drawing/2014/main" id="{A6DF28A5-41E8-4BA5-ADAF-228BFC89F4A1}"/>
-              </a:ext>
-            </a:extLst>
-          </p:cNvPr>
-          <p:cNvSpPr>
-            <a:spLocks xmlns:a="http://schemas.openxmlformats.org/drawingml/2006/main" noGrp="1"/>
-          </p:cNvSpPr>
-          <p:nvPr/>
-        </p:nvSpPr>
-        <p:spPr>
-          <a:xfrm xmlns:a="http://schemas.openxmlformats.org/drawingml/2006/main">
-            <a:off x="10194608" y="4585335"/>
+                <a16:creationId xmlns:a16="http://schemas.microsoft.com/office/drawing/2014/main" id="{32BB1340-ABC1-4610-A462-FB20A786F183}"/>
+              </a:ext>
+            </a:extLst>
+          </p:cNvPr>
+          <p:cNvSpPr>
+            <a:spLocks xmlns:a="http://schemas.openxmlformats.org/drawingml/2006/main" noGrp="1"/>
+          </p:cNvSpPr>
+          <p:nvPr/>
+        </p:nvSpPr>
+        <p:spPr>
+          <a:xfrm xmlns:a="http://schemas.openxmlformats.org/drawingml/2006/main">
+            <a:off x="10194608" y="4021455"/>
             <a:ext cx="7312343" cy="899160"/>
           </a:xfrm>
           <a:prstGeom xmlns:a="http://schemas.openxmlformats.org/drawingml/2006/main" prst="rect">
@@ -11114,18 +11119,18 @@
           <p:cNvPr id="8" name="">
             <a:extLst xmlns:a="http://schemas.openxmlformats.org/drawingml/2006/main">
               <a:ext uri="{FF2B5EF4-FFF2-40B4-BE49-F238E27FC236}">
-                <a16:creationId xmlns:a16="http://schemas.microsoft.com/office/drawing/2014/main" id="{41B04FF1-1374-4B43-94F7-B05A5A00550F}"/>
-              </a:ext>
-            </a:extLst>
-          </p:cNvPr>
-          <p:cNvSpPr>
-            <a:spLocks xmlns:a="http://schemas.openxmlformats.org/drawingml/2006/main" noGrp="1"/>
-          </p:cNvSpPr>
-          <p:nvPr/>
-        </p:nvSpPr>
-        <p:spPr>
-          <a:xfrm xmlns:a="http://schemas.openxmlformats.org/drawingml/2006/main">
-            <a:off x="10401300" y="4762500"/>
+                <a16:creationId xmlns:a16="http://schemas.microsoft.com/office/drawing/2014/main" id="{9C050E92-54E6-49AD-BDA3-A6C708CBF0FC}"/>
+              </a:ext>
+            </a:extLst>
+          </p:cNvPr>
+          <p:cNvSpPr>
+            <a:spLocks xmlns:a="http://schemas.openxmlformats.org/drawingml/2006/main" noGrp="1"/>
+          </p:cNvSpPr>
+          <p:nvPr/>
+        </p:nvSpPr>
+        <p:spPr>
+          <a:xfrm xmlns:a="http://schemas.openxmlformats.org/drawingml/2006/main">
+            <a:off x="10401300" y="4191000"/>
             <a:ext cx="6896100" cy="266700"/>
           </a:xfrm>
           <a:prstGeom xmlns:a="http://schemas.openxmlformats.org/drawingml/2006/main" prst="rect">
@@ -11159,18 +11164,18 @@
           <p:cNvPr id="9" name="">
             <a:extLst xmlns:a="http://schemas.openxmlformats.org/drawingml/2006/main">
               <a:ext uri="{FF2B5EF4-FFF2-40B4-BE49-F238E27FC236}">
-                <a16:creationId xmlns:a16="http://schemas.microsoft.com/office/drawing/2014/main" id="{87C678FD-5B9C-41CA-BD02-7843D5F72447}"/>
-              </a:ext>
-            </a:extLst>
-          </p:cNvPr>
-          <p:cNvSpPr>
-            <a:spLocks xmlns:a="http://schemas.openxmlformats.org/drawingml/2006/main" noGrp="1"/>
-          </p:cNvSpPr>
-          <p:nvPr/>
-        </p:nvSpPr>
-        <p:spPr>
-          <a:xfrm xmlns:a="http://schemas.openxmlformats.org/drawingml/2006/main">
-            <a:off x="10401300" y="5105400"/>
+                <a16:creationId xmlns:a16="http://schemas.microsoft.com/office/drawing/2014/main" id="{0ECDB333-F415-4E30-ABAA-91DA2026D843}"/>
+              </a:ext>
+            </a:extLst>
+          </p:cNvPr>
+          <p:cNvSpPr>
+            <a:spLocks xmlns:a="http://schemas.openxmlformats.org/drawingml/2006/main" noGrp="1"/>
+          </p:cNvSpPr>
+          <p:nvPr/>
+        </p:nvSpPr>
+        <p:spPr>
+          <a:xfrm xmlns:a="http://schemas.openxmlformats.org/drawingml/2006/main">
+            <a:off x="10401300" y="4533900"/>
             <a:ext cx="6896100" cy="228600"/>
           </a:xfrm>
           <a:prstGeom xmlns:a="http://schemas.openxmlformats.org/drawingml/2006/main" prst="rect">
@@ -11204,18 +11209,18 @@
           <p:cNvPr id="10" name="">
             <a:extLst xmlns:a="http://schemas.openxmlformats.org/drawingml/2006/main">
               <a:ext uri="{FF2B5EF4-FFF2-40B4-BE49-F238E27FC236}">
-                <a16:creationId xmlns:a16="http://schemas.microsoft.com/office/drawing/2014/main" id="{1D80795B-4CF7-4B64-BCB6-AE1080100C37}"/>
-              </a:ext>
-            </a:extLst>
-          </p:cNvPr>
-          <p:cNvSpPr>
-            <a:spLocks xmlns:a="http://schemas.openxmlformats.org/drawingml/2006/main" noGrp="1"/>
-          </p:cNvSpPr>
-          <p:nvPr/>
-        </p:nvSpPr>
-        <p:spPr>
-          <a:xfrm xmlns:a="http://schemas.openxmlformats.org/drawingml/2006/main">
-            <a:off x="10194608" y="5713095"/>
+                <a16:creationId xmlns:a16="http://schemas.microsoft.com/office/drawing/2014/main" id="{E3F6DA51-A05F-483F-8ECF-7A9FA316F3D1}"/>
+              </a:ext>
+            </a:extLst>
+          </p:cNvPr>
+          <p:cNvSpPr>
+            <a:spLocks xmlns:a="http://schemas.openxmlformats.org/drawingml/2006/main" noGrp="1"/>
+          </p:cNvSpPr>
+          <p:nvPr/>
+        </p:nvSpPr>
+        <p:spPr>
+          <a:xfrm xmlns:a="http://schemas.openxmlformats.org/drawingml/2006/main">
+            <a:off x="10194608" y="5149215"/>
             <a:ext cx="7312343" cy="899160"/>
           </a:xfrm>
           <a:prstGeom xmlns:a="http://schemas.openxmlformats.org/drawingml/2006/main" prst="rect">
@@ -11237,18 +11242,18 @@
           <p:cNvPr id="11" name="">
             <a:extLst xmlns:a="http://schemas.openxmlformats.org/drawingml/2006/main">
               <a:ext uri="{FF2B5EF4-FFF2-40B4-BE49-F238E27FC236}">
-                <a16:creationId xmlns:a16="http://schemas.microsoft.com/office/drawing/2014/main" id="{2C3076B2-D667-49E6-BD64-0B727AC6E042}"/>
-              </a:ext>
-            </a:extLst>
-          </p:cNvPr>
-          <p:cNvSpPr>
-            <a:spLocks xmlns:a="http://schemas.openxmlformats.org/drawingml/2006/main" noGrp="1"/>
-          </p:cNvSpPr>
-          <p:nvPr/>
-        </p:nvSpPr>
-        <p:spPr>
-          <a:xfrm xmlns:a="http://schemas.openxmlformats.org/drawingml/2006/main">
-            <a:off x="10401300" y="5886450"/>
+                <a16:creationId xmlns:a16="http://schemas.microsoft.com/office/drawing/2014/main" id="{F54532DC-7DE7-48BE-8482-05258D973F2E}"/>
+              </a:ext>
+            </a:extLst>
+          </p:cNvPr>
+          <p:cNvSpPr>
+            <a:spLocks xmlns:a="http://schemas.openxmlformats.org/drawingml/2006/main" noGrp="1"/>
+          </p:cNvSpPr>
+          <p:nvPr/>
+        </p:nvSpPr>
+        <p:spPr>
+          <a:xfrm xmlns:a="http://schemas.openxmlformats.org/drawingml/2006/main">
+            <a:off x="10401300" y="5314950"/>
             <a:ext cx="6896100" cy="266700"/>
           </a:xfrm>
           <a:prstGeom xmlns:a="http://schemas.openxmlformats.org/drawingml/2006/main" prst="rect">
@@ -11282,18 +11287,18 @@
           <p:cNvPr id="12" name="">
             <a:extLst xmlns:a="http://schemas.openxmlformats.org/drawingml/2006/main">
               <a:ext uri="{FF2B5EF4-FFF2-40B4-BE49-F238E27FC236}">
-                <a16:creationId xmlns:a16="http://schemas.microsoft.com/office/drawing/2014/main" id="{9744E718-24F0-4F8C-A535-51B6B664B447}"/>
-              </a:ext>
-            </a:extLst>
-          </p:cNvPr>
-          <p:cNvSpPr>
-            <a:spLocks xmlns:a="http://schemas.openxmlformats.org/drawingml/2006/main" noGrp="1"/>
-          </p:cNvSpPr>
-          <p:nvPr/>
-        </p:nvSpPr>
-        <p:spPr>
-          <a:xfrm xmlns:a="http://schemas.openxmlformats.org/drawingml/2006/main">
-            <a:off x="10401300" y="6229350"/>
+                <a16:creationId xmlns:a16="http://schemas.microsoft.com/office/drawing/2014/main" id="{AF3C1C29-CB04-4101-A263-7DBAB81AACE9}"/>
+              </a:ext>
+            </a:extLst>
+          </p:cNvPr>
+          <p:cNvSpPr>
+            <a:spLocks xmlns:a="http://schemas.openxmlformats.org/drawingml/2006/main" noGrp="1"/>
+          </p:cNvSpPr>
+          <p:nvPr/>
+        </p:nvSpPr>
+        <p:spPr>
+          <a:xfrm xmlns:a="http://schemas.openxmlformats.org/drawingml/2006/main">
+            <a:off x="10401300" y="5657850"/>
             <a:ext cx="6896100" cy="228600"/>
           </a:xfrm>
           <a:prstGeom xmlns:a="http://schemas.openxmlformats.org/drawingml/2006/main" prst="rect">
@@ -11327,18 +11332,18 @@
           <p:cNvPr id="13" name="">
             <a:extLst xmlns:a="http://schemas.openxmlformats.org/drawingml/2006/main">
               <a:ext uri="{FF2B5EF4-FFF2-40B4-BE49-F238E27FC236}">
-                <a16:creationId xmlns:a16="http://schemas.microsoft.com/office/drawing/2014/main" id="{4084B033-3BDA-4080-919F-2E38B648152B}"/>
-              </a:ext>
-            </a:extLst>
-          </p:cNvPr>
-          <p:cNvSpPr>
-            <a:spLocks xmlns:a="http://schemas.openxmlformats.org/drawingml/2006/main" noGrp="1"/>
-          </p:cNvSpPr>
-          <p:nvPr/>
-        </p:nvSpPr>
-        <p:spPr>
-          <a:xfrm xmlns:a="http://schemas.openxmlformats.org/drawingml/2006/main">
-            <a:off x="10194608" y="6840855"/>
+                <a16:creationId xmlns:a16="http://schemas.microsoft.com/office/drawing/2014/main" id="{2C3ABBC6-1076-44EF-A130-23A4AB955DB5}"/>
+              </a:ext>
+            </a:extLst>
+          </p:cNvPr>
+          <p:cNvSpPr>
+            <a:spLocks xmlns:a="http://schemas.openxmlformats.org/drawingml/2006/main" noGrp="1"/>
+          </p:cNvSpPr>
+          <p:nvPr/>
+        </p:nvSpPr>
+        <p:spPr>
+          <a:xfrm xmlns:a="http://schemas.openxmlformats.org/drawingml/2006/main">
+            <a:off x="10194608" y="6276975"/>
             <a:ext cx="7312343" cy="899160"/>
           </a:xfrm>
           <a:prstGeom xmlns:a="http://schemas.openxmlformats.org/drawingml/2006/main" prst="rect">
@@ -11360,18 +11365,18 @@
           <p:cNvPr id="14" name="">
             <a:extLst xmlns:a="http://schemas.openxmlformats.org/drawingml/2006/main">
               <a:ext uri="{FF2B5EF4-FFF2-40B4-BE49-F238E27FC236}">
-                <a16:creationId xmlns:a16="http://schemas.microsoft.com/office/drawing/2014/main" id="{87F3EC05-8B14-4078-86FE-C19F2FAA632D}"/>
-              </a:ext>
-            </a:extLst>
-          </p:cNvPr>
-          <p:cNvSpPr>
-            <a:spLocks xmlns:a="http://schemas.openxmlformats.org/drawingml/2006/main" noGrp="1"/>
-          </p:cNvSpPr>
-          <p:nvPr/>
-        </p:nvSpPr>
-        <p:spPr>
-          <a:xfrm xmlns:a="http://schemas.openxmlformats.org/drawingml/2006/main">
-            <a:off x="10401300" y="7010400"/>
+                <a16:creationId xmlns:a16="http://schemas.microsoft.com/office/drawing/2014/main" id="{D6B47D65-4F70-4D55-8B18-0A57E36AB06B}"/>
+              </a:ext>
+            </a:extLst>
+          </p:cNvPr>
+          <p:cNvSpPr>
+            <a:spLocks xmlns:a="http://schemas.openxmlformats.org/drawingml/2006/main" noGrp="1"/>
+          </p:cNvSpPr>
+          <p:nvPr/>
+        </p:nvSpPr>
+        <p:spPr>
+          <a:xfrm xmlns:a="http://schemas.openxmlformats.org/drawingml/2006/main">
+            <a:off x="10401300" y="6457950"/>
             <a:ext cx="6896100" cy="266700"/>
           </a:xfrm>
           <a:prstGeom xmlns:a="http://schemas.openxmlformats.org/drawingml/2006/main" prst="rect">
@@ -11405,18 +11410,18 @@
           <p:cNvPr id="15" name="">
             <a:extLst xmlns:a="http://schemas.openxmlformats.org/drawingml/2006/main">
               <a:ext uri="{FF2B5EF4-FFF2-40B4-BE49-F238E27FC236}">
-                <a16:creationId xmlns:a16="http://schemas.microsoft.com/office/drawing/2014/main" id="{202D79D8-63BE-4D7E-A634-127ACEA122D8}"/>
-              </a:ext>
-            </a:extLst>
-          </p:cNvPr>
-          <p:cNvSpPr>
-            <a:spLocks xmlns:a="http://schemas.openxmlformats.org/drawingml/2006/main" noGrp="1"/>
-          </p:cNvSpPr>
-          <p:nvPr/>
-        </p:nvSpPr>
-        <p:spPr>
-          <a:xfrm xmlns:a="http://schemas.openxmlformats.org/drawingml/2006/main">
-            <a:off x="10401300" y="7353300"/>
+                <a16:creationId xmlns:a16="http://schemas.microsoft.com/office/drawing/2014/main" id="{FB601B86-54A1-464C-B4D8-611F35F9A7F6}"/>
+              </a:ext>
+            </a:extLst>
+          </p:cNvPr>
+          <p:cNvSpPr>
+            <a:spLocks xmlns:a="http://schemas.openxmlformats.org/drawingml/2006/main" noGrp="1"/>
+          </p:cNvSpPr>
+          <p:nvPr/>
+        </p:nvSpPr>
+        <p:spPr>
+          <a:xfrm xmlns:a="http://schemas.openxmlformats.org/drawingml/2006/main">
+            <a:off x="10401300" y="6781800"/>
             <a:ext cx="6896100" cy="228600"/>
           </a:xfrm>
           <a:prstGeom xmlns:a="http://schemas.openxmlformats.org/drawingml/2006/main" prst="rect">
@@ -11440,17 +11445,140 @@
                   <a:srgbClr val="52677A"/>
                 </a:solidFill>
               </a:rPr>
-              <a:t>Blank concept fields are inferred from question plus answer text.</a:t>
-            </a:r>
-          </a:p>
-        </p:txBody>
-      </p:sp>
-      <p:sp>
-        <p:nvSpPr>
-          <p:cNvPr id="16" name="footer-left">
-            <a:extLst xmlns:a="http://schemas.openxmlformats.org/drawingml/2006/main">
-              <a:ext uri="{FF2B5EF4-FFF2-40B4-BE49-F238E27FC236}">
-                <a16:creationId xmlns:a16="http://schemas.microsoft.com/office/drawing/2014/main" id="{083215C4-C34C-48D6-8F67-F5F62268F9D0}"/>
+              <a:t>Blank or generic concepts are inferred from question plus answer text.</a:t>
+            </a:r>
+          </a:p>
+        </p:txBody>
+      </p:sp>
+      <p:sp>
+        <p:nvSpPr>
+          <p:cNvPr id="16" name="">
+            <a:extLst xmlns:a="http://schemas.openxmlformats.org/drawingml/2006/main">
+              <a:ext uri="{FF2B5EF4-FFF2-40B4-BE49-F238E27FC236}">
+                <a16:creationId xmlns:a16="http://schemas.microsoft.com/office/drawing/2014/main" id="{112C1E77-00B6-4F4D-A8C7-CACBAED3C06A}"/>
+              </a:ext>
+            </a:extLst>
+          </p:cNvPr>
+          <p:cNvSpPr>
+            <a:spLocks xmlns:a="http://schemas.openxmlformats.org/drawingml/2006/main" noGrp="1"/>
+          </p:cNvSpPr>
+          <p:nvPr/>
+        </p:nvSpPr>
+        <p:spPr>
+          <a:xfrm xmlns:a="http://schemas.openxmlformats.org/drawingml/2006/main">
+            <a:off x="10194608" y="7404735"/>
+            <a:ext cx="7312343" cy="899160"/>
+          </a:xfrm>
+          <a:prstGeom xmlns:a="http://schemas.openxmlformats.org/drawingml/2006/main" prst="rect">
+            <a:avLst/>
+          </a:prstGeom>
+          <a:solidFill xmlns:a="http://schemas.openxmlformats.org/drawingml/2006/main">
+            <a:srgbClr val="FFFFFF"/>
+          </a:solidFill>
+          <a:ln xmlns:a="http://schemas.openxmlformats.org/drawingml/2006/main" w="9525">
+            <a:solidFill>
+              <a:srgbClr val="D8E9E7"/>
+            </a:solidFill>
+            <a:prstDash val="solid"/>
+          </a:ln>
+        </p:spPr>
+      </p:sp>
+      <p:sp>
+        <p:nvSpPr>
+          <p:cNvPr id="17" name="">
+            <a:extLst xmlns:a="http://schemas.openxmlformats.org/drawingml/2006/main">
+              <a:ext uri="{FF2B5EF4-FFF2-40B4-BE49-F238E27FC236}">
+                <a16:creationId xmlns:a16="http://schemas.microsoft.com/office/drawing/2014/main" id="{BF5A4886-0C79-4426-B044-92800890EA27}"/>
+              </a:ext>
+            </a:extLst>
+          </p:cNvPr>
+          <p:cNvSpPr>
+            <a:spLocks xmlns:a="http://schemas.openxmlformats.org/drawingml/2006/main" noGrp="1"/>
+          </p:cNvSpPr>
+          <p:nvPr/>
+        </p:nvSpPr>
+        <p:spPr>
+          <a:xfrm xmlns:a="http://schemas.openxmlformats.org/drawingml/2006/main">
+            <a:off x="10401300" y="7581900"/>
+            <a:ext cx="6896100" cy="266700"/>
+          </a:xfrm>
+          <a:prstGeom xmlns:a="http://schemas.openxmlformats.org/drawingml/2006/main" prst="rect">
+            <a:avLst/>
+          </a:prstGeom>
+        </p:spPr>
+        <p:txBody>
+          <a:bodyPr xmlns:a="http://schemas.openxmlformats.org/drawingml/2006/main" lIns="0" tIns="0" rIns="0" bIns="0"/>
+          <a:lstStyle xmlns:a="http://schemas.openxmlformats.org/drawingml/2006/main"/>
+          <a:p xmlns:a="http://schemas.openxmlformats.org/drawingml/2006/main">
+            <a:pPr>
+              <a:defRPr sz="1725" b="1">
+                <a:solidFill>
+                  <a:srgbClr val="3A9D6B"/>
+                </a:solidFill>
+              </a:defRPr>
+            </a:pPr>
+            <a:r>
+              <a:rPr sz="1725" b="1">
+                <a:solidFill>
+                  <a:srgbClr val="3A9D6B"/>
+                </a:solidFill>
+              </a:rPr>
+              <a:t>Coverage</a:t>
+            </a:r>
+          </a:p>
+        </p:txBody>
+      </p:sp>
+      <p:sp>
+        <p:nvSpPr>
+          <p:cNvPr id="18" name="">
+            <a:extLst xmlns:a="http://schemas.openxmlformats.org/drawingml/2006/main">
+              <a:ext uri="{FF2B5EF4-FFF2-40B4-BE49-F238E27FC236}">
+                <a16:creationId xmlns:a16="http://schemas.microsoft.com/office/drawing/2014/main" id="{38A03D6D-073C-4FE6-95ED-1FF2F063FB03}"/>
+              </a:ext>
+            </a:extLst>
+          </p:cNvPr>
+          <p:cNvSpPr>
+            <a:spLocks xmlns:a="http://schemas.openxmlformats.org/drawingml/2006/main" noGrp="1"/>
+          </p:cNvSpPr>
+          <p:nvPr/>
+        </p:nvSpPr>
+        <p:spPr>
+          <a:xfrm xmlns:a="http://schemas.openxmlformats.org/drawingml/2006/main">
+            <a:off x="10401300" y="7924800"/>
+            <a:ext cx="6896100" cy="228600"/>
+          </a:xfrm>
+          <a:prstGeom xmlns:a="http://schemas.openxmlformats.org/drawingml/2006/main" prst="rect">
+            <a:avLst/>
+          </a:prstGeom>
+        </p:spPr>
+        <p:txBody>
+          <a:bodyPr xmlns:a="http://schemas.openxmlformats.org/drawingml/2006/main" lIns="0" tIns="0" rIns="0" bIns="0"/>
+          <a:lstStyle xmlns:a="http://schemas.openxmlformats.org/drawingml/2006/main"/>
+          <a:p xmlns:a="http://schemas.openxmlformats.org/drawingml/2006/main">
+            <a:pPr>
+              <a:defRPr sz="1425">
+                <a:solidFill>
+                  <a:srgbClr val="52677A"/>
+                </a:solidFill>
+              </a:defRPr>
+            </a:pPr>
+            <a:r>
+              <a:rPr sz="1425">
+                <a:solidFill>
+                  <a:srgbClr val="52677A"/>
+                </a:solidFill>
+              </a:rPr>
+              <a:t>Each line is marked used, context, red flag, hard stop, or review.</a:t>
+            </a:r>
+          </a:p>
+        </p:txBody>
+      </p:sp>
+      <p:sp>
+        <p:nvSpPr>
+          <p:cNvPr id="19" name="footer-left">
+            <a:extLst xmlns:a="http://schemas.openxmlformats.org/drawingml/2006/main">
+              <a:ext uri="{FF2B5EF4-FFF2-40B4-BE49-F238E27FC236}">
+                <a16:creationId xmlns:a16="http://schemas.microsoft.com/office/drawing/2014/main" id="{86D46B9E-94D7-47AC-9ACE-49693CD42D72}"/>
               </a:ext>
             </a:extLst>
           </p:cNvPr>
@@ -11492,10 +11620,10 @@
       </p:sp>
       <p:sp>
         <p:nvSpPr>
-          <p:cNvPr id="17" name="footer-right">
-            <a:extLst xmlns:a="http://schemas.openxmlformats.org/drawingml/2006/main">
-              <a:ext uri="{FF2B5EF4-FFF2-40B4-BE49-F238E27FC236}">
-                <a16:creationId xmlns:a16="http://schemas.microsoft.com/office/drawing/2014/main" id="{F7DEE0F9-105A-44EB-AADC-8526BC133A36}"/>
+          <p:cNvPr id="20" name="footer-right">
+            <a:extLst xmlns:a="http://schemas.openxmlformats.org/drawingml/2006/main">
+              <a:ext uri="{FF2B5EF4-FFF2-40B4-BE49-F238E27FC236}">
+                <a16:creationId xmlns:a16="http://schemas.microsoft.com/office/drawing/2014/main" id="{E5D5AC9D-DBB9-4EA4-9C6F-56382E8F8CD9}"/>
               </a:ext>
             </a:extLst>
           </p:cNvPr>
@@ -11538,7 +11666,7 @@
     </p:spTree>
     <p:extLst>
       <p:ext uri="{BB962C8B-B14F-4D97-AF65-F5344CB8AC3E}">
-        <p14:creationId xmlns:p14="http://schemas.microsoft.com/office/powerpoint/2010/main" val="715765277"/>
+        <p14:creationId xmlns:p14="http://schemas.microsoft.com/office/powerpoint/2010/main" val="836998761"/>
       </p:ext>
     </p:extLst>
   </p:cSld>
@@ -11562,7 +11690,7 @@
           <p:cNvPr id="1" name="slide-stage">
             <a:extLst xmlns:a="http://schemas.openxmlformats.org/drawingml/2006/main">
               <a:ext uri="{FF2B5EF4-FFF2-40B4-BE49-F238E27FC236}">
-                <a16:creationId xmlns:a16="http://schemas.microsoft.com/office/drawing/2014/main" id="{F106C5A2-65BA-4B02-BBD7-52558CDC83AC}"/>
+                <a16:creationId xmlns:a16="http://schemas.microsoft.com/office/drawing/2014/main" id="{8371760A-42E4-4DAB-A861-32787606BA6A}"/>
               </a:ext>
             </a:extLst>
           </p:cNvPr>
@@ -11589,7 +11717,7 @@
           <p:cNvPr id="2" name="eyebrow">
             <a:extLst xmlns:a="http://schemas.openxmlformats.org/drawingml/2006/main">
               <a:ext uri="{FF2B5EF4-FFF2-40B4-BE49-F238E27FC236}">
-                <a16:creationId xmlns:a16="http://schemas.microsoft.com/office/drawing/2014/main" id="{ED81A0C5-2C26-4170-904E-30FF61D90B76}"/>
+                <a16:creationId xmlns:a16="http://schemas.microsoft.com/office/drawing/2014/main" id="{9C43446A-F07D-4190-B8A7-CB0AA86DDD61}"/>
               </a:ext>
             </a:extLst>
           </p:cNvPr>
@@ -11634,7 +11762,7 @@
           <p:cNvPr id="3" name="slide-title">
             <a:extLst xmlns:a="http://schemas.openxmlformats.org/drawingml/2006/main">
               <a:ext uri="{FF2B5EF4-FFF2-40B4-BE49-F238E27FC236}">
-                <a16:creationId xmlns:a16="http://schemas.microsoft.com/office/drawing/2014/main" id="{66CEEE43-3B47-44B1-AF4E-B22CAEE06A5A}"/>
+                <a16:creationId xmlns:a16="http://schemas.microsoft.com/office/drawing/2014/main" id="{C203CD08-5529-4EF5-997B-3B3C40AF47BC}"/>
               </a:ext>
             </a:extLst>
           </p:cNvPr>
@@ -11679,7 +11807,7 @@
           <p:cNvPr id="4" name="slide-subtitle">
             <a:extLst xmlns:a="http://schemas.openxmlformats.org/drawingml/2006/main">
               <a:ext uri="{FF2B5EF4-FFF2-40B4-BE49-F238E27FC236}">
-                <a16:creationId xmlns:a16="http://schemas.microsoft.com/office/drawing/2014/main" id="{DA57D0CE-CEC3-4C3C-A970-D266C96208F0}"/>
+                <a16:creationId xmlns:a16="http://schemas.microsoft.com/office/drawing/2014/main" id="{F040C72C-04B1-46BD-AE88-BBC06C894F86}"/>
               </a:ext>
             </a:extLst>
           </p:cNvPr>
@@ -11724,7 +11852,7 @@
           <p:cNvPr id="5" name="">
             <a:extLst xmlns:a="http://schemas.openxmlformats.org/drawingml/2006/main">
               <a:ext uri="{FF2B5EF4-FFF2-40B4-BE49-F238E27FC236}">
-                <a16:creationId xmlns:a16="http://schemas.microsoft.com/office/drawing/2014/main" id="{702517CE-97B4-4D85-8866-EB2B52941E6E}"/>
+                <a16:creationId xmlns:a16="http://schemas.microsoft.com/office/drawing/2014/main" id="{544039A7-DBA8-4D55-B438-27A2CAEEF173}"/>
               </a:ext>
             </a:extLst>
           </p:cNvPr>
@@ -11757,7 +11885,7 @@
           <p:cNvPr id="6" name="">
             <a:extLst xmlns:a="http://schemas.openxmlformats.org/drawingml/2006/main">
               <a:ext uri="{FF2B5EF4-FFF2-40B4-BE49-F238E27FC236}">
-                <a16:creationId xmlns:a16="http://schemas.microsoft.com/office/drawing/2014/main" id="{A558CDE6-6E21-419C-8EB1-784B2BD2ABD7}"/>
+                <a16:creationId xmlns:a16="http://schemas.microsoft.com/office/drawing/2014/main" id="{6C683728-4D27-4877-A6B6-DAF45BDCDC05}"/>
               </a:ext>
             </a:extLst>
           </p:cNvPr>
@@ -11802,7 +11930,7 @@
           <p:cNvPr id="7" name="">
             <a:extLst xmlns:a="http://schemas.openxmlformats.org/drawingml/2006/main">
               <a:ext uri="{FF2B5EF4-FFF2-40B4-BE49-F238E27FC236}">
-                <a16:creationId xmlns:a16="http://schemas.microsoft.com/office/drawing/2014/main" id="{1B940AA6-B0A9-4BE0-B779-9BAE983E5890}"/>
+                <a16:creationId xmlns:a16="http://schemas.microsoft.com/office/drawing/2014/main" id="{009B2B89-9CE7-4AEB-8BB8-C0300EBF3E65}"/>
               </a:ext>
             </a:extLst>
           </p:cNvPr>
@@ -11837,7 +11965,7 @@
                   <a:srgbClr val="52677A"/>
                 </a:solidFill>
               </a:rPr>
-              <a:t>Dialogue, source, patient context</a:t>
+              <a:t>Transcript + coverage audit</a:t>
             </a:r>
           </a:p>
         </p:txBody>
@@ -11847,7 +11975,7 @@
           <p:cNvPr id="8" name="">
             <a:extLst xmlns:a="http://schemas.openxmlformats.org/drawingml/2006/main">
               <a:ext uri="{FF2B5EF4-FFF2-40B4-BE49-F238E27FC236}">
-                <a16:creationId xmlns:a16="http://schemas.microsoft.com/office/drawing/2014/main" id="{403B32F5-6354-4174-9A29-1EE8AF0C6F91}"/>
+                <a16:creationId xmlns:a16="http://schemas.microsoft.com/office/drawing/2014/main" id="{428DE7AD-10E9-4B44-8E7A-5099A05DE8D5}"/>
               </a:ext>
             </a:extLst>
           </p:cNvPr>
@@ -11892,7 +12020,7 @@
           <p:cNvPr id="9" name="">
             <a:extLst xmlns:a="http://schemas.openxmlformats.org/drawingml/2006/main">
               <a:ext uri="{FF2B5EF4-FFF2-40B4-BE49-F238E27FC236}">
-                <a16:creationId xmlns:a16="http://schemas.microsoft.com/office/drawing/2014/main" id="{064A02CD-B14E-4BA8-9AB1-A6C326D10D48}"/>
+                <a16:creationId xmlns:a16="http://schemas.microsoft.com/office/drawing/2014/main" id="{4BEA4922-8F01-496C-B4FB-BD51FC719258}"/>
               </a:ext>
             </a:extLst>
           </p:cNvPr>
@@ -11925,7 +12053,7 @@
           <p:cNvPr id="10" name="">
             <a:extLst xmlns:a="http://schemas.openxmlformats.org/drawingml/2006/main">
               <a:ext uri="{FF2B5EF4-FFF2-40B4-BE49-F238E27FC236}">
-                <a16:creationId xmlns:a16="http://schemas.microsoft.com/office/drawing/2014/main" id="{16783F4B-2F25-4607-9D23-3F544F8FB14D}"/>
+                <a16:creationId xmlns:a16="http://schemas.microsoft.com/office/drawing/2014/main" id="{9B036126-9439-42C4-BAA1-FBFCCCF93E7B}"/>
               </a:ext>
             </a:extLst>
           </p:cNvPr>
@@ -11970,7 +12098,7 @@
           <p:cNvPr id="11" name="">
             <a:extLst xmlns:a="http://schemas.openxmlformats.org/drawingml/2006/main">
               <a:ext uri="{FF2B5EF4-FFF2-40B4-BE49-F238E27FC236}">
-                <a16:creationId xmlns:a16="http://schemas.microsoft.com/office/drawing/2014/main" id="{5308CCB0-EA0A-48D9-A012-CA32D01286C8}"/>
+                <a16:creationId xmlns:a16="http://schemas.microsoft.com/office/drawing/2014/main" id="{8CA6D2DC-DB49-43A7-9163-720D4EBCC2B8}"/>
               </a:ext>
             </a:extLst>
           </p:cNvPr>
@@ -12015,7 +12143,7 @@
           <p:cNvPr id="12" name="">
             <a:extLst xmlns:a="http://schemas.openxmlformats.org/drawingml/2006/main">
               <a:ext uri="{FF2B5EF4-FFF2-40B4-BE49-F238E27FC236}">
-                <a16:creationId xmlns:a16="http://schemas.microsoft.com/office/drawing/2014/main" id="{A77659BE-1F64-4C71-9B12-506F9343AC0A}"/>
+                <a16:creationId xmlns:a16="http://schemas.microsoft.com/office/drawing/2014/main" id="{55925FF5-14E8-4055-86BE-531A61F78706}"/>
               </a:ext>
             </a:extLst>
           </p:cNvPr>
@@ -12060,7 +12188,7 @@
           <p:cNvPr id="13" name="">
             <a:extLst xmlns:a="http://schemas.openxmlformats.org/drawingml/2006/main">
               <a:ext uri="{FF2B5EF4-FFF2-40B4-BE49-F238E27FC236}">
-                <a16:creationId xmlns:a16="http://schemas.microsoft.com/office/drawing/2014/main" id="{BDF8F5EC-AA9E-438B-B5AF-BA92CA5A756A}"/>
+                <a16:creationId xmlns:a16="http://schemas.microsoft.com/office/drawing/2014/main" id="{A2811509-31CE-4E41-A3E6-686A80C19767}"/>
               </a:ext>
             </a:extLst>
           </p:cNvPr>
@@ -12093,7 +12221,7 @@
           <p:cNvPr id="14" name="">
             <a:extLst xmlns:a="http://schemas.openxmlformats.org/drawingml/2006/main">
               <a:ext uri="{FF2B5EF4-FFF2-40B4-BE49-F238E27FC236}">
-                <a16:creationId xmlns:a16="http://schemas.microsoft.com/office/drawing/2014/main" id="{8934D15B-5600-41AB-A928-521385E45FC7}"/>
+                <a16:creationId xmlns:a16="http://schemas.microsoft.com/office/drawing/2014/main" id="{958EEB85-AC65-42B0-99C3-4FFCF3B7290A}"/>
               </a:ext>
             </a:extLst>
           </p:cNvPr>
@@ -12138,7 +12266,7 @@
           <p:cNvPr id="15" name="">
             <a:extLst xmlns:a="http://schemas.openxmlformats.org/drawingml/2006/main">
               <a:ext uri="{FF2B5EF4-FFF2-40B4-BE49-F238E27FC236}">
-                <a16:creationId xmlns:a16="http://schemas.microsoft.com/office/drawing/2014/main" id="{4234885C-E5CB-45CB-92DE-C50B58F2392A}"/>
+                <a16:creationId xmlns:a16="http://schemas.microsoft.com/office/drawing/2014/main" id="{2770A087-0CBF-4341-9248-1786BBD3C3D5}"/>
               </a:ext>
             </a:extLst>
           </p:cNvPr>
@@ -12183,7 +12311,7 @@
           <p:cNvPr id="16" name="">
             <a:extLst xmlns:a="http://schemas.openxmlformats.org/drawingml/2006/main">
               <a:ext uri="{FF2B5EF4-FFF2-40B4-BE49-F238E27FC236}">
-                <a16:creationId xmlns:a16="http://schemas.microsoft.com/office/drawing/2014/main" id="{95C0AD0E-F04A-4D74-90AF-E44BC3338961}"/>
+                <a16:creationId xmlns:a16="http://schemas.microsoft.com/office/drawing/2014/main" id="{5866A73E-6175-47D3-A705-3B33E1CB94AF}"/>
               </a:ext>
             </a:extLst>
           </p:cNvPr>
@@ -12228,7 +12356,7 @@
           <p:cNvPr id="17" name="">
             <a:extLst xmlns:a="http://schemas.openxmlformats.org/drawingml/2006/main">
               <a:ext uri="{FF2B5EF4-FFF2-40B4-BE49-F238E27FC236}">
-                <a16:creationId xmlns:a16="http://schemas.microsoft.com/office/drawing/2014/main" id="{DC3628D6-78BE-4F87-B44E-20612B3DDF2B}"/>
+                <a16:creationId xmlns:a16="http://schemas.microsoft.com/office/drawing/2014/main" id="{23E71F6C-72C7-4E5D-9788-47FDA4E9EE08}"/>
               </a:ext>
             </a:extLst>
           </p:cNvPr>
@@ -12261,7 +12389,7 @@
           <p:cNvPr id="18" name="">
             <a:extLst xmlns:a="http://schemas.openxmlformats.org/drawingml/2006/main">
               <a:ext uri="{FF2B5EF4-FFF2-40B4-BE49-F238E27FC236}">
-                <a16:creationId xmlns:a16="http://schemas.microsoft.com/office/drawing/2014/main" id="{F9B01E5D-642E-456A-A805-CF7C77B9994A}"/>
+                <a16:creationId xmlns:a16="http://schemas.microsoft.com/office/drawing/2014/main" id="{8ED8157B-A2BF-47BF-B5DB-8211F88DD130}"/>
               </a:ext>
             </a:extLst>
           </p:cNvPr>
@@ -12306,7 +12434,7 @@
           <p:cNvPr id="19" name="">
             <a:extLst xmlns:a="http://schemas.openxmlformats.org/drawingml/2006/main">
               <a:ext uri="{FF2B5EF4-FFF2-40B4-BE49-F238E27FC236}">
-                <a16:creationId xmlns:a16="http://schemas.microsoft.com/office/drawing/2014/main" id="{DB57DC81-66E4-45E5-BB27-B703D8FBFBFA}"/>
+                <a16:creationId xmlns:a16="http://schemas.microsoft.com/office/drawing/2014/main" id="{E7FEBCD1-729A-4376-B4BC-807E79440581}"/>
               </a:ext>
             </a:extLst>
           </p:cNvPr>
@@ -12351,7 +12479,7 @@
           <p:cNvPr id="20" name="">
             <a:extLst xmlns:a="http://schemas.openxmlformats.org/drawingml/2006/main">
               <a:ext uri="{FF2B5EF4-FFF2-40B4-BE49-F238E27FC236}">
-                <a16:creationId xmlns:a16="http://schemas.microsoft.com/office/drawing/2014/main" id="{4D9EF77C-7C7E-4A5A-B3E9-5190DD340A5A}"/>
+                <a16:creationId xmlns:a16="http://schemas.microsoft.com/office/drawing/2014/main" id="{8DB0B302-A3C5-456B-8E9C-896EFC22B0D8}"/>
               </a:ext>
             </a:extLst>
           </p:cNvPr>
@@ -12396,7 +12524,7 @@
           <p:cNvPr id="21" name="">
             <a:extLst xmlns:a="http://schemas.openxmlformats.org/drawingml/2006/main">
               <a:ext uri="{FF2B5EF4-FFF2-40B4-BE49-F238E27FC236}">
-                <a16:creationId xmlns:a16="http://schemas.microsoft.com/office/drawing/2014/main" id="{0547C900-0E24-4A93-97E3-2D99C4C6F3D9}"/>
+                <a16:creationId xmlns:a16="http://schemas.microsoft.com/office/drawing/2014/main" id="{52C2391F-E9A4-42F8-A4F5-A2173940EE6A}"/>
               </a:ext>
             </a:extLst>
           </p:cNvPr>
@@ -12429,7 +12557,7 @@
           <p:cNvPr id="22" name="">
             <a:extLst xmlns:a="http://schemas.openxmlformats.org/drawingml/2006/main">
               <a:ext uri="{FF2B5EF4-FFF2-40B4-BE49-F238E27FC236}">
-                <a16:creationId xmlns:a16="http://schemas.microsoft.com/office/drawing/2014/main" id="{349B7A55-ADDE-42E7-9583-328C0D403C78}"/>
+                <a16:creationId xmlns:a16="http://schemas.microsoft.com/office/drawing/2014/main" id="{4FFA31F7-91E0-4908-B5D5-DE1C618B54C2}"/>
               </a:ext>
             </a:extLst>
           </p:cNvPr>
@@ -12474,7 +12602,7 @@
           <p:cNvPr id="23" name="">
             <a:extLst xmlns:a="http://schemas.openxmlformats.org/drawingml/2006/main">
               <a:ext uri="{FF2B5EF4-FFF2-40B4-BE49-F238E27FC236}">
-                <a16:creationId xmlns:a16="http://schemas.microsoft.com/office/drawing/2014/main" id="{6D6D3690-CDA0-4639-A285-101CFCC46220}"/>
+                <a16:creationId xmlns:a16="http://schemas.microsoft.com/office/drawing/2014/main" id="{B0AB54C1-01A8-43CA-9812-16D17D033570}"/>
               </a:ext>
             </a:extLst>
           </p:cNvPr>
@@ -12519,7 +12647,7 @@
           <p:cNvPr id="24" name="">
             <a:extLst xmlns:a="http://schemas.openxmlformats.org/drawingml/2006/main">
               <a:ext uri="{FF2B5EF4-FFF2-40B4-BE49-F238E27FC236}">
-                <a16:creationId xmlns:a16="http://schemas.microsoft.com/office/drawing/2014/main" id="{C4A7A322-58D4-4E09-A3FA-2F7047D280FE}"/>
+                <a16:creationId xmlns:a16="http://schemas.microsoft.com/office/drawing/2014/main" id="{E40C9A19-9DB2-4FA3-8C30-7FB7698562CF}"/>
               </a:ext>
             </a:extLst>
           </p:cNvPr>
@@ -12564,7 +12692,7 @@
           <p:cNvPr id="25" name="">
             <a:extLst xmlns:a="http://schemas.openxmlformats.org/drawingml/2006/main">
               <a:ext uri="{FF2B5EF4-FFF2-40B4-BE49-F238E27FC236}">
-                <a16:creationId xmlns:a16="http://schemas.microsoft.com/office/drawing/2014/main" id="{7900E0F3-7D52-4528-A99B-FC2C6DC965B5}"/>
+                <a16:creationId xmlns:a16="http://schemas.microsoft.com/office/drawing/2014/main" id="{1ED3BC74-060D-49DE-ACD4-2A17E25D613E}"/>
               </a:ext>
             </a:extLst>
           </p:cNvPr>
@@ -12597,7 +12725,7 @@
           <p:cNvPr id="26" name="">
             <a:extLst xmlns:a="http://schemas.openxmlformats.org/drawingml/2006/main">
               <a:ext uri="{FF2B5EF4-FFF2-40B4-BE49-F238E27FC236}">
-                <a16:creationId xmlns:a16="http://schemas.microsoft.com/office/drawing/2014/main" id="{34FF8F1A-8F7A-44B9-BDBC-CEE6D4041FFF}"/>
+                <a16:creationId xmlns:a16="http://schemas.microsoft.com/office/drawing/2014/main" id="{6A1654A7-1EE4-447E-A6C4-0FBBA5365D80}"/>
               </a:ext>
             </a:extLst>
           </p:cNvPr>
@@ -12642,7 +12770,7 @@
           <p:cNvPr id="27" name="">
             <a:extLst xmlns:a="http://schemas.openxmlformats.org/drawingml/2006/main">
               <a:ext uri="{FF2B5EF4-FFF2-40B4-BE49-F238E27FC236}">
-                <a16:creationId xmlns:a16="http://schemas.microsoft.com/office/drawing/2014/main" id="{CA1FE7F0-28D4-4F76-8DF7-46CABA0EADFD}"/>
+                <a16:creationId xmlns:a16="http://schemas.microsoft.com/office/drawing/2014/main" id="{B718BE2B-6E5E-4E67-AAC7-4BECE573AFF4}"/>
               </a:ext>
             </a:extLst>
           </p:cNvPr>
@@ -12687,7 +12815,7 @@
           <p:cNvPr id="28" name="">
             <a:extLst xmlns:a="http://schemas.openxmlformats.org/drawingml/2006/main">
               <a:ext uri="{FF2B5EF4-FFF2-40B4-BE49-F238E27FC236}">
-                <a16:creationId xmlns:a16="http://schemas.microsoft.com/office/drawing/2014/main" id="{18D93C5D-78A8-4CC9-B1E3-64B28DEEDC87}"/>
+                <a16:creationId xmlns:a16="http://schemas.microsoft.com/office/drawing/2014/main" id="{F779002C-7E91-4782-8D7C-B6962A1D3E79}"/>
               </a:ext>
             </a:extLst>
           </p:cNvPr>
@@ -12732,7 +12860,7 @@
           <p:cNvPr id="29" name="footer-left">
             <a:extLst xmlns:a="http://schemas.openxmlformats.org/drawingml/2006/main">
               <a:ext uri="{FF2B5EF4-FFF2-40B4-BE49-F238E27FC236}">
-                <a16:creationId xmlns:a16="http://schemas.microsoft.com/office/drawing/2014/main" id="{F1DC0F73-67F2-4C72-AA5F-3718E2A2F674}"/>
+                <a16:creationId xmlns:a16="http://schemas.microsoft.com/office/drawing/2014/main" id="{75510CA7-6546-4EED-BB9E-FF5544FA4F32}"/>
               </a:ext>
             </a:extLst>
           </p:cNvPr>
@@ -12777,7 +12905,7 @@
           <p:cNvPr id="30" name="footer-right">
             <a:extLst xmlns:a="http://schemas.openxmlformats.org/drawingml/2006/main">
               <a:ext uri="{FF2B5EF4-FFF2-40B4-BE49-F238E27FC236}">
-                <a16:creationId xmlns:a16="http://schemas.microsoft.com/office/drawing/2014/main" id="{0B5800A3-25DF-45A2-8E7E-A3B5EED111C2}"/>
+                <a16:creationId xmlns:a16="http://schemas.microsoft.com/office/drawing/2014/main" id="{3A509A7A-A7DA-44D5-BA26-4410A2CFF4B9}"/>
               </a:ext>
             </a:extLst>
           </p:cNvPr>
@@ -12820,7 +12948,7 @@
     </p:spTree>
     <p:extLst>
       <p:ext uri="{BB962C8B-B14F-4D97-AF65-F5344CB8AC3E}">
-        <p14:creationId xmlns:p14="http://schemas.microsoft.com/office/powerpoint/2010/main" val="1361070387"/>
+        <p14:creationId xmlns:p14="http://schemas.microsoft.com/office/powerpoint/2010/main" val="802387355"/>
       </p:ext>
     </p:extLst>
   </p:cSld>
@@ -12844,7 +12972,7 @@
           <p:cNvPr id="1" name="slide-stage">
             <a:extLst xmlns:a="http://schemas.openxmlformats.org/drawingml/2006/main">
               <a:ext uri="{FF2B5EF4-FFF2-40B4-BE49-F238E27FC236}">
-                <a16:creationId xmlns:a16="http://schemas.microsoft.com/office/drawing/2014/main" id="{121D6E2C-186F-42A7-808A-051EEA83C44C}"/>
+                <a16:creationId xmlns:a16="http://schemas.microsoft.com/office/drawing/2014/main" id="{4AECC966-6B49-4921-9ECA-77172C2DBE60}"/>
               </a:ext>
             </a:extLst>
           </p:cNvPr>
@@ -12871,7 +12999,7 @@
           <p:cNvPr id="2" name="eyebrow">
             <a:extLst xmlns:a="http://schemas.openxmlformats.org/drawingml/2006/main">
               <a:ext uri="{FF2B5EF4-FFF2-40B4-BE49-F238E27FC236}">
-                <a16:creationId xmlns:a16="http://schemas.microsoft.com/office/drawing/2014/main" id="{38D11AE0-37DF-401E-888B-C37931B8C92A}"/>
+                <a16:creationId xmlns:a16="http://schemas.microsoft.com/office/drawing/2014/main" id="{512CC6E9-2574-464E-9C0D-381FBDECC956}"/>
               </a:ext>
             </a:extLst>
           </p:cNvPr>
@@ -12916,7 +13044,7 @@
           <p:cNvPr id="3" name="slide-title">
             <a:extLst xmlns:a="http://schemas.openxmlformats.org/drawingml/2006/main">
               <a:ext uri="{FF2B5EF4-FFF2-40B4-BE49-F238E27FC236}">
-                <a16:creationId xmlns:a16="http://schemas.microsoft.com/office/drawing/2014/main" id="{9419A003-7F9C-4D94-B136-B9E35D418E3C}"/>
+                <a16:creationId xmlns:a16="http://schemas.microsoft.com/office/drawing/2014/main" id="{960D046B-9EEC-474B-AC7F-43A1D52C8CD1}"/>
               </a:ext>
             </a:extLst>
           </p:cNvPr>
@@ -12961,7 +13089,7 @@
           <p:cNvPr id="4" name="slide-subtitle">
             <a:extLst xmlns:a="http://schemas.openxmlformats.org/drawingml/2006/main">
               <a:ext uri="{FF2B5EF4-FFF2-40B4-BE49-F238E27FC236}">
-                <a16:creationId xmlns:a16="http://schemas.microsoft.com/office/drawing/2014/main" id="{C4FA3A7F-AC51-4AB7-AB8A-184C98B6FC63}"/>
+                <a16:creationId xmlns:a16="http://schemas.microsoft.com/office/drawing/2014/main" id="{96E3FECA-D946-4C0D-A745-71EDCEDD37D7}"/>
               </a:ext>
             </a:extLst>
           </p:cNvPr>
@@ -13006,7 +13134,7 @@
           <p:cNvPr id="5" name="">
             <a:extLst xmlns:a="http://schemas.openxmlformats.org/drawingml/2006/main">
               <a:ext uri="{FF2B5EF4-FFF2-40B4-BE49-F238E27FC236}">
-                <a16:creationId xmlns:a16="http://schemas.microsoft.com/office/drawing/2014/main" id="{65C570E7-F2E6-4A03-BC2F-9616ED98ECCB}"/>
+                <a16:creationId xmlns:a16="http://schemas.microsoft.com/office/drawing/2014/main" id="{D80FBF86-A88A-42F9-8333-E82D5220E234}"/>
               </a:ext>
             </a:extLst>
           </p:cNvPr>
@@ -13051,7 +13179,7 @@
           <p:cNvPr id="6" name="">
             <a:extLst xmlns:a="http://schemas.openxmlformats.org/drawingml/2006/main">
               <a:ext uri="{FF2B5EF4-FFF2-40B4-BE49-F238E27FC236}">
-                <a16:creationId xmlns:a16="http://schemas.microsoft.com/office/drawing/2014/main" id="{299D6410-02DE-4A3D-AC66-8758B6F9DEBE}"/>
+                <a16:creationId xmlns:a16="http://schemas.microsoft.com/office/drawing/2014/main" id="{A7ABE885-46E4-4553-8B0A-D9EADFBA7147}"/>
               </a:ext>
             </a:extLst>
           </p:cNvPr>
@@ -13086,7 +13214,7 @@
           <p:cNvPr id="7" name="">
             <a:extLst xmlns:a="http://schemas.openxmlformats.org/drawingml/2006/main">
               <a:ext uri="{FF2B5EF4-FFF2-40B4-BE49-F238E27FC236}">
-                <a16:creationId xmlns:a16="http://schemas.microsoft.com/office/drawing/2014/main" id="{A34C177B-5998-4A4E-B2F1-5B296BE592E9}"/>
+                <a16:creationId xmlns:a16="http://schemas.microsoft.com/office/drawing/2014/main" id="{E77C7642-3892-4891-9ED5-89A548D56C10}"/>
               </a:ext>
             </a:extLst>
           </p:cNvPr>
@@ -13131,7 +13259,7 @@
           <p:cNvPr id="8" name="">
             <a:extLst xmlns:a="http://schemas.openxmlformats.org/drawingml/2006/main">
               <a:ext uri="{FF2B5EF4-FFF2-40B4-BE49-F238E27FC236}">
-                <a16:creationId xmlns:a16="http://schemas.microsoft.com/office/drawing/2014/main" id="{A0A54BB2-C421-481C-B122-43B42558CD88}"/>
+                <a16:creationId xmlns:a16="http://schemas.microsoft.com/office/drawing/2014/main" id="{44BFA504-AC42-411F-A9D9-546440FC7873}"/>
               </a:ext>
             </a:extLst>
           </p:cNvPr>
@@ -13176,7 +13304,7 @@
           <p:cNvPr id="9" name="">
             <a:extLst xmlns:a="http://schemas.openxmlformats.org/drawingml/2006/main">
               <a:ext uri="{FF2B5EF4-FFF2-40B4-BE49-F238E27FC236}">
-                <a16:creationId xmlns:a16="http://schemas.microsoft.com/office/drawing/2014/main" id="{E42264E5-8E39-484F-B555-1235FFD7094C}"/>
+                <a16:creationId xmlns:a16="http://schemas.microsoft.com/office/drawing/2014/main" id="{07A11677-8421-41D4-8AEB-F7BC894858D0}"/>
               </a:ext>
             </a:extLst>
           </p:cNvPr>
@@ -13221,7 +13349,7 @@
           <p:cNvPr id="10" name="">
             <a:extLst xmlns:a="http://schemas.openxmlformats.org/drawingml/2006/main">
               <a:ext uri="{FF2B5EF4-FFF2-40B4-BE49-F238E27FC236}">
-                <a16:creationId xmlns:a16="http://schemas.microsoft.com/office/drawing/2014/main" id="{9A6A4875-4176-45AD-8CDE-20C1B0C36089}"/>
+                <a16:creationId xmlns:a16="http://schemas.microsoft.com/office/drawing/2014/main" id="{B67D1EDD-60BE-46D0-BD7E-30805651D0CF}"/>
               </a:ext>
             </a:extLst>
           </p:cNvPr>
@@ -13256,7 +13384,7 @@
           <p:cNvPr id="11" name="">
             <a:extLst xmlns:a="http://schemas.openxmlformats.org/drawingml/2006/main">
               <a:ext uri="{FF2B5EF4-FFF2-40B4-BE49-F238E27FC236}">
-                <a16:creationId xmlns:a16="http://schemas.microsoft.com/office/drawing/2014/main" id="{A0F5ACA1-7476-4A2E-B643-091995660AF1}"/>
+                <a16:creationId xmlns:a16="http://schemas.microsoft.com/office/drawing/2014/main" id="{2FFED786-4E5B-4300-BA9F-A774B005580B}"/>
               </a:ext>
             </a:extLst>
           </p:cNvPr>
@@ -13301,7 +13429,7 @@
           <p:cNvPr id="12" name="">
             <a:extLst xmlns:a="http://schemas.openxmlformats.org/drawingml/2006/main">
               <a:ext uri="{FF2B5EF4-FFF2-40B4-BE49-F238E27FC236}">
-                <a16:creationId xmlns:a16="http://schemas.microsoft.com/office/drawing/2014/main" id="{C2B7F0DB-06E4-48DE-AAF1-4266783B068A}"/>
+                <a16:creationId xmlns:a16="http://schemas.microsoft.com/office/drawing/2014/main" id="{1877F9E3-4632-48A1-9BB3-A67ECFFD6FBC}"/>
               </a:ext>
             </a:extLst>
           </p:cNvPr>
@@ -13346,7 +13474,7 @@
           <p:cNvPr id="13" name="">
             <a:extLst xmlns:a="http://schemas.openxmlformats.org/drawingml/2006/main">
               <a:ext uri="{FF2B5EF4-FFF2-40B4-BE49-F238E27FC236}">
-                <a16:creationId xmlns:a16="http://schemas.microsoft.com/office/drawing/2014/main" id="{6A22717C-39A7-415D-A276-F773BD4E6F68}"/>
+                <a16:creationId xmlns:a16="http://schemas.microsoft.com/office/drawing/2014/main" id="{CB1DC758-FF96-43A1-A5B8-F1A0E79695A3}"/>
               </a:ext>
             </a:extLst>
           </p:cNvPr>
@@ -13391,7 +13519,7 @@
           <p:cNvPr id="14" name="">
             <a:extLst xmlns:a="http://schemas.openxmlformats.org/drawingml/2006/main">
               <a:ext uri="{FF2B5EF4-FFF2-40B4-BE49-F238E27FC236}">
-                <a16:creationId xmlns:a16="http://schemas.microsoft.com/office/drawing/2014/main" id="{01C39FA4-28F1-4F9B-9BAC-DCA62933E279}"/>
+                <a16:creationId xmlns:a16="http://schemas.microsoft.com/office/drawing/2014/main" id="{554FB6C6-CC08-4BB3-9AA6-2FD55CB03684}"/>
               </a:ext>
             </a:extLst>
           </p:cNvPr>
@@ -13426,7 +13554,7 @@
           <p:cNvPr id="15" name="">
             <a:extLst xmlns:a="http://schemas.openxmlformats.org/drawingml/2006/main">
               <a:ext uri="{FF2B5EF4-FFF2-40B4-BE49-F238E27FC236}">
-                <a16:creationId xmlns:a16="http://schemas.microsoft.com/office/drawing/2014/main" id="{1D0DC7AA-53FC-488A-BAF0-C52D5FC5770A}"/>
+                <a16:creationId xmlns:a16="http://schemas.microsoft.com/office/drawing/2014/main" id="{407E3F18-96B7-4D70-8962-0050DD3F9569}"/>
               </a:ext>
             </a:extLst>
           </p:cNvPr>
@@ -13471,7 +13599,7 @@
           <p:cNvPr id="16" name="">
             <a:extLst xmlns:a="http://schemas.openxmlformats.org/drawingml/2006/main">
               <a:ext uri="{FF2B5EF4-FFF2-40B4-BE49-F238E27FC236}">
-                <a16:creationId xmlns:a16="http://schemas.microsoft.com/office/drawing/2014/main" id="{BB00F1E7-BEB0-436E-8A4C-01089FC48B1D}"/>
+                <a16:creationId xmlns:a16="http://schemas.microsoft.com/office/drawing/2014/main" id="{9844194E-1F1F-4129-B733-C64FD9A9D794}"/>
               </a:ext>
             </a:extLst>
           </p:cNvPr>
@@ -13516,7 +13644,7 @@
           <p:cNvPr id="17" name="">
             <a:extLst xmlns:a="http://schemas.openxmlformats.org/drawingml/2006/main">
               <a:ext uri="{FF2B5EF4-FFF2-40B4-BE49-F238E27FC236}">
-                <a16:creationId xmlns:a16="http://schemas.microsoft.com/office/drawing/2014/main" id="{2139EA21-7DBC-48F1-8F81-6CA000A82105}"/>
+                <a16:creationId xmlns:a16="http://schemas.microsoft.com/office/drawing/2014/main" id="{48ECD49D-82E8-4176-A90D-37C02AAA2EF1}"/>
               </a:ext>
             </a:extLst>
           </p:cNvPr>
@@ -13561,7 +13689,7 @@
           <p:cNvPr id="18" name="">
             <a:extLst xmlns:a="http://schemas.openxmlformats.org/drawingml/2006/main">
               <a:ext uri="{FF2B5EF4-FFF2-40B4-BE49-F238E27FC236}">
-                <a16:creationId xmlns:a16="http://schemas.microsoft.com/office/drawing/2014/main" id="{FF86FC2C-87C9-4C1C-ADBD-2B57D6B92479}"/>
+                <a16:creationId xmlns:a16="http://schemas.microsoft.com/office/drawing/2014/main" id="{B8FFC034-C7D4-48CC-90FB-4FF97B19769D}"/>
               </a:ext>
             </a:extLst>
           </p:cNvPr>
@@ -13596,7 +13724,7 @@
           <p:cNvPr id="19" name="">
             <a:extLst xmlns:a="http://schemas.openxmlformats.org/drawingml/2006/main">
               <a:ext uri="{FF2B5EF4-FFF2-40B4-BE49-F238E27FC236}">
-                <a16:creationId xmlns:a16="http://schemas.microsoft.com/office/drawing/2014/main" id="{3C522F25-78C2-45D4-A150-B2AA2322033F}"/>
+                <a16:creationId xmlns:a16="http://schemas.microsoft.com/office/drawing/2014/main" id="{4AF5BBD0-572E-4F44-89F5-3CE269C68314}"/>
               </a:ext>
             </a:extLst>
           </p:cNvPr>
@@ -13641,7 +13769,7 @@
           <p:cNvPr id="20" name="">
             <a:extLst xmlns:a="http://schemas.openxmlformats.org/drawingml/2006/main">
               <a:ext uri="{FF2B5EF4-FFF2-40B4-BE49-F238E27FC236}">
-                <a16:creationId xmlns:a16="http://schemas.microsoft.com/office/drawing/2014/main" id="{BA513F26-CAC7-4B46-9DB0-C1000AF4AC48}"/>
+                <a16:creationId xmlns:a16="http://schemas.microsoft.com/office/drawing/2014/main" id="{70A7595E-8C79-4EF8-8273-90B93525121E}"/>
               </a:ext>
             </a:extLst>
           </p:cNvPr>
@@ -13686,7 +13814,7 @@
           <p:cNvPr id="21" name="">
             <a:extLst xmlns:a="http://schemas.openxmlformats.org/drawingml/2006/main">
               <a:ext uri="{FF2B5EF4-FFF2-40B4-BE49-F238E27FC236}">
-                <a16:creationId xmlns:a16="http://schemas.microsoft.com/office/drawing/2014/main" id="{5CD44723-BC40-4CEE-993D-FAF9CC4EA138}"/>
+                <a16:creationId xmlns:a16="http://schemas.microsoft.com/office/drawing/2014/main" id="{73EE37B9-E110-4570-98B9-4EE93C1EFDB2}"/>
               </a:ext>
             </a:extLst>
           </p:cNvPr>
@@ -13731,7 +13859,7 @@
           <p:cNvPr id="22" name="">
             <a:extLst xmlns:a="http://schemas.openxmlformats.org/drawingml/2006/main">
               <a:ext uri="{FF2B5EF4-FFF2-40B4-BE49-F238E27FC236}">
-                <a16:creationId xmlns:a16="http://schemas.microsoft.com/office/drawing/2014/main" id="{AE7425BB-DF40-4188-9D20-79D5BF2F09FB}"/>
+                <a16:creationId xmlns:a16="http://schemas.microsoft.com/office/drawing/2014/main" id="{38E42927-8865-45B5-AAC4-1E097BCA3232}"/>
               </a:ext>
             </a:extLst>
           </p:cNvPr>
@@ -13766,7 +13894,7 @@
           <p:cNvPr id="23" name="">
             <a:extLst xmlns:a="http://schemas.openxmlformats.org/drawingml/2006/main">
               <a:ext uri="{FF2B5EF4-FFF2-40B4-BE49-F238E27FC236}">
-                <a16:creationId xmlns:a16="http://schemas.microsoft.com/office/drawing/2014/main" id="{4783A19C-023F-4497-B026-2C09755CD5B3}"/>
+                <a16:creationId xmlns:a16="http://schemas.microsoft.com/office/drawing/2014/main" id="{959609A0-0D27-49B2-992C-22B533480D38}"/>
               </a:ext>
             </a:extLst>
           </p:cNvPr>
@@ -13811,7 +13939,7 @@
           <p:cNvPr id="24" name="">
             <a:extLst xmlns:a="http://schemas.openxmlformats.org/drawingml/2006/main">
               <a:ext uri="{FF2B5EF4-FFF2-40B4-BE49-F238E27FC236}">
-                <a16:creationId xmlns:a16="http://schemas.microsoft.com/office/drawing/2014/main" id="{95018670-BFFD-44C9-B87C-03B8373E3077}"/>
+                <a16:creationId xmlns:a16="http://schemas.microsoft.com/office/drawing/2014/main" id="{78D8F52E-FED3-42BD-9625-C67BC3D671DD}"/>
               </a:ext>
             </a:extLst>
           </p:cNvPr>
@@ -13856,7 +13984,7 @@
           <p:cNvPr id="25" name="footer-left">
             <a:extLst xmlns:a="http://schemas.openxmlformats.org/drawingml/2006/main">
               <a:ext uri="{FF2B5EF4-FFF2-40B4-BE49-F238E27FC236}">
-                <a16:creationId xmlns:a16="http://schemas.microsoft.com/office/drawing/2014/main" id="{36B1D4E8-7B35-4779-B859-367B6A931D22}"/>
+                <a16:creationId xmlns:a16="http://schemas.microsoft.com/office/drawing/2014/main" id="{3D145DA3-491F-46DF-B15E-4DE38F024694}"/>
               </a:ext>
             </a:extLst>
           </p:cNvPr>
@@ -13901,7 +14029,7 @@
           <p:cNvPr id="26" name="footer-right">
             <a:extLst xmlns:a="http://schemas.openxmlformats.org/drawingml/2006/main">
               <a:ext uri="{FF2B5EF4-FFF2-40B4-BE49-F238E27FC236}">
-                <a16:creationId xmlns:a16="http://schemas.microsoft.com/office/drawing/2014/main" id="{E4CBB8B6-7757-47F9-BD40-969CE99C0C6E}"/>
+                <a16:creationId xmlns:a16="http://schemas.microsoft.com/office/drawing/2014/main" id="{6857C547-675F-441C-94EE-235BC43B9C9C}"/>
               </a:ext>
             </a:extLst>
           </p:cNvPr>
@@ -13944,7 +14072,7 @@
     </p:spTree>
     <p:extLst>
       <p:ext uri="{BB962C8B-B14F-4D97-AF65-F5344CB8AC3E}">
-        <p14:creationId xmlns:p14="http://schemas.microsoft.com/office/powerpoint/2010/main" val="393817817"/>
+        <p14:creationId xmlns:p14="http://schemas.microsoft.com/office/powerpoint/2010/main" val="1701728245"/>
       </p:ext>
     </p:extLst>
   </p:cSld>
@@ -13968,7 +14096,7 @@
           <p:cNvPr id="1" name="slide-stage">
             <a:extLst xmlns:a="http://schemas.openxmlformats.org/drawingml/2006/main">
               <a:ext uri="{FF2B5EF4-FFF2-40B4-BE49-F238E27FC236}">
-                <a16:creationId xmlns:a16="http://schemas.microsoft.com/office/drawing/2014/main" id="{11E784D9-C903-4C39-BFEB-AB15FCFA6FD0}"/>
+                <a16:creationId xmlns:a16="http://schemas.microsoft.com/office/drawing/2014/main" id="{8AFEBECE-296F-4E01-BB68-A20389F0D297}"/>
               </a:ext>
             </a:extLst>
           </p:cNvPr>
@@ -13995,7 +14123,7 @@
           <p:cNvPr id="2" name="eyebrow">
             <a:extLst xmlns:a="http://schemas.openxmlformats.org/drawingml/2006/main">
               <a:ext uri="{FF2B5EF4-FFF2-40B4-BE49-F238E27FC236}">
-                <a16:creationId xmlns:a16="http://schemas.microsoft.com/office/drawing/2014/main" id="{761AFC41-D739-4E76-8A76-4F4A310E07BD}"/>
+                <a16:creationId xmlns:a16="http://schemas.microsoft.com/office/drawing/2014/main" id="{684CA95F-B532-46FE-B05C-6CE0C3345F0B}"/>
               </a:ext>
             </a:extLst>
           </p:cNvPr>
@@ -14040,7 +14168,7 @@
           <p:cNvPr id="3" name="slide-title">
             <a:extLst xmlns:a="http://schemas.openxmlformats.org/drawingml/2006/main">
               <a:ext uri="{FF2B5EF4-FFF2-40B4-BE49-F238E27FC236}">
-                <a16:creationId xmlns:a16="http://schemas.microsoft.com/office/drawing/2014/main" id="{EC4AFC63-1DF9-4D6B-9703-B9224F0BC756}"/>
+                <a16:creationId xmlns:a16="http://schemas.microsoft.com/office/drawing/2014/main" id="{C36C36D7-4BB7-406E-809B-1157C6FD3ECF}"/>
               </a:ext>
             </a:extLst>
           </p:cNvPr>
@@ -14085,7 +14213,7 @@
           <p:cNvPr id="4" name="slide-subtitle">
             <a:extLst xmlns:a="http://schemas.openxmlformats.org/drawingml/2006/main">
               <a:ext uri="{FF2B5EF4-FFF2-40B4-BE49-F238E27FC236}">
-                <a16:creationId xmlns:a16="http://schemas.microsoft.com/office/drawing/2014/main" id="{51112165-97D1-4C26-8AEC-C42604CE683D}"/>
+                <a16:creationId xmlns:a16="http://schemas.microsoft.com/office/drawing/2014/main" id="{DCA2699D-1FC8-4409-95C0-B2BFB28BE46F}"/>
               </a:ext>
             </a:extLst>
           </p:cNvPr>
@@ -14130,7 +14258,7 @@
           <p:cNvPr id="5" name="">
             <a:extLst xmlns:a="http://schemas.openxmlformats.org/drawingml/2006/main">
               <a:ext uri="{FF2B5EF4-FFF2-40B4-BE49-F238E27FC236}">
-                <a16:creationId xmlns:a16="http://schemas.microsoft.com/office/drawing/2014/main" id="{C34397B3-AA02-4B15-B125-718F06A10D83}"/>
+                <a16:creationId xmlns:a16="http://schemas.microsoft.com/office/drawing/2014/main" id="{1A73CEDE-495B-4394-B664-2FD3B9ED3EE4}"/>
               </a:ext>
             </a:extLst>
           </p:cNvPr>
@@ -14163,7 +14291,7 @@
           <p:cNvPr id="6" name="">
             <a:extLst xmlns:a="http://schemas.openxmlformats.org/drawingml/2006/main">
               <a:ext uri="{FF2B5EF4-FFF2-40B4-BE49-F238E27FC236}">
-                <a16:creationId xmlns:a16="http://schemas.microsoft.com/office/drawing/2014/main" id="{00993B8D-566B-40FC-832E-3B8184C468FB}"/>
+                <a16:creationId xmlns:a16="http://schemas.microsoft.com/office/drawing/2014/main" id="{45090DA2-0E1F-443D-88F8-6875698D55F0}"/>
               </a:ext>
             </a:extLst>
           </p:cNvPr>
@@ -14208,7 +14336,7 @@
           <p:cNvPr id="7" name="">
             <a:extLst xmlns:a="http://schemas.openxmlformats.org/drawingml/2006/main">
               <a:ext uri="{FF2B5EF4-FFF2-40B4-BE49-F238E27FC236}">
-                <a16:creationId xmlns:a16="http://schemas.microsoft.com/office/drawing/2014/main" id="{AC4C5D0A-965E-4AEA-948D-9DCA4990812A}"/>
+                <a16:creationId xmlns:a16="http://schemas.microsoft.com/office/drawing/2014/main" id="{72AA516F-15F8-485B-9A57-088B7F939F50}"/>
               </a:ext>
             </a:extLst>
           </p:cNvPr>
@@ -14253,7 +14381,7 @@
           <p:cNvPr id="8" name="">
             <a:extLst xmlns:a="http://schemas.openxmlformats.org/drawingml/2006/main">
               <a:ext uri="{FF2B5EF4-FFF2-40B4-BE49-F238E27FC236}">
-                <a16:creationId xmlns:a16="http://schemas.microsoft.com/office/drawing/2014/main" id="{04B08A04-C2AE-4222-BE8C-6E9D3BBD3EC4}"/>
+                <a16:creationId xmlns:a16="http://schemas.microsoft.com/office/drawing/2014/main" id="{13D30066-230A-4DFC-ABCE-F00133C5D877}"/>
               </a:ext>
             </a:extLst>
           </p:cNvPr>
@@ -14286,7 +14414,7 @@
           <p:cNvPr id="9" name="">
             <a:extLst xmlns:a="http://schemas.openxmlformats.org/drawingml/2006/main">
               <a:ext uri="{FF2B5EF4-FFF2-40B4-BE49-F238E27FC236}">
-                <a16:creationId xmlns:a16="http://schemas.microsoft.com/office/drawing/2014/main" id="{D4E3ABDF-FAFB-4F72-B9F8-E9A1F1DA39FA}"/>
+                <a16:creationId xmlns:a16="http://schemas.microsoft.com/office/drawing/2014/main" id="{5C736F0B-756A-4F44-9C80-698BCCDF126D}"/>
               </a:ext>
             </a:extLst>
           </p:cNvPr>
@@ -14331,7 +14459,7 @@
           <p:cNvPr id="10" name="">
             <a:extLst xmlns:a="http://schemas.openxmlformats.org/drawingml/2006/main">
               <a:ext uri="{FF2B5EF4-FFF2-40B4-BE49-F238E27FC236}">
-                <a16:creationId xmlns:a16="http://schemas.microsoft.com/office/drawing/2014/main" id="{6459A15B-6100-4627-9300-5790E800C077}"/>
+                <a16:creationId xmlns:a16="http://schemas.microsoft.com/office/drawing/2014/main" id="{F4CCD210-C8E0-441B-9123-04E4D68B22F6}"/>
               </a:ext>
             </a:extLst>
           </p:cNvPr>
@@ -14376,7 +14504,7 @@
           <p:cNvPr id="11" name="">
             <a:extLst xmlns:a="http://schemas.openxmlformats.org/drawingml/2006/main">
               <a:ext uri="{FF2B5EF4-FFF2-40B4-BE49-F238E27FC236}">
-                <a16:creationId xmlns:a16="http://schemas.microsoft.com/office/drawing/2014/main" id="{A6BAC9A2-AD21-421E-B87E-F0BF905E3B70}"/>
+                <a16:creationId xmlns:a16="http://schemas.microsoft.com/office/drawing/2014/main" id="{ADE2872D-015C-412F-BD63-DB4E3F5D2BCB}"/>
               </a:ext>
             </a:extLst>
           </p:cNvPr>
@@ -14409,7 +14537,7 @@
           <p:cNvPr id="12" name="">
             <a:extLst xmlns:a="http://schemas.openxmlformats.org/drawingml/2006/main">
               <a:ext uri="{FF2B5EF4-FFF2-40B4-BE49-F238E27FC236}">
-                <a16:creationId xmlns:a16="http://schemas.microsoft.com/office/drawing/2014/main" id="{7038FD3F-64DA-461D-973C-BF3B64F2A33B}"/>
+                <a16:creationId xmlns:a16="http://schemas.microsoft.com/office/drawing/2014/main" id="{9D3422B8-A9C6-4EF2-9A01-21F03403E317}"/>
               </a:ext>
             </a:extLst>
           </p:cNvPr>
@@ -14454,7 +14582,7 @@
           <p:cNvPr id="13" name="">
             <a:extLst xmlns:a="http://schemas.openxmlformats.org/drawingml/2006/main">
               <a:ext uri="{FF2B5EF4-FFF2-40B4-BE49-F238E27FC236}">
-                <a16:creationId xmlns:a16="http://schemas.microsoft.com/office/drawing/2014/main" id="{334979CB-9AF0-4932-AC00-EF3A5A747F14}"/>
+                <a16:creationId xmlns:a16="http://schemas.microsoft.com/office/drawing/2014/main" id="{98619AB0-208B-4FE1-AA80-7557DFD6CF76}"/>
               </a:ext>
             </a:extLst>
           </p:cNvPr>
@@ -14499,7 +14627,7 @@
           <p:cNvPr id="14" name="">
             <a:extLst xmlns:a="http://schemas.openxmlformats.org/drawingml/2006/main">
               <a:ext uri="{FF2B5EF4-FFF2-40B4-BE49-F238E27FC236}">
-                <a16:creationId xmlns:a16="http://schemas.microsoft.com/office/drawing/2014/main" id="{63B13E70-F4F3-4954-A2BE-EE6D8AF1392A}"/>
+                <a16:creationId xmlns:a16="http://schemas.microsoft.com/office/drawing/2014/main" id="{936E0596-337C-4B8C-948B-19279DEAFB95}"/>
               </a:ext>
             </a:extLst>
           </p:cNvPr>
@@ -14532,7 +14660,7 @@
           <p:cNvPr id="15" name="">
             <a:extLst xmlns:a="http://schemas.openxmlformats.org/drawingml/2006/main">
               <a:ext uri="{FF2B5EF4-FFF2-40B4-BE49-F238E27FC236}">
-                <a16:creationId xmlns:a16="http://schemas.microsoft.com/office/drawing/2014/main" id="{DDAED00E-B4E4-458C-8E47-3F2E892DFEA7}"/>
+                <a16:creationId xmlns:a16="http://schemas.microsoft.com/office/drawing/2014/main" id="{20CEA9CF-6D83-4BC5-985D-40EC05985694}"/>
               </a:ext>
             </a:extLst>
           </p:cNvPr>
@@ -14577,7 +14705,7 @@
           <p:cNvPr id="16" name="">
             <a:extLst xmlns:a="http://schemas.openxmlformats.org/drawingml/2006/main">
               <a:ext uri="{FF2B5EF4-FFF2-40B4-BE49-F238E27FC236}">
-                <a16:creationId xmlns:a16="http://schemas.microsoft.com/office/drawing/2014/main" id="{6752C6CB-B90B-4D07-8327-BB025A87664C}"/>
+                <a16:creationId xmlns:a16="http://schemas.microsoft.com/office/drawing/2014/main" id="{BC34790A-CB11-4EDC-8148-6A17812A96AB}"/>
               </a:ext>
             </a:extLst>
           </p:cNvPr>
@@ -14622,7 +14750,7 @@
           <p:cNvPr id="17" name="footer-left">
             <a:extLst xmlns:a="http://schemas.openxmlformats.org/drawingml/2006/main">
               <a:ext uri="{FF2B5EF4-FFF2-40B4-BE49-F238E27FC236}">
-                <a16:creationId xmlns:a16="http://schemas.microsoft.com/office/drawing/2014/main" id="{3C9819A6-96AB-4EF7-8E23-475F83FE954A}"/>
+                <a16:creationId xmlns:a16="http://schemas.microsoft.com/office/drawing/2014/main" id="{82CF4626-5FAF-4408-8C2F-C949D8EAE85F}"/>
               </a:ext>
             </a:extLst>
           </p:cNvPr>
@@ -14667,7 +14795,7 @@
           <p:cNvPr id="18" name="footer-right">
             <a:extLst xmlns:a="http://schemas.openxmlformats.org/drawingml/2006/main">
               <a:ext uri="{FF2B5EF4-FFF2-40B4-BE49-F238E27FC236}">
-                <a16:creationId xmlns:a16="http://schemas.microsoft.com/office/drawing/2014/main" id="{D5DDE8EA-D25E-4735-80BB-E8D2D738BB45}"/>
+                <a16:creationId xmlns:a16="http://schemas.microsoft.com/office/drawing/2014/main" id="{1D922650-DBD3-4A59-A9C3-DEEAC2680958}"/>
               </a:ext>
             </a:extLst>
           </p:cNvPr>
@@ -14710,7 +14838,7 @@
     </p:spTree>
     <p:extLst>
       <p:ext uri="{BB962C8B-B14F-4D97-AF65-F5344CB8AC3E}">
-        <p14:creationId xmlns:p14="http://schemas.microsoft.com/office/powerpoint/2010/main" val="1520830265"/>
+        <p14:creationId xmlns:p14="http://schemas.microsoft.com/office/powerpoint/2010/main" val="1747462724"/>
       </p:ext>
     </p:extLst>
   </p:cSld>
@@ -14734,7 +14862,7 @@
           <p:cNvPr id="1" name="slide-stage">
             <a:extLst xmlns:a="http://schemas.openxmlformats.org/drawingml/2006/main">
               <a:ext uri="{FF2B5EF4-FFF2-40B4-BE49-F238E27FC236}">
-                <a16:creationId xmlns:a16="http://schemas.microsoft.com/office/drawing/2014/main" id="{61D71293-E08B-486A-9DFE-2D9FC96251FA}"/>
+                <a16:creationId xmlns:a16="http://schemas.microsoft.com/office/drawing/2014/main" id="{4FABB624-4111-4A5E-87BE-0F57D33A69C8}"/>
               </a:ext>
             </a:extLst>
           </p:cNvPr>
@@ -14761,7 +14889,7 @@
           <p:cNvPr id="2" name="eyebrow">
             <a:extLst xmlns:a="http://schemas.openxmlformats.org/drawingml/2006/main">
               <a:ext uri="{FF2B5EF4-FFF2-40B4-BE49-F238E27FC236}">
-                <a16:creationId xmlns:a16="http://schemas.microsoft.com/office/drawing/2014/main" id="{6DF1B0C7-BB4B-45E7-ABA3-3B9A4128A9B0}"/>
+                <a16:creationId xmlns:a16="http://schemas.microsoft.com/office/drawing/2014/main" id="{BA160E83-BA2D-49D9-921B-818BD0301A0A}"/>
               </a:ext>
             </a:extLst>
           </p:cNvPr>
@@ -14806,7 +14934,7 @@
           <p:cNvPr id="3" name="slide-title">
             <a:extLst xmlns:a="http://schemas.openxmlformats.org/drawingml/2006/main">
               <a:ext uri="{FF2B5EF4-FFF2-40B4-BE49-F238E27FC236}">
-                <a16:creationId xmlns:a16="http://schemas.microsoft.com/office/drawing/2014/main" id="{7356C249-C67A-4940-ACBB-EF1D4A82DCAC}"/>
+                <a16:creationId xmlns:a16="http://schemas.microsoft.com/office/drawing/2014/main" id="{0E7C36D7-F375-4DA9-AAD8-EEBF912ED5B1}"/>
               </a:ext>
             </a:extLst>
           </p:cNvPr>
@@ -14851,7 +14979,7 @@
           <p:cNvPr id="4" name="slide-subtitle">
             <a:extLst xmlns:a="http://schemas.openxmlformats.org/drawingml/2006/main">
               <a:ext uri="{FF2B5EF4-FFF2-40B4-BE49-F238E27FC236}">
-                <a16:creationId xmlns:a16="http://schemas.microsoft.com/office/drawing/2014/main" id="{2D72A8A1-92A6-4BDC-8E9B-4C50EA887747}"/>
+                <a16:creationId xmlns:a16="http://schemas.microsoft.com/office/drawing/2014/main" id="{9D49001F-1238-47FA-88EE-5D1A5ED3DB7F}"/>
               </a:ext>
             </a:extLst>
           </p:cNvPr>
@@ -14896,7 +15024,7 @@
           <p:cNvPr id="5" name="">
             <a:extLst xmlns:a="http://schemas.openxmlformats.org/drawingml/2006/main">
               <a:ext uri="{FF2B5EF4-FFF2-40B4-BE49-F238E27FC236}">
-                <a16:creationId xmlns:a16="http://schemas.microsoft.com/office/drawing/2014/main" id="{5017CED2-38FA-4593-8953-F9EF153025A5}"/>
+                <a16:creationId xmlns:a16="http://schemas.microsoft.com/office/drawing/2014/main" id="{DFEFB059-EDEB-44EA-9292-058E2138FE8F}"/>
               </a:ext>
             </a:extLst>
           </p:cNvPr>
@@ -14941,7 +15069,7 @@
           <p:cNvPr id="6" name="">
             <a:extLst xmlns:a="http://schemas.openxmlformats.org/drawingml/2006/main">
               <a:ext uri="{FF2B5EF4-FFF2-40B4-BE49-F238E27FC236}">
-                <a16:creationId xmlns:a16="http://schemas.microsoft.com/office/drawing/2014/main" id="{702BBC8E-3B9A-46D6-80FB-551AA36EA9D0}"/>
+                <a16:creationId xmlns:a16="http://schemas.microsoft.com/office/drawing/2014/main" id="{C9618B26-8F67-459D-808D-3CC643B92559}"/>
               </a:ext>
             </a:extLst>
           </p:cNvPr>
@@ -14986,7 +15114,7 @@
           <p:cNvPr id="7" name="">
             <a:extLst xmlns:a="http://schemas.openxmlformats.org/drawingml/2006/main">
               <a:ext uri="{FF2B5EF4-FFF2-40B4-BE49-F238E27FC236}">
-                <a16:creationId xmlns:a16="http://schemas.microsoft.com/office/drawing/2014/main" id="{2909ADD9-9EC6-41FA-8F9D-800F7B259494}"/>
+                <a16:creationId xmlns:a16="http://schemas.microsoft.com/office/drawing/2014/main" id="{10B3A8AF-16BD-494A-9DA1-D59CF3BCBEEF}"/>
               </a:ext>
             </a:extLst>
           </p:cNvPr>
@@ -15031,7 +15159,7 @@
           <p:cNvPr id="8" name="">
             <a:extLst xmlns:a="http://schemas.openxmlformats.org/drawingml/2006/main">
               <a:ext uri="{FF2B5EF4-FFF2-40B4-BE49-F238E27FC236}">
-                <a16:creationId xmlns:a16="http://schemas.microsoft.com/office/drawing/2014/main" id="{84CDA97C-9A33-48B4-A778-46DB28BC4818}"/>
+                <a16:creationId xmlns:a16="http://schemas.microsoft.com/office/drawing/2014/main" id="{E064A7B5-CC78-415B-B246-7B0F351525C9}"/>
               </a:ext>
             </a:extLst>
           </p:cNvPr>
@@ -15076,7 +15204,7 @@
           <p:cNvPr id="9" name="">
             <a:extLst xmlns:a="http://schemas.openxmlformats.org/drawingml/2006/main">
               <a:ext uri="{FF2B5EF4-FFF2-40B4-BE49-F238E27FC236}">
-                <a16:creationId xmlns:a16="http://schemas.microsoft.com/office/drawing/2014/main" id="{1D0C2C6D-88DE-487A-922B-5DE0D7BC0CA2}"/>
+                <a16:creationId xmlns:a16="http://schemas.microsoft.com/office/drawing/2014/main" id="{948CFC86-CDA2-4872-A1BC-172936F36A24}"/>
               </a:ext>
             </a:extLst>
           </p:cNvPr>
@@ -15121,7 +15249,7 @@
           <p:cNvPr id="10" name="">
             <a:extLst xmlns:a="http://schemas.openxmlformats.org/drawingml/2006/main">
               <a:ext uri="{FF2B5EF4-FFF2-40B4-BE49-F238E27FC236}">
-                <a16:creationId xmlns:a16="http://schemas.microsoft.com/office/drawing/2014/main" id="{7ED61776-4ECB-4D0F-AEB2-43CAF55B1084}"/>
+                <a16:creationId xmlns:a16="http://schemas.microsoft.com/office/drawing/2014/main" id="{609C1431-6320-491F-BDD0-3E486CF836B9}"/>
               </a:ext>
             </a:extLst>
           </p:cNvPr>
@@ -15166,7 +15294,7 @@
           <p:cNvPr id="11" name="">
             <a:extLst xmlns:a="http://schemas.openxmlformats.org/drawingml/2006/main">
               <a:ext uri="{FF2B5EF4-FFF2-40B4-BE49-F238E27FC236}">
-                <a16:creationId xmlns:a16="http://schemas.microsoft.com/office/drawing/2014/main" id="{2D5B9B03-9CDC-4DCD-A2AA-F413AD7F5437}"/>
+                <a16:creationId xmlns:a16="http://schemas.microsoft.com/office/drawing/2014/main" id="{EB890D24-A9F1-4267-BEC1-A0B5C161D32A}"/>
               </a:ext>
             </a:extLst>
           </p:cNvPr>
@@ -15201,7 +15329,7 @@
           <p:cNvPr id="12" name="">
             <a:extLst xmlns:a="http://schemas.openxmlformats.org/drawingml/2006/main">
               <a:ext uri="{FF2B5EF4-FFF2-40B4-BE49-F238E27FC236}">
-                <a16:creationId xmlns:a16="http://schemas.microsoft.com/office/drawing/2014/main" id="{B4D2AD11-6BCA-46B2-9E36-1586A4AC9732}"/>
+                <a16:creationId xmlns:a16="http://schemas.microsoft.com/office/drawing/2014/main" id="{78C5CFC4-E272-4A8C-A110-A33F08EEB7E7}"/>
               </a:ext>
             </a:extLst>
           </p:cNvPr>
@@ -15246,7 +15374,7 @@
           <p:cNvPr id="13" name="">
             <a:extLst xmlns:a="http://schemas.openxmlformats.org/drawingml/2006/main">
               <a:ext uri="{FF2B5EF4-FFF2-40B4-BE49-F238E27FC236}">
-                <a16:creationId xmlns:a16="http://schemas.microsoft.com/office/drawing/2014/main" id="{5B9AD954-4BC6-4900-B330-151A5841021B}"/>
+                <a16:creationId xmlns:a16="http://schemas.microsoft.com/office/drawing/2014/main" id="{A19E7B48-DC7E-4518-91DE-6E7E29DBD160}"/>
               </a:ext>
             </a:extLst>
           </p:cNvPr>
@@ -15281,7 +15409,7 @@
           <p:cNvPr id="14" name="">
             <a:extLst xmlns:a="http://schemas.openxmlformats.org/drawingml/2006/main">
               <a:ext uri="{FF2B5EF4-FFF2-40B4-BE49-F238E27FC236}">
-                <a16:creationId xmlns:a16="http://schemas.microsoft.com/office/drawing/2014/main" id="{4C394A76-A492-43F7-BB02-53B3B4820AE3}"/>
+                <a16:creationId xmlns:a16="http://schemas.microsoft.com/office/drawing/2014/main" id="{7B5DD68D-DC61-477D-92A6-13A0679ECB5F}"/>
               </a:ext>
             </a:extLst>
           </p:cNvPr>
@@ -15326,7 +15454,7 @@
           <p:cNvPr id="15" name="">
             <a:extLst xmlns:a="http://schemas.openxmlformats.org/drawingml/2006/main">
               <a:ext uri="{FF2B5EF4-FFF2-40B4-BE49-F238E27FC236}">
-                <a16:creationId xmlns:a16="http://schemas.microsoft.com/office/drawing/2014/main" id="{98E4FD3D-85C2-4071-8272-F83077E0CAB7}"/>
+                <a16:creationId xmlns:a16="http://schemas.microsoft.com/office/drawing/2014/main" id="{318B35A1-76C6-4C99-8C67-D867112AC16A}"/>
               </a:ext>
             </a:extLst>
           </p:cNvPr>
@@ -15361,7 +15489,7 @@
           <p:cNvPr id="16" name="">
             <a:extLst xmlns:a="http://schemas.openxmlformats.org/drawingml/2006/main">
               <a:ext uri="{FF2B5EF4-FFF2-40B4-BE49-F238E27FC236}">
-                <a16:creationId xmlns:a16="http://schemas.microsoft.com/office/drawing/2014/main" id="{5C36FE37-66E8-4CFF-B23A-20DD8F8B28F2}"/>
+                <a16:creationId xmlns:a16="http://schemas.microsoft.com/office/drawing/2014/main" id="{791AB325-18B3-402E-86CA-537BD2ED7162}"/>
               </a:ext>
             </a:extLst>
           </p:cNvPr>
@@ -15406,7 +15534,7 @@
           <p:cNvPr id="17" name="footer-left">
             <a:extLst xmlns:a="http://schemas.openxmlformats.org/drawingml/2006/main">
               <a:ext uri="{FF2B5EF4-FFF2-40B4-BE49-F238E27FC236}">
-                <a16:creationId xmlns:a16="http://schemas.microsoft.com/office/drawing/2014/main" id="{56DA161A-B179-4E65-8940-B9A223F0E159}"/>
+                <a16:creationId xmlns:a16="http://schemas.microsoft.com/office/drawing/2014/main" id="{8BE19535-F3FC-4C6B-A7EB-FCA6E58AEFF7}"/>
               </a:ext>
             </a:extLst>
           </p:cNvPr>
@@ -15451,7 +15579,7 @@
           <p:cNvPr id="18" name="footer-right">
             <a:extLst xmlns:a="http://schemas.openxmlformats.org/drawingml/2006/main">
               <a:ext uri="{FF2B5EF4-FFF2-40B4-BE49-F238E27FC236}">
-                <a16:creationId xmlns:a16="http://schemas.microsoft.com/office/drawing/2014/main" id="{4B9EA37B-5E76-41CA-B0E5-B12E1CDD21BC}"/>
+                <a16:creationId xmlns:a16="http://schemas.microsoft.com/office/drawing/2014/main" id="{368F1B90-AA3A-4B64-8C6B-A24613D1F163}"/>
               </a:ext>
             </a:extLst>
           </p:cNvPr>
@@ -15494,7 +15622,7 @@
     </p:spTree>
     <p:extLst>
       <p:ext uri="{BB962C8B-B14F-4D97-AF65-F5344CB8AC3E}">
-        <p14:creationId xmlns:p14="http://schemas.microsoft.com/office/powerpoint/2010/main" val="2052081262"/>
+        <p14:creationId xmlns:p14="http://schemas.microsoft.com/office/powerpoint/2010/main" val="1166750353"/>
       </p:ext>
     </p:extLst>
   </p:cSld>

</xml_diff>